<commit_message>
docs: sync live deployment submission artifacts
</commit_message>
<xml_diff>
--- a/AURA/submission/AURA_5_SLIDES.pptx
+++ b/AURA/submission/AURA_5_SLIDES.pptx
@@ -2,17 +2,17 @@
 <file path=ppt/presentation.xml><?xml version="1.0" encoding="utf-8"?>
 <p:presentation xmlns:p="http://schemas.openxmlformats.org/presentationml/2006/main">
   <p:sldMasterIdLst>
-    <p:sldMasterId xmlns:r="http://schemas.openxmlformats.org/officeDocument/2006/relationships" id="2147483648" r:id="R2df9dcb952c346e7"/>
+    <p:sldMasterId xmlns:r="http://schemas.openxmlformats.org/officeDocument/2006/relationships" id="2147483648" r:id="R071aec8b097d4300"/>
   </p:sldMasterIdLst>
   <p:notesMasterIdLst>
-    <p:notesMasterId xmlns:r="http://schemas.openxmlformats.org/officeDocument/2006/relationships" r:id="Rc79f6310c62b4203"/>
+    <p:notesMasterId xmlns:r="http://schemas.openxmlformats.org/officeDocument/2006/relationships" r:id="Re2851056bd974a0f"/>
   </p:notesMasterIdLst>
   <p:sldIdLst>
-    <p:sldId xmlns:r="http://schemas.openxmlformats.org/officeDocument/2006/relationships" id="256" r:id="R0b834363fdd84091"/>
-    <p:sldId xmlns:r="http://schemas.openxmlformats.org/officeDocument/2006/relationships" id="257" r:id="R75111fbc928746c7"/>
-    <p:sldId xmlns:r="http://schemas.openxmlformats.org/officeDocument/2006/relationships" id="258" r:id="R130f1a04ab6e4328"/>
-    <p:sldId xmlns:r="http://schemas.openxmlformats.org/officeDocument/2006/relationships" id="259" r:id="R9fbaca921fe049e2"/>
-    <p:sldId xmlns:r="http://schemas.openxmlformats.org/officeDocument/2006/relationships" id="260" r:id="R54e951ea125b49df"/>
+    <p:sldId xmlns:r="http://schemas.openxmlformats.org/officeDocument/2006/relationships" id="256" r:id="Rf83dc657b8c14bbc"/>
+    <p:sldId xmlns:r="http://schemas.openxmlformats.org/officeDocument/2006/relationships" id="257" r:id="Rd045088fbc2c410b"/>
+    <p:sldId xmlns:r="http://schemas.openxmlformats.org/officeDocument/2006/relationships" id="258" r:id="R6de6dc70e9dc41c2"/>
+    <p:sldId xmlns:r="http://schemas.openxmlformats.org/officeDocument/2006/relationships" id="259" r:id="R10e8c09a60df422a"/>
+    <p:sldId xmlns:r="http://schemas.openxmlformats.org/officeDocument/2006/relationships" id="260" r:id="Rfcfe875cf0564600"/>
   </p:sldIdLst>
   <p:sldSz cx="12192000" cy="6858000"/>
   <p:notesSz cx="6858000" cy="9144000"/>
@@ -656,7 +656,7 @@
           <a:lstStyle xmlns:a="http://schemas.openxmlformats.org/drawingml/2006/main"/>
           <a:p xmlns:a="http://schemas.openxmlformats.org/drawingml/2006/main">
             <a:r>
-              <a:t>Repository: https://github.com/BondPhuPhamzZ/AURA — Live URL cần điền sau deploy.</a:t>
+              <a:t>Repository: https://github.com/BondPhuPhamzZ/AURA — Live URL: https://bondphupham-001-site1.ltempurl.com/</a:t>
             </a:r>
           </a:p>
         </p:txBody>
@@ -794,7 +794,7 @@
   </p:cSld>
   <p:clrMap bg1="lt1" tx1="dk1" bg2="lt2" tx2="dk2" accent1="accent1" accent2="accent2" accent3="accent3" accent4="accent4" accent5="accent5" accent6="accent6" hlink="hlink" folHlink="folHlink"/>
   <p:sldLayoutIdLst>
-    <p:sldLayoutId xmlns:r="http://schemas.openxmlformats.org/officeDocument/2006/relationships" id="2147483649" r:id="R4fb76e3fab324084"/>
+    <p:sldLayoutId xmlns:r="http://schemas.openxmlformats.org/officeDocument/2006/relationships" id="2147483649" r:id="R7c68d5a9498c4521"/>
   </p:sldLayoutIdLst>
   <p:txStyles>
     <p:titleStyle>
@@ -1345,7 +1345,7 @@
           <p:cNvPr id="47" name="">
             <a:extLst xmlns:a="http://schemas.openxmlformats.org/drawingml/2006/main">
               <a:ext uri="{FF2B5EF4-FFF2-40B4-BE49-F238E27FC236}">
-                <a16:creationId xmlns:a16="http://schemas.microsoft.com/office/drawing/2014/main" id="{DCC3EF61-663F-44C8-A4FA-3AB382FF68ED}"/>
+                <a16:creationId xmlns:a16="http://schemas.microsoft.com/office/drawing/2014/main" id="{A88CBA9E-96C5-4564-BF9F-2844F60735AC}"/>
               </a:ext>
             </a:extLst>
           </p:cNvPr>
@@ -1402,7 +1402,7 @@
           <p:cNvPr id="2" name="">
             <a:extLst xmlns:a="http://schemas.openxmlformats.org/drawingml/2006/main">
               <a:ext uri="{FF2B5EF4-FFF2-40B4-BE49-F238E27FC236}">
-                <a16:creationId xmlns:a16="http://schemas.microsoft.com/office/drawing/2014/main" id="{EF3FBAAE-FF66-4754-BFB4-85E406B8B047}"/>
+                <a16:creationId xmlns:a16="http://schemas.microsoft.com/office/drawing/2014/main" id="{6EFA54AD-F8DF-42A1-99C6-710D5553D8C9}"/>
               </a:ext>
             </a:extLst>
           </p:cNvPr>
@@ -1459,7 +1459,7 @@
           <p:cNvPr id="3" name="">
             <a:extLst xmlns:a="http://schemas.openxmlformats.org/drawingml/2006/main">
               <a:ext uri="{FF2B5EF4-FFF2-40B4-BE49-F238E27FC236}">
-                <a16:creationId xmlns:a16="http://schemas.microsoft.com/office/drawing/2014/main" id="{C0E7EA93-C008-46CE-9A1D-DAE5E94BBA2E}"/>
+                <a16:creationId xmlns:a16="http://schemas.microsoft.com/office/drawing/2014/main" id="{6A416F94-E7C7-41CC-98EC-86F9D2B95DC0}"/>
               </a:ext>
             </a:extLst>
           </p:cNvPr>
@@ -1516,7 +1516,7 @@
           <p:cNvPr id="4" name="">
             <a:extLst xmlns:a="http://schemas.openxmlformats.org/drawingml/2006/main">
               <a:ext uri="{FF2B5EF4-FFF2-40B4-BE49-F238E27FC236}">
-                <a16:creationId xmlns:a16="http://schemas.microsoft.com/office/drawing/2014/main" id="{06576F9D-A5D5-4E57-B903-5F42B20F59B0}"/>
+                <a16:creationId xmlns:a16="http://schemas.microsoft.com/office/drawing/2014/main" id="{A27F8163-7D08-4A0C-A61B-55DDDE47D5D2}"/>
               </a:ext>
             </a:extLst>
           </p:cNvPr>
@@ -1547,7 +1547,7 @@
           <p:cNvPr id="5" name="">
             <a:extLst xmlns:a="http://schemas.openxmlformats.org/drawingml/2006/main">
               <a:ext uri="{FF2B5EF4-FFF2-40B4-BE49-F238E27FC236}">
-                <a16:creationId xmlns:a16="http://schemas.microsoft.com/office/drawing/2014/main" id="{D26DAFF9-61FD-431F-B41D-9881DE0C5748}"/>
+                <a16:creationId xmlns:a16="http://schemas.microsoft.com/office/drawing/2014/main" id="{48456616-8DC5-4DAA-85A7-503B20C513A0}"/>
               </a:ext>
             </a:extLst>
           </p:cNvPr>
@@ -1582,7 +1582,7 @@
           <p:cNvPr id="6" name="">
             <a:extLst xmlns:a="http://schemas.openxmlformats.org/drawingml/2006/main">
               <a:ext uri="{FF2B5EF4-FFF2-40B4-BE49-F238E27FC236}">
-                <a16:creationId xmlns:a16="http://schemas.microsoft.com/office/drawing/2014/main" id="{A954D236-F3F4-4ABE-A254-D7399F1684F5}"/>
+                <a16:creationId xmlns:a16="http://schemas.microsoft.com/office/drawing/2014/main" id="{B05694E2-73A5-406F-86DE-192155054AE4}"/>
               </a:ext>
             </a:extLst>
           </p:cNvPr>
@@ -1646,7 +1646,7 @@
           <p:cNvPr id="7" name="">
             <a:extLst xmlns:a="http://schemas.openxmlformats.org/drawingml/2006/main">
               <a:ext uri="{FF2B5EF4-FFF2-40B4-BE49-F238E27FC236}">
-                <a16:creationId xmlns:a16="http://schemas.microsoft.com/office/drawing/2014/main" id="{F15BB6C6-55E7-4026-AAF9-80CC2E18AE16}"/>
+                <a16:creationId xmlns:a16="http://schemas.microsoft.com/office/drawing/2014/main" id="{C820F5BB-A106-43AC-B8E3-4F906F94C0E5}"/>
               </a:ext>
             </a:extLst>
           </p:cNvPr>
@@ -1703,7 +1703,7 @@
           <p:cNvPr id="8" name="">
             <a:extLst xmlns:a="http://schemas.openxmlformats.org/drawingml/2006/main">
               <a:ext uri="{FF2B5EF4-FFF2-40B4-BE49-F238E27FC236}">
-                <a16:creationId xmlns:a16="http://schemas.microsoft.com/office/drawing/2014/main" id="{B4FCCE9D-43EC-4BD5-99E1-0E6D75AC8AF9}"/>
+                <a16:creationId xmlns:a16="http://schemas.microsoft.com/office/drawing/2014/main" id="{539BD992-04E5-4499-B1AB-602CCABB30B9}"/>
               </a:ext>
             </a:extLst>
           </p:cNvPr>
@@ -1760,7 +1760,7 @@
           <p:cNvPr id="9" name="">
             <a:extLst xmlns:a="http://schemas.openxmlformats.org/drawingml/2006/main">
               <a:ext uri="{FF2B5EF4-FFF2-40B4-BE49-F238E27FC236}">
-                <a16:creationId xmlns:a16="http://schemas.microsoft.com/office/drawing/2014/main" id="{43FCEA03-92EC-4CAD-BC46-926D303F8648}"/>
+                <a16:creationId xmlns:a16="http://schemas.microsoft.com/office/drawing/2014/main" id="{C941F671-08AD-4931-8F46-CE2504A469FA}"/>
               </a:ext>
             </a:extLst>
           </p:cNvPr>
@@ -1792,7 +1792,7 @@
           <p:cNvPr id="10" name="">
             <a:extLst xmlns:a="http://schemas.openxmlformats.org/drawingml/2006/main">
               <a:ext uri="{FF2B5EF4-FFF2-40B4-BE49-F238E27FC236}">
-                <a16:creationId xmlns:a16="http://schemas.microsoft.com/office/drawing/2014/main" id="{6830EF06-5B99-429C-B5E3-5574BD98CC5E}"/>
+                <a16:creationId xmlns:a16="http://schemas.microsoft.com/office/drawing/2014/main" id="{AF0A70C7-B4D3-41CD-8015-08C6ADFDA4A5}"/>
               </a:ext>
             </a:extLst>
           </p:cNvPr>
@@ -1827,7 +1827,7 @@
           <p:cNvPr id="11" name="">
             <a:extLst xmlns:a="http://schemas.openxmlformats.org/drawingml/2006/main">
               <a:ext uri="{FF2B5EF4-FFF2-40B4-BE49-F238E27FC236}">
-                <a16:creationId xmlns:a16="http://schemas.microsoft.com/office/drawing/2014/main" id="{CEFAB2F8-3A48-4EC1-BC4A-784529D711FA}"/>
+                <a16:creationId xmlns:a16="http://schemas.microsoft.com/office/drawing/2014/main" id="{266C3A5D-F5F5-4296-9D03-C6E54C144E08}"/>
               </a:ext>
             </a:extLst>
           </p:cNvPr>
@@ -1891,7 +1891,7 @@
           <p:cNvPr id="12" name="">
             <a:extLst xmlns:a="http://schemas.openxmlformats.org/drawingml/2006/main">
               <a:ext uri="{FF2B5EF4-FFF2-40B4-BE49-F238E27FC236}">
-                <a16:creationId xmlns:a16="http://schemas.microsoft.com/office/drawing/2014/main" id="{C3E60167-9A39-4409-8822-F06865315520}"/>
+                <a16:creationId xmlns:a16="http://schemas.microsoft.com/office/drawing/2014/main" id="{82C1D787-5E79-4AC3-B71F-61B80F27471E}"/>
               </a:ext>
             </a:extLst>
           </p:cNvPr>
@@ -1948,7 +1948,7 @@
           <p:cNvPr id="13" name="">
             <a:extLst xmlns:a="http://schemas.openxmlformats.org/drawingml/2006/main">
               <a:ext uri="{FF2B5EF4-FFF2-40B4-BE49-F238E27FC236}">
-                <a16:creationId xmlns:a16="http://schemas.microsoft.com/office/drawing/2014/main" id="{7F6C7C99-B4C6-4C02-8E5F-179EC9134E41}"/>
+                <a16:creationId xmlns:a16="http://schemas.microsoft.com/office/drawing/2014/main" id="{E1AA79E2-FFE8-4A2F-A206-3CCD9DD51958}"/>
               </a:ext>
             </a:extLst>
           </p:cNvPr>
@@ -2005,7 +2005,7 @@
           <p:cNvPr id="14" name="">
             <a:extLst xmlns:a="http://schemas.openxmlformats.org/drawingml/2006/main">
               <a:ext uri="{FF2B5EF4-FFF2-40B4-BE49-F238E27FC236}">
-                <a16:creationId xmlns:a16="http://schemas.microsoft.com/office/drawing/2014/main" id="{3FB49F77-1EA3-48B3-A58A-85DD60347E74}"/>
+                <a16:creationId xmlns:a16="http://schemas.microsoft.com/office/drawing/2014/main" id="{462A084C-552C-439A-818D-E079E61B48B9}"/>
               </a:ext>
             </a:extLst>
           </p:cNvPr>
@@ -2037,7 +2037,7 @@
           <p:cNvPr id="15" name="">
             <a:extLst xmlns:a="http://schemas.openxmlformats.org/drawingml/2006/main">
               <a:ext uri="{FF2B5EF4-FFF2-40B4-BE49-F238E27FC236}">
-                <a16:creationId xmlns:a16="http://schemas.microsoft.com/office/drawing/2014/main" id="{F55E47F9-0489-4CFC-99C1-691D7537D28D}"/>
+                <a16:creationId xmlns:a16="http://schemas.microsoft.com/office/drawing/2014/main" id="{F1D898FC-525F-4612-AB17-8610CAFEAEEF}"/>
               </a:ext>
             </a:extLst>
           </p:cNvPr>
@@ -2072,7 +2072,7 @@
           <p:cNvPr id="16" name="">
             <a:extLst xmlns:a="http://schemas.openxmlformats.org/drawingml/2006/main">
               <a:ext uri="{FF2B5EF4-FFF2-40B4-BE49-F238E27FC236}">
-                <a16:creationId xmlns:a16="http://schemas.microsoft.com/office/drawing/2014/main" id="{44C834C2-85BE-49F1-B97D-7099E04C7704}"/>
+                <a16:creationId xmlns:a16="http://schemas.microsoft.com/office/drawing/2014/main" id="{B86EE4C8-9F13-4714-A693-22DEC359E4E9}"/>
               </a:ext>
             </a:extLst>
           </p:cNvPr>
@@ -2136,7 +2136,7 @@
           <p:cNvPr id="17" name="">
             <a:extLst xmlns:a="http://schemas.openxmlformats.org/drawingml/2006/main">
               <a:ext uri="{FF2B5EF4-FFF2-40B4-BE49-F238E27FC236}">
-                <a16:creationId xmlns:a16="http://schemas.microsoft.com/office/drawing/2014/main" id="{D69297BF-D083-45AA-9A7F-8FE9D46F0112}"/>
+                <a16:creationId xmlns:a16="http://schemas.microsoft.com/office/drawing/2014/main" id="{23715A34-B7AD-49AD-80AB-4CE51C268EDB}"/>
               </a:ext>
             </a:extLst>
           </p:cNvPr>
@@ -2193,7 +2193,7 @@
           <p:cNvPr id="18" name="">
             <a:extLst xmlns:a="http://schemas.openxmlformats.org/drawingml/2006/main">
               <a:ext uri="{FF2B5EF4-FFF2-40B4-BE49-F238E27FC236}">
-                <a16:creationId xmlns:a16="http://schemas.microsoft.com/office/drawing/2014/main" id="{0F3B29B8-553F-4F6D-A8EB-21C12880FA6A}"/>
+                <a16:creationId xmlns:a16="http://schemas.microsoft.com/office/drawing/2014/main" id="{C2C6059B-8218-4B43-8652-C7284BB25172}"/>
               </a:ext>
             </a:extLst>
           </p:cNvPr>
@@ -2250,7 +2250,7 @@
           <p:cNvPr id="19" name="">
             <a:extLst xmlns:a="http://schemas.openxmlformats.org/drawingml/2006/main">
               <a:ext uri="{FF2B5EF4-FFF2-40B4-BE49-F238E27FC236}">
-                <a16:creationId xmlns:a16="http://schemas.microsoft.com/office/drawing/2014/main" id="{0B16EDF8-6415-41D3-B6AB-CE4A5B0066D9}"/>
+                <a16:creationId xmlns:a16="http://schemas.microsoft.com/office/drawing/2014/main" id="{1B51E216-5063-4C17-B545-C8DE158366F6}"/>
               </a:ext>
             </a:extLst>
           </p:cNvPr>
@@ -2282,7 +2282,7 @@
           <p:cNvPr id="20" name="">
             <a:extLst xmlns:a="http://schemas.openxmlformats.org/drawingml/2006/main">
               <a:ext uri="{FF2B5EF4-FFF2-40B4-BE49-F238E27FC236}">
-                <a16:creationId xmlns:a16="http://schemas.microsoft.com/office/drawing/2014/main" id="{96B9075A-FE91-4A42-B009-9244BCD6273F}"/>
+                <a16:creationId xmlns:a16="http://schemas.microsoft.com/office/drawing/2014/main" id="{FF7DDFB9-BD01-4BF4-903D-862F5EDC5547}"/>
               </a:ext>
             </a:extLst>
           </p:cNvPr>
@@ -2317,7 +2317,7 @@
           <p:cNvPr id="21" name="">
             <a:extLst xmlns:a="http://schemas.openxmlformats.org/drawingml/2006/main">
               <a:ext uri="{FF2B5EF4-FFF2-40B4-BE49-F238E27FC236}">
-                <a16:creationId xmlns:a16="http://schemas.microsoft.com/office/drawing/2014/main" id="{07303CDB-3177-4617-9C5A-51D29D66262F}"/>
+                <a16:creationId xmlns:a16="http://schemas.microsoft.com/office/drawing/2014/main" id="{9339E4DE-30A8-4234-B30A-28D9955FCB05}"/>
               </a:ext>
             </a:extLst>
           </p:cNvPr>
@@ -2381,7 +2381,7 @@
           <p:cNvPr id="22" name="">
             <a:extLst xmlns:a="http://schemas.openxmlformats.org/drawingml/2006/main">
               <a:ext uri="{FF2B5EF4-FFF2-40B4-BE49-F238E27FC236}">
-                <a16:creationId xmlns:a16="http://schemas.microsoft.com/office/drawing/2014/main" id="{0FBBD600-953B-43D3-BFCE-1A48C80818D6}"/>
+                <a16:creationId xmlns:a16="http://schemas.microsoft.com/office/drawing/2014/main" id="{464D69A7-7D4D-4F09-942B-236764153FCF}"/>
               </a:ext>
             </a:extLst>
           </p:cNvPr>
@@ -2438,7 +2438,7 @@
           <p:cNvPr id="23" name="">
             <a:extLst xmlns:a="http://schemas.openxmlformats.org/drawingml/2006/main">
               <a:ext uri="{FF2B5EF4-FFF2-40B4-BE49-F238E27FC236}">
-                <a16:creationId xmlns:a16="http://schemas.microsoft.com/office/drawing/2014/main" id="{F5ED5379-EEEF-4BB9-9D1A-3F68B2E27C83}"/>
+                <a16:creationId xmlns:a16="http://schemas.microsoft.com/office/drawing/2014/main" id="{2B81E3D9-9557-4768-8ECC-1ABF102773E0}"/>
               </a:ext>
             </a:extLst>
           </p:cNvPr>
@@ -2495,7 +2495,7 @@
           <p:cNvPr id="24" name="">
             <a:extLst xmlns:a="http://schemas.openxmlformats.org/drawingml/2006/main">
               <a:ext uri="{FF2B5EF4-FFF2-40B4-BE49-F238E27FC236}">
-                <a16:creationId xmlns:a16="http://schemas.microsoft.com/office/drawing/2014/main" id="{9134D279-0E5B-42D1-8019-4BC31608CB13}"/>
+                <a16:creationId xmlns:a16="http://schemas.microsoft.com/office/drawing/2014/main" id="{8E958229-8BB0-4AE7-AEE1-C9AF731255E0}"/>
               </a:ext>
             </a:extLst>
           </p:cNvPr>
@@ -2527,7 +2527,7 @@
           <p:cNvPr id="25" name="">
             <a:extLst xmlns:a="http://schemas.openxmlformats.org/drawingml/2006/main">
               <a:ext uri="{FF2B5EF4-FFF2-40B4-BE49-F238E27FC236}">
-                <a16:creationId xmlns:a16="http://schemas.microsoft.com/office/drawing/2014/main" id="{44732FE1-D872-41F3-9CBD-8B4F57025A17}"/>
+                <a16:creationId xmlns:a16="http://schemas.microsoft.com/office/drawing/2014/main" id="{88112003-ADC1-4683-97EB-22AB325B8833}"/>
               </a:ext>
             </a:extLst>
           </p:cNvPr>
@@ -2562,7 +2562,7 @@
           <p:cNvPr id="26" name="">
             <a:extLst xmlns:a="http://schemas.openxmlformats.org/drawingml/2006/main">
               <a:ext uri="{FF2B5EF4-FFF2-40B4-BE49-F238E27FC236}">
-                <a16:creationId xmlns:a16="http://schemas.microsoft.com/office/drawing/2014/main" id="{5D251698-23E1-48F7-A6AD-0DA1009B3AF9}"/>
+                <a16:creationId xmlns:a16="http://schemas.microsoft.com/office/drawing/2014/main" id="{CABFAC9A-AA82-454A-A78A-8B689E396D57}"/>
               </a:ext>
             </a:extLst>
           </p:cNvPr>
@@ -2626,7 +2626,7 @@
           <p:cNvPr id="27" name="">
             <a:extLst xmlns:a="http://schemas.openxmlformats.org/drawingml/2006/main">
               <a:ext uri="{FF2B5EF4-FFF2-40B4-BE49-F238E27FC236}">
-                <a16:creationId xmlns:a16="http://schemas.microsoft.com/office/drawing/2014/main" id="{425FBF14-F2DB-49EF-A39C-1F20CAA3C86B}"/>
+                <a16:creationId xmlns:a16="http://schemas.microsoft.com/office/drawing/2014/main" id="{9957AF8C-AED2-46D0-9333-D392B0352BA6}"/>
               </a:ext>
             </a:extLst>
           </p:cNvPr>
@@ -2683,7 +2683,7 @@
           <p:cNvPr id="28" name="">
             <a:extLst xmlns:a="http://schemas.openxmlformats.org/drawingml/2006/main">
               <a:ext uri="{FF2B5EF4-FFF2-40B4-BE49-F238E27FC236}">
-                <a16:creationId xmlns:a16="http://schemas.microsoft.com/office/drawing/2014/main" id="{0FB20088-8A6A-41D8-AC94-1383CCA8DD95}"/>
+                <a16:creationId xmlns:a16="http://schemas.microsoft.com/office/drawing/2014/main" id="{120705B4-2DBF-459F-A467-60841038A3DC}"/>
               </a:ext>
             </a:extLst>
           </p:cNvPr>
@@ -2740,7 +2740,7 @@
           <p:cNvPr id="29" name="">
             <a:extLst xmlns:a="http://schemas.openxmlformats.org/drawingml/2006/main">
               <a:ext uri="{FF2B5EF4-FFF2-40B4-BE49-F238E27FC236}">
-                <a16:creationId xmlns:a16="http://schemas.microsoft.com/office/drawing/2014/main" id="{329B9BF2-DA3F-4623-8639-B04C138CE81E}"/>
+                <a16:creationId xmlns:a16="http://schemas.microsoft.com/office/drawing/2014/main" id="{EC6C82EA-627B-4D2B-B839-7E8C4F019B09}"/>
               </a:ext>
             </a:extLst>
           </p:cNvPr>
@@ -2775,7 +2775,7 @@
           <p:cNvPr id="30" name="">
             <a:extLst xmlns:a="http://schemas.openxmlformats.org/drawingml/2006/main">
               <a:ext uri="{FF2B5EF4-FFF2-40B4-BE49-F238E27FC236}">
-                <a16:creationId xmlns:a16="http://schemas.microsoft.com/office/drawing/2014/main" id="{893BE072-C803-4638-80A8-D8FDEBE956A6}"/>
+                <a16:creationId xmlns:a16="http://schemas.microsoft.com/office/drawing/2014/main" id="{E2D98254-FF1B-4062-BF3D-B75FE6A3E18D}"/>
               </a:ext>
             </a:extLst>
           </p:cNvPr>
@@ -2832,7 +2832,7 @@
           <p:cNvPr id="31" name="">
             <a:extLst xmlns:a="http://schemas.openxmlformats.org/drawingml/2006/main">
               <a:ext uri="{FF2B5EF4-FFF2-40B4-BE49-F238E27FC236}">
-                <a16:creationId xmlns:a16="http://schemas.microsoft.com/office/drawing/2014/main" id="{BB5C17BC-CD42-4F03-9737-976CB10D1ABE}"/>
+                <a16:creationId xmlns:a16="http://schemas.microsoft.com/office/drawing/2014/main" id="{90EFA0B2-8D3D-4211-AD3A-264EE16B69DF}"/>
               </a:ext>
             </a:extLst>
           </p:cNvPr>
@@ -2889,7 +2889,7 @@
           <p:cNvPr id="32" name="">
             <a:extLst xmlns:a="http://schemas.openxmlformats.org/drawingml/2006/main">
               <a:ext uri="{FF2B5EF4-FFF2-40B4-BE49-F238E27FC236}">
-                <a16:creationId xmlns:a16="http://schemas.microsoft.com/office/drawing/2014/main" id="{BBDC83C8-3F91-41B5-9FD6-15D3A94D8657}"/>
+                <a16:creationId xmlns:a16="http://schemas.microsoft.com/office/drawing/2014/main" id="{1E2173E7-9AB8-45BC-8B4A-8427EAFA8008}"/>
               </a:ext>
             </a:extLst>
           </p:cNvPr>
@@ -2946,7 +2946,7 @@
           <p:cNvPr id="33" name="">
             <a:extLst xmlns:a="http://schemas.openxmlformats.org/drawingml/2006/main">
               <a:ext uri="{FF2B5EF4-FFF2-40B4-BE49-F238E27FC236}">
-                <a16:creationId xmlns:a16="http://schemas.microsoft.com/office/drawing/2014/main" id="{4739C6F8-5F65-49ED-AED2-088CBE7CF12B}"/>
+                <a16:creationId xmlns:a16="http://schemas.microsoft.com/office/drawing/2014/main" id="{A804198F-86C6-459C-9EFC-A74F3DDB5729}"/>
               </a:ext>
             </a:extLst>
           </p:cNvPr>
@@ -2981,7 +2981,7 @@
           <p:cNvPr id="34" name="">
             <a:extLst xmlns:a="http://schemas.openxmlformats.org/drawingml/2006/main">
               <a:ext uri="{FF2B5EF4-FFF2-40B4-BE49-F238E27FC236}">
-                <a16:creationId xmlns:a16="http://schemas.microsoft.com/office/drawing/2014/main" id="{6BA59138-5641-4964-B90E-1E6198AECF9B}"/>
+                <a16:creationId xmlns:a16="http://schemas.microsoft.com/office/drawing/2014/main" id="{4A487A91-654B-4C91-8BEF-C259343723E6}"/>
               </a:ext>
             </a:extLst>
           </p:cNvPr>
@@ -3045,7 +3045,7 @@
           <p:cNvPr id="35" name="">
             <a:extLst xmlns:a="http://schemas.openxmlformats.org/drawingml/2006/main">
               <a:ext uri="{FF2B5EF4-FFF2-40B4-BE49-F238E27FC236}">
-                <a16:creationId xmlns:a16="http://schemas.microsoft.com/office/drawing/2014/main" id="{31332363-8A63-470D-AB27-D49CED225AFA}"/>
+                <a16:creationId xmlns:a16="http://schemas.microsoft.com/office/drawing/2014/main" id="{3DAAA2E1-4CD5-46FE-9753-BCB8867A22FC}"/>
               </a:ext>
             </a:extLst>
           </p:cNvPr>
@@ -3102,7 +3102,7 @@
           <p:cNvPr id="36" name="">
             <a:extLst xmlns:a="http://schemas.openxmlformats.org/drawingml/2006/main">
               <a:ext uri="{FF2B5EF4-FFF2-40B4-BE49-F238E27FC236}">
-                <a16:creationId xmlns:a16="http://schemas.microsoft.com/office/drawing/2014/main" id="{52F863C1-69B7-49A3-87E8-C770E4F492AC}"/>
+                <a16:creationId xmlns:a16="http://schemas.microsoft.com/office/drawing/2014/main" id="{830E6761-DC2D-4448-BD37-5E6F0ABBB3ED}"/>
               </a:ext>
             </a:extLst>
           </p:cNvPr>
@@ -3159,7 +3159,7 @@
           <p:cNvPr id="37" name="">
             <a:extLst xmlns:a="http://schemas.openxmlformats.org/drawingml/2006/main">
               <a:ext uri="{FF2B5EF4-FFF2-40B4-BE49-F238E27FC236}">
-                <a16:creationId xmlns:a16="http://schemas.microsoft.com/office/drawing/2014/main" id="{073B2830-0D06-42EB-9689-40CACFE67223}"/>
+                <a16:creationId xmlns:a16="http://schemas.microsoft.com/office/drawing/2014/main" id="{F28B0612-4ABF-466A-966C-4838B0A420B1}"/>
               </a:ext>
             </a:extLst>
           </p:cNvPr>
@@ -3194,7 +3194,7 @@
           <p:cNvPr id="38" name="">
             <a:extLst xmlns:a="http://schemas.openxmlformats.org/drawingml/2006/main">
               <a:ext uri="{FF2B5EF4-FFF2-40B4-BE49-F238E27FC236}">
-                <a16:creationId xmlns:a16="http://schemas.microsoft.com/office/drawing/2014/main" id="{35E1F2C0-270E-4779-983B-25AE51F4DADA}"/>
+                <a16:creationId xmlns:a16="http://schemas.microsoft.com/office/drawing/2014/main" id="{00197C3C-2F40-4220-9919-1D6D8CC4E8AB}"/>
               </a:ext>
             </a:extLst>
           </p:cNvPr>
@@ -3258,7 +3258,7 @@
           <p:cNvPr id="39" name="">
             <a:extLst xmlns:a="http://schemas.openxmlformats.org/drawingml/2006/main">
               <a:ext uri="{FF2B5EF4-FFF2-40B4-BE49-F238E27FC236}">
-                <a16:creationId xmlns:a16="http://schemas.microsoft.com/office/drawing/2014/main" id="{E32A6572-820F-4C6F-86F9-4222B919AD74}"/>
+                <a16:creationId xmlns:a16="http://schemas.microsoft.com/office/drawing/2014/main" id="{72071476-35BB-41BB-925C-D02B058E3FFF}"/>
               </a:ext>
             </a:extLst>
           </p:cNvPr>
@@ -3315,7 +3315,7 @@
           <p:cNvPr id="40" name="">
             <a:extLst xmlns:a="http://schemas.openxmlformats.org/drawingml/2006/main">
               <a:ext uri="{FF2B5EF4-FFF2-40B4-BE49-F238E27FC236}">
-                <a16:creationId xmlns:a16="http://schemas.microsoft.com/office/drawing/2014/main" id="{9C7FA224-C499-4CC7-867C-74506878C480}"/>
+                <a16:creationId xmlns:a16="http://schemas.microsoft.com/office/drawing/2014/main" id="{0AD5652B-8B2B-4F74-A3B1-3BDF7EFE998B}"/>
               </a:ext>
             </a:extLst>
           </p:cNvPr>
@@ -3372,7 +3372,7 @@
           <p:cNvPr id="41" name="">
             <a:extLst xmlns:a="http://schemas.openxmlformats.org/drawingml/2006/main">
               <a:ext uri="{FF2B5EF4-FFF2-40B4-BE49-F238E27FC236}">
-                <a16:creationId xmlns:a16="http://schemas.microsoft.com/office/drawing/2014/main" id="{5665D212-935D-4E23-9864-C59A60953BE2}"/>
+                <a16:creationId xmlns:a16="http://schemas.microsoft.com/office/drawing/2014/main" id="{3314EBFA-AAC9-45B5-8FF5-5AD09F7B7A62}"/>
               </a:ext>
             </a:extLst>
           </p:cNvPr>
@@ -3407,7 +3407,7 @@
           <p:cNvPr id="42" name="">
             <a:extLst xmlns:a="http://schemas.openxmlformats.org/drawingml/2006/main">
               <a:ext uri="{FF2B5EF4-FFF2-40B4-BE49-F238E27FC236}">
-                <a16:creationId xmlns:a16="http://schemas.microsoft.com/office/drawing/2014/main" id="{3AEF1CB8-2211-457F-9687-D9CA11629545}"/>
+                <a16:creationId xmlns:a16="http://schemas.microsoft.com/office/drawing/2014/main" id="{83EF8DB3-1F89-41EC-871E-D7AB1CB5CC8C}"/>
               </a:ext>
             </a:extLst>
           </p:cNvPr>
@@ -3471,7 +3471,7 @@
           <p:cNvPr id="43" name="">
             <a:extLst xmlns:a="http://schemas.openxmlformats.org/drawingml/2006/main">
               <a:ext uri="{FF2B5EF4-FFF2-40B4-BE49-F238E27FC236}">
-                <a16:creationId xmlns:a16="http://schemas.microsoft.com/office/drawing/2014/main" id="{5E0E42C1-FE1C-4B81-8A25-0BD47D56CBB9}"/>
+                <a16:creationId xmlns:a16="http://schemas.microsoft.com/office/drawing/2014/main" id="{9B4877B3-6E75-4B04-8EA8-C9A6B9C5C1B7}"/>
               </a:ext>
             </a:extLst>
           </p:cNvPr>
@@ -3528,7 +3528,7 @@
           <p:cNvPr id="44" name="">
             <a:extLst xmlns:a="http://schemas.openxmlformats.org/drawingml/2006/main">
               <a:ext uri="{FF2B5EF4-FFF2-40B4-BE49-F238E27FC236}">
-                <a16:creationId xmlns:a16="http://schemas.microsoft.com/office/drawing/2014/main" id="{8CBFB9A7-5960-4AC0-B7EC-E880AAE8A798}"/>
+                <a16:creationId xmlns:a16="http://schemas.microsoft.com/office/drawing/2014/main" id="{B0E13C35-2CF2-4D7F-A4AE-8721AAD5C1C5}"/>
               </a:ext>
             </a:extLst>
           </p:cNvPr>
@@ -3585,7 +3585,7 @@
           <p:cNvPr id="45" name="">
             <a:extLst xmlns:a="http://schemas.openxmlformats.org/drawingml/2006/main">
               <a:ext uri="{FF2B5EF4-FFF2-40B4-BE49-F238E27FC236}">
-                <a16:creationId xmlns:a16="http://schemas.microsoft.com/office/drawing/2014/main" id="{B9C18FFB-8099-49DF-ACBE-7DD230A24C8B}"/>
+                <a16:creationId xmlns:a16="http://schemas.microsoft.com/office/drawing/2014/main" id="{58FA647A-523C-4C46-9A38-1AEE1506ACEA}"/>
               </a:ext>
             </a:extLst>
           </p:cNvPr>
@@ -3642,7 +3642,7 @@
           <p:cNvPr id="46" name="">
             <a:extLst xmlns:a="http://schemas.openxmlformats.org/drawingml/2006/main">
               <a:ext uri="{FF2B5EF4-FFF2-40B4-BE49-F238E27FC236}">
-                <a16:creationId xmlns:a16="http://schemas.microsoft.com/office/drawing/2014/main" id="{CB5E4786-F678-4179-9DB6-A4AA9C7CDE74}"/>
+                <a16:creationId xmlns:a16="http://schemas.microsoft.com/office/drawing/2014/main" id="{BC425CC9-63F9-494D-8842-4062DCD3F66B}"/>
               </a:ext>
             </a:extLst>
           </p:cNvPr>
@@ -3697,7 +3697,7 @@
     </p:spTree>
     <p:extLst>
       <p:ext uri="{BB962C8B-B14F-4D97-AF65-F5344CB8AC3E}">
-        <p14:creationId xmlns:p14="http://schemas.microsoft.com/office/powerpoint/2010/main" val="1095950350"/>
+        <p14:creationId xmlns:p14="http://schemas.microsoft.com/office/powerpoint/2010/main" val="879762018"/>
       </p:ext>
     </p:extLst>
   </p:cSld>
@@ -3728,7 +3728,7 @@
           <p:cNvPr id="46" name="">
             <a:extLst xmlns:a="http://schemas.openxmlformats.org/drawingml/2006/main">
               <a:ext uri="{FF2B5EF4-FFF2-40B4-BE49-F238E27FC236}">
-                <a16:creationId xmlns:a16="http://schemas.microsoft.com/office/drawing/2014/main" id="{621F35E9-927B-4403-88A7-72A2CCEA9812}"/>
+                <a16:creationId xmlns:a16="http://schemas.microsoft.com/office/drawing/2014/main" id="{2835A476-33A5-4902-8BDA-477F8B6334C1}"/>
               </a:ext>
             </a:extLst>
           </p:cNvPr>
@@ -3785,7 +3785,7 @@
           <p:cNvPr id="2" name="">
             <a:extLst xmlns:a="http://schemas.openxmlformats.org/drawingml/2006/main">
               <a:ext uri="{FF2B5EF4-FFF2-40B4-BE49-F238E27FC236}">
-                <a16:creationId xmlns:a16="http://schemas.microsoft.com/office/drawing/2014/main" id="{BE9EBAD7-8656-4835-911C-BFDC7CCCEB90}"/>
+                <a16:creationId xmlns:a16="http://schemas.microsoft.com/office/drawing/2014/main" id="{D6679593-35A3-4308-AA8D-E06C6E0ACABD}"/>
               </a:ext>
             </a:extLst>
           </p:cNvPr>
@@ -3842,7 +3842,7 @@
           <p:cNvPr id="3" name="">
             <a:extLst xmlns:a="http://schemas.openxmlformats.org/drawingml/2006/main">
               <a:ext uri="{FF2B5EF4-FFF2-40B4-BE49-F238E27FC236}">
-                <a16:creationId xmlns:a16="http://schemas.microsoft.com/office/drawing/2014/main" id="{B5807F1C-C8DC-46DD-BD87-BA0AA87ED461}"/>
+                <a16:creationId xmlns:a16="http://schemas.microsoft.com/office/drawing/2014/main" id="{9D6231C8-D9E2-457B-BD21-E5076518B816}"/>
               </a:ext>
             </a:extLst>
           </p:cNvPr>
@@ -3899,7 +3899,7 @@
           <p:cNvPr id="4" name="">
             <a:extLst xmlns:a="http://schemas.openxmlformats.org/drawingml/2006/main">
               <a:ext uri="{FF2B5EF4-FFF2-40B4-BE49-F238E27FC236}">
-                <a16:creationId xmlns:a16="http://schemas.microsoft.com/office/drawing/2014/main" id="{F6E84C98-9CAD-497D-A147-8D469EEC41B4}"/>
+                <a16:creationId xmlns:a16="http://schemas.microsoft.com/office/drawing/2014/main" id="{AD659817-B422-4375-969B-43715C22626B}"/>
               </a:ext>
             </a:extLst>
           </p:cNvPr>
@@ -3930,7 +3930,7 @@
           <p:cNvPr id="5" name="">
             <a:extLst xmlns:a="http://schemas.openxmlformats.org/drawingml/2006/main">
               <a:ext uri="{FF2B5EF4-FFF2-40B4-BE49-F238E27FC236}">
-                <a16:creationId xmlns:a16="http://schemas.microsoft.com/office/drawing/2014/main" id="{27B980A0-B5CE-4C18-BCAE-264F00ADAA0A}"/>
+                <a16:creationId xmlns:a16="http://schemas.microsoft.com/office/drawing/2014/main" id="{FF6E18E6-0533-41FB-9C06-C82D0767B235}"/>
               </a:ext>
             </a:extLst>
           </p:cNvPr>
@@ -3965,7 +3965,7 @@
           <p:cNvPr id="6" name="">
             <a:extLst xmlns:a="http://schemas.openxmlformats.org/drawingml/2006/main">
               <a:ext uri="{FF2B5EF4-FFF2-40B4-BE49-F238E27FC236}">
-                <a16:creationId xmlns:a16="http://schemas.microsoft.com/office/drawing/2014/main" id="{92399B6F-50DC-4992-B8E5-D5732F7A0307}"/>
+                <a16:creationId xmlns:a16="http://schemas.microsoft.com/office/drawing/2014/main" id="{CE4D7BF3-C545-4F5F-8F52-1A2C33254470}"/>
               </a:ext>
             </a:extLst>
           </p:cNvPr>
@@ -4029,7 +4029,7 @@
           <p:cNvPr id="7" name="">
             <a:extLst xmlns:a="http://schemas.openxmlformats.org/drawingml/2006/main">
               <a:ext uri="{FF2B5EF4-FFF2-40B4-BE49-F238E27FC236}">
-                <a16:creationId xmlns:a16="http://schemas.microsoft.com/office/drawing/2014/main" id="{7F51F239-E84A-447B-A10D-86BCC3CFC0AA}"/>
+                <a16:creationId xmlns:a16="http://schemas.microsoft.com/office/drawing/2014/main" id="{A0F05F75-E1FD-41D2-998E-4D5F2E00C609}"/>
               </a:ext>
             </a:extLst>
           </p:cNvPr>
@@ -4086,7 +4086,7 @@
           <p:cNvPr id="8" name="">
             <a:extLst xmlns:a="http://schemas.openxmlformats.org/drawingml/2006/main">
               <a:ext uri="{FF2B5EF4-FFF2-40B4-BE49-F238E27FC236}">
-                <a16:creationId xmlns:a16="http://schemas.microsoft.com/office/drawing/2014/main" id="{C0AB6688-DAF3-45BF-BDED-13B7B2298082}"/>
+                <a16:creationId xmlns:a16="http://schemas.microsoft.com/office/drawing/2014/main" id="{F7936A12-2E6F-4D8F-B647-2E1AC03C66E8}"/>
               </a:ext>
             </a:extLst>
           </p:cNvPr>
@@ -4166,7 +4166,7 @@
           <p:cNvPr id="9" name="">
             <a:extLst xmlns:a="http://schemas.openxmlformats.org/drawingml/2006/main">
               <a:ext uri="{FF2B5EF4-FFF2-40B4-BE49-F238E27FC236}">
-                <a16:creationId xmlns:a16="http://schemas.microsoft.com/office/drawing/2014/main" id="{2463C679-52B3-4433-8663-53B0CC62FF9D}"/>
+                <a16:creationId xmlns:a16="http://schemas.microsoft.com/office/drawing/2014/main" id="{12505CF9-0B0A-4E18-9800-D89A69E52AFC}"/>
               </a:ext>
             </a:extLst>
           </p:cNvPr>
@@ -4198,7 +4198,7 @@
           <p:cNvPr id="10" name="">
             <a:extLst xmlns:a="http://schemas.openxmlformats.org/drawingml/2006/main">
               <a:ext uri="{FF2B5EF4-FFF2-40B4-BE49-F238E27FC236}">
-                <a16:creationId xmlns:a16="http://schemas.microsoft.com/office/drawing/2014/main" id="{5AB3E1FB-8F47-4691-A867-DEFC3F7322FD}"/>
+                <a16:creationId xmlns:a16="http://schemas.microsoft.com/office/drawing/2014/main" id="{CF18B6BD-E819-4B09-9839-F2DA78A6F369}"/>
               </a:ext>
             </a:extLst>
           </p:cNvPr>
@@ -4233,7 +4233,7 @@
           <p:cNvPr id="11" name="">
             <a:extLst xmlns:a="http://schemas.openxmlformats.org/drawingml/2006/main">
               <a:ext uri="{FF2B5EF4-FFF2-40B4-BE49-F238E27FC236}">
-                <a16:creationId xmlns:a16="http://schemas.microsoft.com/office/drawing/2014/main" id="{4156B833-CDFC-4537-B51E-667A18F1AA6D}"/>
+                <a16:creationId xmlns:a16="http://schemas.microsoft.com/office/drawing/2014/main" id="{39140974-5DC5-4C4D-9EC5-BF89DE9C63FA}"/>
               </a:ext>
             </a:extLst>
           </p:cNvPr>
@@ -4297,7 +4297,7 @@
           <p:cNvPr id="12" name="">
             <a:extLst xmlns:a="http://schemas.openxmlformats.org/drawingml/2006/main">
               <a:ext uri="{FF2B5EF4-FFF2-40B4-BE49-F238E27FC236}">
-                <a16:creationId xmlns:a16="http://schemas.microsoft.com/office/drawing/2014/main" id="{017E551B-11BA-4D80-A798-C8F3C1B06E83}"/>
+                <a16:creationId xmlns:a16="http://schemas.microsoft.com/office/drawing/2014/main" id="{41D4C14B-B620-4CCE-B350-45ACE6E02AA8}"/>
               </a:ext>
             </a:extLst>
           </p:cNvPr>
@@ -4354,7 +4354,7 @@
           <p:cNvPr id="13" name="">
             <a:extLst xmlns:a="http://schemas.openxmlformats.org/drawingml/2006/main">
               <a:ext uri="{FF2B5EF4-FFF2-40B4-BE49-F238E27FC236}">
-                <a16:creationId xmlns:a16="http://schemas.microsoft.com/office/drawing/2014/main" id="{C5ACAF80-5153-478F-BF79-C56DFC371F14}"/>
+                <a16:creationId xmlns:a16="http://schemas.microsoft.com/office/drawing/2014/main" id="{BC42B0BC-CE1E-4789-9352-685E5F2F7DE9}"/>
               </a:ext>
             </a:extLst>
           </p:cNvPr>
@@ -4434,7 +4434,7 @@
           <p:cNvPr id="14" name="">
             <a:extLst xmlns:a="http://schemas.openxmlformats.org/drawingml/2006/main">
               <a:ext uri="{FF2B5EF4-FFF2-40B4-BE49-F238E27FC236}">
-                <a16:creationId xmlns:a16="http://schemas.microsoft.com/office/drawing/2014/main" id="{FAC1010D-6663-48B8-A91C-B8110C64CC05}"/>
+                <a16:creationId xmlns:a16="http://schemas.microsoft.com/office/drawing/2014/main" id="{1F9D51E8-BF0A-4F31-BAB8-496009B2EC1A}"/>
               </a:ext>
             </a:extLst>
           </p:cNvPr>
@@ -4466,7 +4466,7 @@
           <p:cNvPr id="15" name="">
             <a:extLst xmlns:a="http://schemas.openxmlformats.org/drawingml/2006/main">
               <a:ext uri="{FF2B5EF4-FFF2-40B4-BE49-F238E27FC236}">
-                <a16:creationId xmlns:a16="http://schemas.microsoft.com/office/drawing/2014/main" id="{BC0E641B-573E-44EA-B39B-198BA2F0684A}"/>
+                <a16:creationId xmlns:a16="http://schemas.microsoft.com/office/drawing/2014/main" id="{37D55863-AD1A-4872-9AD9-2C48206855EC}"/>
               </a:ext>
             </a:extLst>
           </p:cNvPr>
@@ -4501,7 +4501,7 @@
           <p:cNvPr id="16" name="">
             <a:extLst xmlns:a="http://schemas.openxmlformats.org/drawingml/2006/main">
               <a:ext uri="{FF2B5EF4-FFF2-40B4-BE49-F238E27FC236}">
-                <a16:creationId xmlns:a16="http://schemas.microsoft.com/office/drawing/2014/main" id="{9E2D0DC6-6324-49D8-8EAF-84FF4360ED74}"/>
+                <a16:creationId xmlns:a16="http://schemas.microsoft.com/office/drawing/2014/main" id="{BF0844FC-E51A-4CC1-90B6-6A9B9120977E}"/>
               </a:ext>
             </a:extLst>
           </p:cNvPr>
@@ -4565,7 +4565,7 @@
           <p:cNvPr id="17" name="">
             <a:extLst xmlns:a="http://schemas.openxmlformats.org/drawingml/2006/main">
               <a:ext uri="{FF2B5EF4-FFF2-40B4-BE49-F238E27FC236}">
-                <a16:creationId xmlns:a16="http://schemas.microsoft.com/office/drawing/2014/main" id="{A2B61197-A736-4398-87F8-D3A8C518ACF2}"/>
+                <a16:creationId xmlns:a16="http://schemas.microsoft.com/office/drawing/2014/main" id="{4ABDDA1C-1079-430B-AC4C-7CC3755E0E08}"/>
               </a:ext>
             </a:extLst>
           </p:cNvPr>
@@ -4622,7 +4622,7 @@
           <p:cNvPr id="18" name="">
             <a:extLst xmlns:a="http://schemas.openxmlformats.org/drawingml/2006/main">
               <a:ext uri="{FF2B5EF4-FFF2-40B4-BE49-F238E27FC236}">
-                <a16:creationId xmlns:a16="http://schemas.microsoft.com/office/drawing/2014/main" id="{556F91A3-3550-4EFB-AB9F-FFA97FC402D5}"/>
+                <a16:creationId xmlns:a16="http://schemas.microsoft.com/office/drawing/2014/main" id="{0389D41C-6CB5-4293-B28C-463D517125A7}"/>
               </a:ext>
             </a:extLst>
           </p:cNvPr>
@@ -4702,7 +4702,7 @@
           <p:cNvPr id="19" name="">
             <a:extLst xmlns:a="http://schemas.openxmlformats.org/drawingml/2006/main">
               <a:ext uri="{FF2B5EF4-FFF2-40B4-BE49-F238E27FC236}">
-                <a16:creationId xmlns:a16="http://schemas.microsoft.com/office/drawing/2014/main" id="{E1FBCFBB-47FA-4445-B6FB-B0E513CD96EB}"/>
+                <a16:creationId xmlns:a16="http://schemas.microsoft.com/office/drawing/2014/main" id="{F15B8EFE-CDF2-4DAE-889E-637885CA66DB}"/>
               </a:ext>
             </a:extLst>
           </p:cNvPr>
@@ -4734,7 +4734,7 @@
           <p:cNvPr id="20" name="">
             <a:extLst xmlns:a="http://schemas.openxmlformats.org/drawingml/2006/main">
               <a:ext uri="{FF2B5EF4-FFF2-40B4-BE49-F238E27FC236}">
-                <a16:creationId xmlns:a16="http://schemas.microsoft.com/office/drawing/2014/main" id="{4EF02891-473F-4882-9027-845345449D34}"/>
+                <a16:creationId xmlns:a16="http://schemas.microsoft.com/office/drawing/2014/main" id="{860F81D0-8CED-4D60-8B1A-AA1AB871E13B}"/>
               </a:ext>
             </a:extLst>
           </p:cNvPr>
@@ -4769,7 +4769,7 @@
           <p:cNvPr id="21" name="">
             <a:extLst xmlns:a="http://schemas.openxmlformats.org/drawingml/2006/main">
               <a:ext uri="{FF2B5EF4-FFF2-40B4-BE49-F238E27FC236}">
-                <a16:creationId xmlns:a16="http://schemas.microsoft.com/office/drawing/2014/main" id="{74F404A2-5EDA-424C-AA00-4996393485FF}"/>
+                <a16:creationId xmlns:a16="http://schemas.microsoft.com/office/drawing/2014/main" id="{9F3C19CB-1961-4799-ABBC-F9725026E16C}"/>
               </a:ext>
             </a:extLst>
           </p:cNvPr>
@@ -4833,7 +4833,7 @@
           <p:cNvPr id="22" name="">
             <a:extLst xmlns:a="http://schemas.openxmlformats.org/drawingml/2006/main">
               <a:ext uri="{FF2B5EF4-FFF2-40B4-BE49-F238E27FC236}">
-                <a16:creationId xmlns:a16="http://schemas.microsoft.com/office/drawing/2014/main" id="{870F0D9B-4ECC-41EE-B766-7F82F7B185B8}"/>
+                <a16:creationId xmlns:a16="http://schemas.microsoft.com/office/drawing/2014/main" id="{F2A67BE1-55BF-4345-BBE3-B1CA85405A1A}"/>
               </a:ext>
             </a:extLst>
           </p:cNvPr>
@@ -4890,7 +4890,7 @@
           <p:cNvPr id="23" name="">
             <a:extLst xmlns:a="http://schemas.openxmlformats.org/drawingml/2006/main">
               <a:ext uri="{FF2B5EF4-FFF2-40B4-BE49-F238E27FC236}">
-                <a16:creationId xmlns:a16="http://schemas.microsoft.com/office/drawing/2014/main" id="{3191D54C-FFCB-46EC-8F89-CB22BE81B11A}"/>
+                <a16:creationId xmlns:a16="http://schemas.microsoft.com/office/drawing/2014/main" id="{F905D2CE-CEB3-4E97-86FF-1FDCAE61B6DA}"/>
               </a:ext>
             </a:extLst>
           </p:cNvPr>
@@ -4970,7 +4970,7 @@
           <p:cNvPr id="24" name="">
             <a:extLst xmlns:a="http://schemas.openxmlformats.org/drawingml/2006/main">
               <a:ext uri="{FF2B5EF4-FFF2-40B4-BE49-F238E27FC236}">
-                <a16:creationId xmlns:a16="http://schemas.microsoft.com/office/drawing/2014/main" id="{E4EA97A5-A262-48F0-AF89-17866AE36D4C}"/>
+                <a16:creationId xmlns:a16="http://schemas.microsoft.com/office/drawing/2014/main" id="{A80F7F4C-B509-4111-A637-8228C0C1194C}"/>
               </a:ext>
             </a:extLst>
           </p:cNvPr>
@@ -5002,7 +5002,7 @@
           <p:cNvPr id="25" name="">
             <a:extLst xmlns:a="http://schemas.openxmlformats.org/drawingml/2006/main">
               <a:ext uri="{FF2B5EF4-FFF2-40B4-BE49-F238E27FC236}">
-                <a16:creationId xmlns:a16="http://schemas.microsoft.com/office/drawing/2014/main" id="{738696B5-0767-4B14-B30D-90D56EC68FAB}"/>
+                <a16:creationId xmlns:a16="http://schemas.microsoft.com/office/drawing/2014/main" id="{527DD757-DB62-42F3-ABDC-A0D0B9A41527}"/>
               </a:ext>
             </a:extLst>
           </p:cNvPr>
@@ -5037,7 +5037,7 @@
           <p:cNvPr id="26" name="">
             <a:extLst xmlns:a="http://schemas.openxmlformats.org/drawingml/2006/main">
               <a:ext uri="{FF2B5EF4-FFF2-40B4-BE49-F238E27FC236}">
-                <a16:creationId xmlns:a16="http://schemas.microsoft.com/office/drawing/2014/main" id="{569F08A5-39A6-4CE4-B98C-51E3DCD4ACD2}"/>
+                <a16:creationId xmlns:a16="http://schemas.microsoft.com/office/drawing/2014/main" id="{E7634883-1D79-4878-A1AA-7BBE8CB61A93}"/>
               </a:ext>
             </a:extLst>
           </p:cNvPr>
@@ -5101,7 +5101,7 @@
           <p:cNvPr id="27" name="">
             <a:extLst xmlns:a="http://schemas.openxmlformats.org/drawingml/2006/main">
               <a:ext uri="{FF2B5EF4-FFF2-40B4-BE49-F238E27FC236}">
-                <a16:creationId xmlns:a16="http://schemas.microsoft.com/office/drawing/2014/main" id="{76E3F720-0ECB-4525-8B3D-30E07DB41B13}"/>
+                <a16:creationId xmlns:a16="http://schemas.microsoft.com/office/drawing/2014/main" id="{C2283A28-CA39-4F49-933A-9DB638CA1108}"/>
               </a:ext>
             </a:extLst>
           </p:cNvPr>
@@ -5158,7 +5158,7 @@
           <p:cNvPr id="28" name="">
             <a:extLst xmlns:a="http://schemas.openxmlformats.org/drawingml/2006/main">
               <a:ext uri="{FF2B5EF4-FFF2-40B4-BE49-F238E27FC236}">
-                <a16:creationId xmlns:a16="http://schemas.microsoft.com/office/drawing/2014/main" id="{1B96D384-69B6-44D7-B1E6-54F61087B136}"/>
+                <a16:creationId xmlns:a16="http://schemas.microsoft.com/office/drawing/2014/main" id="{977DBAB4-2874-46FA-B629-283D9B6F41E2}"/>
               </a:ext>
             </a:extLst>
           </p:cNvPr>
@@ -5238,7 +5238,7 @@
           <p:cNvPr id="29" name="">
             <a:extLst xmlns:a="http://schemas.openxmlformats.org/drawingml/2006/main">
               <a:ext uri="{FF2B5EF4-FFF2-40B4-BE49-F238E27FC236}">
-                <a16:creationId xmlns:a16="http://schemas.microsoft.com/office/drawing/2014/main" id="{2F8CA290-72C3-48A0-9E56-19F7EF6706CE}"/>
+                <a16:creationId xmlns:a16="http://schemas.microsoft.com/office/drawing/2014/main" id="{2BF76EAA-52D4-43AD-9964-6E3991275EB8}"/>
               </a:ext>
             </a:extLst>
           </p:cNvPr>
@@ -5295,7 +5295,7 @@
           <p:cNvPr id="30" name="">
             <a:extLst xmlns:a="http://schemas.openxmlformats.org/drawingml/2006/main">
               <a:ext uri="{FF2B5EF4-FFF2-40B4-BE49-F238E27FC236}">
-                <a16:creationId xmlns:a16="http://schemas.microsoft.com/office/drawing/2014/main" id="{31EAF233-DDF5-493F-91EB-DF6D2FC12E64}"/>
+                <a16:creationId xmlns:a16="http://schemas.microsoft.com/office/drawing/2014/main" id="{248D1ABC-3D5B-48F4-988C-53232556556B}"/>
               </a:ext>
             </a:extLst>
           </p:cNvPr>
@@ -5330,7 +5330,7 @@
           <p:cNvPr id="31" name="">
             <a:extLst xmlns:a="http://schemas.openxmlformats.org/drawingml/2006/main">
               <a:ext uri="{FF2B5EF4-FFF2-40B4-BE49-F238E27FC236}">
-                <a16:creationId xmlns:a16="http://schemas.microsoft.com/office/drawing/2014/main" id="{AC44A16F-10F4-4FDA-BB9C-59F89C3317B4}"/>
+                <a16:creationId xmlns:a16="http://schemas.microsoft.com/office/drawing/2014/main" id="{6970CDD9-2413-4A79-B53D-4D6F05C76C2F}"/>
               </a:ext>
             </a:extLst>
           </p:cNvPr>
@@ -5387,7 +5387,7 @@
           <p:cNvPr id="32" name="">
             <a:extLst xmlns:a="http://schemas.openxmlformats.org/drawingml/2006/main">
               <a:ext uri="{FF2B5EF4-FFF2-40B4-BE49-F238E27FC236}">
-                <a16:creationId xmlns:a16="http://schemas.microsoft.com/office/drawing/2014/main" id="{39115A35-4748-45AD-908F-4C1A0572E675}"/>
+                <a16:creationId xmlns:a16="http://schemas.microsoft.com/office/drawing/2014/main" id="{244770CF-FCE6-4F11-B408-D140730D88C8}"/>
               </a:ext>
             </a:extLst>
           </p:cNvPr>
@@ -5490,7 +5490,7 @@
           <p:cNvPr id="33" name="">
             <a:extLst xmlns:a="http://schemas.openxmlformats.org/drawingml/2006/main">
               <a:ext uri="{FF2B5EF4-FFF2-40B4-BE49-F238E27FC236}">
-                <a16:creationId xmlns:a16="http://schemas.microsoft.com/office/drawing/2014/main" id="{BEDA593E-5301-4866-9479-9ACA99F81803}"/>
+                <a16:creationId xmlns:a16="http://schemas.microsoft.com/office/drawing/2014/main" id="{BEC474BA-C969-4ECD-9030-839D4708E06D}"/>
               </a:ext>
             </a:extLst>
           </p:cNvPr>
@@ -5554,7 +5554,7 @@
           <p:cNvPr id="34" name="">
             <a:extLst xmlns:a="http://schemas.openxmlformats.org/drawingml/2006/main">
               <a:ext uri="{FF2B5EF4-FFF2-40B4-BE49-F238E27FC236}">
-                <a16:creationId xmlns:a16="http://schemas.microsoft.com/office/drawing/2014/main" id="{F626A614-3E78-4137-9504-EE436E773843}"/>
+                <a16:creationId xmlns:a16="http://schemas.microsoft.com/office/drawing/2014/main" id="{6D5DA7D8-EABE-4247-8863-441F4F78A6B5}"/>
               </a:ext>
             </a:extLst>
           </p:cNvPr>
@@ -5611,7 +5611,7 @@
           <p:cNvPr id="35" name="">
             <a:extLst xmlns:a="http://schemas.openxmlformats.org/drawingml/2006/main">
               <a:ext uri="{FF2B5EF4-FFF2-40B4-BE49-F238E27FC236}">
-                <a16:creationId xmlns:a16="http://schemas.microsoft.com/office/drawing/2014/main" id="{5FF00844-5421-4796-BFAE-F7C3754A88FA}"/>
+                <a16:creationId xmlns:a16="http://schemas.microsoft.com/office/drawing/2014/main" id="{E14A2DFE-918D-445E-876C-66700EC1301F}"/>
               </a:ext>
             </a:extLst>
           </p:cNvPr>
@@ -5646,7 +5646,7 @@
           <p:cNvPr id="36" name="">
             <a:extLst xmlns:a="http://schemas.openxmlformats.org/drawingml/2006/main">
               <a:ext uri="{FF2B5EF4-FFF2-40B4-BE49-F238E27FC236}">
-                <a16:creationId xmlns:a16="http://schemas.microsoft.com/office/drawing/2014/main" id="{BF40F9F0-B19A-455C-A8B0-96D86DEF50C4}"/>
+                <a16:creationId xmlns:a16="http://schemas.microsoft.com/office/drawing/2014/main" id="{B4BCB9BA-26DD-4C71-97C3-07E36176B418}"/>
               </a:ext>
             </a:extLst>
           </p:cNvPr>
@@ -5703,7 +5703,7 @@
           <p:cNvPr id="37" name="">
             <a:extLst xmlns:a="http://schemas.openxmlformats.org/drawingml/2006/main">
               <a:ext uri="{FF2B5EF4-FFF2-40B4-BE49-F238E27FC236}">
-                <a16:creationId xmlns:a16="http://schemas.microsoft.com/office/drawing/2014/main" id="{0500C540-688B-4289-90A9-FAC15DAFAC93}"/>
+                <a16:creationId xmlns:a16="http://schemas.microsoft.com/office/drawing/2014/main" id="{F2592463-ECDE-4FD1-A462-47922B320069}"/>
               </a:ext>
             </a:extLst>
           </p:cNvPr>
@@ -5738,7 +5738,7 @@
           <p:cNvPr id="38" name="">
             <a:extLst xmlns:a="http://schemas.openxmlformats.org/drawingml/2006/main">
               <a:ext uri="{FF2B5EF4-FFF2-40B4-BE49-F238E27FC236}">
-                <a16:creationId xmlns:a16="http://schemas.microsoft.com/office/drawing/2014/main" id="{8A7449D5-721C-4221-A346-1B8FD94AE511}"/>
+                <a16:creationId xmlns:a16="http://schemas.microsoft.com/office/drawing/2014/main" id="{3F6323B7-EBB5-438E-A283-03F6A5634ADC}"/>
               </a:ext>
             </a:extLst>
           </p:cNvPr>
@@ -5795,7 +5795,7 @@
           <p:cNvPr id="39" name="">
             <a:extLst xmlns:a="http://schemas.openxmlformats.org/drawingml/2006/main">
               <a:ext uri="{FF2B5EF4-FFF2-40B4-BE49-F238E27FC236}">
-                <a16:creationId xmlns:a16="http://schemas.microsoft.com/office/drawing/2014/main" id="{AA77853A-3BB1-46BE-9E19-C22C365B0FAA}"/>
+                <a16:creationId xmlns:a16="http://schemas.microsoft.com/office/drawing/2014/main" id="{E4E0EAB8-B38B-4E08-9A17-49AA820A4A72}"/>
               </a:ext>
             </a:extLst>
           </p:cNvPr>
@@ -5852,7 +5852,7 @@
           <p:cNvPr id="40" name="">
             <a:extLst xmlns:a="http://schemas.openxmlformats.org/drawingml/2006/main">
               <a:ext uri="{FF2B5EF4-FFF2-40B4-BE49-F238E27FC236}">
-                <a16:creationId xmlns:a16="http://schemas.microsoft.com/office/drawing/2014/main" id="{E3DEEF25-1D5B-432F-BB1E-24AAF32C905B}"/>
+                <a16:creationId xmlns:a16="http://schemas.microsoft.com/office/drawing/2014/main" id="{6FF1963C-49A6-440E-BF67-3DE063E69B8F}"/>
               </a:ext>
             </a:extLst>
           </p:cNvPr>
@@ -5887,7 +5887,7 @@
           <p:cNvPr id="41" name="">
             <a:extLst xmlns:a="http://schemas.openxmlformats.org/drawingml/2006/main">
               <a:ext uri="{FF2B5EF4-FFF2-40B4-BE49-F238E27FC236}">
-                <a16:creationId xmlns:a16="http://schemas.microsoft.com/office/drawing/2014/main" id="{5B3A577B-56E2-425C-A432-BEDB78191D1B}"/>
+                <a16:creationId xmlns:a16="http://schemas.microsoft.com/office/drawing/2014/main" id="{05FBCB37-E2C3-45B7-90FD-35D61990238B}"/>
               </a:ext>
             </a:extLst>
           </p:cNvPr>
@@ -5944,7 +5944,7 @@
           <p:cNvPr id="42" name="">
             <a:extLst xmlns:a="http://schemas.openxmlformats.org/drawingml/2006/main">
               <a:ext uri="{FF2B5EF4-FFF2-40B4-BE49-F238E27FC236}">
-                <a16:creationId xmlns:a16="http://schemas.microsoft.com/office/drawing/2014/main" id="{FEC098D4-FBF7-4C24-A023-163ABC67D967}"/>
+                <a16:creationId xmlns:a16="http://schemas.microsoft.com/office/drawing/2014/main" id="{05B1ACE7-C706-4C25-B50B-44CA5FFE748B}"/>
               </a:ext>
             </a:extLst>
           </p:cNvPr>
@@ -6001,7 +6001,7 @@
           <p:cNvPr id="43" name="">
             <a:extLst xmlns:a="http://schemas.openxmlformats.org/drawingml/2006/main">
               <a:ext uri="{FF2B5EF4-FFF2-40B4-BE49-F238E27FC236}">
-                <a16:creationId xmlns:a16="http://schemas.microsoft.com/office/drawing/2014/main" id="{48554B8D-6019-4B49-9BF1-A128A092E2F6}"/>
+                <a16:creationId xmlns:a16="http://schemas.microsoft.com/office/drawing/2014/main" id="{C23CD8F8-D09C-4B3B-B70B-67C60F655ED0}"/>
               </a:ext>
             </a:extLst>
           </p:cNvPr>
@@ -6058,7 +6058,7 @@
           <p:cNvPr id="44" name="">
             <a:extLst xmlns:a="http://schemas.openxmlformats.org/drawingml/2006/main">
               <a:ext uri="{FF2B5EF4-FFF2-40B4-BE49-F238E27FC236}">
-                <a16:creationId xmlns:a16="http://schemas.microsoft.com/office/drawing/2014/main" id="{EFEBB40E-10C2-4FE8-86CB-8BB3D20923EB}"/>
+                <a16:creationId xmlns:a16="http://schemas.microsoft.com/office/drawing/2014/main" id="{F665DBBB-20EA-419F-9AAC-0C3DF4639E86}"/>
               </a:ext>
             </a:extLst>
           </p:cNvPr>
@@ -6115,7 +6115,7 @@
           <p:cNvPr id="45" name="">
             <a:extLst xmlns:a="http://schemas.openxmlformats.org/drawingml/2006/main">
               <a:ext uri="{FF2B5EF4-FFF2-40B4-BE49-F238E27FC236}">
-                <a16:creationId xmlns:a16="http://schemas.microsoft.com/office/drawing/2014/main" id="{96279B22-FA54-47B0-BAF9-AD822A351DC1}"/>
+                <a16:creationId xmlns:a16="http://schemas.microsoft.com/office/drawing/2014/main" id="{475C9E20-3EBD-4128-BB4E-1CE73BDE28A9}"/>
               </a:ext>
             </a:extLst>
           </p:cNvPr>
@@ -6170,7 +6170,7 @@
     </p:spTree>
     <p:extLst>
       <p:ext uri="{BB962C8B-B14F-4D97-AF65-F5344CB8AC3E}">
-        <p14:creationId xmlns:p14="http://schemas.microsoft.com/office/powerpoint/2010/main" val="109848996"/>
+        <p14:creationId xmlns:p14="http://schemas.microsoft.com/office/powerpoint/2010/main" val="1499603266"/>
       </p:ext>
     </p:extLst>
   </p:cSld>
@@ -6201,7 +6201,7 @@
           <p:cNvPr id="32" name="">
             <a:extLst xmlns:a="http://schemas.openxmlformats.org/drawingml/2006/main">
               <a:ext uri="{FF2B5EF4-FFF2-40B4-BE49-F238E27FC236}">
-                <a16:creationId xmlns:a16="http://schemas.microsoft.com/office/drawing/2014/main" id="{D5131729-38A5-4A6F-A912-0E9327BB3F6C}"/>
+                <a16:creationId xmlns:a16="http://schemas.microsoft.com/office/drawing/2014/main" id="{3578F7F1-6ACA-4371-A8C2-CB9BC9951543}"/>
               </a:ext>
             </a:extLst>
           </p:cNvPr>
@@ -6258,7 +6258,7 @@
           <p:cNvPr id="2" name="">
             <a:extLst xmlns:a="http://schemas.openxmlformats.org/drawingml/2006/main">
               <a:ext uri="{FF2B5EF4-FFF2-40B4-BE49-F238E27FC236}">
-                <a16:creationId xmlns:a16="http://schemas.microsoft.com/office/drawing/2014/main" id="{C7A5C00E-3FFE-464C-9C27-8B4DB86A9C4F}"/>
+                <a16:creationId xmlns:a16="http://schemas.microsoft.com/office/drawing/2014/main" id="{CA2C42B8-1581-4F2F-BC8C-EFCA3A0EE281}"/>
               </a:ext>
             </a:extLst>
           </p:cNvPr>
@@ -6315,7 +6315,7 @@
           <p:cNvPr id="3" name="">
             <a:extLst xmlns:a="http://schemas.openxmlformats.org/drawingml/2006/main">
               <a:ext uri="{FF2B5EF4-FFF2-40B4-BE49-F238E27FC236}">
-                <a16:creationId xmlns:a16="http://schemas.microsoft.com/office/drawing/2014/main" id="{8964D5D6-F9A3-47B0-8CE1-E62F293F0698}"/>
+                <a16:creationId xmlns:a16="http://schemas.microsoft.com/office/drawing/2014/main" id="{82E0AD22-9BA9-4023-8900-3AC514461EA8}"/>
               </a:ext>
             </a:extLst>
           </p:cNvPr>
@@ -6372,7 +6372,7 @@
           <p:cNvPr id="4" name="">
             <a:extLst xmlns:a="http://schemas.openxmlformats.org/drawingml/2006/main">
               <a:ext uri="{FF2B5EF4-FFF2-40B4-BE49-F238E27FC236}">
-                <a16:creationId xmlns:a16="http://schemas.microsoft.com/office/drawing/2014/main" id="{F264C2D3-186D-433F-B2BC-BD1D890FDB7A}"/>
+                <a16:creationId xmlns:a16="http://schemas.microsoft.com/office/drawing/2014/main" id="{EAD90F79-6F8F-410A-B406-00701269EE51}"/>
               </a:ext>
             </a:extLst>
           </p:cNvPr>
@@ -6403,7 +6403,7 @@
           <p:cNvPr id="5" name="">
             <a:extLst xmlns:a="http://schemas.openxmlformats.org/drawingml/2006/main">
               <a:ext uri="{FF2B5EF4-FFF2-40B4-BE49-F238E27FC236}">
-                <a16:creationId xmlns:a16="http://schemas.microsoft.com/office/drawing/2014/main" id="{57F34FBB-389C-4042-9BB2-64AA65611A11}"/>
+                <a16:creationId xmlns:a16="http://schemas.microsoft.com/office/drawing/2014/main" id="{C38AD351-ECED-4D6D-B610-6BD83076DC3D}"/>
               </a:ext>
             </a:extLst>
           </p:cNvPr>
@@ -6438,7 +6438,7 @@
           <p:cNvPr id="6" name="">
             <a:extLst xmlns:a="http://schemas.openxmlformats.org/drawingml/2006/main">
               <a:ext uri="{FF2B5EF4-FFF2-40B4-BE49-F238E27FC236}">
-                <a16:creationId xmlns:a16="http://schemas.microsoft.com/office/drawing/2014/main" id="{117CFB88-882C-407A-A13B-BA579D1D56A1}"/>
+                <a16:creationId xmlns:a16="http://schemas.microsoft.com/office/drawing/2014/main" id="{26B3D9B6-1CBA-4941-B015-6EB1A60AFCAF}"/>
               </a:ext>
             </a:extLst>
           </p:cNvPr>
@@ -6502,7 +6502,7 @@
           <p:cNvPr id="7" name="">
             <a:extLst xmlns:a="http://schemas.openxmlformats.org/drawingml/2006/main">
               <a:ext uri="{FF2B5EF4-FFF2-40B4-BE49-F238E27FC236}">
-                <a16:creationId xmlns:a16="http://schemas.microsoft.com/office/drawing/2014/main" id="{58493260-4A3C-4C23-ACDB-17FDF4B176EC}"/>
+                <a16:creationId xmlns:a16="http://schemas.microsoft.com/office/drawing/2014/main" id="{0E34ABFC-540B-473E-83DA-F0893C1EABCB}"/>
               </a:ext>
             </a:extLst>
           </p:cNvPr>
@@ -6559,7 +6559,7 @@
           <p:cNvPr id="8" name="">
             <a:extLst xmlns:a="http://schemas.openxmlformats.org/drawingml/2006/main">
               <a:ext uri="{FF2B5EF4-FFF2-40B4-BE49-F238E27FC236}">
-                <a16:creationId xmlns:a16="http://schemas.microsoft.com/office/drawing/2014/main" id="{859F8DC7-22C6-432D-9CFD-6FDA27C25F84}"/>
+                <a16:creationId xmlns:a16="http://schemas.microsoft.com/office/drawing/2014/main" id="{C7583161-6F81-468C-9685-9F7AE999259D}"/>
               </a:ext>
             </a:extLst>
           </p:cNvPr>
@@ -6662,7 +6662,7 @@
           <p:cNvPr id="9" name="">
             <a:extLst xmlns:a="http://schemas.openxmlformats.org/drawingml/2006/main">
               <a:ext uri="{FF2B5EF4-FFF2-40B4-BE49-F238E27FC236}">
-                <a16:creationId xmlns:a16="http://schemas.microsoft.com/office/drawing/2014/main" id="{26253DEB-2229-4B7E-9797-C5A0445E619C}"/>
+                <a16:creationId xmlns:a16="http://schemas.microsoft.com/office/drawing/2014/main" id="{4137CD7B-A46D-418F-A7A8-A6043F9F7EAF}"/>
               </a:ext>
             </a:extLst>
           </p:cNvPr>
@@ -6697,7 +6697,7 @@
           <p:cNvPr id="10" name="">
             <a:extLst xmlns:a="http://schemas.openxmlformats.org/drawingml/2006/main">
               <a:ext uri="{FF2B5EF4-FFF2-40B4-BE49-F238E27FC236}">
-                <a16:creationId xmlns:a16="http://schemas.microsoft.com/office/drawing/2014/main" id="{F2FA6821-F45D-457E-85B0-F4A697B0641A}"/>
+                <a16:creationId xmlns:a16="http://schemas.microsoft.com/office/drawing/2014/main" id="{6C35ECAC-234D-467F-AD4F-B196988286B7}"/>
               </a:ext>
             </a:extLst>
           </p:cNvPr>
@@ -6761,7 +6761,7 @@
           <p:cNvPr id="11" name="">
             <a:extLst xmlns:a="http://schemas.openxmlformats.org/drawingml/2006/main">
               <a:ext uri="{FF2B5EF4-FFF2-40B4-BE49-F238E27FC236}">
-                <a16:creationId xmlns:a16="http://schemas.microsoft.com/office/drawing/2014/main" id="{696FE44E-FE61-4226-9E9E-C902F852B6E4}"/>
+                <a16:creationId xmlns:a16="http://schemas.microsoft.com/office/drawing/2014/main" id="{22C4C7A1-CFFD-42BD-83EA-3C6124D4508E}"/>
               </a:ext>
             </a:extLst>
           </p:cNvPr>
@@ -6818,7 +6818,7 @@
           <p:cNvPr id="12" name="">
             <a:extLst xmlns:a="http://schemas.openxmlformats.org/drawingml/2006/main">
               <a:ext uri="{FF2B5EF4-FFF2-40B4-BE49-F238E27FC236}">
-                <a16:creationId xmlns:a16="http://schemas.microsoft.com/office/drawing/2014/main" id="{11FFE742-D3E5-46FF-8557-D637704F8414}"/>
+                <a16:creationId xmlns:a16="http://schemas.microsoft.com/office/drawing/2014/main" id="{D8032F02-3DF5-44A5-A562-8682C7F0D792}"/>
               </a:ext>
             </a:extLst>
           </p:cNvPr>
@@ -6921,7 +6921,7 @@
           <p:cNvPr id="13" name="">
             <a:extLst xmlns:a="http://schemas.openxmlformats.org/drawingml/2006/main">
               <a:ext uri="{FF2B5EF4-FFF2-40B4-BE49-F238E27FC236}">
-                <a16:creationId xmlns:a16="http://schemas.microsoft.com/office/drawing/2014/main" id="{9A154D24-A8BE-4D51-9CDE-24811F6EA703}"/>
+                <a16:creationId xmlns:a16="http://schemas.microsoft.com/office/drawing/2014/main" id="{5538449C-C0EA-4885-BE98-AF9843C87A61}"/>
               </a:ext>
             </a:extLst>
           </p:cNvPr>
@@ -6978,7 +6978,7 @@
           <p:cNvPr id="14" name="">
             <a:extLst xmlns:a="http://schemas.openxmlformats.org/drawingml/2006/main">
               <a:ext uri="{FF2B5EF4-FFF2-40B4-BE49-F238E27FC236}">
-                <a16:creationId xmlns:a16="http://schemas.microsoft.com/office/drawing/2014/main" id="{7029FA7E-683A-45BC-BF10-A55F72D848FE}"/>
+                <a16:creationId xmlns:a16="http://schemas.microsoft.com/office/drawing/2014/main" id="{7FDD3EF8-B2F3-4E27-97AC-188E99F08F91}"/>
               </a:ext>
             </a:extLst>
           </p:cNvPr>
@@ -7013,7 +7013,7 @@
           <p:cNvPr id="15" name="">
             <a:extLst xmlns:a="http://schemas.openxmlformats.org/drawingml/2006/main">
               <a:ext uri="{FF2B5EF4-FFF2-40B4-BE49-F238E27FC236}">
-                <a16:creationId xmlns:a16="http://schemas.microsoft.com/office/drawing/2014/main" id="{85D9D81A-A59E-461B-A8DB-B74DD5E80BB7}"/>
+                <a16:creationId xmlns:a16="http://schemas.microsoft.com/office/drawing/2014/main" id="{4E5EC911-05EE-4A23-BE87-9F101B8E0B42}"/>
               </a:ext>
             </a:extLst>
           </p:cNvPr>
@@ -7070,7 +7070,7 @@
           <p:cNvPr id="16" name="">
             <a:extLst xmlns:a="http://schemas.openxmlformats.org/drawingml/2006/main">
               <a:ext uri="{FF2B5EF4-FFF2-40B4-BE49-F238E27FC236}">
-                <a16:creationId xmlns:a16="http://schemas.microsoft.com/office/drawing/2014/main" id="{8CA20012-C366-426D-B00D-67819D8268BE}"/>
+                <a16:creationId xmlns:a16="http://schemas.microsoft.com/office/drawing/2014/main" id="{A3C59581-8815-4BD2-BE31-10094331E03D}"/>
               </a:ext>
             </a:extLst>
           </p:cNvPr>
@@ -7127,7 +7127,7 @@
           <p:cNvPr id="17" name="">
             <a:extLst xmlns:a="http://schemas.openxmlformats.org/drawingml/2006/main">
               <a:ext uri="{FF2B5EF4-FFF2-40B4-BE49-F238E27FC236}">
-                <a16:creationId xmlns:a16="http://schemas.microsoft.com/office/drawing/2014/main" id="{9A5AE015-69F2-4292-AD32-98E9EE7C435B}"/>
+                <a16:creationId xmlns:a16="http://schemas.microsoft.com/office/drawing/2014/main" id="{88E6EAED-7BE7-4D2E-9DA0-B7D625A3FE6C}"/>
               </a:ext>
             </a:extLst>
           </p:cNvPr>
@@ -7162,7 +7162,7 @@
           <p:cNvPr id="18" name="">
             <a:extLst xmlns:a="http://schemas.openxmlformats.org/drawingml/2006/main">
               <a:ext uri="{FF2B5EF4-FFF2-40B4-BE49-F238E27FC236}">
-                <a16:creationId xmlns:a16="http://schemas.microsoft.com/office/drawing/2014/main" id="{4D68D92B-3578-46DC-9FC4-5AE8B4BE51E0}"/>
+                <a16:creationId xmlns:a16="http://schemas.microsoft.com/office/drawing/2014/main" id="{A3E28E40-5695-4BCC-AD4B-078DF55615DC}"/>
               </a:ext>
             </a:extLst>
           </p:cNvPr>
@@ -7219,7 +7219,7 @@
           <p:cNvPr id="19" name="">
             <a:extLst xmlns:a="http://schemas.openxmlformats.org/drawingml/2006/main">
               <a:ext uri="{FF2B5EF4-FFF2-40B4-BE49-F238E27FC236}">
-                <a16:creationId xmlns:a16="http://schemas.microsoft.com/office/drawing/2014/main" id="{31CCC59D-CE13-4455-A2EB-BF0AFD5CB912}"/>
+                <a16:creationId xmlns:a16="http://schemas.microsoft.com/office/drawing/2014/main" id="{E85702DA-7E61-4950-B701-E457983BF874}"/>
               </a:ext>
             </a:extLst>
           </p:cNvPr>
@@ -7276,7 +7276,7 @@
           <p:cNvPr id="20" name="">
             <a:extLst xmlns:a="http://schemas.openxmlformats.org/drawingml/2006/main">
               <a:ext uri="{FF2B5EF4-FFF2-40B4-BE49-F238E27FC236}">
-                <a16:creationId xmlns:a16="http://schemas.microsoft.com/office/drawing/2014/main" id="{25EE522A-9488-4852-B510-B028412F79EC}"/>
+                <a16:creationId xmlns:a16="http://schemas.microsoft.com/office/drawing/2014/main" id="{4E48C59C-D6DE-41F1-8DD6-43CED4CEE8E2}"/>
               </a:ext>
             </a:extLst>
           </p:cNvPr>
@@ -7311,7 +7311,7 @@
           <p:cNvPr id="21" name="">
             <a:extLst xmlns:a="http://schemas.openxmlformats.org/drawingml/2006/main">
               <a:ext uri="{FF2B5EF4-FFF2-40B4-BE49-F238E27FC236}">
-                <a16:creationId xmlns:a16="http://schemas.microsoft.com/office/drawing/2014/main" id="{936A85FB-4248-41F5-94B5-5841C6AADBD0}"/>
+                <a16:creationId xmlns:a16="http://schemas.microsoft.com/office/drawing/2014/main" id="{B650A001-D399-42C0-B1EE-9A4EB21E83B3}"/>
               </a:ext>
             </a:extLst>
           </p:cNvPr>
@@ -7368,7 +7368,7 @@
           <p:cNvPr id="22" name="">
             <a:extLst xmlns:a="http://schemas.openxmlformats.org/drawingml/2006/main">
               <a:ext uri="{FF2B5EF4-FFF2-40B4-BE49-F238E27FC236}">
-                <a16:creationId xmlns:a16="http://schemas.microsoft.com/office/drawing/2014/main" id="{1471D8F9-27C2-4CC8-B422-CEF3C05FDD22}"/>
+                <a16:creationId xmlns:a16="http://schemas.microsoft.com/office/drawing/2014/main" id="{8590D4CB-6D52-4ED0-A3F3-7047E978A13D}"/>
               </a:ext>
             </a:extLst>
           </p:cNvPr>
@@ -7425,7 +7425,7 @@
           <p:cNvPr id="23" name="">
             <a:extLst xmlns:a="http://schemas.openxmlformats.org/drawingml/2006/main">
               <a:ext uri="{FF2B5EF4-FFF2-40B4-BE49-F238E27FC236}">
-                <a16:creationId xmlns:a16="http://schemas.microsoft.com/office/drawing/2014/main" id="{C78073C7-D788-449A-B515-787C537557E0}"/>
+                <a16:creationId xmlns:a16="http://schemas.microsoft.com/office/drawing/2014/main" id="{AE85F048-0473-4E4B-B499-89409BD7E36A}"/>
               </a:ext>
             </a:extLst>
           </p:cNvPr>
@@ -7460,7 +7460,7 @@
           <p:cNvPr id="24" name="">
             <a:extLst xmlns:a="http://schemas.openxmlformats.org/drawingml/2006/main">
               <a:ext uri="{FF2B5EF4-FFF2-40B4-BE49-F238E27FC236}">
-                <a16:creationId xmlns:a16="http://schemas.microsoft.com/office/drawing/2014/main" id="{B3DED6E5-4D53-4D06-8F28-F12D9458253B}"/>
+                <a16:creationId xmlns:a16="http://schemas.microsoft.com/office/drawing/2014/main" id="{C4C5B54A-3131-4E98-A7F7-65693208878C}"/>
               </a:ext>
             </a:extLst>
           </p:cNvPr>
@@ -7517,7 +7517,7 @@
           <p:cNvPr id="25" name="">
             <a:extLst xmlns:a="http://schemas.openxmlformats.org/drawingml/2006/main">
               <a:ext uri="{FF2B5EF4-FFF2-40B4-BE49-F238E27FC236}">
-                <a16:creationId xmlns:a16="http://schemas.microsoft.com/office/drawing/2014/main" id="{EFE3D44C-2375-4933-934D-7D731311610B}"/>
+                <a16:creationId xmlns:a16="http://schemas.microsoft.com/office/drawing/2014/main" id="{9C5FC60C-0ECF-4670-B6C8-65F694CF536D}"/>
               </a:ext>
             </a:extLst>
           </p:cNvPr>
@@ -7581,7 +7581,7 @@
           <p:cNvPr id="26" name="">
             <a:extLst xmlns:a="http://schemas.openxmlformats.org/drawingml/2006/main">
               <a:ext uri="{FF2B5EF4-FFF2-40B4-BE49-F238E27FC236}">
-                <a16:creationId xmlns:a16="http://schemas.microsoft.com/office/drawing/2014/main" id="{C1E78124-52B3-447A-92D3-CF62830E4F9B}"/>
+                <a16:creationId xmlns:a16="http://schemas.microsoft.com/office/drawing/2014/main" id="{C6377F1A-CA7B-4E4D-9457-0EE026F6C4F4}"/>
               </a:ext>
             </a:extLst>
           </p:cNvPr>
@@ -7645,7 +7645,7 @@
           <p:cNvPr id="27" name="">
             <a:extLst xmlns:a="http://schemas.openxmlformats.org/drawingml/2006/main">
               <a:ext uri="{FF2B5EF4-FFF2-40B4-BE49-F238E27FC236}">
-                <a16:creationId xmlns:a16="http://schemas.microsoft.com/office/drawing/2014/main" id="{1D2CFEF8-CAEB-425C-AFE5-8C6DC5A898BC}"/>
+                <a16:creationId xmlns:a16="http://schemas.microsoft.com/office/drawing/2014/main" id="{2F8E3675-FD91-458B-9255-FE3CE62E6751}"/>
               </a:ext>
             </a:extLst>
           </p:cNvPr>
@@ -7709,7 +7709,7 @@
           <p:cNvPr id="28" name="">
             <a:extLst xmlns:a="http://schemas.openxmlformats.org/drawingml/2006/main">
               <a:ext uri="{FF2B5EF4-FFF2-40B4-BE49-F238E27FC236}">
-                <a16:creationId xmlns:a16="http://schemas.microsoft.com/office/drawing/2014/main" id="{B3B4B8FD-F094-46A6-B4B2-975F88ABB071}"/>
+                <a16:creationId xmlns:a16="http://schemas.microsoft.com/office/drawing/2014/main" id="{00E41A62-8AE2-47DD-B633-F8D41B2B8D16}"/>
               </a:ext>
             </a:extLst>
           </p:cNvPr>
@@ -7773,7 +7773,7 @@
           <p:cNvPr id="29" name="">
             <a:extLst xmlns:a="http://schemas.openxmlformats.org/drawingml/2006/main">
               <a:ext uri="{FF2B5EF4-FFF2-40B4-BE49-F238E27FC236}">
-                <a16:creationId xmlns:a16="http://schemas.microsoft.com/office/drawing/2014/main" id="{3443E1BB-B30E-4EB2-9458-DDD315B3907E}"/>
+                <a16:creationId xmlns:a16="http://schemas.microsoft.com/office/drawing/2014/main" id="{4C310E49-F8A7-465B-8B32-AF0390BC09BA}"/>
               </a:ext>
             </a:extLst>
           </p:cNvPr>
@@ -7830,7 +7830,7 @@
           <p:cNvPr id="30" name="">
             <a:extLst xmlns:a="http://schemas.openxmlformats.org/drawingml/2006/main">
               <a:ext uri="{FF2B5EF4-FFF2-40B4-BE49-F238E27FC236}">
-                <a16:creationId xmlns:a16="http://schemas.microsoft.com/office/drawing/2014/main" id="{9C1DE11E-4CA1-4F84-A1FE-90E52DF55853}"/>
+                <a16:creationId xmlns:a16="http://schemas.microsoft.com/office/drawing/2014/main" id="{31169D09-08B4-4F91-9241-68B3E095D87E}"/>
               </a:ext>
             </a:extLst>
           </p:cNvPr>
@@ -7887,7 +7887,7 @@
           <p:cNvPr id="31" name="">
             <a:extLst xmlns:a="http://schemas.openxmlformats.org/drawingml/2006/main">
               <a:ext uri="{FF2B5EF4-FFF2-40B4-BE49-F238E27FC236}">
-                <a16:creationId xmlns:a16="http://schemas.microsoft.com/office/drawing/2014/main" id="{6D7BC66C-6E67-48FD-9C48-106309B49267}"/>
+                <a16:creationId xmlns:a16="http://schemas.microsoft.com/office/drawing/2014/main" id="{F3A39643-6851-47DC-84FE-C6B0F825184F}"/>
               </a:ext>
             </a:extLst>
           </p:cNvPr>
@@ -7942,7 +7942,7 @@
     </p:spTree>
     <p:extLst>
       <p:ext uri="{BB962C8B-B14F-4D97-AF65-F5344CB8AC3E}">
-        <p14:creationId xmlns:p14="http://schemas.microsoft.com/office/powerpoint/2010/main" val="218570645"/>
+        <p14:creationId xmlns:p14="http://schemas.microsoft.com/office/powerpoint/2010/main" val="2144598308"/>
       </p:ext>
     </p:extLst>
   </p:cSld>
@@ -7973,7 +7973,7 @@
           <p:cNvPr id="32" name="">
             <a:extLst xmlns:a="http://schemas.openxmlformats.org/drawingml/2006/main">
               <a:ext uri="{FF2B5EF4-FFF2-40B4-BE49-F238E27FC236}">
-                <a16:creationId xmlns:a16="http://schemas.microsoft.com/office/drawing/2014/main" id="{AF7DE3F6-F8E3-4E92-9CB7-5DD3EBA7DF74}"/>
+                <a16:creationId xmlns:a16="http://schemas.microsoft.com/office/drawing/2014/main" id="{166E6BED-2346-46D4-952C-645BC3CA8EB4}"/>
               </a:ext>
             </a:extLst>
           </p:cNvPr>
@@ -8030,7 +8030,7 @@
           <p:cNvPr id="2" name="">
             <a:extLst xmlns:a="http://schemas.openxmlformats.org/drawingml/2006/main">
               <a:ext uri="{FF2B5EF4-FFF2-40B4-BE49-F238E27FC236}">
-                <a16:creationId xmlns:a16="http://schemas.microsoft.com/office/drawing/2014/main" id="{D7F9553A-0779-43F5-8736-D1F4C71920D8}"/>
+                <a16:creationId xmlns:a16="http://schemas.microsoft.com/office/drawing/2014/main" id="{AB781700-F7B3-4831-97B1-3A1A0D103B84}"/>
               </a:ext>
             </a:extLst>
           </p:cNvPr>
@@ -8087,7 +8087,7 @@
           <p:cNvPr id="3" name="">
             <a:extLst xmlns:a="http://schemas.openxmlformats.org/drawingml/2006/main">
               <a:ext uri="{FF2B5EF4-FFF2-40B4-BE49-F238E27FC236}">
-                <a16:creationId xmlns:a16="http://schemas.microsoft.com/office/drawing/2014/main" id="{09E8BFCD-D67E-4F19-B39D-D23671B7EFC2}"/>
+                <a16:creationId xmlns:a16="http://schemas.microsoft.com/office/drawing/2014/main" id="{478E7FF0-DEDE-4977-81B5-F55F2610C6DC}"/>
               </a:ext>
             </a:extLst>
           </p:cNvPr>
@@ -8144,7 +8144,7 @@
           <p:cNvPr id="4" name="">
             <a:extLst xmlns:a="http://schemas.openxmlformats.org/drawingml/2006/main">
               <a:ext uri="{FF2B5EF4-FFF2-40B4-BE49-F238E27FC236}">
-                <a16:creationId xmlns:a16="http://schemas.microsoft.com/office/drawing/2014/main" id="{405672DA-C5B0-4D48-B85E-B1F29DE2A4F2}"/>
+                <a16:creationId xmlns:a16="http://schemas.microsoft.com/office/drawing/2014/main" id="{D8FE21B7-9BE7-44E4-ABF9-C52CDC090490}"/>
               </a:ext>
             </a:extLst>
           </p:cNvPr>
@@ -8175,7 +8175,7 @@
           <p:cNvPr id="5" name="">
             <a:extLst xmlns:a="http://schemas.openxmlformats.org/drawingml/2006/main">
               <a:ext uri="{FF2B5EF4-FFF2-40B4-BE49-F238E27FC236}">
-                <a16:creationId xmlns:a16="http://schemas.microsoft.com/office/drawing/2014/main" id="{0D7694B9-8CC5-49C4-85C0-EFA9AF41AF41}"/>
+                <a16:creationId xmlns:a16="http://schemas.microsoft.com/office/drawing/2014/main" id="{DC12D050-A019-4C3E-8B2B-5B1DF78A0B7E}"/>
               </a:ext>
             </a:extLst>
           </p:cNvPr>
@@ -8210,7 +8210,7 @@
           <p:cNvPr id="6" name="">
             <a:extLst xmlns:a="http://schemas.openxmlformats.org/drawingml/2006/main">
               <a:ext uri="{FF2B5EF4-FFF2-40B4-BE49-F238E27FC236}">
-                <a16:creationId xmlns:a16="http://schemas.microsoft.com/office/drawing/2014/main" id="{F8107E3B-D91C-445E-99EC-8AEBC1582683}"/>
+                <a16:creationId xmlns:a16="http://schemas.microsoft.com/office/drawing/2014/main" id="{B50E67BF-6A75-48FE-82B3-21CDBCCC20AC}"/>
               </a:ext>
             </a:extLst>
           </p:cNvPr>
@@ -8274,7 +8274,7 @@
           <p:cNvPr id="7" name="">
             <a:extLst xmlns:a="http://schemas.openxmlformats.org/drawingml/2006/main">
               <a:ext uri="{FF2B5EF4-FFF2-40B4-BE49-F238E27FC236}">
-                <a16:creationId xmlns:a16="http://schemas.microsoft.com/office/drawing/2014/main" id="{EA381FEB-7F58-477D-8D76-BBEFA1055F76}"/>
+                <a16:creationId xmlns:a16="http://schemas.microsoft.com/office/drawing/2014/main" id="{BF91733B-9DFA-4197-B554-F704CE25162D}"/>
               </a:ext>
             </a:extLst>
           </p:cNvPr>
@@ -8331,7 +8331,7 @@
           <p:cNvPr id="8" name="">
             <a:extLst xmlns:a="http://schemas.openxmlformats.org/drawingml/2006/main">
               <a:ext uri="{FF2B5EF4-FFF2-40B4-BE49-F238E27FC236}">
-                <a16:creationId xmlns:a16="http://schemas.microsoft.com/office/drawing/2014/main" id="{FFC49027-CAE1-4E9C-8CB1-4FCFB1962047}"/>
+                <a16:creationId xmlns:a16="http://schemas.microsoft.com/office/drawing/2014/main" id="{9DC32F55-15EF-4DD8-8EA6-C619F45AF6EC}"/>
               </a:ext>
             </a:extLst>
           </p:cNvPr>
@@ -8362,7 +8362,7 @@
           <p:cNvPr id="9" name="">
             <a:extLst xmlns:a="http://schemas.openxmlformats.org/drawingml/2006/main">
               <a:ext uri="{FF2B5EF4-FFF2-40B4-BE49-F238E27FC236}">
-                <a16:creationId xmlns:a16="http://schemas.microsoft.com/office/drawing/2014/main" id="{5D32C9B0-512C-440F-98B2-CCD94D75F18A}"/>
+                <a16:creationId xmlns:a16="http://schemas.microsoft.com/office/drawing/2014/main" id="{7865AFD1-8FFF-4ADD-9FF8-FA485E20C79B}"/>
               </a:ext>
             </a:extLst>
           </p:cNvPr>
@@ -8397,7 +8397,7 @@
           <p:cNvPr id="10" name="">
             <a:extLst xmlns:a="http://schemas.openxmlformats.org/drawingml/2006/main">
               <a:ext uri="{FF2B5EF4-FFF2-40B4-BE49-F238E27FC236}">
-                <a16:creationId xmlns:a16="http://schemas.microsoft.com/office/drawing/2014/main" id="{6B47EC48-7B8D-4297-946F-4A4E673E541C}"/>
+                <a16:creationId xmlns:a16="http://schemas.microsoft.com/office/drawing/2014/main" id="{B1048674-89EC-4E1F-A7B6-2592F6C642EB}"/>
               </a:ext>
             </a:extLst>
           </p:cNvPr>
@@ -8461,7 +8461,7 @@
           <p:cNvPr id="11" name="">
             <a:extLst xmlns:a="http://schemas.openxmlformats.org/drawingml/2006/main">
               <a:ext uri="{FF2B5EF4-FFF2-40B4-BE49-F238E27FC236}">
-                <a16:creationId xmlns:a16="http://schemas.microsoft.com/office/drawing/2014/main" id="{3BCE859A-D68E-432D-B6F4-B2050661F195}"/>
+                <a16:creationId xmlns:a16="http://schemas.microsoft.com/office/drawing/2014/main" id="{4EB03C47-C1E6-4FB0-8412-491A4AF8A9E3}"/>
               </a:ext>
             </a:extLst>
           </p:cNvPr>
@@ -8518,7 +8518,7 @@
           <p:cNvPr id="12" name="">
             <a:extLst xmlns:a="http://schemas.openxmlformats.org/drawingml/2006/main">
               <a:ext uri="{FF2B5EF4-FFF2-40B4-BE49-F238E27FC236}">
-                <a16:creationId xmlns:a16="http://schemas.microsoft.com/office/drawing/2014/main" id="{4445FC70-EA87-4C15-AED1-F5FA34250ED1}"/>
+                <a16:creationId xmlns:a16="http://schemas.microsoft.com/office/drawing/2014/main" id="{8382AAA1-27B4-475D-A67E-DB415C7145BC}"/>
               </a:ext>
             </a:extLst>
           </p:cNvPr>
@@ -8549,7 +8549,7 @@
           <p:cNvPr id="13" name="">
             <a:extLst xmlns:a="http://schemas.openxmlformats.org/drawingml/2006/main">
               <a:ext uri="{FF2B5EF4-FFF2-40B4-BE49-F238E27FC236}">
-                <a16:creationId xmlns:a16="http://schemas.microsoft.com/office/drawing/2014/main" id="{561430FB-E9A7-4921-BF50-3CDC0B5C4E97}"/>
+                <a16:creationId xmlns:a16="http://schemas.microsoft.com/office/drawing/2014/main" id="{BB8744F2-2513-4F81-9D1D-B5F3CB5E7FBB}"/>
               </a:ext>
             </a:extLst>
           </p:cNvPr>
@@ -8584,7 +8584,7 @@
           <p:cNvPr id="14" name="">
             <a:extLst xmlns:a="http://schemas.openxmlformats.org/drawingml/2006/main">
               <a:ext uri="{FF2B5EF4-FFF2-40B4-BE49-F238E27FC236}">
-                <a16:creationId xmlns:a16="http://schemas.microsoft.com/office/drawing/2014/main" id="{E5E05252-28A5-4C5B-9689-58FF143F3963}"/>
+                <a16:creationId xmlns:a16="http://schemas.microsoft.com/office/drawing/2014/main" id="{92B91F0F-E79B-42A4-97E8-8F264DBD2AFF}"/>
               </a:ext>
             </a:extLst>
           </p:cNvPr>
@@ -8648,7 +8648,7 @@
           <p:cNvPr id="15" name="">
             <a:extLst xmlns:a="http://schemas.openxmlformats.org/drawingml/2006/main">
               <a:ext uri="{FF2B5EF4-FFF2-40B4-BE49-F238E27FC236}">
-                <a16:creationId xmlns:a16="http://schemas.microsoft.com/office/drawing/2014/main" id="{53560AB2-DBB9-46A0-B0F8-1A782EDCC1FC}"/>
+                <a16:creationId xmlns:a16="http://schemas.microsoft.com/office/drawing/2014/main" id="{9D3552B2-AE4F-438A-8961-7C71FF8F17CD}"/>
               </a:ext>
             </a:extLst>
           </p:cNvPr>
@@ -8705,7 +8705,7 @@
           <p:cNvPr id="16" name="">
             <a:extLst xmlns:a="http://schemas.openxmlformats.org/drawingml/2006/main">
               <a:ext uri="{FF2B5EF4-FFF2-40B4-BE49-F238E27FC236}">
-                <a16:creationId xmlns:a16="http://schemas.microsoft.com/office/drawing/2014/main" id="{94633B48-AD43-46F7-A33C-F7F1C009F3DB}"/>
+                <a16:creationId xmlns:a16="http://schemas.microsoft.com/office/drawing/2014/main" id="{1F12DEEC-CED8-4699-919A-2199E893FF29}"/>
               </a:ext>
             </a:extLst>
           </p:cNvPr>
@@ -8736,7 +8736,7 @@
           <p:cNvPr id="17" name="">
             <a:extLst xmlns:a="http://schemas.openxmlformats.org/drawingml/2006/main">
               <a:ext uri="{FF2B5EF4-FFF2-40B4-BE49-F238E27FC236}">
-                <a16:creationId xmlns:a16="http://schemas.microsoft.com/office/drawing/2014/main" id="{C3CB6157-D251-4A0C-91BE-68292715EFB8}"/>
+                <a16:creationId xmlns:a16="http://schemas.microsoft.com/office/drawing/2014/main" id="{902997A5-88E3-492B-96F9-41F2ACD77B9D}"/>
               </a:ext>
             </a:extLst>
           </p:cNvPr>
@@ -8771,7 +8771,7 @@
           <p:cNvPr id="18" name="">
             <a:extLst xmlns:a="http://schemas.openxmlformats.org/drawingml/2006/main">
               <a:ext uri="{FF2B5EF4-FFF2-40B4-BE49-F238E27FC236}">
-                <a16:creationId xmlns:a16="http://schemas.microsoft.com/office/drawing/2014/main" id="{CE2455B2-16CE-4DA2-9B93-2D1C3B2720F4}"/>
+                <a16:creationId xmlns:a16="http://schemas.microsoft.com/office/drawing/2014/main" id="{5EEA0FDB-5905-4DC2-AAEB-710ADB0DA5E3}"/>
               </a:ext>
             </a:extLst>
           </p:cNvPr>
@@ -8835,7 +8835,7 @@
           <p:cNvPr id="19" name="">
             <a:extLst xmlns:a="http://schemas.openxmlformats.org/drawingml/2006/main">
               <a:ext uri="{FF2B5EF4-FFF2-40B4-BE49-F238E27FC236}">
-                <a16:creationId xmlns:a16="http://schemas.microsoft.com/office/drawing/2014/main" id="{E7DBA725-2DD5-4F8D-BC75-A1CEA0F6EA0B}"/>
+                <a16:creationId xmlns:a16="http://schemas.microsoft.com/office/drawing/2014/main" id="{734CED9A-4FE8-45B4-A564-3B3558AAE6C6}"/>
               </a:ext>
             </a:extLst>
           </p:cNvPr>
@@ -8892,7 +8892,7 @@
           <p:cNvPr id="20" name="">
             <a:extLst xmlns:a="http://schemas.openxmlformats.org/drawingml/2006/main">
               <a:ext uri="{FF2B5EF4-FFF2-40B4-BE49-F238E27FC236}">
-                <a16:creationId xmlns:a16="http://schemas.microsoft.com/office/drawing/2014/main" id="{C5048765-AC53-404A-990D-F3BEC2C6E6DC}"/>
+                <a16:creationId xmlns:a16="http://schemas.microsoft.com/office/drawing/2014/main" id="{56B0EDD1-F178-4F02-8873-0FA369257B04}"/>
               </a:ext>
             </a:extLst>
           </p:cNvPr>
@@ -8927,7 +8927,7 @@
           <p:cNvPr id="21" name="">
             <a:extLst xmlns:a="http://schemas.openxmlformats.org/drawingml/2006/main">
               <a:ext uri="{FF2B5EF4-FFF2-40B4-BE49-F238E27FC236}">
-                <a16:creationId xmlns:a16="http://schemas.microsoft.com/office/drawing/2014/main" id="{379FA3F0-6252-4444-8F47-8A36AFBA4A37}"/>
+                <a16:creationId xmlns:a16="http://schemas.microsoft.com/office/drawing/2014/main" id="{79D877C1-D9EB-4104-A5DC-F70051DA2792}"/>
               </a:ext>
             </a:extLst>
           </p:cNvPr>
@@ -8984,7 +8984,7 @@
           <p:cNvPr id="22" name="">
             <a:extLst xmlns:a="http://schemas.openxmlformats.org/drawingml/2006/main">
               <a:ext uri="{FF2B5EF4-FFF2-40B4-BE49-F238E27FC236}">
-                <a16:creationId xmlns:a16="http://schemas.microsoft.com/office/drawing/2014/main" id="{247E9926-7619-4198-9C84-AC9B47037F3B}"/>
+                <a16:creationId xmlns:a16="http://schemas.microsoft.com/office/drawing/2014/main" id="{E4F3EF96-4E1A-4E52-BD48-75E9FF0E284F}"/>
               </a:ext>
             </a:extLst>
           </p:cNvPr>
@@ -9041,7 +9041,7 @@
           <p:cNvPr id="23" name="">
             <a:extLst xmlns:a="http://schemas.openxmlformats.org/drawingml/2006/main">
               <a:ext uri="{FF2B5EF4-FFF2-40B4-BE49-F238E27FC236}">
-                <a16:creationId xmlns:a16="http://schemas.microsoft.com/office/drawing/2014/main" id="{D4D3FE98-854D-4F06-A61A-1670BCF74889}"/>
+                <a16:creationId xmlns:a16="http://schemas.microsoft.com/office/drawing/2014/main" id="{133CB091-8E92-4195-AA83-B4DA98872110}"/>
               </a:ext>
             </a:extLst>
           </p:cNvPr>
@@ -9076,7 +9076,7 @@
           <p:cNvPr id="24" name="">
             <a:extLst xmlns:a="http://schemas.openxmlformats.org/drawingml/2006/main">
               <a:ext uri="{FF2B5EF4-FFF2-40B4-BE49-F238E27FC236}">
-                <a16:creationId xmlns:a16="http://schemas.microsoft.com/office/drawing/2014/main" id="{E6D3D8A9-25A6-4DC1-8511-222A91633CED}"/>
+                <a16:creationId xmlns:a16="http://schemas.microsoft.com/office/drawing/2014/main" id="{40C93439-8C03-4B95-9BDF-6011577B470A}"/>
               </a:ext>
             </a:extLst>
           </p:cNvPr>
@@ -9140,7 +9140,7 @@
           <p:cNvPr id="25" name="">
             <a:extLst xmlns:a="http://schemas.openxmlformats.org/drawingml/2006/main">
               <a:ext uri="{FF2B5EF4-FFF2-40B4-BE49-F238E27FC236}">
-                <a16:creationId xmlns:a16="http://schemas.microsoft.com/office/drawing/2014/main" id="{7CD66EF5-01B5-45C9-B896-3EF76D7FFB0F}"/>
+                <a16:creationId xmlns:a16="http://schemas.microsoft.com/office/drawing/2014/main" id="{9177C14B-BDA5-49DE-BED7-14649D6FDC4F}"/>
               </a:ext>
             </a:extLst>
           </p:cNvPr>
@@ -9266,7 +9266,7 @@
           <p:cNvPr id="26" name="">
             <a:extLst xmlns:a="http://schemas.openxmlformats.org/drawingml/2006/main">
               <a:ext uri="{FF2B5EF4-FFF2-40B4-BE49-F238E27FC236}">
-                <a16:creationId xmlns:a16="http://schemas.microsoft.com/office/drawing/2014/main" id="{06C88A20-7CE0-495C-A604-08EAD6072248}"/>
+                <a16:creationId xmlns:a16="http://schemas.microsoft.com/office/drawing/2014/main" id="{D183B7B3-4DC0-4271-BAA3-0AC337430C54}"/>
               </a:ext>
             </a:extLst>
           </p:cNvPr>
@@ -9301,7 +9301,7 @@
           <p:cNvPr id="27" name="">
             <a:extLst xmlns:a="http://schemas.openxmlformats.org/drawingml/2006/main">
               <a:ext uri="{FF2B5EF4-FFF2-40B4-BE49-F238E27FC236}">
-                <a16:creationId xmlns:a16="http://schemas.microsoft.com/office/drawing/2014/main" id="{84E528DF-F47D-4273-9837-038243BC4C63}"/>
+                <a16:creationId xmlns:a16="http://schemas.microsoft.com/office/drawing/2014/main" id="{967C7C85-DE01-4801-821F-69B75F3668E1}"/>
               </a:ext>
             </a:extLst>
           </p:cNvPr>
@@ -9365,7 +9365,7 @@
           <p:cNvPr id="28" name="">
             <a:extLst xmlns:a="http://schemas.openxmlformats.org/drawingml/2006/main">
               <a:ext uri="{FF2B5EF4-FFF2-40B4-BE49-F238E27FC236}">
-                <a16:creationId xmlns:a16="http://schemas.microsoft.com/office/drawing/2014/main" id="{18765649-DEE6-4E2B-AE9C-37A0E854AFF4}"/>
+                <a16:creationId xmlns:a16="http://schemas.microsoft.com/office/drawing/2014/main" id="{725A4AE7-432F-4879-BD84-C23B50780519}"/>
               </a:ext>
             </a:extLst>
           </p:cNvPr>
@@ -9468,7 +9468,7 @@
           <p:cNvPr id="29" name="">
             <a:extLst xmlns:a="http://schemas.openxmlformats.org/drawingml/2006/main">
               <a:ext uri="{FF2B5EF4-FFF2-40B4-BE49-F238E27FC236}">
-                <a16:creationId xmlns:a16="http://schemas.microsoft.com/office/drawing/2014/main" id="{64ECAF9D-2393-43AA-B65E-9188048B5A43}"/>
+                <a16:creationId xmlns:a16="http://schemas.microsoft.com/office/drawing/2014/main" id="{9F618984-37C2-4103-AB15-6EF1B291E3AC}"/>
               </a:ext>
             </a:extLst>
           </p:cNvPr>
@@ -9548,7 +9548,7 @@
           <p:cNvPr id="30" name="">
             <a:extLst xmlns:a="http://schemas.openxmlformats.org/drawingml/2006/main">
               <a:ext uri="{FF2B5EF4-FFF2-40B4-BE49-F238E27FC236}">
-                <a16:creationId xmlns:a16="http://schemas.microsoft.com/office/drawing/2014/main" id="{C841328C-8954-4D0A-A68A-999656C2680F}"/>
+                <a16:creationId xmlns:a16="http://schemas.microsoft.com/office/drawing/2014/main" id="{FCB3D807-88A2-4857-9FD8-44175D50331D}"/>
               </a:ext>
             </a:extLst>
           </p:cNvPr>
@@ -9605,7 +9605,7 @@
           <p:cNvPr id="31" name="">
             <a:extLst xmlns:a="http://schemas.openxmlformats.org/drawingml/2006/main">
               <a:ext uri="{FF2B5EF4-FFF2-40B4-BE49-F238E27FC236}">
-                <a16:creationId xmlns:a16="http://schemas.microsoft.com/office/drawing/2014/main" id="{DEFB85E6-D682-4E1B-87EC-22D4D7C13EFB}"/>
+                <a16:creationId xmlns:a16="http://schemas.microsoft.com/office/drawing/2014/main" id="{701703BB-9B32-48E3-A8B2-C03223092274}"/>
               </a:ext>
             </a:extLst>
           </p:cNvPr>
@@ -9660,7 +9660,7 @@
     </p:spTree>
     <p:extLst>
       <p:ext uri="{BB962C8B-B14F-4D97-AF65-F5344CB8AC3E}">
-        <p14:creationId xmlns:p14="http://schemas.microsoft.com/office/powerpoint/2010/main" val="1170045851"/>
+        <p14:creationId xmlns:p14="http://schemas.microsoft.com/office/powerpoint/2010/main" val="522298994"/>
       </p:ext>
     </p:extLst>
   </p:cSld>
@@ -9691,7 +9691,7 @@
           <p:cNvPr id="36" name="">
             <a:extLst xmlns:a="http://schemas.openxmlformats.org/drawingml/2006/main">
               <a:ext uri="{FF2B5EF4-FFF2-40B4-BE49-F238E27FC236}">
-                <a16:creationId xmlns:a16="http://schemas.microsoft.com/office/drawing/2014/main" id="{19229975-A90D-4485-B99A-DD4EB8E06B20}"/>
+                <a16:creationId xmlns:a16="http://schemas.microsoft.com/office/drawing/2014/main" id="{FD526099-DB5E-4B3E-A702-75DCFC5FCA6C}"/>
               </a:ext>
             </a:extLst>
           </p:cNvPr>
@@ -9748,7 +9748,7 @@
           <p:cNvPr id="2" name="">
             <a:extLst xmlns:a="http://schemas.openxmlformats.org/drawingml/2006/main">
               <a:ext uri="{FF2B5EF4-FFF2-40B4-BE49-F238E27FC236}">
-                <a16:creationId xmlns:a16="http://schemas.microsoft.com/office/drawing/2014/main" id="{B6FEA5E1-FA5D-498C-8F65-592DF3E18479}"/>
+                <a16:creationId xmlns:a16="http://schemas.microsoft.com/office/drawing/2014/main" id="{48309B93-666E-4F4F-BFFD-96DC96C0E776}"/>
               </a:ext>
             </a:extLst>
           </p:cNvPr>
@@ -9805,7 +9805,7 @@
           <p:cNvPr id="3" name="">
             <a:extLst xmlns:a="http://schemas.openxmlformats.org/drawingml/2006/main">
               <a:ext uri="{FF2B5EF4-FFF2-40B4-BE49-F238E27FC236}">
-                <a16:creationId xmlns:a16="http://schemas.microsoft.com/office/drawing/2014/main" id="{8AF29B81-8749-4C2F-ACB3-EA142A01C761}"/>
+                <a16:creationId xmlns:a16="http://schemas.microsoft.com/office/drawing/2014/main" id="{D8B2D9DB-2C14-4182-B9A2-2BB5211D1A8C}"/>
               </a:ext>
             </a:extLst>
           </p:cNvPr>
@@ -9862,7 +9862,7 @@
           <p:cNvPr id="4" name="">
             <a:extLst xmlns:a="http://schemas.openxmlformats.org/drawingml/2006/main">
               <a:ext uri="{FF2B5EF4-FFF2-40B4-BE49-F238E27FC236}">
-                <a16:creationId xmlns:a16="http://schemas.microsoft.com/office/drawing/2014/main" id="{5E1E6626-518A-450B-BF8F-2F38233EED63}"/>
+                <a16:creationId xmlns:a16="http://schemas.microsoft.com/office/drawing/2014/main" id="{B8AB8183-C827-4E10-9403-5C795F1035C0}"/>
               </a:ext>
             </a:extLst>
           </p:cNvPr>
@@ -9893,7 +9893,7 @@
           <p:cNvPr id="5" name="">
             <a:extLst xmlns:a="http://schemas.openxmlformats.org/drawingml/2006/main">
               <a:ext uri="{FF2B5EF4-FFF2-40B4-BE49-F238E27FC236}">
-                <a16:creationId xmlns:a16="http://schemas.microsoft.com/office/drawing/2014/main" id="{00CFEFAE-EEAE-432A-AD99-555BC90B48B6}"/>
+                <a16:creationId xmlns:a16="http://schemas.microsoft.com/office/drawing/2014/main" id="{963BE11C-49B6-4E00-B122-9E3682D62C40}"/>
               </a:ext>
             </a:extLst>
           </p:cNvPr>
@@ -9928,7 +9928,7 @@
           <p:cNvPr id="6" name="">
             <a:extLst xmlns:a="http://schemas.openxmlformats.org/drawingml/2006/main">
               <a:ext uri="{FF2B5EF4-FFF2-40B4-BE49-F238E27FC236}">
-                <a16:creationId xmlns:a16="http://schemas.microsoft.com/office/drawing/2014/main" id="{D3697F06-8E88-4335-82C1-A93EFC36E400}"/>
+                <a16:creationId xmlns:a16="http://schemas.microsoft.com/office/drawing/2014/main" id="{D50983AA-A6B1-41B1-AE24-7F11CF73E3CF}"/>
               </a:ext>
             </a:extLst>
           </p:cNvPr>
@@ -9992,7 +9992,7 @@
           <p:cNvPr id="7" name="">
             <a:extLst xmlns:a="http://schemas.openxmlformats.org/drawingml/2006/main">
               <a:ext uri="{FF2B5EF4-FFF2-40B4-BE49-F238E27FC236}">
-                <a16:creationId xmlns:a16="http://schemas.microsoft.com/office/drawing/2014/main" id="{C5FA98CB-2D09-4A2D-95F3-ECACEDFCCC0D}"/>
+                <a16:creationId xmlns:a16="http://schemas.microsoft.com/office/drawing/2014/main" id="{EC4CC3AE-BCC1-40C8-BF19-BD8D0FF776D6}"/>
               </a:ext>
             </a:extLst>
           </p:cNvPr>
@@ -10049,7 +10049,7 @@
           <p:cNvPr id="8" name="">
             <a:extLst xmlns:a="http://schemas.openxmlformats.org/drawingml/2006/main">
               <a:ext uri="{FF2B5EF4-FFF2-40B4-BE49-F238E27FC236}">
-                <a16:creationId xmlns:a16="http://schemas.microsoft.com/office/drawing/2014/main" id="{2580FB63-9994-429F-A146-8319701ED7D7}"/>
+                <a16:creationId xmlns:a16="http://schemas.microsoft.com/office/drawing/2014/main" id="{C4A1E04C-8A1E-416D-8802-A09EE92D723F}"/>
               </a:ext>
             </a:extLst>
           </p:cNvPr>
@@ -10084,7 +10084,7 @@
           <p:cNvPr id="9" name="">
             <a:extLst xmlns:a="http://schemas.openxmlformats.org/drawingml/2006/main">
               <a:ext uri="{FF2B5EF4-FFF2-40B4-BE49-F238E27FC236}">
-                <a16:creationId xmlns:a16="http://schemas.microsoft.com/office/drawing/2014/main" id="{00BBE7C6-2C39-4588-99EE-D39143A85A36}"/>
+                <a16:creationId xmlns:a16="http://schemas.microsoft.com/office/drawing/2014/main" id="{C91236A3-C13B-40E8-A8CD-B98AD4B178BF}"/>
               </a:ext>
             </a:extLst>
           </p:cNvPr>
@@ -10148,7 +10148,7 @@
           <p:cNvPr id="10" name="">
             <a:extLst xmlns:a="http://schemas.openxmlformats.org/drawingml/2006/main">
               <a:ext uri="{FF2B5EF4-FFF2-40B4-BE49-F238E27FC236}">
-                <a16:creationId xmlns:a16="http://schemas.microsoft.com/office/drawing/2014/main" id="{B7970D32-19E7-47FC-A48A-04E84D19D7AB}"/>
+                <a16:creationId xmlns:a16="http://schemas.microsoft.com/office/drawing/2014/main" id="{D8B44550-DC7A-45A3-8DC9-D82AB2F9EAEA}"/>
               </a:ext>
             </a:extLst>
           </p:cNvPr>
@@ -10205,7 +10205,7 @@
           <p:cNvPr id="11" name="">
             <a:extLst xmlns:a="http://schemas.openxmlformats.org/drawingml/2006/main">
               <a:ext uri="{FF2B5EF4-FFF2-40B4-BE49-F238E27FC236}">
-                <a16:creationId xmlns:a16="http://schemas.microsoft.com/office/drawing/2014/main" id="{05482E71-E562-471E-A2E1-82AD4FCD14CA}"/>
+                <a16:creationId xmlns:a16="http://schemas.microsoft.com/office/drawing/2014/main" id="{2616A0FD-4214-4FBA-900A-22B1E731736E}"/>
               </a:ext>
             </a:extLst>
           </p:cNvPr>
@@ -10240,7 +10240,7 @@
           <p:cNvPr id="12" name="">
             <a:extLst xmlns:a="http://schemas.openxmlformats.org/drawingml/2006/main">
               <a:ext uri="{FF2B5EF4-FFF2-40B4-BE49-F238E27FC236}">
-                <a16:creationId xmlns:a16="http://schemas.microsoft.com/office/drawing/2014/main" id="{7300DA77-C935-40C1-8089-D847BCCFA642}"/>
+                <a16:creationId xmlns:a16="http://schemas.microsoft.com/office/drawing/2014/main" id="{D437E8F3-8E10-4FEC-80EB-EB0427EBD343}"/>
               </a:ext>
             </a:extLst>
           </p:cNvPr>
@@ -10304,7 +10304,7 @@
           <p:cNvPr id="13" name="">
             <a:extLst xmlns:a="http://schemas.openxmlformats.org/drawingml/2006/main">
               <a:ext uri="{FF2B5EF4-FFF2-40B4-BE49-F238E27FC236}">
-                <a16:creationId xmlns:a16="http://schemas.microsoft.com/office/drawing/2014/main" id="{3B91D3CB-EAC0-470F-AEFD-67C683313450}"/>
+                <a16:creationId xmlns:a16="http://schemas.microsoft.com/office/drawing/2014/main" id="{4F0B4C98-53D5-45C5-9ABA-CAAB64752AB9}"/>
               </a:ext>
             </a:extLst>
           </p:cNvPr>
@@ -10361,7 +10361,7 @@
           <p:cNvPr id="14" name="">
             <a:extLst xmlns:a="http://schemas.openxmlformats.org/drawingml/2006/main">
               <a:ext uri="{FF2B5EF4-FFF2-40B4-BE49-F238E27FC236}">
-                <a16:creationId xmlns:a16="http://schemas.microsoft.com/office/drawing/2014/main" id="{C7069C11-B264-4A84-AFCC-8FC9E86E5639}"/>
+                <a16:creationId xmlns:a16="http://schemas.microsoft.com/office/drawing/2014/main" id="{494D83B3-0216-4981-BA3E-4E3400C39976}"/>
               </a:ext>
             </a:extLst>
           </p:cNvPr>
@@ -10396,7 +10396,7 @@
           <p:cNvPr id="15" name="">
             <a:extLst xmlns:a="http://schemas.openxmlformats.org/drawingml/2006/main">
               <a:ext uri="{FF2B5EF4-FFF2-40B4-BE49-F238E27FC236}">
-                <a16:creationId xmlns:a16="http://schemas.microsoft.com/office/drawing/2014/main" id="{B8D5AF0D-9D01-471F-BC6D-3A9BFF6FC347}"/>
+                <a16:creationId xmlns:a16="http://schemas.microsoft.com/office/drawing/2014/main" id="{262FCEEA-50D7-4960-AB48-3B2299C962C1}"/>
               </a:ext>
             </a:extLst>
           </p:cNvPr>
@@ -10460,7 +10460,7 @@
           <p:cNvPr id="16" name="">
             <a:extLst xmlns:a="http://schemas.openxmlformats.org/drawingml/2006/main">
               <a:ext uri="{FF2B5EF4-FFF2-40B4-BE49-F238E27FC236}">
-                <a16:creationId xmlns:a16="http://schemas.microsoft.com/office/drawing/2014/main" id="{2C196AF3-A7D0-4CD6-91CF-8B01772F635D}"/>
+                <a16:creationId xmlns:a16="http://schemas.microsoft.com/office/drawing/2014/main" id="{98EB26B3-2348-46BB-A4D9-2000D7885FE0}"/>
               </a:ext>
             </a:extLst>
           </p:cNvPr>
@@ -10517,7 +10517,7 @@
           <p:cNvPr id="17" name="">
             <a:extLst xmlns:a="http://schemas.openxmlformats.org/drawingml/2006/main">
               <a:ext uri="{FF2B5EF4-FFF2-40B4-BE49-F238E27FC236}">
-                <a16:creationId xmlns:a16="http://schemas.microsoft.com/office/drawing/2014/main" id="{CB8A44D8-F6BE-4C5E-B35B-CAD918C17B4C}"/>
+                <a16:creationId xmlns:a16="http://schemas.microsoft.com/office/drawing/2014/main" id="{1DF23C6B-38BF-4CEF-AA96-7C95197787FD}"/>
               </a:ext>
             </a:extLst>
           </p:cNvPr>
@@ -10552,7 +10552,7 @@
           <p:cNvPr id="18" name="">
             <a:extLst xmlns:a="http://schemas.openxmlformats.org/drawingml/2006/main">
               <a:ext uri="{FF2B5EF4-FFF2-40B4-BE49-F238E27FC236}">
-                <a16:creationId xmlns:a16="http://schemas.microsoft.com/office/drawing/2014/main" id="{A79255FC-CCE0-4495-BFAE-7556A4601AAF}"/>
+                <a16:creationId xmlns:a16="http://schemas.microsoft.com/office/drawing/2014/main" id="{1781CC5E-E8B0-44F4-B369-5447F00046AD}"/>
               </a:ext>
             </a:extLst>
           </p:cNvPr>
@@ -10616,7 +10616,7 @@
           <p:cNvPr id="19" name="">
             <a:extLst xmlns:a="http://schemas.openxmlformats.org/drawingml/2006/main">
               <a:ext uri="{FF2B5EF4-FFF2-40B4-BE49-F238E27FC236}">
-                <a16:creationId xmlns:a16="http://schemas.microsoft.com/office/drawing/2014/main" id="{3BEAA53B-4C81-4DD3-AAF0-C9A576608F7C}"/>
+                <a16:creationId xmlns:a16="http://schemas.microsoft.com/office/drawing/2014/main" id="{6A08E6D9-3FCD-4259-BCBD-9B79DDFBCC49}"/>
               </a:ext>
             </a:extLst>
           </p:cNvPr>
@@ -10673,7 +10673,7 @@
           <p:cNvPr id="20" name="">
             <a:extLst xmlns:a="http://schemas.openxmlformats.org/drawingml/2006/main">
               <a:ext uri="{FF2B5EF4-FFF2-40B4-BE49-F238E27FC236}">
-                <a16:creationId xmlns:a16="http://schemas.microsoft.com/office/drawing/2014/main" id="{D75A93FF-FCD0-4C85-805C-ED464AD9F81B}"/>
+                <a16:creationId xmlns:a16="http://schemas.microsoft.com/office/drawing/2014/main" id="{ACA68395-2EC1-4FFF-8E59-053A1C0B0FD2}"/>
               </a:ext>
             </a:extLst>
           </p:cNvPr>
@@ -10708,7 +10708,7 @@
           <p:cNvPr id="21" name="">
             <a:extLst xmlns:a="http://schemas.openxmlformats.org/drawingml/2006/main">
               <a:ext uri="{FF2B5EF4-FFF2-40B4-BE49-F238E27FC236}">
-                <a16:creationId xmlns:a16="http://schemas.microsoft.com/office/drawing/2014/main" id="{1C2C61D1-2F68-4F9B-8966-C2C1F2EF2A8A}"/>
+                <a16:creationId xmlns:a16="http://schemas.microsoft.com/office/drawing/2014/main" id="{C027C301-2F00-4B1B-AAEC-6E5A1ABFF1C6}"/>
               </a:ext>
             </a:extLst>
           </p:cNvPr>
@@ -10765,7 +10765,7 @@
           <p:cNvPr id="22" name="">
             <a:extLst xmlns:a="http://schemas.openxmlformats.org/drawingml/2006/main">
               <a:ext uri="{FF2B5EF4-FFF2-40B4-BE49-F238E27FC236}">
-                <a16:creationId xmlns:a16="http://schemas.microsoft.com/office/drawing/2014/main" id="{147B680D-46DF-4506-9058-A0BE8A8E9FEE}"/>
+                <a16:creationId xmlns:a16="http://schemas.microsoft.com/office/drawing/2014/main" id="{1B588AB4-08A0-4AF6-A697-BA7FC4F35C2F}"/>
               </a:ext>
             </a:extLst>
           </p:cNvPr>
@@ -10829,7 +10829,7 @@
           <p:cNvPr id="23" name="">
             <a:extLst xmlns:a="http://schemas.openxmlformats.org/drawingml/2006/main">
               <a:ext uri="{FF2B5EF4-FFF2-40B4-BE49-F238E27FC236}">
-                <a16:creationId xmlns:a16="http://schemas.microsoft.com/office/drawing/2014/main" id="{9BC166A3-D87A-4921-81A9-8ECC6CA25E2A}"/>
+                <a16:creationId xmlns:a16="http://schemas.microsoft.com/office/drawing/2014/main" id="{CC86ADF7-2F90-4CA5-A373-B437C1DA9383}"/>
               </a:ext>
             </a:extLst>
           </p:cNvPr>
@@ -10876,7 +10876,7 @@
                 <a:ea typeface="Arial"/>
                 <a:cs typeface="Arial"/>
               </a:rPr>
-              <a:t>Deploy SmarterASP.NET</a:t>
+              <a:t>Bỏ index.html mặc định</a:t>
             </a:r>
           </a:p>
         </p:txBody>
@@ -10886,7 +10886,7 @@
           <p:cNvPr id="24" name="">
             <a:extLst xmlns:a="http://schemas.openxmlformats.org/drawingml/2006/main">
               <a:ext uri="{FF2B5EF4-FFF2-40B4-BE49-F238E27FC236}">
-                <a16:creationId xmlns:a16="http://schemas.microsoft.com/office/drawing/2014/main" id="{4EA0EAE5-B755-4318-AEDC-00E821380DC1}"/>
+                <a16:creationId xmlns:a16="http://schemas.microsoft.com/office/drawing/2014/main" id="{FE60A925-2F94-4934-879F-323996C5A3FF}"/>
               </a:ext>
             </a:extLst>
           </p:cNvPr>
@@ -10950,7 +10950,7 @@
           <p:cNvPr id="25" name="">
             <a:extLst xmlns:a="http://schemas.openxmlformats.org/drawingml/2006/main">
               <a:ext uri="{FF2B5EF4-FFF2-40B4-BE49-F238E27FC236}">
-                <a16:creationId xmlns:a16="http://schemas.microsoft.com/office/drawing/2014/main" id="{B9FF0362-69CB-4FB7-88BF-FB895A98D902}"/>
+                <a16:creationId xmlns:a16="http://schemas.microsoft.com/office/drawing/2014/main" id="{160AD995-690C-4D45-815B-0B3E3D922130}"/>
               </a:ext>
             </a:extLst>
           </p:cNvPr>
@@ -11007,7 +11007,7 @@
           <p:cNvPr id="26" name="">
             <a:extLst xmlns:a="http://schemas.openxmlformats.org/drawingml/2006/main">
               <a:ext uri="{FF2B5EF4-FFF2-40B4-BE49-F238E27FC236}">
-                <a16:creationId xmlns:a16="http://schemas.microsoft.com/office/drawing/2014/main" id="{7220DFD3-BDD9-4B3F-BC73-919110D1F5EE}"/>
+                <a16:creationId xmlns:a16="http://schemas.microsoft.com/office/drawing/2014/main" id="{E998C01A-F98A-4E2A-8721-32975B8E58C3}"/>
               </a:ext>
             </a:extLst>
           </p:cNvPr>
@@ -11071,7 +11071,7 @@
           <p:cNvPr id="27" name="">
             <a:extLst xmlns:a="http://schemas.openxmlformats.org/drawingml/2006/main">
               <a:ext uri="{FF2B5EF4-FFF2-40B4-BE49-F238E27FC236}">
-                <a16:creationId xmlns:a16="http://schemas.microsoft.com/office/drawing/2014/main" id="{289D2016-86A1-4964-9A16-4D5C3B9C6FB9}"/>
+                <a16:creationId xmlns:a16="http://schemas.microsoft.com/office/drawing/2014/main" id="{3DC206DC-3F96-4348-BBDD-B69FCDBC0532}"/>
               </a:ext>
             </a:extLst>
           </p:cNvPr>
@@ -11128,7 +11128,7 @@
           <p:cNvPr id="28" name="">
             <a:extLst xmlns:a="http://schemas.openxmlformats.org/drawingml/2006/main">
               <a:ext uri="{FF2B5EF4-FFF2-40B4-BE49-F238E27FC236}">
-                <a16:creationId xmlns:a16="http://schemas.microsoft.com/office/drawing/2014/main" id="{4D54A855-83E8-438C-887C-F1C97E4F0F6E}"/>
+                <a16:creationId xmlns:a16="http://schemas.microsoft.com/office/drawing/2014/main" id="{1388FFBE-7FC2-4146-BC5E-9A454CDB29FA}"/>
               </a:ext>
             </a:extLst>
           </p:cNvPr>
@@ -11192,7 +11192,7 @@
           <p:cNvPr id="29" name="">
             <a:extLst xmlns:a="http://schemas.openxmlformats.org/drawingml/2006/main">
               <a:ext uri="{FF2B5EF4-FFF2-40B4-BE49-F238E27FC236}">
-                <a16:creationId xmlns:a16="http://schemas.microsoft.com/office/drawing/2014/main" id="{A754A10C-2340-4330-89D8-2D5C7B344218}"/>
+                <a16:creationId xmlns:a16="http://schemas.microsoft.com/office/drawing/2014/main" id="{F5554AA1-E385-41DD-8F5A-3B28DD26C157}"/>
               </a:ext>
             </a:extLst>
           </p:cNvPr>
@@ -11239,7 +11239,7 @@
                 <a:ea typeface="Arial"/>
                 <a:cs typeface="Arial"/>
               </a:rPr>
-              <a:t>Điền Live URL đồng nhất</a:t>
+              <a:t>Gắn link video vào form</a:t>
             </a:r>
           </a:p>
         </p:txBody>
@@ -11249,7 +11249,7 @@
           <p:cNvPr id="30" name="">
             <a:extLst xmlns:a="http://schemas.openxmlformats.org/drawingml/2006/main">
               <a:ext uri="{FF2B5EF4-FFF2-40B4-BE49-F238E27FC236}">
-                <a16:creationId xmlns:a16="http://schemas.microsoft.com/office/drawing/2014/main" id="{E7B49A8F-53CF-4E42-A848-25C2DAA2C99D}"/>
+                <a16:creationId xmlns:a16="http://schemas.microsoft.com/office/drawing/2014/main" id="{52B553E7-221D-4AE2-A6AE-956E9E0DAB85}"/>
               </a:ext>
             </a:extLst>
           </p:cNvPr>
@@ -11284,7 +11284,7 @@
           <p:cNvPr id="31" name="">
             <a:extLst xmlns:a="http://schemas.openxmlformats.org/drawingml/2006/main">
               <a:ext uri="{FF2B5EF4-FFF2-40B4-BE49-F238E27FC236}">
-                <a16:creationId xmlns:a16="http://schemas.microsoft.com/office/drawing/2014/main" id="{46B7648F-3C49-4EB5-99D4-8B826D3C14CD}"/>
+                <a16:creationId xmlns:a16="http://schemas.microsoft.com/office/drawing/2014/main" id="{3738278F-DFBB-4C35-BEED-EA1AA93E8586}"/>
               </a:ext>
             </a:extLst>
           </p:cNvPr>
@@ -11341,7 +11341,7 @@
           <p:cNvPr id="32" name="">
             <a:extLst xmlns:a="http://schemas.openxmlformats.org/drawingml/2006/main">
               <a:ext uri="{FF2B5EF4-FFF2-40B4-BE49-F238E27FC236}">
-                <a16:creationId xmlns:a16="http://schemas.microsoft.com/office/drawing/2014/main" id="{190619B5-384F-4FB5-992E-CED4842E0DE2}"/>
+                <a16:creationId xmlns:a16="http://schemas.microsoft.com/office/drawing/2014/main" id="{148FCED5-CE36-4A64-A95A-5B325797314A}"/>
               </a:ext>
             </a:extLst>
           </p:cNvPr>
@@ -11444,7 +11444,7 @@
           <p:cNvPr id="33" name="">
             <a:extLst xmlns:a="http://schemas.openxmlformats.org/drawingml/2006/main">
               <a:ext uri="{FF2B5EF4-FFF2-40B4-BE49-F238E27FC236}">
-                <a16:creationId xmlns:a16="http://schemas.microsoft.com/office/drawing/2014/main" id="{9ECB10C5-86A4-4312-9526-9A1B941C0D82}"/>
+                <a16:creationId xmlns:a16="http://schemas.microsoft.com/office/drawing/2014/main" id="{7FA73D5B-BB5C-42F4-B266-140CE3AB7DC5}"/>
               </a:ext>
             </a:extLst>
           </p:cNvPr>
@@ -11501,7 +11501,7 @@
           <p:cNvPr id="34" name="">
             <a:extLst xmlns:a="http://schemas.openxmlformats.org/drawingml/2006/main">
               <a:ext uri="{FF2B5EF4-FFF2-40B4-BE49-F238E27FC236}">
-                <a16:creationId xmlns:a16="http://schemas.microsoft.com/office/drawing/2014/main" id="{B539372D-E9E4-4A4D-844D-AF03B8645053}"/>
+                <a16:creationId xmlns:a16="http://schemas.microsoft.com/office/drawing/2014/main" id="{3B402C1C-2931-43B2-8C4E-EAA7D80B033E}"/>
               </a:ext>
             </a:extLst>
           </p:cNvPr>
@@ -11558,7 +11558,7 @@
           <p:cNvPr id="35" name="">
             <a:extLst xmlns:a="http://schemas.openxmlformats.org/drawingml/2006/main">
               <a:ext uri="{FF2B5EF4-FFF2-40B4-BE49-F238E27FC236}">
-                <a16:creationId xmlns:a16="http://schemas.microsoft.com/office/drawing/2014/main" id="{31E4C119-D9E4-449F-826E-BF2422CBDA8F}"/>
+                <a16:creationId xmlns:a16="http://schemas.microsoft.com/office/drawing/2014/main" id="{05C65A85-F475-426E-BAB9-0F0E60C88059}"/>
               </a:ext>
             </a:extLst>
           </p:cNvPr>
@@ -11613,7 +11613,7 @@
     </p:spTree>
     <p:extLst>
       <p:ext uri="{BB962C8B-B14F-4D97-AF65-F5344CB8AC3E}">
-        <p14:creationId xmlns:p14="http://schemas.microsoft.com/office/powerpoint/2010/main" val="1010770920"/>
+        <p14:creationId xmlns:p14="http://schemas.microsoft.com/office/powerpoint/2010/main" val="2092116023"/>
       </p:ext>
     </p:extLst>
   </p:cSld>

</xml_diff>

<commit_message>
docs: align architecture and submission status
</commit_message>
<xml_diff>
--- a/AURA/submission/AURA_5_SLIDES.pptx
+++ b/AURA/submission/AURA_5_SLIDES.pptx
@@ -2,17 +2,17 @@
 <file path=ppt/presentation.xml><?xml version="1.0" encoding="utf-8"?>
 <p:presentation xmlns:p="http://schemas.openxmlformats.org/presentationml/2006/main">
   <p:sldMasterIdLst>
-    <p:sldMasterId xmlns:r="http://schemas.openxmlformats.org/officeDocument/2006/relationships" id="2147483648" r:id="R071aec8b097d4300"/>
+    <p:sldMasterId xmlns:r="http://schemas.openxmlformats.org/officeDocument/2006/relationships" id="2147483648" r:id="R9aa742d8292642fd"/>
   </p:sldMasterIdLst>
   <p:notesMasterIdLst>
-    <p:notesMasterId xmlns:r="http://schemas.openxmlformats.org/officeDocument/2006/relationships" r:id="Re2851056bd974a0f"/>
+    <p:notesMasterId xmlns:r="http://schemas.openxmlformats.org/officeDocument/2006/relationships" r:id="R64cc69ad1bfc401d"/>
   </p:notesMasterIdLst>
   <p:sldIdLst>
-    <p:sldId xmlns:r="http://schemas.openxmlformats.org/officeDocument/2006/relationships" id="256" r:id="Rf83dc657b8c14bbc"/>
-    <p:sldId xmlns:r="http://schemas.openxmlformats.org/officeDocument/2006/relationships" id="257" r:id="Rd045088fbc2c410b"/>
-    <p:sldId xmlns:r="http://schemas.openxmlformats.org/officeDocument/2006/relationships" id="258" r:id="R6de6dc70e9dc41c2"/>
-    <p:sldId xmlns:r="http://schemas.openxmlformats.org/officeDocument/2006/relationships" id="259" r:id="R10e8c09a60df422a"/>
-    <p:sldId xmlns:r="http://schemas.openxmlformats.org/officeDocument/2006/relationships" id="260" r:id="Rfcfe875cf0564600"/>
+    <p:sldId xmlns:r="http://schemas.openxmlformats.org/officeDocument/2006/relationships" id="256" r:id="R8d58b26c3ea14173"/>
+    <p:sldId xmlns:r="http://schemas.openxmlformats.org/officeDocument/2006/relationships" id="257" r:id="R967f463ccb154d17"/>
+    <p:sldId xmlns:r="http://schemas.openxmlformats.org/officeDocument/2006/relationships" id="258" r:id="Rf6af5872248a4499"/>
+    <p:sldId xmlns:r="http://schemas.openxmlformats.org/officeDocument/2006/relationships" id="259" r:id="R96a9de3006944746"/>
+    <p:sldId xmlns:r="http://schemas.openxmlformats.org/officeDocument/2006/relationships" id="260" r:id="R7ba59433a4214c14"/>
   </p:sldIdLst>
   <p:sldSz cx="12192000" cy="6858000"/>
   <p:notesSz cx="6858000" cy="9144000"/>
@@ -794,7 +794,7 @@
   </p:cSld>
   <p:clrMap bg1="lt1" tx1="dk1" bg2="lt2" tx2="dk2" accent1="accent1" accent2="accent2" accent3="accent3" accent4="accent4" accent5="accent5" accent6="accent6" hlink="hlink" folHlink="folHlink"/>
   <p:sldLayoutIdLst>
-    <p:sldLayoutId xmlns:r="http://schemas.openxmlformats.org/officeDocument/2006/relationships" id="2147483649" r:id="R7c68d5a9498c4521"/>
+    <p:sldLayoutId xmlns:r="http://schemas.openxmlformats.org/officeDocument/2006/relationships" id="2147483649" r:id="R8f26aa32d54e4813"/>
   </p:sldLayoutIdLst>
   <p:txStyles>
     <p:titleStyle>
@@ -1345,7 +1345,7 @@
           <p:cNvPr id="47" name="">
             <a:extLst xmlns:a="http://schemas.openxmlformats.org/drawingml/2006/main">
               <a:ext uri="{FF2B5EF4-FFF2-40B4-BE49-F238E27FC236}">
-                <a16:creationId xmlns:a16="http://schemas.microsoft.com/office/drawing/2014/main" id="{A88CBA9E-96C5-4564-BF9F-2844F60735AC}"/>
+                <a16:creationId xmlns:a16="http://schemas.microsoft.com/office/drawing/2014/main" id="{CC727313-801F-4D4C-8D2D-C71D1D675E7B}"/>
               </a:ext>
             </a:extLst>
           </p:cNvPr>
@@ -1402,7 +1402,7 @@
           <p:cNvPr id="2" name="">
             <a:extLst xmlns:a="http://schemas.openxmlformats.org/drawingml/2006/main">
               <a:ext uri="{FF2B5EF4-FFF2-40B4-BE49-F238E27FC236}">
-                <a16:creationId xmlns:a16="http://schemas.microsoft.com/office/drawing/2014/main" id="{6EFA54AD-F8DF-42A1-99C6-710D5553D8C9}"/>
+                <a16:creationId xmlns:a16="http://schemas.microsoft.com/office/drawing/2014/main" id="{0E8AAAF3-6FBA-47D1-86EC-77B05DFB9CA4}"/>
               </a:ext>
             </a:extLst>
           </p:cNvPr>
@@ -1459,7 +1459,7 @@
           <p:cNvPr id="3" name="">
             <a:extLst xmlns:a="http://schemas.openxmlformats.org/drawingml/2006/main">
               <a:ext uri="{FF2B5EF4-FFF2-40B4-BE49-F238E27FC236}">
-                <a16:creationId xmlns:a16="http://schemas.microsoft.com/office/drawing/2014/main" id="{6A416F94-E7C7-41CC-98EC-86F9D2B95DC0}"/>
+                <a16:creationId xmlns:a16="http://schemas.microsoft.com/office/drawing/2014/main" id="{86A881C0-4901-40B9-8A42-8893DD601C0D}"/>
               </a:ext>
             </a:extLst>
           </p:cNvPr>
@@ -1516,7 +1516,7 @@
           <p:cNvPr id="4" name="">
             <a:extLst xmlns:a="http://schemas.openxmlformats.org/drawingml/2006/main">
               <a:ext uri="{FF2B5EF4-FFF2-40B4-BE49-F238E27FC236}">
-                <a16:creationId xmlns:a16="http://schemas.microsoft.com/office/drawing/2014/main" id="{A27F8163-7D08-4A0C-A61B-55DDDE47D5D2}"/>
+                <a16:creationId xmlns:a16="http://schemas.microsoft.com/office/drawing/2014/main" id="{E6EAFFD0-3C7B-4657-AC9C-45675CC3957D}"/>
               </a:ext>
             </a:extLst>
           </p:cNvPr>
@@ -1547,7 +1547,7 @@
           <p:cNvPr id="5" name="">
             <a:extLst xmlns:a="http://schemas.openxmlformats.org/drawingml/2006/main">
               <a:ext uri="{FF2B5EF4-FFF2-40B4-BE49-F238E27FC236}">
-                <a16:creationId xmlns:a16="http://schemas.microsoft.com/office/drawing/2014/main" id="{48456616-8DC5-4DAA-85A7-503B20C513A0}"/>
+                <a16:creationId xmlns:a16="http://schemas.microsoft.com/office/drawing/2014/main" id="{7BCCBCE0-7EFA-4305-8B31-DC7F991404E1}"/>
               </a:ext>
             </a:extLst>
           </p:cNvPr>
@@ -1582,7 +1582,7 @@
           <p:cNvPr id="6" name="">
             <a:extLst xmlns:a="http://schemas.openxmlformats.org/drawingml/2006/main">
               <a:ext uri="{FF2B5EF4-FFF2-40B4-BE49-F238E27FC236}">
-                <a16:creationId xmlns:a16="http://schemas.microsoft.com/office/drawing/2014/main" id="{B05694E2-73A5-406F-86DE-192155054AE4}"/>
+                <a16:creationId xmlns:a16="http://schemas.microsoft.com/office/drawing/2014/main" id="{7881B686-FF36-401A-9AA6-7A54C8B5BB1F}"/>
               </a:ext>
             </a:extLst>
           </p:cNvPr>
@@ -1646,7 +1646,7 @@
           <p:cNvPr id="7" name="">
             <a:extLst xmlns:a="http://schemas.openxmlformats.org/drawingml/2006/main">
               <a:ext uri="{FF2B5EF4-FFF2-40B4-BE49-F238E27FC236}">
-                <a16:creationId xmlns:a16="http://schemas.microsoft.com/office/drawing/2014/main" id="{C820F5BB-A106-43AC-B8E3-4F906F94C0E5}"/>
+                <a16:creationId xmlns:a16="http://schemas.microsoft.com/office/drawing/2014/main" id="{4E48C246-5046-49AF-903E-C47A89451A56}"/>
               </a:ext>
             </a:extLst>
           </p:cNvPr>
@@ -1703,7 +1703,7 @@
           <p:cNvPr id="8" name="">
             <a:extLst xmlns:a="http://schemas.openxmlformats.org/drawingml/2006/main">
               <a:ext uri="{FF2B5EF4-FFF2-40B4-BE49-F238E27FC236}">
-                <a16:creationId xmlns:a16="http://schemas.microsoft.com/office/drawing/2014/main" id="{539BD992-04E5-4499-B1AB-602CCABB30B9}"/>
+                <a16:creationId xmlns:a16="http://schemas.microsoft.com/office/drawing/2014/main" id="{13494BB4-FB75-45C8-9F2A-595C121A59C5}"/>
               </a:ext>
             </a:extLst>
           </p:cNvPr>
@@ -1760,7 +1760,7 @@
           <p:cNvPr id="9" name="">
             <a:extLst xmlns:a="http://schemas.openxmlformats.org/drawingml/2006/main">
               <a:ext uri="{FF2B5EF4-FFF2-40B4-BE49-F238E27FC236}">
-                <a16:creationId xmlns:a16="http://schemas.microsoft.com/office/drawing/2014/main" id="{C941F671-08AD-4931-8F46-CE2504A469FA}"/>
+                <a16:creationId xmlns:a16="http://schemas.microsoft.com/office/drawing/2014/main" id="{C6FE9419-7B99-44E6-BD31-A5D93A1C4798}"/>
               </a:ext>
             </a:extLst>
           </p:cNvPr>
@@ -1792,7 +1792,7 @@
           <p:cNvPr id="10" name="">
             <a:extLst xmlns:a="http://schemas.openxmlformats.org/drawingml/2006/main">
               <a:ext uri="{FF2B5EF4-FFF2-40B4-BE49-F238E27FC236}">
-                <a16:creationId xmlns:a16="http://schemas.microsoft.com/office/drawing/2014/main" id="{AF0A70C7-B4D3-41CD-8015-08C6ADFDA4A5}"/>
+                <a16:creationId xmlns:a16="http://schemas.microsoft.com/office/drawing/2014/main" id="{69D8843A-DD8E-4DB5-B167-D4B1F6360FA3}"/>
               </a:ext>
             </a:extLst>
           </p:cNvPr>
@@ -1827,7 +1827,7 @@
           <p:cNvPr id="11" name="">
             <a:extLst xmlns:a="http://schemas.openxmlformats.org/drawingml/2006/main">
               <a:ext uri="{FF2B5EF4-FFF2-40B4-BE49-F238E27FC236}">
-                <a16:creationId xmlns:a16="http://schemas.microsoft.com/office/drawing/2014/main" id="{266C3A5D-F5F5-4296-9D03-C6E54C144E08}"/>
+                <a16:creationId xmlns:a16="http://schemas.microsoft.com/office/drawing/2014/main" id="{E794F6DB-25F3-4E03-9167-5CDF3D3A276E}"/>
               </a:ext>
             </a:extLst>
           </p:cNvPr>
@@ -1891,7 +1891,7 @@
           <p:cNvPr id="12" name="">
             <a:extLst xmlns:a="http://schemas.openxmlformats.org/drawingml/2006/main">
               <a:ext uri="{FF2B5EF4-FFF2-40B4-BE49-F238E27FC236}">
-                <a16:creationId xmlns:a16="http://schemas.microsoft.com/office/drawing/2014/main" id="{82C1D787-5E79-4AC3-B71F-61B80F27471E}"/>
+                <a16:creationId xmlns:a16="http://schemas.microsoft.com/office/drawing/2014/main" id="{26C2043A-78FA-4D92-8F1C-A2A645CD91C1}"/>
               </a:ext>
             </a:extLst>
           </p:cNvPr>
@@ -1948,7 +1948,7 @@
           <p:cNvPr id="13" name="">
             <a:extLst xmlns:a="http://schemas.openxmlformats.org/drawingml/2006/main">
               <a:ext uri="{FF2B5EF4-FFF2-40B4-BE49-F238E27FC236}">
-                <a16:creationId xmlns:a16="http://schemas.microsoft.com/office/drawing/2014/main" id="{E1AA79E2-FFE8-4A2F-A206-3CCD9DD51958}"/>
+                <a16:creationId xmlns:a16="http://schemas.microsoft.com/office/drawing/2014/main" id="{8F0AC78A-1904-46EE-8A9C-8B2F06720840}"/>
               </a:ext>
             </a:extLst>
           </p:cNvPr>
@@ -2005,7 +2005,7 @@
           <p:cNvPr id="14" name="">
             <a:extLst xmlns:a="http://schemas.openxmlformats.org/drawingml/2006/main">
               <a:ext uri="{FF2B5EF4-FFF2-40B4-BE49-F238E27FC236}">
-                <a16:creationId xmlns:a16="http://schemas.microsoft.com/office/drawing/2014/main" id="{462A084C-552C-439A-818D-E079E61B48B9}"/>
+                <a16:creationId xmlns:a16="http://schemas.microsoft.com/office/drawing/2014/main" id="{0E7AA31E-1E85-493F-B281-CF48893B5647}"/>
               </a:ext>
             </a:extLst>
           </p:cNvPr>
@@ -2037,7 +2037,7 @@
           <p:cNvPr id="15" name="">
             <a:extLst xmlns:a="http://schemas.openxmlformats.org/drawingml/2006/main">
               <a:ext uri="{FF2B5EF4-FFF2-40B4-BE49-F238E27FC236}">
-                <a16:creationId xmlns:a16="http://schemas.microsoft.com/office/drawing/2014/main" id="{F1D898FC-525F-4612-AB17-8610CAFEAEEF}"/>
+                <a16:creationId xmlns:a16="http://schemas.microsoft.com/office/drawing/2014/main" id="{54483989-B2A4-4600-A2EA-43A73406AE58}"/>
               </a:ext>
             </a:extLst>
           </p:cNvPr>
@@ -2072,7 +2072,7 @@
           <p:cNvPr id="16" name="">
             <a:extLst xmlns:a="http://schemas.openxmlformats.org/drawingml/2006/main">
               <a:ext uri="{FF2B5EF4-FFF2-40B4-BE49-F238E27FC236}">
-                <a16:creationId xmlns:a16="http://schemas.microsoft.com/office/drawing/2014/main" id="{B86EE4C8-9F13-4714-A693-22DEC359E4E9}"/>
+                <a16:creationId xmlns:a16="http://schemas.microsoft.com/office/drawing/2014/main" id="{D8DE1A81-36DD-4DFC-B5E8-BCF7D311D4E6}"/>
               </a:ext>
             </a:extLst>
           </p:cNvPr>
@@ -2136,7 +2136,7 @@
           <p:cNvPr id="17" name="">
             <a:extLst xmlns:a="http://schemas.openxmlformats.org/drawingml/2006/main">
               <a:ext uri="{FF2B5EF4-FFF2-40B4-BE49-F238E27FC236}">
-                <a16:creationId xmlns:a16="http://schemas.microsoft.com/office/drawing/2014/main" id="{23715A34-B7AD-49AD-80AB-4CE51C268EDB}"/>
+                <a16:creationId xmlns:a16="http://schemas.microsoft.com/office/drawing/2014/main" id="{2FFFF75C-4F5E-44D3-936C-5A8AC6B16186}"/>
               </a:ext>
             </a:extLst>
           </p:cNvPr>
@@ -2193,7 +2193,7 @@
           <p:cNvPr id="18" name="">
             <a:extLst xmlns:a="http://schemas.openxmlformats.org/drawingml/2006/main">
               <a:ext uri="{FF2B5EF4-FFF2-40B4-BE49-F238E27FC236}">
-                <a16:creationId xmlns:a16="http://schemas.microsoft.com/office/drawing/2014/main" id="{C2C6059B-8218-4B43-8652-C7284BB25172}"/>
+                <a16:creationId xmlns:a16="http://schemas.microsoft.com/office/drawing/2014/main" id="{15EF5A83-7F11-495F-8E85-5FE6DDC6F1AD}"/>
               </a:ext>
             </a:extLst>
           </p:cNvPr>
@@ -2250,7 +2250,7 @@
           <p:cNvPr id="19" name="">
             <a:extLst xmlns:a="http://schemas.openxmlformats.org/drawingml/2006/main">
               <a:ext uri="{FF2B5EF4-FFF2-40B4-BE49-F238E27FC236}">
-                <a16:creationId xmlns:a16="http://schemas.microsoft.com/office/drawing/2014/main" id="{1B51E216-5063-4C17-B545-C8DE158366F6}"/>
+                <a16:creationId xmlns:a16="http://schemas.microsoft.com/office/drawing/2014/main" id="{8FD06FB0-C586-4ABD-8B7A-7E01E465C79C}"/>
               </a:ext>
             </a:extLst>
           </p:cNvPr>
@@ -2282,7 +2282,7 @@
           <p:cNvPr id="20" name="">
             <a:extLst xmlns:a="http://schemas.openxmlformats.org/drawingml/2006/main">
               <a:ext uri="{FF2B5EF4-FFF2-40B4-BE49-F238E27FC236}">
-                <a16:creationId xmlns:a16="http://schemas.microsoft.com/office/drawing/2014/main" id="{FF7DDFB9-BD01-4BF4-903D-862F5EDC5547}"/>
+                <a16:creationId xmlns:a16="http://schemas.microsoft.com/office/drawing/2014/main" id="{96F07508-5904-46F1-AD70-1F9CD97292E5}"/>
               </a:ext>
             </a:extLst>
           </p:cNvPr>
@@ -2317,7 +2317,7 @@
           <p:cNvPr id="21" name="">
             <a:extLst xmlns:a="http://schemas.openxmlformats.org/drawingml/2006/main">
               <a:ext uri="{FF2B5EF4-FFF2-40B4-BE49-F238E27FC236}">
-                <a16:creationId xmlns:a16="http://schemas.microsoft.com/office/drawing/2014/main" id="{9339E4DE-30A8-4234-B30A-28D9955FCB05}"/>
+                <a16:creationId xmlns:a16="http://schemas.microsoft.com/office/drawing/2014/main" id="{D71F3925-A66F-4F23-95CE-FC22975991CA}"/>
               </a:ext>
             </a:extLst>
           </p:cNvPr>
@@ -2381,7 +2381,7 @@
           <p:cNvPr id="22" name="">
             <a:extLst xmlns:a="http://schemas.openxmlformats.org/drawingml/2006/main">
               <a:ext uri="{FF2B5EF4-FFF2-40B4-BE49-F238E27FC236}">
-                <a16:creationId xmlns:a16="http://schemas.microsoft.com/office/drawing/2014/main" id="{464D69A7-7D4D-4F09-942B-236764153FCF}"/>
+                <a16:creationId xmlns:a16="http://schemas.microsoft.com/office/drawing/2014/main" id="{97BED112-0666-4167-9C8A-99E815A1EBDB}"/>
               </a:ext>
             </a:extLst>
           </p:cNvPr>
@@ -2438,7 +2438,7 @@
           <p:cNvPr id="23" name="">
             <a:extLst xmlns:a="http://schemas.openxmlformats.org/drawingml/2006/main">
               <a:ext uri="{FF2B5EF4-FFF2-40B4-BE49-F238E27FC236}">
-                <a16:creationId xmlns:a16="http://schemas.microsoft.com/office/drawing/2014/main" id="{2B81E3D9-9557-4768-8ECC-1ABF102773E0}"/>
+                <a16:creationId xmlns:a16="http://schemas.microsoft.com/office/drawing/2014/main" id="{4367FE42-1142-4249-B754-20CDA45E1EB1}"/>
               </a:ext>
             </a:extLst>
           </p:cNvPr>
@@ -2495,7 +2495,7 @@
           <p:cNvPr id="24" name="">
             <a:extLst xmlns:a="http://schemas.openxmlformats.org/drawingml/2006/main">
               <a:ext uri="{FF2B5EF4-FFF2-40B4-BE49-F238E27FC236}">
-                <a16:creationId xmlns:a16="http://schemas.microsoft.com/office/drawing/2014/main" id="{8E958229-8BB0-4AE7-AEE1-C9AF731255E0}"/>
+                <a16:creationId xmlns:a16="http://schemas.microsoft.com/office/drawing/2014/main" id="{DFA60663-4F48-4429-9940-B7B16B77A70A}"/>
               </a:ext>
             </a:extLst>
           </p:cNvPr>
@@ -2527,7 +2527,7 @@
           <p:cNvPr id="25" name="">
             <a:extLst xmlns:a="http://schemas.openxmlformats.org/drawingml/2006/main">
               <a:ext uri="{FF2B5EF4-FFF2-40B4-BE49-F238E27FC236}">
-                <a16:creationId xmlns:a16="http://schemas.microsoft.com/office/drawing/2014/main" id="{88112003-ADC1-4683-97EB-22AB325B8833}"/>
+                <a16:creationId xmlns:a16="http://schemas.microsoft.com/office/drawing/2014/main" id="{ECB31DFA-EACE-4377-8E58-337AEC13E1D7}"/>
               </a:ext>
             </a:extLst>
           </p:cNvPr>
@@ -2562,7 +2562,7 @@
           <p:cNvPr id="26" name="">
             <a:extLst xmlns:a="http://schemas.openxmlformats.org/drawingml/2006/main">
               <a:ext uri="{FF2B5EF4-FFF2-40B4-BE49-F238E27FC236}">
-                <a16:creationId xmlns:a16="http://schemas.microsoft.com/office/drawing/2014/main" id="{CABFAC9A-AA82-454A-A78A-8B689E396D57}"/>
+                <a16:creationId xmlns:a16="http://schemas.microsoft.com/office/drawing/2014/main" id="{07931E69-D633-4CFA-9FDA-B95E3230D72D}"/>
               </a:ext>
             </a:extLst>
           </p:cNvPr>
@@ -2626,7 +2626,7 @@
           <p:cNvPr id="27" name="">
             <a:extLst xmlns:a="http://schemas.openxmlformats.org/drawingml/2006/main">
               <a:ext uri="{FF2B5EF4-FFF2-40B4-BE49-F238E27FC236}">
-                <a16:creationId xmlns:a16="http://schemas.microsoft.com/office/drawing/2014/main" id="{9957AF8C-AED2-46D0-9333-D392B0352BA6}"/>
+                <a16:creationId xmlns:a16="http://schemas.microsoft.com/office/drawing/2014/main" id="{3165E569-7508-419B-A629-3CE1EA93F6C8}"/>
               </a:ext>
             </a:extLst>
           </p:cNvPr>
@@ -2683,7 +2683,7 @@
           <p:cNvPr id="28" name="">
             <a:extLst xmlns:a="http://schemas.openxmlformats.org/drawingml/2006/main">
               <a:ext uri="{FF2B5EF4-FFF2-40B4-BE49-F238E27FC236}">
-                <a16:creationId xmlns:a16="http://schemas.microsoft.com/office/drawing/2014/main" id="{120705B4-2DBF-459F-A467-60841038A3DC}"/>
+                <a16:creationId xmlns:a16="http://schemas.microsoft.com/office/drawing/2014/main" id="{98D23DE7-045E-4F07-A33A-3A96973CFAD5}"/>
               </a:ext>
             </a:extLst>
           </p:cNvPr>
@@ -2740,7 +2740,7 @@
           <p:cNvPr id="29" name="">
             <a:extLst xmlns:a="http://schemas.openxmlformats.org/drawingml/2006/main">
               <a:ext uri="{FF2B5EF4-FFF2-40B4-BE49-F238E27FC236}">
-                <a16:creationId xmlns:a16="http://schemas.microsoft.com/office/drawing/2014/main" id="{EC6C82EA-627B-4D2B-B839-7E8C4F019B09}"/>
+                <a16:creationId xmlns:a16="http://schemas.microsoft.com/office/drawing/2014/main" id="{9F77F8A0-8809-417C-AD8E-EE2C745BD2CB}"/>
               </a:ext>
             </a:extLst>
           </p:cNvPr>
@@ -2775,7 +2775,7 @@
           <p:cNvPr id="30" name="">
             <a:extLst xmlns:a="http://schemas.openxmlformats.org/drawingml/2006/main">
               <a:ext uri="{FF2B5EF4-FFF2-40B4-BE49-F238E27FC236}">
-                <a16:creationId xmlns:a16="http://schemas.microsoft.com/office/drawing/2014/main" id="{E2D98254-FF1B-4062-BF3D-B75FE6A3E18D}"/>
+                <a16:creationId xmlns:a16="http://schemas.microsoft.com/office/drawing/2014/main" id="{80D7A79B-FD57-4D42-819D-F6F0F618688E}"/>
               </a:ext>
             </a:extLst>
           </p:cNvPr>
@@ -2832,7 +2832,7 @@
           <p:cNvPr id="31" name="">
             <a:extLst xmlns:a="http://schemas.openxmlformats.org/drawingml/2006/main">
               <a:ext uri="{FF2B5EF4-FFF2-40B4-BE49-F238E27FC236}">
-                <a16:creationId xmlns:a16="http://schemas.microsoft.com/office/drawing/2014/main" id="{90EFA0B2-8D3D-4211-AD3A-264EE16B69DF}"/>
+                <a16:creationId xmlns:a16="http://schemas.microsoft.com/office/drawing/2014/main" id="{B1485654-B7BD-42C6-B47A-45DF7F3BCE6E}"/>
               </a:ext>
             </a:extLst>
           </p:cNvPr>
@@ -2889,7 +2889,7 @@
           <p:cNvPr id="32" name="">
             <a:extLst xmlns:a="http://schemas.openxmlformats.org/drawingml/2006/main">
               <a:ext uri="{FF2B5EF4-FFF2-40B4-BE49-F238E27FC236}">
-                <a16:creationId xmlns:a16="http://schemas.microsoft.com/office/drawing/2014/main" id="{1E2173E7-9AB8-45BC-8B4A-8427EAFA8008}"/>
+                <a16:creationId xmlns:a16="http://schemas.microsoft.com/office/drawing/2014/main" id="{631F8DE2-A76B-46D4-8242-B7D8D4BBAB28}"/>
               </a:ext>
             </a:extLst>
           </p:cNvPr>
@@ -2946,7 +2946,7 @@
           <p:cNvPr id="33" name="">
             <a:extLst xmlns:a="http://schemas.openxmlformats.org/drawingml/2006/main">
               <a:ext uri="{FF2B5EF4-FFF2-40B4-BE49-F238E27FC236}">
-                <a16:creationId xmlns:a16="http://schemas.microsoft.com/office/drawing/2014/main" id="{A804198F-86C6-459C-9EFC-A74F3DDB5729}"/>
+                <a16:creationId xmlns:a16="http://schemas.microsoft.com/office/drawing/2014/main" id="{1EF3BF1B-2D04-457E-9379-4E9E6F24BC4F}"/>
               </a:ext>
             </a:extLst>
           </p:cNvPr>
@@ -2981,7 +2981,7 @@
           <p:cNvPr id="34" name="">
             <a:extLst xmlns:a="http://schemas.openxmlformats.org/drawingml/2006/main">
               <a:ext uri="{FF2B5EF4-FFF2-40B4-BE49-F238E27FC236}">
-                <a16:creationId xmlns:a16="http://schemas.microsoft.com/office/drawing/2014/main" id="{4A487A91-654B-4C91-8BEF-C259343723E6}"/>
+                <a16:creationId xmlns:a16="http://schemas.microsoft.com/office/drawing/2014/main" id="{6FB7CABE-A208-48E9-B36A-B746E58D2594}"/>
               </a:ext>
             </a:extLst>
           </p:cNvPr>
@@ -3045,7 +3045,7 @@
           <p:cNvPr id="35" name="">
             <a:extLst xmlns:a="http://schemas.openxmlformats.org/drawingml/2006/main">
               <a:ext uri="{FF2B5EF4-FFF2-40B4-BE49-F238E27FC236}">
-                <a16:creationId xmlns:a16="http://schemas.microsoft.com/office/drawing/2014/main" id="{3DAAA2E1-4CD5-46FE-9753-BCB8867A22FC}"/>
+                <a16:creationId xmlns:a16="http://schemas.microsoft.com/office/drawing/2014/main" id="{00F50DAB-7B68-46CD-880A-7F0B36740A04}"/>
               </a:ext>
             </a:extLst>
           </p:cNvPr>
@@ -3102,7 +3102,7 @@
           <p:cNvPr id="36" name="">
             <a:extLst xmlns:a="http://schemas.openxmlformats.org/drawingml/2006/main">
               <a:ext uri="{FF2B5EF4-FFF2-40B4-BE49-F238E27FC236}">
-                <a16:creationId xmlns:a16="http://schemas.microsoft.com/office/drawing/2014/main" id="{830E6761-DC2D-4448-BD37-5E6F0ABBB3ED}"/>
+                <a16:creationId xmlns:a16="http://schemas.microsoft.com/office/drawing/2014/main" id="{BFB0ADB8-58BE-4081-970C-EE25CE278F36}"/>
               </a:ext>
             </a:extLst>
           </p:cNvPr>
@@ -3159,7 +3159,7 @@
           <p:cNvPr id="37" name="">
             <a:extLst xmlns:a="http://schemas.openxmlformats.org/drawingml/2006/main">
               <a:ext uri="{FF2B5EF4-FFF2-40B4-BE49-F238E27FC236}">
-                <a16:creationId xmlns:a16="http://schemas.microsoft.com/office/drawing/2014/main" id="{F28B0612-4ABF-466A-966C-4838B0A420B1}"/>
+                <a16:creationId xmlns:a16="http://schemas.microsoft.com/office/drawing/2014/main" id="{1E82A3CF-4517-4393-9D4F-A065A70760F2}"/>
               </a:ext>
             </a:extLst>
           </p:cNvPr>
@@ -3194,7 +3194,7 @@
           <p:cNvPr id="38" name="">
             <a:extLst xmlns:a="http://schemas.openxmlformats.org/drawingml/2006/main">
               <a:ext uri="{FF2B5EF4-FFF2-40B4-BE49-F238E27FC236}">
-                <a16:creationId xmlns:a16="http://schemas.microsoft.com/office/drawing/2014/main" id="{00197C3C-2F40-4220-9919-1D6D8CC4E8AB}"/>
+                <a16:creationId xmlns:a16="http://schemas.microsoft.com/office/drawing/2014/main" id="{222A2DB8-DB5B-47EB-AEDA-83E7343D7E78}"/>
               </a:ext>
             </a:extLst>
           </p:cNvPr>
@@ -3258,7 +3258,7 @@
           <p:cNvPr id="39" name="">
             <a:extLst xmlns:a="http://schemas.openxmlformats.org/drawingml/2006/main">
               <a:ext uri="{FF2B5EF4-FFF2-40B4-BE49-F238E27FC236}">
-                <a16:creationId xmlns:a16="http://schemas.microsoft.com/office/drawing/2014/main" id="{72071476-35BB-41BB-925C-D02B058E3FFF}"/>
+                <a16:creationId xmlns:a16="http://schemas.microsoft.com/office/drawing/2014/main" id="{95DE6059-2F68-4687-8A81-39FB7CA19FA1}"/>
               </a:ext>
             </a:extLst>
           </p:cNvPr>
@@ -3315,7 +3315,7 @@
           <p:cNvPr id="40" name="">
             <a:extLst xmlns:a="http://schemas.openxmlformats.org/drawingml/2006/main">
               <a:ext uri="{FF2B5EF4-FFF2-40B4-BE49-F238E27FC236}">
-                <a16:creationId xmlns:a16="http://schemas.microsoft.com/office/drawing/2014/main" id="{0AD5652B-8B2B-4F74-A3B1-3BDF7EFE998B}"/>
+                <a16:creationId xmlns:a16="http://schemas.microsoft.com/office/drawing/2014/main" id="{C8CDF437-C58F-45B5-B610-B633FA303A6C}"/>
               </a:ext>
             </a:extLst>
           </p:cNvPr>
@@ -3372,7 +3372,7 @@
           <p:cNvPr id="41" name="">
             <a:extLst xmlns:a="http://schemas.openxmlformats.org/drawingml/2006/main">
               <a:ext uri="{FF2B5EF4-FFF2-40B4-BE49-F238E27FC236}">
-                <a16:creationId xmlns:a16="http://schemas.microsoft.com/office/drawing/2014/main" id="{3314EBFA-AAC9-45B5-8FF5-5AD09F7B7A62}"/>
+                <a16:creationId xmlns:a16="http://schemas.microsoft.com/office/drawing/2014/main" id="{3B8E4803-C35F-4BC2-A18C-E4997CEDCC65}"/>
               </a:ext>
             </a:extLst>
           </p:cNvPr>
@@ -3407,7 +3407,7 @@
           <p:cNvPr id="42" name="">
             <a:extLst xmlns:a="http://schemas.openxmlformats.org/drawingml/2006/main">
               <a:ext uri="{FF2B5EF4-FFF2-40B4-BE49-F238E27FC236}">
-                <a16:creationId xmlns:a16="http://schemas.microsoft.com/office/drawing/2014/main" id="{83EF8DB3-1F89-41EC-871E-D7AB1CB5CC8C}"/>
+                <a16:creationId xmlns:a16="http://schemas.microsoft.com/office/drawing/2014/main" id="{6828ED7E-A2BA-4597-A123-831825A8D161}"/>
               </a:ext>
             </a:extLst>
           </p:cNvPr>
@@ -3471,7 +3471,7 @@
           <p:cNvPr id="43" name="">
             <a:extLst xmlns:a="http://schemas.openxmlformats.org/drawingml/2006/main">
               <a:ext uri="{FF2B5EF4-FFF2-40B4-BE49-F238E27FC236}">
-                <a16:creationId xmlns:a16="http://schemas.microsoft.com/office/drawing/2014/main" id="{9B4877B3-6E75-4B04-8EA8-C9A6B9C5C1B7}"/>
+                <a16:creationId xmlns:a16="http://schemas.microsoft.com/office/drawing/2014/main" id="{3C975896-EDF1-4752-AB26-19168325E1D0}"/>
               </a:ext>
             </a:extLst>
           </p:cNvPr>
@@ -3528,7 +3528,7 @@
           <p:cNvPr id="44" name="">
             <a:extLst xmlns:a="http://schemas.openxmlformats.org/drawingml/2006/main">
               <a:ext uri="{FF2B5EF4-FFF2-40B4-BE49-F238E27FC236}">
-                <a16:creationId xmlns:a16="http://schemas.microsoft.com/office/drawing/2014/main" id="{B0E13C35-2CF2-4D7F-A4AE-8721AAD5C1C5}"/>
+                <a16:creationId xmlns:a16="http://schemas.microsoft.com/office/drawing/2014/main" id="{46A4AEE6-A665-4F0B-BC57-865ED30055E0}"/>
               </a:ext>
             </a:extLst>
           </p:cNvPr>
@@ -3585,7 +3585,7 @@
           <p:cNvPr id="45" name="">
             <a:extLst xmlns:a="http://schemas.openxmlformats.org/drawingml/2006/main">
               <a:ext uri="{FF2B5EF4-FFF2-40B4-BE49-F238E27FC236}">
-                <a16:creationId xmlns:a16="http://schemas.microsoft.com/office/drawing/2014/main" id="{58FA647A-523C-4C46-9A38-1AEE1506ACEA}"/>
+                <a16:creationId xmlns:a16="http://schemas.microsoft.com/office/drawing/2014/main" id="{D634B312-2911-421D-8321-F88E1BA1ADDB}"/>
               </a:ext>
             </a:extLst>
           </p:cNvPr>
@@ -3642,7 +3642,7 @@
           <p:cNvPr id="46" name="">
             <a:extLst xmlns:a="http://schemas.openxmlformats.org/drawingml/2006/main">
               <a:ext uri="{FF2B5EF4-FFF2-40B4-BE49-F238E27FC236}">
-                <a16:creationId xmlns:a16="http://schemas.microsoft.com/office/drawing/2014/main" id="{BC425CC9-63F9-494D-8842-4062DCD3F66B}"/>
+                <a16:creationId xmlns:a16="http://schemas.microsoft.com/office/drawing/2014/main" id="{7AA1CECC-40B2-41D9-B0B7-53AA4A46297B}"/>
               </a:ext>
             </a:extLst>
           </p:cNvPr>
@@ -3697,7 +3697,7 @@
     </p:spTree>
     <p:extLst>
       <p:ext uri="{BB962C8B-B14F-4D97-AF65-F5344CB8AC3E}">
-        <p14:creationId xmlns:p14="http://schemas.microsoft.com/office/powerpoint/2010/main" val="879762018"/>
+        <p14:creationId xmlns:p14="http://schemas.microsoft.com/office/powerpoint/2010/main" val="1033585041"/>
       </p:ext>
     </p:extLst>
   </p:cSld>
@@ -3728,7 +3728,7 @@
           <p:cNvPr id="46" name="">
             <a:extLst xmlns:a="http://schemas.openxmlformats.org/drawingml/2006/main">
               <a:ext uri="{FF2B5EF4-FFF2-40B4-BE49-F238E27FC236}">
-                <a16:creationId xmlns:a16="http://schemas.microsoft.com/office/drawing/2014/main" id="{2835A476-33A5-4902-8BDA-477F8B6334C1}"/>
+                <a16:creationId xmlns:a16="http://schemas.microsoft.com/office/drawing/2014/main" id="{698F2971-145B-4640-93F7-7C1BEE2F396E}"/>
               </a:ext>
             </a:extLst>
           </p:cNvPr>
@@ -3785,7 +3785,7 @@
           <p:cNvPr id="2" name="">
             <a:extLst xmlns:a="http://schemas.openxmlformats.org/drawingml/2006/main">
               <a:ext uri="{FF2B5EF4-FFF2-40B4-BE49-F238E27FC236}">
-                <a16:creationId xmlns:a16="http://schemas.microsoft.com/office/drawing/2014/main" id="{D6679593-35A3-4308-AA8D-E06C6E0ACABD}"/>
+                <a16:creationId xmlns:a16="http://schemas.microsoft.com/office/drawing/2014/main" id="{12B24CCB-7A89-4610-AE93-342A939F10CA}"/>
               </a:ext>
             </a:extLst>
           </p:cNvPr>
@@ -3842,7 +3842,7 @@
           <p:cNvPr id="3" name="">
             <a:extLst xmlns:a="http://schemas.openxmlformats.org/drawingml/2006/main">
               <a:ext uri="{FF2B5EF4-FFF2-40B4-BE49-F238E27FC236}">
-                <a16:creationId xmlns:a16="http://schemas.microsoft.com/office/drawing/2014/main" id="{9D6231C8-D9E2-457B-BD21-E5076518B816}"/>
+                <a16:creationId xmlns:a16="http://schemas.microsoft.com/office/drawing/2014/main" id="{C7802585-DF26-424B-A41A-4360D268DA66}"/>
               </a:ext>
             </a:extLst>
           </p:cNvPr>
@@ -3899,7 +3899,7 @@
           <p:cNvPr id="4" name="">
             <a:extLst xmlns:a="http://schemas.openxmlformats.org/drawingml/2006/main">
               <a:ext uri="{FF2B5EF4-FFF2-40B4-BE49-F238E27FC236}">
-                <a16:creationId xmlns:a16="http://schemas.microsoft.com/office/drawing/2014/main" id="{AD659817-B422-4375-969B-43715C22626B}"/>
+                <a16:creationId xmlns:a16="http://schemas.microsoft.com/office/drawing/2014/main" id="{2D39AC4F-3AE0-470C-9B5A-C0AACBDC45C5}"/>
               </a:ext>
             </a:extLst>
           </p:cNvPr>
@@ -3930,7 +3930,7 @@
           <p:cNvPr id="5" name="">
             <a:extLst xmlns:a="http://schemas.openxmlformats.org/drawingml/2006/main">
               <a:ext uri="{FF2B5EF4-FFF2-40B4-BE49-F238E27FC236}">
-                <a16:creationId xmlns:a16="http://schemas.microsoft.com/office/drawing/2014/main" id="{FF6E18E6-0533-41FB-9C06-C82D0767B235}"/>
+                <a16:creationId xmlns:a16="http://schemas.microsoft.com/office/drawing/2014/main" id="{8D08885A-BB31-4270-97A3-9E04EED1DE1C}"/>
               </a:ext>
             </a:extLst>
           </p:cNvPr>
@@ -3965,7 +3965,7 @@
           <p:cNvPr id="6" name="">
             <a:extLst xmlns:a="http://schemas.openxmlformats.org/drawingml/2006/main">
               <a:ext uri="{FF2B5EF4-FFF2-40B4-BE49-F238E27FC236}">
-                <a16:creationId xmlns:a16="http://schemas.microsoft.com/office/drawing/2014/main" id="{CE4D7BF3-C545-4F5F-8F52-1A2C33254470}"/>
+                <a16:creationId xmlns:a16="http://schemas.microsoft.com/office/drawing/2014/main" id="{E948CC31-044B-406B-A9A6-6AEA02582540}"/>
               </a:ext>
             </a:extLst>
           </p:cNvPr>
@@ -4029,7 +4029,7 @@
           <p:cNvPr id="7" name="">
             <a:extLst xmlns:a="http://schemas.openxmlformats.org/drawingml/2006/main">
               <a:ext uri="{FF2B5EF4-FFF2-40B4-BE49-F238E27FC236}">
-                <a16:creationId xmlns:a16="http://schemas.microsoft.com/office/drawing/2014/main" id="{A0F05F75-E1FD-41D2-998E-4D5F2E00C609}"/>
+                <a16:creationId xmlns:a16="http://schemas.microsoft.com/office/drawing/2014/main" id="{B26606FF-9E07-45A7-849A-1C5CFB9CC2CC}"/>
               </a:ext>
             </a:extLst>
           </p:cNvPr>
@@ -4086,7 +4086,7 @@
           <p:cNvPr id="8" name="">
             <a:extLst xmlns:a="http://schemas.openxmlformats.org/drawingml/2006/main">
               <a:ext uri="{FF2B5EF4-FFF2-40B4-BE49-F238E27FC236}">
-                <a16:creationId xmlns:a16="http://schemas.microsoft.com/office/drawing/2014/main" id="{F7936A12-2E6F-4D8F-B647-2E1AC03C66E8}"/>
+                <a16:creationId xmlns:a16="http://schemas.microsoft.com/office/drawing/2014/main" id="{7F3D903B-9C70-46F2-8597-E62E0EEAE1AC}"/>
               </a:ext>
             </a:extLst>
           </p:cNvPr>
@@ -4166,7 +4166,7 @@
           <p:cNvPr id="9" name="">
             <a:extLst xmlns:a="http://schemas.openxmlformats.org/drawingml/2006/main">
               <a:ext uri="{FF2B5EF4-FFF2-40B4-BE49-F238E27FC236}">
-                <a16:creationId xmlns:a16="http://schemas.microsoft.com/office/drawing/2014/main" id="{12505CF9-0B0A-4E18-9800-D89A69E52AFC}"/>
+                <a16:creationId xmlns:a16="http://schemas.microsoft.com/office/drawing/2014/main" id="{4A99666E-C86C-420D-ACB2-5452D0F5F1D5}"/>
               </a:ext>
             </a:extLst>
           </p:cNvPr>
@@ -4198,7 +4198,7 @@
           <p:cNvPr id="10" name="">
             <a:extLst xmlns:a="http://schemas.openxmlformats.org/drawingml/2006/main">
               <a:ext uri="{FF2B5EF4-FFF2-40B4-BE49-F238E27FC236}">
-                <a16:creationId xmlns:a16="http://schemas.microsoft.com/office/drawing/2014/main" id="{CF18B6BD-E819-4B09-9839-F2DA78A6F369}"/>
+                <a16:creationId xmlns:a16="http://schemas.microsoft.com/office/drawing/2014/main" id="{8942D3EE-38BF-4685-949B-92FF3E38592D}"/>
               </a:ext>
             </a:extLst>
           </p:cNvPr>
@@ -4233,7 +4233,7 @@
           <p:cNvPr id="11" name="">
             <a:extLst xmlns:a="http://schemas.openxmlformats.org/drawingml/2006/main">
               <a:ext uri="{FF2B5EF4-FFF2-40B4-BE49-F238E27FC236}">
-                <a16:creationId xmlns:a16="http://schemas.microsoft.com/office/drawing/2014/main" id="{39140974-5DC5-4C4D-9EC5-BF89DE9C63FA}"/>
+                <a16:creationId xmlns:a16="http://schemas.microsoft.com/office/drawing/2014/main" id="{62D41D16-D7DA-48E6-960D-30794A9B1924}"/>
               </a:ext>
             </a:extLst>
           </p:cNvPr>
@@ -4297,7 +4297,7 @@
           <p:cNvPr id="12" name="">
             <a:extLst xmlns:a="http://schemas.openxmlformats.org/drawingml/2006/main">
               <a:ext uri="{FF2B5EF4-FFF2-40B4-BE49-F238E27FC236}">
-                <a16:creationId xmlns:a16="http://schemas.microsoft.com/office/drawing/2014/main" id="{41D4C14B-B620-4CCE-B350-45ACE6E02AA8}"/>
+                <a16:creationId xmlns:a16="http://schemas.microsoft.com/office/drawing/2014/main" id="{85DCAC55-15F1-4848-9FE1-7584C3D6C020}"/>
               </a:ext>
             </a:extLst>
           </p:cNvPr>
@@ -4354,7 +4354,7 @@
           <p:cNvPr id="13" name="">
             <a:extLst xmlns:a="http://schemas.openxmlformats.org/drawingml/2006/main">
               <a:ext uri="{FF2B5EF4-FFF2-40B4-BE49-F238E27FC236}">
-                <a16:creationId xmlns:a16="http://schemas.microsoft.com/office/drawing/2014/main" id="{BC42B0BC-CE1E-4789-9352-685E5F2F7DE9}"/>
+                <a16:creationId xmlns:a16="http://schemas.microsoft.com/office/drawing/2014/main" id="{4A0F4A50-CA4D-4FA2-99EF-AB01D354DFB7}"/>
               </a:ext>
             </a:extLst>
           </p:cNvPr>
@@ -4434,7 +4434,7 @@
           <p:cNvPr id="14" name="">
             <a:extLst xmlns:a="http://schemas.openxmlformats.org/drawingml/2006/main">
               <a:ext uri="{FF2B5EF4-FFF2-40B4-BE49-F238E27FC236}">
-                <a16:creationId xmlns:a16="http://schemas.microsoft.com/office/drawing/2014/main" id="{1F9D51E8-BF0A-4F31-BAB8-496009B2EC1A}"/>
+                <a16:creationId xmlns:a16="http://schemas.microsoft.com/office/drawing/2014/main" id="{AE73E00C-FBC9-46BD-A9CC-407646D00EF1}"/>
               </a:ext>
             </a:extLst>
           </p:cNvPr>
@@ -4466,7 +4466,7 @@
           <p:cNvPr id="15" name="">
             <a:extLst xmlns:a="http://schemas.openxmlformats.org/drawingml/2006/main">
               <a:ext uri="{FF2B5EF4-FFF2-40B4-BE49-F238E27FC236}">
-                <a16:creationId xmlns:a16="http://schemas.microsoft.com/office/drawing/2014/main" id="{37D55863-AD1A-4872-9AD9-2C48206855EC}"/>
+                <a16:creationId xmlns:a16="http://schemas.microsoft.com/office/drawing/2014/main" id="{5C0E4481-336C-45D8-8A85-5B964597C6B8}"/>
               </a:ext>
             </a:extLst>
           </p:cNvPr>
@@ -4501,7 +4501,7 @@
           <p:cNvPr id="16" name="">
             <a:extLst xmlns:a="http://schemas.openxmlformats.org/drawingml/2006/main">
               <a:ext uri="{FF2B5EF4-FFF2-40B4-BE49-F238E27FC236}">
-                <a16:creationId xmlns:a16="http://schemas.microsoft.com/office/drawing/2014/main" id="{BF0844FC-E51A-4CC1-90B6-6A9B9120977E}"/>
+                <a16:creationId xmlns:a16="http://schemas.microsoft.com/office/drawing/2014/main" id="{B7C4802A-D2D8-465C-A198-B54617F805DA}"/>
               </a:ext>
             </a:extLst>
           </p:cNvPr>
@@ -4565,7 +4565,7 @@
           <p:cNvPr id="17" name="">
             <a:extLst xmlns:a="http://schemas.openxmlformats.org/drawingml/2006/main">
               <a:ext uri="{FF2B5EF4-FFF2-40B4-BE49-F238E27FC236}">
-                <a16:creationId xmlns:a16="http://schemas.microsoft.com/office/drawing/2014/main" id="{4ABDDA1C-1079-430B-AC4C-7CC3755E0E08}"/>
+                <a16:creationId xmlns:a16="http://schemas.microsoft.com/office/drawing/2014/main" id="{5A856FD9-32ED-45F7-94CF-EB77EBBEAF54}"/>
               </a:ext>
             </a:extLst>
           </p:cNvPr>
@@ -4622,7 +4622,7 @@
           <p:cNvPr id="18" name="">
             <a:extLst xmlns:a="http://schemas.openxmlformats.org/drawingml/2006/main">
               <a:ext uri="{FF2B5EF4-FFF2-40B4-BE49-F238E27FC236}">
-                <a16:creationId xmlns:a16="http://schemas.microsoft.com/office/drawing/2014/main" id="{0389D41C-6CB5-4293-B28C-463D517125A7}"/>
+                <a16:creationId xmlns:a16="http://schemas.microsoft.com/office/drawing/2014/main" id="{4241231F-CD4A-40E4-BA78-7607171775B6}"/>
               </a:ext>
             </a:extLst>
           </p:cNvPr>
@@ -4702,7 +4702,7 @@
           <p:cNvPr id="19" name="">
             <a:extLst xmlns:a="http://schemas.openxmlformats.org/drawingml/2006/main">
               <a:ext uri="{FF2B5EF4-FFF2-40B4-BE49-F238E27FC236}">
-                <a16:creationId xmlns:a16="http://schemas.microsoft.com/office/drawing/2014/main" id="{F15B8EFE-CDF2-4DAE-889E-637885CA66DB}"/>
+                <a16:creationId xmlns:a16="http://schemas.microsoft.com/office/drawing/2014/main" id="{61AD6EA0-BCB6-4388-93A5-3F1313BCFF7E}"/>
               </a:ext>
             </a:extLst>
           </p:cNvPr>
@@ -4734,7 +4734,7 @@
           <p:cNvPr id="20" name="">
             <a:extLst xmlns:a="http://schemas.openxmlformats.org/drawingml/2006/main">
               <a:ext uri="{FF2B5EF4-FFF2-40B4-BE49-F238E27FC236}">
-                <a16:creationId xmlns:a16="http://schemas.microsoft.com/office/drawing/2014/main" id="{860F81D0-8CED-4D60-8B1A-AA1AB871E13B}"/>
+                <a16:creationId xmlns:a16="http://schemas.microsoft.com/office/drawing/2014/main" id="{EAA3B93E-3AB1-40A1-BFD7-26B2EFBC17F0}"/>
               </a:ext>
             </a:extLst>
           </p:cNvPr>
@@ -4769,7 +4769,7 @@
           <p:cNvPr id="21" name="">
             <a:extLst xmlns:a="http://schemas.openxmlformats.org/drawingml/2006/main">
               <a:ext uri="{FF2B5EF4-FFF2-40B4-BE49-F238E27FC236}">
-                <a16:creationId xmlns:a16="http://schemas.microsoft.com/office/drawing/2014/main" id="{9F3C19CB-1961-4799-ABBC-F9725026E16C}"/>
+                <a16:creationId xmlns:a16="http://schemas.microsoft.com/office/drawing/2014/main" id="{66F273D7-749C-42D6-9E48-C54114FE2FAB}"/>
               </a:ext>
             </a:extLst>
           </p:cNvPr>
@@ -4833,7 +4833,7 @@
           <p:cNvPr id="22" name="">
             <a:extLst xmlns:a="http://schemas.openxmlformats.org/drawingml/2006/main">
               <a:ext uri="{FF2B5EF4-FFF2-40B4-BE49-F238E27FC236}">
-                <a16:creationId xmlns:a16="http://schemas.microsoft.com/office/drawing/2014/main" id="{F2A67BE1-55BF-4345-BBE3-B1CA85405A1A}"/>
+                <a16:creationId xmlns:a16="http://schemas.microsoft.com/office/drawing/2014/main" id="{22568819-14F2-4A8B-9295-31F34E45D6C1}"/>
               </a:ext>
             </a:extLst>
           </p:cNvPr>
@@ -4890,7 +4890,7 @@
           <p:cNvPr id="23" name="">
             <a:extLst xmlns:a="http://schemas.openxmlformats.org/drawingml/2006/main">
               <a:ext uri="{FF2B5EF4-FFF2-40B4-BE49-F238E27FC236}">
-                <a16:creationId xmlns:a16="http://schemas.microsoft.com/office/drawing/2014/main" id="{F905D2CE-CEB3-4E97-86FF-1FDCAE61B6DA}"/>
+                <a16:creationId xmlns:a16="http://schemas.microsoft.com/office/drawing/2014/main" id="{132E3492-150C-4CF1-9C80-DEF484DF09FB}"/>
               </a:ext>
             </a:extLst>
           </p:cNvPr>
@@ -4970,7 +4970,7 @@
           <p:cNvPr id="24" name="">
             <a:extLst xmlns:a="http://schemas.openxmlformats.org/drawingml/2006/main">
               <a:ext uri="{FF2B5EF4-FFF2-40B4-BE49-F238E27FC236}">
-                <a16:creationId xmlns:a16="http://schemas.microsoft.com/office/drawing/2014/main" id="{A80F7F4C-B509-4111-A637-8228C0C1194C}"/>
+                <a16:creationId xmlns:a16="http://schemas.microsoft.com/office/drawing/2014/main" id="{7D81DEF5-0CDF-4C86-ACBA-F85904166665}"/>
               </a:ext>
             </a:extLst>
           </p:cNvPr>
@@ -5002,7 +5002,7 @@
           <p:cNvPr id="25" name="">
             <a:extLst xmlns:a="http://schemas.openxmlformats.org/drawingml/2006/main">
               <a:ext uri="{FF2B5EF4-FFF2-40B4-BE49-F238E27FC236}">
-                <a16:creationId xmlns:a16="http://schemas.microsoft.com/office/drawing/2014/main" id="{527DD757-DB62-42F3-ABDC-A0D0B9A41527}"/>
+                <a16:creationId xmlns:a16="http://schemas.microsoft.com/office/drawing/2014/main" id="{C1785B62-2E3D-4F40-8FC6-F1A2DA5689B7}"/>
               </a:ext>
             </a:extLst>
           </p:cNvPr>
@@ -5037,7 +5037,7 @@
           <p:cNvPr id="26" name="">
             <a:extLst xmlns:a="http://schemas.openxmlformats.org/drawingml/2006/main">
               <a:ext uri="{FF2B5EF4-FFF2-40B4-BE49-F238E27FC236}">
-                <a16:creationId xmlns:a16="http://schemas.microsoft.com/office/drawing/2014/main" id="{E7634883-1D79-4878-A1AA-7BBE8CB61A93}"/>
+                <a16:creationId xmlns:a16="http://schemas.microsoft.com/office/drawing/2014/main" id="{F1C4FD62-6EEB-4890-B392-B28B06548685}"/>
               </a:ext>
             </a:extLst>
           </p:cNvPr>
@@ -5101,7 +5101,7 @@
           <p:cNvPr id="27" name="">
             <a:extLst xmlns:a="http://schemas.openxmlformats.org/drawingml/2006/main">
               <a:ext uri="{FF2B5EF4-FFF2-40B4-BE49-F238E27FC236}">
-                <a16:creationId xmlns:a16="http://schemas.microsoft.com/office/drawing/2014/main" id="{C2283A28-CA39-4F49-933A-9DB638CA1108}"/>
+                <a16:creationId xmlns:a16="http://schemas.microsoft.com/office/drawing/2014/main" id="{73FC71A3-5671-4FD9-A3A5-1F238D18412B}"/>
               </a:ext>
             </a:extLst>
           </p:cNvPr>
@@ -5158,7 +5158,7 @@
           <p:cNvPr id="28" name="">
             <a:extLst xmlns:a="http://schemas.openxmlformats.org/drawingml/2006/main">
               <a:ext uri="{FF2B5EF4-FFF2-40B4-BE49-F238E27FC236}">
-                <a16:creationId xmlns:a16="http://schemas.microsoft.com/office/drawing/2014/main" id="{977DBAB4-2874-46FA-B629-283D9B6F41E2}"/>
+                <a16:creationId xmlns:a16="http://schemas.microsoft.com/office/drawing/2014/main" id="{3A345BE2-5DC3-4AFE-B566-F9B438F87D2A}"/>
               </a:ext>
             </a:extLst>
           </p:cNvPr>
@@ -5238,7 +5238,7 @@
           <p:cNvPr id="29" name="">
             <a:extLst xmlns:a="http://schemas.openxmlformats.org/drawingml/2006/main">
               <a:ext uri="{FF2B5EF4-FFF2-40B4-BE49-F238E27FC236}">
-                <a16:creationId xmlns:a16="http://schemas.microsoft.com/office/drawing/2014/main" id="{2BF76EAA-52D4-43AD-9964-6E3991275EB8}"/>
+                <a16:creationId xmlns:a16="http://schemas.microsoft.com/office/drawing/2014/main" id="{6AD210B0-4B90-48FD-8E75-0E456DB56F02}"/>
               </a:ext>
             </a:extLst>
           </p:cNvPr>
@@ -5295,7 +5295,7 @@
           <p:cNvPr id="30" name="">
             <a:extLst xmlns:a="http://schemas.openxmlformats.org/drawingml/2006/main">
               <a:ext uri="{FF2B5EF4-FFF2-40B4-BE49-F238E27FC236}">
-                <a16:creationId xmlns:a16="http://schemas.microsoft.com/office/drawing/2014/main" id="{248D1ABC-3D5B-48F4-988C-53232556556B}"/>
+                <a16:creationId xmlns:a16="http://schemas.microsoft.com/office/drawing/2014/main" id="{BE68A039-4F1E-4093-8558-542160A44F3C}"/>
               </a:ext>
             </a:extLst>
           </p:cNvPr>
@@ -5330,7 +5330,7 @@
           <p:cNvPr id="31" name="">
             <a:extLst xmlns:a="http://schemas.openxmlformats.org/drawingml/2006/main">
               <a:ext uri="{FF2B5EF4-FFF2-40B4-BE49-F238E27FC236}">
-                <a16:creationId xmlns:a16="http://schemas.microsoft.com/office/drawing/2014/main" id="{6970CDD9-2413-4A79-B53D-4D6F05C76C2F}"/>
+                <a16:creationId xmlns:a16="http://schemas.microsoft.com/office/drawing/2014/main" id="{ACA6FECD-A0D3-4681-9E9A-D93F4EDAE7ED}"/>
               </a:ext>
             </a:extLst>
           </p:cNvPr>
@@ -5387,7 +5387,7 @@
           <p:cNvPr id="32" name="">
             <a:extLst xmlns:a="http://schemas.openxmlformats.org/drawingml/2006/main">
               <a:ext uri="{FF2B5EF4-FFF2-40B4-BE49-F238E27FC236}">
-                <a16:creationId xmlns:a16="http://schemas.microsoft.com/office/drawing/2014/main" id="{244770CF-FCE6-4F11-B408-D140730D88C8}"/>
+                <a16:creationId xmlns:a16="http://schemas.microsoft.com/office/drawing/2014/main" id="{B25FEC97-68A0-4B4D-AD53-7DDA1E75D8BC}"/>
               </a:ext>
             </a:extLst>
           </p:cNvPr>
@@ -5490,7 +5490,7 @@
           <p:cNvPr id="33" name="">
             <a:extLst xmlns:a="http://schemas.openxmlformats.org/drawingml/2006/main">
               <a:ext uri="{FF2B5EF4-FFF2-40B4-BE49-F238E27FC236}">
-                <a16:creationId xmlns:a16="http://schemas.microsoft.com/office/drawing/2014/main" id="{BEC474BA-C969-4ECD-9030-839D4708E06D}"/>
+                <a16:creationId xmlns:a16="http://schemas.microsoft.com/office/drawing/2014/main" id="{C1B26B6F-D10C-400E-BBC4-53154CC6B2D0}"/>
               </a:ext>
             </a:extLst>
           </p:cNvPr>
@@ -5554,7 +5554,7 @@
           <p:cNvPr id="34" name="">
             <a:extLst xmlns:a="http://schemas.openxmlformats.org/drawingml/2006/main">
               <a:ext uri="{FF2B5EF4-FFF2-40B4-BE49-F238E27FC236}">
-                <a16:creationId xmlns:a16="http://schemas.microsoft.com/office/drawing/2014/main" id="{6D5DA7D8-EABE-4247-8863-441F4F78A6B5}"/>
+                <a16:creationId xmlns:a16="http://schemas.microsoft.com/office/drawing/2014/main" id="{2E1ED77E-934C-41CD-BB34-5EC7A87CBD42}"/>
               </a:ext>
             </a:extLst>
           </p:cNvPr>
@@ -5611,7 +5611,7 @@
           <p:cNvPr id="35" name="">
             <a:extLst xmlns:a="http://schemas.openxmlformats.org/drawingml/2006/main">
               <a:ext uri="{FF2B5EF4-FFF2-40B4-BE49-F238E27FC236}">
-                <a16:creationId xmlns:a16="http://schemas.microsoft.com/office/drawing/2014/main" id="{E14A2DFE-918D-445E-876C-66700EC1301F}"/>
+                <a16:creationId xmlns:a16="http://schemas.microsoft.com/office/drawing/2014/main" id="{56B670F4-D8B3-407F-B641-85A6D5726A9B}"/>
               </a:ext>
             </a:extLst>
           </p:cNvPr>
@@ -5646,7 +5646,7 @@
           <p:cNvPr id="36" name="">
             <a:extLst xmlns:a="http://schemas.openxmlformats.org/drawingml/2006/main">
               <a:ext uri="{FF2B5EF4-FFF2-40B4-BE49-F238E27FC236}">
-                <a16:creationId xmlns:a16="http://schemas.microsoft.com/office/drawing/2014/main" id="{B4BCB9BA-26DD-4C71-97C3-07E36176B418}"/>
+                <a16:creationId xmlns:a16="http://schemas.microsoft.com/office/drawing/2014/main" id="{3FC2A63F-098A-46E1-8A6E-E3FC0B9F551D}"/>
               </a:ext>
             </a:extLst>
           </p:cNvPr>
@@ -5703,7 +5703,7 @@
           <p:cNvPr id="37" name="">
             <a:extLst xmlns:a="http://schemas.openxmlformats.org/drawingml/2006/main">
               <a:ext uri="{FF2B5EF4-FFF2-40B4-BE49-F238E27FC236}">
-                <a16:creationId xmlns:a16="http://schemas.microsoft.com/office/drawing/2014/main" id="{F2592463-ECDE-4FD1-A462-47922B320069}"/>
+                <a16:creationId xmlns:a16="http://schemas.microsoft.com/office/drawing/2014/main" id="{007DE927-2D71-4A2E-91C4-0858B66D0E9E}"/>
               </a:ext>
             </a:extLst>
           </p:cNvPr>
@@ -5738,7 +5738,7 @@
           <p:cNvPr id="38" name="">
             <a:extLst xmlns:a="http://schemas.openxmlformats.org/drawingml/2006/main">
               <a:ext uri="{FF2B5EF4-FFF2-40B4-BE49-F238E27FC236}">
-                <a16:creationId xmlns:a16="http://schemas.microsoft.com/office/drawing/2014/main" id="{3F6323B7-EBB5-438E-A283-03F6A5634ADC}"/>
+                <a16:creationId xmlns:a16="http://schemas.microsoft.com/office/drawing/2014/main" id="{F19594AD-50CE-422C-94EE-8D5D86771CDA}"/>
               </a:ext>
             </a:extLst>
           </p:cNvPr>
@@ -5795,7 +5795,7 @@
           <p:cNvPr id="39" name="">
             <a:extLst xmlns:a="http://schemas.openxmlformats.org/drawingml/2006/main">
               <a:ext uri="{FF2B5EF4-FFF2-40B4-BE49-F238E27FC236}">
-                <a16:creationId xmlns:a16="http://schemas.microsoft.com/office/drawing/2014/main" id="{E4E0EAB8-B38B-4E08-9A17-49AA820A4A72}"/>
+                <a16:creationId xmlns:a16="http://schemas.microsoft.com/office/drawing/2014/main" id="{7B1B54B7-25F0-40B5-838C-3D932181997D}"/>
               </a:ext>
             </a:extLst>
           </p:cNvPr>
@@ -5852,7 +5852,7 @@
           <p:cNvPr id="40" name="">
             <a:extLst xmlns:a="http://schemas.openxmlformats.org/drawingml/2006/main">
               <a:ext uri="{FF2B5EF4-FFF2-40B4-BE49-F238E27FC236}">
-                <a16:creationId xmlns:a16="http://schemas.microsoft.com/office/drawing/2014/main" id="{6FF1963C-49A6-440E-BF67-3DE063E69B8F}"/>
+                <a16:creationId xmlns:a16="http://schemas.microsoft.com/office/drawing/2014/main" id="{5E5719CB-A80C-459E-A58E-47135B79707E}"/>
               </a:ext>
             </a:extLst>
           </p:cNvPr>
@@ -5887,7 +5887,7 @@
           <p:cNvPr id="41" name="">
             <a:extLst xmlns:a="http://schemas.openxmlformats.org/drawingml/2006/main">
               <a:ext uri="{FF2B5EF4-FFF2-40B4-BE49-F238E27FC236}">
-                <a16:creationId xmlns:a16="http://schemas.microsoft.com/office/drawing/2014/main" id="{05FBCB37-E2C3-45B7-90FD-35D61990238B}"/>
+                <a16:creationId xmlns:a16="http://schemas.microsoft.com/office/drawing/2014/main" id="{6EEC7DBE-C5B7-4D8A-B124-38C15A49512A}"/>
               </a:ext>
             </a:extLst>
           </p:cNvPr>
@@ -5944,7 +5944,7 @@
           <p:cNvPr id="42" name="">
             <a:extLst xmlns:a="http://schemas.openxmlformats.org/drawingml/2006/main">
               <a:ext uri="{FF2B5EF4-FFF2-40B4-BE49-F238E27FC236}">
-                <a16:creationId xmlns:a16="http://schemas.microsoft.com/office/drawing/2014/main" id="{05B1ACE7-C706-4C25-B50B-44CA5FFE748B}"/>
+                <a16:creationId xmlns:a16="http://schemas.microsoft.com/office/drawing/2014/main" id="{DACE9A79-C774-4FD4-ABC5-178C733C84DB}"/>
               </a:ext>
             </a:extLst>
           </p:cNvPr>
@@ -6001,7 +6001,7 @@
           <p:cNvPr id="43" name="">
             <a:extLst xmlns:a="http://schemas.openxmlformats.org/drawingml/2006/main">
               <a:ext uri="{FF2B5EF4-FFF2-40B4-BE49-F238E27FC236}">
-                <a16:creationId xmlns:a16="http://schemas.microsoft.com/office/drawing/2014/main" id="{C23CD8F8-D09C-4B3B-B70B-67C60F655ED0}"/>
+                <a16:creationId xmlns:a16="http://schemas.microsoft.com/office/drawing/2014/main" id="{2BDF8B86-1F49-4EBC-B49F-DBE90E32311D}"/>
               </a:ext>
             </a:extLst>
           </p:cNvPr>
@@ -6058,7 +6058,7 @@
           <p:cNvPr id="44" name="">
             <a:extLst xmlns:a="http://schemas.openxmlformats.org/drawingml/2006/main">
               <a:ext uri="{FF2B5EF4-FFF2-40B4-BE49-F238E27FC236}">
-                <a16:creationId xmlns:a16="http://schemas.microsoft.com/office/drawing/2014/main" id="{F665DBBB-20EA-419F-9AAC-0C3DF4639E86}"/>
+                <a16:creationId xmlns:a16="http://schemas.microsoft.com/office/drawing/2014/main" id="{7FC02FA0-E2B8-410E-BD35-5642BA2A1DCC}"/>
               </a:ext>
             </a:extLst>
           </p:cNvPr>
@@ -6115,7 +6115,7 @@
           <p:cNvPr id="45" name="">
             <a:extLst xmlns:a="http://schemas.openxmlformats.org/drawingml/2006/main">
               <a:ext uri="{FF2B5EF4-FFF2-40B4-BE49-F238E27FC236}">
-                <a16:creationId xmlns:a16="http://schemas.microsoft.com/office/drawing/2014/main" id="{475C9E20-3EBD-4128-BB4E-1CE73BDE28A9}"/>
+                <a16:creationId xmlns:a16="http://schemas.microsoft.com/office/drawing/2014/main" id="{5831E741-6A23-4511-B984-7653D1842D44}"/>
               </a:ext>
             </a:extLst>
           </p:cNvPr>
@@ -6170,7 +6170,7 @@
     </p:spTree>
     <p:extLst>
       <p:ext uri="{BB962C8B-B14F-4D97-AF65-F5344CB8AC3E}">
-        <p14:creationId xmlns:p14="http://schemas.microsoft.com/office/powerpoint/2010/main" val="1499603266"/>
+        <p14:creationId xmlns:p14="http://schemas.microsoft.com/office/powerpoint/2010/main" val="1344282755"/>
       </p:ext>
     </p:extLst>
   </p:cSld>
@@ -6201,7 +6201,7 @@
           <p:cNvPr id="32" name="">
             <a:extLst xmlns:a="http://schemas.openxmlformats.org/drawingml/2006/main">
               <a:ext uri="{FF2B5EF4-FFF2-40B4-BE49-F238E27FC236}">
-                <a16:creationId xmlns:a16="http://schemas.microsoft.com/office/drawing/2014/main" id="{3578F7F1-6ACA-4371-A8C2-CB9BC9951543}"/>
+                <a16:creationId xmlns:a16="http://schemas.microsoft.com/office/drawing/2014/main" id="{C2EC4A61-C658-435A-9C7F-C06A7F3433B8}"/>
               </a:ext>
             </a:extLst>
           </p:cNvPr>
@@ -6258,7 +6258,7 @@
           <p:cNvPr id="2" name="">
             <a:extLst xmlns:a="http://schemas.openxmlformats.org/drawingml/2006/main">
               <a:ext uri="{FF2B5EF4-FFF2-40B4-BE49-F238E27FC236}">
-                <a16:creationId xmlns:a16="http://schemas.microsoft.com/office/drawing/2014/main" id="{CA2C42B8-1581-4F2F-BC8C-EFCA3A0EE281}"/>
+                <a16:creationId xmlns:a16="http://schemas.microsoft.com/office/drawing/2014/main" id="{E000CD93-FB49-4E2F-8B07-4D7620988D00}"/>
               </a:ext>
             </a:extLst>
           </p:cNvPr>
@@ -6315,7 +6315,7 @@
           <p:cNvPr id="3" name="">
             <a:extLst xmlns:a="http://schemas.openxmlformats.org/drawingml/2006/main">
               <a:ext uri="{FF2B5EF4-FFF2-40B4-BE49-F238E27FC236}">
-                <a16:creationId xmlns:a16="http://schemas.microsoft.com/office/drawing/2014/main" id="{82E0AD22-9BA9-4023-8900-3AC514461EA8}"/>
+                <a16:creationId xmlns:a16="http://schemas.microsoft.com/office/drawing/2014/main" id="{1D76307C-8F5A-4491-AE27-7B124838D507}"/>
               </a:ext>
             </a:extLst>
           </p:cNvPr>
@@ -6372,7 +6372,7 @@
           <p:cNvPr id="4" name="">
             <a:extLst xmlns:a="http://schemas.openxmlformats.org/drawingml/2006/main">
               <a:ext uri="{FF2B5EF4-FFF2-40B4-BE49-F238E27FC236}">
-                <a16:creationId xmlns:a16="http://schemas.microsoft.com/office/drawing/2014/main" id="{EAD90F79-6F8F-410A-B406-00701269EE51}"/>
+                <a16:creationId xmlns:a16="http://schemas.microsoft.com/office/drawing/2014/main" id="{B17F867A-8141-491B-AE39-2F878273EBF5}"/>
               </a:ext>
             </a:extLst>
           </p:cNvPr>
@@ -6403,7 +6403,7 @@
           <p:cNvPr id="5" name="">
             <a:extLst xmlns:a="http://schemas.openxmlformats.org/drawingml/2006/main">
               <a:ext uri="{FF2B5EF4-FFF2-40B4-BE49-F238E27FC236}">
-                <a16:creationId xmlns:a16="http://schemas.microsoft.com/office/drawing/2014/main" id="{C38AD351-ECED-4D6D-B610-6BD83076DC3D}"/>
+                <a16:creationId xmlns:a16="http://schemas.microsoft.com/office/drawing/2014/main" id="{36D24EA4-11A5-4895-A5CB-9E6E419FB08D}"/>
               </a:ext>
             </a:extLst>
           </p:cNvPr>
@@ -6438,7 +6438,7 @@
           <p:cNvPr id="6" name="">
             <a:extLst xmlns:a="http://schemas.openxmlformats.org/drawingml/2006/main">
               <a:ext uri="{FF2B5EF4-FFF2-40B4-BE49-F238E27FC236}">
-                <a16:creationId xmlns:a16="http://schemas.microsoft.com/office/drawing/2014/main" id="{26B3D9B6-1CBA-4941-B015-6EB1A60AFCAF}"/>
+                <a16:creationId xmlns:a16="http://schemas.microsoft.com/office/drawing/2014/main" id="{F96F21B7-95A2-44B2-B22D-DB691ADE0250}"/>
               </a:ext>
             </a:extLst>
           </p:cNvPr>
@@ -6502,7 +6502,7 @@
           <p:cNvPr id="7" name="">
             <a:extLst xmlns:a="http://schemas.openxmlformats.org/drawingml/2006/main">
               <a:ext uri="{FF2B5EF4-FFF2-40B4-BE49-F238E27FC236}">
-                <a16:creationId xmlns:a16="http://schemas.microsoft.com/office/drawing/2014/main" id="{0E34ABFC-540B-473E-83DA-F0893C1EABCB}"/>
+                <a16:creationId xmlns:a16="http://schemas.microsoft.com/office/drawing/2014/main" id="{59C6312D-8C24-4FC1-A4BC-114661133BEF}"/>
               </a:ext>
             </a:extLst>
           </p:cNvPr>
@@ -6559,7 +6559,7 @@
           <p:cNvPr id="8" name="">
             <a:extLst xmlns:a="http://schemas.openxmlformats.org/drawingml/2006/main">
               <a:ext uri="{FF2B5EF4-FFF2-40B4-BE49-F238E27FC236}">
-                <a16:creationId xmlns:a16="http://schemas.microsoft.com/office/drawing/2014/main" id="{C7583161-6F81-468C-9685-9F7AE999259D}"/>
+                <a16:creationId xmlns:a16="http://schemas.microsoft.com/office/drawing/2014/main" id="{E5377B5A-ACCB-4FF0-8C3D-5ADA8C3629B5}"/>
               </a:ext>
             </a:extLst>
           </p:cNvPr>
@@ -6662,7 +6662,7 @@
           <p:cNvPr id="9" name="">
             <a:extLst xmlns:a="http://schemas.openxmlformats.org/drawingml/2006/main">
               <a:ext uri="{FF2B5EF4-FFF2-40B4-BE49-F238E27FC236}">
-                <a16:creationId xmlns:a16="http://schemas.microsoft.com/office/drawing/2014/main" id="{4137CD7B-A46D-418F-A7A8-A6043F9F7EAF}"/>
+                <a16:creationId xmlns:a16="http://schemas.microsoft.com/office/drawing/2014/main" id="{AA4396D3-B875-41B2-A015-52CD6E23181B}"/>
               </a:ext>
             </a:extLst>
           </p:cNvPr>
@@ -6697,7 +6697,7 @@
           <p:cNvPr id="10" name="">
             <a:extLst xmlns:a="http://schemas.openxmlformats.org/drawingml/2006/main">
               <a:ext uri="{FF2B5EF4-FFF2-40B4-BE49-F238E27FC236}">
-                <a16:creationId xmlns:a16="http://schemas.microsoft.com/office/drawing/2014/main" id="{6C35ECAC-234D-467F-AD4F-B196988286B7}"/>
+                <a16:creationId xmlns:a16="http://schemas.microsoft.com/office/drawing/2014/main" id="{947854AC-C35D-4DB5-AAB6-177F1E798C32}"/>
               </a:ext>
             </a:extLst>
           </p:cNvPr>
@@ -6761,7 +6761,7 @@
           <p:cNvPr id="11" name="">
             <a:extLst xmlns:a="http://schemas.openxmlformats.org/drawingml/2006/main">
               <a:ext uri="{FF2B5EF4-FFF2-40B4-BE49-F238E27FC236}">
-                <a16:creationId xmlns:a16="http://schemas.microsoft.com/office/drawing/2014/main" id="{22C4C7A1-CFFD-42BD-83EA-3C6124D4508E}"/>
+                <a16:creationId xmlns:a16="http://schemas.microsoft.com/office/drawing/2014/main" id="{26EA3630-7EDA-47C5-A173-FC139650C7B4}"/>
               </a:ext>
             </a:extLst>
           </p:cNvPr>
@@ -6818,7 +6818,7 @@
           <p:cNvPr id="12" name="">
             <a:extLst xmlns:a="http://schemas.openxmlformats.org/drawingml/2006/main">
               <a:ext uri="{FF2B5EF4-FFF2-40B4-BE49-F238E27FC236}">
-                <a16:creationId xmlns:a16="http://schemas.microsoft.com/office/drawing/2014/main" id="{D8032F02-3DF5-44A5-A562-8682C7F0D792}"/>
+                <a16:creationId xmlns:a16="http://schemas.microsoft.com/office/drawing/2014/main" id="{2E0DAF43-4DED-41EF-94BE-3C41398C8A43}"/>
               </a:ext>
             </a:extLst>
           </p:cNvPr>
@@ -6921,7 +6921,7 @@
           <p:cNvPr id="13" name="">
             <a:extLst xmlns:a="http://schemas.openxmlformats.org/drawingml/2006/main">
               <a:ext uri="{FF2B5EF4-FFF2-40B4-BE49-F238E27FC236}">
-                <a16:creationId xmlns:a16="http://schemas.microsoft.com/office/drawing/2014/main" id="{5538449C-C0EA-4885-BE98-AF9843C87A61}"/>
+                <a16:creationId xmlns:a16="http://schemas.microsoft.com/office/drawing/2014/main" id="{40CB9716-4595-4847-A80D-9A2860208F9E}"/>
               </a:ext>
             </a:extLst>
           </p:cNvPr>
@@ -6978,7 +6978,7 @@
           <p:cNvPr id="14" name="">
             <a:extLst xmlns:a="http://schemas.openxmlformats.org/drawingml/2006/main">
               <a:ext uri="{FF2B5EF4-FFF2-40B4-BE49-F238E27FC236}">
-                <a16:creationId xmlns:a16="http://schemas.microsoft.com/office/drawing/2014/main" id="{7FDD3EF8-B2F3-4E27-97AC-188E99F08F91}"/>
+                <a16:creationId xmlns:a16="http://schemas.microsoft.com/office/drawing/2014/main" id="{380AC89C-DE8F-46F4-AAF7-6008DFBEF63D}"/>
               </a:ext>
             </a:extLst>
           </p:cNvPr>
@@ -7013,7 +7013,7 @@
           <p:cNvPr id="15" name="">
             <a:extLst xmlns:a="http://schemas.openxmlformats.org/drawingml/2006/main">
               <a:ext uri="{FF2B5EF4-FFF2-40B4-BE49-F238E27FC236}">
-                <a16:creationId xmlns:a16="http://schemas.microsoft.com/office/drawing/2014/main" id="{4E5EC911-05EE-4A23-BE87-9F101B8E0B42}"/>
+                <a16:creationId xmlns:a16="http://schemas.microsoft.com/office/drawing/2014/main" id="{EC2F5194-5923-4F01-86C6-6203FCAC9904}"/>
               </a:ext>
             </a:extLst>
           </p:cNvPr>
@@ -7070,7 +7070,7 @@
           <p:cNvPr id="16" name="">
             <a:extLst xmlns:a="http://schemas.openxmlformats.org/drawingml/2006/main">
               <a:ext uri="{FF2B5EF4-FFF2-40B4-BE49-F238E27FC236}">
-                <a16:creationId xmlns:a16="http://schemas.microsoft.com/office/drawing/2014/main" id="{A3C59581-8815-4BD2-BE31-10094331E03D}"/>
+                <a16:creationId xmlns:a16="http://schemas.microsoft.com/office/drawing/2014/main" id="{FC5A2EAC-9B24-4D1E-AD71-DFB3E787A720}"/>
               </a:ext>
             </a:extLst>
           </p:cNvPr>
@@ -7127,7 +7127,7 @@
           <p:cNvPr id="17" name="">
             <a:extLst xmlns:a="http://schemas.openxmlformats.org/drawingml/2006/main">
               <a:ext uri="{FF2B5EF4-FFF2-40B4-BE49-F238E27FC236}">
-                <a16:creationId xmlns:a16="http://schemas.microsoft.com/office/drawing/2014/main" id="{88E6EAED-7BE7-4D2E-9DA0-B7D625A3FE6C}"/>
+                <a16:creationId xmlns:a16="http://schemas.microsoft.com/office/drawing/2014/main" id="{B9CFB55E-2641-45F8-B019-FFFC8DC71F70}"/>
               </a:ext>
             </a:extLst>
           </p:cNvPr>
@@ -7162,7 +7162,7 @@
           <p:cNvPr id="18" name="">
             <a:extLst xmlns:a="http://schemas.openxmlformats.org/drawingml/2006/main">
               <a:ext uri="{FF2B5EF4-FFF2-40B4-BE49-F238E27FC236}">
-                <a16:creationId xmlns:a16="http://schemas.microsoft.com/office/drawing/2014/main" id="{A3E28E40-5695-4BCC-AD4B-078DF55615DC}"/>
+                <a16:creationId xmlns:a16="http://schemas.microsoft.com/office/drawing/2014/main" id="{4AE596E8-8FF1-42EB-B474-044163047C74}"/>
               </a:ext>
             </a:extLst>
           </p:cNvPr>
@@ -7219,7 +7219,7 @@
           <p:cNvPr id="19" name="">
             <a:extLst xmlns:a="http://schemas.openxmlformats.org/drawingml/2006/main">
               <a:ext uri="{FF2B5EF4-FFF2-40B4-BE49-F238E27FC236}">
-                <a16:creationId xmlns:a16="http://schemas.microsoft.com/office/drawing/2014/main" id="{E85702DA-7E61-4950-B701-E457983BF874}"/>
+                <a16:creationId xmlns:a16="http://schemas.microsoft.com/office/drawing/2014/main" id="{738D1EC8-9DD0-4074-97A8-204CD7B82AED}"/>
               </a:ext>
             </a:extLst>
           </p:cNvPr>
@@ -7276,7 +7276,7 @@
           <p:cNvPr id="20" name="">
             <a:extLst xmlns:a="http://schemas.openxmlformats.org/drawingml/2006/main">
               <a:ext uri="{FF2B5EF4-FFF2-40B4-BE49-F238E27FC236}">
-                <a16:creationId xmlns:a16="http://schemas.microsoft.com/office/drawing/2014/main" id="{4E48C59C-D6DE-41F1-8DD6-43CED4CEE8E2}"/>
+                <a16:creationId xmlns:a16="http://schemas.microsoft.com/office/drawing/2014/main" id="{67BD07CA-CB80-4CA9-A055-851188CDA9A3}"/>
               </a:ext>
             </a:extLst>
           </p:cNvPr>
@@ -7311,7 +7311,7 @@
           <p:cNvPr id="21" name="">
             <a:extLst xmlns:a="http://schemas.openxmlformats.org/drawingml/2006/main">
               <a:ext uri="{FF2B5EF4-FFF2-40B4-BE49-F238E27FC236}">
-                <a16:creationId xmlns:a16="http://schemas.microsoft.com/office/drawing/2014/main" id="{B650A001-D399-42C0-B1EE-9A4EB21E83B3}"/>
+                <a16:creationId xmlns:a16="http://schemas.microsoft.com/office/drawing/2014/main" id="{BD4C739A-40D1-45AA-90DC-3F86ED84C8A3}"/>
               </a:ext>
             </a:extLst>
           </p:cNvPr>
@@ -7368,7 +7368,7 @@
           <p:cNvPr id="22" name="">
             <a:extLst xmlns:a="http://schemas.openxmlformats.org/drawingml/2006/main">
               <a:ext uri="{FF2B5EF4-FFF2-40B4-BE49-F238E27FC236}">
-                <a16:creationId xmlns:a16="http://schemas.microsoft.com/office/drawing/2014/main" id="{8590D4CB-6D52-4ED0-A3F3-7047E978A13D}"/>
+                <a16:creationId xmlns:a16="http://schemas.microsoft.com/office/drawing/2014/main" id="{3A19CF64-00E5-4052-B461-9E5C9926581F}"/>
               </a:ext>
             </a:extLst>
           </p:cNvPr>
@@ -7425,7 +7425,7 @@
           <p:cNvPr id="23" name="">
             <a:extLst xmlns:a="http://schemas.openxmlformats.org/drawingml/2006/main">
               <a:ext uri="{FF2B5EF4-FFF2-40B4-BE49-F238E27FC236}">
-                <a16:creationId xmlns:a16="http://schemas.microsoft.com/office/drawing/2014/main" id="{AE85F048-0473-4E4B-B499-89409BD7E36A}"/>
+                <a16:creationId xmlns:a16="http://schemas.microsoft.com/office/drawing/2014/main" id="{653AEE6D-1F5A-4054-8DED-609EBEE2BE4B}"/>
               </a:ext>
             </a:extLst>
           </p:cNvPr>
@@ -7460,7 +7460,7 @@
           <p:cNvPr id="24" name="">
             <a:extLst xmlns:a="http://schemas.openxmlformats.org/drawingml/2006/main">
               <a:ext uri="{FF2B5EF4-FFF2-40B4-BE49-F238E27FC236}">
-                <a16:creationId xmlns:a16="http://schemas.microsoft.com/office/drawing/2014/main" id="{C4C5B54A-3131-4E98-A7F7-65693208878C}"/>
+                <a16:creationId xmlns:a16="http://schemas.microsoft.com/office/drawing/2014/main" id="{3F0B9B04-C760-4347-96BF-09DB8AC290FC}"/>
               </a:ext>
             </a:extLst>
           </p:cNvPr>
@@ -7517,7 +7517,7 @@
           <p:cNvPr id="25" name="">
             <a:extLst xmlns:a="http://schemas.openxmlformats.org/drawingml/2006/main">
               <a:ext uri="{FF2B5EF4-FFF2-40B4-BE49-F238E27FC236}">
-                <a16:creationId xmlns:a16="http://schemas.microsoft.com/office/drawing/2014/main" id="{9C5FC60C-0ECF-4670-B6C8-65F694CF536D}"/>
+                <a16:creationId xmlns:a16="http://schemas.microsoft.com/office/drawing/2014/main" id="{2A03C07C-6105-461B-BAE4-1BEDFCCA4C0B}"/>
               </a:ext>
             </a:extLst>
           </p:cNvPr>
@@ -7581,7 +7581,7 @@
           <p:cNvPr id="26" name="">
             <a:extLst xmlns:a="http://schemas.openxmlformats.org/drawingml/2006/main">
               <a:ext uri="{FF2B5EF4-FFF2-40B4-BE49-F238E27FC236}">
-                <a16:creationId xmlns:a16="http://schemas.microsoft.com/office/drawing/2014/main" id="{C6377F1A-CA7B-4E4D-9457-0EE026F6C4F4}"/>
+                <a16:creationId xmlns:a16="http://schemas.microsoft.com/office/drawing/2014/main" id="{E459A54F-CCDF-444D-BB44-771726DFE304}"/>
               </a:ext>
             </a:extLst>
           </p:cNvPr>
@@ -7645,7 +7645,7 @@
           <p:cNvPr id="27" name="">
             <a:extLst xmlns:a="http://schemas.openxmlformats.org/drawingml/2006/main">
               <a:ext uri="{FF2B5EF4-FFF2-40B4-BE49-F238E27FC236}">
-                <a16:creationId xmlns:a16="http://schemas.microsoft.com/office/drawing/2014/main" id="{2F8E3675-FD91-458B-9255-FE3CE62E6751}"/>
+                <a16:creationId xmlns:a16="http://schemas.microsoft.com/office/drawing/2014/main" id="{2019FC9A-9367-47CE-BE66-10CD43B70D05}"/>
               </a:ext>
             </a:extLst>
           </p:cNvPr>
@@ -7709,7 +7709,7 @@
           <p:cNvPr id="28" name="">
             <a:extLst xmlns:a="http://schemas.openxmlformats.org/drawingml/2006/main">
               <a:ext uri="{FF2B5EF4-FFF2-40B4-BE49-F238E27FC236}">
-                <a16:creationId xmlns:a16="http://schemas.microsoft.com/office/drawing/2014/main" id="{00E41A62-8AE2-47DD-B633-F8D41B2B8D16}"/>
+                <a16:creationId xmlns:a16="http://schemas.microsoft.com/office/drawing/2014/main" id="{D30AFE76-87EC-40C2-9EE2-251707BE4D14}"/>
               </a:ext>
             </a:extLst>
           </p:cNvPr>
@@ -7773,7 +7773,7 @@
           <p:cNvPr id="29" name="">
             <a:extLst xmlns:a="http://schemas.openxmlformats.org/drawingml/2006/main">
               <a:ext uri="{FF2B5EF4-FFF2-40B4-BE49-F238E27FC236}">
-                <a16:creationId xmlns:a16="http://schemas.microsoft.com/office/drawing/2014/main" id="{4C310E49-F8A7-465B-8B32-AF0390BC09BA}"/>
+                <a16:creationId xmlns:a16="http://schemas.microsoft.com/office/drawing/2014/main" id="{8CA4298F-F419-492A-9C96-A1E011956022}"/>
               </a:ext>
             </a:extLst>
           </p:cNvPr>
@@ -7830,7 +7830,7 @@
           <p:cNvPr id="30" name="">
             <a:extLst xmlns:a="http://schemas.openxmlformats.org/drawingml/2006/main">
               <a:ext uri="{FF2B5EF4-FFF2-40B4-BE49-F238E27FC236}">
-                <a16:creationId xmlns:a16="http://schemas.microsoft.com/office/drawing/2014/main" id="{31169D09-08B4-4F91-9241-68B3E095D87E}"/>
+                <a16:creationId xmlns:a16="http://schemas.microsoft.com/office/drawing/2014/main" id="{5EB99521-3E0A-47E8-A350-F96875C1B0EA}"/>
               </a:ext>
             </a:extLst>
           </p:cNvPr>
@@ -7887,7 +7887,7 @@
           <p:cNvPr id="31" name="">
             <a:extLst xmlns:a="http://schemas.openxmlformats.org/drawingml/2006/main">
               <a:ext uri="{FF2B5EF4-FFF2-40B4-BE49-F238E27FC236}">
-                <a16:creationId xmlns:a16="http://schemas.microsoft.com/office/drawing/2014/main" id="{F3A39643-6851-47DC-84FE-C6B0F825184F}"/>
+                <a16:creationId xmlns:a16="http://schemas.microsoft.com/office/drawing/2014/main" id="{35790431-6CD7-44D7-B4C3-3DF05412DEAF}"/>
               </a:ext>
             </a:extLst>
           </p:cNvPr>
@@ -7942,7 +7942,7 @@
     </p:spTree>
     <p:extLst>
       <p:ext uri="{BB962C8B-B14F-4D97-AF65-F5344CB8AC3E}">
-        <p14:creationId xmlns:p14="http://schemas.microsoft.com/office/powerpoint/2010/main" val="2144598308"/>
+        <p14:creationId xmlns:p14="http://schemas.microsoft.com/office/powerpoint/2010/main" val="1070911908"/>
       </p:ext>
     </p:extLst>
   </p:cSld>
@@ -7973,7 +7973,7 @@
           <p:cNvPr id="32" name="">
             <a:extLst xmlns:a="http://schemas.openxmlformats.org/drawingml/2006/main">
               <a:ext uri="{FF2B5EF4-FFF2-40B4-BE49-F238E27FC236}">
-                <a16:creationId xmlns:a16="http://schemas.microsoft.com/office/drawing/2014/main" id="{166E6BED-2346-46D4-952C-645BC3CA8EB4}"/>
+                <a16:creationId xmlns:a16="http://schemas.microsoft.com/office/drawing/2014/main" id="{44B760B5-CD28-404A-8700-89E005FE9356}"/>
               </a:ext>
             </a:extLst>
           </p:cNvPr>
@@ -8030,7 +8030,7 @@
           <p:cNvPr id="2" name="">
             <a:extLst xmlns:a="http://schemas.openxmlformats.org/drawingml/2006/main">
               <a:ext uri="{FF2B5EF4-FFF2-40B4-BE49-F238E27FC236}">
-                <a16:creationId xmlns:a16="http://schemas.microsoft.com/office/drawing/2014/main" id="{AB781700-F7B3-4831-97B1-3A1A0D103B84}"/>
+                <a16:creationId xmlns:a16="http://schemas.microsoft.com/office/drawing/2014/main" id="{7A7FA199-56B3-492E-8C52-6B644DBAEB5D}"/>
               </a:ext>
             </a:extLst>
           </p:cNvPr>
@@ -8087,7 +8087,7 @@
           <p:cNvPr id="3" name="">
             <a:extLst xmlns:a="http://schemas.openxmlformats.org/drawingml/2006/main">
               <a:ext uri="{FF2B5EF4-FFF2-40B4-BE49-F238E27FC236}">
-                <a16:creationId xmlns:a16="http://schemas.microsoft.com/office/drawing/2014/main" id="{478E7FF0-DEDE-4977-81B5-F55F2610C6DC}"/>
+                <a16:creationId xmlns:a16="http://schemas.microsoft.com/office/drawing/2014/main" id="{DDBD24A4-0438-4236-8D11-AC5E7612698A}"/>
               </a:ext>
             </a:extLst>
           </p:cNvPr>
@@ -8144,7 +8144,7 @@
           <p:cNvPr id="4" name="">
             <a:extLst xmlns:a="http://schemas.openxmlformats.org/drawingml/2006/main">
               <a:ext uri="{FF2B5EF4-FFF2-40B4-BE49-F238E27FC236}">
-                <a16:creationId xmlns:a16="http://schemas.microsoft.com/office/drawing/2014/main" id="{D8FE21B7-9BE7-44E4-ABF9-C52CDC090490}"/>
+                <a16:creationId xmlns:a16="http://schemas.microsoft.com/office/drawing/2014/main" id="{E18BF944-AF02-4827-AEB6-E092A3CB9692}"/>
               </a:ext>
             </a:extLst>
           </p:cNvPr>
@@ -8175,7 +8175,7 @@
           <p:cNvPr id="5" name="">
             <a:extLst xmlns:a="http://schemas.openxmlformats.org/drawingml/2006/main">
               <a:ext uri="{FF2B5EF4-FFF2-40B4-BE49-F238E27FC236}">
-                <a16:creationId xmlns:a16="http://schemas.microsoft.com/office/drawing/2014/main" id="{DC12D050-A019-4C3E-8B2B-5B1DF78A0B7E}"/>
+                <a16:creationId xmlns:a16="http://schemas.microsoft.com/office/drawing/2014/main" id="{94BEB37A-CF44-476F-A5C9-842CF0D7A7E1}"/>
               </a:ext>
             </a:extLst>
           </p:cNvPr>
@@ -8210,7 +8210,7 @@
           <p:cNvPr id="6" name="">
             <a:extLst xmlns:a="http://schemas.openxmlformats.org/drawingml/2006/main">
               <a:ext uri="{FF2B5EF4-FFF2-40B4-BE49-F238E27FC236}">
-                <a16:creationId xmlns:a16="http://schemas.microsoft.com/office/drawing/2014/main" id="{B50E67BF-6A75-48FE-82B3-21CDBCCC20AC}"/>
+                <a16:creationId xmlns:a16="http://schemas.microsoft.com/office/drawing/2014/main" id="{51510A4A-0D33-4A7E-9C47-DBA258486943}"/>
               </a:ext>
             </a:extLst>
           </p:cNvPr>
@@ -8274,7 +8274,7 @@
           <p:cNvPr id="7" name="">
             <a:extLst xmlns:a="http://schemas.openxmlformats.org/drawingml/2006/main">
               <a:ext uri="{FF2B5EF4-FFF2-40B4-BE49-F238E27FC236}">
-                <a16:creationId xmlns:a16="http://schemas.microsoft.com/office/drawing/2014/main" id="{BF91733B-9DFA-4197-B554-F704CE25162D}"/>
+                <a16:creationId xmlns:a16="http://schemas.microsoft.com/office/drawing/2014/main" id="{53AEB96A-BC6B-42A3-BD41-7E1C06D4AA10}"/>
               </a:ext>
             </a:extLst>
           </p:cNvPr>
@@ -8331,7 +8331,7 @@
           <p:cNvPr id="8" name="">
             <a:extLst xmlns:a="http://schemas.openxmlformats.org/drawingml/2006/main">
               <a:ext uri="{FF2B5EF4-FFF2-40B4-BE49-F238E27FC236}">
-                <a16:creationId xmlns:a16="http://schemas.microsoft.com/office/drawing/2014/main" id="{9DC32F55-15EF-4DD8-8EA6-C619F45AF6EC}"/>
+                <a16:creationId xmlns:a16="http://schemas.microsoft.com/office/drawing/2014/main" id="{A93E0727-6DA0-4357-AC58-C31D9C729024}"/>
               </a:ext>
             </a:extLst>
           </p:cNvPr>
@@ -8362,7 +8362,7 @@
           <p:cNvPr id="9" name="">
             <a:extLst xmlns:a="http://schemas.openxmlformats.org/drawingml/2006/main">
               <a:ext uri="{FF2B5EF4-FFF2-40B4-BE49-F238E27FC236}">
-                <a16:creationId xmlns:a16="http://schemas.microsoft.com/office/drawing/2014/main" id="{7865AFD1-8FFF-4ADD-9FF8-FA485E20C79B}"/>
+                <a16:creationId xmlns:a16="http://schemas.microsoft.com/office/drawing/2014/main" id="{0F76425B-F9B2-41FA-B6AC-E4F9AABA2D53}"/>
               </a:ext>
             </a:extLst>
           </p:cNvPr>
@@ -8397,7 +8397,7 @@
           <p:cNvPr id="10" name="">
             <a:extLst xmlns:a="http://schemas.openxmlformats.org/drawingml/2006/main">
               <a:ext uri="{FF2B5EF4-FFF2-40B4-BE49-F238E27FC236}">
-                <a16:creationId xmlns:a16="http://schemas.microsoft.com/office/drawing/2014/main" id="{B1048674-89EC-4E1F-A7B6-2592F6C642EB}"/>
+                <a16:creationId xmlns:a16="http://schemas.microsoft.com/office/drawing/2014/main" id="{1E512AAE-CDD3-4A15-B569-2972C5AA162A}"/>
               </a:ext>
             </a:extLst>
           </p:cNvPr>
@@ -8461,7 +8461,7 @@
           <p:cNvPr id="11" name="">
             <a:extLst xmlns:a="http://schemas.openxmlformats.org/drawingml/2006/main">
               <a:ext uri="{FF2B5EF4-FFF2-40B4-BE49-F238E27FC236}">
-                <a16:creationId xmlns:a16="http://schemas.microsoft.com/office/drawing/2014/main" id="{4EB03C47-C1E6-4FB0-8412-491A4AF8A9E3}"/>
+                <a16:creationId xmlns:a16="http://schemas.microsoft.com/office/drawing/2014/main" id="{AEC080F7-FB9A-4BCC-906D-1A6711EB6849}"/>
               </a:ext>
             </a:extLst>
           </p:cNvPr>
@@ -8518,7 +8518,7 @@
           <p:cNvPr id="12" name="">
             <a:extLst xmlns:a="http://schemas.openxmlformats.org/drawingml/2006/main">
               <a:ext uri="{FF2B5EF4-FFF2-40B4-BE49-F238E27FC236}">
-                <a16:creationId xmlns:a16="http://schemas.microsoft.com/office/drawing/2014/main" id="{8382AAA1-27B4-475D-A67E-DB415C7145BC}"/>
+                <a16:creationId xmlns:a16="http://schemas.microsoft.com/office/drawing/2014/main" id="{CC30CA43-8A3A-43A4-B192-A126F44AB40C}"/>
               </a:ext>
             </a:extLst>
           </p:cNvPr>
@@ -8549,7 +8549,7 @@
           <p:cNvPr id="13" name="">
             <a:extLst xmlns:a="http://schemas.openxmlformats.org/drawingml/2006/main">
               <a:ext uri="{FF2B5EF4-FFF2-40B4-BE49-F238E27FC236}">
-                <a16:creationId xmlns:a16="http://schemas.microsoft.com/office/drawing/2014/main" id="{BB8744F2-2513-4F81-9D1D-B5F3CB5E7FBB}"/>
+                <a16:creationId xmlns:a16="http://schemas.microsoft.com/office/drawing/2014/main" id="{22F89BC4-8B8F-4B94-B2E7-4C8A4E8E6C6F}"/>
               </a:ext>
             </a:extLst>
           </p:cNvPr>
@@ -8584,7 +8584,7 @@
           <p:cNvPr id="14" name="">
             <a:extLst xmlns:a="http://schemas.openxmlformats.org/drawingml/2006/main">
               <a:ext uri="{FF2B5EF4-FFF2-40B4-BE49-F238E27FC236}">
-                <a16:creationId xmlns:a16="http://schemas.microsoft.com/office/drawing/2014/main" id="{92B91F0F-E79B-42A4-97E8-8F264DBD2AFF}"/>
+                <a16:creationId xmlns:a16="http://schemas.microsoft.com/office/drawing/2014/main" id="{F5751D05-6380-450E-8D92-180927A27AE1}"/>
               </a:ext>
             </a:extLst>
           </p:cNvPr>
@@ -8648,7 +8648,7 @@
           <p:cNvPr id="15" name="">
             <a:extLst xmlns:a="http://schemas.openxmlformats.org/drawingml/2006/main">
               <a:ext uri="{FF2B5EF4-FFF2-40B4-BE49-F238E27FC236}">
-                <a16:creationId xmlns:a16="http://schemas.microsoft.com/office/drawing/2014/main" id="{9D3552B2-AE4F-438A-8961-7C71FF8F17CD}"/>
+                <a16:creationId xmlns:a16="http://schemas.microsoft.com/office/drawing/2014/main" id="{261E25C2-1778-45DA-9ACE-455BED8DC59E}"/>
               </a:ext>
             </a:extLst>
           </p:cNvPr>
@@ -8705,7 +8705,7 @@
           <p:cNvPr id="16" name="">
             <a:extLst xmlns:a="http://schemas.openxmlformats.org/drawingml/2006/main">
               <a:ext uri="{FF2B5EF4-FFF2-40B4-BE49-F238E27FC236}">
-                <a16:creationId xmlns:a16="http://schemas.microsoft.com/office/drawing/2014/main" id="{1F12DEEC-CED8-4699-919A-2199E893FF29}"/>
+                <a16:creationId xmlns:a16="http://schemas.microsoft.com/office/drawing/2014/main" id="{A8BFC2A9-4E0B-482E-90A7-D89E4F5D885A}"/>
               </a:ext>
             </a:extLst>
           </p:cNvPr>
@@ -8736,7 +8736,7 @@
           <p:cNvPr id="17" name="">
             <a:extLst xmlns:a="http://schemas.openxmlformats.org/drawingml/2006/main">
               <a:ext uri="{FF2B5EF4-FFF2-40B4-BE49-F238E27FC236}">
-                <a16:creationId xmlns:a16="http://schemas.microsoft.com/office/drawing/2014/main" id="{902997A5-88E3-492B-96F9-41F2ACD77B9D}"/>
+                <a16:creationId xmlns:a16="http://schemas.microsoft.com/office/drawing/2014/main" id="{2B55A4D5-644D-48A5-97D6-AF7AE587F4EA}"/>
               </a:ext>
             </a:extLst>
           </p:cNvPr>
@@ -8771,7 +8771,7 @@
           <p:cNvPr id="18" name="">
             <a:extLst xmlns:a="http://schemas.openxmlformats.org/drawingml/2006/main">
               <a:ext uri="{FF2B5EF4-FFF2-40B4-BE49-F238E27FC236}">
-                <a16:creationId xmlns:a16="http://schemas.microsoft.com/office/drawing/2014/main" id="{5EEA0FDB-5905-4DC2-AAEB-710ADB0DA5E3}"/>
+                <a16:creationId xmlns:a16="http://schemas.microsoft.com/office/drawing/2014/main" id="{FF9DC070-1866-4FBD-9548-D19709946AE4}"/>
               </a:ext>
             </a:extLst>
           </p:cNvPr>
@@ -8835,7 +8835,7 @@
           <p:cNvPr id="19" name="">
             <a:extLst xmlns:a="http://schemas.openxmlformats.org/drawingml/2006/main">
               <a:ext uri="{FF2B5EF4-FFF2-40B4-BE49-F238E27FC236}">
-                <a16:creationId xmlns:a16="http://schemas.microsoft.com/office/drawing/2014/main" id="{734CED9A-4FE8-45B4-A564-3B3558AAE6C6}"/>
+                <a16:creationId xmlns:a16="http://schemas.microsoft.com/office/drawing/2014/main" id="{DE2A46E6-EBE5-489D-AABC-4B2697D9EDF2}"/>
               </a:ext>
             </a:extLst>
           </p:cNvPr>
@@ -8892,7 +8892,7 @@
           <p:cNvPr id="20" name="">
             <a:extLst xmlns:a="http://schemas.openxmlformats.org/drawingml/2006/main">
               <a:ext uri="{FF2B5EF4-FFF2-40B4-BE49-F238E27FC236}">
-                <a16:creationId xmlns:a16="http://schemas.microsoft.com/office/drawing/2014/main" id="{56B0EDD1-F178-4F02-8873-0FA369257B04}"/>
+                <a16:creationId xmlns:a16="http://schemas.microsoft.com/office/drawing/2014/main" id="{D0C0A49D-0DB6-46BE-9B83-47D792E30E4D}"/>
               </a:ext>
             </a:extLst>
           </p:cNvPr>
@@ -8927,7 +8927,7 @@
           <p:cNvPr id="21" name="">
             <a:extLst xmlns:a="http://schemas.openxmlformats.org/drawingml/2006/main">
               <a:ext uri="{FF2B5EF4-FFF2-40B4-BE49-F238E27FC236}">
-                <a16:creationId xmlns:a16="http://schemas.microsoft.com/office/drawing/2014/main" id="{79D877C1-D9EB-4104-A5DC-F70051DA2792}"/>
+                <a16:creationId xmlns:a16="http://schemas.microsoft.com/office/drawing/2014/main" id="{3D7EF547-EE35-40F4-893E-150C9A8F1011}"/>
               </a:ext>
             </a:extLst>
           </p:cNvPr>
@@ -8984,7 +8984,7 @@
           <p:cNvPr id="22" name="">
             <a:extLst xmlns:a="http://schemas.openxmlformats.org/drawingml/2006/main">
               <a:ext uri="{FF2B5EF4-FFF2-40B4-BE49-F238E27FC236}">
-                <a16:creationId xmlns:a16="http://schemas.microsoft.com/office/drawing/2014/main" id="{E4F3EF96-4E1A-4E52-BD48-75E9FF0E284F}"/>
+                <a16:creationId xmlns:a16="http://schemas.microsoft.com/office/drawing/2014/main" id="{7316EABD-7E74-4293-85F8-ABE8BD92EDEA}"/>
               </a:ext>
             </a:extLst>
           </p:cNvPr>
@@ -9041,7 +9041,7 @@
           <p:cNvPr id="23" name="">
             <a:extLst xmlns:a="http://schemas.openxmlformats.org/drawingml/2006/main">
               <a:ext uri="{FF2B5EF4-FFF2-40B4-BE49-F238E27FC236}">
-                <a16:creationId xmlns:a16="http://schemas.microsoft.com/office/drawing/2014/main" id="{133CB091-8E92-4195-AA83-B4DA98872110}"/>
+                <a16:creationId xmlns:a16="http://schemas.microsoft.com/office/drawing/2014/main" id="{FD41C080-CC19-4CB6-B2B6-617A62C889D3}"/>
               </a:ext>
             </a:extLst>
           </p:cNvPr>
@@ -9076,7 +9076,7 @@
           <p:cNvPr id="24" name="">
             <a:extLst xmlns:a="http://schemas.openxmlformats.org/drawingml/2006/main">
               <a:ext uri="{FF2B5EF4-FFF2-40B4-BE49-F238E27FC236}">
-                <a16:creationId xmlns:a16="http://schemas.microsoft.com/office/drawing/2014/main" id="{40C93439-8C03-4B95-9BDF-6011577B470A}"/>
+                <a16:creationId xmlns:a16="http://schemas.microsoft.com/office/drawing/2014/main" id="{E98CF817-3E08-4502-A78B-7E401E26E14C}"/>
               </a:ext>
             </a:extLst>
           </p:cNvPr>
@@ -9140,7 +9140,7 @@
           <p:cNvPr id="25" name="">
             <a:extLst xmlns:a="http://schemas.openxmlformats.org/drawingml/2006/main">
               <a:ext uri="{FF2B5EF4-FFF2-40B4-BE49-F238E27FC236}">
-                <a16:creationId xmlns:a16="http://schemas.microsoft.com/office/drawing/2014/main" id="{9177C14B-BDA5-49DE-BED7-14649D6FDC4F}"/>
+                <a16:creationId xmlns:a16="http://schemas.microsoft.com/office/drawing/2014/main" id="{DE8B1748-ECB6-44D7-848D-8F6BBDE0D2A5}"/>
               </a:ext>
             </a:extLst>
           </p:cNvPr>
@@ -9266,7 +9266,7 @@
           <p:cNvPr id="26" name="">
             <a:extLst xmlns:a="http://schemas.openxmlformats.org/drawingml/2006/main">
               <a:ext uri="{FF2B5EF4-FFF2-40B4-BE49-F238E27FC236}">
-                <a16:creationId xmlns:a16="http://schemas.microsoft.com/office/drawing/2014/main" id="{D183B7B3-4DC0-4271-BAA3-0AC337430C54}"/>
+                <a16:creationId xmlns:a16="http://schemas.microsoft.com/office/drawing/2014/main" id="{4E98509C-F1C5-4FD0-A3A8-17A68C4F1A8B}"/>
               </a:ext>
             </a:extLst>
           </p:cNvPr>
@@ -9301,7 +9301,7 @@
           <p:cNvPr id="27" name="">
             <a:extLst xmlns:a="http://schemas.openxmlformats.org/drawingml/2006/main">
               <a:ext uri="{FF2B5EF4-FFF2-40B4-BE49-F238E27FC236}">
-                <a16:creationId xmlns:a16="http://schemas.microsoft.com/office/drawing/2014/main" id="{967C7C85-DE01-4801-821F-69B75F3668E1}"/>
+                <a16:creationId xmlns:a16="http://schemas.microsoft.com/office/drawing/2014/main" id="{2AEA05B3-7D6C-420C-B452-30A4ED40CC81}"/>
               </a:ext>
             </a:extLst>
           </p:cNvPr>
@@ -9365,7 +9365,7 @@
           <p:cNvPr id="28" name="">
             <a:extLst xmlns:a="http://schemas.openxmlformats.org/drawingml/2006/main">
               <a:ext uri="{FF2B5EF4-FFF2-40B4-BE49-F238E27FC236}">
-                <a16:creationId xmlns:a16="http://schemas.microsoft.com/office/drawing/2014/main" id="{725A4AE7-432F-4879-BD84-C23B50780519}"/>
+                <a16:creationId xmlns:a16="http://schemas.microsoft.com/office/drawing/2014/main" id="{6711427B-6392-4D91-805C-42E4463CE358}"/>
               </a:ext>
             </a:extLst>
           </p:cNvPr>
@@ -9468,7 +9468,7 @@
           <p:cNvPr id="29" name="">
             <a:extLst xmlns:a="http://schemas.openxmlformats.org/drawingml/2006/main">
               <a:ext uri="{FF2B5EF4-FFF2-40B4-BE49-F238E27FC236}">
-                <a16:creationId xmlns:a16="http://schemas.microsoft.com/office/drawing/2014/main" id="{9F618984-37C2-4103-AB15-6EF1B291E3AC}"/>
+                <a16:creationId xmlns:a16="http://schemas.microsoft.com/office/drawing/2014/main" id="{EB947F2E-6C22-4AA5-84AD-98769FE52C22}"/>
               </a:ext>
             </a:extLst>
           </p:cNvPr>
@@ -9548,7 +9548,7 @@
           <p:cNvPr id="30" name="">
             <a:extLst xmlns:a="http://schemas.openxmlformats.org/drawingml/2006/main">
               <a:ext uri="{FF2B5EF4-FFF2-40B4-BE49-F238E27FC236}">
-                <a16:creationId xmlns:a16="http://schemas.microsoft.com/office/drawing/2014/main" id="{FCB3D807-88A2-4857-9FD8-44175D50331D}"/>
+                <a16:creationId xmlns:a16="http://schemas.microsoft.com/office/drawing/2014/main" id="{189369C9-3470-47C9-A55B-5293CDB3C1C5}"/>
               </a:ext>
             </a:extLst>
           </p:cNvPr>
@@ -9605,7 +9605,7 @@
           <p:cNvPr id="31" name="">
             <a:extLst xmlns:a="http://schemas.openxmlformats.org/drawingml/2006/main">
               <a:ext uri="{FF2B5EF4-FFF2-40B4-BE49-F238E27FC236}">
-                <a16:creationId xmlns:a16="http://schemas.microsoft.com/office/drawing/2014/main" id="{701703BB-9B32-48E3-A8B2-C03223092274}"/>
+                <a16:creationId xmlns:a16="http://schemas.microsoft.com/office/drawing/2014/main" id="{E0FCBE71-BE0C-417D-A886-6066B6A26CE5}"/>
               </a:ext>
             </a:extLst>
           </p:cNvPr>
@@ -9660,7 +9660,7 @@
     </p:spTree>
     <p:extLst>
       <p:ext uri="{BB962C8B-B14F-4D97-AF65-F5344CB8AC3E}">
-        <p14:creationId xmlns:p14="http://schemas.microsoft.com/office/powerpoint/2010/main" val="522298994"/>
+        <p14:creationId xmlns:p14="http://schemas.microsoft.com/office/powerpoint/2010/main" val="1857741313"/>
       </p:ext>
     </p:extLst>
   </p:cSld>
@@ -9691,7 +9691,7 @@
           <p:cNvPr id="36" name="">
             <a:extLst xmlns:a="http://schemas.openxmlformats.org/drawingml/2006/main">
               <a:ext uri="{FF2B5EF4-FFF2-40B4-BE49-F238E27FC236}">
-                <a16:creationId xmlns:a16="http://schemas.microsoft.com/office/drawing/2014/main" id="{FD526099-DB5E-4B3E-A702-75DCFC5FCA6C}"/>
+                <a16:creationId xmlns:a16="http://schemas.microsoft.com/office/drawing/2014/main" id="{7FEFC94C-BB72-49AB-A025-FB9FDC79902E}"/>
               </a:ext>
             </a:extLst>
           </p:cNvPr>
@@ -9748,7 +9748,7 @@
           <p:cNvPr id="2" name="">
             <a:extLst xmlns:a="http://schemas.openxmlformats.org/drawingml/2006/main">
               <a:ext uri="{FF2B5EF4-FFF2-40B4-BE49-F238E27FC236}">
-                <a16:creationId xmlns:a16="http://schemas.microsoft.com/office/drawing/2014/main" id="{48309B93-666E-4F4F-BFFD-96DC96C0E776}"/>
+                <a16:creationId xmlns:a16="http://schemas.microsoft.com/office/drawing/2014/main" id="{BE8245F1-E45F-4E6C-A414-021F4BE68969}"/>
               </a:ext>
             </a:extLst>
           </p:cNvPr>
@@ -9805,7 +9805,7 @@
           <p:cNvPr id="3" name="">
             <a:extLst xmlns:a="http://schemas.openxmlformats.org/drawingml/2006/main">
               <a:ext uri="{FF2B5EF4-FFF2-40B4-BE49-F238E27FC236}">
-                <a16:creationId xmlns:a16="http://schemas.microsoft.com/office/drawing/2014/main" id="{D8B2D9DB-2C14-4182-B9A2-2BB5211D1A8C}"/>
+                <a16:creationId xmlns:a16="http://schemas.microsoft.com/office/drawing/2014/main" id="{E3A023D7-26B2-4059-A230-88054397B41A}"/>
               </a:ext>
             </a:extLst>
           </p:cNvPr>
@@ -9862,7 +9862,7 @@
           <p:cNvPr id="4" name="">
             <a:extLst xmlns:a="http://schemas.openxmlformats.org/drawingml/2006/main">
               <a:ext uri="{FF2B5EF4-FFF2-40B4-BE49-F238E27FC236}">
-                <a16:creationId xmlns:a16="http://schemas.microsoft.com/office/drawing/2014/main" id="{B8AB8183-C827-4E10-9403-5C795F1035C0}"/>
+                <a16:creationId xmlns:a16="http://schemas.microsoft.com/office/drawing/2014/main" id="{A61A3EEA-CA7B-431C-A8C8-22DA20823A2A}"/>
               </a:ext>
             </a:extLst>
           </p:cNvPr>
@@ -9893,7 +9893,7 @@
           <p:cNvPr id="5" name="">
             <a:extLst xmlns:a="http://schemas.openxmlformats.org/drawingml/2006/main">
               <a:ext uri="{FF2B5EF4-FFF2-40B4-BE49-F238E27FC236}">
-                <a16:creationId xmlns:a16="http://schemas.microsoft.com/office/drawing/2014/main" id="{963BE11C-49B6-4E00-B122-9E3682D62C40}"/>
+                <a16:creationId xmlns:a16="http://schemas.microsoft.com/office/drawing/2014/main" id="{07081611-86C0-4111-87EA-B5F3AE3C155D}"/>
               </a:ext>
             </a:extLst>
           </p:cNvPr>
@@ -9928,7 +9928,7 @@
           <p:cNvPr id="6" name="">
             <a:extLst xmlns:a="http://schemas.openxmlformats.org/drawingml/2006/main">
               <a:ext uri="{FF2B5EF4-FFF2-40B4-BE49-F238E27FC236}">
-                <a16:creationId xmlns:a16="http://schemas.microsoft.com/office/drawing/2014/main" id="{D50983AA-A6B1-41B1-AE24-7F11CF73E3CF}"/>
+                <a16:creationId xmlns:a16="http://schemas.microsoft.com/office/drawing/2014/main" id="{8AFE8F35-BCEB-4E07-8E4B-961478626CB5}"/>
               </a:ext>
             </a:extLst>
           </p:cNvPr>
@@ -9992,7 +9992,7 @@
           <p:cNvPr id="7" name="">
             <a:extLst xmlns:a="http://schemas.openxmlformats.org/drawingml/2006/main">
               <a:ext uri="{FF2B5EF4-FFF2-40B4-BE49-F238E27FC236}">
-                <a16:creationId xmlns:a16="http://schemas.microsoft.com/office/drawing/2014/main" id="{EC4CC3AE-BCC1-40C8-BF19-BD8D0FF776D6}"/>
+                <a16:creationId xmlns:a16="http://schemas.microsoft.com/office/drawing/2014/main" id="{E3336FB1-E54B-47CD-99E7-BDAD337E0CB4}"/>
               </a:ext>
             </a:extLst>
           </p:cNvPr>
@@ -10049,7 +10049,7 @@
           <p:cNvPr id="8" name="">
             <a:extLst xmlns:a="http://schemas.openxmlformats.org/drawingml/2006/main">
               <a:ext uri="{FF2B5EF4-FFF2-40B4-BE49-F238E27FC236}">
-                <a16:creationId xmlns:a16="http://schemas.microsoft.com/office/drawing/2014/main" id="{C4A1E04C-8A1E-416D-8802-A09EE92D723F}"/>
+                <a16:creationId xmlns:a16="http://schemas.microsoft.com/office/drawing/2014/main" id="{6C225BE4-C6A4-431C-BDF9-9F10263DFDF5}"/>
               </a:ext>
             </a:extLst>
           </p:cNvPr>
@@ -10084,7 +10084,7 @@
           <p:cNvPr id="9" name="">
             <a:extLst xmlns:a="http://schemas.openxmlformats.org/drawingml/2006/main">
               <a:ext uri="{FF2B5EF4-FFF2-40B4-BE49-F238E27FC236}">
-                <a16:creationId xmlns:a16="http://schemas.microsoft.com/office/drawing/2014/main" id="{C91236A3-C13B-40E8-A8CD-B98AD4B178BF}"/>
+                <a16:creationId xmlns:a16="http://schemas.microsoft.com/office/drawing/2014/main" id="{90CD4954-88EA-47F4-BA62-DEA97D735583}"/>
               </a:ext>
             </a:extLst>
           </p:cNvPr>
@@ -10148,7 +10148,7 @@
           <p:cNvPr id="10" name="">
             <a:extLst xmlns:a="http://schemas.openxmlformats.org/drawingml/2006/main">
               <a:ext uri="{FF2B5EF4-FFF2-40B4-BE49-F238E27FC236}">
-                <a16:creationId xmlns:a16="http://schemas.microsoft.com/office/drawing/2014/main" id="{D8B44550-DC7A-45A3-8DC9-D82AB2F9EAEA}"/>
+                <a16:creationId xmlns:a16="http://schemas.microsoft.com/office/drawing/2014/main" id="{86C09530-78B2-4EE4-89A1-26DE4EBAF4AB}"/>
               </a:ext>
             </a:extLst>
           </p:cNvPr>
@@ -10205,7 +10205,7 @@
           <p:cNvPr id="11" name="">
             <a:extLst xmlns:a="http://schemas.openxmlformats.org/drawingml/2006/main">
               <a:ext uri="{FF2B5EF4-FFF2-40B4-BE49-F238E27FC236}">
-                <a16:creationId xmlns:a16="http://schemas.microsoft.com/office/drawing/2014/main" id="{2616A0FD-4214-4FBA-900A-22B1E731736E}"/>
+                <a16:creationId xmlns:a16="http://schemas.microsoft.com/office/drawing/2014/main" id="{C01C3A7F-C2F8-49BD-91DB-A76967D45778}"/>
               </a:ext>
             </a:extLst>
           </p:cNvPr>
@@ -10240,7 +10240,7 @@
           <p:cNvPr id="12" name="">
             <a:extLst xmlns:a="http://schemas.openxmlformats.org/drawingml/2006/main">
               <a:ext uri="{FF2B5EF4-FFF2-40B4-BE49-F238E27FC236}">
-                <a16:creationId xmlns:a16="http://schemas.microsoft.com/office/drawing/2014/main" id="{D437E8F3-8E10-4FEC-80EB-EB0427EBD343}"/>
+                <a16:creationId xmlns:a16="http://schemas.microsoft.com/office/drawing/2014/main" id="{01E32243-DE6A-4C58-830B-785B6DDD20D2}"/>
               </a:ext>
             </a:extLst>
           </p:cNvPr>
@@ -10304,7 +10304,7 @@
           <p:cNvPr id="13" name="">
             <a:extLst xmlns:a="http://schemas.openxmlformats.org/drawingml/2006/main">
               <a:ext uri="{FF2B5EF4-FFF2-40B4-BE49-F238E27FC236}">
-                <a16:creationId xmlns:a16="http://schemas.microsoft.com/office/drawing/2014/main" id="{4F0B4C98-53D5-45C5-9ABA-CAAB64752AB9}"/>
+                <a16:creationId xmlns:a16="http://schemas.microsoft.com/office/drawing/2014/main" id="{57352111-51FA-4A61-8D78-BEF2BE3B7B14}"/>
               </a:ext>
             </a:extLst>
           </p:cNvPr>
@@ -10361,7 +10361,7 @@
           <p:cNvPr id="14" name="">
             <a:extLst xmlns:a="http://schemas.openxmlformats.org/drawingml/2006/main">
               <a:ext uri="{FF2B5EF4-FFF2-40B4-BE49-F238E27FC236}">
-                <a16:creationId xmlns:a16="http://schemas.microsoft.com/office/drawing/2014/main" id="{494D83B3-0216-4981-BA3E-4E3400C39976}"/>
+                <a16:creationId xmlns:a16="http://schemas.microsoft.com/office/drawing/2014/main" id="{33229209-C2BE-4C10-A728-366F66A7CBA3}"/>
               </a:ext>
             </a:extLst>
           </p:cNvPr>
@@ -10396,7 +10396,7 @@
           <p:cNvPr id="15" name="">
             <a:extLst xmlns:a="http://schemas.openxmlformats.org/drawingml/2006/main">
               <a:ext uri="{FF2B5EF4-FFF2-40B4-BE49-F238E27FC236}">
-                <a16:creationId xmlns:a16="http://schemas.microsoft.com/office/drawing/2014/main" id="{262FCEEA-50D7-4960-AB48-3B2299C962C1}"/>
+                <a16:creationId xmlns:a16="http://schemas.microsoft.com/office/drawing/2014/main" id="{404AD627-5B44-4180-A387-4EB90834DBEA}"/>
               </a:ext>
             </a:extLst>
           </p:cNvPr>
@@ -10460,7 +10460,7 @@
           <p:cNvPr id="16" name="">
             <a:extLst xmlns:a="http://schemas.openxmlformats.org/drawingml/2006/main">
               <a:ext uri="{FF2B5EF4-FFF2-40B4-BE49-F238E27FC236}">
-                <a16:creationId xmlns:a16="http://schemas.microsoft.com/office/drawing/2014/main" id="{98EB26B3-2348-46BB-A4D9-2000D7885FE0}"/>
+                <a16:creationId xmlns:a16="http://schemas.microsoft.com/office/drawing/2014/main" id="{B651C567-CB20-4EE7-B032-D32A35EB7231}"/>
               </a:ext>
             </a:extLst>
           </p:cNvPr>
@@ -10517,7 +10517,7 @@
           <p:cNvPr id="17" name="">
             <a:extLst xmlns:a="http://schemas.openxmlformats.org/drawingml/2006/main">
               <a:ext uri="{FF2B5EF4-FFF2-40B4-BE49-F238E27FC236}">
-                <a16:creationId xmlns:a16="http://schemas.microsoft.com/office/drawing/2014/main" id="{1DF23C6B-38BF-4CEF-AA96-7C95197787FD}"/>
+                <a16:creationId xmlns:a16="http://schemas.microsoft.com/office/drawing/2014/main" id="{51F800E4-7B55-42BA-9011-3638A92FB5A6}"/>
               </a:ext>
             </a:extLst>
           </p:cNvPr>
@@ -10552,7 +10552,7 @@
           <p:cNvPr id="18" name="">
             <a:extLst xmlns:a="http://schemas.openxmlformats.org/drawingml/2006/main">
               <a:ext uri="{FF2B5EF4-FFF2-40B4-BE49-F238E27FC236}">
-                <a16:creationId xmlns:a16="http://schemas.microsoft.com/office/drawing/2014/main" id="{1781CC5E-E8B0-44F4-B369-5447F00046AD}"/>
+                <a16:creationId xmlns:a16="http://schemas.microsoft.com/office/drawing/2014/main" id="{7ECAE1C0-F73F-494F-900C-3B532890228C}"/>
               </a:ext>
             </a:extLst>
           </p:cNvPr>
@@ -10616,7 +10616,7 @@
           <p:cNvPr id="19" name="">
             <a:extLst xmlns:a="http://schemas.openxmlformats.org/drawingml/2006/main">
               <a:ext uri="{FF2B5EF4-FFF2-40B4-BE49-F238E27FC236}">
-                <a16:creationId xmlns:a16="http://schemas.microsoft.com/office/drawing/2014/main" id="{6A08E6D9-3FCD-4259-BCBD-9B79DDFBCC49}"/>
+                <a16:creationId xmlns:a16="http://schemas.microsoft.com/office/drawing/2014/main" id="{D405A962-82F9-46CC-BB8D-72F9392355D1}"/>
               </a:ext>
             </a:extLst>
           </p:cNvPr>
@@ -10673,7 +10673,7 @@
           <p:cNvPr id="20" name="">
             <a:extLst xmlns:a="http://schemas.openxmlformats.org/drawingml/2006/main">
               <a:ext uri="{FF2B5EF4-FFF2-40B4-BE49-F238E27FC236}">
-                <a16:creationId xmlns:a16="http://schemas.microsoft.com/office/drawing/2014/main" id="{ACA68395-2EC1-4FFF-8E59-053A1C0B0FD2}"/>
+                <a16:creationId xmlns:a16="http://schemas.microsoft.com/office/drawing/2014/main" id="{16CDF108-4BE2-44F6-B176-EC9C0BE71EEE}"/>
               </a:ext>
             </a:extLst>
           </p:cNvPr>
@@ -10708,7 +10708,7 @@
           <p:cNvPr id="21" name="">
             <a:extLst xmlns:a="http://schemas.openxmlformats.org/drawingml/2006/main">
               <a:ext uri="{FF2B5EF4-FFF2-40B4-BE49-F238E27FC236}">
-                <a16:creationId xmlns:a16="http://schemas.microsoft.com/office/drawing/2014/main" id="{C027C301-2F00-4B1B-AAEC-6E5A1ABFF1C6}"/>
+                <a16:creationId xmlns:a16="http://schemas.microsoft.com/office/drawing/2014/main" id="{67304251-5D2B-4345-8C30-DDBBFEEC40CC}"/>
               </a:ext>
             </a:extLst>
           </p:cNvPr>
@@ -10765,7 +10765,7 @@
           <p:cNvPr id="22" name="">
             <a:extLst xmlns:a="http://schemas.openxmlformats.org/drawingml/2006/main">
               <a:ext uri="{FF2B5EF4-FFF2-40B4-BE49-F238E27FC236}">
-                <a16:creationId xmlns:a16="http://schemas.microsoft.com/office/drawing/2014/main" id="{1B588AB4-08A0-4AF6-A697-BA7FC4F35C2F}"/>
+                <a16:creationId xmlns:a16="http://schemas.microsoft.com/office/drawing/2014/main" id="{A9AD6359-2F71-4A53-BB57-AB0BF1F63731}"/>
               </a:ext>
             </a:extLst>
           </p:cNvPr>
@@ -10829,7 +10829,7 @@
           <p:cNvPr id="23" name="">
             <a:extLst xmlns:a="http://schemas.openxmlformats.org/drawingml/2006/main">
               <a:ext uri="{FF2B5EF4-FFF2-40B4-BE49-F238E27FC236}">
-                <a16:creationId xmlns:a16="http://schemas.microsoft.com/office/drawing/2014/main" id="{CC86ADF7-2F90-4CA5-A373-B437C1DA9383}"/>
+                <a16:creationId xmlns:a16="http://schemas.microsoft.com/office/drawing/2014/main" id="{B8D4D4AD-D2B2-4BAF-87B0-F790C466EAD2}"/>
               </a:ext>
             </a:extLst>
           </p:cNvPr>
@@ -10876,7 +10876,7 @@
                 <a:ea typeface="Arial"/>
                 <a:cs typeface="Arial"/>
               </a:rPr>
-              <a:t>Bỏ index.html mặc định</a:t>
+              <a:t>Quay Verify production</a:t>
             </a:r>
           </a:p>
         </p:txBody>
@@ -10886,7 +10886,7 @@
           <p:cNvPr id="24" name="">
             <a:extLst xmlns:a="http://schemas.openxmlformats.org/drawingml/2006/main">
               <a:ext uri="{FF2B5EF4-FFF2-40B4-BE49-F238E27FC236}">
-                <a16:creationId xmlns:a16="http://schemas.microsoft.com/office/drawing/2014/main" id="{FE60A925-2F94-4934-879F-323996C5A3FF}"/>
+                <a16:creationId xmlns:a16="http://schemas.microsoft.com/office/drawing/2014/main" id="{0E175079-2038-4B6B-84D4-1E0F363C60D4}"/>
               </a:ext>
             </a:extLst>
           </p:cNvPr>
@@ -10950,7 +10950,7 @@
           <p:cNvPr id="25" name="">
             <a:extLst xmlns:a="http://schemas.openxmlformats.org/drawingml/2006/main">
               <a:ext uri="{FF2B5EF4-FFF2-40B4-BE49-F238E27FC236}">
-                <a16:creationId xmlns:a16="http://schemas.microsoft.com/office/drawing/2014/main" id="{160AD995-690C-4D45-815B-0B3E3D922130}"/>
+                <a16:creationId xmlns:a16="http://schemas.microsoft.com/office/drawing/2014/main" id="{DEBE82E0-BE2E-47F7-9335-DB977892C534}"/>
               </a:ext>
             </a:extLst>
           </p:cNvPr>
@@ -10997,7 +10997,7 @@
                 <a:ea typeface="Arial"/>
                 <a:cs typeface="Arial"/>
               </a:rPr>
-              <a:t>Smoke 1 ảnh + Verify 1 lượt</a:t>
+              <a:t>Demo quản lý + Audit</a:t>
             </a:r>
           </a:p>
         </p:txBody>
@@ -11007,7 +11007,7 @@
           <p:cNvPr id="26" name="">
             <a:extLst xmlns:a="http://schemas.openxmlformats.org/drawingml/2006/main">
               <a:ext uri="{FF2B5EF4-FFF2-40B4-BE49-F238E27FC236}">
-                <a16:creationId xmlns:a16="http://schemas.microsoft.com/office/drawing/2014/main" id="{E998C01A-F98A-4E2A-8721-32975B8E58C3}"/>
+                <a16:creationId xmlns:a16="http://schemas.microsoft.com/office/drawing/2014/main" id="{AAD11F11-361C-44DD-8509-8BAF0D1B9F33}"/>
               </a:ext>
             </a:extLst>
           </p:cNvPr>
@@ -11071,7 +11071,7 @@
           <p:cNvPr id="27" name="">
             <a:extLst xmlns:a="http://schemas.openxmlformats.org/drawingml/2006/main">
               <a:ext uri="{FF2B5EF4-FFF2-40B4-BE49-F238E27FC236}">
-                <a16:creationId xmlns:a16="http://schemas.microsoft.com/office/drawing/2014/main" id="{3DC206DC-3F96-4348-BBDD-B69FCDBC0532}"/>
+                <a16:creationId xmlns:a16="http://schemas.microsoft.com/office/drawing/2014/main" id="{83B1CDE2-F3C5-4FE5-93DB-A70F62150EA5}"/>
               </a:ext>
             </a:extLst>
           </p:cNvPr>
@@ -11118,7 +11118,7 @@
                 <a:ea typeface="Arial"/>
                 <a:cs typeface="Arial"/>
               </a:rPr>
-              <a:t>Quay video &lt; 3 phút</a:t>
+              <a:t>Video dưới 3 phút</a:t>
             </a:r>
           </a:p>
         </p:txBody>
@@ -11128,7 +11128,7 @@
           <p:cNvPr id="28" name="">
             <a:extLst xmlns:a="http://schemas.openxmlformats.org/drawingml/2006/main">
               <a:ext uri="{FF2B5EF4-FFF2-40B4-BE49-F238E27FC236}">
-                <a16:creationId xmlns:a16="http://schemas.microsoft.com/office/drawing/2014/main" id="{1388FFBE-7FC2-4146-BC5E-9A454CDB29FA}"/>
+                <a16:creationId xmlns:a16="http://schemas.microsoft.com/office/drawing/2014/main" id="{ACDF986E-B418-4779-A025-2B0645A52758}"/>
               </a:ext>
             </a:extLst>
           </p:cNvPr>
@@ -11192,7 +11192,7 @@
           <p:cNvPr id="29" name="">
             <a:extLst xmlns:a="http://schemas.openxmlformats.org/drawingml/2006/main">
               <a:ext uri="{FF2B5EF4-FFF2-40B4-BE49-F238E27FC236}">
-                <a16:creationId xmlns:a16="http://schemas.microsoft.com/office/drawing/2014/main" id="{F5554AA1-E385-41DD-8F5A-3B28DD26C157}"/>
+                <a16:creationId xmlns:a16="http://schemas.microsoft.com/office/drawing/2014/main" id="{4D0CBCD3-1586-4749-9DE7-E7F4505BE0AE}"/>
               </a:ext>
             </a:extLst>
           </p:cNvPr>
@@ -11239,7 +11239,7 @@
                 <a:ea typeface="Arial"/>
                 <a:cs typeface="Arial"/>
               </a:rPr>
-              <a:t>Gắn link video vào form</a:t>
+              <a:t>Điền đủ 3 URL nộp</a:t>
             </a:r>
           </a:p>
         </p:txBody>
@@ -11249,7 +11249,7 @@
           <p:cNvPr id="30" name="">
             <a:extLst xmlns:a="http://schemas.openxmlformats.org/drawingml/2006/main">
               <a:ext uri="{FF2B5EF4-FFF2-40B4-BE49-F238E27FC236}">
-                <a16:creationId xmlns:a16="http://schemas.microsoft.com/office/drawing/2014/main" id="{52B553E7-221D-4AE2-A6AE-956E9E0DAB85}"/>
+                <a16:creationId xmlns:a16="http://schemas.microsoft.com/office/drawing/2014/main" id="{27565FC9-14AB-431D-897B-5ACC314D168F}"/>
               </a:ext>
             </a:extLst>
           </p:cNvPr>
@@ -11284,7 +11284,7 @@
           <p:cNvPr id="31" name="">
             <a:extLst xmlns:a="http://schemas.openxmlformats.org/drawingml/2006/main">
               <a:ext uri="{FF2B5EF4-FFF2-40B4-BE49-F238E27FC236}">
-                <a16:creationId xmlns:a16="http://schemas.microsoft.com/office/drawing/2014/main" id="{3738278F-DFBB-4C35-BEED-EA1AA93E8586}"/>
+                <a16:creationId xmlns:a16="http://schemas.microsoft.com/office/drawing/2014/main" id="{9DD8B4A0-D08E-4798-86B0-D0D57EB9608B}"/>
               </a:ext>
             </a:extLst>
           </p:cNvPr>
@@ -11341,7 +11341,7 @@
           <p:cNvPr id="32" name="">
             <a:extLst xmlns:a="http://schemas.openxmlformats.org/drawingml/2006/main">
               <a:ext uri="{FF2B5EF4-FFF2-40B4-BE49-F238E27FC236}">
-                <a16:creationId xmlns:a16="http://schemas.microsoft.com/office/drawing/2014/main" id="{148FCED5-CE36-4A64-A95A-5B325797314A}"/>
+                <a16:creationId xmlns:a16="http://schemas.microsoft.com/office/drawing/2014/main" id="{3F5780A6-FC8B-40BF-99C4-3843CC1DED00}"/>
               </a:ext>
             </a:extLst>
           </p:cNvPr>
@@ -11444,7 +11444,7 @@
           <p:cNvPr id="33" name="">
             <a:extLst xmlns:a="http://schemas.openxmlformats.org/drawingml/2006/main">
               <a:ext uri="{FF2B5EF4-FFF2-40B4-BE49-F238E27FC236}">
-                <a16:creationId xmlns:a16="http://schemas.microsoft.com/office/drawing/2014/main" id="{7FA73D5B-BB5C-42F4-B266-140CE3AB7DC5}"/>
+                <a16:creationId xmlns:a16="http://schemas.microsoft.com/office/drawing/2014/main" id="{303DF588-FBCA-436C-A812-0867E01093E5}"/>
               </a:ext>
             </a:extLst>
           </p:cNvPr>
@@ -11501,7 +11501,7 @@
           <p:cNvPr id="34" name="">
             <a:extLst xmlns:a="http://schemas.openxmlformats.org/drawingml/2006/main">
               <a:ext uri="{FF2B5EF4-FFF2-40B4-BE49-F238E27FC236}">
-                <a16:creationId xmlns:a16="http://schemas.microsoft.com/office/drawing/2014/main" id="{3B402C1C-2931-43B2-8C4E-EAA7D80B033E}"/>
+                <a16:creationId xmlns:a16="http://schemas.microsoft.com/office/drawing/2014/main" id="{0631E212-8155-4394-ACDC-75994D5E3707}"/>
               </a:ext>
             </a:extLst>
           </p:cNvPr>
@@ -11558,7 +11558,7 @@
           <p:cNvPr id="35" name="">
             <a:extLst xmlns:a="http://schemas.openxmlformats.org/drawingml/2006/main">
               <a:ext uri="{FF2B5EF4-FFF2-40B4-BE49-F238E27FC236}">
-                <a16:creationId xmlns:a16="http://schemas.microsoft.com/office/drawing/2014/main" id="{05C65A85-F475-426E-BAB9-0F0E60C88059}"/>
+                <a16:creationId xmlns:a16="http://schemas.microsoft.com/office/drawing/2014/main" id="{4848E8FA-289E-4430-9082-219EBE5BC6EE}"/>
               </a:ext>
             </a:extLst>
           </p:cNvPr>
@@ -11613,7 +11613,7 @@
     </p:spTree>
     <p:extLst>
       <p:ext uri="{BB962C8B-B14F-4D97-AF65-F5344CB8AC3E}">
-        <p14:creationId xmlns:p14="http://schemas.microsoft.com/office/powerpoint/2010/main" val="2092116023"/>
+        <p14:creationId xmlns:p14="http://schemas.microsoft.com/office/powerpoint/2010/main" val="2122155869"/>
       </p:ext>
     </p:extLst>
   </p:cSld>

</xml_diff>

<commit_message>
docs: refresh submission slides and build log
</commit_message>
<xml_diff>
--- a/AURA/submission/AURA_5_SLIDES.pptx
+++ b/AURA/submission/AURA_5_SLIDES.pptx
@@ -2,17 +2,17 @@
 <file path=ppt/presentation.xml><?xml version="1.0" encoding="utf-8"?>
 <p:presentation xmlns:p="http://schemas.openxmlformats.org/presentationml/2006/main">
   <p:sldMasterIdLst>
-    <p:sldMasterId xmlns:r="http://schemas.openxmlformats.org/officeDocument/2006/relationships" id="2147483648" r:id="R9aa742d8292642fd"/>
+    <p:sldMasterId xmlns:r="http://schemas.openxmlformats.org/officeDocument/2006/relationships" id="2147483648" r:id="R49e57d9d7d7d4d6e"/>
   </p:sldMasterIdLst>
   <p:notesMasterIdLst>
-    <p:notesMasterId xmlns:r="http://schemas.openxmlformats.org/officeDocument/2006/relationships" r:id="R64cc69ad1bfc401d"/>
+    <p:notesMasterId xmlns:r="http://schemas.openxmlformats.org/officeDocument/2006/relationships" r:id="R8bb450e2763846a6"/>
   </p:notesMasterIdLst>
   <p:sldIdLst>
-    <p:sldId xmlns:r="http://schemas.openxmlformats.org/officeDocument/2006/relationships" id="256" r:id="R8d58b26c3ea14173"/>
-    <p:sldId xmlns:r="http://schemas.openxmlformats.org/officeDocument/2006/relationships" id="257" r:id="R967f463ccb154d17"/>
-    <p:sldId xmlns:r="http://schemas.openxmlformats.org/officeDocument/2006/relationships" id="258" r:id="Rf6af5872248a4499"/>
-    <p:sldId xmlns:r="http://schemas.openxmlformats.org/officeDocument/2006/relationships" id="259" r:id="R96a9de3006944746"/>
-    <p:sldId xmlns:r="http://schemas.openxmlformats.org/officeDocument/2006/relationships" id="260" r:id="R7ba59433a4214c14"/>
+    <p:sldId xmlns:r="http://schemas.openxmlformats.org/officeDocument/2006/relationships" id="256" r:id="Ref908b6a4dae4350"/>
+    <p:sldId xmlns:r="http://schemas.openxmlformats.org/officeDocument/2006/relationships" id="257" r:id="Rff67534619194122"/>
+    <p:sldId xmlns:r="http://schemas.openxmlformats.org/officeDocument/2006/relationships" id="258" r:id="Ra23dd9606c9a4dbe"/>
+    <p:sldId xmlns:r="http://schemas.openxmlformats.org/officeDocument/2006/relationships" id="259" r:id="R49c145e2bc5148eb"/>
+    <p:sldId xmlns:r="http://schemas.openxmlformats.org/officeDocument/2006/relationships" id="260" r:id="R2e44849f8dc94be2"/>
   </p:sldIdLst>
   <p:sldSz cx="12192000" cy="6858000"/>
   <p:notesSz cx="6858000" cy="9144000"/>
@@ -586,7 +586,7 @@
           <a:lstStyle xmlns:a="http://schemas.openxmlformats.org/drawingml/2006/main"/>
           <a:p xmlns:a="http://schemas.openxmlformats.org/drawingml/2006/main">
             <a:r>
-              <a:t>Nguồn nội bộ: 54 test offline; người dùng xác nhận Verify v2 5/5 local ngày 22/09/2026. Không suy rộng thành accuracy thực tế.</a:t>
+              <a:t>Nguồn nội bộ: 56 test offline; người dùng xác nhận Verify v2 5/5 local ngày 22/09/2026. Không suy rộng thành accuracy thực tế.</a:t>
             </a:r>
           </a:p>
         </p:txBody>
@@ -656,7 +656,7 @@
           <a:lstStyle xmlns:a="http://schemas.openxmlformats.org/drawingml/2006/main"/>
           <a:p xmlns:a="http://schemas.openxmlformats.org/drawingml/2006/main">
             <a:r>
-              <a:t>Repository: https://github.com/BondPhuPhamzZ/AURA — Live URL: https://bondphupham-001-site1.ltempurl.com/</a:t>
+              <a:t>Repository và hướng dẫn chạy localhost: https://github.com/BondPhuPhamzZ/AURA</a:t>
             </a:r>
           </a:p>
         </p:txBody>
@@ -794,7 +794,7 @@
   </p:cSld>
   <p:clrMap bg1="lt1" tx1="dk1" bg2="lt2" tx2="dk2" accent1="accent1" accent2="accent2" accent3="accent3" accent4="accent4" accent5="accent5" accent6="accent6" hlink="hlink" folHlink="folHlink"/>
   <p:sldLayoutIdLst>
-    <p:sldLayoutId xmlns:r="http://schemas.openxmlformats.org/officeDocument/2006/relationships" id="2147483649" r:id="R8f26aa32d54e4813"/>
+    <p:sldLayoutId xmlns:r="http://schemas.openxmlformats.org/officeDocument/2006/relationships" id="2147483649" r:id="Re36b331a80a74c6c"/>
   </p:sldLayoutIdLst>
   <p:txStyles>
     <p:titleStyle>
@@ -1345,7 +1345,7 @@
           <p:cNvPr id="47" name="">
             <a:extLst xmlns:a="http://schemas.openxmlformats.org/drawingml/2006/main">
               <a:ext uri="{FF2B5EF4-FFF2-40B4-BE49-F238E27FC236}">
-                <a16:creationId xmlns:a16="http://schemas.microsoft.com/office/drawing/2014/main" id="{CC727313-801F-4D4C-8D2D-C71D1D675E7B}"/>
+                <a16:creationId xmlns:a16="http://schemas.microsoft.com/office/drawing/2014/main" id="{02C39A8B-6EB9-4682-88EC-0EE753A623F9}"/>
               </a:ext>
             </a:extLst>
           </p:cNvPr>
@@ -1402,7 +1402,7 @@
           <p:cNvPr id="2" name="">
             <a:extLst xmlns:a="http://schemas.openxmlformats.org/drawingml/2006/main">
               <a:ext uri="{FF2B5EF4-FFF2-40B4-BE49-F238E27FC236}">
-                <a16:creationId xmlns:a16="http://schemas.microsoft.com/office/drawing/2014/main" id="{0E8AAAF3-6FBA-47D1-86EC-77B05DFB9CA4}"/>
+                <a16:creationId xmlns:a16="http://schemas.microsoft.com/office/drawing/2014/main" id="{F662F884-9438-446D-8C18-835683342478}"/>
               </a:ext>
             </a:extLst>
           </p:cNvPr>
@@ -1459,7 +1459,7 @@
           <p:cNvPr id="3" name="">
             <a:extLst xmlns:a="http://schemas.openxmlformats.org/drawingml/2006/main">
               <a:ext uri="{FF2B5EF4-FFF2-40B4-BE49-F238E27FC236}">
-                <a16:creationId xmlns:a16="http://schemas.microsoft.com/office/drawing/2014/main" id="{86A881C0-4901-40B9-8A42-8893DD601C0D}"/>
+                <a16:creationId xmlns:a16="http://schemas.microsoft.com/office/drawing/2014/main" id="{C7B47E80-B370-44C1-A390-2319A632C6EE}"/>
               </a:ext>
             </a:extLst>
           </p:cNvPr>
@@ -1516,7 +1516,7 @@
           <p:cNvPr id="4" name="">
             <a:extLst xmlns:a="http://schemas.openxmlformats.org/drawingml/2006/main">
               <a:ext uri="{FF2B5EF4-FFF2-40B4-BE49-F238E27FC236}">
-                <a16:creationId xmlns:a16="http://schemas.microsoft.com/office/drawing/2014/main" id="{E6EAFFD0-3C7B-4657-AC9C-45675CC3957D}"/>
+                <a16:creationId xmlns:a16="http://schemas.microsoft.com/office/drawing/2014/main" id="{8384F392-4F55-4A5E-9597-5551C135325E}"/>
               </a:ext>
             </a:extLst>
           </p:cNvPr>
@@ -1547,7 +1547,7 @@
           <p:cNvPr id="5" name="">
             <a:extLst xmlns:a="http://schemas.openxmlformats.org/drawingml/2006/main">
               <a:ext uri="{FF2B5EF4-FFF2-40B4-BE49-F238E27FC236}">
-                <a16:creationId xmlns:a16="http://schemas.microsoft.com/office/drawing/2014/main" id="{7BCCBCE0-7EFA-4305-8B31-DC7F991404E1}"/>
+                <a16:creationId xmlns:a16="http://schemas.microsoft.com/office/drawing/2014/main" id="{DF002452-E360-4D9E-A7E3-52CFB0B923B5}"/>
               </a:ext>
             </a:extLst>
           </p:cNvPr>
@@ -1582,7 +1582,7 @@
           <p:cNvPr id="6" name="">
             <a:extLst xmlns:a="http://schemas.openxmlformats.org/drawingml/2006/main">
               <a:ext uri="{FF2B5EF4-FFF2-40B4-BE49-F238E27FC236}">
-                <a16:creationId xmlns:a16="http://schemas.microsoft.com/office/drawing/2014/main" id="{7881B686-FF36-401A-9AA6-7A54C8B5BB1F}"/>
+                <a16:creationId xmlns:a16="http://schemas.microsoft.com/office/drawing/2014/main" id="{2F63ED11-395C-4AE9-B64D-38FC2FDAE2B9}"/>
               </a:ext>
             </a:extLst>
           </p:cNvPr>
@@ -1646,7 +1646,7 @@
           <p:cNvPr id="7" name="">
             <a:extLst xmlns:a="http://schemas.openxmlformats.org/drawingml/2006/main">
               <a:ext uri="{FF2B5EF4-FFF2-40B4-BE49-F238E27FC236}">
-                <a16:creationId xmlns:a16="http://schemas.microsoft.com/office/drawing/2014/main" id="{4E48C246-5046-49AF-903E-C47A89451A56}"/>
+                <a16:creationId xmlns:a16="http://schemas.microsoft.com/office/drawing/2014/main" id="{EE7FD7E6-C933-4A81-9640-2EF6BDE0E917}"/>
               </a:ext>
             </a:extLst>
           </p:cNvPr>
@@ -1703,7 +1703,7 @@
           <p:cNvPr id="8" name="">
             <a:extLst xmlns:a="http://schemas.openxmlformats.org/drawingml/2006/main">
               <a:ext uri="{FF2B5EF4-FFF2-40B4-BE49-F238E27FC236}">
-                <a16:creationId xmlns:a16="http://schemas.microsoft.com/office/drawing/2014/main" id="{13494BB4-FB75-45C8-9F2A-595C121A59C5}"/>
+                <a16:creationId xmlns:a16="http://schemas.microsoft.com/office/drawing/2014/main" id="{549D8A33-42B6-409A-8FD6-538FC4ACEA74}"/>
               </a:ext>
             </a:extLst>
           </p:cNvPr>
@@ -1760,7 +1760,7 @@
           <p:cNvPr id="9" name="">
             <a:extLst xmlns:a="http://schemas.openxmlformats.org/drawingml/2006/main">
               <a:ext uri="{FF2B5EF4-FFF2-40B4-BE49-F238E27FC236}">
-                <a16:creationId xmlns:a16="http://schemas.microsoft.com/office/drawing/2014/main" id="{C6FE9419-7B99-44E6-BD31-A5D93A1C4798}"/>
+                <a16:creationId xmlns:a16="http://schemas.microsoft.com/office/drawing/2014/main" id="{2CBA1DC6-1500-42AC-B869-401A2557ACFA}"/>
               </a:ext>
             </a:extLst>
           </p:cNvPr>
@@ -1792,7 +1792,7 @@
           <p:cNvPr id="10" name="">
             <a:extLst xmlns:a="http://schemas.openxmlformats.org/drawingml/2006/main">
               <a:ext uri="{FF2B5EF4-FFF2-40B4-BE49-F238E27FC236}">
-                <a16:creationId xmlns:a16="http://schemas.microsoft.com/office/drawing/2014/main" id="{69D8843A-DD8E-4DB5-B167-D4B1F6360FA3}"/>
+                <a16:creationId xmlns:a16="http://schemas.microsoft.com/office/drawing/2014/main" id="{0988A4F1-F0D3-40C1-9A87-F6DA10909409}"/>
               </a:ext>
             </a:extLst>
           </p:cNvPr>
@@ -1827,7 +1827,7 @@
           <p:cNvPr id="11" name="">
             <a:extLst xmlns:a="http://schemas.openxmlformats.org/drawingml/2006/main">
               <a:ext uri="{FF2B5EF4-FFF2-40B4-BE49-F238E27FC236}">
-                <a16:creationId xmlns:a16="http://schemas.microsoft.com/office/drawing/2014/main" id="{E794F6DB-25F3-4E03-9167-5CDF3D3A276E}"/>
+                <a16:creationId xmlns:a16="http://schemas.microsoft.com/office/drawing/2014/main" id="{FB306973-1482-44C3-AFF1-EB4EFF8AAAFB}"/>
               </a:ext>
             </a:extLst>
           </p:cNvPr>
@@ -1891,7 +1891,7 @@
           <p:cNvPr id="12" name="">
             <a:extLst xmlns:a="http://schemas.openxmlformats.org/drawingml/2006/main">
               <a:ext uri="{FF2B5EF4-FFF2-40B4-BE49-F238E27FC236}">
-                <a16:creationId xmlns:a16="http://schemas.microsoft.com/office/drawing/2014/main" id="{26C2043A-78FA-4D92-8F1C-A2A645CD91C1}"/>
+                <a16:creationId xmlns:a16="http://schemas.microsoft.com/office/drawing/2014/main" id="{7241FF7C-8FE7-4B31-8360-E56109FF78A4}"/>
               </a:ext>
             </a:extLst>
           </p:cNvPr>
@@ -1948,7 +1948,7 @@
           <p:cNvPr id="13" name="">
             <a:extLst xmlns:a="http://schemas.openxmlformats.org/drawingml/2006/main">
               <a:ext uri="{FF2B5EF4-FFF2-40B4-BE49-F238E27FC236}">
-                <a16:creationId xmlns:a16="http://schemas.microsoft.com/office/drawing/2014/main" id="{8F0AC78A-1904-46EE-8A9C-8B2F06720840}"/>
+                <a16:creationId xmlns:a16="http://schemas.microsoft.com/office/drawing/2014/main" id="{C5C02DFA-A07B-4DD5-8971-6AE031EE3C0C}"/>
               </a:ext>
             </a:extLst>
           </p:cNvPr>
@@ -2005,7 +2005,7 @@
           <p:cNvPr id="14" name="">
             <a:extLst xmlns:a="http://schemas.openxmlformats.org/drawingml/2006/main">
               <a:ext uri="{FF2B5EF4-FFF2-40B4-BE49-F238E27FC236}">
-                <a16:creationId xmlns:a16="http://schemas.microsoft.com/office/drawing/2014/main" id="{0E7AA31E-1E85-493F-B281-CF48893B5647}"/>
+                <a16:creationId xmlns:a16="http://schemas.microsoft.com/office/drawing/2014/main" id="{CE9F044F-C190-44EC-BC4C-884D1B87899B}"/>
               </a:ext>
             </a:extLst>
           </p:cNvPr>
@@ -2037,7 +2037,7 @@
           <p:cNvPr id="15" name="">
             <a:extLst xmlns:a="http://schemas.openxmlformats.org/drawingml/2006/main">
               <a:ext uri="{FF2B5EF4-FFF2-40B4-BE49-F238E27FC236}">
-                <a16:creationId xmlns:a16="http://schemas.microsoft.com/office/drawing/2014/main" id="{54483989-B2A4-4600-A2EA-43A73406AE58}"/>
+                <a16:creationId xmlns:a16="http://schemas.microsoft.com/office/drawing/2014/main" id="{3AF93C1D-4BE1-4FA5-8E44-BD5C9BB46801}"/>
               </a:ext>
             </a:extLst>
           </p:cNvPr>
@@ -2072,7 +2072,7 @@
           <p:cNvPr id="16" name="">
             <a:extLst xmlns:a="http://schemas.openxmlformats.org/drawingml/2006/main">
               <a:ext uri="{FF2B5EF4-FFF2-40B4-BE49-F238E27FC236}">
-                <a16:creationId xmlns:a16="http://schemas.microsoft.com/office/drawing/2014/main" id="{D8DE1A81-36DD-4DFC-B5E8-BCF7D311D4E6}"/>
+                <a16:creationId xmlns:a16="http://schemas.microsoft.com/office/drawing/2014/main" id="{30EA2332-8514-43F8-B481-82E2543F78FB}"/>
               </a:ext>
             </a:extLst>
           </p:cNvPr>
@@ -2136,7 +2136,7 @@
           <p:cNvPr id="17" name="">
             <a:extLst xmlns:a="http://schemas.openxmlformats.org/drawingml/2006/main">
               <a:ext uri="{FF2B5EF4-FFF2-40B4-BE49-F238E27FC236}">
-                <a16:creationId xmlns:a16="http://schemas.microsoft.com/office/drawing/2014/main" id="{2FFFF75C-4F5E-44D3-936C-5A8AC6B16186}"/>
+                <a16:creationId xmlns:a16="http://schemas.microsoft.com/office/drawing/2014/main" id="{921FCE40-AD5A-4979-A693-78658B9ABCE2}"/>
               </a:ext>
             </a:extLst>
           </p:cNvPr>
@@ -2193,7 +2193,7 @@
           <p:cNvPr id="18" name="">
             <a:extLst xmlns:a="http://schemas.openxmlformats.org/drawingml/2006/main">
               <a:ext uri="{FF2B5EF4-FFF2-40B4-BE49-F238E27FC236}">
-                <a16:creationId xmlns:a16="http://schemas.microsoft.com/office/drawing/2014/main" id="{15EF5A83-7F11-495F-8E85-5FE6DDC6F1AD}"/>
+                <a16:creationId xmlns:a16="http://schemas.microsoft.com/office/drawing/2014/main" id="{C453EE81-BD66-4BE1-8AEB-4617EAB9E97D}"/>
               </a:ext>
             </a:extLst>
           </p:cNvPr>
@@ -2250,7 +2250,7 @@
           <p:cNvPr id="19" name="">
             <a:extLst xmlns:a="http://schemas.openxmlformats.org/drawingml/2006/main">
               <a:ext uri="{FF2B5EF4-FFF2-40B4-BE49-F238E27FC236}">
-                <a16:creationId xmlns:a16="http://schemas.microsoft.com/office/drawing/2014/main" id="{8FD06FB0-C586-4ABD-8B7A-7E01E465C79C}"/>
+                <a16:creationId xmlns:a16="http://schemas.microsoft.com/office/drawing/2014/main" id="{5CEF3DAC-5BCD-4823-A10D-4F18B18A6AAB}"/>
               </a:ext>
             </a:extLst>
           </p:cNvPr>
@@ -2282,7 +2282,7 @@
           <p:cNvPr id="20" name="">
             <a:extLst xmlns:a="http://schemas.openxmlformats.org/drawingml/2006/main">
               <a:ext uri="{FF2B5EF4-FFF2-40B4-BE49-F238E27FC236}">
-                <a16:creationId xmlns:a16="http://schemas.microsoft.com/office/drawing/2014/main" id="{96F07508-5904-46F1-AD70-1F9CD97292E5}"/>
+                <a16:creationId xmlns:a16="http://schemas.microsoft.com/office/drawing/2014/main" id="{5A293C93-293E-43A5-A1D4-D6221A171881}"/>
               </a:ext>
             </a:extLst>
           </p:cNvPr>
@@ -2317,7 +2317,7 @@
           <p:cNvPr id="21" name="">
             <a:extLst xmlns:a="http://schemas.openxmlformats.org/drawingml/2006/main">
               <a:ext uri="{FF2B5EF4-FFF2-40B4-BE49-F238E27FC236}">
-                <a16:creationId xmlns:a16="http://schemas.microsoft.com/office/drawing/2014/main" id="{D71F3925-A66F-4F23-95CE-FC22975991CA}"/>
+                <a16:creationId xmlns:a16="http://schemas.microsoft.com/office/drawing/2014/main" id="{42234300-7CC0-4950-8FBC-29291D30E2F6}"/>
               </a:ext>
             </a:extLst>
           </p:cNvPr>
@@ -2381,7 +2381,7 @@
           <p:cNvPr id="22" name="">
             <a:extLst xmlns:a="http://schemas.openxmlformats.org/drawingml/2006/main">
               <a:ext uri="{FF2B5EF4-FFF2-40B4-BE49-F238E27FC236}">
-                <a16:creationId xmlns:a16="http://schemas.microsoft.com/office/drawing/2014/main" id="{97BED112-0666-4167-9C8A-99E815A1EBDB}"/>
+                <a16:creationId xmlns:a16="http://schemas.microsoft.com/office/drawing/2014/main" id="{466362F6-A3D3-4116-B065-883165AF96A0}"/>
               </a:ext>
             </a:extLst>
           </p:cNvPr>
@@ -2438,7 +2438,7 @@
           <p:cNvPr id="23" name="">
             <a:extLst xmlns:a="http://schemas.openxmlformats.org/drawingml/2006/main">
               <a:ext uri="{FF2B5EF4-FFF2-40B4-BE49-F238E27FC236}">
-                <a16:creationId xmlns:a16="http://schemas.microsoft.com/office/drawing/2014/main" id="{4367FE42-1142-4249-B754-20CDA45E1EB1}"/>
+                <a16:creationId xmlns:a16="http://schemas.microsoft.com/office/drawing/2014/main" id="{AEBA6D66-6D78-4765-94AB-0E2CDB040665}"/>
               </a:ext>
             </a:extLst>
           </p:cNvPr>
@@ -2495,7 +2495,7 @@
           <p:cNvPr id="24" name="">
             <a:extLst xmlns:a="http://schemas.openxmlformats.org/drawingml/2006/main">
               <a:ext uri="{FF2B5EF4-FFF2-40B4-BE49-F238E27FC236}">
-                <a16:creationId xmlns:a16="http://schemas.microsoft.com/office/drawing/2014/main" id="{DFA60663-4F48-4429-9940-B7B16B77A70A}"/>
+                <a16:creationId xmlns:a16="http://schemas.microsoft.com/office/drawing/2014/main" id="{3E83A75B-29FC-4A88-B110-D67F40F3D151}"/>
               </a:ext>
             </a:extLst>
           </p:cNvPr>
@@ -2527,7 +2527,7 @@
           <p:cNvPr id="25" name="">
             <a:extLst xmlns:a="http://schemas.openxmlformats.org/drawingml/2006/main">
               <a:ext uri="{FF2B5EF4-FFF2-40B4-BE49-F238E27FC236}">
-                <a16:creationId xmlns:a16="http://schemas.microsoft.com/office/drawing/2014/main" id="{ECB31DFA-EACE-4377-8E58-337AEC13E1D7}"/>
+                <a16:creationId xmlns:a16="http://schemas.microsoft.com/office/drawing/2014/main" id="{5344217C-64E5-4AE7-A7AC-3DD313FCB61C}"/>
               </a:ext>
             </a:extLst>
           </p:cNvPr>
@@ -2562,7 +2562,7 @@
           <p:cNvPr id="26" name="">
             <a:extLst xmlns:a="http://schemas.openxmlformats.org/drawingml/2006/main">
               <a:ext uri="{FF2B5EF4-FFF2-40B4-BE49-F238E27FC236}">
-                <a16:creationId xmlns:a16="http://schemas.microsoft.com/office/drawing/2014/main" id="{07931E69-D633-4CFA-9FDA-B95E3230D72D}"/>
+                <a16:creationId xmlns:a16="http://schemas.microsoft.com/office/drawing/2014/main" id="{96CE968A-FFED-4AA7-99EF-B158D6B443BE}"/>
               </a:ext>
             </a:extLst>
           </p:cNvPr>
@@ -2626,7 +2626,7 @@
           <p:cNvPr id="27" name="">
             <a:extLst xmlns:a="http://schemas.openxmlformats.org/drawingml/2006/main">
               <a:ext uri="{FF2B5EF4-FFF2-40B4-BE49-F238E27FC236}">
-                <a16:creationId xmlns:a16="http://schemas.microsoft.com/office/drawing/2014/main" id="{3165E569-7508-419B-A629-3CE1EA93F6C8}"/>
+                <a16:creationId xmlns:a16="http://schemas.microsoft.com/office/drawing/2014/main" id="{8B0D9DC3-4852-4D28-91DB-2E7EC6892A1C}"/>
               </a:ext>
             </a:extLst>
           </p:cNvPr>
@@ -2683,7 +2683,7 @@
           <p:cNvPr id="28" name="">
             <a:extLst xmlns:a="http://schemas.openxmlformats.org/drawingml/2006/main">
               <a:ext uri="{FF2B5EF4-FFF2-40B4-BE49-F238E27FC236}">
-                <a16:creationId xmlns:a16="http://schemas.microsoft.com/office/drawing/2014/main" id="{98D23DE7-045E-4F07-A33A-3A96973CFAD5}"/>
+                <a16:creationId xmlns:a16="http://schemas.microsoft.com/office/drawing/2014/main" id="{7C567FE2-81AE-4137-BE98-2B1AD3B5EC41}"/>
               </a:ext>
             </a:extLst>
           </p:cNvPr>
@@ -2740,7 +2740,7 @@
           <p:cNvPr id="29" name="">
             <a:extLst xmlns:a="http://schemas.openxmlformats.org/drawingml/2006/main">
               <a:ext uri="{FF2B5EF4-FFF2-40B4-BE49-F238E27FC236}">
-                <a16:creationId xmlns:a16="http://schemas.microsoft.com/office/drawing/2014/main" id="{9F77F8A0-8809-417C-AD8E-EE2C745BD2CB}"/>
+                <a16:creationId xmlns:a16="http://schemas.microsoft.com/office/drawing/2014/main" id="{160CF755-A3D6-49DD-AF29-49DE3CF70378}"/>
               </a:ext>
             </a:extLst>
           </p:cNvPr>
@@ -2775,7 +2775,7 @@
           <p:cNvPr id="30" name="">
             <a:extLst xmlns:a="http://schemas.openxmlformats.org/drawingml/2006/main">
               <a:ext uri="{FF2B5EF4-FFF2-40B4-BE49-F238E27FC236}">
-                <a16:creationId xmlns:a16="http://schemas.microsoft.com/office/drawing/2014/main" id="{80D7A79B-FD57-4D42-819D-F6F0F618688E}"/>
+                <a16:creationId xmlns:a16="http://schemas.microsoft.com/office/drawing/2014/main" id="{D38430A0-A6C9-4824-B8D0-6BFB54052369}"/>
               </a:ext>
             </a:extLst>
           </p:cNvPr>
@@ -2832,7 +2832,7 @@
           <p:cNvPr id="31" name="">
             <a:extLst xmlns:a="http://schemas.openxmlformats.org/drawingml/2006/main">
               <a:ext uri="{FF2B5EF4-FFF2-40B4-BE49-F238E27FC236}">
-                <a16:creationId xmlns:a16="http://schemas.microsoft.com/office/drawing/2014/main" id="{B1485654-B7BD-42C6-B47A-45DF7F3BCE6E}"/>
+                <a16:creationId xmlns:a16="http://schemas.microsoft.com/office/drawing/2014/main" id="{3FAD40C1-422C-4080-BDD1-B7B1B556329D}"/>
               </a:ext>
             </a:extLst>
           </p:cNvPr>
@@ -2889,7 +2889,7 @@
           <p:cNvPr id="32" name="">
             <a:extLst xmlns:a="http://schemas.openxmlformats.org/drawingml/2006/main">
               <a:ext uri="{FF2B5EF4-FFF2-40B4-BE49-F238E27FC236}">
-                <a16:creationId xmlns:a16="http://schemas.microsoft.com/office/drawing/2014/main" id="{631F8DE2-A76B-46D4-8242-B7D8D4BBAB28}"/>
+                <a16:creationId xmlns:a16="http://schemas.microsoft.com/office/drawing/2014/main" id="{0C1C7061-31D1-42C1-BF9C-64B68A52FEE5}"/>
               </a:ext>
             </a:extLst>
           </p:cNvPr>
@@ -2946,7 +2946,7 @@
           <p:cNvPr id="33" name="">
             <a:extLst xmlns:a="http://schemas.openxmlformats.org/drawingml/2006/main">
               <a:ext uri="{FF2B5EF4-FFF2-40B4-BE49-F238E27FC236}">
-                <a16:creationId xmlns:a16="http://schemas.microsoft.com/office/drawing/2014/main" id="{1EF3BF1B-2D04-457E-9379-4E9E6F24BC4F}"/>
+                <a16:creationId xmlns:a16="http://schemas.microsoft.com/office/drawing/2014/main" id="{C044CAEB-47C2-4666-BB0E-33355DEB221B}"/>
               </a:ext>
             </a:extLst>
           </p:cNvPr>
@@ -2981,7 +2981,7 @@
           <p:cNvPr id="34" name="">
             <a:extLst xmlns:a="http://schemas.openxmlformats.org/drawingml/2006/main">
               <a:ext uri="{FF2B5EF4-FFF2-40B4-BE49-F238E27FC236}">
-                <a16:creationId xmlns:a16="http://schemas.microsoft.com/office/drawing/2014/main" id="{6FB7CABE-A208-48E9-B36A-B746E58D2594}"/>
+                <a16:creationId xmlns:a16="http://schemas.microsoft.com/office/drawing/2014/main" id="{56BD0E3C-8A33-48CA-82C1-BD7D4866737A}"/>
               </a:ext>
             </a:extLst>
           </p:cNvPr>
@@ -3045,7 +3045,7 @@
           <p:cNvPr id="35" name="">
             <a:extLst xmlns:a="http://schemas.openxmlformats.org/drawingml/2006/main">
               <a:ext uri="{FF2B5EF4-FFF2-40B4-BE49-F238E27FC236}">
-                <a16:creationId xmlns:a16="http://schemas.microsoft.com/office/drawing/2014/main" id="{00F50DAB-7B68-46CD-880A-7F0B36740A04}"/>
+                <a16:creationId xmlns:a16="http://schemas.microsoft.com/office/drawing/2014/main" id="{340FDFAA-D472-45C9-9B82-47550E15981F}"/>
               </a:ext>
             </a:extLst>
           </p:cNvPr>
@@ -3102,7 +3102,7 @@
           <p:cNvPr id="36" name="">
             <a:extLst xmlns:a="http://schemas.openxmlformats.org/drawingml/2006/main">
               <a:ext uri="{FF2B5EF4-FFF2-40B4-BE49-F238E27FC236}">
-                <a16:creationId xmlns:a16="http://schemas.microsoft.com/office/drawing/2014/main" id="{BFB0ADB8-58BE-4081-970C-EE25CE278F36}"/>
+                <a16:creationId xmlns:a16="http://schemas.microsoft.com/office/drawing/2014/main" id="{B175CA50-59F9-494C-B2A3-7B09BAC44043}"/>
               </a:ext>
             </a:extLst>
           </p:cNvPr>
@@ -3159,7 +3159,7 @@
           <p:cNvPr id="37" name="">
             <a:extLst xmlns:a="http://schemas.openxmlformats.org/drawingml/2006/main">
               <a:ext uri="{FF2B5EF4-FFF2-40B4-BE49-F238E27FC236}">
-                <a16:creationId xmlns:a16="http://schemas.microsoft.com/office/drawing/2014/main" id="{1E82A3CF-4517-4393-9D4F-A065A70760F2}"/>
+                <a16:creationId xmlns:a16="http://schemas.microsoft.com/office/drawing/2014/main" id="{2392930B-4F30-426A-A6AD-6C9CD3D05696}"/>
               </a:ext>
             </a:extLst>
           </p:cNvPr>
@@ -3194,7 +3194,7 @@
           <p:cNvPr id="38" name="">
             <a:extLst xmlns:a="http://schemas.openxmlformats.org/drawingml/2006/main">
               <a:ext uri="{FF2B5EF4-FFF2-40B4-BE49-F238E27FC236}">
-                <a16:creationId xmlns:a16="http://schemas.microsoft.com/office/drawing/2014/main" id="{222A2DB8-DB5B-47EB-AEDA-83E7343D7E78}"/>
+                <a16:creationId xmlns:a16="http://schemas.microsoft.com/office/drawing/2014/main" id="{28B4A403-E469-4388-8554-CA2161924BB2}"/>
               </a:ext>
             </a:extLst>
           </p:cNvPr>
@@ -3258,7 +3258,7 @@
           <p:cNvPr id="39" name="">
             <a:extLst xmlns:a="http://schemas.openxmlformats.org/drawingml/2006/main">
               <a:ext uri="{FF2B5EF4-FFF2-40B4-BE49-F238E27FC236}">
-                <a16:creationId xmlns:a16="http://schemas.microsoft.com/office/drawing/2014/main" id="{95DE6059-2F68-4687-8A81-39FB7CA19FA1}"/>
+                <a16:creationId xmlns:a16="http://schemas.microsoft.com/office/drawing/2014/main" id="{1E71C291-DF01-47CC-8374-5F532E17970F}"/>
               </a:ext>
             </a:extLst>
           </p:cNvPr>
@@ -3315,7 +3315,7 @@
           <p:cNvPr id="40" name="">
             <a:extLst xmlns:a="http://schemas.openxmlformats.org/drawingml/2006/main">
               <a:ext uri="{FF2B5EF4-FFF2-40B4-BE49-F238E27FC236}">
-                <a16:creationId xmlns:a16="http://schemas.microsoft.com/office/drawing/2014/main" id="{C8CDF437-C58F-45B5-B610-B633FA303A6C}"/>
+                <a16:creationId xmlns:a16="http://schemas.microsoft.com/office/drawing/2014/main" id="{24B6BDA6-A6B6-43FC-8808-9E99ADB9F68F}"/>
               </a:ext>
             </a:extLst>
           </p:cNvPr>
@@ -3372,7 +3372,7 @@
           <p:cNvPr id="41" name="">
             <a:extLst xmlns:a="http://schemas.openxmlformats.org/drawingml/2006/main">
               <a:ext uri="{FF2B5EF4-FFF2-40B4-BE49-F238E27FC236}">
-                <a16:creationId xmlns:a16="http://schemas.microsoft.com/office/drawing/2014/main" id="{3B8E4803-C35F-4BC2-A18C-E4997CEDCC65}"/>
+                <a16:creationId xmlns:a16="http://schemas.microsoft.com/office/drawing/2014/main" id="{AE5785DF-FD46-4C33-98A7-8C1C703958D0}"/>
               </a:ext>
             </a:extLst>
           </p:cNvPr>
@@ -3407,7 +3407,7 @@
           <p:cNvPr id="42" name="">
             <a:extLst xmlns:a="http://schemas.openxmlformats.org/drawingml/2006/main">
               <a:ext uri="{FF2B5EF4-FFF2-40B4-BE49-F238E27FC236}">
-                <a16:creationId xmlns:a16="http://schemas.microsoft.com/office/drawing/2014/main" id="{6828ED7E-A2BA-4597-A123-831825A8D161}"/>
+                <a16:creationId xmlns:a16="http://schemas.microsoft.com/office/drawing/2014/main" id="{C73E4A6F-146C-4287-8238-BD1FA2631200}"/>
               </a:ext>
             </a:extLst>
           </p:cNvPr>
@@ -3471,7 +3471,7 @@
           <p:cNvPr id="43" name="">
             <a:extLst xmlns:a="http://schemas.openxmlformats.org/drawingml/2006/main">
               <a:ext uri="{FF2B5EF4-FFF2-40B4-BE49-F238E27FC236}">
-                <a16:creationId xmlns:a16="http://schemas.microsoft.com/office/drawing/2014/main" id="{3C975896-EDF1-4752-AB26-19168325E1D0}"/>
+                <a16:creationId xmlns:a16="http://schemas.microsoft.com/office/drawing/2014/main" id="{E2554FC6-7B99-4514-AAF1-E6BA522DB93A}"/>
               </a:ext>
             </a:extLst>
           </p:cNvPr>
@@ -3528,7 +3528,7 @@
           <p:cNvPr id="44" name="">
             <a:extLst xmlns:a="http://schemas.openxmlformats.org/drawingml/2006/main">
               <a:ext uri="{FF2B5EF4-FFF2-40B4-BE49-F238E27FC236}">
-                <a16:creationId xmlns:a16="http://schemas.microsoft.com/office/drawing/2014/main" id="{46A4AEE6-A665-4F0B-BC57-865ED30055E0}"/>
+                <a16:creationId xmlns:a16="http://schemas.microsoft.com/office/drawing/2014/main" id="{AA8B3F8D-BF53-4A03-9D52-75052751D7AF}"/>
               </a:ext>
             </a:extLst>
           </p:cNvPr>
@@ -3585,7 +3585,7 @@
           <p:cNvPr id="45" name="">
             <a:extLst xmlns:a="http://schemas.openxmlformats.org/drawingml/2006/main">
               <a:ext uri="{FF2B5EF4-FFF2-40B4-BE49-F238E27FC236}">
-                <a16:creationId xmlns:a16="http://schemas.microsoft.com/office/drawing/2014/main" id="{D634B312-2911-421D-8321-F88E1BA1ADDB}"/>
+                <a16:creationId xmlns:a16="http://schemas.microsoft.com/office/drawing/2014/main" id="{DCD81D02-4683-46BB-8A34-9CA533E0A3A7}"/>
               </a:ext>
             </a:extLst>
           </p:cNvPr>
@@ -3632,7 +3632,7 @@
                 <a:ea typeface="Arial"/>
                 <a:cs typeface="Arial"/>
               </a:rPr>
-              <a:t>AURA • Track A • 22/09/2026</a:t>
+              <a:t>AURA • Track A • 24/09/2026</a:t>
             </a:r>
           </a:p>
         </p:txBody>
@@ -3642,7 +3642,7 @@
           <p:cNvPr id="46" name="">
             <a:extLst xmlns:a="http://schemas.openxmlformats.org/drawingml/2006/main">
               <a:ext uri="{FF2B5EF4-FFF2-40B4-BE49-F238E27FC236}">
-                <a16:creationId xmlns:a16="http://schemas.microsoft.com/office/drawing/2014/main" id="{7AA1CECC-40B2-41D9-B0B7-53AA4A46297B}"/>
+                <a16:creationId xmlns:a16="http://schemas.microsoft.com/office/drawing/2014/main" id="{9FBD1689-263D-4E2C-80AD-052F4981A6EF}"/>
               </a:ext>
             </a:extLst>
           </p:cNvPr>
@@ -3697,7 +3697,7 @@
     </p:spTree>
     <p:extLst>
       <p:ext uri="{BB962C8B-B14F-4D97-AF65-F5344CB8AC3E}">
-        <p14:creationId xmlns:p14="http://schemas.microsoft.com/office/powerpoint/2010/main" val="1033585041"/>
+        <p14:creationId xmlns:p14="http://schemas.microsoft.com/office/powerpoint/2010/main" val="418484325"/>
       </p:ext>
     </p:extLst>
   </p:cSld>
@@ -3728,7 +3728,7 @@
           <p:cNvPr id="46" name="">
             <a:extLst xmlns:a="http://schemas.openxmlformats.org/drawingml/2006/main">
               <a:ext uri="{FF2B5EF4-FFF2-40B4-BE49-F238E27FC236}">
-                <a16:creationId xmlns:a16="http://schemas.microsoft.com/office/drawing/2014/main" id="{698F2971-145B-4640-93F7-7C1BEE2F396E}"/>
+                <a16:creationId xmlns:a16="http://schemas.microsoft.com/office/drawing/2014/main" id="{0605C085-5D14-4170-992E-42C679AB1033}"/>
               </a:ext>
             </a:extLst>
           </p:cNvPr>
@@ -3785,7 +3785,7 @@
           <p:cNvPr id="2" name="">
             <a:extLst xmlns:a="http://schemas.openxmlformats.org/drawingml/2006/main">
               <a:ext uri="{FF2B5EF4-FFF2-40B4-BE49-F238E27FC236}">
-                <a16:creationId xmlns:a16="http://schemas.microsoft.com/office/drawing/2014/main" id="{12B24CCB-7A89-4610-AE93-342A939F10CA}"/>
+                <a16:creationId xmlns:a16="http://schemas.microsoft.com/office/drawing/2014/main" id="{0CC038C6-DEDC-4DDA-A336-BA89E01DDB35}"/>
               </a:ext>
             </a:extLst>
           </p:cNvPr>
@@ -3842,7 +3842,7 @@
           <p:cNvPr id="3" name="">
             <a:extLst xmlns:a="http://schemas.openxmlformats.org/drawingml/2006/main">
               <a:ext uri="{FF2B5EF4-FFF2-40B4-BE49-F238E27FC236}">
-                <a16:creationId xmlns:a16="http://schemas.microsoft.com/office/drawing/2014/main" id="{C7802585-DF26-424B-A41A-4360D268DA66}"/>
+                <a16:creationId xmlns:a16="http://schemas.microsoft.com/office/drawing/2014/main" id="{DAED8053-7464-4CF0-BF91-2EA64AF28CA4}"/>
               </a:ext>
             </a:extLst>
           </p:cNvPr>
@@ -3899,7 +3899,7 @@
           <p:cNvPr id="4" name="">
             <a:extLst xmlns:a="http://schemas.openxmlformats.org/drawingml/2006/main">
               <a:ext uri="{FF2B5EF4-FFF2-40B4-BE49-F238E27FC236}">
-                <a16:creationId xmlns:a16="http://schemas.microsoft.com/office/drawing/2014/main" id="{2D39AC4F-3AE0-470C-9B5A-C0AACBDC45C5}"/>
+                <a16:creationId xmlns:a16="http://schemas.microsoft.com/office/drawing/2014/main" id="{D536E802-A0C0-4E13-ACF9-F755EA4627F5}"/>
               </a:ext>
             </a:extLst>
           </p:cNvPr>
@@ -3930,7 +3930,7 @@
           <p:cNvPr id="5" name="">
             <a:extLst xmlns:a="http://schemas.openxmlformats.org/drawingml/2006/main">
               <a:ext uri="{FF2B5EF4-FFF2-40B4-BE49-F238E27FC236}">
-                <a16:creationId xmlns:a16="http://schemas.microsoft.com/office/drawing/2014/main" id="{8D08885A-BB31-4270-97A3-9E04EED1DE1C}"/>
+                <a16:creationId xmlns:a16="http://schemas.microsoft.com/office/drawing/2014/main" id="{CC1768A9-CFC5-4F5C-836D-6CFB5DBCF87C}"/>
               </a:ext>
             </a:extLst>
           </p:cNvPr>
@@ -3965,7 +3965,7 @@
           <p:cNvPr id="6" name="">
             <a:extLst xmlns:a="http://schemas.openxmlformats.org/drawingml/2006/main">
               <a:ext uri="{FF2B5EF4-FFF2-40B4-BE49-F238E27FC236}">
-                <a16:creationId xmlns:a16="http://schemas.microsoft.com/office/drawing/2014/main" id="{E948CC31-044B-406B-A9A6-6AEA02582540}"/>
+                <a16:creationId xmlns:a16="http://schemas.microsoft.com/office/drawing/2014/main" id="{2E1B8B43-4C2A-4116-A162-7990B607B177}"/>
               </a:ext>
             </a:extLst>
           </p:cNvPr>
@@ -4029,7 +4029,7 @@
           <p:cNvPr id="7" name="">
             <a:extLst xmlns:a="http://schemas.openxmlformats.org/drawingml/2006/main">
               <a:ext uri="{FF2B5EF4-FFF2-40B4-BE49-F238E27FC236}">
-                <a16:creationId xmlns:a16="http://schemas.microsoft.com/office/drawing/2014/main" id="{B26606FF-9E07-45A7-849A-1C5CFB9CC2CC}"/>
+                <a16:creationId xmlns:a16="http://schemas.microsoft.com/office/drawing/2014/main" id="{37AB3FAD-6EC3-4777-97BE-BBF93E5616D3}"/>
               </a:ext>
             </a:extLst>
           </p:cNvPr>
@@ -4086,7 +4086,7 @@
           <p:cNvPr id="8" name="">
             <a:extLst xmlns:a="http://schemas.openxmlformats.org/drawingml/2006/main">
               <a:ext uri="{FF2B5EF4-FFF2-40B4-BE49-F238E27FC236}">
-                <a16:creationId xmlns:a16="http://schemas.microsoft.com/office/drawing/2014/main" id="{7F3D903B-9C70-46F2-8597-E62E0EEAE1AC}"/>
+                <a16:creationId xmlns:a16="http://schemas.microsoft.com/office/drawing/2014/main" id="{14C256AE-EB1F-4E79-9201-0717959BB270}"/>
               </a:ext>
             </a:extLst>
           </p:cNvPr>
@@ -4166,7 +4166,7 @@
           <p:cNvPr id="9" name="">
             <a:extLst xmlns:a="http://schemas.openxmlformats.org/drawingml/2006/main">
               <a:ext uri="{FF2B5EF4-FFF2-40B4-BE49-F238E27FC236}">
-                <a16:creationId xmlns:a16="http://schemas.microsoft.com/office/drawing/2014/main" id="{4A99666E-C86C-420D-ACB2-5452D0F5F1D5}"/>
+                <a16:creationId xmlns:a16="http://schemas.microsoft.com/office/drawing/2014/main" id="{991E5593-412D-4470-8A45-1B2A4F913AB8}"/>
               </a:ext>
             </a:extLst>
           </p:cNvPr>
@@ -4198,7 +4198,7 @@
           <p:cNvPr id="10" name="">
             <a:extLst xmlns:a="http://schemas.openxmlformats.org/drawingml/2006/main">
               <a:ext uri="{FF2B5EF4-FFF2-40B4-BE49-F238E27FC236}">
-                <a16:creationId xmlns:a16="http://schemas.microsoft.com/office/drawing/2014/main" id="{8942D3EE-38BF-4685-949B-92FF3E38592D}"/>
+                <a16:creationId xmlns:a16="http://schemas.microsoft.com/office/drawing/2014/main" id="{2759D27B-A60D-4125-AEDA-9A137BED098A}"/>
               </a:ext>
             </a:extLst>
           </p:cNvPr>
@@ -4233,7 +4233,7 @@
           <p:cNvPr id="11" name="">
             <a:extLst xmlns:a="http://schemas.openxmlformats.org/drawingml/2006/main">
               <a:ext uri="{FF2B5EF4-FFF2-40B4-BE49-F238E27FC236}">
-                <a16:creationId xmlns:a16="http://schemas.microsoft.com/office/drawing/2014/main" id="{62D41D16-D7DA-48E6-960D-30794A9B1924}"/>
+                <a16:creationId xmlns:a16="http://schemas.microsoft.com/office/drawing/2014/main" id="{B21CF1D9-A8CE-404D-AFE4-A628806E49D8}"/>
               </a:ext>
             </a:extLst>
           </p:cNvPr>
@@ -4297,7 +4297,7 @@
           <p:cNvPr id="12" name="">
             <a:extLst xmlns:a="http://schemas.openxmlformats.org/drawingml/2006/main">
               <a:ext uri="{FF2B5EF4-FFF2-40B4-BE49-F238E27FC236}">
-                <a16:creationId xmlns:a16="http://schemas.microsoft.com/office/drawing/2014/main" id="{85DCAC55-15F1-4848-9FE1-7584C3D6C020}"/>
+                <a16:creationId xmlns:a16="http://schemas.microsoft.com/office/drawing/2014/main" id="{E89E7614-5CC3-4D70-98AB-FC905850DB23}"/>
               </a:ext>
             </a:extLst>
           </p:cNvPr>
@@ -4354,7 +4354,7 @@
           <p:cNvPr id="13" name="">
             <a:extLst xmlns:a="http://schemas.openxmlformats.org/drawingml/2006/main">
               <a:ext uri="{FF2B5EF4-FFF2-40B4-BE49-F238E27FC236}">
-                <a16:creationId xmlns:a16="http://schemas.microsoft.com/office/drawing/2014/main" id="{4A0F4A50-CA4D-4FA2-99EF-AB01D354DFB7}"/>
+                <a16:creationId xmlns:a16="http://schemas.microsoft.com/office/drawing/2014/main" id="{57640B2B-408B-4668-BB42-511A218531A2}"/>
               </a:ext>
             </a:extLst>
           </p:cNvPr>
@@ -4434,7 +4434,7 @@
           <p:cNvPr id="14" name="">
             <a:extLst xmlns:a="http://schemas.openxmlformats.org/drawingml/2006/main">
               <a:ext uri="{FF2B5EF4-FFF2-40B4-BE49-F238E27FC236}">
-                <a16:creationId xmlns:a16="http://schemas.microsoft.com/office/drawing/2014/main" id="{AE73E00C-FBC9-46BD-A9CC-407646D00EF1}"/>
+                <a16:creationId xmlns:a16="http://schemas.microsoft.com/office/drawing/2014/main" id="{EC7179D1-71BF-42FD-BDF3-4698F299CA63}"/>
               </a:ext>
             </a:extLst>
           </p:cNvPr>
@@ -4466,7 +4466,7 @@
           <p:cNvPr id="15" name="">
             <a:extLst xmlns:a="http://schemas.openxmlformats.org/drawingml/2006/main">
               <a:ext uri="{FF2B5EF4-FFF2-40B4-BE49-F238E27FC236}">
-                <a16:creationId xmlns:a16="http://schemas.microsoft.com/office/drawing/2014/main" id="{5C0E4481-336C-45D8-8A85-5B964597C6B8}"/>
+                <a16:creationId xmlns:a16="http://schemas.microsoft.com/office/drawing/2014/main" id="{3D3BE8D3-FC9C-4E17-8029-3BCEA935A09F}"/>
               </a:ext>
             </a:extLst>
           </p:cNvPr>
@@ -4501,7 +4501,7 @@
           <p:cNvPr id="16" name="">
             <a:extLst xmlns:a="http://schemas.openxmlformats.org/drawingml/2006/main">
               <a:ext uri="{FF2B5EF4-FFF2-40B4-BE49-F238E27FC236}">
-                <a16:creationId xmlns:a16="http://schemas.microsoft.com/office/drawing/2014/main" id="{B7C4802A-D2D8-465C-A198-B54617F805DA}"/>
+                <a16:creationId xmlns:a16="http://schemas.microsoft.com/office/drawing/2014/main" id="{CDAF25CD-3B8F-4E8D-B564-68A0B074AF14}"/>
               </a:ext>
             </a:extLst>
           </p:cNvPr>
@@ -4565,7 +4565,7 @@
           <p:cNvPr id="17" name="">
             <a:extLst xmlns:a="http://schemas.openxmlformats.org/drawingml/2006/main">
               <a:ext uri="{FF2B5EF4-FFF2-40B4-BE49-F238E27FC236}">
-                <a16:creationId xmlns:a16="http://schemas.microsoft.com/office/drawing/2014/main" id="{5A856FD9-32ED-45F7-94CF-EB77EBBEAF54}"/>
+                <a16:creationId xmlns:a16="http://schemas.microsoft.com/office/drawing/2014/main" id="{A0A63FAC-E73B-4E87-8807-500850EA3DA9}"/>
               </a:ext>
             </a:extLst>
           </p:cNvPr>
@@ -4622,7 +4622,7 @@
           <p:cNvPr id="18" name="">
             <a:extLst xmlns:a="http://schemas.openxmlformats.org/drawingml/2006/main">
               <a:ext uri="{FF2B5EF4-FFF2-40B4-BE49-F238E27FC236}">
-                <a16:creationId xmlns:a16="http://schemas.microsoft.com/office/drawing/2014/main" id="{4241231F-CD4A-40E4-BA78-7607171775B6}"/>
+                <a16:creationId xmlns:a16="http://schemas.microsoft.com/office/drawing/2014/main" id="{B4EA485E-9F46-4DCF-9BDA-B4821FA91185}"/>
               </a:ext>
             </a:extLst>
           </p:cNvPr>
@@ -4702,7 +4702,7 @@
           <p:cNvPr id="19" name="">
             <a:extLst xmlns:a="http://schemas.openxmlformats.org/drawingml/2006/main">
               <a:ext uri="{FF2B5EF4-FFF2-40B4-BE49-F238E27FC236}">
-                <a16:creationId xmlns:a16="http://schemas.microsoft.com/office/drawing/2014/main" id="{61AD6EA0-BCB6-4388-93A5-3F1313BCFF7E}"/>
+                <a16:creationId xmlns:a16="http://schemas.microsoft.com/office/drawing/2014/main" id="{9EAA03FE-21E5-4BB9-B98D-ADBA858B64E7}"/>
               </a:ext>
             </a:extLst>
           </p:cNvPr>
@@ -4734,7 +4734,7 @@
           <p:cNvPr id="20" name="">
             <a:extLst xmlns:a="http://schemas.openxmlformats.org/drawingml/2006/main">
               <a:ext uri="{FF2B5EF4-FFF2-40B4-BE49-F238E27FC236}">
-                <a16:creationId xmlns:a16="http://schemas.microsoft.com/office/drawing/2014/main" id="{EAA3B93E-3AB1-40A1-BFD7-26B2EFBC17F0}"/>
+                <a16:creationId xmlns:a16="http://schemas.microsoft.com/office/drawing/2014/main" id="{D180AD1F-0DF6-44AD-AB04-EF2A71B9BCF6}"/>
               </a:ext>
             </a:extLst>
           </p:cNvPr>
@@ -4769,7 +4769,7 @@
           <p:cNvPr id="21" name="">
             <a:extLst xmlns:a="http://schemas.openxmlformats.org/drawingml/2006/main">
               <a:ext uri="{FF2B5EF4-FFF2-40B4-BE49-F238E27FC236}">
-                <a16:creationId xmlns:a16="http://schemas.microsoft.com/office/drawing/2014/main" id="{66F273D7-749C-42D6-9E48-C54114FE2FAB}"/>
+                <a16:creationId xmlns:a16="http://schemas.microsoft.com/office/drawing/2014/main" id="{3EFAEA96-2AE1-4F82-9B97-B3F3C20C0FC9}"/>
               </a:ext>
             </a:extLst>
           </p:cNvPr>
@@ -4833,7 +4833,7 @@
           <p:cNvPr id="22" name="">
             <a:extLst xmlns:a="http://schemas.openxmlformats.org/drawingml/2006/main">
               <a:ext uri="{FF2B5EF4-FFF2-40B4-BE49-F238E27FC236}">
-                <a16:creationId xmlns:a16="http://schemas.microsoft.com/office/drawing/2014/main" id="{22568819-14F2-4A8B-9295-31F34E45D6C1}"/>
+                <a16:creationId xmlns:a16="http://schemas.microsoft.com/office/drawing/2014/main" id="{AD696B5F-D4F5-41F0-8B45-4FDA0549108C}"/>
               </a:ext>
             </a:extLst>
           </p:cNvPr>
@@ -4890,7 +4890,7 @@
           <p:cNvPr id="23" name="">
             <a:extLst xmlns:a="http://schemas.openxmlformats.org/drawingml/2006/main">
               <a:ext uri="{FF2B5EF4-FFF2-40B4-BE49-F238E27FC236}">
-                <a16:creationId xmlns:a16="http://schemas.microsoft.com/office/drawing/2014/main" id="{132E3492-150C-4CF1-9C80-DEF484DF09FB}"/>
+                <a16:creationId xmlns:a16="http://schemas.microsoft.com/office/drawing/2014/main" id="{77C4D1CD-6C23-4059-AE3A-94A09BE7B899}"/>
               </a:ext>
             </a:extLst>
           </p:cNvPr>
@@ -4970,7 +4970,7 @@
           <p:cNvPr id="24" name="">
             <a:extLst xmlns:a="http://schemas.openxmlformats.org/drawingml/2006/main">
               <a:ext uri="{FF2B5EF4-FFF2-40B4-BE49-F238E27FC236}">
-                <a16:creationId xmlns:a16="http://schemas.microsoft.com/office/drawing/2014/main" id="{7D81DEF5-0CDF-4C86-ACBA-F85904166665}"/>
+                <a16:creationId xmlns:a16="http://schemas.microsoft.com/office/drawing/2014/main" id="{00DD9658-EE3D-42B4-9E27-C6032F6A711A}"/>
               </a:ext>
             </a:extLst>
           </p:cNvPr>
@@ -5002,7 +5002,7 @@
           <p:cNvPr id="25" name="">
             <a:extLst xmlns:a="http://schemas.openxmlformats.org/drawingml/2006/main">
               <a:ext uri="{FF2B5EF4-FFF2-40B4-BE49-F238E27FC236}">
-                <a16:creationId xmlns:a16="http://schemas.microsoft.com/office/drawing/2014/main" id="{C1785B62-2E3D-4F40-8FC6-F1A2DA5689B7}"/>
+                <a16:creationId xmlns:a16="http://schemas.microsoft.com/office/drawing/2014/main" id="{AF896E8C-DF67-40BC-BAE0-3F425840E228}"/>
               </a:ext>
             </a:extLst>
           </p:cNvPr>
@@ -5037,7 +5037,7 @@
           <p:cNvPr id="26" name="">
             <a:extLst xmlns:a="http://schemas.openxmlformats.org/drawingml/2006/main">
               <a:ext uri="{FF2B5EF4-FFF2-40B4-BE49-F238E27FC236}">
-                <a16:creationId xmlns:a16="http://schemas.microsoft.com/office/drawing/2014/main" id="{F1C4FD62-6EEB-4890-B392-B28B06548685}"/>
+                <a16:creationId xmlns:a16="http://schemas.microsoft.com/office/drawing/2014/main" id="{F79439D9-AD54-469F-8450-40A0DEB71087}"/>
               </a:ext>
             </a:extLst>
           </p:cNvPr>
@@ -5101,7 +5101,7 @@
           <p:cNvPr id="27" name="">
             <a:extLst xmlns:a="http://schemas.openxmlformats.org/drawingml/2006/main">
               <a:ext uri="{FF2B5EF4-FFF2-40B4-BE49-F238E27FC236}">
-                <a16:creationId xmlns:a16="http://schemas.microsoft.com/office/drawing/2014/main" id="{73FC71A3-5671-4FD9-A3A5-1F238D18412B}"/>
+                <a16:creationId xmlns:a16="http://schemas.microsoft.com/office/drawing/2014/main" id="{55B05DB0-DB39-4CC2-B3EE-4D3B4F1A6EAD}"/>
               </a:ext>
             </a:extLst>
           </p:cNvPr>
@@ -5158,7 +5158,7 @@
           <p:cNvPr id="28" name="">
             <a:extLst xmlns:a="http://schemas.openxmlformats.org/drawingml/2006/main">
               <a:ext uri="{FF2B5EF4-FFF2-40B4-BE49-F238E27FC236}">
-                <a16:creationId xmlns:a16="http://schemas.microsoft.com/office/drawing/2014/main" id="{3A345BE2-5DC3-4AFE-B566-F9B438F87D2A}"/>
+                <a16:creationId xmlns:a16="http://schemas.microsoft.com/office/drawing/2014/main" id="{4B734FEB-1AA6-4832-952F-A7817E5D7350}"/>
               </a:ext>
             </a:extLst>
           </p:cNvPr>
@@ -5238,7 +5238,7 @@
           <p:cNvPr id="29" name="">
             <a:extLst xmlns:a="http://schemas.openxmlformats.org/drawingml/2006/main">
               <a:ext uri="{FF2B5EF4-FFF2-40B4-BE49-F238E27FC236}">
-                <a16:creationId xmlns:a16="http://schemas.microsoft.com/office/drawing/2014/main" id="{6AD210B0-4B90-48FD-8E75-0E456DB56F02}"/>
+                <a16:creationId xmlns:a16="http://schemas.microsoft.com/office/drawing/2014/main" id="{C440973F-3661-43DC-AB21-74675D284904}"/>
               </a:ext>
             </a:extLst>
           </p:cNvPr>
@@ -5295,7 +5295,7 @@
           <p:cNvPr id="30" name="">
             <a:extLst xmlns:a="http://schemas.openxmlformats.org/drawingml/2006/main">
               <a:ext uri="{FF2B5EF4-FFF2-40B4-BE49-F238E27FC236}">
-                <a16:creationId xmlns:a16="http://schemas.microsoft.com/office/drawing/2014/main" id="{BE68A039-4F1E-4093-8558-542160A44F3C}"/>
+                <a16:creationId xmlns:a16="http://schemas.microsoft.com/office/drawing/2014/main" id="{D05A42C7-A17D-48D9-840E-787D57D962FE}"/>
               </a:ext>
             </a:extLst>
           </p:cNvPr>
@@ -5330,7 +5330,7 @@
           <p:cNvPr id="31" name="">
             <a:extLst xmlns:a="http://schemas.openxmlformats.org/drawingml/2006/main">
               <a:ext uri="{FF2B5EF4-FFF2-40B4-BE49-F238E27FC236}">
-                <a16:creationId xmlns:a16="http://schemas.microsoft.com/office/drawing/2014/main" id="{ACA6FECD-A0D3-4681-9E9A-D93F4EDAE7ED}"/>
+                <a16:creationId xmlns:a16="http://schemas.microsoft.com/office/drawing/2014/main" id="{F5DD74CE-C20D-40C2-BAD9-517B58F8AD88}"/>
               </a:ext>
             </a:extLst>
           </p:cNvPr>
@@ -5387,7 +5387,7 @@
           <p:cNvPr id="32" name="">
             <a:extLst xmlns:a="http://schemas.openxmlformats.org/drawingml/2006/main">
               <a:ext uri="{FF2B5EF4-FFF2-40B4-BE49-F238E27FC236}">
-                <a16:creationId xmlns:a16="http://schemas.microsoft.com/office/drawing/2014/main" id="{B25FEC97-68A0-4B4D-AD53-7DDA1E75D8BC}"/>
+                <a16:creationId xmlns:a16="http://schemas.microsoft.com/office/drawing/2014/main" id="{8CD49FC7-FD7D-45FB-9210-1C158B935D4A}"/>
               </a:ext>
             </a:extLst>
           </p:cNvPr>
@@ -5490,7 +5490,7 @@
           <p:cNvPr id="33" name="">
             <a:extLst xmlns:a="http://schemas.openxmlformats.org/drawingml/2006/main">
               <a:ext uri="{FF2B5EF4-FFF2-40B4-BE49-F238E27FC236}">
-                <a16:creationId xmlns:a16="http://schemas.microsoft.com/office/drawing/2014/main" id="{C1B26B6F-D10C-400E-BBC4-53154CC6B2D0}"/>
+                <a16:creationId xmlns:a16="http://schemas.microsoft.com/office/drawing/2014/main" id="{1CCAB291-C51E-4DDA-ABB1-59E81D4FB617}"/>
               </a:ext>
             </a:extLst>
           </p:cNvPr>
@@ -5554,7 +5554,7 @@
           <p:cNvPr id="34" name="">
             <a:extLst xmlns:a="http://schemas.openxmlformats.org/drawingml/2006/main">
               <a:ext uri="{FF2B5EF4-FFF2-40B4-BE49-F238E27FC236}">
-                <a16:creationId xmlns:a16="http://schemas.microsoft.com/office/drawing/2014/main" id="{2E1ED77E-934C-41CD-BB34-5EC7A87CBD42}"/>
+                <a16:creationId xmlns:a16="http://schemas.microsoft.com/office/drawing/2014/main" id="{8BCB21C3-84B9-4540-A26B-05F707AAA6F1}"/>
               </a:ext>
             </a:extLst>
           </p:cNvPr>
@@ -5611,7 +5611,7 @@
           <p:cNvPr id="35" name="">
             <a:extLst xmlns:a="http://schemas.openxmlformats.org/drawingml/2006/main">
               <a:ext uri="{FF2B5EF4-FFF2-40B4-BE49-F238E27FC236}">
-                <a16:creationId xmlns:a16="http://schemas.microsoft.com/office/drawing/2014/main" id="{56B670F4-D8B3-407F-B641-85A6D5726A9B}"/>
+                <a16:creationId xmlns:a16="http://schemas.microsoft.com/office/drawing/2014/main" id="{171F1A5B-D7A1-401C-9FFF-61829C4047DA}"/>
               </a:ext>
             </a:extLst>
           </p:cNvPr>
@@ -5646,7 +5646,7 @@
           <p:cNvPr id="36" name="">
             <a:extLst xmlns:a="http://schemas.openxmlformats.org/drawingml/2006/main">
               <a:ext uri="{FF2B5EF4-FFF2-40B4-BE49-F238E27FC236}">
-                <a16:creationId xmlns:a16="http://schemas.microsoft.com/office/drawing/2014/main" id="{3FC2A63F-098A-46E1-8A6E-E3FC0B9F551D}"/>
+                <a16:creationId xmlns:a16="http://schemas.microsoft.com/office/drawing/2014/main" id="{2C32ABF9-D8C3-4468-B4AE-B4EC11D98062}"/>
               </a:ext>
             </a:extLst>
           </p:cNvPr>
@@ -5703,7 +5703,7 @@
           <p:cNvPr id="37" name="">
             <a:extLst xmlns:a="http://schemas.openxmlformats.org/drawingml/2006/main">
               <a:ext uri="{FF2B5EF4-FFF2-40B4-BE49-F238E27FC236}">
-                <a16:creationId xmlns:a16="http://schemas.microsoft.com/office/drawing/2014/main" id="{007DE927-2D71-4A2E-91C4-0858B66D0E9E}"/>
+                <a16:creationId xmlns:a16="http://schemas.microsoft.com/office/drawing/2014/main" id="{67C0C971-67F4-4CF1-B2A1-A76A85C6AD23}"/>
               </a:ext>
             </a:extLst>
           </p:cNvPr>
@@ -5738,7 +5738,7 @@
           <p:cNvPr id="38" name="">
             <a:extLst xmlns:a="http://schemas.openxmlformats.org/drawingml/2006/main">
               <a:ext uri="{FF2B5EF4-FFF2-40B4-BE49-F238E27FC236}">
-                <a16:creationId xmlns:a16="http://schemas.microsoft.com/office/drawing/2014/main" id="{F19594AD-50CE-422C-94EE-8D5D86771CDA}"/>
+                <a16:creationId xmlns:a16="http://schemas.microsoft.com/office/drawing/2014/main" id="{4C4588F2-F713-47B5-BAF2-FD0DCD803890}"/>
               </a:ext>
             </a:extLst>
           </p:cNvPr>
@@ -5795,7 +5795,7 @@
           <p:cNvPr id="39" name="">
             <a:extLst xmlns:a="http://schemas.openxmlformats.org/drawingml/2006/main">
               <a:ext uri="{FF2B5EF4-FFF2-40B4-BE49-F238E27FC236}">
-                <a16:creationId xmlns:a16="http://schemas.microsoft.com/office/drawing/2014/main" id="{7B1B54B7-25F0-40B5-838C-3D932181997D}"/>
+                <a16:creationId xmlns:a16="http://schemas.microsoft.com/office/drawing/2014/main" id="{39F2087D-F31B-4215-ACB8-158E77660EDD}"/>
               </a:ext>
             </a:extLst>
           </p:cNvPr>
@@ -5852,7 +5852,7 @@
           <p:cNvPr id="40" name="">
             <a:extLst xmlns:a="http://schemas.openxmlformats.org/drawingml/2006/main">
               <a:ext uri="{FF2B5EF4-FFF2-40B4-BE49-F238E27FC236}">
-                <a16:creationId xmlns:a16="http://schemas.microsoft.com/office/drawing/2014/main" id="{5E5719CB-A80C-459E-A58E-47135B79707E}"/>
+                <a16:creationId xmlns:a16="http://schemas.microsoft.com/office/drawing/2014/main" id="{B4772714-F722-44B2-99E8-F700239A86F8}"/>
               </a:ext>
             </a:extLst>
           </p:cNvPr>
@@ -5887,7 +5887,7 @@
           <p:cNvPr id="41" name="">
             <a:extLst xmlns:a="http://schemas.openxmlformats.org/drawingml/2006/main">
               <a:ext uri="{FF2B5EF4-FFF2-40B4-BE49-F238E27FC236}">
-                <a16:creationId xmlns:a16="http://schemas.microsoft.com/office/drawing/2014/main" id="{6EEC7DBE-C5B7-4D8A-B124-38C15A49512A}"/>
+                <a16:creationId xmlns:a16="http://schemas.microsoft.com/office/drawing/2014/main" id="{6523C9E9-776E-4C34-AACD-AD1D017A1E16}"/>
               </a:ext>
             </a:extLst>
           </p:cNvPr>
@@ -5944,7 +5944,7 @@
           <p:cNvPr id="42" name="">
             <a:extLst xmlns:a="http://schemas.openxmlformats.org/drawingml/2006/main">
               <a:ext uri="{FF2B5EF4-FFF2-40B4-BE49-F238E27FC236}">
-                <a16:creationId xmlns:a16="http://schemas.microsoft.com/office/drawing/2014/main" id="{DACE9A79-C774-4FD4-ABC5-178C733C84DB}"/>
+                <a16:creationId xmlns:a16="http://schemas.microsoft.com/office/drawing/2014/main" id="{4B2D3429-AB4E-43DC-B90E-2CDD90AC6DE9}"/>
               </a:ext>
             </a:extLst>
           </p:cNvPr>
@@ -6001,7 +6001,7 @@
           <p:cNvPr id="43" name="">
             <a:extLst xmlns:a="http://schemas.openxmlformats.org/drawingml/2006/main">
               <a:ext uri="{FF2B5EF4-FFF2-40B4-BE49-F238E27FC236}">
-                <a16:creationId xmlns:a16="http://schemas.microsoft.com/office/drawing/2014/main" id="{2BDF8B86-1F49-4EBC-B49F-DBE90E32311D}"/>
+                <a16:creationId xmlns:a16="http://schemas.microsoft.com/office/drawing/2014/main" id="{A0932C49-CC60-428B-8995-CAC50DE9F720}"/>
               </a:ext>
             </a:extLst>
           </p:cNvPr>
@@ -6058,7 +6058,7 @@
           <p:cNvPr id="44" name="">
             <a:extLst xmlns:a="http://schemas.openxmlformats.org/drawingml/2006/main">
               <a:ext uri="{FF2B5EF4-FFF2-40B4-BE49-F238E27FC236}">
-                <a16:creationId xmlns:a16="http://schemas.microsoft.com/office/drawing/2014/main" id="{7FC02FA0-E2B8-410E-BD35-5642BA2A1DCC}"/>
+                <a16:creationId xmlns:a16="http://schemas.microsoft.com/office/drawing/2014/main" id="{4CF2BE82-506D-4E3A-B266-1EDD27E63116}"/>
               </a:ext>
             </a:extLst>
           </p:cNvPr>
@@ -6105,7 +6105,7 @@
                 <a:ea typeface="Arial"/>
                 <a:cs typeface="Arial"/>
               </a:rPr>
-              <a:t>AURA • Track A • 22/09/2026</a:t>
+              <a:t>AURA • Track A • 24/09/2026</a:t>
             </a:r>
           </a:p>
         </p:txBody>
@@ -6115,7 +6115,7 @@
           <p:cNvPr id="45" name="">
             <a:extLst xmlns:a="http://schemas.openxmlformats.org/drawingml/2006/main">
               <a:ext uri="{FF2B5EF4-FFF2-40B4-BE49-F238E27FC236}">
-                <a16:creationId xmlns:a16="http://schemas.microsoft.com/office/drawing/2014/main" id="{5831E741-6A23-4511-B984-7653D1842D44}"/>
+                <a16:creationId xmlns:a16="http://schemas.microsoft.com/office/drawing/2014/main" id="{E01E7B43-353F-453D-821D-8287E97FE918}"/>
               </a:ext>
             </a:extLst>
           </p:cNvPr>
@@ -6170,7 +6170,7 @@
     </p:spTree>
     <p:extLst>
       <p:ext uri="{BB962C8B-B14F-4D97-AF65-F5344CB8AC3E}">
-        <p14:creationId xmlns:p14="http://schemas.microsoft.com/office/powerpoint/2010/main" val="1344282755"/>
+        <p14:creationId xmlns:p14="http://schemas.microsoft.com/office/powerpoint/2010/main" val="1298736877"/>
       </p:ext>
     </p:extLst>
   </p:cSld>
@@ -6201,7 +6201,7 @@
           <p:cNvPr id="32" name="">
             <a:extLst xmlns:a="http://schemas.openxmlformats.org/drawingml/2006/main">
               <a:ext uri="{FF2B5EF4-FFF2-40B4-BE49-F238E27FC236}">
-                <a16:creationId xmlns:a16="http://schemas.microsoft.com/office/drawing/2014/main" id="{C2EC4A61-C658-435A-9C7F-C06A7F3433B8}"/>
+                <a16:creationId xmlns:a16="http://schemas.microsoft.com/office/drawing/2014/main" id="{9352CD83-EC42-4721-98F9-BFFEB5EB4F44}"/>
               </a:ext>
             </a:extLst>
           </p:cNvPr>
@@ -6258,7 +6258,7 @@
           <p:cNvPr id="2" name="">
             <a:extLst xmlns:a="http://schemas.openxmlformats.org/drawingml/2006/main">
               <a:ext uri="{FF2B5EF4-FFF2-40B4-BE49-F238E27FC236}">
-                <a16:creationId xmlns:a16="http://schemas.microsoft.com/office/drawing/2014/main" id="{E000CD93-FB49-4E2F-8B07-4D7620988D00}"/>
+                <a16:creationId xmlns:a16="http://schemas.microsoft.com/office/drawing/2014/main" id="{C5CFF0C0-C154-4308-A732-246F89FAD9D4}"/>
               </a:ext>
             </a:extLst>
           </p:cNvPr>
@@ -6315,7 +6315,7 @@
           <p:cNvPr id="3" name="">
             <a:extLst xmlns:a="http://schemas.openxmlformats.org/drawingml/2006/main">
               <a:ext uri="{FF2B5EF4-FFF2-40B4-BE49-F238E27FC236}">
-                <a16:creationId xmlns:a16="http://schemas.microsoft.com/office/drawing/2014/main" id="{1D76307C-8F5A-4491-AE27-7B124838D507}"/>
+                <a16:creationId xmlns:a16="http://schemas.microsoft.com/office/drawing/2014/main" id="{C65A78CD-8C4E-46BC-A495-C8668CB798C0}"/>
               </a:ext>
             </a:extLst>
           </p:cNvPr>
@@ -6372,7 +6372,7 @@
           <p:cNvPr id="4" name="">
             <a:extLst xmlns:a="http://schemas.openxmlformats.org/drawingml/2006/main">
               <a:ext uri="{FF2B5EF4-FFF2-40B4-BE49-F238E27FC236}">
-                <a16:creationId xmlns:a16="http://schemas.microsoft.com/office/drawing/2014/main" id="{B17F867A-8141-491B-AE39-2F878273EBF5}"/>
+                <a16:creationId xmlns:a16="http://schemas.microsoft.com/office/drawing/2014/main" id="{ECBD8713-92C0-4E3F-B4CA-6667BE10AAEA}"/>
               </a:ext>
             </a:extLst>
           </p:cNvPr>
@@ -6403,7 +6403,7 @@
           <p:cNvPr id="5" name="">
             <a:extLst xmlns:a="http://schemas.openxmlformats.org/drawingml/2006/main">
               <a:ext uri="{FF2B5EF4-FFF2-40B4-BE49-F238E27FC236}">
-                <a16:creationId xmlns:a16="http://schemas.microsoft.com/office/drawing/2014/main" id="{36D24EA4-11A5-4895-A5CB-9E6E419FB08D}"/>
+                <a16:creationId xmlns:a16="http://schemas.microsoft.com/office/drawing/2014/main" id="{DB50243C-510A-45DF-A2C6-5E4124644D53}"/>
               </a:ext>
             </a:extLst>
           </p:cNvPr>
@@ -6438,7 +6438,7 @@
           <p:cNvPr id="6" name="">
             <a:extLst xmlns:a="http://schemas.openxmlformats.org/drawingml/2006/main">
               <a:ext uri="{FF2B5EF4-FFF2-40B4-BE49-F238E27FC236}">
-                <a16:creationId xmlns:a16="http://schemas.microsoft.com/office/drawing/2014/main" id="{F96F21B7-95A2-44B2-B22D-DB691ADE0250}"/>
+                <a16:creationId xmlns:a16="http://schemas.microsoft.com/office/drawing/2014/main" id="{03261E96-2696-4A86-B1EB-818F4EEA005B}"/>
               </a:ext>
             </a:extLst>
           </p:cNvPr>
@@ -6502,7 +6502,7 @@
           <p:cNvPr id="7" name="">
             <a:extLst xmlns:a="http://schemas.openxmlformats.org/drawingml/2006/main">
               <a:ext uri="{FF2B5EF4-FFF2-40B4-BE49-F238E27FC236}">
-                <a16:creationId xmlns:a16="http://schemas.microsoft.com/office/drawing/2014/main" id="{59C6312D-8C24-4FC1-A4BC-114661133BEF}"/>
+                <a16:creationId xmlns:a16="http://schemas.microsoft.com/office/drawing/2014/main" id="{EE385361-CAB1-40CC-B9E0-4F0932DE14BC}"/>
               </a:ext>
             </a:extLst>
           </p:cNvPr>
@@ -6559,7 +6559,7 @@
           <p:cNvPr id="8" name="">
             <a:extLst xmlns:a="http://schemas.openxmlformats.org/drawingml/2006/main">
               <a:ext uri="{FF2B5EF4-FFF2-40B4-BE49-F238E27FC236}">
-                <a16:creationId xmlns:a16="http://schemas.microsoft.com/office/drawing/2014/main" id="{E5377B5A-ACCB-4FF0-8C3D-5ADA8C3629B5}"/>
+                <a16:creationId xmlns:a16="http://schemas.microsoft.com/office/drawing/2014/main" id="{3D5ACE60-6365-47F2-A225-D92E15B5199E}"/>
               </a:ext>
             </a:extLst>
           </p:cNvPr>
@@ -6662,7 +6662,7 @@
           <p:cNvPr id="9" name="">
             <a:extLst xmlns:a="http://schemas.openxmlformats.org/drawingml/2006/main">
               <a:ext uri="{FF2B5EF4-FFF2-40B4-BE49-F238E27FC236}">
-                <a16:creationId xmlns:a16="http://schemas.microsoft.com/office/drawing/2014/main" id="{AA4396D3-B875-41B2-A015-52CD6E23181B}"/>
+                <a16:creationId xmlns:a16="http://schemas.microsoft.com/office/drawing/2014/main" id="{9031C83D-1B90-4072-8810-1CAC81E6D5CD}"/>
               </a:ext>
             </a:extLst>
           </p:cNvPr>
@@ -6697,7 +6697,7 @@
           <p:cNvPr id="10" name="">
             <a:extLst xmlns:a="http://schemas.openxmlformats.org/drawingml/2006/main">
               <a:ext uri="{FF2B5EF4-FFF2-40B4-BE49-F238E27FC236}">
-                <a16:creationId xmlns:a16="http://schemas.microsoft.com/office/drawing/2014/main" id="{947854AC-C35D-4DB5-AAB6-177F1E798C32}"/>
+                <a16:creationId xmlns:a16="http://schemas.microsoft.com/office/drawing/2014/main" id="{2DDA1E73-C84F-4A5C-A022-2362650F7792}"/>
               </a:ext>
             </a:extLst>
           </p:cNvPr>
@@ -6761,7 +6761,7 @@
           <p:cNvPr id="11" name="">
             <a:extLst xmlns:a="http://schemas.openxmlformats.org/drawingml/2006/main">
               <a:ext uri="{FF2B5EF4-FFF2-40B4-BE49-F238E27FC236}">
-                <a16:creationId xmlns:a16="http://schemas.microsoft.com/office/drawing/2014/main" id="{26EA3630-7EDA-47C5-A173-FC139650C7B4}"/>
+                <a16:creationId xmlns:a16="http://schemas.microsoft.com/office/drawing/2014/main" id="{37991916-C4D1-4B4A-95BC-A1AC9CDEB753}"/>
               </a:ext>
             </a:extLst>
           </p:cNvPr>
@@ -6818,7 +6818,7 @@
           <p:cNvPr id="12" name="">
             <a:extLst xmlns:a="http://schemas.openxmlformats.org/drawingml/2006/main">
               <a:ext uri="{FF2B5EF4-FFF2-40B4-BE49-F238E27FC236}">
-                <a16:creationId xmlns:a16="http://schemas.microsoft.com/office/drawing/2014/main" id="{2E0DAF43-4DED-41EF-94BE-3C41398C8A43}"/>
+                <a16:creationId xmlns:a16="http://schemas.microsoft.com/office/drawing/2014/main" id="{B2DC99CC-3472-4DAF-AAC4-538DA70B6824}"/>
               </a:ext>
             </a:extLst>
           </p:cNvPr>
@@ -6921,7 +6921,7 @@
           <p:cNvPr id="13" name="">
             <a:extLst xmlns:a="http://schemas.openxmlformats.org/drawingml/2006/main">
               <a:ext uri="{FF2B5EF4-FFF2-40B4-BE49-F238E27FC236}">
-                <a16:creationId xmlns:a16="http://schemas.microsoft.com/office/drawing/2014/main" id="{40CB9716-4595-4847-A80D-9A2860208F9E}"/>
+                <a16:creationId xmlns:a16="http://schemas.microsoft.com/office/drawing/2014/main" id="{394FC22E-849E-46B4-8C9A-C78E13C5F0E4}"/>
               </a:ext>
             </a:extLst>
           </p:cNvPr>
@@ -6978,7 +6978,7 @@
           <p:cNvPr id="14" name="">
             <a:extLst xmlns:a="http://schemas.openxmlformats.org/drawingml/2006/main">
               <a:ext uri="{FF2B5EF4-FFF2-40B4-BE49-F238E27FC236}">
-                <a16:creationId xmlns:a16="http://schemas.microsoft.com/office/drawing/2014/main" id="{380AC89C-DE8F-46F4-AAF7-6008DFBEF63D}"/>
+                <a16:creationId xmlns:a16="http://schemas.microsoft.com/office/drawing/2014/main" id="{867AC612-3B6D-4A8C-B541-233512271025}"/>
               </a:ext>
             </a:extLst>
           </p:cNvPr>
@@ -7013,7 +7013,7 @@
           <p:cNvPr id="15" name="">
             <a:extLst xmlns:a="http://schemas.openxmlformats.org/drawingml/2006/main">
               <a:ext uri="{FF2B5EF4-FFF2-40B4-BE49-F238E27FC236}">
-                <a16:creationId xmlns:a16="http://schemas.microsoft.com/office/drawing/2014/main" id="{EC2F5194-5923-4F01-86C6-6203FCAC9904}"/>
+                <a16:creationId xmlns:a16="http://schemas.microsoft.com/office/drawing/2014/main" id="{CB0B5D3B-4D64-4775-B743-027128D5AE1C}"/>
               </a:ext>
             </a:extLst>
           </p:cNvPr>
@@ -7060,7 +7060,7 @@
                 <a:ea typeface="Arial"/>
                 <a:cs typeface="Arial"/>
               </a:rPr>
-              <a:t>54/54</a:t>
+              <a:t>56/56</a:t>
             </a:r>
           </a:p>
         </p:txBody>
@@ -7070,7 +7070,7 @@
           <p:cNvPr id="16" name="">
             <a:extLst xmlns:a="http://schemas.openxmlformats.org/drawingml/2006/main">
               <a:ext uri="{FF2B5EF4-FFF2-40B4-BE49-F238E27FC236}">
-                <a16:creationId xmlns:a16="http://schemas.microsoft.com/office/drawing/2014/main" id="{FC5A2EAC-9B24-4D1E-AD71-DFB3E787A720}"/>
+                <a16:creationId xmlns:a16="http://schemas.microsoft.com/office/drawing/2014/main" id="{DAD1184B-78BF-4EE5-B252-94134F3C7950}"/>
               </a:ext>
             </a:extLst>
           </p:cNvPr>
@@ -7127,7 +7127,7 @@
           <p:cNvPr id="17" name="">
             <a:extLst xmlns:a="http://schemas.openxmlformats.org/drawingml/2006/main">
               <a:ext uri="{FF2B5EF4-FFF2-40B4-BE49-F238E27FC236}">
-                <a16:creationId xmlns:a16="http://schemas.microsoft.com/office/drawing/2014/main" id="{B9CFB55E-2641-45F8-B019-FFFC8DC71F70}"/>
+                <a16:creationId xmlns:a16="http://schemas.microsoft.com/office/drawing/2014/main" id="{A8C6B52F-4610-43CD-B661-3DA0F6C1878A}"/>
               </a:ext>
             </a:extLst>
           </p:cNvPr>
@@ -7162,7 +7162,7 @@
           <p:cNvPr id="18" name="">
             <a:extLst xmlns:a="http://schemas.openxmlformats.org/drawingml/2006/main">
               <a:ext uri="{FF2B5EF4-FFF2-40B4-BE49-F238E27FC236}">
-                <a16:creationId xmlns:a16="http://schemas.microsoft.com/office/drawing/2014/main" id="{4AE596E8-8FF1-42EB-B474-044163047C74}"/>
+                <a16:creationId xmlns:a16="http://schemas.microsoft.com/office/drawing/2014/main" id="{79D27054-9D39-4C10-AC06-BA58923ED2C6}"/>
               </a:ext>
             </a:extLst>
           </p:cNvPr>
@@ -7219,7 +7219,7 @@
           <p:cNvPr id="19" name="">
             <a:extLst xmlns:a="http://schemas.openxmlformats.org/drawingml/2006/main">
               <a:ext uri="{FF2B5EF4-FFF2-40B4-BE49-F238E27FC236}">
-                <a16:creationId xmlns:a16="http://schemas.microsoft.com/office/drawing/2014/main" id="{738D1EC8-9DD0-4074-97A8-204CD7B82AED}"/>
+                <a16:creationId xmlns:a16="http://schemas.microsoft.com/office/drawing/2014/main" id="{A8357B6C-1710-41D7-B010-7EF2C470D214}"/>
               </a:ext>
             </a:extLst>
           </p:cNvPr>
@@ -7276,7 +7276,7 @@
           <p:cNvPr id="20" name="">
             <a:extLst xmlns:a="http://schemas.openxmlformats.org/drawingml/2006/main">
               <a:ext uri="{FF2B5EF4-FFF2-40B4-BE49-F238E27FC236}">
-                <a16:creationId xmlns:a16="http://schemas.microsoft.com/office/drawing/2014/main" id="{67BD07CA-CB80-4CA9-A055-851188CDA9A3}"/>
+                <a16:creationId xmlns:a16="http://schemas.microsoft.com/office/drawing/2014/main" id="{DCAD157F-D8CC-4C4C-8B6D-6480246BDA79}"/>
               </a:ext>
             </a:extLst>
           </p:cNvPr>
@@ -7311,7 +7311,7 @@
           <p:cNvPr id="21" name="">
             <a:extLst xmlns:a="http://schemas.openxmlformats.org/drawingml/2006/main">
               <a:ext uri="{FF2B5EF4-FFF2-40B4-BE49-F238E27FC236}">
-                <a16:creationId xmlns:a16="http://schemas.microsoft.com/office/drawing/2014/main" id="{BD4C739A-40D1-45AA-90DC-3F86ED84C8A3}"/>
+                <a16:creationId xmlns:a16="http://schemas.microsoft.com/office/drawing/2014/main" id="{421BC51B-03E8-4437-8ABA-D203227C25E1}"/>
               </a:ext>
             </a:extLst>
           </p:cNvPr>
@@ -7368,7 +7368,7 @@
           <p:cNvPr id="22" name="">
             <a:extLst xmlns:a="http://schemas.openxmlformats.org/drawingml/2006/main">
               <a:ext uri="{FF2B5EF4-FFF2-40B4-BE49-F238E27FC236}">
-                <a16:creationId xmlns:a16="http://schemas.microsoft.com/office/drawing/2014/main" id="{3A19CF64-00E5-4052-B461-9E5C9926581F}"/>
+                <a16:creationId xmlns:a16="http://schemas.microsoft.com/office/drawing/2014/main" id="{51B8BADC-D8B8-4233-87EB-35920694F6BB}"/>
               </a:ext>
             </a:extLst>
           </p:cNvPr>
@@ -7425,7 +7425,7 @@
           <p:cNvPr id="23" name="">
             <a:extLst xmlns:a="http://schemas.openxmlformats.org/drawingml/2006/main">
               <a:ext uri="{FF2B5EF4-FFF2-40B4-BE49-F238E27FC236}">
-                <a16:creationId xmlns:a16="http://schemas.microsoft.com/office/drawing/2014/main" id="{653AEE6D-1F5A-4054-8DED-609EBEE2BE4B}"/>
+                <a16:creationId xmlns:a16="http://schemas.microsoft.com/office/drawing/2014/main" id="{2872D36F-7F77-4C47-AE6F-7A170B839CBC}"/>
               </a:ext>
             </a:extLst>
           </p:cNvPr>
@@ -7460,7 +7460,7 @@
           <p:cNvPr id="24" name="">
             <a:extLst xmlns:a="http://schemas.openxmlformats.org/drawingml/2006/main">
               <a:ext uri="{FF2B5EF4-FFF2-40B4-BE49-F238E27FC236}">
-                <a16:creationId xmlns:a16="http://schemas.microsoft.com/office/drawing/2014/main" id="{3F0B9B04-C760-4347-96BF-09DB8AC290FC}"/>
+                <a16:creationId xmlns:a16="http://schemas.microsoft.com/office/drawing/2014/main" id="{F94E7843-4C6C-4625-A129-9474CCFF45A7}"/>
               </a:ext>
             </a:extLst>
           </p:cNvPr>
@@ -7517,7 +7517,7 @@
           <p:cNvPr id="25" name="">
             <a:extLst xmlns:a="http://schemas.openxmlformats.org/drawingml/2006/main">
               <a:ext uri="{FF2B5EF4-FFF2-40B4-BE49-F238E27FC236}">
-                <a16:creationId xmlns:a16="http://schemas.microsoft.com/office/drawing/2014/main" id="{2A03C07C-6105-461B-BAE4-1BEDFCCA4C0B}"/>
+                <a16:creationId xmlns:a16="http://schemas.microsoft.com/office/drawing/2014/main" id="{901236AC-11F8-4D35-A4DF-EA9213F28C58}"/>
               </a:ext>
             </a:extLst>
           </p:cNvPr>
@@ -7581,7 +7581,7 @@
           <p:cNvPr id="26" name="">
             <a:extLst xmlns:a="http://schemas.openxmlformats.org/drawingml/2006/main">
               <a:ext uri="{FF2B5EF4-FFF2-40B4-BE49-F238E27FC236}">
-                <a16:creationId xmlns:a16="http://schemas.microsoft.com/office/drawing/2014/main" id="{E459A54F-CCDF-444D-BB44-771726DFE304}"/>
+                <a16:creationId xmlns:a16="http://schemas.microsoft.com/office/drawing/2014/main" id="{E99C6858-887F-4925-A432-623BA1186D0D}"/>
               </a:ext>
             </a:extLst>
           </p:cNvPr>
@@ -7645,7 +7645,7 @@
           <p:cNvPr id="27" name="">
             <a:extLst xmlns:a="http://schemas.openxmlformats.org/drawingml/2006/main">
               <a:ext uri="{FF2B5EF4-FFF2-40B4-BE49-F238E27FC236}">
-                <a16:creationId xmlns:a16="http://schemas.microsoft.com/office/drawing/2014/main" id="{2019FC9A-9367-47CE-BE66-10CD43B70D05}"/>
+                <a16:creationId xmlns:a16="http://schemas.microsoft.com/office/drawing/2014/main" id="{2255316C-C29F-4B2A-A96A-84C94FCDE8A7}"/>
               </a:ext>
             </a:extLst>
           </p:cNvPr>
@@ -7709,7 +7709,7 @@
           <p:cNvPr id="28" name="">
             <a:extLst xmlns:a="http://schemas.openxmlformats.org/drawingml/2006/main">
               <a:ext uri="{FF2B5EF4-FFF2-40B4-BE49-F238E27FC236}">
-                <a16:creationId xmlns:a16="http://schemas.microsoft.com/office/drawing/2014/main" id="{D30AFE76-87EC-40C2-9EE2-251707BE4D14}"/>
+                <a16:creationId xmlns:a16="http://schemas.microsoft.com/office/drawing/2014/main" id="{F00D6DDB-0ADC-4067-9041-401A58F202BE}"/>
               </a:ext>
             </a:extLst>
           </p:cNvPr>
@@ -7773,7 +7773,7 @@
           <p:cNvPr id="29" name="">
             <a:extLst xmlns:a="http://schemas.openxmlformats.org/drawingml/2006/main">
               <a:ext uri="{FF2B5EF4-FFF2-40B4-BE49-F238E27FC236}">
-                <a16:creationId xmlns:a16="http://schemas.microsoft.com/office/drawing/2014/main" id="{8CA4298F-F419-492A-9C96-A1E011956022}"/>
+                <a16:creationId xmlns:a16="http://schemas.microsoft.com/office/drawing/2014/main" id="{F62D40B0-6BD4-4190-A222-D605AB491197}"/>
               </a:ext>
             </a:extLst>
           </p:cNvPr>
@@ -7830,7 +7830,7 @@
           <p:cNvPr id="30" name="">
             <a:extLst xmlns:a="http://schemas.openxmlformats.org/drawingml/2006/main">
               <a:ext uri="{FF2B5EF4-FFF2-40B4-BE49-F238E27FC236}">
-                <a16:creationId xmlns:a16="http://schemas.microsoft.com/office/drawing/2014/main" id="{5EB99521-3E0A-47E8-A350-F96875C1B0EA}"/>
+                <a16:creationId xmlns:a16="http://schemas.microsoft.com/office/drawing/2014/main" id="{5DA1F709-6965-4349-B155-941C39A1755B}"/>
               </a:ext>
             </a:extLst>
           </p:cNvPr>
@@ -7877,7 +7877,7 @@
                 <a:ea typeface="Arial"/>
                 <a:cs typeface="Arial"/>
               </a:rPr>
-              <a:t>AURA • Track A • 22/09/2026</a:t>
+              <a:t>AURA • Track A • 24/09/2026</a:t>
             </a:r>
           </a:p>
         </p:txBody>
@@ -7887,7 +7887,7 @@
           <p:cNvPr id="31" name="">
             <a:extLst xmlns:a="http://schemas.openxmlformats.org/drawingml/2006/main">
               <a:ext uri="{FF2B5EF4-FFF2-40B4-BE49-F238E27FC236}">
-                <a16:creationId xmlns:a16="http://schemas.microsoft.com/office/drawing/2014/main" id="{35790431-6CD7-44D7-B4C3-3DF05412DEAF}"/>
+                <a16:creationId xmlns:a16="http://schemas.microsoft.com/office/drawing/2014/main" id="{D8184D41-FC83-49A4-BFA6-95E2424B84DF}"/>
               </a:ext>
             </a:extLst>
           </p:cNvPr>
@@ -7942,7 +7942,7 @@
     </p:spTree>
     <p:extLst>
       <p:ext uri="{BB962C8B-B14F-4D97-AF65-F5344CB8AC3E}">
-        <p14:creationId xmlns:p14="http://schemas.microsoft.com/office/powerpoint/2010/main" val="1070911908"/>
+        <p14:creationId xmlns:p14="http://schemas.microsoft.com/office/powerpoint/2010/main" val="1764396408"/>
       </p:ext>
     </p:extLst>
   </p:cSld>
@@ -7973,7 +7973,7 @@
           <p:cNvPr id="32" name="">
             <a:extLst xmlns:a="http://schemas.openxmlformats.org/drawingml/2006/main">
               <a:ext uri="{FF2B5EF4-FFF2-40B4-BE49-F238E27FC236}">
-                <a16:creationId xmlns:a16="http://schemas.microsoft.com/office/drawing/2014/main" id="{44B760B5-CD28-404A-8700-89E005FE9356}"/>
+                <a16:creationId xmlns:a16="http://schemas.microsoft.com/office/drawing/2014/main" id="{55C7333D-A533-431F-8BDD-71D280101290}"/>
               </a:ext>
             </a:extLst>
           </p:cNvPr>
@@ -8030,7 +8030,7 @@
           <p:cNvPr id="2" name="">
             <a:extLst xmlns:a="http://schemas.openxmlformats.org/drawingml/2006/main">
               <a:ext uri="{FF2B5EF4-FFF2-40B4-BE49-F238E27FC236}">
-                <a16:creationId xmlns:a16="http://schemas.microsoft.com/office/drawing/2014/main" id="{7A7FA199-56B3-492E-8C52-6B644DBAEB5D}"/>
+                <a16:creationId xmlns:a16="http://schemas.microsoft.com/office/drawing/2014/main" id="{15B78FEE-68CB-4FA1-A6BE-B4042EE51658}"/>
               </a:ext>
             </a:extLst>
           </p:cNvPr>
@@ -8087,7 +8087,7 @@
           <p:cNvPr id="3" name="">
             <a:extLst xmlns:a="http://schemas.openxmlformats.org/drawingml/2006/main">
               <a:ext uri="{FF2B5EF4-FFF2-40B4-BE49-F238E27FC236}">
-                <a16:creationId xmlns:a16="http://schemas.microsoft.com/office/drawing/2014/main" id="{DDBD24A4-0438-4236-8D11-AC5E7612698A}"/>
+                <a16:creationId xmlns:a16="http://schemas.microsoft.com/office/drawing/2014/main" id="{EC43740A-4287-4408-8F80-C854CA51E9CB}"/>
               </a:ext>
             </a:extLst>
           </p:cNvPr>
@@ -8144,7 +8144,7 @@
           <p:cNvPr id="4" name="">
             <a:extLst xmlns:a="http://schemas.openxmlformats.org/drawingml/2006/main">
               <a:ext uri="{FF2B5EF4-FFF2-40B4-BE49-F238E27FC236}">
-                <a16:creationId xmlns:a16="http://schemas.microsoft.com/office/drawing/2014/main" id="{E18BF944-AF02-4827-AEB6-E092A3CB9692}"/>
+                <a16:creationId xmlns:a16="http://schemas.microsoft.com/office/drawing/2014/main" id="{AA12600E-EB11-42B2-8963-116232E34859}"/>
               </a:ext>
             </a:extLst>
           </p:cNvPr>
@@ -8175,7 +8175,7 @@
           <p:cNvPr id="5" name="">
             <a:extLst xmlns:a="http://schemas.openxmlformats.org/drawingml/2006/main">
               <a:ext uri="{FF2B5EF4-FFF2-40B4-BE49-F238E27FC236}">
-                <a16:creationId xmlns:a16="http://schemas.microsoft.com/office/drawing/2014/main" id="{94BEB37A-CF44-476F-A5C9-842CF0D7A7E1}"/>
+                <a16:creationId xmlns:a16="http://schemas.microsoft.com/office/drawing/2014/main" id="{4EFB6987-7264-4109-AAC8-726EEDFD8E2E}"/>
               </a:ext>
             </a:extLst>
           </p:cNvPr>
@@ -8210,7 +8210,7 @@
           <p:cNvPr id="6" name="">
             <a:extLst xmlns:a="http://schemas.openxmlformats.org/drawingml/2006/main">
               <a:ext uri="{FF2B5EF4-FFF2-40B4-BE49-F238E27FC236}">
-                <a16:creationId xmlns:a16="http://schemas.microsoft.com/office/drawing/2014/main" id="{51510A4A-0D33-4A7E-9C47-DBA258486943}"/>
+                <a16:creationId xmlns:a16="http://schemas.microsoft.com/office/drawing/2014/main" id="{8CF1378F-DDB7-4E43-813A-E71076571843}"/>
               </a:ext>
             </a:extLst>
           </p:cNvPr>
@@ -8274,7 +8274,7 @@
           <p:cNvPr id="7" name="">
             <a:extLst xmlns:a="http://schemas.openxmlformats.org/drawingml/2006/main">
               <a:ext uri="{FF2B5EF4-FFF2-40B4-BE49-F238E27FC236}">
-                <a16:creationId xmlns:a16="http://schemas.microsoft.com/office/drawing/2014/main" id="{53AEB96A-BC6B-42A3-BD41-7E1C06D4AA10}"/>
+                <a16:creationId xmlns:a16="http://schemas.microsoft.com/office/drawing/2014/main" id="{DD1F54E2-93FC-41AC-B4BF-2474C69A1AAB}"/>
               </a:ext>
             </a:extLst>
           </p:cNvPr>
@@ -8321,7 +8321,7 @@
                 <a:ea typeface="Arial"/>
                 <a:cs typeface="Arial"/>
               </a:rPr>
-              <a:t>Razor MVC • fetch/fragment • polling 10s</a:t>
+              <a:t>Razor MVC • fetch cho AI • reload sau workflow write</a:t>
             </a:r>
           </a:p>
         </p:txBody>
@@ -8331,7 +8331,7 @@
           <p:cNvPr id="8" name="">
             <a:extLst xmlns:a="http://schemas.openxmlformats.org/drawingml/2006/main">
               <a:ext uri="{FF2B5EF4-FFF2-40B4-BE49-F238E27FC236}">
-                <a16:creationId xmlns:a16="http://schemas.microsoft.com/office/drawing/2014/main" id="{A93E0727-6DA0-4357-AC58-C31D9C729024}"/>
+                <a16:creationId xmlns:a16="http://schemas.microsoft.com/office/drawing/2014/main" id="{269644BA-8D9B-4A12-82A0-7FA7EBD975DD}"/>
               </a:ext>
             </a:extLst>
           </p:cNvPr>
@@ -8362,7 +8362,7 @@
           <p:cNvPr id="9" name="">
             <a:extLst xmlns:a="http://schemas.openxmlformats.org/drawingml/2006/main">
               <a:ext uri="{FF2B5EF4-FFF2-40B4-BE49-F238E27FC236}">
-                <a16:creationId xmlns:a16="http://schemas.microsoft.com/office/drawing/2014/main" id="{0F76425B-F9B2-41FA-B6AC-E4F9AABA2D53}"/>
+                <a16:creationId xmlns:a16="http://schemas.microsoft.com/office/drawing/2014/main" id="{E48AD046-B02F-4A06-84B9-1A31C3A44718}"/>
               </a:ext>
             </a:extLst>
           </p:cNvPr>
@@ -8397,7 +8397,7 @@
           <p:cNvPr id="10" name="">
             <a:extLst xmlns:a="http://schemas.openxmlformats.org/drawingml/2006/main">
               <a:ext uri="{FF2B5EF4-FFF2-40B4-BE49-F238E27FC236}">
-                <a16:creationId xmlns:a16="http://schemas.microsoft.com/office/drawing/2014/main" id="{1E512AAE-CDD3-4A15-B569-2972C5AA162A}"/>
+                <a16:creationId xmlns:a16="http://schemas.microsoft.com/office/drawing/2014/main" id="{E52D228D-C5A2-45EA-A668-17FEA5A91597}"/>
               </a:ext>
             </a:extLst>
           </p:cNvPr>
@@ -8461,7 +8461,7 @@
           <p:cNvPr id="11" name="">
             <a:extLst xmlns:a="http://schemas.openxmlformats.org/drawingml/2006/main">
               <a:ext uri="{FF2B5EF4-FFF2-40B4-BE49-F238E27FC236}">
-                <a16:creationId xmlns:a16="http://schemas.microsoft.com/office/drawing/2014/main" id="{AEC080F7-FB9A-4BCC-906D-1A6711EB6849}"/>
+                <a16:creationId xmlns:a16="http://schemas.microsoft.com/office/drawing/2014/main" id="{944EB041-2B3D-422F-9BFB-90479D422069}"/>
               </a:ext>
             </a:extLst>
           </p:cNvPr>
@@ -8518,7 +8518,7 @@
           <p:cNvPr id="12" name="">
             <a:extLst xmlns:a="http://schemas.openxmlformats.org/drawingml/2006/main">
               <a:ext uri="{FF2B5EF4-FFF2-40B4-BE49-F238E27FC236}">
-                <a16:creationId xmlns:a16="http://schemas.microsoft.com/office/drawing/2014/main" id="{CC30CA43-8A3A-43A4-B192-A126F44AB40C}"/>
+                <a16:creationId xmlns:a16="http://schemas.microsoft.com/office/drawing/2014/main" id="{ACD3DDEB-5A94-4B80-BD3D-0CFBFEA7B8E1}"/>
               </a:ext>
             </a:extLst>
           </p:cNvPr>
@@ -8549,7 +8549,7 @@
           <p:cNvPr id="13" name="">
             <a:extLst xmlns:a="http://schemas.openxmlformats.org/drawingml/2006/main">
               <a:ext uri="{FF2B5EF4-FFF2-40B4-BE49-F238E27FC236}">
-                <a16:creationId xmlns:a16="http://schemas.microsoft.com/office/drawing/2014/main" id="{22F89BC4-8B8F-4B94-B2E7-4C8A4E8E6C6F}"/>
+                <a16:creationId xmlns:a16="http://schemas.microsoft.com/office/drawing/2014/main" id="{9E34EEF9-AC77-472D-820E-4B186FD195D0}"/>
               </a:ext>
             </a:extLst>
           </p:cNvPr>
@@ -8584,7 +8584,7 @@
           <p:cNvPr id="14" name="">
             <a:extLst xmlns:a="http://schemas.openxmlformats.org/drawingml/2006/main">
               <a:ext uri="{FF2B5EF4-FFF2-40B4-BE49-F238E27FC236}">
-                <a16:creationId xmlns:a16="http://schemas.microsoft.com/office/drawing/2014/main" id="{F5751D05-6380-450E-8D92-180927A27AE1}"/>
+                <a16:creationId xmlns:a16="http://schemas.microsoft.com/office/drawing/2014/main" id="{E2CD799D-5FD4-4F36-984B-52177FE195F3}"/>
               </a:ext>
             </a:extLst>
           </p:cNvPr>
@@ -8648,7 +8648,7 @@
           <p:cNvPr id="15" name="">
             <a:extLst xmlns:a="http://schemas.openxmlformats.org/drawingml/2006/main">
               <a:ext uri="{FF2B5EF4-FFF2-40B4-BE49-F238E27FC236}">
-                <a16:creationId xmlns:a16="http://schemas.microsoft.com/office/drawing/2014/main" id="{261E25C2-1778-45DA-9ACE-455BED8DC59E}"/>
+                <a16:creationId xmlns:a16="http://schemas.microsoft.com/office/drawing/2014/main" id="{3E84499E-F26B-4C34-AFEF-4A6CD7181541}"/>
               </a:ext>
             </a:extLst>
           </p:cNvPr>
@@ -8705,7 +8705,7 @@
           <p:cNvPr id="16" name="">
             <a:extLst xmlns:a="http://schemas.openxmlformats.org/drawingml/2006/main">
               <a:ext uri="{FF2B5EF4-FFF2-40B4-BE49-F238E27FC236}">
-                <a16:creationId xmlns:a16="http://schemas.microsoft.com/office/drawing/2014/main" id="{A8BFC2A9-4E0B-482E-90A7-D89E4F5D885A}"/>
+                <a16:creationId xmlns:a16="http://schemas.microsoft.com/office/drawing/2014/main" id="{B9788397-81FC-4238-8257-B9A0C22D9A6D}"/>
               </a:ext>
             </a:extLst>
           </p:cNvPr>
@@ -8736,7 +8736,7 @@
           <p:cNvPr id="17" name="">
             <a:extLst xmlns:a="http://schemas.openxmlformats.org/drawingml/2006/main">
               <a:ext uri="{FF2B5EF4-FFF2-40B4-BE49-F238E27FC236}">
-                <a16:creationId xmlns:a16="http://schemas.microsoft.com/office/drawing/2014/main" id="{2B55A4D5-644D-48A5-97D6-AF7AE587F4EA}"/>
+                <a16:creationId xmlns:a16="http://schemas.microsoft.com/office/drawing/2014/main" id="{8515FDE9-751D-4BE6-86B9-3D60D234C742}"/>
               </a:ext>
             </a:extLst>
           </p:cNvPr>
@@ -8771,7 +8771,7 @@
           <p:cNvPr id="18" name="">
             <a:extLst xmlns:a="http://schemas.openxmlformats.org/drawingml/2006/main">
               <a:ext uri="{FF2B5EF4-FFF2-40B4-BE49-F238E27FC236}">
-                <a16:creationId xmlns:a16="http://schemas.microsoft.com/office/drawing/2014/main" id="{FF9DC070-1866-4FBD-9548-D19709946AE4}"/>
+                <a16:creationId xmlns:a16="http://schemas.microsoft.com/office/drawing/2014/main" id="{401CDFA4-E52D-4B0D-97EA-68A6D051B41E}"/>
               </a:ext>
             </a:extLst>
           </p:cNvPr>
@@ -8835,7 +8835,7 @@
           <p:cNvPr id="19" name="">
             <a:extLst xmlns:a="http://schemas.openxmlformats.org/drawingml/2006/main">
               <a:ext uri="{FF2B5EF4-FFF2-40B4-BE49-F238E27FC236}">
-                <a16:creationId xmlns:a16="http://schemas.microsoft.com/office/drawing/2014/main" id="{DE2A46E6-EBE5-489D-AABC-4B2697D9EDF2}"/>
+                <a16:creationId xmlns:a16="http://schemas.microsoft.com/office/drawing/2014/main" id="{D22FAC9A-2079-4CFB-8629-55959C1C82F2}"/>
               </a:ext>
             </a:extLst>
           </p:cNvPr>
@@ -8892,7 +8892,7 @@
           <p:cNvPr id="20" name="">
             <a:extLst xmlns:a="http://schemas.openxmlformats.org/drawingml/2006/main">
               <a:ext uri="{FF2B5EF4-FFF2-40B4-BE49-F238E27FC236}">
-                <a16:creationId xmlns:a16="http://schemas.microsoft.com/office/drawing/2014/main" id="{D0C0A49D-0DB6-46BE-9B83-47D792E30E4D}"/>
+                <a16:creationId xmlns:a16="http://schemas.microsoft.com/office/drawing/2014/main" id="{51994FB4-AB7F-40B1-8360-8BC156636672}"/>
               </a:ext>
             </a:extLst>
           </p:cNvPr>
@@ -8927,7 +8927,7 @@
           <p:cNvPr id="21" name="">
             <a:extLst xmlns:a="http://schemas.openxmlformats.org/drawingml/2006/main">
               <a:ext uri="{FF2B5EF4-FFF2-40B4-BE49-F238E27FC236}">
-                <a16:creationId xmlns:a16="http://schemas.microsoft.com/office/drawing/2014/main" id="{3D7EF547-EE35-40F4-893E-150C9A8F1011}"/>
+                <a16:creationId xmlns:a16="http://schemas.microsoft.com/office/drawing/2014/main" id="{FF74227C-2DBF-4D1B-B986-F4099C4B5005}"/>
               </a:ext>
             </a:extLst>
           </p:cNvPr>
@@ -8984,7 +8984,7 @@
           <p:cNvPr id="22" name="">
             <a:extLst xmlns:a="http://schemas.openxmlformats.org/drawingml/2006/main">
               <a:ext uri="{FF2B5EF4-FFF2-40B4-BE49-F238E27FC236}">
-                <a16:creationId xmlns:a16="http://schemas.microsoft.com/office/drawing/2014/main" id="{7316EABD-7E74-4293-85F8-ABE8BD92EDEA}"/>
+                <a16:creationId xmlns:a16="http://schemas.microsoft.com/office/drawing/2014/main" id="{FD926762-EB22-41E4-B121-65BBE7CD3F47}"/>
               </a:ext>
             </a:extLst>
           </p:cNvPr>
@@ -9041,7 +9041,7 @@
           <p:cNvPr id="23" name="">
             <a:extLst xmlns:a="http://schemas.openxmlformats.org/drawingml/2006/main">
               <a:ext uri="{FF2B5EF4-FFF2-40B4-BE49-F238E27FC236}">
-                <a16:creationId xmlns:a16="http://schemas.microsoft.com/office/drawing/2014/main" id="{FD41C080-CC19-4CB6-B2B6-617A62C889D3}"/>
+                <a16:creationId xmlns:a16="http://schemas.microsoft.com/office/drawing/2014/main" id="{E1121E1A-CF14-4124-8C93-FE32AD4B3338}"/>
               </a:ext>
             </a:extLst>
           </p:cNvPr>
@@ -9076,7 +9076,7 @@
           <p:cNvPr id="24" name="">
             <a:extLst xmlns:a="http://schemas.openxmlformats.org/drawingml/2006/main">
               <a:ext uri="{FF2B5EF4-FFF2-40B4-BE49-F238E27FC236}">
-                <a16:creationId xmlns:a16="http://schemas.microsoft.com/office/drawing/2014/main" id="{E98CF817-3E08-4502-A78B-7E401E26E14C}"/>
+                <a16:creationId xmlns:a16="http://schemas.microsoft.com/office/drawing/2014/main" id="{3CC49D6E-04EB-4EA4-8D35-3AC4AC161600}"/>
               </a:ext>
             </a:extLst>
           </p:cNvPr>
@@ -9140,7 +9140,7 @@
           <p:cNvPr id="25" name="">
             <a:extLst xmlns:a="http://schemas.openxmlformats.org/drawingml/2006/main">
               <a:ext uri="{FF2B5EF4-FFF2-40B4-BE49-F238E27FC236}">
-                <a16:creationId xmlns:a16="http://schemas.microsoft.com/office/drawing/2014/main" id="{DE8B1748-ECB6-44D7-848D-8F6BBDE0D2A5}"/>
+                <a16:creationId xmlns:a16="http://schemas.microsoft.com/office/drawing/2014/main" id="{979A203B-C47A-46CA-A498-3144325E7C6A}"/>
               </a:ext>
             </a:extLst>
           </p:cNvPr>
@@ -9266,7 +9266,7 @@
           <p:cNvPr id="26" name="">
             <a:extLst xmlns:a="http://schemas.openxmlformats.org/drawingml/2006/main">
               <a:ext uri="{FF2B5EF4-FFF2-40B4-BE49-F238E27FC236}">
-                <a16:creationId xmlns:a16="http://schemas.microsoft.com/office/drawing/2014/main" id="{4E98509C-F1C5-4FD0-A3A8-17A68C4F1A8B}"/>
+                <a16:creationId xmlns:a16="http://schemas.microsoft.com/office/drawing/2014/main" id="{B9D84C25-8007-433F-8596-32C5E8C7AEE1}"/>
               </a:ext>
             </a:extLst>
           </p:cNvPr>
@@ -9301,7 +9301,7 @@
           <p:cNvPr id="27" name="">
             <a:extLst xmlns:a="http://schemas.openxmlformats.org/drawingml/2006/main">
               <a:ext uri="{FF2B5EF4-FFF2-40B4-BE49-F238E27FC236}">
-                <a16:creationId xmlns:a16="http://schemas.microsoft.com/office/drawing/2014/main" id="{2AEA05B3-7D6C-420C-B452-30A4ED40CC81}"/>
+                <a16:creationId xmlns:a16="http://schemas.microsoft.com/office/drawing/2014/main" id="{99453110-DB53-41B1-8C88-07094BE26CBB}"/>
               </a:ext>
             </a:extLst>
           </p:cNvPr>
@@ -9365,7 +9365,7 @@
           <p:cNvPr id="28" name="">
             <a:extLst xmlns:a="http://schemas.openxmlformats.org/drawingml/2006/main">
               <a:ext uri="{FF2B5EF4-FFF2-40B4-BE49-F238E27FC236}">
-                <a16:creationId xmlns:a16="http://schemas.microsoft.com/office/drawing/2014/main" id="{6711427B-6392-4D91-805C-42E4463CE358}"/>
+                <a16:creationId xmlns:a16="http://schemas.microsoft.com/office/drawing/2014/main" id="{283ED22D-E080-4002-9112-753FDE19A6AE}"/>
               </a:ext>
             </a:extLst>
           </p:cNvPr>
@@ -9468,7 +9468,7 @@
           <p:cNvPr id="29" name="">
             <a:extLst xmlns:a="http://schemas.openxmlformats.org/drawingml/2006/main">
               <a:ext uri="{FF2B5EF4-FFF2-40B4-BE49-F238E27FC236}">
-                <a16:creationId xmlns:a16="http://schemas.microsoft.com/office/drawing/2014/main" id="{EB947F2E-6C22-4AA5-84AD-98769FE52C22}"/>
+                <a16:creationId xmlns:a16="http://schemas.microsoft.com/office/drawing/2014/main" id="{8A805275-42DD-456E-A506-4F030CCEE5F4}"/>
               </a:ext>
             </a:extLst>
           </p:cNvPr>
@@ -9548,7 +9548,7 @@
           <p:cNvPr id="30" name="">
             <a:extLst xmlns:a="http://schemas.openxmlformats.org/drawingml/2006/main">
               <a:ext uri="{FF2B5EF4-FFF2-40B4-BE49-F238E27FC236}">
-                <a16:creationId xmlns:a16="http://schemas.microsoft.com/office/drawing/2014/main" id="{189369C9-3470-47C9-A55B-5293CDB3C1C5}"/>
+                <a16:creationId xmlns:a16="http://schemas.microsoft.com/office/drawing/2014/main" id="{C6DC08D4-B5D3-46C6-B2A0-53A35183FE4A}"/>
               </a:ext>
             </a:extLst>
           </p:cNvPr>
@@ -9595,7 +9595,7 @@
                 <a:ea typeface="Arial"/>
                 <a:cs typeface="Arial"/>
               </a:rPr>
-              <a:t>AURA • Track A • 22/09/2026</a:t>
+              <a:t>AURA • Track A • 24/09/2026</a:t>
             </a:r>
           </a:p>
         </p:txBody>
@@ -9605,7 +9605,7 @@
           <p:cNvPr id="31" name="">
             <a:extLst xmlns:a="http://schemas.openxmlformats.org/drawingml/2006/main">
               <a:ext uri="{FF2B5EF4-FFF2-40B4-BE49-F238E27FC236}">
-                <a16:creationId xmlns:a16="http://schemas.microsoft.com/office/drawing/2014/main" id="{E0FCBE71-BE0C-417D-A886-6066B6A26CE5}"/>
+                <a16:creationId xmlns:a16="http://schemas.microsoft.com/office/drawing/2014/main" id="{04F35ED3-D658-4E77-B172-CD010A272EBA}"/>
               </a:ext>
             </a:extLst>
           </p:cNvPr>
@@ -9660,7 +9660,7 @@
     </p:spTree>
     <p:extLst>
       <p:ext uri="{BB962C8B-B14F-4D97-AF65-F5344CB8AC3E}">
-        <p14:creationId xmlns:p14="http://schemas.microsoft.com/office/powerpoint/2010/main" val="1857741313"/>
+        <p14:creationId xmlns:p14="http://schemas.microsoft.com/office/powerpoint/2010/main" val="1059866678"/>
       </p:ext>
     </p:extLst>
   </p:cSld>
@@ -9691,7 +9691,7 @@
           <p:cNvPr id="36" name="">
             <a:extLst xmlns:a="http://schemas.openxmlformats.org/drawingml/2006/main">
               <a:ext uri="{FF2B5EF4-FFF2-40B4-BE49-F238E27FC236}">
-                <a16:creationId xmlns:a16="http://schemas.microsoft.com/office/drawing/2014/main" id="{7FEFC94C-BB72-49AB-A025-FB9FDC79902E}"/>
+                <a16:creationId xmlns:a16="http://schemas.microsoft.com/office/drawing/2014/main" id="{6C17614D-C903-4326-B504-14ADAFB1C2BB}"/>
               </a:ext>
             </a:extLst>
           </p:cNvPr>
@@ -9748,7 +9748,7 @@
           <p:cNvPr id="2" name="">
             <a:extLst xmlns:a="http://schemas.openxmlformats.org/drawingml/2006/main">
               <a:ext uri="{FF2B5EF4-FFF2-40B4-BE49-F238E27FC236}">
-                <a16:creationId xmlns:a16="http://schemas.microsoft.com/office/drawing/2014/main" id="{BE8245F1-E45F-4E6C-A414-021F4BE68969}"/>
+                <a16:creationId xmlns:a16="http://schemas.microsoft.com/office/drawing/2014/main" id="{E9B84560-5721-47EC-8762-93107DFDFEB4}"/>
               </a:ext>
             </a:extLst>
           </p:cNvPr>
@@ -9805,7 +9805,7 @@
           <p:cNvPr id="3" name="">
             <a:extLst xmlns:a="http://schemas.openxmlformats.org/drawingml/2006/main">
               <a:ext uri="{FF2B5EF4-FFF2-40B4-BE49-F238E27FC236}">
-                <a16:creationId xmlns:a16="http://schemas.microsoft.com/office/drawing/2014/main" id="{E3A023D7-26B2-4059-A230-88054397B41A}"/>
+                <a16:creationId xmlns:a16="http://schemas.microsoft.com/office/drawing/2014/main" id="{EE4AE8C5-D81B-4BD1-BFD8-C28D10C1529E}"/>
               </a:ext>
             </a:extLst>
           </p:cNvPr>
@@ -9862,7 +9862,7 @@
           <p:cNvPr id="4" name="">
             <a:extLst xmlns:a="http://schemas.openxmlformats.org/drawingml/2006/main">
               <a:ext uri="{FF2B5EF4-FFF2-40B4-BE49-F238E27FC236}">
-                <a16:creationId xmlns:a16="http://schemas.microsoft.com/office/drawing/2014/main" id="{A61A3EEA-CA7B-431C-A8C8-22DA20823A2A}"/>
+                <a16:creationId xmlns:a16="http://schemas.microsoft.com/office/drawing/2014/main" id="{5883DDBA-2A02-4646-9E35-B3B24DFC6CC7}"/>
               </a:ext>
             </a:extLst>
           </p:cNvPr>
@@ -9893,7 +9893,7 @@
           <p:cNvPr id="5" name="">
             <a:extLst xmlns:a="http://schemas.openxmlformats.org/drawingml/2006/main">
               <a:ext uri="{FF2B5EF4-FFF2-40B4-BE49-F238E27FC236}">
-                <a16:creationId xmlns:a16="http://schemas.microsoft.com/office/drawing/2014/main" id="{07081611-86C0-4111-87EA-B5F3AE3C155D}"/>
+                <a16:creationId xmlns:a16="http://schemas.microsoft.com/office/drawing/2014/main" id="{73D0C7FB-5D27-446E-AA9B-F521283428C1}"/>
               </a:ext>
             </a:extLst>
           </p:cNvPr>
@@ -9928,7 +9928,7 @@
           <p:cNvPr id="6" name="">
             <a:extLst xmlns:a="http://schemas.openxmlformats.org/drawingml/2006/main">
               <a:ext uri="{FF2B5EF4-FFF2-40B4-BE49-F238E27FC236}">
-                <a16:creationId xmlns:a16="http://schemas.microsoft.com/office/drawing/2014/main" id="{8AFE8F35-BCEB-4E07-8E4B-961478626CB5}"/>
+                <a16:creationId xmlns:a16="http://schemas.microsoft.com/office/drawing/2014/main" id="{95F5419B-B113-43FA-9EEA-5B5D6021E55A}"/>
               </a:ext>
             </a:extLst>
           </p:cNvPr>
@@ -9992,7 +9992,7 @@
           <p:cNvPr id="7" name="">
             <a:extLst xmlns:a="http://schemas.openxmlformats.org/drawingml/2006/main">
               <a:ext uri="{FF2B5EF4-FFF2-40B4-BE49-F238E27FC236}">
-                <a16:creationId xmlns:a16="http://schemas.microsoft.com/office/drawing/2014/main" id="{E3336FB1-E54B-47CD-99E7-BDAD337E0CB4}"/>
+                <a16:creationId xmlns:a16="http://schemas.microsoft.com/office/drawing/2014/main" id="{C4E83DBA-A8CE-4E07-AA93-ED11F04930EC}"/>
               </a:ext>
             </a:extLst>
           </p:cNvPr>
@@ -10049,7 +10049,7 @@
           <p:cNvPr id="8" name="">
             <a:extLst xmlns:a="http://schemas.openxmlformats.org/drawingml/2006/main">
               <a:ext uri="{FF2B5EF4-FFF2-40B4-BE49-F238E27FC236}">
-                <a16:creationId xmlns:a16="http://schemas.microsoft.com/office/drawing/2014/main" id="{6C225BE4-C6A4-431C-BDF9-9F10263DFDF5}"/>
+                <a16:creationId xmlns:a16="http://schemas.microsoft.com/office/drawing/2014/main" id="{9212419D-189B-415F-8166-D0EEECB0F73E}"/>
               </a:ext>
             </a:extLst>
           </p:cNvPr>
@@ -10084,7 +10084,7 @@
           <p:cNvPr id="9" name="">
             <a:extLst xmlns:a="http://schemas.openxmlformats.org/drawingml/2006/main">
               <a:ext uri="{FF2B5EF4-FFF2-40B4-BE49-F238E27FC236}">
-                <a16:creationId xmlns:a16="http://schemas.microsoft.com/office/drawing/2014/main" id="{90CD4954-88EA-47F4-BA62-DEA97D735583}"/>
+                <a16:creationId xmlns:a16="http://schemas.microsoft.com/office/drawing/2014/main" id="{1FA20384-8C6A-453C-86C3-B5AAE919C665}"/>
               </a:ext>
             </a:extLst>
           </p:cNvPr>
@@ -10148,7 +10148,7 @@
           <p:cNvPr id="10" name="">
             <a:extLst xmlns:a="http://schemas.openxmlformats.org/drawingml/2006/main">
               <a:ext uri="{FF2B5EF4-FFF2-40B4-BE49-F238E27FC236}">
-                <a16:creationId xmlns:a16="http://schemas.microsoft.com/office/drawing/2014/main" id="{86C09530-78B2-4EE4-89A1-26DE4EBAF4AB}"/>
+                <a16:creationId xmlns:a16="http://schemas.microsoft.com/office/drawing/2014/main" id="{2FF7AB46-5B5A-459E-AE91-7CAAE17504ED}"/>
               </a:ext>
             </a:extLst>
           </p:cNvPr>
@@ -10205,7 +10205,7 @@
           <p:cNvPr id="11" name="">
             <a:extLst xmlns:a="http://schemas.openxmlformats.org/drawingml/2006/main">
               <a:ext uri="{FF2B5EF4-FFF2-40B4-BE49-F238E27FC236}">
-                <a16:creationId xmlns:a16="http://schemas.microsoft.com/office/drawing/2014/main" id="{C01C3A7F-C2F8-49BD-91DB-A76967D45778}"/>
+                <a16:creationId xmlns:a16="http://schemas.microsoft.com/office/drawing/2014/main" id="{7686FC49-04B5-4109-807F-CB89FADD2508}"/>
               </a:ext>
             </a:extLst>
           </p:cNvPr>
@@ -10240,7 +10240,7 @@
           <p:cNvPr id="12" name="">
             <a:extLst xmlns:a="http://schemas.openxmlformats.org/drawingml/2006/main">
               <a:ext uri="{FF2B5EF4-FFF2-40B4-BE49-F238E27FC236}">
-                <a16:creationId xmlns:a16="http://schemas.microsoft.com/office/drawing/2014/main" id="{01E32243-DE6A-4C58-830B-785B6DDD20D2}"/>
+                <a16:creationId xmlns:a16="http://schemas.microsoft.com/office/drawing/2014/main" id="{DFDBE800-200D-40CC-AEBD-1075F4B1E5DA}"/>
               </a:ext>
             </a:extLst>
           </p:cNvPr>
@@ -10304,7 +10304,7 @@
           <p:cNvPr id="13" name="">
             <a:extLst xmlns:a="http://schemas.openxmlformats.org/drawingml/2006/main">
               <a:ext uri="{FF2B5EF4-FFF2-40B4-BE49-F238E27FC236}">
-                <a16:creationId xmlns:a16="http://schemas.microsoft.com/office/drawing/2014/main" id="{57352111-51FA-4A61-8D78-BEF2BE3B7B14}"/>
+                <a16:creationId xmlns:a16="http://schemas.microsoft.com/office/drawing/2014/main" id="{9DECE2DE-B986-4900-9CDE-364E18E453C5}"/>
               </a:ext>
             </a:extLst>
           </p:cNvPr>
@@ -10361,7 +10361,7 @@
           <p:cNvPr id="14" name="">
             <a:extLst xmlns:a="http://schemas.openxmlformats.org/drawingml/2006/main">
               <a:ext uri="{FF2B5EF4-FFF2-40B4-BE49-F238E27FC236}">
-                <a16:creationId xmlns:a16="http://schemas.microsoft.com/office/drawing/2014/main" id="{33229209-C2BE-4C10-A728-366F66A7CBA3}"/>
+                <a16:creationId xmlns:a16="http://schemas.microsoft.com/office/drawing/2014/main" id="{B27CA201-DCE5-4AD8-AA96-CB2B70AA9A36}"/>
               </a:ext>
             </a:extLst>
           </p:cNvPr>
@@ -10396,7 +10396,7 @@
           <p:cNvPr id="15" name="">
             <a:extLst xmlns:a="http://schemas.openxmlformats.org/drawingml/2006/main">
               <a:ext uri="{FF2B5EF4-FFF2-40B4-BE49-F238E27FC236}">
-                <a16:creationId xmlns:a16="http://schemas.microsoft.com/office/drawing/2014/main" id="{404AD627-5B44-4180-A387-4EB90834DBEA}"/>
+                <a16:creationId xmlns:a16="http://schemas.microsoft.com/office/drawing/2014/main" id="{BA81A46F-5841-43D1-B404-EF5B2B0453A0}"/>
               </a:ext>
             </a:extLst>
           </p:cNvPr>
@@ -10460,7 +10460,7 @@
           <p:cNvPr id="16" name="">
             <a:extLst xmlns:a="http://schemas.openxmlformats.org/drawingml/2006/main">
               <a:ext uri="{FF2B5EF4-FFF2-40B4-BE49-F238E27FC236}">
-                <a16:creationId xmlns:a16="http://schemas.microsoft.com/office/drawing/2014/main" id="{B651C567-CB20-4EE7-B032-D32A35EB7231}"/>
+                <a16:creationId xmlns:a16="http://schemas.microsoft.com/office/drawing/2014/main" id="{38727B3A-CDAC-4154-BE4B-89F20E68637F}"/>
               </a:ext>
             </a:extLst>
           </p:cNvPr>
@@ -10517,7 +10517,7 @@
           <p:cNvPr id="17" name="">
             <a:extLst xmlns:a="http://schemas.openxmlformats.org/drawingml/2006/main">
               <a:ext uri="{FF2B5EF4-FFF2-40B4-BE49-F238E27FC236}">
-                <a16:creationId xmlns:a16="http://schemas.microsoft.com/office/drawing/2014/main" id="{51F800E4-7B55-42BA-9011-3638A92FB5A6}"/>
+                <a16:creationId xmlns:a16="http://schemas.microsoft.com/office/drawing/2014/main" id="{EC968E58-6B62-4EC0-85E2-D7FF6CB6591C}"/>
               </a:ext>
             </a:extLst>
           </p:cNvPr>
@@ -10552,7 +10552,7 @@
           <p:cNvPr id="18" name="">
             <a:extLst xmlns:a="http://schemas.openxmlformats.org/drawingml/2006/main">
               <a:ext uri="{FF2B5EF4-FFF2-40B4-BE49-F238E27FC236}">
-                <a16:creationId xmlns:a16="http://schemas.microsoft.com/office/drawing/2014/main" id="{7ECAE1C0-F73F-494F-900C-3B532890228C}"/>
+                <a16:creationId xmlns:a16="http://schemas.microsoft.com/office/drawing/2014/main" id="{9DB9D497-FC74-4A44-8EE6-5A5F10B32901}"/>
               </a:ext>
             </a:extLst>
           </p:cNvPr>
@@ -10616,7 +10616,7 @@
           <p:cNvPr id="19" name="">
             <a:extLst xmlns:a="http://schemas.openxmlformats.org/drawingml/2006/main">
               <a:ext uri="{FF2B5EF4-FFF2-40B4-BE49-F238E27FC236}">
-                <a16:creationId xmlns:a16="http://schemas.microsoft.com/office/drawing/2014/main" id="{D405A962-82F9-46CC-BB8D-72F9392355D1}"/>
+                <a16:creationId xmlns:a16="http://schemas.microsoft.com/office/drawing/2014/main" id="{DE7763FF-270B-4273-A709-4DC6E0ABB749}"/>
               </a:ext>
             </a:extLst>
           </p:cNvPr>
@@ -10673,7 +10673,7 @@
           <p:cNvPr id="20" name="">
             <a:extLst xmlns:a="http://schemas.openxmlformats.org/drawingml/2006/main">
               <a:ext uri="{FF2B5EF4-FFF2-40B4-BE49-F238E27FC236}">
-                <a16:creationId xmlns:a16="http://schemas.microsoft.com/office/drawing/2014/main" id="{16CDF108-4BE2-44F6-B176-EC9C0BE71EEE}"/>
+                <a16:creationId xmlns:a16="http://schemas.microsoft.com/office/drawing/2014/main" id="{4E6443D0-4046-41C9-BC79-20F0F174C9FE}"/>
               </a:ext>
             </a:extLst>
           </p:cNvPr>
@@ -10708,7 +10708,7 @@
           <p:cNvPr id="21" name="">
             <a:extLst xmlns:a="http://schemas.openxmlformats.org/drawingml/2006/main">
               <a:ext uri="{FF2B5EF4-FFF2-40B4-BE49-F238E27FC236}">
-                <a16:creationId xmlns:a16="http://schemas.microsoft.com/office/drawing/2014/main" id="{67304251-5D2B-4345-8C30-DDBBFEEC40CC}"/>
+                <a16:creationId xmlns:a16="http://schemas.microsoft.com/office/drawing/2014/main" id="{17F7CAC4-E6FE-4F5F-ACF0-8C39E411AB9A}"/>
               </a:ext>
             </a:extLst>
           </p:cNvPr>
@@ -10755,7 +10755,7 @@
                 <a:ea typeface="Arial"/>
                 <a:cs typeface="Arial"/>
               </a:rPr>
-              <a:t>TRƯỚC KHI NỘP</a:t>
+              <a:t>ĐÃ BÀN GIAO</a:t>
             </a:r>
           </a:p>
         </p:txBody>
@@ -10765,7 +10765,7 @@
           <p:cNvPr id="22" name="">
             <a:extLst xmlns:a="http://schemas.openxmlformats.org/drawingml/2006/main">
               <a:ext uri="{FF2B5EF4-FFF2-40B4-BE49-F238E27FC236}">
-                <a16:creationId xmlns:a16="http://schemas.microsoft.com/office/drawing/2014/main" id="{A9AD6359-2F71-4A53-BB57-AB0BF1F63731}"/>
+                <a16:creationId xmlns:a16="http://schemas.microsoft.com/office/drawing/2014/main" id="{A08466DB-E2D2-4232-AB99-4EB089566487}"/>
               </a:ext>
             </a:extLst>
           </p:cNvPr>
@@ -10829,7 +10829,7 @@
           <p:cNvPr id="23" name="">
             <a:extLst xmlns:a="http://schemas.openxmlformats.org/drawingml/2006/main">
               <a:ext uri="{FF2B5EF4-FFF2-40B4-BE49-F238E27FC236}">
-                <a16:creationId xmlns:a16="http://schemas.microsoft.com/office/drawing/2014/main" id="{B8D4D4AD-D2B2-4BAF-87B0-F790C466EAD2}"/>
+                <a16:creationId xmlns:a16="http://schemas.microsoft.com/office/drawing/2014/main" id="{A54DCFA8-E2FF-4B38-9E0B-7D2785526331}"/>
               </a:ext>
             </a:extLst>
           </p:cNvPr>
@@ -10876,7 +10876,7 @@
                 <a:ea typeface="Arial"/>
                 <a:cs typeface="Arial"/>
               </a:rPr>
-              <a:t>Quay Verify production</a:t>
+              <a:t>Repo + hướng dẫn local</a:t>
             </a:r>
           </a:p>
         </p:txBody>
@@ -10886,7 +10886,7 @@
           <p:cNvPr id="24" name="">
             <a:extLst xmlns:a="http://schemas.openxmlformats.org/drawingml/2006/main">
               <a:ext uri="{FF2B5EF4-FFF2-40B4-BE49-F238E27FC236}">
-                <a16:creationId xmlns:a16="http://schemas.microsoft.com/office/drawing/2014/main" id="{0E175079-2038-4B6B-84D4-1E0F363C60D4}"/>
+                <a16:creationId xmlns:a16="http://schemas.microsoft.com/office/drawing/2014/main" id="{928B96A4-D9D1-4B92-B8BD-6AF08FF32125}"/>
               </a:ext>
             </a:extLst>
           </p:cNvPr>
@@ -10950,7 +10950,7 @@
           <p:cNvPr id="25" name="">
             <a:extLst xmlns:a="http://schemas.openxmlformats.org/drawingml/2006/main">
               <a:ext uri="{FF2B5EF4-FFF2-40B4-BE49-F238E27FC236}">
-                <a16:creationId xmlns:a16="http://schemas.microsoft.com/office/drawing/2014/main" id="{DEBE82E0-BE2E-47F7-9335-DB977892C534}"/>
+                <a16:creationId xmlns:a16="http://schemas.microsoft.com/office/drawing/2014/main" id="{6BA23449-8C30-4736-A002-E8C8E09782E0}"/>
               </a:ext>
             </a:extLst>
           </p:cNvPr>
@@ -10997,7 +10997,7 @@
                 <a:ea typeface="Arial"/>
                 <a:cs typeface="Arial"/>
               </a:rPr>
-              <a:t>Demo quản lý + Audit</a:t>
+              <a:t>56 test offline</a:t>
             </a:r>
           </a:p>
         </p:txBody>
@@ -11007,7 +11007,7 @@
           <p:cNvPr id="26" name="">
             <a:extLst xmlns:a="http://schemas.openxmlformats.org/drawingml/2006/main">
               <a:ext uri="{FF2B5EF4-FFF2-40B4-BE49-F238E27FC236}">
-                <a16:creationId xmlns:a16="http://schemas.microsoft.com/office/drawing/2014/main" id="{AAD11F11-361C-44DD-8509-8BAF0D1B9F33}"/>
+                <a16:creationId xmlns:a16="http://schemas.microsoft.com/office/drawing/2014/main" id="{94E04D04-4683-4B96-BFA8-860B5F401813}"/>
               </a:ext>
             </a:extLst>
           </p:cNvPr>
@@ -11071,7 +11071,7 @@
           <p:cNvPr id="27" name="">
             <a:extLst xmlns:a="http://schemas.openxmlformats.org/drawingml/2006/main">
               <a:ext uri="{FF2B5EF4-FFF2-40B4-BE49-F238E27FC236}">
-                <a16:creationId xmlns:a16="http://schemas.microsoft.com/office/drawing/2014/main" id="{83B1CDE2-F3C5-4FE5-93DB-A70F62150EA5}"/>
+                <a16:creationId xmlns:a16="http://schemas.microsoft.com/office/drawing/2014/main" id="{6A72793D-B9AA-4078-8BBF-7369D96BE3D4}"/>
               </a:ext>
             </a:extLst>
           </p:cNvPr>
@@ -11118,7 +11118,7 @@
                 <a:ea typeface="Arial"/>
                 <a:cs typeface="Arial"/>
               </a:rPr>
-              <a:t>Video dưới 3 phút</a:t>
+              <a:t>5 Verify + 15 ca BGK</a:t>
             </a:r>
           </a:p>
         </p:txBody>
@@ -11128,7 +11128,7 @@
           <p:cNvPr id="28" name="">
             <a:extLst xmlns:a="http://schemas.openxmlformats.org/drawingml/2006/main">
               <a:ext uri="{FF2B5EF4-FFF2-40B4-BE49-F238E27FC236}">
-                <a16:creationId xmlns:a16="http://schemas.microsoft.com/office/drawing/2014/main" id="{ACDF986E-B418-4779-A025-2B0645A52758}"/>
+                <a16:creationId xmlns:a16="http://schemas.microsoft.com/office/drawing/2014/main" id="{C815364C-B2E1-4EF5-BE4A-C9EC1728FF8A}"/>
               </a:ext>
             </a:extLst>
           </p:cNvPr>
@@ -11192,7 +11192,7 @@
           <p:cNvPr id="29" name="">
             <a:extLst xmlns:a="http://schemas.openxmlformats.org/drawingml/2006/main">
               <a:ext uri="{FF2B5EF4-FFF2-40B4-BE49-F238E27FC236}">
-                <a16:creationId xmlns:a16="http://schemas.microsoft.com/office/drawing/2014/main" id="{4D0CBCD3-1586-4749-9DE7-E7F4505BE0AE}"/>
+                <a16:creationId xmlns:a16="http://schemas.microsoft.com/office/drawing/2014/main" id="{19E247C8-FE9F-4D23-921C-A62F1EE8DA34}"/>
               </a:ext>
             </a:extLst>
           </p:cNvPr>
@@ -11239,7 +11239,7 @@
                 <a:ea typeface="Arial"/>
                 <a:cs typeface="Arial"/>
               </a:rPr>
-              <a:t>Điền đủ 3 URL nộp</a:t>
+              <a:t>Video • slide • Build Log</a:t>
             </a:r>
           </a:p>
         </p:txBody>
@@ -11249,7 +11249,7 @@
           <p:cNvPr id="30" name="">
             <a:extLst xmlns:a="http://schemas.openxmlformats.org/drawingml/2006/main">
               <a:ext uri="{FF2B5EF4-FFF2-40B4-BE49-F238E27FC236}">
-                <a16:creationId xmlns:a16="http://schemas.microsoft.com/office/drawing/2014/main" id="{27565FC9-14AB-431D-897B-5ACC314D168F}"/>
+                <a16:creationId xmlns:a16="http://schemas.microsoft.com/office/drawing/2014/main" id="{5FB9E27C-5BDE-4768-B220-9B58ED32F67D}"/>
               </a:ext>
             </a:extLst>
           </p:cNvPr>
@@ -11284,7 +11284,7 @@
           <p:cNvPr id="31" name="">
             <a:extLst xmlns:a="http://schemas.openxmlformats.org/drawingml/2006/main">
               <a:ext uri="{FF2B5EF4-FFF2-40B4-BE49-F238E27FC236}">
-                <a16:creationId xmlns:a16="http://schemas.microsoft.com/office/drawing/2014/main" id="{9DD8B4A0-D08E-4798-86B0-D0D57EB9608B}"/>
+                <a16:creationId xmlns:a16="http://schemas.microsoft.com/office/drawing/2014/main" id="{181400ED-12CA-4499-B065-C611C2072E8D}"/>
               </a:ext>
             </a:extLst>
           </p:cNvPr>
@@ -11341,7 +11341,7 @@
           <p:cNvPr id="32" name="">
             <a:extLst xmlns:a="http://schemas.openxmlformats.org/drawingml/2006/main">
               <a:ext uri="{FF2B5EF4-FFF2-40B4-BE49-F238E27FC236}">
-                <a16:creationId xmlns:a16="http://schemas.microsoft.com/office/drawing/2014/main" id="{3F5780A6-FC8B-40BF-99C4-3843CC1DED00}"/>
+                <a16:creationId xmlns:a16="http://schemas.microsoft.com/office/drawing/2014/main" id="{DD7798F0-F390-4D4F-831A-6C72BCFE3910}"/>
               </a:ext>
             </a:extLst>
           </p:cNvPr>
@@ -11444,7 +11444,7 @@
           <p:cNvPr id="33" name="">
             <a:extLst xmlns:a="http://schemas.openxmlformats.org/drawingml/2006/main">
               <a:ext uri="{FF2B5EF4-FFF2-40B4-BE49-F238E27FC236}">
-                <a16:creationId xmlns:a16="http://schemas.microsoft.com/office/drawing/2014/main" id="{303DF588-FBCA-436C-A812-0867E01093E5}"/>
+                <a16:creationId xmlns:a16="http://schemas.microsoft.com/office/drawing/2014/main" id="{F65569A8-7D79-4713-9C33-B37222580412}"/>
               </a:ext>
             </a:extLst>
           </p:cNvPr>
@@ -11501,7 +11501,7 @@
           <p:cNvPr id="34" name="">
             <a:extLst xmlns:a="http://schemas.openxmlformats.org/drawingml/2006/main">
               <a:ext uri="{FF2B5EF4-FFF2-40B4-BE49-F238E27FC236}">
-                <a16:creationId xmlns:a16="http://schemas.microsoft.com/office/drawing/2014/main" id="{0631E212-8155-4394-ACDC-75994D5E3707}"/>
+                <a16:creationId xmlns:a16="http://schemas.microsoft.com/office/drawing/2014/main" id="{4510E04C-3740-4967-BAE2-D8A721D380AC}"/>
               </a:ext>
             </a:extLst>
           </p:cNvPr>
@@ -11558,7 +11558,7 @@
           <p:cNvPr id="35" name="">
             <a:extLst xmlns:a="http://schemas.openxmlformats.org/drawingml/2006/main">
               <a:ext uri="{FF2B5EF4-FFF2-40B4-BE49-F238E27FC236}">
-                <a16:creationId xmlns:a16="http://schemas.microsoft.com/office/drawing/2014/main" id="{4848E8FA-289E-4430-9082-219EBE5BC6EE}"/>
+                <a16:creationId xmlns:a16="http://schemas.microsoft.com/office/drawing/2014/main" id="{1CFC910A-6C57-4E49-BA1E-6A9BBA333987}"/>
               </a:ext>
             </a:extLst>
           </p:cNvPr>
@@ -11613,7 +11613,7 @@
     </p:spTree>
     <p:extLst>
       <p:ext uri="{BB962C8B-B14F-4D97-AF65-F5344CB8AC3E}">
-        <p14:creationId xmlns:p14="http://schemas.microsoft.com/office/powerpoint/2010/main" val="2122155869"/>
+        <p14:creationId xmlns:p14="http://schemas.microsoft.com/office/powerpoint/2010/main" val="1335129906"/>
       </p:ext>
     </p:extLst>
   </p:cSld>

</xml_diff>

<commit_message>
docs: refresh submission artifacts for provider options
</commit_message>
<xml_diff>
--- a/AURA/submission/AURA_5_SLIDES.pptx
+++ b/AURA/submission/AURA_5_SLIDES.pptx
@@ -2,17 +2,17 @@
 <file path=ppt/presentation.xml><?xml version="1.0" encoding="utf-8"?>
 <p:presentation xmlns:p="http://schemas.openxmlformats.org/presentationml/2006/main">
   <p:sldMasterIdLst>
-    <p:sldMasterId xmlns:r="http://schemas.openxmlformats.org/officeDocument/2006/relationships" id="2147483648" r:id="R49e57d9d7d7d4d6e"/>
+    <p:sldMasterId xmlns:r="http://schemas.openxmlformats.org/officeDocument/2006/relationships" id="2147483648" r:id="R8da427f69f564124"/>
   </p:sldMasterIdLst>
   <p:notesMasterIdLst>
-    <p:notesMasterId xmlns:r="http://schemas.openxmlformats.org/officeDocument/2006/relationships" r:id="R8bb450e2763846a6"/>
+    <p:notesMasterId xmlns:r="http://schemas.openxmlformats.org/officeDocument/2006/relationships" r:id="R4de5340a29794497"/>
   </p:notesMasterIdLst>
   <p:sldIdLst>
-    <p:sldId xmlns:r="http://schemas.openxmlformats.org/officeDocument/2006/relationships" id="256" r:id="Ref908b6a4dae4350"/>
-    <p:sldId xmlns:r="http://schemas.openxmlformats.org/officeDocument/2006/relationships" id="257" r:id="Rff67534619194122"/>
-    <p:sldId xmlns:r="http://schemas.openxmlformats.org/officeDocument/2006/relationships" id="258" r:id="Ra23dd9606c9a4dbe"/>
-    <p:sldId xmlns:r="http://schemas.openxmlformats.org/officeDocument/2006/relationships" id="259" r:id="R49c145e2bc5148eb"/>
-    <p:sldId xmlns:r="http://schemas.openxmlformats.org/officeDocument/2006/relationships" id="260" r:id="R2e44849f8dc94be2"/>
+    <p:sldId xmlns:r="http://schemas.openxmlformats.org/officeDocument/2006/relationships" id="256" r:id="R9b6b96808cc64c90"/>
+    <p:sldId xmlns:r="http://schemas.openxmlformats.org/officeDocument/2006/relationships" id="257" r:id="Rc565471c4e6d46ce"/>
+    <p:sldId xmlns:r="http://schemas.openxmlformats.org/officeDocument/2006/relationships" id="258" r:id="R7082c92563664a36"/>
+    <p:sldId xmlns:r="http://schemas.openxmlformats.org/officeDocument/2006/relationships" id="259" r:id="Rb4499c1123184116"/>
+    <p:sldId xmlns:r="http://schemas.openxmlformats.org/officeDocument/2006/relationships" id="260" r:id="Rc3242bc076f74bf9"/>
   </p:sldIdLst>
   <p:sldSz cx="12192000" cy="6858000"/>
   <p:notesSz cx="6858000" cy="9144000"/>
@@ -586,7 +586,7 @@
           <a:lstStyle xmlns:a="http://schemas.openxmlformats.org/drawingml/2006/main"/>
           <a:p xmlns:a="http://schemas.openxmlformats.org/drawingml/2006/main">
             <a:r>
-              <a:t>Nguồn nội bộ: 56 test offline; người dùng xác nhận Verify v2 5/5 local ngày 22/09/2026. Không suy rộng thành accuracy thực tế.</a:t>
+              <a:t>Nguồn nội bộ: 60 test offline; người dùng xác nhận Verify v2 5/5 local ngày 22/09/2026. Không suy rộng thành accuracy thực tế.</a:t>
             </a:r>
           </a:p>
         </p:txBody>
@@ -794,7 +794,7 @@
   </p:cSld>
   <p:clrMap bg1="lt1" tx1="dk1" bg2="lt2" tx2="dk2" accent1="accent1" accent2="accent2" accent3="accent3" accent4="accent4" accent5="accent5" accent6="accent6" hlink="hlink" folHlink="folHlink"/>
   <p:sldLayoutIdLst>
-    <p:sldLayoutId xmlns:r="http://schemas.openxmlformats.org/officeDocument/2006/relationships" id="2147483649" r:id="Re36b331a80a74c6c"/>
+    <p:sldLayoutId xmlns:r="http://schemas.openxmlformats.org/officeDocument/2006/relationships" id="2147483649" r:id="R2fa286435e3449fd"/>
   </p:sldLayoutIdLst>
   <p:txStyles>
     <p:titleStyle>
@@ -1345,7 +1345,7 @@
           <p:cNvPr id="47" name="">
             <a:extLst xmlns:a="http://schemas.openxmlformats.org/drawingml/2006/main">
               <a:ext uri="{FF2B5EF4-FFF2-40B4-BE49-F238E27FC236}">
-                <a16:creationId xmlns:a16="http://schemas.microsoft.com/office/drawing/2014/main" id="{02C39A8B-6EB9-4682-88EC-0EE753A623F9}"/>
+                <a16:creationId xmlns:a16="http://schemas.microsoft.com/office/drawing/2014/main" id="{F59658FC-988A-41BB-AB1C-C0526A710AE8}"/>
               </a:ext>
             </a:extLst>
           </p:cNvPr>
@@ -1402,7 +1402,7 @@
           <p:cNvPr id="2" name="">
             <a:extLst xmlns:a="http://schemas.openxmlformats.org/drawingml/2006/main">
               <a:ext uri="{FF2B5EF4-FFF2-40B4-BE49-F238E27FC236}">
-                <a16:creationId xmlns:a16="http://schemas.microsoft.com/office/drawing/2014/main" id="{F662F884-9438-446D-8C18-835683342478}"/>
+                <a16:creationId xmlns:a16="http://schemas.microsoft.com/office/drawing/2014/main" id="{B5CE0600-2B92-4735-A15D-0E5BB1EE27F0}"/>
               </a:ext>
             </a:extLst>
           </p:cNvPr>
@@ -1459,7 +1459,7 @@
           <p:cNvPr id="3" name="">
             <a:extLst xmlns:a="http://schemas.openxmlformats.org/drawingml/2006/main">
               <a:ext uri="{FF2B5EF4-FFF2-40B4-BE49-F238E27FC236}">
-                <a16:creationId xmlns:a16="http://schemas.microsoft.com/office/drawing/2014/main" id="{C7B47E80-B370-44C1-A390-2319A632C6EE}"/>
+                <a16:creationId xmlns:a16="http://schemas.microsoft.com/office/drawing/2014/main" id="{82AF457D-99A6-49A0-B887-1CA31843B63F}"/>
               </a:ext>
             </a:extLst>
           </p:cNvPr>
@@ -1516,7 +1516,7 @@
           <p:cNvPr id="4" name="">
             <a:extLst xmlns:a="http://schemas.openxmlformats.org/drawingml/2006/main">
               <a:ext uri="{FF2B5EF4-FFF2-40B4-BE49-F238E27FC236}">
-                <a16:creationId xmlns:a16="http://schemas.microsoft.com/office/drawing/2014/main" id="{8384F392-4F55-4A5E-9597-5551C135325E}"/>
+                <a16:creationId xmlns:a16="http://schemas.microsoft.com/office/drawing/2014/main" id="{31FE8974-C635-4CA9-95BA-C9791E7A14F4}"/>
               </a:ext>
             </a:extLst>
           </p:cNvPr>
@@ -1547,7 +1547,7 @@
           <p:cNvPr id="5" name="">
             <a:extLst xmlns:a="http://schemas.openxmlformats.org/drawingml/2006/main">
               <a:ext uri="{FF2B5EF4-FFF2-40B4-BE49-F238E27FC236}">
-                <a16:creationId xmlns:a16="http://schemas.microsoft.com/office/drawing/2014/main" id="{DF002452-E360-4D9E-A7E3-52CFB0B923B5}"/>
+                <a16:creationId xmlns:a16="http://schemas.microsoft.com/office/drawing/2014/main" id="{83AE6E5E-8205-4BB3-8410-F6817AE0E52E}"/>
               </a:ext>
             </a:extLst>
           </p:cNvPr>
@@ -1582,7 +1582,7 @@
           <p:cNvPr id="6" name="">
             <a:extLst xmlns:a="http://schemas.openxmlformats.org/drawingml/2006/main">
               <a:ext uri="{FF2B5EF4-FFF2-40B4-BE49-F238E27FC236}">
-                <a16:creationId xmlns:a16="http://schemas.microsoft.com/office/drawing/2014/main" id="{2F63ED11-395C-4AE9-B64D-38FC2FDAE2B9}"/>
+                <a16:creationId xmlns:a16="http://schemas.microsoft.com/office/drawing/2014/main" id="{6939F1F3-2623-4D66-AF64-D62F778D69F5}"/>
               </a:ext>
             </a:extLst>
           </p:cNvPr>
@@ -1646,7 +1646,7 @@
           <p:cNvPr id="7" name="">
             <a:extLst xmlns:a="http://schemas.openxmlformats.org/drawingml/2006/main">
               <a:ext uri="{FF2B5EF4-FFF2-40B4-BE49-F238E27FC236}">
-                <a16:creationId xmlns:a16="http://schemas.microsoft.com/office/drawing/2014/main" id="{EE7FD7E6-C933-4A81-9640-2EF6BDE0E917}"/>
+                <a16:creationId xmlns:a16="http://schemas.microsoft.com/office/drawing/2014/main" id="{85964B4E-D315-44E6-B3F3-5448354A0063}"/>
               </a:ext>
             </a:extLst>
           </p:cNvPr>
@@ -1703,7 +1703,7 @@
           <p:cNvPr id="8" name="">
             <a:extLst xmlns:a="http://schemas.openxmlformats.org/drawingml/2006/main">
               <a:ext uri="{FF2B5EF4-FFF2-40B4-BE49-F238E27FC236}">
-                <a16:creationId xmlns:a16="http://schemas.microsoft.com/office/drawing/2014/main" id="{549D8A33-42B6-409A-8FD6-538FC4ACEA74}"/>
+                <a16:creationId xmlns:a16="http://schemas.microsoft.com/office/drawing/2014/main" id="{FDAEED3D-B47A-4EB0-A2E3-9FB5662976E9}"/>
               </a:ext>
             </a:extLst>
           </p:cNvPr>
@@ -1760,7 +1760,7 @@
           <p:cNvPr id="9" name="">
             <a:extLst xmlns:a="http://schemas.openxmlformats.org/drawingml/2006/main">
               <a:ext uri="{FF2B5EF4-FFF2-40B4-BE49-F238E27FC236}">
-                <a16:creationId xmlns:a16="http://schemas.microsoft.com/office/drawing/2014/main" id="{2CBA1DC6-1500-42AC-B869-401A2557ACFA}"/>
+                <a16:creationId xmlns:a16="http://schemas.microsoft.com/office/drawing/2014/main" id="{C5332A7D-30EF-4F1B-A4E0-0E514325BFFA}"/>
               </a:ext>
             </a:extLst>
           </p:cNvPr>
@@ -1792,7 +1792,7 @@
           <p:cNvPr id="10" name="">
             <a:extLst xmlns:a="http://schemas.openxmlformats.org/drawingml/2006/main">
               <a:ext uri="{FF2B5EF4-FFF2-40B4-BE49-F238E27FC236}">
-                <a16:creationId xmlns:a16="http://schemas.microsoft.com/office/drawing/2014/main" id="{0988A4F1-F0D3-40C1-9A87-F6DA10909409}"/>
+                <a16:creationId xmlns:a16="http://schemas.microsoft.com/office/drawing/2014/main" id="{918FD1A4-1191-4451-96C7-7D6DC4075125}"/>
               </a:ext>
             </a:extLst>
           </p:cNvPr>
@@ -1827,7 +1827,7 @@
           <p:cNvPr id="11" name="">
             <a:extLst xmlns:a="http://schemas.openxmlformats.org/drawingml/2006/main">
               <a:ext uri="{FF2B5EF4-FFF2-40B4-BE49-F238E27FC236}">
-                <a16:creationId xmlns:a16="http://schemas.microsoft.com/office/drawing/2014/main" id="{FB306973-1482-44C3-AFF1-EB4EFF8AAAFB}"/>
+                <a16:creationId xmlns:a16="http://schemas.microsoft.com/office/drawing/2014/main" id="{71D84B43-590F-4135-9DC7-D67984EB7A32}"/>
               </a:ext>
             </a:extLst>
           </p:cNvPr>
@@ -1891,7 +1891,7 @@
           <p:cNvPr id="12" name="">
             <a:extLst xmlns:a="http://schemas.openxmlformats.org/drawingml/2006/main">
               <a:ext uri="{FF2B5EF4-FFF2-40B4-BE49-F238E27FC236}">
-                <a16:creationId xmlns:a16="http://schemas.microsoft.com/office/drawing/2014/main" id="{7241FF7C-8FE7-4B31-8360-E56109FF78A4}"/>
+                <a16:creationId xmlns:a16="http://schemas.microsoft.com/office/drawing/2014/main" id="{F952A321-2075-47F6-9B84-90A0F20EA3EE}"/>
               </a:ext>
             </a:extLst>
           </p:cNvPr>
@@ -1948,7 +1948,7 @@
           <p:cNvPr id="13" name="">
             <a:extLst xmlns:a="http://schemas.openxmlformats.org/drawingml/2006/main">
               <a:ext uri="{FF2B5EF4-FFF2-40B4-BE49-F238E27FC236}">
-                <a16:creationId xmlns:a16="http://schemas.microsoft.com/office/drawing/2014/main" id="{C5C02DFA-A07B-4DD5-8971-6AE031EE3C0C}"/>
+                <a16:creationId xmlns:a16="http://schemas.microsoft.com/office/drawing/2014/main" id="{580A34B3-952C-41BC-BFF9-12DCD0023DC3}"/>
               </a:ext>
             </a:extLst>
           </p:cNvPr>
@@ -2005,7 +2005,7 @@
           <p:cNvPr id="14" name="">
             <a:extLst xmlns:a="http://schemas.openxmlformats.org/drawingml/2006/main">
               <a:ext uri="{FF2B5EF4-FFF2-40B4-BE49-F238E27FC236}">
-                <a16:creationId xmlns:a16="http://schemas.microsoft.com/office/drawing/2014/main" id="{CE9F044F-C190-44EC-BC4C-884D1B87899B}"/>
+                <a16:creationId xmlns:a16="http://schemas.microsoft.com/office/drawing/2014/main" id="{A102B5A2-3844-49E3-A5E9-765392EDAA0D}"/>
               </a:ext>
             </a:extLst>
           </p:cNvPr>
@@ -2037,7 +2037,7 @@
           <p:cNvPr id="15" name="">
             <a:extLst xmlns:a="http://schemas.openxmlformats.org/drawingml/2006/main">
               <a:ext uri="{FF2B5EF4-FFF2-40B4-BE49-F238E27FC236}">
-                <a16:creationId xmlns:a16="http://schemas.microsoft.com/office/drawing/2014/main" id="{3AF93C1D-4BE1-4FA5-8E44-BD5C9BB46801}"/>
+                <a16:creationId xmlns:a16="http://schemas.microsoft.com/office/drawing/2014/main" id="{8EE85FBB-9250-4085-9F87-38FB98260577}"/>
               </a:ext>
             </a:extLst>
           </p:cNvPr>
@@ -2072,7 +2072,7 @@
           <p:cNvPr id="16" name="">
             <a:extLst xmlns:a="http://schemas.openxmlformats.org/drawingml/2006/main">
               <a:ext uri="{FF2B5EF4-FFF2-40B4-BE49-F238E27FC236}">
-                <a16:creationId xmlns:a16="http://schemas.microsoft.com/office/drawing/2014/main" id="{30EA2332-8514-43F8-B481-82E2543F78FB}"/>
+                <a16:creationId xmlns:a16="http://schemas.microsoft.com/office/drawing/2014/main" id="{E7000A8D-A657-4B76-81AE-9E8BE271D7F9}"/>
               </a:ext>
             </a:extLst>
           </p:cNvPr>
@@ -2136,7 +2136,7 @@
           <p:cNvPr id="17" name="">
             <a:extLst xmlns:a="http://schemas.openxmlformats.org/drawingml/2006/main">
               <a:ext uri="{FF2B5EF4-FFF2-40B4-BE49-F238E27FC236}">
-                <a16:creationId xmlns:a16="http://schemas.microsoft.com/office/drawing/2014/main" id="{921FCE40-AD5A-4979-A693-78658B9ABCE2}"/>
+                <a16:creationId xmlns:a16="http://schemas.microsoft.com/office/drawing/2014/main" id="{E13DACBF-24A1-4192-A382-CFBEAACD392F}"/>
               </a:ext>
             </a:extLst>
           </p:cNvPr>
@@ -2193,7 +2193,7 @@
           <p:cNvPr id="18" name="">
             <a:extLst xmlns:a="http://schemas.openxmlformats.org/drawingml/2006/main">
               <a:ext uri="{FF2B5EF4-FFF2-40B4-BE49-F238E27FC236}">
-                <a16:creationId xmlns:a16="http://schemas.microsoft.com/office/drawing/2014/main" id="{C453EE81-BD66-4BE1-8AEB-4617EAB9E97D}"/>
+                <a16:creationId xmlns:a16="http://schemas.microsoft.com/office/drawing/2014/main" id="{F7CA152B-FD84-4CA7-90C4-AFFE6A28DAE9}"/>
               </a:ext>
             </a:extLst>
           </p:cNvPr>
@@ -2250,7 +2250,7 @@
           <p:cNvPr id="19" name="">
             <a:extLst xmlns:a="http://schemas.openxmlformats.org/drawingml/2006/main">
               <a:ext uri="{FF2B5EF4-FFF2-40B4-BE49-F238E27FC236}">
-                <a16:creationId xmlns:a16="http://schemas.microsoft.com/office/drawing/2014/main" id="{5CEF3DAC-5BCD-4823-A10D-4F18B18A6AAB}"/>
+                <a16:creationId xmlns:a16="http://schemas.microsoft.com/office/drawing/2014/main" id="{EEF45564-AB9D-4922-A027-DA6586F6D8E6}"/>
               </a:ext>
             </a:extLst>
           </p:cNvPr>
@@ -2282,7 +2282,7 @@
           <p:cNvPr id="20" name="">
             <a:extLst xmlns:a="http://schemas.openxmlformats.org/drawingml/2006/main">
               <a:ext uri="{FF2B5EF4-FFF2-40B4-BE49-F238E27FC236}">
-                <a16:creationId xmlns:a16="http://schemas.microsoft.com/office/drawing/2014/main" id="{5A293C93-293E-43A5-A1D4-D6221A171881}"/>
+                <a16:creationId xmlns:a16="http://schemas.microsoft.com/office/drawing/2014/main" id="{F3ADA410-C12A-476F-ADC9-2938E60E26A0}"/>
               </a:ext>
             </a:extLst>
           </p:cNvPr>
@@ -2317,7 +2317,7 @@
           <p:cNvPr id="21" name="">
             <a:extLst xmlns:a="http://schemas.openxmlformats.org/drawingml/2006/main">
               <a:ext uri="{FF2B5EF4-FFF2-40B4-BE49-F238E27FC236}">
-                <a16:creationId xmlns:a16="http://schemas.microsoft.com/office/drawing/2014/main" id="{42234300-7CC0-4950-8FBC-29291D30E2F6}"/>
+                <a16:creationId xmlns:a16="http://schemas.microsoft.com/office/drawing/2014/main" id="{A2DDFF50-0430-46DF-A977-5F191CA5014C}"/>
               </a:ext>
             </a:extLst>
           </p:cNvPr>
@@ -2381,7 +2381,7 @@
           <p:cNvPr id="22" name="">
             <a:extLst xmlns:a="http://schemas.openxmlformats.org/drawingml/2006/main">
               <a:ext uri="{FF2B5EF4-FFF2-40B4-BE49-F238E27FC236}">
-                <a16:creationId xmlns:a16="http://schemas.microsoft.com/office/drawing/2014/main" id="{466362F6-A3D3-4116-B065-883165AF96A0}"/>
+                <a16:creationId xmlns:a16="http://schemas.microsoft.com/office/drawing/2014/main" id="{29C29A12-440F-482C-88C9-799D91B239E5}"/>
               </a:ext>
             </a:extLst>
           </p:cNvPr>
@@ -2438,7 +2438,7 @@
           <p:cNvPr id="23" name="">
             <a:extLst xmlns:a="http://schemas.openxmlformats.org/drawingml/2006/main">
               <a:ext uri="{FF2B5EF4-FFF2-40B4-BE49-F238E27FC236}">
-                <a16:creationId xmlns:a16="http://schemas.microsoft.com/office/drawing/2014/main" id="{AEBA6D66-6D78-4765-94AB-0E2CDB040665}"/>
+                <a16:creationId xmlns:a16="http://schemas.microsoft.com/office/drawing/2014/main" id="{1AA8B0F3-5B45-462D-B1FF-A2FDD9064EE3}"/>
               </a:ext>
             </a:extLst>
           </p:cNvPr>
@@ -2495,7 +2495,7 @@
           <p:cNvPr id="24" name="">
             <a:extLst xmlns:a="http://schemas.openxmlformats.org/drawingml/2006/main">
               <a:ext uri="{FF2B5EF4-FFF2-40B4-BE49-F238E27FC236}">
-                <a16:creationId xmlns:a16="http://schemas.microsoft.com/office/drawing/2014/main" id="{3E83A75B-29FC-4A88-B110-D67F40F3D151}"/>
+                <a16:creationId xmlns:a16="http://schemas.microsoft.com/office/drawing/2014/main" id="{8F9140C6-50D2-4055-81BB-7508B93B74AD}"/>
               </a:ext>
             </a:extLst>
           </p:cNvPr>
@@ -2527,7 +2527,7 @@
           <p:cNvPr id="25" name="">
             <a:extLst xmlns:a="http://schemas.openxmlformats.org/drawingml/2006/main">
               <a:ext uri="{FF2B5EF4-FFF2-40B4-BE49-F238E27FC236}">
-                <a16:creationId xmlns:a16="http://schemas.microsoft.com/office/drawing/2014/main" id="{5344217C-64E5-4AE7-A7AC-3DD313FCB61C}"/>
+                <a16:creationId xmlns:a16="http://schemas.microsoft.com/office/drawing/2014/main" id="{FB06200B-B879-49DB-802B-019F41365E35}"/>
               </a:ext>
             </a:extLst>
           </p:cNvPr>
@@ -2562,7 +2562,7 @@
           <p:cNvPr id="26" name="">
             <a:extLst xmlns:a="http://schemas.openxmlformats.org/drawingml/2006/main">
               <a:ext uri="{FF2B5EF4-FFF2-40B4-BE49-F238E27FC236}">
-                <a16:creationId xmlns:a16="http://schemas.microsoft.com/office/drawing/2014/main" id="{96CE968A-FFED-4AA7-99EF-B158D6B443BE}"/>
+                <a16:creationId xmlns:a16="http://schemas.microsoft.com/office/drawing/2014/main" id="{525A1B6B-421F-4186-B7B8-7420D41D5980}"/>
               </a:ext>
             </a:extLst>
           </p:cNvPr>
@@ -2626,7 +2626,7 @@
           <p:cNvPr id="27" name="">
             <a:extLst xmlns:a="http://schemas.openxmlformats.org/drawingml/2006/main">
               <a:ext uri="{FF2B5EF4-FFF2-40B4-BE49-F238E27FC236}">
-                <a16:creationId xmlns:a16="http://schemas.microsoft.com/office/drawing/2014/main" id="{8B0D9DC3-4852-4D28-91DB-2E7EC6892A1C}"/>
+                <a16:creationId xmlns:a16="http://schemas.microsoft.com/office/drawing/2014/main" id="{B2AD6CBC-7FB6-47FA-B736-116C844CDB9D}"/>
               </a:ext>
             </a:extLst>
           </p:cNvPr>
@@ -2683,7 +2683,7 @@
           <p:cNvPr id="28" name="">
             <a:extLst xmlns:a="http://schemas.openxmlformats.org/drawingml/2006/main">
               <a:ext uri="{FF2B5EF4-FFF2-40B4-BE49-F238E27FC236}">
-                <a16:creationId xmlns:a16="http://schemas.microsoft.com/office/drawing/2014/main" id="{7C567FE2-81AE-4137-BE98-2B1AD3B5EC41}"/>
+                <a16:creationId xmlns:a16="http://schemas.microsoft.com/office/drawing/2014/main" id="{B7E87B2F-6263-4028-95B7-E044824655BD}"/>
               </a:ext>
             </a:extLst>
           </p:cNvPr>
@@ -2740,7 +2740,7 @@
           <p:cNvPr id="29" name="">
             <a:extLst xmlns:a="http://schemas.openxmlformats.org/drawingml/2006/main">
               <a:ext uri="{FF2B5EF4-FFF2-40B4-BE49-F238E27FC236}">
-                <a16:creationId xmlns:a16="http://schemas.microsoft.com/office/drawing/2014/main" id="{160CF755-A3D6-49DD-AF29-49DE3CF70378}"/>
+                <a16:creationId xmlns:a16="http://schemas.microsoft.com/office/drawing/2014/main" id="{F2CA905A-C151-47C8-9E7E-66E3950B4189}"/>
               </a:ext>
             </a:extLst>
           </p:cNvPr>
@@ -2775,7 +2775,7 @@
           <p:cNvPr id="30" name="">
             <a:extLst xmlns:a="http://schemas.openxmlformats.org/drawingml/2006/main">
               <a:ext uri="{FF2B5EF4-FFF2-40B4-BE49-F238E27FC236}">
-                <a16:creationId xmlns:a16="http://schemas.microsoft.com/office/drawing/2014/main" id="{D38430A0-A6C9-4824-B8D0-6BFB54052369}"/>
+                <a16:creationId xmlns:a16="http://schemas.microsoft.com/office/drawing/2014/main" id="{F5BD2151-6A1C-4E59-B3CB-37B78B5A2112}"/>
               </a:ext>
             </a:extLst>
           </p:cNvPr>
@@ -2832,7 +2832,7 @@
           <p:cNvPr id="31" name="">
             <a:extLst xmlns:a="http://schemas.openxmlformats.org/drawingml/2006/main">
               <a:ext uri="{FF2B5EF4-FFF2-40B4-BE49-F238E27FC236}">
-                <a16:creationId xmlns:a16="http://schemas.microsoft.com/office/drawing/2014/main" id="{3FAD40C1-422C-4080-BDD1-B7B1B556329D}"/>
+                <a16:creationId xmlns:a16="http://schemas.microsoft.com/office/drawing/2014/main" id="{29812ACA-246E-449B-93FE-A930AE32DC06}"/>
               </a:ext>
             </a:extLst>
           </p:cNvPr>
@@ -2889,7 +2889,7 @@
           <p:cNvPr id="32" name="">
             <a:extLst xmlns:a="http://schemas.openxmlformats.org/drawingml/2006/main">
               <a:ext uri="{FF2B5EF4-FFF2-40B4-BE49-F238E27FC236}">
-                <a16:creationId xmlns:a16="http://schemas.microsoft.com/office/drawing/2014/main" id="{0C1C7061-31D1-42C1-BF9C-64B68A52FEE5}"/>
+                <a16:creationId xmlns:a16="http://schemas.microsoft.com/office/drawing/2014/main" id="{BA9B3C2B-3B49-415E-91DF-186A4532EC0B}"/>
               </a:ext>
             </a:extLst>
           </p:cNvPr>
@@ -2946,7 +2946,7 @@
           <p:cNvPr id="33" name="">
             <a:extLst xmlns:a="http://schemas.openxmlformats.org/drawingml/2006/main">
               <a:ext uri="{FF2B5EF4-FFF2-40B4-BE49-F238E27FC236}">
-                <a16:creationId xmlns:a16="http://schemas.microsoft.com/office/drawing/2014/main" id="{C044CAEB-47C2-4666-BB0E-33355DEB221B}"/>
+                <a16:creationId xmlns:a16="http://schemas.microsoft.com/office/drawing/2014/main" id="{CA76CD83-9FC0-4643-9DCF-30E8AA17087E}"/>
               </a:ext>
             </a:extLst>
           </p:cNvPr>
@@ -2981,7 +2981,7 @@
           <p:cNvPr id="34" name="">
             <a:extLst xmlns:a="http://schemas.openxmlformats.org/drawingml/2006/main">
               <a:ext uri="{FF2B5EF4-FFF2-40B4-BE49-F238E27FC236}">
-                <a16:creationId xmlns:a16="http://schemas.microsoft.com/office/drawing/2014/main" id="{56BD0E3C-8A33-48CA-82C1-BD7D4866737A}"/>
+                <a16:creationId xmlns:a16="http://schemas.microsoft.com/office/drawing/2014/main" id="{3042472B-5151-454F-AA06-D8470637C441}"/>
               </a:ext>
             </a:extLst>
           </p:cNvPr>
@@ -3045,7 +3045,7 @@
           <p:cNvPr id="35" name="">
             <a:extLst xmlns:a="http://schemas.openxmlformats.org/drawingml/2006/main">
               <a:ext uri="{FF2B5EF4-FFF2-40B4-BE49-F238E27FC236}">
-                <a16:creationId xmlns:a16="http://schemas.microsoft.com/office/drawing/2014/main" id="{340FDFAA-D472-45C9-9B82-47550E15981F}"/>
+                <a16:creationId xmlns:a16="http://schemas.microsoft.com/office/drawing/2014/main" id="{199B9FA9-7F68-4747-B909-867C3357B4B2}"/>
               </a:ext>
             </a:extLst>
           </p:cNvPr>
@@ -3102,7 +3102,7 @@
           <p:cNvPr id="36" name="">
             <a:extLst xmlns:a="http://schemas.openxmlformats.org/drawingml/2006/main">
               <a:ext uri="{FF2B5EF4-FFF2-40B4-BE49-F238E27FC236}">
-                <a16:creationId xmlns:a16="http://schemas.microsoft.com/office/drawing/2014/main" id="{B175CA50-59F9-494C-B2A3-7B09BAC44043}"/>
+                <a16:creationId xmlns:a16="http://schemas.microsoft.com/office/drawing/2014/main" id="{E993E80D-3621-4938-A289-36E8EBFE4C85}"/>
               </a:ext>
             </a:extLst>
           </p:cNvPr>
@@ -3159,7 +3159,7 @@
           <p:cNvPr id="37" name="">
             <a:extLst xmlns:a="http://schemas.openxmlformats.org/drawingml/2006/main">
               <a:ext uri="{FF2B5EF4-FFF2-40B4-BE49-F238E27FC236}">
-                <a16:creationId xmlns:a16="http://schemas.microsoft.com/office/drawing/2014/main" id="{2392930B-4F30-426A-A6AD-6C9CD3D05696}"/>
+                <a16:creationId xmlns:a16="http://schemas.microsoft.com/office/drawing/2014/main" id="{5138D811-5AD3-4BDF-A30A-5059C3A3B680}"/>
               </a:ext>
             </a:extLst>
           </p:cNvPr>
@@ -3194,7 +3194,7 @@
           <p:cNvPr id="38" name="">
             <a:extLst xmlns:a="http://schemas.openxmlformats.org/drawingml/2006/main">
               <a:ext uri="{FF2B5EF4-FFF2-40B4-BE49-F238E27FC236}">
-                <a16:creationId xmlns:a16="http://schemas.microsoft.com/office/drawing/2014/main" id="{28B4A403-E469-4388-8554-CA2161924BB2}"/>
+                <a16:creationId xmlns:a16="http://schemas.microsoft.com/office/drawing/2014/main" id="{E2F48456-794C-4707-93A3-939411723295}"/>
               </a:ext>
             </a:extLst>
           </p:cNvPr>
@@ -3258,7 +3258,7 @@
           <p:cNvPr id="39" name="">
             <a:extLst xmlns:a="http://schemas.openxmlformats.org/drawingml/2006/main">
               <a:ext uri="{FF2B5EF4-FFF2-40B4-BE49-F238E27FC236}">
-                <a16:creationId xmlns:a16="http://schemas.microsoft.com/office/drawing/2014/main" id="{1E71C291-DF01-47CC-8374-5F532E17970F}"/>
+                <a16:creationId xmlns:a16="http://schemas.microsoft.com/office/drawing/2014/main" id="{B9C07B09-352F-47A1-9CC0-3206E2DDEACE}"/>
               </a:ext>
             </a:extLst>
           </p:cNvPr>
@@ -3315,7 +3315,7 @@
           <p:cNvPr id="40" name="">
             <a:extLst xmlns:a="http://schemas.openxmlformats.org/drawingml/2006/main">
               <a:ext uri="{FF2B5EF4-FFF2-40B4-BE49-F238E27FC236}">
-                <a16:creationId xmlns:a16="http://schemas.microsoft.com/office/drawing/2014/main" id="{24B6BDA6-A6B6-43FC-8808-9E99ADB9F68F}"/>
+                <a16:creationId xmlns:a16="http://schemas.microsoft.com/office/drawing/2014/main" id="{080AE680-3B67-45A8-A5DD-1CAC9DA2DFF2}"/>
               </a:ext>
             </a:extLst>
           </p:cNvPr>
@@ -3372,7 +3372,7 @@
           <p:cNvPr id="41" name="">
             <a:extLst xmlns:a="http://schemas.openxmlformats.org/drawingml/2006/main">
               <a:ext uri="{FF2B5EF4-FFF2-40B4-BE49-F238E27FC236}">
-                <a16:creationId xmlns:a16="http://schemas.microsoft.com/office/drawing/2014/main" id="{AE5785DF-FD46-4C33-98A7-8C1C703958D0}"/>
+                <a16:creationId xmlns:a16="http://schemas.microsoft.com/office/drawing/2014/main" id="{2F027B09-8B26-46D2-97A0-896E162714D4}"/>
               </a:ext>
             </a:extLst>
           </p:cNvPr>
@@ -3407,7 +3407,7 @@
           <p:cNvPr id="42" name="">
             <a:extLst xmlns:a="http://schemas.openxmlformats.org/drawingml/2006/main">
               <a:ext uri="{FF2B5EF4-FFF2-40B4-BE49-F238E27FC236}">
-                <a16:creationId xmlns:a16="http://schemas.microsoft.com/office/drawing/2014/main" id="{C73E4A6F-146C-4287-8238-BD1FA2631200}"/>
+                <a16:creationId xmlns:a16="http://schemas.microsoft.com/office/drawing/2014/main" id="{09F4F1FB-C6E0-465E-B5C7-CA023FC96FD4}"/>
               </a:ext>
             </a:extLst>
           </p:cNvPr>
@@ -3471,7 +3471,7 @@
           <p:cNvPr id="43" name="">
             <a:extLst xmlns:a="http://schemas.openxmlformats.org/drawingml/2006/main">
               <a:ext uri="{FF2B5EF4-FFF2-40B4-BE49-F238E27FC236}">
-                <a16:creationId xmlns:a16="http://schemas.microsoft.com/office/drawing/2014/main" id="{E2554FC6-7B99-4514-AAF1-E6BA522DB93A}"/>
+                <a16:creationId xmlns:a16="http://schemas.microsoft.com/office/drawing/2014/main" id="{BAA21ED3-47E7-487E-A98D-7E25458B4447}"/>
               </a:ext>
             </a:extLst>
           </p:cNvPr>
@@ -3528,7 +3528,7 @@
           <p:cNvPr id="44" name="">
             <a:extLst xmlns:a="http://schemas.openxmlformats.org/drawingml/2006/main">
               <a:ext uri="{FF2B5EF4-FFF2-40B4-BE49-F238E27FC236}">
-                <a16:creationId xmlns:a16="http://schemas.microsoft.com/office/drawing/2014/main" id="{AA8B3F8D-BF53-4A03-9D52-75052751D7AF}"/>
+                <a16:creationId xmlns:a16="http://schemas.microsoft.com/office/drawing/2014/main" id="{42B7785A-9DD5-440C-97FD-9904C759F74F}"/>
               </a:ext>
             </a:extLst>
           </p:cNvPr>
@@ -3585,7 +3585,7 @@
           <p:cNvPr id="45" name="">
             <a:extLst xmlns:a="http://schemas.openxmlformats.org/drawingml/2006/main">
               <a:ext uri="{FF2B5EF4-FFF2-40B4-BE49-F238E27FC236}">
-                <a16:creationId xmlns:a16="http://schemas.microsoft.com/office/drawing/2014/main" id="{DCD81D02-4683-46BB-8A34-9CA533E0A3A7}"/>
+                <a16:creationId xmlns:a16="http://schemas.microsoft.com/office/drawing/2014/main" id="{C10537FD-A5C9-4ADE-B152-2D1566D551DA}"/>
               </a:ext>
             </a:extLst>
           </p:cNvPr>
@@ -3632,7 +3632,7 @@
                 <a:ea typeface="Arial"/>
                 <a:cs typeface="Arial"/>
               </a:rPr>
-              <a:t>AURA • Track A • 24/09/2026</a:t>
+              <a:t>AURA • Track A • 26/09/2026</a:t>
             </a:r>
           </a:p>
         </p:txBody>
@@ -3642,7 +3642,7 @@
           <p:cNvPr id="46" name="">
             <a:extLst xmlns:a="http://schemas.openxmlformats.org/drawingml/2006/main">
               <a:ext uri="{FF2B5EF4-FFF2-40B4-BE49-F238E27FC236}">
-                <a16:creationId xmlns:a16="http://schemas.microsoft.com/office/drawing/2014/main" id="{9FBD1689-263D-4E2C-80AD-052F4981A6EF}"/>
+                <a16:creationId xmlns:a16="http://schemas.microsoft.com/office/drawing/2014/main" id="{D0C8C8FE-D493-4A98-A5E2-C546563508F7}"/>
               </a:ext>
             </a:extLst>
           </p:cNvPr>
@@ -3697,7 +3697,7 @@
     </p:spTree>
     <p:extLst>
       <p:ext uri="{BB962C8B-B14F-4D97-AF65-F5344CB8AC3E}">
-        <p14:creationId xmlns:p14="http://schemas.microsoft.com/office/powerpoint/2010/main" val="418484325"/>
+        <p14:creationId xmlns:p14="http://schemas.microsoft.com/office/powerpoint/2010/main" val="2046781202"/>
       </p:ext>
     </p:extLst>
   </p:cSld>
@@ -3728,7 +3728,7 @@
           <p:cNvPr id="46" name="">
             <a:extLst xmlns:a="http://schemas.openxmlformats.org/drawingml/2006/main">
               <a:ext uri="{FF2B5EF4-FFF2-40B4-BE49-F238E27FC236}">
-                <a16:creationId xmlns:a16="http://schemas.microsoft.com/office/drawing/2014/main" id="{0605C085-5D14-4170-992E-42C679AB1033}"/>
+                <a16:creationId xmlns:a16="http://schemas.microsoft.com/office/drawing/2014/main" id="{3E2381FB-04B8-4B58-9076-FE30466E5DC7}"/>
               </a:ext>
             </a:extLst>
           </p:cNvPr>
@@ -3785,7 +3785,7 @@
           <p:cNvPr id="2" name="">
             <a:extLst xmlns:a="http://schemas.openxmlformats.org/drawingml/2006/main">
               <a:ext uri="{FF2B5EF4-FFF2-40B4-BE49-F238E27FC236}">
-                <a16:creationId xmlns:a16="http://schemas.microsoft.com/office/drawing/2014/main" id="{0CC038C6-DEDC-4DDA-A336-BA89E01DDB35}"/>
+                <a16:creationId xmlns:a16="http://schemas.microsoft.com/office/drawing/2014/main" id="{6292501A-48A1-4EBA-942C-416A1757C460}"/>
               </a:ext>
             </a:extLst>
           </p:cNvPr>
@@ -3842,7 +3842,7 @@
           <p:cNvPr id="3" name="">
             <a:extLst xmlns:a="http://schemas.openxmlformats.org/drawingml/2006/main">
               <a:ext uri="{FF2B5EF4-FFF2-40B4-BE49-F238E27FC236}">
-                <a16:creationId xmlns:a16="http://schemas.microsoft.com/office/drawing/2014/main" id="{DAED8053-7464-4CF0-BF91-2EA64AF28CA4}"/>
+                <a16:creationId xmlns:a16="http://schemas.microsoft.com/office/drawing/2014/main" id="{7C8CD2CF-CE19-4983-8120-9213BB975E78}"/>
               </a:ext>
             </a:extLst>
           </p:cNvPr>
@@ -3899,7 +3899,7 @@
           <p:cNvPr id="4" name="">
             <a:extLst xmlns:a="http://schemas.openxmlformats.org/drawingml/2006/main">
               <a:ext uri="{FF2B5EF4-FFF2-40B4-BE49-F238E27FC236}">
-                <a16:creationId xmlns:a16="http://schemas.microsoft.com/office/drawing/2014/main" id="{D536E802-A0C0-4E13-ACF9-F755EA4627F5}"/>
+                <a16:creationId xmlns:a16="http://schemas.microsoft.com/office/drawing/2014/main" id="{48984FEC-B0A5-4DD6-BF31-EA063A88B7D5}"/>
               </a:ext>
             </a:extLst>
           </p:cNvPr>
@@ -3930,7 +3930,7 @@
           <p:cNvPr id="5" name="">
             <a:extLst xmlns:a="http://schemas.openxmlformats.org/drawingml/2006/main">
               <a:ext uri="{FF2B5EF4-FFF2-40B4-BE49-F238E27FC236}">
-                <a16:creationId xmlns:a16="http://schemas.microsoft.com/office/drawing/2014/main" id="{CC1768A9-CFC5-4F5C-836D-6CFB5DBCF87C}"/>
+                <a16:creationId xmlns:a16="http://schemas.microsoft.com/office/drawing/2014/main" id="{D138D663-22B7-44D8-821C-CBB25803BE27}"/>
               </a:ext>
             </a:extLst>
           </p:cNvPr>
@@ -3965,7 +3965,7 @@
           <p:cNvPr id="6" name="">
             <a:extLst xmlns:a="http://schemas.openxmlformats.org/drawingml/2006/main">
               <a:ext uri="{FF2B5EF4-FFF2-40B4-BE49-F238E27FC236}">
-                <a16:creationId xmlns:a16="http://schemas.microsoft.com/office/drawing/2014/main" id="{2E1B8B43-4C2A-4116-A162-7990B607B177}"/>
+                <a16:creationId xmlns:a16="http://schemas.microsoft.com/office/drawing/2014/main" id="{530FA893-5A7D-4C63-B952-8A589BE024E6}"/>
               </a:ext>
             </a:extLst>
           </p:cNvPr>
@@ -4029,7 +4029,7 @@
           <p:cNvPr id="7" name="">
             <a:extLst xmlns:a="http://schemas.openxmlformats.org/drawingml/2006/main">
               <a:ext uri="{FF2B5EF4-FFF2-40B4-BE49-F238E27FC236}">
-                <a16:creationId xmlns:a16="http://schemas.microsoft.com/office/drawing/2014/main" id="{37AB3FAD-6EC3-4777-97BE-BBF93E5616D3}"/>
+                <a16:creationId xmlns:a16="http://schemas.microsoft.com/office/drawing/2014/main" id="{C893B330-6BFC-40C9-AE91-5D3694285A06}"/>
               </a:ext>
             </a:extLst>
           </p:cNvPr>
@@ -4086,7 +4086,7 @@
           <p:cNvPr id="8" name="">
             <a:extLst xmlns:a="http://schemas.openxmlformats.org/drawingml/2006/main">
               <a:ext uri="{FF2B5EF4-FFF2-40B4-BE49-F238E27FC236}">
-                <a16:creationId xmlns:a16="http://schemas.microsoft.com/office/drawing/2014/main" id="{14C256AE-EB1F-4E79-9201-0717959BB270}"/>
+                <a16:creationId xmlns:a16="http://schemas.microsoft.com/office/drawing/2014/main" id="{8BA1908F-C245-42A5-882A-C50811E08A54}"/>
               </a:ext>
             </a:extLst>
           </p:cNvPr>
@@ -4166,7 +4166,7 @@
           <p:cNvPr id="9" name="">
             <a:extLst xmlns:a="http://schemas.openxmlformats.org/drawingml/2006/main">
               <a:ext uri="{FF2B5EF4-FFF2-40B4-BE49-F238E27FC236}">
-                <a16:creationId xmlns:a16="http://schemas.microsoft.com/office/drawing/2014/main" id="{991E5593-412D-4470-8A45-1B2A4F913AB8}"/>
+                <a16:creationId xmlns:a16="http://schemas.microsoft.com/office/drawing/2014/main" id="{88E2ECE6-AE09-4036-92A9-0CE8C25C3079}"/>
               </a:ext>
             </a:extLst>
           </p:cNvPr>
@@ -4198,7 +4198,7 @@
           <p:cNvPr id="10" name="">
             <a:extLst xmlns:a="http://schemas.openxmlformats.org/drawingml/2006/main">
               <a:ext uri="{FF2B5EF4-FFF2-40B4-BE49-F238E27FC236}">
-                <a16:creationId xmlns:a16="http://schemas.microsoft.com/office/drawing/2014/main" id="{2759D27B-A60D-4125-AEDA-9A137BED098A}"/>
+                <a16:creationId xmlns:a16="http://schemas.microsoft.com/office/drawing/2014/main" id="{32C979CB-B042-4FD8-B78A-08BCEE388F69}"/>
               </a:ext>
             </a:extLst>
           </p:cNvPr>
@@ -4233,7 +4233,7 @@
           <p:cNvPr id="11" name="">
             <a:extLst xmlns:a="http://schemas.openxmlformats.org/drawingml/2006/main">
               <a:ext uri="{FF2B5EF4-FFF2-40B4-BE49-F238E27FC236}">
-                <a16:creationId xmlns:a16="http://schemas.microsoft.com/office/drawing/2014/main" id="{B21CF1D9-A8CE-404D-AFE4-A628806E49D8}"/>
+                <a16:creationId xmlns:a16="http://schemas.microsoft.com/office/drawing/2014/main" id="{8338FF07-B2AC-4A57-BDDB-D090C7965C57}"/>
               </a:ext>
             </a:extLst>
           </p:cNvPr>
@@ -4297,7 +4297,7 @@
           <p:cNvPr id="12" name="">
             <a:extLst xmlns:a="http://schemas.openxmlformats.org/drawingml/2006/main">
               <a:ext uri="{FF2B5EF4-FFF2-40B4-BE49-F238E27FC236}">
-                <a16:creationId xmlns:a16="http://schemas.microsoft.com/office/drawing/2014/main" id="{E89E7614-5CC3-4D70-98AB-FC905850DB23}"/>
+                <a16:creationId xmlns:a16="http://schemas.microsoft.com/office/drawing/2014/main" id="{313F1AEC-1E43-489A-9641-F979BE1ECF27}"/>
               </a:ext>
             </a:extLst>
           </p:cNvPr>
@@ -4354,7 +4354,7 @@
           <p:cNvPr id="13" name="">
             <a:extLst xmlns:a="http://schemas.openxmlformats.org/drawingml/2006/main">
               <a:ext uri="{FF2B5EF4-FFF2-40B4-BE49-F238E27FC236}">
-                <a16:creationId xmlns:a16="http://schemas.microsoft.com/office/drawing/2014/main" id="{57640B2B-408B-4668-BB42-511A218531A2}"/>
+                <a16:creationId xmlns:a16="http://schemas.microsoft.com/office/drawing/2014/main" id="{FAAB85FE-5763-4A7C-A1C1-4B4DE8AC119D}"/>
               </a:ext>
             </a:extLst>
           </p:cNvPr>
@@ -4434,7 +4434,7 @@
           <p:cNvPr id="14" name="">
             <a:extLst xmlns:a="http://schemas.openxmlformats.org/drawingml/2006/main">
               <a:ext uri="{FF2B5EF4-FFF2-40B4-BE49-F238E27FC236}">
-                <a16:creationId xmlns:a16="http://schemas.microsoft.com/office/drawing/2014/main" id="{EC7179D1-71BF-42FD-BDF3-4698F299CA63}"/>
+                <a16:creationId xmlns:a16="http://schemas.microsoft.com/office/drawing/2014/main" id="{CBAC1B73-3112-488B-AD53-79F91875947A}"/>
               </a:ext>
             </a:extLst>
           </p:cNvPr>
@@ -4466,7 +4466,7 @@
           <p:cNvPr id="15" name="">
             <a:extLst xmlns:a="http://schemas.openxmlformats.org/drawingml/2006/main">
               <a:ext uri="{FF2B5EF4-FFF2-40B4-BE49-F238E27FC236}">
-                <a16:creationId xmlns:a16="http://schemas.microsoft.com/office/drawing/2014/main" id="{3D3BE8D3-FC9C-4E17-8029-3BCEA935A09F}"/>
+                <a16:creationId xmlns:a16="http://schemas.microsoft.com/office/drawing/2014/main" id="{DB95356A-56C5-4885-9B8D-07404BB37025}"/>
               </a:ext>
             </a:extLst>
           </p:cNvPr>
@@ -4501,7 +4501,7 @@
           <p:cNvPr id="16" name="">
             <a:extLst xmlns:a="http://schemas.openxmlformats.org/drawingml/2006/main">
               <a:ext uri="{FF2B5EF4-FFF2-40B4-BE49-F238E27FC236}">
-                <a16:creationId xmlns:a16="http://schemas.microsoft.com/office/drawing/2014/main" id="{CDAF25CD-3B8F-4E8D-B564-68A0B074AF14}"/>
+                <a16:creationId xmlns:a16="http://schemas.microsoft.com/office/drawing/2014/main" id="{9A78F900-F659-46BA-B7A0-31C9E864373D}"/>
               </a:ext>
             </a:extLst>
           </p:cNvPr>
@@ -4565,7 +4565,7 @@
           <p:cNvPr id="17" name="">
             <a:extLst xmlns:a="http://schemas.openxmlformats.org/drawingml/2006/main">
               <a:ext uri="{FF2B5EF4-FFF2-40B4-BE49-F238E27FC236}">
-                <a16:creationId xmlns:a16="http://schemas.microsoft.com/office/drawing/2014/main" id="{A0A63FAC-E73B-4E87-8807-500850EA3DA9}"/>
+                <a16:creationId xmlns:a16="http://schemas.microsoft.com/office/drawing/2014/main" id="{B2F736FB-878B-4E49-8C19-4CCAE4BEDFB0}"/>
               </a:ext>
             </a:extLst>
           </p:cNvPr>
@@ -4622,7 +4622,7 @@
           <p:cNvPr id="18" name="">
             <a:extLst xmlns:a="http://schemas.openxmlformats.org/drawingml/2006/main">
               <a:ext uri="{FF2B5EF4-FFF2-40B4-BE49-F238E27FC236}">
-                <a16:creationId xmlns:a16="http://schemas.microsoft.com/office/drawing/2014/main" id="{B4EA485E-9F46-4DCF-9BDA-B4821FA91185}"/>
+                <a16:creationId xmlns:a16="http://schemas.microsoft.com/office/drawing/2014/main" id="{ADA0824D-2093-427A-9207-05D9AD43AF4F}"/>
               </a:ext>
             </a:extLst>
           </p:cNvPr>
@@ -4669,7 +4669,7 @@
                 <a:ea typeface="Arial"/>
                 <a:cs typeface="Arial"/>
               </a:rPr>
-              <a:t>Qwen/OpenRouter</a:t>
+              <a:t>Provider cấu hình</a:t>
             </a:r>
           </a:p>
           <a:p xmlns:a="http://schemas.openxmlformats.org/drawingml/2006/main">
@@ -4702,7 +4702,7 @@
           <p:cNvPr id="19" name="">
             <a:extLst xmlns:a="http://schemas.openxmlformats.org/drawingml/2006/main">
               <a:ext uri="{FF2B5EF4-FFF2-40B4-BE49-F238E27FC236}">
-                <a16:creationId xmlns:a16="http://schemas.microsoft.com/office/drawing/2014/main" id="{9EAA03FE-21E5-4BB9-B98D-ADBA858B64E7}"/>
+                <a16:creationId xmlns:a16="http://schemas.microsoft.com/office/drawing/2014/main" id="{0411F8CC-9129-4B1D-B545-17E764966C2B}"/>
               </a:ext>
             </a:extLst>
           </p:cNvPr>
@@ -4734,7 +4734,7 @@
           <p:cNvPr id="20" name="">
             <a:extLst xmlns:a="http://schemas.openxmlformats.org/drawingml/2006/main">
               <a:ext uri="{FF2B5EF4-FFF2-40B4-BE49-F238E27FC236}">
-                <a16:creationId xmlns:a16="http://schemas.microsoft.com/office/drawing/2014/main" id="{D180AD1F-0DF6-44AD-AB04-EF2A71B9BCF6}"/>
+                <a16:creationId xmlns:a16="http://schemas.microsoft.com/office/drawing/2014/main" id="{4D55CCC5-8C63-491D-B764-D9277A6708D5}"/>
               </a:ext>
             </a:extLst>
           </p:cNvPr>
@@ -4769,7 +4769,7 @@
           <p:cNvPr id="21" name="">
             <a:extLst xmlns:a="http://schemas.openxmlformats.org/drawingml/2006/main">
               <a:ext uri="{FF2B5EF4-FFF2-40B4-BE49-F238E27FC236}">
-                <a16:creationId xmlns:a16="http://schemas.microsoft.com/office/drawing/2014/main" id="{3EFAEA96-2AE1-4F82-9B97-B3F3C20C0FC9}"/>
+                <a16:creationId xmlns:a16="http://schemas.microsoft.com/office/drawing/2014/main" id="{C0AD07E4-B152-430A-BF67-86C35A27DB2F}"/>
               </a:ext>
             </a:extLst>
           </p:cNvPr>
@@ -4833,7 +4833,7 @@
           <p:cNvPr id="22" name="">
             <a:extLst xmlns:a="http://schemas.openxmlformats.org/drawingml/2006/main">
               <a:ext uri="{FF2B5EF4-FFF2-40B4-BE49-F238E27FC236}">
-                <a16:creationId xmlns:a16="http://schemas.microsoft.com/office/drawing/2014/main" id="{AD696B5F-D4F5-41F0-8B45-4FDA0549108C}"/>
+                <a16:creationId xmlns:a16="http://schemas.microsoft.com/office/drawing/2014/main" id="{F4DF76E3-A1DB-4FC5-8E8D-754132C7C515}"/>
               </a:ext>
             </a:extLst>
           </p:cNvPr>
@@ -4890,7 +4890,7 @@
           <p:cNvPr id="23" name="">
             <a:extLst xmlns:a="http://schemas.openxmlformats.org/drawingml/2006/main">
               <a:ext uri="{FF2B5EF4-FFF2-40B4-BE49-F238E27FC236}">
-                <a16:creationId xmlns:a16="http://schemas.microsoft.com/office/drawing/2014/main" id="{77C4D1CD-6C23-4059-AE3A-94A09BE7B899}"/>
+                <a16:creationId xmlns:a16="http://schemas.microsoft.com/office/drawing/2014/main" id="{4C7E24C1-8C92-4442-A6EC-7F90FD6D6D23}"/>
               </a:ext>
             </a:extLst>
           </p:cNvPr>
@@ -4970,7 +4970,7 @@
           <p:cNvPr id="24" name="">
             <a:extLst xmlns:a="http://schemas.openxmlformats.org/drawingml/2006/main">
               <a:ext uri="{FF2B5EF4-FFF2-40B4-BE49-F238E27FC236}">
-                <a16:creationId xmlns:a16="http://schemas.microsoft.com/office/drawing/2014/main" id="{00DD9658-EE3D-42B4-9E27-C6032F6A711A}"/>
+                <a16:creationId xmlns:a16="http://schemas.microsoft.com/office/drawing/2014/main" id="{F9D34DB6-2C75-49A3-9ACF-A19463F56CA9}"/>
               </a:ext>
             </a:extLst>
           </p:cNvPr>
@@ -5002,7 +5002,7 @@
           <p:cNvPr id="25" name="">
             <a:extLst xmlns:a="http://schemas.openxmlformats.org/drawingml/2006/main">
               <a:ext uri="{FF2B5EF4-FFF2-40B4-BE49-F238E27FC236}">
-                <a16:creationId xmlns:a16="http://schemas.microsoft.com/office/drawing/2014/main" id="{AF896E8C-DF67-40BC-BAE0-3F425840E228}"/>
+                <a16:creationId xmlns:a16="http://schemas.microsoft.com/office/drawing/2014/main" id="{B316C9F3-986C-4AB8-89BA-8BA8EB2E056A}"/>
               </a:ext>
             </a:extLst>
           </p:cNvPr>
@@ -5037,7 +5037,7 @@
           <p:cNvPr id="26" name="">
             <a:extLst xmlns:a="http://schemas.openxmlformats.org/drawingml/2006/main">
               <a:ext uri="{FF2B5EF4-FFF2-40B4-BE49-F238E27FC236}">
-                <a16:creationId xmlns:a16="http://schemas.microsoft.com/office/drawing/2014/main" id="{F79439D9-AD54-469F-8450-40A0DEB71087}"/>
+                <a16:creationId xmlns:a16="http://schemas.microsoft.com/office/drawing/2014/main" id="{0583C03B-8E15-47BD-B7AA-78552F28AF27}"/>
               </a:ext>
             </a:extLst>
           </p:cNvPr>
@@ -5101,7 +5101,7 @@
           <p:cNvPr id="27" name="">
             <a:extLst xmlns:a="http://schemas.openxmlformats.org/drawingml/2006/main">
               <a:ext uri="{FF2B5EF4-FFF2-40B4-BE49-F238E27FC236}">
-                <a16:creationId xmlns:a16="http://schemas.microsoft.com/office/drawing/2014/main" id="{55B05DB0-DB39-4CC2-B3EE-4D3B4F1A6EAD}"/>
+                <a16:creationId xmlns:a16="http://schemas.microsoft.com/office/drawing/2014/main" id="{00368D05-01DD-43C9-A729-42E364C055D4}"/>
               </a:ext>
             </a:extLst>
           </p:cNvPr>
@@ -5158,7 +5158,7 @@
           <p:cNvPr id="28" name="">
             <a:extLst xmlns:a="http://schemas.openxmlformats.org/drawingml/2006/main">
               <a:ext uri="{FF2B5EF4-FFF2-40B4-BE49-F238E27FC236}">
-                <a16:creationId xmlns:a16="http://schemas.microsoft.com/office/drawing/2014/main" id="{4B734FEB-1AA6-4832-952F-A7817E5D7350}"/>
+                <a16:creationId xmlns:a16="http://schemas.microsoft.com/office/drawing/2014/main" id="{D89D875E-2A4D-4042-9FF0-9E16D65360EC}"/>
               </a:ext>
             </a:extLst>
           </p:cNvPr>
@@ -5238,7 +5238,7 @@
           <p:cNvPr id="29" name="">
             <a:extLst xmlns:a="http://schemas.openxmlformats.org/drawingml/2006/main">
               <a:ext uri="{FF2B5EF4-FFF2-40B4-BE49-F238E27FC236}">
-                <a16:creationId xmlns:a16="http://schemas.microsoft.com/office/drawing/2014/main" id="{C440973F-3661-43DC-AB21-74675D284904}"/>
+                <a16:creationId xmlns:a16="http://schemas.microsoft.com/office/drawing/2014/main" id="{ED19241E-1C87-4759-AB93-E25F7ECF408E}"/>
               </a:ext>
             </a:extLst>
           </p:cNvPr>
@@ -5295,7 +5295,7 @@
           <p:cNvPr id="30" name="">
             <a:extLst xmlns:a="http://schemas.openxmlformats.org/drawingml/2006/main">
               <a:ext uri="{FF2B5EF4-FFF2-40B4-BE49-F238E27FC236}">
-                <a16:creationId xmlns:a16="http://schemas.microsoft.com/office/drawing/2014/main" id="{D05A42C7-A17D-48D9-840E-787D57D962FE}"/>
+                <a16:creationId xmlns:a16="http://schemas.microsoft.com/office/drawing/2014/main" id="{216E7803-FF71-4142-90DC-3FA65FF8C8AA}"/>
               </a:ext>
             </a:extLst>
           </p:cNvPr>
@@ -5330,7 +5330,7 @@
           <p:cNvPr id="31" name="">
             <a:extLst xmlns:a="http://schemas.openxmlformats.org/drawingml/2006/main">
               <a:ext uri="{FF2B5EF4-FFF2-40B4-BE49-F238E27FC236}">
-                <a16:creationId xmlns:a16="http://schemas.microsoft.com/office/drawing/2014/main" id="{F5DD74CE-C20D-40C2-BAD9-517B58F8AD88}"/>
+                <a16:creationId xmlns:a16="http://schemas.microsoft.com/office/drawing/2014/main" id="{142AD4D0-54B3-452B-8734-0622B2C6DCC0}"/>
               </a:ext>
             </a:extLst>
           </p:cNvPr>
@@ -5387,7 +5387,7 @@
           <p:cNvPr id="32" name="">
             <a:extLst xmlns:a="http://schemas.openxmlformats.org/drawingml/2006/main">
               <a:ext uri="{FF2B5EF4-FFF2-40B4-BE49-F238E27FC236}">
-                <a16:creationId xmlns:a16="http://schemas.microsoft.com/office/drawing/2014/main" id="{8CD49FC7-FD7D-45FB-9210-1C158B935D4A}"/>
+                <a16:creationId xmlns:a16="http://schemas.microsoft.com/office/drawing/2014/main" id="{7F63E0A9-B259-492F-AC10-02ABEAA63E58}"/>
               </a:ext>
             </a:extLst>
           </p:cNvPr>
@@ -5490,7 +5490,7 @@
           <p:cNvPr id="33" name="">
             <a:extLst xmlns:a="http://schemas.openxmlformats.org/drawingml/2006/main">
               <a:ext uri="{FF2B5EF4-FFF2-40B4-BE49-F238E27FC236}">
-                <a16:creationId xmlns:a16="http://schemas.microsoft.com/office/drawing/2014/main" id="{1CCAB291-C51E-4DDA-ABB1-59E81D4FB617}"/>
+                <a16:creationId xmlns:a16="http://schemas.microsoft.com/office/drawing/2014/main" id="{A09CFC93-8C24-4602-9C75-B6C1F0016A5E}"/>
               </a:ext>
             </a:extLst>
           </p:cNvPr>
@@ -5554,7 +5554,7 @@
           <p:cNvPr id="34" name="">
             <a:extLst xmlns:a="http://schemas.openxmlformats.org/drawingml/2006/main">
               <a:ext uri="{FF2B5EF4-FFF2-40B4-BE49-F238E27FC236}">
-                <a16:creationId xmlns:a16="http://schemas.microsoft.com/office/drawing/2014/main" id="{8BCB21C3-84B9-4540-A26B-05F707AAA6F1}"/>
+                <a16:creationId xmlns:a16="http://schemas.microsoft.com/office/drawing/2014/main" id="{AA97E46C-30CE-4053-8CEB-68E4984BCBE1}"/>
               </a:ext>
             </a:extLst>
           </p:cNvPr>
@@ -5611,7 +5611,7 @@
           <p:cNvPr id="35" name="">
             <a:extLst xmlns:a="http://schemas.openxmlformats.org/drawingml/2006/main">
               <a:ext uri="{FF2B5EF4-FFF2-40B4-BE49-F238E27FC236}">
-                <a16:creationId xmlns:a16="http://schemas.microsoft.com/office/drawing/2014/main" id="{171F1A5B-D7A1-401C-9FFF-61829C4047DA}"/>
+                <a16:creationId xmlns:a16="http://schemas.microsoft.com/office/drawing/2014/main" id="{19C5FC80-185D-4AFD-8C72-721761FF7980}"/>
               </a:ext>
             </a:extLst>
           </p:cNvPr>
@@ -5646,7 +5646,7 @@
           <p:cNvPr id="36" name="">
             <a:extLst xmlns:a="http://schemas.openxmlformats.org/drawingml/2006/main">
               <a:ext uri="{FF2B5EF4-FFF2-40B4-BE49-F238E27FC236}">
-                <a16:creationId xmlns:a16="http://schemas.microsoft.com/office/drawing/2014/main" id="{2C32ABF9-D8C3-4468-B4AE-B4EC11D98062}"/>
+                <a16:creationId xmlns:a16="http://schemas.microsoft.com/office/drawing/2014/main" id="{A4B83AC4-DA4C-46EA-811E-BBA10DB105EB}"/>
               </a:ext>
             </a:extLst>
           </p:cNvPr>
@@ -5703,7 +5703,7 @@
           <p:cNvPr id="37" name="">
             <a:extLst xmlns:a="http://schemas.openxmlformats.org/drawingml/2006/main">
               <a:ext uri="{FF2B5EF4-FFF2-40B4-BE49-F238E27FC236}">
-                <a16:creationId xmlns:a16="http://schemas.microsoft.com/office/drawing/2014/main" id="{67C0C971-67F4-4CF1-B2A1-A76A85C6AD23}"/>
+                <a16:creationId xmlns:a16="http://schemas.microsoft.com/office/drawing/2014/main" id="{9A2B141E-E346-4CC3-9B70-5BDAD0490C09}"/>
               </a:ext>
             </a:extLst>
           </p:cNvPr>
@@ -5738,7 +5738,7 @@
           <p:cNvPr id="38" name="">
             <a:extLst xmlns:a="http://schemas.openxmlformats.org/drawingml/2006/main">
               <a:ext uri="{FF2B5EF4-FFF2-40B4-BE49-F238E27FC236}">
-                <a16:creationId xmlns:a16="http://schemas.microsoft.com/office/drawing/2014/main" id="{4C4588F2-F713-47B5-BAF2-FD0DCD803890}"/>
+                <a16:creationId xmlns:a16="http://schemas.microsoft.com/office/drawing/2014/main" id="{B88B36D9-6207-4BAE-B6D0-B391834C833C}"/>
               </a:ext>
             </a:extLst>
           </p:cNvPr>
@@ -5795,7 +5795,7 @@
           <p:cNvPr id="39" name="">
             <a:extLst xmlns:a="http://schemas.openxmlformats.org/drawingml/2006/main">
               <a:ext uri="{FF2B5EF4-FFF2-40B4-BE49-F238E27FC236}">
-                <a16:creationId xmlns:a16="http://schemas.microsoft.com/office/drawing/2014/main" id="{39F2087D-F31B-4215-ACB8-158E77660EDD}"/>
+                <a16:creationId xmlns:a16="http://schemas.microsoft.com/office/drawing/2014/main" id="{D4F9DE2A-C526-47D0-BA2F-5B782C33E40E}"/>
               </a:ext>
             </a:extLst>
           </p:cNvPr>
@@ -5852,7 +5852,7 @@
           <p:cNvPr id="40" name="">
             <a:extLst xmlns:a="http://schemas.openxmlformats.org/drawingml/2006/main">
               <a:ext uri="{FF2B5EF4-FFF2-40B4-BE49-F238E27FC236}">
-                <a16:creationId xmlns:a16="http://schemas.microsoft.com/office/drawing/2014/main" id="{B4772714-F722-44B2-99E8-F700239A86F8}"/>
+                <a16:creationId xmlns:a16="http://schemas.microsoft.com/office/drawing/2014/main" id="{5327CB62-9B1B-4974-8950-8E2603DEB475}"/>
               </a:ext>
             </a:extLst>
           </p:cNvPr>
@@ -5887,7 +5887,7 @@
           <p:cNvPr id="41" name="">
             <a:extLst xmlns:a="http://schemas.openxmlformats.org/drawingml/2006/main">
               <a:ext uri="{FF2B5EF4-FFF2-40B4-BE49-F238E27FC236}">
-                <a16:creationId xmlns:a16="http://schemas.microsoft.com/office/drawing/2014/main" id="{6523C9E9-776E-4C34-AACD-AD1D017A1E16}"/>
+                <a16:creationId xmlns:a16="http://schemas.microsoft.com/office/drawing/2014/main" id="{ED371E23-F83F-4D16-9943-93C4EF3B73D9}"/>
               </a:ext>
             </a:extLst>
           </p:cNvPr>
@@ -5944,7 +5944,7 @@
           <p:cNvPr id="42" name="">
             <a:extLst xmlns:a="http://schemas.openxmlformats.org/drawingml/2006/main">
               <a:ext uri="{FF2B5EF4-FFF2-40B4-BE49-F238E27FC236}">
-                <a16:creationId xmlns:a16="http://schemas.microsoft.com/office/drawing/2014/main" id="{4B2D3429-AB4E-43DC-B90E-2CDD90AC6DE9}"/>
+                <a16:creationId xmlns:a16="http://schemas.microsoft.com/office/drawing/2014/main" id="{5017D63C-7838-48D9-87BE-09DC703B7A4A}"/>
               </a:ext>
             </a:extLst>
           </p:cNvPr>
@@ -6001,7 +6001,7 @@
           <p:cNvPr id="43" name="">
             <a:extLst xmlns:a="http://schemas.openxmlformats.org/drawingml/2006/main">
               <a:ext uri="{FF2B5EF4-FFF2-40B4-BE49-F238E27FC236}">
-                <a16:creationId xmlns:a16="http://schemas.microsoft.com/office/drawing/2014/main" id="{A0932C49-CC60-428B-8995-CAC50DE9F720}"/>
+                <a16:creationId xmlns:a16="http://schemas.microsoft.com/office/drawing/2014/main" id="{6F7EBCC8-E985-4956-823B-1D29C71905D1}"/>
               </a:ext>
             </a:extLst>
           </p:cNvPr>
@@ -6058,7 +6058,7 @@
           <p:cNvPr id="44" name="">
             <a:extLst xmlns:a="http://schemas.openxmlformats.org/drawingml/2006/main">
               <a:ext uri="{FF2B5EF4-FFF2-40B4-BE49-F238E27FC236}">
-                <a16:creationId xmlns:a16="http://schemas.microsoft.com/office/drawing/2014/main" id="{4CF2BE82-506D-4E3A-B266-1EDD27E63116}"/>
+                <a16:creationId xmlns:a16="http://schemas.microsoft.com/office/drawing/2014/main" id="{2038C833-403E-448B-9D11-2812A2641D15}"/>
               </a:ext>
             </a:extLst>
           </p:cNvPr>
@@ -6105,7 +6105,7 @@
                 <a:ea typeface="Arial"/>
                 <a:cs typeface="Arial"/>
               </a:rPr>
-              <a:t>AURA • Track A • 24/09/2026</a:t>
+              <a:t>AURA • Track A • 26/09/2026</a:t>
             </a:r>
           </a:p>
         </p:txBody>
@@ -6115,7 +6115,7 @@
           <p:cNvPr id="45" name="">
             <a:extLst xmlns:a="http://schemas.openxmlformats.org/drawingml/2006/main">
               <a:ext uri="{FF2B5EF4-FFF2-40B4-BE49-F238E27FC236}">
-                <a16:creationId xmlns:a16="http://schemas.microsoft.com/office/drawing/2014/main" id="{E01E7B43-353F-453D-821D-8287E97FE918}"/>
+                <a16:creationId xmlns:a16="http://schemas.microsoft.com/office/drawing/2014/main" id="{CF0238C2-5EF1-47F9-900A-8C8BA123A330}"/>
               </a:ext>
             </a:extLst>
           </p:cNvPr>
@@ -6170,7 +6170,7 @@
     </p:spTree>
     <p:extLst>
       <p:ext uri="{BB962C8B-B14F-4D97-AF65-F5344CB8AC3E}">
-        <p14:creationId xmlns:p14="http://schemas.microsoft.com/office/powerpoint/2010/main" val="1298736877"/>
+        <p14:creationId xmlns:p14="http://schemas.microsoft.com/office/powerpoint/2010/main" val="688689080"/>
       </p:ext>
     </p:extLst>
   </p:cSld>
@@ -6201,7 +6201,7 @@
           <p:cNvPr id="32" name="">
             <a:extLst xmlns:a="http://schemas.openxmlformats.org/drawingml/2006/main">
               <a:ext uri="{FF2B5EF4-FFF2-40B4-BE49-F238E27FC236}">
-                <a16:creationId xmlns:a16="http://schemas.microsoft.com/office/drawing/2014/main" id="{9352CD83-EC42-4721-98F9-BFFEB5EB4F44}"/>
+                <a16:creationId xmlns:a16="http://schemas.microsoft.com/office/drawing/2014/main" id="{FE3BF0EF-7ECD-462C-AF15-10398808603E}"/>
               </a:ext>
             </a:extLst>
           </p:cNvPr>
@@ -6258,7 +6258,7 @@
           <p:cNvPr id="2" name="">
             <a:extLst xmlns:a="http://schemas.openxmlformats.org/drawingml/2006/main">
               <a:ext uri="{FF2B5EF4-FFF2-40B4-BE49-F238E27FC236}">
-                <a16:creationId xmlns:a16="http://schemas.microsoft.com/office/drawing/2014/main" id="{C5CFF0C0-C154-4308-A732-246F89FAD9D4}"/>
+                <a16:creationId xmlns:a16="http://schemas.microsoft.com/office/drawing/2014/main" id="{6B1C86B1-E505-47A1-95F8-57843D1583C6}"/>
               </a:ext>
             </a:extLst>
           </p:cNvPr>
@@ -6315,7 +6315,7 @@
           <p:cNvPr id="3" name="">
             <a:extLst xmlns:a="http://schemas.openxmlformats.org/drawingml/2006/main">
               <a:ext uri="{FF2B5EF4-FFF2-40B4-BE49-F238E27FC236}">
-                <a16:creationId xmlns:a16="http://schemas.microsoft.com/office/drawing/2014/main" id="{C65A78CD-8C4E-46BC-A495-C8668CB798C0}"/>
+                <a16:creationId xmlns:a16="http://schemas.microsoft.com/office/drawing/2014/main" id="{5BA16765-30FA-4BB8-9EDF-8B149E87460F}"/>
               </a:ext>
             </a:extLst>
           </p:cNvPr>
@@ -6372,7 +6372,7 @@
           <p:cNvPr id="4" name="">
             <a:extLst xmlns:a="http://schemas.openxmlformats.org/drawingml/2006/main">
               <a:ext uri="{FF2B5EF4-FFF2-40B4-BE49-F238E27FC236}">
-                <a16:creationId xmlns:a16="http://schemas.microsoft.com/office/drawing/2014/main" id="{ECBD8713-92C0-4E3F-B4CA-6667BE10AAEA}"/>
+                <a16:creationId xmlns:a16="http://schemas.microsoft.com/office/drawing/2014/main" id="{C8A21EFB-9D9E-4DCA-BFE0-321AD5ABB23F}"/>
               </a:ext>
             </a:extLst>
           </p:cNvPr>
@@ -6403,7 +6403,7 @@
           <p:cNvPr id="5" name="">
             <a:extLst xmlns:a="http://schemas.openxmlformats.org/drawingml/2006/main">
               <a:ext uri="{FF2B5EF4-FFF2-40B4-BE49-F238E27FC236}">
-                <a16:creationId xmlns:a16="http://schemas.microsoft.com/office/drawing/2014/main" id="{DB50243C-510A-45DF-A2C6-5E4124644D53}"/>
+                <a16:creationId xmlns:a16="http://schemas.microsoft.com/office/drawing/2014/main" id="{1D7B8510-0FFD-4220-AAE6-903CA22648FA}"/>
               </a:ext>
             </a:extLst>
           </p:cNvPr>
@@ -6438,7 +6438,7 @@
           <p:cNvPr id="6" name="">
             <a:extLst xmlns:a="http://schemas.openxmlformats.org/drawingml/2006/main">
               <a:ext uri="{FF2B5EF4-FFF2-40B4-BE49-F238E27FC236}">
-                <a16:creationId xmlns:a16="http://schemas.microsoft.com/office/drawing/2014/main" id="{03261E96-2696-4A86-B1EB-818F4EEA005B}"/>
+                <a16:creationId xmlns:a16="http://schemas.microsoft.com/office/drawing/2014/main" id="{365D3D3A-0839-44BE-82E4-BA1AAFEEBCFF}"/>
               </a:ext>
             </a:extLst>
           </p:cNvPr>
@@ -6502,7 +6502,7 @@
           <p:cNvPr id="7" name="">
             <a:extLst xmlns:a="http://schemas.openxmlformats.org/drawingml/2006/main">
               <a:ext uri="{FF2B5EF4-FFF2-40B4-BE49-F238E27FC236}">
-                <a16:creationId xmlns:a16="http://schemas.microsoft.com/office/drawing/2014/main" id="{EE385361-CAB1-40CC-B9E0-4F0932DE14BC}"/>
+                <a16:creationId xmlns:a16="http://schemas.microsoft.com/office/drawing/2014/main" id="{7266CAA8-57C0-4DFA-97B5-5D593E2FB5A9}"/>
               </a:ext>
             </a:extLst>
           </p:cNvPr>
@@ -6559,7 +6559,7 @@
           <p:cNvPr id="8" name="">
             <a:extLst xmlns:a="http://schemas.openxmlformats.org/drawingml/2006/main">
               <a:ext uri="{FF2B5EF4-FFF2-40B4-BE49-F238E27FC236}">
-                <a16:creationId xmlns:a16="http://schemas.microsoft.com/office/drawing/2014/main" id="{3D5ACE60-6365-47F2-A225-D92E15B5199E}"/>
+                <a16:creationId xmlns:a16="http://schemas.microsoft.com/office/drawing/2014/main" id="{4B224471-6077-4D7A-AA16-D794FCEF4606}"/>
               </a:ext>
             </a:extLst>
           </p:cNvPr>
@@ -6662,7 +6662,7 @@
           <p:cNvPr id="9" name="">
             <a:extLst xmlns:a="http://schemas.openxmlformats.org/drawingml/2006/main">
               <a:ext uri="{FF2B5EF4-FFF2-40B4-BE49-F238E27FC236}">
-                <a16:creationId xmlns:a16="http://schemas.microsoft.com/office/drawing/2014/main" id="{9031C83D-1B90-4072-8810-1CAC81E6D5CD}"/>
+                <a16:creationId xmlns:a16="http://schemas.microsoft.com/office/drawing/2014/main" id="{C1FC5F92-21FD-4BD7-97A0-4C5229286AEB}"/>
               </a:ext>
             </a:extLst>
           </p:cNvPr>
@@ -6697,7 +6697,7 @@
           <p:cNvPr id="10" name="">
             <a:extLst xmlns:a="http://schemas.openxmlformats.org/drawingml/2006/main">
               <a:ext uri="{FF2B5EF4-FFF2-40B4-BE49-F238E27FC236}">
-                <a16:creationId xmlns:a16="http://schemas.microsoft.com/office/drawing/2014/main" id="{2DDA1E73-C84F-4A5C-A022-2362650F7792}"/>
+                <a16:creationId xmlns:a16="http://schemas.microsoft.com/office/drawing/2014/main" id="{FF6B1319-363E-45EF-99CD-E3DEC52B19FA}"/>
               </a:ext>
             </a:extLst>
           </p:cNvPr>
@@ -6761,7 +6761,7 @@
           <p:cNvPr id="11" name="">
             <a:extLst xmlns:a="http://schemas.openxmlformats.org/drawingml/2006/main">
               <a:ext uri="{FF2B5EF4-FFF2-40B4-BE49-F238E27FC236}">
-                <a16:creationId xmlns:a16="http://schemas.microsoft.com/office/drawing/2014/main" id="{37991916-C4D1-4B4A-95BC-A1AC9CDEB753}"/>
+                <a16:creationId xmlns:a16="http://schemas.microsoft.com/office/drawing/2014/main" id="{6232DCE0-95EA-43EC-BAD3-8141F391E401}"/>
               </a:ext>
             </a:extLst>
           </p:cNvPr>
@@ -6818,7 +6818,7 @@
           <p:cNvPr id="12" name="">
             <a:extLst xmlns:a="http://schemas.openxmlformats.org/drawingml/2006/main">
               <a:ext uri="{FF2B5EF4-FFF2-40B4-BE49-F238E27FC236}">
-                <a16:creationId xmlns:a16="http://schemas.microsoft.com/office/drawing/2014/main" id="{B2DC99CC-3472-4DAF-AAC4-538DA70B6824}"/>
+                <a16:creationId xmlns:a16="http://schemas.microsoft.com/office/drawing/2014/main" id="{A75FDCAF-B7DD-4E57-B229-B59D22615125}"/>
               </a:ext>
             </a:extLst>
           </p:cNvPr>
@@ -6921,7 +6921,7 @@
           <p:cNvPr id="13" name="">
             <a:extLst xmlns:a="http://schemas.openxmlformats.org/drawingml/2006/main">
               <a:ext uri="{FF2B5EF4-FFF2-40B4-BE49-F238E27FC236}">
-                <a16:creationId xmlns:a16="http://schemas.microsoft.com/office/drawing/2014/main" id="{394FC22E-849E-46B4-8C9A-C78E13C5F0E4}"/>
+                <a16:creationId xmlns:a16="http://schemas.microsoft.com/office/drawing/2014/main" id="{D3BFEF4F-5B42-4AF6-ACB2-FFF9A2A6336F}"/>
               </a:ext>
             </a:extLst>
           </p:cNvPr>
@@ -6978,7 +6978,7 @@
           <p:cNvPr id="14" name="">
             <a:extLst xmlns:a="http://schemas.openxmlformats.org/drawingml/2006/main">
               <a:ext uri="{FF2B5EF4-FFF2-40B4-BE49-F238E27FC236}">
-                <a16:creationId xmlns:a16="http://schemas.microsoft.com/office/drawing/2014/main" id="{867AC612-3B6D-4A8C-B541-233512271025}"/>
+                <a16:creationId xmlns:a16="http://schemas.microsoft.com/office/drawing/2014/main" id="{09469467-AB29-48B5-9874-B5B2BCDA4744}"/>
               </a:ext>
             </a:extLst>
           </p:cNvPr>
@@ -7013,7 +7013,7 @@
           <p:cNvPr id="15" name="">
             <a:extLst xmlns:a="http://schemas.openxmlformats.org/drawingml/2006/main">
               <a:ext uri="{FF2B5EF4-FFF2-40B4-BE49-F238E27FC236}">
-                <a16:creationId xmlns:a16="http://schemas.microsoft.com/office/drawing/2014/main" id="{CB0B5D3B-4D64-4775-B743-027128D5AE1C}"/>
+                <a16:creationId xmlns:a16="http://schemas.microsoft.com/office/drawing/2014/main" id="{D5A42E79-23DF-40B4-9EBF-B2A7DCC1B7EA}"/>
               </a:ext>
             </a:extLst>
           </p:cNvPr>
@@ -7060,7 +7060,7 @@
                 <a:ea typeface="Arial"/>
                 <a:cs typeface="Arial"/>
               </a:rPr>
-              <a:t>56/56</a:t>
+              <a:t>60/60</a:t>
             </a:r>
           </a:p>
         </p:txBody>
@@ -7070,7 +7070,7 @@
           <p:cNvPr id="16" name="">
             <a:extLst xmlns:a="http://schemas.openxmlformats.org/drawingml/2006/main">
               <a:ext uri="{FF2B5EF4-FFF2-40B4-BE49-F238E27FC236}">
-                <a16:creationId xmlns:a16="http://schemas.microsoft.com/office/drawing/2014/main" id="{DAD1184B-78BF-4EE5-B252-94134F3C7950}"/>
+                <a16:creationId xmlns:a16="http://schemas.microsoft.com/office/drawing/2014/main" id="{0764C305-A938-4336-8789-3D48A7E09850}"/>
               </a:ext>
             </a:extLst>
           </p:cNvPr>
@@ -7127,7 +7127,7 @@
           <p:cNvPr id="17" name="">
             <a:extLst xmlns:a="http://schemas.openxmlformats.org/drawingml/2006/main">
               <a:ext uri="{FF2B5EF4-FFF2-40B4-BE49-F238E27FC236}">
-                <a16:creationId xmlns:a16="http://schemas.microsoft.com/office/drawing/2014/main" id="{A8C6B52F-4610-43CD-B661-3DA0F6C1878A}"/>
+                <a16:creationId xmlns:a16="http://schemas.microsoft.com/office/drawing/2014/main" id="{E7D873BC-9B4A-4CD9-9851-70FB7FC20996}"/>
               </a:ext>
             </a:extLst>
           </p:cNvPr>
@@ -7162,7 +7162,7 @@
           <p:cNvPr id="18" name="">
             <a:extLst xmlns:a="http://schemas.openxmlformats.org/drawingml/2006/main">
               <a:ext uri="{FF2B5EF4-FFF2-40B4-BE49-F238E27FC236}">
-                <a16:creationId xmlns:a16="http://schemas.microsoft.com/office/drawing/2014/main" id="{79D27054-9D39-4C10-AC06-BA58923ED2C6}"/>
+                <a16:creationId xmlns:a16="http://schemas.microsoft.com/office/drawing/2014/main" id="{E0DAEFAF-312D-4D7F-905B-C2885F123888}"/>
               </a:ext>
             </a:extLst>
           </p:cNvPr>
@@ -7219,7 +7219,7 @@
           <p:cNvPr id="19" name="">
             <a:extLst xmlns:a="http://schemas.openxmlformats.org/drawingml/2006/main">
               <a:ext uri="{FF2B5EF4-FFF2-40B4-BE49-F238E27FC236}">
-                <a16:creationId xmlns:a16="http://schemas.microsoft.com/office/drawing/2014/main" id="{A8357B6C-1710-41D7-B010-7EF2C470D214}"/>
+                <a16:creationId xmlns:a16="http://schemas.microsoft.com/office/drawing/2014/main" id="{30728E5A-0178-4C42-9380-0038E353DDAA}"/>
               </a:ext>
             </a:extLst>
           </p:cNvPr>
@@ -7276,7 +7276,7 @@
           <p:cNvPr id="20" name="">
             <a:extLst xmlns:a="http://schemas.openxmlformats.org/drawingml/2006/main">
               <a:ext uri="{FF2B5EF4-FFF2-40B4-BE49-F238E27FC236}">
-                <a16:creationId xmlns:a16="http://schemas.microsoft.com/office/drawing/2014/main" id="{DCAD157F-D8CC-4C4C-8B6D-6480246BDA79}"/>
+                <a16:creationId xmlns:a16="http://schemas.microsoft.com/office/drawing/2014/main" id="{3BCB30B9-5D74-42B5-9710-ABC76626A7A5}"/>
               </a:ext>
             </a:extLst>
           </p:cNvPr>
@@ -7311,7 +7311,7 @@
           <p:cNvPr id="21" name="">
             <a:extLst xmlns:a="http://schemas.openxmlformats.org/drawingml/2006/main">
               <a:ext uri="{FF2B5EF4-FFF2-40B4-BE49-F238E27FC236}">
-                <a16:creationId xmlns:a16="http://schemas.microsoft.com/office/drawing/2014/main" id="{421BC51B-03E8-4437-8ABA-D203227C25E1}"/>
+                <a16:creationId xmlns:a16="http://schemas.microsoft.com/office/drawing/2014/main" id="{78341962-1335-40B5-ADAF-C5827C0A374B}"/>
               </a:ext>
             </a:extLst>
           </p:cNvPr>
@@ -7368,7 +7368,7 @@
           <p:cNvPr id="22" name="">
             <a:extLst xmlns:a="http://schemas.openxmlformats.org/drawingml/2006/main">
               <a:ext uri="{FF2B5EF4-FFF2-40B4-BE49-F238E27FC236}">
-                <a16:creationId xmlns:a16="http://schemas.microsoft.com/office/drawing/2014/main" id="{51B8BADC-D8B8-4233-87EB-35920694F6BB}"/>
+                <a16:creationId xmlns:a16="http://schemas.microsoft.com/office/drawing/2014/main" id="{14DA44B0-04CD-44EE-A859-E72BFFDE2B70}"/>
               </a:ext>
             </a:extLst>
           </p:cNvPr>
@@ -7425,7 +7425,7 @@
           <p:cNvPr id="23" name="">
             <a:extLst xmlns:a="http://schemas.openxmlformats.org/drawingml/2006/main">
               <a:ext uri="{FF2B5EF4-FFF2-40B4-BE49-F238E27FC236}">
-                <a16:creationId xmlns:a16="http://schemas.microsoft.com/office/drawing/2014/main" id="{2872D36F-7F77-4C47-AE6F-7A170B839CBC}"/>
+                <a16:creationId xmlns:a16="http://schemas.microsoft.com/office/drawing/2014/main" id="{4A17DF5B-1D2D-4AA6-900F-2C58C230CEE2}"/>
               </a:ext>
             </a:extLst>
           </p:cNvPr>
@@ -7460,7 +7460,7 @@
           <p:cNvPr id="24" name="">
             <a:extLst xmlns:a="http://schemas.openxmlformats.org/drawingml/2006/main">
               <a:ext uri="{FF2B5EF4-FFF2-40B4-BE49-F238E27FC236}">
-                <a16:creationId xmlns:a16="http://schemas.microsoft.com/office/drawing/2014/main" id="{F94E7843-4C6C-4625-A129-9474CCFF45A7}"/>
+                <a16:creationId xmlns:a16="http://schemas.microsoft.com/office/drawing/2014/main" id="{E57C62A5-5667-4ABA-B471-BC43110F1F5F}"/>
               </a:ext>
             </a:extLst>
           </p:cNvPr>
@@ -7517,7 +7517,7 @@
           <p:cNvPr id="25" name="">
             <a:extLst xmlns:a="http://schemas.openxmlformats.org/drawingml/2006/main">
               <a:ext uri="{FF2B5EF4-FFF2-40B4-BE49-F238E27FC236}">
-                <a16:creationId xmlns:a16="http://schemas.microsoft.com/office/drawing/2014/main" id="{901236AC-11F8-4D35-A4DF-EA9213F28C58}"/>
+                <a16:creationId xmlns:a16="http://schemas.microsoft.com/office/drawing/2014/main" id="{2B0F0D76-8AD8-4132-B7E3-D9D9A54665E6}"/>
               </a:ext>
             </a:extLst>
           </p:cNvPr>
@@ -7581,7 +7581,7 @@
           <p:cNvPr id="26" name="">
             <a:extLst xmlns:a="http://schemas.openxmlformats.org/drawingml/2006/main">
               <a:ext uri="{FF2B5EF4-FFF2-40B4-BE49-F238E27FC236}">
-                <a16:creationId xmlns:a16="http://schemas.microsoft.com/office/drawing/2014/main" id="{E99C6858-887F-4925-A432-623BA1186D0D}"/>
+                <a16:creationId xmlns:a16="http://schemas.microsoft.com/office/drawing/2014/main" id="{F0F9CF7C-E3CF-4188-9654-30BA1BC5C39A}"/>
               </a:ext>
             </a:extLst>
           </p:cNvPr>
@@ -7645,7 +7645,7 @@
           <p:cNvPr id="27" name="">
             <a:extLst xmlns:a="http://schemas.openxmlformats.org/drawingml/2006/main">
               <a:ext uri="{FF2B5EF4-FFF2-40B4-BE49-F238E27FC236}">
-                <a16:creationId xmlns:a16="http://schemas.microsoft.com/office/drawing/2014/main" id="{2255316C-C29F-4B2A-A96A-84C94FCDE8A7}"/>
+                <a16:creationId xmlns:a16="http://schemas.microsoft.com/office/drawing/2014/main" id="{CA635995-6FBE-4F37-888B-CFE83A7F6D59}"/>
               </a:ext>
             </a:extLst>
           </p:cNvPr>
@@ -7709,7 +7709,7 @@
           <p:cNvPr id="28" name="">
             <a:extLst xmlns:a="http://schemas.openxmlformats.org/drawingml/2006/main">
               <a:ext uri="{FF2B5EF4-FFF2-40B4-BE49-F238E27FC236}">
-                <a16:creationId xmlns:a16="http://schemas.microsoft.com/office/drawing/2014/main" id="{F00D6DDB-0ADC-4067-9041-401A58F202BE}"/>
+                <a16:creationId xmlns:a16="http://schemas.microsoft.com/office/drawing/2014/main" id="{294C2A48-26A2-41E5-9F53-9AF18B3B699E}"/>
               </a:ext>
             </a:extLst>
           </p:cNvPr>
@@ -7773,7 +7773,7 @@
           <p:cNvPr id="29" name="">
             <a:extLst xmlns:a="http://schemas.openxmlformats.org/drawingml/2006/main">
               <a:ext uri="{FF2B5EF4-FFF2-40B4-BE49-F238E27FC236}">
-                <a16:creationId xmlns:a16="http://schemas.microsoft.com/office/drawing/2014/main" id="{F62D40B0-6BD4-4190-A222-D605AB491197}"/>
+                <a16:creationId xmlns:a16="http://schemas.microsoft.com/office/drawing/2014/main" id="{2D29C0B5-9B7E-4D18-8007-A5C6895DCE76}"/>
               </a:ext>
             </a:extLst>
           </p:cNvPr>
@@ -7830,7 +7830,7 @@
           <p:cNvPr id="30" name="">
             <a:extLst xmlns:a="http://schemas.openxmlformats.org/drawingml/2006/main">
               <a:ext uri="{FF2B5EF4-FFF2-40B4-BE49-F238E27FC236}">
-                <a16:creationId xmlns:a16="http://schemas.microsoft.com/office/drawing/2014/main" id="{5DA1F709-6965-4349-B155-941C39A1755B}"/>
+                <a16:creationId xmlns:a16="http://schemas.microsoft.com/office/drawing/2014/main" id="{5905F1B9-AF7F-4126-BF6D-7215B0D33883}"/>
               </a:ext>
             </a:extLst>
           </p:cNvPr>
@@ -7877,7 +7877,7 @@
                 <a:ea typeface="Arial"/>
                 <a:cs typeface="Arial"/>
               </a:rPr>
-              <a:t>AURA • Track A • 24/09/2026</a:t>
+              <a:t>AURA • Track A • 26/09/2026</a:t>
             </a:r>
           </a:p>
         </p:txBody>
@@ -7887,7 +7887,7 @@
           <p:cNvPr id="31" name="">
             <a:extLst xmlns:a="http://schemas.openxmlformats.org/drawingml/2006/main">
               <a:ext uri="{FF2B5EF4-FFF2-40B4-BE49-F238E27FC236}">
-                <a16:creationId xmlns:a16="http://schemas.microsoft.com/office/drawing/2014/main" id="{D8184D41-FC83-49A4-BFA6-95E2424B84DF}"/>
+                <a16:creationId xmlns:a16="http://schemas.microsoft.com/office/drawing/2014/main" id="{4F805BBE-0C62-4043-ADF2-3C82C79BF87F}"/>
               </a:ext>
             </a:extLst>
           </p:cNvPr>
@@ -7942,7 +7942,7 @@
     </p:spTree>
     <p:extLst>
       <p:ext uri="{BB962C8B-B14F-4D97-AF65-F5344CB8AC3E}">
-        <p14:creationId xmlns:p14="http://schemas.microsoft.com/office/powerpoint/2010/main" val="1764396408"/>
+        <p14:creationId xmlns:p14="http://schemas.microsoft.com/office/powerpoint/2010/main" val="1090811683"/>
       </p:ext>
     </p:extLst>
   </p:cSld>
@@ -7973,7 +7973,7 @@
           <p:cNvPr id="32" name="">
             <a:extLst xmlns:a="http://schemas.openxmlformats.org/drawingml/2006/main">
               <a:ext uri="{FF2B5EF4-FFF2-40B4-BE49-F238E27FC236}">
-                <a16:creationId xmlns:a16="http://schemas.microsoft.com/office/drawing/2014/main" id="{55C7333D-A533-431F-8BDD-71D280101290}"/>
+                <a16:creationId xmlns:a16="http://schemas.microsoft.com/office/drawing/2014/main" id="{E4C98F8B-A9FB-400C-BB4D-4DDA3AF9BA63}"/>
               </a:ext>
             </a:extLst>
           </p:cNvPr>
@@ -8030,7 +8030,7 @@
           <p:cNvPr id="2" name="">
             <a:extLst xmlns:a="http://schemas.openxmlformats.org/drawingml/2006/main">
               <a:ext uri="{FF2B5EF4-FFF2-40B4-BE49-F238E27FC236}">
-                <a16:creationId xmlns:a16="http://schemas.microsoft.com/office/drawing/2014/main" id="{15B78FEE-68CB-4FA1-A6BE-B4042EE51658}"/>
+                <a16:creationId xmlns:a16="http://schemas.microsoft.com/office/drawing/2014/main" id="{BA12FF13-A8B8-48E2-9D10-1C489FB140FC}"/>
               </a:ext>
             </a:extLst>
           </p:cNvPr>
@@ -8087,7 +8087,7 @@
           <p:cNvPr id="3" name="">
             <a:extLst xmlns:a="http://schemas.openxmlformats.org/drawingml/2006/main">
               <a:ext uri="{FF2B5EF4-FFF2-40B4-BE49-F238E27FC236}">
-                <a16:creationId xmlns:a16="http://schemas.microsoft.com/office/drawing/2014/main" id="{EC43740A-4287-4408-8F80-C854CA51E9CB}"/>
+                <a16:creationId xmlns:a16="http://schemas.microsoft.com/office/drawing/2014/main" id="{7F6C40A2-C547-427D-B4B4-0EFE7E14F68A}"/>
               </a:ext>
             </a:extLst>
           </p:cNvPr>
@@ -8144,7 +8144,7 @@
           <p:cNvPr id="4" name="">
             <a:extLst xmlns:a="http://schemas.openxmlformats.org/drawingml/2006/main">
               <a:ext uri="{FF2B5EF4-FFF2-40B4-BE49-F238E27FC236}">
-                <a16:creationId xmlns:a16="http://schemas.microsoft.com/office/drawing/2014/main" id="{AA12600E-EB11-42B2-8963-116232E34859}"/>
+                <a16:creationId xmlns:a16="http://schemas.microsoft.com/office/drawing/2014/main" id="{1B8B43D1-7E24-4F7C-8B32-115E2D6B364F}"/>
               </a:ext>
             </a:extLst>
           </p:cNvPr>
@@ -8175,7 +8175,7 @@
           <p:cNvPr id="5" name="">
             <a:extLst xmlns:a="http://schemas.openxmlformats.org/drawingml/2006/main">
               <a:ext uri="{FF2B5EF4-FFF2-40B4-BE49-F238E27FC236}">
-                <a16:creationId xmlns:a16="http://schemas.microsoft.com/office/drawing/2014/main" id="{4EFB6987-7264-4109-AAC8-726EEDFD8E2E}"/>
+                <a16:creationId xmlns:a16="http://schemas.microsoft.com/office/drawing/2014/main" id="{1B39586A-1969-40BA-93C7-FB4429FCFBC4}"/>
               </a:ext>
             </a:extLst>
           </p:cNvPr>
@@ -8210,7 +8210,7 @@
           <p:cNvPr id="6" name="">
             <a:extLst xmlns:a="http://schemas.openxmlformats.org/drawingml/2006/main">
               <a:ext uri="{FF2B5EF4-FFF2-40B4-BE49-F238E27FC236}">
-                <a16:creationId xmlns:a16="http://schemas.microsoft.com/office/drawing/2014/main" id="{8CF1378F-DDB7-4E43-813A-E71076571843}"/>
+                <a16:creationId xmlns:a16="http://schemas.microsoft.com/office/drawing/2014/main" id="{ED43F4B3-6E55-43A0-AD74-5930524DD67C}"/>
               </a:ext>
             </a:extLst>
           </p:cNvPr>
@@ -8274,7 +8274,7 @@
           <p:cNvPr id="7" name="">
             <a:extLst xmlns:a="http://schemas.openxmlformats.org/drawingml/2006/main">
               <a:ext uri="{FF2B5EF4-FFF2-40B4-BE49-F238E27FC236}">
-                <a16:creationId xmlns:a16="http://schemas.microsoft.com/office/drawing/2014/main" id="{DD1F54E2-93FC-41AC-B4BF-2474C69A1AAB}"/>
+                <a16:creationId xmlns:a16="http://schemas.microsoft.com/office/drawing/2014/main" id="{2FA8869D-B529-4A6A-B742-6D898031A179}"/>
               </a:ext>
             </a:extLst>
           </p:cNvPr>
@@ -8331,7 +8331,7 @@
           <p:cNvPr id="8" name="">
             <a:extLst xmlns:a="http://schemas.openxmlformats.org/drawingml/2006/main">
               <a:ext uri="{FF2B5EF4-FFF2-40B4-BE49-F238E27FC236}">
-                <a16:creationId xmlns:a16="http://schemas.microsoft.com/office/drawing/2014/main" id="{269644BA-8D9B-4A12-82A0-7FA7EBD975DD}"/>
+                <a16:creationId xmlns:a16="http://schemas.microsoft.com/office/drawing/2014/main" id="{7C2532BC-12A3-431D-B244-FF99E53FBA89}"/>
               </a:ext>
             </a:extLst>
           </p:cNvPr>
@@ -8362,7 +8362,7 @@
           <p:cNvPr id="9" name="">
             <a:extLst xmlns:a="http://schemas.openxmlformats.org/drawingml/2006/main">
               <a:ext uri="{FF2B5EF4-FFF2-40B4-BE49-F238E27FC236}">
-                <a16:creationId xmlns:a16="http://schemas.microsoft.com/office/drawing/2014/main" id="{E48AD046-B02F-4A06-84B9-1A31C3A44718}"/>
+                <a16:creationId xmlns:a16="http://schemas.microsoft.com/office/drawing/2014/main" id="{EBCCD049-463C-47B7-A910-472E339C49F3}"/>
               </a:ext>
             </a:extLst>
           </p:cNvPr>
@@ -8397,7 +8397,7 @@
           <p:cNvPr id="10" name="">
             <a:extLst xmlns:a="http://schemas.openxmlformats.org/drawingml/2006/main">
               <a:ext uri="{FF2B5EF4-FFF2-40B4-BE49-F238E27FC236}">
-                <a16:creationId xmlns:a16="http://schemas.microsoft.com/office/drawing/2014/main" id="{E52D228D-C5A2-45EA-A668-17FEA5A91597}"/>
+                <a16:creationId xmlns:a16="http://schemas.microsoft.com/office/drawing/2014/main" id="{70D1CEDC-6D8C-46B0-8A06-9F0DDE510E23}"/>
               </a:ext>
             </a:extLst>
           </p:cNvPr>
@@ -8461,7 +8461,7 @@
           <p:cNvPr id="11" name="">
             <a:extLst xmlns:a="http://schemas.openxmlformats.org/drawingml/2006/main">
               <a:ext uri="{FF2B5EF4-FFF2-40B4-BE49-F238E27FC236}">
-                <a16:creationId xmlns:a16="http://schemas.microsoft.com/office/drawing/2014/main" id="{944EB041-2B3D-422F-9BFB-90479D422069}"/>
+                <a16:creationId xmlns:a16="http://schemas.microsoft.com/office/drawing/2014/main" id="{184506B5-E3FA-4590-8028-A8446285C16B}"/>
               </a:ext>
             </a:extLst>
           </p:cNvPr>
@@ -8518,7 +8518,7 @@
           <p:cNvPr id="12" name="">
             <a:extLst xmlns:a="http://schemas.openxmlformats.org/drawingml/2006/main">
               <a:ext uri="{FF2B5EF4-FFF2-40B4-BE49-F238E27FC236}">
-                <a16:creationId xmlns:a16="http://schemas.microsoft.com/office/drawing/2014/main" id="{ACD3DDEB-5A94-4B80-BD3D-0CFBFEA7B8E1}"/>
+                <a16:creationId xmlns:a16="http://schemas.microsoft.com/office/drawing/2014/main" id="{53CDEADE-24FD-421D-B718-B7C0980B43D5}"/>
               </a:ext>
             </a:extLst>
           </p:cNvPr>
@@ -8549,7 +8549,7 @@
           <p:cNvPr id="13" name="">
             <a:extLst xmlns:a="http://schemas.openxmlformats.org/drawingml/2006/main">
               <a:ext uri="{FF2B5EF4-FFF2-40B4-BE49-F238E27FC236}">
-                <a16:creationId xmlns:a16="http://schemas.microsoft.com/office/drawing/2014/main" id="{9E34EEF9-AC77-472D-820E-4B186FD195D0}"/>
+                <a16:creationId xmlns:a16="http://schemas.microsoft.com/office/drawing/2014/main" id="{63F3A068-6344-4738-93C9-47B75F447838}"/>
               </a:ext>
             </a:extLst>
           </p:cNvPr>
@@ -8584,7 +8584,7 @@
           <p:cNvPr id="14" name="">
             <a:extLst xmlns:a="http://schemas.openxmlformats.org/drawingml/2006/main">
               <a:ext uri="{FF2B5EF4-FFF2-40B4-BE49-F238E27FC236}">
-                <a16:creationId xmlns:a16="http://schemas.microsoft.com/office/drawing/2014/main" id="{E2CD799D-5FD4-4F36-984B-52177FE195F3}"/>
+                <a16:creationId xmlns:a16="http://schemas.microsoft.com/office/drawing/2014/main" id="{9404659C-7243-446B-BED8-C346BA5C0DDD}"/>
               </a:ext>
             </a:extLst>
           </p:cNvPr>
@@ -8648,7 +8648,7 @@
           <p:cNvPr id="15" name="">
             <a:extLst xmlns:a="http://schemas.openxmlformats.org/drawingml/2006/main">
               <a:ext uri="{FF2B5EF4-FFF2-40B4-BE49-F238E27FC236}">
-                <a16:creationId xmlns:a16="http://schemas.microsoft.com/office/drawing/2014/main" id="{3E84499E-F26B-4C34-AFEF-4A6CD7181541}"/>
+                <a16:creationId xmlns:a16="http://schemas.microsoft.com/office/drawing/2014/main" id="{69F228A6-58AD-48C8-8275-044CC4C9F16A}"/>
               </a:ext>
             </a:extLst>
           </p:cNvPr>
@@ -8705,7 +8705,7 @@
           <p:cNvPr id="16" name="">
             <a:extLst xmlns:a="http://schemas.openxmlformats.org/drawingml/2006/main">
               <a:ext uri="{FF2B5EF4-FFF2-40B4-BE49-F238E27FC236}">
-                <a16:creationId xmlns:a16="http://schemas.microsoft.com/office/drawing/2014/main" id="{B9788397-81FC-4238-8257-B9A0C22D9A6D}"/>
+                <a16:creationId xmlns:a16="http://schemas.microsoft.com/office/drawing/2014/main" id="{46BBE92A-0360-4E6F-A2E4-F57080C6BA0C}"/>
               </a:ext>
             </a:extLst>
           </p:cNvPr>
@@ -8736,7 +8736,7 @@
           <p:cNvPr id="17" name="">
             <a:extLst xmlns:a="http://schemas.openxmlformats.org/drawingml/2006/main">
               <a:ext uri="{FF2B5EF4-FFF2-40B4-BE49-F238E27FC236}">
-                <a16:creationId xmlns:a16="http://schemas.microsoft.com/office/drawing/2014/main" id="{8515FDE9-751D-4BE6-86B9-3D60D234C742}"/>
+                <a16:creationId xmlns:a16="http://schemas.microsoft.com/office/drawing/2014/main" id="{754473BC-2AE7-43B6-B6B4-1976EDCA8273}"/>
               </a:ext>
             </a:extLst>
           </p:cNvPr>
@@ -8771,7 +8771,7 @@
           <p:cNvPr id="18" name="">
             <a:extLst xmlns:a="http://schemas.openxmlformats.org/drawingml/2006/main">
               <a:ext uri="{FF2B5EF4-FFF2-40B4-BE49-F238E27FC236}">
-                <a16:creationId xmlns:a16="http://schemas.microsoft.com/office/drawing/2014/main" id="{401CDFA4-E52D-4B0D-97EA-68A6D051B41E}"/>
+                <a16:creationId xmlns:a16="http://schemas.microsoft.com/office/drawing/2014/main" id="{72E7FC2E-1B96-4ECE-ABCC-282E2B85BB0C}"/>
               </a:ext>
             </a:extLst>
           </p:cNvPr>
@@ -8835,7 +8835,7 @@
           <p:cNvPr id="19" name="">
             <a:extLst xmlns:a="http://schemas.openxmlformats.org/drawingml/2006/main">
               <a:ext uri="{FF2B5EF4-FFF2-40B4-BE49-F238E27FC236}">
-                <a16:creationId xmlns:a16="http://schemas.microsoft.com/office/drawing/2014/main" id="{D22FAC9A-2079-4CFB-8629-55959C1C82F2}"/>
+                <a16:creationId xmlns:a16="http://schemas.microsoft.com/office/drawing/2014/main" id="{9263ED7F-65B2-466A-A6BE-C3DB51B335B6}"/>
               </a:ext>
             </a:extLst>
           </p:cNvPr>
@@ -8892,7 +8892,7 @@
           <p:cNvPr id="20" name="">
             <a:extLst xmlns:a="http://schemas.openxmlformats.org/drawingml/2006/main">
               <a:ext uri="{FF2B5EF4-FFF2-40B4-BE49-F238E27FC236}">
-                <a16:creationId xmlns:a16="http://schemas.microsoft.com/office/drawing/2014/main" id="{51994FB4-AB7F-40B1-8360-8BC156636672}"/>
+                <a16:creationId xmlns:a16="http://schemas.microsoft.com/office/drawing/2014/main" id="{D3674E1B-8384-4B40-ACD6-898E3B5B0099}"/>
               </a:ext>
             </a:extLst>
           </p:cNvPr>
@@ -8927,7 +8927,7 @@
           <p:cNvPr id="21" name="">
             <a:extLst xmlns:a="http://schemas.openxmlformats.org/drawingml/2006/main">
               <a:ext uri="{FF2B5EF4-FFF2-40B4-BE49-F238E27FC236}">
-                <a16:creationId xmlns:a16="http://schemas.microsoft.com/office/drawing/2014/main" id="{FF74227C-2DBF-4D1B-B986-F4099C4B5005}"/>
+                <a16:creationId xmlns:a16="http://schemas.microsoft.com/office/drawing/2014/main" id="{181B091C-263D-4F7B-95B2-8D4C44256807}"/>
               </a:ext>
             </a:extLst>
           </p:cNvPr>
@@ -8974,7 +8974,7 @@
                 <a:ea typeface="Arial"/>
                 <a:cs typeface="Arial"/>
               </a:rPr>
-              <a:t>OPENROUTER / QWEN</a:t>
+              <a:t>VISION PROVIDER</a:t>
             </a:r>
           </a:p>
         </p:txBody>
@@ -8984,7 +8984,7 @@
           <p:cNvPr id="22" name="">
             <a:extLst xmlns:a="http://schemas.openxmlformats.org/drawingml/2006/main">
               <a:ext uri="{FF2B5EF4-FFF2-40B4-BE49-F238E27FC236}">
-                <a16:creationId xmlns:a16="http://schemas.microsoft.com/office/drawing/2014/main" id="{FD926762-EB22-41E4-B121-65BBE7CD3F47}"/>
+                <a16:creationId xmlns:a16="http://schemas.microsoft.com/office/drawing/2014/main" id="{C6DBD1ED-C90F-47D3-AB60-BCFAD6240053}"/>
               </a:ext>
             </a:extLst>
           </p:cNvPr>
@@ -8996,7 +8996,7 @@
         <p:spPr>
           <a:xfrm xmlns:a="http://schemas.openxmlformats.org/drawingml/2006/main">
             <a:off x="714375" y="5562600"/>
-            <a:ext cx="6667500" cy="266700"/>
+            <a:ext cx="7429500" cy="266700"/>
           </a:xfrm>
           <a:prstGeom xmlns:a="http://schemas.openxmlformats.org/drawingml/2006/main" prst="rect">
             <a:avLst/>
@@ -9013,7 +9013,7 @@
           <a:lstStyle xmlns:a="http://schemas.openxmlformats.org/drawingml/2006/main"/>
           <a:p xmlns:a="http://schemas.openxmlformats.org/drawingml/2006/main">
             <a:pPr algn="l">
-              <a:defRPr sz="1425" b="1">
+              <a:defRPr sz="1350" b="1">
                 <a:solidFill>
                   <a:srgbClr val="F5F8FF"/>
                 </a:solidFill>
@@ -9023,7 +9023,7 @@
               </a:defRPr>
             </a:pPr>
             <a:r>
-              <a:rPr sz="1425" b="1">
+              <a:rPr sz="1350" b="1">
                 <a:solidFill>
                   <a:srgbClr val="F5F8FF"/>
                 </a:solidFill>
@@ -9031,7 +9031,7 @@
                 <a:ea typeface="Arial"/>
                 <a:cs typeface="Arial"/>
               </a:rPr>
-              <a:t>Trích xuất JSON có cấu trúc • không có quyền quyết định</a:t>
+              <a:t>OpenRouter mặc định • Ollama local tùy chọn • không có quyền quyết định</a:t>
             </a:r>
           </a:p>
         </p:txBody>
@@ -9041,7 +9041,7 @@
           <p:cNvPr id="23" name="">
             <a:extLst xmlns:a="http://schemas.openxmlformats.org/drawingml/2006/main">
               <a:ext uri="{FF2B5EF4-FFF2-40B4-BE49-F238E27FC236}">
-                <a16:creationId xmlns:a16="http://schemas.microsoft.com/office/drawing/2014/main" id="{E1121E1A-CF14-4124-8C93-FE32AD4B3338}"/>
+                <a16:creationId xmlns:a16="http://schemas.microsoft.com/office/drawing/2014/main" id="{96836C47-39DF-4B73-A4FF-D23E6D60207F}"/>
               </a:ext>
             </a:extLst>
           </p:cNvPr>
@@ -9076,7 +9076,7 @@
           <p:cNvPr id="24" name="">
             <a:extLst xmlns:a="http://schemas.openxmlformats.org/drawingml/2006/main">
               <a:ext uri="{FF2B5EF4-FFF2-40B4-BE49-F238E27FC236}">
-                <a16:creationId xmlns:a16="http://schemas.microsoft.com/office/drawing/2014/main" id="{3CC49D6E-04EB-4EA4-8D35-3AC4AC161600}"/>
+                <a16:creationId xmlns:a16="http://schemas.microsoft.com/office/drawing/2014/main" id="{B62862DB-16AE-4281-8AC0-6124F65454E6}"/>
               </a:ext>
             </a:extLst>
           </p:cNvPr>
@@ -9140,7 +9140,7 @@
           <p:cNvPr id="25" name="">
             <a:extLst xmlns:a="http://schemas.openxmlformats.org/drawingml/2006/main">
               <a:ext uri="{FF2B5EF4-FFF2-40B4-BE49-F238E27FC236}">
-                <a16:creationId xmlns:a16="http://schemas.microsoft.com/office/drawing/2014/main" id="{979A203B-C47A-46CA-A498-3144325E7C6A}"/>
+                <a16:creationId xmlns:a16="http://schemas.microsoft.com/office/drawing/2014/main" id="{C68F89E3-EFA9-4FD7-B956-BCBDAE259E67}"/>
               </a:ext>
             </a:extLst>
           </p:cNvPr>
@@ -9210,7 +9210,7 @@
                 <a:ea typeface="Arial"/>
                 <a:cs typeface="Arial"/>
               </a:rPr>
-              <a:t>Qwen/OpenRouter</a:t>
+              <a:t>Vision provider</a:t>
             </a:r>
           </a:p>
           <a:p xmlns:a="http://schemas.openxmlformats.org/drawingml/2006/main">
@@ -9266,7 +9266,7 @@
           <p:cNvPr id="26" name="">
             <a:extLst xmlns:a="http://schemas.openxmlformats.org/drawingml/2006/main">
               <a:ext uri="{FF2B5EF4-FFF2-40B4-BE49-F238E27FC236}">
-                <a16:creationId xmlns:a16="http://schemas.microsoft.com/office/drawing/2014/main" id="{B9D84C25-8007-433F-8596-32C5E8C7AEE1}"/>
+                <a16:creationId xmlns:a16="http://schemas.microsoft.com/office/drawing/2014/main" id="{9A5B5D56-74C6-445B-B90B-0BFDA0FEBC83}"/>
               </a:ext>
             </a:extLst>
           </p:cNvPr>
@@ -9301,7 +9301,7 @@
           <p:cNvPr id="27" name="">
             <a:extLst xmlns:a="http://schemas.openxmlformats.org/drawingml/2006/main">
               <a:ext uri="{FF2B5EF4-FFF2-40B4-BE49-F238E27FC236}">
-                <a16:creationId xmlns:a16="http://schemas.microsoft.com/office/drawing/2014/main" id="{99453110-DB53-41B1-8C88-07094BE26CBB}"/>
+                <a16:creationId xmlns:a16="http://schemas.microsoft.com/office/drawing/2014/main" id="{41C66F36-03F7-4F71-9FC1-7C4EF31989D2}"/>
               </a:ext>
             </a:extLst>
           </p:cNvPr>
@@ -9365,7 +9365,7 @@
           <p:cNvPr id="28" name="">
             <a:extLst xmlns:a="http://schemas.openxmlformats.org/drawingml/2006/main">
               <a:ext uri="{FF2B5EF4-FFF2-40B4-BE49-F238E27FC236}">
-                <a16:creationId xmlns:a16="http://schemas.microsoft.com/office/drawing/2014/main" id="{283ED22D-E080-4002-9112-753FDE19A6AE}"/>
+                <a16:creationId xmlns:a16="http://schemas.microsoft.com/office/drawing/2014/main" id="{3B9BA82E-F631-4156-A335-357155F5C86E}"/>
               </a:ext>
             </a:extLst>
           </p:cNvPr>
@@ -9468,7 +9468,7 @@
           <p:cNvPr id="29" name="">
             <a:extLst xmlns:a="http://schemas.openxmlformats.org/drawingml/2006/main">
               <a:ext uri="{FF2B5EF4-FFF2-40B4-BE49-F238E27FC236}">
-                <a16:creationId xmlns:a16="http://schemas.microsoft.com/office/drawing/2014/main" id="{8A805275-42DD-456E-A506-4F030CCEE5F4}"/>
+                <a16:creationId xmlns:a16="http://schemas.microsoft.com/office/drawing/2014/main" id="{2B6001FC-4BD7-4051-B9DC-EE34BCFE3A90}"/>
               </a:ext>
             </a:extLst>
           </p:cNvPr>
@@ -9548,7 +9548,7 @@
           <p:cNvPr id="30" name="">
             <a:extLst xmlns:a="http://schemas.openxmlformats.org/drawingml/2006/main">
               <a:ext uri="{FF2B5EF4-FFF2-40B4-BE49-F238E27FC236}">
-                <a16:creationId xmlns:a16="http://schemas.microsoft.com/office/drawing/2014/main" id="{C6DC08D4-B5D3-46C6-B2A0-53A35183FE4A}"/>
+                <a16:creationId xmlns:a16="http://schemas.microsoft.com/office/drawing/2014/main" id="{92C34C6A-2F66-4006-ACBF-F52D9306CDBC}"/>
               </a:ext>
             </a:extLst>
           </p:cNvPr>
@@ -9595,7 +9595,7 @@
                 <a:ea typeface="Arial"/>
                 <a:cs typeface="Arial"/>
               </a:rPr>
-              <a:t>AURA • Track A • 24/09/2026</a:t>
+              <a:t>AURA • Track A • 26/09/2026</a:t>
             </a:r>
           </a:p>
         </p:txBody>
@@ -9605,7 +9605,7 @@
           <p:cNvPr id="31" name="">
             <a:extLst xmlns:a="http://schemas.openxmlformats.org/drawingml/2006/main">
               <a:ext uri="{FF2B5EF4-FFF2-40B4-BE49-F238E27FC236}">
-                <a16:creationId xmlns:a16="http://schemas.microsoft.com/office/drawing/2014/main" id="{04F35ED3-D658-4E77-B172-CD010A272EBA}"/>
+                <a16:creationId xmlns:a16="http://schemas.microsoft.com/office/drawing/2014/main" id="{33DF3C62-13EE-4A30-A6B0-623BE0457103}"/>
               </a:ext>
             </a:extLst>
           </p:cNvPr>
@@ -9660,7 +9660,7 @@
     </p:spTree>
     <p:extLst>
       <p:ext uri="{BB962C8B-B14F-4D97-AF65-F5344CB8AC3E}">
-        <p14:creationId xmlns:p14="http://schemas.microsoft.com/office/powerpoint/2010/main" val="1059866678"/>
+        <p14:creationId xmlns:p14="http://schemas.microsoft.com/office/powerpoint/2010/main" val="2147251502"/>
       </p:ext>
     </p:extLst>
   </p:cSld>
@@ -9691,7 +9691,7 @@
           <p:cNvPr id="36" name="">
             <a:extLst xmlns:a="http://schemas.openxmlformats.org/drawingml/2006/main">
               <a:ext uri="{FF2B5EF4-FFF2-40B4-BE49-F238E27FC236}">
-                <a16:creationId xmlns:a16="http://schemas.microsoft.com/office/drawing/2014/main" id="{6C17614D-C903-4326-B504-14ADAFB1C2BB}"/>
+                <a16:creationId xmlns:a16="http://schemas.microsoft.com/office/drawing/2014/main" id="{A7D9F511-3F84-4246-8A32-9BD5A62F63F3}"/>
               </a:ext>
             </a:extLst>
           </p:cNvPr>
@@ -9748,7 +9748,7 @@
           <p:cNvPr id="2" name="">
             <a:extLst xmlns:a="http://schemas.openxmlformats.org/drawingml/2006/main">
               <a:ext uri="{FF2B5EF4-FFF2-40B4-BE49-F238E27FC236}">
-                <a16:creationId xmlns:a16="http://schemas.microsoft.com/office/drawing/2014/main" id="{E9B84560-5721-47EC-8762-93107DFDFEB4}"/>
+                <a16:creationId xmlns:a16="http://schemas.microsoft.com/office/drawing/2014/main" id="{DAE46E6C-E2C3-403E-81D1-F58F438669D0}"/>
               </a:ext>
             </a:extLst>
           </p:cNvPr>
@@ -9805,7 +9805,7 @@
           <p:cNvPr id="3" name="">
             <a:extLst xmlns:a="http://schemas.openxmlformats.org/drawingml/2006/main">
               <a:ext uri="{FF2B5EF4-FFF2-40B4-BE49-F238E27FC236}">
-                <a16:creationId xmlns:a16="http://schemas.microsoft.com/office/drawing/2014/main" id="{EE4AE8C5-D81B-4BD1-BFD8-C28D10C1529E}"/>
+                <a16:creationId xmlns:a16="http://schemas.microsoft.com/office/drawing/2014/main" id="{18A30C45-3C15-4E25-B770-D4B9C2BCEFC6}"/>
               </a:ext>
             </a:extLst>
           </p:cNvPr>
@@ -9862,7 +9862,7 @@
           <p:cNvPr id="4" name="">
             <a:extLst xmlns:a="http://schemas.openxmlformats.org/drawingml/2006/main">
               <a:ext uri="{FF2B5EF4-FFF2-40B4-BE49-F238E27FC236}">
-                <a16:creationId xmlns:a16="http://schemas.microsoft.com/office/drawing/2014/main" id="{5883DDBA-2A02-4646-9E35-B3B24DFC6CC7}"/>
+                <a16:creationId xmlns:a16="http://schemas.microsoft.com/office/drawing/2014/main" id="{F1628B59-343F-498F-8DDD-664254CC7A5A}"/>
               </a:ext>
             </a:extLst>
           </p:cNvPr>
@@ -9893,7 +9893,7 @@
           <p:cNvPr id="5" name="">
             <a:extLst xmlns:a="http://schemas.openxmlformats.org/drawingml/2006/main">
               <a:ext uri="{FF2B5EF4-FFF2-40B4-BE49-F238E27FC236}">
-                <a16:creationId xmlns:a16="http://schemas.microsoft.com/office/drawing/2014/main" id="{73D0C7FB-5D27-446E-AA9B-F521283428C1}"/>
+                <a16:creationId xmlns:a16="http://schemas.microsoft.com/office/drawing/2014/main" id="{F5E70F4A-8DE6-4BC7-9FEA-B47AC8CEA72C}"/>
               </a:ext>
             </a:extLst>
           </p:cNvPr>
@@ -9928,7 +9928,7 @@
           <p:cNvPr id="6" name="">
             <a:extLst xmlns:a="http://schemas.openxmlformats.org/drawingml/2006/main">
               <a:ext uri="{FF2B5EF4-FFF2-40B4-BE49-F238E27FC236}">
-                <a16:creationId xmlns:a16="http://schemas.microsoft.com/office/drawing/2014/main" id="{95F5419B-B113-43FA-9EEA-5B5D6021E55A}"/>
+                <a16:creationId xmlns:a16="http://schemas.microsoft.com/office/drawing/2014/main" id="{7F7A81B2-02A3-4220-9538-2778DAB6992C}"/>
               </a:ext>
             </a:extLst>
           </p:cNvPr>
@@ -9992,7 +9992,7 @@
           <p:cNvPr id="7" name="">
             <a:extLst xmlns:a="http://schemas.openxmlformats.org/drawingml/2006/main">
               <a:ext uri="{FF2B5EF4-FFF2-40B4-BE49-F238E27FC236}">
-                <a16:creationId xmlns:a16="http://schemas.microsoft.com/office/drawing/2014/main" id="{C4E83DBA-A8CE-4E07-AA93-ED11F04930EC}"/>
+                <a16:creationId xmlns:a16="http://schemas.microsoft.com/office/drawing/2014/main" id="{7F43864A-354C-409D-8D2E-C182474AFAB6}"/>
               </a:ext>
             </a:extLst>
           </p:cNvPr>
@@ -10049,7 +10049,7 @@
           <p:cNvPr id="8" name="">
             <a:extLst xmlns:a="http://schemas.openxmlformats.org/drawingml/2006/main">
               <a:ext uri="{FF2B5EF4-FFF2-40B4-BE49-F238E27FC236}">
-                <a16:creationId xmlns:a16="http://schemas.microsoft.com/office/drawing/2014/main" id="{9212419D-189B-415F-8166-D0EEECB0F73E}"/>
+                <a16:creationId xmlns:a16="http://schemas.microsoft.com/office/drawing/2014/main" id="{98ADA44D-473F-49D0-825C-39C063908913}"/>
               </a:ext>
             </a:extLst>
           </p:cNvPr>
@@ -10084,7 +10084,7 @@
           <p:cNvPr id="9" name="">
             <a:extLst xmlns:a="http://schemas.openxmlformats.org/drawingml/2006/main">
               <a:ext uri="{FF2B5EF4-FFF2-40B4-BE49-F238E27FC236}">
-                <a16:creationId xmlns:a16="http://schemas.microsoft.com/office/drawing/2014/main" id="{1FA20384-8C6A-453C-86C3-B5AAE919C665}"/>
+                <a16:creationId xmlns:a16="http://schemas.microsoft.com/office/drawing/2014/main" id="{81E75505-D7D8-4D77-9C6A-BB7D2D38B8BC}"/>
               </a:ext>
             </a:extLst>
           </p:cNvPr>
@@ -10148,7 +10148,7 @@
           <p:cNvPr id="10" name="">
             <a:extLst xmlns:a="http://schemas.openxmlformats.org/drawingml/2006/main">
               <a:ext uri="{FF2B5EF4-FFF2-40B4-BE49-F238E27FC236}">
-                <a16:creationId xmlns:a16="http://schemas.microsoft.com/office/drawing/2014/main" id="{2FF7AB46-5B5A-459E-AE91-7CAAE17504ED}"/>
+                <a16:creationId xmlns:a16="http://schemas.microsoft.com/office/drawing/2014/main" id="{9C5B6AF0-3E5D-483C-809B-E947662B526E}"/>
               </a:ext>
             </a:extLst>
           </p:cNvPr>
@@ -10205,7 +10205,7 @@
           <p:cNvPr id="11" name="">
             <a:extLst xmlns:a="http://schemas.openxmlformats.org/drawingml/2006/main">
               <a:ext uri="{FF2B5EF4-FFF2-40B4-BE49-F238E27FC236}">
-                <a16:creationId xmlns:a16="http://schemas.microsoft.com/office/drawing/2014/main" id="{7686FC49-04B5-4109-807F-CB89FADD2508}"/>
+                <a16:creationId xmlns:a16="http://schemas.microsoft.com/office/drawing/2014/main" id="{38733E9F-EBC4-4C23-842F-04261CB0A9B4}"/>
               </a:ext>
             </a:extLst>
           </p:cNvPr>
@@ -10240,7 +10240,7 @@
           <p:cNvPr id="12" name="">
             <a:extLst xmlns:a="http://schemas.openxmlformats.org/drawingml/2006/main">
               <a:ext uri="{FF2B5EF4-FFF2-40B4-BE49-F238E27FC236}">
-                <a16:creationId xmlns:a16="http://schemas.microsoft.com/office/drawing/2014/main" id="{DFDBE800-200D-40CC-AEBD-1075F4B1E5DA}"/>
+                <a16:creationId xmlns:a16="http://schemas.microsoft.com/office/drawing/2014/main" id="{2C4383DC-EE2E-4743-9F3E-4DA6B68AF79D}"/>
               </a:ext>
             </a:extLst>
           </p:cNvPr>
@@ -10304,7 +10304,7 @@
           <p:cNvPr id="13" name="">
             <a:extLst xmlns:a="http://schemas.openxmlformats.org/drawingml/2006/main">
               <a:ext uri="{FF2B5EF4-FFF2-40B4-BE49-F238E27FC236}">
-                <a16:creationId xmlns:a16="http://schemas.microsoft.com/office/drawing/2014/main" id="{9DECE2DE-B986-4900-9CDE-364E18E453C5}"/>
+                <a16:creationId xmlns:a16="http://schemas.microsoft.com/office/drawing/2014/main" id="{DDE09DE1-742D-4572-98F3-994B97BBF239}"/>
               </a:ext>
             </a:extLst>
           </p:cNvPr>
@@ -10361,7 +10361,7 @@
           <p:cNvPr id="14" name="">
             <a:extLst xmlns:a="http://schemas.openxmlformats.org/drawingml/2006/main">
               <a:ext uri="{FF2B5EF4-FFF2-40B4-BE49-F238E27FC236}">
-                <a16:creationId xmlns:a16="http://schemas.microsoft.com/office/drawing/2014/main" id="{B27CA201-DCE5-4AD8-AA96-CB2B70AA9A36}"/>
+                <a16:creationId xmlns:a16="http://schemas.microsoft.com/office/drawing/2014/main" id="{5E5D1082-77DB-48FE-8E8C-702394C6DA22}"/>
               </a:ext>
             </a:extLst>
           </p:cNvPr>
@@ -10396,7 +10396,7 @@
           <p:cNvPr id="15" name="">
             <a:extLst xmlns:a="http://schemas.openxmlformats.org/drawingml/2006/main">
               <a:ext uri="{FF2B5EF4-FFF2-40B4-BE49-F238E27FC236}">
-                <a16:creationId xmlns:a16="http://schemas.microsoft.com/office/drawing/2014/main" id="{BA81A46F-5841-43D1-B404-EF5B2B0453A0}"/>
+                <a16:creationId xmlns:a16="http://schemas.microsoft.com/office/drawing/2014/main" id="{FD4EF920-3827-48AC-8EA8-A540B1EAFA17}"/>
               </a:ext>
             </a:extLst>
           </p:cNvPr>
@@ -10460,7 +10460,7 @@
           <p:cNvPr id="16" name="">
             <a:extLst xmlns:a="http://schemas.openxmlformats.org/drawingml/2006/main">
               <a:ext uri="{FF2B5EF4-FFF2-40B4-BE49-F238E27FC236}">
-                <a16:creationId xmlns:a16="http://schemas.microsoft.com/office/drawing/2014/main" id="{38727B3A-CDAC-4154-BE4B-89F20E68637F}"/>
+                <a16:creationId xmlns:a16="http://schemas.microsoft.com/office/drawing/2014/main" id="{B99AE377-E2EE-4CFB-97EE-44AFC8FF409D}"/>
               </a:ext>
             </a:extLst>
           </p:cNvPr>
@@ -10517,7 +10517,7 @@
           <p:cNvPr id="17" name="">
             <a:extLst xmlns:a="http://schemas.openxmlformats.org/drawingml/2006/main">
               <a:ext uri="{FF2B5EF4-FFF2-40B4-BE49-F238E27FC236}">
-                <a16:creationId xmlns:a16="http://schemas.microsoft.com/office/drawing/2014/main" id="{EC968E58-6B62-4EC0-85E2-D7FF6CB6591C}"/>
+                <a16:creationId xmlns:a16="http://schemas.microsoft.com/office/drawing/2014/main" id="{9632999C-2E59-469C-B02E-E51D24E33CCF}"/>
               </a:ext>
             </a:extLst>
           </p:cNvPr>
@@ -10552,7 +10552,7 @@
           <p:cNvPr id="18" name="">
             <a:extLst xmlns:a="http://schemas.openxmlformats.org/drawingml/2006/main">
               <a:ext uri="{FF2B5EF4-FFF2-40B4-BE49-F238E27FC236}">
-                <a16:creationId xmlns:a16="http://schemas.microsoft.com/office/drawing/2014/main" id="{9DB9D497-FC74-4A44-8EE6-5A5F10B32901}"/>
+                <a16:creationId xmlns:a16="http://schemas.microsoft.com/office/drawing/2014/main" id="{E492A665-5EA5-4FBF-8554-8859BD015036}"/>
               </a:ext>
             </a:extLst>
           </p:cNvPr>
@@ -10616,7 +10616,7 @@
           <p:cNvPr id="19" name="">
             <a:extLst xmlns:a="http://schemas.openxmlformats.org/drawingml/2006/main">
               <a:ext uri="{FF2B5EF4-FFF2-40B4-BE49-F238E27FC236}">
-                <a16:creationId xmlns:a16="http://schemas.microsoft.com/office/drawing/2014/main" id="{DE7763FF-270B-4273-A709-4DC6E0ABB749}"/>
+                <a16:creationId xmlns:a16="http://schemas.microsoft.com/office/drawing/2014/main" id="{32ED5841-ED95-4CE1-843F-42B023F7A4C3}"/>
               </a:ext>
             </a:extLst>
           </p:cNvPr>
@@ -10673,7 +10673,7 @@
           <p:cNvPr id="20" name="">
             <a:extLst xmlns:a="http://schemas.openxmlformats.org/drawingml/2006/main">
               <a:ext uri="{FF2B5EF4-FFF2-40B4-BE49-F238E27FC236}">
-                <a16:creationId xmlns:a16="http://schemas.microsoft.com/office/drawing/2014/main" id="{4E6443D0-4046-41C9-BC79-20F0F174C9FE}"/>
+                <a16:creationId xmlns:a16="http://schemas.microsoft.com/office/drawing/2014/main" id="{0C7869E0-BA0A-47F6-A1FD-F6B6F77D541B}"/>
               </a:ext>
             </a:extLst>
           </p:cNvPr>
@@ -10708,7 +10708,7 @@
           <p:cNvPr id="21" name="">
             <a:extLst xmlns:a="http://schemas.openxmlformats.org/drawingml/2006/main">
               <a:ext uri="{FF2B5EF4-FFF2-40B4-BE49-F238E27FC236}">
-                <a16:creationId xmlns:a16="http://schemas.microsoft.com/office/drawing/2014/main" id="{17F7CAC4-E6FE-4F5F-ACF0-8C39E411AB9A}"/>
+                <a16:creationId xmlns:a16="http://schemas.microsoft.com/office/drawing/2014/main" id="{87DE44A8-F1BD-4457-AD3A-0CF8D60B2E3B}"/>
               </a:ext>
             </a:extLst>
           </p:cNvPr>
@@ -10765,7 +10765,7 @@
           <p:cNvPr id="22" name="">
             <a:extLst xmlns:a="http://schemas.openxmlformats.org/drawingml/2006/main">
               <a:ext uri="{FF2B5EF4-FFF2-40B4-BE49-F238E27FC236}">
-                <a16:creationId xmlns:a16="http://schemas.microsoft.com/office/drawing/2014/main" id="{A08466DB-E2D2-4232-AB99-4EB089566487}"/>
+                <a16:creationId xmlns:a16="http://schemas.microsoft.com/office/drawing/2014/main" id="{A2714775-80E6-4680-9308-500FCDD44FA8}"/>
               </a:ext>
             </a:extLst>
           </p:cNvPr>
@@ -10829,7 +10829,7 @@
           <p:cNvPr id="23" name="">
             <a:extLst xmlns:a="http://schemas.openxmlformats.org/drawingml/2006/main">
               <a:ext uri="{FF2B5EF4-FFF2-40B4-BE49-F238E27FC236}">
-                <a16:creationId xmlns:a16="http://schemas.microsoft.com/office/drawing/2014/main" id="{A54DCFA8-E2FF-4B38-9E0B-7D2785526331}"/>
+                <a16:creationId xmlns:a16="http://schemas.microsoft.com/office/drawing/2014/main" id="{B03486CF-2D33-46A8-B255-D2E8577646AE}"/>
               </a:ext>
             </a:extLst>
           </p:cNvPr>
@@ -10886,7 +10886,7 @@
           <p:cNvPr id="24" name="">
             <a:extLst xmlns:a="http://schemas.openxmlformats.org/drawingml/2006/main">
               <a:ext uri="{FF2B5EF4-FFF2-40B4-BE49-F238E27FC236}">
-                <a16:creationId xmlns:a16="http://schemas.microsoft.com/office/drawing/2014/main" id="{928B96A4-D9D1-4B92-B8BD-6AF08FF32125}"/>
+                <a16:creationId xmlns:a16="http://schemas.microsoft.com/office/drawing/2014/main" id="{D751C290-69BC-4229-B401-519CE8049FB8}"/>
               </a:ext>
             </a:extLst>
           </p:cNvPr>
@@ -10950,7 +10950,7 @@
           <p:cNvPr id="25" name="">
             <a:extLst xmlns:a="http://schemas.openxmlformats.org/drawingml/2006/main">
               <a:ext uri="{FF2B5EF4-FFF2-40B4-BE49-F238E27FC236}">
-                <a16:creationId xmlns:a16="http://schemas.microsoft.com/office/drawing/2014/main" id="{6BA23449-8C30-4736-A002-E8C8E09782E0}"/>
+                <a16:creationId xmlns:a16="http://schemas.microsoft.com/office/drawing/2014/main" id="{2A38C3EF-7C77-4CBA-ADB3-7829BE7D0DE4}"/>
               </a:ext>
             </a:extLst>
           </p:cNvPr>
@@ -10997,7 +10997,7 @@
                 <a:ea typeface="Arial"/>
                 <a:cs typeface="Arial"/>
               </a:rPr>
-              <a:t>56 test offline</a:t>
+              <a:t>60 test offline</a:t>
             </a:r>
           </a:p>
         </p:txBody>
@@ -11007,7 +11007,7 @@
           <p:cNvPr id="26" name="">
             <a:extLst xmlns:a="http://schemas.openxmlformats.org/drawingml/2006/main">
               <a:ext uri="{FF2B5EF4-FFF2-40B4-BE49-F238E27FC236}">
-                <a16:creationId xmlns:a16="http://schemas.microsoft.com/office/drawing/2014/main" id="{94E04D04-4683-4B96-BFA8-860B5F401813}"/>
+                <a16:creationId xmlns:a16="http://schemas.microsoft.com/office/drawing/2014/main" id="{049B0C0D-D028-44A4-8CC5-A8C1CA09862F}"/>
               </a:ext>
             </a:extLst>
           </p:cNvPr>
@@ -11071,7 +11071,7 @@
           <p:cNvPr id="27" name="">
             <a:extLst xmlns:a="http://schemas.openxmlformats.org/drawingml/2006/main">
               <a:ext uri="{FF2B5EF4-FFF2-40B4-BE49-F238E27FC236}">
-                <a16:creationId xmlns:a16="http://schemas.microsoft.com/office/drawing/2014/main" id="{6A72793D-B9AA-4078-8BBF-7369D96BE3D4}"/>
+                <a16:creationId xmlns:a16="http://schemas.microsoft.com/office/drawing/2014/main" id="{10BCAE0B-1872-44D1-8229-EAF3DF472EED}"/>
               </a:ext>
             </a:extLst>
           </p:cNvPr>
@@ -11128,7 +11128,7 @@
           <p:cNvPr id="28" name="">
             <a:extLst xmlns:a="http://schemas.openxmlformats.org/drawingml/2006/main">
               <a:ext uri="{FF2B5EF4-FFF2-40B4-BE49-F238E27FC236}">
-                <a16:creationId xmlns:a16="http://schemas.microsoft.com/office/drawing/2014/main" id="{C815364C-B2E1-4EF5-BE4A-C9EC1728FF8A}"/>
+                <a16:creationId xmlns:a16="http://schemas.microsoft.com/office/drawing/2014/main" id="{989CC3AC-B6A9-485B-AE61-FF16F4C8612C}"/>
               </a:ext>
             </a:extLst>
           </p:cNvPr>
@@ -11192,7 +11192,7 @@
           <p:cNvPr id="29" name="">
             <a:extLst xmlns:a="http://schemas.openxmlformats.org/drawingml/2006/main">
               <a:ext uri="{FF2B5EF4-FFF2-40B4-BE49-F238E27FC236}">
-                <a16:creationId xmlns:a16="http://schemas.microsoft.com/office/drawing/2014/main" id="{19E247C8-FE9F-4D23-921C-A62F1EE8DA34}"/>
+                <a16:creationId xmlns:a16="http://schemas.microsoft.com/office/drawing/2014/main" id="{3216F844-EA58-42E5-829C-BF33E352E4A5}"/>
               </a:ext>
             </a:extLst>
           </p:cNvPr>
@@ -11249,7 +11249,7 @@
           <p:cNvPr id="30" name="">
             <a:extLst xmlns:a="http://schemas.openxmlformats.org/drawingml/2006/main">
               <a:ext uri="{FF2B5EF4-FFF2-40B4-BE49-F238E27FC236}">
-                <a16:creationId xmlns:a16="http://schemas.microsoft.com/office/drawing/2014/main" id="{5FB9E27C-5BDE-4768-B220-9B58ED32F67D}"/>
+                <a16:creationId xmlns:a16="http://schemas.microsoft.com/office/drawing/2014/main" id="{D2C7465D-14FE-42CC-9188-6733E4DA0781}"/>
               </a:ext>
             </a:extLst>
           </p:cNvPr>
@@ -11284,7 +11284,7 @@
           <p:cNvPr id="31" name="">
             <a:extLst xmlns:a="http://schemas.openxmlformats.org/drawingml/2006/main">
               <a:ext uri="{FF2B5EF4-FFF2-40B4-BE49-F238E27FC236}">
-                <a16:creationId xmlns:a16="http://schemas.microsoft.com/office/drawing/2014/main" id="{181400ED-12CA-4499-B065-C611C2072E8D}"/>
+                <a16:creationId xmlns:a16="http://schemas.microsoft.com/office/drawing/2014/main" id="{D919065C-79E8-48F9-81E2-96D0408C15B4}"/>
               </a:ext>
             </a:extLst>
           </p:cNvPr>
@@ -11341,7 +11341,7 @@
           <p:cNvPr id="32" name="">
             <a:extLst xmlns:a="http://schemas.openxmlformats.org/drawingml/2006/main">
               <a:ext uri="{FF2B5EF4-FFF2-40B4-BE49-F238E27FC236}">
-                <a16:creationId xmlns:a16="http://schemas.microsoft.com/office/drawing/2014/main" id="{DD7798F0-F390-4D4F-831A-6C72BCFE3910}"/>
+                <a16:creationId xmlns:a16="http://schemas.microsoft.com/office/drawing/2014/main" id="{8DFE7E68-FEF6-4AFA-B20E-74707E5D683A}"/>
               </a:ext>
             </a:extLst>
           </p:cNvPr>
@@ -11444,7 +11444,7 @@
           <p:cNvPr id="33" name="">
             <a:extLst xmlns:a="http://schemas.openxmlformats.org/drawingml/2006/main">
               <a:ext uri="{FF2B5EF4-FFF2-40B4-BE49-F238E27FC236}">
-                <a16:creationId xmlns:a16="http://schemas.microsoft.com/office/drawing/2014/main" id="{F65569A8-7D79-4713-9C33-B37222580412}"/>
+                <a16:creationId xmlns:a16="http://schemas.microsoft.com/office/drawing/2014/main" id="{D96F2B64-88EC-463F-8E1E-84790BAD74CD}"/>
               </a:ext>
             </a:extLst>
           </p:cNvPr>
@@ -11491,7 +11491,7 @@
                 <a:ea typeface="Arial"/>
                 <a:cs typeface="Arial"/>
               </a:rPr>
-              <a:t>Lộ trình: benchmark Qwen3-VL 4B self-host khi có dữ liệu và phần cứng phù hợp.</a:t>
+              <a:t>Lộ trình: benchmark Ollama + Qwen3-VL 4B local; OpenRouter 8B vẫn là baseline.</a:t>
             </a:r>
           </a:p>
         </p:txBody>
@@ -11501,7 +11501,7 @@
           <p:cNvPr id="34" name="">
             <a:extLst xmlns:a="http://schemas.openxmlformats.org/drawingml/2006/main">
               <a:ext uri="{FF2B5EF4-FFF2-40B4-BE49-F238E27FC236}">
-                <a16:creationId xmlns:a16="http://schemas.microsoft.com/office/drawing/2014/main" id="{4510E04C-3740-4967-BAE2-D8A721D380AC}"/>
+                <a16:creationId xmlns:a16="http://schemas.microsoft.com/office/drawing/2014/main" id="{2B5D78F2-BD03-4052-8BEE-BE1825911890}"/>
               </a:ext>
             </a:extLst>
           </p:cNvPr>
@@ -11558,7 +11558,7 @@
           <p:cNvPr id="35" name="">
             <a:extLst xmlns:a="http://schemas.openxmlformats.org/drawingml/2006/main">
               <a:ext uri="{FF2B5EF4-FFF2-40B4-BE49-F238E27FC236}">
-                <a16:creationId xmlns:a16="http://schemas.microsoft.com/office/drawing/2014/main" id="{1CFC910A-6C57-4E49-BA1E-6A9BBA333987}"/>
+                <a16:creationId xmlns:a16="http://schemas.microsoft.com/office/drawing/2014/main" id="{4758C7BD-B705-4183-BD7E-576DF13AFE49}"/>
               </a:ext>
             </a:extLst>
           </p:cNvPr>
@@ -11613,7 +11613,7 @@
     </p:spTree>
     <p:extLst>
       <p:ext uri="{BB962C8B-B14F-4D97-AF65-F5344CB8AC3E}">
-        <p14:creationId xmlns:p14="http://schemas.microsoft.com/office/powerpoint/2010/main" val="1335129906"/>
+        <p14:creationId xmlns:p14="http://schemas.microsoft.com/office/powerpoint/2010/main" val="149235308"/>
       </p:ext>
     </p:extLst>
   </p:cSld>

</xml_diff>

<commit_message>
docs: refresh submission evidence artifacts
</commit_message>
<xml_diff>
--- a/AURA/submission/AURA_5_SLIDES.pptx
+++ b/AURA/submission/AURA_5_SLIDES.pptx
@@ -2,17 +2,17 @@
 <file path=ppt/presentation.xml><?xml version="1.0" encoding="utf-8"?>
 <p:presentation xmlns:p="http://schemas.openxmlformats.org/presentationml/2006/main">
   <p:sldMasterIdLst>
-    <p:sldMasterId xmlns:r="http://schemas.openxmlformats.org/officeDocument/2006/relationships" id="2147483648" r:id="R8da427f69f564124"/>
+    <p:sldMasterId xmlns:r="http://schemas.openxmlformats.org/officeDocument/2006/relationships" id="2147483648" r:id="R26d4c4b0b3714900"/>
   </p:sldMasterIdLst>
   <p:notesMasterIdLst>
-    <p:notesMasterId xmlns:r="http://schemas.openxmlformats.org/officeDocument/2006/relationships" r:id="R4de5340a29794497"/>
+    <p:notesMasterId xmlns:r="http://schemas.openxmlformats.org/officeDocument/2006/relationships" r:id="R71d3a1f8e3cd4470"/>
   </p:notesMasterIdLst>
   <p:sldIdLst>
-    <p:sldId xmlns:r="http://schemas.openxmlformats.org/officeDocument/2006/relationships" id="256" r:id="R9b6b96808cc64c90"/>
-    <p:sldId xmlns:r="http://schemas.openxmlformats.org/officeDocument/2006/relationships" id="257" r:id="Rc565471c4e6d46ce"/>
-    <p:sldId xmlns:r="http://schemas.openxmlformats.org/officeDocument/2006/relationships" id="258" r:id="R7082c92563664a36"/>
-    <p:sldId xmlns:r="http://schemas.openxmlformats.org/officeDocument/2006/relationships" id="259" r:id="Rb4499c1123184116"/>
-    <p:sldId xmlns:r="http://schemas.openxmlformats.org/officeDocument/2006/relationships" id="260" r:id="Rc3242bc076f74bf9"/>
+    <p:sldId xmlns:r="http://schemas.openxmlformats.org/officeDocument/2006/relationships" id="256" r:id="Rc63751a8637b4e52"/>
+    <p:sldId xmlns:r="http://schemas.openxmlformats.org/officeDocument/2006/relationships" id="257" r:id="R5b8422a539734411"/>
+    <p:sldId xmlns:r="http://schemas.openxmlformats.org/officeDocument/2006/relationships" id="258" r:id="R8216570f89e044c6"/>
+    <p:sldId xmlns:r="http://schemas.openxmlformats.org/officeDocument/2006/relationships" id="259" r:id="Rd558da52f8a5485c"/>
+    <p:sldId xmlns:r="http://schemas.openxmlformats.org/officeDocument/2006/relationships" id="260" r:id="Raee8451b8bdc44c1"/>
   </p:sldIdLst>
   <p:sldSz cx="12192000" cy="6858000"/>
   <p:notesSz cx="6858000" cy="9144000"/>
@@ -586,7 +586,7 @@
           <a:lstStyle xmlns:a="http://schemas.openxmlformats.org/drawingml/2006/main"/>
           <a:p xmlns:a="http://schemas.openxmlformats.org/drawingml/2006/main">
             <a:r>
-              <a:t>Nguồn nội bộ: 60 test offline; người dùng xác nhận Verify v2 5/5 local ngày 22/09/2026. Không suy rộng thành accuracy thực tế.</a:t>
+              <a:t>Nguồn nội bộ: 70 test offline; Ollama 4B đạt 15/15 qua ba batch liên tiếp trên 5 fixture tổng hợp ngày 27/09/2026. Không suy rộng thành accuracy thực tế.</a:t>
             </a:r>
           </a:p>
         </p:txBody>
@@ -794,7 +794,7 @@
   </p:cSld>
   <p:clrMap bg1="lt1" tx1="dk1" bg2="lt2" tx2="dk2" accent1="accent1" accent2="accent2" accent3="accent3" accent4="accent4" accent5="accent5" accent6="accent6" hlink="hlink" folHlink="folHlink"/>
   <p:sldLayoutIdLst>
-    <p:sldLayoutId xmlns:r="http://schemas.openxmlformats.org/officeDocument/2006/relationships" id="2147483649" r:id="R2fa286435e3449fd"/>
+    <p:sldLayoutId xmlns:r="http://schemas.openxmlformats.org/officeDocument/2006/relationships" id="2147483649" r:id="R9da7d6cd32914c33"/>
   </p:sldLayoutIdLst>
   <p:txStyles>
     <p:titleStyle>
@@ -1345,7 +1345,7 @@
           <p:cNvPr id="47" name="">
             <a:extLst xmlns:a="http://schemas.openxmlformats.org/drawingml/2006/main">
               <a:ext uri="{FF2B5EF4-FFF2-40B4-BE49-F238E27FC236}">
-                <a16:creationId xmlns:a16="http://schemas.microsoft.com/office/drawing/2014/main" id="{F59658FC-988A-41BB-AB1C-C0526A710AE8}"/>
+                <a16:creationId xmlns:a16="http://schemas.microsoft.com/office/drawing/2014/main" id="{4DD194C1-9B27-4AE3-9EEF-4E8C7A7A1DF3}"/>
               </a:ext>
             </a:extLst>
           </p:cNvPr>
@@ -1402,7 +1402,7 @@
           <p:cNvPr id="2" name="">
             <a:extLst xmlns:a="http://schemas.openxmlformats.org/drawingml/2006/main">
               <a:ext uri="{FF2B5EF4-FFF2-40B4-BE49-F238E27FC236}">
-                <a16:creationId xmlns:a16="http://schemas.microsoft.com/office/drawing/2014/main" id="{B5CE0600-2B92-4735-A15D-0E5BB1EE27F0}"/>
+                <a16:creationId xmlns:a16="http://schemas.microsoft.com/office/drawing/2014/main" id="{6E380DF7-21BF-4170-BC7E-515200AE2B50}"/>
               </a:ext>
             </a:extLst>
           </p:cNvPr>
@@ -1459,7 +1459,7 @@
           <p:cNvPr id="3" name="">
             <a:extLst xmlns:a="http://schemas.openxmlformats.org/drawingml/2006/main">
               <a:ext uri="{FF2B5EF4-FFF2-40B4-BE49-F238E27FC236}">
-                <a16:creationId xmlns:a16="http://schemas.microsoft.com/office/drawing/2014/main" id="{82AF457D-99A6-49A0-B887-1CA31843B63F}"/>
+                <a16:creationId xmlns:a16="http://schemas.microsoft.com/office/drawing/2014/main" id="{31DCE96D-67FC-4CC2-B194-B0C45191F079}"/>
               </a:ext>
             </a:extLst>
           </p:cNvPr>
@@ -1516,7 +1516,7 @@
           <p:cNvPr id="4" name="">
             <a:extLst xmlns:a="http://schemas.openxmlformats.org/drawingml/2006/main">
               <a:ext uri="{FF2B5EF4-FFF2-40B4-BE49-F238E27FC236}">
-                <a16:creationId xmlns:a16="http://schemas.microsoft.com/office/drawing/2014/main" id="{31FE8974-C635-4CA9-95BA-C9791E7A14F4}"/>
+                <a16:creationId xmlns:a16="http://schemas.microsoft.com/office/drawing/2014/main" id="{A40B5D48-7F73-47A1-9B5D-0711A80974BE}"/>
               </a:ext>
             </a:extLst>
           </p:cNvPr>
@@ -1547,7 +1547,7 @@
           <p:cNvPr id="5" name="">
             <a:extLst xmlns:a="http://schemas.openxmlformats.org/drawingml/2006/main">
               <a:ext uri="{FF2B5EF4-FFF2-40B4-BE49-F238E27FC236}">
-                <a16:creationId xmlns:a16="http://schemas.microsoft.com/office/drawing/2014/main" id="{83AE6E5E-8205-4BB3-8410-F6817AE0E52E}"/>
+                <a16:creationId xmlns:a16="http://schemas.microsoft.com/office/drawing/2014/main" id="{27CC8CB1-D02A-4F70-A3BF-F1F4D5DBFFA3}"/>
               </a:ext>
             </a:extLst>
           </p:cNvPr>
@@ -1582,7 +1582,7 @@
           <p:cNvPr id="6" name="">
             <a:extLst xmlns:a="http://schemas.openxmlformats.org/drawingml/2006/main">
               <a:ext uri="{FF2B5EF4-FFF2-40B4-BE49-F238E27FC236}">
-                <a16:creationId xmlns:a16="http://schemas.microsoft.com/office/drawing/2014/main" id="{6939F1F3-2623-4D66-AF64-D62F778D69F5}"/>
+                <a16:creationId xmlns:a16="http://schemas.microsoft.com/office/drawing/2014/main" id="{4E0E5271-0852-4A0E-B3F8-060B758B8F21}"/>
               </a:ext>
             </a:extLst>
           </p:cNvPr>
@@ -1646,7 +1646,7 @@
           <p:cNvPr id="7" name="">
             <a:extLst xmlns:a="http://schemas.openxmlformats.org/drawingml/2006/main">
               <a:ext uri="{FF2B5EF4-FFF2-40B4-BE49-F238E27FC236}">
-                <a16:creationId xmlns:a16="http://schemas.microsoft.com/office/drawing/2014/main" id="{85964B4E-D315-44E6-B3F3-5448354A0063}"/>
+                <a16:creationId xmlns:a16="http://schemas.microsoft.com/office/drawing/2014/main" id="{14AFA416-EEE9-4CBF-B250-DC634F3175A0}"/>
               </a:ext>
             </a:extLst>
           </p:cNvPr>
@@ -1703,7 +1703,7 @@
           <p:cNvPr id="8" name="">
             <a:extLst xmlns:a="http://schemas.openxmlformats.org/drawingml/2006/main">
               <a:ext uri="{FF2B5EF4-FFF2-40B4-BE49-F238E27FC236}">
-                <a16:creationId xmlns:a16="http://schemas.microsoft.com/office/drawing/2014/main" id="{FDAEED3D-B47A-4EB0-A2E3-9FB5662976E9}"/>
+                <a16:creationId xmlns:a16="http://schemas.microsoft.com/office/drawing/2014/main" id="{F528AC9C-15D5-44E4-AE81-3383537E50DA}"/>
               </a:ext>
             </a:extLst>
           </p:cNvPr>
@@ -1760,7 +1760,7 @@
           <p:cNvPr id="9" name="">
             <a:extLst xmlns:a="http://schemas.openxmlformats.org/drawingml/2006/main">
               <a:ext uri="{FF2B5EF4-FFF2-40B4-BE49-F238E27FC236}">
-                <a16:creationId xmlns:a16="http://schemas.microsoft.com/office/drawing/2014/main" id="{C5332A7D-30EF-4F1B-A4E0-0E514325BFFA}"/>
+                <a16:creationId xmlns:a16="http://schemas.microsoft.com/office/drawing/2014/main" id="{34837B5C-8456-4CFE-A77B-57EB34103968}"/>
               </a:ext>
             </a:extLst>
           </p:cNvPr>
@@ -1792,7 +1792,7 @@
           <p:cNvPr id="10" name="">
             <a:extLst xmlns:a="http://schemas.openxmlformats.org/drawingml/2006/main">
               <a:ext uri="{FF2B5EF4-FFF2-40B4-BE49-F238E27FC236}">
-                <a16:creationId xmlns:a16="http://schemas.microsoft.com/office/drawing/2014/main" id="{918FD1A4-1191-4451-96C7-7D6DC4075125}"/>
+                <a16:creationId xmlns:a16="http://schemas.microsoft.com/office/drawing/2014/main" id="{069AC3C6-101B-44E3-9520-4D26F4C5BF40}"/>
               </a:ext>
             </a:extLst>
           </p:cNvPr>
@@ -1827,7 +1827,7 @@
           <p:cNvPr id="11" name="">
             <a:extLst xmlns:a="http://schemas.openxmlformats.org/drawingml/2006/main">
               <a:ext uri="{FF2B5EF4-FFF2-40B4-BE49-F238E27FC236}">
-                <a16:creationId xmlns:a16="http://schemas.microsoft.com/office/drawing/2014/main" id="{71D84B43-590F-4135-9DC7-D67984EB7A32}"/>
+                <a16:creationId xmlns:a16="http://schemas.microsoft.com/office/drawing/2014/main" id="{A6EF6476-DA67-41C4-A44C-EDF735FF054B}"/>
               </a:ext>
             </a:extLst>
           </p:cNvPr>
@@ -1891,7 +1891,7 @@
           <p:cNvPr id="12" name="">
             <a:extLst xmlns:a="http://schemas.openxmlformats.org/drawingml/2006/main">
               <a:ext uri="{FF2B5EF4-FFF2-40B4-BE49-F238E27FC236}">
-                <a16:creationId xmlns:a16="http://schemas.microsoft.com/office/drawing/2014/main" id="{F952A321-2075-47F6-9B84-90A0F20EA3EE}"/>
+                <a16:creationId xmlns:a16="http://schemas.microsoft.com/office/drawing/2014/main" id="{A29762DF-5728-4393-9EBF-CC49F0B7664F}"/>
               </a:ext>
             </a:extLst>
           </p:cNvPr>
@@ -1948,7 +1948,7 @@
           <p:cNvPr id="13" name="">
             <a:extLst xmlns:a="http://schemas.openxmlformats.org/drawingml/2006/main">
               <a:ext uri="{FF2B5EF4-FFF2-40B4-BE49-F238E27FC236}">
-                <a16:creationId xmlns:a16="http://schemas.microsoft.com/office/drawing/2014/main" id="{580A34B3-952C-41BC-BFF9-12DCD0023DC3}"/>
+                <a16:creationId xmlns:a16="http://schemas.microsoft.com/office/drawing/2014/main" id="{B235E8A7-2841-47AF-80D0-708299C7D52A}"/>
               </a:ext>
             </a:extLst>
           </p:cNvPr>
@@ -2005,7 +2005,7 @@
           <p:cNvPr id="14" name="">
             <a:extLst xmlns:a="http://schemas.openxmlformats.org/drawingml/2006/main">
               <a:ext uri="{FF2B5EF4-FFF2-40B4-BE49-F238E27FC236}">
-                <a16:creationId xmlns:a16="http://schemas.microsoft.com/office/drawing/2014/main" id="{A102B5A2-3844-49E3-A5E9-765392EDAA0D}"/>
+                <a16:creationId xmlns:a16="http://schemas.microsoft.com/office/drawing/2014/main" id="{54FDFD93-BD6A-4C83-96E9-9537F0B36C8F}"/>
               </a:ext>
             </a:extLst>
           </p:cNvPr>
@@ -2037,7 +2037,7 @@
           <p:cNvPr id="15" name="">
             <a:extLst xmlns:a="http://schemas.openxmlformats.org/drawingml/2006/main">
               <a:ext uri="{FF2B5EF4-FFF2-40B4-BE49-F238E27FC236}">
-                <a16:creationId xmlns:a16="http://schemas.microsoft.com/office/drawing/2014/main" id="{8EE85FBB-9250-4085-9F87-38FB98260577}"/>
+                <a16:creationId xmlns:a16="http://schemas.microsoft.com/office/drawing/2014/main" id="{D41A0E68-798C-4267-A9FD-6B6D34BBF219}"/>
               </a:ext>
             </a:extLst>
           </p:cNvPr>
@@ -2072,7 +2072,7 @@
           <p:cNvPr id="16" name="">
             <a:extLst xmlns:a="http://schemas.openxmlformats.org/drawingml/2006/main">
               <a:ext uri="{FF2B5EF4-FFF2-40B4-BE49-F238E27FC236}">
-                <a16:creationId xmlns:a16="http://schemas.microsoft.com/office/drawing/2014/main" id="{E7000A8D-A657-4B76-81AE-9E8BE271D7F9}"/>
+                <a16:creationId xmlns:a16="http://schemas.microsoft.com/office/drawing/2014/main" id="{EA8F6051-4C89-4F35-9801-99E760E0EBCB}"/>
               </a:ext>
             </a:extLst>
           </p:cNvPr>
@@ -2136,7 +2136,7 @@
           <p:cNvPr id="17" name="">
             <a:extLst xmlns:a="http://schemas.openxmlformats.org/drawingml/2006/main">
               <a:ext uri="{FF2B5EF4-FFF2-40B4-BE49-F238E27FC236}">
-                <a16:creationId xmlns:a16="http://schemas.microsoft.com/office/drawing/2014/main" id="{E13DACBF-24A1-4192-A382-CFBEAACD392F}"/>
+                <a16:creationId xmlns:a16="http://schemas.microsoft.com/office/drawing/2014/main" id="{07736A36-EB48-4312-9B4E-175893F2934F}"/>
               </a:ext>
             </a:extLst>
           </p:cNvPr>
@@ -2193,7 +2193,7 @@
           <p:cNvPr id="18" name="">
             <a:extLst xmlns:a="http://schemas.openxmlformats.org/drawingml/2006/main">
               <a:ext uri="{FF2B5EF4-FFF2-40B4-BE49-F238E27FC236}">
-                <a16:creationId xmlns:a16="http://schemas.microsoft.com/office/drawing/2014/main" id="{F7CA152B-FD84-4CA7-90C4-AFFE6A28DAE9}"/>
+                <a16:creationId xmlns:a16="http://schemas.microsoft.com/office/drawing/2014/main" id="{E1B8F1BF-2095-4259-AD31-DB6815AC6F13}"/>
               </a:ext>
             </a:extLst>
           </p:cNvPr>
@@ -2250,7 +2250,7 @@
           <p:cNvPr id="19" name="">
             <a:extLst xmlns:a="http://schemas.openxmlformats.org/drawingml/2006/main">
               <a:ext uri="{FF2B5EF4-FFF2-40B4-BE49-F238E27FC236}">
-                <a16:creationId xmlns:a16="http://schemas.microsoft.com/office/drawing/2014/main" id="{EEF45564-AB9D-4922-A027-DA6586F6D8E6}"/>
+                <a16:creationId xmlns:a16="http://schemas.microsoft.com/office/drawing/2014/main" id="{5918DD97-F6CF-4719-9C5C-EA1114FB92FC}"/>
               </a:ext>
             </a:extLst>
           </p:cNvPr>
@@ -2282,7 +2282,7 @@
           <p:cNvPr id="20" name="">
             <a:extLst xmlns:a="http://schemas.openxmlformats.org/drawingml/2006/main">
               <a:ext uri="{FF2B5EF4-FFF2-40B4-BE49-F238E27FC236}">
-                <a16:creationId xmlns:a16="http://schemas.microsoft.com/office/drawing/2014/main" id="{F3ADA410-C12A-476F-ADC9-2938E60E26A0}"/>
+                <a16:creationId xmlns:a16="http://schemas.microsoft.com/office/drawing/2014/main" id="{23131D07-15BF-4A88-9A1B-7E0EC44B679B}"/>
               </a:ext>
             </a:extLst>
           </p:cNvPr>
@@ -2317,7 +2317,7 @@
           <p:cNvPr id="21" name="">
             <a:extLst xmlns:a="http://schemas.openxmlformats.org/drawingml/2006/main">
               <a:ext uri="{FF2B5EF4-FFF2-40B4-BE49-F238E27FC236}">
-                <a16:creationId xmlns:a16="http://schemas.microsoft.com/office/drawing/2014/main" id="{A2DDFF50-0430-46DF-A977-5F191CA5014C}"/>
+                <a16:creationId xmlns:a16="http://schemas.microsoft.com/office/drawing/2014/main" id="{508B90B5-1AD1-45EF-849B-6D89047F41FB}"/>
               </a:ext>
             </a:extLst>
           </p:cNvPr>
@@ -2381,7 +2381,7 @@
           <p:cNvPr id="22" name="">
             <a:extLst xmlns:a="http://schemas.openxmlformats.org/drawingml/2006/main">
               <a:ext uri="{FF2B5EF4-FFF2-40B4-BE49-F238E27FC236}">
-                <a16:creationId xmlns:a16="http://schemas.microsoft.com/office/drawing/2014/main" id="{29C29A12-440F-482C-88C9-799D91B239E5}"/>
+                <a16:creationId xmlns:a16="http://schemas.microsoft.com/office/drawing/2014/main" id="{31A2C1AA-7D70-4FBC-934E-F53F372BA785}"/>
               </a:ext>
             </a:extLst>
           </p:cNvPr>
@@ -2438,7 +2438,7 @@
           <p:cNvPr id="23" name="">
             <a:extLst xmlns:a="http://schemas.openxmlformats.org/drawingml/2006/main">
               <a:ext uri="{FF2B5EF4-FFF2-40B4-BE49-F238E27FC236}">
-                <a16:creationId xmlns:a16="http://schemas.microsoft.com/office/drawing/2014/main" id="{1AA8B0F3-5B45-462D-B1FF-A2FDD9064EE3}"/>
+                <a16:creationId xmlns:a16="http://schemas.microsoft.com/office/drawing/2014/main" id="{973729AD-D156-442C-A90E-163BCA00CA38}"/>
               </a:ext>
             </a:extLst>
           </p:cNvPr>
@@ -2495,7 +2495,7 @@
           <p:cNvPr id="24" name="">
             <a:extLst xmlns:a="http://schemas.openxmlformats.org/drawingml/2006/main">
               <a:ext uri="{FF2B5EF4-FFF2-40B4-BE49-F238E27FC236}">
-                <a16:creationId xmlns:a16="http://schemas.microsoft.com/office/drawing/2014/main" id="{8F9140C6-50D2-4055-81BB-7508B93B74AD}"/>
+                <a16:creationId xmlns:a16="http://schemas.microsoft.com/office/drawing/2014/main" id="{AB6D8C78-29D8-47B9-BCA1-E246E8DA995E}"/>
               </a:ext>
             </a:extLst>
           </p:cNvPr>
@@ -2527,7 +2527,7 @@
           <p:cNvPr id="25" name="">
             <a:extLst xmlns:a="http://schemas.openxmlformats.org/drawingml/2006/main">
               <a:ext uri="{FF2B5EF4-FFF2-40B4-BE49-F238E27FC236}">
-                <a16:creationId xmlns:a16="http://schemas.microsoft.com/office/drawing/2014/main" id="{FB06200B-B879-49DB-802B-019F41365E35}"/>
+                <a16:creationId xmlns:a16="http://schemas.microsoft.com/office/drawing/2014/main" id="{0FA735CB-F520-42CE-B79F-F1B3BBB50335}"/>
               </a:ext>
             </a:extLst>
           </p:cNvPr>
@@ -2562,7 +2562,7 @@
           <p:cNvPr id="26" name="">
             <a:extLst xmlns:a="http://schemas.openxmlformats.org/drawingml/2006/main">
               <a:ext uri="{FF2B5EF4-FFF2-40B4-BE49-F238E27FC236}">
-                <a16:creationId xmlns:a16="http://schemas.microsoft.com/office/drawing/2014/main" id="{525A1B6B-421F-4186-B7B8-7420D41D5980}"/>
+                <a16:creationId xmlns:a16="http://schemas.microsoft.com/office/drawing/2014/main" id="{D18BA187-0A23-4E51-81FB-97153F9DC169}"/>
               </a:ext>
             </a:extLst>
           </p:cNvPr>
@@ -2626,7 +2626,7 @@
           <p:cNvPr id="27" name="">
             <a:extLst xmlns:a="http://schemas.openxmlformats.org/drawingml/2006/main">
               <a:ext uri="{FF2B5EF4-FFF2-40B4-BE49-F238E27FC236}">
-                <a16:creationId xmlns:a16="http://schemas.microsoft.com/office/drawing/2014/main" id="{B2AD6CBC-7FB6-47FA-B736-116C844CDB9D}"/>
+                <a16:creationId xmlns:a16="http://schemas.microsoft.com/office/drawing/2014/main" id="{9745A3AB-02CE-4FAC-9C9F-17AD64D78198}"/>
               </a:ext>
             </a:extLst>
           </p:cNvPr>
@@ -2683,7 +2683,7 @@
           <p:cNvPr id="28" name="">
             <a:extLst xmlns:a="http://schemas.openxmlformats.org/drawingml/2006/main">
               <a:ext uri="{FF2B5EF4-FFF2-40B4-BE49-F238E27FC236}">
-                <a16:creationId xmlns:a16="http://schemas.microsoft.com/office/drawing/2014/main" id="{B7E87B2F-6263-4028-95B7-E044824655BD}"/>
+                <a16:creationId xmlns:a16="http://schemas.microsoft.com/office/drawing/2014/main" id="{3761B49E-DD2A-437B-8838-8164A6202935}"/>
               </a:ext>
             </a:extLst>
           </p:cNvPr>
@@ -2740,7 +2740,7 @@
           <p:cNvPr id="29" name="">
             <a:extLst xmlns:a="http://schemas.openxmlformats.org/drawingml/2006/main">
               <a:ext uri="{FF2B5EF4-FFF2-40B4-BE49-F238E27FC236}">
-                <a16:creationId xmlns:a16="http://schemas.microsoft.com/office/drawing/2014/main" id="{F2CA905A-C151-47C8-9E7E-66E3950B4189}"/>
+                <a16:creationId xmlns:a16="http://schemas.microsoft.com/office/drawing/2014/main" id="{9C6C5F41-A075-47DE-9B63-E9B6E1BE8039}"/>
               </a:ext>
             </a:extLst>
           </p:cNvPr>
@@ -2775,7 +2775,7 @@
           <p:cNvPr id="30" name="">
             <a:extLst xmlns:a="http://schemas.openxmlformats.org/drawingml/2006/main">
               <a:ext uri="{FF2B5EF4-FFF2-40B4-BE49-F238E27FC236}">
-                <a16:creationId xmlns:a16="http://schemas.microsoft.com/office/drawing/2014/main" id="{F5BD2151-6A1C-4E59-B3CB-37B78B5A2112}"/>
+                <a16:creationId xmlns:a16="http://schemas.microsoft.com/office/drawing/2014/main" id="{AE9138B9-AEB4-4FED-A4BF-4C65D0D23172}"/>
               </a:ext>
             </a:extLst>
           </p:cNvPr>
@@ -2832,7 +2832,7 @@
           <p:cNvPr id="31" name="">
             <a:extLst xmlns:a="http://schemas.openxmlformats.org/drawingml/2006/main">
               <a:ext uri="{FF2B5EF4-FFF2-40B4-BE49-F238E27FC236}">
-                <a16:creationId xmlns:a16="http://schemas.microsoft.com/office/drawing/2014/main" id="{29812ACA-246E-449B-93FE-A930AE32DC06}"/>
+                <a16:creationId xmlns:a16="http://schemas.microsoft.com/office/drawing/2014/main" id="{F34642F6-A8C8-4BC8-9C62-332B62A286EE}"/>
               </a:ext>
             </a:extLst>
           </p:cNvPr>
@@ -2889,7 +2889,7 @@
           <p:cNvPr id="32" name="">
             <a:extLst xmlns:a="http://schemas.openxmlformats.org/drawingml/2006/main">
               <a:ext uri="{FF2B5EF4-FFF2-40B4-BE49-F238E27FC236}">
-                <a16:creationId xmlns:a16="http://schemas.microsoft.com/office/drawing/2014/main" id="{BA9B3C2B-3B49-415E-91DF-186A4532EC0B}"/>
+                <a16:creationId xmlns:a16="http://schemas.microsoft.com/office/drawing/2014/main" id="{C557602C-2B0B-49CD-8422-FFCA03E0BF79}"/>
               </a:ext>
             </a:extLst>
           </p:cNvPr>
@@ -2946,7 +2946,7 @@
           <p:cNvPr id="33" name="">
             <a:extLst xmlns:a="http://schemas.openxmlformats.org/drawingml/2006/main">
               <a:ext uri="{FF2B5EF4-FFF2-40B4-BE49-F238E27FC236}">
-                <a16:creationId xmlns:a16="http://schemas.microsoft.com/office/drawing/2014/main" id="{CA76CD83-9FC0-4643-9DCF-30E8AA17087E}"/>
+                <a16:creationId xmlns:a16="http://schemas.microsoft.com/office/drawing/2014/main" id="{49468B12-9B9D-4AB6-BF3A-82D675FED8AA}"/>
               </a:ext>
             </a:extLst>
           </p:cNvPr>
@@ -2981,7 +2981,7 @@
           <p:cNvPr id="34" name="">
             <a:extLst xmlns:a="http://schemas.openxmlformats.org/drawingml/2006/main">
               <a:ext uri="{FF2B5EF4-FFF2-40B4-BE49-F238E27FC236}">
-                <a16:creationId xmlns:a16="http://schemas.microsoft.com/office/drawing/2014/main" id="{3042472B-5151-454F-AA06-D8470637C441}"/>
+                <a16:creationId xmlns:a16="http://schemas.microsoft.com/office/drawing/2014/main" id="{62DB80D3-A08A-4B93-B43C-7E30BFC775AB}"/>
               </a:ext>
             </a:extLst>
           </p:cNvPr>
@@ -3045,7 +3045,7 @@
           <p:cNvPr id="35" name="">
             <a:extLst xmlns:a="http://schemas.openxmlformats.org/drawingml/2006/main">
               <a:ext uri="{FF2B5EF4-FFF2-40B4-BE49-F238E27FC236}">
-                <a16:creationId xmlns:a16="http://schemas.microsoft.com/office/drawing/2014/main" id="{199B9FA9-7F68-4747-B909-867C3357B4B2}"/>
+                <a16:creationId xmlns:a16="http://schemas.microsoft.com/office/drawing/2014/main" id="{34B3397B-E01D-4B81-B119-D283D3FDEACF}"/>
               </a:ext>
             </a:extLst>
           </p:cNvPr>
@@ -3102,7 +3102,7 @@
           <p:cNvPr id="36" name="">
             <a:extLst xmlns:a="http://schemas.openxmlformats.org/drawingml/2006/main">
               <a:ext uri="{FF2B5EF4-FFF2-40B4-BE49-F238E27FC236}">
-                <a16:creationId xmlns:a16="http://schemas.microsoft.com/office/drawing/2014/main" id="{E993E80D-3621-4938-A289-36E8EBFE4C85}"/>
+                <a16:creationId xmlns:a16="http://schemas.microsoft.com/office/drawing/2014/main" id="{1704EE13-DEE8-4146-A719-5DC3D537C4F4}"/>
               </a:ext>
             </a:extLst>
           </p:cNvPr>
@@ -3159,7 +3159,7 @@
           <p:cNvPr id="37" name="">
             <a:extLst xmlns:a="http://schemas.openxmlformats.org/drawingml/2006/main">
               <a:ext uri="{FF2B5EF4-FFF2-40B4-BE49-F238E27FC236}">
-                <a16:creationId xmlns:a16="http://schemas.microsoft.com/office/drawing/2014/main" id="{5138D811-5AD3-4BDF-A30A-5059C3A3B680}"/>
+                <a16:creationId xmlns:a16="http://schemas.microsoft.com/office/drawing/2014/main" id="{692D80AF-AB21-4AF1-A5EA-7D4435870B3C}"/>
               </a:ext>
             </a:extLst>
           </p:cNvPr>
@@ -3194,7 +3194,7 @@
           <p:cNvPr id="38" name="">
             <a:extLst xmlns:a="http://schemas.openxmlformats.org/drawingml/2006/main">
               <a:ext uri="{FF2B5EF4-FFF2-40B4-BE49-F238E27FC236}">
-                <a16:creationId xmlns:a16="http://schemas.microsoft.com/office/drawing/2014/main" id="{E2F48456-794C-4707-93A3-939411723295}"/>
+                <a16:creationId xmlns:a16="http://schemas.microsoft.com/office/drawing/2014/main" id="{C0E1746E-9616-4C79-8470-244370039DAD}"/>
               </a:ext>
             </a:extLst>
           </p:cNvPr>
@@ -3258,7 +3258,7 @@
           <p:cNvPr id="39" name="">
             <a:extLst xmlns:a="http://schemas.openxmlformats.org/drawingml/2006/main">
               <a:ext uri="{FF2B5EF4-FFF2-40B4-BE49-F238E27FC236}">
-                <a16:creationId xmlns:a16="http://schemas.microsoft.com/office/drawing/2014/main" id="{B9C07B09-352F-47A1-9CC0-3206E2DDEACE}"/>
+                <a16:creationId xmlns:a16="http://schemas.microsoft.com/office/drawing/2014/main" id="{42C5B7CD-C554-428E-A040-C971CAC9F490}"/>
               </a:ext>
             </a:extLst>
           </p:cNvPr>
@@ -3315,7 +3315,7 @@
           <p:cNvPr id="40" name="">
             <a:extLst xmlns:a="http://schemas.openxmlformats.org/drawingml/2006/main">
               <a:ext uri="{FF2B5EF4-FFF2-40B4-BE49-F238E27FC236}">
-                <a16:creationId xmlns:a16="http://schemas.microsoft.com/office/drawing/2014/main" id="{080AE680-3B67-45A8-A5DD-1CAC9DA2DFF2}"/>
+                <a16:creationId xmlns:a16="http://schemas.microsoft.com/office/drawing/2014/main" id="{706634C2-A70E-457F-B0F3-06EF8028C937}"/>
               </a:ext>
             </a:extLst>
           </p:cNvPr>
@@ -3372,7 +3372,7 @@
           <p:cNvPr id="41" name="">
             <a:extLst xmlns:a="http://schemas.openxmlformats.org/drawingml/2006/main">
               <a:ext uri="{FF2B5EF4-FFF2-40B4-BE49-F238E27FC236}">
-                <a16:creationId xmlns:a16="http://schemas.microsoft.com/office/drawing/2014/main" id="{2F027B09-8B26-46D2-97A0-896E162714D4}"/>
+                <a16:creationId xmlns:a16="http://schemas.microsoft.com/office/drawing/2014/main" id="{1AD674A9-EEFC-4C2F-B7AE-FE86CE0FE945}"/>
               </a:ext>
             </a:extLst>
           </p:cNvPr>
@@ -3407,7 +3407,7 @@
           <p:cNvPr id="42" name="">
             <a:extLst xmlns:a="http://schemas.openxmlformats.org/drawingml/2006/main">
               <a:ext uri="{FF2B5EF4-FFF2-40B4-BE49-F238E27FC236}">
-                <a16:creationId xmlns:a16="http://schemas.microsoft.com/office/drawing/2014/main" id="{09F4F1FB-C6E0-465E-B5C7-CA023FC96FD4}"/>
+                <a16:creationId xmlns:a16="http://schemas.microsoft.com/office/drawing/2014/main" id="{C16438E5-DF7E-48EF-8CE7-68676873E842}"/>
               </a:ext>
             </a:extLst>
           </p:cNvPr>
@@ -3471,7 +3471,7 @@
           <p:cNvPr id="43" name="">
             <a:extLst xmlns:a="http://schemas.openxmlformats.org/drawingml/2006/main">
               <a:ext uri="{FF2B5EF4-FFF2-40B4-BE49-F238E27FC236}">
-                <a16:creationId xmlns:a16="http://schemas.microsoft.com/office/drawing/2014/main" id="{BAA21ED3-47E7-487E-A98D-7E25458B4447}"/>
+                <a16:creationId xmlns:a16="http://schemas.microsoft.com/office/drawing/2014/main" id="{BCB726B5-BF87-4DEC-96ED-7EC36C8FE4F1}"/>
               </a:ext>
             </a:extLst>
           </p:cNvPr>
@@ -3528,7 +3528,7 @@
           <p:cNvPr id="44" name="">
             <a:extLst xmlns:a="http://schemas.openxmlformats.org/drawingml/2006/main">
               <a:ext uri="{FF2B5EF4-FFF2-40B4-BE49-F238E27FC236}">
-                <a16:creationId xmlns:a16="http://schemas.microsoft.com/office/drawing/2014/main" id="{42B7785A-9DD5-440C-97FD-9904C759F74F}"/>
+                <a16:creationId xmlns:a16="http://schemas.microsoft.com/office/drawing/2014/main" id="{A95AE993-64A1-4E3E-A1D4-8F93BB7215CC}"/>
               </a:ext>
             </a:extLst>
           </p:cNvPr>
@@ -3585,7 +3585,7 @@
           <p:cNvPr id="45" name="">
             <a:extLst xmlns:a="http://schemas.openxmlformats.org/drawingml/2006/main">
               <a:ext uri="{FF2B5EF4-FFF2-40B4-BE49-F238E27FC236}">
-                <a16:creationId xmlns:a16="http://schemas.microsoft.com/office/drawing/2014/main" id="{C10537FD-A5C9-4ADE-B152-2D1566D551DA}"/>
+                <a16:creationId xmlns:a16="http://schemas.microsoft.com/office/drawing/2014/main" id="{42F87EE2-A47F-4EC5-9732-2FA935E722CA}"/>
               </a:ext>
             </a:extLst>
           </p:cNvPr>
@@ -3632,7 +3632,7 @@
                 <a:ea typeface="Arial"/>
                 <a:cs typeface="Arial"/>
               </a:rPr>
-              <a:t>AURA • Track A • 26/09/2026</a:t>
+              <a:t>AURA • Track A • 27/09/2026</a:t>
             </a:r>
           </a:p>
         </p:txBody>
@@ -3642,7 +3642,7 @@
           <p:cNvPr id="46" name="">
             <a:extLst xmlns:a="http://schemas.openxmlformats.org/drawingml/2006/main">
               <a:ext uri="{FF2B5EF4-FFF2-40B4-BE49-F238E27FC236}">
-                <a16:creationId xmlns:a16="http://schemas.microsoft.com/office/drawing/2014/main" id="{D0C8C8FE-D493-4A98-A5E2-C546563508F7}"/>
+                <a16:creationId xmlns:a16="http://schemas.microsoft.com/office/drawing/2014/main" id="{7759AF2E-479B-425B-9405-44772A3E677F}"/>
               </a:ext>
             </a:extLst>
           </p:cNvPr>
@@ -3697,7 +3697,7 @@
     </p:spTree>
     <p:extLst>
       <p:ext uri="{BB962C8B-B14F-4D97-AF65-F5344CB8AC3E}">
-        <p14:creationId xmlns:p14="http://schemas.microsoft.com/office/powerpoint/2010/main" val="2046781202"/>
+        <p14:creationId xmlns:p14="http://schemas.microsoft.com/office/powerpoint/2010/main" val="1374718484"/>
       </p:ext>
     </p:extLst>
   </p:cSld>
@@ -3728,7 +3728,7 @@
           <p:cNvPr id="46" name="">
             <a:extLst xmlns:a="http://schemas.openxmlformats.org/drawingml/2006/main">
               <a:ext uri="{FF2B5EF4-FFF2-40B4-BE49-F238E27FC236}">
-                <a16:creationId xmlns:a16="http://schemas.microsoft.com/office/drawing/2014/main" id="{3E2381FB-04B8-4B58-9076-FE30466E5DC7}"/>
+                <a16:creationId xmlns:a16="http://schemas.microsoft.com/office/drawing/2014/main" id="{D87ADFE3-AC32-44BE-A8B0-4395C345ED1F}"/>
               </a:ext>
             </a:extLst>
           </p:cNvPr>
@@ -3785,7 +3785,7 @@
           <p:cNvPr id="2" name="">
             <a:extLst xmlns:a="http://schemas.openxmlformats.org/drawingml/2006/main">
               <a:ext uri="{FF2B5EF4-FFF2-40B4-BE49-F238E27FC236}">
-                <a16:creationId xmlns:a16="http://schemas.microsoft.com/office/drawing/2014/main" id="{6292501A-48A1-4EBA-942C-416A1757C460}"/>
+                <a16:creationId xmlns:a16="http://schemas.microsoft.com/office/drawing/2014/main" id="{048660DE-E392-4717-A43F-57FD93B80C46}"/>
               </a:ext>
             </a:extLst>
           </p:cNvPr>
@@ -3842,7 +3842,7 @@
           <p:cNvPr id="3" name="">
             <a:extLst xmlns:a="http://schemas.openxmlformats.org/drawingml/2006/main">
               <a:ext uri="{FF2B5EF4-FFF2-40B4-BE49-F238E27FC236}">
-                <a16:creationId xmlns:a16="http://schemas.microsoft.com/office/drawing/2014/main" id="{7C8CD2CF-CE19-4983-8120-9213BB975E78}"/>
+                <a16:creationId xmlns:a16="http://schemas.microsoft.com/office/drawing/2014/main" id="{0079FBB6-6E46-4A67-A748-26863E207F45}"/>
               </a:ext>
             </a:extLst>
           </p:cNvPr>
@@ -3899,7 +3899,7 @@
           <p:cNvPr id="4" name="">
             <a:extLst xmlns:a="http://schemas.openxmlformats.org/drawingml/2006/main">
               <a:ext uri="{FF2B5EF4-FFF2-40B4-BE49-F238E27FC236}">
-                <a16:creationId xmlns:a16="http://schemas.microsoft.com/office/drawing/2014/main" id="{48984FEC-B0A5-4DD6-BF31-EA063A88B7D5}"/>
+                <a16:creationId xmlns:a16="http://schemas.microsoft.com/office/drawing/2014/main" id="{FDAE4FC0-0BD0-4B36-A82F-90170A81D37D}"/>
               </a:ext>
             </a:extLst>
           </p:cNvPr>
@@ -3930,7 +3930,7 @@
           <p:cNvPr id="5" name="">
             <a:extLst xmlns:a="http://schemas.openxmlformats.org/drawingml/2006/main">
               <a:ext uri="{FF2B5EF4-FFF2-40B4-BE49-F238E27FC236}">
-                <a16:creationId xmlns:a16="http://schemas.microsoft.com/office/drawing/2014/main" id="{D138D663-22B7-44D8-821C-CBB25803BE27}"/>
+                <a16:creationId xmlns:a16="http://schemas.microsoft.com/office/drawing/2014/main" id="{0DCFA816-8097-427D-BEA8-35B182B714B3}"/>
               </a:ext>
             </a:extLst>
           </p:cNvPr>
@@ -3965,7 +3965,7 @@
           <p:cNvPr id="6" name="">
             <a:extLst xmlns:a="http://schemas.openxmlformats.org/drawingml/2006/main">
               <a:ext uri="{FF2B5EF4-FFF2-40B4-BE49-F238E27FC236}">
-                <a16:creationId xmlns:a16="http://schemas.microsoft.com/office/drawing/2014/main" id="{530FA893-5A7D-4C63-B952-8A589BE024E6}"/>
+                <a16:creationId xmlns:a16="http://schemas.microsoft.com/office/drawing/2014/main" id="{CBA7C262-B064-4602-AEA4-2E7D1A54DE17}"/>
               </a:ext>
             </a:extLst>
           </p:cNvPr>
@@ -4029,7 +4029,7 @@
           <p:cNvPr id="7" name="">
             <a:extLst xmlns:a="http://schemas.openxmlformats.org/drawingml/2006/main">
               <a:ext uri="{FF2B5EF4-FFF2-40B4-BE49-F238E27FC236}">
-                <a16:creationId xmlns:a16="http://schemas.microsoft.com/office/drawing/2014/main" id="{C893B330-6BFC-40C9-AE91-5D3694285A06}"/>
+                <a16:creationId xmlns:a16="http://schemas.microsoft.com/office/drawing/2014/main" id="{C92D8564-D80C-4171-B2A6-86899FCA9875}"/>
               </a:ext>
             </a:extLst>
           </p:cNvPr>
@@ -4086,7 +4086,7 @@
           <p:cNvPr id="8" name="">
             <a:extLst xmlns:a="http://schemas.openxmlformats.org/drawingml/2006/main">
               <a:ext uri="{FF2B5EF4-FFF2-40B4-BE49-F238E27FC236}">
-                <a16:creationId xmlns:a16="http://schemas.microsoft.com/office/drawing/2014/main" id="{8BA1908F-C245-42A5-882A-C50811E08A54}"/>
+                <a16:creationId xmlns:a16="http://schemas.microsoft.com/office/drawing/2014/main" id="{F94A911A-BBF8-4072-927C-313F431C62E9}"/>
               </a:ext>
             </a:extLst>
           </p:cNvPr>
@@ -4166,7 +4166,7 @@
           <p:cNvPr id="9" name="">
             <a:extLst xmlns:a="http://schemas.openxmlformats.org/drawingml/2006/main">
               <a:ext uri="{FF2B5EF4-FFF2-40B4-BE49-F238E27FC236}">
-                <a16:creationId xmlns:a16="http://schemas.microsoft.com/office/drawing/2014/main" id="{88E2ECE6-AE09-4036-92A9-0CE8C25C3079}"/>
+                <a16:creationId xmlns:a16="http://schemas.microsoft.com/office/drawing/2014/main" id="{2F6BFE7B-4272-46F3-A858-358BB4655998}"/>
               </a:ext>
             </a:extLst>
           </p:cNvPr>
@@ -4198,7 +4198,7 @@
           <p:cNvPr id="10" name="">
             <a:extLst xmlns:a="http://schemas.openxmlformats.org/drawingml/2006/main">
               <a:ext uri="{FF2B5EF4-FFF2-40B4-BE49-F238E27FC236}">
-                <a16:creationId xmlns:a16="http://schemas.microsoft.com/office/drawing/2014/main" id="{32C979CB-B042-4FD8-B78A-08BCEE388F69}"/>
+                <a16:creationId xmlns:a16="http://schemas.microsoft.com/office/drawing/2014/main" id="{FC5AC3FB-5A3A-4594-A728-0454BEAF21F1}"/>
               </a:ext>
             </a:extLst>
           </p:cNvPr>
@@ -4233,7 +4233,7 @@
           <p:cNvPr id="11" name="">
             <a:extLst xmlns:a="http://schemas.openxmlformats.org/drawingml/2006/main">
               <a:ext uri="{FF2B5EF4-FFF2-40B4-BE49-F238E27FC236}">
-                <a16:creationId xmlns:a16="http://schemas.microsoft.com/office/drawing/2014/main" id="{8338FF07-B2AC-4A57-BDDB-D090C7965C57}"/>
+                <a16:creationId xmlns:a16="http://schemas.microsoft.com/office/drawing/2014/main" id="{4B84C902-0961-46A5-8CBE-996BCC9BFAD6}"/>
               </a:ext>
             </a:extLst>
           </p:cNvPr>
@@ -4297,7 +4297,7 @@
           <p:cNvPr id="12" name="">
             <a:extLst xmlns:a="http://schemas.openxmlformats.org/drawingml/2006/main">
               <a:ext uri="{FF2B5EF4-FFF2-40B4-BE49-F238E27FC236}">
-                <a16:creationId xmlns:a16="http://schemas.microsoft.com/office/drawing/2014/main" id="{313F1AEC-1E43-489A-9641-F979BE1ECF27}"/>
+                <a16:creationId xmlns:a16="http://schemas.microsoft.com/office/drawing/2014/main" id="{6A0D87B7-03D5-4E1D-8157-FBEE80A86840}"/>
               </a:ext>
             </a:extLst>
           </p:cNvPr>
@@ -4354,7 +4354,7 @@
           <p:cNvPr id="13" name="">
             <a:extLst xmlns:a="http://schemas.openxmlformats.org/drawingml/2006/main">
               <a:ext uri="{FF2B5EF4-FFF2-40B4-BE49-F238E27FC236}">
-                <a16:creationId xmlns:a16="http://schemas.microsoft.com/office/drawing/2014/main" id="{FAAB85FE-5763-4A7C-A1C1-4B4DE8AC119D}"/>
+                <a16:creationId xmlns:a16="http://schemas.microsoft.com/office/drawing/2014/main" id="{093C2EE5-BB47-439E-B12E-C86437355684}"/>
               </a:ext>
             </a:extLst>
           </p:cNvPr>
@@ -4434,7 +4434,7 @@
           <p:cNvPr id="14" name="">
             <a:extLst xmlns:a="http://schemas.openxmlformats.org/drawingml/2006/main">
               <a:ext uri="{FF2B5EF4-FFF2-40B4-BE49-F238E27FC236}">
-                <a16:creationId xmlns:a16="http://schemas.microsoft.com/office/drawing/2014/main" id="{CBAC1B73-3112-488B-AD53-79F91875947A}"/>
+                <a16:creationId xmlns:a16="http://schemas.microsoft.com/office/drawing/2014/main" id="{72C6292B-D666-4770-BAF3-B11B3ACC726E}"/>
               </a:ext>
             </a:extLst>
           </p:cNvPr>
@@ -4466,7 +4466,7 @@
           <p:cNvPr id="15" name="">
             <a:extLst xmlns:a="http://schemas.openxmlformats.org/drawingml/2006/main">
               <a:ext uri="{FF2B5EF4-FFF2-40B4-BE49-F238E27FC236}">
-                <a16:creationId xmlns:a16="http://schemas.microsoft.com/office/drawing/2014/main" id="{DB95356A-56C5-4885-9B8D-07404BB37025}"/>
+                <a16:creationId xmlns:a16="http://schemas.microsoft.com/office/drawing/2014/main" id="{35DD643E-FF50-428E-AA6B-964812D37347}"/>
               </a:ext>
             </a:extLst>
           </p:cNvPr>
@@ -4501,7 +4501,7 @@
           <p:cNvPr id="16" name="">
             <a:extLst xmlns:a="http://schemas.openxmlformats.org/drawingml/2006/main">
               <a:ext uri="{FF2B5EF4-FFF2-40B4-BE49-F238E27FC236}">
-                <a16:creationId xmlns:a16="http://schemas.microsoft.com/office/drawing/2014/main" id="{9A78F900-F659-46BA-B7A0-31C9E864373D}"/>
+                <a16:creationId xmlns:a16="http://schemas.microsoft.com/office/drawing/2014/main" id="{64C991E1-08DB-48D4-8E65-518D4D0AFB7E}"/>
               </a:ext>
             </a:extLst>
           </p:cNvPr>
@@ -4565,7 +4565,7 @@
           <p:cNvPr id="17" name="">
             <a:extLst xmlns:a="http://schemas.openxmlformats.org/drawingml/2006/main">
               <a:ext uri="{FF2B5EF4-FFF2-40B4-BE49-F238E27FC236}">
-                <a16:creationId xmlns:a16="http://schemas.microsoft.com/office/drawing/2014/main" id="{B2F736FB-878B-4E49-8C19-4CCAE4BEDFB0}"/>
+                <a16:creationId xmlns:a16="http://schemas.microsoft.com/office/drawing/2014/main" id="{3579179F-287C-414B-A9A0-6EFAB942DB5F}"/>
               </a:ext>
             </a:extLst>
           </p:cNvPr>
@@ -4622,7 +4622,7 @@
           <p:cNvPr id="18" name="">
             <a:extLst xmlns:a="http://schemas.openxmlformats.org/drawingml/2006/main">
               <a:ext uri="{FF2B5EF4-FFF2-40B4-BE49-F238E27FC236}">
-                <a16:creationId xmlns:a16="http://schemas.microsoft.com/office/drawing/2014/main" id="{ADA0824D-2093-427A-9207-05D9AD43AF4F}"/>
+                <a16:creationId xmlns:a16="http://schemas.microsoft.com/office/drawing/2014/main" id="{23B6C4ED-6C94-4AEE-B527-BCF97A3FE2E5}"/>
               </a:ext>
             </a:extLst>
           </p:cNvPr>
@@ -4669,7 +4669,7 @@
                 <a:ea typeface="Arial"/>
                 <a:cs typeface="Arial"/>
               </a:rPr>
-              <a:t>Provider cấu hình</a:t>
+              <a:t>JSON Schema</a:t>
             </a:r>
           </a:p>
           <a:p xmlns:a="http://schemas.openxmlformats.org/drawingml/2006/main">
@@ -4692,7 +4692,7 @@
                 <a:ea typeface="Arial"/>
                 <a:cs typeface="Arial"/>
               </a:rPr>
-              <a:t>JSON Schema</a:t>
+              <a:t>+ semantic repair</a:t>
             </a:r>
           </a:p>
         </p:txBody>
@@ -4702,7 +4702,7 @@
           <p:cNvPr id="19" name="">
             <a:extLst xmlns:a="http://schemas.openxmlformats.org/drawingml/2006/main">
               <a:ext uri="{FF2B5EF4-FFF2-40B4-BE49-F238E27FC236}">
-                <a16:creationId xmlns:a16="http://schemas.microsoft.com/office/drawing/2014/main" id="{0411F8CC-9129-4B1D-B545-17E764966C2B}"/>
+                <a16:creationId xmlns:a16="http://schemas.microsoft.com/office/drawing/2014/main" id="{5EB83095-0A3F-4CE0-BCD4-82AA860A8740}"/>
               </a:ext>
             </a:extLst>
           </p:cNvPr>
@@ -4734,7 +4734,7 @@
           <p:cNvPr id="20" name="">
             <a:extLst xmlns:a="http://schemas.openxmlformats.org/drawingml/2006/main">
               <a:ext uri="{FF2B5EF4-FFF2-40B4-BE49-F238E27FC236}">
-                <a16:creationId xmlns:a16="http://schemas.microsoft.com/office/drawing/2014/main" id="{4D55CCC5-8C63-491D-B764-D9277A6708D5}"/>
+                <a16:creationId xmlns:a16="http://schemas.microsoft.com/office/drawing/2014/main" id="{B40555A2-6479-4FF2-93B1-2C899C4BB4AC}"/>
               </a:ext>
             </a:extLst>
           </p:cNvPr>
@@ -4769,7 +4769,7 @@
           <p:cNvPr id="21" name="">
             <a:extLst xmlns:a="http://schemas.openxmlformats.org/drawingml/2006/main">
               <a:ext uri="{FF2B5EF4-FFF2-40B4-BE49-F238E27FC236}">
-                <a16:creationId xmlns:a16="http://schemas.microsoft.com/office/drawing/2014/main" id="{C0AD07E4-B152-430A-BF67-86C35A27DB2F}"/>
+                <a16:creationId xmlns:a16="http://schemas.microsoft.com/office/drawing/2014/main" id="{24A14DAE-EBB0-45A4-815D-C08033031950}"/>
               </a:ext>
             </a:extLst>
           </p:cNvPr>
@@ -4833,7 +4833,7 @@
           <p:cNvPr id="22" name="">
             <a:extLst xmlns:a="http://schemas.openxmlformats.org/drawingml/2006/main">
               <a:ext uri="{FF2B5EF4-FFF2-40B4-BE49-F238E27FC236}">
-                <a16:creationId xmlns:a16="http://schemas.microsoft.com/office/drawing/2014/main" id="{F4DF76E3-A1DB-4FC5-8E8D-754132C7C515}"/>
+                <a16:creationId xmlns:a16="http://schemas.microsoft.com/office/drawing/2014/main" id="{00028F68-4ED8-4C30-8DE8-25446C460F29}"/>
               </a:ext>
             </a:extLst>
           </p:cNvPr>
@@ -4890,7 +4890,7 @@
           <p:cNvPr id="23" name="">
             <a:extLst xmlns:a="http://schemas.openxmlformats.org/drawingml/2006/main">
               <a:ext uri="{FF2B5EF4-FFF2-40B4-BE49-F238E27FC236}">
-                <a16:creationId xmlns:a16="http://schemas.microsoft.com/office/drawing/2014/main" id="{4C7E24C1-8C92-4442-A6EC-7F90FD6D6D23}"/>
+                <a16:creationId xmlns:a16="http://schemas.microsoft.com/office/drawing/2014/main" id="{3CC2DDEE-E46E-4268-B747-A08605B34FD9}"/>
               </a:ext>
             </a:extLst>
           </p:cNvPr>
@@ -4970,7 +4970,7 @@
           <p:cNvPr id="24" name="">
             <a:extLst xmlns:a="http://schemas.openxmlformats.org/drawingml/2006/main">
               <a:ext uri="{FF2B5EF4-FFF2-40B4-BE49-F238E27FC236}">
-                <a16:creationId xmlns:a16="http://schemas.microsoft.com/office/drawing/2014/main" id="{F9D34DB6-2C75-49A3-9ACF-A19463F56CA9}"/>
+                <a16:creationId xmlns:a16="http://schemas.microsoft.com/office/drawing/2014/main" id="{6391FA4C-0482-495D-B826-68406A865160}"/>
               </a:ext>
             </a:extLst>
           </p:cNvPr>
@@ -5002,7 +5002,7 @@
           <p:cNvPr id="25" name="">
             <a:extLst xmlns:a="http://schemas.openxmlformats.org/drawingml/2006/main">
               <a:ext uri="{FF2B5EF4-FFF2-40B4-BE49-F238E27FC236}">
-                <a16:creationId xmlns:a16="http://schemas.microsoft.com/office/drawing/2014/main" id="{B316C9F3-986C-4AB8-89BA-8BA8EB2E056A}"/>
+                <a16:creationId xmlns:a16="http://schemas.microsoft.com/office/drawing/2014/main" id="{09E71EEA-84BD-4FD3-B5CE-D033EF2C3E5B}"/>
               </a:ext>
             </a:extLst>
           </p:cNvPr>
@@ -5037,7 +5037,7 @@
           <p:cNvPr id="26" name="">
             <a:extLst xmlns:a="http://schemas.openxmlformats.org/drawingml/2006/main">
               <a:ext uri="{FF2B5EF4-FFF2-40B4-BE49-F238E27FC236}">
-                <a16:creationId xmlns:a16="http://schemas.microsoft.com/office/drawing/2014/main" id="{0583C03B-8E15-47BD-B7AA-78552F28AF27}"/>
+                <a16:creationId xmlns:a16="http://schemas.microsoft.com/office/drawing/2014/main" id="{E7D13FE1-7A91-4B52-AF13-D0810065739D}"/>
               </a:ext>
             </a:extLst>
           </p:cNvPr>
@@ -5101,7 +5101,7 @@
           <p:cNvPr id="27" name="">
             <a:extLst xmlns:a="http://schemas.openxmlformats.org/drawingml/2006/main">
               <a:ext uri="{FF2B5EF4-FFF2-40B4-BE49-F238E27FC236}">
-                <a16:creationId xmlns:a16="http://schemas.microsoft.com/office/drawing/2014/main" id="{00368D05-01DD-43C9-A729-42E364C055D4}"/>
+                <a16:creationId xmlns:a16="http://schemas.microsoft.com/office/drawing/2014/main" id="{EF058F16-A595-4C2B-91C0-0CD03F7EC359}"/>
               </a:ext>
             </a:extLst>
           </p:cNvPr>
@@ -5158,7 +5158,7 @@
           <p:cNvPr id="28" name="">
             <a:extLst xmlns:a="http://schemas.openxmlformats.org/drawingml/2006/main">
               <a:ext uri="{FF2B5EF4-FFF2-40B4-BE49-F238E27FC236}">
-                <a16:creationId xmlns:a16="http://schemas.microsoft.com/office/drawing/2014/main" id="{D89D875E-2A4D-4042-9FF0-9E16D65360EC}"/>
+                <a16:creationId xmlns:a16="http://schemas.microsoft.com/office/drawing/2014/main" id="{CE2EB175-F439-4269-B09A-98B6D9D97187}"/>
               </a:ext>
             </a:extLst>
           </p:cNvPr>
@@ -5238,7 +5238,7 @@
           <p:cNvPr id="29" name="">
             <a:extLst xmlns:a="http://schemas.openxmlformats.org/drawingml/2006/main">
               <a:ext uri="{FF2B5EF4-FFF2-40B4-BE49-F238E27FC236}">
-                <a16:creationId xmlns:a16="http://schemas.microsoft.com/office/drawing/2014/main" id="{ED19241E-1C87-4759-AB93-E25F7ECF408E}"/>
+                <a16:creationId xmlns:a16="http://schemas.microsoft.com/office/drawing/2014/main" id="{B1E8C0D5-07AF-4A0C-9107-AE5A9656283E}"/>
               </a:ext>
             </a:extLst>
           </p:cNvPr>
@@ -5295,7 +5295,7 @@
           <p:cNvPr id="30" name="">
             <a:extLst xmlns:a="http://schemas.openxmlformats.org/drawingml/2006/main">
               <a:ext uri="{FF2B5EF4-FFF2-40B4-BE49-F238E27FC236}">
-                <a16:creationId xmlns:a16="http://schemas.microsoft.com/office/drawing/2014/main" id="{216E7803-FF71-4142-90DC-3FA65FF8C8AA}"/>
+                <a16:creationId xmlns:a16="http://schemas.microsoft.com/office/drawing/2014/main" id="{BAD310B8-AFAF-4D80-B504-18C375137B97}"/>
               </a:ext>
             </a:extLst>
           </p:cNvPr>
@@ -5330,7 +5330,7 @@
           <p:cNvPr id="31" name="">
             <a:extLst xmlns:a="http://schemas.openxmlformats.org/drawingml/2006/main">
               <a:ext uri="{FF2B5EF4-FFF2-40B4-BE49-F238E27FC236}">
-                <a16:creationId xmlns:a16="http://schemas.microsoft.com/office/drawing/2014/main" id="{142AD4D0-54B3-452B-8734-0622B2C6DCC0}"/>
+                <a16:creationId xmlns:a16="http://schemas.microsoft.com/office/drawing/2014/main" id="{BDAEABD5-5B57-4B9B-AF51-F2645DD97554}"/>
               </a:ext>
             </a:extLst>
           </p:cNvPr>
@@ -5387,7 +5387,7 @@
           <p:cNvPr id="32" name="">
             <a:extLst xmlns:a="http://schemas.openxmlformats.org/drawingml/2006/main">
               <a:ext uri="{FF2B5EF4-FFF2-40B4-BE49-F238E27FC236}">
-                <a16:creationId xmlns:a16="http://schemas.microsoft.com/office/drawing/2014/main" id="{7F63E0A9-B259-492F-AC10-02ABEAA63E58}"/>
+                <a16:creationId xmlns:a16="http://schemas.microsoft.com/office/drawing/2014/main" id="{02CA9AB7-7919-4B8F-A2E1-54934AC65326}"/>
               </a:ext>
             </a:extLst>
           </p:cNvPr>
@@ -5490,7 +5490,7 @@
           <p:cNvPr id="33" name="">
             <a:extLst xmlns:a="http://schemas.openxmlformats.org/drawingml/2006/main">
               <a:ext uri="{FF2B5EF4-FFF2-40B4-BE49-F238E27FC236}">
-                <a16:creationId xmlns:a16="http://schemas.microsoft.com/office/drawing/2014/main" id="{A09CFC93-8C24-4602-9C75-B6C1F0016A5E}"/>
+                <a16:creationId xmlns:a16="http://schemas.microsoft.com/office/drawing/2014/main" id="{617B21E4-C230-4329-BFB2-25D1A1931C60}"/>
               </a:ext>
             </a:extLst>
           </p:cNvPr>
@@ -5554,7 +5554,7 @@
           <p:cNvPr id="34" name="">
             <a:extLst xmlns:a="http://schemas.openxmlformats.org/drawingml/2006/main">
               <a:ext uri="{FF2B5EF4-FFF2-40B4-BE49-F238E27FC236}">
-                <a16:creationId xmlns:a16="http://schemas.microsoft.com/office/drawing/2014/main" id="{AA97E46C-30CE-4053-8CEB-68E4984BCBE1}"/>
+                <a16:creationId xmlns:a16="http://schemas.microsoft.com/office/drawing/2014/main" id="{F55F3685-CE10-4EE4-943F-6022659EC7CF}"/>
               </a:ext>
             </a:extLst>
           </p:cNvPr>
@@ -5611,7 +5611,7 @@
           <p:cNvPr id="35" name="">
             <a:extLst xmlns:a="http://schemas.openxmlformats.org/drawingml/2006/main">
               <a:ext uri="{FF2B5EF4-FFF2-40B4-BE49-F238E27FC236}">
-                <a16:creationId xmlns:a16="http://schemas.microsoft.com/office/drawing/2014/main" id="{19C5FC80-185D-4AFD-8C72-721761FF7980}"/>
+                <a16:creationId xmlns:a16="http://schemas.microsoft.com/office/drawing/2014/main" id="{57147C61-E28D-4858-9996-E8F8563B278C}"/>
               </a:ext>
             </a:extLst>
           </p:cNvPr>
@@ -5646,7 +5646,7 @@
           <p:cNvPr id="36" name="">
             <a:extLst xmlns:a="http://schemas.openxmlformats.org/drawingml/2006/main">
               <a:ext uri="{FF2B5EF4-FFF2-40B4-BE49-F238E27FC236}">
-                <a16:creationId xmlns:a16="http://schemas.microsoft.com/office/drawing/2014/main" id="{A4B83AC4-DA4C-46EA-811E-BBA10DB105EB}"/>
+                <a16:creationId xmlns:a16="http://schemas.microsoft.com/office/drawing/2014/main" id="{AED62043-197B-4449-AE0C-F4583DFE740B}"/>
               </a:ext>
             </a:extLst>
           </p:cNvPr>
@@ -5703,7 +5703,7 @@
           <p:cNvPr id="37" name="">
             <a:extLst xmlns:a="http://schemas.openxmlformats.org/drawingml/2006/main">
               <a:ext uri="{FF2B5EF4-FFF2-40B4-BE49-F238E27FC236}">
-                <a16:creationId xmlns:a16="http://schemas.microsoft.com/office/drawing/2014/main" id="{9A2B141E-E346-4CC3-9B70-5BDAD0490C09}"/>
+                <a16:creationId xmlns:a16="http://schemas.microsoft.com/office/drawing/2014/main" id="{1F580BE1-10F1-4C2F-B409-44CEF435B951}"/>
               </a:ext>
             </a:extLst>
           </p:cNvPr>
@@ -5738,7 +5738,7 @@
           <p:cNvPr id="38" name="">
             <a:extLst xmlns:a="http://schemas.openxmlformats.org/drawingml/2006/main">
               <a:ext uri="{FF2B5EF4-FFF2-40B4-BE49-F238E27FC236}">
-                <a16:creationId xmlns:a16="http://schemas.microsoft.com/office/drawing/2014/main" id="{B88B36D9-6207-4BAE-B6D0-B391834C833C}"/>
+                <a16:creationId xmlns:a16="http://schemas.microsoft.com/office/drawing/2014/main" id="{56E7EB7C-21D3-4873-A7BC-1C702A37C3F8}"/>
               </a:ext>
             </a:extLst>
           </p:cNvPr>
@@ -5795,7 +5795,7 @@
           <p:cNvPr id="39" name="">
             <a:extLst xmlns:a="http://schemas.openxmlformats.org/drawingml/2006/main">
               <a:ext uri="{FF2B5EF4-FFF2-40B4-BE49-F238E27FC236}">
-                <a16:creationId xmlns:a16="http://schemas.microsoft.com/office/drawing/2014/main" id="{D4F9DE2A-C526-47D0-BA2F-5B782C33E40E}"/>
+                <a16:creationId xmlns:a16="http://schemas.microsoft.com/office/drawing/2014/main" id="{5C7360C2-9524-4FC6-9693-A783284E1A4A}"/>
               </a:ext>
             </a:extLst>
           </p:cNvPr>
@@ -5852,7 +5852,7 @@
           <p:cNvPr id="40" name="">
             <a:extLst xmlns:a="http://schemas.openxmlformats.org/drawingml/2006/main">
               <a:ext uri="{FF2B5EF4-FFF2-40B4-BE49-F238E27FC236}">
-                <a16:creationId xmlns:a16="http://schemas.microsoft.com/office/drawing/2014/main" id="{5327CB62-9B1B-4974-8950-8E2603DEB475}"/>
+                <a16:creationId xmlns:a16="http://schemas.microsoft.com/office/drawing/2014/main" id="{7E76257E-2119-4FBE-A073-0BC3AAEC2697}"/>
               </a:ext>
             </a:extLst>
           </p:cNvPr>
@@ -5887,7 +5887,7 @@
           <p:cNvPr id="41" name="">
             <a:extLst xmlns:a="http://schemas.openxmlformats.org/drawingml/2006/main">
               <a:ext uri="{FF2B5EF4-FFF2-40B4-BE49-F238E27FC236}">
-                <a16:creationId xmlns:a16="http://schemas.microsoft.com/office/drawing/2014/main" id="{ED371E23-F83F-4D16-9943-93C4EF3B73D9}"/>
+                <a16:creationId xmlns:a16="http://schemas.microsoft.com/office/drawing/2014/main" id="{A844219B-DC8E-42C0-8696-8940C5D33870}"/>
               </a:ext>
             </a:extLst>
           </p:cNvPr>
@@ -5944,7 +5944,7 @@
           <p:cNvPr id="42" name="">
             <a:extLst xmlns:a="http://schemas.openxmlformats.org/drawingml/2006/main">
               <a:ext uri="{FF2B5EF4-FFF2-40B4-BE49-F238E27FC236}">
-                <a16:creationId xmlns:a16="http://schemas.microsoft.com/office/drawing/2014/main" id="{5017D63C-7838-48D9-87BE-09DC703B7A4A}"/>
+                <a16:creationId xmlns:a16="http://schemas.microsoft.com/office/drawing/2014/main" id="{8EA7C99F-8421-4001-9C1D-43252693CD55}"/>
               </a:ext>
             </a:extLst>
           </p:cNvPr>
@@ -6001,7 +6001,7 @@
           <p:cNvPr id="43" name="">
             <a:extLst xmlns:a="http://schemas.openxmlformats.org/drawingml/2006/main">
               <a:ext uri="{FF2B5EF4-FFF2-40B4-BE49-F238E27FC236}">
-                <a16:creationId xmlns:a16="http://schemas.microsoft.com/office/drawing/2014/main" id="{6F7EBCC8-E985-4956-823B-1D29C71905D1}"/>
+                <a16:creationId xmlns:a16="http://schemas.microsoft.com/office/drawing/2014/main" id="{141E4FDF-A1BF-4F59-AE49-D3B52DCF0DD7}"/>
               </a:ext>
             </a:extLst>
           </p:cNvPr>
@@ -6058,7 +6058,7 @@
           <p:cNvPr id="44" name="">
             <a:extLst xmlns:a="http://schemas.openxmlformats.org/drawingml/2006/main">
               <a:ext uri="{FF2B5EF4-FFF2-40B4-BE49-F238E27FC236}">
-                <a16:creationId xmlns:a16="http://schemas.microsoft.com/office/drawing/2014/main" id="{2038C833-403E-448B-9D11-2812A2641D15}"/>
+                <a16:creationId xmlns:a16="http://schemas.microsoft.com/office/drawing/2014/main" id="{BAB3B6F7-3E77-4B1A-B806-030D4B45EA9B}"/>
               </a:ext>
             </a:extLst>
           </p:cNvPr>
@@ -6105,7 +6105,7 @@
                 <a:ea typeface="Arial"/>
                 <a:cs typeface="Arial"/>
               </a:rPr>
-              <a:t>AURA • Track A • 26/09/2026</a:t>
+              <a:t>AURA • Track A • 27/09/2026</a:t>
             </a:r>
           </a:p>
         </p:txBody>
@@ -6115,7 +6115,7 @@
           <p:cNvPr id="45" name="">
             <a:extLst xmlns:a="http://schemas.openxmlformats.org/drawingml/2006/main">
               <a:ext uri="{FF2B5EF4-FFF2-40B4-BE49-F238E27FC236}">
-                <a16:creationId xmlns:a16="http://schemas.microsoft.com/office/drawing/2014/main" id="{CF0238C2-5EF1-47F9-900A-8C8BA123A330}"/>
+                <a16:creationId xmlns:a16="http://schemas.microsoft.com/office/drawing/2014/main" id="{D84ABC0B-B7BA-4150-B743-6570662EDFAE}"/>
               </a:ext>
             </a:extLst>
           </p:cNvPr>
@@ -6170,7 +6170,7 @@
     </p:spTree>
     <p:extLst>
       <p:ext uri="{BB962C8B-B14F-4D97-AF65-F5344CB8AC3E}">
-        <p14:creationId xmlns:p14="http://schemas.microsoft.com/office/powerpoint/2010/main" val="688689080"/>
+        <p14:creationId xmlns:p14="http://schemas.microsoft.com/office/powerpoint/2010/main" val="1535782144"/>
       </p:ext>
     </p:extLst>
   </p:cSld>
@@ -6201,7 +6201,7 @@
           <p:cNvPr id="32" name="">
             <a:extLst xmlns:a="http://schemas.openxmlformats.org/drawingml/2006/main">
               <a:ext uri="{FF2B5EF4-FFF2-40B4-BE49-F238E27FC236}">
-                <a16:creationId xmlns:a16="http://schemas.microsoft.com/office/drawing/2014/main" id="{FE3BF0EF-7ECD-462C-AF15-10398808603E}"/>
+                <a16:creationId xmlns:a16="http://schemas.microsoft.com/office/drawing/2014/main" id="{2AD7A4FE-309A-40CF-A069-DB48B977F1DC}"/>
               </a:ext>
             </a:extLst>
           </p:cNvPr>
@@ -6258,7 +6258,7 @@
           <p:cNvPr id="2" name="">
             <a:extLst xmlns:a="http://schemas.openxmlformats.org/drawingml/2006/main">
               <a:ext uri="{FF2B5EF4-FFF2-40B4-BE49-F238E27FC236}">
-                <a16:creationId xmlns:a16="http://schemas.microsoft.com/office/drawing/2014/main" id="{6B1C86B1-E505-47A1-95F8-57843D1583C6}"/>
+                <a16:creationId xmlns:a16="http://schemas.microsoft.com/office/drawing/2014/main" id="{6819CDC8-D97E-4AF7-AABC-6D98B66DA702}"/>
               </a:ext>
             </a:extLst>
           </p:cNvPr>
@@ -6315,7 +6315,7 @@
           <p:cNvPr id="3" name="">
             <a:extLst xmlns:a="http://schemas.openxmlformats.org/drawingml/2006/main">
               <a:ext uri="{FF2B5EF4-FFF2-40B4-BE49-F238E27FC236}">
-                <a16:creationId xmlns:a16="http://schemas.microsoft.com/office/drawing/2014/main" id="{5BA16765-30FA-4BB8-9EDF-8B149E87460F}"/>
+                <a16:creationId xmlns:a16="http://schemas.microsoft.com/office/drawing/2014/main" id="{73730901-D11C-423D-9F5B-80392071EF63}"/>
               </a:ext>
             </a:extLst>
           </p:cNvPr>
@@ -6372,7 +6372,7 @@
           <p:cNvPr id="4" name="">
             <a:extLst xmlns:a="http://schemas.openxmlformats.org/drawingml/2006/main">
               <a:ext uri="{FF2B5EF4-FFF2-40B4-BE49-F238E27FC236}">
-                <a16:creationId xmlns:a16="http://schemas.microsoft.com/office/drawing/2014/main" id="{C8A21EFB-9D9E-4DCA-BFE0-321AD5ABB23F}"/>
+                <a16:creationId xmlns:a16="http://schemas.microsoft.com/office/drawing/2014/main" id="{F97F6BAA-8CE3-40CE-9166-32EDEB36848E}"/>
               </a:ext>
             </a:extLst>
           </p:cNvPr>
@@ -6403,7 +6403,7 @@
           <p:cNvPr id="5" name="">
             <a:extLst xmlns:a="http://schemas.openxmlformats.org/drawingml/2006/main">
               <a:ext uri="{FF2B5EF4-FFF2-40B4-BE49-F238E27FC236}">
-                <a16:creationId xmlns:a16="http://schemas.microsoft.com/office/drawing/2014/main" id="{1D7B8510-0FFD-4220-AAE6-903CA22648FA}"/>
+                <a16:creationId xmlns:a16="http://schemas.microsoft.com/office/drawing/2014/main" id="{177C0B64-2853-4D05-9F35-4E21D2B1F62B}"/>
               </a:ext>
             </a:extLst>
           </p:cNvPr>
@@ -6438,7 +6438,7 @@
           <p:cNvPr id="6" name="">
             <a:extLst xmlns:a="http://schemas.openxmlformats.org/drawingml/2006/main">
               <a:ext uri="{FF2B5EF4-FFF2-40B4-BE49-F238E27FC236}">
-                <a16:creationId xmlns:a16="http://schemas.microsoft.com/office/drawing/2014/main" id="{365D3D3A-0839-44BE-82E4-BA1AAFEEBCFF}"/>
+                <a16:creationId xmlns:a16="http://schemas.microsoft.com/office/drawing/2014/main" id="{88795651-7027-4F93-BFA3-65FE576B3BB7}"/>
               </a:ext>
             </a:extLst>
           </p:cNvPr>
@@ -6502,7 +6502,7 @@
           <p:cNvPr id="7" name="">
             <a:extLst xmlns:a="http://schemas.openxmlformats.org/drawingml/2006/main">
               <a:ext uri="{FF2B5EF4-FFF2-40B4-BE49-F238E27FC236}">
-                <a16:creationId xmlns:a16="http://schemas.microsoft.com/office/drawing/2014/main" id="{7266CAA8-57C0-4DFA-97B5-5D593E2FB5A9}"/>
+                <a16:creationId xmlns:a16="http://schemas.microsoft.com/office/drawing/2014/main" id="{1E60FACF-BFE2-424D-A3AA-A71EE8A56196}"/>
               </a:ext>
             </a:extLst>
           </p:cNvPr>
@@ -6559,7 +6559,7 @@
           <p:cNvPr id="8" name="">
             <a:extLst xmlns:a="http://schemas.openxmlformats.org/drawingml/2006/main">
               <a:ext uri="{FF2B5EF4-FFF2-40B4-BE49-F238E27FC236}">
-                <a16:creationId xmlns:a16="http://schemas.microsoft.com/office/drawing/2014/main" id="{4B224471-6077-4D7A-AA16-D794FCEF4606}"/>
+                <a16:creationId xmlns:a16="http://schemas.microsoft.com/office/drawing/2014/main" id="{9BDB8A9A-C999-4BF8-8903-3B44F3FB027F}"/>
               </a:ext>
             </a:extLst>
           </p:cNvPr>
@@ -6662,7 +6662,7 @@
           <p:cNvPr id="9" name="">
             <a:extLst xmlns:a="http://schemas.openxmlformats.org/drawingml/2006/main">
               <a:ext uri="{FF2B5EF4-FFF2-40B4-BE49-F238E27FC236}">
-                <a16:creationId xmlns:a16="http://schemas.microsoft.com/office/drawing/2014/main" id="{C1FC5F92-21FD-4BD7-97A0-4C5229286AEB}"/>
+                <a16:creationId xmlns:a16="http://schemas.microsoft.com/office/drawing/2014/main" id="{B78B11EE-78FA-4ED1-824F-86D3B5912242}"/>
               </a:ext>
             </a:extLst>
           </p:cNvPr>
@@ -6697,7 +6697,7 @@
           <p:cNvPr id="10" name="">
             <a:extLst xmlns:a="http://schemas.openxmlformats.org/drawingml/2006/main">
               <a:ext uri="{FF2B5EF4-FFF2-40B4-BE49-F238E27FC236}">
-                <a16:creationId xmlns:a16="http://schemas.microsoft.com/office/drawing/2014/main" id="{FF6B1319-363E-45EF-99CD-E3DEC52B19FA}"/>
+                <a16:creationId xmlns:a16="http://schemas.microsoft.com/office/drawing/2014/main" id="{0654EEEA-8F5A-4121-BF5F-DEB2A0CF08F2}"/>
               </a:ext>
             </a:extLst>
           </p:cNvPr>
@@ -6761,7 +6761,7 @@
           <p:cNvPr id="11" name="">
             <a:extLst xmlns:a="http://schemas.openxmlformats.org/drawingml/2006/main">
               <a:ext uri="{FF2B5EF4-FFF2-40B4-BE49-F238E27FC236}">
-                <a16:creationId xmlns:a16="http://schemas.microsoft.com/office/drawing/2014/main" id="{6232DCE0-95EA-43EC-BAD3-8141F391E401}"/>
+                <a16:creationId xmlns:a16="http://schemas.microsoft.com/office/drawing/2014/main" id="{B701C4DF-18E6-417B-8014-1703567C0078}"/>
               </a:ext>
             </a:extLst>
           </p:cNvPr>
@@ -6818,7 +6818,7 @@
           <p:cNvPr id="12" name="">
             <a:extLst xmlns:a="http://schemas.openxmlformats.org/drawingml/2006/main">
               <a:ext uri="{FF2B5EF4-FFF2-40B4-BE49-F238E27FC236}">
-                <a16:creationId xmlns:a16="http://schemas.microsoft.com/office/drawing/2014/main" id="{A75FDCAF-B7DD-4E57-B229-B59D22615125}"/>
+                <a16:creationId xmlns:a16="http://schemas.microsoft.com/office/drawing/2014/main" id="{EB5C0D9B-751B-4AD3-9842-C94211DE3304}"/>
               </a:ext>
             </a:extLst>
           </p:cNvPr>
@@ -6921,7 +6921,7 @@
           <p:cNvPr id="13" name="">
             <a:extLst xmlns:a="http://schemas.openxmlformats.org/drawingml/2006/main">
               <a:ext uri="{FF2B5EF4-FFF2-40B4-BE49-F238E27FC236}">
-                <a16:creationId xmlns:a16="http://schemas.microsoft.com/office/drawing/2014/main" id="{D3BFEF4F-5B42-4AF6-ACB2-FFF9A2A6336F}"/>
+                <a16:creationId xmlns:a16="http://schemas.microsoft.com/office/drawing/2014/main" id="{07445294-B96F-40CF-B81B-ECA324381B0F}"/>
               </a:ext>
             </a:extLst>
           </p:cNvPr>
@@ -6978,7 +6978,7 @@
           <p:cNvPr id="14" name="">
             <a:extLst xmlns:a="http://schemas.openxmlformats.org/drawingml/2006/main">
               <a:ext uri="{FF2B5EF4-FFF2-40B4-BE49-F238E27FC236}">
-                <a16:creationId xmlns:a16="http://schemas.microsoft.com/office/drawing/2014/main" id="{09469467-AB29-48B5-9874-B5B2BCDA4744}"/>
+                <a16:creationId xmlns:a16="http://schemas.microsoft.com/office/drawing/2014/main" id="{34E8F69A-A8AD-4FD5-8B36-4A4E34F2EA2F}"/>
               </a:ext>
             </a:extLst>
           </p:cNvPr>
@@ -7013,7 +7013,7 @@
           <p:cNvPr id="15" name="">
             <a:extLst xmlns:a="http://schemas.openxmlformats.org/drawingml/2006/main">
               <a:ext uri="{FF2B5EF4-FFF2-40B4-BE49-F238E27FC236}">
-                <a16:creationId xmlns:a16="http://schemas.microsoft.com/office/drawing/2014/main" id="{D5A42E79-23DF-40B4-9EBF-B2A7DCC1B7EA}"/>
+                <a16:creationId xmlns:a16="http://schemas.microsoft.com/office/drawing/2014/main" id="{90CCE7F1-DF8F-4F4E-8BF3-D1121F53013B}"/>
               </a:ext>
             </a:extLst>
           </p:cNvPr>
@@ -7060,7 +7060,7 @@
                 <a:ea typeface="Arial"/>
                 <a:cs typeface="Arial"/>
               </a:rPr>
-              <a:t>60/60</a:t>
+              <a:t>70/70</a:t>
             </a:r>
           </a:p>
         </p:txBody>
@@ -7070,7 +7070,7 @@
           <p:cNvPr id="16" name="">
             <a:extLst xmlns:a="http://schemas.openxmlformats.org/drawingml/2006/main">
               <a:ext uri="{FF2B5EF4-FFF2-40B4-BE49-F238E27FC236}">
-                <a16:creationId xmlns:a16="http://schemas.microsoft.com/office/drawing/2014/main" id="{0764C305-A938-4336-8789-3D48A7E09850}"/>
+                <a16:creationId xmlns:a16="http://schemas.microsoft.com/office/drawing/2014/main" id="{F2E52BCA-E69A-47BA-912E-793E5597E6FA}"/>
               </a:ext>
             </a:extLst>
           </p:cNvPr>
@@ -7127,7 +7127,7 @@
           <p:cNvPr id="17" name="">
             <a:extLst xmlns:a="http://schemas.openxmlformats.org/drawingml/2006/main">
               <a:ext uri="{FF2B5EF4-FFF2-40B4-BE49-F238E27FC236}">
-                <a16:creationId xmlns:a16="http://schemas.microsoft.com/office/drawing/2014/main" id="{E7D873BC-9B4A-4CD9-9851-70FB7FC20996}"/>
+                <a16:creationId xmlns:a16="http://schemas.microsoft.com/office/drawing/2014/main" id="{EDDED24C-6C2F-4CE0-82B1-F82FD4393ED0}"/>
               </a:ext>
             </a:extLst>
           </p:cNvPr>
@@ -7162,7 +7162,7 @@
           <p:cNvPr id="18" name="">
             <a:extLst xmlns:a="http://schemas.openxmlformats.org/drawingml/2006/main">
               <a:ext uri="{FF2B5EF4-FFF2-40B4-BE49-F238E27FC236}">
-                <a16:creationId xmlns:a16="http://schemas.microsoft.com/office/drawing/2014/main" id="{E0DAEFAF-312D-4D7F-905B-C2885F123888}"/>
+                <a16:creationId xmlns:a16="http://schemas.microsoft.com/office/drawing/2014/main" id="{CBFE9959-741B-4E89-BB47-B481A9B38918}"/>
               </a:ext>
             </a:extLst>
           </p:cNvPr>
@@ -7209,7 +7209,7 @@
                 <a:ea typeface="Arial"/>
                 <a:cs typeface="Arial"/>
               </a:rPr>
-              <a:t>5/5</a:t>
+              <a:t>15/15</a:t>
             </a:r>
           </a:p>
         </p:txBody>
@@ -7219,7 +7219,7 @@
           <p:cNvPr id="19" name="">
             <a:extLst xmlns:a="http://schemas.openxmlformats.org/drawingml/2006/main">
               <a:ext uri="{FF2B5EF4-FFF2-40B4-BE49-F238E27FC236}">
-                <a16:creationId xmlns:a16="http://schemas.microsoft.com/office/drawing/2014/main" id="{30728E5A-0178-4C42-9380-0038E353DDAA}"/>
+                <a16:creationId xmlns:a16="http://schemas.microsoft.com/office/drawing/2014/main" id="{F1D534A9-5784-4DA1-86A7-64452DDD47FF}"/>
               </a:ext>
             </a:extLst>
           </p:cNvPr>
@@ -7266,7 +7266,7 @@
                 <a:ea typeface="Arial"/>
                 <a:cs typeface="Arial"/>
               </a:rPr>
-              <a:t>Verify v2 local</a:t>
+              <a:t>3 batch Ollama</a:t>
             </a:r>
           </a:p>
         </p:txBody>
@@ -7276,7 +7276,7 @@
           <p:cNvPr id="20" name="">
             <a:extLst xmlns:a="http://schemas.openxmlformats.org/drawingml/2006/main">
               <a:ext uri="{FF2B5EF4-FFF2-40B4-BE49-F238E27FC236}">
-                <a16:creationId xmlns:a16="http://schemas.microsoft.com/office/drawing/2014/main" id="{3BCB30B9-5D74-42B5-9710-ABC76626A7A5}"/>
+                <a16:creationId xmlns:a16="http://schemas.microsoft.com/office/drawing/2014/main" id="{125F8995-BE60-4836-BDA1-B12B4D7622CD}"/>
               </a:ext>
             </a:extLst>
           </p:cNvPr>
@@ -7311,7 +7311,7 @@
           <p:cNvPr id="21" name="">
             <a:extLst xmlns:a="http://schemas.openxmlformats.org/drawingml/2006/main">
               <a:ext uri="{FF2B5EF4-FFF2-40B4-BE49-F238E27FC236}">
-                <a16:creationId xmlns:a16="http://schemas.microsoft.com/office/drawing/2014/main" id="{78341962-1335-40B5-ADAF-C5827C0A374B}"/>
+                <a16:creationId xmlns:a16="http://schemas.microsoft.com/office/drawing/2014/main" id="{DD39DC26-7987-4370-8F25-60C05A625127}"/>
               </a:ext>
             </a:extLst>
           </p:cNvPr>
@@ -7368,7 +7368,7 @@
           <p:cNvPr id="22" name="">
             <a:extLst xmlns:a="http://schemas.openxmlformats.org/drawingml/2006/main">
               <a:ext uri="{FF2B5EF4-FFF2-40B4-BE49-F238E27FC236}">
-                <a16:creationId xmlns:a16="http://schemas.microsoft.com/office/drawing/2014/main" id="{14DA44B0-04CD-44EE-A859-E72BFFDE2B70}"/>
+                <a16:creationId xmlns:a16="http://schemas.microsoft.com/office/drawing/2014/main" id="{042A37F4-B83D-4D4F-B0F0-D75526B5C28B}"/>
               </a:ext>
             </a:extLst>
           </p:cNvPr>
@@ -7425,7 +7425,7 @@
           <p:cNvPr id="23" name="">
             <a:extLst xmlns:a="http://schemas.openxmlformats.org/drawingml/2006/main">
               <a:ext uri="{FF2B5EF4-FFF2-40B4-BE49-F238E27FC236}">
-                <a16:creationId xmlns:a16="http://schemas.microsoft.com/office/drawing/2014/main" id="{4A17DF5B-1D2D-4AA6-900F-2C58C230CEE2}"/>
+                <a16:creationId xmlns:a16="http://schemas.microsoft.com/office/drawing/2014/main" id="{A63B6292-50C3-4B5F-A552-3D0C01A1AFC0}"/>
               </a:ext>
             </a:extLst>
           </p:cNvPr>
@@ -7460,7 +7460,7 @@
           <p:cNvPr id="24" name="">
             <a:extLst xmlns:a="http://schemas.openxmlformats.org/drawingml/2006/main">
               <a:ext uri="{FF2B5EF4-FFF2-40B4-BE49-F238E27FC236}">
-                <a16:creationId xmlns:a16="http://schemas.microsoft.com/office/drawing/2014/main" id="{E57C62A5-5667-4ABA-B471-BC43110F1F5F}"/>
+                <a16:creationId xmlns:a16="http://schemas.microsoft.com/office/drawing/2014/main" id="{BD320F17-3C87-4D09-884E-408D992D21A5}"/>
               </a:ext>
             </a:extLst>
           </p:cNvPr>
@@ -7517,7 +7517,7 @@
           <p:cNvPr id="25" name="">
             <a:extLst xmlns:a="http://schemas.openxmlformats.org/drawingml/2006/main">
               <a:ext uri="{FF2B5EF4-FFF2-40B4-BE49-F238E27FC236}">
-                <a16:creationId xmlns:a16="http://schemas.microsoft.com/office/drawing/2014/main" id="{2B0F0D76-8AD8-4132-B7E3-D9D9A54665E6}"/>
+                <a16:creationId xmlns:a16="http://schemas.microsoft.com/office/drawing/2014/main" id="{9A4320E5-BF4E-4BBD-8A09-EECD69525266}"/>
               </a:ext>
             </a:extLst>
           </p:cNvPr>
@@ -7581,7 +7581,7 @@
           <p:cNvPr id="26" name="">
             <a:extLst xmlns:a="http://schemas.openxmlformats.org/drawingml/2006/main">
               <a:ext uri="{FF2B5EF4-FFF2-40B4-BE49-F238E27FC236}">
-                <a16:creationId xmlns:a16="http://schemas.microsoft.com/office/drawing/2014/main" id="{F0F9CF7C-E3CF-4188-9654-30BA1BC5C39A}"/>
+                <a16:creationId xmlns:a16="http://schemas.microsoft.com/office/drawing/2014/main" id="{F7088B7B-EB3C-49AB-A1CB-E2CB29BE9C9A}"/>
               </a:ext>
             </a:extLst>
           </p:cNvPr>
@@ -7645,7 +7645,7 @@
           <p:cNvPr id="27" name="">
             <a:extLst xmlns:a="http://schemas.openxmlformats.org/drawingml/2006/main">
               <a:ext uri="{FF2B5EF4-FFF2-40B4-BE49-F238E27FC236}">
-                <a16:creationId xmlns:a16="http://schemas.microsoft.com/office/drawing/2014/main" id="{CA635995-6FBE-4F37-888B-CFE83A7F6D59}"/>
+                <a16:creationId xmlns:a16="http://schemas.microsoft.com/office/drawing/2014/main" id="{E74EDD8B-528E-4FFF-BCE7-8E2871155CE4}"/>
               </a:ext>
             </a:extLst>
           </p:cNvPr>
@@ -7709,7 +7709,7 @@
           <p:cNvPr id="28" name="">
             <a:extLst xmlns:a="http://schemas.openxmlformats.org/drawingml/2006/main">
               <a:ext uri="{FF2B5EF4-FFF2-40B4-BE49-F238E27FC236}">
-                <a16:creationId xmlns:a16="http://schemas.microsoft.com/office/drawing/2014/main" id="{294C2A48-26A2-41E5-9F53-9AF18B3B699E}"/>
+                <a16:creationId xmlns:a16="http://schemas.microsoft.com/office/drawing/2014/main" id="{DE45CA5B-9555-44A5-85F5-0C1EFE5B304C}"/>
               </a:ext>
             </a:extLst>
           </p:cNvPr>
@@ -7773,7 +7773,7 @@
           <p:cNvPr id="29" name="">
             <a:extLst xmlns:a="http://schemas.openxmlformats.org/drawingml/2006/main">
               <a:ext uri="{FF2B5EF4-FFF2-40B4-BE49-F238E27FC236}">
-                <a16:creationId xmlns:a16="http://schemas.microsoft.com/office/drawing/2014/main" id="{2D29C0B5-9B7E-4D18-8007-A5C6895DCE76}"/>
+                <a16:creationId xmlns:a16="http://schemas.microsoft.com/office/drawing/2014/main" id="{D0FEB4FE-682D-4150-A1C5-77349FCE2640}"/>
               </a:ext>
             </a:extLst>
           </p:cNvPr>
@@ -7830,7 +7830,7 @@
           <p:cNvPr id="30" name="">
             <a:extLst xmlns:a="http://schemas.openxmlformats.org/drawingml/2006/main">
               <a:ext uri="{FF2B5EF4-FFF2-40B4-BE49-F238E27FC236}">
-                <a16:creationId xmlns:a16="http://schemas.microsoft.com/office/drawing/2014/main" id="{5905F1B9-AF7F-4126-BF6D-7215B0D33883}"/>
+                <a16:creationId xmlns:a16="http://schemas.microsoft.com/office/drawing/2014/main" id="{FB58A309-E418-4365-9BD4-F0FB33D44C07}"/>
               </a:ext>
             </a:extLst>
           </p:cNvPr>
@@ -7877,7 +7877,7 @@
                 <a:ea typeface="Arial"/>
                 <a:cs typeface="Arial"/>
               </a:rPr>
-              <a:t>AURA • Track A • 26/09/2026</a:t>
+              <a:t>AURA • Track A • 27/09/2026</a:t>
             </a:r>
           </a:p>
         </p:txBody>
@@ -7887,7 +7887,7 @@
           <p:cNvPr id="31" name="">
             <a:extLst xmlns:a="http://schemas.openxmlformats.org/drawingml/2006/main">
               <a:ext uri="{FF2B5EF4-FFF2-40B4-BE49-F238E27FC236}">
-                <a16:creationId xmlns:a16="http://schemas.microsoft.com/office/drawing/2014/main" id="{4F805BBE-0C62-4043-ADF2-3C82C79BF87F}"/>
+                <a16:creationId xmlns:a16="http://schemas.microsoft.com/office/drawing/2014/main" id="{9C9EC89A-2648-4850-8834-E005994AD7C1}"/>
               </a:ext>
             </a:extLst>
           </p:cNvPr>
@@ -7942,7 +7942,7 @@
     </p:spTree>
     <p:extLst>
       <p:ext uri="{BB962C8B-B14F-4D97-AF65-F5344CB8AC3E}">
-        <p14:creationId xmlns:p14="http://schemas.microsoft.com/office/powerpoint/2010/main" val="1090811683"/>
+        <p14:creationId xmlns:p14="http://schemas.microsoft.com/office/powerpoint/2010/main" val="980071519"/>
       </p:ext>
     </p:extLst>
   </p:cSld>
@@ -7973,7 +7973,7 @@
           <p:cNvPr id="32" name="">
             <a:extLst xmlns:a="http://schemas.openxmlformats.org/drawingml/2006/main">
               <a:ext uri="{FF2B5EF4-FFF2-40B4-BE49-F238E27FC236}">
-                <a16:creationId xmlns:a16="http://schemas.microsoft.com/office/drawing/2014/main" id="{E4C98F8B-A9FB-400C-BB4D-4DDA3AF9BA63}"/>
+                <a16:creationId xmlns:a16="http://schemas.microsoft.com/office/drawing/2014/main" id="{38D79211-2651-4EC6-B4E8-C1081D68795A}"/>
               </a:ext>
             </a:extLst>
           </p:cNvPr>
@@ -8030,7 +8030,7 @@
           <p:cNvPr id="2" name="">
             <a:extLst xmlns:a="http://schemas.openxmlformats.org/drawingml/2006/main">
               <a:ext uri="{FF2B5EF4-FFF2-40B4-BE49-F238E27FC236}">
-                <a16:creationId xmlns:a16="http://schemas.microsoft.com/office/drawing/2014/main" id="{BA12FF13-A8B8-48E2-9D10-1C489FB140FC}"/>
+                <a16:creationId xmlns:a16="http://schemas.microsoft.com/office/drawing/2014/main" id="{2889F82E-BBB9-45ED-A268-D3D6FBD0CC7D}"/>
               </a:ext>
             </a:extLst>
           </p:cNvPr>
@@ -8087,7 +8087,7 @@
           <p:cNvPr id="3" name="">
             <a:extLst xmlns:a="http://schemas.openxmlformats.org/drawingml/2006/main">
               <a:ext uri="{FF2B5EF4-FFF2-40B4-BE49-F238E27FC236}">
-                <a16:creationId xmlns:a16="http://schemas.microsoft.com/office/drawing/2014/main" id="{7F6C40A2-C547-427D-B4B4-0EFE7E14F68A}"/>
+                <a16:creationId xmlns:a16="http://schemas.microsoft.com/office/drawing/2014/main" id="{7B167745-E7B5-4CE8-8A18-F445420467E3}"/>
               </a:ext>
             </a:extLst>
           </p:cNvPr>
@@ -8144,7 +8144,7 @@
           <p:cNvPr id="4" name="">
             <a:extLst xmlns:a="http://schemas.openxmlformats.org/drawingml/2006/main">
               <a:ext uri="{FF2B5EF4-FFF2-40B4-BE49-F238E27FC236}">
-                <a16:creationId xmlns:a16="http://schemas.microsoft.com/office/drawing/2014/main" id="{1B8B43D1-7E24-4F7C-8B32-115E2D6B364F}"/>
+                <a16:creationId xmlns:a16="http://schemas.microsoft.com/office/drawing/2014/main" id="{2B3E5CED-1BFF-420F-A11A-C60DB00085F4}"/>
               </a:ext>
             </a:extLst>
           </p:cNvPr>
@@ -8175,7 +8175,7 @@
           <p:cNvPr id="5" name="">
             <a:extLst xmlns:a="http://schemas.openxmlformats.org/drawingml/2006/main">
               <a:ext uri="{FF2B5EF4-FFF2-40B4-BE49-F238E27FC236}">
-                <a16:creationId xmlns:a16="http://schemas.microsoft.com/office/drawing/2014/main" id="{1B39586A-1969-40BA-93C7-FB4429FCFBC4}"/>
+                <a16:creationId xmlns:a16="http://schemas.microsoft.com/office/drawing/2014/main" id="{B5CFFA01-4877-4386-A0D3-8182FF5088E9}"/>
               </a:ext>
             </a:extLst>
           </p:cNvPr>
@@ -8210,7 +8210,7 @@
           <p:cNvPr id="6" name="">
             <a:extLst xmlns:a="http://schemas.openxmlformats.org/drawingml/2006/main">
               <a:ext uri="{FF2B5EF4-FFF2-40B4-BE49-F238E27FC236}">
-                <a16:creationId xmlns:a16="http://schemas.microsoft.com/office/drawing/2014/main" id="{ED43F4B3-6E55-43A0-AD74-5930524DD67C}"/>
+                <a16:creationId xmlns:a16="http://schemas.microsoft.com/office/drawing/2014/main" id="{541265C9-ACCE-4DEE-B2DF-7807AEE3F0C8}"/>
               </a:ext>
             </a:extLst>
           </p:cNvPr>
@@ -8274,7 +8274,7 @@
           <p:cNvPr id="7" name="">
             <a:extLst xmlns:a="http://schemas.openxmlformats.org/drawingml/2006/main">
               <a:ext uri="{FF2B5EF4-FFF2-40B4-BE49-F238E27FC236}">
-                <a16:creationId xmlns:a16="http://schemas.microsoft.com/office/drawing/2014/main" id="{2FA8869D-B529-4A6A-B742-6D898031A179}"/>
+                <a16:creationId xmlns:a16="http://schemas.microsoft.com/office/drawing/2014/main" id="{AD1875ED-FAC1-4985-A712-8DC9B634824A}"/>
               </a:ext>
             </a:extLst>
           </p:cNvPr>
@@ -8331,7 +8331,7 @@
           <p:cNvPr id="8" name="">
             <a:extLst xmlns:a="http://schemas.openxmlformats.org/drawingml/2006/main">
               <a:ext uri="{FF2B5EF4-FFF2-40B4-BE49-F238E27FC236}">
-                <a16:creationId xmlns:a16="http://schemas.microsoft.com/office/drawing/2014/main" id="{7C2532BC-12A3-431D-B244-FF99E53FBA89}"/>
+                <a16:creationId xmlns:a16="http://schemas.microsoft.com/office/drawing/2014/main" id="{C68223BC-CD2E-4A52-A485-F9079919235D}"/>
               </a:ext>
             </a:extLst>
           </p:cNvPr>
@@ -8362,7 +8362,7 @@
           <p:cNvPr id="9" name="">
             <a:extLst xmlns:a="http://schemas.openxmlformats.org/drawingml/2006/main">
               <a:ext uri="{FF2B5EF4-FFF2-40B4-BE49-F238E27FC236}">
-                <a16:creationId xmlns:a16="http://schemas.microsoft.com/office/drawing/2014/main" id="{EBCCD049-463C-47B7-A910-472E339C49F3}"/>
+                <a16:creationId xmlns:a16="http://schemas.microsoft.com/office/drawing/2014/main" id="{174F5118-ACDF-4B81-AABF-FADB88F523A6}"/>
               </a:ext>
             </a:extLst>
           </p:cNvPr>
@@ -8397,7 +8397,7 @@
           <p:cNvPr id="10" name="">
             <a:extLst xmlns:a="http://schemas.openxmlformats.org/drawingml/2006/main">
               <a:ext uri="{FF2B5EF4-FFF2-40B4-BE49-F238E27FC236}">
-                <a16:creationId xmlns:a16="http://schemas.microsoft.com/office/drawing/2014/main" id="{70D1CEDC-6D8C-46B0-8A06-9F0DDE510E23}"/>
+                <a16:creationId xmlns:a16="http://schemas.microsoft.com/office/drawing/2014/main" id="{AE53392C-C249-48EF-8F14-B0C2D9A6D095}"/>
               </a:ext>
             </a:extLst>
           </p:cNvPr>
@@ -8461,7 +8461,7 @@
           <p:cNvPr id="11" name="">
             <a:extLst xmlns:a="http://schemas.openxmlformats.org/drawingml/2006/main">
               <a:ext uri="{FF2B5EF4-FFF2-40B4-BE49-F238E27FC236}">
-                <a16:creationId xmlns:a16="http://schemas.microsoft.com/office/drawing/2014/main" id="{184506B5-E3FA-4590-8028-A8446285C16B}"/>
+                <a16:creationId xmlns:a16="http://schemas.microsoft.com/office/drawing/2014/main" id="{07BA0F69-E727-4653-AF51-B84EC60F9460}"/>
               </a:ext>
             </a:extLst>
           </p:cNvPr>
@@ -8518,7 +8518,7 @@
           <p:cNvPr id="12" name="">
             <a:extLst xmlns:a="http://schemas.openxmlformats.org/drawingml/2006/main">
               <a:ext uri="{FF2B5EF4-FFF2-40B4-BE49-F238E27FC236}">
-                <a16:creationId xmlns:a16="http://schemas.microsoft.com/office/drawing/2014/main" id="{53CDEADE-24FD-421D-B718-B7C0980B43D5}"/>
+                <a16:creationId xmlns:a16="http://schemas.microsoft.com/office/drawing/2014/main" id="{AA0C7B5E-65AB-4D13-BE2C-182340566177}"/>
               </a:ext>
             </a:extLst>
           </p:cNvPr>
@@ -8549,7 +8549,7 @@
           <p:cNvPr id="13" name="">
             <a:extLst xmlns:a="http://schemas.openxmlformats.org/drawingml/2006/main">
               <a:ext uri="{FF2B5EF4-FFF2-40B4-BE49-F238E27FC236}">
-                <a16:creationId xmlns:a16="http://schemas.microsoft.com/office/drawing/2014/main" id="{63F3A068-6344-4738-93C9-47B75F447838}"/>
+                <a16:creationId xmlns:a16="http://schemas.microsoft.com/office/drawing/2014/main" id="{34D08274-6A1A-445F-8810-76BA933AC8B3}"/>
               </a:ext>
             </a:extLst>
           </p:cNvPr>
@@ -8584,7 +8584,7 @@
           <p:cNvPr id="14" name="">
             <a:extLst xmlns:a="http://schemas.openxmlformats.org/drawingml/2006/main">
               <a:ext uri="{FF2B5EF4-FFF2-40B4-BE49-F238E27FC236}">
-                <a16:creationId xmlns:a16="http://schemas.microsoft.com/office/drawing/2014/main" id="{9404659C-7243-446B-BED8-C346BA5C0DDD}"/>
+                <a16:creationId xmlns:a16="http://schemas.microsoft.com/office/drawing/2014/main" id="{2B92940C-29DF-4E6E-BED8-3DE46C019140}"/>
               </a:ext>
             </a:extLst>
           </p:cNvPr>
@@ -8648,7 +8648,7 @@
           <p:cNvPr id="15" name="">
             <a:extLst xmlns:a="http://schemas.openxmlformats.org/drawingml/2006/main">
               <a:ext uri="{FF2B5EF4-FFF2-40B4-BE49-F238E27FC236}">
-                <a16:creationId xmlns:a16="http://schemas.microsoft.com/office/drawing/2014/main" id="{69F228A6-58AD-48C8-8275-044CC4C9F16A}"/>
+                <a16:creationId xmlns:a16="http://schemas.microsoft.com/office/drawing/2014/main" id="{9F77F630-7A27-47AC-A29B-03E6E43E79FD}"/>
               </a:ext>
             </a:extLst>
           </p:cNvPr>
@@ -8695,7 +8695,7 @@
                 <a:ea typeface="Arial"/>
                 <a:cs typeface="Arial"/>
               </a:rPr>
-              <a:t>IVisionExtractor → PolicyDecisionEngine → EscalationWorkflow</a:t>
+              <a:t>Semantic validator → PolicyDecisionEngine → EscalationWorkflow</a:t>
             </a:r>
           </a:p>
         </p:txBody>
@@ -8705,7 +8705,7 @@
           <p:cNvPr id="16" name="">
             <a:extLst xmlns:a="http://schemas.openxmlformats.org/drawingml/2006/main">
               <a:ext uri="{FF2B5EF4-FFF2-40B4-BE49-F238E27FC236}">
-                <a16:creationId xmlns:a16="http://schemas.microsoft.com/office/drawing/2014/main" id="{46BBE92A-0360-4E6F-A2E4-F57080C6BA0C}"/>
+                <a16:creationId xmlns:a16="http://schemas.microsoft.com/office/drawing/2014/main" id="{E808892F-0B09-411C-A17B-112A3ABBC60F}"/>
               </a:ext>
             </a:extLst>
           </p:cNvPr>
@@ -8736,7 +8736,7 @@
           <p:cNvPr id="17" name="">
             <a:extLst xmlns:a="http://schemas.openxmlformats.org/drawingml/2006/main">
               <a:ext uri="{FF2B5EF4-FFF2-40B4-BE49-F238E27FC236}">
-                <a16:creationId xmlns:a16="http://schemas.microsoft.com/office/drawing/2014/main" id="{754473BC-2AE7-43B6-B6B4-1976EDCA8273}"/>
+                <a16:creationId xmlns:a16="http://schemas.microsoft.com/office/drawing/2014/main" id="{5E482A05-BD4D-488C-B336-2E94A8ABF40B}"/>
               </a:ext>
             </a:extLst>
           </p:cNvPr>
@@ -8771,7 +8771,7 @@
           <p:cNvPr id="18" name="">
             <a:extLst xmlns:a="http://schemas.openxmlformats.org/drawingml/2006/main">
               <a:ext uri="{FF2B5EF4-FFF2-40B4-BE49-F238E27FC236}">
-                <a16:creationId xmlns:a16="http://schemas.microsoft.com/office/drawing/2014/main" id="{72E7FC2E-1B96-4ECE-ABCC-282E2B85BB0C}"/>
+                <a16:creationId xmlns:a16="http://schemas.microsoft.com/office/drawing/2014/main" id="{9F135116-EB7B-4058-B7DB-65DBDA7CBE34}"/>
               </a:ext>
             </a:extLst>
           </p:cNvPr>
@@ -8835,7 +8835,7 @@
           <p:cNvPr id="19" name="">
             <a:extLst xmlns:a="http://schemas.openxmlformats.org/drawingml/2006/main">
               <a:ext uri="{FF2B5EF4-FFF2-40B4-BE49-F238E27FC236}">
-                <a16:creationId xmlns:a16="http://schemas.microsoft.com/office/drawing/2014/main" id="{9263ED7F-65B2-466A-A6BE-C3DB51B335B6}"/>
+                <a16:creationId xmlns:a16="http://schemas.microsoft.com/office/drawing/2014/main" id="{0B09530A-DD4D-4BD1-86BA-AD11DFC5DEFE}"/>
               </a:ext>
             </a:extLst>
           </p:cNvPr>
@@ -8892,7 +8892,7 @@
           <p:cNvPr id="20" name="">
             <a:extLst xmlns:a="http://schemas.openxmlformats.org/drawingml/2006/main">
               <a:ext uri="{FF2B5EF4-FFF2-40B4-BE49-F238E27FC236}">
-                <a16:creationId xmlns:a16="http://schemas.microsoft.com/office/drawing/2014/main" id="{D3674E1B-8384-4B40-ACD6-898E3B5B0099}"/>
+                <a16:creationId xmlns:a16="http://schemas.microsoft.com/office/drawing/2014/main" id="{84E6715A-4EE4-4334-8F4B-59FE1BB3CD59}"/>
               </a:ext>
             </a:extLst>
           </p:cNvPr>
@@ -8927,7 +8927,7 @@
           <p:cNvPr id="21" name="">
             <a:extLst xmlns:a="http://schemas.openxmlformats.org/drawingml/2006/main">
               <a:ext uri="{FF2B5EF4-FFF2-40B4-BE49-F238E27FC236}">
-                <a16:creationId xmlns:a16="http://schemas.microsoft.com/office/drawing/2014/main" id="{181B091C-263D-4F7B-95B2-8D4C44256807}"/>
+                <a16:creationId xmlns:a16="http://schemas.microsoft.com/office/drawing/2014/main" id="{2D331702-7F8C-44A5-B595-8A553F8D9962}"/>
               </a:ext>
             </a:extLst>
           </p:cNvPr>
@@ -8984,7 +8984,7 @@
           <p:cNvPr id="22" name="">
             <a:extLst xmlns:a="http://schemas.openxmlformats.org/drawingml/2006/main">
               <a:ext uri="{FF2B5EF4-FFF2-40B4-BE49-F238E27FC236}">
-                <a16:creationId xmlns:a16="http://schemas.microsoft.com/office/drawing/2014/main" id="{C6DBD1ED-C90F-47D3-AB60-BCFAD6240053}"/>
+                <a16:creationId xmlns:a16="http://schemas.microsoft.com/office/drawing/2014/main" id="{EA32488F-A370-4A47-B864-CE5A17F9F6CD}"/>
               </a:ext>
             </a:extLst>
           </p:cNvPr>
@@ -9041,7 +9041,7 @@
           <p:cNvPr id="23" name="">
             <a:extLst xmlns:a="http://schemas.openxmlformats.org/drawingml/2006/main">
               <a:ext uri="{FF2B5EF4-FFF2-40B4-BE49-F238E27FC236}">
-                <a16:creationId xmlns:a16="http://schemas.microsoft.com/office/drawing/2014/main" id="{96836C47-39DF-4B73-A4FF-D23E6D60207F}"/>
+                <a16:creationId xmlns:a16="http://schemas.microsoft.com/office/drawing/2014/main" id="{0610D4FE-8245-424F-A601-F17CC8CA0D99}"/>
               </a:ext>
             </a:extLst>
           </p:cNvPr>
@@ -9076,7 +9076,7 @@
           <p:cNvPr id="24" name="">
             <a:extLst xmlns:a="http://schemas.openxmlformats.org/drawingml/2006/main">
               <a:ext uri="{FF2B5EF4-FFF2-40B4-BE49-F238E27FC236}">
-                <a16:creationId xmlns:a16="http://schemas.microsoft.com/office/drawing/2014/main" id="{B62862DB-16AE-4281-8AC0-6124F65454E6}"/>
+                <a16:creationId xmlns:a16="http://schemas.microsoft.com/office/drawing/2014/main" id="{984EE886-4BB0-4071-97B5-24984D5FBE62}"/>
               </a:ext>
             </a:extLst>
           </p:cNvPr>
@@ -9140,7 +9140,7 @@
           <p:cNvPr id="25" name="">
             <a:extLst xmlns:a="http://schemas.openxmlformats.org/drawingml/2006/main">
               <a:ext uri="{FF2B5EF4-FFF2-40B4-BE49-F238E27FC236}">
-                <a16:creationId xmlns:a16="http://schemas.microsoft.com/office/drawing/2014/main" id="{C68F89E3-EFA9-4FD7-B956-BCBDAE259E67}"/>
+                <a16:creationId xmlns:a16="http://schemas.microsoft.com/office/drawing/2014/main" id="{9EC74595-F82B-4705-8537-FAC3E5EE10AE}"/>
               </a:ext>
             </a:extLst>
           </p:cNvPr>
@@ -9266,7 +9266,7 @@
           <p:cNvPr id="26" name="">
             <a:extLst xmlns:a="http://schemas.openxmlformats.org/drawingml/2006/main">
               <a:ext uri="{FF2B5EF4-FFF2-40B4-BE49-F238E27FC236}">
-                <a16:creationId xmlns:a16="http://schemas.microsoft.com/office/drawing/2014/main" id="{9A5B5D56-74C6-445B-B90B-0BFDA0FEBC83}"/>
+                <a16:creationId xmlns:a16="http://schemas.microsoft.com/office/drawing/2014/main" id="{18BCD2D8-841E-4BEB-8B44-BD17A1BD888A}"/>
               </a:ext>
             </a:extLst>
           </p:cNvPr>
@@ -9301,7 +9301,7 @@
           <p:cNvPr id="27" name="">
             <a:extLst xmlns:a="http://schemas.openxmlformats.org/drawingml/2006/main">
               <a:ext uri="{FF2B5EF4-FFF2-40B4-BE49-F238E27FC236}">
-                <a16:creationId xmlns:a16="http://schemas.microsoft.com/office/drawing/2014/main" id="{41C66F36-03F7-4F71-9FC1-7C4EF31989D2}"/>
+                <a16:creationId xmlns:a16="http://schemas.microsoft.com/office/drawing/2014/main" id="{E97A7B24-97F2-44DD-93CD-2DB4E1F88717}"/>
               </a:ext>
             </a:extLst>
           </p:cNvPr>
@@ -9365,7 +9365,7 @@
           <p:cNvPr id="28" name="">
             <a:extLst xmlns:a="http://schemas.openxmlformats.org/drawingml/2006/main">
               <a:ext uri="{FF2B5EF4-FFF2-40B4-BE49-F238E27FC236}">
-                <a16:creationId xmlns:a16="http://schemas.microsoft.com/office/drawing/2014/main" id="{3B9BA82E-F631-4156-A335-357155F5C86E}"/>
+                <a16:creationId xmlns:a16="http://schemas.microsoft.com/office/drawing/2014/main" id="{62F87716-AC95-4522-8112-BAB30DEEB7B7}"/>
               </a:ext>
             </a:extLst>
           </p:cNvPr>
@@ -9468,7 +9468,7 @@
           <p:cNvPr id="29" name="">
             <a:extLst xmlns:a="http://schemas.openxmlformats.org/drawingml/2006/main">
               <a:ext uri="{FF2B5EF4-FFF2-40B4-BE49-F238E27FC236}">
-                <a16:creationId xmlns:a16="http://schemas.microsoft.com/office/drawing/2014/main" id="{2B6001FC-4BD7-4051-B9DC-EE34BCFE3A90}"/>
+                <a16:creationId xmlns:a16="http://schemas.microsoft.com/office/drawing/2014/main" id="{BE979A21-F0D3-4D40-B269-02F05D767ADE}"/>
               </a:ext>
             </a:extLst>
           </p:cNvPr>
@@ -9548,7 +9548,7 @@
           <p:cNvPr id="30" name="">
             <a:extLst xmlns:a="http://schemas.openxmlformats.org/drawingml/2006/main">
               <a:ext uri="{FF2B5EF4-FFF2-40B4-BE49-F238E27FC236}">
-                <a16:creationId xmlns:a16="http://schemas.microsoft.com/office/drawing/2014/main" id="{92C34C6A-2F66-4006-ACBF-F52D9306CDBC}"/>
+                <a16:creationId xmlns:a16="http://schemas.microsoft.com/office/drawing/2014/main" id="{6B4977F0-FFD4-49D0-B6A0-33F1AFCD4C3E}"/>
               </a:ext>
             </a:extLst>
           </p:cNvPr>
@@ -9595,7 +9595,7 @@
                 <a:ea typeface="Arial"/>
                 <a:cs typeface="Arial"/>
               </a:rPr>
-              <a:t>AURA • Track A • 26/09/2026</a:t>
+              <a:t>AURA • Track A • 27/09/2026</a:t>
             </a:r>
           </a:p>
         </p:txBody>
@@ -9605,7 +9605,7 @@
           <p:cNvPr id="31" name="">
             <a:extLst xmlns:a="http://schemas.openxmlformats.org/drawingml/2006/main">
               <a:ext uri="{FF2B5EF4-FFF2-40B4-BE49-F238E27FC236}">
-                <a16:creationId xmlns:a16="http://schemas.microsoft.com/office/drawing/2014/main" id="{33DF3C62-13EE-4A30-A6B0-623BE0457103}"/>
+                <a16:creationId xmlns:a16="http://schemas.microsoft.com/office/drawing/2014/main" id="{9D7065C4-F349-4F5D-B54A-C9DCC461491E}"/>
               </a:ext>
             </a:extLst>
           </p:cNvPr>
@@ -9660,7 +9660,7 @@
     </p:spTree>
     <p:extLst>
       <p:ext uri="{BB962C8B-B14F-4D97-AF65-F5344CB8AC3E}">
-        <p14:creationId xmlns:p14="http://schemas.microsoft.com/office/powerpoint/2010/main" val="2147251502"/>
+        <p14:creationId xmlns:p14="http://schemas.microsoft.com/office/powerpoint/2010/main" val="906637743"/>
       </p:ext>
     </p:extLst>
   </p:cSld>
@@ -9691,7 +9691,7 @@
           <p:cNvPr id="36" name="">
             <a:extLst xmlns:a="http://schemas.openxmlformats.org/drawingml/2006/main">
               <a:ext uri="{FF2B5EF4-FFF2-40B4-BE49-F238E27FC236}">
-                <a16:creationId xmlns:a16="http://schemas.microsoft.com/office/drawing/2014/main" id="{A7D9F511-3F84-4246-8A32-9BD5A62F63F3}"/>
+                <a16:creationId xmlns:a16="http://schemas.microsoft.com/office/drawing/2014/main" id="{0A466144-C42D-4EF4-BBDE-F2C4042DCD88}"/>
               </a:ext>
             </a:extLst>
           </p:cNvPr>
@@ -9748,7 +9748,7 @@
           <p:cNvPr id="2" name="">
             <a:extLst xmlns:a="http://schemas.openxmlformats.org/drawingml/2006/main">
               <a:ext uri="{FF2B5EF4-FFF2-40B4-BE49-F238E27FC236}">
-                <a16:creationId xmlns:a16="http://schemas.microsoft.com/office/drawing/2014/main" id="{DAE46E6C-E2C3-403E-81D1-F58F438669D0}"/>
+                <a16:creationId xmlns:a16="http://schemas.microsoft.com/office/drawing/2014/main" id="{7E0E9709-BD79-4A55-A90E-1DD00B1CC156}"/>
               </a:ext>
             </a:extLst>
           </p:cNvPr>
@@ -9805,7 +9805,7 @@
           <p:cNvPr id="3" name="">
             <a:extLst xmlns:a="http://schemas.openxmlformats.org/drawingml/2006/main">
               <a:ext uri="{FF2B5EF4-FFF2-40B4-BE49-F238E27FC236}">
-                <a16:creationId xmlns:a16="http://schemas.microsoft.com/office/drawing/2014/main" id="{18A30C45-3C15-4E25-B770-D4B9C2BCEFC6}"/>
+                <a16:creationId xmlns:a16="http://schemas.microsoft.com/office/drawing/2014/main" id="{A439423D-3299-46D1-9CC1-F9DEC8E73FA1}"/>
               </a:ext>
             </a:extLst>
           </p:cNvPr>
@@ -9862,7 +9862,7 @@
           <p:cNvPr id="4" name="">
             <a:extLst xmlns:a="http://schemas.openxmlformats.org/drawingml/2006/main">
               <a:ext uri="{FF2B5EF4-FFF2-40B4-BE49-F238E27FC236}">
-                <a16:creationId xmlns:a16="http://schemas.microsoft.com/office/drawing/2014/main" id="{F1628B59-343F-498F-8DDD-664254CC7A5A}"/>
+                <a16:creationId xmlns:a16="http://schemas.microsoft.com/office/drawing/2014/main" id="{40151083-CCF9-4FFF-BE11-81BE4E4AE963}"/>
               </a:ext>
             </a:extLst>
           </p:cNvPr>
@@ -9893,7 +9893,7 @@
           <p:cNvPr id="5" name="">
             <a:extLst xmlns:a="http://schemas.openxmlformats.org/drawingml/2006/main">
               <a:ext uri="{FF2B5EF4-FFF2-40B4-BE49-F238E27FC236}">
-                <a16:creationId xmlns:a16="http://schemas.microsoft.com/office/drawing/2014/main" id="{F5E70F4A-8DE6-4BC7-9FEA-B47AC8CEA72C}"/>
+                <a16:creationId xmlns:a16="http://schemas.microsoft.com/office/drawing/2014/main" id="{5D64F738-2A5C-49C4-A327-9578A3787858}"/>
               </a:ext>
             </a:extLst>
           </p:cNvPr>
@@ -9928,7 +9928,7 @@
           <p:cNvPr id="6" name="">
             <a:extLst xmlns:a="http://schemas.openxmlformats.org/drawingml/2006/main">
               <a:ext uri="{FF2B5EF4-FFF2-40B4-BE49-F238E27FC236}">
-                <a16:creationId xmlns:a16="http://schemas.microsoft.com/office/drawing/2014/main" id="{7F7A81B2-02A3-4220-9538-2778DAB6992C}"/>
+                <a16:creationId xmlns:a16="http://schemas.microsoft.com/office/drawing/2014/main" id="{7470A48A-65EF-4B0F-A5D1-C1DEFA543003}"/>
               </a:ext>
             </a:extLst>
           </p:cNvPr>
@@ -9992,7 +9992,7 @@
           <p:cNvPr id="7" name="">
             <a:extLst xmlns:a="http://schemas.openxmlformats.org/drawingml/2006/main">
               <a:ext uri="{FF2B5EF4-FFF2-40B4-BE49-F238E27FC236}">
-                <a16:creationId xmlns:a16="http://schemas.microsoft.com/office/drawing/2014/main" id="{7F43864A-354C-409D-8D2E-C182474AFAB6}"/>
+                <a16:creationId xmlns:a16="http://schemas.microsoft.com/office/drawing/2014/main" id="{C037EFBF-C9D5-48F5-81DB-0DBDC656AC8A}"/>
               </a:ext>
             </a:extLst>
           </p:cNvPr>
@@ -10049,7 +10049,7 @@
           <p:cNvPr id="8" name="">
             <a:extLst xmlns:a="http://schemas.openxmlformats.org/drawingml/2006/main">
               <a:ext uri="{FF2B5EF4-FFF2-40B4-BE49-F238E27FC236}">
-                <a16:creationId xmlns:a16="http://schemas.microsoft.com/office/drawing/2014/main" id="{98ADA44D-473F-49D0-825C-39C063908913}"/>
+                <a16:creationId xmlns:a16="http://schemas.microsoft.com/office/drawing/2014/main" id="{71BEBB03-A4EF-4D66-A411-A70EB8D5C4B4}"/>
               </a:ext>
             </a:extLst>
           </p:cNvPr>
@@ -10084,7 +10084,7 @@
           <p:cNvPr id="9" name="">
             <a:extLst xmlns:a="http://schemas.openxmlformats.org/drawingml/2006/main">
               <a:ext uri="{FF2B5EF4-FFF2-40B4-BE49-F238E27FC236}">
-                <a16:creationId xmlns:a16="http://schemas.microsoft.com/office/drawing/2014/main" id="{81E75505-D7D8-4D77-9C6A-BB7D2D38B8BC}"/>
+                <a16:creationId xmlns:a16="http://schemas.microsoft.com/office/drawing/2014/main" id="{16B5400A-7DEA-4659-85C1-C307256CF267}"/>
               </a:ext>
             </a:extLst>
           </p:cNvPr>
@@ -10148,7 +10148,7 @@
           <p:cNvPr id="10" name="">
             <a:extLst xmlns:a="http://schemas.openxmlformats.org/drawingml/2006/main">
               <a:ext uri="{FF2B5EF4-FFF2-40B4-BE49-F238E27FC236}">
-                <a16:creationId xmlns:a16="http://schemas.microsoft.com/office/drawing/2014/main" id="{9C5B6AF0-3E5D-483C-809B-E947662B526E}"/>
+                <a16:creationId xmlns:a16="http://schemas.microsoft.com/office/drawing/2014/main" id="{48B298A2-4B66-45FE-86BA-FE3395B5CC4A}"/>
               </a:ext>
             </a:extLst>
           </p:cNvPr>
@@ -10205,7 +10205,7 @@
           <p:cNvPr id="11" name="">
             <a:extLst xmlns:a="http://schemas.openxmlformats.org/drawingml/2006/main">
               <a:ext uri="{FF2B5EF4-FFF2-40B4-BE49-F238E27FC236}">
-                <a16:creationId xmlns:a16="http://schemas.microsoft.com/office/drawing/2014/main" id="{38733E9F-EBC4-4C23-842F-04261CB0A9B4}"/>
+                <a16:creationId xmlns:a16="http://schemas.microsoft.com/office/drawing/2014/main" id="{89B2E81A-A39B-415B-8F16-7BF7D3CC16C4}"/>
               </a:ext>
             </a:extLst>
           </p:cNvPr>
@@ -10240,7 +10240,7 @@
           <p:cNvPr id="12" name="">
             <a:extLst xmlns:a="http://schemas.openxmlformats.org/drawingml/2006/main">
               <a:ext uri="{FF2B5EF4-FFF2-40B4-BE49-F238E27FC236}">
-                <a16:creationId xmlns:a16="http://schemas.microsoft.com/office/drawing/2014/main" id="{2C4383DC-EE2E-4743-9F3E-4DA6B68AF79D}"/>
+                <a16:creationId xmlns:a16="http://schemas.microsoft.com/office/drawing/2014/main" id="{F6C2C07E-177F-422D-8589-B6B9D41519AB}"/>
               </a:ext>
             </a:extLst>
           </p:cNvPr>
@@ -10294,7 +10294,7 @@
                 <a:ea typeface="Arial"/>
                 <a:cs typeface="Arial"/>
               </a:rPr>
-              <a:t>JSON lệch schema</a:t>
+              <a:t>JSON / semantic sai</a:t>
             </a:r>
           </a:p>
         </p:txBody>
@@ -10304,7 +10304,7 @@
           <p:cNvPr id="13" name="">
             <a:extLst xmlns:a="http://schemas.openxmlformats.org/drawingml/2006/main">
               <a:ext uri="{FF2B5EF4-FFF2-40B4-BE49-F238E27FC236}">
-                <a16:creationId xmlns:a16="http://schemas.microsoft.com/office/drawing/2014/main" id="{DDE09DE1-742D-4572-98F3-994B97BBF239}"/>
+                <a16:creationId xmlns:a16="http://schemas.microsoft.com/office/drawing/2014/main" id="{2B1AB71E-364A-49E0-8BB5-FE813B2C6CA9}"/>
               </a:ext>
             </a:extLst>
           </p:cNvPr>
@@ -10351,7 +10351,7 @@
                 <a:ea typeface="Arial"/>
                 <a:cs typeface="Arial"/>
               </a:rPr>
-              <a:t>Chuẩn hóa giới hạn • fail-safe nếu vẫn sai</a:t>
+              <a:t>Repair đúng 1 lần • rồi FACT fail-safe</a:t>
             </a:r>
           </a:p>
         </p:txBody>
@@ -10361,7 +10361,7 @@
           <p:cNvPr id="14" name="">
             <a:extLst xmlns:a="http://schemas.openxmlformats.org/drawingml/2006/main">
               <a:ext uri="{FF2B5EF4-FFF2-40B4-BE49-F238E27FC236}">
-                <a16:creationId xmlns:a16="http://schemas.microsoft.com/office/drawing/2014/main" id="{5E5D1082-77DB-48FE-8E8C-702394C6DA22}"/>
+                <a16:creationId xmlns:a16="http://schemas.microsoft.com/office/drawing/2014/main" id="{ABC518E1-ED4A-4F29-8952-7F6603D85D92}"/>
               </a:ext>
             </a:extLst>
           </p:cNvPr>
@@ -10396,7 +10396,7 @@
           <p:cNvPr id="15" name="">
             <a:extLst xmlns:a="http://schemas.openxmlformats.org/drawingml/2006/main">
               <a:ext uri="{FF2B5EF4-FFF2-40B4-BE49-F238E27FC236}">
-                <a16:creationId xmlns:a16="http://schemas.microsoft.com/office/drawing/2014/main" id="{FD4EF920-3827-48AC-8EA8-A540B1EAFA17}"/>
+                <a16:creationId xmlns:a16="http://schemas.microsoft.com/office/drawing/2014/main" id="{7C6A1B62-C8E6-4D73-B3CD-8BE353D64505}"/>
               </a:ext>
             </a:extLst>
           </p:cNvPr>
@@ -10460,7 +10460,7 @@
           <p:cNvPr id="16" name="">
             <a:extLst xmlns:a="http://schemas.openxmlformats.org/drawingml/2006/main">
               <a:ext uri="{FF2B5EF4-FFF2-40B4-BE49-F238E27FC236}">
-                <a16:creationId xmlns:a16="http://schemas.microsoft.com/office/drawing/2014/main" id="{B99AE377-E2EE-4CFB-97EE-44AFC8FF409D}"/>
+                <a16:creationId xmlns:a16="http://schemas.microsoft.com/office/drawing/2014/main" id="{4A8C3100-7235-4213-B48C-AB9AB90A8F18}"/>
               </a:ext>
             </a:extLst>
           </p:cNvPr>
@@ -10517,7 +10517,7 @@
           <p:cNvPr id="17" name="">
             <a:extLst xmlns:a="http://schemas.openxmlformats.org/drawingml/2006/main">
               <a:ext uri="{FF2B5EF4-FFF2-40B4-BE49-F238E27FC236}">
-                <a16:creationId xmlns:a16="http://schemas.microsoft.com/office/drawing/2014/main" id="{9632999C-2E59-469C-B02E-E51D24E33CCF}"/>
+                <a16:creationId xmlns:a16="http://schemas.microsoft.com/office/drawing/2014/main" id="{EF681309-7E06-4EDE-AAF7-6BC9F58B7277}"/>
               </a:ext>
             </a:extLst>
           </p:cNvPr>
@@ -10552,7 +10552,7 @@
           <p:cNvPr id="18" name="">
             <a:extLst xmlns:a="http://schemas.openxmlformats.org/drawingml/2006/main">
               <a:ext uri="{FF2B5EF4-FFF2-40B4-BE49-F238E27FC236}">
-                <a16:creationId xmlns:a16="http://schemas.microsoft.com/office/drawing/2014/main" id="{E492A665-5EA5-4FBF-8554-8859BD015036}"/>
+                <a16:creationId xmlns:a16="http://schemas.microsoft.com/office/drawing/2014/main" id="{DB2ABAC0-3DC0-46E9-B390-3BB6E8C6B762}"/>
               </a:ext>
             </a:extLst>
           </p:cNvPr>
@@ -10616,7 +10616,7 @@
           <p:cNvPr id="19" name="">
             <a:extLst xmlns:a="http://schemas.openxmlformats.org/drawingml/2006/main">
               <a:ext uri="{FF2B5EF4-FFF2-40B4-BE49-F238E27FC236}">
-                <a16:creationId xmlns:a16="http://schemas.microsoft.com/office/drawing/2014/main" id="{32ED5841-ED95-4CE1-843F-42B023F7A4C3}"/>
+                <a16:creationId xmlns:a16="http://schemas.microsoft.com/office/drawing/2014/main" id="{E32D3629-3703-4F83-9ACF-FBE7DB470606}"/>
               </a:ext>
             </a:extLst>
           </p:cNvPr>
@@ -10673,7 +10673,7 @@
           <p:cNvPr id="20" name="">
             <a:extLst xmlns:a="http://schemas.openxmlformats.org/drawingml/2006/main">
               <a:ext uri="{FF2B5EF4-FFF2-40B4-BE49-F238E27FC236}">
-                <a16:creationId xmlns:a16="http://schemas.microsoft.com/office/drawing/2014/main" id="{0C7869E0-BA0A-47F6-A1FD-F6B6F77D541B}"/>
+                <a16:creationId xmlns:a16="http://schemas.microsoft.com/office/drawing/2014/main" id="{C1B0AF00-F86C-459E-ACE3-02877BBFD9A1}"/>
               </a:ext>
             </a:extLst>
           </p:cNvPr>
@@ -10708,7 +10708,7 @@
           <p:cNvPr id="21" name="">
             <a:extLst xmlns:a="http://schemas.openxmlformats.org/drawingml/2006/main">
               <a:ext uri="{FF2B5EF4-FFF2-40B4-BE49-F238E27FC236}">
-                <a16:creationId xmlns:a16="http://schemas.microsoft.com/office/drawing/2014/main" id="{87DE44A8-F1BD-4457-AD3A-0CF8D60B2E3B}"/>
+                <a16:creationId xmlns:a16="http://schemas.microsoft.com/office/drawing/2014/main" id="{2D5EDCB6-3A4D-4B51-9ABE-072EEF4DFABA}"/>
               </a:ext>
             </a:extLst>
           </p:cNvPr>
@@ -10765,7 +10765,7 @@
           <p:cNvPr id="22" name="">
             <a:extLst xmlns:a="http://schemas.openxmlformats.org/drawingml/2006/main">
               <a:ext uri="{FF2B5EF4-FFF2-40B4-BE49-F238E27FC236}">
-                <a16:creationId xmlns:a16="http://schemas.microsoft.com/office/drawing/2014/main" id="{A2714775-80E6-4680-9308-500FCDD44FA8}"/>
+                <a16:creationId xmlns:a16="http://schemas.microsoft.com/office/drawing/2014/main" id="{E86C508F-A5E9-409D-A5B2-18811BCE5EAD}"/>
               </a:ext>
             </a:extLst>
           </p:cNvPr>
@@ -10829,7 +10829,7 @@
           <p:cNvPr id="23" name="">
             <a:extLst xmlns:a="http://schemas.openxmlformats.org/drawingml/2006/main">
               <a:ext uri="{FF2B5EF4-FFF2-40B4-BE49-F238E27FC236}">
-                <a16:creationId xmlns:a16="http://schemas.microsoft.com/office/drawing/2014/main" id="{B03486CF-2D33-46A8-B255-D2E8577646AE}"/>
+                <a16:creationId xmlns:a16="http://schemas.microsoft.com/office/drawing/2014/main" id="{8AC6710E-4CD8-4D6E-9E4E-51E146074014}"/>
               </a:ext>
             </a:extLst>
           </p:cNvPr>
@@ -10886,7 +10886,7 @@
           <p:cNvPr id="24" name="">
             <a:extLst xmlns:a="http://schemas.openxmlformats.org/drawingml/2006/main">
               <a:ext uri="{FF2B5EF4-FFF2-40B4-BE49-F238E27FC236}">
-                <a16:creationId xmlns:a16="http://schemas.microsoft.com/office/drawing/2014/main" id="{D751C290-69BC-4229-B401-519CE8049FB8}"/>
+                <a16:creationId xmlns:a16="http://schemas.microsoft.com/office/drawing/2014/main" id="{44FC9BCF-5A3B-4A9A-B2F6-1DC5BC38703B}"/>
               </a:ext>
             </a:extLst>
           </p:cNvPr>
@@ -10950,7 +10950,7 @@
           <p:cNvPr id="25" name="">
             <a:extLst xmlns:a="http://schemas.openxmlformats.org/drawingml/2006/main">
               <a:ext uri="{FF2B5EF4-FFF2-40B4-BE49-F238E27FC236}">
-                <a16:creationId xmlns:a16="http://schemas.microsoft.com/office/drawing/2014/main" id="{2A38C3EF-7C77-4CBA-ADB3-7829BE7D0DE4}"/>
+                <a16:creationId xmlns:a16="http://schemas.microsoft.com/office/drawing/2014/main" id="{D3032DA4-11C5-4BF8-8352-827F2ED56382}"/>
               </a:ext>
             </a:extLst>
           </p:cNvPr>
@@ -10997,7 +10997,7 @@
                 <a:ea typeface="Arial"/>
                 <a:cs typeface="Arial"/>
               </a:rPr>
-              <a:t>60 test offline</a:t>
+              <a:t>70 test offline</a:t>
             </a:r>
           </a:p>
         </p:txBody>
@@ -11007,7 +11007,7 @@
           <p:cNvPr id="26" name="">
             <a:extLst xmlns:a="http://schemas.openxmlformats.org/drawingml/2006/main">
               <a:ext uri="{FF2B5EF4-FFF2-40B4-BE49-F238E27FC236}">
-                <a16:creationId xmlns:a16="http://schemas.microsoft.com/office/drawing/2014/main" id="{049B0C0D-D028-44A4-8CC5-A8C1CA09862F}"/>
+                <a16:creationId xmlns:a16="http://schemas.microsoft.com/office/drawing/2014/main" id="{EB826F3F-331D-41E7-A25E-6540DD001D5C}"/>
               </a:ext>
             </a:extLst>
           </p:cNvPr>
@@ -11071,7 +11071,7 @@
           <p:cNvPr id="27" name="">
             <a:extLst xmlns:a="http://schemas.openxmlformats.org/drawingml/2006/main">
               <a:ext uri="{FF2B5EF4-FFF2-40B4-BE49-F238E27FC236}">
-                <a16:creationId xmlns:a16="http://schemas.microsoft.com/office/drawing/2014/main" id="{10BCAE0B-1872-44D1-8229-EAF3DF472EED}"/>
+                <a16:creationId xmlns:a16="http://schemas.microsoft.com/office/drawing/2014/main" id="{82E904AD-7500-4A4E-8830-29483B8EE85C}"/>
               </a:ext>
             </a:extLst>
           </p:cNvPr>
@@ -11118,7 +11118,7 @@
                 <a:ea typeface="Arial"/>
                 <a:cs typeface="Arial"/>
               </a:rPr>
-              <a:t>5 Verify + 15 ca BGK</a:t>
+              <a:t>15/15 fixture + 15 ca BGK</a:t>
             </a:r>
           </a:p>
         </p:txBody>
@@ -11128,7 +11128,7 @@
           <p:cNvPr id="28" name="">
             <a:extLst xmlns:a="http://schemas.openxmlformats.org/drawingml/2006/main">
               <a:ext uri="{FF2B5EF4-FFF2-40B4-BE49-F238E27FC236}">
-                <a16:creationId xmlns:a16="http://schemas.microsoft.com/office/drawing/2014/main" id="{989CC3AC-B6A9-485B-AE61-FF16F4C8612C}"/>
+                <a16:creationId xmlns:a16="http://schemas.microsoft.com/office/drawing/2014/main" id="{1758F18C-3293-47C1-B0CC-B7FAEBFDC2E6}"/>
               </a:ext>
             </a:extLst>
           </p:cNvPr>
@@ -11192,7 +11192,7 @@
           <p:cNvPr id="29" name="">
             <a:extLst xmlns:a="http://schemas.openxmlformats.org/drawingml/2006/main">
               <a:ext uri="{FF2B5EF4-FFF2-40B4-BE49-F238E27FC236}">
-                <a16:creationId xmlns:a16="http://schemas.microsoft.com/office/drawing/2014/main" id="{3216F844-EA58-42E5-829C-BF33E352E4A5}"/>
+                <a16:creationId xmlns:a16="http://schemas.microsoft.com/office/drawing/2014/main" id="{0C199269-86D3-4F49-A7D1-83B31E155454}"/>
               </a:ext>
             </a:extLst>
           </p:cNvPr>
@@ -11249,7 +11249,7 @@
           <p:cNvPr id="30" name="">
             <a:extLst xmlns:a="http://schemas.openxmlformats.org/drawingml/2006/main">
               <a:ext uri="{FF2B5EF4-FFF2-40B4-BE49-F238E27FC236}">
-                <a16:creationId xmlns:a16="http://schemas.microsoft.com/office/drawing/2014/main" id="{D2C7465D-14FE-42CC-9188-6733E4DA0781}"/>
+                <a16:creationId xmlns:a16="http://schemas.microsoft.com/office/drawing/2014/main" id="{B1EB5949-1F57-4A7E-9882-AA3D2B688D69}"/>
               </a:ext>
             </a:extLst>
           </p:cNvPr>
@@ -11284,7 +11284,7 @@
           <p:cNvPr id="31" name="">
             <a:extLst xmlns:a="http://schemas.openxmlformats.org/drawingml/2006/main">
               <a:ext uri="{FF2B5EF4-FFF2-40B4-BE49-F238E27FC236}">
-                <a16:creationId xmlns:a16="http://schemas.microsoft.com/office/drawing/2014/main" id="{D919065C-79E8-48F9-81E2-96D0408C15B4}"/>
+                <a16:creationId xmlns:a16="http://schemas.microsoft.com/office/drawing/2014/main" id="{80F4D599-F829-46FC-8287-167ECE85C3F7}"/>
               </a:ext>
             </a:extLst>
           </p:cNvPr>
@@ -11341,7 +11341,7 @@
           <p:cNvPr id="32" name="">
             <a:extLst xmlns:a="http://schemas.openxmlformats.org/drawingml/2006/main">
               <a:ext uri="{FF2B5EF4-FFF2-40B4-BE49-F238E27FC236}">
-                <a16:creationId xmlns:a16="http://schemas.microsoft.com/office/drawing/2014/main" id="{8DFE7E68-FEF6-4AFA-B20E-74707E5D683A}"/>
+                <a16:creationId xmlns:a16="http://schemas.microsoft.com/office/drawing/2014/main" id="{E255A861-F1F0-4331-B1A0-AD414991D982}"/>
               </a:ext>
             </a:extLst>
           </p:cNvPr>
@@ -11444,7 +11444,7 @@
           <p:cNvPr id="33" name="">
             <a:extLst xmlns:a="http://schemas.openxmlformats.org/drawingml/2006/main">
               <a:ext uri="{FF2B5EF4-FFF2-40B4-BE49-F238E27FC236}">
-                <a16:creationId xmlns:a16="http://schemas.microsoft.com/office/drawing/2014/main" id="{D96F2B64-88EC-463F-8E1E-84790BAD74CD}"/>
+                <a16:creationId xmlns:a16="http://schemas.microsoft.com/office/drawing/2014/main" id="{4D3AA8EE-4F9E-473D-B331-685B61C49082}"/>
               </a:ext>
             </a:extLst>
           </p:cNvPr>
@@ -11491,7 +11491,7 @@
                 <a:ea typeface="Arial"/>
                 <a:cs typeface="Arial"/>
               </a:rPr>
-              <a:t>Lộ trình: benchmark Ollama + Qwen3-VL 4B local; OpenRouter 8B vẫn là baseline.</a:t>
+              <a:t>Ollama 4B đã qua fixture gate; benchmark độc lập vẫn là điều kiện đổi baseline.</a:t>
             </a:r>
           </a:p>
         </p:txBody>
@@ -11501,7 +11501,7 @@
           <p:cNvPr id="34" name="">
             <a:extLst xmlns:a="http://schemas.openxmlformats.org/drawingml/2006/main">
               <a:ext uri="{FF2B5EF4-FFF2-40B4-BE49-F238E27FC236}">
-                <a16:creationId xmlns:a16="http://schemas.microsoft.com/office/drawing/2014/main" id="{2B5D78F2-BD03-4052-8BEE-BE1825911890}"/>
+                <a16:creationId xmlns:a16="http://schemas.microsoft.com/office/drawing/2014/main" id="{9822607D-BEC6-4582-B35B-D56871477ECF}"/>
               </a:ext>
             </a:extLst>
           </p:cNvPr>
@@ -11558,7 +11558,7 @@
           <p:cNvPr id="35" name="">
             <a:extLst xmlns:a="http://schemas.openxmlformats.org/drawingml/2006/main">
               <a:ext uri="{FF2B5EF4-FFF2-40B4-BE49-F238E27FC236}">
-                <a16:creationId xmlns:a16="http://schemas.microsoft.com/office/drawing/2014/main" id="{4758C7BD-B705-4183-BD7E-576DF13AFE49}"/>
+                <a16:creationId xmlns:a16="http://schemas.microsoft.com/office/drawing/2014/main" id="{FFBE6900-6EDC-408E-AFA9-3EF3AB3322EA}"/>
               </a:ext>
             </a:extLst>
           </p:cNvPr>
@@ -11613,7 +11613,7 @@
     </p:spTree>
     <p:extLst>
       <p:ext uri="{BB962C8B-B14F-4D97-AF65-F5344CB8AC3E}">
-        <p14:creationId xmlns:p14="http://schemas.microsoft.com/office/powerpoint/2010/main" val="149235308"/>
+        <p14:creationId xmlns:p14="http://schemas.microsoft.com/office/powerpoint/2010/main" val="517388069"/>
       </p:ext>
     </p:extLst>
   </p:cSld>

</xml_diff>

<commit_message>
docs: refresh submission benchmark artifacts
</commit_message>
<xml_diff>
--- a/AURA/submission/AURA_5_SLIDES.pptx
+++ b/AURA/submission/AURA_5_SLIDES.pptx
@@ -2,17 +2,17 @@
 <file path=ppt/presentation.xml><?xml version="1.0" encoding="utf-8"?>
 <p:presentation xmlns:p="http://schemas.openxmlformats.org/presentationml/2006/main">
   <p:sldMasterIdLst>
-    <p:sldMasterId xmlns:r="http://schemas.openxmlformats.org/officeDocument/2006/relationships" id="2147483648" r:id="R26d4c4b0b3714900"/>
+    <p:sldMasterId xmlns:r="http://schemas.openxmlformats.org/officeDocument/2006/relationships" id="2147483648" r:id="R24f5abe0f39d484f"/>
   </p:sldMasterIdLst>
   <p:notesMasterIdLst>
-    <p:notesMasterId xmlns:r="http://schemas.openxmlformats.org/officeDocument/2006/relationships" r:id="R71d3a1f8e3cd4470"/>
+    <p:notesMasterId xmlns:r="http://schemas.openxmlformats.org/officeDocument/2006/relationships" r:id="Rad9e27b9c1124157"/>
   </p:notesMasterIdLst>
   <p:sldIdLst>
-    <p:sldId xmlns:r="http://schemas.openxmlformats.org/officeDocument/2006/relationships" id="256" r:id="Rc63751a8637b4e52"/>
-    <p:sldId xmlns:r="http://schemas.openxmlformats.org/officeDocument/2006/relationships" id="257" r:id="R5b8422a539734411"/>
-    <p:sldId xmlns:r="http://schemas.openxmlformats.org/officeDocument/2006/relationships" id="258" r:id="R8216570f89e044c6"/>
-    <p:sldId xmlns:r="http://schemas.openxmlformats.org/officeDocument/2006/relationships" id="259" r:id="Rd558da52f8a5485c"/>
-    <p:sldId xmlns:r="http://schemas.openxmlformats.org/officeDocument/2006/relationships" id="260" r:id="Raee8451b8bdc44c1"/>
+    <p:sldId xmlns:r="http://schemas.openxmlformats.org/officeDocument/2006/relationships" id="256" r:id="R9ab9b30b66ed4054"/>
+    <p:sldId xmlns:r="http://schemas.openxmlformats.org/officeDocument/2006/relationships" id="257" r:id="Rbf9228bc3bc542a6"/>
+    <p:sldId xmlns:r="http://schemas.openxmlformats.org/officeDocument/2006/relationships" id="258" r:id="R55d3e9c73ab84995"/>
+    <p:sldId xmlns:r="http://schemas.openxmlformats.org/officeDocument/2006/relationships" id="259" r:id="R60e8d0328db04e2d"/>
+    <p:sldId xmlns:r="http://schemas.openxmlformats.org/officeDocument/2006/relationships" id="260" r:id="R75564caabc30404c"/>
   </p:sldIdLst>
   <p:sldSz cx="12192000" cy="6858000"/>
   <p:notesSz cx="6858000" cy="9144000"/>
@@ -586,7 +586,7 @@
           <a:lstStyle xmlns:a="http://schemas.openxmlformats.org/drawingml/2006/main"/>
           <a:p xmlns:a="http://schemas.openxmlformats.org/drawingml/2006/main">
             <a:r>
-              <a:t>Nguồn nội bộ: 70 test offline; Ollama 4B đạt 15/15 qua ba batch liên tiếp trên 5 fixture tổng hợp ngày 27/09/2026. Không suy rộng thành accuracy thực tế.</a:t>
+              <a:t>Nguồn nội bộ: 70 test offline; Ollama 4B đạt 25/25 qua năm batch liên tiếp trên 5 fixture tổng hợp và upload HoaDon1 đạt AUTO_APPROVE 3/3 ngày 27/09/2026. Không suy rộng thành accuracy thực tế.</a:t>
             </a:r>
           </a:p>
         </p:txBody>
@@ -794,7 +794,7 @@
   </p:cSld>
   <p:clrMap bg1="lt1" tx1="dk1" bg2="lt2" tx2="dk2" accent1="accent1" accent2="accent2" accent3="accent3" accent4="accent4" accent5="accent5" accent6="accent6" hlink="hlink" folHlink="folHlink"/>
   <p:sldLayoutIdLst>
-    <p:sldLayoutId xmlns:r="http://schemas.openxmlformats.org/officeDocument/2006/relationships" id="2147483649" r:id="R9da7d6cd32914c33"/>
+    <p:sldLayoutId xmlns:r="http://schemas.openxmlformats.org/officeDocument/2006/relationships" id="2147483649" r:id="R9ba4a952822248f1"/>
   </p:sldLayoutIdLst>
   <p:txStyles>
     <p:titleStyle>
@@ -1345,7 +1345,7 @@
           <p:cNvPr id="47" name="">
             <a:extLst xmlns:a="http://schemas.openxmlformats.org/drawingml/2006/main">
               <a:ext uri="{FF2B5EF4-FFF2-40B4-BE49-F238E27FC236}">
-                <a16:creationId xmlns:a16="http://schemas.microsoft.com/office/drawing/2014/main" id="{4DD194C1-9B27-4AE3-9EEF-4E8C7A7A1DF3}"/>
+                <a16:creationId xmlns:a16="http://schemas.microsoft.com/office/drawing/2014/main" id="{FEAE6662-3697-411F-8998-F138FF2E8C61}"/>
               </a:ext>
             </a:extLst>
           </p:cNvPr>
@@ -1402,7 +1402,7 @@
           <p:cNvPr id="2" name="">
             <a:extLst xmlns:a="http://schemas.openxmlformats.org/drawingml/2006/main">
               <a:ext uri="{FF2B5EF4-FFF2-40B4-BE49-F238E27FC236}">
-                <a16:creationId xmlns:a16="http://schemas.microsoft.com/office/drawing/2014/main" id="{6E380DF7-21BF-4170-BC7E-515200AE2B50}"/>
+                <a16:creationId xmlns:a16="http://schemas.microsoft.com/office/drawing/2014/main" id="{31FBE51F-54CD-49FA-BCE1-215412155644}"/>
               </a:ext>
             </a:extLst>
           </p:cNvPr>
@@ -1459,7 +1459,7 @@
           <p:cNvPr id="3" name="">
             <a:extLst xmlns:a="http://schemas.openxmlformats.org/drawingml/2006/main">
               <a:ext uri="{FF2B5EF4-FFF2-40B4-BE49-F238E27FC236}">
-                <a16:creationId xmlns:a16="http://schemas.microsoft.com/office/drawing/2014/main" id="{31DCE96D-67FC-4CC2-B194-B0C45191F079}"/>
+                <a16:creationId xmlns:a16="http://schemas.microsoft.com/office/drawing/2014/main" id="{3079F3FC-AF12-43AE-8702-921D91233BEF}"/>
               </a:ext>
             </a:extLst>
           </p:cNvPr>
@@ -1516,7 +1516,7 @@
           <p:cNvPr id="4" name="">
             <a:extLst xmlns:a="http://schemas.openxmlformats.org/drawingml/2006/main">
               <a:ext uri="{FF2B5EF4-FFF2-40B4-BE49-F238E27FC236}">
-                <a16:creationId xmlns:a16="http://schemas.microsoft.com/office/drawing/2014/main" id="{A40B5D48-7F73-47A1-9B5D-0711A80974BE}"/>
+                <a16:creationId xmlns:a16="http://schemas.microsoft.com/office/drawing/2014/main" id="{787D22B3-F9D2-4B7C-99BA-69738C4B756E}"/>
               </a:ext>
             </a:extLst>
           </p:cNvPr>
@@ -1547,7 +1547,7 @@
           <p:cNvPr id="5" name="">
             <a:extLst xmlns:a="http://schemas.openxmlformats.org/drawingml/2006/main">
               <a:ext uri="{FF2B5EF4-FFF2-40B4-BE49-F238E27FC236}">
-                <a16:creationId xmlns:a16="http://schemas.microsoft.com/office/drawing/2014/main" id="{27CC8CB1-D02A-4F70-A3BF-F1F4D5DBFFA3}"/>
+                <a16:creationId xmlns:a16="http://schemas.microsoft.com/office/drawing/2014/main" id="{09467F9E-4CBE-4F40-AF08-163129DB1567}"/>
               </a:ext>
             </a:extLst>
           </p:cNvPr>
@@ -1582,7 +1582,7 @@
           <p:cNvPr id="6" name="">
             <a:extLst xmlns:a="http://schemas.openxmlformats.org/drawingml/2006/main">
               <a:ext uri="{FF2B5EF4-FFF2-40B4-BE49-F238E27FC236}">
-                <a16:creationId xmlns:a16="http://schemas.microsoft.com/office/drawing/2014/main" id="{4E0E5271-0852-4A0E-B3F8-060B758B8F21}"/>
+                <a16:creationId xmlns:a16="http://schemas.microsoft.com/office/drawing/2014/main" id="{FCFA891D-B19D-4F6C-BDF0-7A65877D5AA8}"/>
               </a:ext>
             </a:extLst>
           </p:cNvPr>
@@ -1646,7 +1646,7 @@
           <p:cNvPr id="7" name="">
             <a:extLst xmlns:a="http://schemas.openxmlformats.org/drawingml/2006/main">
               <a:ext uri="{FF2B5EF4-FFF2-40B4-BE49-F238E27FC236}">
-                <a16:creationId xmlns:a16="http://schemas.microsoft.com/office/drawing/2014/main" id="{14AFA416-EEE9-4CBF-B250-DC634F3175A0}"/>
+                <a16:creationId xmlns:a16="http://schemas.microsoft.com/office/drawing/2014/main" id="{2DD71A78-72C0-4AB5-A4A3-01F2F03F2CC2}"/>
               </a:ext>
             </a:extLst>
           </p:cNvPr>
@@ -1703,7 +1703,7 @@
           <p:cNvPr id="8" name="">
             <a:extLst xmlns:a="http://schemas.openxmlformats.org/drawingml/2006/main">
               <a:ext uri="{FF2B5EF4-FFF2-40B4-BE49-F238E27FC236}">
-                <a16:creationId xmlns:a16="http://schemas.microsoft.com/office/drawing/2014/main" id="{F528AC9C-15D5-44E4-AE81-3383537E50DA}"/>
+                <a16:creationId xmlns:a16="http://schemas.microsoft.com/office/drawing/2014/main" id="{8BB3D061-7849-4097-B5CC-47714DFE8353}"/>
               </a:ext>
             </a:extLst>
           </p:cNvPr>
@@ -1760,7 +1760,7 @@
           <p:cNvPr id="9" name="">
             <a:extLst xmlns:a="http://schemas.openxmlformats.org/drawingml/2006/main">
               <a:ext uri="{FF2B5EF4-FFF2-40B4-BE49-F238E27FC236}">
-                <a16:creationId xmlns:a16="http://schemas.microsoft.com/office/drawing/2014/main" id="{34837B5C-8456-4CFE-A77B-57EB34103968}"/>
+                <a16:creationId xmlns:a16="http://schemas.microsoft.com/office/drawing/2014/main" id="{B8301CFF-5262-47F0-9B91-B56F038426B2}"/>
               </a:ext>
             </a:extLst>
           </p:cNvPr>
@@ -1792,7 +1792,7 @@
           <p:cNvPr id="10" name="">
             <a:extLst xmlns:a="http://schemas.openxmlformats.org/drawingml/2006/main">
               <a:ext uri="{FF2B5EF4-FFF2-40B4-BE49-F238E27FC236}">
-                <a16:creationId xmlns:a16="http://schemas.microsoft.com/office/drawing/2014/main" id="{069AC3C6-101B-44E3-9520-4D26F4C5BF40}"/>
+                <a16:creationId xmlns:a16="http://schemas.microsoft.com/office/drawing/2014/main" id="{3CE8170D-724D-473B-99FD-92EBF3903723}"/>
               </a:ext>
             </a:extLst>
           </p:cNvPr>
@@ -1827,7 +1827,7 @@
           <p:cNvPr id="11" name="">
             <a:extLst xmlns:a="http://schemas.openxmlformats.org/drawingml/2006/main">
               <a:ext uri="{FF2B5EF4-FFF2-40B4-BE49-F238E27FC236}">
-                <a16:creationId xmlns:a16="http://schemas.microsoft.com/office/drawing/2014/main" id="{A6EF6476-DA67-41C4-A44C-EDF735FF054B}"/>
+                <a16:creationId xmlns:a16="http://schemas.microsoft.com/office/drawing/2014/main" id="{B779AE0A-D2BF-4854-9B80-C09077C13996}"/>
               </a:ext>
             </a:extLst>
           </p:cNvPr>
@@ -1891,7 +1891,7 @@
           <p:cNvPr id="12" name="">
             <a:extLst xmlns:a="http://schemas.openxmlformats.org/drawingml/2006/main">
               <a:ext uri="{FF2B5EF4-FFF2-40B4-BE49-F238E27FC236}">
-                <a16:creationId xmlns:a16="http://schemas.microsoft.com/office/drawing/2014/main" id="{A29762DF-5728-4393-9EBF-CC49F0B7664F}"/>
+                <a16:creationId xmlns:a16="http://schemas.microsoft.com/office/drawing/2014/main" id="{1ED38FEE-20A1-4998-B976-9FB925E779E7}"/>
               </a:ext>
             </a:extLst>
           </p:cNvPr>
@@ -1948,7 +1948,7 @@
           <p:cNvPr id="13" name="">
             <a:extLst xmlns:a="http://schemas.openxmlformats.org/drawingml/2006/main">
               <a:ext uri="{FF2B5EF4-FFF2-40B4-BE49-F238E27FC236}">
-                <a16:creationId xmlns:a16="http://schemas.microsoft.com/office/drawing/2014/main" id="{B235E8A7-2841-47AF-80D0-708299C7D52A}"/>
+                <a16:creationId xmlns:a16="http://schemas.microsoft.com/office/drawing/2014/main" id="{E3E619CC-027E-42C7-9A9F-BF1965DDE0B4}"/>
               </a:ext>
             </a:extLst>
           </p:cNvPr>
@@ -2005,7 +2005,7 @@
           <p:cNvPr id="14" name="">
             <a:extLst xmlns:a="http://schemas.openxmlformats.org/drawingml/2006/main">
               <a:ext uri="{FF2B5EF4-FFF2-40B4-BE49-F238E27FC236}">
-                <a16:creationId xmlns:a16="http://schemas.microsoft.com/office/drawing/2014/main" id="{54FDFD93-BD6A-4C83-96E9-9537F0B36C8F}"/>
+                <a16:creationId xmlns:a16="http://schemas.microsoft.com/office/drawing/2014/main" id="{F55840E3-C0DC-4372-B9A2-D635B638DD18}"/>
               </a:ext>
             </a:extLst>
           </p:cNvPr>
@@ -2037,7 +2037,7 @@
           <p:cNvPr id="15" name="">
             <a:extLst xmlns:a="http://schemas.openxmlformats.org/drawingml/2006/main">
               <a:ext uri="{FF2B5EF4-FFF2-40B4-BE49-F238E27FC236}">
-                <a16:creationId xmlns:a16="http://schemas.microsoft.com/office/drawing/2014/main" id="{D41A0E68-798C-4267-A9FD-6B6D34BBF219}"/>
+                <a16:creationId xmlns:a16="http://schemas.microsoft.com/office/drawing/2014/main" id="{BC015C40-3325-4082-A245-19FA8DCBB574}"/>
               </a:ext>
             </a:extLst>
           </p:cNvPr>
@@ -2072,7 +2072,7 @@
           <p:cNvPr id="16" name="">
             <a:extLst xmlns:a="http://schemas.openxmlformats.org/drawingml/2006/main">
               <a:ext uri="{FF2B5EF4-FFF2-40B4-BE49-F238E27FC236}">
-                <a16:creationId xmlns:a16="http://schemas.microsoft.com/office/drawing/2014/main" id="{EA8F6051-4C89-4F35-9801-99E760E0EBCB}"/>
+                <a16:creationId xmlns:a16="http://schemas.microsoft.com/office/drawing/2014/main" id="{76A45FBD-A98D-418A-A7ED-70CC71B0EF89}"/>
               </a:ext>
             </a:extLst>
           </p:cNvPr>
@@ -2136,7 +2136,7 @@
           <p:cNvPr id="17" name="">
             <a:extLst xmlns:a="http://schemas.openxmlformats.org/drawingml/2006/main">
               <a:ext uri="{FF2B5EF4-FFF2-40B4-BE49-F238E27FC236}">
-                <a16:creationId xmlns:a16="http://schemas.microsoft.com/office/drawing/2014/main" id="{07736A36-EB48-4312-9B4E-175893F2934F}"/>
+                <a16:creationId xmlns:a16="http://schemas.microsoft.com/office/drawing/2014/main" id="{A63C7764-48D2-434F-A533-65C2AE44F3E4}"/>
               </a:ext>
             </a:extLst>
           </p:cNvPr>
@@ -2193,7 +2193,7 @@
           <p:cNvPr id="18" name="">
             <a:extLst xmlns:a="http://schemas.openxmlformats.org/drawingml/2006/main">
               <a:ext uri="{FF2B5EF4-FFF2-40B4-BE49-F238E27FC236}">
-                <a16:creationId xmlns:a16="http://schemas.microsoft.com/office/drawing/2014/main" id="{E1B8F1BF-2095-4259-AD31-DB6815AC6F13}"/>
+                <a16:creationId xmlns:a16="http://schemas.microsoft.com/office/drawing/2014/main" id="{C7AE6C5A-4D82-44B5-A0E3-864A169679E0}"/>
               </a:ext>
             </a:extLst>
           </p:cNvPr>
@@ -2250,7 +2250,7 @@
           <p:cNvPr id="19" name="">
             <a:extLst xmlns:a="http://schemas.openxmlformats.org/drawingml/2006/main">
               <a:ext uri="{FF2B5EF4-FFF2-40B4-BE49-F238E27FC236}">
-                <a16:creationId xmlns:a16="http://schemas.microsoft.com/office/drawing/2014/main" id="{5918DD97-F6CF-4719-9C5C-EA1114FB92FC}"/>
+                <a16:creationId xmlns:a16="http://schemas.microsoft.com/office/drawing/2014/main" id="{CD3526D4-8926-4CE7-B511-77CD60BD056F}"/>
               </a:ext>
             </a:extLst>
           </p:cNvPr>
@@ -2282,7 +2282,7 @@
           <p:cNvPr id="20" name="">
             <a:extLst xmlns:a="http://schemas.openxmlformats.org/drawingml/2006/main">
               <a:ext uri="{FF2B5EF4-FFF2-40B4-BE49-F238E27FC236}">
-                <a16:creationId xmlns:a16="http://schemas.microsoft.com/office/drawing/2014/main" id="{23131D07-15BF-4A88-9A1B-7E0EC44B679B}"/>
+                <a16:creationId xmlns:a16="http://schemas.microsoft.com/office/drawing/2014/main" id="{5BE3A239-7F74-4332-9BE1-E2D38BB04DA8}"/>
               </a:ext>
             </a:extLst>
           </p:cNvPr>
@@ -2317,7 +2317,7 @@
           <p:cNvPr id="21" name="">
             <a:extLst xmlns:a="http://schemas.openxmlformats.org/drawingml/2006/main">
               <a:ext uri="{FF2B5EF4-FFF2-40B4-BE49-F238E27FC236}">
-                <a16:creationId xmlns:a16="http://schemas.microsoft.com/office/drawing/2014/main" id="{508B90B5-1AD1-45EF-849B-6D89047F41FB}"/>
+                <a16:creationId xmlns:a16="http://schemas.microsoft.com/office/drawing/2014/main" id="{D91DC745-EBA6-40F5-BDDF-FEFE2D258915}"/>
               </a:ext>
             </a:extLst>
           </p:cNvPr>
@@ -2381,7 +2381,7 @@
           <p:cNvPr id="22" name="">
             <a:extLst xmlns:a="http://schemas.openxmlformats.org/drawingml/2006/main">
               <a:ext uri="{FF2B5EF4-FFF2-40B4-BE49-F238E27FC236}">
-                <a16:creationId xmlns:a16="http://schemas.microsoft.com/office/drawing/2014/main" id="{31A2C1AA-7D70-4FBC-934E-F53F372BA785}"/>
+                <a16:creationId xmlns:a16="http://schemas.microsoft.com/office/drawing/2014/main" id="{2B4F1D70-CE8D-4EAB-A249-6895F33BE3F4}"/>
               </a:ext>
             </a:extLst>
           </p:cNvPr>
@@ -2438,7 +2438,7 @@
           <p:cNvPr id="23" name="">
             <a:extLst xmlns:a="http://schemas.openxmlformats.org/drawingml/2006/main">
               <a:ext uri="{FF2B5EF4-FFF2-40B4-BE49-F238E27FC236}">
-                <a16:creationId xmlns:a16="http://schemas.microsoft.com/office/drawing/2014/main" id="{973729AD-D156-442C-A90E-163BCA00CA38}"/>
+                <a16:creationId xmlns:a16="http://schemas.microsoft.com/office/drawing/2014/main" id="{40C710F2-FDFE-4BD6-8BE0-7C6D67212445}"/>
               </a:ext>
             </a:extLst>
           </p:cNvPr>
@@ -2495,7 +2495,7 @@
           <p:cNvPr id="24" name="">
             <a:extLst xmlns:a="http://schemas.openxmlformats.org/drawingml/2006/main">
               <a:ext uri="{FF2B5EF4-FFF2-40B4-BE49-F238E27FC236}">
-                <a16:creationId xmlns:a16="http://schemas.microsoft.com/office/drawing/2014/main" id="{AB6D8C78-29D8-47B9-BCA1-E246E8DA995E}"/>
+                <a16:creationId xmlns:a16="http://schemas.microsoft.com/office/drawing/2014/main" id="{C2743D16-19EE-44B7-8E16-E3110D55A653}"/>
               </a:ext>
             </a:extLst>
           </p:cNvPr>
@@ -2527,7 +2527,7 @@
           <p:cNvPr id="25" name="">
             <a:extLst xmlns:a="http://schemas.openxmlformats.org/drawingml/2006/main">
               <a:ext uri="{FF2B5EF4-FFF2-40B4-BE49-F238E27FC236}">
-                <a16:creationId xmlns:a16="http://schemas.microsoft.com/office/drawing/2014/main" id="{0FA735CB-F520-42CE-B79F-F1B3BBB50335}"/>
+                <a16:creationId xmlns:a16="http://schemas.microsoft.com/office/drawing/2014/main" id="{1B59CA9A-B5F0-41D3-B9FE-69EB8E96F50F}"/>
               </a:ext>
             </a:extLst>
           </p:cNvPr>
@@ -2562,7 +2562,7 @@
           <p:cNvPr id="26" name="">
             <a:extLst xmlns:a="http://schemas.openxmlformats.org/drawingml/2006/main">
               <a:ext uri="{FF2B5EF4-FFF2-40B4-BE49-F238E27FC236}">
-                <a16:creationId xmlns:a16="http://schemas.microsoft.com/office/drawing/2014/main" id="{D18BA187-0A23-4E51-81FB-97153F9DC169}"/>
+                <a16:creationId xmlns:a16="http://schemas.microsoft.com/office/drawing/2014/main" id="{E9DA7AD8-FAF1-432D-A98F-9344448DB6F5}"/>
               </a:ext>
             </a:extLst>
           </p:cNvPr>
@@ -2626,7 +2626,7 @@
           <p:cNvPr id="27" name="">
             <a:extLst xmlns:a="http://schemas.openxmlformats.org/drawingml/2006/main">
               <a:ext uri="{FF2B5EF4-FFF2-40B4-BE49-F238E27FC236}">
-                <a16:creationId xmlns:a16="http://schemas.microsoft.com/office/drawing/2014/main" id="{9745A3AB-02CE-4FAC-9C9F-17AD64D78198}"/>
+                <a16:creationId xmlns:a16="http://schemas.microsoft.com/office/drawing/2014/main" id="{BAD6470F-E39B-4F5F-B9C4-CDA1455CDE4C}"/>
               </a:ext>
             </a:extLst>
           </p:cNvPr>
@@ -2683,7 +2683,7 @@
           <p:cNvPr id="28" name="">
             <a:extLst xmlns:a="http://schemas.openxmlformats.org/drawingml/2006/main">
               <a:ext uri="{FF2B5EF4-FFF2-40B4-BE49-F238E27FC236}">
-                <a16:creationId xmlns:a16="http://schemas.microsoft.com/office/drawing/2014/main" id="{3761B49E-DD2A-437B-8838-8164A6202935}"/>
+                <a16:creationId xmlns:a16="http://schemas.microsoft.com/office/drawing/2014/main" id="{06DD0875-CEA8-410F-8E51-CCFF7654D55B}"/>
               </a:ext>
             </a:extLst>
           </p:cNvPr>
@@ -2740,7 +2740,7 @@
           <p:cNvPr id="29" name="">
             <a:extLst xmlns:a="http://schemas.openxmlformats.org/drawingml/2006/main">
               <a:ext uri="{FF2B5EF4-FFF2-40B4-BE49-F238E27FC236}">
-                <a16:creationId xmlns:a16="http://schemas.microsoft.com/office/drawing/2014/main" id="{9C6C5F41-A075-47DE-9B63-E9B6E1BE8039}"/>
+                <a16:creationId xmlns:a16="http://schemas.microsoft.com/office/drawing/2014/main" id="{7026D4F1-3C33-48F6-8FFF-B1710E8F7EC8}"/>
               </a:ext>
             </a:extLst>
           </p:cNvPr>
@@ -2775,7 +2775,7 @@
           <p:cNvPr id="30" name="">
             <a:extLst xmlns:a="http://schemas.openxmlformats.org/drawingml/2006/main">
               <a:ext uri="{FF2B5EF4-FFF2-40B4-BE49-F238E27FC236}">
-                <a16:creationId xmlns:a16="http://schemas.microsoft.com/office/drawing/2014/main" id="{AE9138B9-AEB4-4FED-A4BF-4C65D0D23172}"/>
+                <a16:creationId xmlns:a16="http://schemas.microsoft.com/office/drawing/2014/main" id="{A60416CF-0E3A-4D0A-B024-1E931D7F33F2}"/>
               </a:ext>
             </a:extLst>
           </p:cNvPr>
@@ -2832,7 +2832,7 @@
           <p:cNvPr id="31" name="">
             <a:extLst xmlns:a="http://schemas.openxmlformats.org/drawingml/2006/main">
               <a:ext uri="{FF2B5EF4-FFF2-40B4-BE49-F238E27FC236}">
-                <a16:creationId xmlns:a16="http://schemas.microsoft.com/office/drawing/2014/main" id="{F34642F6-A8C8-4BC8-9C62-332B62A286EE}"/>
+                <a16:creationId xmlns:a16="http://schemas.microsoft.com/office/drawing/2014/main" id="{2858A551-B60C-4B5F-9634-8348F5C39DB0}"/>
               </a:ext>
             </a:extLst>
           </p:cNvPr>
@@ -2889,7 +2889,7 @@
           <p:cNvPr id="32" name="">
             <a:extLst xmlns:a="http://schemas.openxmlformats.org/drawingml/2006/main">
               <a:ext uri="{FF2B5EF4-FFF2-40B4-BE49-F238E27FC236}">
-                <a16:creationId xmlns:a16="http://schemas.microsoft.com/office/drawing/2014/main" id="{C557602C-2B0B-49CD-8422-FFCA03E0BF79}"/>
+                <a16:creationId xmlns:a16="http://schemas.microsoft.com/office/drawing/2014/main" id="{86B18DE7-C6DF-408B-BE03-05DB838536A8}"/>
               </a:ext>
             </a:extLst>
           </p:cNvPr>
@@ -2946,7 +2946,7 @@
           <p:cNvPr id="33" name="">
             <a:extLst xmlns:a="http://schemas.openxmlformats.org/drawingml/2006/main">
               <a:ext uri="{FF2B5EF4-FFF2-40B4-BE49-F238E27FC236}">
-                <a16:creationId xmlns:a16="http://schemas.microsoft.com/office/drawing/2014/main" id="{49468B12-9B9D-4AB6-BF3A-82D675FED8AA}"/>
+                <a16:creationId xmlns:a16="http://schemas.microsoft.com/office/drawing/2014/main" id="{9E9DF9E0-3B39-4093-AE06-39997EE7BF92}"/>
               </a:ext>
             </a:extLst>
           </p:cNvPr>
@@ -2981,7 +2981,7 @@
           <p:cNvPr id="34" name="">
             <a:extLst xmlns:a="http://schemas.openxmlformats.org/drawingml/2006/main">
               <a:ext uri="{FF2B5EF4-FFF2-40B4-BE49-F238E27FC236}">
-                <a16:creationId xmlns:a16="http://schemas.microsoft.com/office/drawing/2014/main" id="{62DB80D3-A08A-4B93-B43C-7E30BFC775AB}"/>
+                <a16:creationId xmlns:a16="http://schemas.microsoft.com/office/drawing/2014/main" id="{F30B0555-ED27-4274-BABC-CC0052BF02C2}"/>
               </a:ext>
             </a:extLst>
           </p:cNvPr>
@@ -3045,7 +3045,7 @@
           <p:cNvPr id="35" name="">
             <a:extLst xmlns:a="http://schemas.openxmlformats.org/drawingml/2006/main">
               <a:ext uri="{FF2B5EF4-FFF2-40B4-BE49-F238E27FC236}">
-                <a16:creationId xmlns:a16="http://schemas.microsoft.com/office/drawing/2014/main" id="{34B3397B-E01D-4B81-B119-D283D3FDEACF}"/>
+                <a16:creationId xmlns:a16="http://schemas.microsoft.com/office/drawing/2014/main" id="{E5BB13E0-B77A-4AC7-9EDA-4116423B62ED}"/>
               </a:ext>
             </a:extLst>
           </p:cNvPr>
@@ -3102,7 +3102,7 @@
           <p:cNvPr id="36" name="">
             <a:extLst xmlns:a="http://schemas.openxmlformats.org/drawingml/2006/main">
               <a:ext uri="{FF2B5EF4-FFF2-40B4-BE49-F238E27FC236}">
-                <a16:creationId xmlns:a16="http://schemas.microsoft.com/office/drawing/2014/main" id="{1704EE13-DEE8-4146-A719-5DC3D537C4F4}"/>
+                <a16:creationId xmlns:a16="http://schemas.microsoft.com/office/drawing/2014/main" id="{774AE0F0-3D95-4CDF-88C3-FF54961668DA}"/>
               </a:ext>
             </a:extLst>
           </p:cNvPr>
@@ -3159,7 +3159,7 @@
           <p:cNvPr id="37" name="">
             <a:extLst xmlns:a="http://schemas.openxmlformats.org/drawingml/2006/main">
               <a:ext uri="{FF2B5EF4-FFF2-40B4-BE49-F238E27FC236}">
-                <a16:creationId xmlns:a16="http://schemas.microsoft.com/office/drawing/2014/main" id="{692D80AF-AB21-4AF1-A5EA-7D4435870B3C}"/>
+                <a16:creationId xmlns:a16="http://schemas.microsoft.com/office/drawing/2014/main" id="{491CCD93-4B70-4AD1-8FC3-4F32701E0817}"/>
               </a:ext>
             </a:extLst>
           </p:cNvPr>
@@ -3194,7 +3194,7 @@
           <p:cNvPr id="38" name="">
             <a:extLst xmlns:a="http://schemas.openxmlformats.org/drawingml/2006/main">
               <a:ext uri="{FF2B5EF4-FFF2-40B4-BE49-F238E27FC236}">
-                <a16:creationId xmlns:a16="http://schemas.microsoft.com/office/drawing/2014/main" id="{C0E1746E-9616-4C79-8470-244370039DAD}"/>
+                <a16:creationId xmlns:a16="http://schemas.microsoft.com/office/drawing/2014/main" id="{FCD1E1B3-B27A-43D8-9290-8DA883D2AA68}"/>
               </a:ext>
             </a:extLst>
           </p:cNvPr>
@@ -3258,7 +3258,7 @@
           <p:cNvPr id="39" name="">
             <a:extLst xmlns:a="http://schemas.openxmlformats.org/drawingml/2006/main">
               <a:ext uri="{FF2B5EF4-FFF2-40B4-BE49-F238E27FC236}">
-                <a16:creationId xmlns:a16="http://schemas.microsoft.com/office/drawing/2014/main" id="{42C5B7CD-C554-428E-A040-C971CAC9F490}"/>
+                <a16:creationId xmlns:a16="http://schemas.microsoft.com/office/drawing/2014/main" id="{5C519177-A95D-4B74-BB03-98D9F97C7234}"/>
               </a:ext>
             </a:extLst>
           </p:cNvPr>
@@ -3315,7 +3315,7 @@
           <p:cNvPr id="40" name="">
             <a:extLst xmlns:a="http://schemas.openxmlformats.org/drawingml/2006/main">
               <a:ext uri="{FF2B5EF4-FFF2-40B4-BE49-F238E27FC236}">
-                <a16:creationId xmlns:a16="http://schemas.microsoft.com/office/drawing/2014/main" id="{706634C2-A70E-457F-B0F3-06EF8028C937}"/>
+                <a16:creationId xmlns:a16="http://schemas.microsoft.com/office/drawing/2014/main" id="{575FD67D-405D-4BCC-8C3E-830B078287C3}"/>
               </a:ext>
             </a:extLst>
           </p:cNvPr>
@@ -3372,7 +3372,7 @@
           <p:cNvPr id="41" name="">
             <a:extLst xmlns:a="http://schemas.openxmlformats.org/drawingml/2006/main">
               <a:ext uri="{FF2B5EF4-FFF2-40B4-BE49-F238E27FC236}">
-                <a16:creationId xmlns:a16="http://schemas.microsoft.com/office/drawing/2014/main" id="{1AD674A9-EEFC-4C2F-B7AE-FE86CE0FE945}"/>
+                <a16:creationId xmlns:a16="http://schemas.microsoft.com/office/drawing/2014/main" id="{6089AB8D-8879-446B-9D34-0732A08E68C5}"/>
               </a:ext>
             </a:extLst>
           </p:cNvPr>
@@ -3407,7 +3407,7 @@
           <p:cNvPr id="42" name="">
             <a:extLst xmlns:a="http://schemas.openxmlformats.org/drawingml/2006/main">
               <a:ext uri="{FF2B5EF4-FFF2-40B4-BE49-F238E27FC236}">
-                <a16:creationId xmlns:a16="http://schemas.microsoft.com/office/drawing/2014/main" id="{C16438E5-DF7E-48EF-8CE7-68676873E842}"/>
+                <a16:creationId xmlns:a16="http://schemas.microsoft.com/office/drawing/2014/main" id="{DABDE7B5-586E-4333-9D00-D3A2578CF739}"/>
               </a:ext>
             </a:extLst>
           </p:cNvPr>
@@ -3471,7 +3471,7 @@
           <p:cNvPr id="43" name="">
             <a:extLst xmlns:a="http://schemas.openxmlformats.org/drawingml/2006/main">
               <a:ext uri="{FF2B5EF4-FFF2-40B4-BE49-F238E27FC236}">
-                <a16:creationId xmlns:a16="http://schemas.microsoft.com/office/drawing/2014/main" id="{BCB726B5-BF87-4DEC-96ED-7EC36C8FE4F1}"/>
+                <a16:creationId xmlns:a16="http://schemas.microsoft.com/office/drawing/2014/main" id="{9CEAF2EC-7446-4B95-A3FF-7339859A951A}"/>
               </a:ext>
             </a:extLst>
           </p:cNvPr>
@@ -3528,7 +3528,7 @@
           <p:cNvPr id="44" name="">
             <a:extLst xmlns:a="http://schemas.openxmlformats.org/drawingml/2006/main">
               <a:ext uri="{FF2B5EF4-FFF2-40B4-BE49-F238E27FC236}">
-                <a16:creationId xmlns:a16="http://schemas.microsoft.com/office/drawing/2014/main" id="{A95AE993-64A1-4E3E-A1D4-8F93BB7215CC}"/>
+                <a16:creationId xmlns:a16="http://schemas.microsoft.com/office/drawing/2014/main" id="{E214BA73-7D10-4F48-8853-879DD092DA22}"/>
               </a:ext>
             </a:extLst>
           </p:cNvPr>
@@ -3585,7 +3585,7 @@
           <p:cNvPr id="45" name="">
             <a:extLst xmlns:a="http://schemas.openxmlformats.org/drawingml/2006/main">
               <a:ext uri="{FF2B5EF4-FFF2-40B4-BE49-F238E27FC236}">
-                <a16:creationId xmlns:a16="http://schemas.microsoft.com/office/drawing/2014/main" id="{42F87EE2-A47F-4EC5-9732-2FA935E722CA}"/>
+                <a16:creationId xmlns:a16="http://schemas.microsoft.com/office/drawing/2014/main" id="{CA55B00A-FB47-4386-82B2-E2AEAC29E6F8}"/>
               </a:ext>
             </a:extLst>
           </p:cNvPr>
@@ -3642,7 +3642,7 @@
           <p:cNvPr id="46" name="">
             <a:extLst xmlns:a="http://schemas.openxmlformats.org/drawingml/2006/main">
               <a:ext uri="{FF2B5EF4-FFF2-40B4-BE49-F238E27FC236}">
-                <a16:creationId xmlns:a16="http://schemas.microsoft.com/office/drawing/2014/main" id="{7759AF2E-479B-425B-9405-44772A3E677F}"/>
+                <a16:creationId xmlns:a16="http://schemas.microsoft.com/office/drawing/2014/main" id="{AA24989F-D925-4AA0-9316-14B022F5D33F}"/>
               </a:ext>
             </a:extLst>
           </p:cNvPr>
@@ -3697,7 +3697,7 @@
     </p:spTree>
     <p:extLst>
       <p:ext uri="{BB962C8B-B14F-4D97-AF65-F5344CB8AC3E}">
-        <p14:creationId xmlns:p14="http://schemas.microsoft.com/office/powerpoint/2010/main" val="1374718484"/>
+        <p14:creationId xmlns:p14="http://schemas.microsoft.com/office/powerpoint/2010/main" val="68081013"/>
       </p:ext>
     </p:extLst>
   </p:cSld>
@@ -3728,7 +3728,7 @@
           <p:cNvPr id="46" name="">
             <a:extLst xmlns:a="http://schemas.openxmlformats.org/drawingml/2006/main">
               <a:ext uri="{FF2B5EF4-FFF2-40B4-BE49-F238E27FC236}">
-                <a16:creationId xmlns:a16="http://schemas.microsoft.com/office/drawing/2014/main" id="{D87ADFE3-AC32-44BE-A8B0-4395C345ED1F}"/>
+                <a16:creationId xmlns:a16="http://schemas.microsoft.com/office/drawing/2014/main" id="{D4B9596A-ACFB-4B30-82F6-318A41EBADE1}"/>
               </a:ext>
             </a:extLst>
           </p:cNvPr>
@@ -3785,7 +3785,7 @@
           <p:cNvPr id="2" name="">
             <a:extLst xmlns:a="http://schemas.openxmlformats.org/drawingml/2006/main">
               <a:ext uri="{FF2B5EF4-FFF2-40B4-BE49-F238E27FC236}">
-                <a16:creationId xmlns:a16="http://schemas.microsoft.com/office/drawing/2014/main" id="{048660DE-E392-4717-A43F-57FD93B80C46}"/>
+                <a16:creationId xmlns:a16="http://schemas.microsoft.com/office/drawing/2014/main" id="{CFAB7E73-EEBF-44F1-8E0C-D65FC33C2528}"/>
               </a:ext>
             </a:extLst>
           </p:cNvPr>
@@ -3842,7 +3842,7 @@
           <p:cNvPr id="3" name="">
             <a:extLst xmlns:a="http://schemas.openxmlformats.org/drawingml/2006/main">
               <a:ext uri="{FF2B5EF4-FFF2-40B4-BE49-F238E27FC236}">
-                <a16:creationId xmlns:a16="http://schemas.microsoft.com/office/drawing/2014/main" id="{0079FBB6-6E46-4A67-A748-26863E207F45}"/>
+                <a16:creationId xmlns:a16="http://schemas.microsoft.com/office/drawing/2014/main" id="{9D277E5A-AB8F-43FD-AB08-4DFFB3DE6C11}"/>
               </a:ext>
             </a:extLst>
           </p:cNvPr>
@@ -3899,7 +3899,7 @@
           <p:cNvPr id="4" name="">
             <a:extLst xmlns:a="http://schemas.openxmlformats.org/drawingml/2006/main">
               <a:ext uri="{FF2B5EF4-FFF2-40B4-BE49-F238E27FC236}">
-                <a16:creationId xmlns:a16="http://schemas.microsoft.com/office/drawing/2014/main" id="{FDAE4FC0-0BD0-4B36-A82F-90170A81D37D}"/>
+                <a16:creationId xmlns:a16="http://schemas.microsoft.com/office/drawing/2014/main" id="{6C5F7063-5080-42FF-B190-9B5044445E0E}"/>
               </a:ext>
             </a:extLst>
           </p:cNvPr>
@@ -3930,7 +3930,7 @@
           <p:cNvPr id="5" name="">
             <a:extLst xmlns:a="http://schemas.openxmlformats.org/drawingml/2006/main">
               <a:ext uri="{FF2B5EF4-FFF2-40B4-BE49-F238E27FC236}">
-                <a16:creationId xmlns:a16="http://schemas.microsoft.com/office/drawing/2014/main" id="{0DCFA816-8097-427D-BEA8-35B182B714B3}"/>
+                <a16:creationId xmlns:a16="http://schemas.microsoft.com/office/drawing/2014/main" id="{F1769CFC-62EA-4504-92AA-02DB489E8265}"/>
               </a:ext>
             </a:extLst>
           </p:cNvPr>
@@ -3965,7 +3965,7 @@
           <p:cNvPr id="6" name="">
             <a:extLst xmlns:a="http://schemas.openxmlformats.org/drawingml/2006/main">
               <a:ext uri="{FF2B5EF4-FFF2-40B4-BE49-F238E27FC236}">
-                <a16:creationId xmlns:a16="http://schemas.microsoft.com/office/drawing/2014/main" id="{CBA7C262-B064-4602-AEA4-2E7D1A54DE17}"/>
+                <a16:creationId xmlns:a16="http://schemas.microsoft.com/office/drawing/2014/main" id="{8761DEC2-3F0F-46FF-99B5-B96CC43F1DD8}"/>
               </a:ext>
             </a:extLst>
           </p:cNvPr>
@@ -4029,7 +4029,7 @@
           <p:cNvPr id="7" name="">
             <a:extLst xmlns:a="http://schemas.openxmlformats.org/drawingml/2006/main">
               <a:ext uri="{FF2B5EF4-FFF2-40B4-BE49-F238E27FC236}">
-                <a16:creationId xmlns:a16="http://schemas.microsoft.com/office/drawing/2014/main" id="{C92D8564-D80C-4171-B2A6-86899FCA9875}"/>
+                <a16:creationId xmlns:a16="http://schemas.microsoft.com/office/drawing/2014/main" id="{EA8A166E-1D9B-4172-91A8-B6040156C433}"/>
               </a:ext>
             </a:extLst>
           </p:cNvPr>
@@ -4086,7 +4086,7 @@
           <p:cNvPr id="8" name="">
             <a:extLst xmlns:a="http://schemas.openxmlformats.org/drawingml/2006/main">
               <a:ext uri="{FF2B5EF4-FFF2-40B4-BE49-F238E27FC236}">
-                <a16:creationId xmlns:a16="http://schemas.microsoft.com/office/drawing/2014/main" id="{F94A911A-BBF8-4072-927C-313F431C62E9}"/>
+                <a16:creationId xmlns:a16="http://schemas.microsoft.com/office/drawing/2014/main" id="{91053987-1B06-48FB-B06B-EC58FBD65D5E}"/>
               </a:ext>
             </a:extLst>
           </p:cNvPr>
@@ -4166,7 +4166,7 @@
           <p:cNvPr id="9" name="">
             <a:extLst xmlns:a="http://schemas.openxmlformats.org/drawingml/2006/main">
               <a:ext uri="{FF2B5EF4-FFF2-40B4-BE49-F238E27FC236}">
-                <a16:creationId xmlns:a16="http://schemas.microsoft.com/office/drawing/2014/main" id="{2F6BFE7B-4272-46F3-A858-358BB4655998}"/>
+                <a16:creationId xmlns:a16="http://schemas.microsoft.com/office/drawing/2014/main" id="{A6D65C4A-0956-48B6-A393-436213157112}"/>
               </a:ext>
             </a:extLst>
           </p:cNvPr>
@@ -4198,7 +4198,7 @@
           <p:cNvPr id="10" name="">
             <a:extLst xmlns:a="http://schemas.openxmlformats.org/drawingml/2006/main">
               <a:ext uri="{FF2B5EF4-FFF2-40B4-BE49-F238E27FC236}">
-                <a16:creationId xmlns:a16="http://schemas.microsoft.com/office/drawing/2014/main" id="{FC5AC3FB-5A3A-4594-A728-0454BEAF21F1}"/>
+                <a16:creationId xmlns:a16="http://schemas.microsoft.com/office/drawing/2014/main" id="{4C549197-0F61-47D3-9F6F-B51B7581928A}"/>
               </a:ext>
             </a:extLst>
           </p:cNvPr>
@@ -4233,7 +4233,7 @@
           <p:cNvPr id="11" name="">
             <a:extLst xmlns:a="http://schemas.openxmlformats.org/drawingml/2006/main">
               <a:ext uri="{FF2B5EF4-FFF2-40B4-BE49-F238E27FC236}">
-                <a16:creationId xmlns:a16="http://schemas.microsoft.com/office/drawing/2014/main" id="{4B84C902-0961-46A5-8CBE-996BCC9BFAD6}"/>
+                <a16:creationId xmlns:a16="http://schemas.microsoft.com/office/drawing/2014/main" id="{F1B3FB3E-A986-46E4-BE79-D751797AE5FB}"/>
               </a:ext>
             </a:extLst>
           </p:cNvPr>
@@ -4297,7 +4297,7 @@
           <p:cNvPr id="12" name="">
             <a:extLst xmlns:a="http://schemas.openxmlformats.org/drawingml/2006/main">
               <a:ext uri="{FF2B5EF4-FFF2-40B4-BE49-F238E27FC236}">
-                <a16:creationId xmlns:a16="http://schemas.microsoft.com/office/drawing/2014/main" id="{6A0D87B7-03D5-4E1D-8157-FBEE80A86840}"/>
+                <a16:creationId xmlns:a16="http://schemas.microsoft.com/office/drawing/2014/main" id="{C618EBA9-DB33-4FF6-9572-772E90F141AE}"/>
               </a:ext>
             </a:extLst>
           </p:cNvPr>
@@ -4354,7 +4354,7 @@
           <p:cNvPr id="13" name="">
             <a:extLst xmlns:a="http://schemas.openxmlformats.org/drawingml/2006/main">
               <a:ext uri="{FF2B5EF4-FFF2-40B4-BE49-F238E27FC236}">
-                <a16:creationId xmlns:a16="http://schemas.microsoft.com/office/drawing/2014/main" id="{093C2EE5-BB47-439E-B12E-C86437355684}"/>
+                <a16:creationId xmlns:a16="http://schemas.microsoft.com/office/drawing/2014/main" id="{91301CDA-E4BB-4DDD-B2B0-F610525F7BA5}"/>
               </a:ext>
             </a:extLst>
           </p:cNvPr>
@@ -4434,7 +4434,7 @@
           <p:cNvPr id="14" name="">
             <a:extLst xmlns:a="http://schemas.openxmlformats.org/drawingml/2006/main">
               <a:ext uri="{FF2B5EF4-FFF2-40B4-BE49-F238E27FC236}">
-                <a16:creationId xmlns:a16="http://schemas.microsoft.com/office/drawing/2014/main" id="{72C6292B-D666-4770-BAF3-B11B3ACC726E}"/>
+                <a16:creationId xmlns:a16="http://schemas.microsoft.com/office/drawing/2014/main" id="{AEFD2BEA-A7E9-4216-84A6-9D1807C2ABBA}"/>
               </a:ext>
             </a:extLst>
           </p:cNvPr>
@@ -4466,7 +4466,7 @@
           <p:cNvPr id="15" name="">
             <a:extLst xmlns:a="http://schemas.openxmlformats.org/drawingml/2006/main">
               <a:ext uri="{FF2B5EF4-FFF2-40B4-BE49-F238E27FC236}">
-                <a16:creationId xmlns:a16="http://schemas.microsoft.com/office/drawing/2014/main" id="{35DD643E-FF50-428E-AA6B-964812D37347}"/>
+                <a16:creationId xmlns:a16="http://schemas.microsoft.com/office/drawing/2014/main" id="{74509B0D-82D5-4EF8-9C95-7D037364E089}"/>
               </a:ext>
             </a:extLst>
           </p:cNvPr>
@@ -4501,7 +4501,7 @@
           <p:cNvPr id="16" name="">
             <a:extLst xmlns:a="http://schemas.openxmlformats.org/drawingml/2006/main">
               <a:ext uri="{FF2B5EF4-FFF2-40B4-BE49-F238E27FC236}">
-                <a16:creationId xmlns:a16="http://schemas.microsoft.com/office/drawing/2014/main" id="{64C991E1-08DB-48D4-8E65-518D4D0AFB7E}"/>
+                <a16:creationId xmlns:a16="http://schemas.microsoft.com/office/drawing/2014/main" id="{A9EB2EF5-62EB-4C9D-B667-3595A667066E}"/>
               </a:ext>
             </a:extLst>
           </p:cNvPr>
@@ -4565,7 +4565,7 @@
           <p:cNvPr id="17" name="">
             <a:extLst xmlns:a="http://schemas.openxmlformats.org/drawingml/2006/main">
               <a:ext uri="{FF2B5EF4-FFF2-40B4-BE49-F238E27FC236}">
-                <a16:creationId xmlns:a16="http://schemas.microsoft.com/office/drawing/2014/main" id="{3579179F-287C-414B-A9A0-6EFAB942DB5F}"/>
+                <a16:creationId xmlns:a16="http://schemas.microsoft.com/office/drawing/2014/main" id="{FCC7C225-0D02-49AC-9463-51179AD459ED}"/>
               </a:ext>
             </a:extLst>
           </p:cNvPr>
@@ -4622,7 +4622,7 @@
           <p:cNvPr id="18" name="">
             <a:extLst xmlns:a="http://schemas.openxmlformats.org/drawingml/2006/main">
               <a:ext uri="{FF2B5EF4-FFF2-40B4-BE49-F238E27FC236}">
-                <a16:creationId xmlns:a16="http://schemas.microsoft.com/office/drawing/2014/main" id="{23B6C4ED-6C94-4AEE-B527-BCF97A3FE2E5}"/>
+                <a16:creationId xmlns:a16="http://schemas.microsoft.com/office/drawing/2014/main" id="{86CDD257-F55F-4E98-A33E-6F19C2D5482F}"/>
               </a:ext>
             </a:extLst>
           </p:cNvPr>
@@ -4702,7 +4702,7 @@
           <p:cNvPr id="19" name="">
             <a:extLst xmlns:a="http://schemas.openxmlformats.org/drawingml/2006/main">
               <a:ext uri="{FF2B5EF4-FFF2-40B4-BE49-F238E27FC236}">
-                <a16:creationId xmlns:a16="http://schemas.microsoft.com/office/drawing/2014/main" id="{5EB83095-0A3F-4CE0-BCD4-82AA860A8740}"/>
+                <a16:creationId xmlns:a16="http://schemas.microsoft.com/office/drawing/2014/main" id="{CC55D96E-5532-433B-B8E1-070B85B2DF3D}"/>
               </a:ext>
             </a:extLst>
           </p:cNvPr>
@@ -4734,7 +4734,7 @@
           <p:cNvPr id="20" name="">
             <a:extLst xmlns:a="http://schemas.openxmlformats.org/drawingml/2006/main">
               <a:ext uri="{FF2B5EF4-FFF2-40B4-BE49-F238E27FC236}">
-                <a16:creationId xmlns:a16="http://schemas.microsoft.com/office/drawing/2014/main" id="{B40555A2-6479-4FF2-93B1-2C899C4BB4AC}"/>
+                <a16:creationId xmlns:a16="http://schemas.microsoft.com/office/drawing/2014/main" id="{548C89ED-467A-4FA6-8D4B-C03764B57739}"/>
               </a:ext>
             </a:extLst>
           </p:cNvPr>
@@ -4769,7 +4769,7 @@
           <p:cNvPr id="21" name="">
             <a:extLst xmlns:a="http://schemas.openxmlformats.org/drawingml/2006/main">
               <a:ext uri="{FF2B5EF4-FFF2-40B4-BE49-F238E27FC236}">
-                <a16:creationId xmlns:a16="http://schemas.microsoft.com/office/drawing/2014/main" id="{24A14DAE-EBB0-45A4-815D-C08033031950}"/>
+                <a16:creationId xmlns:a16="http://schemas.microsoft.com/office/drawing/2014/main" id="{DA23A4B7-A703-42DE-9645-F67AEA177F21}"/>
               </a:ext>
             </a:extLst>
           </p:cNvPr>
@@ -4833,7 +4833,7 @@
           <p:cNvPr id="22" name="">
             <a:extLst xmlns:a="http://schemas.openxmlformats.org/drawingml/2006/main">
               <a:ext uri="{FF2B5EF4-FFF2-40B4-BE49-F238E27FC236}">
-                <a16:creationId xmlns:a16="http://schemas.microsoft.com/office/drawing/2014/main" id="{00028F68-4ED8-4C30-8DE8-25446C460F29}"/>
+                <a16:creationId xmlns:a16="http://schemas.microsoft.com/office/drawing/2014/main" id="{9151DFFC-6B1D-47A9-A522-C9EC409D3BCF}"/>
               </a:ext>
             </a:extLst>
           </p:cNvPr>
@@ -4890,7 +4890,7 @@
           <p:cNvPr id="23" name="">
             <a:extLst xmlns:a="http://schemas.openxmlformats.org/drawingml/2006/main">
               <a:ext uri="{FF2B5EF4-FFF2-40B4-BE49-F238E27FC236}">
-                <a16:creationId xmlns:a16="http://schemas.microsoft.com/office/drawing/2014/main" id="{3CC2DDEE-E46E-4268-B747-A08605B34FD9}"/>
+                <a16:creationId xmlns:a16="http://schemas.microsoft.com/office/drawing/2014/main" id="{C0CBA39B-7B02-4D70-B012-180E69EC2D0F}"/>
               </a:ext>
             </a:extLst>
           </p:cNvPr>
@@ -4970,7 +4970,7 @@
           <p:cNvPr id="24" name="">
             <a:extLst xmlns:a="http://schemas.openxmlformats.org/drawingml/2006/main">
               <a:ext uri="{FF2B5EF4-FFF2-40B4-BE49-F238E27FC236}">
-                <a16:creationId xmlns:a16="http://schemas.microsoft.com/office/drawing/2014/main" id="{6391FA4C-0482-495D-B826-68406A865160}"/>
+                <a16:creationId xmlns:a16="http://schemas.microsoft.com/office/drawing/2014/main" id="{098A2526-0EE8-4F1B-96BF-A15BD7FC93CC}"/>
               </a:ext>
             </a:extLst>
           </p:cNvPr>
@@ -5002,7 +5002,7 @@
           <p:cNvPr id="25" name="">
             <a:extLst xmlns:a="http://schemas.openxmlformats.org/drawingml/2006/main">
               <a:ext uri="{FF2B5EF4-FFF2-40B4-BE49-F238E27FC236}">
-                <a16:creationId xmlns:a16="http://schemas.microsoft.com/office/drawing/2014/main" id="{09E71EEA-84BD-4FD3-B5CE-D033EF2C3E5B}"/>
+                <a16:creationId xmlns:a16="http://schemas.microsoft.com/office/drawing/2014/main" id="{7B690CEB-0DE9-4F5B-9D90-B58F95C12BF8}"/>
               </a:ext>
             </a:extLst>
           </p:cNvPr>
@@ -5037,7 +5037,7 @@
           <p:cNvPr id="26" name="">
             <a:extLst xmlns:a="http://schemas.openxmlformats.org/drawingml/2006/main">
               <a:ext uri="{FF2B5EF4-FFF2-40B4-BE49-F238E27FC236}">
-                <a16:creationId xmlns:a16="http://schemas.microsoft.com/office/drawing/2014/main" id="{E7D13FE1-7A91-4B52-AF13-D0810065739D}"/>
+                <a16:creationId xmlns:a16="http://schemas.microsoft.com/office/drawing/2014/main" id="{3C8FFA90-2DC4-4E0D-8E2A-EF8A809A8290}"/>
               </a:ext>
             </a:extLst>
           </p:cNvPr>
@@ -5101,7 +5101,7 @@
           <p:cNvPr id="27" name="">
             <a:extLst xmlns:a="http://schemas.openxmlformats.org/drawingml/2006/main">
               <a:ext uri="{FF2B5EF4-FFF2-40B4-BE49-F238E27FC236}">
-                <a16:creationId xmlns:a16="http://schemas.microsoft.com/office/drawing/2014/main" id="{EF058F16-A595-4C2B-91C0-0CD03F7EC359}"/>
+                <a16:creationId xmlns:a16="http://schemas.microsoft.com/office/drawing/2014/main" id="{2EDA0258-2049-4213-96C3-A6EB28EC4E37}"/>
               </a:ext>
             </a:extLst>
           </p:cNvPr>
@@ -5158,7 +5158,7 @@
           <p:cNvPr id="28" name="">
             <a:extLst xmlns:a="http://schemas.openxmlformats.org/drawingml/2006/main">
               <a:ext uri="{FF2B5EF4-FFF2-40B4-BE49-F238E27FC236}">
-                <a16:creationId xmlns:a16="http://schemas.microsoft.com/office/drawing/2014/main" id="{CE2EB175-F439-4269-B09A-98B6D9D97187}"/>
+                <a16:creationId xmlns:a16="http://schemas.microsoft.com/office/drawing/2014/main" id="{8E4610CD-7308-409D-806A-0B553AE876F9}"/>
               </a:ext>
             </a:extLst>
           </p:cNvPr>
@@ -5238,7 +5238,7 @@
           <p:cNvPr id="29" name="">
             <a:extLst xmlns:a="http://schemas.openxmlformats.org/drawingml/2006/main">
               <a:ext uri="{FF2B5EF4-FFF2-40B4-BE49-F238E27FC236}">
-                <a16:creationId xmlns:a16="http://schemas.microsoft.com/office/drawing/2014/main" id="{B1E8C0D5-07AF-4A0C-9107-AE5A9656283E}"/>
+                <a16:creationId xmlns:a16="http://schemas.microsoft.com/office/drawing/2014/main" id="{404664C9-AE3C-4002-93FE-54C18BEF3D43}"/>
               </a:ext>
             </a:extLst>
           </p:cNvPr>
@@ -5295,7 +5295,7 @@
           <p:cNvPr id="30" name="">
             <a:extLst xmlns:a="http://schemas.openxmlformats.org/drawingml/2006/main">
               <a:ext uri="{FF2B5EF4-FFF2-40B4-BE49-F238E27FC236}">
-                <a16:creationId xmlns:a16="http://schemas.microsoft.com/office/drawing/2014/main" id="{BAD310B8-AFAF-4D80-B504-18C375137B97}"/>
+                <a16:creationId xmlns:a16="http://schemas.microsoft.com/office/drawing/2014/main" id="{B39E6EF8-13E2-4B9A-A5C4-10855B98C228}"/>
               </a:ext>
             </a:extLst>
           </p:cNvPr>
@@ -5330,7 +5330,7 @@
           <p:cNvPr id="31" name="">
             <a:extLst xmlns:a="http://schemas.openxmlformats.org/drawingml/2006/main">
               <a:ext uri="{FF2B5EF4-FFF2-40B4-BE49-F238E27FC236}">
-                <a16:creationId xmlns:a16="http://schemas.microsoft.com/office/drawing/2014/main" id="{BDAEABD5-5B57-4B9B-AF51-F2645DD97554}"/>
+                <a16:creationId xmlns:a16="http://schemas.microsoft.com/office/drawing/2014/main" id="{7BA8CE2C-D2BA-4DFB-8689-AFBCCAA670BE}"/>
               </a:ext>
             </a:extLst>
           </p:cNvPr>
@@ -5387,7 +5387,7 @@
           <p:cNvPr id="32" name="">
             <a:extLst xmlns:a="http://schemas.openxmlformats.org/drawingml/2006/main">
               <a:ext uri="{FF2B5EF4-FFF2-40B4-BE49-F238E27FC236}">
-                <a16:creationId xmlns:a16="http://schemas.microsoft.com/office/drawing/2014/main" id="{02CA9AB7-7919-4B8F-A2E1-54934AC65326}"/>
+                <a16:creationId xmlns:a16="http://schemas.microsoft.com/office/drawing/2014/main" id="{A0AF5824-A3A7-4258-9F48-BE6B93A62C6B}"/>
               </a:ext>
             </a:extLst>
           </p:cNvPr>
@@ -5490,7 +5490,7 @@
           <p:cNvPr id="33" name="">
             <a:extLst xmlns:a="http://schemas.openxmlformats.org/drawingml/2006/main">
               <a:ext uri="{FF2B5EF4-FFF2-40B4-BE49-F238E27FC236}">
-                <a16:creationId xmlns:a16="http://schemas.microsoft.com/office/drawing/2014/main" id="{617B21E4-C230-4329-BFB2-25D1A1931C60}"/>
+                <a16:creationId xmlns:a16="http://schemas.microsoft.com/office/drawing/2014/main" id="{80DDC9C6-8C0F-40DB-91D7-7C9387F79182}"/>
               </a:ext>
             </a:extLst>
           </p:cNvPr>
@@ -5554,7 +5554,7 @@
           <p:cNvPr id="34" name="">
             <a:extLst xmlns:a="http://schemas.openxmlformats.org/drawingml/2006/main">
               <a:ext uri="{FF2B5EF4-FFF2-40B4-BE49-F238E27FC236}">
-                <a16:creationId xmlns:a16="http://schemas.microsoft.com/office/drawing/2014/main" id="{F55F3685-CE10-4EE4-943F-6022659EC7CF}"/>
+                <a16:creationId xmlns:a16="http://schemas.microsoft.com/office/drawing/2014/main" id="{4674333A-2DEA-47AF-8260-739B6BF8612C}"/>
               </a:ext>
             </a:extLst>
           </p:cNvPr>
@@ -5611,7 +5611,7 @@
           <p:cNvPr id="35" name="">
             <a:extLst xmlns:a="http://schemas.openxmlformats.org/drawingml/2006/main">
               <a:ext uri="{FF2B5EF4-FFF2-40B4-BE49-F238E27FC236}">
-                <a16:creationId xmlns:a16="http://schemas.microsoft.com/office/drawing/2014/main" id="{57147C61-E28D-4858-9996-E8F8563B278C}"/>
+                <a16:creationId xmlns:a16="http://schemas.microsoft.com/office/drawing/2014/main" id="{46896355-91E3-48F4-B0E9-82F22B532A78}"/>
               </a:ext>
             </a:extLst>
           </p:cNvPr>
@@ -5646,7 +5646,7 @@
           <p:cNvPr id="36" name="">
             <a:extLst xmlns:a="http://schemas.openxmlformats.org/drawingml/2006/main">
               <a:ext uri="{FF2B5EF4-FFF2-40B4-BE49-F238E27FC236}">
-                <a16:creationId xmlns:a16="http://schemas.microsoft.com/office/drawing/2014/main" id="{AED62043-197B-4449-AE0C-F4583DFE740B}"/>
+                <a16:creationId xmlns:a16="http://schemas.microsoft.com/office/drawing/2014/main" id="{A7D320F2-D5E8-4D46-965D-746A69088FCE}"/>
               </a:ext>
             </a:extLst>
           </p:cNvPr>
@@ -5703,7 +5703,7 @@
           <p:cNvPr id="37" name="">
             <a:extLst xmlns:a="http://schemas.openxmlformats.org/drawingml/2006/main">
               <a:ext uri="{FF2B5EF4-FFF2-40B4-BE49-F238E27FC236}">
-                <a16:creationId xmlns:a16="http://schemas.microsoft.com/office/drawing/2014/main" id="{1F580BE1-10F1-4C2F-B409-44CEF435B951}"/>
+                <a16:creationId xmlns:a16="http://schemas.microsoft.com/office/drawing/2014/main" id="{6EE05417-D43F-419D-85B5-D0C0C1A896AF}"/>
               </a:ext>
             </a:extLst>
           </p:cNvPr>
@@ -5738,7 +5738,7 @@
           <p:cNvPr id="38" name="">
             <a:extLst xmlns:a="http://schemas.openxmlformats.org/drawingml/2006/main">
               <a:ext uri="{FF2B5EF4-FFF2-40B4-BE49-F238E27FC236}">
-                <a16:creationId xmlns:a16="http://schemas.microsoft.com/office/drawing/2014/main" id="{56E7EB7C-21D3-4873-A7BC-1C702A37C3F8}"/>
+                <a16:creationId xmlns:a16="http://schemas.microsoft.com/office/drawing/2014/main" id="{4B168846-1339-4E68-B5F9-69407056D1AC}"/>
               </a:ext>
             </a:extLst>
           </p:cNvPr>
@@ -5795,7 +5795,7 @@
           <p:cNvPr id="39" name="">
             <a:extLst xmlns:a="http://schemas.openxmlformats.org/drawingml/2006/main">
               <a:ext uri="{FF2B5EF4-FFF2-40B4-BE49-F238E27FC236}">
-                <a16:creationId xmlns:a16="http://schemas.microsoft.com/office/drawing/2014/main" id="{5C7360C2-9524-4FC6-9693-A783284E1A4A}"/>
+                <a16:creationId xmlns:a16="http://schemas.microsoft.com/office/drawing/2014/main" id="{899ACCD5-002F-43DD-98F6-23C224B05534}"/>
               </a:ext>
             </a:extLst>
           </p:cNvPr>
@@ -5852,7 +5852,7 @@
           <p:cNvPr id="40" name="">
             <a:extLst xmlns:a="http://schemas.openxmlformats.org/drawingml/2006/main">
               <a:ext uri="{FF2B5EF4-FFF2-40B4-BE49-F238E27FC236}">
-                <a16:creationId xmlns:a16="http://schemas.microsoft.com/office/drawing/2014/main" id="{7E76257E-2119-4FBE-A073-0BC3AAEC2697}"/>
+                <a16:creationId xmlns:a16="http://schemas.microsoft.com/office/drawing/2014/main" id="{0DD775EC-C59F-4D27-BAEC-4F00354F6C1D}"/>
               </a:ext>
             </a:extLst>
           </p:cNvPr>
@@ -5887,7 +5887,7 @@
           <p:cNvPr id="41" name="">
             <a:extLst xmlns:a="http://schemas.openxmlformats.org/drawingml/2006/main">
               <a:ext uri="{FF2B5EF4-FFF2-40B4-BE49-F238E27FC236}">
-                <a16:creationId xmlns:a16="http://schemas.microsoft.com/office/drawing/2014/main" id="{A844219B-DC8E-42C0-8696-8940C5D33870}"/>
+                <a16:creationId xmlns:a16="http://schemas.microsoft.com/office/drawing/2014/main" id="{D704BADF-A857-4A06-A26C-985BF5ADE377}"/>
               </a:ext>
             </a:extLst>
           </p:cNvPr>
@@ -5944,7 +5944,7 @@
           <p:cNvPr id="42" name="">
             <a:extLst xmlns:a="http://schemas.openxmlformats.org/drawingml/2006/main">
               <a:ext uri="{FF2B5EF4-FFF2-40B4-BE49-F238E27FC236}">
-                <a16:creationId xmlns:a16="http://schemas.microsoft.com/office/drawing/2014/main" id="{8EA7C99F-8421-4001-9C1D-43252693CD55}"/>
+                <a16:creationId xmlns:a16="http://schemas.microsoft.com/office/drawing/2014/main" id="{14DEF5A2-7656-41E6-BF54-54AE0EDAE4B0}"/>
               </a:ext>
             </a:extLst>
           </p:cNvPr>
@@ -6001,7 +6001,7 @@
           <p:cNvPr id="43" name="">
             <a:extLst xmlns:a="http://schemas.openxmlformats.org/drawingml/2006/main">
               <a:ext uri="{FF2B5EF4-FFF2-40B4-BE49-F238E27FC236}">
-                <a16:creationId xmlns:a16="http://schemas.microsoft.com/office/drawing/2014/main" id="{141E4FDF-A1BF-4F59-AE49-D3B52DCF0DD7}"/>
+                <a16:creationId xmlns:a16="http://schemas.microsoft.com/office/drawing/2014/main" id="{F03BCA15-7847-44E9-9471-2F6459CEB920}"/>
               </a:ext>
             </a:extLst>
           </p:cNvPr>
@@ -6058,7 +6058,7 @@
           <p:cNvPr id="44" name="">
             <a:extLst xmlns:a="http://schemas.openxmlformats.org/drawingml/2006/main">
               <a:ext uri="{FF2B5EF4-FFF2-40B4-BE49-F238E27FC236}">
-                <a16:creationId xmlns:a16="http://schemas.microsoft.com/office/drawing/2014/main" id="{BAB3B6F7-3E77-4B1A-B806-030D4B45EA9B}"/>
+                <a16:creationId xmlns:a16="http://schemas.microsoft.com/office/drawing/2014/main" id="{5984B83B-8701-4BD1-9565-38452AF219D4}"/>
               </a:ext>
             </a:extLst>
           </p:cNvPr>
@@ -6115,7 +6115,7 @@
           <p:cNvPr id="45" name="">
             <a:extLst xmlns:a="http://schemas.openxmlformats.org/drawingml/2006/main">
               <a:ext uri="{FF2B5EF4-FFF2-40B4-BE49-F238E27FC236}">
-                <a16:creationId xmlns:a16="http://schemas.microsoft.com/office/drawing/2014/main" id="{D84ABC0B-B7BA-4150-B743-6570662EDFAE}"/>
+                <a16:creationId xmlns:a16="http://schemas.microsoft.com/office/drawing/2014/main" id="{A346D776-68E1-4A3D-81C1-A918F6A4751A}"/>
               </a:ext>
             </a:extLst>
           </p:cNvPr>
@@ -6170,7 +6170,7 @@
     </p:spTree>
     <p:extLst>
       <p:ext uri="{BB962C8B-B14F-4D97-AF65-F5344CB8AC3E}">
-        <p14:creationId xmlns:p14="http://schemas.microsoft.com/office/powerpoint/2010/main" val="1535782144"/>
+        <p14:creationId xmlns:p14="http://schemas.microsoft.com/office/powerpoint/2010/main" val="14046063"/>
       </p:ext>
     </p:extLst>
   </p:cSld>
@@ -6201,7 +6201,7 @@
           <p:cNvPr id="32" name="">
             <a:extLst xmlns:a="http://schemas.openxmlformats.org/drawingml/2006/main">
               <a:ext uri="{FF2B5EF4-FFF2-40B4-BE49-F238E27FC236}">
-                <a16:creationId xmlns:a16="http://schemas.microsoft.com/office/drawing/2014/main" id="{2AD7A4FE-309A-40CF-A069-DB48B977F1DC}"/>
+                <a16:creationId xmlns:a16="http://schemas.microsoft.com/office/drawing/2014/main" id="{02B20103-BF75-4212-8D31-B600E082DA4A}"/>
               </a:ext>
             </a:extLst>
           </p:cNvPr>
@@ -6258,7 +6258,7 @@
           <p:cNvPr id="2" name="">
             <a:extLst xmlns:a="http://schemas.openxmlformats.org/drawingml/2006/main">
               <a:ext uri="{FF2B5EF4-FFF2-40B4-BE49-F238E27FC236}">
-                <a16:creationId xmlns:a16="http://schemas.microsoft.com/office/drawing/2014/main" id="{6819CDC8-D97E-4AF7-AABC-6D98B66DA702}"/>
+                <a16:creationId xmlns:a16="http://schemas.microsoft.com/office/drawing/2014/main" id="{17107F9E-17BC-4F18-B0F6-DFCF49BF1D30}"/>
               </a:ext>
             </a:extLst>
           </p:cNvPr>
@@ -6315,7 +6315,7 @@
           <p:cNvPr id="3" name="">
             <a:extLst xmlns:a="http://schemas.openxmlformats.org/drawingml/2006/main">
               <a:ext uri="{FF2B5EF4-FFF2-40B4-BE49-F238E27FC236}">
-                <a16:creationId xmlns:a16="http://schemas.microsoft.com/office/drawing/2014/main" id="{73730901-D11C-423D-9F5B-80392071EF63}"/>
+                <a16:creationId xmlns:a16="http://schemas.microsoft.com/office/drawing/2014/main" id="{E25A8C2B-1826-4766-82CD-3179179C33C6}"/>
               </a:ext>
             </a:extLst>
           </p:cNvPr>
@@ -6372,7 +6372,7 @@
           <p:cNvPr id="4" name="">
             <a:extLst xmlns:a="http://schemas.openxmlformats.org/drawingml/2006/main">
               <a:ext uri="{FF2B5EF4-FFF2-40B4-BE49-F238E27FC236}">
-                <a16:creationId xmlns:a16="http://schemas.microsoft.com/office/drawing/2014/main" id="{F97F6BAA-8CE3-40CE-9166-32EDEB36848E}"/>
+                <a16:creationId xmlns:a16="http://schemas.microsoft.com/office/drawing/2014/main" id="{D72E2632-C683-4B06-B302-C2F7670F1355}"/>
               </a:ext>
             </a:extLst>
           </p:cNvPr>
@@ -6403,7 +6403,7 @@
           <p:cNvPr id="5" name="">
             <a:extLst xmlns:a="http://schemas.openxmlformats.org/drawingml/2006/main">
               <a:ext uri="{FF2B5EF4-FFF2-40B4-BE49-F238E27FC236}">
-                <a16:creationId xmlns:a16="http://schemas.microsoft.com/office/drawing/2014/main" id="{177C0B64-2853-4D05-9F35-4E21D2B1F62B}"/>
+                <a16:creationId xmlns:a16="http://schemas.microsoft.com/office/drawing/2014/main" id="{94DC86BC-15B3-48FC-81C2-62E579DAAB4E}"/>
               </a:ext>
             </a:extLst>
           </p:cNvPr>
@@ -6438,7 +6438,7 @@
           <p:cNvPr id="6" name="">
             <a:extLst xmlns:a="http://schemas.openxmlformats.org/drawingml/2006/main">
               <a:ext uri="{FF2B5EF4-FFF2-40B4-BE49-F238E27FC236}">
-                <a16:creationId xmlns:a16="http://schemas.microsoft.com/office/drawing/2014/main" id="{88795651-7027-4F93-BFA3-65FE576B3BB7}"/>
+                <a16:creationId xmlns:a16="http://schemas.microsoft.com/office/drawing/2014/main" id="{8355226A-18A4-479E-B03E-4AF88FD35ECC}"/>
               </a:ext>
             </a:extLst>
           </p:cNvPr>
@@ -6502,7 +6502,7 @@
           <p:cNvPr id="7" name="">
             <a:extLst xmlns:a="http://schemas.openxmlformats.org/drawingml/2006/main">
               <a:ext uri="{FF2B5EF4-FFF2-40B4-BE49-F238E27FC236}">
-                <a16:creationId xmlns:a16="http://schemas.microsoft.com/office/drawing/2014/main" id="{1E60FACF-BFE2-424D-A3AA-A71EE8A56196}"/>
+                <a16:creationId xmlns:a16="http://schemas.microsoft.com/office/drawing/2014/main" id="{7CFB0FD9-BF37-4B36-8092-B5DEB8912914}"/>
               </a:ext>
             </a:extLst>
           </p:cNvPr>
@@ -6559,7 +6559,7 @@
           <p:cNvPr id="8" name="">
             <a:extLst xmlns:a="http://schemas.openxmlformats.org/drawingml/2006/main">
               <a:ext uri="{FF2B5EF4-FFF2-40B4-BE49-F238E27FC236}">
-                <a16:creationId xmlns:a16="http://schemas.microsoft.com/office/drawing/2014/main" id="{9BDB8A9A-C999-4BF8-8903-3B44F3FB027F}"/>
+                <a16:creationId xmlns:a16="http://schemas.microsoft.com/office/drawing/2014/main" id="{2B7ECABD-2E1B-4F0B-BA42-2717D2FF3A95}"/>
               </a:ext>
             </a:extLst>
           </p:cNvPr>
@@ -6662,7 +6662,7 @@
           <p:cNvPr id="9" name="">
             <a:extLst xmlns:a="http://schemas.openxmlformats.org/drawingml/2006/main">
               <a:ext uri="{FF2B5EF4-FFF2-40B4-BE49-F238E27FC236}">
-                <a16:creationId xmlns:a16="http://schemas.microsoft.com/office/drawing/2014/main" id="{B78B11EE-78FA-4ED1-824F-86D3B5912242}"/>
+                <a16:creationId xmlns:a16="http://schemas.microsoft.com/office/drawing/2014/main" id="{A8E1F485-8DEA-42F0-ABE4-A97A28CE82E9}"/>
               </a:ext>
             </a:extLst>
           </p:cNvPr>
@@ -6697,7 +6697,7 @@
           <p:cNvPr id="10" name="">
             <a:extLst xmlns:a="http://schemas.openxmlformats.org/drawingml/2006/main">
               <a:ext uri="{FF2B5EF4-FFF2-40B4-BE49-F238E27FC236}">
-                <a16:creationId xmlns:a16="http://schemas.microsoft.com/office/drawing/2014/main" id="{0654EEEA-8F5A-4121-BF5F-DEB2A0CF08F2}"/>
+                <a16:creationId xmlns:a16="http://schemas.microsoft.com/office/drawing/2014/main" id="{8F9625D2-9C82-4DB7-9216-A242297E0EDE}"/>
               </a:ext>
             </a:extLst>
           </p:cNvPr>
@@ -6761,7 +6761,7 @@
           <p:cNvPr id="11" name="">
             <a:extLst xmlns:a="http://schemas.openxmlformats.org/drawingml/2006/main">
               <a:ext uri="{FF2B5EF4-FFF2-40B4-BE49-F238E27FC236}">
-                <a16:creationId xmlns:a16="http://schemas.microsoft.com/office/drawing/2014/main" id="{B701C4DF-18E6-417B-8014-1703567C0078}"/>
+                <a16:creationId xmlns:a16="http://schemas.microsoft.com/office/drawing/2014/main" id="{B5D0135D-488B-418D-BBE8-E05AA7A96E2C}"/>
               </a:ext>
             </a:extLst>
           </p:cNvPr>
@@ -6818,7 +6818,7 @@
           <p:cNvPr id="12" name="">
             <a:extLst xmlns:a="http://schemas.openxmlformats.org/drawingml/2006/main">
               <a:ext uri="{FF2B5EF4-FFF2-40B4-BE49-F238E27FC236}">
-                <a16:creationId xmlns:a16="http://schemas.microsoft.com/office/drawing/2014/main" id="{EB5C0D9B-751B-4AD3-9842-C94211DE3304}"/>
+                <a16:creationId xmlns:a16="http://schemas.microsoft.com/office/drawing/2014/main" id="{F3074DA7-5473-455E-B6F8-0AB9A3397E31}"/>
               </a:ext>
             </a:extLst>
           </p:cNvPr>
@@ -6921,7 +6921,7 @@
           <p:cNvPr id="13" name="">
             <a:extLst xmlns:a="http://schemas.openxmlformats.org/drawingml/2006/main">
               <a:ext uri="{FF2B5EF4-FFF2-40B4-BE49-F238E27FC236}">
-                <a16:creationId xmlns:a16="http://schemas.microsoft.com/office/drawing/2014/main" id="{07445294-B96F-40CF-B81B-ECA324381B0F}"/>
+                <a16:creationId xmlns:a16="http://schemas.microsoft.com/office/drawing/2014/main" id="{8B946FFC-C1CE-4AB1-890D-E21372C44B72}"/>
               </a:ext>
             </a:extLst>
           </p:cNvPr>
@@ -6978,7 +6978,7 @@
           <p:cNvPr id="14" name="">
             <a:extLst xmlns:a="http://schemas.openxmlformats.org/drawingml/2006/main">
               <a:ext uri="{FF2B5EF4-FFF2-40B4-BE49-F238E27FC236}">
-                <a16:creationId xmlns:a16="http://schemas.microsoft.com/office/drawing/2014/main" id="{34E8F69A-A8AD-4FD5-8B36-4A4E34F2EA2F}"/>
+                <a16:creationId xmlns:a16="http://schemas.microsoft.com/office/drawing/2014/main" id="{9CC72FD0-989C-433D-9CEF-792BC34F8AFB}"/>
               </a:ext>
             </a:extLst>
           </p:cNvPr>
@@ -7013,7 +7013,7 @@
           <p:cNvPr id="15" name="">
             <a:extLst xmlns:a="http://schemas.openxmlformats.org/drawingml/2006/main">
               <a:ext uri="{FF2B5EF4-FFF2-40B4-BE49-F238E27FC236}">
-                <a16:creationId xmlns:a16="http://schemas.microsoft.com/office/drawing/2014/main" id="{90CCE7F1-DF8F-4F4E-8BF3-D1121F53013B}"/>
+                <a16:creationId xmlns:a16="http://schemas.microsoft.com/office/drawing/2014/main" id="{31183644-02D1-4A68-97CD-C04305689435}"/>
               </a:ext>
             </a:extLst>
           </p:cNvPr>
@@ -7070,7 +7070,7 @@
           <p:cNvPr id="16" name="">
             <a:extLst xmlns:a="http://schemas.openxmlformats.org/drawingml/2006/main">
               <a:ext uri="{FF2B5EF4-FFF2-40B4-BE49-F238E27FC236}">
-                <a16:creationId xmlns:a16="http://schemas.microsoft.com/office/drawing/2014/main" id="{F2E52BCA-E69A-47BA-912E-793E5597E6FA}"/>
+                <a16:creationId xmlns:a16="http://schemas.microsoft.com/office/drawing/2014/main" id="{C8CF8808-38F2-4443-97C1-0F3409A6DCF1}"/>
               </a:ext>
             </a:extLst>
           </p:cNvPr>
@@ -7127,7 +7127,7 @@
           <p:cNvPr id="17" name="">
             <a:extLst xmlns:a="http://schemas.openxmlformats.org/drawingml/2006/main">
               <a:ext uri="{FF2B5EF4-FFF2-40B4-BE49-F238E27FC236}">
-                <a16:creationId xmlns:a16="http://schemas.microsoft.com/office/drawing/2014/main" id="{EDDED24C-6C2F-4CE0-82B1-F82FD4393ED0}"/>
+                <a16:creationId xmlns:a16="http://schemas.microsoft.com/office/drawing/2014/main" id="{0761174A-4109-4D8E-84B2-F40C334C0491}"/>
               </a:ext>
             </a:extLst>
           </p:cNvPr>
@@ -7162,7 +7162,7 @@
           <p:cNvPr id="18" name="">
             <a:extLst xmlns:a="http://schemas.openxmlformats.org/drawingml/2006/main">
               <a:ext uri="{FF2B5EF4-FFF2-40B4-BE49-F238E27FC236}">
-                <a16:creationId xmlns:a16="http://schemas.microsoft.com/office/drawing/2014/main" id="{CBFE9959-741B-4E89-BB47-B481A9B38918}"/>
+                <a16:creationId xmlns:a16="http://schemas.microsoft.com/office/drawing/2014/main" id="{99CCE02D-431F-4A6C-B1CC-6AFE41750883}"/>
               </a:ext>
             </a:extLst>
           </p:cNvPr>
@@ -7209,7 +7209,7 @@
                 <a:ea typeface="Arial"/>
                 <a:cs typeface="Arial"/>
               </a:rPr>
-              <a:t>15/15</a:t>
+              <a:t>25/25</a:t>
             </a:r>
           </a:p>
         </p:txBody>
@@ -7219,7 +7219,7 @@
           <p:cNvPr id="19" name="">
             <a:extLst xmlns:a="http://schemas.openxmlformats.org/drawingml/2006/main">
               <a:ext uri="{FF2B5EF4-FFF2-40B4-BE49-F238E27FC236}">
-                <a16:creationId xmlns:a16="http://schemas.microsoft.com/office/drawing/2014/main" id="{F1D534A9-5784-4DA1-86A7-64452DDD47FF}"/>
+                <a16:creationId xmlns:a16="http://schemas.microsoft.com/office/drawing/2014/main" id="{543A5F7D-F769-43B4-A3A7-1284519C01CD}"/>
               </a:ext>
             </a:extLst>
           </p:cNvPr>
@@ -7266,7 +7266,7 @@
                 <a:ea typeface="Arial"/>
                 <a:cs typeface="Arial"/>
               </a:rPr>
-              <a:t>3 batch Ollama</a:t>
+              <a:t>5 batch Ollama</a:t>
             </a:r>
           </a:p>
         </p:txBody>
@@ -7276,7 +7276,7 @@
           <p:cNvPr id="20" name="">
             <a:extLst xmlns:a="http://schemas.openxmlformats.org/drawingml/2006/main">
               <a:ext uri="{FF2B5EF4-FFF2-40B4-BE49-F238E27FC236}">
-                <a16:creationId xmlns:a16="http://schemas.microsoft.com/office/drawing/2014/main" id="{125F8995-BE60-4836-BDA1-B12B4D7622CD}"/>
+                <a16:creationId xmlns:a16="http://schemas.microsoft.com/office/drawing/2014/main" id="{84C9A89F-877F-47A9-9410-AEF7F0927855}"/>
               </a:ext>
             </a:extLst>
           </p:cNvPr>
@@ -7311,7 +7311,7 @@
           <p:cNvPr id="21" name="">
             <a:extLst xmlns:a="http://schemas.openxmlformats.org/drawingml/2006/main">
               <a:ext uri="{FF2B5EF4-FFF2-40B4-BE49-F238E27FC236}">
-                <a16:creationId xmlns:a16="http://schemas.microsoft.com/office/drawing/2014/main" id="{DD39DC26-7987-4370-8F25-60C05A625127}"/>
+                <a16:creationId xmlns:a16="http://schemas.microsoft.com/office/drawing/2014/main" id="{6202FE67-2BA9-403C-BA6C-FF6633C21998}"/>
               </a:ext>
             </a:extLst>
           </p:cNvPr>
@@ -7368,7 +7368,7 @@
           <p:cNvPr id="22" name="">
             <a:extLst xmlns:a="http://schemas.openxmlformats.org/drawingml/2006/main">
               <a:ext uri="{FF2B5EF4-FFF2-40B4-BE49-F238E27FC236}">
-                <a16:creationId xmlns:a16="http://schemas.microsoft.com/office/drawing/2014/main" id="{042A37F4-B83D-4D4F-B0F0-D75526B5C28B}"/>
+                <a16:creationId xmlns:a16="http://schemas.microsoft.com/office/drawing/2014/main" id="{760EE61B-9BD4-4D3A-8975-78F9FB2F6F28}"/>
               </a:ext>
             </a:extLst>
           </p:cNvPr>
@@ -7425,7 +7425,7 @@
           <p:cNvPr id="23" name="">
             <a:extLst xmlns:a="http://schemas.openxmlformats.org/drawingml/2006/main">
               <a:ext uri="{FF2B5EF4-FFF2-40B4-BE49-F238E27FC236}">
-                <a16:creationId xmlns:a16="http://schemas.microsoft.com/office/drawing/2014/main" id="{A63B6292-50C3-4B5F-A552-3D0C01A1AFC0}"/>
+                <a16:creationId xmlns:a16="http://schemas.microsoft.com/office/drawing/2014/main" id="{ED9D1E60-3C74-429F-AAE1-3EE23505A03D}"/>
               </a:ext>
             </a:extLst>
           </p:cNvPr>
@@ -7460,7 +7460,7 @@
           <p:cNvPr id="24" name="">
             <a:extLst xmlns:a="http://schemas.openxmlformats.org/drawingml/2006/main">
               <a:ext uri="{FF2B5EF4-FFF2-40B4-BE49-F238E27FC236}">
-                <a16:creationId xmlns:a16="http://schemas.microsoft.com/office/drawing/2014/main" id="{BD320F17-3C87-4D09-884E-408D992D21A5}"/>
+                <a16:creationId xmlns:a16="http://schemas.microsoft.com/office/drawing/2014/main" id="{F84B0A42-D1A4-4629-A02D-512100CF8466}"/>
               </a:ext>
             </a:extLst>
           </p:cNvPr>
@@ -7517,7 +7517,7 @@
           <p:cNvPr id="25" name="">
             <a:extLst xmlns:a="http://schemas.openxmlformats.org/drawingml/2006/main">
               <a:ext uri="{FF2B5EF4-FFF2-40B4-BE49-F238E27FC236}">
-                <a16:creationId xmlns:a16="http://schemas.microsoft.com/office/drawing/2014/main" id="{9A4320E5-BF4E-4BBD-8A09-EECD69525266}"/>
+                <a16:creationId xmlns:a16="http://schemas.microsoft.com/office/drawing/2014/main" id="{F7FFBD06-7521-4902-BA19-F2FD0D83086B}"/>
               </a:ext>
             </a:extLst>
           </p:cNvPr>
@@ -7581,7 +7581,7 @@
           <p:cNvPr id="26" name="">
             <a:extLst xmlns:a="http://schemas.openxmlformats.org/drawingml/2006/main">
               <a:ext uri="{FF2B5EF4-FFF2-40B4-BE49-F238E27FC236}">
-                <a16:creationId xmlns:a16="http://schemas.microsoft.com/office/drawing/2014/main" id="{F7088B7B-EB3C-49AB-A1CB-E2CB29BE9C9A}"/>
+                <a16:creationId xmlns:a16="http://schemas.microsoft.com/office/drawing/2014/main" id="{22F4A38A-EF93-45D9-AB53-916E5EA8A119}"/>
               </a:ext>
             </a:extLst>
           </p:cNvPr>
@@ -7645,7 +7645,7 @@
           <p:cNvPr id="27" name="">
             <a:extLst xmlns:a="http://schemas.openxmlformats.org/drawingml/2006/main">
               <a:ext uri="{FF2B5EF4-FFF2-40B4-BE49-F238E27FC236}">
-                <a16:creationId xmlns:a16="http://schemas.microsoft.com/office/drawing/2014/main" id="{E74EDD8B-528E-4FFF-BCE7-8E2871155CE4}"/>
+                <a16:creationId xmlns:a16="http://schemas.microsoft.com/office/drawing/2014/main" id="{DA0DA986-F1D2-4C71-984C-A4A3688417B5}"/>
               </a:ext>
             </a:extLst>
           </p:cNvPr>
@@ -7709,7 +7709,7 @@
           <p:cNvPr id="28" name="">
             <a:extLst xmlns:a="http://schemas.openxmlformats.org/drawingml/2006/main">
               <a:ext uri="{FF2B5EF4-FFF2-40B4-BE49-F238E27FC236}">
-                <a16:creationId xmlns:a16="http://schemas.microsoft.com/office/drawing/2014/main" id="{DE45CA5B-9555-44A5-85F5-0C1EFE5B304C}"/>
+                <a16:creationId xmlns:a16="http://schemas.microsoft.com/office/drawing/2014/main" id="{F6632851-0F1C-4D10-97EE-AF6448D0EA5E}"/>
               </a:ext>
             </a:extLst>
           </p:cNvPr>
@@ -7773,7 +7773,7 @@
           <p:cNvPr id="29" name="">
             <a:extLst xmlns:a="http://schemas.openxmlformats.org/drawingml/2006/main">
               <a:ext uri="{FF2B5EF4-FFF2-40B4-BE49-F238E27FC236}">
-                <a16:creationId xmlns:a16="http://schemas.microsoft.com/office/drawing/2014/main" id="{D0FEB4FE-682D-4150-A1C5-77349FCE2640}"/>
+                <a16:creationId xmlns:a16="http://schemas.microsoft.com/office/drawing/2014/main" id="{DC7FCF29-64B1-4204-B6FB-56A2C6FB7621}"/>
               </a:ext>
             </a:extLst>
           </p:cNvPr>
@@ -7830,7 +7830,7 @@
           <p:cNvPr id="30" name="">
             <a:extLst xmlns:a="http://schemas.openxmlformats.org/drawingml/2006/main">
               <a:ext uri="{FF2B5EF4-FFF2-40B4-BE49-F238E27FC236}">
-                <a16:creationId xmlns:a16="http://schemas.microsoft.com/office/drawing/2014/main" id="{FB58A309-E418-4365-9BD4-F0FB33D44C07}"/>
+                <a16:creationId xmlns:a16="http://schemas.microsoft.com/office/drawing/2014/main" id="{A594575D-1F67-4199-98D6-FF29354A2677}"/>
               </a:ext>
             </a:extLst>
           </p:cNvPr>
@@ -7887,7 +7887,7 @@
           <p:cNvPr id="31" name="">
             <a:extLst xmlns:a="http://schemas.openxmlformats.org/drawingml/2006/main">
               <a:ext uri="{FF2B5EF4-FFF2-40B4-BE49-F238E27FC236}">
-                <a16:creationId xmlns:a16="http://schemas.microsoft.com/office/drawing/2014/main" id="{9C9EC89A-2648-4850-8834-E005994AD7C1}"/>
+                <a16:creationId xmlns:a16="http://schemas.microsoft.com/office/drawing/2014/main" id="{510B1184-EC26-4BE8-90FE-117A67BEEB08}"/>
               </a:ext>
             </a:extLst>
           </p:cNvPr>
@@ -7942,7 +7942,7 @@
     </p:spTree>
     <p:extLst>
       <p:ext uri="{BB962C8B-B14F-4D97-AF65-F5344CB8AC3E}">
-        <p14:creationId xmlns:p14="http://schemas.microsoft.com/office/powerpoint/2010/main" val="980071519"/>
+        <p14:creationId xmlns:p14="http://schemas.microsoft.com/office/powerpoint/2010/main" val="770262610"/>
       </p:ext>
     </p:extLst>
   </p:cSld>
@@ -7973,7 +7973,7 @@
           <p:cNvPr id="32" name="">
             <a:extLst xmlns:a="http://schemas.openxmlformats.org/drawingml/2006/main">
               <a:ext uri="{FF2B5EF4-FFF2-40B4-BE49-F238E27FC236}">
-                <a16:creationId xmlns:a16="http://schemas.microsoft.com/office/drawing/2014/main" id="{38D79211-2651-4EC6-B4E8-C1081D68795A}"/>
+                <a16:creationId xmlns:a16="http://schemas.microsoft.com/office/drawing/2014/main" id="{5B340970-7A24-4A98-A4A7-8DBFD5E16795}"/>
               </a:ext>
             </a:extLst>
           </p:cNvPr>
@@ -8030,7 +8030,7 @@
           <p:cNvPr id="2" name="">
             <a:extLst xmlns:a="http://schemas.openxmlformats.org/drawingml/2006/main">
               <a:ext uri="{FF2B5EF4-FFF2-40B4-BE49-F238E27FC236}">
-                <a16:creationId xmlns:a16="http://schemas.microsoft.com/office/drawing/2014/main" id="{2889F82E-BBB9-45ED-A268-D3D6FBD0CC7D}"/>
+                <a16:creationId xmlns:a16="http://schemas.microsoft.com/office/drawing/2014/main" id="{9D3A1660-F0C4-4B0D-97B6-DCC795CC9C44}"/>
               </a:ext>
             </a:extLst>
           </p:cNvPr>
@@ -8087,7 +8087,7 @@
           <p:cNvPr id="3" name="">
             <a:extLst xmlns:a="http://schemas.openxmlformats.org/drawingml/2006/main">
               <a:ext uri="{FF2B5EF4-FFF2-40B4-BE49-F238E27FC236}">
-                <a16:creationId xmlns:a16="http://schemas.microsoft.com/office/drawing/2014/main" id="{7B167745-E7B5-4CE8-8A18-F445420467E3}"/>
+                <a16:creationId xmlns:a16="http://schemas.microsoft.com/office/drawing/2014/main" id="{911B0C07-3014-42E6-8FF3-A4D74ACF9A14}"/>
               </a:ext>
             </a:extLst>
           </p:cNvPr>
@@ -8144,7 +8144,7 @@
           <p:cNvPr id="4" name="">
             <a:extLst xmlns:a="http://schemas.openxmlformats.org/drawingml/2006/main">
               <a:ext uri="{FF2B5EF4-FFF2-40B4-BE49-F238E27FC236}">
-                <a16:creationId xmlns:a16="http://schemas.microsoft.com/office/drawing/2014/main" id="{2B3E5CED-1BFF-420F-A11A-C60DB00085F4}"/>
+                <a16:creationId xmlns:a16="http://schemas.microsoft.com/office/drawing/2014/main" id="{551D5184-F4E9-46CF-B612-A527A60605BC}"/>
               </a:ext>
             </a:extLst>
           </p:cNvPr>
@@ -8175,7 +8175,7 @@
           <p:cNvPr id="5" name="">
             <a:extLst xmlns:a="http://schemas.openxmlformats.org/drawingml/2006/main">
               <a:ext uri="{FF2B5EF4-FFF2-40B4-BE49-F238E27FC236}">
-                <a16:creationId xmlns:a16="http://schemas.microsoft.com/office/drawing/2014/main" id="{B5CFFA01-4877-4386-A0D3-8182FF5088E9}"/>
+                <a16:creationId xmlns:a16="http://schemas.microsoft.com/office/drawing/2014/main" id="{C59DCDDE-EFE0-4A3D-BFED-2510D424C5B2}"/>
               </a:ext>
             </a:extLst>
           </p:cNvPr>
@@ -8210,7 +8210,7 @@
           <p:cNvPr id="6" name="">
             <a:extLst xmlns:a="http://schemas.openxmlformats.org/drawingml/2006/main">
               <a:ext uri="{FF2B5EF4-FFF2-40B4-BE49-F238E27FC236}">
-                <a16:creationId xmlns:a16="http://schemas.microsoft.com/office/drawing/2014/main" id="{541265C9-ACCE-4DEE-B2DF-7807AEE3F0C8}"/>
+                <a16:creationId xmlns:a16="http://schemas.microsoft.com/office/drawing/2014/main" id="{C049B5B7-4943-4D61-B4EC-588324C81CDF}"/>
               </a:ext>
             </a:extLst>
           </p:cNvPr>
@@ -8274,7 +8274,7 @@
           <p:cNvPr id="7" name="">
             <a:extLst xmlns:a="http://schemas.openxmlformats.org/drawingml/2006/main">
               <a:ext uri="{FF2B5EF4-FFF2-40B4-BE49-F238E27FC236}">
-                <a16:creationId xmlns:a16="http://schemas.microsoft.com/office/drawing/2014/main" id="{AD1875ED-FAC1-4985-A712-8DC9B634824A}"/>
+                <a16:creationId xmlns:a16="http://schemas.microsoft.com/office/drawing/2014/main" id="{EB267D78-7C88-4167-86FB-8F6E372A3A1B}"/>
               </a:ext>
             </a:extLst>
           </p:cNvPr>
@@ -8331,7 +8331,7 @@
           <p:cNvPr id="8" name="">
             <a:extLst xmlns:a="http://schemas.openxmlformats.org/drawingml/2006/main">
               <a:ext uri="{FF2B5EF4-FFF2-40B4-BE49-F238E27FC236}">
-                <a16:creationId xmlns:a16="http://schemas.microsoft.com/office/drawing/2014/main" id="{C68223BC-CD2E-4A52-A485-F9079919235D}"/>
+                <a16:creationId xmlns:a16="http://schemas.microsoft.com/office/drawing/2014/main" id="{60C06941-A5CC-4FC0-82A0-D10696F8272C}"/>
               </a:ext>
             </a:extLst>
           </p:cNvPr>
@@ -8362,7 +8362,7 @@
           <p:cNvPr id="9" name="">
             <a:extLst xmlns:a="http://schemas.openxmlformats.org/drawingml/2006/main">
               <a:ext uri="{FF2B5EF4-FFF2-40B4-BE49-F238E27FC236}">
-                <a16:creationId xmlns:a16="http://schemas.microsoft.com/office/drawing/2014/main" id="{174F5118-ACDF-4B81-AABF-FADB88F523A6}"/>
+                <a16:creationId xmlns:a16="http://schemas.microsoft.com/office/drawing/2014/main" id="{39286934-4012-44B2-8228-11F0CFB5D415}"/>
               </a:ext>
             </a:extLst>
           </p:cNvPr>
@@ -8397,7 +8397,7 @@
           <p:cNvPr id="10" name="">
             <a:extLst xmlns:a="http://schemas.openxmlformats.org/drawingml/2006/main">
               <a:ext uri="{FF2B5EF4-FFF2-40B4-BE49-F238E27FC236}">
-                <a16:creationId xmlns:a16="http://schemas.microsoft.com/office/drawing/2014/main" id="{AE53392C-C249-48EF-8F14-B0C2D9A6D095}"/>
+                <a16:creationId xmlns:a16="http://schemas.microsoft.com/office/drawing/2014/main" id="{49161385-B2C7-45CD-A1AF-B199C45281E2}"/>
               </a:ext>
             </a:extLst>
           </p:cNvPr>
@@ -8461,7 +8461,7 @@
           <p:cNvPr id="11" name="">
             <a:extLst xmlns:a="http://schemas.openxmlformats.org/drawingml/2006/main">
               <a:ext uri="{FF2B5EF4-FFF2-40B4-BE49-F238E27FC236}">
-                <a16:creationId xmlns:a16="http://schemas.microsoft.com/office/drawing/2014/main" id="{07BA0F69-E727-4653-AF51-B84EC60F9460}"/>
+                <a16:creationId xmlns:a16="http://schemas.microsoft.com/office/drawing/2014/main" id="{90EB1B26-B677-4BEA-B826-8942F391FE14}"/>
               </a:ext>
             </a:extLst>
           </p:cNvPr>
@@ -8518,7 +8518,7 @@
           <p:cNvPr id="12" name="">
             <a:extLst xmlns:a="http://schemas.openxmlformats.org/drawingml/2006/main">
               <a:ext uri="{FF2B5EF4-FFF2-40B4-BE49-F238E27FC236}">
-                <a16:creationId xmlns:a16="http://schemas.microsoft.com/office/drawing/2014/main" id="{AA0C7B5E-65AB-4D13-BE2C-182340566177}"/>
+                <a16:creationId xmlns:a16="http://schemas.microsoft.com/office/drawing/2014/main" id="{FA1D0147-1F6F-4CBC-9F8A-BAA9FBC7780E}"/>
               </a:ext>
             </a:extLst>
           </p:cNvPr>
@@ -8549,7 +8549,7 @@
           <p:cNvPr id="13" name="">
             <a:extLst xmlns:a="http://schemas.openxmlformats.org/drawingml/2006/main">
               <a:ext uri="{FF2B5EF4-FFF2-40B4-BE49-F238E27FC236}">
-                <a16:creationId xmlns:a16="http://schemas.microsoft.com/office/drawing/2014/main" id="{34D08274-6A1A-445F-8810-76BA933AC8B3}"/>
+                <a16:creationId xmlns:a16="http://schemas.microsoft.com/office/drawing/2014/main" id="{3D70BBF3-9F15-4568-B0F8-B90B52838444}"/>
               </a:ext>
             </a:extLst>
           </p:cNvPr>
@@ -8584,7 +8584,7 @@
           <p:cNvPr id="14" name="">
             <a:extLst xmlns:a="http://schemas.openxmlformats.org/drawingml/2006/main">
               <a:ext uri="{FF2B5EF4-FFF2-40B4-BE49-F238E27FC236}">
-                <a16:creationId xmlns:a16="http://schemas.microsoft.com/office/drawing/2014/main" id="{2B92940C-29DF-4E6E-BED8-3DE46C019140}"/>
+                <a16:creationId xmlns:a16="http://schemas.microsoft.com/office/drawing/2014/main" id="{25EA2A5F-6A7C-4F4C-97C6-51031759BAE0}"/>
               </a:ext>
             </a:extLst>
           </p:cNvPr>
@@ -8648,7 +8648,7 @@
           <p:cNvPr id="15" name="">
             <a:extLst xmlns:a="http://schemas.openxmlformats.org/drawingml/2006/main">
               <a:ext uri="{FF2B5EF4-FFF2-40B4-BE49-F238E27FC236}">
-                <a16:creationId xmlns:a16="http://schemas.microsoft.com/office/drawing/2014/main" id="{9F77F630-7A27-47AC-A29B-03E6E43E79FD}"/>
+                <a16:creationId xmlns:a16="http://schemas.microsoft.com/office/drawing/2014/main" id="{38DA81CD-5AF6-4CD9-B546-393DC90C1145}"/>
               </a:ext>
             </a:extLst>
           </p:cNvPr>
@@ -8705,7 +8705,7 @@
           <p:cNvPr id="16" name="">
             <a:extLst xmlns:a="http://schemas.openxmlformats.org/drawingml/2006/main">
               <a:ext uri="{FF2B5EF4-FFF2-40B4-BE49-F238E27FC236}">
-                <a16:creationId xmlns:a16="http://schemas.microsoft.com/office/drawing/2014/main" id="{E808892F-0B09-411C-A17B-112A3ABBC60F}"/>
+                <a16:creationId xmlns:a16="http://schemas.microsoft.com/office/drawing/2014/main" id="{7E9C5076-807E-45E7-AA9C-4397FF7DC2BB}"/>
               </a:ext>
             </a:extLst>
           </p:cNvPr>
@@ -8736,7 +8736,7 @@
           <p:cNvPr id="17" name="">
             <a:extLst xmlns:a="http://schemas.openxmlformats.org/drawingml/2006/main">
               <a:ext uri="{FF2B5EF4-FFF2-40B4-BE49-F238E27FC236}">
-                <a16:creationId xmlns:a16="http://schemas.microsoft.com/office/drawing/2014/main" id="{5E482A05-BD4D-488C-B336-2E94A8ABF40B}"/>
+                <a16:creationId xmlns:a16="http://schemas.microsoft.com/office/drawing/2014/main" id="{78A5F205-97A8-4ADA-A06D-85322C2C4C7C}"/>
               </a:ext>
             </a:extLst>
           </p:cNvPr>
@@ -8771,7 +8771,7 @@
           <p:cNvPr id="18" name="">
             <a:extLst xmlns:a="http://schemas.openxmlformats.org/drawingml/2006/main">
               <a:ext uri="{FF2B5EF4-FFF2-40B4-BE49-F238E27FC236}">
-                <a16:creationId xmlns:a16="http://schemas.microsoft.com/office/drawing/2014/main" id="{9F135116-EB7B-4058-B7DB-65DBDA7CBE34}"/>
+                <a16:creationId xmlns:a16="http://schemas.microsoft.com/office/drawing/2014/main" id="{4FD87AB8-FB4B-4150-A3CE-D307CEDABC46}"/>
               </a:ext>
             </a:extLst>
           </p:cNvPr>
@@ -8835,7 +8835,7 @@
           <p:cNvPr id="19" name="">
             <a:extLst xmlns:a="http://schemas.openxmlformats.org/drawingml/2006/main">
               <a:ext uri="{FF2B5EF4-FFF2-40B4-BE49-F238E27FC236}">
-                <a16:creationId xmlns:a16="http://schemas.microsoft.com/office/drawing/2014/main" id="{0B09530A-DD4D-4BD1-86BA-AD11DFC5DEFE}"/>
+                <a16:creationId xmlns:a16="http://schemas.microsoft.com/office/drawing/2014/main" id="{242AD7FE-A3C0-4F3A-98C4-09135A254AC1}"/>
               </a:ext>
             </a:extLst>
           </p:cNvPr>
@@ -8892,7 +8892,7 @@
           <p:cNvPr id="20" name="">
             <a:extLst xmlns:a="http://schemas.openxmlformats.org/drawingml/2006/main">
               <a:ext uri="{FF2B5EF4-FFF2-40B4-BE49-F238E27FC236}">
-                <a16:creationId xmlns:a16="http://schemas.microsoft.com/office/drawing/2014/main" id="{84E6715A-4EE4-4334-8F4B-59FE1BB3CD59}"/>
+                <a16:creationId xmlns:a16="http://schemas.microsoft.com/office/drawing/2014/main" id="{C5B3005C-09FA-4BE6-8FD8-9CAAF9D903A0}"/>
               </a:ext>
             </a:extLst>
           </p:cNvPr>
@@ -8927,7 +8927,7 @@
           <p:cNvPr id="21" name="">
             <a:extLst xmlns:a="http://schemas.openxmlformats.org/drawingml/2006/main">
               <a:ext uri="{FF2B5EF4-FFF2-40B4-BE49-F238E27FC236}">
-                <a16:creationId xmlns:a16="http://schemas.microsoft.com/office/drawing/2014/main" id="{2D331702-7F8C-44A5-B595-8A553F8D9962}"/>
+                <a16:creationId xmlns:a16="http://schemas.microsoft.com/office/drawing/2014/main" id="{81FC778F-DA6A-4B74-8531-9944B68358E6}"/>
               </a:ext>
             </a:extLst>
           </p:cNvPr>
@@ -8984,7 +8984,7 @@
           <p:cNvPr id="22" name="">
             <a:extLst xmlns:a="http://schemas.openxmlformats.org/drawingml/2006/main">
               <a:ext uri="{FF2B5EF4-FFF2-40B4-BE49-F238E27FC236}">
-                <a16:creationId xmlns:a16="http://schemas.microsoft.com/office/drawing/2014/main" id="{EA32488F-A370-4A47-B864-CE5A17F9F6CD}"/>
+                <a16:creationId xmlns:a16="http://schemas.microsoft.com/office/drawing/2014/main" id="{8781FFC0-ACD6-4CD4-BFFB-02EE9E5FC42F}"/>
               </a:ext>
             </a:extLst>
           </p:cNvPr>
@@ -9041,7 +9041,7 @@
           <p:cNvPr id="23" name="">
             <a:extLst xmlns:a="http://schemas.openxmlformats.org/drawingml/2006/main">
               <a:ext uri="{FF2B5EF4-FFF2-40B4-BE49-F238E27FC236}">
-                <a16:creationId xmlns:a16="http://schemas.microsoft.com/office/drawing/2014/main" id="{0610D4FE-8245-424F-A601-F17CC8CA0D99}"/>
+                <a16:creationId xmlns:a16="http://schemas.microsoft.com/office/drawing/2014/main" id="{0F419EE2-0F80-461F-8D21-874238285321}"/>
               </a:ext>
             </a:extLst>
           </p:cNvPr>
@@ -9076,7 +9076,7 @@
           <p:cNvPr id="24" name="">
             <a:extLst xmlns:a="http://schemas.openxmlformats.org/drawingml/2006/main">
               <a:ext uri="{FF2B5EF4-FFF2-40B4-BE49-F238E27FC236}">
-                <a16:creationId xmlns:a16="http://schemas.microsoft.com/office/drawing/2014/main" id="{984EE886-4BB0-4071-97B5-24984D5FBE62}"/>
+                <a16:creationId xmlns:a16="http://schemas.microsoft.com/office/drawing/2014/main" id="{70A95F56-A51C-425C-BD2C-F6339DA4A02B}"/>
               </a:ext>
             </a:extLst>
           </p:cNvPr>
@@ -9140,7 +9140,7 @@
           <p:cNvPr id="25" name="">
             <a:extLst xmlns:a="http://schemas.openxmlformats.org/drawingml/2006/main">
               <a:ext uri="{FF2B5EF4-FFF2-40B4-BE49-F238E27FC236}">
-                <a16:creationId xmlns:a16="http://schemas.microsoft.com/office/drawing/2014/main" id="{9EC74595-F82B-4705-8537-FAC3E5EE10AE}"/>
+                <a16:creationId xmlns:a16="http://schemas.microsoft.com/office/drawing/2014/main" id="{C98DB958-11F3-43BE-90D5-2ACB1B6A081F}"/>
               </a:ext>
             </a:extLst>
           </p:cNvPr>
@@ -9266,7 +9266,7 @@
           <p:cNvPr id="26" name="">
             <a:extLst xmlns:a="http://schemas.openxmlformats.org/drawingml/2006/main">
               <a:ext uri="{FF2B5EF4-FFF2-40B4-BE49-F238E27FC236}">
-                <a16:creationId xmlns:a16="http://schemas.microsoft.com/office/drawing/2014/main" id="{18BCD2D8-841E-4BEB-8B44-BD17A1BD888A}"/>
+                <a16:creationId xmlns:a16="http://schemas.microsoft.com/office/drawing/2014/main" id="{2A8D8AC5-2D4A-430A-BA30-AFD344E966EE}"/>
               </a:ext>
             </a:extLst>
           </p:cNvPr>
@@ -9301,7 +9301,7 @@
           <p:cNvPr id="27" name="">
             <a:extLst xmlns:a="http://schemas.openxmlformats.org/drawingml/2006/main">
               <a:ext uri="{FF2B5EF4-FFF2-40B4-BE49-F238E27FC236}">
-                <a16:creationId xmlns:a16="http://schemas.microsoft.com/office/drawing/2014/main" id="{E97A7B24-97F2-44DD-93CD-2DB4E1F88717}"/>
+                <a16:creationId xmlns:a16="http://schemas.microsoft.com/office/drawing/2014/main" id="{9139B6B6-AE3C-4D07-A063-9221CE6360E7}"/>
               </a:ext>
             </a:extLst>
           </p:cNvPr>
@@ -9365,7 +9365,7 @@
           <p:cNvPr id="28" name="">
             <a:extLst xmlns:a="http://schemas.openxmlformats.org/drawingml/2006/main">
               <a:ext uri="{FF2B5EF4-FFF2-40B4-BE49-F238E27FC236}">
-                <a16:creationId xmlns:a16="http://schemas.microsoft.com/office/drawing/2014/main" id="{62F87716-AC95-4522-8112-BAB30DEEB7B7}"/>
+                <a16:creationId xmlns:a16="http://schemas.microsoft.com/office/drawing/2014/main" id="{9E0F677F-A47F-49F1-9E0B-81671C45FA0F}"/>
               </a:ext>
             </a:extLst>
           </p:cNvPr>
@@ -9468,7 +9468,7 @@
           <p:cNvPr id="29" name="">
             <a:extLst xmlns:a="http://schemas.openxmlformats.org/drawingml/2006/main">
               <a:ext uri="{FF2B5EF4-FFF2-40B4-BE49-F238E27FC236}">
-                <a16:creationId xmlns:a16="http://schemas.microsoft.com/office/drawing/2014/main" id="{BE979A21-F0D3-4D40-B269-02F05D767ADE}"/>
+                <a16:creationId xmlns:a16="http://schemas.microsoft.com/office/drawing/2014/main" id="{CB9CB659-4190-422B-BA69-22962A00637D}"/>
               </a:ext>
             </a:extLst>
           </p:cNvPr>
@@ -9548,7 +9548,7 @@
           <p:cNvPr id="30" name="">
             <a:extLst xmlns:a="http://schemas.openxmlformats.org/drawingml/2006/main">
               <a:ext uri="{FF2B5EF4-FFF2-40B4-BE49-F238E27FC236}">
-                <a16:creationId xmlns:a16="http://schemas.microsoft.com/office/drawing/2014/main" id="{6B4977F0-FFD4-49D0-B6A0-33F1AFCD4C3E}"/>
+                <a16:creationId xmlns:a16="http://schemas.microsoft.com/office/drawing/2014/main" id="{D0DC51BD-DA53-4668-BE0D-FC372F5D9887}"/>
               </a:ext>
             </a:extLst>
           </p:cNvPr>
@@ -9605,7 +9605,7 @@
           <p:cNvPr id="31" name="">
             <a:extLst xmlns:a="http://schemas.openxmlformats.org/drawingml/2006/main">
               <a:ext uri="{FF2B5EF4-FFF2-40B4-BE49-F238E27FC236}">
-                <a16:creationId xmlns:a16="http://schemas.microsoft.com/office/drawing/2014/main" id="{9D7065C4-F349-4F5D-B54A-C9DCC461491E}"/>
+                <a16:creationId xmlns:a16="http://schemas.microsoft.com/office/drawing/2014/main" id="{69C39D5C-91DD-49E7-A178-97B9C255644C}"/>
               </a:ext>
             </a:extLst>
           </p:cNvPr>
@@ -9660,7 +9660,7 @@
     </p:spTree>
     <p:extLst>
       <p:ext uri="{BB962C8B-B14F-4D97-AF65-F5344CB8AC3E}">
-        <p14:creationId xmlns:p14="http://schemas.microsoft.com/office/powerpoint/2010/main" val="906637743"/>
+        <p14:creationId xmlns:p14="http://schemas.microsoft.com/office/powerpoint/2010/main" val="59728221"/>
       </p:ext>
     </p:extLst>
   </p:cSld>
@@ -9691,7 +9691,7 @@
           <p:cNvPr id="36" name="">
             <a:extLst xmlns:a="http://schemas.openxmlformats.org/drawingml/2006/main">
               <a:ext uri="{FF2B5EF4-FFF2-40B4-BE49-F238E27FC236}">
-                <a16:creationId xmlns:a16="http://schemas.microsoft.com/office/drawing/2014/main" id="{0A466144-C42D-4EF4-BBDE-F2C4042DCD88}"/>
+                <a16:creationId xmlns:a16="http://schemas.microsoft.com/office/drawing/2014/main" id="{87C060AB-DD9F-4137-A5A2-1E0C454E5610}"/>
               </a:ext>
             </a:extLst>
           </p:cNvPr>
@@ -9748,7 +9748,7 @@
           <p:cNvPr id="2" name="">
             <a:extLst xmlns:a="http://schemas.openxmlformats.org/drawingml/2006/main">
               <a:ext uri="{FF2B5EF4-FFF2-40B4-BE49-F238E27FC236}">
-                <a16:creationId xmlns:a16="http://schemas.microsoft.com/office/drawing/2014/main" id="{7E0E9709-BD79-4A55-A90E-1DD00B1CC156}"/>
+                <a16:creationId xmlns:a16="http://schemas.microsoft.com/office/drawing/2014/main" id="{3AAD56FD-EA6C-4953-A605-29206D7ECBA7}"/>
               </a:ext>
             </a:extLst>
           </p:cNvPr>
@@ -9805,7 +9805,7 @@
           <p:cNvPr id="3" name="">
             <a:extLst xmlns:a="http://schemas.openxmlformats.org/drawingml/2006/main">
               <a:ext uri="{FF2B5EF4-FFF2-40B4-BE49-F238E27FC236}">
-                <a16:creationId xmlns:a16="http://schemas.microsoft.com/office/drawing/2014/main" id="{A439423D-3299-46D1-9CC1-F9DEC8E73FA1}"/>
+                <a16:creationId xmlns:a16="http://schemas.microsoft.com/office/drawing/2014/main" id="{8A5C203C-AA62-4B2A-BF5E-68C130C62136}"/>
               </a:ext>
             </a:extLst>
           </p:cNvPr>
@@ -9862,7 +9862,7 @@
           <p:cNvPr id="4" name="">
             <a:extLst xmlns:a="http://schemas.openxmlformats.org/drawingml/2006/main">
               <a:ext uri="{FF2B5EF4-FFF2-40B4-BE49-F238E27FC236}">
-                <a16:creationId xmlns:a16="http://schemas.microsoft.com/office/drawing/2014/main" id="{40151083-CCF9-4FFF-BE11-81BE4E4AE963}"/>
+                <a16:creationId xmlns:a16="http://schemas.microsoft.com/office/drawing/2014/main" id="{B4184025-C3AD-481F-B1E2-52A20429DE0C}"/>
               </a:ext>
             </a:extLst>
           </p:cNvPr>
@@ -9893,7 +9893,7 @@
           <p:cNvPr id="5" name="">
             <a:extLst xmlns:a="http://schemas.openxmlformats.org/drawingml/2006/main">
               <a:ext uri="{FF2B5EF4-FFF2-40B4-BE49-F238E27FC236}">
-                <a16:creationId xmlns:a16="http://schemas.microsoft.com/office/drawing/2014/main" id="{5D64F738-2A5C-49C4-A327-9578A3787858}"/>
+                <a16:creationId xmlns:a16="http://schemas.microsoft.com/office/drawing/2014/main" id="{0428225E-C14C-469A-8588-BDECC14D3928}"/>
               </a:ext>
             </a:extLst>
           </p:cNvPr>
@@ -9928,7 +9928,7 @@
           <p:cNvPr id="6" name="">
             <a:extLst xmlns:a="http://schemas.openxmlformats.org/drawingml/2006/main">
               <a:ext uri="{FF2B5EF4-FFF2-40B4-BE49-F238E27FC236}">
-                <a16:creationId xmlns:a16="http://schemas.microsoft.com/office/drawing/2014/main" id="{7470A48A-65EF-4B0F-A5D1-C1DEFA543003}"/>
+                <a16:creationId xmlns:a16="http://schemas.microsoft.com/office/drawing/2014/main" id="{3502BB02-2CCB-4569-9DA1-83D2E73FBA18}"/>
               </a:ext>
             </a:extLst>
           </p:cNvPr>
@@ -9992,7 +9992,7 @@
           <p:cNvPr id="7" name="">
             <a:extLst xmlns:a="http://schemas.openxmlformats.org/drawingml/2006/main">
               <a:ext uri="{FF2B5EF4-FFF2-40B4-BE49-F238E27FC236}">
-                <a16:creationId xmlns:a16="http://schemas.microsoft.com/office/drawing/2014/main" id="{C037EFBF-C9D5-48F5-81DB-0DBDC656AC8A}"/>
+                <a16:creationId xmlns:a16="http://schemas.microsoft.com/office/drawing/2014/main" id="{C9460E6B-6FC5-4FB6-BA29-3B965FEE2399}"/>
               </a:ext>
             </a:extLst>
           </p:cNvPr>
@@ -10049,7 +10049,7 @@
           <p:cNvPr id="8" name="">
             <a:extLst xmlns:a="http://schemas.openxmlformats.org/drawingml/2006/main">
               <a:ext uri="{FF2B5EF4-FFF2-40B4-BE49-F238E27FC236}">
-                <a16:creationId xmlns:a16="http://schemas.microsoft.com/office/drawing/2014/main" id="{71BEBB03-A4EF-4D66-A411-A70EB8D5C4B4}"/>
+                <a16:creationId xmlns:a16="http://schemas.microsoft.com/office/drawing/2014/main" id="{DDF11BF3-0B3F-4CE6-9F2D-2D776642094C}"/>
               </a:ext>
             </a:extLst>
           </p:cNvPr>
@@ -10084,7 +10084,7 @@
           <p:cNvPr id="9" name="">
             <a:extLst xmlns:a="http://schemas.openxmlformats.org/drawingml/2006/main">
               <a:ext uri="{FF2B5EF4-FFF2-40B4-BE49-F238E27FC236}">
-                <a16:creationId xmlns:a16="http://schemas.microsoft.com/office/drawing/2014/main" id="{16B5400A-7DEA-4659-85C1-C307256CF267}"/>
+                <a16:creationId xmlns:a16="http://schemas.microsoft.com/office/drawing/2014/main" id="{5F73C406-4297-4FE3-A7CA-5ABAA5CDDAAD}"/>
               </a:ext>
             </a:extLst>
           </p:cNvPr>
@@ -10148,7 +10148,7 @@
           <p:cNvPr id="10" name="">
             <a:extLst xmlns:a="http://schemas.openxmlformats.org/drawingml/2006/main">
               <a:ext uri="{FF2B5EF4-FFF2-40B4-BE49-F238E27FC236}">
-                <a16:creationId xmlns:a16="http://schemas.microsoft.com/office/drawing/2014/main" id="{48B298A2-4B66-45FE-86BA-FE3395B5CC4A}"/>
+                <a16:creationId xmlns:a16="http://schemas.microsoft.com/office/drawing/2014/main" id="{EA3E99C5-401B-4D61-BDE1-1C6ED92F9669}"/>
               </a:ext>
             </a:extLst>
           </p:cNvPr>
@@ -10205,7 +10205,7 @@
           <p:cNvPr id="11" name="">
             <a:extLst xmlns:a="http://schemas.openxmlformats.org/drawingml/2006/main">
               <a:ext uri="{FF2B5EF4-FFF2-40B4-BE49-F238E27FC236}">
-                <a16:creationId xmlns:a16="http://schemas.microsoft.com/office/drawing/2014/main" id="{89B2E81A-A39B-415B-8F16-7BF7D3CC16C4}"/>
+                <a16:creationId xmlns:a16="http://schemas.microsoft.com/office/drawing/2014/main" id="{4492E3C5-E4F5-40F1-A5A4-402CE524A53D}"/>
               </a:ext>
             </a:extLst>
           </p:cNvPr>
@@ -10240,7 +10240,7 @@
           <p:cNvPr id="12" name="">
             <a:extLst xmlns:a="http://schemas.openxmlformats.org/drawingml/2006/main">
               <a:ext uri="{FF2B5EF4-FFF2-40B4-BE49-F238E27FC236}">
-                <a16:creationId xmlns:a16="http://schemas.microsoft.com/office/drawing/2014/main" id="{F6C2C07E-177F-422D-8589-B6B9D41519AB}"/>
+                <a16:creationId xmlns:a16="http://schemas.microsoft.com/office/drawing/2014/main" id="{B11023EF-B951-46B2-83CD-3506A0539C85}"/>
               </a:ext>
             </a:extLst>
           </p:cNvPr>
@@ -10304,7 +10304,7 @@
           <p:cNvPr id="13" name="">
             <a:extLst xmlns:a="http://schemas.openxmlformats.org/drawingml/2006/main">
               <a:ext uri="{FF2B5EF4-FFF2-40B4-BE49-F238E27FC236}">
-                <a16:creationId xmlns:a16="http://schemas.microsoft.com/office/drawing/2014/main" id="{2B1AB71E-364A-49E0-8BB5-FE813B2C6CA9}"/>
+                <a16:creationId xmlns:a16="http://schemas.microsoft.com/office/drawing/2014/main" id="{FCF32586-FFEB-4BD1-A7F4-9D5632B6DCD2}"/>
               </a:ext>
             </a:extLst>
           </p:cNvPr>
@@ -10361,7 +10361,7 @@
           <p:cNvPr id="14" name="">
             <a:extLst xmlns:a="http://schemas.openxmlformats.org/drawingml/2006/main">
               <a:ext uri="{FF2B5EF4-FFF2-40B4-BE49-F238E27FC236}">
-                <a16:creationId xmlns:a16="http://schemas.microsoft.com/office/drawing/2014/main" id="{ABC518E1-ED4A-4F29-8952-7F6603D85D92}"/>
+                <a16:creationId xmlns:a16="http://schemas.microsoft.com/office/drawing/2014/main" id="{3D86652E-7DF0-47E8-B96D-E4516BB445A0}"/>
               </a:ext>
             </a:extLst>
           </p:cNvPr>
@@ -10396,7 +10396,7 @@
           <p:cNvPr id="15" name="">
             <a:extLst xmlns:a="http://schemas.openxmlformats.org/drawingml/2006/main">
               <a:ext uri="{FF2B5EF4-FFF2-40B4-BE49-F238E27FC236}">
-                <a16:creationId xmlns:a16="http://schemas.microsoft.com/office/drawing/2014/main" id="{7C6A1B62-C8E6-4D73-B3CD-8BE353D64505}"/>
+                <a16:creationId xmlns:a16="http://schemas.microsoft.com/office/drawing/2014/main" id="{163AE1C2-3783-4FC5-A375-C3AC695D1A1E}"/>
               </a:ext>
             </a:extLst>
           </p:cNvPr>
@@ -10460,7 +10460,7 @@
           <p:cNvPr id="16" name="">
             <a:extLst xmlns:a="http://schemas.openxmlformats.org/drawingml/2006/main">
               <a:ext uri="{FF2B5EF4-FFF2-40B4-BE49-F238E27FC236}">
-                <a16:creationId xmlns:a16="http://schemas.microsoft.com/office/drawing/2014/main" id="{4A8C3100-7235-4213-B48C-AB9AB90A8F18}"/>
+                <a16:creationId xmlns:a16="http://schemas.microsoft.com/office/drawing/2014/main" id="{94D9A4D4-9A1C-49B2-9CE9-7A46575EC644}"/>
               </a:ext>
             </a:extLst>
           </p:cNvPr>
@@ -10517,7 +10517,7 @@
           <p:cNvPr id="17" name="">
             <a:extLst xmlns:a="http://schemas.openxmlformats.org/drawingml/2006/main">
               <a:ext uri="{FF2B5EF4-FFF2-40B4-BE49-F238E27FC236}">
-                <a16:creationId xmlns:a16="http://schemas.microsoft.com/office/drawing/2014/main" id="{EF681309-7E06-4EDE-AAF7-6BC9F58B7277}"/>
+                <a16:creationId xmlns:a16="http://schemas.microsoft.com/office/drawing/2014/main" id="{94231696-40C1-477D-9546-40B06183B6E3}"/>
               </a:ext>
             </a:extLst>
           </p:cNvPr>
@@ -10552,7 +10552,7 @@
           <p:cNvPr id="18" name="">
             <a:extLst xmlns:a="http://schemas.openxmlformats.org/drawingml/2006/main">
               <a:ext uri="{FF2B5EF4-FFF2-40B4-BE49-F238E27FC236}">
-                <a16:creationId xmlns:a16="http://schemas.microsoft.com/office/drawing/2014/main" id="{DB2ABAC0-3DC0-46E9-B390-3BB6E8C6B762}"/>
+                <a16:creationId xmlns:a16="http://schemas.microsoft.com/office/drawing/2014/main" id="{881C83AA-C3BA-4DE7-BD2D-F777CA05329F}"/>
               </a:ext>
             </a:extLst>
           </p:cNvPr>
@@ -10616,7 +10616,7 @@
           <p:cNvPr id="19" name="">
             <a:extLst xmlns:a="http://schemas.openxmlformats.org/drawingml/2006/main">
               <a:ext uri="{FF2B5EF4-FFF2-40B4-BE49-F238E27FC236}">
-                <a16:creationId xmlns:a16="http://schemas.microsoft.com/office/drawing/2014/main" id="{E32D3629-3703-4F83-9ACF-FBE7DB470606}"/>
+                <a16:creationId xmlns:a16="http://schemas.microsoft.com/office/drawing/2014/main" id="{374B3F7B-FF55-418C-8D48-FB60CC810F3A}"/>
               </a:ext>
             </a:extLst>
           </p:cNvPr>
@@ -10673,7 +10673,7 @@
           <p:cNvPr id="20" name="">
             <a:extLst xmlns:a="http://schemas.openxmlformats.org/drawingml/2006/main">
               <a:ext uri="{FF2B5EF4-FFF2-40B4-BE49-F238E27FC236}">
-                <a16:creationId xmlns:a16="http://schemas.microsoft.com/office/drawing/2014/main" id="{C1B0AF00-F86C-459E-ACE3-02877BBFD9A1}"/>
+                <a16:creationId xmlns:a16="http://schemas.microsoft.com/office/drawing/2014/main" id="{6D1ABECD-7D4A-43C8-8404-AD6A73EC917D}"/>
               </a:ext>
             </a:extLst>
           </p:cNvPr>
@@ -10708,7 +10708,7 @@
           <p:cNvPr id="21" name="">
             <a:extLst xmlns:a="http://schemas.openxmlformats.org/drawingml/2006/main">
               <a:ext uri="{FF2B5EF4-FFF2-40B4-BE49-F238E27FC236}">
-                <a16:creationId xmlns:a16="http://schemas.microsoft.com/office/drawing/2014/main" id="{2D5EDCB6-3A4D-4B51-9ABE-072EEF4DFABA}"/>
+                <a16:creationId xmlns:a16="http://schemas.microsoft.com/office/drawing/2014/main" id="{5B16B967-3659-47B6-B966-E6A6E4CA008E}"/>
               </a:ext>
             </a:extLst>
           </p:cNvPr>
@@ -10765,7 +10765,7 @@
           <p:cNvPr id="22" name="">
             <a:extLst xmlns:a="http://schemas.openxmlformats.org/drawingml/2006/main">
               <a:ext uri="{FF2B5EF4-FFF2-40B4-BE49-F238E27FC236}">
-                <a16:creationId xmlns:a16="http://schemas.microsoft.com/office/drawing/2014/main" id="{E86C508F-A5E9-409D-A5B2-18811BCE5EAD}"/>
+                <a16:creationId xmlns:a16="http://schemas.microsoft.com/office/drawing/2014/main" id="{B7C22252-47FE-4A85-8501-4EBD1CD3AD29}"/>
               </a:ext>
             </a:extLst>
           </p:cNvPr>
@@ -10829,7 +10829,7 @@
           <p:cNvPr id="23" name="">
             <a:extLst xmlns:a="http://schemas.openxmlformats.org/drawingml/2006/main">
               <a:ext uri="{FF2B5EF4-FFF2-40B4-BE49-F238E27FC236}">
-                <a16:creationId xmlns:a16="http://schemas.microsoft.com/office/drawing/2014/main" id="{8AC6710E-4CD8-4D6E-9E4E-51E146074014}"/>
+                <a16:creationId xmlns:a16="http://schemas.microsoft.com/office/drawing/2014/main" id="{98F740BA-F319-4EC8-B915-31AF05C164C6}"/>
               </a:ext>
             </a:extLst>
           </p:cNvPr>
@@ -10886,7 +10886,7 @@
           <p:cNvPr id="24" name="">
             <a:extLst xmlns:a="http://schemas.openxmlformats.org/drawingml/2006/main">
               <a:ext uri="{FF2B5EF4-FFF2-40B4-BE49-F238E27FC236}">
-                <a16:creationId xmlns:a16="http://schemas.microsoft.com/office/drawing/2014/main" id="{44FC9BCF-5A3B-4A9A-B2F6-1DC5BC38703B}"/>
+                <a16:creationId xmlns:a16="http://schemas.microsoft.com/office/drawing/2014/main" id="{67670B92-A43C-4C71-8604-DD3B28FB0A04}"/>
               </a:ext>
             </a:extLst>
           </p:cNvPr>
@@ -10950,7 +10950,7 @@
           <p:cNvPr id="25" name="">
             <a:extLst xmlns:a="http://schemas.openxmlformats.org/drawingml/2006/main">
               <a:ext uri="{FF2B5EF4-FFF2-40B4-BE49-F238E27FC236}">
-                <a16:creationId xmlns:a16="http://schemas.microsoft.com/office/drawing/2014/main" id="{D3032DA4-11C5-4BF8-8352-827F2ED56382}"/>
+                <a16:creationId xmlns:a16="http://schemas.microsoft.com/office/drawing/2014/main" id="{38FCB651-7C64-44A9-94B5-2BC78F90296F}"/>
               </a:ext>
             </a:extLst>
           </p:cNvPr>
@@ -11007,7 +11007,7 @@
           <p:cNvPr id="26" name="">
             <a:extLst xmlns:a="http://schemas.openxmlformats.org/drawingml/2006/main">
               <a:ext uri="{FF2B5EF4-FFF2-40B4-BE49-F238E27FC236}">
-                <a16:creationId xmlns:a16="http://schemas.microsoft.com/office/drawing/2014/main" id="{EB826F3F-331D-41E7-A25E-6540DD001D5C}"/>
+                <a16:creationId xmlns:a16="http://schemas.microsoft.com/office/drawing/2014/main" id="{F51E1EB5-DA2C-47B9-BD9E-B223ECBB10D5}"/>
               </a:ext>
             </a:extLst>
           </p:cNvPr>
@@ -11071,7 +11071,7 @@
           <p:cNvPr id="27" name="">
             <a:extLst xmlns:a="http://schemas.openxmlformats.org/drawingml/2006/main">
               <a:ext uri="{FF2B5EF4-FFF2-40B4-BE49-F238E27FC236}">
-                <a16:creationId xmlns:a16="http://schemas.microsoft.com/office/drawing/2014/main" id="{82E904AD-7500-4A4E-8830-29483B8EE85C}"/>
+                <a16:creationId xmlns:a16="http://schemas.microsoft.com/office/drawing/2014/main" id="{1E4FD999-5A37-4636-8F19-E9F4C3AB54DD}"/>
               </a:ext>
             </a:extLst>
           </p:cNvPr>
@@ -11118,7 +11118,7 @@
                 <a:ea typeface="Arial"/>
                 <a:cs typeface="Arial"/>
               </a:rPr>
-              <a:t>15/15 fixture + 15 ca BGK</a:t>
+              <a:t>25/25 fixture + 15 ca BGK</a:t>
             </a:r>
           </a:p>
         </p:txBody>
@@ -11128,7 +11128,7 @@
           <p:cNvPr id="28" name="">
             <a:extLst xmlns:a="http://schemas.openxmlformats.org/drawingml/2006/main">
               <a:ext uri="{FF2B5EF4-FFF2-40B4-BE49-F238E27FC236}">
-                <a16:creationId xmlns:a16="http://schemas.microsoft.com/office/drawing/2014/main" id="{1758F18C-3293-47C1-B0CC-B7FAEBFDC2E6}"/>
+                <a16:creationId xmlns:a16="http://schemas.microsoft.com/office/drawing/2014/main" id="{7670BC19-B3FA-4DE0-9BCD-2533EDEDFCE5}"/>
               </a:ext>
             </a:extLst>
           </p:cNvPr>
@@ -11192,7 +11192,7 @@
           <p:cNvPr id="29" name="">
             <a:extLst xmlns:a="http://schemas.openxmlformats.org/drawingml/2006/main">
               <a:ext uri="{FF2B5EF4-FFF2-40B4-BE49-F238E27FC236}">
-                <a16:creationId xmlns:a16="http://schemas.microsoft.com/office/drawing/2014/main" id="{0C199269-86D3-4F49-A7D1-83B31E155454}"/>
+                <a16:creationId xmlns:a16="http://schemas.microsoft.com/office/drawing/2014/main" id="{1C5B9B22-1066-4502-B1FE-8AF14534CB2F}"/>
               </a:ext>
             </a:extLst>
           </p:cNvPr>
@@ -11249,7 +11249,7 @@
           <p:cNvPr id="30" name="">
             <a:extLst xmlns:a="http://schemas.openxmlformats.org/drawingml/2006/main">
               <a:ext uri="{FF2B5EF4-FFF2-40B4-BE49-F238E27FC236}">
-                <a16:creationId xmlns:a16="http://schemas.microsoft.com/office/drawing/2014/main" id="{B1EB5949-1F57-4A7E-9882-AA3D2B688D69}"/>
+                <a16:creationId xmlns:a16="http://schemas.microsoft.com/office/drawing/2014/main" id="{55621037-3A98-4DB2-9721-7C5DFEEC494C}"/>
               </a:ext>
             </a:extLst>
           </p:cNvPr>
@@ -11284,7 +11284,7 @@
           <p:cNvPr id="31" name="">
             <a:extLst xmlns:a="http://schemas.openxmlformats.org/drawingml/2006/main">
               <a:ext uri="{FF2B5EF4-FFF2-40B4-BE49-F238E27FC236}">
-                <a16:creationId xmlns:a16="http://schemas.microsoft.com/office/drawing/2014/main" id="{80F4D599-F829-46FC-8287-167ECE85C3F7}"/>
+                <a16:creationId xmlns:a16="http://schemas.microsoft.com/office/drawing/2014/main" id="{A1FBE79C-C59D-4B09-B327-88E525D04AA8}"/>
               </a:ext>
             </a:extLst>
           </p:cNvPr>
@@ -11341,7 +11341,7 @@
           <p:cNvPr id="32" name="">
             <a:extLst xmlns:a="http://schemas.openxmlformats.org/drawingml/2006/main">
               <a:ext uri="{FF2B5EF4-FFF2-40B4-BE49-F238E27FC236}">
-                <a16:creationId xmlns:a16="http://schemas.microsoft.com/office/drawing/2014/main" id="{E255A861-F1F0-4331-B1A0-AD414991D982}"/>
+                <a16:creationId xmlns:a16="http://schemas.microsoft.com/office/drawing/2014/main" id="{E90E496F-2177-4F26-BBFD-AF1361088C4B}"/>
               </a:ext>
             </a:extLst>
           </p:cNvPr>
@@ -11444,7 +11444,7 @@
           <p:cNvPr id="33" name="">
             <a:extLst xmlns:a="http://schemas.openxmlformats.org/drawingml/2006/main">
               <a:ext uri="{FF2B5EF4-FFF2-40B4-BE49-F238E27FC236}">
-                <a16:creationId xmlns:a16="http://schemas.microsoft.com/office/drawing/2014/main" id="{4D3AA8EE-4F9E-473D-B331-685B61C49082}"/>
+                <a16:creationId xmlns:a16="http://schemas.microsoft.com/office/drawing/2014/main" id="{737C383A-7BD9-4494-8762-D50876D38F84}"/>
               </a:ext>
             </a:extLst>
           </p:cNvPr>
@@ -11501,7 +11501,7 @@
           <p:cNvPr id="34" name="">
             <a:extLst xmlns:a="http://schemas.openxmlformats.org/drawingml/2006/main">
               <a:ext uri="{FF2B5EF4-FFF2-40B4-BE49-F238E27FC236}">
-                <a16:creationId xmlns:a16="http://schemas.microsoft.com/office/drawing/2014/main" id="{9822607D-BEC6-4582-B35B-D56871477ECF}"/>
+                <a16:creationId xmlns:a16="http://schemas.microsoft.com/office/drawing/2014/main" id="{EC6420B5-25FC-4C09-9508-1CFCA9042400}"/>
               </a:ext>
             </a:extLst>
           </p:cNvPr>
@@ -11558,7 +11558,7 @@
           <p:cNvPr id="35" name="">
             <a:extLst xmlns:a="http://schemas.openxmlformats.org/drawingml/2006/main">
               <a:ext uri="{FF2B5EF4-FFF2-40B4-BE49-F238E27FC236}">
-                <a16:creationId xmlns:a16="http://schemas.microsoft.com/office/drawing/2014/main" id="{FFBE6900-6EDC-408E-AFA9-3EF3AB3322EA}"/>
+                <a16:creationId xmlns:a16="http://schemas.microsoft.com/office/drawing/2014/main" id="{EBF47A3F-8783-4667-8094-CE4A84146134}"/>
               </a:ext>
             </a:extLst>
           </p:cNvPr>
@@ -11613,7 +11613,7 @@
     </p:spTree>
     <p:extLst>
       <p:ext uri="{BB962C8B-B14F-4D97-AF65-F5344CB8AC3E}">
-        <p14:creationId xmlns:p14="http://schemas.microsoft.com/office/powerpoint/2010/main" val="517388069"/>
+        <p14:creationId xmlns:p14="http://schemas.microsoft.com/office/powerpoint/2010/main" val="1390269432"/>
       </p:ext>
     </p:extLst>
   </p:cSld>

</xml_diff>

<commit_message>
docs: record OpenRouter benchmark and model decision
</commit_message>
<xml_diff>
--- a/AURA/submission/AURA_5_SLIDES.pptx
+++ b/AURA/submission/AURA_5_SLIDES.pptx
@@ -2,17 +2,17 @@
 <file path=ppt/presentation.xml><?xml version="1.0" encoding="utf-8"?>
 <p:presentation xmlns:p="http://schemas.openxmlformats.org/presentationml/2006/main">
   <p:sldMasterIdLst>
-    <p:sldMasterId xmlns:r="http://schemas.openxmlformats.org/officeDocument/2006/relationships" id="2147483648" r:id="R24f5abe0f39d484f"/>
+    <p:sldMasterId xmlns:r="http://schemas.openxmlformats.org/officeDocument/2006/relationships" id="2147483648" r:id="R54ddcdcfd7a545d5"/>
   </p:sldMasterIdLst>
   <p:notesMasterIdLst>
-    <p:notesMasterId xmlns:r="http://schemas.openxmlformats.org/officeDocument/2006/relationships" r:id="Rad9e27b9c1124157"/>
+    <p:notesMasterId xmlns:r="http://schemas.openxmlformats.org/officeDocument/2006/relationships" r:id="Rdd0998c484374032"/>
   </p:notesMasterIdLst>
   <p:sldIdLst>
-    <p:sldId xmlns:r="http://schemas.openxmlformats.org/officeDocument/2006/relationships" id="256" r:id="R9ab9b30b66ed4054"/>
-    <p:sldId xmlns:r="http://schemas.openxmlformats.org/officeDocument/2006/relationships" id="257" r:id="Rbf9228bc3bc542a6"/>
-    <p:sldId xmlns:r="http://schemas.openxmlformats.org/officeDocument/2006/relationships" id="258" r:id="R55d3e9c73ab84995"/>
-    <p:sldId xmlns:r="http://schemas.openxmlformats.org/officeDocument/2006/relationships" id="259" r:id="R60e8d0328db04e2d"/>
-    <p:sldId xmlns:r="http://schemas.openxmlformats.org/officeDocument/2006/relationships" id="260" r:id="R75564caabc30404c"/>
+    <p:sldId xmlns:r="http://schemas.openxmlformats.org/officeDocument/2006/relationships" id="256" r:id="R6225d1d87fab4a40"/>
+    <p:sldId xmlns:r="http://schemas.openxmlformats.org/officeDocument/2006/relationships" id="257" r:id="R59f9d370cf1342e6"/>
+    <p:sldId xmlns:r="http://schemas.openxmlformats.org/officeDocument/2006/relationships" id="258" r:id="R3ba8958438294371"/>
+    <p:sldId xmlns:r="http://schemas.openxmlformats.org/officeDocument/2006/relationships" id="259" r:id="R1e88cf1770914e62"/>
+    <p:sldId xmlns:r="http://schemas.openxmlformats.org/officeDocument/2006/relationships" id="260" r:id="R5361d892d2c1485c"/>
   </p:sldIdLst>
   <p:sldSz cx="12192000" cy="6858000"/>
   <p:notesSz cx="6858000" cy="9144000"/>
@@ -586,7 +586,7 @@
           <a:lstStyle xmlns:a="http://schemas.openxmlformats.org/drawingml/2006/main"/>
           <a:p xmlns:a="http://schemas.openxmlformats.org/drawingml/2006/main">
             <a:r>
-              <a:t>Nguồn nội bộ: 70 test offline; Ollama 4B đạt 25/25 qua năm batch liên tiếp trên 5 fixture tổng hợp và upload HoaDon1 đạt AUTO_APPROVE 3/3 ngày 27/09/2026. Không suy rộng thành accuracy thực tế.</a:t>
+              <a:t>Nguồn nội bộ ngày 27/09/2026: 70 test offline; OpenRouter 8B đạt 15/15 qua ba batch, adjusted P95 11,317 giây; Ollama 4B đạt 25/25 qua năm batch trên cùng 5 fixture tổng hợp. Không suy rộng thành accuracy thực tế.</a:t>
             </a:r>
           </a:p>
         </p:txBody>
@@ -794,7 +794,7 @@
   </p:cSld>
   <p:clrMap bg1="lt1" tx1="dk1" bg2="lt2" tx2="dk2" accent1="accent1" accent2="accent2" accent3="accent3" accent4="accent4" accent5="accent5" accent6="accent6" hlink="hlink" folHlink="folHlink"/>
   <p:sldLayoutIdLst>
-    <p:sldLayoutId xmlns:r="http://schemas.openxmlformats.org/officeDocument/2006/relationships" id="2147483649" r:id="R9ba4a952822248f1"/>
+    <p:sldLayoutId xmlns:r="http://schemas.openxmlformats.org/officeDocument/2006/relationships" id="2147483649" r:id="R58193fb4a82d4270"/>
   </p:sldLayoutIdLst>
   <p:txStyles>
     <p:titleStyle>
@@ -1345,7 +1345,7 @@
           <p:cNvPr id="47" name="">
             <a:extLst xmlns:a="http://schemas.openxmlformats.org/drawingml/2006/main">
               <a:ext uri="{FF2B5EF4-FFF2-40B4-BE49-F238E27FC236}">
-                <a16:creationId xmlns:a16="http://schemas.microsoft.com/office/drawing/2014/main" id="{FEAE6662-3697-411F-8998-F138FF2E8C61}"/>
+                <a16:creationId xmlns:a16="http://schemas.microsoft.com/office/drawing/2014/main" id="{3D09ADDB-BB92-49EE-91AF-79C59973C7E9}"/>
               </a:ext>
             </a:extLst>
           </p:cNvPr>
@@ -1402,7 +1402,7 @@
           <p:cNvPr id="2" name="">
             <a:extLst xmlns:a="http://schemas.openxmlformats.org/drawingml/2006/main">
               <a:ext uri="{FF2B5EF4-FFF2-40B4-BE49-F238E27FC236}">
-                <a16:creationId xmlns:a16="http://schemas.microsoft.com/office/drawing/2014/main" id="{31FBE51F-54CD-49FA-BCE1-215412155644}"/>
+                <a16:creationId xmlns:a16="http://schemas.microsoft.com/office/drawing/2014/main" id="{DE17CFDC-CD48-490C-8DA7-40D3C92863F8}"/>
               </a:ext>
             </a:extLst>
           </p:cNvPr>
@@ -1459,7 +1459,7 @@
           <p:cNvPr id="3" name="">
             <a:extLst xmlns:a="http://schemas.openxmlformats.org/drawingml/2006/main">
               <a:ext uri="{FF2B5EF4-FFF2-40B4-BE49-F238E27FC236}">
-                <a16:creationId xmlns:a16="http://schemas.microsoft.com/office/drawing/2014/main" id="{3079F3FC-AF12-43AE-8702-921D91233BEF}"/>
+                <a16:creationId xmlns:a16="http://schemas.microsoft.com/office/drawing/2014/main" id="{E4689CB0-C36B-4983-B407-AA48F10B02B6}"/>
               </a:ext>
             </a:extLst>
           </p:cNvPr>
@@ -1516,7 +1516,7 @@
           <p:cNvPr id="4" name="">
             <a:extLst xmlns:a="http://schemas.openxmlformats.org/drawingml/2006/main">
               <a:ext uri="{FF2B5EF4-FFF2-40B4-BE49-F238E27FC236}">
-                <a16:creationId xmlns:a16="http://schemas.microsoft.com/office/drawing/2014/main" id="{787D22B3-F9D2-4B7C-99BA-69738C4B756E}"/>
+                <a16:creationId xmlns:a16="http://schemas.microsoft.com/office/drawing/2014/main" id="{D02AA200-4333-45C9-A044-3D767FF170DD}"/>
               </a:ext>
             </a:extLst>
           </p:cNvPr>
@@ -1547,7 +1547,7 @@
           <p:cNvPr id="5" name="">
             <a:extLst xmlns:a="http://schemas.openxmlformats.org/drawingml/2006/main">
               <a:ext uri="{FF2B5EF4-FFF2-40B4-BE49-F238E27FC236}">
-                <a16:creationId xmlns:a16="http://schemas.microsoft.com/office/drawing/2014/main" id="{09467F9E-4CBE-4F40-AF08-163129DB1567}"/>
+                <a16:creationId xmlns:a16="http://schemas.microsoft.com/office/drawing/2014/main" id="{907546B7-0FD0-469C-8C38-557C7C609861}"/>
               </a:ext>
             </a:extLst>
           </p:cNvPr>
@@ -1582,7 +1582,7 @@
           <p:cNvPr id="6" name="">
             <a:extLst xmlns:a="http://schemas.openxmlformats.org/drawingml/2006/main">
               <a:ext uri="{FF2B5EF4-FFF2-40B4-BE49-F238E27FC236}">
-                <a16:creationId xmlns:a16="http://schemas.microsoft.com/office/drawing/2014/main" id="{FCFA891D-B19D-4F6C-BDF0-7A65877D5AA8}"/>
+                <a16:creationId xmlns:a16="http://schemas.microsoft.com/office/drawing/2014/main" id="{BD9C3744-CA97-40BC-8D9E-6332C272B7B0}"/>
               </a:ext>
             </a:extLst>
           </p:cNvPr>
@@ -1646,7 +1646,7 @@
           <p:cNvPr id="7" name="">
             <a:extLst xmlns:a="http://schemas.openxmlformats.org/drawingml/2006/main">
               <a:ext uri="{FF2B5EF4-FFF2-40B4-BE49-F238E27FC236}">
-                <a16:creationId xmlns:a16="http://schemas.microsoft.com/office/drawing/2014/main" id="{2DD71A78-72C0-4AB5-A4A3-01F2F03F2CC2}"/>
+                <a16:creationId xmlns:a16="http://schemas.microsoft.com/office/drawing/2014/main" id="{927DA05B-1956-415F-BB31-8EEA1894775B}"/>
               </a:ext>
             </a:extLst>
           </p:cNvPr>
@@ -1703,7 +1703,7 @@
           <p:cNvPr id="8" name="">
             <a:extLst xmlns:a="http://schemas.openxmlformats.org/drawingml/2006/main">
               <a:ext uri="{FF2B5EF4-FFF2-40B4-BE49-F238E27FC236}">
-                <a16:creationId xmlns:a16="http://schemas.microsoft.com/office/drawing/2014/main" id="{8BB3D061-7849-4097-B5CC-47714DFE8353}"/>
+                <a16:creationId xmlns:a16="http://schemas.microsoft.com/office/drawing/2014/main" id="{2E4D4107-E5C9-484C-8D3D-E32369786703}"/>
               </a:ext>
             </a:extLst>
           </p:cNvPr>
@@ -1760,7 +1760,7 @@
           <p:cNvPr id="9" name="">
             <a:extLst xmlns:a="http://schemas.openxmlformats.org/drawingml/2006/main">
               <a:ext uri="{FF2B5EF4-FFF2-40B4-BE49-F238E27FC236}">
-                <a16:creationId xmlns:a16="http://schemas.microsoft.com/office/drawing/2014/main" id="{B8301CFF-5262-47F0-9B91-B56F038426B2}"/>
+                <a16:creationId xmlns:a16="http://schemas.microsoft.com/office/drawing/2014/main" id="{72EA4846-E452-4548-ADA4-A195B9DE322E}"/>
               </a:ext>
             </a:extLst>
           </p:cNvPr>
@@ -1792,7 +1792,7 @@
           <p:cNvPr id="10" name="">
             <a:extLst xmlns:a="http://schemas.openxmlformats.org/drawingml/2006/main">
               <a:ext uri="{FF2B5EF4-FFF2-40B4-BE49-F238E27FC236}">
-                <a16:creationId xmlns:a16="http://schemas.microsoft.com/office/drawing/2014/main" id="{3CE8170D-724D-473B-99FD-92EBF3903723}"/>
+                <a16:creationId xmlns:a16="http://schemas.microsoft.com/office/drawing/2014/main" id="{5C2A5911-DA2A-46F8-BD6C-502C03984274}"/>
               </a:ext>
             </a:extLst>
           </p:cNvPr>
@@ -1827,7 +1827,7 @@
           <p:cNvPr id="11" name="">
             <a:extLst xmlns:a="http://schemas.openxmlformats.org/drawingml/2006/main">
               <a:ext uri="{FF2B5EF4-FFF2-40B4-BE49-F238E27FC236}">
-                <a16:creationId xmlns:a16="http://schemas.microsoft.com/office/drawing/2014/main" id="{B779AE0A-D2BF-4854-9B80-C09077C13996}"/>
+                <a16:creationId xmlns:a16="http://schemas.microsoft.com/office/drawing/2014/main" id="{2589097D-9534-4BCA-B0F3-1B1EE1D12A8D}"/>
               </a:ext>
             </a:extLst>
           </p:cNvPr>
@@ -1891,7 +1891,7 @@
           <p:cNvPr id="12" name="">
             <a:extLst xmlns:a="http://schemas.openxmlformats.org/drawingml/2006/main">
               <a:ext uri="{FF2B5EF4-FFF2-40B4-BE49-F238E27FC236}">
-                <a16:creationId xmlns:a16="http://schemas.microsoft.com/office/drawing/2014/main" id="{1ED38FEE-20A1-4998-B976-9FB925E779E7}"/>
+                <a16:creationId xmlns:a16="http://schemas.microsoft.com/office/drawing/2014/main" id="{6F88FCB9-46A5-4E69-B925-E14420FBAFF0}"/>
               </a:ext>
             </a:extLst>
           </p:cNvPr>
@@ -1948,7 +1948,7 @@
           <p:cNvPr id="13" name="">
             <a:extLst xmlns:a="http://schemas.openxmlformats.org/drawingml/2006/main">
               <a:ext uri="{FF2B5EF4-FFF2-40B4-BE49-F238E27FC236}">
-                <a16:creationId xmlns:a16="http://schemas.microsoft.com/office/drawing/2014/main" id="{E3E619CC-027E-42C7-9A9F-BF1965DDE0B4}"/>
+                <a16:creationId xmlns:a16="http://schemas.microsoft.com/office/drawing/2014/main" id="{2900DF66-5229-46A9-916B-3D04630F20F5}"/>
               </a:ext>
             </a:extLst>
           </p:cNvPr>
@@ -2005,7 +2005,7 @@
           <p:cNvPr id="14" name="">
             <a:extLst xmlns:a="http://schemas.openxmlformats.org/drawingml/2006/main">
               <a:ext uri="{FF2B5EF4-FFF2-40B4-BE49-F238E27FC236}">
-                <a16:creationId xmlns:a16="http://schemas.microsoft.com/office/drawing/2014/main" id="{F55840E3-C0DC-4372-B9A2-D635B638DD18}"/>
+                <a16:creationId xmlns:a16="http://schemas.microsoft.com/office/drawing/2014/main" id="{02E46289-9563-475A-8274-F126AB552115}"/>
               </a:ext>
             </a:extLst>
           </p:cNvPr>
@@ -2037,7 +2037,7 @@
           <p:cNvPr id="15" name="">
             <a:extLst xmlns:a="http://schemas.openxmlformats.org/drawingml/2006/main">
               <a:ext uri="{FF2B5EF4-FFF2-40B4-BE49-F238E27FC236}">
-                <a16:creationId xmlns:a16="http://schemas.microsoft.com/office/drawing/2014/main" id="{BC015C40-3325-4082-A245-19FA8DCBB574}"/>
+                <a16:creationId xmlns:a16="http://schemas.microsoft.com/office/drawing/2014/main" id="{CEC19FEA-2AAB-456F-A10E-2A6FC2E7DC68}"/>
               </a:ext>
             </a:extLst>
           </p:cNvPr>
@@ -2072,7 +2072,7 @@
           <p:cNvPr id="16" name="">
             <a:extLst xmlns:a="http://schemas.openxmlformats.org/drawingml/2006/main">
               <a:ext uri="{FF2B5EF4-FFF2-40B4-BE49-F238E27FC236}">
-                <a16:creationId xmlns:a16="http://schemas.microsoft.com/office/drawing/2014/main" id="{76A45FBD-A98D-418A-A7ED-70CC71B0EF89}"/>
+                <a16:creationId xmlns:a16="http://schemas.microsoft.com/office/drawing/2014/main" id="{80AA883D-AA92-4DD5-B3BD-ACE4F5370DC9}"/>
               </a:ext>
             </a:extLst>
           </p:cNvPr>
@@ -2136,7 +2136,7 @@
           <p:cNvPr id="17" name="">
             <a:extLst xmlns:a="http://schemas.openxmlformats.org/drawingml/2006/main">
               <a:ext uri="{FF2B5EF4-FFF2-40B4-BE49-F238E27FC236}">
-                <a16:creationId xmlns:a16="http://schemas.microsoft.com/office/drawing/2014/main" id="{A63C7764-48D2-434F-A533-65C2AE44F3E4}"/>
+                <a16:creationId xmlns:a16="http://schemas.microsoft.com/office/drawing/2014/main" id="{84FB223E-535D-46A3-925E-14EEF54A1BF2}"/>
               </a:ext>
             </a:extLst>
           </p:cNvPr>
@@ -2193,7 +2193,7 @@
           <p:cNvPr id="18" name="">
             <a:extLst xmlns:a="http://schemas.openxmlformats.org/drawingml/2006/main">
               <a:ext uri="{FF2B5EF4-FFF2-40B4-BE49-F238E27FC236}">
-                <a16:creationId xmlns:a16="http://schemas.microsoft.com/office/drawing/2014/main" id="{C7AE6C5A-4D82-44B5-A0E3-864A169679E0}"/>
+                <a16:creationId xmlns:a16="http://schemas.microsoft.com/office/drawing/2014/main" id="{BE49A9EB-809F-49C0-956C-FB6A264454B3}"/>
               </a:ext>
             </a:extLst>
           </p:cNvPr>
@@ -2250,7 +2250,7 @@
           <p:cNvPr id="19" name="">
             <a:extLst xmlns:a="http://schemas.openxmlformats.org/drawingml/2006/main">
               <a:ext uri="{FF2B5EF4-FFF2-40B4-BE49-F238E27FC236}">
-                <a16:creationId xmlns:a16="http://schemas.microsoft.com/office/drawing/2014/main" id="{CD3526D4-8926-4CE7-B511-77CD60BD056F}"/>
+                <a16:creationId xmlns:a16="http://schemas.microsoft.com/office/drawing/2014/main" id="{0A7FB152-1A7B-44A0-B3E2-BB93D1F3D1E5}"/>
               </a:ext>
             </a:extLst>
           </p:cNvPr>
@@ -2282,7 +2282,7 @@
           <p:cNvPr id="20" name="">
             <a:extLst xmlns:a="http://schemas.openxmlformats.org/drawingml/2006/main">
               <a:ext uri="{FF2B5EF4-FFF2-40B4-BE49-F238E27FC236}">
-                <a16:creationId xmlns:a16="http://schemas.microsoft.com/office/drawing/2014/main" id="{5BE3A239-7F74-4332-9BE1-E2D38BB04DA8}"/>
+                <a16:creationId xmlns:a16="http://schemas.microsoft.com/office/drawing/2014/main" id="{744A52AF-8F92-4775-A1AE-317367AC99C7}"/>
               </a:ext>
             </a:extLst>
           </p:cNvPr>
@@ -2317,7 +2317,7 @@
           <p:cNvPr id="21" name="">
             <a:extLst xmlns:a="http://schemas.openxmlformats.org/drawingml/2006/main">
               <a:ext uri="{FF2B5EF4-FFF2-40B4-BE49-F238E27FC236}">
-                <a16:creationId xmlns:a16="http://schemas.microsoft.com/office/drawing/2014/main" id="{D91DC745-EBA6-40F5-BDDF-FEFE2D258915}"/>
+                <a16:creationId xmlns:a16="http://schemas.microsoft.com/office/drawing/2014/main" id="{D38EC16D-A125-4CBC-9338-BF98295A0FBA}"/>
               </a:ext>
             </a:extLst>
           </p:cNvPr>
@@ -2381,7 +2381,7 @@
           <p:cNvPr id="22" name="">
             <a:extLst xmlns:a="http://schemas.openxmlformats.org/drawingml/2006/main">
               <a:ext uri="{FF2B5EF4-FFF2-40B4-BE49-F238E27FC236}">
-                <a16:creationId xmlns:a16="http://schemas.microsoft.com/office/drawing/2014/main" id="{2B4F1D70-CE8D-4EAB-A249-6895F33BE3F4}"/>
+                <a16:creationId xmlns:a16="http://schemas.microsoft.com/office/drawing/2014/main" id="{EB388E99-720D-40EE-BDE0-33D1D8D1F043}"/>
               </a:ext>
             </a:extLst>
           </p:cNvPr>
@@ -2438,7 +2438,7 @@
           <p:cNvPr id="23" name="">
             <a:extLst xmlns:a="http://schemas.openxmlformats.org/drawingml/2006/main">
               <a:ext uri="{FF2B5EF4-FFF2-40B4-BE49-F238E27FC236}">
-                <a16:creationId xmlns:a16="http://schemas.microsoft.com/office/drawing/2014/main" id="{40C710F2-FDFE-4BD6-8BE0-7C6D67212445}"/>
+                <a16:creationId xmlns:a16="http://schemas.microsoft.com/office/drawing/2014/main" id="{86B09A0C-AFE9-4705-9531-A3D729795AAD}"/>
               </a:ext>
             </a:extLst>
           </p:cNvPr>
@@ -2495,7 +2495,7 @@
           <p:cNvPr id="24" name="">
             <a:extLst xmlns:a="http://schemas.openxmlformats.org/drawingml/2006/main">
               <a:ext uri="{FF2B5EF4-FFF2-40B4-BE49-F238E27FC236}">
-                <a16:creationId xmlns:a16="http://schemas.microsoft.com/office/drawing/2014/main" id="{C2743D16-19EE-44B7-8E16-E3110D55A653}"/>
+                <a16:creationId xmlns:a16="http://schemas.microsoft.com/office/drawing/2014/main" id="{1004B251-7E5A-44D6-8098-C9FC998E24FE}"/>
               </a:ext>
             </a:extLst>
           </p:cNvPr>
@@ -2527,7 +2527,7 @@
           <p:cNvPr id="25" name="">
             <a:extLst xmlns:a="http://schemas.openxmlformats.org/drawingml/2006/main">
               <a:ext uri="{FF2B5EF4-FFF2-40B4-BE49-F238E27FC236}">
-                <a16:creationId xmlns:a16="http://schemas.microsoft.com/office/drawing/2014/main" id="{1B59CA9A-B5F0-41D3-B9FE-69EB8E96F50F}"/>
+                <a16:creationId xmlns:a16="http://schemas.microsoft.com/office/drawing/2014/main" id="{8F20987D-659B-451B-9E31-EFD386B6C6EA}"/>
               </a:ext>
             </a:extLst>
           </p:cNvPr>
@@ -2562,7 +2562,7 @@
           <p:cNvPr id="26" name="">
             <a:extLst xmlns:a="http://schemas.openxmlformats.org/drawingml/2006/main">
               <a:ext uri="{FF2B5EF4-FFF2-40B4-BE49-F238E27FC236}">
-                <a16:creationId xmlns:a16="http://schemas.microsoft.com/office/drawing/2014/main" id="{E9DA7AD8-FAF1-432D-A98F-9344448DB6F5}"/>
+                <a16:creationId xmlns:a16="http://schemas.microsoft.com/office/drawing/2014/main" id="{5317EF17-68BA-4D17-BD58-B6419B79060C}"/>
               </a:ext>
             </a:extLst>
           </p:cNvPr>
@@ -2626,7 +2626,7 @@
           <p:cNvPr id="27" name="">
             <a:extLst xmlns:a="http://schemas.openxmlformats.org/drawingml/2006/main">
               <a:ext uri="{FF2B5EF4-FFF2-40B4-BE49-F238E27FC236}">
-                <a16:creationId xmlns:a16="http://schemas.microsoft.com/office/drawing/2014/main" id="{BAD6470F-E39B-4F5F-B9C4-CDA1455CDE4C}"/>
+                <a16:creationId xmlns:a16="http://schemas.microsoft.com/office/drawing/2014/main" id="{A4E11C91-BDCA-4DE1-B2A5-26EDF5D123DB}"/>
               </a:ext>
             </a:extLst>
           </p:cNvPr>
@@ -2683,7 +2683,7 @@
           <p:cNvPr id="28" name="">
             <a:extLst xmlns:a="http://schemas.openxmlformats.org/drawingml/2006/main">
               <a:ext uri="{FF2B5EF4-FFF2-40B4-BE49-F238E27FC236}">
-                <a16:creationId xmlns:a16="http://schemas.microsoft.com/office/drawing/2014/main" id="{06DD0875-CEA8-410F-8E51-CCFF7654D55B}"/>
+                <a16:creationId xmlns:a16="http://schemas.microsoft.com/office/drawing/2014/main" id="{71574303-DA43-469A-9063-7820B92C8AAA}"/>
               </a:ext>
             </a:extLst>
           </p:cNvPr>
@@ -2740,7 +2740,7 @@
           <p:cNvPr id="29" name="">
             <a:extLst xmlns:a="http://schemas.openxmlformats.org/drawingml/2006/main">
               <a:ext uri="{FF2B5EF4-FFF2-40B4-BE49-F238E27FC236}">
-                <a16:creationId xmlns:a16="http://schemas.microsoft.com/office/drawing/2014/main" id="{7026D4F1-3C33-48F6-8FFF-B1710E8F7EC8}"/>
+                <a16:creationId xmlns:a16="http://schemas.microsoft.com/office/drawing/2014/main" id="{D4E61484-5B66-4619-86B4-0FCF004BA80B}"/>
               </a:ext>
             </a:extLst>
           </p:cNvPr>
@@ -2775,7 +2775,7 @@
           <p:cNvPr id="30" name="">
             <a:extLst xmlns:a="http://schemas.openxmlformats.org/drawingml/2006/main">
               <a:ext uri="{FF2B5EF4-FFF2-40B4-BE49-F238E27FC236}">
-                <a16:creationId xmlns:a16="http://schemas.microsoft.com/office/drawing/2014/main" id="{A60416CF-0E3A-4D0A-B024-1E931D7F33F2}"/>
+                <a16:creationId xmlns:a16="http://schemas.microsoft.com/office/drawing/2014/main" id="{CA729FCF-E707-447A-8F1D-2F1511EC4EA2}"/>
               </a:ext>
             </a:extLst>
           </p:cNvPr>
@@ -2832,7 +2832,7 @@
           <p:cNvPr id="31" name="">
             <a:extLst xmlns:a="http://schemas.openxmlformats.org/drawingml/2006/main">
               <a:ext uri="{FF2B5EF4-FFF2-40B4-BE49-F238E27FC236}">
-                <a16:creationId xmlns:a16="http://schemas.microsoft.com/office/drawing/2014/main" id="{2858A551-B60C-4B5F-9634-8348F5C39DB0}"/>
+                <a16:creationId xmlns:a16="http://schemas.microsoft.com/office/drawing/2014/main" id="{51A25B47-3512-4AED-AE42-B84FC10B0676}"/>
               </a:ext>
             </a:extLst>
           </p:cNvPr>
@@ -2889,7 +2889,7 @@
           <p:cNvPr id="32" name="">
             <a:extLst xmlns:a="http://schemas.openxmlformats.org/drawingml/2006/main">
               <a:ext uri="{FF2B5EF4-FFF2-40B4-BE49-F238E27FC236}">
-                <a16:creationId xmlns:a16="http://schemas.microsoft.com/office/drawing/2014/main" id="{86B18DE7-C6DF-408B-BE03-05DB838536A8}"/>
+                <a16:creationId xmlns:a16="http://schemas.microsoft.com/office/drawing/2014/main" id="{2CD36433-971B-44E8-BA54-99AEA29B412A}"/>
               </a:ext>
             </a:extLst>
           </p:cNvPr>
@@ -2946,7 +2946,7 @@
           <p:cNvPr id="33" name="">
             <a:extLst xmlns:a="http://schemas.openxmlformats.org/drawingml/2006/main">
               <a:ext uri="{FF2B5EF4-FFF2-40B4-BE49-F238E27FC236}">
-                <a16:creationId xmlns:a16="http://schemas.microsoft.com/office/drawing/2014/main" id="{9E9DF9E0-3B39-4093-AE06-39997EE7BF92}"/>
+                <a16:creationId xmlns:a16="http://schemas.microsoft.com/office/drawing/2014/main" id="{2B0A8808-3F86-4AB1-BF05-52A532473646}"/>
               </a:ext>
             </a:extLst>
           </p:cNvPr>
@@ -2981,7 +2981,7 @@
           <p:cNvPr id="34" name="">
             <a:extLst xmlns:a="http://schemas.openxmlformats.org/drawingml/2006/main">
               <a:ext uri="{FF2B5EF4-FFF2-40B4-BE49-F238E27FC236}">
-                <a16:creationId xmlns:a16="http://schemas.microsoft.com/office/drawing/2014/main" id="{F30B0555-ED27-4274-BABC-CC0052BF02C2}"/>
+                <a16:creationId xmlns:a16="http://schemas.microsoft.com/office/drawing/2014/main" id="{8F4638E7-CA8C-411D-BB62-228FA8250465}"/>
               </a:ext>
             </a:extLst>
           </p:cNvPr>
@@ -3045,7 +3045,7 @@
           <p:cNvPr id="35" name="">
             <a:extLst xmlns:a="http://schemas.openxmlformats.org/drawingml/2006/main">
               <a:ext uri="{FF2B5EF4-FFF2-40B4-BE49-F238E27FC236}">
-                <a16:creationId xmlns:a16="http://schemas.microsoft.com/office/drawing/2014/main" id="{E5BB13E0-B77A-4AC7-9EDA-4116423B62ED}"/>
+                <a16:creationId xmlns:a16="http://schemas.microsoft.com/office/drawing/2014/main" id="{06FD06CF-0EA4-4782-BA43-3D59219B1A2B}"/>
               </a:ext>
             </a:extLst>
           </p:cNvPr>
@@ -3102,7 +3102,7 @@
           <p:cNvPr id="36" name="">
             <a:extLst xmlns:a="http://schemas.openxmlformats.org/drawingml/2006/main">
               <a:ext uri="{FF2B5EF4-FFF2-40B4-BE49-F238E27FC236}">
-                <a16:creationId xmlns:a16="http://schemas.microsoft.com/office/drawing/2014/main" id="{774AE0F0-3D95-4CDF-88C3-FF54961668DA}"/>
+                <a16:creationId xmlns:a16="http://schemas.microsoft.com/office/drawing/2014/main" id="{E24F02DD-15F5-4B38-A181-0D611E472E9C}"/>
               </a:ext>
             </a:extLst>
           </p:cNvPr>
@@ -3159,7 +3159,7 @@
           <p:cNvPr id="37" name="">
             <a:extLst xmlns:a="http://schemas.openxmlformats.org/drawingml/2006/main">
               <a:ext uri="{FF2B5EF4-FFF2-40B4-BE49-F238E27FC236}">
-                <a16:creationId xmlns:a16="http://schemas.microsoft.com/office/drawing/2014/main" id="{491CCD93-4B70-4AD1-8FC3-4F32701E0817}"/>
+                <a16:creationId xmlns:a16="http://schemas.microsoft.com/office/drawing/2014/main" id="{EB6E78FA-FFE8-48BA-AFFA-126F8D10C330}"/>
               </a:ext>
             </a:extLst>
           </p:cNvPr>
@@ -3194,7 +3194,7 @@
           <p:cNvPr id="38" name="">
             <a:extLst xmlns:a="http://schemas.openxmlformats.org/drawingml/2006/main">
               <a:ext uri="{FF2B5EF4-FFF2-40B4-BE49-F238E27FC236}">
-                <a16:creationId xmlns:a16="http://schemas.microsoft.com/office/drawing/2014/main" id="{FCD1E1B3-B27A-43D8-9290-8DA883D2AA68}"/>
+                <a16:creationId xmlns:a16="http://schemas.microsoft.com/office/drawing/2014/main" id="{DF4C72DA-4488-489D-A4F2-418725C2B123}"/>
               </a:ext>
             </a:extLst>
           </p:cNvPr>
@@ -3258,7 +3258,7 @@
           <p:cNvPr id="39" name="">
             <a:extLst xmlns:a="http://schemas.openxmlformats.org/drawingml/2006/main">
               <a:ext uri="{FF2B5EF4-FFF2-40B4-BE49-F238E27FC236}">
-                <a16:creationId xmlns:a16="http://schemas.microsoft.com/office/drawing/2014/main" id="{5C519177-A95D-4B74-BB03-98D9F97C7234}"/>
+                <a16:creationId xmlns:a16="http://schemas.microsoft.com/office/drawing/2014/main" id="{EA5DCC1D-3ECC-44D8-B254-BB5060C85A59}"/>
               </a:ext>
             </a:extLst>
           </p:cNvPr>
@@ -3315,7 +3315,7 @@
           <p:cNvPr id="40" name="">
             <a:extLst xmlns:a="http://schemas.openxmlformats.org/drawingml/2006/main">
               <a:ext uri="{FF2B5EF4-FFF2-40B4-BE49-F238E27FC236}">
-                <a16:creationId xmlns:a16="http://schemas.microsoft.com/office/drawing/2014/main" id="{575FD67D-405D-4BCC-8C3E-830B078287C3}"/>
+                <a16:creationId xmlns:a16="http://schemas.microsoft.com/office/drawing/2014/main" id="{2973519E-DD51-45A7-A6BF-FD63A1DF2562}"/>
               </a:ext>
             </a:extLst>
           </p:cNvPr>
@@ -3372,7 +3372,7 @@
           <p:cNvPr id="41" name="">
             <a:extLst xmlns:a="http://schemas.openxmlformats.org/drawingml/2006/main">
               <a:ext uri="{FF2B5EF4-FFF2-40B4-BE49-F238E27FC236}">
-                <a16:creationId xmlns:a16="http://schemas.microsoft.com/office/drawing/2014/main" id="{6089AB8D-8879-446B-9D34-0732A08E68C5}"/>
+                <a16:creationId xmlns:a16="http://schemas.microsoft.com/office/drawing/2014/main" id="{6CED4958-FAC4-4027-AEA5-1F435BF90F6A}"/>
               </a:ext>
             </a:extLst>
           </p:cNvPr>
@@ -3407,7 +3407,7 @@
           <p:cNvPr id="42" name="">
             <a:extLst xmlns:a="http://schemas.openxmlformats.org/drawingml/2006/main">
               <a:ext uri="{FF2B5EF4-FFF2-40B4-BE49-F238E27FC236}">
-                <a16:creationId xmlns:a16="http://schemas.microsoft.com/office/drawing/2014/main" id="{DABDE7B5-586E-4333-9D00-D3A2578CF739}"/>
+                <a16:creationId xmlns:a16="http://schemas.microsoft.com/office/drawing/2014/main" id="{2041CF21-E7D5-421F-B393-C5D722FE8B2E}"/>
               </a:ext>
             </a:extLst>
           </p:cNvPr>
@@ -3471,7 +3471,7 @@
           <p:cNvPr id="43" name="">
             <a:extLst xmlns:a="http://schemas.openxmlformats.org/drawingml/2006/main">
               <a:ext uri="{FF2B5EF4-FFF2-40B4-BE49-F238E27FC236}">
-                <a16:creationId xmlns:a16="http://schemas.microsoft.com/office/drawing/2014/main" id="{9CEAF2EC-7446-4B95-A3FF-7339859A951A}"/>
+                <a16:creationId xmlns:a16="http://schemas.microsoft.com/office/drawing/2014/main" id="{84487992-0E04-40C2-936C-0C55F1176EDB}"/>
               </a:ext>
             </a:extLst>
           </p:cNvPr>
@@ -3528,7 +3528,7 @@
           <p:cNvPr id="44" name="">
             <a:extLst xmlns:a="http://schemas.openxmlformats.org/drawingml/2006/main">
               <a:ext uri="{FF2B5EF4-FFF2-40B4-BE49-F238E27FC236}">
-                <a16:creationId xmlns:a16="http://schemas.microsoft.com/office/drawing/2014/main" id="{E214BA73-7D10-4F48-8853-879DD092DA22}"/>
+                <a16:creationId xmlns:a16="http://schemas.microsoft.com/office/drawing/2014/main" id="{37980E84-FE43-4803-8EFD-B4F1972755FE}"/>
               </a:ext>
             </a:extLst>
           </p:cNvPr>
@@ -3585,7 +3585,7 @@
           <p:cNvPr id="45" name="">
             <a:extLst xmlns:a="http://schemas.openxmlformats.org/drawingml/2006/main">
               <a:ext uri="{FF2B5EF4-FFF2-40B4-BE49-F238E27FC236}">
-                <a16:creationId xmlns:a16="http://schemas.microsoft.com/office/drawing/2014/main" id="{CA55B00A-FB47-4386-82B2-E2AEAC29E6F8}"/>
+                <a16:creationId xmlns:a16="http://schemas.microsoft.com/office/drawing/2014/main" id="{857D9CB1-F4A2-487E-93E4-FB2364643F92}"/>
               </a:ext>
             </a:extLst>
           </p:cNvPr>
@@ -3642,7 +3642,7 @@
           <p:cNvPr id="46" name="">
             <a:extLst xmlns:a="http://schemas.openxmlformats.org/drawingml/2006/main">
               <a:ext uri="{FF2B5EF4-FFF2-40B4-BE49-F238E27FC236}">
-                <a16:creationId xmlns:a16="http://schemas.microsoft.com/office/drawing/2014/main" id="{AA24989F-D925-4AA0-9316-14B022F5D33F}"/>
+                <a16:creationId xmlns:a16="http://schemas.microsoft.com/office/drawing/2014/main" id="{90B4949D-662D-4811-B27D-25424623BE47}"/>
               </a:ext>
             </a:extLst>
           </p:cNvPr>
@@ -3697,7 +3697,7 @@
     </p:spTree>
     <p:extLst>
       <p:ext uri="{BB962C8B-B14F-4D97-AF65-F5344CB8AC3E}">
-        <p14:creationId xmlns:p14="http://schemas.microsoft.com/office/powerpoint/2010/main" val="68081013"/>
+        <p14:creationId xmlns:p14="http://schemas.microsoft.com/office/powerpoint/2010/main" val="416319040"/>
       </p:ext>
     </p:extLst>
   </p:cSld>
@@ -3728,7 +3728,7 @@
           <p:cNvPr id="46" name="">
             <a:extLst xmlns:a="http://schemas.openxmlformats.org/drawingml/2006/main">
               <a:ext uri="{FF2B5EF4-FFF2-40B4-BE49-F238E27FC236}">
-                <a16:creationId xmlns:a16="http://schemas.microsoft.com/office/drawing/2014/main" id="{D4B9596A-ACFB-4B30-82F6-318A41EBADE1}"/>
+                <a16:creationId xmlns:a16="http://schemas.microsoft.com/office/drawing/2014/main" id="{7E802ECC-373A-42B0-B680-77E7C3614F42}"/>
               </a:ext>
             </a:extLst>
           </p:cNvPr>
@@ -3785,7 +3785,7 @@
           <p:cNvPr id="2" name="">
             <a:extLst xmlns:a="http://schemas.openxmlformats.org/drawingml/2006/main">
               <a:ext uri="{FF2B5EF4-FFF2-40B4-BE49-F238E27FC236}">
-                <a16:creationId xmlns:a16="http://schemas.microsoft.com/office/drawing/2014/main" id="{CFAB7E73-EEBF-44F1-8E0C-D65FC33C2528}"/>
+                <a16:creationId xmlns:a16="http://schemas.microsoft.com/office/drawing/2014/main" id="{F24CD579-C03E-454F-8919-D5EDCEE73566}"/>
               </a:ext>
             </a:extLst>
           </p:cNvPr>
@@ -3842,7 +3842,7 @@
           <p:cNvPr id="3" name="">
             <a:extLst xmlns:a="http://schemas.openxmlformats.org/drawingml/2006/main">
               <a:ext uri="{FF2B5EF4-FFF2-40B4-BE49-F238E27FC236}">
-                <a16:creationId xmlns:a16="http://schemas.microsoft.com/office/drawing/2014/main" id="{9D277E5A-AB8F-43FD-AB08-4DFFB3DE6C11}"/>
+                <a16:creationId xmlns:a16="http://schemas.microsoft.com/office/drawing/2014/main" id="{BE1D70B6-D8CC-4940-BF57-EC7DAD3BB054}"/>
               </a:ext>
             </a:extLst>
           </p:cNvPr>
@@ -3899,7 +3899,7 @@
           <p:cNvPr id="4" name="">
             <a:extLst xmlns:a="http://schemas.openxmlformats.org/drawingml/2006/main">
               <a:ext uri="{FF2B5EF4-FFF2-40B4-BE49-F238E27FC236}">
-                <a16:creationId xmlns:a16="http://schemas.microsoft.com/office/drawing/2014/main" id="{6C5F7063-5080-42FF-B190-9B5044445E0E}"/>
+                <a16:creationId xmlns:a16="http://schemas.microsoft.com/office/drawing/2014/main" id="{65A23B33-E73D-47B5-AE71-DEEB9825487B}"/>
               </a:ext>
             </a:extLst>
           </p:cNvPr>
@@ -3930,7 +3930,7 @@
           <p:cNvPr id="5" name="">
             <a:extLst xmlns:a="http://schemas.openxmlformats.org/drawingml/2006/main">
               <a:ext uri="{FF2B5EF4-FFF2-40B4-BE49-F238E27FC236}">
-                <a16:creationId xmlns:a16="http://schemas.microsoft.com/office/drawing/2014/main" id="{F1769CFC-62EA-4504-92AA-02DB489E8265}"/>
+                <a16:creationId xmlns:a16="http://schemas.microsoft.com/office/drawing/2014/main" id="{01573BB9-1BE9-402A-A45E-A52553A9AD92}"/>
               </a:ext>
             </a:extLst>
           </p:cNvPr>
@@ -3965,7 +3965,7 @@
           <p:cNvPr id="6" name="">
             <a:extLst xmlns:a="http://schemas.openxmlformats.org/drawingml/2006/main">
               <a:ext uri="{FF2B5EF4-FFF2-40B4-BE49-F238E27FC236}">
-                <a16:creationId xmlns:a16="http://schemas.microsoft.com/office/drawing/2014/main" id="{8761DEC2-3F0F-46FF-99B5-B96CC43F1DD8}"/>
+                <a16:creationId xmlns:a16="http://schemas.microsoft.com/office/drawing/2014/main" id="{15968E68-0280-4CE9-9C48-38E3661A1D7A}"/>
               </a:ext>
             </a:extLst>
           </p:cNvPr>
@@ -4029,7 +4029,7 @@
           <p:cNvPr id="7" name="">
             <a:extLst xmlns:a="http://schemas.openxmlformats.org/drawingml/2006/main">
               <a:ext uri="{FF2B5EF4-FFF2-40B4-BE49-F238E27FC236}">
-                <a16:creationId xmlns:a16="http://schemas.microsoft.com/office/drawing/2014/main" id="{EA8A166E-1D9B-4172-91A8-B6040156C433}"/>
+                <a16:creationId xmlns:a16="http://schemas.microsoft.com/office/drawing/2014/main" id="{4F3885F4-454F-4AFA-8062-B03446D33710}"/>
               </a:ext>
             </a:extLst>
           </p:cNvPr>
@@ -4086,7 +4086,7 @@
           <p:cNvPr id="8" name="">
             <a:extLst xmlns:a="http://schemas.openxmlformats.org/drawingml/2006/main">
               <a:ext uri="{FF2B5EF4-FFF2-40B4-BE49-F238E27FC236}">
-                <a16:creationId xmlns:a16="http://schemas.microsoft.com/office/drawing/2014/main" id="{91053987-1B06-48FB-B06B-EC58FBD65D5E}"/>
+                <a16:creationId xmlns:a16="http://schemas.microsoft.com/office/drawing/2014/main" id="{27175CE0-7F7C-41B6-A19F-D010A0242FE2}"/>
               </a:ext>
             </a:extLst>
           </p:cNvPr>
@@ -4166,7 +4166,7 @@
           <p:cNvPr id="9" name="">
             <a:extLst xmlns:a="http://schemas.openxmlformats.org/drawingml/2006/main">
               <a:ext uri="{FF2B5EF4-FFF2-40B4-BE49-F238E27FC236}">
-                <a16:creationId xmlns:a16="http://schemas.microsoft.com/office/drawing/2014/main" id="{A6D65C4A-0956-48B6-A393-436213157112}"/>
+                <a16:creationId xmlns:a16="http://schemas.microsoft.com/office/drawing/2014/main" id="{63778FAF-03D0-49C6-8E7E-4F89F8DFDDCD}"/>
               </a:ext>
             </a:extLst>
           </p:cNvPr>
@@ -4198,7 +4198,7 @@
           <p:cNvPr id="10" name="">
             <a:extLst xmlns:a="http://schemas.openxmlformats.org/drawingml/2006/main">
               <a:ext uri="{FF2B5EF4-FFF2-40B4-BE49-F238E27FC236}">
-                <a16:creationId xmlns:a16="http://schemas.microsoft.com/office/drawing/2014/main" id="{4C549197-0F61-47D3-9F6F-B51B7581928A}"/>
+                <a16:creationId xmlns:a16="http://schemas.microsoft.com/office/drawing/2014/main" id="{FF0A932C-4074-48B0-89BE-288E6ED1AE45}"/>
               </a:ext>
             </a:extLst>
           </p:cNvPr>
@@ -4233,7 +4233,7 @@
           <p:cNvPr id="11" name="">
             <a:extLst xmlns:a="http://schemas.openxmlformats.org/drawingml/2006/main">
               <a:ext uri="{FF2B5EF4-FFF2-40B4-BE49-F238E27FC236}">
-                <a16:creationId xmlns:a16="http://schemas.microsoft.com/office/drawing/2014/main" id="{F1B3FB3E-A986-46E4-BE79-D751797AE5FB}"/>
+                <a16:creationId xmlns:a16="http://schemas.microsoft.com/office/drawing/2014/main" id="{3C11D6F7-32B6-44D8-958C-AE5A94F23C6C}"/>
               </a:ext>
             </a:extLst>
           </p:cNvPr>
@@ -4297,7 +4297,7 @@
           <p:cNvPr id="12" name="">
             <a:extLst xmlns:a="http://schemas.openxmlformats.org/drawingml/2006/main">
               <a:ext uri="{FF2B5EF4-FFF2-40B4-BE49-F238E27FC236}">
-                <a16:creationId xmlns:a16="http://schemas.microsoft.com/office/drawing/2014/main" id="{C618EBA9-DB33-4FF6-9572-772E90F141AE}"/>
+                <a16:creationId xmlns:a16="http://schemas.microsoft.com/office/drawing/2014/main" id="{1187DE3C-BC2C-43F8-82D6-5437A174C2F1}"/>
               </a:ext>
             </a:extLst>
           </p:cNvPr>
@@ -4354,7 +4354,7 @@
           <p:cNvPr id="13" name="">
             <a:extLst xmlns:a="http://schemas.openxmlformats.org/drawingml/2006/main">
               <a:ext uri="{FF2B5EF4-FFF2-40B4-BE49-F238E27FC236}">
-                <a16:creationId xmlns:a16="http://schemas.microsoft.com/office/drawing/2014/main" id="{91301CDA-E4BB-4DDD-B2B0-F610525F7BA5}"/>
+                <a16:creationId xmlns:a16="http://schemas.microsoft.com/office/drawing/2014/main" id="{23BBFD7B-1951-4D85-86C8-7C6E9A728447}"/>
               </a:ext>
             </a:extLst>
           </p:cNvPr>
@@ -4434,7 +4434,7 @@
           <p:cNvPr id="14" name="">
             <a:extLst xmlns:a="http://schemas.openxmlformats.org/drawingml/2006/main">
               <a:ext uri="{FF2B5EF4-FFF2-40B4-BE49-F238E27FC236}">
-                <a16:creationId xmlns:a16="http://schemas.microsoft.com/office/drawing/2014/main" id="{AEFD2BEA-A7E9-4216-84A6-9D1807C2ABBA}"/>
+                <a16:creationId xmlns:a16="http://schemas.microsoft.com/office/drawing/2014/main" id="{44CFBA01-E736-40BF-935E-406831F9DA11}"/>
               </a:ext>
             </a:extLst>
           </p:cNvPr>
@@ -4466,7 +4466,7 @@
           <p:cNvPr id="15" name="">
             <a:extLst xmlns:a="http://schemas.openxmlformats.org/drawingml/2006/main">
               <a:ext uri="{FF2B5EF4-FFF2-40B4-BE49-F238E27FC236}">
-                <a16:creationId xmlns:a16="http://schemas.microsoft.com/office/drawing/2014/main" id="{74509B0D-82D5-4EF8-9C95-7D037364E089}"/>
+                <a16:creationId xmlns:a16="http://schemas.microsoft.com/office/drawing/2014/main" id="{5F589F30-90CB-48DD-8009-01A59BA3B688}"/>
               </a:ext>
             </a:extLst>
           </p:cNvPr>
@@ -4501,7 +4501,7 @@
           <p:cNvPr id="16" name="">
             <a:extLst xmlns:a="http://schemas.openxmlformats.org/drawingml/2006/main">
               <a:ext uri="{FF2B5EF4-FFF2-40B4-BE49-F238E27FC236}">
-                <a16:creationId xmlns:a16="http://schemas.microsoft.com/office/drawing/2014/main" id="{A9EB2EF5-62EB-4C9D-B667-3595A667066E}"/>
+                <a16:creationId xmlns:a16="http://schemas.microsoft.com/office/drawing/2014/main" id="{91062955-965C-4D3E-8E4B-93167D6D133C}"/>
               </a:ext>
             </a:extLst>
           </p:cNvPr>
@@ -4565,7 +4565,7 @@
           <p:cNvPr id="17" name="">
             <a:extLst xmlns:a="http://schemas.openxmlformats.org/drawingml/2006/main">
               <a:ext uri="{FF2B5EF4-FFF2-40B4-BE49-F238E27FC236}">
-                <a16:creationId xmlns:a16="http://schemas.microsoft.com/office/drawing/2014/main" id="{FCC7C225-0D02-49AC-9463-51179AD459ED}"/>
+                <a16:creationId xmlns:a16="http://schemas.microsoft.com/office/drawing/2014/main" id="{26FDBE0E-F337-4DE8-8372-08161B3458A7}"/>
               </a:ext>
             </a:extLst>
           </p:cNvPr>
@@ -4622,7 +4622,7 @@
           <p:cNvPr id="18" name="">
             <a:extLst xmlns:a="http://schemas.openxmlformats.org/drawingml/2006/main">
               <a:ext uri="{FF2B5EF4-FFF2-40B4-BE49-F238E27FC236}">
-                <a16:creationId xmlns:a16="http://schemas.microsoft.com/office/drawing/2014/main" id="{86CDD257-F55F-4E98-A33E-6F19C2D5482F}"/>
+                <a16:creationId xmlns:a16="http://schemas.microsoft.com/office/drawing/2014/main" id="{FB7B9F2E-7BA9-465F-B9C4-294F9867B49F}"/>
               </a:ext>
             </a:extLst>
           </p:cNvPr>
@@ -4702,7 +4702,7 @@
           <p:cNvPr id="19" name="">
             <a:extLst xmlns:a="http://schemas.openxmlformats.org/drawingml/2006/main">
               <a:ext uri="{FF2B5EF4-FFF2-40B4-BE49-F238E27FC236}">
-                <a16:creationId xmlns:a16="http://schemas.microsoft.com/office/drawing/2014/main" id="{CC55D96E-5532-433B-B8E1-070B85B2DF3D}"/>
+                <a16:creationId xmlns:a16="http://schemas.microsoft.com/office/drawing/2014/main" id="{2C619651-87D1-4A12-BEF2-6290C141F090}"/>
               </a:ext>
             </a:extLst>
           </p:cNvPr>
@@ -4734,7 +4734,7 @@
           <p:cNvPr id="20" name="">
             <a:extLst xmlns:a="http://schemas.openxmlformats.org/drawingml/2006/main">
               <a:ext uri="{FF2B5EF4-FFF2-40B4-BE49-F238E27FC236}">
-                <a16:creationId xmlns:a16="http://schemas.microsoft.com/office/drawing/2014/main" id="{548C89ED-467A-4FA6-8D4B-C03764B57739}"/>
+                <a16:creationId xmlns:a16="http://schemas.microsoft.com/office/drawing/2014/main" id="{91AE2897-4949-4E65-8EA1-A270D16A0292}"/>
               </a:ext>
             </a:extLst>
           </p:cNvPr>
@@ -4769,7 +4769,7 @@
           <p:cNvPr id="21" name="">
             <a:extLst xmlns:a="http://schemas.openxmlformats.org/drawingml/2006/main">
               <a:ext uri="{FF2B5EF4-FFF2-40B4-BE49-F238E27FC236}">
-                <a16:creationId xmlns:a16="http://schemas.microsoft.com/office/drawing/2014/main" id="{DA23A4B7-A703-42DE-9645-F67AEA177F21}"/>
+                <a16:creationId xmlns:a16="http://schemas.microsoft.com/office/drawing/2014/main" id="{42E12128-1E45-43BC-92AB-057E9FA95243}"/>
               </a:ext>
             </a:extLst>
           </p:cNvPr>
@@ -4833,7 +4833,7 @@
           <p:cNvPr id="22" name="">
             <a:extLst xmlns:a="http://schemas.openxmlformats.org/drawingml/2006/main">
               <a:ext uri="{FF2B5EF4-FFF2-40B4-BE49-F238E27FC236}">
-                <a16:creationId xmlns:a16="http://schemas.microsoft.com/office/drawing/2014/main" id="{9151DFFC-6B1D-47A9-A522-C9EC409D3BCF}"/>
+                <a16:creationId xmlns:a16="http://schemas.microsoft.com/office/drawing/2014/main" id="{D0A9A8B6-9976-411F-B52C-C224FF1CCEAC}"/>
               </a:ext>
             </a:extLst>
           </p:cNvPr>
@@ -4890,7 +4890,7 @@
           <p:cNvPr id="23" name="">
             <a:extLst xmlns:a="http://schemas.openxmlformats.org/drawingml/2006/main">
               <a:ext uri="{FF2B5EF4-FFF2-40B4-BE49-F238E27FC236}">
-                <a16:creationId xmlns:a16="http://schemas.microsoft.com/office/drawing/2014/main" id="{C0CBA39B-7B02-4D70-B012-180E69EC2D0F}"/>
+                <a16:creationId xmlns:a16="http://schemas.microsoft.com/office/drawing/2014/main" id="{73EDB0B8-28DF-4A8D-9920-F3B1A5765A20}"/>
               </a:ext>
             </a:extLst>
           </p:cNvPr>
@@ -4970,7 +4970,7 @@
           <p:cNvPr id="24" name="">
             <a:extLst xmlns:a="http://schemas.openxmlformats.org/drawingml/2006/main">
               <a:ext uri="{FF2B5EF4-FFF2-40B4-BE49-F238E27FC236}">
-                <a16:creationId xmlns:a16="http://schemas.microsoft.com/office/drawing/2014/main" id="{098A2526-0EE8-4F1B-96BF-A15BD7FC93CC}"/>
+                <a16:creationId xmlns:a16="http://schemas.microsoft.com/office/drawing/2014/main" id="{40BFAF53-B046-4A71-B1CF-122914E0FF55}"/>
               </a:ext>
             </a:extLst>
           </p:cNvPr>
@@ -5002,7 +5002,7 @@
           <p:cNvPr id="25" name="">
             <a:extLst xmlns:a="http://schemas.openxmlformats.org/drawingml/2006/main">
               <a:ext uri="{FF2B5EF4-FFF2-40B4-BE49-F238E27FC236}">
-                <a16:creationId xmlns:a16="http://schemas.microsoft.com/office/drawing/2014/main" id="{7B690CEB-0DE9-4F5B-9D90-B58F95C12BF8}"/>
+                <a16:creationId xmlns:a16="http://schemas.microsoft.com/office/drawing/2014/main" id="{B7C73259-140A-4D02-9810-04F6B31FA975}"/>
               </a:ext>
             </a:extLst>
           </p:cNvPr>
@@ -5037,7 +5037,7 @@
           <p:cNvPr id="26" name="">
             <a:extLst xmlns:a="http://schemas.openxmlformats.org/drawingml/2006/main">
               <a:ext uri="{FF2B5EF4-FFF2-40B4-BE49-F238E27FC236}">
-                <a16:creationId xmlns:a16="http://schemas.microsoft.com/office/drawing/2014/main" id="{3C8FFA90-2DC4-4E0D-8E2A-EF8A809A8290}"/>
+                <a16:creationId xmlns:a16="http://schemas.microsoft.com/office/drawing/2014/main" id="{355E3971-1628-49FC-8FA9-3C53C3669577}"/>
               </a:ext>
             </a:extLst>
           </p:cNvPr>
@@ -5101,7 +5101,7 @@
           <p:cNvPr id="27" name="">
             <a:extLst xmlns:a="http://schemas.openxmlformats.org/drawingml/2006/main">
               <a:ext uri="{FF2B5EF4-FFF2-40B4-BE49-F238E27FC236}">
-                <a16:creationId xmlns:a16="http://schemas.microsoft.com/office/drawing/2014/main" id="{2EDA0258-2049-4213-96C3-A6EB28EC4E37}"/>
+                <a16:creationId xmlns:a16="http://schemas.microsoft.com/office/drawing/2014/main" id="{7642EACD-5E6E-40C3-9BF7-5EECFA0897C6}"/>
               </a:ext>
             </a:extLst>
           </p:cNvPr>
@@ -5158,7 +5158,7 @@
           <p:cNvPr id="28" name="">
             <a:extLst xmlns:a="http://schemas.openxmlformats.org/drawingml/2006/main">
               <a:ext uri="{FF2B5EF4-FFF2-40B4-BE49-F238E27FC236}">
-                <a16:creationId xmlns:a16="http://schemas.microsoft.com/office/drawing/2014/main" id="{8E4610CD-7308-409D-806A-0B553AE876F9}"/>
+                <a16:creationId xmlns:a16="http://schemas.microsoft.com/office/drawing/2014/main" id="{A4AFED9E-499D-49BC-91A6-D103D38D20F6}"/>
               </a:ext>
             </a:extLst>
           </p:cNvPr>
@@ -5238,7 +5238,7 @@
           <p:cNvPr id="29" name="">
             <a:extLst xmlns:a="http://schemas.openxmlformats.org/drawingml/2006/main">
               <a:ext uri="{FF2B5EF4-FFF2-40B4-BE49-F238E27FC236}">
-                <a16:creationId xmlns:a16="http://schemas.microsoft.com/office/drawing/2014/main" id="{404664C9-AE3C-4002-93FE-54C18BEF3D43}"/>
+                <a16:creationId xmlns:a16="http://schemas.microsoft.com/office/drawing/2014/main" id="{665D29DB-1DA6-4E38-98B4-DC1D49FCD933}"/>
               </a:ext>
             </a:extLst>
           </p:cNvPr>
@@ -5295,7 +5295,7 @@
           <p:cNvPr id="30" name="">
             <a:extLst xmlns:a="http://schemas.openxmlformats.org/drawingml/2006/main">
               <a:ext uri="{FF2B5EF4-FFF2-40B4-BE49-F238E27FC236}">
-                <a16:creationId xmlns:a16="http://schemas.microsoft.com/office/drawing/2014/main" id="{B39E6EF8-13E2-4B9A-A5C4-10855B98C228}"/>
+                <a16:creationId xmlns:a16="http://schemas.microsoft.com/office/drawing/2014/main" id="{DDC9FF5D-D129-4B63-938B-D4BF580121FB}"/>
               </a:ext>
             </a:extLst>
           </p:cNvPr>
@@ -5330,7 +5330,7 @@
           <p:cNvPr id="31" name="">
             <a:extLst xmlns:a="http://schemas.openxmlformats.org/drawingml/2006/main">
               <a:ext uri="{FF2B5EF4-FFF2-40B4-BE49-F238E27FC236}">
-                <a16:creationId xmlns:a16="http://schemas.microsoft.com/office/drawing/2014/main" id="{7BA8CE2C-D2BA-4DFB-8689-AFBCCAA670BE}"/>
+                <a16:creationId xmlns:a16="http://schemas.microsoft.com/office/drawing/2014/main" id="{BA63295E-E847-41D2-83EA-0117CF9DA70E}"/>
               </a:ext>
             </a:extLst>
           </p:cNvPr>
@@ -5387,7 +5387,7 @@
           <p:cNvPr id="32" name="">
             <a:extLst xmlns:a="http://schemas.openxmlformats.org/drawingml/2006/main">
               <a:ext uri="{FF2B5EF4-FFF2-40B4-BE49-F238E27FC236}">
-                <a16:creationId xmlns:a16="http://schemas.microsoft.com/office/drawing/2014/main" id="{A0AF5824-A3A7-4258-9F48-BE6B93A62C6B}"/>
+                <a16:creationId xmlns:a16="http://schemas.microsoft.com/office/drawing/2014/main" id="{F26D6E69-2F47-47CA-AF97-6CB1DFAAEA89}"/>
               </a:ext>
             </a:extLst>
           </p:cNvPr>
@@ -5490,7 +5490,7 @@
           <p:cNvPr id="33" name="">
             <a:extLst xmlns:a="http://schemas.openxmlformats.org/drawingml/2006/main">
               <a:ext uri="{FF2B5EF4-FFF2-40B4-BE49-F238E27FC236}">
-                <a16:creationId xmlns:a16="http://schemas.microsoft.com/office/drawing/2014/main" id="{80DDC9C6-8C0F-40DB-91D7-7C9387F79182}"/>
+                <a16:creationId xmlns:a16="http://schemas.microsoft.com/office/drawing/2014/main" id="{F9DFE736-B81B-4629-8D26-CD9276E7CD51}"/>
               </a:ext>
             </a:extLst>
           </p:cNvPr>
@@ -5554,7 +5554,7 @@
           <p:cNvPr id="34" name="">
             <a:extLst xmlns:a="http://schemas.openxmlformats.org/drawingml/2006/main">
               <a:ext uri="{FF2B5EF4-FFF2-40B4-BE49-F238E27FC236}">
-                <a16:creationId xmlns:a16="http://schemas.microsoft.com/office/drawing/2014/main" id="{4674333A-2DEA-47AF-8260-739B6BF8612C}"/>
+                <a16:creationId xmlns:a16="http://schemas.microsoft.com/office/drawing/2014/main" id="{B94F9699-62BD-448F-A797-F597159A65DE}"/>
               </a:ext>
             </a:extLst>
           </p:cNvPr>
@@ -5611,7 +5611,7 @@
           <p:cNvPr id="35" name="">
             <a:extLst xmlns:a="http://schemas.openxmlformats.org/drawingml/2006/main">
               <a:ext uri="{FF2B5EF4-FFF2-40B4-BE49-F238E27FC236}">
-                <a16:creationId xmlns:a16="http://schemas.microsoft.com/office/drawing/2014/main" id="{46896355-91E3-48F4-B0E9-82F22B532A78}"/>
+                <a16:creationId xmlns:a16="http://schemas.microsoft.com/office/drawing/2014/main" id="{E0B317D6-A12D-4020-ABE6-5517B17619ED}"/>
               </a:ext>
             </a:extLst>
           </p:cNvPr>
@@ -5646,7 +5646,7 @@
           <p:cNvPr id="36" name="">
             <a:extLst xmlns:a="http://schemas.openxmlformats.org/drawingml/2006/main">
               <a:ext uri="{FF2B5EF4-FFF2-40B4-BE49-F238E27FC236}">
-                <a16:creationId xmlns:a16="http://schemas.microsoft.com/office/drawing/2014/main" id="{A7D320F2-D5E8-4D46-965D-746A69088FCE}"/>
+                <a16:creationId xmlns:a16="http://schemas.microsoft.com/office/drawing/2014/main" id="{42E7069D-D9E5-4857-BA11-3A8B279DF0EA}"/>
               </a:ext>
             </a:extLst>
           </p:cNvPr>
@@ -5703,7 +5703,7 @@
           <p:cNvPr id="37" name="">
             <a:extLst xmlns:a="http://schemas.openxmlformats.org/drawingml/2006/main">
               <a:ext uri="{FF2B5EF4-FFF2-40B4-BE49-F238E27FC236}">
-                <a16:creationId xmlns:a16="http://schemas.microsoft.com/office/drawing/2014/main" id="{6EE05417-D43F-419D-85B5-D0C0C1A896AF}"/>
+                <a16:creationId xmlns:a16="http://schemas.microsoft.com/office/drawing/2014/main" id="{0249DD5F-1F0A-46AB-8C8D-127D647BBAC9}"/>
               </a:ext>
             </a:extLst>
           </p:cNvPr>
@@ -5738,7 +5738,7 @@
           <p:cNvPr id="38" name="">
             <a:extLst xmlns:a="http://schemas.openxmlformats.org/drawingml/2006/main">
               <a:ext uri="{FF2B5EF4-FFF2-40B4-BE49-F238E27FC236}">
-                <a16:creationId xmlns:a16="http://schemas.microsoft.com/office/drawing/2014/main" id="{4B168846-1339-4E68-B5F9-69407056D1AC}"/>
+                <a16:creationId xmlns:a16="http://schemas.microsoft.com/office/drawing/2014/main" id="{7FF2B915-358E-4067-9BC2-23930135456C}"/>
               </a:ext>
             </a:extLst>
           </p:cNvPr>
@@ -5795,7 +5795,7 @@
           <p:cNvPr id="39" name="">
             <a:extLst xmlns:a="http://schemas.openxmlformats.org/drawingml/2006/main">
               <a:ext uri="{FF2B5EF4-FFF2-40B4-BE49-F238E27FC236}">
-                <a16:creationId xmlns:a16="http://schemas.microsoft.com/office/drawing/2014/main" id="{899ACCD5-002F-43DD-98F6-23C224B05534}"/>
+                <a16:creationId xmlns:a16="http://schemas.microsoft.com/office/drawing/2014/main" id="{DB40092D-1288-4BF8-85E0-103AE12073DA}"/>
               </a:ext>
             </a:extLst>
           </p:cNvPr>
@@ -5852,7 +5852,7 @@
           <p:cNvPr id="40" name="">
             <a:extLst xmlns:a="http://schemas.openxmlformats.org/drawingml/2006/main">
               <a:ext uri="{FF2B5EF4-FFF2-40B4-BE49-F238E27FC236}">
-                <a16:creationId xmlns:a16="http://schemas.microsoft.com/office/drawing/2014/main" id="{0DD775EC-C59F-4D27-BAEC-4F00354F6C1D}"/>
+                <a16:creationId xmlns:a16="http://schemas.microsoft.com/office/drawing/2014/main" id="{4F119F92-EBC7-4885-971E-E01A47BBAFB1}"/>
               </a:ext>
             </a:extLst>
           </p:cNvPr>
@@ -5887,7 +5887,7 @@
           <p:cNvPr id="41" name="">
             <a:extLst xmlns:a="http://schemas.openxmlformats.org/drawingml/2006/main">
               <a:ext uri="{FF2B5EF4-FFF2-40B4-BE49-F238E27FC236}">
-                <a16:creationId xmlns:a16="http://schemas.microsoft.com/office/drawing/2014/main" id="{D704BADF-A857-4A06-A26C-985BF5ADE377}"/>
+                <a16:creationId xmlns:a16="http://schemas.microsoft.com/office/drawing/2014/main" id="{B780295E-1FD9-482C-B86D-5136BA4A9A13}"/>
               </a:ext>
             </a:extLst>
           </p:cNvPr>
@@ -5944,7 +5944,7 @@
           <p:cNvPr id="42" name="">
             <a:extLst xmlns:a="http://schemas.openxmlformats.org/drawingml/2006/main">
               <a:ext uri="{FF2B5EF4-FFF2-40B4-BE49-F238E27FC236}">
-                <a16:creationId xmlns:a16="http://schemas.microsoft.com/office/drawing/2014/main" id="{14DEF5A2-7656-41E6-BF54-54AE0EDAE4B0}"/>
+                <a16:creationId xmlns:a16="http://schemas.microsoft.com/office/drawing/2014/main" id="{C01860C4-1723-455B-ACF7-F81205ADE25F}"/>
               </a:ext>
             </a:extLst>
           </p:cNvPr>
@@ -6001,7 +6001,7 @@
           <p:cNvPr id="43" name="">
             <a:extLst xmlns:a="http://schemas.openxmlformats.org/drawingml/2006/main">
               <a:ext uri="{FF2B5EF4-FFF2-40B4-BE49-F238E27FC236}">
-                <a16:creationId xmlns:a16="http://schemas.microsoft.com/office/drawing/2014/main" id="{F03BCA15-7847-44E9-9471-2F6459CEB920}"/>
+                <a16:creationId xmlns:a16="http://schemas.microsoft.com/office/drawing/2014/main" id="{B6731A43-A0EC-41C7-B6B8-DD53797E244E}"/>
               </a:ext>
             </a:extLst>
           </p:cNvPr>
@@ -6058,7 +6058,7 @@
           <p:cNvPr id="44" name="">
             <a:extLst xmlns:a="http://schemas.openxmlformats.org/drawingml/2006/main">
               <a:ext uri="{FF2B5EF4-FFF2-40B4-BE49-F238E27FC236}">
-                <a16:creationId xmlns:a16="http://schemas.microsoft.com/office/drawing/2014/main" id="{5984B83B-8701-4BD1-9565-38452AF219D4}"/>
+                <a16:creationId xmlns:a16="http://schemas.microsoft.com/office/drawing/2014/main" id="{C8FA0309-35E6-4D40-8D9C-231CE4673112}"/>
               </a:ext>
             </a:extLst>
           </p:cNvPr>
@@ -6115,7 +6115,7 @@
           <p:cNvPr id="45" name="">
             <a:extLst xmlns:a="http://schemas.openxmlformats.org/drawingml/2006/main">
               <a:ext uri="{FF2B5EF4-FFF2-40B4-BE49-F238E27FC236}">
-                <a16:creationId xmlns:a16="http://schemas.microsoft.com/office/drawing/2014/main" id="{A346D776-68E1-4A3D-81C1-A918F6A4751A}"/>
+                <a16:creationId xmlns:a16="http://schemas.microsoft.com/office/drawing/2014/main" id="{534B01D5-253B-49F3-831C-685E91FCD057}"/>
               </a:ext>
             </a:extLst>
           </p:cNvPr>
@@ -6170,7 +6170,7 @@
     </p:spTree>
     <p:extLst>
       <p:ext uri="{BB962C8B-B14F-4D97-AF65-F5344CB8AC3E}">
-        <p14:creationId xmlns:p14="http://schemas.microsoft.com/office/powerpoint/2010/main" val="14046063"/>
+        <p14:creationId xmlns:p14="http://schemas.microsoft.com/office/powerpoint/2010/main" val="2131015304"/>
       </p:ext>
     </p:extLst>
   </p:cSld>
@@ -6201,7 +6201,7 @@
           <p:cNvPr id="32" name="">
             <a:extLst xmlns:a="http://schemas.openxmlformats.org/drawingml/2006/main">
               <a:ext uri="{FF2B5EF4-FFF2-40B4-BE49-F238E27FC236}">
-                <a16:creationId xmlns:a16="http://schemas.microsoft.com/office/drawing/2014/main" id="{02B20103-BF75-4212-8D31-B600E082DA4A}"/>
+                <a16:creationId xmlns:a16="http://schemas.microsoft.com/office/drawing/2014/main" id="{3504F7A3-2F76-420B-A56A-9E3A7DD1C09A}"/>
               </a:ext>
             </a:extLst>
           </p:cNvPr>
@@ -6258,7 +6258,7 @@
           <p:cNvPr id="2" name="">
             <a:extLst xmlns:a="http://schemas.openxmlformats.org/drawingml/2006/main">
               <a:ext uri="{FF2B5EF4-FFF2-40B4-BE49-F238E27FC236}">
-                <a16:creationId xmlns:a16="http://schemas.microsoft.com/office/drawing/2014/main" id="{17107F9E-17BC-4F18-B0F6-DFCF49BF1D30}"/>
+                <a16:creationId xmlns:a16="http://schemas.microsoft.com/office/drawing/2014/main" id="{01A41E1A-AF42-4F0A-BE13-EC78643208CC}"/>
               </a:ext>
             </a:extLst>
           </p:cNvPr>
@@ -6315,7 +6315,7 @@
           <p:cNvPr id="3" name="">
             <a:extLst xmlns:a="http://schemas.openxmlformats.org/drawingml/2006/main">
               <a:ext uri="{FF2B5EF4-FFF2-40B4-BE49-F238E27FC236}">
-                <a16:creationId xmlns:a16="http://schemas.microsoft.com/office/drawing/2014/main" id="{E25A8C2B-1826-4766-82CD-3179179C33C6}"/>
+                <a16:creationId xmlns:a16="http://schemas.microsoft.com/office/drawing/2014/main" id="{73045061-BC94-4238-901A-9C2134B04B72}"/>
               </a:ext>
             </a:extLst>
           </p:cNvPr>
@@ -6372,7 +6372,7 @@
           <p:cNvPr id="4" name="">
             <a:extLst xmlns:a="http://schemas.openxmlformats.org/drawingml/2006/main">
               <a:ext uri="{FF2B5EF4-FFF2-40B4-BE49-F238E27FC236}">
-                <a16:creationId xmlns:a16="http://schemas.microsoft.com/office/drawing/2014/main" id="{D72E2632-C683-4B06-B302-C2F7670F1355}"/>
+                <a16:creationId xmlns:a16="http://schemas.microsoft.com/office/drawing/2014/main" id="{22656E99-79B4-47B4-BCAB-686D787A8981}"/>
               </a:ext>
             </a:extLst>
           </p:cNvPr>
@@ -6403,7 +6403,7 @@
           <p:cNvPr id="5" name="">
             <a:extLst xmlns:a="http://schemas.openxmlformats.org/drawingml/2006/main">
               <a:ext uri="{FF2B5EF4-FFF2-40B4-BE49-F238E27FC236}">
-                <a16:creationId xmlns:a16="http://schemas.microsoft.com/office/drawing/2014/main" id="{94DC86BC-15B3-48FC-81C2-62E579DAAB4E}"/>
+                <a16:creationId xmlns:a16="http://schemas.microsoft.com/office/drawing/2014/main" id="{6629C8E7-C1AB-4DB4-94DA-904FB750B07E}"/>
               </a:ext>
             </a:extLst>
           </p:cNvPr>
@@ -6438,7 +6438,7 @@
           <p:cNvPr id="6" name="">
             <a:extLst xmlns:a="http://schemas.openxmlformats.org/drawingml/2006/main">
               <a:ext uri="{FF2B5EF4-FFF2-40B4-BE49-F238E27FC236}">
-                <a16:creationId xmlns:a16="http://schemas.microsoft.com/office/drawing/2014/main" id="{8355226A-18A4-479E-B03E-4AF88FD35ECC}"/>
+                <a16:creationId xmlns:a16="http://schemas.microsoft.com/office/drawing/2014/main" id="{AF00511E-1668-4D77-B6F0-2CC183976EB9}"/>
               </a:ext>
             </a:extLst>
           </p:cNvPr>
@@ -6502,7 +6502,7 @@
           <p:cNvPr id="7" name="">
             <a:extLst xmlns:a="http://schemas.openxmlformats.org/drawingml/2006/main">
               <a:ext uri="{FF2B5EF4-FFF2-40B4-BE49-F238E27FC236}">
-                <a16:creationId xmlns:a16="http://schemas.microsoft.com/office/drawing/2014/main" id="{7CFB0FD9-BF37-4B36-8092-B5DEB8912914}"/>
+                <a16:creationId xmlns:a16="http://schemas.microsoft.com/office/drawing/2014/main" id="{8B3028CA-D038-42E8-A8DB-85FFEBF71B99}"/>
               </a:ext>
             </a:extLst>
           </p:cNvPr>
@@ -6559,7 +6559,7 @@
           <p:cNvPr id="8" name="">
             <a:extLst xmlns:a="http://schemas.openxmlformats.org/drawingml/2006/main">
               <a:ext uri="{FF2B5EF4-FFF2-40B4-BE49-F238E27FC236}">
-                <a16:creationId xmlns:a16="http://schemas.microsoft.com/office/drawing/2014/main" id="{2B7ECABD-2E1B-4F0B-BA42-2717D2FF3A95}"/>
+                <a16:creationId xmlns:a16="http://schemas.microsoft.com/office/drawing/2014/main" id="{9BB0372E-E65E-4FCB-BA5C-14FDCDBBAF9A}"/>
               </a:ext>
             </a:extLst>
           </p:cNvPr>
@@ -6662,7 +6662,7 @@
           <p:cNvPr id="9" name="">
             <a:extLst xmlns:a="http://schemas.openxmlformats.org/drawingml/2006/main">
               <a:ext uri="{FF2B5EF4-FFF2-40B4-BE49-F238E27FC236}">
-                <a16:creationId xmlns:a16="http://schemas.microsoft.com/office/drawing/2014/main" id="{A8E1F485-8DEA-42F0-ABE4-A97A28CE82E9}"/>
+                <a16:creationId xmlns:a16="http://schemas.microsoft.com/office/drawing/2014/main" id="{106B82A9-C42E-4853-AEC9-912EE927198B}"/>
               </a:ext>
             </a:extLst>
           </p:cNvPr>
@@ -6697,7 +6697,7 @@
           <p:cNvPr id="10" name="">
             <a:extLst xmlns:a="http://schemas.openxmlformats.org/drawingml/2006/main">
               <a:ext uri="{FF2B5EF4-FFF2-40B4-BE49-F238E27FC236}">
-                <a16:creationId xmlns:a16="http://schemas.microsoft.com/office/drawing/2014/main" id="{8F9625D2-9C82-4DB7-9216-A242297E0EDE}"/>
+                <a16:creationId xmlns:a16="http://schemas.microsoft.com/office/drawing/2014/main" id="{06DBA6A5-8C91-4925-9A7E-AE42749B916B}"/>
               </a:ext>
             </a:extLst>
           </p:cNvPr>
@@ -6761,7 +6761,7 @@
           <p:cNvPr id="11" name="">
             <a:extLst xmlns:a="http://schemas.openxmlformats.org/drawingml/2006/main">
               <a:ext uri="{FF2B5EF4-FFF2-40B4-BE49-F238E27FC236}">
-                <a16:creationId xmlns:a16="http://schemas.microsoft.com/office/drawing/2014/main" id="{B5D0135D-488B-418D-BBE8-E05AA7A96E2C}"/>
+                <a16:creationId xmlns:a16="http://schemas.microsoft.com/office/drawing/2014/main" id="{535CCC4A-6630-424A-96B4-FF2599991BFB}"/>
               </a:ext>
             </a:extLst>
           </p:cNvPr>
@@ -6818,7 +6818,7 @@
           <p:cNvPr id="12" name="">
             <a:extLst xmlns:a="http://schemas.openxmlformats.org/drawingml/2006/main">
               <a:ext uri="{FF2B5EF4-FFF2-40B4-BE49-F238E27FC236}">
-                <a16:creationId xmlns:a16="http://schemas.microsoft.com/office/drawing/2014/main" id="{F3074DA7-5473-455E-B6F8-0AB9A3397E31}"/>
+                <a16:creationId xmlns:a16="http://schemas.microsoft.com/office/drawing/2014/main" id="{A40F1A27-DBBB-48AB-8A52-DEA1C27FAB9E}"/>
               </a:ext>
             </a:extLst>
           </p:cNvPr>
@@ -6921,7 +6921,7 @@
           <p:cNvPr id="13" name="">
             <a:extLst xmlns:a="http://schemas.openxmlformats.org/drawingml/2006/main">
               <a:ext uri="{FF2B5EF4-FFF2-40B4-BE49-F238E27FC236}">
-                <a16:creationId xmlns:a16="http://schemas.microsoft.com/office/drawing/2014/main" id="{8B946FFC-C1CE-4AB1-890D-E21372C44B72}"/>
+                <a16:creationId xmlns:a16="http://schemas.microsoft.com/office/drawing/2014/main" id="{65D84DA2-A149-41DF-95D0-E56474AA7A4A}"/>
               </a:ext>
             </a:extLst>
           </p:cNvPr>
@@ -6978,7 +6978,7 @@
           <p:cNvPr id="14" name="">
             <a:extLst xmlns:a="http://schemas.openxmlformats.org/drawingml/2006/main">
               <a:ext uri="{FF2B5EF4-FFF2-40B4-BE49-F238E27FC236}">
-                <a16:creationId xmlns:a16="http://schemas.microsoft.com/office/drawing/2014/main" id="{9CC72FD0-989C-433D-9CEF-792BC34F8AFB}"/>
+                <a16:creationId xmlns:a16="http://schemas.microsoft.com/office/drawing/2014/main" id="{01E665D7-D0E6-4007-8744-59ACEF841FF3}"/>
               </a:ext>
             </a:extLst>
           </p:cNvPr>
@@ -7013,7 +7013,7 @@
           <p:cNvPr id="15" name="">
             <a:extLst xmlns:a="http://schemas.openxmlformats.org/drawingml/2006/main">
               <a:ext uri="{FF2B5EF4-FFF2-40B4-BE49-F238E27FC236}">
-                <a16:creationId xmlns:a16="http://schemas.microsoft.com/office/drawing/2014/main" id="{31183644-02D1-4A68-97CD-C04305689435}"/>
+                <a16:creationId xmlns:a16="http://schemas.microsoft.com/office/drawing/2014/main" id="{2044DFEC-7276-4D69-89D6-29DEA923E440}"/>
               </a:ext>
             </a:extLst>
           </p:cNvPr>
@@ -7070,7 +7070,7 @@
           <p:cNvPr id="16" name="">
             <a:extLst xmlns:a="http://schemas.openxmlformats.org/drawingml/2006/main">
               <a:ext uri="{FF2B5EF4-FFF2-40B4-BE49-F238E27FC236}">
-                <a16:creationId xmlns:a16="http://schemas.microsoft.com/office/drawing/2014/main" id="{C8CF8808-38F2-4443-97C1-0F3409A6DCF1}"/>
+                <a16:creationId xmlns:a16="http://schemas.microsoft.com/office/drawing/2014/main" id="{FE8CBCF1-8AA6-4174-8D12-5497A850BA45}"/>
               </a:ext>
             </a:extLst>
           </p:cNvPr>
@@ -7127,7 +7127,7 @@
           <p:cNvPr id="17" name="">
             <a:extLst xmlns:a="http://schemas.openxmlformats.org/drawingml/2006/main">
               <a:ext uri="{FF2B5EF4-FFF2-40B4-BE49-F238E27FC236}">
-                <a16:creationId xmlns:a16="http://schemas.microsoft.com/office/drawing/2014/main" id="{0761174A-4109-4D8E-84B2-F40C334C0491}"/>
+                <a16:creationId xmlns:a16="http://schemas.microsoft.com/office/drawing/2014/main" id="{8C53D0DF-6BFE-468D-8F41-86EF26422C73}"/>
               </a:ext>
             </a:extLst>
           </p:cNvPr>
@@ -7162,7 +7162,7 @@
           <p:cNvPr id="18" name="">
             <a:extLst xmlns:a="http://schemas.openxmlformats.org/drawingml/2006/main">
               <a:ext uri="{FF2B5EF4-FFF2-40B4-BE49-F238E27FC236}">
-                <a16:creationId xmlns:a16="http://schemas.microsoft.com/office/drawing/2014/main" id="{99CCE02D-431F-4A6C-B1CC-6AFE41750883}"/>
+                <a16:creationId xmlns:a16="http://schemas.microsoft.com/office/drawing/2014/main" id="{1E61C449-B78E-43CD-B152-BD31B372511B}"/>
               </a:ext>
             </a:extLst>
           </p:cNvPr>
@@ -7209,7 +7209,7 @@
                 <a:ea typeface="Arial"/>
                 <a:cs typeface="Arial"/>
               </a:rPr>
-              <a:t>25/25</a:t>
+              <a:t>15/15</a:t>
             </a:r>
           </a:p>
         </p:txBody>
@@ -7219,7 +7219,7 @@
           <p:cNvPr id="19" name="">
             <a:extLst xmlns:a="http://schemas.openxmlformats.org/drawingml/2006/main">
               <a:ext uri="{FF2B5EF4-FFF2-40B4-BE49-F238E27FC236}">
-                <a16:creationId xmlns:a16="http://schemas.microsoft.com/office/drawing/2014/main" id="{543A5F7D-F769-43B4-A3A7-1284519C01CD}"/>
+                <a16:creationId xmlns:a16="http://schemas.microsoft.com/office/drawing/2014/main" id="{C3C0AFDA-624D-4A9A-8543-2E49F9E86FB9}"/>
               </a:ext>
             </a:extLst>
           </p:cNvPr>
@@ -7266,7 +7266,7 @@
                 <a:ea typeface="Arial"/>
                 <a:cs typeface="Arial"/>
               </a:rPr>
-              <a:t>5 batch Ollama</a:t>
+              <a:t>3 batch OpenRouter</a:t>
             </a:r>
           </a:p>
         </p:txBody>
@@ -7276,7 +7276,7 @@
           <p:cNvPr id="20" name="">
             <a:extLst xmlns:a="http://schemas.openxmlformats.org/drawingml/2006/main">
               <a:ext uri="{FF2B5EF4-FFF2-40B4-BE49-F238E27FC236}">
-                <a16:creationId xmlns:a16="http://schemas.microsoft.com/office/drawing/2014/main" id="{84C9A89F-877F-47A9-9410-AEF7F0927855}"/>
+                <a16:creationId xmlns:a16="http://schemas.microsoft.com/office/drawing/2014/main" id="{8E01DEAC-6B75-4AF6-AF90-E5684E04CC50}"/>
               </a:ext>
             </a:extLst>
           </p:cNvPr>
@@ -7311,7 +7311,7 @@
           <p:cNvPr id="21" name="">
             <a:extLst xmlns:a="http://schemas.openxmlformats.org/drawingml/2006/main">
               <a:ext uri="{FF2B5EF4-FFF2-40B4-BE49-F238E27FC236}">
-                <a16:creationId xmlns:a16="http://schemas.microsoft.com/office/drawing/2014/main" id="{6202FE67-2BA9-403C-BA6C-FF6633C21998}"/>
+                <a16:creationId xmlns:a16="http://schemas.microsoft.com/office/drawing/2014/main" id="{94FCDB9C-107F-46C4-AF04-88EFD7072ECA}"/>
               </a:ext>
             </a:extLst>
           </p:cNvPr>
@@ -7358,7 +7358,7 @@
                 <a:ea typeface="Arial"/>
                 <a:cs typeface="Arial"/>
               </a:rPr>
-              <a:t>15</a:t>
+              <a:t>25/25</a:t>
             </a:r>
           </a:p>
         </p:txBody>
@@ -7368,7 +7368,7 @@
           <p:cNvPr id="22" name="">
             <a:extLst xmlns:a="http://schemas.openxmlformats.org/drawingml/2006/main">
               <a:ext uri="{FF2B5EF4-FFF2-40B4-BE49-F238E27FC236}">
-                <a16:creationId xmlns:a16="http://schemas.microsoft.com/office/drawing/2014/main" id="{760EE61B-9BD4-4D3A-8975-78F9FB2F6F28}"/>
+                <a16:creationId xmlns:a16="http://schemas.microsoft.com/office/drawing/2014/main" id="{49B8D79A-8C8A-4C76-A14E-250607C466D1}"/>
               </a:ext>
             </a:extLst>
           </p:cNvPr>
@@ -7415,7 +7415,7 @@
                 <a:ea typeface="Arial"/>
                 <a:cs typeface="Arial"/>
               </a:rPr>
-              <a:t>ca BGK khóa</a:t>
+              <a:t>5 batch Ollama</a:t>
             </a:r>
           </a:p>
         </p:txBody>
@@ -7425,7 +7425,7 @@
           <p:cNvPr id="23" name="">
             <a:extLst xmlns:a="http://schemas.openxmlformats.org/drawingml/2006/main">
               <a:ext uri="{FF2B5EF4-FFF2-40B4-BE49-F238E27FC236}">
-                <a16:creationId xmlns:a16="http://schemas.microsoft.com/office/drawing/2014/main" id="{ED9D1E60-3C74-429F-AAE1-3EE23505A03D}"/>
+                <a16:creationId xmlns:a16="http://schemas.microsoft.com/office/drawing/2014/main" id="{6B5E69AE-8C06-4A46-BA82-70D36BA9D3BB}"/>
               </a:ext>
             </a:extLst>
           </p:cNvPr>
@@ -7460,7 +7460,7 @@
           <p:cNvPr id="24" name="">
             <a:extLst xmlns:a="http://schemas.openxmlformats.org/drawingml/2006/main">
               <a:ext uri="{FF2B5EF4-FFF2-40B4-BE49-F238E27FC236}">
-                <a16:creationId xmlns:a16="http://schemas.microsoft.com/office/drawing/2014/main" id="{F84B0A42-D1A4-4629-A02D-512100CF8466}"/>
+                <a16:creationId xmlns:a16="http://schemas.microsoft.com/office/drawing/2014/main" id="{2F80F450-4304-439F-84C0-B6CBDA47D51C}"/>
               </a:ext>
             </a:extLst>
           </p:cNvPr>
@@ -7517,7 +7517,7 @@
           <p:cNvPr id="25" name="">
             <a:extLst xmlns:a="http://schemas.openxmlformats.org/drawingml/2006/main">
               <a:ext uri="{FF2B5EF4-FFF2-40B4-BE49-F238E27FC236}">
-                <a16:creationId xmlns:a16="http://schemas.microsoft.com/office/drawing/2014/main" id="{F7FFBD06-7521-4902-BA19-F2FD0D83086B}"/>
+                <a16:creationId xmlns:a16="http://schemas.microsoft.com/office/drawing/2014/main" id="{E540E6C2-4A73-43F6-8125-40951B0D85B6}"/>
               </a:ext>
             </a:extLst>
           </p:cNvPr>
@@ -7581,7 +7581,7 @@
           <p:cNvPr id="26" name="">
             <a:extLst xmlns:a="http://schemas.openxmlformats.org/drawingml/2006/main">
               <a:ext uri="{FF2B5EF4-FFF2-40B4-BE49-F238E27FC236}">
-                <a16:creationId xmlns:a16="http://schemas.microsoft.com/office/drawing/2014/main" id="{22F4A38A-EF93-45D9-AB53-916E5EA8A119}"/>
+                <a16:creationId xmlns:a16="http://schemas.microsoft.com/office/drawing/2014/main" id="{F199BDD5-70CF-434A-A89D-C93F8DEF4A82}"/>
               </a:ext>
             </a:extLst>
           </p:cNvPr>
@@ -7645,7 +7645,7 @@
           <p:cNvPr id="27" name="">
             <a:extLst xmlns:a="http://schemas.openxmlformats.org/drawingml/2006/main">
               <a:ext uri="{FF2B5EF4-FFF2-40B4-BE49-F238E27FC236}">
-                <a16:creationId xmlns:a16="http://schemas.microsoft.com/office/drawing/2014/main" id="{DA0DA986-F1D2-4C71-984C-A4A3688417B5}"/>
+                <a16:creationId xmlns:a16="http://schemas.microsoft.com/office/drawing/2014/main" id="{20490585-706B-4A53-8A9C-81DF11292FC1}"/>
               </a:ext>
             </a:extLst>
           </p:cNvPr>
@@ -7709,7 +7709,7 @@
           <p:cNvPr id="28" name="">
             <a:extLst xmlns:a="http://schemas.openxmlformats.org/drawingml/2006/main">
               <a:ext uri="{FF2B5EF4-FFF2-40B4-BE49-F238E27FC236}">
-                <a16:creationId xmlns:a16="http://schemas.microsoft.com/office/drawing/2014/main" id="{F6632851-0F1C-4D10-97EE-AF6448D0EA5E}"/>
+                <a16:creationId xmlns:a16="http://schemas.microsoft.com/office/drawing/2014/main" id="{A818FDF6-44AE-4EC5-BC55-4907C9FC1D96}"/>
               </a:ext>
             </a:extLst>
           </p:cNvPr>
@@ -7773,7 +7773,7 @@
           <p:cNvPr id="29" name="">
             <a:extLst xmlns:a="http://schemas.openxmlformats.org/drawingml/2006/main">
               <a:ext uri="{FF2B5EF4-FFF2-40B4-BE49-F238E27FC236}">
-                <a16:creationId xmlns:a16="http://schemas.microsoft.com/office/drawing/2014/main" id="{DC7FCF29-64B1-4204-B6FB-56A2C6FB7621}"/>
+                <a16:creationId xmlns:a16="http://schemas.microsoft.com/office/drawing/2014/main" id="{77037A80-CE8E-4FCD-8408-D37C63CC8632}"/>
               </a:ext>
             </a:extLst>
           </p:cNvPr>
@@ -7830,7 +7830,7 @@
           <p:cNvPr id="30" name="">
             <a:extLst xmlns:a="http://schemas.openxmlformats.org/drawingml/2006/main">
               <a:ext uri="{FF2B5EF4-FFF2-40B4-BE49-F238E27FC236}">
-                <a16:creationId xmlns:a16="http://schemas.microsoft.com/office/drawing/2014/main" id="{A594575D-1F67-4199-98D6-FF29354A2677}"/>
+                <a16:creationId xmlns:a16="http://schemas.microsoft.com/office/drawing/2014/main" id="{104A2776-443E-4891-908E-02FBA3ADAB2C}"/>
               </a:ext>
             </a:extLst>
           </p:cNvPr>
@@ -7887,7 +7887,7 @@
           <p:cNvPr id="31" name="">
             <a:extLst xmlns:a="http://schemas.openxmlformats.org/drawingml/2006/main">
               <a:ext uri="{FF2B5EF4-FFF2-40B4-BE49-F238E27FC236}">
-                <a16:creationId xmlns:a16="http://schemas.microsoft.com/office/drawing/2014/main" id="{510B1184-EC26-4BE8-90FE-117A67BEEB08}"/>
+                <a16:creationId xmlns:a16="http://schemas.microsoft.com/office/drawing/2014/main" id="{2C8C706C-B032-4DB7-AC53-740A2C0FDC00}"/>
               </a:ext>
             </a:extLst>
           </p:cNvPr>
@@ -7942,7 +7942,7 @@
     </p:spTree>
     <p:extLst>
       <p:ext uri="{BB962C8B-B14F-4D97-AF65-F5344CB8AC3E}">
-        <p14:creationId xmlns:p14="http://schemas.microsoft.com/office/powerpoint/2010/main" val="770262610"/>
+        <p14:creationId xmlns:p14="http://schemas.microsoft.com/office/powerpoint/2010/main" val="1457455713"/>
       </p:ext>
     </p:extLst>
   </p:cSld>
@@ -7973,7 +7973,7 @@
           <p:cNvPr id="32" name="">
             <a:extLst xmlns:a="http://schemas.openxmlformats.org/drawingml/2006/main">
               <a:ext uri="{FF2B5EF4-FFF2-40B4-BE49-F238E27FC236}">
-                <a16:creationId xmlns:a16="http://schemas.microsoft.com/office/drawing/2014/main" id="{5B340970-7A24-4A98-A4A7-8DBFD5E16795}"/>
+                <a16:creationId xmlns:a16="http://schemas.microsoft.com/office/drawing/2014/main" id="{3DA78FEF-08FD-4D8A-8723-3876DCDAAC38}"/>
               </a:ext>
             </a:extLst>
           </p:cNvPr>
@@ -8030,7 +8030,7 @@
           <p:cNvPr id="2" name="">
             <a:extLst xmlns:a="http://schemas.openxmlformats.org/drawingml/2006/main">
               <a:ext uri="{FF2B5EF4-FFF2-40B4-BE49-F238E27FC236}">
-                <a16:creationId xmlns:a16="http://schemas.microsoft.com/office/drawing/2014/main" id="{9D3A1660-F0C4-4B0D-97B6-DCC795CC9C44}"/>
+                <a16:creationId xmlns:a16="http://schemas.microsoft.com/office/drawing/2014/main" id="{4F235510-CBF4-41DC-8227-DEB812991213}"/>
               </a:ext>
             </a:extLst>
           </p:cNvPr>
@@ -8087,7 +8087,7 @@
           <p:cNvPr id="3" name="">
             <a:extLst xmlns:a="http://schemas.openxmlformats.org/drawingml/2006/main">
               <a:ext uri="{FF2B5EF4-FFF2-40B4-BE49-F238E27FC236}">
-                <a16:creationId xmlns:a16="http://schemas.microsoft.com/office/drawing/2014/main" id="{911B0C07-3014-42E6-8FF3-A4D74ACF9A14}"/>
+                <a16:creationId xmlns:a16="http://schemas.microsoft.com/office/drawing/2014/main" id="{C77168F9-1984-4706-A6BF-9FA71991A501}"/>
               </a:ext>
             </a:extLst>
           </p:cNvPr>
@@ -8144,7 +8144,7 @@
           <p:cNvPr id="4" name="">
             <a:extLst xmlns:a="http://schemas.openxmlformats.org/drawingml/2006/main">
               <a:ext uri="{FF2B5EF4-FFF2-40B4-BE49-F238E27FC236}">
-                <a16:creationId xmlns:a16="http://schemas.microsoft.com/office/drawing/2014/main" id="{551D5184-F4E9-46CF-B612-A527A60605BC}"/>
+                <a16:creationId xmlns:a16="http://schemas.microsoft.com/office/drawing/2014/main" id="{EF530EA7-86BB-40F3-8669-CBCA376251EC}"/>
               </a:ext>
             </a:extLst>
           </p:cNvPr>
@@ -8175,7 +8175,7 @@
           <p:cNvPr id="5" name="">
             <a:extLst xmlns:a="http://schemas.openxmlformats.org/drawingml/2006/main">
               <a:ext uri="{FF2B5EF4-FFF2-40B4-BE49-F238E27FC236}">
-                <a16:creationId xmlns:a16="http://schemas.microsoft.com/office/drawing/2014/main" id="{C59DCDDE-EFE0-4A3D-BFED-2510D424C5B2}"/>
+                <a16:creationId xmlns:a16="http://schemas.microsoft.com/office/drawing/2014/main" id="{36D60BD5-A756-4D3E-B9BC-673D520A018A}"/>
               </a:ext>
             </a:extLst>
           </p:cNvPr>
@@ -8210,7 +8210,7 @@
           <p:cNvPr id="6" name="">
             <a:extLst xmlns:a="http://schemas.openxmlformats.org/drawingml/2006/main">
               <a:ext uri="{FF2B5EF4-FFF2-40B4-BE49-F238E27FC236}">
-                <a16:creationId xmlns:a16="http://schemas.microsoft.com/office/drawing/2014/main" id="{C049B5B7-4943-4D61-B4EC-588324C81CDF}"/>
+                <a16:creationId xmlns:a16="http://schemas.microsoft.com/office/drawing/2014/main" id="{CA4CDE98-8457-4E8F-BC5B-178E42C06B44}"/>
               </a:ext>
             </a:extLst>
           </p:cNvPr>
@@ -8274,7 +8274,7 @@
           <p:cNvPr id="7" name="">
             <a:extLst xmlns:a="http://schemas.openxmlformats.org/drawingml/2006/main">
               <a:ext uri="{FF2B5EF4-FFF2-40B4-BE49-F238E27FC236}">
-                <a16:creationId xmlns:a16="http://schemas.microsoft.com/office/drawing/2014/main" id="{EB267D78-7C88-4167-86FB-8F6E372A3A1B}"/>
+                <a16:creationId xmlns:a16="http://schemas.microsoft.com/office/drawing/2014/main" id="{C68315EB-FD75-45DF-9B55-6DB24B43A1F1}"/>
               </a:ext>
             </a:extLst>
           </p:cNvPr>
@@ -8331,7 +8331,7 @@
           <p:cNvPr id="8" name="">
             <a:extLst xmlns:a="http://schemas.openxmlformats.org/drawingml/2006/main">
               <a:ext uri="{FF2B5EF4-FFF2-40B4-BE49-F238E27FC236}">
-                <a16:creationId xmlns:a16="http://schemas.microsoft.com/office/drawing/2014/main" id="{60C06941-A5CC-4FC0-82A0-D10696F8272C}"/>
+                <a16:creationId xmlns:a16="http://schemas.microsoft.com/office/drawing/2014/main" id="{25AACF48-8451-4D11-B4B9-5BC0AC012ECC}"/>
               </a:ext>
             </a:extLst>
           </p:cNvPr>
@@ -8362,7 +8362,7 @@
           <p:cNvPr id="9" name="">
             <a:extLst xmlns:a="http://schemas.openxmlformats.org/drawingml/2006/main">
               <a:ext uri="{FF2B5EF4-FFF2-40B4-BE49-F238E27FC236}">
-                <a16:creationId xmlns:a16="http://schemas.microsoft.com/office/drawing/2014/main" id="{39286934-4012-44B2-8228-11F0CFB5D415}"/>
+                <a16:creationId xmlns:a16="http://schemas.microsoft.com/office/drawing/2014/main" id="{47C6CB81-A60F-4C6E-8661-CE5EB5B10ADA}"/>
               </a:ext>
             </a:extLst>
           </p:cNvPr>
@@ -8397,7 +8397,7 @@
           <p:cNvPr id="10" name="">
             <a:extLst xmlns:a="http://schemas.openxmlformats.org/drawingml/2006/main">
               <a:ext uri="{FF2B5EF4-FFF2-40B4-BE49-F238E27FC236}">
-                <a16:creationId xmlns:a16="http://schemas.microsoft.com/office/drawing/2014/main" id="{49161385-B2C7-45CD-A1AF-B199C45281E2}"/>
+                <a16:creationId xmlns:a16="http://schemas.microsoft.com/office/drawing/2014/main" id="{6AE48849-5B38-43EA-8C7B-D21CD5F19119}"/>
               </a:ext>
             </a:extLst>
           </p:cNvPr>
@@ -8461,7 +8461,7 @@
           <p:cNvPr id="11" name="">
             <a:extLst xmlns:a="http://schemas.openxmlformats.org/drawingml/2006/main">
               <a:ext uri="{FF2B5EF4-FFF2-40B4-BE49-F238E27FC236}">
-                <a16:creationId xmlns:a16="http://schemas.microsoft.com/office/drawing/2014/main" id="{90EB1B26-B677-4BEA-B826-8942F391FE14}"/>
+                <a16:creationId xmlns:a16="http://schemas.microsoft.com/office/drawing/2014/main" id="{BB738590-826D-45ED-B5EB-2D0A5806AC5D}"/>
               </a:ext>
             </a:extLst>
           </p:cNvPr>
@@ -8518,7 +8518,7 @@
           <p:cNvPr id="12" name="">
             <a:extLst xmlns:a="http://schemas.openxmlformats.org/drawingml/2006/main">
               <a:ext uri="{FF2B5EF4-FFF2-40B4-BE49-F238E27FC236}">
-                <a16:creationId xmlns:a16="http://schemas.microsoft.com/office/drawing/2014/main" id="{FA1D0147-1F6F-4CBC-9F8A-BAA9FBC7780E}"/>
+                <a16:creationId xmlns:a16="http://schemas.microsoft.com/office/drawing/2014/main" id="{6612A2ED-6EB3-4CB1-98E9-33A666DE0AE5}"/>
               </a:ext>
             </a:extLst>
           </p:cNvPr>
@@ -8549,7 +8549,7 @@
           <p:cNvPr id="13" name="">
             <a:extLst xmlns:a="http://schemas.openxmlformats.org/drawingml/2006/main">
               <a:ext uri="{FF2B5EF4-FFF2-40B4-BE49-F238E27FC236}">
-                <a16:creationId xmlns:a16="http://schemas.microsoft.com/office/drawing/2014/main" id="{3D70BBF3-9F15-4568-B0F8-B90B52838444}"/>
+                <a16:creationId xmlns:a16="http://schemas.microsoft.com/office/drawing/2014/main" id="{5CF6B5F1-A5B9-414D-9612-07EAEA1E6437}"/>
               </a:ext>
             </a:extLst>
           </p:cNvPr>
@@ -8584,7 +8584,7 @@
           <p:cNvPr id="14" name="">
             <a:extLst xmlns:a="http://schemas.openxmlformats.org/drawingml/2006/main">
               <a:ext uri="{FF2B5EF4-FFF2-40B4-BE49-F238E27FC236}">
-                <a16:creationId xmlns:a16="http://schemas.microsoft.com/office/drawing/2014/main" id="{25EA2A5F-6A7C-4F4C-97C6-51031759BAE0}"/>
+                <a16:creationId xmlns:a16="http://schemas.microsoft.com/office/drawing/2014/main" id="{19B0D017-8F6B-49A2-8DA5-646171535E80}"/>
               </a:ext>
             </a:extLst>
           </p:cNvPr>
@@ -8648,7 +8648,7 @@
           <p:cNvPr id="15" name="">
             <a:extLst xmlns:a="http://schemas.openxmlformats.org/drawingml/2006/main">
               <a:ext uri="{FF2B5EF4-FFF2-40B4-BE49-F238E27FC236}">
-                <a16:creationId xmlns:a16="http://schemas.microsoft.com/office/drawing/2014/main" id="{38DA81CD-5AF6-4CD9-B546-393DC90C1145}"/>
+                <a16:creationId xmlns:a16="http://schemas.microsoft.com/office/drawing/2014/main" id="{FC9A2A95-F035-4528-AE25-B16A601A339E}"/>
               </a:ext>
             </a:extLst>
           </p:cNvPr>
@@ -8705,7 +8705,7 @@
           <p:cNvPr id="16" name="">
             <a:extLst xmlns:a="http://schemas.openxmlformats.org/drawingml/2006/main">
               <a:ext uri="{FF2B5EF4-FFF2-40B4-BE49-F238E27FC236}">
-                <a16:creationId xmlns:a16="http://schemas.microsoft.com/office/drawing/2014/main" id="{7E9C5076-807E-45E7-AA9C-4397FF7DC2BB}"/>
+                <a16:creationId xmlns:a16="http://schemas.microsoft.com/office/drawing/2014/main" id="{0667DF3B-CD5B-43CB-9FAB-75D8A1BBAFF9}"/>
               </a:ext>
             </a:extLst>
           </p:cNvPr>
@@ -8736,7 +8736,7 @@
           <p:cNvPr id="17" name="">
             <a:extLst xmlns:a="http://schemas.openxmlformats.org/drawingml/2006/main">
               <a:ext uri="{FF2B5EF4-FFF2-40B4-BE49-F238E27FC236}">
-                <a16:creationId xmlns:a16="http://schemas.microsoft.com/office/drawing/2014/main" id="{78A5F205-97A8-4ADA-A06D-85322C2C4C7C}"/>
+                <a16:creationId xmlns:a16="http://schemas.microsoft.com/office/drawing/2014/main" id="{E83AF7AB-98CC-495B-9552-A3FD812BAF12}"/>
               </a:ext>
             </a:extLst>
           </p:cNvPr>
@@ -8771,7 +8771,7 @@
           <p:cNvPr id="18" name="">
             <a:extLst xmlns:a="http://schemas.openxmlformats.org/drawingml/2006/main">
               <a:ext uri="{FF2B5EF4-FFF2-40B4-BE49-F238E27FC236}">
-                <a16:creationId xmlns:a16="http://schemas.microsoft.com/office/drawing/2014/main" id="{4FD87AB8-FB4B-4150-A3CE-D307CEDABC46}"/>
+                <a16:creationId xmlns:a16="http://schemas.microsoft.com/office/drawing/2014/main" id="{0EC2E14E-A952-4A45-8269-5094BBD88D21}"/>
               </a:ext>
             </a:extLst>
           </p:cNvPr>
@@ -8835,7 +8835,7 @@
           <p:cNvPr id="19" name="">
             <a:extLst xmlns:a="http://schemas.openxmlformats.org/drawingml/2006/main">
               <a:ext uri="{FF2B5EF4-FFF2-40B4-BE49-F238E27FC236}">
-                <a16:creationId xmlns:a16="http://schemas.microsoft.com/office/drawing/2014/main" id="{242AD7FE-A3C0-4F3A-98C4-09135A254AC1}"/>
+                <a16:creationId xmlns:a16="http://schemas.microsoft.com/office/drawing/2014/main" id="{443411D9-0F07-40E2-B212-1B21FCFF86B3}"/>
               </a:ext>
             </a:extLst>
           </p:cNvPr>
@@ -8892,7 +8892,7 @@
           <p:cNvPr id="20" name="">
             <a:extLst xmlns:a="http://schemas.openxmlformats.org/drawingml/2006/main">
               <a:ext uri="{FF2B5EF4-FFF2-40B4-BE49-F238E27FC236}">
-                <a16:creationId xmlns:a16="http://schemas.microsoft.com/office/drawing/2014/main" id="{C5B3005C-09FA-4BE6-8FD8-9CAAF9D903A0}"/>
+                <a16:creationId xmlns:a16="http://schemas.microsoft.com/office/drawing/2014/main" id="{5BAEDB39-4BDB-4B7D-9AB1-0CD046993D7D}"/>
               </a:ext>
             </a:extLst>
           </p:cNvPr>
@@ -8927,7 +8927,7 @@
           <p:cNvPr id="21" name="">
             <a:extLst xmlns:a="http://schemas.openxmlformats.org/drawingml/2006/main">
               <a:ext uri="{FF2B5EF4-FFF2-40B4-BE49-F238E27FC236}">
-                <a16:creationId xmlns:a16="http://schemas.microsoft.com/office/drawing/2014/main" id="{81FC778F-DA6A-4B74-8531-9944B68358E6}"/>
+                <a16:creationId xmlns:a16="http://schemas.microsoft.com/office/drawing/2014/main" id="{36DEA40F-5B20-4244-BF39-2BBDEF93C0C3}"/>
               </a:ext>
             </a:extLst>
           </p:cNvPr>
@@ -8984,7 +8984,7 @@
           <p:cNvPr id="22" name="">
             <a:extLst xmlns:a="http://schemas.openxmlformats.org/drawingml/2006/main">
               <a:ext uri="{FF2B5EF4-FFF2-40B4-BE49-F238E27FC236}">
-                <a16:creationId xmlns:a16="http://schemas.microsoft.com/office/drawing/2014/main" id="{8781FFC0-ACD6-4CD4-BFFB-02EE9E5FC42F}"/>
+                <a16:creationId xmlns:a16="http://schemas.microsoft.com/office/drawing/2014/main" id="{61F297BD-D5D0-4C06-B3BE-F6009441621B}"/>
               </a:ext>
             </a:extLst>
           </p:cNvPr>
@@ -9041,7 +9041,7 @@
           <p:cNvPr id="23" name="">
             <a:extLst xmlns:a="http://schemas.openxmlformats.org/drawingml/2006/main">
               <a:ext uri="{FF2B5EF4-FFF2-40B4-BE49-F238E27FC236}">
-                <a16:creationId xmlns:a16="http://schemas.microsoft.com/office/drawing/2014/main" id="{0F419EE2-0F80-461F-8D21-874238285321}"/>
+                <a16:creationId xmlns:a16="http://schemas.microsoft.com/office/drawing/2014/main" id="{1AAA9614-9A11-49A8-9FBB-D00445399814}"/>
               </a:ext>
             </a:extLst>
           </p:cNvPr>
@@ -9076,7 +9076,7 @@
           <p:cNvPr id="24" name="">
             <a:extLst xmlns:a="http://schemas.openxmlformats.org/drawingml/2006/main">
               <a:ext uri="{FF2B5EF4-FFF2-40B4-BE49-F238E27FC236}">
-                <a16:creationId xmlns:a16="http://schemas.microsoft.com/office/drawing/2014/main" id="{70A95F56-A51C-425C-BD2C-F6339DA4A02B}"/>
+                <a16:creationId xmlns:a16="http://schemas.microsoft.com/office/drawing/2014/main" id="{0EA8CA72-7D03-4CB3-95BD-09F601B0031F}"/>
               </a:ext>
             </a:extLst>
           </p:cNvPr>
@@ -9140,7 +9140,7 @@
           <p:cNvPr id="25" name="">
             <a:extLst xmlns:a="http://schemas.openxmlformats.org/drawingml/2006/main">
               <a:ext uri="{FF2B5EF4-FFF2-40B4-BE49-F238E27FC236}">
-                <a16:creationId xmlns:a16="http://schemas.microsoft.com/office/drawing/2014/main" id="{C98DB958-11F3-43BE-90D5-2ACB1B6A081F}"/>
+                <a16:creationId xmlns:a16="http://schemas.microsoft.com/office/drawing/2014/main" id="{1F9352B5-3460-45BB-B1A2-E106119EE4D7}"/>
               </a:ext>
             </a:extLst>
           </p:cNvPr>
@@ -9266,7 +9266,7 @@
           <p:cNvPr id="26" name="">
             <a:extLst xmlns:a="http://schemas.openxmlformats.org/drawingml/2006/main">
               <a:ext uri="{FF2B5EF4-FFF2-40B4-BE49-F238E27FC236}">
-                <a16:creationId xmlns:a16="http://schemas.microsoft.com/office/drawing/2014/main" id="{2A8D8AC5-2D4A-430A-BA30-AFD344E966EE}"/>
+                <a16:creationId xmlns:a16="http://schemas.microsoft.com/office/drawing/2014/main" id="{D2CB3B77-5C4F-4113-B3A7-39761D77801A}"/>
               </a:ext>
             </a:extLst>
           </p:cNvPr>
@@ -9301,7 +9301,7 @@
           <p:cNvPr id="27" name="">
             <a:extLst xmlns:a="http://schemas.openxmlformats.org/drawingml/2006/main">
               <a:ext uri="{FF2B5EF4-FFF2-40B4-BE49-F238E27FC236}">
-                <a16:creationId xmlns:a16="http://schemas.microsoft.com/office/drawing/2014/main" id="{9139B6B6-AE3C-4D07-A063-9221CE6360E7}"/>
+                <a16:creationId xmlns:a16="http://schemas.microsoft.com/office/drawing/2014/main" id="{C38EEC69-430A-4914-BE76-003DAC458BDB}"/>
               </a:ext>
             </a:extLst>
           </p:cNvPr>
@@ -9365,7 +9365,7 @@
           <p:cNvPr id="28" name="">
             <a:extLst xmlns:a="http://schemas.openxmlformats.org/drawingml/2006/main">
               <a:ext uri="{FF2B5EF4-FFF2-40B4-BE49-F238E27FC236}">
-                <a16:creationId xmlns:a16="http://schemas.microsoft.com/office/drawing/2014/main" id="{9E0F677F-A47F-49F1-9E0B-81671C45FA0F}"/>
+                <a16:creationId xmlns:a16="http://schemas.microsoft.com/office/drawing/2014/main" id="{1BE608E0-9C47-4E89-8ABF-501A718F3523}"/>
               </a:ext>
             </a:extLst>
           </p:cNvPr>
@@ -9468,7 +9468,7 @@
           <p:cNvPr id="29" name="">
             <a:extLst xmlns:a="http://schemas.openxmlformats.org/drawingml/2006/main">
               <a:ext uri="{FF2B5EF4-FFF2-40B4-BE49-F238E27FC236}">
-                <a16:creationId xmlns:a16="http://schemas.microsoft.com/office/drawing/2014/main" id="{CB9CB659-4190-422B-BA69-22962A00637D}"/>
+                <a16:creationId xmlns:a16="http://schemas.microsoft.com/office/drawing/2014/main" id="{81792C32-48B4-4AED-B5FF-45E55E2FA2D4}"/>
               </a:ext>
             </a:extLst>
           </p:cNvPr>
@@ -9548,7 +9548,7 @@
           <p:cNvPr id="30" name="">
             <a:extLst xmlns:a="http://schemas.openxmlformats.org/drawingml/2006/main">
               <a:ext uri="{FF2B5EF4-FFF2-40B4-BE49-F238E27FC236}">
-                <a16:creationId xmlns:a16="http://schemas.microsoft.com/office/drawing/2014/main" id="{D0DC51BD-DA53-4668-BE0D-FC372F5D9887}"/>
+                <a16:creationId xmlns:a16="http://schemas.microsoft.com/office/drawing/2014/main" id="{C46CF95A-C15A-417B-B0D4-A336C0F21F0B}"/>
               </a:ext>
             </a:extLst>
           </p:cNvPr>
@@ -9605,7 +9605,7 @@
           <p:cNvPr id="31" name="">
             <a:extLst xmlns:a="http://schemas.openxmlformats.org/drawingml/2006/main">
               <a:ext uri="{FF2B5EF4-FFF2-40B4-BE49-F238E27FC236}">
-                <a16:creationId xmlns:a16="http://schemas.microsoft.com/office/drawing/2014/main" id="{69C39D5C-91DD-49E7-A178-97B9C255644C}"/>
+                <a16:creationId xmlns:a16="http://schemas.microsoft.com/office/drawing/2014/main" id="{8C85143F-9E1C-41E1-8443-3AD9D571B0FA}"/>
               </a:ext>
             </a:extLst>
           </p:cNvPr>
@@ -9660,7 +9660,7 @@
     </p:spTree>
     <p:extLst>
       <p:ext uri="{BB962C8B-B14F-4D97-AF65-F5344CB8AC3E}">
-        <p14:creationId xmlns:p14="http://schemas.microsoft.com/office/powerpoint/2010/main" val="59728221"/>
+        <p14:creationId xmlns:p14="http://schemas.microsoft.com/office/powerpoint/2010/main" val="1065899052"/>
       </p:ext>
     </p:extLst>
   </p:cSld>
@@ -9691,7 +9691,7 @@
           <p:cNvPr id="36" name="">
             <a:extLst xmlns:a="http://schemas.openxmlformats.org/drawingml/2006/main">
               <a:ext uri="{FF2B5EF4-FFF2-40B4-BE49-F238E27FC236}">
-                <a16:creationId xmlns:a16="http://schemas.microsoft.com/office/drawing/2014/main" id="{87C060AB-DD9F-4137-A5A2-1E0C454E5610}"/>
+                <a16:creationId xmlns:a16="http://schemas.microsoft.com/office/drawing/2014/main" id="{F46BC1A3-A202-49F7-A76C-17BB98AE7794}"/>
               </a:ext>
             </a:extLst>
           </p:cNvPr>
@@ -9748,7 +9748,7 @@
           <p:cNvPr id="2" name="">
             <a:extLst xmlns:a="http://schemas.openxmlformats.org/drawingml/2006/main">
               <a:ext uri="{FF2B5EF4-FFF2-40B4-BE49-F238E27FC236}">
-                <a16:creationId xmlns:a16="http://schemas.microsoft.com/office/drawing/2014/main" id="{3AAD56FD-EA6C-4953-A605-29206D7ECBA7}"/>
+                <a16:creationId xmlns:a16="http://schemas.microsoft.com/office/drawing/2014/main" id="{6DAD5CAC-4806-4D2E-B01B-60525667E280}"/>
               </a:ext>
             </a:extLst>
           </p:cNvPr>
@@ -9805,7 +9805,7 @@
           <p:cNvPr id="3" name="">
             <a:extLst xmlns:a="http://schemas.openxmlformats.org/drawingml/2006/main">
               <a:ext uri="{FF2B5EF4-FFF2-40B4-BE49-F238E27FC236}">
-                <a16:creationId xmlns:a16="http://schemas.microsoft.com/office/drawing/2014/main" id="{8A5C203C-AA62-4B2A-BF5E-68C130C62136}"/>
+                <a16:creationId xmlns:a16="http://schemas.microsoft.com/office/drawing/2014/main" id="{E477D522-A3F4-4989-8D8A-A17918728C63}"/>
               </a:ext>
             </a:extLst>
           </p:cNvPr>
@@ -9862,7 +9862,7 @@
           <p:cNvPr id="4" name="">
             <a:extLst xmlns:a="http://schemas.openxmlformats.org/drawingml/2006/main">
               <a:ext uri="{FF2B5EF4-FFF2-40B4-BE49-F238E27FC236}">
-                <a16:creationId xmlns:a16="http://schemas.microsoft.com/office/drawing/2014/main" id="{B4184025-C3AD-481F-B1E2-52A20429DE0C}"/>
+                <a16:creationId xmlns:a16="http://schemas.microsoft.com/office/drawing/2014/main" id="{0DD3BD9C-E364-43DE-A80B-E402AC29E646}"/>
               </a:ext>
             </a:extLst>
           </p:cNvPr>
@@ -9893,7 +9893,7 @@
           <p:cNvPr id="5" name="">
             <a:extLst xmlns:a="http://schemas.openxmlformats.org/drawingml/2006/main">
               <a:ext uri="{FF2B5EF4-FFF2-40B4-BE49-F238E27FC236}">
-                <a16:creationId xmlns:a16="http://schemas.microsoft.com/office/drawing/2014/main" id="{0428225E-C14C-469A-8588-BDECC14D3928}"/>
+                <a16:creationId xmlns:a16="http://schemas.microsoft.com/office/drawing/2014/main" id="{B7016B3A-334A-41CC-8CA4-26F072C3F512}"/>
               </a:ext>
             </a:extLst>
           </p:cNvPr>
@@ -9928,7 +9928,7 @@
           <p:cNvPr id="6" name="">
             <a:extLst xmlns:a="http://schemas.openxmlformats.org/drawingml/2006/main">
               <a:ext uri="{FF2B5EF4-FFF2-40B4-BE49-F238E27FC236}">
-                <a16:creationId xmlns:a16="http://schemas.microsoft.com/office/drawing/2014/main" id="{3502BB02-2CCB-4569-9DA1-83D2E73FBA18}"/>
+                <a16:creationId xmlns:a16="http://schemas.microsoft.com/office/drawing/2014/main" id="{8E93DCE2-3975-4EF0-9126-798B85E8F1B6}"/>
               </a:ext>
             </a:extLst>
           </p:cNvPr>
@@ -9992,7 +9992,7 @@
           <p:cNvPr id="7" name="">
             <a:extLst xmlns:a="http://schemas.openxmlformats.org/drawingml/2006/main">
               <a:ext uri="{FF2B5EF4-FFF2-40B4-BE49-F238E27FC236}">
-                <a16:creationId xmlns:a16="http://schemas.microsoft.com/office/drawing/2014/main" id="{C9460E6B-6FC5-4FB6-BA29-3B965FEE2399}"/>
+                <a16:creationId xmlns:a16="http://schemas.microsoft.com/office/drawing/2014/main" id="{2917BC28-CD08-4470-927B-1AB79397F481}"/>
               </a:ext>
             </a:extLst>
           </p:cNvPr>
@@ -10049,7 +10049,7 @@
           <p:cNvPr id="8" name="">
             <a:extLst xmlns:a="http://schemas.openxmlformats.org/drawingml/2006/main">
               <a:ext uri="{FF2B5EF4-FFF2-40B4-BE49-F238E27FC236}">
-                <a16:creationId xmlns:a16="http://schemas.microsoft.com/office/drawing/2014/main" id="{DDF11BF3-0B3F-4CE6-9F2D-2D776642094C}"/>
+                <a16:creationId xmlns:a16="http://schemas.microsoft.com/office/drawing/2014/main" id="{29C828BB-5088-47EA-9C48-BD4FC27F023A}"/>
               </a:ext>
             </a:extLst>
           </p:cNvPr>
@@ -10084,7 +10084,7 @@
           <p:cNvPr id="9" name="">
             <a:extLst xmlns:a="http://schemas.openxmlformats.org/drawingml/2006/main">
               <a:ext uri="{FF2B5EF4-FFF2-40B4-BE49-F238E27FC236}">
-                <a16:creationId xmlns:a16="http://schemas.microsoft.com/office/drawing/2014/main" id="{5F73C406-4297-4FE3-A7CA-5ABAA5CDDAAD}"/>
+                <a16:creationId xmlns:a16="http://schemas.microsoft.com/office/drawing/2014/main" id="{DEA3703D-3F52-4EDB-A0FD-4F00FFF99B18}"/>
               </a:ext>
             </a:extLst>
           </p:cNvPr>
@@ -10148,7 +10148,7 @@
           <p:cNvPr id="10" name="">
             <a:extLst xmlns:a="http://schemas.openxmlformats.org/drawingml/2006/main">
               <a:ext uri="{FF2B5EF4-FFF2-40B4-BE49-F238E27FC236}">
-                <a16:creationId xmlns:a16="http://schemas.microsoft.com/office/drawing/2014/main" id="{EA3E99C5-401B-4D61-BDE1-1C6ED92F9669}"/>
+                <a16:creationId xmlns:a16="http://schemas.microsoft.com/office/drawing/2014/main" id="{05B79E84-E00E-4E90-896A-C2A8FE8AAADC}"/>
               </a:ext>
             </a:extLst>
           </p:cNvPr>
@@ -10205,7 +10205,7 @@
           <p:cNvPr id="11" name="">
             <a:extLst xmlns:a="http://schemas.openxmlformats.org/drawingml/2006/main">
               <a:ext uri="{FF2B5EF4-FFF2-40B4-BE49-F238E27FC236}">
-                <a16:creationId xmlns:a16="http://schemas.microsoft.com/office/drawing/2014/main" id="{4492E3C5-E4F5-40F1-A5A4-402CE524A53D}"/>
+                <a16:creationId xmlns:a16="http://schemas.microsoft.com/office/drawing/2014/main" id="{CCDBEF86-64F8-4CEB-93E1-00B15DA1DB4B}"/>
               </a:ext>
             </a:extLst>
           </p:cNvPr>
@@ -10240,7 +10240,7 @@
           <p:cNvPr id="12" name="">
             <a:extLst xmlns:a="http://schemas.openxmlformats.org/drawingml/2006/main">
               <a:ext uri="{FF2B5EF4-FFF2-40B4-BE49-F238E27FC236}">
-                <a16:creationId xmlns:a16="http://schemas.microsoft.com/office/drawing/2014/main" id="{B11023EF-B951-46B2-83CD-3506A0539C85}"/>
+                <a16:creationId xmlns:a16="http://schemas.microsoft.com/office/drawing/2014/main" id="{946C8DB3-1586-4E7C-AA5C-5867BE56A46E}"/>
               </a:ext>
             </a:extLst>
           </p:cNvPr>
@@ -10304,7 +10304,7 @@
           <p:cNvPr id="13" name="">
             <a:extLst xmlns:a="http://schemas.openxmlformats.org/drawingml/2006/main">
               <a:ext uri="{FF2B5EF4-FFF2-40B4-BE49-F238E27FC236}">
-                <a16:creationId xmlns:a16="http://schemas.microsoft.com/office/drawing/2014/main" id="{FCF32586-FFEB-4BD1-A7F4-9D5632B6DCD2}"/>
+                <a16:creationId xmlns:a16="http://schemas.microsoft.com/office/drawing/2014/main" id="{093655E2-D92B-4F9A-A9FF-FF940A28793D}"/>
               </a:ext>
             </a:extLst>
           </p:cNvPr>
@@ -10361,7 +10361,7 @@
           <p:cNvPr id="14" name="">
             <a:extLst xmlns:a="http://schemas.openxmlformats.org/drawingml/2006/main">
               <a:ext uri="{FF2B5EF4-FFF2-40B4-BE49-F238E27FC236}">
-                <a16:creationId xmlns:a16="http://schemas.microsoft.com/office/drawing/2014/main" id="{3D86652E-7DF0-47E8-B96D-E4516BB445A0}"/>
+                <a16:creationId xmlns:a16="http://schemas.microsoft.com/office/drawing/2014/main" id="{B4A48FB1-4068-4F92-B8D6-D2D213724A64}"/>
               </a:ext>
             </a:extLst>
           </p:cNvPr>
@@ -10396,7 +10396,7 @@
           <p:cNvPr id="15" name="">
             <a:extLst xmlns:a="http://schemas.openxmlformats.org/drawingml/2006/main">
               <a:ext uri="{FF2B5EF4-FFF2-40B4-BE49-F238E27FC236}">
-                <a16:creationId xmlns:a16="http://schemas.microsoft.com/office/drawing/2014/main" id="{163AE1C2-3783-4FC5-A375-C3AC695D1A1E}"/>
+                <a16:creationId xmlns:a16="http://schemas.microsoft.com/office/drawing/2014/main" id="{AF8A4F65-85E2-400E-9C00-6FAF71E956A7}"/>
               </a:ext>
             </a:extLst>
           </p:cNvPr>
@@ -10460,7 +10460,7 @@
           <p:cNvPr id="16" name="">
             <a:extLst xmlns:a="http://schemas.openxmlformats.org/drawingml/2006/main">
               <a:ext uri="{FF2B5EF4-FFF2-40B4-BE49-F238E27FC236}">
-                <a16:creationId xmlns:a16="http://schemas.microsoft.com/office/drawing/2014/main" id="{94D9A4D4-9A1C-49B2-9CE9-7A46575EC644}"/>
+                <a16:creationId xmlns:a16="http://schemas.microsoft.com/office/drawing/2014/main" id="{EDABB3C1-9319-4EB0-80E8-9A8B6ED9634F}"/>
               </a:ext>
             </a:extLst>
           </p:cNvPr>
@@ -10517,7 +10517,7 @@
           <p:cNvPr id="17" name="">
             <a:extLst xmlns:a="http://schemas.openxmlformats.org/drawingml/2006/main">
               <a:ext uri="{FF2B5EF4-FFF2-40B4-BE49-F238E27FC236}">
-                <a16:creationId xmlns:a16="http://schemas.microsoft.com/office/drawing/2014/main" id="{94231696-40C1-477D-9546-40B06183B6E3}"/>
+                <a16:creationId xmlns:a16="http://schemas.microsoft.com/office/drawing/2014/main" id="{F45AA0D9-A4AD-4C5B-BE17-D9D226FA74D1}"/>
               </a:ext>
             </a:extLst>
           </p:cNvPr>
@@ -10552,7 +10552,7 @@
           <p:cNvPr id="18" name="">
             <a:extLst xmlns:a="http://schemas.openxmlformats.org/drawingml/2006/main">
               <a:ext uri="{FF2B5EF4-FFF2-40B4-BE49-F238E27FC236}">
-                <a16:creationId xmlns:a16="http://schemas.microsoft.com/office/drawing/2014/main" id="{881C83AA-C3BA-4DE7-BD2D-F777CA05329F}"/>
+                <a16:creationId xmlns:a16="http://schemas.microsoft.com/office/drawing/2014/main" id="{137817DF-1EC7-4718-BC64-8B77BDE4E353}"/>
               </a:ext>
             </a:extLst>
           </p:cNvPr>
@@ -10616,7 +10616,7 @@
           <p:cNvPr id="19" name="">
             <a:extLst xmlns:a="http://schemas.openxmlformats.org/drawingml/2006/main">
               <a:ext uri="{FF2B5EF4-FFF2-40B4-BE49-F238E27FC236}">
-                <a16:creationId xmlns:a16="http://schemas.microsoft.com/office/drawing/2014/main" id="{374B3F7B-FF55-418C-8D48-FB60CC810F3A}"/>
+                <a16:creationId xmlns:a16="http://schemas.microsoft.com/office/drawing/2014/main" id="{1391B645-8901-4C32-ADD3-B3630BB00BEA}"/>
               </a:ext>
             </a:extLst>
           </p:cNvPr>
@@ -10673,7 +10673,7 @@
           <p:cNvPr id="20" name="">
             <a:extLst xmlns:a="http://schemas.openxmlformats.org/drawingml/2006/main">
               <a:ext uri="{FF2B5EF4-FFF2-40B4-BE49-F238E27FC236}">
-                <a16:creationId xmlns:a16="http://schemas.microsoft.com/office/drawing/2014/main" id="{6D1ABECD-7D4A-43C8-8404-AD6A73EC917D}"/>
+                <a16:creationId xmlns:a16="http://schemas.microsoft.com/office/drawing/2014/main" id="{ACE71D56-A0DA-4F4C-AC8E-F56813E46EED}"/>
               </a:ext>
             </a:extLst>
           </p:cNvPr>
@@ -10708,7 +10708,7 @@
           <p:cNvPr id="21" name="">
             <a:extLst xmlns:a="http://schemas.openxmlformats.org/drawingml/2006/main">
               <a:ext uri="{FF2B5EF4-FFF2-40B4-BE49-F238E27FC236}">
-                <a16:creationId xmlns:a16="http://schemas.microsoft.com/office/drawing/2014/main" id="{5B16B967-3659-47B6-B966-E6A6E4CA008E}"/>
+                <a16:creationId xmlns:a16="http://schemas.microsoft.com/office/drawing/2014/main" id="{0A9EB236-4E5C-4E37-BC2A-4A197F54BB64}"/>
               </a:ext>
             </a:extLst>
           </p:cNvPr>
@@ -10765,7 +10765,7 @@
           <p:cNvPr id="22" name="">
             <a:extLst xmlns:a="http://schemas.openxmlformats.org/drawingml/2006/main">
               <a:ext uri="{FF2B5EF4-FFF2-40B4-BE49-F238E27FC236}">
-                <a16:creationId xmlns:a16="http://schemas.microsoft.com/office/drawing/2014/main" id="{B7C22252-47FE-4A85-8501-4EBD1CD3AD29}"/>
+                <a16:creationId xmlns:a16="http://schemas.microsoft.com/office/drawing/2014/main" id="{1E9DB9B5-75B9-444B-995C-EF73C4220F09}"/>
               </a:ext>
             </a:extLst>
           </p:cNvPr>
@@ -10829,7 +10829,7 @@
           <p:cNvPr id="23" name="">
             <a:extLst xmlns:a="http://schemas.openxmlformats.org/drawingml/2006/main">
               <a:ext uri="{FF2B5EF4-FFF2-40B4-BE49-F238E27FC236}">
-                <a16:creationId xmlns:a16="http://schemas.microsoft.com/office/drawing/2014/main" id="{98F740BA-F319-4EC8-B915-31AF05C164C6}"/>
+                <a16:creationId xmlns:a16="http://schemas.microsoft.com/office/drawing/2014/main" id="{BBE72994-16A2-4420-8CCC-826673A06537}"/>
               </a:ext>
             </a:extLst>
           </p:cNvPr>
@@ -10886,7 +10886,7 @@
           <p:cNvPr id="24" name="">
             <a:extLst xmlns:a="http://schemas.openxmlformats.org/drawingml/2006/main">
               <a:ext uri="{FF2B5EF4-FFF2-40B4-BE49-F238E27FC236}">
-                <a16:creationId xmlns:a16="http://schemas.microsoft.com/office/drawing/2014/main" id="{67670B92-A43C-4C71-8604-DD3B28FB0A04}"/>
+                <a16:creationId xmlns:a16="http://schemas.microsoft.com/office/drawing/2014/main" id="{81EC2D43-6CB6-405E-B498-032A3538F91A}"/>
               </a:ext>
             </a:extLst>
           </p:cNvPr>
@@ -10950,7 +10950,7 @@
           <p:cNvPr id="25" name="">
             <a:extLst xmlns:a="http://schemas.openxmlformats.org/drawingml/2006/main">
               <a:ext uri="{FF2B5EF4-FFF2-40B4-BE49-F238E27FC236}">
-                <a16:creationId xmlns:a16="http://schemas.microsoft.com/office/drawing/2014/main" id="{38FCB651-7C64-44A9-94B5-2BC78F90296F}"/>
+                <a16:creationId xmlns:a16="http://schemas.microsoft.com/office/drawing/2014/main" id="{2662FE0F-9F11-4D9B-A126-4ABEF1CD8E7F}"/>
               </a:ext>
             </a:extLst>
           </p:cNvPr>
@@ -11007,7 +11007,7 @@
           <p:cNvPr id="26" name="">
             <a:extLst xmlns:a="http://schemas.openxmlformats.org/drawingml/2006/main">
               <a:ext uri="{FF2B5EF4-FFF2-40B4-BE49-F238E27FC236}">
-                <a16:creationId xmlns:a16="http://schemas.microsoft.com/office/drawing/2014/main" id="{F51E1EB5-DA2C-47B9-BD9E-B223ECBB10D5}"/>
+                <a16:creationId xmlns:a16="http://schemas.microsoft.com/office/drawing/2014/main" id="{DE3812FB-6E43-4624-9FD8-5E245B5133DC}"/>
               </a:ext>
             </a:extLst>
           </p:cNvPr>
@@ -11071,7 +11071,7 @@
           <p:cNvPr id="27" name="">
             <a:extLst xmlns:a="http://schemas.openxmlformats.org/drawingml/2006/main">
               <a:ext uri="{FF2B5EF4-FFF2-40B4-BE49-F238E27FC236}">
-                <a16:creationId xmlns:a16="http://schemas.microsoft.com/office/drawing/2014/main" id="{1E4FD999-5A37-4636-8F19-E9F4C3AB54DD}"/>
+                <a16:creationId xmlns:a16="http://schemas.microsoft.com/office/drawing/2014/main" id="{625602AE-13C5-454F-A8B7-DB46EC53818E}"/>
               </a:ext>
             </a:extLst>
           </p:cNvPr>
@@ -11118,7 +11118,7 @@
                 <a:ea typeface="Arial"/>
                 <a:cs typeface="Arial"/>
               </a:rPr>
-              <a:t>25/25 fixture + 15 ca BGK</a:t>
+              <a:t>15/15 OR • 25/25 local</a:t>
             </a:r>
           </a:p>
         </p:txBody>
@@ -11128,7 +11128,7 @@
           <p:cNvPr id="28" name="">
             <a:extLst xmlns:a="http://schemas.openxmlformats.org/drawingml/2006/main">
               <a:ext uri="{FF2B5EF4-FFF2-40B4-BE49-F238E27FC236}">
-                <a16:creationId xmlns:a16="http://schemas.microsoft.com/office/drawing/2014/main" id="{7670BC19-B3FA-4DE0-9BCD-2533EDEDFCE5}"/>
+                <a16:creationId xmlns:a16="http://schemas.microsoft.com/office/drawing/2014/main" id="{59C83D30-8D76-40C5-BDBC-4731B1445FCB}"/>
               </a:ext>
             </a:extLst>
           </p:cNvPr>
@@ -11192,7 +11192,7 @@
           <p:cNvPr id="29" name="">
             <a:extLst xmlns:a="http://schemas.openxmlformats.org/drawingml/2006/main">
               <a:ext uri="{FF2B5EF4-FFF2-40B4-BE49-F238E27FC236}">
-                <a16:creationId xmlns:a16="http://schemas.microsoft.com/office/drawing/2014/main" id="{1C5B9B22-1066-4502-B1FE-8AF14534CB2F}"/>
+                <a16:creationId xmlns:a16="http://schemas.microsoft.com/office/drawing/2014/main" id="{AC060F70-263D-455B-942A-90F9BE01C59A}"/>
               </a:ext>
             </a:extLst>
           </p:cNvPr>
@@ -11249,7 +11249,7 @@
           <p:cNvPr id="30" name="">
             <a:extLst xmlns:a="http://schemas.openxmlformats.org/drawingml/2006/main">
               <a:ext uri="{FF2B5EF4-FFF2-40B4-BE49-F238E27FC236}">
-                <a16:creationId xmlns:a16="http://schemas.microsoft.com/office/drawing/2014/main" id="{55621037-3A98-4DB2-9721-7C5DFEEC494C}"/>
+                <a16:creationId xmlns:a16="http://schemas.microsoft.com/office/drawing/2014/main" id="{623AECBB-E664-4745-A81C-7272E32C4061}"/>
               </a:ext>
             </a:extLst>
           </p:cNvPr>
@@ -11284,7 +11284,7 @@
           <p:cNvPr id="31" name="">
             <a:extLst xmlns:a="http://schemas.openxmlformats.org/drawingml/2006/main">
               <a:ext uri="{FF2B5EF4-FFF2-40B4-BE49-F238E27FC236}">
-                <a16:creationId xmlns:a16="http://schemas.microsoft.com/office/drawing/2014/main" id="{A1FBE79C-C59D-4B09-B327-88E525D04AA8}"/>
+                <a16:creationId xmlns:a16="http://schemas.microsoft.com/office/drawing/2014/main" id="{F5F2EF3D-AD3C-47EA-B59E-B9391F1F243F}"/>
               </a:ext>
             </a:extLst>
           </p:cNvPr>
@@ -11341,7 +11341,7 @@
           <p:cNvPr id="32" name="">
             <a:extLst xmlns:a="http://schemas.openxmlformats.org/drawingml/2006/main">
               <a:ext uri="{FF2B5EF4-FFF2-40B4-BE49-F238E27FC236}">
-                <a16:creationId xmlns:a16="http://schemas.microsoft.com/office/drawing/2014/main" id="{E90E496F-2177-4F26-BBFD-AF1361088C4B}"/>
+                <a16:creationId xmlns:a16="http://schemas.microsoft.com/office/drawing/2014/main" id="{125B3BE2-3BC7-43B5-B6D2-4AE1DB606954}"/>
               </a:ext>
             </a:extLst>
           </p:cNvPr>
@@ -11444,7 +11444,7 @@
           <p:cNvPr id="33" name="">
             <a:extLst xmlns:a="http://schemas.openxmlformats.org/drawingml/2006/main">
               <a:ext uri="{FF2B5EF4-FFF2-40B4-BE49-F238E27FC236}">
-                <a16:creationId xmlns:a16="http://schemas.microsoft.com/office/drawing/2014/main" id="{737C383A-7BD9-4494-8762-D50876D38F84}"/>
+                <a16:creationId xmlns:a16="http://schemas.microsoft.com/office/drawing/2014/main" id="{340D99FF-1910-460B-9828-4E009B7E76FB}"/>
               </a:ext>
             </a:extLst>
           </p:cNvPr>
@@ -11501,7 +11501,7 @@
           <p:cNvPr id="34" name="">
             <a:extLst xmlns:a="http://schemas.openxmlformats.org/drawingml/2006/main">
               <a:ext uri="{FF2B5EF4-FFF2-40B4-BE49-F238E27FC236}">
-                <a16:creationId xmlns:a16="http://schemas.microsoft.com/office/drawing/2014/main" id="{EC6420B5-25FC-4C09-9508-1CFCA9042400}"/>
+                <a16:creationId xmlns:a16="http://schemas.microsoft.com/office/drawing/2014/main" id="{F1F17892-0B04-4F7F-AF77-D4DE212894EF}"/>
               </a:ext>
             </a:extLst>
           </p:cNvPr>
@@ -11558,7 +11558,7 @@
           <p:cNvPr id="35" name="">
             <a:extLst xmlns:a="http://schemas.openxmlformats.org/drawingml/2006/main">
               <a:ext uri="{FF2B5EF4-FFF2-40B4-BE49-F238E27FC236}">
-                <a16:creationId xmlns:a16="http://schemas.microsoft.com/office/drawing/2014/main" id="{EBF47A3F-8783-4667-8094-CE4A84146134}"/>
+                <a16:creationId xmlns:a16="http://schemas.microsoft.com/office/drawing/2014/main" id="{33C5D697-FFCF-4F37-A6C1-5AC8275DDE1A}"/>
               </a:ext>
             </a:extLst>
           </p:cNvPr>
@@ -11613,7 +11613,7 @@
     </p:spTree>
     <p:extLst>
       <p:ext uri="{BB962C8B-B14F-4D97-AF65-F5344CB8AC3E}">
-        <p14:creationId xmlns:p14="http://schemas.microsoft.com/office/powerpoint/2010/main" val="1390269432"/>
+        <p14:creationId xmlns:p14="http://schemas.microsoft.com/office/powerpoint/2010/main" val="843106229"/>
       </p:ext>
     </p:extLst>
   </p:cSld>

</xml_diff>

<commit_message>
docs: align proposal with resilient AI pipeline
</commit_message>
<xml_diff>
--- a/AURA/submission/AURA_5_SLIDES.pptx
+++ b/AURA/submission/AURA_5_SLIDES.pptx
@@ -2,17 +2,17 @@
 <file path=ppt/presentation.xml><?xml version="1.0" encoding="utf-8"?>
 <p:presentation xmlns:p="http://schemas.openxmlformats.org/presentationml/2006/main">
   <p:sldMasterIdLst>
-    <p:sldMasterId xmlns:r="http://schemas.openxmlformats.org/officeDocument/2006/relationships" id="2147483648" r:id="R54ddcdcfd7a545d5"/>
+    <p:sldMasterId xmlns:r="http://schemas.openxmlformats.org/officeDocument/2006/relationships" id="2147483648" r:id="R05037d59b07a4cc1"/>
   </p:sldMasterIdLst>
   <p:notesMasterIdLst>
-    <p:notesMasterId xmlns:r="http://schemas.openxmlformats.org/officeDocument/2006/relationships" r:id="Rdd0998c484374032"/>
+    <p:notesMasterId xmlns:r="http://schemas.openxmlformats.org/officeDocument/2006/relationships" r:id="Re16c9e82868c4a29"/>
   </p:notesMasterIdLst>
   <p:sldIdLst>
-    <p:sldId xmlns:r="http://schemas.openxmlformats.org/officeDocument/2006/relationships" id="256" r:id="R6225d1d87fab4a40"/>
-    <p:sldId xmlns:r="http://schemas.openxmlformats.org/officeDocument/2006/relationships" id="257" r:id="R59f9d370cf1342e6"/>
-    <p:sldId xmlns:r="http://schemas.openxmlformats.org/officeDocument/2006/relationships" id="258" r:id="R3ba8958438294371"/>
-    <p:sldId xmlns:r="http://schemas.openxmlformats.org/officeDocument/2006/relationships" id="259" r:id="R1e88cf1770914e62"/>
-    <p:sldId xmlns:r="http://schemas.openxmlformats.org/officeDocument/2006/relationships" id="260" r:id="R5361d892d2c1485c"/>
+    <p:sldId xmlns:r="http://schemas.openxmlformats.org/officeDocument/2006/relationships" id="256" r:id="Rf4d67348cfff4712"/>
+    <p:sldId xmlns:r="http://schemas.openxmlformats.org/officeDocument/2006/relationships" id="257" r:id="Ra1b50c867a7c4515"/>
+    <p:sldId xmlns:r="http://schemas.openxmlformats.org/officeDocument/2006/relationships" id="258" r:id="R5e15d508eae840d7"/>
+    <p:sldId xmlns:r="http://schemas.openxmlformats.org/officeDocument/2006/relationships" id="259" r:id="R235e7a1204fc4739"/>
+    <p:sldId xmlns:r="http://schemas.openxmlformats.org/officeDocument/2006/relationships" id="260" r:id="Ra688c402d47043af"/>
   </p:sldIdLst>
   <p:sldSz cx="12192000" cy="6858000"/>
   <p:notesSz cx="6858000" cy="9144000"/>
@@ -586,7 +586,7 @@
           <a:lstStyle xmlns:a="http://schemas.openxmlformats.org/drawingml/2006/main"/>
           <a:p xmlns:a="http://schemas.openxmlformats.org/drawingml/2006/main">
             <a:r>
-              <a:t>Nguồn nội bộ ngày 27/09/2026: 70 test offline; OpenRouter 8B đạt 15/15 qua ba batch, adjusted P95 11,317 giây; Ollama 4B đạt 25/25 qua năm batch trên cùng 5 fixture tổng hợp. Không suy rộng thành accuracy thực tế.</a:t>
+              <a:t>Nguồn nội bộ ngày 28/09/2026: 80 test offline; benchmark model ngày 27/09 ghi OpenRouter 8B đạt 15/15 qua ba batch, adjusted P95 11,317 giây và Ollama 4B đạt 25/25 qua năm batch trên cùng 5 fixture tổng hợp. Không suy rộng thành accuracy thực tế.</a:t>
             </a:r>
           </a:p>
         </p:txBody>
@@ -726,7 +726,7 @@
           <a:lstStyle xmlns:a="http://schemas.openxmlformats.org/drawingml/2006/main"/>
           <a:p xmlns:a="http://schemas.openxmlformats.org/drawingml/2006/main">
             <a:r>
-              <a:t>Nguồn deploy: https://render.com/docs/free ; https://www.smarterasp.net/support/kb/a2437/how-to-set-environment-variable-for-your-account.aspx . Cơ chế retry đối chiếu OpenRouterVisionExtractorService.cs.</a:t>
+              <a:t>Nguồn kỹ thuật trong repo: ReceiptProcessingWorker.cs, ConfiguredVisionExtractor.cs, VisionCircuitBreaker.cs và docs/SPRINT2_IMPLEMENTATION_PROGRESS_2026-09-28.md.</a:t>
             </a:r>
           </a:p>
         </p:txBody>
@@ -794,7 +794,7 @@
   </p:cSld>
   <p:clrMap bg1="lt1" tx1="dk1" bg2="lt2" tx2="dk2" accent1="accent1" accent2="accent2" accent3="accent3" accent4="accent4" accent5="accent5" accent6="accent6" hlink="hlink" folHlink="folHlink"/>
   <p:sldLayoutIdLst>
-    <p:sldLayoutId xmlns:r="http://schemas.openxmlformats.org/officeDocument/2006/relationships" id="2147483649" r:id="R58193fb4a82d4270"/>
+    <p:sldLayoutId xmlns:r="http://schemas.openxmlformats.org/officeDocument/2006/relationships" id="2147483649" r:id="R5e24a9f384c04eea"/>
   </p:sldLayoutIdLst>
   <p:txStyles>
     <p:titleStyle>
@@ -1345,7 +1345,7 @@
           <p:cNvPr id="47" name="">
             <a:extLst xmlns:a="http://schemas.openxmlformats.org/drawingml/2006/main">
               <a:ext uri="{FF2B5EF4-FFF2-40B4-BE49-F238E27FC236}">
-                <a16:creationId xmlns:a16="http://schemas.microsoft.com/office/drawing/2014/main" id="{3D09ADDB-BB92-49EE-91AF-79C59973C7E9}"/>
+                <a16:creationId xmlns:a16="http://schemas.microsoft.com/office/drawing/2014/main" id="{35E868D2-B838-4BCF-A363-75619F704C40}"/>
               </a:ext>
             </a:extLst>
           </p:cNvPr>
@@ -1402,7 +1402,7 @@
           <p:cNvPr id="2" name="">
             <a:extLst xmlns:a="http://schemas.openxmlformats.org/drawingml/2006/main">
               <a:ext uri="{FF2B5EF4-FFF2-40B4-BE49-F238E27FC236}">
-                <a16:creationId xmlns:a16="http://schemas.microsoft.com/office/drawing/2014/main" id="{DE17CFDC-CD48-490C-8DA7-40D3C92863F8}"/>
+                <a16:creationId xmlns:a16="http://schemas.microsoft.com/office/drawing/2014/main" id="{4B6F3656-AD84-4AE2-9B16-8671DD462FA8}"/>
               </a:ext>
             </a:extLst>
           </p:cNvPr>
@@ -1459,7 +1459,7 @@
           <p:cNvPr id="3" name="">
             <a:extLst xmlns:a="http://schemas.openxmlformats.org/drawingml/2006/main">
               <a:ext uri="{FF2B5EF4-FFF2-40B4-BE49-F238E27FC236}">
-                <a16:creationId xmlns:a16="http://schemas.microsoft.com/office/drawing/2014/main" id="{E4689CB0-C36B-4983-B407-AA48F10B02B6}"/>
+                <a16:creationId xmlns:a16="http://schemas.microsoft.com/office/drawing/2014/main" id="{0B3A7C9A-B179-4902-A0E2-EA25F1771BEF}"/>
               </a:ext>
             </a:extLst>
           </p:cNvPr>
@@ -1516,7 +1516,7 @@
           <p:cNvPr id="4" name="">
             <a:extLst xmlns:a="http://schemas.openxmlformats.org/drawingml/2006/main">
               <a:ext uri="{FF2B5EF4-FFF2-40B4-BE49-F238E27FC236}">
-                <a16:creationId xmlns:a16="http://schemas.microsoft.com/office/drawing/2014/main" id="{D02AA200-4333-45C9-A044-3D767FF170DD}"/>
+                <a16:creationId xmlns:a16="http://schemas.microsoft.com/office/drawing/2014/main" id="{22203BD3-F36D-43FD-B6D7-A89322A06918}"/>
               </a:ext>
             </a:extLst>
           </p:cNvPr>
@@ -1547,7 +1547,7 @@
           <p:cNvPr id="5" name="">
             <a:extLst xmlns:a="http://schemas.openxmlformats.org/drawingml/2006/main">
               <a:ext uri="{FF2B5EF4-FFF2-40B4-BE49-F238E27FC236}">
-                <a16:creationId xmlns:a16="http://schemas.microsoft.com/office/drawing/2014/main" id="{907546B7-0FD0-469C-8C38-557C7C609861}"/>
+                <a16:creationId xmlns:a16="http://schemas.microsoft.com/office/drawing/2014/main" id="{C92F7855-F0DE-4F5B-989C-4834F8C7CDD5}"/>
               </a:ext>
             </a:extLst>
           </p:cNvPr>
@@ -1582,7 +1582,7 @@
           <p:cNvPr id="6" name="">
             <a:extLst xmlns:a="http://schemas.openxmlformats.org/drawingml/2006/main">
               <a:ext uri="{FF2B5EF4-FFF2-40B4-BE49-F238E27FC236}">
-                <a16:creationId xmlns:a16="http://schemas.microsoft.com/office/drawing/2014/main" id="{BD9C3744-CA97-40BC-8D9E-6332C272B7B0}"/>
+                <a16:creationId xmlns:a16="http://schemas.microsoft.com/office/drawing/2014/main" id="{3A228DA1-5D56-451E-B248-9D46420ED9A6}"/>
               </a:ext>
             </a:extLst>
           </p:cNvPr>
@@ -1646,7 +1646,7 @@
           <p:cNvPr id="7" name="">
             <a:extLst xmlns:a="http://schemas.openxmlformats.org/drawingml/2006/main">
               <a:ext uri="{FF2B5EF4-FFF2-40B4-BE49-F238E27FC236}">
-                <a16:creationId xmlns:a16="http://schemas.microsoft.com/office/drawing/2014/main" id="{927DA05B-1956-415F-BB31-8EEA1894775B}"/>
+                <a16:creationId xmlns:a16="http://schemas.microsoft.com/office/drawing/2014/main" id="{1DBBE4FB-C843-4397-9A87-791659DCFE40}"/>
               </a:ext>
             </a:extLst>
           </p:cNvPr>
@@ -1703,7 +1703,7 @@
           <p:cNvPr id="8" name="">
             <a:extLst xmlns:a="http://schemas.openxmlformats.org/drawingml/2006/main">
               <a:ext uri="{FF2B5EF4-FFF2-40B4-BE49-F238E27FC236}">
-                <a16:creationId xmlns:a16="http://schemas.microsoft.com/office/drawing/2014/main" id="{2E4D4107-E5C9-484C-8D3D-E32369786703}"/>
+                <a16:creationId xmlns:a16="http://schemas.microsoft.com/office/drawing/2014/main" id="{4AA07307-5EBC-42C9-BEF1-37E28C9C1950}"/>
               </a:ext>
             </a:extLst>
           </p:cNvPr>
@@ -1760,7 +1760,7 @@
           <p:cNvPr id="9" name="">
             <a:extLst xmlns:a="http://schemas.openxmlformats.org/drawingml/2006/main">
               <a:ext uri="{FF2B5EF4-FFF2-40B4-BE49-F238E27FC236}">
-                <a16:creationId xmlns:a16="http://schemas.microsoft.com/office/drawing/2014/main" id="{72EA4846-E452-4548-ADA4-A195B9DE322E}"/>
+                <a16:creationId xmlns:a16="http://schemas.microsoft.com/office/drawing/2014/main" id="{FDBCDCBC-00D4-414D-8C6F-F09C7A954EC9}"/>
               </a:ext>
             </a:extLst>
           </p:cNvPr>
@@ -1792,7 +1792,7 @@
           <p:cNvPr id="10" name="">
             <a:extLst xmlns:a="http://schemas.openxmlformats.org/drawingml/2006/main">
               <a:ext uri="{FF2B5EF4-FFF2-40B4-BE49-F238E27FC236}">
-                <a16:creationId xmlns:a16="http://schemas.microsoft.com/office/drawing/2014/main" id="{5C2A5911-DA2A-46F8-BD6C-502C03984274}"/>
+                <a16:creationId xmlns:a16="http://schemas.microsoft.com/office/drawing/2014/main" id="{5B2EC2C0-5431-416D-BB01-17C13404EA30}"/>
               </a:ext>
             </a:extLst>
           </p:cNvPr>
@@ -1827,7 +1827,7 @@
           <p:cNvPr id="11" name="">
             <a:extLst xmlns:a="http://schemas.openxmlformats.org/drawingml/2006/main">
               <a:ext uri="{FF2B5EF4-FFF2-40B4-BE49-F238E27FC236}">
-                <a16:creationId xmlns:a16="http://schemas.microsoft.com/office/drawing/2014/main" id="{2589097D-9534-4BCA-B0F3-1B1EE1D12A8D}"/>
+                <a16:creationId xmlns:a16="http://schemas.microsoft.com/office/drawing/2014/main" id="{0DDFA1F8-C37C-42C7-A33D-0E452D35EC00}"/>
               </a:ext>
             </a:extLst>
           </p:cNvPr>
@@ -1891,7 +1891,7 @@
           <p:cNvPr id="12" name="">
             <a:extLst xmlns:a="http://schemas.openxmlformats.org/drawingml/2006/main">
               <a:ext uri="{FF2B5EF4-FFF2-40B4-BE49-F238E27FC236}">
-                <a16:creationId xmlns:a16="http://schemas.microsoft.com/office/drawing/2014/main" id="{6F88FCB9-46A5-4E69-B925-E14420FBAFF0}"/>
+                <a16:creationId xmlns:a16="http://schemas.microsoft.com/office/drawing/2014/main" id="{325F535E-F804-4029-B39A-3711BFD5F19E}"/>
               </a:ext>
             </a:extLst>
           </p:cNvPr>
@@ -1948,7 +1948,7 @@
           <p:cNvPr id="13" name="">
             <a:extLst xmlns:a="http://schemas.openxmlformats.org/drawingml/2006/main">
               <a:ext uri="{FF2B5EF4-FFF2-40B4-BE49-F238E27FC236}">
-                <a16:creationId xmlns:a16="http://schemas.microsoft.com/office/drawing/2014/main" id="{2900DF66-5229-46A9-916B-3D04630F20F5}"/>
+                <a16:creationId xmlns:a16="http://schemas.microsoft.com/office/drawing/2014/main" id="{7746FA5A-EA42-4C20-91D5-35526F6D1B31}"/>
               </a:ext>
             </a:extLst>
           </p:cNvPr>
@@ -2005,7 +2005,7 @@
           <p:cNvPr id="14" name="">
             <a:extLst xmlns:a="http://schemas.openxmlformats.org/drawingml/2006/main">
               <a:ext uri="{FF2B5EF4-FFF2-40B4-BE49-F238E27FC236}">
-                <a16:creationId xmlns:a16="http://schemas.microsoft.com/office/drawing/2014/main" id="{02E46289-9563-475A-8274-F126AB552115}"/>
+                <a16:creationId xmlns:a16="http://schemas.microsoft.com/office/drawing/2014/main" id="{4F1076C2-5579-405E-9C3E-AD04BB0BB8D8}"/>
               </a:ext>
             </a:extLst>
           </p:cNvPr>
@@ -2037,7 +2037,7 @@
           <p:cNvPr id="15" name="">
             <a:extLst xmlns:a="http://schemas.openxmlformats.org/drawingml/2006/main">
               <a:ext uri="{FF2B5EF4-FFF2-40B4-BE49-F238E27FC236}">
-                <a16:creationId xmlns:a16="http://schemas.microsoft.com/office/drawing/2014/main" id="{CEC19FEA-2AAB-456F-A10E-2A6FC2E7DC68}"/>
+                <a16:creationId xmlns:a16="http://schemas.microsoft.com/office/drawing/2014/main" id="{B17E57FE-5EC0-4F4B-8AE1-69378DDE7DB1}"/>
               </a:ext>
             </a:extLst>
           </p:cNvPr>
@@ -2072,7 +2072,7 @@
           <p:cNvPr id="16" name="">
             <a:extLst xmlns:a="http://schemas.openxmlformats.org/drawingml/2006/main">
               <a:ext uri="{FF2B5EF4-FFF2-40B4-BE49-F238E27FC236}">
-                <a16:creationId xmlns:a16="http://schemas.microsoft.com/office/drawing/2014/main" id="{80AA883D-AA92-4DD5-B3BD-ACE4F5370DC9}"/>
+                <a16:creationId xmlns:a16="http://schemas.microsoft.com/office/drawing/2014/main" id="{CA10ABDB-3387-4264-856C-4AD09927DEB4}"/>
               </a:ext>
             </a:extLst>
           </p:cNvPr>
@@ -2136,7 +2136,7 @@
           <p:cNvPr id="17" name="">
             <a:extLst xmlns:a="http://schemas.openxmlformats.org/drawingml/2006/main">
               <a:ext uri="{FF2B5EF4-FFF2-40B4-BE49-F238E27FC236}">
-                <a16:creationId xmlns:a16="http://schemas.microsoft.com/office/drawing/2014/main" id="{84FB223E-535D-46A3-925E-14EEF54A1BF2}"/>
+                <a16:creationId xmlns:a16="http://schemas.microsoft.com/office/drawing/2014/main" id="{3100B212-9C34-4012-BCD4-C52FAC54075A}"/>
               </a:ext>
             </a:extLst>
           </p:cNvPr>
@@ -2193,7 +2193,7 @@
           <p:cNvPr id="18" name="">
             <a:extLst xmlns:a="http://schemas.openxmlformats.org/drawingml/2006/main">
               <a:ext uri="{FF2B5EF4-FFF2-40B4-BE49-F238E27FC236}">
-                <a16:creationId xmlns:a16="http://schemas.microsoft.com/office/drawing/2014/main" id="{BE49A9EB-809F-49C0-956C-FB6A264454B3}"/>
+                <a16:creationId xmlns:a16="http://schemas.microsoft.com/office/drawing/2014/main" id="{F956106A-69F1-4ACA-B902-711759B66E80}"/>
               </a:ext>
             </a:extLst>
           </p:cNvPr>
@@ -2250,7 +2250,7 @@
           <p:cNvPr id="19" name="">
             <a:extLst xmlns:a="http://schemas.openxmlformats.org/drawingml/2006/main">
               <a:ext uri="{FF2B5EF4-FFF2-40B4-BE49-F238E27FC236}">
-                <a16:creationId xmlns:a16="http://schemas.microsoft.com/office/drawing/2014/main" id="{0A7FB152-1A7B-44A0-B3E2-BB93D1F3D1E5}"/>
+                <a16:creationId xmlns:a16="http://schemas.microsoft.com/office/drawing/2014/main" id="{45ED9181-5399-487E-9611-6B65C6A3410F}"/>
               </a:ext>
             </a:extLst>
           </p:cNvPr>
@@ -2282,7 +2282,7 @@
           <p:cNvPr id="20" name="">
             <a:extLst xmlns:a="http://schemas.openxmlformats.org/drawingml/2006/main">
               <a:ext uri="{FF2B5EF4-FFF2-40B4-BE49-F238E27FC236}">
-                <a16:creationId xmlns:a16="http://schemas.microsoft.com/office/drawing/2014/main" id="{744A52AF-8F92-4775-A1AE-317367AC99C7}"/>
+                <a16:creationId xmlns:a16="http://schemas.microsoft.com/office/drawing/2014/main" id="{BF543D96-3721-4AE9-87C6-447CCE3B911A}"/>
               </a:ext>
             </a:extLst>
           </p:cNvPr>
@@ -2317,7 +2317,7 @@
           <p:cNvPr id="21" name="">
             <a:extLst xmlns:a="http://schemas.openxmlformats.org/drawingml/2006/main">
               <a:ext uri="{FF2B5EF4-FFF2-40B4-BE49-F238E27FC236}">
-                <a16:creationId xmlns:a16="http://schemas.microsoft.com/office/drawing/2014/main" id="{D38EC16D-A125-4CBC-9338-BF98295A0FBA}"/>
+                <a16:creationId xmlns:a16="http://schemas.microsoft.com/office/drawing/2014/main" id="{79C6E711-F5F4-4CBF-90FF-F420C6C5B00C}"/>
               </a:ext>
             </a:extLst>
           </p:cNvPr>
@@ -2381,7 +2381,7 @@
           <p:cNvPr id="22" name="">
             <a:extLst xmlns:a="http://schemas.openxmlformats.org/drawingml/2006/main">
               <a:ext uri="{FF2B5EF4-FFF2-40B4-BE49-F238E27FC236}">
-                <a16:creationId xmlns:a16="http://schemas.microsoft.com/office/drawing/2014/main" id="{EB388E99-720D-40EE-BDE0-33D1D8D1F043}"/>
+                <a16:creationId xmlns:a16="http://schemas.microsoft.com/office/drawing/2014/main" id="{4CEB23D5-B47D-4621-BC6B-4B84BC4D99AD}"/>
               </a:ext>
             </a:extLst>
           </p:cNvPr>
@@ -2438,7 +2438,7 @@
           <p:cNvPr id="23" name="">
             <a:extLst xmlns:a="http://schemas.openxmlformats.org/drawingml/2006/main">
               <a:ext uri="{FF2B5EF4-FFF2-40B4-BE49-F238E27FC236}">
-                <a16:creationId xmlns:a16="http://schemas.microsoft.com/office/drawing/2014/main" id="{86B09A0C-AFE9-4705-9531-A3D729795AAD}"/>
+                <a16:creationId xmlns:a16="http://schemas.microsoft.com/office/drawing/2014/main" id="{C2764D1D-C3F8-4599-B7CE-38D2CC07B0DC}"/>
               </a:ext>
             </a:extLst>
           </p:cNvPr>
@@ -2495,7 +2495,7 @@
           <p:cNvPr id="24" name="">
             <a:extLst xmlns:a="http://schemas.openxmlformats.org/drawingml/2006/main">
               <a:ext uri="{FF2B5EF4-FFF2-40B4-BE49-F238E27FC236}">
-                <a16:creationId xmlns:a16="http://schemas.microsoft.com/office/drawing/2014/main" id="{1004B251-7E5A-44D6-8098-C9FC998E24FE}"/>
+                <a16:creationId xmlns:a16="http://schemas.microsoft.com/office/drawing/2014/main" id="{8A043663-16C1-4D2A-AB85-53B9B9A7E850}"/>
               </a:ext>
             </a:extLst>
           </p:cNvPr>
@@ -2527,7 +2527,7 @@
           <p:cNvPr id="25" name="">
             <a:extLst xmlns:a="http://schemas.openxmlformats.org/drawingml/2006/main">
               <a:ext uri="{FF2B5EF4-FFF2-40B4-BE49-F238E27FC236}">
-                <a16:creationId xmlns:a16="http://schemas.microsoft.com/office/drawing/2014/main" id="{8F20987D-659B-451B-9E31-EFD386B6C6EA}"/>
+                <a16:creationId xmlns:a16="http://schemas.microsoft.com/office/drawing/2014/main" id="{4DEF86DE-6402-4DF2-9A5B-25D9D96D5FF6}"/>
               </a:ext>
             </a:extLst>
           </p:cNvPr>
@@ -2562,7 +2562,7 @@
           <p:cNvPr id="26" name="">
             <a:extLst xmlns:a="http://schemas.openxmlformats.org/drawingml/2006/main">
               <a:ext uri="{FF2B5EF4-FFF2-40B4-BE49-F238E27FC236}">
-                <a16:creationId xmlns:a16="http://schemas.microsoft.com/office/drawing/2014/main" id="{5317EF17-68BA-4D17-BD58-B6419B79060C}"/>
+                <a16:creationId xmlns:a16="http://schemas.microsoft.com/office/drawing/2014/main" id="{E81B0109-0C48-40F6-AA25-5DD1DBE2B76F}"/>
               </a:ext>
             </a:extLst>
           </p:cNvPr>
@@ -2626,7 +2626,7 @@
           <p:cNvPr id="27" name="">
             <a:extLst xmlns:a="http://schemas.openxmlformats.org/drawingml/2006/main">
               <a:ext uri="{FF2B5EF4-FFF2-40B4-BE49-F238E27FC236}">
-                <a16:creationId xmlns:a16="http://schemas.microsoft.com/office/drawing/2014/main" id="{A4E11C91-BDCA-4DE1-B2A5-26EDF5D123DB}"/>
+                <a16:creationId xmlns:a16="http://schemas.microsoft.com/office/drawing/2014/main" id="{A53B535A-35CB-4F20-A71F-E9F5EB7A8566}"/>
               </a:ext>
             </a:extLst>
           </p:cNvPr>
@@ -2683,7 +2683,7 @@
           <p:cNvPr id="28" name="">
             <a:extLst xmlns:a="http://schemas.openxmlformats.org/drawingml/2006/main">
               <a:ext uri="{FF2B5EF4-FFF2-40B4-BE49-F238E27FC236}">
-                <a16:creationId xmlns:a16="http://schemas.microsoft.com/office/drawing/2014/main" id="{71574303-DA43-469A-9063-7820B92C8AAA}"/>
+                <a16:creationId xmlns:a16="http://schemas.microsoft.com/office/drawing/2014/main" id="{8F987823-3CD0-4F4B-955A-FABD81AA6407}"/>
               </a:ext>
             </a:extLst>
           </p:cNvPr>
@@ -2740,7 +2740,7 @@
           <p:cNvPr id="29" name="">
             <a:extLst xmlns:a="http://schemas.openxmlformats.org/drawingml/2006/main">
               <a:ext uri="{FF2B5EF4-FFF2-40B4-BE49-F238E27FC236}">
-                <a16:creationId xmlns:a16="http://schemas.microsoft.com/office/drawing/2014/main" id="{D4E61484-5B66-4619-86B4-0FCF004BA80B}"/>
+                <a16:creationId xmlns:a16="http://schemas.microsoft.com/office/drawing/2014/main" id="{1BAB520E-C131-4763-8B9F-E6E1D0A53E24}"/>
               </a:ext>
             </a:extLst>
           </p:cNvPr>
@@ -2775,7 +2775,7 @@
           <p:cNvPr id="30" name="">
             <a:extLst xmlns:a="http://schemas.openxmlformats.org/drawingml/2006/main">
               <a:ext uri="{FF2B5EF4-FFF2-40B4-BE49-F238E27FC236}">
-                <a16:creationId xmlns:a16="http://schemas.microsoft.com/office/drawing/2014/main" id="{CA729FCF-E707-447A-8F1D-2F1511EC4EA2}"/>
+                <a16:creationId xmlns:a16="http://schemas.microsoft.com/office/drawing/2014/main" id="{2855C151-E073-4874-AC4F-94810E75AEBF}"/>
               </a:ext>
             </a:extLst>
           </p:cNvPr>
@@ -2832,7 +2832,7 @@
           <p:cNvPr id="31" name="">
             <a:extLst xmlns:a="http://schemas.openxmlformats.org/drawingml/2006/main">
               <a:ext uri="{FF2B5EF4-FFF2-40B4-BE49-F238E27FC236}">
-                <a16:creationId xmlns:a16="http://schemas.microsoft.com/office/drawing/2014/main" id="{51A25B47-3512-4AED-AE42-B84FC10B0676}"/>
+                <a16:creationId xmlns:a16="http://schemas.microsoft.com/office/drawing/2014/main" id="{53696A0D-DF29-4EB1-B822-6304F6D966D4}"/>
               </a:ext>
             </a:extLst>
           </p:cNvPr>
@@ -2889,7 +2889,7 @@
           <p:cNvPr id="32" name="">
             <a:extLst xmlns:a="http://schemas.openxmlformats.org/drawingml/2006/main">
               <a:ext uri="{FF2B5EF4-FFF2-40B4-BE49-F238E27FC236}">
-                <a16:creationId xmlns:a16="http://schemas.microsoft.com/office/drawing/2014/main" id="{2CD36433-971B-44E8-BA54-99AEA29B412A}"/>
+                <a16:creationId xmlns:a16="http://schemas.microsoft.com/office/drawing/2014/main" id="{58C64288-E284-4E45-BC18-59097EF18532}"/>
               </a:ext>
             </a:extLst>
           </p:cNvPr>
@@ -2946,7 +2946,7 @@
           <p:cNvPr id="33" name="">
             <a:extLst xmlns:a="http://schemas.openxmlformats.org/drawingml/2006/main">
               <a:ext uri="{FF2B5EF4-FFF2-40B4-BE49-F238E27FC236}">
-                <a16:creationId xmlns:a16="http://schemas.microsoft.com/office/drawing/2014/main" id="{2B0A8808-3F86-4AB1-BF05-52A532473646}"/>
+                <a16:creationId xmlns:a16="http://schemas.microsoft.com/office/drawing/2014/main" id="{DB83B350-00E1-4B1D-81DF-8F89397B6932}"/>
               </a:ext>
             </a:extLst>
           </p:cNvPr>
@@ -2981,7 +2981,7 @@
           <p:cNvPr id="34" name="">
             <a:extLst xmlns:a="http://schemas.openxmlformats.org/drawingml/2006/main">
               <a:ext uri="{FF2B5EF4-FFF2-40B4-BE49-F238E27FC236}">
-                <a16:creationId xmlns:a16="http://schemas.microsoft.com/office/drawing/2014/main" id="{8F4638E7-CA8C-411D-BB62-228FA8250465}"/>
+                <a16:creationId xmlns:a16="http://schemas.microsoft.com/office/drawing/2014/main" id="{6136DBC3-2BD8-494A-8BF7-E5949A48DE6B}"/>
               </a:ext>
             </a:extLst>
           </p:cNvPr>
@@ -3045,7 +3045,7 @@
           <p:cNvPr id="35" name="">
             <a:extLst xmlns:a="http://schemas.openxmlformats.org/drawingml/2006/main">
               <a:ext uri="{FF2B5EF4-FFF2-40B4-BE49-F238E27FC236}">
-                <a16:creationId xmlns:a16="http://schemas.microsoft.com/office/drawing/2014/main" id="{06FD06CF-0EA4-4782-BA43-3D59219B1A2B}"/>
+                <a16:creationId xmlns:a16="http://schemas.microsoft.com/office/drawing/2014/main" id="{30CA994E-D04C-45BC-9E16-6350AC412B9B}"/>
               </a:ext>
             </a:extLst>
           </p:cNvPr>
@@ -3102,7 +3102,7 @@
           <p:cNvPr id="36" name="">
             <a:extLst xmlns:a="http://schemas.openxmlformats.org/drawingml/2006/main">
               <a:ext uri="{FF2B5EF4-FFF2-40B4-BE49-F238E27FC236}">
-                <a16:creationId xmlns:a16="http://schemas.microsoft.com/office/drawing/2014/main" id="{E24F02DD-15F5-4B38-A181-0D611E472E9C}"/>
+                <a16:creationId xmlns:a16="http://schemas.microsoft.com/office/drawing/2014/main" id="{E3B194DB-3A72-449D-A864-3A0F833DC87C}"/>
               </a:ext>
             </a:extLst>
           </p:cNvPr>
@@ -3159,7 +3159,7 @@
           <p:cNvPr id="37" name="">
             <a:extLst xmlns:a="http://schemas.openxmlformats.org/drawingml/2006/main">
               <a:ext uri="{FF2B5EF4-FFF2-40B4-BE49-F238E27FC236}">
-                <a16:creationId xmlns:a16="http://schemas.microsoft.com/office/drawing/2014/main" id="{EB6E78FA-FFE8-48BA-AFFA-126F8D10C330}"/>
+                <a16:creationId xmlns:a16="http://schemas.microsoft.com/office/drawing/2014/main" id="{C4D18935-E3F6-4212-9CCA-1E96238A990E}"/>
               </a:ext>
             </a:extLst>
           </p:cNvPr>
@@ -3194,7 +3194,7 @@
           <p:cNvPr id="38" name="">
             <a:extLst xmlns:a="http://schemas.openxmlformats.org/drawingml/2006/main">
               <a:ext uri="{FF2B5EF4-FFF2-40B4-BE49-F238E27FC236}">
-                <a16:creationId xmlns:a16="http://schemas.microsoft.com/office/drawing/2014/main" id="{DF4C72DA-4488-489D-A4F2-418725C2B123}"/>
+                <a16:creationId xmlns:a16="http://schemas.microsoft.com/office/drawing/2014/main" id="{965518CB-2DCF-46DF-BE63-698194920773}"/>
               </a:ext>
             </a:extLst>
           </p:cNvPr>
@@ -3258,7 +3258,7 @@
           <p:cNvPr id="39" name="">
             <a:extLst xmlns:a="http://schemas.openxmlformats.org/drawingml/2006/main">
               <a:ext uri="{FF2B5EF4-FFF2-40B4-BE49-F238E27FC236}">
-                <a16:creationId xmlns:a16="http://schemas.microsoft.com/office/drawing/2014/main" id="{EA5DCC1D-3ECC-44D8-B254-BB5060C85A59}"/>
+                <a16:creationId xmlns:a16="http://schemas.microsoft.com/office/drawing/2014/main" id="{97DC5760-F9F4-4DE6-9C33-1C7D5681B282}"/>
               </a:ext>
             </a:extLst>
           </p:cNvPr>
@@ -3315,7 +3315,7 @@
           <p:cNvPr id="40" name="">
             <a:extLst xmlns:a="http://schemas.openxmlformats.org/drawingml/2006/main">
               <a:ext uri="{FF2B5EF4-FFF2-40B4-BE49-F238E27FC236}">
-                <a16:creationId xmlns:a16="http://schemas.microsoft.com/office/drawing/2014/main" id="{2973519E-DD51-45A7-A6BF-FD63A1DF2562}"/>
+                <a16:creationId xmlns:a16="http://schemas.microsoft.com/office/drawing/2014/main" id="{55A8A4F9-95EA-43A8-B8FF-D7400268D97A}"/>
               </a:ext>
             </a:extLst>
           </p:cNvPr>
@@ -3372,7 +3372,7 @@
           <p:cNvPr id="41" name="">
             <a:extLst xmlns:a="http://schemas.openxmlformats.org/drawingml/2006/main">
               <a:ext uri="{FF2B5EF4-FFF2-40B4-BE49-F238E27FC236}">
-                <a16:creationId xmlns:a16="http://schemas.microsoft.com/office/drawing/2014/main" id="{6CED4958-FAC4-4027-AEA5-1F435BF90F6A}"/>
+                <a16:creationId xmlns:a16="http://schemas.microsoft.com/office/drawing/2014/main" id="{8D70387F-4E55-4487-A7DA-91510E18447C}"/>
               </a:ext>
             </a:extLst>
           </p:cNvPr>
@@ -3407,7 +3407,7 @@
           <p:cNvPr id="42" name="">
             <a:extLst xmlns:a="http://schemas.openxmlformats.org/drawingml/2006/main">
               <a:ext uri="{FF2B5EF4-FFF2-40B4-BE49-F238E27FC236}">
-                <a16:creationId xmlns:a16="http://schemas.microsoft.com/office/drawing/2014/main" id="{2041CF21-E7D5-421F-B393-C5D722FE8B2E}"/>
+                <a16:creationId xmlns:a16="http://schemas.microsoft.com/office/drawing/2014/main" id="{D600ECBC-CE68-4FA7-AD94-BE0D8B66A83C}"/>
               </a:ext>
             </a:extLst>
           </p:cNvPr>
@@ -3471,7 +3471,7 @@
           <p:cNvPr id="43" name="">
             <a:extLst xmlns:a="http://schemas.openxmlformats.org/drawingml/2006/main">
               <a:ext uri="{FF2B5EF4-FFF2-40B4-BE49-F238E27FC236}">
-                <a16:creationId xmlns:a16="http://schemas.microsoft.com/office/drawing/2014/main" id="{84487992-0E04-40C2-936C-0C55F1176EDB}"/>
+                <a16:creationId xmlns:a16="http://schemas.microsoft.com/office/drawing/2014/main" id="{945B28BB-490D-4709-9DB5-6CB697C952B9}"/>
               </a:ext>
             </a:extLst>
           </p:cNvPr>
@@ -3528,7 +3528,7 @@
           <p:cNvPr id="44" name="">
             <a:extLst xmlns:a="http://schemas.openxmlformats.org/drawingml/2006/main">
               <a:ext uri="{FF2B5EF4-FFF2-40B4-BE49-F238E27FC236}">
-                <a16:creationId xmlns:a16="http://schemas.microsoft.com/office/drawing/2014/main" id="{37980E84-FE43-4803-8EFD-B4F1972755FE}"/>
+                <a16:creationId xmlns:a16="http://schemas.microsoft.com/office/drawing/2014/main" id="{C087BF0E-E709-4599-8174-4FE304CAB63A}"/>
               </a:ext>
             </a:extLst>
           </p:cNvPr>
@@ -3585,7 +3585,7 @@
           <p:cNvPr id="45" name="">
             <a:extLst xmlns:a="http://schemas.openxmlformats.org/drawingml/2006/main">
               <a:ext uri="{FF2B5EF4-FFF2-40B4-BE49-F238E27FC236}">
-                <a16:creationId xmlns:a16="http://schemas.microsoft.com/office/drawing/2014/main" id="{857D9CB1-F4A2-487E-93E4-FB2364643F92}"/>
+                <a16:creationId xmlns:a16="http://schemas.microsoft.com/office/drawing/2014/main" id="{487BA7C8-2D88-4F70-87AA-18B4421C8966}"/>
               </a:ext>
             </a:extLst>
           </p:cNvPr>
@@ -3632,7 +3632,7 @@
                 <a:ea typeface="Arial"/>
                 <a:cs typeface="Arial"/>
               </a:rPr>
-              <a:t>AURA • Track A • 27/09/2026</a:t>
+              <a:t>AURA • Track A • 28/09/2026</a:t>
             </a:r>
           </a:p>
         </p:txBody>
@@ -3642,7 +3642,7 @@
           <p:cNvPr id="46" name="">
             <a:extLst xmlns:a="http://schemas.openxmlformats.org/drawingml/2006/main">
               <a:ext uri="{FF2B5EF4-FFF2-40B4-BE49-F238E27FC236}">
-                <a16:creationId xmlns:a16="http://schemas.microsoft.com/office/drawing/2014/main" id="{90B4949D-662D-4811-B27D-25424623BE47}"/>
+                <a16:creationId xmlns:a16="http://schemas.microsoft.com/office/drawing/2014/main" id="{450C0210-1D68-47E6-9E3E-DD393EEFECC0}"/>
               </a:ext>
             </a:extLst>
           </p:cNvPr>
@@ -3697,7 +3697,7 @@
     </p:spTree>
     <p:extLst>
       <p:ext uri="{BB962C8B-B14F-4D97-AF65-F5344CB8AC3E}">
-        <p14:creationId xmlns:p14="http://schemas.microsoft.com/office/powerpoint/2010/main" val="416319040"/>
+        <p14:creationId xmlns:p14="http://schemas.microsoft.com/office/powerpoint/2010/main" val="471610132"/>
       </p:ext>
     </p:extLst>
   </p:cSld>
@@ -3728,7 +3728,7 @@
           <p:cNvPr id="46" name="">
             <a:extLst xmlns:a="http://schemas.openxmlformats.org/drawingml/2006/main">
               <a:ext uri="{FF2B5EF4-FFF2-40B4-BE49-F238E27FC236}">
-                <a16:creationId xmlns:a16="http://schemas.microsoft.com/office/drawing/2014/main" id="{7E802ECC-373A-42B0-B680-77E7C3614F42}"/>
+                <a16:creationId xmlns:a16="http://schemas.microsoft.com/office/drawing/2014/main" id="{BECA64BF-ABD5-4C68-8441-F8301E93E37C}"/>
               </a:ext>
             </a:extLst>
           </p:cNvPr>
@@ -3785,7 +3785,7 @@
           <p:cNvPr id="2" name="">
             <a:extLst xmlns:a="http://schemas.openxmlformats.org/drawingml/2006/main">
               <a:ext uri="{FF2B5EF4-FFF2-40B4-BE49-F238E27FC236}">
-                <a16:creationId xmlns:a16="http://schemas.microsoft.com/office/drawing/2014/main" id="{F24CD579-C03E-454F-8919-D5EDCEE73566}"/>
+                <a16:creationId xmlns:a16="http://schemas.microsoft.com/office/drawing/2014/main" id="{A41D88A1-E7C4-41AC-9148-3180E3445E04}"/>
               </a:ext>
             </a:extLst>
           </p:cNvPr>
@@ -3842,7 +3842,7 @@
           <p:cNvPr id="3" name="">
             <a:extLst xmlns:a="http://schemas.openxmlformats.org/drawingml/2006/main">
               <a:ext uri="{FF2B5EF4-FFF2-40B4-BE49-F238E27FC236}">
-                <a16:creationId xmlns:a16="http://schemas.microsoft.com/office/drawing/2014/main" id="{BE1D70B6-D8CC-4940-BF57-EC7DAD3BB054}"/>
+                <a16:creationId xmlns:a16="http://schemas.microsoft.com/office/drawing/2014/main" id="{2AE9CE7E-1583-41A4-86FD-EB635E8B02B0}"/>
               </a:ext>
             </a:extLst>
           </p:cNvPr>
@@ -3899,7 +3899,7 @@
           <p:cNvPr id="4" name="">
             <a:extLst xmlns:a="http://schemas.openxmlformats.org/drawingml/2006/main">
               <a:ext uri="{FF2B5EF4-FFF2-40B4-BE49-F238E27FC236}">
-                <a16:creationId xmlns:a16="http://schemas.microsoft.com/office/drawing/2014/main" id="{65A23B33-E73D-47B5-AE71-DEEB9825487B}"/>
+                <a16:creationId xmlns:a16="http://schemas.microsoft.com/office/drawing/2014/main" id="{46131AA8-8B60-47B1-BF4A-83DD21FBE4C2}"/>
               </a:ext>
             </a:extLst>
           </p:cNvPr>
@@ -3930,7 +3930,7 @@
           <p:cNvPr id="5" name="">
             <a:extLst xmlns:a="http://schemas.openxmlformats.org/drawingml/2006/main">
               <a:ext uri="{FF2B5EF4-FFF2-40B4-BE49-F238E27FC236}">
-                <a16:creationId xmlns:a16="http://schemas.microsoft.com/office/drawing/2014/main" id="{01573BB9-1BE9-402A-A45E-A52553A9AD92}"/>
+                <a16:creationId xmlns:a16="http://schemas.microsoft.com/office/drawing/2014/main" id="{6D03EE38-322D-4FEC-8DDE-D8738B738363}"/>
               </a:ext>
             </a:extLst>
           </p:cNvPr>
@@ -3965,7 +3965,7 @@
           <p:cNvPr id="6" name="">
             <a:extLst xmlns:a="http://schemas.openxmlformats.org/drawingml/2006/main">
               <a:ext uri="{FF2B5EF4-FFF2-40B4-BE49-F238E27FC236}">
-                <a16:creationId xmlns:a16="http://schemas.microsoft.com/office/drawing/2014/main" id="{15968E68-0280-4CE9-9C48-38E3661A1D7A}"/>
+                <a16:creationId xmlns:a16="http://schemas.microsoft.com/office/drawing/2014/main" id="{1D155FBF-BEC9-4E98-9BBB-297891844E0E}"/>
               </a:ext>
             </a:extLst>
           </p:cNvPr>
@@ -4029,7 +4029,7 @@
           <p:cNvPr id="7" name="">
             <a:extLst xmlns:a="http://schemas.openxmlformats.org/drawingml/2006/main">
               <a:ext uri="{FF2B5EF4-FFF2-40B4-BE49-F238E27FC236}">
-                <a16:creationId xmlns:a16="http://schemas.microsoft.com/office/drawing/2014/main" id="{4F3885F4-454F-4AFA-8062-B03446D33710}"/>
+                <a16:creationId xmlns:a16="http://schemas.microsoft.com/office/drawing/2014/main" id="{D476A85E-929D-4404-B5AA-BE19C4F90FBC}"/>
               </a:ext>
             </a:extLst>
           </p:cNvPr>
@@ -4086,7 +4086,7 @@
           <p:cNvPr id="8" name="">
             <a:extLst xmlns:a="http://schemas.openxmlformats.org/drawingml/2006/main">
               <a:ext uri="{FF2B5EF4-FFF2-40B4-BE49-F238E27FC236}">
-                <a16:creationId xmlns:a16="http://schemas.microsoft.com/office/drawing/2014/main" id="{27175CE0-7F7C-41B6-A19F-D010A0242FE2}"/>
+                <a16:creationId xmlns:a16="http://schemas.microsoft.com/office/drawing/2014/main" id="{BCAED28B-4FDA-4A81-A748-96ED6F343E02}"/>
               </a:ext>
             </a:extLst>
           </p:cNvPr>
@@ -4133,7 +4133,7 @@
                 <a:ea typeface="Arial"/>
                 <a:cs typeface="Arial"/>
               </a:rPr>
-              <a:t>JPG/PNG ≤5MB</a:t>
+              <a:t>Ảnh + số tiền</a:t>
             </a:r>
           </a:p>
           <a:p xmlns:a="http://schemas.openxmlformats.org/drawingml/2006/main">
@@ -4156,7 +4156,7 @@
                 <a:ea typeface="Arial"/>
                 <a:cs typeface="Arial"/>
               </a:rPr>
-              <a:t>+ số tiền</a:t>
+              <a:t>+ người gửi</a:t>
             </a:r>
           </a:p>
         </p:txBody>
@@ -4166,7 +4166,7 @@
           <p:cNvPr id="9" name="">
             <a:extLst xmlns:a="http://schemas.openxmlformats.org/drawingml/2006/main">
               <a:ext uri="{FF2B5EF4-FFF2-40B4-BE49-F238E27FC236}">
-                <a16:creationId xmlns:a16="http://schemas.microsoft.com/office/drawing/2014/main" id="{63778FAF-03D0-49C6-8E7E-4F89F8DFDDCD}"/>
+                <a16:creationId xmlns:a16="http://schemas.microsoft.com/office/drawing/2014/main" id="{E6CFD08E-2193-4DA0-9263-A346918692CA}"/>
               </a:ext>
             </a:extLst>
           </p:cNvPr>
@@ -4198,7 +4198,7 @@
           <p:cNvPr id="10" name="">
             <a:extLst xmlns:a="http://schemas.openxmlformats.org/drawingml/2006/main">
               <a:ext uri="{FF2B5EF4-FFF2-40B4-BE49-F238E27FC236}">
-                <a16:creationId xmlns:a16="http://schemas.microsoft.com/office/drawing/2014/main" id="{FF0A932C-4074-48B0-89BE-288E6ED1AE45}"/>
+                <a16:creationId xmlns:a16="http://schemas.microsoft.com/office/drawing/2014/main" id="{37043D7B-A363-41EE-8D35-67D8CFDC92A3}"/>
               </a:ext>
             </a:extLst>
           </p:cNvPr>
@@ -4233,7 +4233,7 @@
           <p:cNvPr id="11" name="">
             <a:extLst xmlns:a="http://schemas.openxmlformats.org/drawingml/2006/main">
               <a:ext uri="{FF2B5EF4-FFF2-40B4-BE49-F238E27FC236}">
-                <a16:creationId xmlns:a16="http://schemas.microsoft.com/office/drawing/2014/main" id="{3C11D6F7-32B6-44D8-958C-AE5A94F23C6C}"/>
+                <a16:creationId xmlns:a16="http://schemas.microsoft.com/office/drawing/2014/main" id="{7FC278AE-81A2-4247-B984-E97F59B27FBA}"/>
               </a:ext>
             </a:extLst>
           </p:cNvPr>
@@ -4297,7 +4297,7 @@
           <p:cNvPr id="12" name="">
             <a:extLst xmlns:a="http://schemas.openxmlformats.org/drawingml/2006/main">
               <a:ext uri="{FF2B5EF4-FFF2-40B4-BE49-F238E27FC236}">
-                <a16:creationId xmlns:a16="http://schemas.microsoft.com/office/drawing/2014/main" id="{1187DE3C-BC2C-43F8-82D6-5437A174C2F1}"/>
+                <a16:creationId xmlns:a16="http://schemas.microsoft.com/office/drawing/2014/main" id="{E8F9A1ED-A622-486A-94F7-8F28A6624D4E}"/>
               </a:ext>
             </a:extLst>
           </p:cNvPr>
@@ -4344,7 +4344,7 @@
                 <a:ea typeface="Arial"/>
                 <a:cs typeface="Arial"/>
               </a:rPr>
-              <a:t>Kiểm file</a:t>
+              <a:t>Nhận hồ sơ</a:t>
             </a:r>
           </a:p>
         </p:txBody>
@@ -4354,7 +4354,7 @@
           <p:cNvPr id="13" name="">
             <a:extLst xmlns:a="http://schemas.openxmlformats.org/drawingml/2006/main">
               <a:ext uri="{FF2B5EF4-FFF2-40B4-BE49-F238E27FC236}">
-                <a16:creationId xmlns:a16="http://schemas.microsoft.com/office/drawing/2014/main" id="{23BBFD7B-1951-4D85-86C8-7C6E9A728447}"/>
+                <a16:creationId xmlns:a16="http://schemas.microsoft.com/office/drawing/2014/main" id="{A719A28B-5675-4853-847D-2BF4499B4C64}"/>
               </a:ext>
             </a:extLst>
           </p:cNvPr>
@@ -4401,7 +4401,7 @@
                 <a:ea typeface="Arial"/>
                 <a:cs typeface="Arial"/>
               </a:rPr>
-              <a:t>MIME • magic bytes</a:t>
+              <a:t>Lưu PENDING</a:t>
             </a:r>
           </a:p>
           <a:p xmlns:a="http://schemas.openxmlformats.org/drawingml/2006/main">
@@ -4424,7 +4424,7 @@
                 <a:ea typeface="Arial"/>
                 <a:cs typeface="Arial"/>
               </a:rPr>
-              <a:t>SHA-256</a:t>
+              <a:t>trả HTTP 202</a:t>
             </a:r>
           </a:p>
         </p:txBody>
@@ -4434,7 +4434,7 @@
           <p:cNvPr id="14" name="">
             <a:extLst xmlns:a="http://schemas.openxmlformats.org/drawingml/2006/main">
               <a:ext uri="{FF2B5EF4-FFF2-40B4-BE49-F238E27FC236}">
-                <a16:creationId xmlns:a16="http://schemas.microsoft.com/office/drawing/2014/main" id="{44CFBA01-E736-40BF-935E-406831F9DA11}"/>
+                <a16:creationId xmlns:a16="http://schemas.microsoft.com/office/drawing/2014/main" id="{0D1B8002-C62B-4022-82F9-B105C8D69782}"/>
               </a:ext>
             </a:extLst>
           </p:cNvPr>
@@ -4466,7 +4466,7 @@
           <p:cNvPr id="15" name="">
             <a:extLst xmlns:a="http://schemas.openxmlformats.org/drawingml/2006/main">
               <a:ext uri="{FF2B5EF4-FFF2-40B4-BE49-F238E27FC236}">
-                <a16:creationId xmlns:a16="http://schemas.microsoft.com/office/drawing/2014/main" id="{5F589F30-90CB-48DD-8009-01A59BA3B688}"/>
+                <a16:creationId xmlns:a16="http://schemas.microsoft.com/office/drawing/2014/main" id="{C5CD20E7-EBD3-4D00-BC27-763BFB891F41}"/>
               </a:ext>
             </a:extLst>
           </p:cNvPr>
@@ -4501,7 +4501,7 @@
           <p:cNvPr id="16" name="">
             <a:extLst xmlns:a="http://schemas.openxmlformats.org/drawingml/2006/main">
               <a:ext uri="{FF2B5EF4-FFF2-40B4-BE49-F238E27FC236}">
-                <a16:creationId xmlns:a16="http://schemas.microsoft.com/office/drawing/2014/main" id="{91062955-965C-4D3E-8E4B-93167D6D133C}"/>
+                <a16:creationId xmlns:a16="http://schemas.microsoft.com/office/drawing/2014/main" id="{3CC042A8-F67D-4439-BDAB-8FD34326EDBC}"/>
               </a:ext>
             </a:extLst>
           </p:cNvPr>
@@ -4565,7 +4565,7 @@
           <p:cNvPr id="17" name="">
             <a:extLst xmlns:a="http://schemas.openxmlformats.org/drawingml/2006/main">
               <a:ext uri="{FF2B5EF4-FFF2-40B4-BE49-F238E27FC236}">
-                <a16:creationId xmlns:a16="http://schemas.microsoft.com/office/drawing/2014/main" id="{26FDBE0E-F337-4DE8-8372-08161B3458A7}"/>
+                <a16:creationId xmlns:a16="http://schemas.microsoft.com/office/drawing/2014/main" id="{3EAFF1F9-BDCB-4DFF-95D1-1A5035AC5388}"/>
               </a:ext>
             </a:extLst>
           </p:cNvPr>
@@ -4612,7 +4612,7 @@
                 <a:ea typeface="Arial"/>
                 <a:cs typeface="Arial"/>
               </a:rPr>
-              <a:t>Vision</a:t>
+              <a:t>Worker</a:t>
             </a:r>
           </a:p>
         </p:txBody>
@@ -4622,7 +4622,7 @@
           <p:cNvPr id="18" name="">
             <a:extLst xmlns:a="http://schemas.openxmlformats.org/drawingml/2006/main">
               <a:ext uri="{FF2B5EF4-FFF2-40B4-BE49-F238E27FC236}">
-                <a16:creationId xmlns:a16="http://schemas.microsoft.com/office/drawing/2014/main" id="{FB7B9F2E-7BA9-465F-B9C4-294F9867B49F}"/>
+                <a16:creationId xmlns:a16="http://schemas.microsoft.com/office/drawing/2014/main" id="{E8F822EB-4F92-472B-8373-8098266649D9}"/>
               </a:ext>
             </a:extLst>
           </p:cNvPr>
@@ -4669,7 +4669,7 @@
                 <a:ea typeface="Arial"/>
                 <a:cs typeface="Arial"/>
               </a:rPr>
-              <a:t>JSON Schema</a:t>
+              <a:t>Claim bằng lease</a:t>
             </a:r>
           </a:p>
           <a:p xmlns:a="http://schemas.openxmlformats.org/drawingml/2006/main">
@@ -4692,7 +4692,7 @@
                 <a:ea typeface="Arial"/>
                 <a:cs typeface="Arial"/>
               </a:rPr>
-              <a:t>+ semantic repair</a:t>
+              <a:t>khôi phục sau restart</a:t>
             </a:r>
           </a:p>
         </p:txBody>
@@ -4702,7 +4702,7 @@
           <p:cNvPr id="19" name="">
             <a:extLst xmlns:a="http://schemas.openxmlformats.org/drawingml/2006/main">
               <a:ext uri="{FF2B5EF4-FFF2-40B4-BE49-F238E27FC236}">
-                <a16:creationId xmlns:a16="http://schemas.microsoft.com/office/drawing/2014/main" id="{2C619651-87D1-4A12-BEF2-6290C141F090}"/>
+                <a16:creationId xmlns:a16="http://schemas.microsoft.com/office/drawing/2014/main" id="{1C73E80D-8554-4AC3-A82F-5DF4DB0F87A4}"/>
               </a:ext>
             </a:extLst>
           </p:cNvPr>
@@ -4734,7 +4734,7 @@
           <p:cNvPr id="20" name="">
             <a:extLst xmlns:a="http://schemas.openxmlformats.org/drawingml/2006/main">
               <a:ext uri="{FF2B5EF4-FFF2-40B4-BE49-F238E27FC236}">
-                <a16:creationId xmlns:a16="http://schemas.microsoft.com/office/drawing/2014/main" id="{91AE2897-4949-4E65-8EA1-A270D16A0292}"/>
+                <a16:creationId xmlns:a16="http://schemas.microsoft.com/office/drawing/2014/main" id="{A256ECD7-EF39-43A9-AE8B-F3D370D3BCDA}"/>
               </a:ext>
             </a:extLst>
           </p:cNvPr>
@@ -4769,7 +4769,7 @@
           <p:cNvPr id="21" name="">
             <a:extLst xmlns:a="http://schemas.openxmlformats.org/drawingml/2006/main">
               <a:ext uri="{FF2B5EF4-FFF2-40B4-BE49-F238E27FC236}">
-                <a16:creationId xmlns:a16="http://schemas.microsoft.com/office/drawing/2014/main" id="{42E12128-1E45-43BC-92AB-057E9FA95243}"/>
+                <a16:creationId xmlns:a16="http://schemas.microsoft.com/office/drawing/2014/main" id="{9A3353D5-DC45-47ED-AD90-9D562E0E3E8C}"/>
               </a:ext>
             </a:extLst>
           </p:cNvPr>
@@ -4833,7 +4833,7 @@
           <p:cNvPr id="22" name="">
             <a:extLst xmlns:a="http://schemas.openxmlformats.org/drawingml/2006/main">
               <a:ext uri="{FF2B5EF4-FFF2-40B4-BE49-F238E27FC236}">
-                <a16:creationId xmlns:a16="http://schemas.microsoft.com/office/drawing/2014/main" id="{D0A9A8B6-9976-411F-B52C-C224FF1CCEAC}"/>
+                <a16:creationId xmlns:a16="http://schemas.microsoft.com/office/drawing/2014/main" id="{E445A0D3-BC54-4F3E-BB17-F398A4B3C683}"/>
               </a:ext>
             </a:extLst>
           </p:cNvPr>
@@ -4880,7 +4880,7 @@
                 <a:ea typeface="Arial"/>
                 <a:cs typeface="Arial"/>
               </a:rPr>
-              <a:t>Policy</a:t>
+              <a:t>Vision</a:t>
             </a:r>
           </a:p>
         </p:txBody>
@@ -4890,7 +4890,7 @@
           <p:cNvPr id="23" name="">
             <a:extLst xmlns:a="http://schemas.openxmlformats.org/drawingml/2006/main">
               <a:ext uri="{FF2B5EF4-FFF2-40B4-BE49-F238E27FC236}">
-                <a16:creationId xmlns:a16="http://schemas.microsoft.com/office/drawing/2014/main" id="{73EDB0B8-28DF-4A8D-9920-F3B1A5765A20}"/>
+                <a16:creationId xmlns:a16="http://schemas.microsoft.com/office/drawing/2014/main" id="{B8FBC0DB-0173-48BF-B16B-CFBA12F933DD}"/>
               </a:ext>
             </a:extLst>
           </p:cNvPr>
@@ -4937,7 +4937,7 @@
                 <a:ea typeface="Arial"/>
                 <a:cs typeface="Arial"/>
               </a:rPr>
-              <a:t>C# tất định</a:t>
+              <a:t>Primary hoặc fallback</a:t>
             </a:r>
           </a:p>
           <a:p xmlns:a="http://schemas.openxmlformats.org/drawingml/2006/main">
@@ -4960,7 +4960,7 @@
                 <a:ea typeface="Arial"/>
                 <a:cs typeface="Arial"/>
               </a:rPr>
-              <a:t>FACT → POLICY → AUTHORITY</a:t>
+              <a:t>+ semantic repair</a:t>
             </a:r>
           </a:p>
         </p:txBody>
@@ -4970,7 +4970,7 @@
           <p:cNvPr id="24" name="">
             <a:extLst xmlns:a="http://schemas.openxmlformats.org/drawingml/2006/main">
               <a:ext uri="{FF2B5EF4-FFF2-40B4-BE49-F238E27FC236}">
-                <a16:creationId xmlns:a16="http://schemas.microsoft.com/office/drawing/2014/main" id="{40BFAF53-B046-4A71-B1CF-122914E0FF55}"/>
+                <a16:creationId xmlns:a16="http://schemas.microsoft.com/office/drawing/2014/main" id="{BC68115A-67B3-4080-B470-6318FDE31F52}"/>
               </a:ext>
             </a:extLst>
           </p:cNvPr>
@@ -5002,7 +5002,7 @@
           <p:cNvPr id="25" name="">
             <a:extLst xmlns:a="http://schemas.openxmlformats.org/drawingml/2006/main">
               <a:ext uri="{FF2B5EF4-FFF2-40B4-BE49-F238E27FC236}">
-                <a16:creationId xmlns:a16="http://schemas.microsoft.com/office/drawing/2014/main" id="{B7C73259-140A-4D02-9810-04F6B31FA975}"/>
+                <a16:creationId xmlns:a16="http://schemas.microsoft.com/office/drawing/2014/main" id="{17795A6F-5319-476A-B5BF-32CBB53DDE24}"/>
               </a:ext>
             </a:extLst>
           </p:cNvPr>
@@ -5037,7 +5037,7 @@
           <p:cNvPr id="26" name="">
             <a:extLst xmlns:a="http://schemas.openxmlformats.org/drawingml/2006/main">
               <a:ext uri="{FF2B5EF4-FFF2-40B4-BE49-F238E27FC236}">
-                <a16:creationId xmlns:a16="http://schemas.microsoft.com/office/drawing/2014/main" id="{355E3971-1628-49FC-8FA9-3C53C3669577}"/>
+                <a16:creationId xmlns:a16="http://schemas.microsoft.com/office/drawing/2014/main" id="{077FD1E1-7ED3-460B-963A-E6D959723C87}"/>
               </a:ext>
             </a:extLst>
           </p:cNvPr>
@@ -5101,7 +5101,7 @@
           <p:cNvPr id="27" name="">
             <a:extLst xmlns:a="http://schemas.openxmlformats.org/drawingml/2006/main">
               <a:ext uri="{FF2B5EF4-FFF2-40B4-BE49-F238E27FC236}">
-                <a16:creationId xmlns:a16="http://schemas.microsoft.com/office/drawing/2014/main" id="{7642EACD-5E6E-40C3-9BF7-5EECFA0897C6}"/>
+                <a16:creationId xmlns:a16="http://schemas.microsoft.com/office/drawing/2014/main" id="{655A5341-3335-43CB-9E6D-FE2A0444486B}"/>
               </a:ext>
             </a:extLst>
           </p:cNvPr>
@@ -5148,7 +5148,7 @@
                 <a:ea typeface="Arial"/>
                 <a:cs typeface="Arial"/>
               </a:rPr>
-              <a:t>Kết quả</a:t>
+              <a:t>Policy</a:t>
             </a:r>
           </a:p>
         </p:txBody>
@@ -5158,7 +5158,7 @@
           <p:cNvPr id="28" name="">
             <a:extLst xmlns:a="http://schemas.openxmlformats.org/drawingml/2006/main">
               <a:ext uri="{FF2B5EF4-FFF2-40B4-BE49-F238E27FC236}">
-                <a16:creationId xmlns:a16="http://schemas.microsoft.com/office/drawing/2014/main" id="{A4AFED9E-499D-49BC-91A6-D103D38D20F6}"/>
+                <a16:creationId xmlns:a16="http://schemas.microsoft.com/office/drawing/2014/main" id="{9057EF70-CBF6-4A9D-A2EC-5CDB8E2FF64E}"/>
               </a:ext>
             </a:extLst>
           </p:cNvPr>
@@ -5238,7 +5238,7 @@
           <p:cNvPr id="29" name="">
             <a:extLst xmlns:a="http://schemas.openxmlformats.org/drawingml/2006/main">
               <a:ext uri="{FF2B5EF4-FFF2-40B4-BE49-F238E27FC236}">
-                <a16:creationId xmlns:a16="http://schemas.microsoft.com/office/drawing/2014/main" id="{665D29DB-1DA6-4E38-98B4-DC1D49FCD933}"/>
+                <a16:creationId xmlns:a16="http://schemas.microsoft.com/office/drawing/2014/main" id="{4A171EF8-1518-4424-BFFE-B378FDAD8A31}"/>
               </a:ext>
             </a:extLst>
           </p:cNvPr>
@@ -5295,7 +5295,7 @@
           <p:cNvPr id="30" name="">
             <a:extLst xmlns:a="http://schemas.openxmlformats.org/drawingml/2006/main">
               <a:ext uri="{FF2B5EF4-FFF2-40B4-BE49-F238E27FC236}">
-                <a16:creationId xmlns:a16="http://schemas.microsoft.com/office/drawing/2014/main" id="{DDC9FF5D-D129-4B63-938B-D4BF580121FB}"/>
+                <a16:creationId xmlns:a16="http://schemas.microsoft.com/office/drawing/2014/main" id="{D0B52E2F-B6AB-44A9-AD06-8BE21C931AC7}"/>
               </a:ext>
             </a:extLst>
           </p:cNvPr>
@@ -5330,7 +5330,7 @@
           <p:cNvPr id="31" name="">
             <a:extLst xmlns:a="http://schemas.openxmlformats.org/drawingml/2006/main">
               <a:ext uri="{FF2B5EF4-FFF2-40B4-BE49-F238E27FC236}">
-                <a16:creationId xmlns:a16="http://schemas.microsoft.com/office/drawing/2014/main" id="{BA63295E-E847-41D2-83EA-0117CF9DA70E}"/>
+                <a16:creationId xmlns:a16="http://schemas.microsoft.com/office/drawing/2014/main" id="{9A4CF0E7-2A06-4519-BF8F-9512B5E448EB}"/>
               </a:ext>
             </a:extLst>
           </p:cNvPr>
@@ -5387,7 +5387,7 @@
           <p:cNvPr id="32" name="">
             <a:extLst xmlns:a="http://schemas.openxmlformats.org/drawingml/2006/main">
               <a:ext uri="{FF2B5EF4-FFF2-40B4-BE49-F238E27FC236}">
-                <a16:creationId xmlns:a16="http://schemas.microsoft.com/office/drawing/2014/main" id="{F26D6E69-2F47-47CA-AF97-6CB1DFAAEA89}"/>
+                <a16:creationId xmlns:a16="http://schemas.microsoft.com/office/drawing/2014/main" id="{57DB7137-D438-4542-B75E-61755EAD4F51}"/>
               </a:ext>
             </a:extLst>
           </p:cNvPr>
@@ -5490,7 +5490,7 @@
           <p:cNvPr id="33" name="">
             <a:extLst xmlns:a="http://schemas.openxmlformats.org/drawingml/2006/main">
               <a:ext uri="{FF2B5EF4-FFF2-40B4-BE49-F238E27FC236}">
-                <a16:creationId xmlns:a16="http://schemas.microsoft.com/office/drawing/2014/main" id="{F9DFE736-B81B-4629-8D26-CD9276E7CD51}"/>
+                <a16:creationId xmlns:a16="http://schemas.microsoft.com/office/drawing/2014/main" id="{10572BFA-2A26-4571-ADE1-43E82EAF3AAA}"/>
               </a:ext>
             </a:extLst>
           </p:cNvPr>
@@ -5554,7 +5554,7 @@
           <p:cNvPr id="34" name="">
             <a:extLst xmlns:a="http://schemas.openxmlformats.org/drawingml/2006/main">
               <a:ext uri="{FF2B5EF4-FFF2-40B4-BE49-F238E27FC236}">
-                <a16:creationId xmlns:a16="http://schemas.microsoft.com/office/drawing/2014/main" id="{B94F9699-62BD-448F-A797-F597159A65DE}"/>
+                <a16:creationId xmlns:a16="http://schemas.microsoft.com/office/drawing/2014/main" id="{03DA5A23-8043-4DD8-828B-44F7A6DF8DC0}"/>
               </a:ext>
             </a:extLst>
           </p:cNvPr>
@@ -5611,7 +5611,7 @@
           <p:cNvPr id="35" name="">
             <a:extLst xmlns:a="http://schemas.openxmlformats.org/drawingml/2006/main">
               <a:ext uri="{FF2B5EF4-FFF2-40B4-BE49-F238E27FC236}">
-                <a16:creationId xmlns:a16="http://schemas.microsoft.com/office/drawing/2014/main" id="{E0B317D6-A12D-4020-ABE6-5517B17619ED}"/>
+                <a16:creationId xmlns:a16="http://schemas.microsoft.com/office/drawing/2014/main" id="{190A84B7-1556-44C2-9D58-B992848C65E5}"/>
               </a:ext>
             </a:extLst>
           </p:cNvPr>
@@ -5646,7 +5646,7 @@
           <p:cNvPr id="36" name="">
             <a:extLst xmlns:a="http://schemas.openxmlformats.org/drawingml/2006/main">
               <a:ext uri="{FF2B5EF4-FFF2-40B4-BE49-F238E27FC236}">
-                <a16:creationId xmlns:a16="http://schemas.microsoft.com/office/drawing/2014/main" id="{42E7069D-D9E5-4857-BA11-3A8B279DF0EA}"/>
+                <a16:creationId xmlns:a16="http://schemas.microsoft.com/office/drawing/2014/main" id="{041F6ECE-05D9-4929-95D9-ACC61CA5A928}"/>
               </a:ext>
             </a:extLst>
           </p:cNvPr>
@@ -5703,7 +5703,7 @@
           <p:cNvPr id="37" name="">
             <a:extLst xmlns:a="http://schemas.openxmlformats.org/drawingml/2006/main">
               <a:ext uri="{FF2B5EF4-FFF2-40B4-BE49-F238E27FC236}">
-                <a16:creationId xmlns:a16="http://schemas.microsoft.com/office/drawing/2014/main" id="{0249DD5F-1F0A-46AB-8C8D-127D647BBAC9}"/>
+                <a16:creationId xmlns:a16="http://schemas.microsoft.com/office/drawing/2014/main" id="{C76D600A-CCC1-46BF-9605-9172DCE225F4}"/>
               </a:ext>
             </a:extLst>
           </p:cNvPr>
@@ -5738,7 +5738,7 @@
           <p:cNvPr id="38" name="">
             <a:extLst xmlns:a="http://schemas.openxmlformats.org/drawingml/2006/main">
               <a:ext uri="{FF2B5EF4-FFF2-40B4-BE49-F238E27FC236}">
-                <a16:creationId xmlns:a16="http://schemas.microsoft.com/office/drawing/2014/main" id="{7FF2B915-358E-4067-9BC2-23930135456C}"/>
+                <a16:creationId xmlns:a16="http://schemas.microsoft.com/office/drawing/2014/main" id="{4F6E1B76-46B1-4A50-B613-2D726236F63C}"/>
               </a:ext>
             </a:extLst>
           </p:cNvPr>
@@ -5795,7 +5795,7 @@
           <p:cNvPr id="39" name="">
             <a:extLst xmlns:a="http://schemas.openxmlformats.org/drawingml/2006/main">
               <a:ext uri="{FF2B5EF4-FFF2-40B4-BE49-F238E27FC236}">
-                <a16:creationId xmlns:a16="http://schemas.microsoft.com/office/drawing/2014/main" id="{DB40092D-1288-4BF8-85E0-103AE12073DA}"/>
+                <a16:creationId xmlns:a16="http://schemas.microsoft.com/office/drawing/2014/main" id="{26181900-2E01-49A4-BC3C-F5E1A83C4CF4}"/>
               </a:ext>
             </a:extLst>
           </p:cNvPr>
@@ -5852,7 +5852,7 @@
           <p:cNvPr id="40" name="">
             <a:extLst xmlns:a="http://schemas.openxmlformats.org/drawingml/2006/main">
               <a:ext uri="{FF2B5EF4-FFF2-40B4-BE49-F238E27FC236}">
-                <a16:creationId xmlns:a16="http://schemas.microsoft.com/office/drawing/2014/main" id="{4F119F92-EBC7-4885-971E-E01A47BBAFB1}"/>
+                <a16:creationId xmlns:a16="http://schemas.microsoft.com/office/drawing/2014/main" id="{5FDE8118-6F1D-401A-9F7E-6BF601FAB09E}"/>
               </a:ext>
             </a:extLst>
           </p:cNvPr>
@@ -5887,7 +5887,7 @@
           <p:cNvPr id="41" name="">
             <a:extLst xmlns:a="http://schemas.openxmlformats.org/drawingml/2006/main">
               <a:ext uri="{FF2B5EF4-FFF2-40B4-BE49-F238E27FC236}">
-                <a16:creationId xmlns:a16="http://schemas.microsoft.com/office/drawing/2014/main" id="{B780295E-1FD9-482C-B86D-5136BA4A9A13}"/>
+                <a16:creationId xmlns:a16="http://schemas.microsoft.com/office/drawing/2014/main" id="{95785793-FC7D-4ADE-BB2F-7D5DA5C87FC5}"/>
               </a:ext>
             </a:extLst>
           </p:cNvPr>
@@ -5944,7 +5944,7 @@
           <p:cNvPr id="42" name="">
             <a:extLst xmlns:a="http://schemas.openxmlformats.org/drawingml/2006/main">
               <a:ext uri="{FF2B5EF4-FFF2-40B4-BE49-F238E27FC236}">
-                <a16:creationId xmlns:a16="http://schemas.microsoft.com/office/drawing/2014/main" id="{C01860C4-1723-455B-ACF7-F81205ADE25F}"/>
+                <a16:creationId xmlns:a16="http://schemas.microsoft.com/office/drawing/2014/main" id="{EDD8834C-D3C5-48E4-B329-8D2EED7E0858}"/>
               </a:ext>
             </a:extLst>
           </p:cNvPr>
@@ -6001,7 +6001,7 @@
           <p:cNvPr id="43" name="">
             <a:extLst xmlns:a="http://schemas.openxmlformats.org/drawingml/2006/main">
               <a:ext uri="{FF2B5EF4-FFF2-40B4-BE49-F238E27FC236}">
-                <a16:creationId xmlns:a16="http://schemas.microsoft.com/office/drawing/2014/main" id="{B6731A43-A0EC-41C7-B6B8-DD53797E244E}"/>
+                <a16:creationId xmlns:a16="http://schemas.microsoft.com/office/drawing/2014/main" id="{319B5AF1-7243-4791-99AF-93792E82F6B8}"/>
               </a:ext>
             </a:extLst>
           </p:cNvPr>
@@ -6058,7 +6058,7 @@
           <p:cNvPr id="44" name="">
             <a:extLst xmlns:a="http://schemas.openxmlformats.org/drawingml/2006/main">
               <a:ext uri="{FF2B5EF4-FFF2-40B4-BE49-F238E27FC236}">
-                <a16:creationId xmlns:a16="http://schemas.microsoft.com/office/drawing/2014/main" id="{C8FA0309-35E6-4D40-8D9C-231CE4673112}"/>
+                <a16:creationId xmlns:a16="http://schemas.microsoft.com/office/drawing/2014/main" id="{181B7454-5A75-4D1A-821A-CAE18502508C}"/>
               </a:ext>
             </a:extLst>
           </p:cNvPr>
@@ -6105,7 +6105,7 @@
                 <a:ea typeface="Arial"/>
                 <a:cs typeface="Arial"/>
               </a:rPr>
-              <a:t>AURA • Track A • 27/09/2026</a:t>
+              <a:t>AURA • Track A • 28/09/2026</a:t>
             </a:r>
           </a:p>
         </p:txBody>
@@ -6115,7 +6115,7 @@
           <p:cNvPr id="45" name="">
             <a:extLst xmlns:a="http://schemas.openxmlformats.org/drawingml/2006/main">
               <a:ext uri="{FF2B5EF4-FFF2-40B4-BE49-F238E27FC236}">
-                <a16:creationId xmlns:a16="http://schemas.microsoft.com/office/drawing/2014/main" id="{534B01D5-253B-49F3-831C-685E91FCD057}"/>
+                <a16:creationId xmlns:a16="http://schemas.microsoft.com/office/drawing/2014/main" id="{35B6F12A-A6DF-49B3-A033-96113F8B3CCC}"/>
               </a:ext>
             </a:extLst>
           </p:cNvPr>
@@ -6170,7 +6170,7 @@
     </p:spTree>
     <p:extLst>
       <p:ext uri="{BB962C8B-B14F-4D97-AF65-F5344CB8AC3E}">
-        <p14:creationId xmlns:p14="http://schemas.microsoft.com/office/powerpoint/2010/main" val="2131015304"/>
+        <p14:creationId xmlns:p14="http://schemas.microsoft.com/office/powerpoint/2010/main" val="784806105"/>
       </p:ext>
     </p:extLst>
   </p:cSld>
@@ -6201,7 +6201,7 @@
           <p:cNvPr id="32" name="">
             <a:extLst xmlns:a="http://schemas.openxmlformats.org/drawingml/2006/main">
               <a:ext uri="{FF2B5EF4-FFF2-40B4-BE49-F238E27FC236}">
-                <a16:creationId xmlns:a16="http://schemas.microsoft.com/office/drawing/2014/main" id="{3504F7A3-2F76-420B-A56A-9E3A7DD1C09A}"/>
+                <a16:creationId xmlns:a16="http://schemas.microsoft.com/office/drawing/2014/main" id="{8F592570-DA95-4DA5-955E-307956D5C3E4}"/>
               </a:ext>
             </a:extLst>
           </p:cNvPr>
@@ -6258,7 +6258,7 @@
           <p:cNvPr id="2" name="">
             <a:extLst xmlns:a="http://schemas.openxmlformats.org/drawingml/2006/main">
               <a:ext uri="{FF2B5EF4-FFF2-40B4-BE49-F238E27FC236}">
-                <a16:creationId xmlns:a16="http://schemas.microsoft.com/office/drawing/2014/main" id="{01A41E1A-AF42-4F0A-BE13-EC78643208CC}"/>
+                <a16:creationId xmlns:a16="http://schemas.microsoft.com/office/drawing/2014/main" id="{A4A2E198-46A0-4625-A42D-47620626A713}"/>
               </a:ext>
             </a:extLst>
           </p:cNvPr>
@@ -6315,7 +6315,7 @@
           <p:cNvPr id="3" name="">
             <a:extLst xmlns:a="http://schemas.openxmlformats.org/drawingml/2006/main">
               <a:ext uri="{FF2B5EF4-FFF2-40B4-BE49-F238E27FC236}">
-                <a16:creationId xmlns:a16="http://schemas.microsoft.com/office/drawing/2014/main" id="{73045061-BC94-4238-901A-9C2134B04B72}"/>
+                <a16:creationId xmlns:a16="http://schemas.microsoft.com/office/drawing/2014/main" id="{FD6667D6-C822-462F-90EB-6FDA3B734F3B}"/>
               </a:ext>
             </a:extLst>
           </p:cNvPr>
@@ -6372,7 +6372,7 @@
           <p:cNvPr id="4" name="">
             <a:extLst xmlns:a="http://schemas.openxmlformats.org/drawingml/2006/main">
               <a:ext uri="{FF2B5EF4-FFF2-40B4-BE49-F238E27FC236}">
-                <a16:creationId xmlns:a16="http://schemas.microsoft.com/office/drawing/2014/main" id="{22656E99-79B4-47B4-BCAB-686D787A8981}"/>
+                <a16:creationId xmlns:a16="http://schemas.microsoft.com/office/drawing/2014/main" id="{386E53CB-8EAF-47F3-92D8-55AF617E3333}"/>
               </a:ext>
             </a:extLst>
           </p:cNvPr>
@@ -6403,7 +6403,7 @@
           <p:cNvPr id="5" name="">
             <a:extLst xmlns:a="http://schemas.openxmlformats.org/drawingml/2006/main">
               <a:ext uri="{FF2B5EF4-FFF2-40B4-BE49-F238E27FC236}">
-                <a16:creationId xmlns:a16="http://schemas.microsoft.com/office/drawing/2014/main" id="{6629C8E7-C1AB-4DB4-94DA-904FB750B07E}"/>
+                <a16:creationId xmlns:a16="http://schemas.microsoft.com/office/drawing/2014/main" id="{08F5A809-E04E-4B29-BF6C-775F5E352B6C}"/>
               </a:ext>
             </a:extLst>
           </p:cNvPr>
@@ -6438,7 +6438,7 @@
           <p:cNvPr id="6" name="">
             <a:extLst xmlns:a="http://schemas.openxmlformats.org/drawingml/2006/main">
               <a:ext uri="{FF2B5EF4-FFF2-40B4-BE49-F238E27FC236}">
-                <a16:creationId xmlns:a16="http://schemas.microsoft.com/office/drawing/2014/main" id="{AF00511E-1668-4D77-B6F0-2CC183976EB9}"/>
+                <a16:creationId xmlns:a16="http://schemas.microsoft.com/office/drawing/2014/main" id="{55DD62BC-90C6-4285-96FD-FFCB14BDE69D}"/>
               </a:ext>
             </a:extLst>
           </p:cNvPr>
@@ -6502,7 +6502,7 @@
           <p:cNvPr id="7" name="">
             <a:extLst xmlns:a="http://schemas.openxmlformats.org/drawingml/2006/main">
               <a:ext uri="{FF2B5EF4-FFF2-40B4-BE49-F238E27FC236}">
-                <a16:creationId xmlns:a16="http://schemas.microsoft.com/office/drawing/2014/main" id="{8B3028CA-D038-42E8-A8DB-85FFEBF71B99}"/>
+                <a16:creationId xmlns:a16="http://schemas.microsoft.com/office/drawing/2014/main" id="{F3C4BBA8-9D34-4356-BF9D-6178D7E3FA5E}"/>
               </a:ext>
             </a:extLst>
           </p:cNvPr>
@@ -6559,7 +6559,7 @@
           <p:cNvPr id="8" name="">
             <a:extLst xmlns:a="http://schemas.openxmlformats.org/drawingml/2006/main">
               <a:ext uri="{FF2B5EF4-FFF2-40B4-BE49-F238E27FC236}">
-                <a16:creationId xmlns:a16="http://schemas.microsoft.com/office/drawing/2014/main" id="{9BB0372E-E65E-4FCB-BA5C-14FDCDBBAF9A}"/>
+                <a16:creationId xmlns:a16="http://schemas.microsoft.com/office/drawing/2014/main" id="{07A099F2-4F65-4401-A162-8D868E2569CC}"/>
               </a:ext>
             </a:extLst>
           </p:cNvPr>
@@ -6662,7 +6662,7 @@
           <p:cNvPr id="9" name="">
             <a:extLst xmlns:a="http://schemas.openxmlformats.org/drawingml/2006/main">
               <a:ext uri="{FF2B5EF4-FFF2-40B4-BE49-F238E27FC236}">
-                <a16:creationId xmlns:a16="http://schemas.microsoft.com/office/drawing/2014/main" id="{106B82A9-C42E-4853-AEC9-912EE927198B}"/>
+                <a16:creationId xmlns:a16="http://schemas.microsoft.com/office/drawing/2014/main" id="{96B0F1F6-8C20-44A0-964F-93027A2C456B}"/>
               </a:ext>
             </a:extLst>
           </p:cNvPr>
@@ -6697,7 +6697,7 @@
           <p:cNvPr id="10" name="">
             <a:extLst xmlns:a="http://schemas.openxmlformats.org/drawingml/2006/main">
               <a:ext uri="{FF2B5EF4-FFF2-40B4-BE49-F238E27FC236}">
-                <a16:creationId xmlns:a16="http://schemas.microsoft.com/office/drawing/2014/main" id="{06DBA6A5-8C91-4925-9A7E-AE42749B916B}"/>
+                <a16:creationId xmlns:a16="http://schemas.microsoft.com/office/drawing/2014/main" id="{509E3170-C9F1-49B3-B747-67BF6229F745}"/>
               </a:ext>
             </a:extLst>
           </p:cNvPr>
@@ -6761,7 +6761,7 @@
           <p:cNvPr id="11" name="">
             <a:extLst xmlns:a="http://schemas.openxmlformats.org/drawingml/2006/main">
               <a:ext uri="{FF2B5EF4-FFF2-40B4-BE49-F238E27FC236}">
-                <a16:creationId xmlns:a16="http://schemas.microsoft.com/office/drawing/2014/main" id="{535CCC4A-6630-424A-96B4-FF2599991BFB}"/>
+                <a16:creationId xmlns:a16="http://schemas.microsoft.com/office/drawing/2014/main" id="{DD5A962D-3B68-4F26-8E08-63F1177A37BD}"/>
               </a:ext>
             </a:extLst>
           </p:cNvPr>
@@ -6818,7 +6818,7 @@
           <p:cNvPr id="12" name="">
             <a:extLst xmlns:a="http://schemas.openxmlformats.org/drawingml/2006/main">
               <a:ext uri="{FF2B5EF4-FFF2-40B4-BE49-F238E27FC236}">
-                <a16:creationId xmlns:a16="http://schemas.microsoft.com/office/drawing/2014/main" id="{A40F1A27-DBBB-48AB-8A52-DEA1C27FAB9E}"/>
+                <a16:creationId xmlns:a16="http://schemas.microsoft.com/office/drawing/2014/main" id="{4C3DA508-1EE3-4E60-8433-EC30BDD2294B}"/>
               </a:ext>
             </a:extLst>
           </p:cNvPr>
@@ -6921,7 +6921,7 @@
           <p:cNvPr id="13" name="">
             <a:extLst xmlns:a="http://schemas.openxmlformats.org/drawingml/2006/main">
               <a:ext uri="{FF2B5EF4-FFF2-40B4-BE49-F238E27FC236}">
-                <a16:creationId xmlns:a16="http://schemas.microsoft.com/office/drawing/2014/main" id="{65D84DA2-A149-41DF-95D0-E56474AA7A4A}"/>
+                <a16:creationId xmlns:a16="http://schemas.microsoft.com/office/drawing/2014/main" id="{D3DD97C5-4D90-4761-83EC-96889298C116}"/>
               </a:ext>
             </a:extLst>
           </p:cNvPr>
@@ -6978,7 +6978,7 @@
           <p:cNvPr id="14" name="">
             <a:extLst xmlns:a="http://schemas.openxmlformats.org/drawingml/2006/main">
               <a:ext uri="{FF2B5EF4-FFF2-40B4-BE49-F238E27FC236}">
-                <a16:creationId xmlns:a16="http://schemas.microsoft.com/office/drawing/2014/main" id="{01E665D7-D0E6-4007-8744-59ACEF841FF3}"/>
+                <a16:creationId xmlns:a16="http://schemas.microsoft.com/office/drawing/2014/main" id="{A32FBCEB-99F5-4005-A693-395F0B0C7999}"/>
               </a:ext>
             </a:extLst>
           </p:cNvPr>
@@ -7013,7 +7013,7 @@
           <p:cNvPr id="15" name="">
             <a:extLst xmlns:a="http://schemas.openxmlformats.org/drawingml/2006/main">
               <a:ext uri="{FF2B5EF4-FFF2-40B4-BE49-F238E27FC236}">
-                <a16:creationId xmlns:a16="http://schemas.microsoft.com/office/drawing/2014/main" id="{2044DFEC-7276-4D69-89D6-29DEA923E440}"/>
+                <a16:creationId xmlns:a16="http://schemas.microsoft.com/office/drawing/2014/main" id="{18EF5F3A-8240-412E-899E-EE988265C6A2}"/>
               </a:ext>
             </a:extLst>
           </p:cNvPr>
@@ -7060,7 +7060,7 @@
                 <a:ea typeface="Arial"/>
                 <a:cs typeface="Arial"/>
               </a:rPr>
-              <a:t>70/70</a:t>
+              <a:t>80/80</a:t>
             </a:r>
           </a:p>
         </p:txBody>
@@ -7070,7 +7070,7 @@
           <p:cNvPr id="16" name="">
             <a:extLst xmlns:a="http://schemas.openxmlformats.org/drawingml/2006/main">
               <a:ext uri="{FF2B5EF4-FFF2-40B4-BE49-F238E27FC236}">
-                <a16:creationId xmlns:a16="http://schemas.microsoft.com/office/drawing/2014/main" id="{FE8CBCF1-8AA6-4174-8D12-5497A850BA45}"/>
+                <a16:creationId xmlns:a16="http://schemas.microsoft.com/office/drawing/2014/main" id="{1B28C39E-672C-41EF-98FA-62FE544EF7D7}"/>
               </a:ext>
             </a:extLst>
           </p:cNvPr>
@@ -7127,7 +7127,7 @@
           <p:cNvPr id="17" name="">
             <a:extLst xmlns:a="http://schemas.openxmlformats.org/drawingml/2006/main">
               <a:ext uri="{FF2B5EF4-FFF2-40B4-BE49-F238E27FC236}">
-                <a16:creationId xmlns:a16="http://schemas.microsoft.com/office/drawing/2014/main" id="{8C53D0DF-6BFE-468D-8F41-86EF26422C73}"/>
+                <a16:creationId xmlns:a16="http://schemas.microsoft.com/office/drawing/2014/main" id="{E482A920-2AB3-45C1-B94E-52DF62849946}"/>
               </a:ext>
             </a:extLst>
           </p:cNvPr>
@@ -7162,7 +7162,7 @@
           <p:cNvPr id="18" name="">
             <a:extLst xmlns:a="http://schemas.openxmlformats.org/drawingml/2006/main">
               <a:ext uri="{FF2B5EF4-FFF2-40B4-BE49-F238E27FC236}">
-                <a16:creationId xmlns:a16="http://schemas.microsoft.com/office/drawing/2014/main" id="{1E61C449-B78E-43CD-B152-BD31B372511B}"/>
+                <a16:creationId xmlns:a16="http://schemas.microsoft.com/office/drawing/2014/main" id="{D9388B0D-EE3D-4FF9-AB7C-311614A41CFE}"/>
               </a:ext>
             </a:extLst>
           </p:cNvPr>
@@ -7219,7 +7219,7 @@
           <p:cNvPr id="19" name="">
             <a:extLst xmlns:a="http://schemas.openxmlformats.org/drawingml/2006/main">
               <a:ext uri="{FF2B5EF4-FFF2-40B4-BE49-F238E27FC236}">
-                <a16:creationId xmlns:a16="http://schemas.microsoft.com/office/drawing/2014/main" id="{C3C0AFDA-624D-4A9A-8543-2E49F9E86FB9}"/>
+                <a16:creationId xmlns:a16="http://schemas.microsoft.com/office/drawing/2014/main" id="{E51D4998-7B44-4BF7-A2BD-7291F8E90B99}"/>
               </a:ext>
             </a:extLst>
           </p:cNvPr>
@@ -7276,7 +7276,7 @@
           <p:cNvPr id="20" name="">
             <a:extLst xmlns:a="http://schemas.openxmlformats.org/drawingml/2006/main">
               <a:ext uri="{FF2B5EF4-FFF2-40B4-BE49-F238E27FC236}">
-                <a16:creationId xmlns:a16="http://schemas.microsoft.com/office/drawing/2014/main" id="{8E01DEAC-6B75-4AF6-AF90-E5684E04CC50}"/>
+                <a16:creationId xmlns:a16="http://schemas.microsoft.com/office/drawing/2014/main" id="{CB805D05-24C9-4B21-8D29-01282C16CDE6}"/>
               </a:ext>
             </a:extLst>
           </p:cNvPr>
@@ -7311,7 +7311,7 @@
           <p:cNvPr id="21" name="">
             <a:extLst xmlns:a="http://schemas.openxmlformats.org/drawingml/2006/main">
               <a:ext uri="{FF2B5EF4-FFF2-40B4-BE49-F238E27FC236}">
-                <a16:creationId xmlns:a16="http://schemas.microsoft.com/office/drawing/2014/main" id="{94FCDB9C-107F-46C4-AF04-88EFD7072ECA}"/>
+                <a16:creationId xmlns:a16="http://schemas.microsoft.com/office/drawing/2014/main" id="{34AB1469-0634-4A1F-B645-29533F92E785}"/>
               </a:ext>
             </a:extLst>
           </p:cNvPr>
@@ -7368,7 +7368,7 @@
           <p:cNvPr id="22" name="">
             <a:extLst xmlns:a="http://schemas.openxmlformats.org/drawingml/2006/main">
               <a:ext uri="{FF2B5EF4-FFF2-40B4-BE49-F238E27FC236}">
-                <a16:creationId xmlns:a16="http://schemas.microsoft.com/office/drawing/2014/main" id="{49B8D79A-8C8A-4C76-A14E-250607C466D1}"/>
+                <a16:creationId xmlns:a16="http://schemas.microsoft.com/office/drawing/2014/main" id="{4A87A388-E2BB-4358-BBF9-E2C3B345B77F}"/>
               </a:ext>
             </a:extLst>
           </p:cNvPr>
@@ -7425,7 +7425,7 @@
           <p:cNvPr id="23" name="">
             <a:extLst xmlns:a="http://schemas.openxmlformats.org/drawingml/2006/main">
               <a:ext uri="{FF2B5EF4-FFF2-40B4-BE49-F238E27FC236}">
-                <a16:creationId xmlns:a16="http://schemas.microsoft.com/office/drawing/2014/main" id="{6B5E69AE-8C06-4A46-BA82-70D36BA9D3BB}"/>
+                <a16:creationId xmlns:a16="http://schemas.microsoft.com/office/drawing/2014/main" id="{12E2ADB2-38FE-460C-BFFC-5EE285219DC1}"/>
               </a:ext>
             </a:extLst>
           </p:cNvPr>
@@ -7460,7 +7460,7 @@
           <p:cNvPr id="24" name="">
             <a:extLst xmlns:a="http://schemas.openxmlformats.org/drawingml/2006/main">
               <a:ext uri="{FF2B5EF4-FFF2-40B4-BE49-F238E27FC236}">
-                <a16:creationId xmlns:a16="http://schemas.microsoft.com/office/drawing/2014/main" id="{2F80F450-4304-439F-84C0-B6CBDA47D51C}"/>
+                <a16:creationId xmlns:a16="http://schemas.microsoft.com/office/drawing/2014/main" id="{246F2763-848A-422E-B708-B77109DDD2B2}"/>
               </a:ext>
             </a:extLst>
           </p:cNvPr>
@@ -7517,7 +7517,7 @@
           <p:cNvPr id="25" name="">
             <a:extLst xmlns:a="http://schemas.openxmlformats.org/drawingml/2006/main">
               <a:ext uri="{FF2B5EF4-FFF2-40B4-BE49-F238E27FC236}">
-                <a16:creationId xmlns:a16="http://schemas.microsoft.com/office/drawing/2014/main" id="{E540E6C2-4A73-43F6-8125-40951B0D85B6}"/>
+                <a16:creationId xmlns:a16="http://schemas.microsoft.com/office/drawing/2014/main" id="{354AB628-C799-4E79-A3D1-61B5224AF747}"/>
               </a:ext>
             </a:extLst>
           </p:cNvPr>
@@ -7581,7 +7581,7 @@
           <p:cNvPr id="26" name="">
             <a:extLst xmlns:a="http://schemas.openxmlformats.org/drawingml/2006/main">
               <a:ext uri="{FF2B5EF4-FFF2-40B4-BE49-F238E27FC236}">
-                <a16:creationId xmlns:a16="http://schemas.microsoft.com/office/drawing/2014/main" id="{F199BDD5-70CF-434A-A89D-C93F8DEF4A82}"/>
+                <a16:creationId xmlns:a16="http://schemas.microsoft.com/office/drawing/2014/main" id="{1C3FC13D-378A-417D-B383-58ABB040542A}"/>
               </a:ext>
             </a:extLst>
           </p:cNvPr>
@@ -7645,7 +7645,7 @@
           <p:cNvPr id="27" name="">
             <a:extLst xmlns:a="http://schemas.openxmlformats.org/drawingml/2006/main">
               <a:ext uri="{FF2B5EF4-FFF2-40B4-BE49-F238E27FC236}">
-                <a16:creationId xmlns:a16="http://schemas.microsoft.com/office/drawing/2014/main" id="{20490585-706B-4A53-8A9C-81DF11292FC1}"/>
+                <a16:creationId xmlns:a16="http://schemas.microsoft.com/office/drawing/2014/main" id="{4E98133B-91F8-4C48-A1C3-C96D782154F2}"/>
               </a:ext>
             </a:extLst>
           </p:cNvPr>
@@ -7709,7 +7709,7 @@
           <p:cNvPr id="28" name="">
             <a:extLst xmlns:a="http://schemas.openxmlformats.org/drawingml/2006/main">
               <a:ext uri="{FF2B5EF4-FFF2-40B4-BE49-F238E27FC236}">
-                <a16:creationId xmlns:a16="http://schemas.microsoft.com/office/drawing/2014/main" id="{A818FDF6-44AE-4EC5-BC55-4907C9FC1D96}"/>
+                <a16:creationId xmlns:a16="http://schemas.microsoft.com/office/drawing/2014/main" id="{C37E2D67-A5A8-45F6-97A6-1515902FE661}"/>
               </a:ext>
             </a:extLst>
           </p:cNvPr>
@@ -7773,7 +7773,7 @@
           <p:cNvPr id="29" name="">
             <a:extLst xmlns:a="http://schemas.openxmlformats.org/drawingml/2006/main">
               <a:ext uri="{FF2B5EF4-FFF2-40B4-BE49-F238E27FC236}">
-                <a16:creationId xmlns:a16="http://schemas.microsoft.com/office/drawing/2014/main" id="{77037A80-CE8E-4FCD-8408-D37C63CC8632}"/>
+                <a16:creationId xmlns:a16="http://schemas.microsoft.com/office/drawing/2014/main" id="{CDB9DD4D-BEC3-4373-9524-85246CB19B6E}"/>
               </a:ext>
             </a:extLst>
           </p:cNvPr>
@@ -7830,7 +7830,7 @@
           <p:cNvPr id="30" name="">
             <a:extLst xmlns:a="http://schemas.openxmlformats.org/drawingml/2006/main">
               <a:ext uri="{FF2B5EF4-FFF2-40B4-BE49-F238E27FC236}">
-                <a16:creationId xmlns:a16="http://schemas.microsoft.com/office/drawing/2014/main" id="{104A2776-443E-4891-908E-02FBA3ADAB2C}"/>
+                <a16:creationId xmlns:a16="http://schemas.microsoft.com/office/drawing/2014/main" id="{1155CE8A-2AC2-4D22-AA29-E3F9E1CB9941}"/>
               </a:ext>
             </a:extLst>
           </p:cNvPr>
@@ -7877,7 +7877,7 @@
                 <a:ea typeface="Arial"/>
                 <a:cs typeface="Arial"/>
               </a:rPr>
-              <a:t>AURA • Track A • 27/09/2026</a:t>
+              <a:t>AURA • Track A • 28/09/2026</a:t>
             </a:r>
           </a:p>
         </p:txBody>
@@ -7887,7 +7887,7 @@
           <p:cNvPr id="31" name="">
             <a:extLst xmlns:a="http://schemas.openxmlformats.org/drawingml/2006/main">
               <a:ext uri="{FF2B5EF4-FFF2-40B4-BE49-F238E27FC236}">
-                <a16:creationId xmlns:a16="http://schemas.microsoft.com/office/drawing/2014/main" id="{2C8C706C-B032-4DB7-AC53-740A2C0FDC00}"/>
+                <a16:creationId xmlns:a16="http://schemas.microsoft.com/office/drawing/2014/main" id="{91CD3FB4-8355-47C3-9CCF-DDDCBF5C10CE}"/>
               </a:ext>
             </a:extLst>
           </p:cNvPr>
@@ -7942,7 +7942,7 @@
     </p:spTree>
     <p:extLst>
       <p:ext uri="{BB962C8B-B14F-4D97-AF65-F5344CB8AC3E}">
-        <p14:creationId xmlns:p14="http://schemas.microsoft.com/office/powerpoint/2010/main" val="1457455713"/>
+        <p14:creationId xmlns:p14="http://schemas.microsoft.com/office/powerpoint/2010/main" val="529784666"/>
       </p:ext>
     </p:extLst>
   </p:cSld>
@@ -7973,7 +7973,7 @@
           <p:cNvPr id="32" name="">
             <a:extLst xmlns:a="http://schemas.openxmlformats.org/drawingml/2006/main">
               <a:ext uri="{FF2B5EF4-FFF2-40B4-BE49-F238E27FC236}">
-                <a16:creationId xmlns:a16="http://schemas.microsoft.com/office/drawing/2014/main" id="{3DA78FEF-08FD-4D8A-8723-3876DCDAAC38}"/>
+                <a16:creationId xmlns:a16="http://schemas.microsoft.com/office/drawing/2014/main" id="{13A17095-CA91-4DEC-A8B8-322B077AD283}"/>
               </a:ext>
             </a:extLst>
           </p:cNvPr>
@@ -8030,7 +8030,7 @@
           <p:cNvPr id="2" name="">
             <a:extLst xmlns:a="http://schemas.openxmlformats.org/drawingml/2006/main">
               <a:ext uri="{FF2B5EF4-FFF2-40B4-BE49-F238E27FC236}">
-                <a16:creationId xmlns:a16="http://schemas.microsoft.com/office/drawing/2014/main" id="{4F235510-CBF4-41DC-8227-DEB812991213}"/>
+                <a16:creationId xmlns:a16="http://schemas.microsoft.com/office/drawing/2014/main" id="{7C3804C1-23F2-4A6C-A52B-6DB3A11328A0}"/>
               </a:ext>
             </a:extLst>
           </p:cNvPr>
@@ -8087,7 +8087,7 @@
           <p:cNvPr id="3" name="">
             <a:extLst xmlns:a="http://schemas.openxmlformats.org/drawingml/2006/main">
               <a:ext uri="{FF2B5EF4-FFF2-40B4-BE49-F238E27FC236}">
-                <a16:creationId xmlns:a16="http://schemas.microsoft.com/office/drawing/2014/main" id="{C77168F9-1984-4706-A6BF-9FA71991A501}"/>
+                <a16:creationId xmlns:a16="http://schemas.microsoft.com/office/drawing/2014/main" id="{65FBDFCC-2389-4CB0-B501-2AC7C29C3CC2}"/>
               </a:ext>
             </a:extLst>
           </p:cNvPr>
@@ -8144,7 +8144,7 @@
           <p:cNvPr id="4" name="">
             <a:extLst xmlns:a="http://schemas.openxmlformats.org/drawingml/2006/main">
               <a:ext uri="{FF2B5EF4-FFF2-40B4-BE49-F238E27FC236}">
-                <a16:creationId xmlns:a16="http://schemas.microsoft.com/office/drawing/2014/main" id="{EF530EA7-86BB-40F3-8669-CBCA376251EC}"/>
+                <a16:creationId xmlns:a16="http://schemas.microsoft.com/office/drawing/2014/main" id="{1C9C4CA0-BEBF-42E8-8D10-9AA1AF28CA5F}"/>
               </a:ext>
             </a:extLst>
           </p:cNvPr>
@@ -8175,7 +8175,7 @@
           <p:cNvPr id="5" name="">
             <a:extLst xmlns:a="http://schemas.openxmlformats.org/drawingml/2006/main">
               <a:ext uri="{FF2B5EF4-FFF2-40B4-BE49-F238E27FC236}">
-                <a16:creationId xmlns:a16="http://schemas.microsoft.com/office/drawing/2014/main" id="{36D60BD5-A756-4D3E-B9BC-673D520A018A}"/>
+                <a16:creationId xmlns:a16="http://schemas.microsoft.com/office/drawing/2014/main" id="{9DFB70C2-97E2-4823-891F-8D9420CAB553}"/>
               </a:ext>
             </a:extLst>
           </p:cNvPr>
@@ -8210,7 +8210,7 @@
           <p:cNvPr id="6" name="">
             <a:extLst xmlns:a="http://schemas.openxmlformats.org/drawingml/2006/main">
               <a:ext uri="{FF2B5EF4-FFF2-40B4-BE49-F238E27FC236}">
-                <a16:creationId xmlns:a16="http://schemas.microsoft.com/office/drawing/2014/main" id="{CA4CDE98-8457-4E8F-BC5B-178E42C06B44}"/>
+                <a16:creationId xmlns:a16="http://schemas.microsoft.com/office/drawing/2014/main" id="{BFB85BC5-0A14-46CC-BF1F-1F5AC5E3A16B}"/>
               </a:ext>
             </a:extLst>
           </p:cNvPr>
@@ -8274,7 +8274,7 @@
           <p:cNvPr id="7" name="">
             <a:extLst xmlns:a="http://schemas.openxmlformats.org/drawingml/2006/main">
               <a:ext uri="{FF2B5EF4-FFF2-40B4-BE49-F238E27FC236}">
-                <a16:creationId xmlns:a16="http://schemas.microsoft.com/office/drawing/2014/main" id="{C68315EB-FD75-45DF-9B55-6DB24B43A1F1}"/>
+                <a16:creationId xmlns:a16="http://schemas.microsoft.com/office/drawing/2014/main" id="{61369E59-6602-4182-92A1-2B69C9FEBE82}"/>
               </a:ext>
             </a:extLst>
           </p:cNvPr>
@@ -8321,7 +8321,7 @@
                 <a:ea typeface="Arial"/>
                 <a:cs typeface="Arial"/>
               </a:rPr>
-              <a:t>Razor MVC • fetch cho AI • reload sau workflow write</a:t>
+              <a:t>Razor MVC • fetch HTTP 202 • status polling sau upload</a:t>
             </a:r>
           </a:p>
         </p:txBody>
@@ -8331,7 +8331,7 @@
           <p:cNvPr id="8" name="">
             <a:extLst xmlns:a="http://schemas.openxmlformats.org/drawingml/2006/main">
               <a:ext uri="{FF2B5EF4-FFF2-40B4-BE49-F238E27FC236}">
-                <a16:creationId xmlns:a16="http://schemas.microsoft.com/office/drawing/2014/main" id="{25AACF48-8451-4D11-B4B9-5BC0AC012ECC}"/>
+                <a16:creationId xmlns:a16="http://schemas.microsoft.com/office/drawing/2014/main" id="{4E639FC7-F1DD-4926-AD57-9F23D20BD5B9}"/>
               </a:ext>
             </a:extLst>
           </p:cNvPr>
@@ -8362,7 +8362,7 @@
           <p:cNvPr id="9" name="">
             <a:extLst xmlns:a="http://schemas.openxmlformats.org/drawingml/2006/main">
               <a:ext uri="{FF2B5EF4-FFF2-40B4-BE49-F238E27FC236}">
-                <a16:creationId xmlns:a16="http://schemas.microsoft.com/office/drawing/2014/main" id="{47C6CB81-A60F-4C6E-8661-CE5EB5B10ADA}"/>
+                <a16:creationId xmlns:a16="http://schemas.microsoft.com/office/drawing/2014/main" id="{1FF093E2-2A36-4D4E-BBB6-E18926E3B5F4}"/>
               </a:ext>
             </a:extLst>
           </p:cNvPr>
@@ -8397,7 +8397,7 @@
           <p:cNvPr id="10" name="">
             <a:extLst xmlns:a="http://schemas.openxmlformats.org/drawingml/2006/main">
               <a:ext uri="{FF2B5EF4-FFF2-40B4-BE49-F238E27FC236}">
-                <a16:creationId xmlns:a16="http://schemas.microsoft.com/office/drawing/2014/main" id="{6AE48849-5B38-43EA-8C7B-D21CD5F19119}"/>
+                <a16:creationId xmlns:a16="http://schemas.microsoft.com/office/drawing/2014/main" id="{59642926-B4CC-4CEA-BB32-B467A292D90E}"/>
               </a:ext>
             </a:extLst>
           </p:cNvPr>
@@ -8461,7 +8461,7 @@
           <p:cNvPr id="11" name="">
             <a:extLst xmlns:a="http://schemas.openxmlformats.org/drawingml/2006/main">
               <a:ext uri="{FF2B5EF4-FFF2-40B4-BE49-F238E27FC236}">
-                <a16:creationId xmlns:a16="http://schemas.microsoft.com/office/drawing/2014/main" id="{BB738590-826D-45ED-B5EB-2D0A5806AC5D}"/>
+                <a16:creationId xmlns:a16="http://schemas.microsoft.com/office/drawing/2014/main" id="{A2C578C4-D5A5-46AD-89BE-92E9D1C1ABDC}"/>
               </a:ext>
             </a:extLst>
           </p:cNvPr>
@@ -8508,7 +8508,7 @@
                 <a:ea typeface="Arial"/>
                 <a:cs typeface="Arial"/>
               </a:rPr>
-              <a:t>Applicant / Verify / Reviewer • state validation</a:t>
+              <a:t>DB-backed worker • lease • circuit breaker</a:t>
             </a:r>
           </a:p>
         </p:txBody>
@@ -8518,7 +8518,7 @@
           <p:cNvPr id="12" name="">
             <a:extLst xmlns:a="http://schemas.openxmlformats.org/drawingml/2006/main">
               <a:ext uri="{FF2B5EF4-FFF2-40B4-BE49-F238E27FC236}">
-                <a16:creationId xmlns:a16="http://schemas.microsoft.com/office/drawing/2014/main" id="{6612A2ED-6EB3-4CB1-98E9-33A666DE0AE5}"/>
+                <a16:creationId xmlns:a16="http://schemas.microsoft.com/office/drawing/2014/main" id="{866CBA1A-9812-4724-A26B-56496348F739}"/>
               </a:ext>
             </a:extLst>
           </p:cNvPr>
@@ -8549,7 +8549,7 @@
           <p:cNvPr id="13" name="">
             <a:extLst xmlns:a="http://schemas.openxmlformats.org/drawingml/2006/main">
               <a:ext uri="{FF2B5EF4-FFF2-40B4-BE49-F238E27FC236}">
-                <a16:creationId xmlns:a16="http://schemas.microsoft.com/office/drawing/2014/main" id="{5CF6B5F1-A5B9-414D-9612-07EAEA1E6437}"/>
+                <a16:creationId xmlns:a16="http://schemas.microsoft.com/office/drawing/2014/main" id="{1F44E280-0316-4166-A3D4-1FC3EBAEEF25}"/>
               </a:ext>
             </a:extLst>
           </p:cNvPr>
@@ -8584,7 +8584,7 @@
           <p:cNvPr id="14" name="">
             <a:extLst xmlns:a="http://schemas.openxmlformats.org/drawingml/2006/main">
               <a:ext uri="{FF2B5EF4-FFF2-40B4-BE49-F238E27FC236}">
-                <a16:creationId xmlns:a16="http://schemas.microsoft.com/office/drawing/2014/main" id="{19B0D017-8F6B-49A2-8DA5-646171535E80}"/>
+                <a16:creationId xmlns:a16="http://schemas.microsoft.com/office/drawing/2014/main" id="{2BA9D034-F7EE-406C-A88C-089145780AD7}"/>
               </a:ext>
             </a:extLst>
           </p:cNvPr>
@@ -8648,7 +8648,7 @@
           <p:cNvPr id="15" name="">
             <a:extLst xmlns:a="http://schemas.openxmlformats.org/drawingml/2006/main">
               <a:ext uri="{FF2B5EF4-FFF2-40B4-BE49-F238E27FC236}">
-                <a16:creationId xmlns:a16="http://schemas.microsoft.com/office/drawing/2014/main" id="{FC9A2A95-F035-4528-AE25-B16A601A339E}"/>
+                <a16:creationId xmlns:a16="http://schemas.microsoft.com/office/drawing/2014/main" id="{8886E739-DA84-4C53-9CD2-46FDAA80F99A}"/>
               </a:ext>
             </a:extLst>
           </p:cNvPr>
@@ -8705,7 +8705,7 @@
           <p:cNvPr id="16" name="">
             <a:extLst xmlns:a="http://schemas.openxmlformats.org/drawingml/2006/main">
               <a:ext uri="{FF2B5EF4-FFF2-40B4-BE49-F238E27FC236}">
-                <a16:creationId xmlns:a16="http://schemas.microsoft.com/office/drawing/2014/main" id="{0667DF3B-CD5B-43CB-9FAB-75D8A1BBAFF9}"/>
+                <a16:creationId xmlns:a16="http://schemas.microsoft.com/office/drawing/2014/main" id="{9CBF72C2-A9E2-4C60-95E3-30C7AB7F7FC3}"/>
               </a:ext>
             </a:extLst>
           </p:cNvPr>
@@ -8736,7 +8736,7 @@
           <p:cNvPr id="17" name="">
             <a:extLst xmlns:a="http://schemas.openxmlformats.org/drawingml/2006/main">
               <a:ext uri="{FF2B5EF4-FFF2-40B4-BE49-F238E27FC236}">
-                <a16:creationId xmlns:a16="http://schemas.microsoft.com/office/drawing/2014/main" id="{E83AF7AB-98CC-495B-9552-A3FD812BAF12}"/>
+                <a16:creationId xmlns:a16="http://schemas.microsoft.com/office/drawing/2014/main" id="{AB31FB8E-A67C-4039-AC82-6293C14CE225}"/>
               </a:ext>
             </a:extLst>
           </p:cNvPr>
@@ -8771,7 +8771,7 @@
           <p:cNvPr id="18" name="">
             <a:extLst xmlns:a="http://schemas.openxmlformats.org/drawingml/2006/main">
               <a:ext uri="{FF2B5EF4-FFF2-40B4-BE49-F238E27FC236}">
-                <a16:creationId xmlns:a16="http://schemas.microsoft.com/office/drawing/2014/main" id="{0EC2E14E-A952-4A45-8269-5094BBD88D21}"/>
+                <a16:creationId xmlns:a16="http://schemas.microsoft.com/office/drawing/2014/main" id="{6BCD454B-D0EC-4DF5-83BE-6007FCB82B83}"/>
               </a:ext>
             </a:extLst>
           </p:cNvPr>
@@ -8835,7 +8835,7 @@
           <p:cNvPr id="19" name="">
             <a:extLst xmlns:a="http://schemas.openxmlformats.org/drawingml/2006/main">
               <a:ext uri="{FF2B5EF4-FFF2-40B4-BE49-F238E27FC236}">
-                <a16:creationId xmlns:a16="http://schemas.microsoft.com/office/drawing/2014/main" id="{443411D9-0F07-40E2-B212-1B21FCFF86B3}"/>
+                <a16:creationId xmlns:a16="http://schemas.microsoft.com/office/drawing/2014/main" id="{2CB89E84-9478-4F17-9094-97639BBBF917}"/>
               </a:ext>
             </a:extLst>
           </p:cNvPr>
@@ -8892,7 +8892,7 @@
           <p:cNvPr id="20" name="">
             <a:extLst xmlns:a="http://schemas.openxmlformats.org/drawingml/2006/main">
               <a:ext uri="{FF2B5EF4-FFF2-40B4-BE49-F238E27FC236}">
-                <a16:creationId xmlns:a16="http://schemas.microsoft.com/office/drawing/2014/main" id="{5BAEDB39-4BDB-4B7D-9AB1-0CD046993D7D}"/>
+                <a16:creationId xmlns:a16="http://schemas.microsoft.com/office/drawing/2014/main" id="{FB7669B9-BBDA-4C0D-AB08-15CD5038B362}"/>
               </a:ext>
             </a:extLst>
           </p:cNvPr>
@@ -8927,7 +8927,7 @@
           <p:cNvPr id="21" name="">
             <a:extLst xmlns:a="http://schemas.openxmlformats.org/drawingml/2006/main">
               <a:ext uri="{FF2B5EF4-FFF2-40B4-BE49-F238E27FC236}">
-                <a16:creationId xmlns:a16="http://schemas.microsoft.com/office/drawing/2014/main" id="{36DEA40F-5B20-4244-BF39-2BBDEF93C0C3}"/>
+                <a16:creationId xmlns:a16="http://schemas.microsoft.com/office/drawing/2014/main" id="{609F7F3B-E490-47D6-BA0D-B6BED09631F2}"/>
               </a:ext>
             </a:extLst>
           </p:cNvPr>
@@ -8984,7 +8984,7 @@
           <p:cNvPr id="22" name="">
             <a:extLst xmlns:a="http://schemas.openxmlformats.org/drawingml/2006/main">
               <a:ext uri="{FF2B5EF4-FFF2-40B4-BE49-F238E27FC236}">
-                <a16:creationId xmlns:a16="http://schemas.microsoft.com/office/drawing/2014/main" id="{61F297BD-D5D0-4C06-B3BE-F6009441621B}"/>
+                <a16:creationId xmlns:a16="http://schemas.microsoft.com/office/drawing/2014/main" id="{3C3DC408-96EE-45C1-9CF0-48CBF0ADFA5A}"/>
               </a:ext>
             </a:extLst>
           </p:cNvPr>
@@ -8996,7 +8996,7 @@
         <p:spPr>
           <a:xfrm xmlns:a="http://schemas.openxmlformats.org/drawingml/2006/main">
             <a:off x="714375" y="5562600"/>
-            <a:ext cx="7429500" cy="266700"/>
+            <a:ext cx="6572250" cy="266700"/>
           </a:xfrm>
           <a:prstGeom xmlns:a="http://schemas.openxmlformats.org/drawingml/2006/main" prst="rect">
             <a:avLst/>
@@ -9031,7 +9031,7 @@
                 <a:ea typeface="Arial"/>
                 <a:cs typeface="Arial"/>
               </a:rPr>
-              <a:t>OpenRouter mặc định • Ollama local tùy chọn • không có quyền quyết định</a:t>
+              <a:t>OpenRouter chính • Ollama fallback opt-in • model không quyết định</a:t>
             </a:r>
           </a:p>
         </p:txBody>
@@ -9041,7 +9041,7 @@
           <p:cNvPr id="23" name="">
             <a:extLst xmlns:a="http://schemas.openxmlformats.org/drawingml/2006/main">
               <a:ext uri="{FF2B5EF4-FFF2-40B4-BE49-F238E27FC236}">
-                <a16:creationId xmlns:a16="http://schemas.microsoft.com/office/drawing/2014/main" id="{1AAA9614-9A11-49A8-9FBB-D00445399814}"/>
+                <a16:creationId xmlns:a16="http://schemas.microsoft.com/office/drawing/2014/main" id="{1A5C5E2F-3A26-4D37-A8C7-904238DA8AEE}"/>
               </a:ext>
             </a:extLst>
           </p:cNvPr>
@@ -9076,7 +9076,7 @@
           <p:cNvPr id="24" name="">
             <a:extLst xmlns:a="http://schemas.openxmlformats.org/drawingml/2006/main">
               <a:ext uri="{FF2B5EF4-FFF2-40B4-BE49-F238E27FC236}">
-                <a16:creationId xmlns:a16="http://schemas.microsoft.com/office/drawing/2014/main" id="{0EA8CA72-7D03-4CB3-95BD-09F601B0031F}"/>
+                <a16:creationId xmlns:a16="http://schemas.microsoft.com/office/drawing/2014/main" id="{54A67F21-6F24-4C24-92D4-82E1C7DA2548}"/>
               </a:ext>
             </a:extLst>
           </p:cNvPr>
@@ -9140,7 +9140,7 @@
           <p:cNvPr id="25" name="">
             <a:extLst xmlns:a="http://schemas.openxmlformats.org/drawingml/2006/main">
               <a:ext uri="{FF2B5EF4-FFF2-40B4-BE49-F238E27FC236}">
-                <a16:creationId xmlns:a16="http://schemas.microsoft.com/office/drawing/2014/main" id="{1F9352B5-3460-45BB-B1A2-E106119EE4D7}"/>
+                <a16:creationId xmlns:a16="http://schemas.microsoft.com/office/drawing/2014/main" id="{195B5D1E-A023-4AAA-B9E4-2F266735A3EE}"/>
               </a:ext>
             </a:extLst>
           </p:cNvPr>
@@ -9266,7 +9266,7 @@
           <p:cNvPr id="26" name="">
             <a:extLst xmlns:a="http://schemas.openxmlformats.org/drawingml/2006/main">
               <a:ext uri="{FF2B5EF4-FFF2-40B4-BE49-F238E27FC236}">
-                <a16:creationId xmlns:a16="http://schemas.microsoft.com/office/drawing/2014/main" id="{D2CB3B77-5C4F-4113-B3A7-39761D77801A}"/>
+                <a16:creationId xmlns:a16="http://schemas.microsoft.com/office/drawing/2014/main" id="{4608BCA0-2617-4ECA-96F5-92CBFFB5B4A6}"/>
               </a:ext>
             </a:extLst>
           </p:cNvPr>
@@ -9301,7 +9301,7 @@
           <p:cNvPr id="27" name="">
             <a:extLst xmlns:a="http://schemas.openxmlformats.org/drawingml/2006/main">
               <a:ext uri="{FF2B5EF4-FFF2-40B4-BE49-F238E27FC236}">
-                <a16:creationId xmlns:a16="http://schemas.microsoft.com/office/drawing/2014/main" id="{C38EEC69-430A-4914-BE76-003DAC458BDB}"/>
+                <a16:creationId xmlns:a16="http://schemas.microsoft.com/office/drawing/2014/main" id="{3228AD01-A96D-44F1-91F7-EF73954FA256}"/>
               </a:ext>
             </a:extLst>
           </p:cNvPr>
@@ -9365,7 +9365,7 @@
           <p:cNvPr id="28" name="">
             <a:extLst xmlns:a="http://schemas.openxmlformats.org/drawingml/2006/main">
               <a:ext uri="{FF2B5EF4-FFF2-40B4-BE49-F238E27FC236}">
-                <a16:creationId xmlns:a16="http://schemas.microsoft.com/office/drawing/2014/main" id="{1BE608E0-9C47-4E89-8ABF-501A718F3523}"/>
+                <a16:creationId xmlns:a16="http://schemas.microsoft.com/office/drawing/2014/main" id="{A67D648C-29FE-4E5E-9F4F-60AE25B2001A}"/>
               </a:ext>
             </a:extLst>
           </p:cNvPr>
@@ -9468,7 +9468,7 @@
           <p:cNvPr id="29" name="">
             <a:extLst xmlns:a="http://schemas.openxmlformats.org/drawingml/2006/main">
               <a:ext uri="{FF2B5EF4-FFF2-40B4-BE49-F238E27FC236}">
-                <a16:creationId xmlns:a16="http://schemas.microsoft.com/office/drawing/2014/main" id="{81792C32-48B4-4AED-B5FF-45E55E2FA2D4}"/>
+                <a16:creationId xmlns:a16="http://schemas.microsoft.com/office/drawing/2014/main" id="{6D5297A3-694D-4BEC-A14E-886E986C8DE6}"/>
               </a:ext>
             </a:extLst>
           </p:cNvPr>
@@ -9548,7 +9548,7 @@
           <p:cNvPr id="30" name="">
             <a:extLst xmlns:a="http://schemas.openxmlformats.org/drawingml/2006/main">
               <a:ext uri="{FF2B5EF4-FFF2-40B4-BE49-F238E27FC236}">
-                <a16:creationId xmlns:a16="http://schemas.microsoft.com/office/drawing/2014/main" id="{C46CF95A-C15A-417B-B0D4-A336C0F21F0B}"/>
+                <a16:creationId xmlns:a16="http://schemas.microsoft.com/office/drawing/2014/main" id="{A3EFFB27-34A5-486C-B12F-70387DF04625}"/>
               </a:ext>
             </a:extLst>
           </p:cNvPr>
@@ -9595,7 +9595,7 @@
                 <a:ea typeface="Arial"/>
                 <a:cs typeface="Arial"/>
               </a:rPr>
-              <a:t>AURA • Track A • 27/09/2026</a:t>
+              <a:t>AURA • Track A • 28/09/2026</a:t>
             </a:r>
           </a:p>
         </p:txBody>
@@ -9605,7 +9605,7 @@
           <p:cNvPr id="31" name="">
             <a:extLst xmlns:a="http://schemas.openxmlformats.org/drawingml/2006/main">
               <a:ext uri="{FF2B5EF4-FFF2-40B4-BE49-F238E27FC236}">
-                <a16:creationId xmlns:a16="http://schemas.microsoft.com/office/drawing/2014/main" id="{8C85143F-9E1C-41E1-8443-3AD9D571B0FA}"/>
+                <a16:creationId xmlns:a16="http://schemas.microsoft.com/office/drawing/2014/main" id="{4C8CE4A1-C6ED-4979-A160-8FB6BDCF4DEE}"/>
               </a:ext>
             </a:extLst>
           </p:cNvPr>
@@ -9660,7 +9660,7 @@
     </p:spTree>
     <p:extLst>
       <p:ext uri="{BB962C8B-B14F-4D97-AF65-F5344CB8AC3E}">
-        <p14:creationId xmlns:p14="http://schemas.microsoft.com/office/powerpoint/2010/main" val="1065899052"/>
+        <p14:creationId xmlns:p14="http://schemas.microsoft.com/office/powerpoint/2010/main" val="1741885100"/>
       </p:ext>
     </p:extLst>
   </p:cSld>
@@ -9691,7 +9691,7 @@
           <p:cNvPr id="36" name="">
             <a:extLst xmlns:a="http://schemas.openxmlformats.org/drawingml/2006/main">
               <a:ext uri="{FF2B5EF4-FFF2-40B4-BE49-F238E27FC236}">
-                <a16:creationId xmlns:a16="http://schemas.microsoft.com/office/drawing/2014/main" id="{F46BC1A3-A202-49F7-A76C-17BB98AE7794}"/>
+                <a16:creationId xmlns:a16="http://schemas.microsoft.com/office/drawing/2014/main" id="{45D7C1A2-2525-4A5F-95A0-3A63453239BC}"/>
               </a:ext>
             </a:extLst>
           </p:cNvPr>
@@ -9748,7 +9748,7 @@
           <p:cNvPr id="2" name="">
             <a:extLst xmlns:a="http://schemas.openxmlformats.org/drawingml/2006/main">
               <a:ext uri="{FF2B5EF4-FFF2-40B4-BE49-F238E27FC236}">
-                <a16:creationId xmlns:a16="http://schemas.microsoft.com/office/drawing/2014/main" id="{6DAD5CAC-4806-4D2E-B01B-60525667E280}"/>
+                <a16:creationId xmlns:a16="http://schemas.microsoft.com/office/drawing/2014/main" id="{64E13182-255F-4344-90EB-A6A604DAFC5B}"/>
               </a:ext>
             </a:extLst>
           </p:cNvPr>
@@ -9795,7 +9795,7 @@
                 <a:ea typeface="Arial"/>
                 <a:cs typeface="Arial"/>
               </a:rPr>
-              <a:t>Giới hạn được nói thẳng — và cách fail-safe</a:t>
+              <a:t>Giới hạn hiện tại và cách fail-safe</a:t>
             </a:r>
           </a:p>
         </p:txBody>
@@ -9805,7 +9805,7 @@
           <p:cNvPr id="3" name="">
             <a:extLst xmlns:a="http://schemas.openxmlformats.org/drawingml/2006/main">
               <a:ext uri="{FF2B5EF4-FFF2-40B4-BE49-F238E27FC236}">
-                <a16:creationId xmlns:a16="http://schemas.microsoft.com/office/drawing/2014/main" id="{E477D522-A3F4-4989-8D8A-A17918728C63}"/>
+                <a16:creationId xmlns:a16="http://schemas.microsoft.com/office/drawing/2014/main" id="{916D2511-D4F0-41B5-BC24-A061335985A6}"/>
               </a:ext>
             </a:extLst>
           </p:cNvPr>
@@ -9852,7 +9852,7 @@
                 <a:ea typeface="Arial"/>
                 <a:cs typeface="Arial"/>
               </a:rPr>
-              <a:t>Không gọi một retry là circuit breaker; không biến lỗi provider thành quyết định nghiệp vụ.</a:t>
+              <a:t>Fallback có allowlist và circuit breaker; lỗi dữ liệu không được che bằng đổi model.</a:t>
             </a:r>
           </a:p>
         </p:txBody>
@@ -9862,7 +9862,7 @@
           <p:cNvPr id="4" name="">
             <a:extLst xmlns:a="http://schemas.openxmlformats.org/drawingml/2006/main">
               <a:ext uri="{FF2B5EF4-FFF2-40B4-BE49-F238E27FC236}">
-                <a16:creationId xmlns:a16="http://schemas.microsoft.com/office/drawing/2014/main" id="{0DD3BD9C-E364-43DE-A80B-E402AC29E646}"/>
+                <a16:creationId xmlns:a16="http://schemas.microsoft.com/office/drawing/2014/main" id="{CCFF5C06-0735-4D74-A857-3C5B65575399}"/>
               </a:ext>
             </a:extLst>
           </p:cNvPr>
@@ -9893,7 +9893,7 @@
           <p:cNvPr id="5" name="">
             <a:extLst xmlns:a="http://schemas.openxmlformats.org/drawingml/2006/main">
               <a:ext uri="{FF2B5EF4-FFF2-40B4-BE49-F238E27FC236}">
-                <a16:creationId xmlns:a16="http://schemas.microsoft.com/office/drawing/2014/main" id="{B7016B3A-334A-41CC-8CA4-26F072C3F512}"/>
+                <a16:creationId xmlns:a16="http://schemas.microsoft.com/office/drawing/2014/main" id="{C8DBE54B-921B-4D48-ADA9-8158313DC027}"/>
               </a:ext>
             </a:extLst>
           </p:cNvPr>
@@ -9928,7 +9928,7 @@
           <p:cNvPr id="6" name="">
             <a:extLst xmlns:a="http://schemas.openxmlformats.org/drawingml/2006/main">
               <a:ext uri="{FF2B5EF4-FFF2-40B4-BE49-F238E27FC236}">
-                <a16:creationId xmlns:a16="http://schemas.microsoft.com/office/drawing/2014/main" id="{8E93DCE2-3975-4EF0-9126-798B85E8F1B6}"/>
+                <a16:creationId xmlns:a16="http://schemas.microsoft.com/office/drawing/2014/main" id="{D034CC8A-857E-49CD-9C29-29E8DDBC22AF}"/>
               </a:ext>
             </a:extLst>
           </p:cNvPr>
@@ -9982,7 +9982,7 @@
                 <a:ea typeface="Arial"/>
                 <a:cs typeface="Arial"/>
               </a:rPr>
-              <a:t>429 / hết credit</a:t>
+              <a:t>429 / timeout</a:t>
             </a:r>
           </a:p>
         </p:txBody>
@@ -9992,7 +9992,7 @@
           <p:cNvPr id="7" name="">
             <a:extLst xmlns:a="http://schemas.openxmlformats.org/drawingml/2006/main">
               <a:ext uri="{FF2B5EF4-FFF2-40B4-BE49-F238E27FC236}">
-                <a16:creationId xmlns:a16="http://schemas.microsoft.com/office/drawing/2014/main" id="{2917BC28-CD08-4470-927B-1AB79397F481}"/>
+                <a16:creationId xmlns:a16="http://schemas.microsoft.com/office/drawing/2014/main" id="{A6041D08-FA77-4160-B559-4ED6E85C213A}"/>
               </a:ext>
             </a:extLst>
           </p:cNvPr>
@@ -10039,7 +10039,7 @@
                 <a:ea typeface="Arial"/>
                 <a:cs typeface="Arial"/>
               </a:rPr>
-              <a:t>Không retry • dừng phần Verify còn lại</a:t>
+              <a:t>Fallback 1 lần nếu bật • audit provider</a:t>
             </a:r>
           </a:p>
         </p:txBody>
@@ -10049,7 +10049,7 @@
           <p:cNvPr id="8" name="">
             <a:extLst xmlns:a="http://schemas.openxmlformats.org/drawingml/2006/main">
               <a:ext uri="{FF2B5EF4-FFF2-40B4-BE49-F238E27FC236}">
-                <a16:creationId xmlns:a16="http://schemas.microsoft.com/office/drawing/2014/main" id="{29C828BB-5088-47EA-9C48-BD4FC27F023A}"/>
+                <a16:creationId xmlns:a16="http://schemas.microsoft.com/office/drawing/2014/main" id="{C721AC74-B1D2-415E-86B6-4D734CC26054}"/>
               </a:ext>
             </a:extLst>
           </p:cNvPr>
@@ -10084,7 +10084,7 @@
           <p:cNvPr id="9" name="">
             <a:extLst xmlns:a="http://schemas.openxmlformats.org/drawingml/2006/main">
               <a:ext uri="{FF2B5EF4-FFF2-40B4-BE49-F238E27FC236}">
-                <a16:creationId xmlns:a16="http://schemas.microsoft.com/office/drawing/2014/main" id="{DEA3703D-3F52-4EDB-A0FD-4F00FFF99B18}"/>
+                <a16:creationId xmlns:a16="http://schemas.microsoft.com/office/drawing/2014/main" id="{47CD94E5-3244-4CBE-8779-57E9E86C5E1F}"/>
               </a:ext>
             </a:extLst>
           </p:cNvPr>
@@ -10138,7 +10138,7 @@
                 <a:ea typeface="Arial"/>
                 <a:cs typeface="Arial"/>
               </a:rPr>
-              <a:t>5xx tạm thời</a:t>
+              <a:t>Provider lỗi liên tiếp</a:t>
             </a:r>
           </a:p>
         </p:txBody>
@@ -10148,7 +10148,7 @@
           <p:cNvPr id="10" name="">
             <a:extLst xmlns:a="http://schemas.openxmlformats.org/drawingml/2006/main">
               <a:ext uri="{FF2B5EF4-FFF2-40B4-BE49-F238E27FC236}">
-                <a16:creationId xmlns:a16="http://schemas.microsoft.com/office/drawing/2014/main" id="{05B79E84-E00E-4E90-896A-C2A8FE8AAADC}"/>
+                <a16:creationId xmlns:a16="http://schemas.microsoft.com/office/drawing/2014/main" id="{021066F6-1A6C-47E4-8D58-8289070F90FF}"/>
               </a:ext>
             </a:extLst>
           </p:cNvPr>
@@ -10195,7 +10195,7 @@
                 <a:ea typeface="Arial"/>
                 <a:cs typeface="Arial"/>
               </a:rPr>
-              <a:t>Retry tối đa 1 lần • rồi kiểm thủ công</a:t>
+              <a:t>Circuit mở • cooldown • primary probe</a:t>
             </a:r>
           </a:p>
         </p:txBody>
@@ -10205,7 +10205,7 @@
           <p:cNvPr id="11" name="">
             <a:extLst xmlns:a="http://schemas.openxmlformats.org/drawingml/2006/main">
               <a:ext uri="{FF2B5EF4-FFF2-40B4-BE49-F238E27FC236}">
-                <a16:creationId xmlns:a16="http://schemas.microsoft.com/office/drawing/2014/main" id="{CCDBEF86-64F8-4CEB-93E1-00B15DA1DB4B}"/>
+                <a16:creationId xmlns:a16="http://schemas.microsoft.com/office/drawing/2014/main" id="{6ACF737A-56B9-4DB3-841A-B448690789DE}"/>
               </a:ext>
             </a:extLst>
           </p:cNvPr>
@@ -10240,7 +10240,7 @@
           <p:cNvPr id="12" name="">
             <a:extLst xmlns:a="http://schemas.openxmlformats.org/drawingml/2006/main">
               <a:ext uri="{FF2B5EF4-FFF2-40B4-BE49-F238E27FC236}">
-                <a16:creationId xmlns:a16="http://schemas.microsoft.com/office/drawing/2014/main" id="{946C8DB3-1586-4E7C-AA5C-5867BE56A46E}"/>
+                <a16:creationId xmlns:a16="http://schemas.microsoft.com/office/drawing/2014/main" id="{92E3EC1A-CF7F-4412-8049-B912F35D70AC}"/>
               </a:ext>
             </a:extLst>
           </p:cNvPr>
@@ -10304,7 +10304,7 @@
           <p:cNvPr id="13" name="">
             <a:extLst xmlns:a="http://schemas.openxmlformats.org/drawingml/2006/main">
               <a:ext uri="{FF2B5EF4-FFF2-40B4-BE49-F238E27FC236}">
-                <a16:creationId xmlns:a16="http://schemas.microsoft.com/office/drawing/2014/main" id="{093655E2-D92B-4F9A-A9FF-FF940A28793D}"/>
+                <a16:creationId xmlns:a16="http://schemas.microsoft.com/office/drawing/2014/main" id="{33E40CB1-276E-467A-AB99-68AE2E98DA4F}"/>
               </a:ext>
             </a:extLst>
           </p:cNvPr>
@@ -10361,7 +10361,7 @@
           <p:cNvPr id="14" name="">
             <a:extLst xmlns:a="http://schemas.openxmlformats.org/drawingml/2006/main">
               <a:ext uri="{FF2B5EF4-FFF2-40B4-BE49-F238E27FC236}">
-                <a16:creationId xmlns:a16="http://schemas.microsoft.com/office/drawing/2014/main" id="{B4A48FB1-4068-4F92-B8D6-D2D213724A64}"/>
+                <a16:creationId xmlns:a16="http://schemas.microsoft.com/office/drawing/2014/main" id="{D88E0D87-79F1-47AB-B8D7-E7C6831647E2}"/>
               </a:ext>
             </a:extLst>
           </p:cNvPr>
@@ -10396,7 +10396,7 @@
           <p:cNvPr id="15" name="">
             <a:extLst xmlns:a="http://schemas.openxmlformats.org/drawingml/2006/main">
               <a:ext uri="{FF2B5EF4-FFF2-40B4-BE49-F238E27FC236}">
-                <a16:creationId xmlns:a16="http://schemas.microsoft.com/office/drawing/2014/main" id="{AF8A4F65-85E2-400E-9C00-6FAF71E956A7}"/>
+                <a16:creationId xmlns:a16="http://schemas.microsoft.com/office/drawing/2014/main" id="{93C467A8-2792-49EA-A6D7-B7544E4F3734}"/>
               </a:ext>
             </a:extLst>
           </p:cNvPr>
@@ -10450,7 +10450,7 @@
                 <a:ea typeface="Arial"/>
                 <a:cs typeface="Arial"/>
               </a:rPr>
-              <a:t>Ảnh mơ hồ / giả</a:t>
+              <a:t>App restart</a:t>
             </a:r>
           </a:p>
         </p:txBody>
@@ -10460,7 +10460,7 @@
           <p:cNvPr id="16" name="">
             <a:extLst xmlns:a="http://schemas.openxmlformats.org/drawingml/2006/main">
               <a:ext uri="{FF2B5EF4-FFF2-40B4-BE49-F238E27FC236}">
-                <a16:creationId xmlns:a16="http://schemas.microsoft.com/office/drawing/2014/main" id="{EDABB3C1-9319-4EB0-80E8-9A8B6ED9634F}"/>
+                <a16:creationId xmlns:a16="http://schemas.microsoft.com/office/drawing/2014/main" id="{C13D7B20-05FF-44F3-B270-12B9DA97C46C}"/>
               </a:ext>
             </a:extLst>
           </p:cNvPr>
@@ -10507,7 +10507,7 @@
                 <a:ea typeface="Arial"/>
                 <a:cs typeface="Arial"/>
               </a:rPr>
-              <a:t>FACT ưu tiên • không auto-approve</a:t>
+              <a:t>DB job + lease • worker reclaim</a:t>
             </a:r>
           </a:p>
         </p:txBody>
@@ -10517,7 +10517,7 @@
           <p:cNvPr id="17" name="">
             <a:extLst xmlns:a="http://schemas.openxmlformats.org/drawingml/2006/main">
               <a:ext uri="{FF2B5EF4-FFF2-40B4-BE49-F238E27FC236}">
-                <a16:creationId xmlns:a16="http://schemas.microsoft.com/office/drawing/2014/main" id="{F45AA0D9-A4AD-4C5B-BE17-D9D226FA74D1}"/>
+                <a16:creationId xmlns:a16="http://schemas.microsoft.com/office/drawing/2014/main" id="{1B9FCAE8-CBBB-4F15-BAFB-788354F7285F}"/>
               </a:ext>
             </a:extLst>
           </p:cNvPr>
@@ -10552,7 +10552,7 @@
           <p:cNvPr id="18" name="">
             <a:extLst xmlns:a="http://schemas.openxmlformats.org/drawingml/2006/main">
               <a:ext uri="{FF2B5EF4-FFF2-40B4-BE49-F238E27FC236}">
-                <a16:creationId xmlns:a16="http://schemas.microsoft.com/office/drawing/2014/main" id="{137817DF-1EC7-4718-BC64-8B77BDE4E353}"/>
+                <a16:creationId xmlns:a16="http://schemas.microsoft.com/office/drawing/2014/main" id="{C1A14AFB-1AEC-4A9D-B465-4628EFF70ACA}"/>
               </a:ext>
             </a:extLst>
           </p:cNvPr>
@@ -10606,7 +10606,7 @@
                 <a:ea typeface="Arial"/>
                 <a:cs typeface="Arial"/>
               </a:rPr>
-              <a:t>Storage / deploy</a:t>
+              <a:t>Ảnh mơ hồ / giả</a:t>
             </a:r>
           </a:p>
         </p:txBody>
@@ -10616,7 +10616,7 @@
           <p:cNvPr id="19" name="">
             <a:extLst xmlns:a="http://schemas.openxmlformats.org/drawingml/2006/main">
               <a:ext uri="{FF2B5EF4-FFF2-40B4-BE49-F238E27FC236}">
-                <a16:creationId xmlns:a16="http://schemas.microsoft.com/office/drawing/2014/main" id="{1391B645-8901-4C32-ADD3-B3630BB00BEA}"/>
+                <a16:creationId xmlns:a16="http://schemas.microsoft.com/office/drawing/2014/main" id="{142F1871-3FDD-4DEC-A3A4-2DE7F4CC7802}"/>
               </a:ext>
             </a:extLst>
           </p:cNvPr>
@@ -10663,7 +10663,7 @@
                 <a:ea typeface="Arial"/>
                 <a:cs typeface="Arial"/>
               </a:rPr>
-              <a:t>SQL Server + private folder bền</a:t>
+              <a:t>FACT ưu tiên • không auto-approve</a:t>
             </a:r>
           </a:p>
         </p:txBody>
@@ -10673,7 +10673,7 @@
           <p:cNvPr id="20" name="">
             <a:extLst xmlns:a="http://schemas.openxmlformats.org/drawingml/2006/main">
               <a:ext uri="{FF2B5EF4-FFF2-40B4-BE49-F238E27FC236}">
-                <a16:creationId xmlns:a16="http://schemas.microsoft.com/office/drawing/2014/main" id="{ACE71D56-A0DA-4F4C-AC8E-F56813E46EED}"/>
+                <a16:creationId xmlns:a16="http://schemas.microsoft.com/office/drawing/2014/main" id="{839D8D05-D358-4416-8AF6-AD5A5333298D}"/>
               </a:ext>
             </a:extLst>
           </p:cNvPr>
@@ -10708,7 +10708,7 @@
           <p:cNvPr id="21" name="">
             <a:extLst xmlns:a="http://schemas.openxmlformats.org/drawingml/2006/main">
               <a:ext uri="{FF2B5EF4-FFF2-40B4-BE49-F238E27FC236}">
-                <a16:creationId xmlns:a16="http://schemas.microsoft.com/office/drawing/2014/main" id="{0A9EB236-4E5C-4E37-BC2A-4A197F54BB64}"/>
+                <a16:creationId xmlns:a16="http://schemas.microsoft.com/office/drawing/2014/main" id="{FEE004C9-ACD5-446B-A5B8-50D9BB1C2529}"/>
               </a:ext>
             </a:extLst>
           </p:cNvPr>
@@ -10765,7 +10765,7 @@
           <p:cNvPr id="22" name="">
             <a:extLst xmlns:a="http://schemas.openxmlformats.org/drawingml/2006/main">
               <a:ext uri="{FF2B5EF4-FFF2-40B4-BE49-F238E27FC236}">
-                <a16:creationId xmlns:a16="http://schemas.microsoft.com/office/drawing/2014/main" id="{1E9DB9B5-75B9-444B-995C-EF73C4220F09}"/>
+                <a16:creationId xmlns:a16="http://schemas.microsoft.com/office/drawing/2014/main" id="{9C138F3C-C4DB-4B23-A8D5-E5F0EF60714C}"/>
               </a:ext>
             </a:extLst>
           </p:cNvPr>
@@ -10829,7 +10829,7 @@
           <p:cNvPr id="23" name="">
             <a:extLst xmlns:a="http://schemas.openxmlformats.org/drawingml/2006/main">
               <a:ext uri="{FF2B5EF4-FFF2-40B4-BE49-F238E27FC236}">
-                <a16:creationId xmlns:a16="http://schemas.microsoft.com/office/drawing/2014/main" id="{BBE72994-16A2-4420-8CCC-826673A06537}"/>
+                <a16:creationId xmlns:a16="http://schemas.microsoft.com/office/drawing/2014/main" id="{FDDFF1A8-A63A-4970-918E-52B131D4764D}"/>
               </a:ext>
             </a:extLst>
           </p:cNvPr>
@@ -10876,7 +10876,7 @@
                 <a:ea typeface="Arial"/>
                 <a:cs typeface="Arial"/>
               </a:rPr>
-              <a:t>Repo + hướng dẫn local</a:t>
+              <a:t>DB-backed upload queue</a:t>
             </a:r>
           </a:p>
         </p:txBody>
@@ -10886,7 +10886,7 @@
           <p:cNvPr id="24" name="">
             <a:extLst xmlns:a="http://schemas.openxmlformats.org/drawingml/2006/main">
               <a:ext uri="{FF2B5EF4-FFF2-40B4-BE49-F238E27FC236}">
-                <a16:creationId xmlns:a16="http://schemas.microsoft.com/office/drawing/2014/main" id="{81EC2D43-6CB6-405E-B498-032A3538F91A}"/>
+                <a16:creationId xmlns:a16="http://schemas.microsoft.com/office/drawing/2014/main" id="{BF6B5B96-6028-4D4C-9E25-137127677B83}"/>
               </a:ext>
             </a:extLst>
           </p:cNvPr>
@@ -10950,7 +10950,7 @@
           <p:cNvPr id="25" name="">
             <a:extLst xmlns:a="http://schemas.openxmlformats.org/drawingml/2006/main">
               <a:ext uri="{FF2B5EF4-FFF2-40B4-BE49-F238E27FC236}">
-                <a16:creationId xmlns:a16="http://schemas.microsoft.com/office/drawing/2014/main" id="{2662FE0F-9F11-4D9B-A126-4ABEF1CD8E7F}"/>
+                <a16:creationId xmlns:a16="http://schemas.microsoft.com/office/drawing/2014/main" id="{07243428-4DC9-4F7E-90CE-7ABD2E920BFB}"/>
               </a:ext>
             </a:extLst>
           </p:cNvPr>
@@ -10997,7 +10997,7 @@
                 <a:ea typeface="Arial"/>
                 <a:cs typeface="Arial"/>
               </a:rPr>
-              <a:t>70 test offline</a:t>
+              <a:t>80 test offline</a:t>
             </a:r>
           </a:p>
         </p:txBody>
@@ -11007,7 +11007,7 @@
           <p:cNvPr id="26" name="">
             <a:extLst xmlns:a="http://schemas.openxmlformats.org/drawingml/2006/main">
               <a:ext uri="{FF2B5EF4-FFF2-40B4-BE49-F238E27FC236}">
-                <a16:creationId xmlns:a16="http://schemas.microsoft.com/office/drawing/2014/main" id="{DE3812FB-6E43-4624-9FD8-5E245B5133DC}"/>
+                <a16:creationId xmlns:a16="http://schemas.microsoft.com/office/drawing/2014/main" id="{86CBABCF-2129-4C5F-B2E7-5ED3C47741B9}"/>
               </a:ext>
             </a:extLst>
           </p:cNvPr>
@@ -11071,7 +11071,7 @@
           <p:cNvPr id="27" name="">
             <a:extLst xmlns:a="http://schemas.openxmlformats.org/drawingml/2006/main">
               <a:ext uri="{FF2B5EF4-FFF2-40B4-BE49-F238E27FC236}">
-                <a16:creationId xmlns:a16="http://schemas.microsoft.com/office/drawing/2014/main" id="{625602AE-13C5-454F-A8B7-DB46EC53818E}"/>
+                <a16:creationId xmlns:a16="http://schemas.microsoft.com/office/drawing/2014/main" id="{0EAAE57E-04CB-4C64-9538-ED5B212DD0F6}"/>
               </a:ext>
             </a:extLst>
           </p:cNvPr>
@@ -11128,7 +11128,7 @@
           <p:cNvPr id="28" name="">
             <a:extLst xmlns:a="http://schemas.openxmlformats.org/drawingml/2006/main">
               <a:ext uri="{FF2B5EF4-FFF2-40B4-BE49-F238E27FC236}">
-                <a16:creationId xmlns:a16="http://schemas.microsoft.com/office/drawing/2014/main" id="{59C83D30-8D76-40C5-BDBC-4731B1445FCB}"/>
+                <a16:creationId xmlns:a16="http://schemas.microsoft.com/office/drawing/2014/main" id="{3EEC0573-6485-4D4B-9A80-B5C546A2B188}"/>
               </a:ext>
             </a:extLst>
           </p:cNvPr>
@@ -11192,7 +11192,7 @@
           <p:cNvPr id="29" name="">
             <a:extLst xmlns:a="http://schemas.openxmlformats.org/drawingml/2006/main">
               <a:ext uri="{FF2B5EF4-FFF2-40B4-BE49-F238E27FC236}">
-                <a16:creationId xmlns:a16="http://schemas.microsoft.com/office/drawing/2014/main" id="{AC060F70-263D-455B-942A-90F9BE01C59A}"/>
+                <a16:creationId xmlns:a16="http://schemas.microsoft.com/office/drawing/2014/main" id="{E8E309E7-F1CE-41B1-B92B-75FAD17B73E5}"/>
               </a:ext>
             </a:extLst>
           </p:cNvPr>
@@ -11239,7 +11239,7 @@
                 <a:ea typeface="Arial"/>
                 <a:cs typeface="Arial"/>
               </a:rPr>
-              <a:t>Video • slide • Build Log</a:t>
+              <a:t>Fallback opt-in + audit</a:t>
             </a:r>
           </a:p>
         </p:txBody>
@@ -11249,7 +11249,7 @@
           <p:cNvPr id="30" name="">
             <a:extLst xmlns:a="http://schemas.openxmlformats.org/drawingml/2006/main">
               <a:ext uri="{FF2B5EF4-FFF2-40B4-BE49-F238E27FC236}">
-                <a16:creationId xmlns:a16="http://schemas.microsoft.com/office/drawing/2014/main" id="{623AECBB-E664-4745-A81C-7272E32C4061}"/>
+                <a16:creationId xmlns:a16="http://schemas.microsoft.com/office/drawing/2014/main" id="{D39F1673-3D59-4B6C-8FE5-3DA8A10F8116}"/>
               </a:ext>
             </a:extLst>
           </p:cNvPr>
@@ -11284,7 +11284,7 @@
           <p:cNvPr id="31" name="">
             <a:extLst xmlns:a="http://schemas.openxmlformats.org/drawingml/2006/main">
               <a:ext uri="{FF2B5EF4-FFF2-40B4-BE49-F238E27FC236}">
-                <a16:creationId xmlns:a16="http://schemas.microsoft.com/office/drawing/2014/main" id="{F5F2EF3D-AD3C-47EA-B59E-B9391F1F243F}"/>
+                <a16:creationId xmlns:a16="http://schemas.microsoft.com/office/drawing/2014/main" id="{BCA4B6C8-5930-4AF6-8DE8-1FE24117355F}"/>
               </a:ext>
             </a:extLst>
           </p:cNvPr>
@@ -11331,7 +11331,7 @@
                 <a:ea typeface="Arial"/>
                 <a:cs typeface="Arial"/>
               </a:rPr>
-              <a:t>CHƯA CÓ TRONG SPRINT 1</a:t>
+              <a:t>CHƯA CÓ TRONG BASELINE</a:t>
             </a:r>
           </a:p>
         </p:txBody>
@@ -11341,7 +11341,7 @@
           <p:cNvPr id="32" name="">
             <a:extLst xmlns:a="http://schemas.openxmlformats.org/drawingml/2006/main">
               <a:ext uri="{FF2B5EF4-FFF2-40B4-BE49-F238E27FC236}">
-                <a16:creationId xmlns:a16="http://schemas.microsoft.com/office/drawing/2014/main" id="{125B3BE2-3BC7-43B5-B6D2-4AE1DB606954}"/>
+                <a16:creationId xmlns:a16="http://schemas.microsoft.com/office/drawing/2014/main" id="{E8D7F4CD-788E-4631-BE9C-E9F955F0F0AE}"/>
               </a:ext>
             </a:extLst>
           </p:cNvPr>
@@ -11444,7 +11444,7 @@
           <p:cNvPr id="33" name="">
             <a:extLst xmlns:a="http://schemas.openxmlformats.org/drawingml/2006/main">
               <a:ext uri="{FF2B5EF4-FFF2-40B4-BE49-F238E27FC236}">
-                <a16:creationId xmlns:a16="http://schemas.microsoft.com/office/drawing/2014/main" id="{340D99FF-1910-460B-9828-4E009B7E76FB}"/>
+                <a16:creationId xmlns:a16="http://schemas.microsoft.com/office/drawing/2014/main" id="{BF7CB6F2-7F57-46F2-A1B7-FA2EE3E87DC8}"/>
               </a:ext>
             </a:extLst>
           </p:cNvPr>
@@ -11491,7 +11491,7 @@
                 <a:ea typeface="Arial"/>
                 <a:cs typeface="Arial"/>
               </a:rPr>
-              <a:t>Ollama 4B đã qua fixture gate; benchmark độc lập vẫn là điều kiện đổi baseline.</a:t>
+              <a:t>Verify vẫn đúng 5 ca BTC; fallback phải tắt khi benchmark từng provider.</a:t>
             </a:r>
           </a:p>
         </p:txBody>
@@ -11501,7 +11501,7 @@
           <p:cNvPr id="34" name="">
             <a:extLst xmlns:a="http://schemas.openxmlformats.org/drawingml/2006/main">
               <a:ext uri="{FF2B5EF4-FFF2-40B4-BE49-F238E27FC236}">
-                <a16:creationId xmlns:a16="http://schemas.microsoft.com/office/drawing/2014/main" id="{F1F17892-0B04-4F7F-AF77-D4DE212894EF}"/>
+                <a16:creationId xmlns:a16="http://schemas.microsoft.com/office/drawing/2014/main" id="{FA399DBA-7C42-4F92-8B87-9CD9FF505F5E}"/>
               </a:ext>
             </a:extLst>
           </p:cNvPr>
@@ -11558,7 +11558,7 @@
           <p:cNvPr id="35" name="">
             <a:extLst xmlns:a="http://schemas.openxmlformats.org/drawingml/2006/main">
               <a:ext uri="{FF2B5EF4-FFF2-40B4-BE49-F238E27FC236}">
-                <a16:creationId xmlns:a16="http://schemas.microsoft.com/office/drawing/2014/main" id="{33C5D697-FFCF-4F37-A6C1-5AC8275DDE1A}"/>
+                <a16:creationId xmlns:a16="http://schemas.microsoft.com/office/drawing/2014/main" id="{C49EE0CF-AF8E-42E8-95BC-4DF36E9FAF4F}"/>
               </a:ext>
             </a:extLst>
           </p:cNvPr>
@@ -11613,7 +11613,7 @@
     </p:spTree>
     <p:extLst>
       <p:ext uri="{BB962C8B-B14F-4D97-AF65-F5344CB8AC3E}">
-        <p14:creationId xmlns:p14="http://schemas.microsoft.com/office/powerpoint/2010/main" val="843106229"/>
+        <p14:creationId xmlns:p14="http://schemas.microsoft.com/office/powerpoint/2010/main" val="255517678"/>
       </p:ext>
     </p:extLst>
   </p:cSld>

</xml_diff>

<commit_message>
docs: align submission with extended evaluation workflow
</commit_message>
<xml_diff>
--- a/AURA/submission/AURA_5_SLIDES.pptx
+++ b/AURA/submission/AURA_5_SLIDES.pptx
@@ -2,17 +2,17 @@
 <file path=ppt/presentation.xml><?xml version="1.0" encoding="utf-8"?>
 <p:presentation xmlns:p="http://schemas.openxmlformats.org/presentationml/2006/main">
   <p:sldMasterIdLst>
-    <p:sldMasterId xmlns:r="http://schemas.openxmlformats.org/officeDocument/2006/relationships" id="2147483648" r:id="R05037d59b07a4cc1"/>
+    <p:sldMasterId xmlns:r="http://schemas.openxmlformats.org/officeDocument/2006/relationships" id="2147483648" r:id="R8dbcd48ae31440cf"/>
   </p:sldMasterIdLst>
   <p:notesMasterIdLst>
-    <p:notesMasterId xmlns:r="http://schemas.openxmlformats.org/officeDocument/2006/relationships" r:id="Re16c9e82868c4a29"/>
+    <p:notesMasterId xmlns:r="http://schemas.openxmlformats.org/officeDocument/2006/relationships" r:id="Rf69c1baef6e94e25"/>
   </p:notesMasterIdLst>
   <p:sldIdLst>
-    <p:sldId xmlns:r="http://schemas.openxmlformats.org/officeDocument/2006/relationships" id="256" r:id="Rf4d67348cfff4712"/>
-    <p:sldId xmlns:r="http://schemas.openxmlformats.org/officeDocument/2006/relationships" id="257" r:id="Ra1b50c867a7c4515"/>
-    <p:sldId xmlns:r="http://schemas.openxmlformats.org/officeDocument/2006/relationships" id="258" r:id="R5e15d508eae840d7"/>
-    <p:sldId xmlns:r="http://schemas.openxmlformats.org/officeDocument/2006/relationships" id="259" r:id="R235e7a1204fc4739"/>
-    <p:sldId xmlns:r="http://schemas.openxmlformats.org/officeDocument/2006/relationships" id="260" r:id="Ra688c402d47043af"/>
+    <p:sldId xmlns:r="http://schemas.openxmlformats.org/officeDocument/2006/relationships" id="256" r:id="Rdb068fec59674faf"/>
+    <p:sldId xmlns:r="http://schemas.openxmlformats.org/officeDocument/2006/relationships" id="257" r:id="R7926e257b98c427b"/>
+    <p:sldId xmlns:r="http://schemas.openxmlformats.org/officeDocument/2006/relationships" id="258" r:id="Re6c7db2d3e6b4902"/>
+    <p:sldId xmlns:r="http://schemas.openxmlformats.org/officeDocument/2006/relationships" id="259" r:id="Ra7916086c67742f9"/>
+    <p:sldId xmlns:r="http://schemas.openxmlformats.org/officeDocument/2006/relationships" id="260" r:id="R0627b5e26e0a4d06"/>
   </p:sldIdLst>
   <p:sldSz cx="12192000" cy="6858000"/>
   <p:notesSz cx="6858000" cy="9144000"/>
@@ -726,7 +726,7 @@
           <a:lstStyle xmlns:a="http://schemas.openxmlformats.org/drawingml/2006/main"/>
           <a:p xmlns:a="http://schemas.openxmlformats.org/drawingml/2006/main">
             <a:r>
-              <a:t>Nguồn kỹ thuật trong repo: ReceiptProcessingWorker.cs, ConfiguredVisionExtractor.cs, VisionCircuitBreaker.cs và docs/SPRINT2_IMPLEMENTATION_PROGRESS_2026-09-28.md.</a:t>
+              <a:t>Nguồn kỹ thuật trong repo: ReceiptProcessingWorker.cs, ConfiguredVisionExtractor.cs, VisionCircuitBreaker.cs, tools/Invoke-ExtendedDatasetEvaluation.ps1 và docs/SPRINT2_IMPLEMENTATION_PROGRESS_2026-09-28.md. EF Core 8.0.31 đã qua vulnerability scan không còn advisory.</a:t>
             </a:r>
           </a:p>
         </p:txBody>
@@ -794,7 +794,7 @@
   </p:cSld>
   <p:clrMap bg1="lt1" tx1="dk1" bg2="lt2" tx2="dk2" accent1="accent1" accent2="accent2" accent3="accent3" accent4="accent4" accent5="accent5" accent6="accent6" hlink="hlink" folHlink="folHlink"/>
   <p:sldLayoutIdLst>
-    <p:sldLayoutId xmlns:r="http://schemas.openxmlformats.org/officeDocument/2006/relationships" id="2147483649" r:id="R5e24a9f384c04eea"/>
+    <p:sldLayoutId xmlns:r="http://schemas.openxmlformats.org/officeDocument/2006/relationships" id="2147483649" r:id="Recc014f5756e4297"/>
   </p:sldLayoutIdLst>
   <p:txStyles>
     <p:titleStyle>
@@ -1345,7 +1345,7 @@
           <p:cNvPr id="47" name="">
             <a:extLst xmlns:a="http://schemas.openxmlformats.org/drawingml/2006/main">
               <a:ext uri="{FF2B5EF4-FFF2-40B4-BE49-F238E27FC236}">
-                <a16:creationId xmlns:a16="http://schemas.microsoft.com/office/drawing/2014/main" id="{35E868D2-B838-4BCF-A363-75619F704C40}"/>
+                <a16:creationId xmlns:a16="http://schemas.microsoft.com/office/drawing/2014/main" id="{04E954BC-4B83-41FA-BE98-80AB8CCF0257}"/>
               </a:ext>
             </a:extLst>
           </p:cNvPr>
@@ -1402,7 +1402,7 @@
           <p:cNvPr id="2" name="">
             <a:extLst xmlns:a="http://schemas.openxmlformats.org/drawingml/2006/main">
               <a:ext uri="{FF2B5EF4-FFF2-40B4-BE49-F238E27FC236}">
-                <a16:creationId xmlns:a16="http://schemas.microsoft.com/office/drawing/2014/main" id="{4B6F3656-AD84-4AE2-9B16-8671DD462FA8}"/>
+                <a16:creationId xmlns:a16="http://schemas.microsoft.com/office/drawing/2014/main" id="{D2DA4915-CED4-451E-BE5F-59A4405C0BBA}"/>
               </a:ext>
             </a:extLst>
           </p:cNvPr>
@@ -1459,7 +1459,7 @@
           <p:cNvPr id="3" name="">
             <a:extLst xmlns:a="http://schemas.openxmlformats.org/drawingml/2006/main">
               <a:ext uri="{FF2B5EF4-FFF2-40B4-BE49-F238E27FC236}">
-                <a16:creationId xmlns:a16="http://schemas.microsoft.com/office/drawing/2014/main" id="{0B3A7C9A-B179-4902-A0E2-EA25F1771BEF}"/>
+                <a16:creationId xmlns:a16="http://schemas.microsoft.com/office/drawing/2014/main" id="{22BBF3BC-D672-43D1-AB69-E7783BD5CD85}"/>
               </a:ext>
             </a:extLst>
           </p:cNvPr>
@@ -1516,7 +1516,7 @@
           <p:cNvPr id="4" name="">
             <a:extLst xmlns:a="http://schemas.openxmlformats.org/drawingml/2006/main">
               <a:ext uri="{FF2B5EF4-FFF2-40B4-BE49-F238E27FC236}">
-                <a16:creationId xmlns:a16="http://schemas.microsoft.com/office/drawing/2014/main" id="{22203BD3-F36D-43FD-B6D7-A89322A06918}"/>
+                <a16:creationId xmlns:a16="http://schemas.microsoft.com/office/drawing/2014/main" id="{73A00C70-262E-4988-B228-5A596225A3ED}"/>
               </a:ext>
             </a:extLst>
           </p:cNvPr>
@@ -1547,7 +1547,7 @@
           <p:cNvPr id="5" name="">
             <a:extLst xmlns:a="http://schemas.openxmlformats.org/drawingml/2006/main">
               <a:ext uri="{FF2B5EF4-FFF2-40B4-BE49-F238E27FC236}">
-                <a16:creationId xmlns:a16="http://schemas.microsoft.com/office/drawing/2014/main" id="{C92F7855-F0DE-4F5B-989C-4834F8C7CDD5}"/>
+                <a16:creationId xmlns:a16="http://schemas.microsoft.com/office/drawing/2014/main" id="{198A3320-F627-43B0-B180-D44E94D9F8A5}"/>
               </a:ext>
             </a:extLst>
           </p:cNvPr>
@@ -1582,7 +1582,7 @@
           <p:cNvPr id="6" name="">
             <a:extLst xmlns:a="http://schemas.openxmlformats.org/drawingml/2006/main">
               <a:ext uri="{FF2B5EF4-FFF2-40B4-BE49-F238E27FC236}">
-                <a16:creationId xmlns:a16="http://schemas.microsoft.com/office/drawing/2014/main" id="{3A228DA1-5D56-451E-B248-9D46420ED9A6}"/>
+                <a16:creationId xmlns:a16="http://schemas.microsoft.com/office/drawing/2014/main" id="{CAADD83A-6763-4021-AAAC-F6CA9A5D480D}"/>
               </a:ext>
             </a:extLst>
           </p:cNvPr>
@@ -1646,7 +1646,7 @@
           <p:cNvPr id="7" name="">
             <a:extLst xmlns:a="http://schemas.openxmlformats.org/drawingml/2006/main">
               <a:ext uri="{FF2B5EF4-FFF2-40B4-BE49-F238E27FC236}">
-                <a16:creationId xmlns:a16="http://schemas.microsoft.com/office/drawing/2014/main" id="{1DBBE4FB-C843-4397-9A87-791659DCFE40}"/>
+                <a16:creationId xmlns:a16="http://schemas.microsoft.com/office/drawing/2014/main" id="{63E9BFF4-5E7F-485C-BC02-12595C469B95}"/>
               </a:ext>
             </a:extLst>
           </p:cNvPr>
@@ -1703,7 +1703,7 @@
           <p:cNvPr id="8" name="">
             <a:extLst xmlns:a="http://schemas.openxmlformats.org/drawingml/2006/main">
               <a:ext uri="{FF2B5EF4-FFF2-40B4-BE49-F238E27FC236}">
-                <a16:creationId xmlns:a16="http://schemas.microsoft.com/office/drawing/2014/main" id="{4AA07307-5EBC-42C9-BEF1-37E28C9C1950}"/>
+                <a16:creationId xmlns:a16="http://schemas.microsoft.com/office/drawing/2014/main" id="{AE5D8E86-0D23-475E-B607-5B24C61CB66E}"/>
               </a:ext>
             </a:extLst>
           </p:cNvPr>
@@ -1760,7 +1760,7 @@
           <p:cNvPr id="9" name="">
             <a:extLst xmlns:a="http://schemas.openxmlformats.org/drawingml/2006/main">
               <a:ext uri="{FF2B5EF4-FFF2-40B4-BE49-F238E27FC236}">
-                <a16:creationId xmlns:a16="http://schemas.microsoft.com/office/drawing/2014/main" id="{FDBCDCBC-00D4-414D-8C6F-F09C7A954EC9}"/>
+                <a16:creationId xmlns:a16="http://schemas.microsoft.com/office/drawing/2014/main" id="{20BBA6AE-25B7-443F-82D4-AD8F886BA5AD}"/>
               </a:ext>
             </a:extLst>
           </p:cNvPr>
@@ -1792,7 +1792,7 @@
           <p:cNvPr id="10" name="">
             <a:extLst xmlns:a="http://schemas.openxmlformats.org/drawingml/2006/main">
               <a:ext uri="{FF2B5EF4-FFF2-40B4-BE49-F238E27FC236}">
-                <a16:creationId xmlns:a16="http://schemas.microsoft.com/office/drawing/2014/main" id="{5B2EC2C0-5431-416D-BB01-17C13404EA30}"/>
+                <a16:creationId xmlns:a16="http://schemas.microsoft.com/office/drawing/2014/main" id="{AF0C7324-AF47-4731-BCCD-01737C084BB7}"/>
               </a:ext>
             </a:extLst>
           </p:cNvPr>
@@ -1827,7 +1827,7 @@
           <p:cNvPr id="11" name="">
             <a:extLst xmlns:a="http://schemas.openxmlformats.org/drawingml/2006/main">
               <a:ext uri="{FF2B5EF4-FFF2-40B4-BE49-F238E27FC236}">
-                <a16:creationId xmlns:a16="http://schemas.microsoft.com/office/drawing/2014/main" id="{0DDFA1F8-C37C-42C7-A33D-0E452D35EC00}"/>
+                <a16:creationId xmlns:a16="http://schemas.microsoft.com/office/drawing/2014/main" id="{B9F0311C-D2A5-4DBB-930D-3EE573131351}"/>
               </a:ext>
             </a:extLst>
           </p:cNvPr>
@@ -1891,7 +1891,7 @@
           <p:cNvPr id="12" name="">
             <a:extLst xmlns:a="http://schemas.openxmlformats.org/drawingml/2006/main">
               <a:ext uri="{FF2B5EF4-FFF2-40B4-BE49-F238E27FC236}">
-                <a16:creationId xmlns:a16="http://schemas.microsoft.com/office/drawing/2014/main" id="{325F535E-F804-4029-B39A-3711BFD5F19E}"/>
+                <a16:creationId xmlns:a16="http://schemas.microsoft.com/office/drawing/2014/main" id="{09F0CC81-DC54-44F6-B963-CFBE082AAEC8}"/>
               </a:ext>
             </a:extLst>
           </p:cNvPr>
@@ -1948,7 +1948,7 @@
           <p:cNvPr id="13" name="">
             <a:extLst xmlns:a="http://schemas.openxmlformats.org/drawingml/2006/main">
               <a:ext uri="{FF2B5EF4-FFF2-40B4-BE49-F238E27FC236}">
-                <a16:creationId xmlns:a16="http://schemas.microsoft.com/office/drawing/2014/main" id="{7746FA5A-EA42-4C20-91D5-35526F6D1B31}"/>
+                <a16:creationId xmlns:a16="http://schemas.microsoft.com/office/drawing/2014/main" id="{5E733F93-F759-444B-90B0-27CD4353E611}"/>
               </a:ext>
             </a:extLst>
           </p:cNvPr>
@@ -2005,7 +2005,7 @@
           <p:cNvPr id="14" name="">
             <a:extLst xmlns:a="http://schemas.openxmlformats.org/drawingml/2006/main">
               <a:ext uri="{FF2B5EF4-FFF2-40B4-BE49-F238E27FC236}">
-                <a16:creationId xmlns:a16="http://schemas.microsoft.com/office/drawing/2014/main" id="{4F1076C2-5579-405E-9C3E-AD04BB0BB8D8}"/>
+                <a16:creationId xmlns:a16="http://schemas.microsoft.com/office/drawing/2014/main" id="{5D767604-61CF-4FF3-8656-9D142EF2B021}"/>
               </a:ext>
             </a:extLst>
           </p:cNvPr>
@@ -2037,7 +2037,7 @@
           <p:cNvPr id="15" name="">
             <a:extLst xmlns:a="http://schemas.openxmlformats.org/drawingml/2006/main">
               <a:ext uri="{FF2B5EF4-FFF2-40B4-BE49-F238E27FC236}">
-                <a16:creationId xmlns:a16="http://schemas.microsoft.com/office/drawing/2014/main" id="{B17E57FE-5EC0-4F4B-8AE1-69378DDE7DB1}"/>
+                <a16:creationId xmlns:a16="http://schemas.microsoft.com/office/drawing/2014/main" id="{8B437931-18A8-4CD7-9B52-D626689A60BC}"/>
               </a:ext>
             </a:extLst>
           </p:cNvPr>
@@ -2072,7 +2072,7 @@
           <p:cNvPr id="16" name="">
             <a:extLst xmlns:a="http://schemas.openxmlformats.org/drawingml/2006/main">
               <a:ext uri="{FF2B5EF4-FFF2-40B4-BE49-F238E27FC236}">
-                <a16:creationId xmlns:a16="http://schemas.microsoft.com/office/drawing/2014/main" id="{CA10ABDB-3387-4264-856C-4AD09927DEB4}"/>
+                <a16:creationId xmlns:a16="http://schemas.microsoft.com/office/drawing/2014/main" id="{C88770A4-D0F2-4D1D-96C4-1ADD9F190AED}"/>
               </a:ext>
             </a:extLst>
           </p:cNvPr>
@@ -2136,7 +2136,7 @@
           <p:cNvPr id="17" name="">
             <a:extLst xmlns:a="http://schemas.openxmlformats.org/drawingml/2006/main">
               <a:ext uri="{FF2B5EF4-FFF2-40B4-BE49-F238E27FC236}">
-                <a16:creationId xmlns:a16="http://schemas.microsoft.com/office/drawing/2014/main" id="{3100B212-9C34-4012-BCD4-C52FAC54075A}"/>
+                <a16:creationId xmlns:a16="http://schemas.microsoft.com/office/drawing/2014/main" id="{7FBAB8B4-81A6-4132-A6AA-16B4947AD057}"/>
               </a:ext>
             </a:extLst>
           </p:cNvPr>
@@ -2193,7 +2193,7 @@
           <p:cNvPr id="18" name="">
             <a:extLst xmlns:a="http://schemas.openxmlformats.org/drawingml/2006/main">
               <a:ext uri="{FF2B5EF4-FFF2-40B4-BE49-F238E27FC236}">
-                <a16:creationId xmlns:a16="http://schemas.microsoft.com/office/drawing/2014/main" id="{F956106A-69F1-4ACA-B902-711759B66E80}"/>
+                <a16:creationId xmlns:a16="http://schemas.microsoft.com/office/drawing/2014/main" id="{622002EE-F5C3-4EC7-B4A0-9582336519A6}"/>
               </a:ext>
             </a:extLst>
           </p:cNvPr>
@@ -2250,7 +2250,7 @@
           <p:cNvPr id="19" name="">
             <a:extLst xmlns:a="http://schemas.openxmlformats.org/drawingml/2006/main">
               <a:ext uri="{FF2B5EF4-FFF2-40B4-BE49-F238E27FC236}">
-                <a16:creationId xmlns:a16="http://schemas.microsoft.com/office/drawing/2014/main" id="{45ED9181-5399-487E-9611-6B65C6A3410F}"/>
+                <a16:creationId xmlns:a16="http://schemas.microsoft.com/office/drawing/2014/main" id="{3A4E9743-A896-4F7F-996E-9581092069A4}"/>
               </a:ext>
             </a:extLst>
           </p:cNvPr>
@@ -2282,7 +2282,7 @@
           <p:cNvPr id="20" name="">
             <a:extLst xmlns:a="http://schemas.openxmlformats.org/drawingml/2006/main">
               <a:ext uri="{FF2B5EF4-FFF2-40B4-BE49-F238E27FC236}">
-                <a16:creationId xmlns:a16="http://schemas.microsoft.com/office/drawing/2014/main" id="{BF543D96-3721-4AE9-87C6-447CCE3B911A}"/>
+                <a16:creationId xmlns:a16="http://schemas.microsoft.com/office/drawing/2014/main" id="{890C3043-AA79-467C-B937-BBCB5B9E7DB4}"/>
               </a:ext>
             </a:extLst>
           </p:cNvPr>
@@ -2317,7 +2317,7 @@
           <p:cNvPr id="21" name="">
             <a:extLst xmlns:a="http://schemas.openxmlformats.org/drawingml/2006/main">
               <a:ext uri="{FF2B5EF4-FFF2-40B4-BE49-F238E27FC236}">
-                <a16:creationId xmlns:a16="http://schemas.microsoft.com/office/drawing/2014/main" id="{79C6E711-F5F4-4CBF-90FF-F420C6C5B00C}"/>
+                <a16:creationId xmlns:a16="http://schemas.microsoft.com/office/drawing/2014/main" id="{CE451EF7-A920-4EC9-A716-D1028F8D026B}"/>
               </a:ext>
             </a:extLst>
           </p:cNvPr>
@@ -2381,7 +2381,7 @@
           <p:cNvPr id="22" name="">
             <a:extLst xmlns:a="http://schemas.openxmlformats.org/drawingml/2006/main">
               <a:ext uri="{FF2B5EF4-FFF2-40B4-BE49-F238E27FC236}">
-                <a16:creationId xmlns:a16="http://schemas.microsoft.com/office/drawing/2014/main" id="{4CEB23D5-B47D-4621-BC6B-4B84BC4D99AD}"/>
+                <a16:creationId xmlns:a16="http://schemas.microsoft.com/office/drawing/2014/main" id="{B0B7A445-6E87-4720-B935-F505730D08B7}"/>
               </a:ext>
             </a:extLst>
           </p:cNvPr>
@@ -2438,7 +2438,7 @@
           <p:cNvPr id="23" name="">
             <a:extLst xmlns:a="http://schemas.openxmlformats.org/drawingml/2006/main">
               <a:ext uri="{FF2B5EF4-FFF2-40B4-BE49-F238E27FC236}">
-                <a16:creationId xmlns:a16="http://schemas.microsoft.com/office/drawing/2014/main" id="{C2764D1D-C3F8-4599-B7CE-38D2CC07B0DC}"/>
+                <a16:creationId xmlns:a16="http://schemas.microsoft.com/office/drawing/2014/main" id="{7815F6A8-9506-494D-9404-E92AA429E2FF}"/>
               </a:ext>
             </a:extLst>
           </p:cNvPr>
@@ -2495,7 +2495,7 @@
           <p:cNvPr id="24" name="">
             <a:extLst xmlns:a="http://schemas.openxmlformats.org/drawingml/2006/main">
               <a:ext uri="{FF2B5EF4-FFF2-40B4-BE49-F238E27FC236}">
-                <a16:creationId xmlns:a16="http://schemas.microsoft.com/office/drawing/2014/main" id="{8A043663-16C1-4D2A-AB85-53B9B9A7E850}"/>
+                <a16:creationId xmlns:a16="http://schemas.microsoft.com/office/drawing/2014/main" id="{FB054566-C47C-401D-85F3-5545BA155F0B}"/>
               </a:ext>
             </a:extLst>
           </p:cNvPr>
@@ -2527,7 +2527,7 @@
           <p:cNvPr id="25" name="">
             <a:extLst xmlns:a="http://schemas.openxmlformats.org/drawingml/2006/main">
               <a:ext uri="{FF2B5EF4-FFF2-40B4-BE49-F238E27FC236}">
-                <a16:creationId xmlns:a16="http://schemas.microsoft.com/office/drawing/2014/main" id="{4DEF86DE-6402-4DF2-9A5B-25D9D96D5FF6}"/>
+                <a16:creationId xmlns:a16="http://schemas.microsoft.com/office/drawing/2014/main" id="{2C4D73AD-2460-4FE9-AD34-34D0586489DB}"/>
               </a:ext>
             </a:extLst>
           </p:cNvPr>
@@ -2562,7 +2562,7 @@
           <p:cNvPr id="26" name="">
             <a:extLst xmlns:a="http://schemas.openxmlformats.org/drawingml/2006/main">
               <a:ext uri="{FF2B5EF4-FFF2-40B4-BE49-F238E27FC236}">
-                <a16:creationId xmlns:a16="http://schemas.microsoft.com/office/drawing/2014/main" id="{E81B0109-0C48-40F6-AA25-5DD1DBE2B76F}"/>
+                <a16:creationId xmlns:a16="http://schemas.microsoft.com/office/drawing/2014/main" id="{6C9137E8-3846-44C3-AC30-57B5A84176EE}"/>
               </a:ext>
             </a:extLst>
           </p:cNvPr>
@@ -2626,7 +2626,7 @@
           <p:cNvPr id="27" name="">
             <a:extLst xmlns:a="http://schemas.openxmlformats.org/drawingml/2006/main">
               <a:ext uri="{FF2B5EF4-FFF2-40B4-BE49-F238E27FC236}">
-                <a16:creationId xmlns:a16="http://schemas.microsoft.com/office/drawing/2014/main" id="{A53B535A-35CB-4F20-A71F-E9F5EB7A8566}"/>
+                <a16:creationId xmlns:a16="http://schemas.microsoft.com/office/drawing/2014/main" id="{90E946AE-7DB7-4772-810F-944D2C677DAE}"/>
               </a:ext>
             </a:extLst>
           </p:cNvPr>
@@ -2683,7 +2683,7 @@
           <p:cNvPr id="28" name="">
             <a:extLst xmlns:a="http://schemas.openxmlformats.org/drawingml/2006/main">
               <a:ext uri="{FF2B5EF4-FFF2-40B4-BE49-F238E27FC236}">
-                <a16:creationId xmlns:a16="http://schemas.microsoft.com/office/drawing/2014/main" id="{8F987823-3CD0-4F4B-955A-FABD81AA6407}"/>
+                <a16:creationId xmlns:a16="http://schemas.microsoft.com/office/drawing/2014/main" id="{D9262CF1-ACC3-4412-90DD-93FB9B6F87C5}"/>
               </a:ext>
             </a:extLst>
           </p:cNvPr>
@@ -2740,7 +2740,7 @@
           <p:cNvPr id="29" name="">
             <a:extLst xmlns:a="http://schemas.openxmlformats.org/drawingml/2006/main">
               <a:ext uri="{FF2B5EF4-FFF2-40B4-BE49-F238E27FC236}">
-                <a16:creationId xmlns:a16="http://schemas.microsoft.com/office/drawing/2014/main" id="{1BAB520E-C131-4763-8B9F-E6E1D0A53E24}"/>
+                <a16:creationId xmlns:a16="http://schemas.microsoft.com/office/drawing/2014/main" id="{F1D69133-2759-4E37-B91D-AFAE61C5F3CD}"/>
               </a:ext>
             </a:extLst>
           </p:cNvPr>
@@ -2775,7 +2775,7 @@
           <p:cNvPr id="30" name="">
             <a:extLst xmlns:a="http://schemas.openxmlformats.org/drawingml/2006/main">
               <a:ext uri="{FF2B5EF4-FFF2-40B4-BE49-F238E27FC236}">
-                <a16:creationId xmlns:a16="http://schemas.microsoft.com/office/drawing/2014/main" id="{2855C151-E073-4874-AC4F-94810E75AEBF}"/>
+                <a16:creationId xmlns:a16="http://schemas.microsoft.com/office/drawing/2014/main" id="{954F7157-F32C-45D2-A7E6-0857D095C1A2}"/>
               </a:ext>
             </a:extLst>
           </p:cNvPr>
@@ -2832,7 +2832,7 @@
           <p:cNvPr id="31" name="">
             <a:extLst xmlns:a="http://schemas.openxmlformats.org/drawingml/2006/main">
               <a:ext uri="{FF2B5EF4-FFF2-40B4-BE49-F238E27FC236}">
-                <a16:creationId xmlns:a16="http://schemas.microsoft.com/office/drawing/2014/main" id="{53696A0D-DF29-4EB1-B822-6304F6D966D4}"/>
+                <a16:creationId xmlns:a16="http://schemas.microsoft.com/office/drawing/2014/main" id="{A54340C4-8552-4677-BA34-B7AB8F1B6B89}"/>
               </a:ext>
             </a:extLst>
           </p:cNvPr>
@@ -2889,7 +2889,7 @@
           <p:cNvPr id="32" name="">
             <a:extLst xmlns:a="http://schemas.openxmlformats.org/drawingml/2006/main">
               <a:ext uri="{FF2B5EF4-FFF2-40B4-BE49-F238E27FC236}">
-                <a16:creationId xmlns:a16="http://schemas.microsoft.com/office/drawing/2014/main" id="{58C64288-E284-4E45-BC18-59097EF18532}"/>
+                <a16:creationId xmlns:a16="http://schemas.microsoft.com/office/drawing/2014/main" id="{A6160FC1-A261-4D0F-887B-204626DE4F16}"/>
               </a:ext>
             </a:extLst>
           </p:cNvPr>
@@ -2946,7 +2946,7 @@
           <p:cNvPr id="33" name="">
             <a:extLst xmlns:a="http://schemas.openxmlformats.org/drawingml/2006/main">
               <a:ext uri="{FF2B5EF4-FFF2-40B4-BE49-F238E27FC236}">
-                <a16:creationId xmlns:a16="http://schemas.microsoft.com/office/drawing/2014/main" id="{DB83B350-00E1-4B1D-81DF-8F89397B6932}"/>
+                <a16:creationId xmlns:a16="http://schemas.microsoft.com/office/drawing/2014/main" id="{58C3B264-0500-401A-9121-25949BE8C613}"/>
               </a:ext>
             </a:extLst>
           </p:cNvPr>
@@ -2981,7 +2981,7 @@
           <p:cNvPr id="34" name="">
             <a:extLst xmlns:a="http://schemas.openxmlformats.org/drawingml/2006/main">
               <a:ext uri="{FF2B5EF4-FFF2-40B4-BE49-F238E27FC236}">
-                <a16:creationId xmlns:a16="http://schemas.microsoft.com/office/drawing/2014/main" id="{6136DBC3-2BD8-494A-8BF7-E5949A48DE6B}"/>
+                <a16:creationId xmlns:a16="http://schemas.microsoft.com/office/drawing/2014/main" id="{4AC9581A-890F-4C22-9DE4-B013386B309D}"/>
               </a:ext>
             </a:extLst>
           </p:cNvPr>
@@ -3045,7 +3045,7 @@
           <p:cNvPr id="35" name="">
             <a:extLst xmlns:a="http://schemas.openxmlformats.org/drawingml/2006/main">
               <a:ext uri="{FF2B5EF4-FFF2-40B4-BE49-F238E27FC236}">
-                <a16:creationId xmlns:a16="http://schemas.microsoft.com/office/drawing/2014/main" id="{30CA994E-D04C-45BC-9E16-6350AC412B9B}"/>
+                <a16:creationId xmlns:a16="http://schemas.microsoft.com/office/drawing/2014/main" id="{98C9547F-9E13-496B-BEE9-04E2E73FE830}"/>
               </a:ext>
             </a:extLst>
           </p:cNvPr>
@@ -3102,7 +3102,7 @@
           <p:cNvPr id="36" name="">
             <a:extLst xmlns:a="http://schemas.openxmlformats.org/drawingml/2006/main">
               <a:ext uri="{FF2B5EF4-FFF2-40B4-BE49-F238E27FC236}">
-                <a16:creationId xmlns:a16="http://schemas.microsoft.com/office/drawing/2014/main" id="{E3B194DB-3A72-449D-A864-3A0F833DC87C}"/>
+                <a16:creationId xmlns:a16="http://schemas.microsoft.com/office/drawing/2014/main" id="{3ABBFDC6-7E12-498E-B96E-921ECBEA49A6}"/>
               </a:ext>
             </a:extLst>
           </p:cNvPr>
@@ -3159,7 +3159,7 @@
           <p:cNvPr id="37" name="">
             <a:extLst xmlns:a="http://schemas.openxmlformats.org/drawingml/2006/main">
               <a:ext uri="{FF2B5EF4-FFF2-40B4-BE49-F238E27FC236}">
-                <a16:creationId xmlns:a16="http://schemas.microsoft.com/office/drawing/2014/main" id="{C4D18935-E3F6-4212-9CCA-1E96238A990E}"/>
+                <a16:creationId xmlns:a16="http://schemas.microsoft.com/office/drawing/2014/main" id="{3A9B1BCC-3396-48F9-8DD9-D927CD3E1FE5}"/>
               </a:ext>
             </a:extLst>
           </p:cNvPr>
@@ -3194,7 +3194,7 @@
           <p:cNvPr id="38" name="">
             <a:extLst xmlns:a="http://schemas.openxmlformats.org/drawingml/2006/main">
               <a:ext uri="{FF2B5EF4-FFF2-40B4-BE49-F238E27FC236}">
-                <a16:creationId xmlns:a16="http://schemas.microsoft.com/office/drawing/2014/main" id="{965518CB-2DCF-46DF-BE63-698194920773}"/>
+                <a16:creationId xmlns:a16="http://schemas.microsoft.com/office/drawing/2014/main" id="{B5D206B7-3E65-4008-8B47-28C572698692}"/>
               </a:ext>
             </a:extLst>
           </p:cNvPr>
@@ -3258,7 +3258,7 @@
           <p:cNvPr id="39" name="">
             <a:extLst xmlns:a="http://schemas.openxmlformats.org/drawingml/2006/main">
               <a:ext uri="{FF2B5EF4-FFF2-40B4-BE49-F238E27FC236}">
-                <a16:creationId xmlns:a16="http://schemas.microsoft.com/office/drawing/2014/main" id="{97DC5760-F9F4-4DE6-9C33-1C7D5681B282}"/>
+                <a16:creationId xmlns:a16="http://schemas.microsoft.com/office/drawing/2014/main" id="{D7EF9C25-F091-44D3-9D6A-90523E6BA78F}"/>
               </a:ext>
             </a:extLst>
           </p:cNvPr>
@@ -3315,7 +3315,7 @@
           <p:cNvPr id="40" name="">
             <a:extLst xmlns:a="http://schemas.openxmlformats.org/drawingml/2006/main">
               <a:ext uri="{FF2B5EF4-FFF2-40B4-BE49-F238E27FC236}">
-                <a16:creationId xmlns:a16="http://schemas.microsoft.com/office/drawing/2014/main" id="{55A8A4F9-95EA-43A8-B8FF-D7400268D97A}"/>
+                <a16:creationId xmlns:a16="http://schemas.microsoft.com/office/drawing/2014/main" id="{B8AF8498-1AB9-4EB8-84AE-EF4FC0DEDF34}"/>
               </a:ext>
             </a:extLst>
           </p:cNvPr>
@@ -3372,7 +3372,7 @@
           <p:cNvPr id="41" name="">
             <a:extLst xmlns:a="http://schemas.openxmlformats.org/drawingml/2006/main">
               <a:ext uri="{FF2B5EF4-FFF2-40B4-BE49-F238E27FC236}">
-                <a16:creationId xmlns:a16="http://schemas.microsoft.com/office/drawing/2014/main" id="{8D70387F-4E55-4487-A7DA-91510E18447C}"/>
+                <a16:creationId xmlns:a16="http://schemas.microsoft.com/office/drawing/2014/main" id="{09F39C5E-A1F0-4A93-BFF9-A47D49DE7AE3}"/>
               </a:ext>
             </a:extLst>
           </p:cNvPr>
@@ -3407,7 +3407,7 @@
           <p:cNvPr id="42" name="">
             <a:extLst xmlns:a="http://schemas.openxmlformats.org/drawingml/2006/main">
               <a:ext uri="{FF2B5EF4-FFF2-40B4-BE49-F238E27FC236}">
-                <a16:creationId xmlns:a16="http://schemas.microsoft.com/office/drawing/2014/main" id="{D600ECBC-CE68-4FA7-AD94-BE0D8B66A83C}"/>
+                <a16:creationId xmlns:a16="http://schemas.microsoft.com/office/drawing/2014/main" id="{C5CD0EB6-C55B-42B7-92A2-DEA997005F98}"/>
               </a:ext>
             </a:extLst>
           </p:cNvPr>
@@ -3471,7 +3471,7 @@
           <p:cNvPr id="43" name="">
             <a:extLst xmlns:a="http://schemas.openxmlformats.org/drawingml/2006/main">
               <a:ext uri="{FF2B5EF4-FFF2-40B4-BE49-F238E27FC236}">
-                <a16:creationId xmlns:a16="http://schemas.microsoft.com/office/drawing/2014/main" id="{945B28BB-490D-4709-9DB5-6CB697C952B9}"/>
+                <a16:creationId xmlns:a16="http://schemas.microsoft.com/office/drawing/2014/main" id="{0196A5AD-1AF1-4B28-BA36-A4AD7D48723F}"/>
               </a:ext>
             </a:extLst>
           </p:cNvPr>
@@ -3528,7 +3528,7 @@
           <p:cNvPr id="44" name="">
             <a:extLst xmlns:a="http://schemas.openxmlformats.org/drawingml/2006/main">
               <a:ext uri="{FF2B5EF4-FFF2-40B4-BE49-F238E27FC236}">
-                <a16:creationId xmlns:a16="http://schemas.microsoft.com/office/drawing/2014/main" id="{C087BF0E-E709-4599-8174-4FE304CAB63A}"/>
+                <a16:creationId xmlns:a16="http://schemas.microsoft.com/office/drawing/2014/main" id="{3442DF6C-6194-433E-A1E2-0E7D1E5FDCF4}"/>
               </a:ext>
             </a:extLst>
           </p:cNvPr>
@@ -3585,7 +3585,7 @@
           <p:cNvPr id="45" name="">
             <a:extLst xmlns:a="http://schemas.openxmlformats.org/drawingml/2006/main">
               <a:ext uri="{FF2B5EF4-FFF2-40B4-BE49-F238E27FC236}">
-                <a16:creationId xmlns:a16="http://schemas.microsoft.com/office/drawing/2014/main" id="{487BA7C8-2D88-4F70-87AA-18B4421C8966}"/>
+                <a16:creationId xmlns:a16="http://schemas.microsoft.com/office/drawing/2014/main" id="{BE30318E-DD57-4D16-AA08-22254C059782}"/>
               </a:ext>
             </a:extLst>
           </p:cNvPr>
@@ -3642,7 +3642,7 @@
           <p:cNvPr id="46" name="">
             <a:extLst xmlns:a="http://schemas.openxmlformats.org/drawingml/2006/main">
               <a:ext uri="{FF2B5EF4-FFF2-40B4-BE49-F238E27FC236}">
-                <a16:creationId xmlns:a16="http://schemas.microsoft.com/office/drawing/2014/main" id="{450C0210-1D68-47E6-9E3E-DD393EEFECC0}"/>
+                <a16:creationId xmlns:a16="http://schemas.microsoft.com/office/drawing/2014/main" id="{427F6410-90E8-413F-A040-60ED371B40B1}"/>
               </a:ext>
             </a:extLst>
           </p:cNvPr>
@@ -3697,7 +3697,7 @@
     </p:spTree>
     <p:extLst>
       <p:ext uri="{BB962C8B-B14F-4D97-AF65-F5344CB8AC3E}">
-        <p14:creationId xmlns:p14="http://schemas.microsoft.com/office/powerpoint/2010/main" val="471610132"/>
+        <p14:creationId xmlns:p14="http://schemas.microsoft.com/office/powerpoint/2010/main" val="1312256303"/>
       </p:ext>
     </p:extLst>
   </p:cSld>
@@ -3728,7 +3728,7 @@
           <p:cNvPr id="46" name="">
             <a:extLst xmlns:a="http://schemas.openxmlformats.org/drawingml/2006/main">
               <a:ext uri="{FF2B5EF4-FFF2-40B4-BE49-F238E27FC236}">
-                <a16:creationId xmlns:a16="http://schemas.microsoft.com/office/drawing/2014/main" id="{BECA64BF-ABD5-4C68-8441-F8301E93E37C}"/>
+                <a16:creationId xmlns:a16="http://schemas.microsoft.com/office/drawing/2014/main" id="{B83E29CA-AC37-4AAB-8071-D2391E3552E5}"/>
               </a:ext>
             </a:extLst>
           </p:cNvPr>
@@ -3785,7 +3785,7 @@
           <p:cNvPr id="2" name="">
             <a:extLst xmlns:a="http://schemas.openxmlformats.org/drawingml/2006/main">
               <a:ext uri="{FF2B5EF4-FFF2-40B4-BE49-F238E27FC236}">
-                <a16:creationId xmlns:a16="http://schemas.microsoft.com/office/drawing/2014/main" id="{A41D88A1-E7C4-41AC-9148-3180E3445E04}"/>
+                <a16:creationId xmlns:a16="http://schemas.microsoft.com/office/drawing/2014/main" id="{01063799-33B1-479C-B188-64DB77661DFA}"/>
               </a:ext>
             </a:extLst>
           </p:cNvPr>
@@ -3842,7 +3842,7 @@
           <p:cNvPr id="3" name="">
             <a:extLst xmlns:a="http://schemas.openxmlformats.org/drawingml/2006/main">
               <a:ext uri="{FF2B5EF4-FFF2-40B4-BE49-F238E27FC236}">
-                <a16:creationId xmlns:a16="http://schemas.microsoft.com/office/drawing/2014/main" id="{2AE9CE7E-1583-41A4-86FD-EB635E8B02B0}"/>
+                <a16:creationId xmlns:a16="http://schemas.microsoft.com/office/drawing/2014/main" id="{FE569C1E-3334-422A-8312-E7FECA0C9DB9}"/>
               </a:ext>
             </a:extLst>
           </p:cNvPr>
@@ -3899,7 +3899,7 @@
           <p:cNvPr id="4" name="">
             <a:extLst xmlns:a="http://schemas.openxmlformats.org/drawingml/2006/main">
               <a:ext uri="{FF2B5EF4-FFF2-40B4-BE49-F238E27FC236}">
-                <a16:creationId xmlns:a16="http://schemas.microsoft.com/office/drawing/2014/main" id="{46131AA8-8B60-47B1-BF4A-83DD21FBE4C2}"/>
+                <a16:creationId xmlns:a16="http://schemas.microsoft.com/office/drawing/2014/main" id="{41D55A90-D85A-4D53-85F9-F2144C68F6DE}"/>
               </a:ext>
             </a:extLst>
           </p:cNvPr>
@@ -3930,7 +3930,7 @@
           <p:cNvPr id="5" name="">
             <a:extLst xmlns:a="http://schemas.openxmlformats.org/drawingml/2006/main">
               <a:ext uri="{FF2B5EF4-FFF2-40B4-BE49-F238E27FC236}">
-                <a16:creationId xmlns:a16="http://schemas.microsoft.com/office/drawing/2014/main" id="{6D03EE38-322D-4FEC-8DDE-D8738B738363}"/>
+                <a16:creationId xmlns:a16="http://schemas.microsoft.com/office/drawing/2014/main" id="{AA9BFEB0-121E-4AB3-92B2-EAB04703BFC3}"/>
               </a:ext>
             </a:extLst>
           </p:cNvPr>
@@ -3965,7 +3965,7 @@
           <p:cNvPr id="6" name="">
             <a:extLst xmlns:a="http://schemas.openxmlformats.org/drawingml/2006/main">
               <a:ext uri="{FF2B5EF4-FFF2-40B4-BE49-F238E27FC236}">
-                <a16:creationId xmlns:a16="http://schemas.microsoft.com/office/drawing/2014/main" id="{1D155FBF-BEC9-4E98-9BBB-297891844E0E}"/>
+                <a16:creationId xmlns:a16="http://schemas.microsoft.com/office/drawing/2014/main" id="{17C0965E-7713-46A1-87C8-9E4AA3CB9B9A}"/>
               </a:ext>
             </a:extLst>
           </p:cNvPr>
@@ -4029,7 +4029,7 @@
           <p:cNvPr id="7" name="">
             <a:extLst xmlns:a="http://schemas.openxmlformats.org/drawingml/2006/main">
               <a:ext uri="{FF2B5EF4-FFF2-40B4-BE49-F238E27FC236}">
-                <a16:creationId xmlns:a16="http://schemas.microsoft.com/office/drawing/2014/main" id="{D476A85E-929D-4404-B5AA-BE19C4F90FBC}"/>
+                <a16:creationId xmlns:a16="http://schemas.microsoft.com/office/drawing/2014/main" id="{9F2CA09E-2D79-48B0-8CFA-08657C37F54B}"/>
               </a:ext>
             </a:extLst>
           </p:cNvPr>
@@ -4086,7 +4086,7 @@
           <p:cNvPr id="8" name="">
             <a:extLst xmlns:a="http://schemas.openxmlformats.org/drawingml/2006/main">
               <a:ext uri="{FF2B5EF4-FFF2-40B4-BE49-F238E27FC236}">
-                <a16:creationId xmlns:a16="http://schemas.microsoft.com/office/drawing/2014/main" id="{BCAED28B-4FDA-4A81-A748-96ED6F343E02}"/>
+                <a16:creationId xmlns:a16="http://schemas.microsoft.com/office/drawing/2014/main" id="{1F344C95-517F-4471-8685-97C4C2F61BEE}"/>
               </a:ext>
             </a:extLst>
           </p:cNvPr>
@@ -4166,7 +4166,7 @@
           <p:cNvPr id="9" name="">
             <a:extLst xmlns:a="http://schemas.openxmlformats.org/drawingml/2006/main">
               <a:ext uri="{FF2B5EF4-FFF2-40B4-BE49-F238E27FC236}">
-                <a16:creationId xmlns:a16="http://schemas.microsoft.com/office/drawing/2014/main" id="{E6CFD08E-2193-4DA0-9263-A346918692CA}"/>
+                <a16:creationId xmlns:a16="http://schemas.microsoft.com/office/drawing/2014/main" id="{9F3C9F37-8783-4B04-93AB-ECA41B4802A6}"/>
               </a:ext>
             </a:extLst>
           </p:cNvPr>
@@ -4198,7 +4198,7 @@
           <p:cNvPr id="10" name="">
             <a:extLst xmlns:a="http://schemas.openxmlformats.org/drawingml/2006/main">
               <a:ext uri="{FF2B5EF4-FFF2-40B4-BE49-F238E27FC236}">
-                <a16:creationId xmlns:a16="http://schemas.microsoft.com/office/drawing/2014/main" id="{37043D7B-A363-41EE-8D35-67D8CFDC92A3}"/>
+                <a16:creationId xmlns:a16="http://schemas.microsoft.com/office/drawing/2014/main" id="{7E2666C5-6E67-4EA7-81AB-AC79B881D8FB}"/>
               </a:ext>
             </a:extLst>
           </p:cNvPr>
@@ -4233,7 +4233,7 @@
           <p:cNvPr id="11" name="">
             <a:extLst xmlns:a="http://schemas.openxmlformats.org/drawingml/2006/main">
               <a:ext uri="{FF2B5EF4-FFF2-40B4-BE49-F238E27FC236}">
-                <a16:creationId xmlns:a16="http://schemas.microsoft.com/office/drawing/2014/main" id="{7FC278AE-81A2-4247-B984-E97F59B27FBA}"/>
+                <a16:creationId xmlns:a16="http://schemas.microsoft.com/office/drawing/2014/main" id="{4C040304-0C54-4CA6-A9EA-7BF0DC74C529}"/>
               </a:ext>
             </a:extLst>
           </p:cNvPr>
@@ -4297,7 +4297,7 @@
           <p:cNvPr id="12" name="">
             <a:extLst xmlns:a="http://schemas.openxmlformats.org/drawingml/2006/main">
               <a:ext uri="{FF2B5EF4-FFF2-40B4-BE49-F238E27FC236}">
-                <a16:creationId xmlns:a16="http://schemas.microsoft.com/office/drawing/2014/main" id="{E8F9A1ED-A622-486A-94F7-8F28A6624D4E}"/>
+                <a16:creationId xmlns:a16="http://schemas.microsoft.com/office/drawing/2014/main" id="{4EB19CFA-E1E4-4D7F-A4D6-82949D0B2F3A}"/>
               </a:ext>
             </a:extLst>
           </p:cNvPr>
@@ -4354,7 +4354,7 @@
           <p:cNvPr id="13" name="">
             <a:extLst xmlns:a="http://schemas.openxmlformats.org/drawingml/2006/main">
               <a:ext uri="{FF2B5EF4-FFF2-40B4-BE49-F238E27FC236}">
-                <a16:creationId xmlns:a16="http://schemas.microsoft.com/office/drawing/2014/main" id="{A719A28B-5675-4853-847D-2BF4499B4C64}"/>
+                <a16:creationId xmlns:a16="http://schemas.microsoft.com/office/drawing/2014/main" id="{A7FDFCED-A9F1-4B23-BAEC-083D510E57B2}"/>
               </a:ext>
             </a:extLst>
           </p:cNvPr>
@@ -4434,7 +4434,7 @@
           <p:cNvPr id="14" name="">
             <a:extLst xmlns:a="http://schemas.openxmlformats.org/drawingml/2006/main">
               <a:ext uri="{FF2B5EF4-FFF2-40B4-BE49-F238E27FC236}">
-                <a16:creationId xmlns:a16="http://schemas.microsoft.com/office/drawing/2014/main" id="{0D1B8002-C62B-4022-82F9-B105C8D69782}"/>
+                <a16:creationId xmlns:a16="http://schemas.microsoft.com/office/drawing/2014/main" id="{369172BE-4604-4BAC-AFF6-8CCDC7E93025}"/>
               </a:ext>
             </a:extLst>
           </p:cNvPr>
@@ -4466,7 +4466,7 @@
           <p:cNvPr id="15" name="">
             <a:extLst xmlns:a="http://schemas.openxmlformats.org/drawingml/2006/main">
               <a:ext uri="{FF2B5EF4-FFF2-40B4-BE49-F238E27FC236}">
-                <a16:creationId xmlns:a16="http://schemas.microsoft.com/office/drawing/2014/main" id="{C5CD20E7-EBD3-4D00-BC27-763BFB891F41}"/>
+                <a16:creationId xmlns:a16="http://schemas.microsoft.com/office/drawing/2014/main" id="{C556895A-997C-4AD7-BB51-07200B6C1718}"/>
               </a:ext>
             </a:extLst>
           </p:cNvPr>
@@ -4501,7 +4501,7 @@
           <p:cNvPr id="16" name="">
             <a:extLst xmlns:a="http://schemas.openxmlformats.org/drawingml/2006/main">
               <a:ext uri="{FF2B5EF4-FFF2-40B4-BE49-F238E27FC236}">
-                <a16:creationId xmlns:a16="http://schemas.microsoft.com/office/drawing/2014/main" id="{3CC042A8-F67D-4439-BDAB-8FD34326EDBC}"/>
+                <a16:creationId xmlns:a16="http://schemas.microsoft.com/office/drawing/2014/main" id="{3FE2C693-2F83-41CC-A2B0-26CD7ED2B22E}"/>
               </a:ext>
             </a:extLst>
           </p:cNvPr>
@@ -4565,7 +4565,7 @@
           <p:cNvPr id="17" name="">
             <a:extLst xmlns:a="http://schemas.openxmlformats.org/drawingml/2006/main">
               <a:ext uri="{FF2B5EF4-FFF2-40B4-BE49-F238E27FC236}">
-                <a16:creationId xmlns:a16="http://schemas.microsoft.com/office/drawing/2014/main" id="{3EAFF1F9-BDCB-4DFF-95D1-1A5035AC5388}"/>
+                <a16:creationId xmlns:a16="http://schemas.microsoft.com/office/drawing/2014/main" id="{88CB3BCE-2625-4FDC-9F17-0F0BE6EC3696}"/>
               </a:ext>
             </a:extLst>
           </p:cNvPr>
@@ -4622,7 +4622,7 @@
           <p:cNvPr id="18" name="">
             <a:extLst xmlns:a="http://schemas.openxmlformats.org/drawingml/2006/main">
               <a:ext uri="{FF2B5EF4-FFF2-40B4-BE49-F238E27FC236}">
-                <a16:creationId xmlns:a16="http://schemas.microsoft.com/office/drawing/2014/main" id="{E8F822EB-4F92-472B-8373-8098266649D9}"/>
+                <a16:creationId xmlns:a16="http://schemas.microsoft.com/office/drawing/2014/main" id="{A05A2F21-8533-45C8-96E6-663413B91A89}"/>
               </a:ext>
             </a:extLst>
           </p:cNvPr>
@@ -4702,7 +4702,7 @@
           <p:cNvPr id="19" name="">
             <a:extLst xmlns:a="http://schemas.openxmlformats.org/drawingml/2006/main">
               <a:ext uri="{FF2B5EF4-FFF2-40B4-BE49-F238E27FC236}">
-                <a16:creationId xmlns:a16="http://schemas.microsoft.com/office/drawing/2014/main" id="{1C73E80D-8554-4AC3-A82F-5DF4DB0F87A4}"/>
+                <a16:creationId xmlns:a16="http://schemas.microsoft.com/office/drawing/2014/main" id="{8A83641B-7CBF-4B3A-A93D-C58395EA1B60}"/>
               </a:ext>
             </a:extLst>
           </p:cNvPr>
@@ -4734,7 +4734,7 @@
           <p:cNvPr id="20" name="">
             <a:extLst xmlns:a="http://schemas.openxmlformats.org/drawingml/2006/main">
               <a:ext uri="{FF2B5EF4-FFF2-40B4-BE49-F238E27FC236}">
-                <a16:creationId xmlns:a16="http://schemas.microsoft.com/office/drawing/2014/main" id="{A256ECD7-EF39-43A9-AE8B-F3D370D3BCDA}"/>
+                <a16:creationId xmlns:a16="http://schemas.microsoft.com/office/drawing/2014/main" id="{0E641222-5C28-4F10-8A9A-C79C8B26461F}"/>
               </a:ext>
             </a:extLst>
           </p:cNvPr>
@@ -4769,7 +4769,7 @@
           <p:cNvPr id="21" name="">
             <a:extLst xmlns:a="http://schemas.openxmlformats.org/drawingml/2006/main">
               <a:ext uri="{FF2B5EF4-FFF2-40B4-BE49-F238E27FC236}">
-                <a16:creationId xmlns:a16="http://schemas.microsoft.com/office/drawing/2014/main" id="{9A3353D5-DC45-47ED-AD90-9D562E0E3E8C}"/>
+                <a16:creationId xmlns:a16="http://schemas.microsoft.com/office/drawing/2014/main" id="{658C1D05-AC19-426C-AF18-8FA6845F2EE5}"/>
               </a:ext>
             </a:extLst>
           </p:cNvPr>
@@ -4833,7 +4833,7 @@
           <p:cNvPr id="22" name="">
             <a:extLst xmlns:a="http://schemas.openxmlformats.org/drawingml/2006/main">
               <a:ext uri="{FF2B5EF4-FFF2-40B4-BE49-F238E27FC236}">
-                <a16:creationId xmlns:a16="http://schemas.microsoft.com/office/drawing/2014/main" id="{E445A0D3-BC54-4F3E-BB17-F398A4B3C683}"/>
+                <a16:creationId xmlns:a16="http://schemas.microsoft.com/office/drawing/2014/main" id="{0AEC3B4C-E532-488D-A8B6-3F982D8DBEE3}"/>
               </a:ext>
             </a:extLst>
           </p:cNvPr>
@@ -4890,7 +4890,7 @@
           <p:cNvPr id="23" name="">
             <a:extLst xmlns:a="http://schemas.openxmlformats.org/drawingml/2006/main">
               <a:ext uri="{FF2B5EF4-FFF2-40B4-BE49-F238E27FC236}">
-                <a16:creationId xmlns:a16="http://schemas.microsoft.com/office/drawing/2014/main" id="{B8FBC0DB-0173-48BF-B16B-CFBA12F933DD}"/>
+                <a16:creationId xmlns:a16="http://schemas.microsoft.com/office/drawing/2014/main" id="{B62B967B-EF4D-4172-8534-61CA7C847B6C}"/>
               </a:ext>
             </a:extLst>
           </p:cNvPr>
@@ -4970,7 +4970,7 @@
           <p:cNvPr id="24" name="">
             <a:extLst xmlns:a="http://schemas.openxmlformats.org/drawingml/2006/main">
               <a:ext uri="{FF2B5EF4-FFF2-40B4-BE49-F238E27FC236}">
-                <a16:creationId xmlns:a16="http://schemas.microsoft.com/office/drawing/2014/main" id="{BC68115A-67B3-4080-B470-6318FDE31F52}"/>
+                <a16:creationId xmlns:a16="http://schemas.microsoft.com/office/drawing/2014/main" id="{56E8BBDF-DFD7-4D13-B9BF-8F2BB56BF258}"/>
               </a:ext>
             </a:extLst>
           </p:cNvPr>
@@ -5002,7 +5002,7 @@
           <p:cNvPr id="25" name="">
             <a:extLst xmlns:a="http://schemas.openxmlformats.org/drawingml/2006/main">
               <a:ext uri="{FF2B5EF4-FFF2-40B4-BE49-F238E27FC236}">
-                <a16:creationId xmlns:a16="http://schemas.microsoft.com/office/drawing/2014/main" id="{17795A6F-5319-476A-B5BF-32CBB53DDE24}"/>
+                <a16:creationId xmlns:a16="http://schemas.microsoft.com/office/drawing/2014/main" id="{20263D52-4C92-4472-8B1A-DF4C8E933A92}"/>
               </a:ext>
             </a:extLst>
           </p:cNvPr>
@@ -5037,7 +5037,7 @@
           <p:cNvPr id="26" name="">
             <a:extLst xmlns:a="http://schemas.openxmlformats.org/drawingml/2006/main">
               <a:ext uri="{FF2B5EF4-FFF2-40B4-BE49-F238E27FC236}">
-                <a16:creationId xmlns:a16="http://schemas.microsoft.com/office/drawing/2014/main" id="{077FD1E1-7ED3-460B-963A-E6D959723C87}"/>
+                <a16:creationId xmlns:a16="http://schemas.microsoft.com/office/drawing/2014/main" id="{91D84956-F645-4EF3-A917-23D65104A76F}"/>
               </a:ext>
             </a:extLst>
           </p:cNvPr>
@@ -5101,7 +5101,7 @@
           <p:cNvPr id="27" name="">
             <a:extLst xmlns:a="http://schemas.openxmlformats.org/drawingml/2006/main">
               <a:ext uri="{FF2B5EF4-FFF2-40B4-BE49-F238E27FC236}">
-                <a16:creationId xmlns:a16="http://schemas.microsoft.com/office/drawing/2014/main" id="{655A5341-3335-43CB-9E6D-FE2A0444486B}"/>
+                <a16:creationId xmlns:a16="http://schemas.microsoft.com/office/drawing/2014/main" id="{BA61DDDC-D231-4651-8DE2-1F56ED5B5BBB}"/>
               </a:ext>
             </a:extLst>
           </p:cNvPr>
@@ -5158,7 +5158,7 @@
           <p:cNvPr id="28" name="">
             <a:extLst xmlns:a="http://schemas.openxmlformats.org/drawingml/2006/main">
               <a:ext uri="{FF2B5EF4-FFF2-40B4-BE49-F238E27FC236}">
-                <a16:creationId xmlns:a16="http://schemas.microsoft.com/office/drawing/2014/main" id="{9057EF70-CBF6-4A9D-A2EC-5CDB8E2FF64E}"/>
+                <a16:creationId xmlns:a16="http://schemas.microsoft.com/office/drawing/2014/main" id="{15E25E55-BE3B-4D4A-85B3-E00161343FED}"/>
               </a:ext>
             </a:extLst>
           </p:cNvPr>
@@ -5238,7 +5238,7 @@
           <p:cNvPr id="29" name="">
             <a:extLst xmlns:a="http://schemas.openxmlformats.org/drawingml/2006/main">
               <a:ext uri="{FF2B5EF4-FFF2-40B4-BE49-F238E27FC236}">
-                <a16:creationId xmlns:a16="http://schemas.microsoft.com/office/drawing/2014/main" id="{4A171EF8-1518-4424-BFFE-B378FDAD8A31}"/>
+                <a16:creationId xmlns:a16="http://schemas.microsoft.com/office/drawing/2014/main" id="{C38B3561-E117-4CB3-BBEB-60D03F03CF7E}"/>
               </a:ext>
             </a:extLst>
           </p:cNvPr>
@@ -5295,7 +5295,7 @@
           <p:cNvPr id="30" name="">
             <a:extLst xmlns:a="http://schemas.openxmlformats.org/drawingml/2006/main">
               <a:ext uri="{FF2B5EF4-FFF2-40B4-BE49-F238E27FC236}">
-                <a16:creationId xmlns:a16="http://schemas.microsoft.com/office/drawing/2014/main" id="{D0B52E2F-B6AB-44A9-AD06-8BE21C931AC7}"/>
+                <a16:creationId xmlns:a16="http://schemas.microsoft.com/office/drawing/2014/main" id="{EB69352E-A44E-4CA8-AAA6-98470D5E993D}"/>
               </a:ext>
             </a:extLst>
           </p:cNvPr>
@@ -5330,7 +5330,7 @@
           <p:cNvPr id="31" name="">
             <a:extLst xmlns:a="http://schemas.openxmlformats.org/drawingml/2006/main">
               <a:ext uri="{FF2B5EF4-FFF2-40B4-BE49-F238E27FC236}">
-                <a16:creationId xmlns:a16="http://schemas.microsoft.com/office/drawing/2014/main" id="{9A4CF0E7-2A06-4519-BF8F-9512B5E448EB}"/>
+                <a16:creationId xmlns:a16="http://schemas.microsoft.com/office/drawing/2014/main" id="{0CEE3442-E3CC-42B4-BFEF-E1D0241BAC96}"/>
               </a:ext>
             </a:extLst>
           </p:cNvPr>
@@ -5387,7 +5387,7 @@
           <p:cNvPr id="32" name="">
             <a:extLst xmlns:a="http://schemas.openxmlformats.org/drawingml/2006/main">
               <a:ext uri="{FF2B5EF4-FFF2-40B4-BE49-F238E27FC236}">
-                <a16:creationId xmlns:a16="http://schemas.microsoft.com/office/drawing/2014/main" id="{57DB7137-D438-4542-B75E-61755EAD4F51}"/>
+                <a16:creationId xmlns:a16="http://schemas.microsoft.com/office/drawing/2014/main" id="{A9A8BEAC-5E52-43C7-9793-2B71978B2DC8}"/>
               </a:ext>
             </a:extLst>
           </p:cNvPr>
@@ -5490,7 +5490,7 @@
           <p:cNvPr id="33" name="">
             <a:extLst xmlns:a="http://schemas.openxmlformats.org/drawingml/2006/main">
               <a:ext uri="{FF2B5EF4-FFF2-40B4-BE49-F238E27FC236}">
-                <a16:creationId xmlns:a16="http://schemas.microsoft.com/office/drawing/2014/main" id="{10572BFA-2A26-4571-ADE1-43E82EAF3AAA}"/>
+                <a16:creationId xmlns:a16="http://schemas.microsoft.com/office/drawing/2014/main" id="{27996679-A74B-45F4-97AD-5C51E21D1C4A}"/>
               </a:ext>
             </a:extLst>
           </p:cNvPr>
@@ -5554,7 +5554,7 @@
           <p:cNvPr id="34" name="">
             <a:extLst xmlns:a="http://schemas.openxmlformats.org/drawingml/2006/main">
               <a:ext uri="{FF2B5EF4-FFF2-40B4-BE49-F238E27FC236}">
-                <a16:creationId xmlns:a16="http://schemas.microsoft.com/office/drawing/2014/main" id="{03DA5A23-8043-4DD8-828B-44F7A6DF8DC0}"/>
+                <a16:creationId xmlns:a16="http://schemas.microsoft.com/office/drawing/2014/main" id="{C5C2C59E-C789-449F-9317-002C7F01F25F}"/>
               </a:ext>
             </a:extLst>
           </p:cNvPr>
@@ -5611,7 +5611,7 @@
           <p:cNvPr id="35" name="">
             <a:extLst xmlns:a="http://schemas.openxmlformats.org/drawingml/2006/main">
               <a:ext uri="{FF2B5EF4-FFF2-40B4-BE49-F238E27FC236}">
-                <a16:creationId xmlns:a16="http://schemas.microsoft.com/office/drawing/2014/main" id="{190A84B7-1556-44C2-9D58-B992848C65E5}"/>
+                <a16:creationId xmlns:a16="http://schemas.microsoft.com/office/drawing/2014/main" id="{973742AD-7BE0-455E-905B-C4399F992974}"/>
               </a:ext>
             </a:extLst>
           </p:cNvPr>
@@ -5646,7 +5646,7 @@
           <p:cNvPr id="36" name="">
             <a:extLst xmlns:a="http://schemas.openxmlformats.org/drawingml/2006/main">
               <a:ext uri="{FF2B5EF4-FFF2-40B4-BE49-F238E27FC236}">
-                <a16:creationId xmlns:a16="http://schemas.microsoft.com/office/drawing/2014/main" id="{041F6ECE-05D9-4929-95D9-ACC61CA5A928}"/>
+                <a16:creationId xmlns:a16="http://schemas.microsoft.com/office/drawing/2014/main" id="{3667DC94-DCE7-4AAB-9742-AD141F726E63}"/>
               </a:ext>
             </a:extLst>
           </p:cNvPr>
@@ -5703,7 +5703,7 @@
           <p:cNvPr id="37" name="">
             <a:extLst xmlns:a="http://schemas.openxmlformats.org/drawingml/2006/main">
               <a:ext uri="{FF2B5EF4-FFF2-40B4-BE49-F238E27FC236}">
-                <a16:creationId xmlns:a16="http://schemas.microsoft.com/office/drawing/2014/main" id="{C76D600A-CCC1-46BF-9605-9172DCE225F4}"/>
+                <a16:creationId xmlns:a16="http://schemas.microsoft.com/office/drawing/2014/main" id="{F98EBCCA-349F-4806-8A97-A02E1EF49948}"/>
               </a:ext>
             </a:extLst>
           </p:cNvPr>
@@ -5738,7 +5738,7 @@
           <p:cNvPr id="38" name="">
             <a:extLst xmlns:a="http://schemas.openxmlformats.org/drawingml/2006/main">
               <a:ext uri="{FF2B5EF4-FFF2-40B4-BE49-F238E27FC236}">
-                <a16:creationId xmlns:a16="http://schemas.microsoft.com/office/drawing/2014/main" id="{4F6E1B76-46B1-4A50-B613-2D726236F63C}"/>
+                <a16:creationId xmlns:a16="http://schemas.microsoft.com/office/drawing/2014/main" id="{1BF72F76-832F-487C-97F0-789425F47FF8}"/>
               </a:ext>
             </a:extLst>
           </p:cNvPr>
@@ -5795,7 +5795,7 @@
           <p:cNvPr id="39" name="">
             <a:extLst xmlns:a="http://schemas.openxmlformats.org/drawingml/2006/main">
               <a:ext uri="{FF2B5EF4-FFF2-40B4-BE49-F238E27FC236}">
-                <a16:creationId xmlns:a16="http://schemas.microsoft.com/office/drawing/2014/main" id="{26181900-2E01-49A4-BC3C-F5E1A83C4CF4}"/>
+                <a16:creationId xmlns:a16="http://schemas.microsoft.com/office/drawing/2014/main" id="{4BA8AA67-124A-4B4B-AC91-AA0BB9D2C586}"/>
               </a:ext>
             </a:extLst>
           </p:cNvPr>
@@ -5852,7 +5852,7 @@
           <p:cNvPr id="40" name="">
             <a:extLst xmlns:a="http://schemas.openxmlformats.org/drawingml/2006/main">
               <a:ext uri="{FF2B5EF4-FFF2-40B4-BE49-F238E27FC236}">
-                <a16:creationId xmlns:a16="http://schemas.microsoft.com/office/drawing/2014/main" id="{5FDE8118-6F1D-401A-9F7E-6BF601FAB09E}"/>
+                <a16:creationId xmlns:a16="http://schemas.microsoft.com/office/drawing/2014/main" id="{EEC6B636-24E2-4A96-B6F1-B0BEAB6AC1A0}"/>
               </a:ext>
             </a:extLst>
           </p:cNvPr>
@@ -5887,7 +5887,7 @@
           <p:cNvPr id="41" name="">
             <a:extLst xmlns:a="http://schemas.openxmlformats.org/drawingml/2006/main">
               <a:ext uri="{FF2B5EF4-FFF2-40B4-BE49-F238E27FC236}">
-                <a16:creationId xmlns:a16="http://schemas.microsoft.com/office/drawing/2014/main" id="{95785793-FC7D-4ADE-BB2F-7D5DA5C87FC5}"/>
+                <a16:creationId xmlns:a16="http://schemas.microsoft.com/office/drawing/2014/main" id="{41FCCD93-9945-4910-9DAE-D18C129E9BB1}"/>
               </a:ext>
             </a:extLst>
           </p:cNvPr>
@@ -5944,7 +5944,7 @@
           <p:cNvPr id="42" name="">
             <a:extLst xmlns:a="http://schemas.openxmlformats.org/drawingml/2006/main">
               <a:ext uri="{FF2B5EF4-FFF2-40B4-BE49-F238E27FC236}">
-                <a16:creationId xmlns:a16="http://schemas.microsoft.com/office/drawing/2014/main" id="{EDD8834C-D3C5-48E4-B329-8D2EED7E0858}"/>
+                <a16:creationId xmlns:a16="http://schemas.microsoft.com/office/drawing/2014/main" id="{7E367BE5-0723-4ED0-8B10-47524621FA43}"/>
               </a:ext>
             </a:extLst>
           </p:cNvPr>
@@ -6001,7 +6001,7 @@
           <p:cNvPr id="43" name="">
             <a:extLst xmlns:a="http://schemas.openxmlformats.org/drawingml/2006/main">
               <a:ext uri="{FF2B5EF4-FFF2-40B4-BE49-F238E27FC236}">
-                <a16:creationId xmlns:a16="http://schemas.microsoft.com/office/drawing/2014/main" id="{319B5AF1-7243-4791-99AF-93792E82F6B8}"/>
+                <a16:creationId xmlns:a16="http://schemas.microsoft.com/office/drawing/2014/main" id="{8F6DC59A-394F-4419-89C9-436E21EE10E0}"/>
               </a:ext>
             </a:extLst>
           </p:cNvPr>
@@ -6058,7 +6058,7 @@
           <p:cNvPr id="44" name="">
             <a:extLst xmlns:a="http://schemas.openxmlformats.org/drawingml/2006/main">
               <a:ext uri="{FF2B5EF4-FFF2-40B4-BE49-F238E27FC236}">
-                <a16:creationId xmlns:a16="http://schemas.microsoft.com/office/drawing/2014/main" id="{181B7454-5A75-4D1A-821A-CAE18502508C}"/>
+                <a16:creationId xmlns:a16="http://schemas.microsoft.com/office/drawing/2014/main" id="{F9CC139D-58DC-4FFE-8A1A-5E49607A4469}"/>
               </a:ext>
             </a:extLst>
           </p:cNvPr>
@@ -6115,7 +6115,7 @@
           <p:cNvPr id="45" name="">
             <a:extLst xmlns:a="http://schemas.openxmlformats.org/drawingml/2006/main">
               <a:ext uri="{FF2B5EF4-FFF2-40B4-BE49-F238E27FC236}">
-                <a16:creationId xmlns:a16="http://schemas.microsoft.com/office/drawing/2014/main" id="{35B6F12A-A6DF-49B3-A033-96113F8B3CCC}"/>
+                <a16:creationId xmlns:a16="http://schemas.microsoft.com/office/drawing/2014/main" id="{40B2CABF-13B2-4CE1-8366-F1C6B3F2D7A6}"/>
               </a:ext>
             </a:extLst>
           </p:cNvPr>
@@ -6170,7 +6170,7 @@
     </p:spTree>
     <p:extLst>
       <p:ext uri="{BB962C8B-B14F-4D97-AF65-F5344CB8AC3E}">
-        <p14:creationId xmlns:p14="http://schemas.microsoft.com/office/powerpoint/2010/main" val="784806105"/>
+        <p14:creationId xmlns:p14="http://schemas.microsoft.com/office/powerpoint/2010/main" val="1773435177"/>
       </p:ext>
     </p:extLst>
   </p:cSld>
@@ -6201,7 +6201,7 @@
           <p:cNvPr id="32" name="">
             <a:extLst xmlns:a="http://schemas.openxmlformats.org/drawingml/2006/main">
               <a:ext uri="{FF2B5EF4-FFF2-40B4-BE49-F238E27FC236}">
-                <a16:creationId xmlns:a16="http://schemas.microsoft.com/office/drawing/2014/main" id="{8F592570-DA95-4DA5-955E-307956D5C3E4}"/>
+                <a16:creationId xmlns:a16="http://schemas.microsoft.com/office/drawing/2014/main" id="{A8AA4AA3-A292-492C-811F-C028C73F23D2}"/>
               </a:ext>
             </a:extLst>
           </p:cNvPr>
@@ -6258,7 +6258,7 @@
           <p:cNvPr id="2" name="">
             <a:extLst xmlns:a="http://schemas.openxmlformats.org/drawingml/2006/main">
               <a:ext uri="{FF2B5EF4-FFF2-40B4-BE49-F238E27FC236}">
-                <a16:creationId xmlns:a16="http://schemas.microsoft.com/office/drawing/2014/main" id="{A4A2E198-46A0-4625-A42D-47620626A713}"/>
+                <a16:creationId xmlns:a16="http://schemas.microsoft.com/office/drawing/2014/main" id="{D9D3DE90-79AB-46CB-AFC6-46E198BA602D}"/>
               </a:ext>
             </a:extLst>
           </p:cNvPr>
@@ -6315,7 +6315,7 @@
           <p:cNvPr id="3" name="">
             <a:extLst xmlns:a="http://schemas.openxmlformats.org/drawingml/2006/main">
               <a:ext uri="{FF2B5EF4-FFF2-40B4-BE49-F238E27FC236}">
-                <a16:creationId xmlns:a16="http://schemas.microsoft.com/office/drawing/2014/main" id="{FD6667D6-C822-462F-90EB-6FDA3B734F3B}"/>
+                <a16:creationId xmlns:a16="http://schemas.microsoft.com/office/drawing/2014/main" id="{94A41282-D1A9-4CDF-BFCE-08D93B4D7E9C}"/>
               </a:ext>
             </a:extLst>
           </p:cNvPr>
@@ -6372,7 +6372,7 @@
           <p:cNvPr id="4" name="">
             <a:extLst xmlns:a="http://schemas.openxmlformats.org/drawingml/2006/main">
               <a:ext uri="{FF2B5EF4-FFF2-40B4-BE49-F238E27FC236}">
-                <a16:creationId xmlns:a16="http://schemas.microsoft.com/office/drawing/2014/main" id="{386E53CB-8EAF-47F3-92D8-55AF617E3333}"/>
+                <a16:creationId xmlns:a16="http://schemas.microsoft.com/office/drawing/2014/main" id="{A19267D8-0088-4EEE-9C52-6E1C7694AE2F}"/>
               </a:ext>
             </a:extLst>
           </p:cNvPr>
@@ -6403,7 +6403,7 @@
           <p:cNvPr id="5" name="">
             <a:extLst xmlns:a="http://schemas.openxmlformats.org/drawingml/2006/main">
               <a:ext uri="{FF2B5EF4-FFF2-40B4-BE49-F238E27FC236}">
-                <a16:creationId xmlns:a16="http://schemas.microsoft.com/office/drawing/2014/main" id="{08F5A809-E04E-4B29-BF6C-775F5E352B6C}"/>
+                <a16:creationId xmlns:a16="http://schemas.microsoft.com/office/drawing/2014/main" id="{52826983-A69B-4619-AAAA-31E0AD7B2975}"/>
               </a:ext>
             </a:extLst>
           </p:cNvPr>
@@ -6438,7 +6438,7 @@
           <p:cNvPr id="6" name="">
             <a:extLst xmlns:a="http://schemas.openxmlformats.org/drawingml/2006/main">
               <a:ext uri="{FF2B5EF4-FFF2-40B4-BE49-F238E27FC236}">
-                <a16:creationId xmlns:a16="http://schemas.microsoft.com/office/drawing/2014/main" id="{55DD62BC-90C6-4285-96FD-FFCB14BDE69D}"/>
+                <a16:creationId xmlns:a16="http://schemas.microsoft.com/office/drawing/2014/main" id="{E370F510-46A0-4CAF-BE0F-2EF7B565ED3A}"/>
               </a:ext>
             </a:extLst>
           </p:cNvPr>
@@ -6502,7 +6502,7 @@
           <p:cNvPr id="7" name="">
             <a:extLst xmlns:a="http://schemas.openxmlformats.org/drawingml/2006/main">
               <a:ext uri="{FF2B5EF4-FFF2-40B4-BE49-F238E27FC236}">
-                <a16:creationId xmlns:a16="http://schemas.microsoft.com/office/drawing/2014/main" id="{F3C4BBA8-9D34-4356-BF9D-6178D7E3FA5E}"/>
+                <a16:creationId xmlns:a16="http://schemas.microsoft.com/office/drawing/2014/main" id="{51551537-F4EF-4321-9060-DF83EC99784F}"/>
               </a:ext>
             </a:extLst>
           </p:cNvPr>
@@ -6559,7 +6559,7 @@
           <p:cNvPr id="8" name="">
             <a:extLst xmlns:a="http://schemas.openxmlformats.org/drawingml/2006/main">
               <a:ext uri="{FF2B5EF4-FFF2-40B4-BE49-F238E27FC236}">
-                <a16:creationId xmlns:a16="http://schemas.microsoft.com/office/drawing/2014/main" id="{07A099F2-4F65-4401-A162-8D868E2569CC}"/>
+                <a16:creationId xmlns:a16="http://schemas.microsoft.com/office/drawing/2014/main" id="{85760E5C-D703-40BF-B939-5243A0A0AB60}"/>
               </a:ext>
             </a:extLst>
           </p:cNvPr>
@@ -6662,7 +6662,7 @@
           <p:cNvPr id="9" name="">
             <a:extLst xmlns:a="http://schemas.openxmlformats.org/drawingml/2006/main">
               <a:ext uri="{FF2B5EF4-FFF2-40B4-BE49-F238E27FC236}">
-                <a16:creationId xmlns:a16="http://schemas.microsoft.com/office/drawing/2014/main" id="{96B0F1F6-8C20-44A0-964F-93027A2C456B}"/>
+                <a16:creationId xmlns:a16="http://schemas.microsoft.com/office/drawing/2014/main" id="{A0D0FEB1-66B1-4731-B9A9-A7A6F8B44EF9}"/>
               </a:ext>
             </a:extLst>
           </p:cNvPr>
@@ -6697,7 +6697,7 @@
           <p:cNvPr id="10" name="">
             <a:extLst xmlns:a="http://schemas.openxmlformats.org/drawingml/2006/main">
               <a:ext uri="{FF2B5EF4-FFF2-40B4-BE49-F238E27FC236}">
-                <a16:creationId xmlns:a16="http://schemas.microsoft.com/office/drawing/2014/main" id="{509E3170-C9F1-49B3-B747-67BF6229F745}"/>
+                <a16:creationId xmlns:a16="http://schemas.microsoft.com/office/drawing/2014/main" id="{0802A94E-BED5-4A44-9924-6F078FEAE752}"/>
               </a:ext>
             </a:extLst>
           </p:cNvPr>
@@ -6761,7 +6761,7 @@
           <p:cNvPr id="11" name="">
             <a:extLst xmlns:a="http://schemas.openxmlformats.org/drawingml/2006/main">
               <a:ext uri="{FF2B5EF4-FFF2-40B4-BE49-F238E27FC236}">
-                <a16:creationId xmlns:a16="http://schemas.microsoft.com/office/drawing/2014/main" id="{DD5A962D-3B68-4F26-8E08-63F1177A37BD}"/>
+                <a16:creationId xmlns:a16="http://schemas.microsoft.com/office/drawing/2014/main" id="{308B9667-21D6-4931-B7C3-16005ACEABA7}"/>
               </a:ext>
             </a:extLst>
           </p:cNvPr>
@@ -6818,7 +6818,7 @@
           <p:cNvPr id="12" name="">
             <a:extLst xmlns:a="http://schemas.openxmlformats.org/drawingml/2006/main">
               <a:ext uri="{FF2B5EF4-FFF2-40B4-BE49-F238E27FC236}">
-                <a16:creationId xmlns:a16="http://schemas.microsoft.com/office/drawing/2014/main" id="{4C3DA508-1EE3-4E60-8433-EC30BDD2294B}"/>
+                <a16:creationId xmlns:a16="http://schemas.microsoft.com/office/drawing/2014/main" id="{C61B6D5F-145D-47C6-84E8-5F698FB00C7D}"/>
               </a:ext>
             </a:extLst>
           </p:cNvPr>
@@ -6921,7 +6921,7 @@
           <p:cNvPr id="13" name="">
             <a:extLst xmlns:a="http://schemas.openxmlformats.org/drawingml/2006/main">
               <a:ext uri="{FF2B5EF4-FFF2-40B4-BE49-F238E27FC236}">
-                <a16:creationId xmlns:a16="http://schemas.microsoft.com/office/drawing/2014/main" id="{D3DD97C5-4D90-4761-83EC-96889298C116}"/>
+                <a16:creationId xmlns:a16="http://schemas.microsoft.com/office/drawing/2014/main" id="{D67074C8-BC84-4D62-9AFB-C852456FC28C}"/>
               </a:ext>
             </a:extLst>
           </p:cNvPr>
@@ -6978,7 +6978,7 @@
           <p:cNvPr id="14" name="">
             <a:extLst xmlns:a="http://schemas.openxmlformats.org/drawingml/2006/main">
               <a:ext uri="{FF2B5EF4-FFF2-40B4-BE49-F238E27FC236}">
-                <a16:creationId xmlns:a16="http://schemas.microsoft.com/office/drawing/2014/main" id="{A32FBCEB-99F5-4005-A693-395F0B0C7999}"/>
+                <a16:creationId xmlns:a16="http://schemas.microsoft.com/office/drawing/2014/main" id="{2437CBF2-8A68-4043-9532-996422742ECA}"/>
               </a:ext>
             </a:extLst>
           </p:cNvPr>
@@ -7013,7 +7013,7 @@
           <p:cNvPr id="15" name="">
             <a:extLst xmlns:a="http://schemas.openxmlformats.org/drawingml/2006/main">
               <a:ext uri="{FF2B5EF4-FFF2-40B4-BE49-F238E27FC236}">
-                <a16:creationId xmlns:a16="http://schemas.microsoft.com/office/drawing/2014/main" id="{18EF5F3A-8240-412E-899E-EE988265C6A2}"/>
+                <a16:creationId xmlns:a16="http://schemas.microsoft.com/office/drawing/2014/main" id="{296898CC-8370-47BE-AEF2-7AE791337A35}"/>
               </a:ext>
             </a:extLst>
           </p:cNvPr>
@@ -7070,7 +7070,7 @@
           <p:cNvPr id="16" name="">
             <a:extLst xmlns:a="http://schemas.openxmlformats.org/drawingml/2006/main">
               <a:ext uri="{FF2B5EF4-FFF2-40B4-BE49-F238E27FC236}">
-                <a16:creationId xmlns:a16="http://schemas.microsoft.com/office/drawing/2014/main" id="{1B28C39E-672C-41EF-98FA-62FE544EF7D7}"/>
+                <a16:creationId xmlns:a16="http://schemas.microsoft.com/office/drawing/2014/main" id="{8807F973-7735-41C1-8A45-9EA6B1AB6FF0}"/>
               </a:ext>
             </a:extLst>
           </p:cNvPr>
@@ -7127,7 +7127,7 @@
           <p:cNvPr id="17" name="">
             <a:extLst xmlns:a="http://schemas.openxmlformats.org/drawingml/2006/main">
               <a:ext uri="{FF2B5EF4-FFF2-40B4-BE49-F238E27FC236}">
-                <a16:creationId xmlns:a16="http://schemas.microsoft.com/office/drawing/2014/main" id="{E482A920-2AB3-45C1-B94E-52DF62849946}"/>
+                <a16:creationId xmlns:a16="http://schemas.microsoft.com/office/drawing/2014/main" id="{49753C23-0E32-4B55-8EBE-892A59AEFC4C}"/>
               </a:ext>
             </a:extLst>
           </p:cNvPr>
@@ -7162,7 +7162,7 @@
           <p:cNvPr id="18" name="">
             <a:extLst xmlns:a="http://schemas.openxmlformats.org/drawingml/2006/main">
               <a:ext uri="{FF2B5EF4-FFF2-40B4-BE49-F238E27FC236}">
-                <a16:creationId xmlns:a16="http://schemas.microsoft.com/office/drawing/2014/main" id="{D9388B0D-EE3D-4FF9-AB7C-311614A41CFE}"/>
+                <a16:creationId xmlns:a16="http://schemas.microsoft.com/office/drawing/2014/main" id="{7DF5B126-B4F3-447C-AC77-98ECD6175B2D}"/>
               </a:ext>
             </a:extLst>
           </p:cNvPr>
@@ -7219,7 +7219,7 @@
           <p:cNvPr id="19" name="">
             <a:extLst xmlns:a="http://schemas.openxmlformats.org/drawingml/2006/main">
               <a:ext uri="{FF2B5EF4-FFF2-40B4-BE49-F238E27FC236}">
-                <a16:creationId xmlns:a16="http://schemas.microsoft.com/office/drawing/2014/main" id="{E51D4998-7B44-4BF7-A2BD-7291F8E90B99}"/>
+                <a16:creationId xmlns:a16="http://schemas.microsoft.com/office/drawing/2014/main" id="{70E2E7BA-3022-4ABB-93AD-DA6176BBF849}"/>
               </a:ext>
             </a:extLst>
           </p:cNvPr>
@@ -7276,7 +7276,7 @@
           <p:cNvPr id="20" name="">
             <a:extLst xmlns:a="http://schemas.openxmlformats.org/drawingml/2006/main">
               <a:ext uri="{FF2B5EF4-FFF2-40B4-BE49-F238E27FC236}">
-                <a16:creationId xmlns:a16="http://schemas.microsoft.com/office/drawing/2014/main" id="{CB805D05-24C9-4B21-8D29-01282C16CDE6}"/>
+                <a16:creationId xmlns:a16="http://schemas.microsoft.com/office/drawing/2014/main" id="{42BEC1F0-B7BD-4FCE-BD08-E4195316CAC2}"/>
               </a:ext>
             </a:extLst>
           </p:cNvPr>
@@ -7311,7 +7311,7 @@
           <p:cNvPr id="21" name="">
             <a:extLst xmlns:a="http://schemas.openxmlformats.org/drawingml/2006/main">
               <a:ext uri="{FF2B5EF4-FFF2-40B4-BE49-F238E27FC236}">
-                <a16:creationId xmlns:a16="http://schemas.microsoft.com/office/drawing/2014/main" id="{34AB1469-0634-4A1F-B645-29533F92E785}"/>
+                <a16:creationId xmlns:a16="http://schemas.microsoft.com/office/drawing/2014/main" id="{04B452CF-054B-4C8D-8825-FCCE8713580E}"/>
               </a:ext>
             </a:extLst>
           </p:cNvPr>
@@ -7368,7 +7368,7 @@
           <p:cNvPr id="22" name="">
             <a:extLst xmlns:a="http://schemas.openxmlformats.org/drawingml/2006/main">
               <a:ext uri="{FF2B5EF4-FFF2-40B4-BE49-F238E27FC236}">
-                <a16:creationId xmlns:a16="http://schemas.microsoft.com/office/drawing/2014/main" id="{4A87A388-E2BB-4358-BBF9-E2C3B345B77F}"/>
+                <a16:creationId xmlns:a16="http://schemas.microsoft.com/office/drawing/2014/main" id="{5A893AB7-EE27-439D-8F16-19ADE9BE83BC}"/>
               </a:ext>
             </a:extLst>
           </p:cNvPr>
@@ -7425,7 +7425,7 @@
           <p:cNvPr id="23" name="">
             <a:extLst xmlns:a="http://schemas.openxmlformats.org/drawingml/2006/main">
               <a:ext uri="{FF2B5EF4-FFF2-40B4-BE49-F238E27FC236}">
-                <a16:creationId xmlns:a16="http://schemas.microsoft.com/office/drawing/2014/main" id="{12E2ADB2-38FE-460C-BFFC-5EE285219DC1}"/>
+                <a16:creationId xmlns:a16="http://schemas.microsoft.com/office/drawing/2014/main" id="{5B02E96E-6168-4FF7-BB01-0075BF8FF4F2}"/>
               </a:ext>
             </a:extLst>
           </p:cNvPr>
@@ -7460,7 +7460,7 @@
           <p:cNvPr id="24" name="">
             <a:extLst xmlns:a="http://schemas.openxmlformats.org/drawingml/2006/main">
               <a:ext uri="{FF2B5EF4-FFF2-40B4-BE49-F238E27FC236}">
-                <a16:creationId xmlns:a16="http://schemas.microsoft.com/office/drawing/2014/main" id="{246F2763-848A-422E-B708-B77109DDD2B2}"/>
+                <a16:creationId xmlns:a16="http://schemas.microsoft.com/office/drawing/2014/main" id="{943790C8-8AFE-4A16-8F2F-56E9ACD9F265}"/>
               </a:ext>
             </a:extLst>
           </p:cNvPr>
@@ -7517,7 +7517,7 @@
           <p:cNvPr id="25" name="">
             <a:extLst xmlns:a="http://schemas.openxmlformats.org/drawingml/2006/main">
               <a:ext uri="{FF2B5EF4-FFF2-40B4-BE49-F238E27FC236}">
-                <a16:creationId xmlns:a16="http://schemas.microsoft.com/office/drawing/2014/main" id="{354AB628-C799-4E79-A3D1-61B5224AF747}"/>
+                <a16:creationId xmlns:a16="http://schemas.microsoft.com/office/drawing/2014/main" id="{38B2441C-E12F-4127-9CDB-51DA66E06932}"/>
               </a:ext>
             </a:extLst>
           </p:cNvPr>
@@ -7581,7 +7581,7 @@
           <p:cNvPr id="26" name="">
             <a:extLst xmlns:a="http://schemas.openxmlformats.org/drawingml/2006/main">
               <a:ext uri="{FF2B5EF4-FFF2-40B4-BE49-F238E27FC236}">
-                <a16:creationId xmlns:a16="http://schemas.microsoft.com/office/drawing/2014/main" id="{1C3FC13D-378A-417D-B383-58ABB040542A}"/>
+                <a16:creationId xmlns:a16="http://schemas.microsoft.com/office/drawing/2014/main" id="{2E6B4854-60AD-41E6-9FFD-650D76A21619}"/>
               </a:ext>
             </a:extLst>
           </p:cNvPr>
@@ -7645,7 +7645,7 @@
           <p:cNvPr id="27" name="">
             <a:extLst xmlns:a="http://schemas.openxmlformats.org/drawingml/2006/main">
               <a:ext uri="{FF2B5EF4-FFF2-40B4-BE49-F238E27FC236}">
-                <a16:creationId xmlns:a16="http://schemas.microsoft.com/office/drawing/2014/main" id="{4E98133B-91F8-4C48-A1C3-C96D782154F2}"/>
+                <a16:creationId xmlns:a16="http://schemas.microsoft.com/office/drawing/2014/main" id="{F5AD453D-99B4-4DC3-9A6A-F560882311FC}"/>
               </a:ext>
             </a:extLst>
           </p:cNvPr>
@@ -7709,7 +7709,7 @@
           <p:cNvPr id="28" name="">
             <a:extLst xmlns:a="http://schemas.openxmlformats.org/drawingml/2006/main">
               <a:ext uri="{FF2B5EF4-FFF2-40B4-BE49-F238E27FC236}">
-                <a16:creationId xmlns:a16="http://schemas.microsoft.com/office/drawing/2014/main" id="{C37E2D67-A5A8-45F6-97A6-1515902FE661}"/>
+                <a16:creationId xmlns:a16="http://schemas.microsoft.com/office/drawing/2014/main" id="{DED49C01-64EE-4ADC-A960-695616B5E795}"/>
               </a:ext>
             </a:extLst>
           </p:cNvPr>
@@ -7773,7 +7773,7 @@
           <p:cNvPr id="29" name="">
             <a:extLst xmlns:a="http://schemas.openxmlformats.org/drawingml/2006/main">
               <a:ext uri="{FF2B5EF4-FFF2-40B4-BE49-F238E27FC236}">
-                <a16:creationId xmlns:a16="http://schemas.microsoft.com/office/drawing/2014/main" id="{CDB9DD4D-BEC3-4373-9524-85246CB19B6E}"/>
+                <a16:creationId xmlns:a16="http://schemas.microsoft.com/office/drawing/2014/main" id="{8A485574-0005-47B7-8687-7E3D14E7B164}"/>
               </a:ext>
             </a:extLst>
           </p:cNvPr>
@@ -7830,7 +7830,7 @@
           <p:cNvPr id="30" name="">
             <a:extLst xmlns:a="http://schemas.openxmlformats.org/drawingml/2006/main">
               <a:ext uri="{FF2B5EF4-FFF2-40B4-BE49-F238E27FC236}">
-                <a16:creationId xmlns:a16="http://schemas.microsoft.com/office/drawing/2014/main" id="{1155CE8A-2AC2-4D22-AA29-E3F9E1CB9941}"/>
+                <a16:creationId xmlns:a16="http://schemas.microsoft.com/office/drawing/2014/main" id="{7D67A564-EEFE-4A03-99A9-D2212534DA90}"/>
               </a:ext>
             </a:extLst>
           </p:cNvPr>
@@ -7887,7 +7887,7 @@
           <p:cNvPr id="31" name="">
             <a:extLst xmlns:a="http://schemas.openxmlformats.org/drawingml/2006/main">
               <a:ext uri="{FF2B5EF4-FFF2-40B4-BE49-F238E27FC236}">
-                <a16:creationId xmlns:a16="http://schemas.microsoft.com/office/drawing/2014/main" id="{91CD3FB4-8355-47C3-9CCF-DDDCBF5C10CE}"/>
+                <a16:creationId xmlns:a16="http://schemas.microsoft.com/office/drawing/2014/main" id="{D7359B28-6A08-43A7-82CB-6B620EE512BA}"/>
               </a:ext>
             </a:extLst>
           </p:cNvPr>
@@ -7942,7 +7942,7 @@
     </p:spTree>
     <p:extLst>
       <p:ext uri="{BB962C8B-B14F-4D97-AF65-F5344CB8AC3E}">
-        <p14:creationId xmlns:p14="http://schemas.microsoft.com/office/powerpoint/2010/main" val="529784666"/>
+        <p14:creationId xmlns:p14="http://schemas.microsoft.com/office/powerpoint/2010/main" val="211203926"/>
       </p:ext>
     </p:extLst>
   </p:cSld>
@@ -7973,7 +7973,7 @@
           <p:cNvPr id="32" name="">
             <a:extLst xmlns:a="http://schemas.openxmlformats.org/drawingml/2006/main">
               <a:ext uri="{FF2B5EF4-FFF2-40B4-BE49-F238E27FC236}">
-                <a16:creationId xmlns:a16="http://schemas.microsoft.com/office/drawing/2014/main" id="{13A17095-CA91-4DEC-A8B8-322B077AD283}"/>
+                <a16:creationId xmlns:a16="http://schemas.microsoft.com/office/drawing/2014/main" id="{329D43FE-F06B-49DB-B5F0-16D73A296A05}"/>
               </a:ext>
             </a:extLst>
           </p:cNvPr>
@@ -8030,7 +8030,7 @@
           <p:cNvPr id="2" name="">
             <a:extLst xmlns:a="http://schemas.openxmlformats.org/drawingml/2006/main">
               <a:ext uri="{FF2B5EF4-FFF2-40B4-BE49-F238E27FC236}">
-                <a16:creationId xmlns:a16="http://schemas.microsoft.com/office/drawing/2014/main" id="{7C3804C1-23F2-4A6C-A52B-6DB3A11328A0}"/>
+                <a16:creationId xmlns:a16="http://schemas.microsoft.com/office/drawing/2014/main" id="{3A89D916-01CE-4843-8DA5-0E267FE6C0F8}"/>
               </a:ext>
             </a:extLst>
           </p:cNvPr>
@@ -8087,7 +8087,7 @@
           <p:cNvPr id="3" name="">
             <a:extLst xmlns:a="http://schemas.openxmlformats.org/drawingml/2006/main">
               <a:ext uri="{FF2B5EF4-FFF2-40B4-BE49-F238E27FC236}">
-                <a16:creationId xmlns:a16="http://schemas.microsoft.com/office/drawing/2014/main" id="{65FBDFCC-2389-4CB0-B501-2AC7C29C3CC2}"/>
+                <a16:creationId xmlns:a16="http://schemas.microsoft.com/office/drawing/2014/main" id="{98D2D73B-B3E5-48D8-ABF4-A140DE27E1EB}"/>
               </a:ext>
             </a:extLst>
           </p:cNvPr>
@@ -8144,7 +8144,7 @@
           <p:cNvPr id="4" name="">
             <a:extLst xmlns:a="http://schemas.openxmlformats.org/drawingml/2006/main">
               <a:ext uri="{FF2B5EF4-FFF2-40B4-BE49-F238E27FC236}">
-                <a16:creationId xmlns:a16="http://schemas.microsoft.com/office/drawing/2014/main" id="{1C9C4CA0-BEBF-42E8-8D10-9AA1AF28CA5F}"/>
+                <a16:creationId xmlns:a16="http://schemas.microsoft.com/office/drawing/2014/main" id="{2ED0CDC4-E3B4-456C-9550-10EF95AF9B29}"/>
               </a:ext>
             </a:extLst>
           </p:cNvPr>
@@ -8175,7 +8175,7 @@
           <p:cNvPr id="5" name="">
             <a:extLst xmlns:a="http://schemas.openxmlformats.org/drawingml/2006/main">
               <a:ext uri="{FF2B5EF4-FFF2-40B4-BE49-F238E27FC236}">
-                <a16:creationId xmlns:a16="http://schemas.microsoft.com/office/drawing/2014/main" id="{9DFB70C2-97E2-4823-891F-8D9420CAB553}"/>
+                <a16:creationId xmlns:a16="http://schemas.microsoft.com/office/drawing/2014/main" id="{99663A5A-072C-420E-A0CF-FD13FDECCCA8}"/>
               </a:ext>
             </a:extLst>
           </p:cNvPr>
@@ -8210,7 +8210,7 @@
           <p:cNvPr id="6" name="">
             <a:extLst xmlns:a="http://schemas.openxmlformats.org/drawingml/2006/main">
               <a:ext uri="{FF2B5EF4-FFF2-40B4-BE49-F238E27FC236}">
-                <a16:creationId xmlns:a16="http://schemas.microsoft.com/office/drawing/2014/main" id="{BFB85BC5-0A14-46CC-BF1F-1F5AC5E3A16B}"/>
+                <a16:creationId xmlns:a16="http://schemas.microsoft.com/office/drawing/2014/main" id="{1175A6B4-B978-4AAA-8F87-332AB80BB7F7}"/>
               </a:ext>
             </a:extLst>
           </p:cNvPr>
@@ -8274,7 +8274,7 @@
           <p:cNvPr id="7" name="">
             <a:extLst xmlns:a="http://schemas.openxmlformats.org/drawingml/2006/main">
               <a:ext uri="{FF2B5EF4-FFF2-40B4-BE49-F238E27FC236}">
-                <a16:creationId xmlns:a16="http://schemas.microsoft.com/office/drawing/2014/main" id="{61369E59-6602-4182-92A1-2B69C9FEBE82}"/>
+                <a16:creationId xmlns:a16="http://schemas.microsoft.com/office/drawing/2014/main" id="{58E97EDA-D76C-4F66-B0CC-26ACA2B2C6C0}"/>
               </a:ext>
             </a:extLst>
           </p:cNvPr>
@@ -8331,7 +8331,7 @@
           <p:cNvPr id="8" name="">
             <a:extLst xmlns:a="http://schemas.openxmlformats.org/drawingml/2006/main">
               <a:ext uri="{FF2B5EF4-FFF2-40B4-BE49-F238E27FC236}">
-                <a16:creationId xmlns:a16="http://schemas.microsoft.com/office/drawing/2014/main" id="{4E639FC7-F1DD-4926-AD57-9F23D20BD5B9}"/>
+                <a16:creationId xmlns:a16="http://schemas.microsoft.com/office/drawing/2014/main" id="{5BE957FC-22AC-4B5F-98FE-F2858ACA97D4}"/>
               </a:ext>
             </a:extLst>
           </p:cNvPr>
@@ -8362,7 +8362,7 @@
           <p:cNvPr id="9" name="">
             <a:extLst xmlns:a="http://schemas.openxmlformats.org/drawingml/2006/main">
               <a:ext uri="{FF2B5EF4-FFF2-40B4-BE49-F238E27FC236}">
-                <a16:creationId xmlns:a16="http://schemas.microsoft.com/office/drawing/2014/main" id="{1FF093E2-2A36-4D4E-BBB6-E18926E3B5F4}"/>
+                <a16:creationId xmlns:a16="http://schemas.microsoft.com/office/drawing/2014/main" id="{B66495C1-A327-48F7-A851-4938ABDD7972}"/>
               </a:ext>
             </a:extLst>
           </p:cNvPr>
@@ -8397,7 +8397,7 @@
           <p:cNvPr id="10" name="">
             <a:extLst xmlns:a="http://schemas.openxmlformats.org/drawingml/2006/main">
               <a:ext uri="{FF2B5EF4-FFF2-40B4-BE49-F238E27FC236}">
-                <a16:creationId xmlns:a16="http://schemas.microsoft.com/office/drawing/2014/main" id="{59642926-B4CC-4CEA-BB32-B467A292D90E}"/>
+                <a16:creationId xmlns:a16="http://schemas.microsoft.com/office/drawing/2014/main" id="{F6EB59F0-B0D5-4845-9FBA-3801288441EF}"/>
               </a:ext>
             </a:extLst>
           </p:cNvPr>
@@ -8461,7 +8461,7 @@
           <p:cNvPr id="11" name="">
             <a:extLst xmlns:a="http://schemas.openxmlformats.org/drawingml/2006/main">
               <a:ext uri="{FF2B5EF4-FFF2-40B4-BE49-F238E27FC236}">
-                <a16:creationId xmlns:a16="http://schemas.microsoft.com/office/drawing/2014/main" id="{A2C578C4-D5A5-46AD-89BE-92E9D1C1ABDC}"/>
+                <a16:creationId xmlns:a16="http://schemas.microsoft.com/office/drawing/2014/main" id="{C5C40859-E89C-4DD2-8557-9F0F8BA24B38}"/>
               </a:ext>
             </a:extLst>
           </p:cNvPr>
@@ -8518,7 +8518,7 @@
           <p:cNvPr id="12" name="">
             <a:extLst xmlns:a="http://schemas.openxmlformats.org/drawingml/2006/main">
               <a:ext uri="{FF2B5EF4-FFF2-40B4-BE49-F238E27FC236}">
-                <a16:creationId xmlns:a16="http://schemas.microsoft.com/office/drawing/2014/main" id="{866CBA1A-9812-4724-A26B-56496348F739}"/>
+                <a16:creationId xmlns:a16="http://schemas.microsoft.com/office/drawing/2014/main" id="{DEEE48EA-6BCD-41A7-B0DA-030270E85BFD}"/>
               </a:ext>
             </a:extLst>
           </p:cNvPr>
@@ -8549,7 +8549,7 @@
           <p:cNvPr id="13" name="">
             <a:extLst xmlns:a="http://schemas.openxmlformats.org/drawingml/2006/main">
               <a:ext uri="{FF2B5EF4-FFF2-40B4-BE49-F238E27FC236}">
-                <a16:creationId xmlns:a16="http://schemas.microsoft.com/office/drawing/2014/main" id="{1F44E280-0316-4166-A3D4-1FC3EBAEEF25}"/>
+                <a16:creationId xmlns:a16="http://schemas.microsoft.com/office/drawing/2014/main" id="{B86486BC-F8E6-4FC2-8BF3-2C23EF8CD618}"/>
               </a:ext>
             </a:extLst>
           </p:cNvPr>
@@ -8584,7 +8584,7 @@
           <p:cNvPr id="14" name="">
             <a:extLst xmlns:a="http://schemas.openxmlformats.org/drawingml/2006/main">
               <a:ext uri="{FF2B5EF4-FFF2-40B4-BE49-F238E27FC236}">
-                <a16:creationId xmlns:a16="http://schemas.microsoft.com/office/drawing/2014/main" id="{2BA9D034-F7EE-406C-A88C-089145780AD7}"/>
+                <a16:creationId xmlns:a16="http://schemas.microsoft.com/office/drawing/2014/main" id="{106124C4-438C-47DB-9201-A948451219FC}"/>
               </a:ext>
             </a:extLst>
           </p:cNvPr>
@@ -8648,7 +8648,7 @@
           <p:cNvPr id="15" name="">
             <a:extLst xmlns:a="http://schemas.openxmlformats.org/drawingml/2006/main">
               <a:ext uri="{FF2B5EF4-FFF2-40B4-BE49-F238E27FC236}">
-                <a16:creationId xmlns:a16="http://schemas.microsoft.com/office/drawing/2014/main" id="{8886E739-DA84-4C53-9CD2-46FDAA80F99A}"/>
+                <a16:creationId xmlns:a16="http://schemas.microsoft.com/office/drawing/2014/main" id="{F1953AFB-CA06-4676-9A2E-DFC34673427E}"/>
               </a:ext>
             </a:extLst>
           </p:cNvPr>
@@ -8705,7 +8705,7 @@
           <p:cNvPr id="16" name="">
             <a:extLst xmlns:a="http://schemas.openxmlformats.org/drawingml/2006/main">
               <a:ext uri="{FF2B5EF4-FFF2-40B4-BE49-F238E27FC236}">
-                <a16:creationId xmlns:a16="http://schemas.microsoft.com/office/drawing/2014/main" id="{9CBF72C2-A9E2-4C60-95E3-30C7AB7F7FC3}"/>
+                <a16:creationId xmlns:a16="http://schemas.microsoft.com/office/drawing/2014/main" id="{9F202033-F9A3-4CED-A84C-6F2455E1821B}"/>
               </a:ext>
             </a:extLst>
           </p:cNvPr>
@@ -8736,7 +8736,7 @@
           <p:cNvPr id="17" name="">
             <a:extLst xmlns:a="http://schemas.openxmlformats.org/drawingml/2006/main">
               <a:ext uri="{FF2B5EF4-FFF2-40B4-BE49-F238E27FC236}">
-                <a16:creationId xmlns:a16="http://schemas.microsoft.com/office/drawing/2014/main" id="{AB31FB8E-A67C-4039-AC82-6293C14CE225}"/>
+                <a16:creationId xmlns:a16="http://schemas.microsoft.com/office/drawing/2014/main" id="{7836AB93-6C05-406A-AFFF-29CFB7C575AA}"/>
               </a:ext>
             </a:extLst>
           </p:cNvPr>
@@ -8771,7 +8771,7 @@
           <p:cNvPr id="18" name="">
             <a:extLst xmlns:a="http://schemas.openxmlformats.org/drawingml/2006/main">
               <a:ext uri="{FF2B5EF4-FFF2-40B4-BE49-F238E27FC236}">
-                <a16:creationId xmlns:a16="http://schemas.microsoft.com/office/drawing/2014/main" id="{6BCD454B-D0EC-4DF5-83BE-6007FCB82B83}"/>
+                <a16:creationId xmlns:a16="http://schemas.microsoft.com/office/drawing/2014/main" id="{20F9BC3E-C3D5-44D6-964E-1EA1E31EC0DF}"/>
               </a:ext>
             </a:extLst>
           </p:cNvPr>
@@ -8835,7 +8835,7 @@
           <p:cNvPr id="19" name="">
             <a:extLst xmlns:a="http://schemas.openxmlformats.org/drawingml/2006/main">
               <a:ext uri="{FF2B5EF4-FFF2-40B4-BE49-F238E27FC236}">
-                <a16:creationId xmlns:a16="http://schemas.microsoft.com/office/drawing/2014/main" id="{2CB89E84-9478-4F17-9094-97639BBBF917}"/>
+                <a16:creationId xmlns:a16="http://schemas.microsoft.com/office/drawing/2014/main" id="{9B923D05-BD16-43AC-A083-0219B615C871}"/>
               </a:ext>
             </a:extLst>
           </p:cNvPr>
@@ -8892,7 +8892,7 @@
           <p:cNvPr id="20" name="">
             <a:extLst xmlns:a="http://schemas.openxmlformats.org/drawingml/2006/main">
               <a:ext uri="{FF2B5EF4-FFF2-40B4-BE49-F238E27FC236}">
-                <a16:creationId xmlns:a16="http://schemas.microsoft.com/office/drawing/2014/main" id="{FB7669B9-BBDA-4C0D-AB08-15CD5038B362}"/>
+                <a16:creationId xmlns:a16="http://schemas.microsoft.com/office/drawing/2014/main" id="{B26446F0-7742-4C87-89D9-D4937C650D46}"/>
               </a:ext>
             </a:extLst>
           </p:cNvPr>
@@ -8927,7 +8927,7 @@
           <p:cNvPr id="21" name="">
             <a:extLst xmlns:a="http://schemas.openxmlformats.org/drawingml/2006/main">
               <a:ext uri="{FF2B5EF4-FFF2-40B4-BE49-F238E27FC236}">
-                <a16:creationId xmlns:a16="http://schemas.microsoft.com/office/drawing/2014/main" id="{609F7F3B-E490-47D6-BA0D-B6BED09631F2}"/>
+                <a16:creationId xmlns:a16="http://schemas.microsoft.com/office/drawing/2014/main" id="{3F83D8EF-614A-4FFC-A978-1603803821B2}"/>
               </a:ext>
             </a:extLst>
           </p:cNvPr>
@@ -8984,7 +8984,7 @@
           <p:cNvPr id="22" name="">
             <a:extLst xmlns:a="http://schemas.openxmlformats.org/drawingml/2006/main">
               <a:ext uri="{FF2B5EF4-FFF2-40B4-BE49-F238E27FC236}">
-                <a16:creationId xmlns:a16="http://schemas.microsoft.com/office/drawing/2014/main" id="{3C3DC408-96EE-45C1-9CF0-48CBF0ADFA5A}"/>
+                <a16:creationId xmlns:a16="http://schemas.microsoft.com/office/drawing/2014/main" id="{DC2E37AC-1EF2-4E7D-8F90-E230ADE63D63}"/>
               </a:ext>
             </a:extLst>
           </p:cNvPr>
@@ -9041,7 +9041,7 @@
           <p:cNvPr id="23" name="">
             <a:extLst xmlns:a="http://schemas.openxmlformats.org/drawingml/2006/main">
               <a:ext uri="{FF2B5EF4-FFF2-40B4-BE49-F238E27FC236}">
-                <a16:creationId xmlns:a16="http://schemas.microsoft.com/office/drawing/2014/main" id="{1A5C5E2F-3A26-4D37-A8C7-904238DA8AEE}"/>
+                <a16:creationId xmlns:a16="http://schemas.microsoft.com/office/drawing/2014/main" id="{A963FA58-2544-4859-A191-810A70E918E9}"/>
               </a:ext>
             </a:extLst>
           </p:cNvPr>
@@ -9076,7 +9076,7 @@
           <p:cNvPr id="24" name="">
             <a:extLst xmlns:a="http://schemas.openxmlformats.org/drawingml/2006/main">
               <a:ext uri="{FF2B5EF4-FFF2-40B4-BE49-F238E27FC236}">
-                <a16:creationId xmlns:a16="http://schemas.microsoft.com/office/drawing/2014/main" id="{54A67F21-6F24-4C24-92D4-82E1C7DA2548}"/>
+                <a16:creationId xmlns:a16="http://schemas.microsoft.com/office/drawing/2014/main" id="{02F24F32-765B-43D1-9E2A-DD84112FD48E}"/>
               </a:ext>
             </a:extLst>
           </p:cNvPr>
@@ -9140,7 +9140,7 @@
           <p:cNvPr id="25" name="">
             <a:extLst xmlns:a="http://schemas.openxmlformats.org/drawingml/2006/main">
               <a:ext uri="{FF2B5EF4-FFF2-40B4-BE49-F238E27FC236}">
-                <a16:creationId xmlns:a16="http://schemas.microsoft.com/office/drawing/2014/main" id="{195B5D1E-A023-4AAA-B9E4-2F266735A3EE}"/>
+                <a16:creationId xmlns:a16="http://schemas.microsoft.com/office/drawing/2014/main" id="{A2BB38EF-84A4-4830-95A0-2F360527FFCB}"/>
               </a:ext>
             </a:extLst>
           </p:cNvPr>
@@ -9266,7 +9266,7 @@
           <p:cNvPr id="26" name="">
             <a:extLst xmlns:a="http://schemas.openxmlformats.org/drawingml/2006/main">
               <a:ext uri="{FF2B5EF4-FFF2-40B4-BE49-F238E27FC236}">
-                <a16:creationId xmlns:a16="http://schemas.microsoft.com/office/drawing/2014/main" id="{4608BCA0-2617-4ECA-96F5-92CBFFB5B4A6}"/>
+                <a16:creationId xmlns:a16="http://schemas.microsoft.com/office/drawing/2014/main" id="{D4258E4A-E0C1-4D16-AC91-C28C028B4EE8}"/>
               </a:ext>
             </a:extLst>
           </p:cNvPr>
@@ -9301,7 +9301,7 @@
           <p:cNvPr id="27" name="">
             <a:extLst xmlns:a="http://schemas.openxmlformats.org/drawingml/2006/main">
               <a:ext uri="{FF2B5EF4-FFF2-40B4-BE49-F238E27FC236}">
-                <a16:creationId xmlns:a16="http://schemas.microsoft.com/office/drawing/2014/main" id="{3228AD01-A96D-44F1-91F7-EF73954FA256}"/>
+                <a16:creationId xmlns:a16="http://schemas.microsoft.com/office/drawing/2014/main" id="{54BD79B4-E483-482E-8876-BC5A191A6312}"/>
               </a:ext>
             </a:extLst>
           </p:cNvPr>
@@ -9365,7 +9365,7 @@
           <p:cNvPr id="28" name="">
             <a:extLst xmlns:a="http://schemas.openxmlformats.org/drawingml/2006/main">
               <a:ext uri="{FF2B5EF4-FFF2-40B4-BE49-F238E27FC236}">
-                <a16:creationId xmlns:a16="http://schemas.microsoft.com/office/drawing/2014/main" id="{A67D648C-29FE-4E5E-9F4F-60AE25B2001A}"/>
+                <a16:creationId xmlns:a16="http://schemas.microsoft.com/office/drawing/2014/main" id="{28059F51-3EF2-4D4E-9FAC-2CA56A33B76B}"/>
               </a:ext>
             </a:extLst>
           </p:cNvPr>
@@ -9435,7 +9435,7 @@
                 <a:ea typeface="Arial"/>
                 <a:cs typeface="Arial"/>
               </a:rPr>
-              <a:t>5 ca Verify</a:t>
+              <a:t>5 ca Verify trên UI</a:t>
             </a:r>
           </a:p>
           <a:p xmlns:a="http://schemas.openxmlformats.org/drawingml/2006/main">
@@ -9458,7 +9458,7 @@
                 <a:ea typeface="Arial"/>
                 <a:cs typeface="Arial"/>
               </a:rPr>
-              <a:t>15 ca giao BGK</a:t>
+              <a:t>15/30 ca qua runner</a:t>
             </a:r>
           </a:p>
         </p:txBody>
@@ -9468,7 +9468,7 @@
           <p:cNvPr id="29" name="">
             <a:extLst xmlns:a="http://schemas.openxmlformats.org/drawingml/2006/main">
               <a:ext uri="{FF2B5EF4-FFF2-40B4-BE49-F238E27FC236}">
-                <a16:creationId xmlns:a16="http://schemas.microsoft.com/office/drawing/2014/main" id="{6D5297A3-694D-4BEC-A14E-886E986C8DE6}"/>
+                <a16:creationId xmlns:a16="http://schemas.microsoft.com/office/drawing/2014/main" id="{935BBE93-8477-4DB6-9771-8A0FB2F06231}"/>
               </a:ext>
             </a:extLst>
           </p:cNvPr>
@@ -9548,7 +9548,7 @@
           <p:cNvPr id="30" name="">
             <a:extLst xmlns:a="http://schemas.openxmlformats.org/drawingml/2006/main">
               <a:ext uri="{FF2B5EF4-FFF2-40B4-BE49-F238E27FC236}">
-                <a16:creationId xmlns:a16="http://schemas.microsoft.com/office/drawing/2014/main" id="{A3EFFB27-34A5-486C-B12F-70387DF04625}"/>
+                <a16:creationId xmlns:a16="http://schemas.microsoft.com/office/drawing/2014/main" id="{A1541F4D-75B0-4FDA-8E85-E611A4B287D5}"/>
               </a:ext>
             </a:extLst>
           </p:cNvPr>
@@ -9605,7 +9605,7 @@
           <p:cNvPr id="31" name="">
             <a:extLst xmlns:a="http://schemas.openxmlformats.org/drawingml/2006/main">
               <a:ext uri="{FF2B5EF4-FFF2-40B4-BE49-F238E27FC236}">
-                <a16:creationId xmlns:a16="http://schemas.microsoft.com/office/drawing/2014/main" id="{4C8CE4A1-C6ED-4979-A160-8FB6BDCF4DEE}"/>
+                <a16:creationId xmlns:a16="http://schemas.microsoft.com/office/drawing/2014/main" id="{DBD098D4-410E-471A-AFE5-BFFCEA62D2F9}"/>
               </a:ext>
             </a:extLst>
           </p:cNvPr>
@@ -9660,7 +9660,7 @@
     </p:spTree>
     <p:extLst>
       <p:ext uri="{BB962C8B-B14F-4D97-AF65-F5344CB8AC3E}">
-        <p14:creationId xmlns:p14="http://schemas.microsoft.com/office/powerpoint/2010/main" val="1741885100"/>
+        <p14:creationId xmlns:p14="http://schemas.microsoft.com/office/powerpoint/2010/main" val="1047596726"/>
       </p:ext>
     </p:extLst>
   </p:cSld>
@@ -9691,7 +9691,7 @@
           <p:cNvPr id="36" name="">
             <a:extLst xmlns:a="http://schemas.openxmlformats.org/drawingml/2006/main">
               <a:ext uri="{FF2B5EF4-FFF2-40B4-BE49-F238E27FC236}">
-                <a16:creationId xmlns:a16="http://schemas.microsoft.com/office/drawing/2014/main" id="{45D7C1A2-2525-4A5F-95A0-3A63453239BC}"/>
+                <a16:creationId xmlns:a16="http://schemas.microsoft.com/office/drawing/2014/main" id="{6EE12D9A-AB11-4EBC-BFAB-C517A742EB4B}"/>
               </a:ext>
             </a:extLst>
           </p:cNvPr>
@@ -9748,7 +9748,7 @@
           <p:cNvPr id="2" name="">
             <a:extLst xmlns:a="http://schemas.openxmlformats.org/drawingml/2006/main">
               <a:ext uri="{FF2B5EF4-FFF2-40B4-BE49-F238E27FC236}">
-                <a16:creationId xmlns:a16="http://schemas.microsoft.com/office/drawing/2014/main" id="{64E13182-255F-4344-90EB-A6A604DAFC5B}"/>
+                <a16:creationId xmlns:a16="http://schemas.microsoft.com/office/drawing/2014/main" id="{C9650FF0-3646-495C-9679-680E56FD0ABC}"/>
               </a:ext>
             </a:extLst>
           </p:cNvPr>
@@ -9805,7 +9805,7 @@
           <p:cNvPr id="3" name="">
             <a:extLst xmlns:a="http://schemas.openxmlformats.org/drawingml/2006/main">
               <a:ext uri="{FF2B5EF4-FFF2-40B4-BE49-F238E27FC236}">
-                <a16:creationId xmlns:a16="http://schemas.microsoft.com/office/drawing/2014/main" id="{916D2511-D4F0-41B5-BC24-A061335985A6}"/>
+                <a16:creationId xmlns:a16="http://schemas.microsoft.com/office/drawing/2014/main" id="{52654260-1F46-4C0A-B6C6-C7D7C0F6735E}"/>
               </a:ext>
             </a:extLst>
           </p:cNvPr>
@@ -9862,7 +9862,7 @@
           <p:cNvPr id="4" name="">
             <a:extLst xmlns:a="http://schemas.openxmlformats.org/drawingml/2006/main">
               <a:ext uri="{FF2B5EF4-FFF2-40B4-BE49-F238E27FC236}">
-                <a16:creationId xmlns:a16="http://schemas.microsoft.com/office/drawing/2014/main" id="{CCFF5C06-0735-4D74-A857-3C5B65575399}"/>
+                <a16:creationId xmlns:a16="http://schemas.microsoft.com/office/drawing/2014/main" id="{BF605A12-2DE4-4E1F-9864-34D5FC24476D}"/>
               </a:ext>
             </a:extLst>
           </p:cNvPr>
@@ -9893,7 +9893,7 @@
           <p:cNvPr id="5" name="">
             <a:extLst xmlns:a="http://schemas.openxmlformats.org/drawingml/2006/main">
               <a:ext uri="{FF2B5EF4-FFF2-40B4-BE49-F238E27FC236}">
-                <a16:creationId xmlns:a16="http://schemas.microsoft.com/office/drawing/2014/main" id="{C8DBE54B-921B-4D48-ADA9-8158313DC027}"/>
+                <a16:creationId xmlns:a16="http://schemas.microsoft.com/office/drawing/2014/main" id="{6D09C9AE-4961-453B-9813-245E8D3B7274}"/>
               </a:ext>
             </a:extLst>
           </p:cNvPr>
@@ -9928,7 +9928,7 @@
           <p:cNvPr id="6" name="">
             <a:extLst xmlns:a="http://schemas.openxmlformats.org/drawingml/2006/main">
               <a:ext uri="{FF2B5EF4-FFF2-40B4-BE49-F238E27FC236}">
-                <a16:creationId xmlns:a16="http://schemas.microsoft.com/office/drawing/2014/main" id="{D034CC8A-857E-49CD-9C29-29E8DDBC22AF}"/>
+                <a16:creationId xmlns:a16="http://schemas.microsoft.com/office/drawing/2014/main" id="{E52CDAA8-F29B-411E-979E-73B0EBCBB79D}"/>
               </a:ext>
             </a:extLst>
           </p:cNvPr>
@@ -9992,7 +9992,7 @@
           <p:cNvPr id="7" name="">
             <a:extLst xmlns:a="http://schemas.openxmlformats.org/drawingml/2006/main">
               <a:ext uri="{FF2B5EF4-FFF2-40B4-BE49-F238E27FC236}">
-                <a16:creationId xmlns:a16="http://schemas.microsoft.com/office/drawing/2014/main" id="{A6041D08-FA77-4160-B559-4ED6E85C213A}"/>
+                <a16:creationId xmlns:a16="http://schemas.microsoft.com/office/drawing/2014/main" id="{CC8CD4BD-9C21-4D7D-BEAD-7A283B3ACED4}"/>
               </a:ext>
             </a:extLst>
           </p:cNvPr>
@@ -10049,7 +10049,7 @@
           <p:cNvPr id="8" name="">
             <a:extLst xmlns:a="http://schemas.openxmlformats.org/drawingml/2006/main">
               <a:ext uri="{FF2B5EF4-FFF2-40B4-BE49-F238E27FC236}">
-                <a16:creationId xmlns:a16="http://schemas.microsoft.com/office/drawing/2014/main" id="{C721AC74-B1D2-415E-86B6-4D734CC26054}"/>
+                <a16:creationId xmlns:a16="http://schemas.microsoft.com/office/drawing/2014/main" id="{12679D0D-1F37-4DED-9A3E-52F585959C6A}"/>
               </a:ext>
             </a:extLst>
           </p:cNvPr>
@@ -10084,7 +10084,7 @@
           <p:cNvPr id="9" name="">
             <a:extLst xmlns:a="http://schemas.openxmlformats.org/drawingml/2006/main">
               <a:ext uri="{FF2B5EF4-FFF2-40B4-BE49-F238E27FC236}">
-                <a16:creationId xmlns:a16="http://schemas.microsoft.com/office/drawing/2014/main" id="{47CD94E5-3244-4CBE-8779-57E9E86C5E1F}"/>
+                <a16:creationId xmlns:a16="http://schemas.microsoft.com/office/drawing/2014/main" id="{2460B240-F810-438F-B01C-03796836BF11}"/>
               </a:ext>
             </a:extLst>
           </p:cNvPr>
@@ -10148,7 +10148,7 @@
           <p:cNvPr id="10" name="">
             <a:extLst xmlns:a="http://schemas.openxmlformats.org/drawingml/2006/main">
               <a:ext uri="{FF2B5EF4-FFF2-40B4-BE49-F238E27FC236}">
-                <a16:creationId xmlns:a16="http://schemas.microsoft.com/office/drawing/2014/main" id="{021066F6-1A6C-47E4-8D58-8289070F90FF}"/>
+                <a16:creationId xmlns:a16="http://schemas.microsoft.com/office/drawing/2014/main" id="{365B4A58-53A8-471A-B172-C43E84F0E801}"/>
               </a:ext>
             </a:extLst>
           </p:cNvPr>
@@ -10205,7 +10205,7 @@
           <p:cNvPr id="11" name="">
             <a:extLst xmlns:a="http://schemas.openxmlformats.org/drawingml/2006/main">
               <a:ext uri="{FF2B5EF4-FFF2-40B4-BE49-F238E27FC236}">
-                <a16:creationId xmlns:a16="http://schemas.microsoft.com/office/drawing/2014/main" id="{6ACF737A-56B9-4DB3-841A-B448690789DE}"/>
+                <a16:creationId xmlns:a16="http://schemas.microsoft.com/office/drawing/2014/main" id="{0081012C-8103-4E34-9590-DB88627FDE67}"/>
               </a:ext>
             </a:extLst>
           </p:cNvPr>
@@ -10240,7 +10240,7 @@
           <p:cNvPr id="12" name="">
             <a:extLst xmlns:a="http://schemas.openxmlformats.org/drawingml/2006/main">
               <a:ext uri="{FF2B5EF4-FFF2-40B4-BE49-F238E27FC236}">
-                <a16:creationId xmlns:a16="http://schemas.microsoft.com/office/drawing/2014/main" id="{92E3EC1A-CF7F-4412-8049-B912F35D70AC}"/>
+                <a16:creationId xmlns:a16="http://schemas.microsoft.com/office/drawing/2014/main" id="{06F60557-9E1C-4FC4-87F0-4E7D645627F7}"/>
               </a:ext>
             </a:extLst>
           </p:cNvPr>
@@ -10304,7 +10304,7 @@
           <p:cNvPr id="13" name="">
             <a:extLst xmlns:a="http://schemas.openxmlformats.org/drawingml/2006/main">
               <a:ext uri="{FF2B5EF4-FFF2-40B4-BE49-F238E27FC236}">
-                <a16:creationId xmlns:a16="http://schemas.microsoft.com/office/drawing/2014/main" id="{33E40CB1-276E-467A-AB99-68AE2E98DA4F}"/>
+                <a16:creationId xmlns:a16="http://schemas.microsoft.com/office/drawing/2014/main" id="{7C306BCD-F188-4E2C-9DAC-482076EDFBF1}"/>
               </a:ext>
             </a:extLst>
           </p:cNvPr>
@@ -10361,7 +10361,7 @@
           <p:cNvPr id="14" name="">
             <a:extLst xmlns:a="http://schemas.openxmlformats.org/drawingml/2006/main">
               <a:ext uri="{FF2B5EF4-FFF2-40B4-BE49-F238E27FC236}">
-                <a16:creationId xmlns:a16="http://schemas.microsoft.com/office/drawing/2014/main" id="{D88E0D87-79F1-47AB-B8D7-E7C6831647E2}"/>
+                <a16:creationId xmlns:a16="http://schemas.microsoft.com/office/drawing/2014/main" id="{711197D6-9EB6-4BEF-8D50-F35F0E453C22}"/>
               </a:ext>
             </a:extLst>
           </p:cNvPr>
@@ -10396,7 +10396,7 @@
           <p:cNvPr id="15" name="">
             <a:extLst xmlns:a="http://schemas.openxmlformats.org/drawingml/2006/main">
               <a:ext uri="{FF2B5EF4-FFF2-40B4-BE49-F238E27FC236}">
-                <a16:creationId xmlns:a16="http://schemas.microsoft.com/office/drawing/2014/main" id="{93C467A8-2792-49EA-A6D7-B7544E4F3734}"/>
+                <a16:creationId xmlns:a16="http://schemas.microsoft.com/office/drawing/2014/main" id="{F625E8CA-5678-4E91-AB6D-7D7B21BD722C}"/>
               </a:ext>
             </a:extLst>
           </p:cNvPr>
@@ -10460,7 +10460,7 @@
           <p:cNvPr id="16" name="">
             <a:extLst xmlns:a="http://schemas.openxmlformats.org/drawingml/2006/main">
               <a:ext uri="{FF2B5EF4-FFF2-40B4-BE49-F238E27FC236}">
-                <a16:creationId xmlns:a16="http://schemas.microsoft.com/office/drawing/2014/main" id="{C13D7B20-05FF-44F3-B270-12B9DA97C46C}"/>
+                <a16:creationId xmlns:a16="http://schemas.microsoft.com/office/drawing/2014/main" id="{4F3E0836-7FF3-4147-88A0-1B0B6FBAC9C6}"/>
               </a:ext>
             </a:extLst>
           </p:cNvPr>
@@ -10517,7 +10517,7 @@
           <p:cNvPr id="17" name="">
             <a:extLst xmlns:a="http://schemas.openxmlformats.org/drawingml/2006/main">
               <a:ext uri="{FF2B5EF4-FFF2-40B4-BE49-F238E27FC236}">
-                <a16:creationId xmlns:a16="http://schemas.microsoft.com/office/drawing/2014/main" id="{1B9FCAE8-CBBB-4F15-BAFB-788354F7285F}"/>
+                <a16:creationId xmlns:a16="http://schemas.microsoft.com/office/drawing/2014/main" id="{70729957-40B0-4A76-91CA-9C04F024EF57}"/>
               </a:ext>
             </a:extLst>
           </p:cNvPr>
@@ -10552,7 +10552,7 @@
           <p:cNvPr id="18" name="">
             <a:extLst xmlns:a="http://schemas.openxmlformats.org/drawingml/2006/main">
               <a:ext uri="{FF2B5EF4-FFF2-40B4-BE49-F238E27FC236}">
-                <a16:creationId xmlns:a16="http://schemas.microsoft.com/office/drawing/2014/main" id="{C1A14AFB-1AEC-4A9D-B465-4628EFF70ACA}"/>
+                <a16:creationId xmlns:a16="http://schemas.microsoft.com/office/drawing/2014/main" id="{8F4B847C-5B5B-4F99-A539-0D3B54BC18D0}"/>
               </a:ext>
             </a:extLst>
           </p:cNvPr>
@@ -10616,7 +10616,7 @@
           <p:cNvPr id="19" name="">
             <a:extLst xmlns:a="http://schemas.openxmlformats.org/drawingml/2006/main">
               <a:ext uri="{FF2B5EF4-FFF2-40B4-BE49-F238E27FC236}">
-                <a16:creationId xmlns:a16="http://schemas.microsoft.com/office/drawing/2014/main" id="{142F1871-3FDD-4DEC-A3A4-2DE7F4CC7802}"/>
+                <a16:creationId xmlns:a16="http://schemas.microsoft.com/office/drawing/2014/main" id="{067328D4-26A1-4480-85CE-59FCAD512FF2}"/>
               </a:ext>
             </a:extLst>
           </p:cNvPr>
@@ -10673,7 +10673,7 @@
           <p:cNvPr id="20" name="">
             <a:extLst xmlns:a="http://schemas.openxmlformats.org/drawingml/2006/main">
               <a:ext uri="{FF2B5EF4-FFF2-40B4-BE49-F238E27FC236}">
-                <a16:creationId xmlns:a16="http://schemas.microsoft.com/office/drawing/2014/main" id="{839D8D05-D358-4416-8AF6-AD5A5333298D}"/>
+                <a16:creationId xmlns:a16="http://schemas.microsoft.com/office/drawing/2014/main" id="{69042EC6-9337-4D18-BCF0-5397D933023F}"/>
               </a:ext>
             </a:extLst>
           </p:cNvPr>
@@ -10708,7 +10708,7 @@
           <p:cNvPr id="21" name="">
             <a:extLst xmlns:a="http://schemas.openxmlformats.org/drawingml/2006/main">
               <a:ext uri="{FF2B5EF4-FFF2-40B4-BE49-F238E27FC236}">
-                <a16:creationId xmlns:a16="http://schemas.microsoft.com/office/drawing/2014/main" id="{FEE004C9-ACD5-446B-A5B8-50D9BB1C2529}"/>
+                <a16:creationId xmlns:a16="http://schemas.microsoft.com/office/drawing/2014/main" id="{29CC0D10-2A51-468D-8089-1977AE4AE8ED}"/>
               </a:ext>
             </a:extLst>
           </p:cNvPr>
@@ -10765,7 +10765,7 @@
           <p:cNvPr id="22" name="">
             <a:extLst xmlns:a="http://schemas.openxmlformats.org/drawingml/2006/main">
               <a:ext uri="{FF2B5EF4-FFF2-40B4-BE49-F238E27FC236}">
-                <a16:creationId xmlns:a16="http://schemas.microsoft.com/office/drawing/2014/main" id="{9C138F3C-C4DB-4B23-A8D5-E5F0EF60714C}"/>
+                <a16:creationId xmlns:a16="http://schemas.microsoft.com/office/drawing/2014/main" id="{D49E29D0-E0D4-4BC4-9F46-1A785E7288C5}"/>
               </a:ext>
             </a:extLst>
           </p:cNvPr>
@@ -10829,7 +10829,7 @@
           <p:cNvPr id="23" name="">
             <a:extLst xmlns:a="http://schemas.openxmlformats.org/drawingml/2006/main">
               <a:ext uri="{FF2B5EF4-FFF2-40B4-BE49-F238E27FC236}">
-                <a16:creationId xmlns:a16="http://schemas.microsoft.com/office/drawing/2014/main" id="{FDDFF1A8-A63A-4970-918E-52B131D4764D}"/>
+                <a16:creationId xmlns:a16="http://schemas.microsoft.com/office/drawing/2014/main" id="{432F1AC6-08DD-42F0-A8B5-07F918907F9E}"/>
               </a:ext>
             </a:extLst>
           </p:cNvPr>
@@ -10886,7 +10886,7 @@
           <p:cNvPr id="24" name="">
             <a:extLst xmlns:a="http://schemas.openxmlformats.org/drawingml/2006/main">
               <a:ext uri="{FF2B5EF4-FFF2-40B4-BE49-F238E27FC236}">
-                <a16:creationId xmlns:a16="http://schemas.microsoft.com/office/drawing/2014/main" id="{BF6B5B96-6028-4D4C-9E25-137127677B83}"/>
+                <a16:creationId xmlns:a16="http://schemas.microsoft.com/office/drawing/2014/main" id="{A894080D-8268-436C-B017-EAFBB7D44B4A}"/>
               </a:ext>
             </a:extLst>
           </p:cNvPr>
@@ -10950,7 +10950,7 @@
           <p:cNvPr id="25" name="">
             <a:extLst xmlns:a="http://schemas.openxmlformats.org/drawingml/2006/main">
               <a:ext uri="{FF2B5EF4-FFF2-40B4-BE49-F238E27FC236}">
-                <a16:creationId xmlns:a16="http://schemas.microsoft.com/office/drawing/2014/main" id="{07243428-4DC9-4F7E-90CE-7ABD2E920BFB}"/>
+                <a16:creationId xmlns:a16="http://schemas.microsoft.com/office/drawing/2014/main" id="{D46A5E37-38C2-4B90-9CEC-E71D3E7BA65B}"/>
               </a:ext>
             </a:extLst>
           </p:cNvPr>
@@ -10997,7 +10997,7 @@
                 <a:ea typeface="Arial"/>
                 <a:cs typeface="Arial"/>
               </a:rPr>
-              <a:t>80 test offline</a:t>
+              <a:t>80 test • dependency sạch</a:t>
             </a:r>
           </a:p>
         </p:txBody>
@@ -11007,7 +11007,7 @@
           <p:cNvPr id="26" name="">
             <a:extLst xmlns:a="http://schemas.openxmlformats.org/drawingml/2006/main">
               <a:ext uri="{FF2B5EF4-FFF2-40B4-BE49-F238E27FC236}">
-                <a16:creationId xmlns:a16="http://schemas.microsoft.com/office/drawing/2014/main" id="{86CBABCF-2129-4C5F-B2E7-5ED3C47741B9}"/>
+                <a16:creationId xmlns:a16="http://schemas.microsoft.com/office/drawing/2014/main" id="{DFB39F87-526F-479A-8DC9-505071FE628B}"/>
               </a:ext>
             </a:extLst>
           </p:cNvPr>
@@ -11071,7 +11071,7 @@
           <p:cNvPr id="27" name="">
             <a:extLst xmlns:a="http://schemas.openxmlformats.org/drawingml/2006/main">
               <a:ext uri="{FF2B5EF4-FFF2-40B4-BE49-F238E27FC236}">
-                <a16:creationId xmlns:a16="http://schemas.microsoft.com/office/drawing/2014/main" id="{0EAAE57E-04CB-4C64-9538-ED5B212DD0F6}"/>
+                <a16:creationId xmlns:a16="http://schemas.microsoft.com/office/drawing/2014/main" id="{80A86D24-742A-4B0A-87B3-CBC52A0C148B}"/>
               </a:ext>
             </a:extLst>
           </p:cNvPr>
@@ -11118,7 +11118,7 @@
                 <a:ea typeface="Arial"/>
                 <a:cs typeface="Arial"/>
               </a:rPr>
-              <a:t>15/15 OR • 25/25 local</a:t>
+              <a:t>Evaluator 15/30 ngoài UI</a:t>
             </a:r>
           </a:p>
         </p:txBody>
@@ -11128,7 +11128,7 @@
           <p:cNvPr id="28" name="">
             <a:extLst xmlns:a="http://schemas.openxmlformats.org/drawingml/2006/main">
               <a:ext uri="{FF2B5EF4-FFF2-40B4-BE49-F238E27FC236}">
-                <a16:creationId xmlns:a16="http://schemas.microsoft.com/office/drawing/2014/main" id="{3EEC0573-6485-4D4B-9A80-B5C546A2B188}"/>
+                <a16:creationId xmlns:a16="http://schemas.microsoft.com/office/drawing/2014/main" id="{D7E74F18-1BE2-4D0D-8DDE-1E85D98FCDC5}"/>
               </a:ext>
             </a:extLst>
           </p:cNvPr>
@@ -11192,7 +11192,7 @@
           <p:cNvPr id="29" name="">
             <a:extLst xmlns:a="http://schemas.openxmlformats.org/drawingml/2006/main">
               <a:ext uri="{FF2B5EF4-FFF2-40B4-BE49-F238E27FC236}">
-                <a16:creationId xmlns:a16="http://schemas.microsoft.com/office/drawing/2014/main" id="{E8E309E7-F1CE-41B1-B92B-75FAD17B73E5}"/>
+                <a16:creationId xmlns:a16="http://schemas.microsoft.com/office/drawing/2014/main" id="{EBBD8CCC-A61F-4999-B353-1BF75768EAF7}"/>
               </a:ext>
             </a:extLst>
           </p:cNvPr>
@@ -11249,7 +11249,7 @@
           <p:cNvPr id="30" name="">
             <a:extLst xmlns:a="http://schemas.openxmlformats.org/drawingml/2006/main">
               <a:ext uri="{FF2B5EF4-FFF2-40B4-BE49-F238E27FC236}">
-                <a16:creationId xmlns:a16="http://schemas.microsoft.com/office/drawing/2014/main" id="{D39F1673-3D59-4B6C-8FE5-3DA8A10F8116}"/>
+                <a16:creationId xmlns:a16="http://schemas.microsoft.com/office/drawing/2014/main" id="{149C2A80-5F04-4625-8A77-329837B3CE90}"/>
               </a:ext>
             </a:extLst>
           </p:cNvPr>
@@ -11284,7 +11284,7 @@
           <p:cNvPr id="31" name="">
             <a:extLst xmlns:a="http://schemas.openxmlformats.org/drawingml/2006/main">
               <a:ext uri="{FF2B5EF4-FFF2-40B4-BE49-F238E27FC236}">
-                <a16:creationId xmlns:a16="http://schemas.microsoft.com/office/drawing/2014/main" id="{BCA4B6C8-5930-4AF6-8DE8-1FE24117355F}"/>
+                <a16:creationId xmlns:a16="http://schemas.microsoft.com/office/drawing/2014/main" id="{9BC73C9F-02D7-4AD7-BCD7-13325F1BB017}"/>
               </a:ext>
             </a:extLst>
           </p:cNvPr>
@@ -11341,7 +11341,7 @@
           <p:cNvPr id="32" name="">
             <a:extLst xmlns:a="http://schemas.openxmlformats.org/drawingml/2006/main">
               <a:ext uri="{FF2B5EF4-FFF2-40B4-BE49-F238E27FC236}">
-                <a16:creationId xmlns:a16="http://schemas.microsoft.com/office/drawing/2014/main" id="{E8D7F4CD-788E-4631-BE9C-E9F955F0F0AE}"/>
+                <a16:creationId xmlns:a16="http://schemas.microsoft.com/office/drawing/2014/main" id="{7332533A-452E-4B01-AA6C-FA2693039C1E}"/>
               </a:ext>
             </a:extLst>
           </p:cNvPr>
@@ -11444,7 +11444,7 @@
           <p:cNvPr id="33" name="">
             <a:extLst xmlns:a="http://schemas.openxmlformats.org/drawingml/2006/main">
               <a:ext uri="{FF2B5EF4-FFF2-40B4-BE49-F238E27FC236}">
-                <a16:creationId xmlns:a16="http://schemas.microsoft.com/office/drawing/2014/main" id="{BF7CB6F2-7F57-46F2-A1B7-FA2EE3E87DC8}"/>
+                <a16:creationId xmlns:a16="http://schemas.microsoft.com/office/drawing/2014/main" id="{A1402768-0258-443F-9636-8DCBBB1D1704}"/>
               </a:ext>
             </a:extLst>
           </p:cNvPr>
@@ -11491,7 +11491,7 @@
                 <a:ea typeface="Arial"/>
                 <a:cs typeface="Arial"/>
               </a:rPr>
-              <a:t>Verify vẫn đúng 5 ca BTC; fallback phải tắt khi benchmark từng provider.</a:t>
+              <a:t>Verify vẫn đúng 5 ca BTC; runner mở rộng không làm rối dashboard.</a:t>
             </a:r>
           </a:p>
         </p:txBody>
@@ -11501,7 +11501,7 @@
           <p:cNvPr id="34" name="">
             <a:extLst xmlns:a="http://schemas.openxmlformats.org/drawingml/2006/main">
               <a:ext uri="{FF2B5EF4-FFF2-40B4-BE49-F238E27FC236}">
-                <a16:creationId xmlns:a16="http://schemas.microsoft.com/office/drawing/2014/main" id="{FA399DBA-7C42-4F92-8B87-9CD9FF505F5E}"/>
+                <a16:creationId xmlns:a16="http://schemas.microsoft.com/office/drawing/2014/main" id="{4F4BBD86-A5FC-486E-9C56-3D60A31C9191}"/>
               </a:ext>
             </a:extLst>
           </p:cNvPr>
@@ -11558,7 +11558,7 @@
           <p:cNvPr id="35" name="">
             <a:extLst xmlns:a="http://schemas.openxmlformats.org/drawingml/2006/main">
               <a:ext uri="{FF2B5EF4-FFF2-40B4-BE49-F238E27FC236}">
-                <a16:creationId xmlns:a16="http://schemas.microsoft.com/office/drawing/2014/main" id="{C49EE0CF-AF8E-42E8-95BC-4DF36E9FAF4F}"/>
+                <a16:creationId xmlns:a16="http://schemas.microsoft.com/office/drawing/2014/main" id="{97631999-5C6F-4265-B7C6-16CB3E48BB33}"/>
               </a:ext>
             </a:extLst>
           </p:cNvPr>
@@ -11613,7 +11613,7 @@
     </p:spTree>
     <p:extLst>
       <p:ext uri="{BB962C8B-B14F-4D97-AF65-F5344CB8AC3E}">
-        <p14:creationId xmlns:p14="http://schemas.microsoft.com/office/powerpoint/2010/main" val="255517678"/>
+        <p14:creationId xmlns:p14="http://schemas.microsoft.com/office/powerpoint/2010/main" val="1738193066"/>
       </p:ext>
     </p:extLst>
   </p:cSld>

</xml_diff>

<commit_message>
docs: align submission with demo readiness
</commit_message>
<xml_diff>
--- a/AURA/submission/AURA_5_SLIDES.pptx
+++ b/AURA/submission/AURA_5_SLIDES.pptx
@@ -2,17 +2,17 @@
 <file path=ppt/presentation.xml><?xml version="1.0" encoding="utf-8"?>
 <p:presentation xmlns:p="http://schemas.openxmlformats.org/presentationml/2006/main">
   <p:sldMasterIdLst>
-    <p:sldMasterId xmlns:r="http://schemas.openxmlformats.org/officeDocument/2006/relationships" id="2147483648" r:id="R8dbcd48ae31440cf"/>
+    <p:sldMasterId xmlns:r="http://schemas.openxmlformats.org/officeDocument/2006/relationships" id="2147483648" r:id="R9e7193389c4c479f"/>
   </p:sldMasterIdLst>
   <p:notesMasterIdLst>
-    <p:notesMasterId xmlns:r="http://schemas.openxmlformats.org/officeDocument/2006/relationships" r:id="Rf69c1baef6e94e25"/>
+    <p:notesMasterId xmlns:r="http://schemas.openxmlformats.org/officeDocument/2006/relationships" r:id="Rfba7543f2a224346"/>
   </p:notesMasterIdLst>
   <p:sldIdLst>
-    <p:sldId xmlns:r="http://schemas.openxmlformats.org/officeDocument/2006/relationships" id="256" r:id="Rdb068fec59674faf"/>
-    <p:sldId xmlns:r="http://schemas.openxmlformats.org/officeDocument/2006/relationships" id="257" r:id="R7926e257b98c427b"/>
-    <p:sldId xmlns:r="http://schemas.openxmlformats.org/officeDocument/2006/relationships" id="258" r:id="Re6c7db2d3e6b4902"/>
-    <p:sldId xmlns:r="http://schemas.openxmlformats.org/officeDocument/2006/relationships" id="259" r:id="Ra7916086c67742f9"/>
-    <p:sldId xmlns:r="http://schemas.openxmlformats.org/officeDocument/2006/relationships" id="260" r:id="R0627b5e26e0a4d06"/>
+    <p:sldId xmlns:r="http://schemas.openxmlformats.org/officeDocument/2006/relationships" id="256" r:id="R444b5d8215c843a4"/>
+    <p:sldId xmlns:r="http://schemas.openxmlformats.org/officeDocument/2006/relationships" id="257" r:id="Rcad3797ea7e947bf"/>
+    <p:sldId xmlns:r="http://schemas.openxmlformats.org/officeDocument/2006/relationships" id="258" r:id="R058fd522820b4899"/>
+    <p:sldId xmlns:r="http://schemas.openxmlformats.org/officeDocument/2006/relationships" id="259" r:id="R9dd385b2feae4e4f"/>
+    <p:sldId xmlns:r="http://schemas.openxmlformats.org/officeDocument/2006/relationships" id="260" r:id="Rdd6f2d6b3eac404a"/>
   </p:sldIdLst>
   <p:sldSz cx="12192000" cy="6858000"/>
   <p:notesSz cx="6858000" cy="9144000"/>
@@ -586,7 +586,7 @@
           <a:lstStyle xmlns:a="http://schemas.openxmlformats.org/drawingml/2006/main"/>
           <a:p xmlns:a="http://schemas.openxmlformats.org/drawingml/2006/main">
             <a:r>
-              <a:t>Nguồn nội bộ ngày 28/09/2026: 80 test offline; benchmark model ngày 27/09 ghi OpenRouter 8B đạt 15/15 qua ba batch, adjusted P95 11,317 giây và Ollama 4B đạt 25/25 qua năm batch trên cùng 5 fixture tổng hợp. Không suy rộng thành accuracy thực tế.</a:t>
+              <a:t>Nguồn nội bộ ngày 29/09/2026: 88 test offline. Trên cùng judge set 15 ca và fallback tắt, OpenRouter 8B đạt 15/15 quyết định, 70/75 field, P95 16,459 giây; Ollama 4B đạt 14/15, 73/75 field, P95 58,318 giây và bỏ sót escalation TK-12. Đây là regression trên dữ liệu tổng hợp, không phải accuracy thực tế.</a:t>
             </a:r>
           </a:p>
         </p:txBody>
@@ -794,7 +794,7 @@
   </p:cSld>
   <p:clrMap bg1="lt1" tx1="dk1" bg2="lt2" tx2="dk2" accent1="accent1" accent2="accent2" accent3="accent3" accent4="accent4" accent5="accent5" accent6="accent6" hlink="hlink" folHlink="folHlink"/>
   <p:sldLayoutIdLst>
-    <p:sldLayoutId xmlns:r="http://schemas.openxmlformats.org/officeDocument/2006/relationships" id="2147483649" r:id="Recc014f5756e4297"/>
+    <p:sldLayoutId xmlns:r="http://schemas.openxmlformats.org/officeDocument/2006/relationships" id="2147483649" r:id="Rda69367881ac4482"/>
   </p:sldLayoutIdLst>
   <p:txStyles>
     <p:titleStyle>
@@ -1345,19 +1345,19 @@
           <p:cNvPr id="47" name="">
             <a:extLst xmlns:a="http://schemas.openxmlformats.org/drawingml/2006/main">
               <a:ext uri="{FF2B5EF4-FFF2-40B4-BE49-F238E27FC236}">
-                <a16:creationId xmlns:a16="http://schemas.microsoft.com/office/drawing/2014/main" id="{04E954BC-4B83-41FA-BE98-80AB8CCF0257}"/>
-              </a:ext>
-            </a:extLst>
-          </p:cNvPr>
-          <p:cNvSpPr>
-            <a:spLocks xmlns:a="http://schemas.openxmlformats.org/drawingml/2006/main" noGrp="1"/>
-          </p:cNvSpPr>
-          <p:nvPr/>
-        </p:nvSpPr>
-        <p:spPr>
-          <a:xfrm xmlns:a="http://schemas.openxmlformats.org/drawingml/2006/main">
-            <a:off x="514350" y="361950"/>
-            <a:ext cx="514350" cy="323850"/>
+                <a16:creationId xmlns:a16="http://schemas.microsoft.com/office/drawing/2014/main" id="{A9D3DD7C-AB40-45FF-9C5C-A1A1ABDE6211}"/>
+              </a:ext>
+            </a:extLst>
+          </p:cNvPr>
+          <p:cNvSpPr>
+            <a:spLocks xmlns:a="http://schemas.openxmlformats.org/drawingml/2006/main" noGrp="1"/>
+          </p:cNvSpPr>
+          <p:nvPr/>
+        </p:nvSpPr>
+        <p:spPr>
+          <a:xfrm xmlns:a="http://schemas.openxmlformats.org/drawingml/2006/main">
+            <a:off x="476250" y="361950"/>
+            <a:ext cx="647700" cy="323850"/>
           </a:xfrm>
           <a:prstGeom xmlns:a="http://schemas.openxmlformats.org/drawingml/2006/main" prst="rect">
             <a:avLst/>
@@ -1402,7 +1402,7 @@
           <p:cNvPr id="2" name="">
             <a:extLst xmlns:a="http://schemas.openxmlformats.org/drawingml/2006/main">
               <a:ext uri="{FF2B5EF4-FFF2-40B4-BE49-F238E27FC236}">
-                <a16:creationId xmlns:a16="http://schemas.microsoft.com/office/drawing/2014/main" id="{D2DA4915-CED4-451E-BE5F-59A4405C0BBA}"/>
+                <a16:creationId xmlns:a16="http://schemas.microsoft.com/office/drawing/2014/main" id="{B14C883B-9F82-42C5-97DE-9A2C5C7BF395}"/>
               </a:ext>
             </a:extLst>
           </p:cNvPr>
@@ -1459,7 +1459,7 @@
           <p:cNvPr id="3" name="">
             <a:extLst xmlns:a="http://schemas.openxmlformats.org/drawingml/2006/main">
               <a:ext uri="{FF2B5EF4-FFF2-40B4-BE49-F238E27FC236}">
-                <a16:creationId xmlns:a16="http://schemas.microsoft.com/office/drawing/2014/main" id="{22BBF3BC-D672-43D1-AB69-E7783BD5CD85}"/>
+                <a16:creationId xmlns:a16="http://schemas.microsoft.com/office/drawing/2014/main" id="{2ACF1AD1-832E-4828-A54E-E602C33C18A5}"/>
               </a:ext>
             </a:extLst>
           </p:cNvPr>
@@ -1516,7 +1516,7 @@
           <p:cNvPr id="4" name="">
             <a:extLst xmlns:a="http://schemas.openxmlformats.org/drawingml/2006/main">
               <a:ext uri="{FF2B5EF4-FFF2-40B4-BE49-F238E27FC236}">
-                <a16:creationId xmlns:a16="http://schemas.microsoft.com/office/drawing/2014/main" id="{73A00C70-262E-4988-B228-5A596225A3ED}"/>
+                <a16:creationId xmlns:a16="http://schemas.microsoft.com/office/drawing/2014/main" id="{D80B92E6-E58F-4E63-90DA-06E0EE4F56EF}"/>
               </a:ext>
             </a:extLst>
           </p:cNvPr>
@@ -1547,7 +1547,7 @@
           <p:cNvPr id="5" name="">
             <a:extLst xmlns:a="http://schemas.openxmlformats.org/drawingml/2006/main">
               <a:ext uri="{FF2B5EF4-FFF2-40B4-BE49-F238E27FC236}">
-                <a16:creationId xmlns:a16="http://schemas.microsoft.com/office/drawing/2014/main" id="{198A3320-F627-43B0-B180-D44E94D9F8A5}"/>
+                <a16:creationId xmlns:a16="http://schemas.microsoft.com/office/drawing/2014/main" id="{07409AF2-B64A-4FC9-8BCA-194AA041423F}"/>
               </a:ext>
             </a:extLst>
           </p:cNvPr>
@@ -1582,7 +1582,7 @@
           <p:cNvPr id="6" name="">
             <a:extLst xmlns:a="http://schemas.openxmlformats.org/drawingml/2006/main">
               <a:ext uri="{FF2B5EF4-FFF2-40B4-BE49-F238E27FC236}">
-                <a16:creationId xmlns:a16="http://schemas.microsoft.com/office/drawing/2014/main" id="{CAADD83A-6763-4021-AAAC-F6CA9A5D480D}"/>
+                <a16:creationId xmlns:a16="http://schemas.microsoft.com/office/drawing/2014/main" id="{0D34F22A-B4E5-4371-B6DB-E55046191767}"/>
               </a:ext>
             </a:extLst>
           </p:cNvPr>
@@ -1646,7 +1646,7 @@
           <p:cNvPr id="7" name="">
             <a:extLst xmlns:a="http://schemas.openxmlformats.org/drawingml/2006/main">
               <a:ext uri="{FF2B5EF4-FFF2-40B4-BE49-F238E27FC236}">
-                <a16:creationId xmlns:a16="http://schemas.microsoft.com/office/drawing/2014/main" id="{63E9BFF4-5E7F-485C-BC02-12595C469B95}"/>
+                <a16:creationId xmlns:a16="http://schemas.microsoft.com/office/drawing/2014/main" id="{3AA2E305-F3CA-42C8-AA0F-823ABDD7D193}"/>
               </a:ext>
             </a:extLst>
           </p:cNvPr>
@@ -1703,7 +1703,7 @@
           <p:cNvPr id="8" name="">
             <a:extLst xmlns:a="http://schemas.openxmlformats.org/drawingml/2006/main">
               <a:ext uri="{FF2B5EF4-FFF2-40B4-BE49-F238E27FC236}">
-                <a16:creationId xmlns:a16="http://schemas.microsoft.com/office/drawing/2014/main" id="{AE5D8E86-0D23-475E-B607-5B24C61CB66E}"/>
+                <a16:creationId xmlns:a16="http://schemas.microsoft.com/office/drawing/2014/main" id="{96DFA13C-4D28-421F-930C-4DA473082837}"/>
               </a:ext>
             </a:extLst>
           </p:cNvPr>
@@ -1760,7 +1760,7 @@
           <p:cNvPr id="9" name="">
             <a:extLst xmlns:a="http://schemas.openxmlformats.org/drawingml/2006/main">
               <a:ext uri="{FF2B5EF4-FFF2-40B4-BE49-F238E27FC236}">
-                <a16:creationId xmlns:a16="http://schemas.microsoft.com/office/drawing/2014/main" id="{20BBA6AE-25B7-443F-82D4-AD8F886BA5AD}"/>
+                <a16:creationId xmlns:a16="http://schemas.microsoft.com/office/drawing/2014/main" id="{12272AB9-EA50-46C7-A3A1-E69D50CD828D}"/>
               </a:ext>
             </a:extLst>
           </p:cNvPr>
@@ -1792,7 +1792,7 @@
           <p:cNvPr id="10" name="">
             <a:extLst xmlns:a="http://schemas.openxmlformats.org/drawingml/2006/main">
               <a:ext uri="{FF2B5EF4-FFF2-40B4-BE49-F238E27FC236}">
-                <a16:creationId xmlns:a16="http://schemas.microsoft.com/office/drawing/2014/main" id="{AF0C7324-AF47-4731-BCCD-01737C084BB7}"/>
+                <a16:creationId xmlns:a16="http://schemas.microsoft.com/office/drawing/2014/main" id="{C6F56CF6-0E19-4709-AFAF-A22CA5F14DCD}"/>
               </a:ext>
             </a:extLst>
           </p:cNvPr>
@@ -1827,7 +1827,7 @@
           <p:cNvPr id="11" name="">
             <a:extLst xmlns:a="http://schemas.openxmlformats.org/drawingml/2006/main">
               <a:ext uri="{FF2B5EF4-FFF2-40B4-BE49-F238E27FC236}">
-                <a16:creationId xmlns:a16="http://schemas.microsoft.com/office/drawing/2014/main" id="{B9F0311C-D2A5-4DBB-930D-3EE573131351}"/>
+                <a16:creationId xmlns:a16="http://schemas.microsoft.com/office/drawing/2014/main" id="{4A9F99B2-35BD-4351-8C8F-557DD3E6D27A}"/>
               </a:ext>
             </a:extLst>
           </p:cNvPr>
@@ -1891,7 +1891,7 @@
           <p:cNvPr id="12" name="">
             <a:extLst xmlns:a="http://schemas.openxmlformats.org/drawingml/2006/main">
               <a:ext uri="{FF2B5EF4-FFF2-40B4-BE49-F238E27FC236}">
-                <a16:creationId xmlns:a16="http://schemas.microsoft.com/office/drawing/2014/main" id="{09F0CC81-DC54-44F6-B963-CFBE082AAEC8}"/>
+                <a16:creationId xmlns:a16="http://schemas.microsoft.com/office/drawing/2014/main" id="{6F30783E-EA33-44A7-93FD-D3F6666BBEA9}"/>
               </a:ext>
             </a:extLst>
           </p:cNvPr>
@@ -1948,7 +1948,7 @@
           <p:cNvPr id="13" name="">
             <a:extLst xmlns:a="http://schemas.openxmlformats.org/drawingml/2006/main">
               <a:ext uri="{FF2B5EF4-FFF2-40B4-BE49-F238E27FC236}">
-                <a16:creationId xmlns:a16="http://schemas.microsoft.com/office/drawing/2014/main" id="{5E733F93-F759-444B-90B0-27CD4353E611}"/>
+                <a16:creationId xmlns:a16="http://schemas.microsoft.com/office/drawing/2014/main" id="{B3B11663-267D-46D1-B6C3-4FE6BB6DE4A0}"/>
               </a:ext>
             </a:extLst>
           </p:cNvPr>
@@ -2005,7 +2005,7 @@
           <p:cNvPr id="14" name="">
             <a:extLst xmlns:a="http://schemas.openxmlformats.org/drawingml/2006/main">
               <a:ext uri="{FF2B5EF4-FFF2-40B4-BE49-F238E27FC236}">
-                <a16:creationId xmlns:a16="http://schemas.microsoft.com/office/drawing/2014/main" id="{5D767604-61CF-4FF3-8656-9D142EF2B021}"/>
+                <a16:creationId xmlns:a16="http://schemas.microsoft.com/office/drawing/2014/main" id="{914118FC-E3BB-450F-A7D0-A4346A63B6BE}"/>
               </a:ext>
             </a:extLst>
           </p:cNvPr>
@@ -2037,7 +2037,7 @@
           <p:cNvPr id="15" name="">
             <a:extLst xmlns:a="http://schemas.openxmlformats.org/drawingml/2006/main">
               <a:ext uri="{FF2B5EF4-FFF2-40B4-BE49-F238E27FC236}">
-                <a16:creationId xmlns:a16="http://schemas.microsoft.com/office/drawing/2014/main" id="{8B437931-18A8-4CD7-9B52-D626689A60BC}"/>
+                <a16:creationId xmlns:a16="http://schemas.microsoft.com/office/drawing/2014/main" id="{4319B866-DDDE-46A3-83D0-C6075CAD2E63}"/>
               </a:ext>
             </a:extLst>
           </p:cNvPr>
@@ -2072,7 +2072,7 @@
           <p:cNvPr id="16" name="">
             <a:extLst xmlns:a="http://schemas.openxmlformats.org/drawingml/2006/main">
               <a:ext uri="{FF2B5EF4-FFF2-40B4-BE49-F238E27FC236}">
-                <a16:creationId xmlns:a16="http://schemas.microsoft.com/office/drawing/2014/main" id="{C88770A4-D0F2-4D1D-96C4-1ADD9F190AED}"/>
+                <a16:creationId xmlns:a16="http://schemas.microsoft.com/office/drawing/2014/main" id="{8CC895C2-1DBA-4746-9417-687FAAC53848}"/>
               </a:ext>
             </a:extLst>
           </p:cNvPr>
@@ -2136,7 +2136,7 @@
           <p:cNvPr id="17" name="">
             <a:extLst xmlns:a="http://schemas.openxmlformats.org/drawingml/2006/main">
               <a:ext uri="{FF2B5EF4-FFF2-40B4-BE49-F238E27FC236}">
-                <a16:creationId xmlns:a16="http://schemas.microsoft.com/office/drawing/2014/main" id="{7FBAB8B4-81A6-4132-A6AA-16B4947AD057}"/>
+                <a16:creationId xmlns:a16="http://schemas.microsoft.com/office/drawing/2014/main" id="{3794DD8C-C792-4CAF-952C-7DA032A32826}"/>
               </a:ext>
             </a:extLst>
           </p:cNvPr>
@@ -2193,7 +2193,7 @@
           <p:cNvPr id="18" name="">
             <a:extLst xmlns:a="http://schemas.openxmlformats.org/drawingml/2006/main">
               <a:ext uri="{FF2B5EF4-FFF2-40B4-BE49-F238E27FC236}">
-                <a16:creationId xmlns:a16="http://schemas.microsoft.com/office/drawing/2014/main" id="{622002EE-F5C3-4EC7-B4A0-9582336519A6}"/>
+                <a16:creationId xmlns:a16="http://schemas.microsoft.com/office/drawing/2014/main" id="{36B63EBD-E08B-49C8-B007-65157047A159}"/>
               </a:ext>
             </a:extLst>
           </p:cNvPr>
@@ -2250,7 +2250,7 @@
           <p:cNvPr id="19" name="">
             <a:extLst xmlns:a="http://schemas.openxmlformats.org/drawingml/2006/main">
               <a:ext uri="{FF2B5EF4-FFF2-40B4-BE49-F238E27FC236}">
-                <a16:creationId xmlns:a16="http://schemas.microsoft.com/office/drawing/2014/main" id="{3A4E9743-A896-4F7F-996E-9581092069A4}"/>
+                <a16:creationId xmlns:a16="http://schemas.microsoft.com/office/drawing/2014/main" id="{686798EA-0BD9-484A-96C3-B705D6EED67D}"/>
               </a:ext>
             </a:extLst>
           </p:cNvPr>
@@ -2282,7 +2282,7 @@
           <p:cNvPr id="20" name="">
             <a:extLst xmlns:a="http://schemas.openxmlformats.org/drawingml/2006/main">
               <a:ext uri="{FF2B5EF4-FFF2-40B4-BE49-F238E27FC236}">
-                <a16:creationId xmlns:a16="http://schemas.microsoft.com/office/drawing/2014/main" id="{890C3043-AA79-467C-B937-BBCB5B9E7DB4}"/>
+                <a16:creationId xmlns:a16="http://schemas.microsoft.com/office/drawing/2014/main" id="{4DA1CFD3-CBDC-4057-AA08-097069D80B44}"/>
               </a:ext>
             </a:extLst>
           </p:cNvPr>
@@ -2317,7 +2317,7 @@
           <p:cNvPr id="21" name="">
             <a:extLst xmlns:a="http://schemas.openxmlformats.org/drawingml/2006/main">
               <a:ext uri="{FF2B5EF4-FFF2-40B4-BE49-F238E27FC236}">
-                <a16:creationId xmlns:a16="http://schemas.microsoft.com/office/drawing/2014/main" id="{CE451EF7-A920-4EC9-A716-D1028F8D026B}"/>
+                <a16:creationId xmlns:a16="http://schemas.microsoft.com/office/drawing/2014/main" id="{A42C4FBA-A8D8-463D-B314-4C6E78473E77}"/>
               </a:ext>
             </a:extLst>
           </p:cNvPr>
@@ -2381,7 +2381,7 @@
           <p:cNvPr id="22" name="">
             <a:extLst xmlns:a="http://schemas.openxmlformats.org/drawingml/2006/main">
               <a:ext uri="{FF2B5EF4-FFF2-40B4-BE49-F238E27FC236}">
-                <a16:creationId xmlns:a16="http://schemas.microsoft.com/office/drawing/2014/main" id="{B0B7A445-6E87-4720-B935-F505730D08B7}"/>
+                <a16:creationId xmlns:a16="http://schemas.microsoft.com/office/drawing/2014/main" id="{D774019D-AEDE-4140-8AE9-7DDBA272E526}"/>
               </a:ext>
             </a:extLst>
           </p:cNvPr>
@@ -2438,7 +2438,7 @@
           <p:cNvPr id="23" name="">
             <a:extLst xmlns:a="http://schemas.openxmlformats.org/drawingml/2006/main">
               <a:ext uri="{FF2B5EF4-FFF2-40B4-BE49-F238E27FC236}">
-                <a16:creationId xmlns:a16="http://schemas.microsoft.com/office/drawing/2014/main" id="{7815F6A8-9506-494D-9404-E92AA429E2FF}"/>
+                <a16:creationId xmlns:a16="http://schemas.microsoft.com/office/drawing/2014/main" id="{D3DEC7F0-88C1-4D66-938E-9824F0E61B41}"/>
               </a:ext>
             </a:extLst>
           </p:cNvPr>
@@ -2495,7 +2495,7 @@
           <p:cNvPr id="24" name="">
             <a:extLst xmlns:a="http://schemas.openxmlformats.org/drawingml/2006/main">
               <a:ext uri="{FF2B5EF4-FFF2-40B4-BE49-F238E27FC236}">
-                <a16:creationId xmlns:a16="http://schemas.microsoft.com/office/drawing/2014/main" id="{FB054566-C47C-401D-85F3-5545BA155F0B}"/>
+                <a16:creationId xmlns:a16="http://schemas.microsoft.com/office/drawing/2014/main" id="{A1F92B6B-E025-40EC-8C2A-7DFDAEEF17A7}"/>
               </a:ext>
             </a:extLst>
           </p:cNvPr>
@@ -2527,7 +2527,7 @@
           <p:cNvPr id="25" name="">
             <a:extLst xmlns:a="http://schemas.openxmlformats.org/drawingml/2006/main">
               <a:ext uri="{FF2B5EF4-FFF2-40B4-BE49-F238E27FC236}">
-                <a16:creationId xmlns:a16="http://schemas.microsoft.com/office/drawing/2014/main" id="{2C4D73AD-2460-4FE9-AD34-34D0586489DB}"/>
+                <a16:creationId xmlns:a16="http://schemas.microsoft.com/office/drawing/2014/main" id="{30815BA1-7720-454C-A17E-7B12535128E7}"/>
               </a:ext>
             </a:extLst>
           </p:cNvPr>
@@ -2562,7 +2562,7 @@
           <p:cNvPr id="26" name="">
             <a:extLst xmlns:a="http://schemas.openxmlformats.org/drawingml/2006/main">
               <a:ext uri="{FF2B5EF4-FFF2-40B4-BE49-F238E27FC236}">
-                <a16:creationId xmlns:a16="http://schemas.microsoft.com/office/drawing/2014/main" id="{6C9137E8-3846-44C3-AC30-57B5A84176EE}"/>
+                <a16:creationId xmlns:a16="http://schemas.microsoft.com/office/drawing/2014/main" id="{7BF1CC40-C2FB-4D9C-B597-3632E21C9E95}"/>
               </a:ext>
             </a:extLst>
           </p:cNvPr>
@@ -2626,7 +2626,7 @@
           <p:cNvPr id="27" name="">
             <a:extLst xmlns:a="http://schemas.openxmlformats.org/drawingml/2006/main">
               <a:ext uri="{FF2B5EF4-FFF2-40B4-BE49-F238E27FC236}">
-                <a16:creationId xmlns:a16="http://schemas.microsoft.com/office/drawing/2014/main" id="{90E946AE-7DB7-4772-810F-944D2C677DAE}"/>
+                <a16:creationId xmlns:a16="http://schemas.microsoft.com/office/drawing/2014/main" id="{8EECFBFC-C4CE-462C-8E65-1B8FA8F2596F}"/>
               </a:ext>
             </a:extLst>
           </p:cNvPr>
@@ -2683,7 +2683,7 @@
           <p:cNvPr id="28" name="">
             <a:extLst xmlns:a="http://schemas.openxmlformats.org/drawingml/2006/main">
               <a:ext uri="{FF2B5EF4-FFF2-40B4-BE49-F238E27FC236}">
-                <a16:creationId xmlns:a16="http://schemas.microsoft.com/office/drawing/2014/main" id="{D9262CF1-ACC3-4412-90DD-93FB9B6F87C5}"/>
+                <a16:creationId xmlns:a16="http://schemas.microsoft.com/office/drawing/2014/main" id="{AD6EFCB5-BB9B-4BC6-BCC9-00068898F325}"/>
               </a:ext>
             </a:extLst>
           </p:cNvPr>
@@ -2740,7 +2740,7 @@
           <p:cNvPr id="29" name="">
             <a:extLst xmlns:a="http://schemas.openxmlformats.org/drawingml/2006/main">
               <a:ext uri="{FF2B5EF4-FFF2-40B4-BE49-F238E27FC236}">
-                <a16:creationId xmlns:a16="http://schemas.microsoft.com/office/drawing/2014/main" id="{F1D69133-2759-4E37-B91D-AFAE61C5F3CD}"/>
+                <a16:creationId xmlns:a16="http://schemas.microsoft.com/office/drawing/2014/main" id="{3A1C41CC-F1FC-4BD0-AF0D-8D843AB434A1}"/>
               </a:ext>
             </a:extLst>
           </p:cNvPr>
@@ -2775,7 +2775,7 @@
           <p:cNvPr id="30" name="">
             <a:extLst xmlns:a="http://schemas.openxmlformats.org/drawingml/2006/main">
               <a:ext uri="{FF2B5EF4-FFF2-40B4-BE49-F238E27FC236}">
-                <a16:creationId xmlns:a16="http://schemas.microsoft.com/office/drawing/2014/main" id="{954F7157-F32C-45D2-A7E6-0857D095C1A2}"/>
+                <a16:creationId xmlns:a16="http://schemas.microsoft.com/office/drawing/2014/main" id="{43B797F0-54BA-45DB-A22A-A46935985E17}"/>
               </a:ext>
             </a:extLst>
           </p:cNvPr>
@@ -2832,7 +2832,7 @@
           <p:cNvPr id="31" name="">
             <a:extLst xmlns:a="http://schemas.openxmlformats.org/drawingml/2006/main">
               <a:ext uri="{FF2B5EF4-FFF2-40B4-BE49-F238E27FC236}">
-                <a16:creationId xmlns:a16="http://schemas.microsoft.com/office/drawing/2014/main" id="{A54340C4-8552-4677-BA34-B7AB8F1B6B89}"/>
+                <a16:creationId xmlns:a16="http://schemas.microsoft.com/office/drawing/2014/main" id="{08EE402C-8437-466A-A04B-E2E197C6D53E}"/>
               </a:ext>
             </a:extLst>
           </p:cNvPr>
@@ -2889,7 +2889,7 @@
           <p:cNvPr id="32" name="">
             <a:extLst xmlns:a="http://schemas.openxmlformats.org/drawingml/2006/main">
               <a:ext uri="{FF2B5EF4-FFF2-40B4-BE49-F238E27FC236}">
-                <a16:creationId xmlns:a16="http://schemas.microsoft.com/office/drawing/2014/main" id="{A6160FC1-A261-4D0F-887B-204626DE4F16}"/>
+                <a16:creationId xmlns:a16="http://schemas.microsoft.com/office/drawing/2014/main" id="{282570A2-D7D0-409B-87AA-EB4E4FBB33A5}"/>
               </a:ext>
             </a:extLst>
           </p:cNvPr>
@@ -2946,7 +2946,7 @@
           <p:cNvPr id="33" name="">
             <a:extLst xmlns:a="http://schemas.openxmlformats.org/drawingml/2006/main">
               <a:ext uri="{FF2B5EF4-FFF2-40B4-BE49-F238E27FC236}">
-                <a16:creationId xmlns:a16="http://schemas.microsoft.com/office/drawing/2014/main" id="{58C3B264-0500-401A-9121-25949BE8C613}"/>
+                <a16:creationId xmlns:a16="http://schemas.microsoft.com/office/drawing/2014/main" id="{06EB1464-4294-44EB-9A11-CEA2A2E92F9D}"/>
               </a:ext>
             </a:extLst>
           </p:cNvPr>
@@ -2981,7 +2981,7 @@
           <p:cNvPr id="34" name="">
             <a:extLst xmlns:a="http://schemas.openxmlformats.org/drawingml/2006/main">
               <a:ext uri="{FF2B5EF4-FFF2-40B4-BE49-F238E27FC236}">
-                <a16:creationId xmlns:a16="http://schemas.microsoft.com/office/drawing/2014/main" id="{4AC9581A-890F-4C22-9DE4-B013386B309D}"/>
+                <a16:creationId xmlns:a16="http://schemas.microsoft.com/office/drawing/2014/main" id="{A3C096B4-61CB-46AF-A339-69F54224E55E}"/>
               </a:ext>
             </a:extLst>
           </p:cNvPr>
@@ -3045,7 +3045,7 @@
           <p:cNvPr id="35" name="">
             <a:extLst xmlns:a="http://schemas.openxmlformats.org/drawingml/2006/main">
               <a:ext uri="{FF2B5EF4-FFF2-40B4-BE49-F238E27FC236}">
-                <a16:creationId xmlns:a16="http://schemas.microsoft.com/office/drawing/2014/main" id="{98C9547F-9E13-496B-BEE9-04E2E73FE830}"/>
+                <a16:creationId xmlns:a16="http://schemas.microsoft.com/office/drawing/2014/main" id="{58D85E29-E49D-4E82-9950-65BDBD70325D}"/>
               </a:ext>
             </a:extLst>
           </p:cNvPr>
@@ -3102,7 +3102,7 @@
           <p:cNvPr id="36" name="">
             <a:extLst xmlns:a="http://schemas.openxmlformats.org/drawingml/2006/main">
               <a:ext uri="{FF2B5EF4-FFF2-40B4-BE49-F238E27FC236}">
-                <a16:creationId xmlns:a16="http://schemas.microsoft.com/office/drawing/2014/main" id="{3ABBFDC6-7E12-498E-B96E-921ECBEA49A6}"/>
+                <a16:creationId xmlns:a16="http://schemas.microsoft.com/office/drawing/2014/main" id="{E2DE8B14-5D3C-4E14-A4D1-24A1DF9BD445}"/>
               </a:ext>
             </a:extLst>
           </p:cNvPr>
@@ -3159,7 +3159,7 @@
           <p:cNvPr id="37" name="">
             <a:extLst xmlns:a="http://schemas.openxmlformats.org/drawingml/2006/main">
               <a:ext uri="{FF2B5EF4-FFF2-40B4-BE49-F238E27FC236}">
-                <a16:creationId xmlns:a16="http://schemas.microsoft.com/office/drawing/2014/main" id="{3A9B1BCC-3396-48F9-8DD9-D927CD3E1FE5}"/>
+                <a16:creationId xmlns:a16="http://schemas.microsoft.com/office/drawing/2014/main" id="{39743324-0A15-4587-A54D-7AB28050BCF9}"/>
               </a:ext>
             </a:extLst>
           </p:cNvPr>
@@ -3194,7 +3194,7 @@
           <p:cNvPr id="38" name="">
             <a:extLst xmlns:a="http://schemas.openxmlformats.org/drawingml/2006/main">
               <a:ext uri="{FF2B5EF4-FFF2-40B4-BE49-F238E27FC236}">
-                <a16:creationId xmlns:a16="http://schemas.microsoft.com/office/drawing/2014/main" id="{B5D206B7-3E65-4008-8B47-28C572698692}"/>
+                <a16:creationId xmlns:a16="http://schemas.microsoft.com/office/drawing/2014/main" id="{AF2785C6-610E-4D14-9672-0ACB17C15CC6}"/>
               </a:ext>
             </a:extLst>
           </p:cNvPr>
@@ -3258,7 +3258,7 @@
           <p:cNvPr id="39" name="">
             <a:extLst xmlns:a="http://schemas.openxmlformats.org/drawingml/2006/main">
               <a:ext uri="{FF2B5EF4-FFF2-40B4-BE49-F238E27FC236}">
-                <a16:creationId xmlns:a16="http://schemas.microsoft.com/office/drawing/2014/main" id="{D7EF9C25-F091-44D3-9D6A-90523E6BA78F}"/>
+                <a16:creationId xmlns:a16="http://schemas.microsoft.com/office/drawing/2014/main" id="{76D30F6B-E613-43C8-9CFF-DE0F6030E300}"/>
               </a:ext>
             </a:extLst>
           </p:cNvPr>
@@ -3315,7 +3315,7 @@
           <p:cNvPr id="40" name="">
             <a:extLst xmlns:a="http://schemas.openxmlformats.org/drawingml/2006/main">
               <a:ext uri="{FF2B5EF4-FFF2-40B4-BE49-F238E27FC236}">
-                <a16:creationId xmlns:a16="http://schemas.microsoft.com/office/drawing/2014/main" id="{B8AF8498-1AB9-4EB8-84AE-EF4FC0DEDF34}"/>
+                <a16:creationId xmlns:a16="http://schemas.microsoft.com/office/drawing/2014/main" id="{3C960F8D-BB57-4314-AA55-E5AC3C83D008}"/>
               </a:ext>
             </a:extLst>
           </p:cNvPr>
@@ -3372,7 +3372,7 @@
           <p:cNvPr id="41" name="">
             <a:extLst xmlns:a="http://schemas.openxmlformats.org/drawingml/2006/main">
               <a:ext uri="{FF2B5EF4-FFF2-40B4-BE49-F238E27FC236}">
-                <a16:creationId xmlns:a16="http://schemas.microsoft.com/office/drawing/2014/main" id="{09F39C5E-A1F0-4A93-BFF9-A47D49DE7AE3}"/>
+                <a16:creationId xmlns:a16="http://schemas.microsoft.com/office/drawing/2014/main" id="{A14CB60A-57BE-4C19-BBBA-6F00B52A9B22}"/>
               </a:ext>
             </a:extLst>
           </p:cNvPr>
@@ -3407,7 +3407,7 @@
           <p:cNvPr id="42" name="">
             <a:extLst xmlns:a="http://schemas.openxmlformats.org/drawingml/2006/main">
               <a:ext uri="{FF2B5EF4-FFF2-40B4-BE49-F238E27FC236}">
-                <a16:creationId xmlns:a16="http://schemas.microsoft.com/office/drawing/2014/main" id="{C5CD0EB6-C55B-42B7-92A2-DEA997005F98}"/>
+                <a16:creationId xmlns:a16="http://schemas.microsoft.com/office/drawing/2014/main" id="{6E06BF3D-1B94-4729-9102-A4D5841ED5C2}"/>
               </a:ext>
             </a:extLst>
           </p:cNvPr>
@@ -3471,7 +3471,7 @@
           <p:cNvPr id="43" name="">
             <a:extLst xmlns:a="http://schemas.openxmlformats.org/drawingml/2006/main">
               <a:ext uri="{FF2B5EF4-FFF2-40B4-BE49-F238E27FC236}">
-                <a16:creationId xmlns:a16="http://schemas.microsoft.com/office/drawing/2014/main" id="{0196A5AD-1AF1-4B28-BA36-A4AD7D48723F}"/>
+                <a16:creationId xmlns:a16="http://schemas.microsoft.com/office/drawing/2014/main" id="{4A1BB0A0-AD8E-481B-9910-7C76F3339786}"/>
               </a:ext>
             </a:extLst>
           </p:cNvPr>
@@ -3528,7 +3528,7 @@
           <p:cNvPr id="44" name="">
             <a:extLst xmlns:a="http://schemas.openxmlformats.org/drawingml/2006/main">
               <a:ext uri="{FF2B5EF4-FFF2-40B4-BE49-F238E27FC236}">
-                <a16:creationId xmlns:a16="http://schemas.microsoft.com/office/drawing/2014/main" id="{3442DF6C-6194-433E-A1E2-0E7D1E5FDCF4}"/>
+                <a16:creationId xmlns:a16="http://schemas.microsoft.com/office/drawing/2014/main" id="{93E465CE-1914-4E20-806D-1277B6672388}"/>
               </a:ext>
             </a:extLst>
           </p:cNvPr>
@@ -3585,7 +3585,7 @@
           <p:cNvPr id="45" name="">
             <a:extLst xmlns:a="http://schemas.openxmlformats.org/drawingml/2006/main">
               <a:ext uri="{FF2B5EF4-FFF2-40B4-BE49-F238E27FC236}">
-                <a16:creationId xmlns:a16="http://schemas.microsoft.com/office/drawing/2014/main" id="{BE30318E-DD57-4D16-AA08-22254C059782}"/>
+                <a16:creationId xmlns:a16="http://schemas.microsoft.com/office/drawing/2014/main" id="{98961D38-EC24-4731-8F98-C44AEBE83878}"/>
               </a:ext>
             </a:extLst>
           </p:cNvPr>
@@ -3632,7 +3632,7 @@
                 <a:ea typeface="Arial"/>
                 <a:cs typeface="Arial"/>
               </a:rPr>
-              <a:t>AURA • Track A • 28/09/2026</a:t>
+              <a:t>AURA • Track A • 29/09/2026</a:t>
             </a:r>
           </a:p>
         </p:txBody>
@@ -3642,19 +3642,19 @@
           <p:cNvPr id="46" name="">
             <a:extLst xmlns:a="http://schemas.openxmlformats.org/drawingml/2006/main">
               <a:ext uri="{FF2B5EF4-FFF2-40B4-BE49-F238E27FC236}">
-                <a16:creationId xmlns:a16="http://schemas.microsoft.com/office/drawing/2014/main" id="{427F6410-90E8-413F-A040-60ED371B40B1}"/>
-              </a:ext>
-            </a:extLst>
-          </p:cNvPr>
-          <p:cNvSpPr>
-            <a:spLocks xmlns:a="http://schemas.openxmlformats.org/drawingml/2006/main" noGrp="1"/>
-          </p:cNvSpPr>
-          <p:nvPr/>
-        </p:nvSpPr>
-        <p:spPr>
-          <a:xfrm xmlns:a="http://schemas.openxmlformats.org/drawingml/2006/main">
-            <a:off x="11049000" y="6515100"/>
-            <a:ext cx="609600" cy="190500"/>
+                <a16:creationId xmlns:a16="http://schemas.microsoft.com/office/drawing/2014/main" id="{18F16737-2A42-444A-AA24-7BCCE0690D9E}"/>
+              </a:ext>
+            </a:extLst>
+          </p:cNvPr>
+          <p:cNvSpPr>
+            <a:spLocks xmlns:a="http://schemas.openxmlformats.org/drawingml/2006/main" noGrp="1"/>
+          </p:cNvSpPr>
+          <p:nvPr/>
+        </p:nvSpPr>
+        <p:spPr>
+          <a:xfrm xmlns:a="http://schemas.openxmlformats.org/drawingml/2006/main">
+            <a:off x="11144250" y="6515100"/>
+            <a:ext cx="514350" cy="190500"/>
           </a:xfrm>
           <a:prstGeom xmlns:a="http://schemas.openxmlformats.org/drawingml/2006/main" prst="rect">
             <a:avLst/>
@@ -3689,7 +3689,7 @@
                 <a:ea typeface="Arial"/>
                 <a:cs typeface="Arial"/>
               </a:rPr>
-              <a:t>1/5</a:t>
+              <a:t>1</a:t>
             </a:r>
           </a:p>
         </p:txBody>
@@ -3697,7 +3697,7 @@
     </p:spTree>
     <p:extLst>
       <p:ext uri="{BB962C8B-B14F-4D97-AF65-F5344CB8AC3E}">
-        <p14:creationId xmlns:p14="http://schemas.microsoft.com/office/powerpoint/2010/main" val="1312256303"/>
+        <p14:creationId xmlns:p14="http://schemas.microsoft.com/office/powerpoint/2010/main" val="1301676064"/>
       </p:ext>
     </p:extLst>
   </p:cSld>
@@ -3728,19 +3728,19 @@
           <p:cNvPr id="46" name="">
             <a:extLst xmlns:a="http://schemas.openxmlformats.org/drawingml/2006/main">
               <a:ext uri="{FF2B5EF4-FFF2-40B4-BE49-F238E27FC236}">
-                <a16:creationId xmlns:a16="http://schemas.microsoft.com/office/drawing/2014/main" id="{B83E29CA-AC37-4AAB-8071-D2391E3552E5}"/>
-              </a:ext>
-            </a:extLst>
-          </p:cNvPr>
-          <p:cNvSpPr>
-            <a:spLocks xmlns:a="http://schemas.openxmlformats.org/drawingml/2006/main" noGrp="1"/>
-          </p:cNvSpPr>
-          <p:nvPr/>
-        </p:nvSpPr>
-        <p:spPr>
-          <a:xfrm xmlns:a="http://schemas.openxmlformats.org/drawingml/2006/main">
-            <a:off x="514350" y="361950"/>
-            <a:ext cx="514350" cy="323850"/>
+                <a16:creationId xmlns:a16="http://schemas.microsoft.com/office/drawing/2014/main" id="{D2214A10-3A76-409B-90B5-6D4EE7B256B9}"/>
+              </a:ext>
+            </a:extLst>
+          </p:cNvPr>
+          <p:cNvSpPr>
+            <a:spLocks xmlns:a="http://schemas.openxmlformats.org/drawingml/2006/main" noGrp="1"/>
+          </p:cNvSpPr>
+          <p:nvPr/>
+        </p:nvSpPr>
+        <p:spPr>
+          <a:xfrm xmlns:a="http://schemas.openxmlformats.org/drawingml/2006/main">
+            <a:off x="476250" y="361950"/>
+            <a:ext cx="647700" cy="323850"/>
           </a:xfrm>
           <a:prstGeom xmlns:a="http://schemas.openxmlformats.org/drawingml/2006/main" prst="rect">
             <a:avLst/>
@@ -3785,7 +3785,7 @@
           <p:cNvPr id="2" name="">
             <a:extLst xmlns:a="http://schemas.openxmlformats.org/drawingml/2006/main">
               <a:ext uri="{FF2B5EF4-FFF2-40B4-BE49-F238E27FC236}">
-                <a16:creationId xmlns:a16="http://schemas.microsoft.com/office/drawing/2014/main" id="{01063799-33B1-479C-B188-64DB77661DFA}"/>
+                <a16:creationId xmlns:a16="http://schemas.microsoft.com/office/drawing/2014/main" id="{B8C1D48B-7ED0-4966-B46F-73223077C43B}"/>
               </a:ext>
             </a:extLst>
           </p:cNvPr>
@@ -3842,7 +3842,7 @@
           <p:cNvPr id="3" name="">
             <a:extLst xmlns:a="http://schemas.openxmlformats.org/drawingml/2006/main">
               <a:ext uri="{FF2B5EF4-FFF2-40B4-BE49-F238E27FC236}">
-                <a16:creationId xmlns:a16="http://schemas.microsoft.com/office/drawing/2014/main" id="{FE569C1E-3334-422A-8312-E7FECA0C9DB9}"/>
+                <a16:creationId xmlns:a16="http://schemas.microsoft.com/office/drawing/2014/main" id="{7B88E3D0-ED25-4410-B597-38C712242067}"/>
               </a:ext>
             </a:extLst>
           </p:cNvPr>
@@ -3899,7 +3899,7 @@
           <p:cNvPr id="4" name="">
             <a:extLst xmlns:a="http://schemas.openxmlformats.org/drawingml/2006/main">
               <a:ext uri="{FF2B5EF4-FFF2-40B4-BE49-F238E27FC236}">
-                <a16:creationId xmlns:a16="http://schemas.microsoft.com/office/drawing/2014/main" id="{41D55A90-D85A-4D53-85F9-F2144C68F6DE}"/>
+                <a16:creationId xmlns:a16="http://schemas.microsoft.com/office/drawing/2014/main" id="{8AAAC328-2C5E-46CD-9242-3F2B27118F90}"/>
               </a:ext>
             </a:extLst>
           </p:cNvPr>
@@ -3930,7 +3930,7 @@
           <p:cNvPr id="5" name="">
             <a:extLst xmlns:a="http://schemas.openxmlformats.org/drawingml/2006/main">
               <a:ext uri="{FF2B5EF4-FFF2-40B4-BE49-F238E27FC236}">
-                <a16:creationId xmlns:a16="http://schemas.microsoft.com/office/drawing/2014/main" id="{AA9BFEB0-121E-4AB3-92B2-EAB04703BFC3}"/>
+                <a16:creationId xmlns:a16="http://schemas.microsoft.com/office/drawing/2014/main" id="{EFC6F7E2-95DA-47DE-AB40-05579A8F2699}"/>
               </a:ext>
             </a:extLst>
           </p:cNvPr>
@@ -3965,7 +3965,7 @@
           <p:cNvPr id="6" name="">
             <a:extLst xmlns:a="http://schemas.openxmlformats.org/drawingml/2006/main">
               <a:ext uri="{FF2B5EF4-FFF2-40B4-BE49-F238E27FC236}">
-                <a16:creationId xmlns:a16="http://schemas.microsoft.com/office/drawing/2014/main" id="{17C0965E-7713-46A1-87C8-9E4AA3CB9B9A}"/>
+                <a16:creationId xmlns:a16="http://schemas.microsoft.com/office/drawing/2014/main" id="{96D369E3-441D-41DC-AE4C-CB1C0007EB6E}"/>
               </a:ext>
             </a:extLst>
           </p:cNvPr>
@@ -4029,7 +4029,7 @@
           <p:cNvPr id="7" name="">
             <a:extLst xmlns:a="http://schemas.openxmlformats.org/drawingml/2006/main">
               <a:ext uri="{FF2B5EF4-FFF2-40B4-BE49-F238E27FC236}">
-                <a16:creationId xmlns:a16="http://schemas.microsoft.com/office/drawing/2014/main" id="{9F2CA09E-2D79-48B0-8CFA-08657C37F54B}"/>
+                <a16:creationId xmlns:a16="http://schemas.microsoft.com/office/drawing/2014/main" id="{55FB52E9-B781-421D-83A0-0A49048DBBA5}"/>
               </a:ext>
             </a:extLst>
           </p:cNvPr>
@@ -4086,7 +4086,7 @@
           <p:cNvPr id="8" name="">
             <a:extLst xmlns:a="http://schemas.openxmlformats.org/drawingml/2006/main">
               <a:ext uri="{FF2B5EF4-FFF2-40B4-BE49-F238E27FC236}">
-                <a16:creationId xmlns:a16="http://schemas.microsoft.com/office/drawing/2014/main" id="{1F344C95-517F-4471-8685-97C4C2F61BEE}"/>
+                <a16:creationId xmlns:a16="http://schemas.microsoft.com/office/drawing/2014/main" id="{09C2A86A-0CCF-46C8-9B55-C66B44C977C5}"/>
               </a:ext>
             </a:extLst>
           </p:cNvPr>
@@ -4166,7 +4166,7 @@
           <p:cNvPr id="9" name="">
             <a:extLst xmlns:a="http://schemas.openxmlformats.org/drawingml/2006/main">
               <a:ext uri="{FF2B5EF4-FFF2-40B4-BE49-F238E27FC236}">
-                <a16:creationId xmlns:a16="http://schemas.microsoft.com/office/drawing/2014/main" id="{9F3C9F37-8783-4B04-93AB-ECA41B4802A6}"/>
+                <a16:creationId xmlns:a16="http://schemas.microsoft.com/office/drawing/2014/main" id="{6CB3AF58-1B76-433E-A14E-93D31CFB7AED}"/>
               </a:ext>
             </a:extLst>
           </p:cNvPr>
@@ -4198,7 +4198,7 @@
           <p:cNvPr id="10" name="">
             <a:extLst xmlns:a="http://schemas.openxmlformats.org/drawingml/2006/main">
               <a:ext uri="{FF2B5EF4-FFF2-40B4-BE49-F238E27FC236}">
-                <a16:creationId xmlns:a16="http://schemas.microsoft.com/office/drawing/2014/main" id="{7E2666C5-6E67-4EA7-81AB-AC79B881D8FB}"/>
+                <a16:creationId xmlns:a16="http://schemas.microsoft.com/office/drawing/2014/main" id="{3884C95F-6AC8-43AD-8F2A-A02A3588FFE3}"/>
               </a:ext>
             </a:extLst>
           </p:cNvPr>
@@ -4233,7 +4233,7 @@
           <p:cNvPr id="11" name="">
             <a:extLst xmlns:a="http://schemas.openxmlformats.org/drawingml/2006/main">
               <a:ext uri="{FF2B5EF4-FFF2-40B4-BE49-F238E27FC236}">
-                <a16:creationId xmlns:a16="http://schemas.microsoft.com/office/drawing/2014/main" id="{4C040304-0C54-4CA6-A9EA-7BF0DC74C529}"/>
+                <a16:creationId xmlns:a16="http://schemas.microsoft.com/office/drawing/2014/main" id="{8D176936-37F7-4280-82E5-00A7931CD362}"/>
               </a:ext>
             </a:extLst>
           </p:cNvPr>
@@ -4297,7 +4297,7 @@
           <p:cNvPr id="12" name="">
             <a:extLst xmlns:a="http://schemas.openxmlformats.org/drawingml/2006/main">
               <a:ext uri="{FF2B5EF4-FFF2-40B4-BE49-F238E27FC236}">
-                <a16:creationId xmlns:a16="http://schemas.microsoft.com/office/drawing/2014/main" id="{4EB19CFA-E1E4-4D7F-A4D6-82949D0B2F3A}"/>
+                <a16:creationId xmlns:a16="http://schemas.microsoft.com/office/drawing/2014/main" id="{32252EB2-EECF-4863-A79B-6C6AB577EE8A}"/>
               </a:ext>
             </a:extLst>
           </p:cNvPr>
@@ -4354,7 +4354,7 @@
           <p:cNvPr id="13" name="">
             <a:extLst xmlns:a="http://schemas.openxmlformats.org/drawingml/2006/main">
               <a:ext uri="{FF2B5EF4-FFF2-40B4-BE49-F238E27FC236}">
-                <a16:creationId xmlns:a16="http://schemas.microsoft.com/office/drawing/2014/main" id="{A7FDFCED-A9F1-4B23-BAEC-083D510E57B2}"/>
+                <a16:creationId xmlns:a16="http://schemas.microsoft.com/office/drawing/2014/main" id="{84A4D7F0-E782-435A-A922-90F3AC5F8D37}"/>
               </a:ext>
             </a:extLst>
           </p:cNvPr>
@@ -4434,7 +4434,7 @@
           <p:cNvPr id="14" name="">
             <a:extLst xmlns:a="http://schemas.openxmlformats.org/drawingml/2006/main">
               <a:ext uri="{FF2B5EF4-FFF2-40B4-BE49-F238E27FC236}">
-                <a16:creationId xmlns:a16="http://schemas.microsoft.com/office/drawing/2014/main" id="{369172BE-4604-4BAC-AFF6-8CCDC7E93025}"/>
+                <a16:creationId xmlns:a16="http://schemas.microsoft.com/office/drawing/2014/main" id="{39B7F54D-2066-4578-AE7B-F29E90B6DD4A}"/>
               </a:ext>
             </a:extLst>
           </p:cNvPr>
@@ -4466,7 +4466,7 @@
           <p:cNvPr id="15" name="">
             <a:extLst xmlns:a="http://schemas.openxmlformats.org/drawingml/2006/main">
               <a:ext uri="{FF2B5EF4-FFF2-40B4-BE49-F238E27FC236}">
-                <a16:creationId xmlns:a16="http://schemas.microsoft.com/office/drawing/2014/main" id="{C556895A-997C-4AD7-BB51-07200B6C1718}"/>
+                <a16:creationId xmlns:a16="http://schemas.microsoft.com/office/drawing/2014/main" id="{3DC7A1FD-C8A1-4A91-98C2-4C3BC6AC9A5D}"/>
               </a:ext>
             </a:extLst>
           </p:cNvPr>
@@ -4501,7 +4501,7 @@
           <p:cNvPr id="16" name="">
             <a:extLst xmlns:a="http://schemas.openxmlformats.org/drawingml/2006/main">
               <a:ext uri="{FF2B5EF4-FFF2-40B4-BE49-F238E27FC236}">
-                <a16:creationId xmlns:a16="http://schemas.microsoft.com/office/drawing/2014/main" id="{3FE2C693-2F83-41CC-A2B0-26CD7ED2B22E}"/>
+                <a16:creationId xmlns:a16="http://schemas.microsoft.com/office/drawing/2014/main" id="{F2E11145-3AD7-48D1-967E-3CF19DFFDFC7}"/>
               </a:ext>
             </a:extLst>
           </p:cNvPr>
@@ -4565,7 +4565,7 @@
           <p:cNvPr id="17" name="">
             <a:extLst xmlns:a="http://schemas.openxmlformats.org/drawingml/2006/main">
               <a:ext uri="{FF2B5EF4-FFF2-40B4-BE49-F238E27FC236}">
-                <a16:creationId xmlns:a16="http://schemas.microsoft.com/office/drawing/2014/main" id="{88CB3BCE-2625-4FDC-9F17-0F0BE6EC3696}"/>
+                <a16:creationId xmlns:a16="http://schemas.microsoft.com/office/drawing/2014/main" id="{F0D0B5A7-524A-442F-A014-EA450AE2E52C}"/>
               </a:ext>
             </a:extLst>
           </p:cNvPr>
@@ -4622,7 +4622,7 @@
           <p:cNvPr id="18" name="">
             <a:extLst xmlns:a="http://schemas.openxmlformats.org/drawingml/2006/main">
               <a:ext uri="{FF2B5EF4-FFF2-40B4-BE49-F238E27FC236}">
-                <a16:creationId xmlns:a16="http://schemas.microsoft.com/office/drawing/2014/main" id="{A05A2F21-8533-45C8-96E6-663413B91A89}"/>
+                <a16:creationId xmlns:a16="http://schemas.microsoft.com/office/drawing/2014/main" id="{82127236-45C2-4F5D-AD3F-95346500DDFF}"/>
               </a:ext>
             </a:extLst>
           </p:cNvPr>
@@ -4702,7 +4702,7 @@
           <p:cNvPr id="19" name="">
             <a:extLst xmlns:a="http://schemas.openxmlformats.org/drawingml/2006/main">
               <a:ext uri="{FF2B5EF4-FFF2-40B4-BE49-F238E27FC236}">
-                <a16:creationId xmlns:a16="http://schemas.microsoft.com/office/drawing/2014/main" id="{8A83641B-7CBF-4B3A-A93D-C58395EA1B60}"/>
+                <a16:creationId xmlns:a16="http://schemas.microsoft.com/office/drawing/2014/main" id="{CDCF6E4E-A334-46F9-9CB2-51ABF0EACA6F}"/>
               </a:ext>
             </a:extLst>
           </p:cNvPr>
@@ -4734,7 +4734,7 @@
           <p:cNvPr id="20" name="">
             <a:extLst xmlns:a="http://schemas.openxmlformats.org/drawingml/2006/main">
               <a:ext uri="{FF2B5EF4-FFF2-40B4-BE49-F238E27FC236}">
-                <a16:creationId xmlns:a16="http://schemas.microsoft.com/office/drawing/2014/main" id="{0E641222-5C28-4F10-8A9A-C79C8B26461F}"/>
+                <a16:creationId xmlns:a16="http://schemas.microsoft.com/office/drawing/2014/main" id="{D1AC6ABB-A934-4671-B55C-58A6129CC98E}"/>
               </a:ext>
             </a:extLst>
           </p:cNvPr>
@@ -4769,7 +4769,7 @@
           <p:cNvPr id="21" name="">
             <a:extLst xmlns:a="http://schemas.openxmlformats.org/drawingml/2006/main">
               <a:ext uri="{FF2B5EF4-FFF2-40B4-BE49-F238E27FC236}">
-                <a16:creationId xmlns:a16="http://schemas.microsoft.com/office/drawing/2014/main" id="{658C1D05-AC19-426C-AF18-8FA6845F2EE5}"/>
+                <a16:creationId xmlns:a16="http://schemas.microsoft.com/office/drawing/2014/main" id="{E344DBE8-0CF4-41F1-99B2-57BB8F38E7FE}"/>
               </a:ext>
             </a:extLst>
           </p:cNvPr>
@@ -4833,7 +4833,7 @@
           <p:cNvPr id="22" name="">
             <a:extLst xmlns:a="http://schemas.openxmlformats.org/drawingml/2006/main">
               <a:ext uri="{FF2B5EF4-FFF2-40B4-BE49-F238E27FC236}">
-                <a16:creationId xmlns:a16="http://schemas.microsoft.com/office/drawing/2014/main" id="{0AEC3B4C-E532-488D-A8B6-3F982D8DBEE3}"/>
+                <a16:creationId xmlns:a16="http://schemas.microsoft.com/office/drawing/2014/main" id="{0EF344E7-18C4-4C8B-8487-AEDFBEB25D9F}"/>
               </a:ext>
             </a:extLst>
           </p:cNvPr>
@@ -4890,7 +4890,7 @@
           <p:cNvPr id="23" name="">
             <a:extLst xmlns:a="http://schemas.openxmlformats.org/drawingml/2006/main">
               <a:ext uri="{FF2B5EF4-FFF2-40B4-BE49-F238E27FC236}">
-                <a16:creationId xmlns:a16="http://schemas.microsoft.com/office/drawing/2014/main" id="{B62B967B-EF4D-4172-8534-61CA7C847B6C}"/>
+                <a16:creationId xmlns:a16="http://schemas.microsoft.com/office/drawing/2014/main" id="{96D1C6BA-47DF-4C86-8410-35A6C4DE24A8}"/>
               </a:ext>
             </a:extLst>
           </p:cNvPr>
@@ -4970,7 +4970,7 @@
           <p:cNvPr id="24" name="">
             <a:extLst xmlns:a="http://schemas.openxmlformats.org/drawingml/2006/main">
               <a:ext uri="{FF2B5EF4-FFF2-40B4-BE49-F238E27FC236}">
-                <a16:creationId xmlns:a16="http://schemas.microsoft.com/office/drawing/2014/main" id="{56E8BBDF-DFD7-4D13-B9BF-8F2BB56BF258}"/>
+                <a16:creationId xmlns:a16="http://schemas.microsoft.com/office/drawing/2014/main" id="{AC0DABF3-E205-4EE8-86D2-5B299091FE68}"/>
               </a:ext>
             </a:extLst>
           </p:cNvPr>
@@ -5002,7 +5002,7 @@
           <p:cNvPr id="25" name="">
             <a:extLst xmlns:a="http://schemas.openxmlformats.org/drawingml/2006/main">
               <a:ext uri="{FF2B5EF4-FFF2-40B4-BE49-F238E27FC236}">
-                <a16:creationId xmlns:a16="http://schemas.microsoft.com/office/drawing/2014/main" id="{20263D52-4C92-4472-8B1A-DF4C8E933A92}"/>
+                <a16:creationId xmlns:a16="http://schemas.microsoft.com/office/drawing/2014/main" id="{BC900DCB-13D9-4B4C-A3AF-27753B8C4EFD}"/>
               </a:ext>
             </a:extLst>
           </p:cNvPr>
@@ -5037,7 +5037,7 @@
           <p:cNvPr id="26" name="">
             <a:extLst xmlns:a="http://schemas.openxmlformats.org/drawingml/2006/main">
               <a:ext uri="{FF2B5EF4-FFF2-40B4-BE49-F238E27FC236}">
-                <a16:creationId xmlns:a16="http://schemas.microsoft.com/office/drawing/2014/main" id="{91D84956-F645-4EF3-A917-23D65104A76F}"/>
+                <a16:creationId xmlns:a16="http://schemas.microsoft.com/office/drawing/2014/main" id="{A1D910F7-ED4A-4136-B553-2A4134CE9BB7}"/>
               </a:ext>
             </a:extLst>
           </p:cNvPr>
@@ -5101,7 +5101,7 @@
           <p:cNvPr id="27" name="">
             <a:extLst xmlns:a="http://schemas.openxmlformats.org/drawingml/2006/main">
               <a:ext uri="{FF2B5EF4-FFF2-40B4-BE49-F238E27FC236}">
-                <a16:creationId xmlns:a16="http://schemas.microsoft.com/office/drawing/2014/main" id="{BA61DDDC-D231-4651-8DE2-1F56ED5B5BBB}"/>
+                <a16:creationId xmlns:a16="http://schemas.microsoft.com/office/drawing/2014/main" id="{4CBC92FD-E461-43FD-8AD3-64FA06A4E903}"/>
               </a:ext>
             </a:extLst>
           </p:cNvPr>
@@ -5158,7 +5158,7 @@
           <p:cNvPr id="28" name="">
             <a:extLst xmlns:a="http://schemas.openxmlformats.org/drawingml/2006/main">
               <a:ext uri="{FF2B5EF4-FFF2-40B4-BE49-F238E27FC236}">
-                <a16:creationId xmlns:a16="http://schemas.microsoft.com/office/drawing/2014/main" id="{15E25E55-BE3B-4D4A-85B3-E00161343FED}"/>
+                <a16:creationId xmlns:a16="http://schemas.microsoft.com/office/drawing/2014/main" id="{C96C360E-9D17-42A3-BEEC-081F134A00D9}"/>
               </a:ext>
             </a:extLst>
           </p:cNvPr>
@@ -5238,7 +5238,7 @@
           <p:cNvPr id="29" name="">
             <a:extLst xmlns:a="http://schemas.openxmlformats.org/drawingml/2006/main">
               <a:ext uri="{FF2B5EF4-FFF2-40B4-BE49-F238E27FC236}">
-                <a16:creationId xmlns:a16="http://schemas.microsoft.com/office/drawing/2014/main" id="{C38B3561-E117-4CB3-BBEB-60D03F03CF7E}"/>
+                <a16:creationId xmlns:a16="http://schemas.microsoft.com/office/drawing/2014/main" id="{4CCEAF37-05E0-4979-93C7-074919A6E2F7}"/>
               </a:ext>
             </a:extLst>
           </p:cNvPr>
@@ -5295,7 +5295,7 @@
           <p:cNvPr id="30" name="">
             <a:extLst xmlns:a="http://schemas.openxmlformats.org/drawingml/2006/main">
               <a:ext uri="{FF2B5EF4-FFF2-40B4-BE49-F238E27FC236}">
-                <a16:creationId xmlns:a16="http://schemas.microsoft.com/office/drawing/2014/main" id="{EB69352E-A44E-4CA8-AAA6-98470D5E993D}"/>
+                <a16:creationId xmlns:a16="http://schemas.microsoft.com/office/drawing/2014/main" id="{0F60504B-B519-4ED4-A0BD-B9FC9C8FA552}"/>
               </a:ext>
             </a:extLst>
           </p:cNvPr>
@@ -5330,7 +5330,7 @@
           <p:cNvPr id="31" name="">
             <a:extLst xmlns:a="http://schemas.openxmlformats.org/drawingml/2006/main">
               <a:ext uri="{FF2B5EF4-FFF2-40B4-BE49-F238E27FC236}">
-                <a16:creationId xmlns:a16="http://schemas.microsoft.com/office/drawing/2014/main" id="{0CEE3442-E3CC-42B4-BFEF-E1D0241BAC96}"/>
+                <a16:creationId xmlns:a16="http://schemas.microsoft.com/office/drawing/2014/main" id="{C50002B9-D32B-48C0-B094-491F9F7B67B6}"/>
               </a:ext>
             </a:extLst>
           </p:cNvPr>
@@ -5387,7 +5387,7 @@
           <p:cNvPr id="32" name="">
             <a:extLst xmlns:a="http://schemas.openxmlformats.org/drawingml/2006/main">
               <a:ext uri="{FF2B5EF4-FFF2-40B4-BE49-F238E27FC236}">
-                <a16:creationId xmlns:a16="http://schemas.microsoft.com/office/drawing/2014/main" id="{A9A8BEAC-5E52-43C7-9793-2B71978B2DC8}"/>
+                <a16:creationId xmlns:a16="http://schemas.microsoft.com/office/drawing/2014/main" id="{45C3E939-D54A-45CD-A52F-C38387ABE473}"/>
               </a:ext>
             </a:extLst>
           </p:cNvPr>
@@ -5490,7 +5490,7 @@
           <p:cNvPr id="33" name="">
             <a:extLst xmlns:a="http://schemas.openxmlformats.org/drawingml/2006/main">
               <a:ext uri="{FF2B5EF4-FFF2-40B4-BE49-F238E27FC236}">
-                <a16:creationId xmlns:a16="http://schemas.microsoft.com/office/drawing/2014/main" id="{27996679-A74B-45F4-97AD-5C51E21D1C4A}"/>
+                <a16:creationId xmlns:a16="http://schemas.microsoft.com/office/drawing/2014/main" id="{BE0792BD-00CE-4DFD-A2A5-6D86A44041EC}"/>
               </a:ext>
             </a:extLst>
           </p:cNvPr>
@@ -5554,7 +5554,7 @@
           <p:cNvPr id="34" name="">
             <a:extLst xmlns:a="http://schemas.openxmlformats.org/drawingml/2006/main">
               <a:ext uri="{FF2B5EF4-FFF2-40B4-BE49-F238E27FC236}">
-                <a16:creationId xmlns:a16="http://schemas.microsoft.com/office/drawing/2014/main" id="{C5C2C59E-C789-449F-9317-002C7F01F25F}"/>
+                <a16:creationId xmlns:a16="http://schemas.microsoft.com/office/drawing/2014/main" id="{03945626-0DC8-4D0B-8CA6-BCE4750BEDA5}"/>
               </a:ext>
             </a:extLst>
           </p:cNvPr>
@@ -5611,7 +5611,7 @@
           <p:cNvPr id="35" name="">
             <a:extLst xmlns:a="http://schemas.openxmlformats.org/drawingml/2006/main">
               <a:ext uri="{FF2B5EF4-FFF2-40B4-BE49-F238E27FC236}">
-                <a16:creationId xmlns:a16="http://schemas.microsoft.com/office/drawing/2014/main" id="{973742AD-7BE0-455E-905B-C4399F992974}"/>
+                <a16:creationId xmlns:a16="http://schemas.microsoft.com/office/drawing/2014/main" id="{7A10B349-25EB-4832-BE8A-63E308C0263F}"/>
               </a:ext>
             </a:extLst>
           </p:cNvPr>
@@ -5646,7 +5646,7 @@
           <p:cNvPr id="36" name="">
             <a:extLst xmlns:a="http://schemas.openxmlformats.org/drawingml/2006/main">
               <a:ext uri="{FF2B5EF4-FFF2-40B4-BE49-F238E27FC236}">
-                <a16:creationId xmlns:a16="http://schemas.microsoft.com/office/drawing/2014/main" id="{3667DC94-DCE7-4AAB-9742-AD141F726E63}"/>
+                <a16:creationId xmlns:a16="http://schemas.microsoft.com/office/drawing/2014/main" id="{4695052A-FE11-4BB3-ABB9-62CF8E633C55}"/>
               </a:ext>
             </a:extLst>
           </p:cNvPr>
@@ -5703,7 +5703,7 @@
           <p:cNvPr id="37" name="">
             <a:extLst xmlns:a="http://schemas.openxmlformats.org/drawingml/2006/main">
               <a:ext uri="{FF2B5EF4-FFF2-40B4-BE49-F238E27FC236}">
-                <a16:creationId xmlns:a16="http://schemas.microsoft.com/office/drawing/2014/main" id="{F98EBCCA-349F-4806-8A97-A02E1EF49948}"/>
+                <a16:creationId xmlns:a16="http://schemas.microsoft.com/office/drawing/2014/main" id="{4F086726-399D-4313-8188-535711382CD1}"/>
               </a:ext>
             </a:extLst>
           </p:cNvPr>
@@ -5738,7 +5738,7 @@
           <p:cNvPr id="38" name="">
             <a:extLst xmlns:a="http://schemas.openxmlformats.org/drawingml/2006/main">
               <a:ext uri="{FF2B5EF4-FFF2-40B4-BE49-F238E27FC236}">
-                <a16:creationId xmlns:a16="http://schemas.microsoft.com/office/drawing/2014/main" id="{1BF72F76-832F-487C-97F0-789425F47FF8}"/>
+                <a16:creationId xmlns:a16="http://schemas.microsoft.com/office/drawing/2014/main" id="{359E557A-85C9-4BBD-BAC0-1A1A8DA8593B}"/>
               </a:ext>
             </a:extLst>
           </p:cNvPr>
@@ -5795,7 +5795,7 @@
           <p:cNvPr id="39" name="">
             <a:extLst xmlns:a="http://schemas.openxmlformats.org/drawingml/2006/main">
               <a:ext uri="{FF2B5EF4-FFF2-40B4-BE49-F238E27FC236}">
-                <a16:creationId xmlns:a16="http://schemas.microsoft.com/office/drawing/2014/main" id="{4BA8AA67-124A-4B4B-AC91-AA0BB9D2C586}"/>
+                <a16:creationId xmlns:a16="http://schemas.microsoft.com/office/drawing/2014/main" id="{27DFE4B2-5726-4900-B5EC-7F08BB6A8A67}"/>
               </a:ext>
             </a:extLst>
           </p:cNvPr>
@@ -5852,7 +5852,7 @@
           <p:cNvPr id="40" name="">
             <a:extLst xmlns:a="http://schemas.openxmlformats.org/drawingml/2006/main">
               <a:ext uri="{FF2B5EF4-FFF2-40B4-BE49-F238E27FC236}">
-                <a16:creationId xmlns:a16="http://schemas.microsoft.com/office/drawing/2014/main" id="{EEC6B636-24E2-4A96-B6F1-B0BEAB6AC1A0}"/>
+                <a16:creationId xmlns:a16="http://schemas.microsoft.com/office/drawing/2014/main" id="{94DE32EC-29BF-43DB-91DF-83E7AA5795F1}"/>
               </a:ext>
             </a:extLst>
           </p:cNvPr>
@@ -5887,7 +5887,7 @@
           <p:cNvPr id="41" name="">
             <a:extLst xmlns:a="http://schemas.openxmlformats.org/drawingml/2006/main">
               <a:ext uri="{FF2B5EF4-FFF2-40B4-BE49-F238E27FC236}">
-                <a16:creationId xmlns:a16="http://schemas.microsoft.com/office/drawing/2014/main" id="{41FCCD93-9945-4910-9DAE-D18C129E9BB1}"/>
+                <a16:creationId xmlns:a16="http://schemas.microsoft.com/office/drawing/2014/main" id="{26D848C2-5642-4C5C-AD94-CCA0E1AF85EB}"/>
               </a:ext>
             </a:extLst>
           </p:cNvPr>
@@ -5944,7 +5944,7 @@
           <p:cNvPr id="42" name="">
             <a:extLst xmlns:a="http://schemas.openxmlformats.org/drawingml/2006/main">
               <a:ext uri="{FF2B5EF4-FFF2-40B4-BE49-F238E27FC236}">
-                <a16:creationId xmlns:a16="http://schemas.microsoft.com/office/drawing/2014/main" id="{7E367BE5-0723-4ED0-8B10-47524621FA43}"/>
+                <a16:creationId xmlns:a16="http://schemas.microsoft.com/office/drawing/2014/main" id="{C592658B-16BE-4E60-B98C-ABC6E24CEC40}"/>
               </a:ext>
             </a:extLst>
           </p:cNvPr>
@@ -6001,7 +6001,7 @@
           <p:cNvPr id="43" name="">
             <a:extLst xmlns:a="http://schemas.openxmlformats.org/drawingml/2006/main">
               <a:ext uri="{FF2B5EF4-FFF2-40B4-BE49-F238E27FC236}">
-                <a16:creationId xmlns:a16="http://schemas.microsoft.com/office/drawing/2014/main" id="{8F6DC59A-394F-4419-89C9-436E21EE10E0}"/>
+                <a16:creationId xmlns:a16="http://schemas.microsoft.com/office/drawing/2014/main" id="{0F236101-C0B0-44EE-9EC9-FB22A53A1B57}"/>
               </a:ext>
             </a:extLst>
           </p:cNvPr>
@@ -6058,7 +6058,7 @@
           <p:cNvPr id="44" name="">
             <a:extLst xmlns:a="http://schemas.openxmlformats.org/drawingml/2006/main">
               <a:ext uri="{FF2B5EF4-FFF2-40B4-BE49-F238E27FC236}">
-                <a16:creationId xmlns:a16="http://schemas.microsoft.com/office/drawing/2014/main" id="{F9CC139D-58DC-4FFE-8A1A-5E49607A4469}"/>
+                <a16:creationId xmlns:a16="http://schemas.microsoft.com/office/drawing/2014/main" id="{7F88C814-A85C-4FAF-AA3D-951C6E78A169}"/>
               </a:ext>
             </a:extLst>
           </p:cNvPr>
@@ -6105,7 +6105,7 @@
                 <a:ea typeface="Arial"/>
                 <a:cs typeface="Arial"/>
               </a:rPr>
-              <a:t>AURA • Track A • 28/09/2026</a:t>
+              <a:t>AURA • Track A • 29/09/2026</a:t>
             </a:r>
           </a:p>
         </p:txBody>
@@ -6115,19 +6115,19 @@
           <p:cNvPr id="45" name="">
             <a:extLst xmlns:a="http://schemas.openxmlformats.org/drawingml/2006/main">
               <a:ext uri="{FF2B5EF4-FFF2-40B4-BE49-F238E27FC236}">
-                <a16:creationId xmlns:a16="http://schemas.microsoft.com/office/drawing/2014/main" id="{40B2CABF-13B2-4CE1-8366-F1C6B3F2D7A6}"/>
-              </a:ext>
-            </a:extLst>
-          </p:cNvPr>
-          <p:cNvSpPr>
-            <a:spLocks xmlns:a="http://schemas.openxmlformats.org/drawingml/2006/main" noGrp="1"/>
-          </p:cNvSpPr>
-          <p:nvPr/>
-        </p:nvSpPr>
-        <p:spPr>
-          <a:xfrm xmlns:a="http://schemas.openxmlformats.org/drawingml/2006/main">
-            <a:off x="11049000" y="6515100"/>
-            <a:ext cx="609600" cy="190500"/>
+                <a16:creationId xmlns:a16="http://schemas.microsoft.com/office/drawing/2014/main" id="{54D8EB5D-0920-4769-A423-4BD0182DE530}"/>
+              </a:ext>
+            </a:extLst>
+          </p:cNvPr>
+          <p:cNvSpPr>
+            <a:spLocks xmlns:a="http://schemas.openxmlformats.org/drawingml/2006/main" noGrp="1"/>
+          </p:cNvSpPr>
+          <p:nvPr/>
+        </p:nvSpPr>
+        <p:spPr>
+          <a:xfrm xmlns:a="http://schemas.openxmlformats.org/drawingml/2006/main">
+            <a:off x="11144250" y="6515100"/>
+            <a:ext cx="514350" cy="190500"/>
           </a:xfrm>
           <a:prstGeom xmlns:a="http://schemas.openxmlformats.org/drawingml/2006/main" prst="rect">
             <a:avLst/>
@@ -6162,7 +6162,7 @@
                 <a:ea typeface="Arial"/>
                 <a:cs typeface="Arial"/>
               </a:rPr>
-              <a:t>2/5</a:t>
+              <a:t>2</a:t>
             </a:r>
           </a:p>
         </p:txBody>
@@ -6170,7 +6170,7 @@
     </p:spTree>
     <p:extLst>
       <p:ext uri="{BB962C8B-B14F-4D97-AF65-F5344CB8AC3E}">
-        <p14:creationId xmlns:p14="http://schemas.microsoft.com/office/powerpoint/2010/main" val="1773435177"/>
+        <p14:creationId xmlns:p14="http://schemas.microsoft.com/office/powerpoint/2010/main" val="1428657496"/>
       </p:ext>
     </p:extLst>
   </p:cSld>
@@ -6201,19 +6201,19 @@
           <p:cNvPr id="32" name="">
             <a:extLst xmlns:a="http://schemas.openxmlformats.org/drawingml/2006/main">
               <a:ext uri="{FF2B5EF4-FFF2-40B4-BE49-F238E27FC236}">
-                <a16:creationId xmlns:a16="http://schemas.microsoft.com/office/drawing/2014/main" id="{A8AA4AA3-A292-492C-811F-C028C73F23D2}"/>
-              </a:ext>
-            </a:extLst>
-          </p:cNvPr>
-          <p:cNvSpPr>
-            <a:spLocks xmlns:a="http://schemas.openxmlformats.org/drawingml/2006/main" noGrp="1"/>
-          </p:cNvSpPr>
-          <p:nvPr/>
-        </p:nvSpPr>
-        <p:spPr>
-          <a:xfrm xmlns:a="http://schemas.openxmlformats.org/drawingml/2006/main">
-            <a:off x="514350" y="361950"/>
-            <a:ext cx="514350" cy="323850"/>
+                <a16:creationId xmlns:a16="http://schemas.microsoft.com/office/drawing/2014/main" id="{BE538872-EC6D-4C9A-8C4B-AE44C7D96BE5}"/>
+              </a:ext>
+            </a:extLst>
+          </p:cNvPr>
+          <p:cNvSpPr>
+            <a:spLocks xmlns:a="http://schemas.openxmlformats.org/drawingml/2006/main" noGrp="1"/>
+          </p:cNvSpPr>
+          <p:nvPr/>
+        </p:nvSpPr>
+        <p:spPr>
+          <a:xfrm xmlns:a="http://schemas.openxmlformats.org/drawingml/2006/main">
+            <a:off x="476250" y="361950"/>
+            <a:ext cx="647700" cy="323850"/>
           </a:xfrm>
           <a:prstGeom xmlns:a="http://schemas.openxmlformats.org/drawingml/2006/main" prst="rect">
             <a:avLst/>
@@ -6258,7 +6258,7 @@
           <p:cNvPr id="2" name="">
             <a:extLst xmlns:a="http://schemas.openxmlformats.org/drawingml/2006/main">
               <a:ext uri="{FF2B5EF4-FFF2-40B4-BE49-F238E27FC236}">
-                <a16:creationId xmlns:a16="http://schemas.microsoft.com/office/drawing/2014/main" id="{D9D3DE90-79AB-46CB-AFC6-46E198BA602D}"/>
+                <a16:creationId xmlns:a16="http://schemas.microsoft.com/office/drawing/2014/main" id="{E780E054-5D38-4922-A26A-2BBBE74272E9}"/>
               </a:ext>
             </a:extLst>
           </p:cNvPr>
@@ -6305,7 +6305,7 @@
                 <a:ea typeface="Arial"/>
                 <a:cs typeface="Arial"/>
               </a:rPr>
-              <a:t>Tác động phải đo được — không tự tuyên bố</a:t>
+              <a:t>Bằng chứng kỹ thuật và tác động cần đo</a:t>
             </a:r>
           </a:p>
         </p:txBody>
@@ -6315,7 +6315,7 @@
           <p:cNvPr id="3" name="">
             <a:extLst xmlns:a="http://schemas.openxmlformats.org/drawingml/2006/main">
               <a:ext uri="{FF2B5EF4-FFF2-40B4-BE49-F238E27FC236}">
-                <a16:creationId xmlns:a16="http://schemas.microsoft.com/office/drawing/2014/main" id="{94A41282-D1A9-4CDF-BFCE-08D93B4D7E9C}"/>
+                <a16:creationId xmlns:a16="http://schemas.microsoft.com/office/drawing/2014/main" id="{03BACAEB-9ED8-489C-9FE4-64DB35CD7348}"/>
               </a:ext>
             </a:extLst>
           </p:cNvPr>
@@ -6362,7 +6362,7 @@
                 <a:ea typeface="Arial"/>
                 <a:cs typeface="Arial"/>
               </a:rPr>
-              <a:t>AURA phân biệt kết quả kỹ thuật đã xác minh với tác động vận hành cần pilot.</a:t>
+              <a:t>Kết quả regression đã có; hiệu quả vận hành chỉ kết luận sau pilot độc lập.</a:t>
             </a:r>
           </a:p>
         </p:txBody>
@@ -6372,7 +6372,7 @@
           <p:cNvPr id="4" name="">
             <a:extLst xmlns:a="http://schemas.openxmlformats.org/drawingml/2006/main">
               <a:ext uri="{FF2B5EF4-FFF2-40B4-BE49-F238E27FC236}">
-                <a16:creationId xmlns:a16="http://schemas.microsoft.com/office/drawing/2014/main" id="{A19267D8-0088-4EEE-9C52-6E1C7694AE2F}"/>
+                <a16:creationId xmlns:a16="http://schemas.microsoft.com/office/drawing/2014/main" id="{69B79DC7-53FC-449A-86D9-7EA5146E2104}"/>
               </a:ext>
             </a:extLst>
           </p:cNvPr>
@@ -6403,7 +6403,7 @@
           <p:cNvPr id="5" name="">
             <a:extLst xmlns:a="http://schemas.openxmlformats.org/drawingml/2006/main">
               <a:ext uri="{FF2B5EF4-FFF2-40B4-BE49-F238E27FC236}">
-                <a16:creationId xmlns:a16="http://schemas.microsoft.com/office/drawing/2014/main" id="{52826983-A69B-4619-AAAA-31E0AD7B2975}"/>
+                <a16:creationId xmlns:a16="http://schemas.microsoft.com/office/drawing/2014/main" id="{B95024D4-9D84-4907-B25D-83CFCE694A5D}"/>
               </a:ext>
             </a:extLst>
           </p:cNvPr>
@@ -6438,7 +6438,7 @@
           <p:cNvPr id="6" name="">
             <a:extLst xmlns:a="http://schemas.openxmlformats.org/drawingml/2006/main">
               <a:ext uri="{FF2B5EF4-FFF2-40B4-BE49-F238E27FC236}">
-                <a16:creationId xmlns:a16="http://schemas.microsoft.com/office/drawing/2014/main" id="{E370F510-46A0-4CAF-BE0F-2EF7B565ED3A}"/>
+                <a16:creationId xmlns:a16="http://schemas.microsoft.com/office/drawing/2014/main" id="{1EDCA404-84FE-4476-9C3E-71B2A29F396A}"/>
               </a:ext>
             </a:extLst>
           </p:cNvPr>
@@ -6502,7 +6502,7 @@
           <p:cNvPr id="7" name="">
             <a:extLst xmlns:a="http://schemas.openxmlformats.org/drawingml/2006/main">
               <a:ext uri="{FF2B5EF4-FFF2-40B4-BE49-F238E27FC236}">
-                <a16:creationId xmlns:a16="http://schemas.microsoft.com/office/drawing/2014/main" id="{51551537-F4EF-4321-9060-DF83EC99784F}"/>
+                <a16:creationId xmlns:a16="http://schemas.microsoft.com/office/drawing/2014/main" id="{0C1F17F0-1720-4A3B-AF3E-01325A1E8102}"/>
               </a:ext>
             </a:extLst>
           </p:cNvPr>
@@ -6559,7 +6559,7 @@
           <p:cNvPr id="8" name="">
             <a:extLst xmlns:a="http://schemas.openxmlformats.org/drawingml/2006/main">
               <a:ext uri="{FF2B5EF4-FFF2-40B4-BE49-F238E27FC236}">
-                <a16:creationId xmlns:a16="http://schemas.microsoft.com/office/drawing/2014/main" id="{85760E5C-D703-40BF-B939-5243A0A0AB60}"/>
+                <a16:creationId xmlns:a16="http://schemas.microsoft.com/office/drawing/2014/main" id="{AA7AEAE4-41E3-461A-8FEF-EAFBEC7E7D7F}"/>
               </a:ext>
             </a:extLst>
           </p:cNvPr>
@@ -6662,7 +6662,7 @@
           <p:cNvPr id="9" name="">
             <a:extLst xmlns:a="http://schemas.openxmlformats.org/drawingml/2006/main">
               <a:ext uri="{FF2B5EF4-FFF2-40B4-BE49-F238E27FC236}">
-                <a16:creationId xmlns:a16="http://schemas.microsoft.com/office/drawing/2014/main" id="{A0D0FEB1-66B1-4731-B9A9-A7A6F8B44EF9}"/>
+                <a16:creationId xmlns:a16="http://schemas.microsoft.com/office/drawing/2014/main" id="{178F698E-F610-455D-970D-65B1E1ABE903}"/>
               </a:ext>
             </a:extLst>
           </p:cNvPr>
@@ -6697,7 +6697,7 @@
           <p:cNvPr id="10" name="">
             <a:extLst xmlns:a="http://schemas.openxmlformats.org/drawingml/2006/main">
               <a:ext uri="{FF2B5EF4-FFF2-40B4-BE49-F238E27FC236}">
-                <a16:creationId xmlns:a16="http://schemas.microsoft.com/office/drawing/2014/main" id="{0802A94E-BED5-4A44-9924-6F078FEAE752}"/>
+                <a16:creationId xmlns:a16="http://schemas.microsoft.com/office/drawing/2014/main" id="{8324D67F-5CE5-4D34-A9EC-F0B91CF9FDE8}"/>
               </a:ext>
             </a:extLst>
           </p:cNvPr>
@@ -6761,7 +6761,7 @@
           <p:cNvPr id="11" name="">
             <a:extLst xmlns:a="http://schemas.openxmlformats.org/drawingml/2006/main">
               <a:ext uri="{FF2B5EF4-FFF2-40B4-BE49-F238E27FC236}">
-                <a16:creationId xmlns:a16="http://schemas.microsoft.com/office/drawing/2014/main" id="{308B9667-21D6-4931-B7C3-16005ACEABA7}"/>
+                <a16:creationId xmlns:a16="http://schemas.microsoft.com/office/drawing/2014/main" id="{B9BFFC87-5A0A-4556-B29B-A3F5A0DDDC10}"/>
               </a:ext>
             </a:extLst>
           </p:cNvPr>
@@ -6818,7 +6818,7 @@
           <p:cNvPr id="12" name="">
             <a:extLst xmlns:a="http://schemas.openxmlformats.org/drawingml/2006/main">
               <a:ext uri="{FF2B5EF4-FFF2-40B4-BE49-F238E27FC236}">
-                <a16:creationId xmlns:a16="http://schemas.microsoft.com/office/drawing/2014/main" id="{C61B6D5F-145D-47C6-84E8-5F698FB00C7D}"/>
+                <a16:creationId xmlns:a16="http://schemas.microsoft.com/office/drawing/2014/main" id="{7EF55849-DC5E-4779-8805-E0785A486F42}"/>
               </a:ext>
             </a:extLst>
           </p:cNvPr>
@@ -6921,7 +6921,7 @@
           <p:cNvPr id="13" name="">
             <a:extLst xmlns:a="http://schemas.openxmlformats.org/drawingml/2006/main">
               <a:ext uri="{FF2B5EF4-FFF2-40B4-BE49-F238E27FC236}">
-                <a16:creationId xmlns:a16="http://schemas.microsoft.com/office/drawing/2014/main" id="{D67074C8-BC84-4D62-9AFB-C852456FC28C}"/>
+                <a16:creationId xmlns:a16="http://schemas.microsoft.com/office/drawing/2014/main" id="{AFE5A64E-DF54-4C16-8801-2BF9F389F37F}"/>
               </a:ext>
             </a:extLst>
           </p:cNvPr>
@@ -6978,7 +6978,7 @@
           <p:cNvPr id="14" name="">
             <a:extLst xmlns:a="http://schemas.openxmlformats.org/drawingml/2006/main">
               <a:ext uri="{FF2B5EF4-FFF2-40B4-BE49-F238E27FC236}">
-                <a16:creationId xmlns:a16="http://schemas.microsoft.com/office/drawing/2014/main" id="{2437CBF2-8A68-4043-9532-996422742ECA}"/>
+                <a16:creationId xmlns:a16="http://schemas.microsoft.com/office/drawing/2014/main" id="{AFD66E98-2A43-4161-A809-CF8F87DE964D}"/>
               </a:ext>
             </a:extLst>
           </p:cNvPr>
@@ -7013,7 +7013,7 @@
           <p:cNvPr id="15" name="">
             <a:extLst xmlns:a="http://schemas.openxmlformats.org/drawingml/2006/main">
               <a:ext uri="{FF2B5EF4-FFF2-40B4-BE49-F238E27FC236}">
-                <a16:creationId xmlns:a16="http://schemas.microsoft.com/office/drawing/2014/main" id="{296898CC-8370-47BE-AEF2-7AE791337A35}"/>
+                <a16:creationId xmlns:a16="http://schemas.microsoft.com/office/drawing/2014/main" id="{06A01848-4061-4037-923A-886AFEBDA554}"/>
               </a:ext>
             </a:extLst>
           </p:cNvPr>
@@ -7060,7 +7060,7 @@
                 <a:ea typeface="Arial"/>
                 <a:cs typeface="Arial"/>
               </a:rPr>
-              <a:t>80/80</a:t>
+              <a:t>88/88</a:t>
             </a:r>
           </a:p>
         </p:txBody>
@@ -7070,7 +7070,7 @@
           <p:cNvPr id="16" name="">
             <a:extLst xmlns:a="http://schemas.openxmlformats.org/drawingml/2006/main">
               <a:ext uri="{FF2B5EF4-FFF2-40B4-BE49-F238E27FC236}">
-                <a16:creationId xmlns:a16="http://schemas.microsoft.com/office/drawing/2014/main" id="{8807F973-7735-41C1-8A45-9EA6B1AB6FF0}"/>
+                <a16:creationId xmlns:a16="http://schemas.microsoft.com/office/drawing/2014/main" id="{C9CA77E4-A57E-4128-B0C8-59479913FFB6}"/>
               </a:ext>
             </a:extLst>
           </p:cNvPr>
@@ -7127,7 +7127,7 @@
           <p:cNvPr id="17" name="">
             <a:extLst xmlns:a="http://schemas.openxmlformats.org/drawingml/2006/main">
               <a:ext uri="{FF2B5EF4-FFF2-40B4-BE49-F238E27FC236}">
-                <a16:creationId xmlns:a16="http://schemas.microsoft.com/office/drawing/2014/main" id="{49753C23-0E32-4B55-8EBE-892A59AEFC4C}"/>
+                <a16:creationId xmlns:a16="http://schemas.microsoft.com/office/drawing/2014/main" id="{DC3C45E0-3F26-45B9-8C2E-EADDDF2E832E}"/>
               </a:ext>
             </a:extLst>
           </p:cNvPr>
@@ -7162,7 +7162,7 @@
           <p:cNvPr id="18" name="">
             <a:extLst xmlns:a="http://schemas.openxmlformats.org/drawingml/2006/main">
               <a:ext uri="{FF2B5EF4-FFF2-40B4-BE49-F238E27FC236}">
-                <a16:creationId xmlns:a16="http://schemas.microsoft.com/office/drawing/2014/main" id="{7DF5B126-B4F3-447C-AC77-98ECD6175B2D}"/>
+                <a16:creationId xmlns:a16="http://schemas.microsoft.com/office/drawing/2014/main" id="{813A5899-EAB9-424D-BAA7-2393ECA055F1}"/>
               </a:ext>
             </a:extLst>
           </p:cNvPr>
@@ -7219,7 +7219,7 @@
           <p:cNvPr id="19" name="">
             <a:extLst xmlns:a="http://schemas.openxmlformats.org/drawingml/2006/main">
               <a:ext uri="{FF2B5EF4-FFF2-40B4-BE49-F238E27FC236}">
-                <a16:creationId xmlns:a16="http://schemas.microsoft.com/office/drawing/2014/main" id="{70E2E7BA-3022-4ABB-93AD-DA6176BBF849}"/>
+                <a16:creationId xmlns:a16="http://schemas.microsoft.com/office/drawing/2014/main" id="{85E66399-AD72-4D5A-940D-A5A417CDB3F2}"/>
               </a:ext>
             </a:extLst>
           </p:cNvPr>
@@ -7243,7 +7243,7 @@
         </p:spPr>
         <p:txBody>
           <a:bodyPr xmlns:a="http://schemas.openxmlformats.org/drawingml/2006/main" lIns="0" tIns="0" rIns="0" bIns="0" anchor="t">
-            <a:normAutofit fontScale="100000"/>
+            <a:normAutofit fontScale="95646"/>
           </a:bodyPr>
           <a:lstStyle xmlns:a="http://schemas.openxmlformats.org/drawingml/2006/main"/>
           <a:p xmlns:a="http://schemas.openxmlformats.org/drawingml/2006/main">
@@ -7266,7 +7266,7 @@
                 <a:ea typeface="Arial"/>
                 <a:cs typeface="Arial"/>
               </a:rPr>
-              <a:t>3 batch OpenRouter</a:t>
+              <a:t>judge set OpenRouter</a:t>
             </a:r>
           </a:p>
         </p:txBody>
@@ -7276,7 +7276,7 @@
           <p:cNvPr id="20" name="">
             <a:extLst xmlns:a="http://schemas.openxmlformats.org/drawingml/2006/main">
               <a:ext uri="{FF2B5EF4-FFF2-40B4-BE49-F238E27FC236}">
-                <a16:creationId xmlns:a16="http://schemas.microsoft.com/office/drawing/2014/main" id="{42BEC1F0-B7BD-4FCE-BD08-E4195316CAC2}"/>
+                <a16:creationId xmlns:a16="http://schemas.microsoft.com/office/drawing/2014/main" id="{7D9C7005-D313-401E-A86F-36D72AD76F60}"/>
               </a:ext>
             </a:extLst>
           </p:cNvPr>
@@ -7311,7 +7311,7 @@
           <p:cNvPr id="21" name="">
             <a:extLst xmlns:a="http://schemas.openxmlformats.org/drawingml/2006/main">
               <a:ext uri="{FF2B5EF4-FFF2-40B4-BE49-F238E27FC236}">
-                <a16:creationId xmlns:a16="http://schemas.microsoft.com/office/drawing/2014/main" id="{04B452CF-054B-4C8D-8825-FCCE8713580E}"/>
+                <a16:creationId xmlns:a16="http://schemas.microsoft.com/office/drawing/2014/main" id="{EB66505E-8547-46B7-BD26-3AD894E82A0E}"/>
               </a:ext>
             </a:extLst>
           </p:cNvPr>
@@ -7358,7 +7358,7 @@
                 <a:ea typeface="Arial"/>
                 <a:cs typeface="Arial"/>
               </a:rPr>
-              <a:t>25/25</a:t>
+              <a:t>14/15</a:t>
             </a:r>
           </a:p>
         </p:txBody>
@@ -7368,7 +7368,7 @@
           <p:cNvPr id="22" name="">
             <a:extLst xmlns:a="http://schemas.openxmlformats.org/drawingml/2006/main">
               <a:ext uri="{FF2B5EF4-FFF2-40B4-BE49-F238E27FC236}">
-                <a16:creationId xmlns:a16="http://schemas.microsoft.com/office/drawing/2014/main" id="{5A893AB7-EE27-439D-8F16-19ADE9BE83BC}"/>
+                <a16:creationId xmlns:a16="http://schemas.microsoft.com/office/drawing/2014/main" id="{4EFFB63F-F7CE-4333-B6B1-DA9C59779A92}"/>
               </a:ext>
             </a:extLst>
           </p:cNvPr>
@@ -7415,7 +7415,7 @@
                 <a:ea typeface="Arial"/>
                 <a:cs typeface="Arial"/>
               </a:rPr>
-              <a:t>5 batch Ollama</a:t>
+              <a:t>judge set Ollama</a:t>
             </a:r>
           </a:p>
         </p:txBody>
@@ -7425,7 +7425,7 @@
           <p:cNvPr id="23" name="">
             <a:extLst xmlns:a="http://schemas.openxmlformats.org/drawingml/2006/main">
               <a:ext uri="{FF2B5EF4-FFF2-40B4-BE49-F238E27FC236}">
-                <a16:creationId xmlns:a16="http://schemas.microsoft.com/office/drawing/2014/main" id="{5B02E96E-6168-4FF7-BB01-0075BF8FF4F2}"/>
+                <a16:creationId xmlns:a16="http://schemas.microsoft.com/office/drawing/2014/main" id="{3324DA6B-5C0A-4257-AC2A-EF66C836D5F0}"/>
               </a:ext>
             </a:extLst>
           </p:cNvPr>
@@ -7460,7 +7460,7 @@
           <p:cNvPr id="24" name="">
             <a:extLst xmlns:a="http://schemas.openxmlformats.org/drawingml/2006/main">
               <a:ext uri="{FF2B5EF4-FFF2-40B4-BE49-F238E27FC236}">
-                <a16:creationId xmlns:a16="http://schemas.microsoft.com/office/drawing/2014/main" id="{943790C8-8AFE-4A16-8F2F-56E9ACD9F265}"/>
+                <a16:creationId xmlns:a16="http://schemas.microsoft.com/office/drawing/2014/main" id="{9B8E0151-6E91-47AD-BEFD-9C21CBCEAC6E}"/>
               </a:ext>
             </a:extLst>
           </p:cNvPr>
@@ -7517,7 +7517,7 @@
           <p:cNvPr id="25" name="">
             <a:extLst xmlns:a="http://schemas.openxmlformats.org/drawingml/2006/main">
               <a:ext uri="{FF2B5EF4-FFF2-40B4-BE49-F238E27FC236}">
-                <a16:creationId xmlns:a16="http://schemas.microsoft.com/office/drawing/2014/main" id="{38B2441C-E12F-4127-9CDB-51DA66E06932}"/>
+                <a16:creationId xmlns:a16="http://schemas.microsoft.com/office/drawing/2014/main" id="{BBB8178F-5FF6-4F14-A52B-A5CF9721FF92}"/>
               </a:ext>
             </a:extLst>
           </p:cNvPr>
@@ -7581,7 +7581,7 @@
           <p:cNvPr id="26" name="">
             <a:extLst xmlns:a="http://schemas.openxmlformats.org/drawingml/2006/main">
               <a:ext uri="{FF2B5EF4-FFF2-40B4-BE49-F238E27FC236}">
-                <a16:creationId xmlns:a16="http://schemas.microsoft.com/office/drawing/2014/main" id="{2E6B4854-60AD-41E6-9FFD-650D76A21619}"/>
+                <a16:creationId xmlns:a16="http://schemas.microsoft.com/office/drawing/2014/main" id="{03F7FEC1-42E4-4538-A342-59FBBB2BC740}"/>
               </a:ext>
             </a:extLst>
           </p:cNvPr>
@@ -7645,7 +7645,7 @@
           <p:cNvPr id="27" name="">
             <a:extLst xmlns:a="http://schemas.openxmlformats.org/drawingml/2006/main">
               <a:ext uri="{FF2B5EF4-FFF2-40B4-BE49-F238E27FC236}">
-                <a16:creationId xmlns:a16="http://schemas.microsoft.com/office/drawing/2014/main" id="{F5AD453D-99B4-4DC3-9A6A-F560882311FC}"/>
+                <a16:creationId xmlns:a16="http://schemas.microsoft.com/office/drawing/2014/main" id="{91E6E5B5-086E-46C6-8786-4292E07A69DC}"/>
               </a:ext>
             </a:extLst>
           </p:cNvPr>
@@ -7709,7 +7709,7 @@
           <p:cNvPr id="28" name="">
             <a:extLst xmlns:a="http://schemas.openxmlformats.org/drawingml/2006/main">
               <a:ext uri="{FF2B5EF4-FFF2-40B4-BE49-F238E27FC236}">
-                <a16:creationId xmlns:a16="http://schemas.microsoft.com/office/drawing/2014/main" id="{DED49C01-64EE-4ADC-A960-695616B5E795}"/>
+                <a16:creationId xmlns:a16="http://schemas.microsoft.com/office/drawing/2014/main" id="{A7DBC37A-5F3B-4861-BA4D-A1F92E0B5E8F}"/>
               </a:ext>
             </a:extLst>
           </p:cNvPr>
@@ -7773,7 +7773,7 @@
           <p:cNvPr id="29" name="">
             <a:extLst xmlns:a="http://schemas.openxmlformats.org/drawingml/2006/main">
               <a:ext uri="{FF2B5EF4-FFF2-40B4-BE49-F238E27FC236}">
-                <a16:creationId xmlns:a16="http://schemas.microsoft.com/office/drawing/2014/main" id="{8A485574-0005-47B7-8687-7E3D14E7B164}"/>
+                <a16:creationId xmlns:a16="http://schemas.microsoft.com/office/drawing/2014/main" id="{867049EB-F346-45A6-88CE-B0F104A6CBA9}"/>
               </a:ext>
             </a:extLst>
           </p:cNvPr>
@@ -7830,7 +7830,7 @@
           <p:cNvPr id="30" name="">
             <a:extLst xmlns:a="http://schemas.openxmlformats.org/drawingml/2006/main">
               <a:ext uri="{FF2B5EF4-FFF2-40B4-BE49-F238E27FC236}">
-                <a16:creationId xmlns:a16="http://schemas.microsoft.com/office/drawing/2014/main" id="{7D67A564-EEFE-4A03-99A9-D2212534DA90}"/>
+                <a16:creationId xmlns:a16="http://schemas.microsoft.com/office/drawing/2014/main" id="{3A28D2E1-F9A6-4667-94C9-A115539ADA73}"/>
               </a:ext>
             </a:extLst>
           </p:cNvPr>
@@ -7877,7 +7877,7 @@
                 <a:ea typeface="Arial"/>
                 <a:cs typeface="Arial"/>
               </a:rPr>
-              <a:t>AURA • Track A • 28/09/2026</a:t>
+              <a:t>AURA • Track A • 29/09/2026</a:t>
             </a:r>
           </a:p>
         </p:txBody>
@@ -7887,19 +7887,19 @@
           <p:cNvPr id="31" name="">
             <a:extLst xmlns:a="http://schemas.openxmlformats.org/drawingml/2006/main">
               <a:ext uri="{FF2B5EF4-FFF2-40B4-BE49-F238E27FC236}">
-                <a16:creationId xmlns:a16="http://schemas.microsoft.com/office/drawing/2014/main" id="{D7359B28-6A08-43A7-82CB-6B620EE512BA}"/>
-              </a:ext>
-            </a:extLst>
-          </p:cNvPr>
-          <p:cNvSpPr>
-            <a:spLocks xmlns:a="http://schemas.openxmlformats.org/drawingml/2006/main" noGrp="1"/>
-          </p:cNvSpPr>
-          <p:nvPr/>
-        </p:nvSpPr>
-        <p:spPr>
-          <a:xfrm xmlns:a="http://schemas.openxmlformats.org/drawingml/2006/main">
-            <a:off x="11049000" y="6515100"/>
-            <a:ext cx="609600" cy="190500"/>
+                <a16:creationId xmlns:a16="http://schemas.microsoft.com/office/drawing/2014/main" id="{ACCE9224-371A-4758-BC41-8E2E838669EC}"/>
+              </a:ext>
+            </a:extLst>
+          </p:cNvPr>
+          <p:cNvSpPr>
+            <a:spLocks xmlns:a="http://schemas.openxmlformats.org/drawingml/2006/main" noGrp="1"/>
+          </p:cNvSpPr>
+          <p:nvPr/>
+        </p:nvSpPr>
+        <p:spPr>
+          <a:xfrm xmlns:a="http://schemas.openxmlformats.org/drawingml/2006/main">
+            <a:off x="11144250" y="6515100"/>
+            <a:ext cx="514350" cy="190500"/>
           </a:xfrm>
           <a:prstGeom xmlns:a="http://schemas.openxmlformats.org/drawingml/2006/main" prst="rect">
             <a:avLst/>
@@ -7934,7 +7934,7 @@
                 <a:ea typeface="Arial"/>
                 <a:cs typeface="Arial"/>
               </a:rPr>
-              <a:t>3/5</a:t>
+              <a:t>3</a:t>
             </a:r>
           </a:p>
         </p:txBody>
@@ -7942,7 +7942,7 @@
     </p:spTree>
     <p:extLst>
       <p:ext uri="{BB962C8B-B14F-4D97-AF65-F5344CB8AC3E}">
-        <p14:creationId xmlns:p14="http://schemas.microsoft.com/office/powerpoint/2010/main" val="211203926"/>
+        <p14:creationId xmlns:p14="http://schemas.microsoft.com/office/powerpoint/2010/main" val="1010242632"/>
       </p:ext>
     </p:extLst>
   </p:cSld>
@@ -7973,19 +7973,19 @@
           <p:cNvPr id="32" name="">
             <a:extLst xmlns:a="http://schemas.openxmlformats.org/drawingml/2006/main">
               <a:ext uri="{FF2B5EF4-FFF2-40B4-BE49-F238E27FC236}">
-                <a16:creationId xmlns:a16="http://schemas.microsoft.com/office/drawing/2014/main" id="{329D43FE-F06B-49DB-B5F0-16D73A296A05}"/>
-              </a:ext>
-            </a:extLst>
-          </p:cNvPr>
-          <p:cNvSpPr>
-            <a:spLocks xmlns:a="http://schemas.openxmlformats.org/drawingml/2006/main" noGrp="1"/>
-          </p:cNvSpPr>
-          <p:nvPr/>
-        </p:nvSpPr>
-        <p:spPr>
-          <a:xfrm xmlns:a="http://schemas.openxmlformats.org/drawingml/2006/main">
-            <a:off x="514350" y="361950"/>
-            <a:ext cx="514350" cy="323850"/>
+                <a16:creationId xmlns:a16="http://schemas.microsoft.com/office/drawing/2014/main" id="{C3797956-D0AB-4ABE-8237-256A67E996B7}"/>
+              </a:ext>
+            </a:extLst>
+          </p:cNvPr>
+          <p:cNvSpPr>
+            <a:spLocks xmlns:a="http://schemas.openxmlformats.org/drawingml/2006/main" noGrp="1"/>
+          </p:cNvSpPr>
+          <p:nvPr/>
+        </p:nvSpPr>
+        <p:spPr>
+          <a:xfrm xmlns:a="http://schemas.openxmlformats.org/drawingml/2006/main">
+            <a:off x="476250" y="361950"/>
+            <a:ext cx="647700" cy="323850"/>
           </a:xfrm>
           <a:prstGeom xmlns:a="http://schemas.openxmlformats.org/drawingml/2006/main" prst="rect">
             <a:avLst/>
@@ -8030,7 +8030,7 @@
           <p:cNvPr id="2" name="">
             <a:extLst xmlns:a="http://schemas.openxmlformats.org/drawingml/2006/main">
               <a:ext uri="{FF2B5EF4-FFF2-40B4-BE49-F238E27FC236}">
-                <a16:creationId xmlns:a16="http://schemas.microsoft.com/office/drawing/2014/main" id="{3A89D916-01CE-4843-8DA5-0E267FE6C0F8}"/>
+                <a16:creationId xmlns:a16="http://schemas.microsoft.com/office/drawing/2014/main" id="{584FD613-F647-45A0-B3A3-403EBF9545C0}"/>
               </a:ext>
             </a:extLst>
           </p:cNvPr>
@@ -8087,7 +8087,7 @@
           <p:cNvPr id="3" name="">
             <a:extLst xmlns:a="http://schemas.openxmlformats.org/drawingml/2006/main">
               <a:ext uri="{FF2B5EF4-FFF2-40B4-BE49-F238E27FC236}">
-                <a16:creationId xmlns:a16="http://schemas.microsoft.com/office/drawing/2014/main" id="{98D2D73B-B3E5-48D8-ABF4-A140DE27E1EB}"/>
+                <a16:creationId xmlns:a16="http://schemas.microsoft.com/office/drawing/2014/main" id="{DDAF7492-EF35-4CB8-A7D7-1BFAF8DAC934}"/>
               </a:ext>
             </a:extLst>
           </p:cNvPr>
@@ -8144,7 +8144,7 @@
           <p:cNvPr id="4" name="">
             <a:extLst xmlns:a="http://schemas.openxmlformats.org/drawingml/2006/main">
               <a:ext uri="{FF2B5EF4-FFF2-40B4-BE49-F238E27FC236}">
-                <a16:creationId xmlns:a16="http://schemas.microsoft.com/office/drawing/2014/main" id="{2ED0CDC4-E3B4-456C-9550-10EF95AF9B29}"/>
+                <a16:creationId xmlns:a16="http://schemas.microsoft.com/office/drawing/2014/main" id="{C68FC1DA-61E2-4196-8AAE-3AFF0F5B11AE}"/>
               </a:ext>
             </a:extLst>
           </p:cNvPr>
@@ -8175,7 +8175,7 @@
           <p:cNvPr id="5" name="">
             <a:extLst xmlns:a="http://schemas.openxmlformats.org/drawingml/2006/main">
               <a:ext uri="{FF2B5EF4-FFF2-40B4-BE49-F238E27FC236}">
-                <a16:creationId xmlns:a16="http://schemas.microsoft.com/office/drawing/2014/main" id="{99663A5A-072C-420E-A0CF-FD13FDECCCA8}"/>
+                <a16:creationId xmlns:a16="http://schemas.microsoft.com/office/drawing/2014/main" id="{0947BFFA-6A40-4B65-93B3-B6CD23776516}"/>
               </a:ext>
             </a:extLst>
           </p:cNvPr>
@@ -8210,7 +8210,7 @@
           <p:cNvPr id="6" name="">
             <a:extLst xmlns:a="http://schemas.openxmlformats.org/drawingml/2006/main">
               <a:ext uri="{FF2B5EF4-FFF2-40B4-BE49-F238E27FC236}">
-                <a16:creationId xmlns:a16="http://schemas.microsoft.com/office/drawing/2014/main" id="{1175A6B4-B978-4AAA-8F87-332AB80BB7F7}"/>
+                <a16:creationId xmlns:a16="http://schemas.microsoft.com/office/drawing/2014/main" id="{8BE2A748-C40B-41CE-B5B9-AF472279F817}"/>
               </a:ext>
             </a:extLst>
           </p:cNvPr>
@@ -8274,7 +8274,7 @@
           <p:cNvPr id="7" name="">
             <a:extLst xmlns:a="http://schemas.openxmlformats.org/drawingml/2006/main">
               <a:ext uri="{FF2B5EF4-FFF2-40B4-BE49-F238E27FC236}">
-                <a16:creationId xmlns:a16="http://schemas.microsoft.com/office/drawing/2014/main" id="{58E97EDA-D76C-4F66-B0CC-26ACA2B2C6C0}"/>
+                <a16:creationId xmlns:a16="http://schemas.microsoft.com/office/drawing/2014/main" id="{C64947A7-EF2C-4DFB-AD11-8E8AA244ACF4}"/>
               </a:ext>
             </a:extLst>
           </p:cNvPr>
@@ -8331,7 +8331,7 @@
           <p:cNvPr id="8" name="">
             <a:extLst xmlns:a="http://schemas.openxmlformats.org/drawingml/2006/main">
               <a:ext uri="{FF2B5EF4-FFF2-40B4-BE49-F238E27FC236}">
-                <a16:creationId xmlns:a16="http://schemas.microsoft.com/office/drawing/2014/main" id="{5BE957FC-22AC-4B5F-98FE-F2858ACA97D4}"/>
+                <a16:creationId xmlns:a16="http://schemas.microsoft.com/office/drawing/2014/main" id="{038EA3FD-5A69-40AC-BE2A-08E43F871C36}"/>
               </a:ext>
             </a:extLst>
           </p:cNvPr>
@@ -8362,7 +8362,7 @@
           <p:cNvPr id="9" name="">
             <a:extLst xmlns:a="http://schemas.openxmlformats.org/drawingml/2006/main">
               <a:ext uri="{FF2B5EF4-FFF2-40B4-BE49-F238E27FC236}">
-                <a16:creationId xmlns:a16="http://schemas.microsoft.com/office/drawing/2014/main" id="{B66495C1-A327-48F7-A851-4938ABDD7972}"/>
+                <a16:creationId xmlns:a16="http://schemas.microsoft.com/office/drawing/2014/main" id="{4F713B53-810C-4735-B11B-3B4F0B13A3C6}"/>
               </a:ext>
             </a:extLst>
           </p:cNvPr>
@@ -8397,7 +8397,7 @@
           <p:cNvPr id="10" name="">
             <a:extLst xmlns:a="http://schemas.openxmlformats.org/drawingml/2006/main">
               <a:ext uri="{FF2B5EF4-FFF2-40B4-BE49-F238E27FC236}">
-                <a16:creationId xmlns:a16="http://schemas.microsoft.com/office/drawing/2014/main" id="{F6EB59F0-B0D5-4845-9FBA-3801288441EF}"/>
+                <a16:creationId xmlns:a16="http://schemas.microsoft.com/office/drawing/2014/main" id="{9A171F2B-C0A9-4A0E-90BE-A44CF697DC87}"/>
               </a:ext>
             </a:extLst>
           </p:cNvPr>
@@ -8461,7 +8461,7 @@
           <p:cNvPr id="11" name="">
             <a:extLst xmlns:a="http://schemas.openxmlformats.org/drawingml/2006/main">
               <a:ext uri="{FF2B5EF4-FFF2-40B4-BE49-F238E27FC236}">
-                <a16:creationId xmlns:a16="http://schemas.microsoft.com/office/drawing/2014/main" id="{C5C40859-E89C-4DD2-8557-9F0F8BA24B38}"/>
+                <a16:creationId xmlns:a16="http://schemas.microsoft.com/office/drawing/2014/main" id="{358EF0B2-D731-4039-AF85-CA1FE4013427}"/>
               </a:ext>
             </a:extLst>
           </p:cNvPr>
@@ -8518,7 +8518,7 @@
           <p:cNvPr id="12" name="">
             <a:extLst xmlns:a="http://schemas.openxmlformats.org/drawingml/2006/main">
               <a:ext uri="{FF2B5EF4-FFF2-40B4-BE49-F238E27FC236}">
-                <a16:creationId xmlns:a16="http://schemas.microsoft.com/office/drawing/2014/main" id="{DEEE48EA-6BCD-41A7-B0DA-030270E85BFD}"/>
+                <a16:creationId xmlns:a16="http://schemas.microsoft.com/office/drawing/2014/main" id="{F1361D28-EC35-4048-ABA0-5CA77EA6916F}"/>
               </a:ext>
             </a:extLst>
           </p:cNvPr>
@@ -8549,7 +8549,7 @@
           <p:cNvPr id="13" name="">
             <a:extLst xmlns:a="http://schemas.openxmlformats.org/drawingml/2006/main">
               <a:ext uri="{FF2B5EF4-FFF2-40B4-BE49-F238E27FC236}">
-                <a16:creationId xmlns:a16="http://schemas.microsoft.com/office/drawing/2014/main" id="{B86486BC-F8E6-4FC2-8BF3-2C23EF8CD618}"/>
+                <a16:creationId xmlns:a16="http://schemas.microsoft.com/office/drawing/2014/main" id="{B6D06C3B-8363-4CA6-B36A-1ABE910BC47A}"/>
               </a:ext>
             </a:extLst>
           </p:cNvPr>
@@ -8584,7 +8584,7 @@
           <p:cNvPr id="14" name="">
             <a:extLst xmlns:a="http://schemas.openxmlformats.org/drawingml/2006/main">
               <a:ext uri="{FF2B5EF4-FFF2-40B4-BE49-F238E27FC236}">
-                <a16:creationId xmlns:a16="http://schemas.microsoft.com/office/drawing/2014/main" id="{106124C4-438C-47DB-9201-A948451219FC}"/>
+                <a16:creationId xmlns:a16="http://schemas.microsoft.com/office/drawing/2014/main" id="{012012A0-B699-48A7-A0FC-3D178EAF882D}"/>
               </a:ext>
             </a:extLst>
           </p:cNvPr>
@@ -8648,7 +8648,7 @@
           <p:cNvPr id="15" name="">
             <a:extLst xmlns:a="http://schemas.openxmlformats.org/drawingml/2006/main">
               <a:ext uri="{FF2B5EF4-FFF2-40B4-BE49-F238E27FC236}">
-                <a16:creationId xmlns:a16="http://schemas.microsoft.com/office/drawing/2014/main" id="{F1953AFB-CA06-4676-9A2E-DFC34673427E}"/>
+                <a16:creationId xmlns:a16="http://schemas.microsoft.com/office/drawing/2014/main" id="{92DE37FE-2809-45E7-B66A-FEC91E2281E7}"/>
               </a:ext>
             </a:extLst>
           </p:cNvPr>
@@ -8705,7 +8705,7 @@
           <p:cNvPr id="16" name="">
             <a:extLst xmlns:a="http://schemas.openxmlformats.org/drawingml/2006/main">
               <a:ext uri="{FF2B5EF4-FFF2-40B4-BE49-F238E27FC236}">
-                <a16:creationId xmlns:a16="http://schemas.microsoft.com/office/drawing/2014/main" id="{9F202033-F9A3-4CED-A84C-6F2455E1821B}"/>
+                <a16:creationId xmlns:a16="http://schemas.microsoft.com/office/drawing/2014/main" id="{36D34321-C0F6-45D2-8748-5B32DD85BDCB}"/>
               </a:ext>
             </a:extLst>
           </p:cNvPr>
@@ -8736,7 +8736,7 @@
           <p:cNvPr id="17" name="">
             <a:extLst xmlns:a="http://schemas.openxmlformats.org/drawingml/2006/main">
               <a:ext uri="{FF2B5EF4-FFF2-40B4-BE49-F238E27FC236}">
-                <a16:creationId xmlns:a16="http://schemas.microsoft.com/office/drawing/2014/main" id="{7836AB93-6C05-406A-AFFF-29CFB7C575AA}"/>
+                <a16:creationId xmlns:a16="http://schemas.microsoft.com/office/drawing/2014/main" id="{2B100DBD-C125-4B5C-B893-4BCDB102CB82}"/>
               </a:ext>
             </a:extLst>
           </p:cNvPr>
@@ -8771,7 +8771,7 @@
           <p:cNvPr id="18" name="">
             <a:extLst xmlns:a="http://schemas.openxmlformats.org/drawingml/2006/main">
               <a:ext uri="{FF2B5EF4-FFF2-40B4-BE49-F238E27FC236}">
-                <a16:creationId xmlns:a16="http://schemas.microsoft.com/office/drawing/2014/main" id="{20F9BC3E-C3D5-44D6-964E-1EA1E31EC0DF}"/>
+                <a16:creationId xmlns:a16="http://schemas.microsoft.com/office/drawing/2014/main" id="{5B2BE495-6DAA-4C39-B090-44F8ECF5CFDB}"/>
               </a:ext>
             </a:extLst>
           </p:cNvPr>
@@ -8835,7 +8835,7 @@
           <p:cNvPr id="19" name="">
             <a:extLst xmlns:a="http://schemas.openxmlformats.org/drawingml/2006/main">
               <a:ext uri="{FF2B5EF4-FFF2-40B4-BE49-F238E27FC236}">
-                <a16:creationId xmlns:a16="http://schemas.microsoft.com/office/drawing/2014/main" id="{9B923D05-BD16-43AC-A083-0219B615C871}"/>
+                <a16:creationId xmlns:a16="http://schemas.microsoft.com/office/drawing/2014/main" id="{E2ACBCB5-1186-4093-A1E9-61BA11089E11}"/>
               </a:ext>
             </a:extLst>
           </p:cNvPr>
@@ -8892,7 +8892,7 @@
           <p:cNvPr id="20" name="">
             <a:extLst xmlns:a="http://schemas.openxmlformats.org/drawingml/2006/main">
               <a:ext uri="{FF2B5EF4-FFF2-40B4-BE49-F238E27FC236}">
-                <a16:creationId xmlns:a16="http://schemas.microsoft.com/office/drawing/2014/main" id="{B26446F0-7742-4C87-89D9-D4937C650D46}"/>
+                <a16:creationId xmlns:a16="http://schemas.microsoft.com/office/drawing/2014/main" id="{8AFD75CD-F46E-4FC3-9FDA-C710708228CE}"/>
               </a:ext>
             </a:extLst>
           </p:cNvPr>
@@ -8927,7 +8927,7 @@
           <p:cNvPr id="21" name="">
             <a:extLst xmlns:a="http://schemas.openxmlformats.org/drawingml/2006/main">
               <a:ext uri="{FF2B5EF4-FFF2-40B4-BE49-F238E27FC236}">
-                <a16:creationId xmlns:a16="http://schemas.microsoft.com/office/drawing/2014/main" id="{3F83D8EF-614A-4FFC-A978-1603803821B2}"/>
+                <a16:creationId xmlns:a16="http://schemas.microsoft.com/office/drawing/2014/main" id="{EB5A99A9-9124-4D91-908C-2593A41F62BF}"/>
               </a:ext>
             </a:extLst>
           </p:cNvPr>
@@ -8984,7 +8984,7 @@
           <p:cNvPr id="22" name="">
             <a:extLst xmlns:a="http://schemas.openxmlformats.org/drawingml/2006/main">
               <a:ext uri="{FF2B5EF4-FFF2-40B4-BE49-F238E27FC236}">
-                <a16:creationId xmlns:a16="http://schemas.microsoft.com/office/drawing/2014/main" id="{DC2E37AC-1EF2-4E7D-8F90-E230ADE63D63}"/>
+                <a16:creationId xmlns:a16="http://schemas.microsoft.com/office/drawing/2014/main" id="{097B3A0C-7B05-4679-9412-892C86D5E6B1}"/>
               </a:ext>
             </a:extLst>
           </p:cNvPr>
@@ -9041,7 +9041,7 @@
           <p:cNvPr id="23" name="">
             <a:extLst xmlns:a="http://schemas.openxmlformats.org/drawingml/2006/main">
               <a:ext uri="{FF2B5EF4-FFF2-40B4-BE49-F238E27FC236}">
-                <a16:creationId xmlns:a16="http://schemas.microsoft.com/office/drawing/2014/main" id="{A963FA58-2544-4859-A191-810A70E918E9}"/>
+                <a16:creationId xmlns:a16="http://schemas.microsoft.com/office/drawing/2014/main" id="{F4DEE146-82BD-4027-8398-91E4E8257EA2}"/>
               </a:ext>
             </a:extLst>
           </p:cNvPr>
@@ -9076,7 +9076,7 @@
           <p:cNvPr id="24" name="">
             <a:extLst xmlns:a="http://schemas.openxmlformats.org/drawingml/2006/main">
               <a:ext uri="{FF2B5EF4-FFF2-40B4-BE49-F238E27FC236}">
-                <a16:creationId xmlns:a16="http://schemas.microsoft.com/office/drawing/2014/main" id="{02F24F32-765B-43D1-9E2A-DD84112FD48E}"/>
+                <a16:creationId xmlns:a16="http://schemas.microsoft.com/office/drawing/2014/main" id="{54581F25-E189-4B17-8588-E502C3945BB7}"/>
               </a:ext>
             </a:extLst>
           </p:cNvPr>
@@ -9140,7 +9140,7 @@
           <p:cNvPr id="25" name="">
             <a:extLst xmlns:a="http://schemas.openxmlformats.org/drawingml/2006/main">
               <a:ext uri="{FF2B5EF4-FFF2-40B4-BE49-F238E27FC236}">
-                <a16:creationId xmlns:a16="http://schemas.microsoft.com/office/drawing/2014/main" id="{A2BB38EF-84A4-4830-95A0-2F360527FFCB}"/>
+                <a16:creationId xmlns:a16="http://schemas.microsoft.com/office/drawing/2014/main" id="{0C3227FA-61B5-461F-82D9-9AE24B495BB7}"/>
               </a:ext>
             </a:extLst>
           </p:cNvPr>
@@ -9266,7 +9266,7 @@
           <p:cNvPr id="26" name="">
             <a:extLst xmlns:a="http://schemas.openxmlformats.org/drawingml/2006/main">
               <a:ext uri="{FF2B5EF4-FFF2-40B4-BE49-F238E27FC236}">
-                <a16:creationId xmlns:a16="http://schemas.microsoft.com/office/drawing/2014/main" id="{D4258E4A-E0C1-4D16-AC91-C28C028B4EE8}"/>
+                <a16:creationId xmlns:a16="http://schemas.microsoft.com/office/drawing/2014/main" id="{6500BE82-ADB8-45F2-9216-93D025EFF740}"/>
               </a:ext>
             </a:extLst>
           </p:cNvPr>
@@ -9301,7 +9301,7 @@
           <p:cNvPr id="27" name="">
             <a:extLst xmlns:a="http://schemas.openxmlformats.org/drawingml/2006/main">
               <a:ext uri="{FF2B5EF4-FFF2-40B4-BE49-F238E27FC236}">
-                <a16:creationId xmlns:a16="http://schemas.microsoft.com/office/drawing/2014/main" id="{54BD79B4-E483-482E-8876-BC5A191A6312}"/>
+                <a16:creationId xmlns:a16="http://schemas.microsoft.com/office/drawing/2014/main" id="{4052A8CE-7B55-4A4C-BA69-B8DAF84B0E98}"/>
               </a:ext>
             </a:extLst>
           </p:cNvPr>
@@ -9365,7 +9365,7 @@
           <p:cNvPr id="28" name="">
             <a:extLst xmlns:a="http://schemas.openxmlformats.org/drawingml/2006/main">
               <a:ext uri="{FF2B5EF4-FFF2-40B4-BE49-F238E27FC236}">
-                <a16:creationId xmlns:a16="http://schemas.microsoft.com/office/drawing/2014/main" id="{28059F51-3EF2-4D4E-9FAC-2CA56A33B76B}"/>
+                <a16:creationId xmlns:a16="http://schemas.microsoft.com/office/drawing/2014/main" id="{89F5758B-8147-4705-88A2-D70E41BCCE76}"/>
               </a:ext>
             </a:extLst>
           </p:cNvPr>
@@ -9468,7 +9468,7 @@
           <p:cNvPr id="29" name="">
             <a:extLst xmlns:a="http://schemas.openxmlformats.org/drawingml/2006/main">
               <a:ext uri="{FF2B5EF4-FFF2-40B4-BE49-F238E27FC236}">
-                <a16:creationId xmlns:a16="http://schemas.microsoft.com/office/drawing/2014/main" id="{935BBE93-8477-4DB6-9771-8A0FB2F06231}"/>
+                <a16:creationId xmlns:a16="http://schemas.microsoft.com/office/drawing/2014/main" id="{45FDFC91-52B1-4998-9203-6677A7F07DB1}"/>
               </a:ext>
             </a:extLst>
           </p:cNvPr>
@@ -9548,7 +9548,7 @@
           <p:cNvPr id="30" name="">
             <a:extLst xmlns:a="http://schemas.openxmlformats.org/drawingml/2006/main">
               <a:ext uri="{FF2B5EF4-FFF2-40B4-BE49-F238E27FC236}">
-                <a16:creationId xmlns:a16="http://schemas.microsoft.com/office/drawing/2014/main" id="{A1541F4D-75B0-4FDA-8E85-E611A4B287D5}"/>
+                <a16:creationId xmlns:a16="http://schemas.microsoft.com/office/drawing/2014/main" id="{9AF184A3-E8CB-4E03-B489-716B8EAB1E69}"/>
               </a:ext>
             </a:extLst>
           </p:cNvPr>
@@ -9595,7 +9595,7 @@
                 <a:ea typeface="Arial"/>
                 <a:cs typeface="Arial"/>
               </a:rPr>
-              <a:t>AURA • Track A • 28/09/2026</a:t>
+              <a:t>AURA • Track A • 29/09/2026</a:t>
             </a:r>
           </a:p>
         </p:txBody>
@@ -9605,19 +9605,19 @@
           <p:cNvPr id="31" name="">
             <a:extLst xmlns:a="http://schemas.openxmlformats.org/drawingml/2006/main">
               <a:ext uri="{FF2B5EF4-FFF2-40B4-BE49-F238E27FC236}">
-                <a16:creationId xmlns:a16="http://schemas.microsoft.com/office/drawing/2014/main" id="{DBD098D4-410E-471A-AFE5-BFFCEA62D2F9}"/>
-              </a:ext>
-            </a:extLst>
-          </p:cNvPr>
-          <p:cNvSpPr>
-            <a:spLocks xmlns:a="http://schemas.openxmlformats.org/drawingml/2006/main" noGrp="1"/>
-          </p:cNvSpPr>
-          <p:nvPr/>
-        </p:nvSpPr>
-        <p:spPr>
-          <a:xfrm xmlns:a="http://schemas.openxmlformats.org/drawingml/2006/main">
-            <a:off x="11049000" y="6515100"/>
-            <a:ext cx="609600" cy="190500"/>
+                <a16:creationId xmlns:a16="http://schemas.microsoft.com/office/drawing/2014/main" id="{5D4A919A-9CD0-47CC-B372-451FDCCFCB5A}"/>
+              </a:ext>
+            </a:extLst>
+          </p:cNvPr>
+          <p:cNvSpPr>
+            <a:spLocks xmlns:a="http://schemas.openxmlformats.org/drawingml/2006/main" noGrp="1"/>
+          </p:cNvSpPr>
+          <p:nvPr/>
+        </p:nvSpPr>
+        <p:spPr>
+          <a:xfrm xmlns:a="http://schemas.openxmlformats.org/drawingml/2006/main">
+            <a:off x="11144250" y="6515100"/>
+            <a:ext cx="514350" cy="190500"/>
           </a:xfrm>
           <a:prstGeom xmlns:a="http://schemas.openxmlformats.org/drawingml/2006/main" prst="rect">
             <a:avLst/>
@@ -9652,7 +9652,7 @@
                 <a:ea typeface="Arial"/>
                 <a:cs typeface="Arial"/>
               </a:rPr>
-              <a:t>4/5</a:t>
+              <a:t>4</a:t>
             </a:r>
           </a:p>
         </p:txBody>
@@ -9660,7 +9660,7 @@
     </p:spTree>
     <p:extLst>
       <p:ext uri="{BB962C8B-B14F-4D97-AF65-F5344CB8AC3E}">
-        <p14:creationId xmlns:p14="http://schemas.microsoft.com/office/powerpoint/2010/main" val="1047596726"/>
+        <p14:creationId xmlns:p14="http://schemas.microsoft.com/office/powerpoint/2010/main" val="256710604"/>
       </p:ext>
     </p:extLst>
   </p:cSld>
@@ -9691,19 +9691,19 @@
           <p:cNvPr id="36" name="">
             <a:extLst xmlns:a="http://schemas.openxmlformats.org/drawingml/2006/main">
               <a:ext uri="{FF2B5EF4-FFF2-40B4-BE49-F238E27FC236}">
-                <a16:creationId xmlns:a16="http://schemas.microsoft.com/office/drawing/2014/main" id="{6EE12D9A-AB11-4EBC-BFAB-C517A742EB4B}"/>
-              </a:ext>
-            </a:extLst>
-          </p:cNvPr>
-          <p:cNvSpPr>
-            <a:spLocks xmlns:a="http://schemas.openxmlformats.org/drawingml/2006/main" noGrp="1"/>
-          </p:cNvSpPr>
-          <p:nvPr/>
-        </p:nvSpPr>
-        <p:spPr>
-          <a:xfrm xmlns:a="http://schemas.openxmlformats.org/drawingml/2006/main">
-            <a:off x="514350" y="361950"/>
-            <a:ext cx="514350" cy="323850"/>
+                <a16:creationId xmlns:a16="http://schemas.microsoft.com/office/drawing/2014/main" id="{A16660F7-6B35-4B54-8E85-1650FA0E0DC2}"/>
+              </a:ext>
+            </a:extLst>
+          </p:cNvPr>
+          <p:cNvSpPr>
+            <a:spLocks xmlns:a="http://schemas.openxmlformats.org/drawingml/2006/main" noGrp="1"/>
+          </p:cNvSpPr>
+          <p:nvPr/>
+        </p:nvSpPr>
+        <p:spPr>
+          <a:xfrm xmlns:a="http://schemas.openxmlformats.org/drawingml/2006/main">
+            <a:off x="476250" y="361950"/>
+            <a:ext cx="647700" cy="323850"/>
           </a:xfrm>
           <a:prstGeom xmlns:a="http://schemas.openxmlformats.org/drawingml/2006/main" prst="rect">
             <a:avLst/>
@@ -9748,7 +9748,7 @@
           <p:cNvPr id="2" name="">
             <a:extLst xmlns:a="http://schemas.openxmlformats.org/drawingml/2006/main">
               <a:ext uri="{FF2B5EF4-FFF2-40B4-BE49-F238E27FC236}">
-                <a16:creationId xmlns:a16="http://schemas.microsoft.com/office/drawing/2014/main" id="{C9650FF0-3646-495C-9679-680E56FD0ABC}"/>
+                <a16:creationId xmlns:a16="http://schemas.microsoft.com/office/drawing/2014/main" id="{B51DE4AB-F50F-4263-A5BF-7E2EBF5AB805}"/>
               </a:ext>
             </a:extLst>
           </p:cNvPr>
@@ -9805,7 +9805,7 @@
           <p:cNvPr id="3" name="">
             <a:extLst xmlns:a="http://schemas.openxmlformats.org/drawingml/2006/main">
               <a:ext uri="{FF2B5EF4-FFF2-40B4-BE49-F238E27FC236}">
-                <a16:creationId xmlns:a16="http://schemas.microsoft.com/office/drawing/2014/main" id="{52654260-1F46-4C0A-B6C6-C7D7C0F6735E}"/>
+                <a16:creationId xmlns:a16="http://schemas.microsoft.com/office/drawing/2014/main" id="{576A80D2-565A-473F-8B84-4D35C4E15EAE}"/>
               </a:ext>
             </a:extLst>
           </p:cNvPr>
@@ -9862,7 +9862,7 @@
           <p:cNvPr id="4" name="">
             <a:extLst xmlns:a="http://schemas.openxmlformats.org/drawingml/2006/main">
               <a:ext uri="{FF2B5EF4-FFF2-40B4-BE49-F238E27FC236}">
-                <a16:creationId xmlns:a16="http://schemas.microsoft.com/office/drawing/2014/main" id="{BF605A12-2DE4-4E1F-9864-34D5FC24476D}"/>
+                <a16:creationId xmlns:a16="http://schemas.microsoft.com/office/drawing/2014/main" id="{3760200E-956C-4A65-8026-AA43D8C08C4A}"/>
               </a:ext>
             </a:extLst>
           </p:cNvPr>
@@ -9893,7 +9893,7 @@
           <p:cNvPr id="5" name="">
             <a:extLst xmlns:a="http://schemas.openxmlformats.org/drawingml/2006/main">
               <a:ext uri="{FF2B5EF4-FFF2-40B4-BE49-F238E27FC236}">
-                <a16:creationId xmlns:a16="http://schemas.microsoft.com/office/drawing/2014/main" id="{6D09C9AE-4961-453B-9813-245E8D3B7274}"/>
+                <a16:creationId xmlns:a16="http://schemas.microsoft.com/office/drawing/2014/main" id="{7EFD42A3-2DAD-4852-B4B4-EF4551F96EB9}"/>
               </a:ext>
             </a:extLst>
           </p:cNvPr>
@@ -9928,7 +9928,7 @@
           <p:cNvPr id="6" name="">
             <a:extLst xmlns:a="http://schemas.openxmlformats.org/drawingml/2006/main">
               <a:ext uri="{FF2B5EF4-FFF2-40B4-BE49-F238E27FC236}">
-                <a16:creationId xmlns:a16="http://schemas.microsoft.com/office/drawing/2014/main" id="{E52CDAA8-F29B-411E-979E-73B0EBCBB79D}"/>
+                <a16:creationId xmlns:a16="http://schemas.microsoft.com/office/drawing/2014/main" id="{6390E90F-65F0-4FE7-AC47-64CD57EC2706}"/>
               </a:ext>
             </a:extLst>
           </p:cNvPr>
@@ -9992,7 +9992,7 @@
           <p:cNvPr id="7" name="">
             <a:extLst xmlns:a="http://schemas.openxmlformats.org/drawingml/2006/main">
               <a:ext uri="{FF2B5EF4-FFF2-40B4-BE49-F238E27FC236}">
-                <a16:creationId xmlns:a16="http://schemas.microsoft.com/office/drawing/2014/main" id="{CC8CD4BD-9C21-4D7D-BEAD-7A283B3ACED4}"/>
+                <a16:creationId xmlns:a16="http://schemas.microsoft.com/office/drawing/2014/main" id="{C49BAB55-DDDC-40B3-A340-D9478987D9E3}"/>
               </a:ext>
             </a:extLst>
           </p:cNvPr>
@@ -10049,7 +10049,7 @@
           <p:cNvPr id="8" name="">
             <a:extLst xmlns:a="http://schemas.openxmlformats.org/drawingml/2006/main">
               <a:ext uri="{FF2B5EF4-FFF2-40B4-BE49-F238E27FC236}">
-                <a16:creationId xmlns:a16="http://schemas.microsoft.com/office/drawing/2014/main" id="{12679D0D-1F37-4DED-9A3E-52F585959C6A}"/>
+                <a16:creationId xmlns:a16="http://schemas.microsoft.com/office/drawing/2014/main" id="{971BE1AE-F9A3-45FB-8DB9-6BF1D70C7258}"/>
               </a:ext>
             </a:extLst>
           </p:cNvPr>
@@ -10084,7 +10084,7 @@
           <p:cNvPr id="9" name="">
             <a:extLst xmlns:a="http://schemas.openxmlformats.org/drawingml/2006/main">
               <a:ext uri="{FF2B5EF4-FFF2-40B4-BE49-F238E27FC236}">
-                <a16:creationId xmlns:a16="http://schemas.microsoft.com/office/drawing/2014/main" id="{2460B240-F810-438F-B01C-03796836BF11}"/>
+                <a16:creationId xmlns:a16="http://schemas.microsoft.com/office/drawing/2014/main" id="{AA76DA5F-4173-4BAD-BBBE-491D06203558}"/>
               </a:ext>
             </a:extLst>
           </p:cNvPr>
@@ -10148,7 +10148,7 @@
           <p:cNvPr id="10" name="">
             <a:extLst xmlns:a="http://schemas.openxmlformats.org/drawingml/2006/main">
               <a:ext uri="{FF2B5EF4-FFF2-40B4-BE49-F238E27FC236}">
-                <a16:creationId xmlns:a16="http://schemas.microsoft.com/office/drawing/2014/main" id="{365B4A58-53A8-471A-B172-C43E84F0E801}"/>
+                <a16:creationId xmlns:a16="http://schemas.microsoft.com/office/drawing/2014/main" id="{5FF8EC0D-8F1A-4032-AA1B-5EBAF3268AC6}"/>
               </a:ext>
             </a:extLst>
           </p:cNvPr>
@@ -10205,7 +10205,7 @@
           <p:cNvPr id="11" name="">
             <a:extLst xmlns:a="http://schemas.openxmlformats.org/drawingml/2006/main">
               <a:ext uri="{FF2B5EF4-FFF2-40B4-BE49-F238E27FC236}">
-                <a16:creationId xmlns:a16="http://schemas.microsoft.com/office/drawing/2014/main" id="{0081012C-8103-4E34-9590-DB88627FDE67}"/>
+                <a16:creationId xmlns:a16="http://schemas.microsoft.com/office/drawing/2014/main" id="{FF402F3F-E8C0-4015-9CB6-112AAACAD414}"/>
               </a:ext>
             </a:extLst>
           </p:cNvPr>
@@ -10240,7 +10240,7 @@
           <p:cNvPr id="12" name="">
             <a:extLst xmlns:a="http://schemas.openxmlformats.org/drawingml/2006/main">
               <a:ext uri="{FF2B5EF4-FFF2-40B4-BE49-F238E27FC236}">
-                <a16:creationId xmlns:a16="http://schemas.microsoft.com/office/drawing/2014/main" id="{06F60557-9E1C-4FC4-87F0-4E7D645627F7}"/>
+                <a16:creationId xmlns:a16="http://schemas.microsoft.com/office/drawing/2014/main" id="{9FF10EF8-C01F-4DB2-855B-46CBB70F2E0F}"/>
               </a:ext>
             </a:extLst>
           </p:cNvPr>
@@ -10304,7 +10304,7 @@
           <p:cNvPr id="13" name="">
             <a:extLst xmlns:a="http://schemas.openxmlformats.org/drawingml/2006/main">
               <a:ext uri="{FF2B5EF4-FFF2-40B4-BE49-F238E27FC236}">
-                <a16:creationId xmlns:a16="http://schemas.microsoft.com/office/drawing/2014/main" id="{7C306BCD-F188-4E2C-9DAC-482076EDFBF1}"/>
+                <a16:creationId xmlns:a16="http://schemas.microsoft.com/office/drawing/2014/main" id="{EDBE5333-C63A-4B4C-8666-BB594203F6BD}"/>
               </a:ext>
             </a:extLst>
           </p:cNvPr>
@@ -10361,7 +10361,7 @@
           <p:cNvPr id="14" name="">
             <a:extLst xmlns:a="http://schemas.openxmlformats.org/drawingml/2006/main">
               <a:ext uri="{FF2B5EF4-FFF2-40B4-BE49-F238E27FC236}">
-                <a16:creationId xmlns:a16="http://schemas.microsoft.com/office/drawing/2014/main" id="{711197D6-9EB6-4BEF-8D50-F35F0E453C22}"/>
+                <a16:creationId xmlns:a16="http://schemas.microsoft.com/office/drawing/2014/main" id="{CD5A9DA9-FBC4-4BAE-B2A6-E48B8DCD558B}"/>
               </a:ext>
             </a:extLst>
           </p:cNvPr>
@@ -10396,7 +10396,7 @@
           <p:cNvPr id="15" name="">
             <a:extLst xmlns:a="http://schemas.openxmlformats.org/drawingml/2006/main">
               <a:ext uri="{FF2B5EF4-FFF2-40B4-BE49-F238E27FC236}">
-                <a16:creationId xmlns:a16="http://schemas.microsoft.com/office/drawing/2014/main" id="{F625E8CA-5678-4E91-AB6D-7D7B21BD722C}"/>
+                <a16:creationId xmlns:a16="http://schemas.microsoft.com/office/drawing/2014/main" id="{F65F1017-AEF8-4FF3-AC3E-A8D3B9BE9A4B}"/>
               </a:ext>
             </a:extLst>
           </p:cNvPr>
@@ -10460,7 +10460,7 @@
           <p:cNvPr id="16" name="">
             <a:extLst xmlns:a="http://schemas.openxmlformats.org/drawingml/2006/main">
               <a:ext uri="{FF2B5EF4-FFF2-40B4-BE49-F238E27FC236}">
-                <a16:creationId xmlns:a16="http://schemas.microsoft.com/office/drawing/2014/main" id="{4F3E0836-7FF3-4147-88A0-1B0B6FBAC9C6}"/>
+                <a16:creationId xmlns:a16="http://schemas.microsoft.com/office/drawing/2014/main" id="{9BB7DF9A-C022-4D2F-8A3C-7A68E2F0D510}"/>
               </a:ext>
             </a:extLst>
           </p:cNvPr>
@@ -10517,7 +10517,7 @@
           <p:cNvPr id="17" name="">
             <a:extLst xmlns:a="http://schemas.openxmlformats.org/drawingml/2006/main">
               <a:ext uri="{FF2B5EF4-FFF2-40B4-BE49-F238E27FC236}">
-                <a16:creationId xmlns:a16="http://schemas.microsoft.com/office/drawing/2014/main" id="{70729957-40B0-4A76-91CA-9C04F024EF57}"/>
+                <a16:creationId xmlns:a16="http://schemas.microsoft.com/office/drawing/2014/main" id="{3110C781-4201-4081-8F4A-8E0662B9C1F7}"/>
               </a:ext>
             </a:extLst>
           </p:cNvPr>
@@ -10552,7 +10552,7 @@
           <p:cNvPr id="18" name="">
             <a:extLst xmlns:a="http://schemas.openxmlformats.org/drawingml/2006/main">
               <a:ext uri="{FF2B5EF4-FFF2-40B4-BE49-F238E27FC236}">
-                <a16:creationId xmlns:a16="http://schemas.microsoft.com/office/drawing/2014/main" id="{8F4B847C-5B5B-4F99-A539-0D3B54BC18D0}"/>
+                <a16:creationId xmlns:a16="http://schemas.microsoft.com/office/drawing/2014/main" id="{B94A8D97-B80C-4B75-8C14-B2B75C1584CC}"/>
               </a:ext>
             </a:extLst>
           </p:cNvPr>
@@ -10616,7 +10616,7 @@
           <p:cNvPr id="19" name="">
             <a:extLst xmlns:a="http://schemas.openxmlformats.org/drawingml/2006/main">
               <a:ext uri="{FF2B5EF4-FFF2-40B4-BE49-F238E27FC236}">
-                <a16:creationId xmlns:a16="http://schemas.microsoft.com/office/drawing/2014/main" id="{067328D4-26A1-4480-85CE-59FCAD512FF2}"/>
+                <a16:creationId xmlns:a16="http://schemas.microsoft.com/office/drawing/2014/main" id="{C4612155-6BB9-4BA4-9392-A31F56F2BC41}"/>
               </a:ext>
             </a:extLst>
           </p:cNvPr>
@@ -10673,7 +10673,7 @@
           <p:cNvPr id="20" name="">
             <a:extLst xmlns:a="http://schemas.openxmlformats.org/drawingml/2006/main">
               <a:ext uri="{FF2B5EF4-FFF2-40B4-BE49-F238E27FC236}">
-                <a16:creationId xmlns:a16="http://schemas.microsoft.com/office/drawing/2014/main" id="{69042EC6-9337-4D18-BCF0-5397D933023F}"/>
+                <a16:creationId xmlns:a16="http://schemas.microsoft.com/office/drawing/2014/main" id="{063BC6BA-2D26-47FE-B6CF-778123DAF5D3}"/>
               </a:ext>
             </a:extLst>
           </p:cNvPr>
@@ -10708,7 +10708,7 @@
           <p:cNvPr id="21" name="">
             <a:extLst xmlns:a="http://schemas.openxmlformats.org/drawingml/2006/main">
               <a:ext uri="{FF2B5EF4-FFF2-40B4-BE49-F238E27FC236}">
-                <a16:creationId xmlns:a16="http://schemas.microsoft.com/office/drawing/2014/main" id="{29CC0D10-2A51-468D-8089-1977AE4AE8ED}"/>
+                <a16:creationId xmlns:a16="http://schemas.microsoft.com/office/drawing/2014/main" id="{2DD09EC1-2B82-4265-9B64-CC1D62B3F581}"/>
               </a:ext>
             </a:extLst>
           </p:cNvPr>
@@ -10765,7 +10765,7 @@
           <p:cNvPr id="22" name="">
             <a:extLst xmlns:a="http://schemas.openxmlformats.org/drawingml/2006/main">
               <a:ext uri="{FF2B5EF4-FFF2-40B4-BE49-F238E27FC236}">
-                <a16:creationId xmlns:a16="http://schemas.microsoft.com/office/drawing/2014/main" id="{D49E29D0-E0D4-4BC4-9F46-1A785E7288C5}"/>
+                <a16:creationId xmlns:a16="http://schemas.microsoft.com/office/drawing/2014/main" id="{9EC00940-8144-4DBD-BE2F-F2876EA4FA13}"/>
               </a:ext>
             </a:extLst>
           </p:cNvPr>
@@ -10829,7 +10829,7 @@
           <p:cNvPr id="23" name="">
             <a:extLst xmlns:a="http://schemas.openxmlformats.org/drawingml/2006/main">
               <a:ext uri="{FF2B5EF4-FFF2-40B4-BE49-F238E27FC236}">
-                <a16:creationId xmlns:a16="http://schemas.microsoft.com/office/drawing/2014/main" id="{432F1AC6-08DD-42F0-A8B5-07F918907F9E}"/>
+                <a16:creationId xmlns:a16="http://schemas.microsoft.com/office/drawing/2014/main" id="{E4263592-ADBB-47B0-B960-BDA2900952E7}"/>
               </a:ext>
             </a:extLst>
           </p:cNvPr>
@@ -10886,7 +10886,7 @@
           <p:cNvPr id="24" name="">
             <a:extLst xmlns:a="http://schemas.openxmlformats.org/drawingml/2006/main">
               <a:ext uri="{FF2B5EF4-FFF2-40B4-BE49-F238E27FC236}">
-                <a16:creationId xmlns:a16="http://schemas.microsoft.com/office/drawing/2014/main" id="{A894080D-8268-436C-B017-EAFBB7D44B4A}"/>
+                <a16:creationId xmlns:a16="http://schemas.microsoft.com/office/drawing/2014/main" id="{3E3E10A3-F978-4168-B8E4-CAB1EC173477}"/>
               </a:ext>
             </a:extLst>
           </p:cNvPr>
@@ -10950,7 +10950,7 @@
           <p:cNvPr id="25" name="">
             <a:extLst xmlns:a="http://schemas.openxmlformats.org/drawingml/2006/main">
               <a:ext uri="{FF2B5EF4-FFF2-40B4-BE49-F238E27FC236}">
-                <a16:creationId xmlns:a16="http://schemas.microsoft.com/office/drawing/2014/main" id="{D46A5E37-38C2-4B90-9CEC-E71D3E7BA65B}"/>
+                <a16:creationId xmlns:a16="http://schemas.microsoft.com/office/drawing/2014/main" id="{61C89442-DF5A-4FD4-A477-EC749C64EDED}"/>
               </a:ext>
             </a:extLst>
           </p:cNvPr>
@@ -10997,7 +10997,7 @@
                 <a:ea typeface="Arial"/>
                 <a:cs typeface="Arial"/>
               </a:rPr>
-              <a:t>80 test • dependency sạch</a:t>
+              <a:t>88 test • dependency sạch</a:t>
             </a:r>
           </a:p>
         </p:txBody>
@@ -11007,7 +11007,7 @@
           <p:cNvPr id="26" name="">
             <a:extLst xmlns:a="http://schemas.openxmlformats.org/drawingml/2006/main">
               <a:ext uri="{FF2B5EF4-FFF2-40B4-BE49-F238E27FC236}">
-                <a16:creationId xmlns:a16="http://schemas.microsoft.com/office/drawing/2014/main" id="{DFB39F87-526F-479A-8DC9-505071FE628B}"/>
+                <a16:creationId xmlns:a16="http://schemas.microsoft.com/office/drawing/2014/main" id="{17E96996-977A-4D9F-AABB-F8C463DCCF2E}"/>
               </a:ext>
             </a:extLst>
           </p:cNvPr>
@@ -11071,7 +11071,7 @@
           <p:cNvPr id="27" name="">
             <a:extLst xmlns:a="http://schemas.openxmlformats.org/drawingml/2006/main">
               <a:ext uri="{FF2B5EF4-FFF2-40B4-BE49-F238E27FC236}">
-                <a16:creationId xmlns:a16="http://schemas.microsoft.com/office/drawing/2014/main" id="{80A86D24-742A-4B0A-87B3-CBC52A0C148B}"/>
+                <a16:creationId xmlns:a16="http://schemas.microsoft.com/office/drawing/2014/main" id="{1FA98ECF-16D4-4814-BEFE-D219AB884394}"/>
               </a:ext>
             </a:extLst>
           </p:cNvPr>
@@ -11128,7 +11128,7 @@
           <p:cNvPr id="28" name="">
             <a:extLst xmlns:a="http://schemas.openxmlformats.org/drawingml/2006/main">
               <a:ext uri="{FF2B5EF4-FFF2-40B4-BE49-F238E27FC236}">
-                <a16:creationId xmlns:a16="http://schemas.microsoft.com/office/drawing/2014/main" id="{D7E74F18-1BE2-4D0D-8DDE-1E85D98FCDC5}"/>
+                <a16:creationId xmlns:a16="http://schemas.microsoft.com/office/drawing/2014/main" id="{60025AA3-2C9F-4266-9780-5054685676F7}"/>
               </a:ext>
             </a:extLst>
           </p:cNvPr>
@@ -11192,7 +11192,7 @@
           <p:cNvPr id="29" name="">
             <a:extLst xmlns:a="http://schemas.openxmlformats.org/drawingml/2006/main">
               <a:ext uri="{FF2B5EF4-FFF2-40B4-BE49-F238E27FC236}">
-                <a16:creationId xmlns:a16="http://schemas.microsoft.com/office/drawing/2014/main" id="{EBBD8CCC-A61F-4999-B353-1BF75768EAF7}"/>
+                <a16:creationId xmlns:a16="http://schemas.microsoft.com/office/drawing/2014/main" id="{60E40681-1D09-4C36-99DC-943D0C9E7960}"/>
               </a:ext>
             </a:extLst>
           </p:cNvPr>
@@ -11249,7 +11249,7 @@
           <p:cNvPr id="30" name="">
             <a:extLst xmlns:a="http://schemas.openxmlformats.org/drawingml/2006/main">
               <a:ext uri="{FF2B5EF4-FFF2-40B4-BE49-F238E27FC236}">
-                <a16:creationId xmlns:a16="http://schemas.microsoft.com/office/drawing/2014/main" id="{149C2A80-5F04-4625-8A77-329837B3CE90}"/>
+                <a16:creationId xmlns:a16="http://schemas.microsoft.com/office/drawing/2014/main" id="{120659C5-313F-4279-B596-4D52BB5BCA8B}"/>
               </a:ext>
             </a:extLst>
           </p:cNvPr>
@@ -11284,7 +11284,7 @@
           <p:cNvPr id="31" name="">
             <a:extLst xmlns:a="http://schemas.openxmlformats.org/drawingml/2006/main">
               <a:ext uri="{FF2B5EF4-FFF2-40B4-BE49-F238E27FC236}">
-                <a16:creationId xmlns:a16="http://schemas.microsoft.com/office/drawing/2014/main" id="{9BC73C9F-02D7-4AD7-BCD7-13325F1BB017}"/>
+                <a16:creationId xmlns:a16="http://schemas.microsoft.com/office/drawing/2014/main" id="{5C99FB65-877E-4CA3-8C54-0D404849106A}"/>
               </a:ext>
             </a:extLst>
           </p:cNvPr>
@@ -11341,7 +11341,7 @@
           <p:cNvPr id="32" name="">
             <a:extLst xmlns:a="http://schemas.openxmlformats.org/drawingml/2006/main">
               <a:ext uri="{FF2B5EF4-FFF2-40B4-BE49-F238E27FC236}">
-                <a16:creationId xmlns:a16="http://schemas.microsoft.com/office/drawing/2014/main" id="{7332533A-452E-4B01-AA6C-FA2693039C1E}"/>
+                <a16:creationId xmlns:a16="http://schemas.microsoft.com/office/drawing/2014/main" id="{193D3B54-4658-409A-9182-6AD57E038F3D}"/>
               </a:ext>
             </a:extLst>
           </p:cNvPr>
@@ -11444,7 +11444,7 @@
           <p:cNvPr id="33" name="">
             <a:extLst xmlns:a="http://schemas.openxmlformats.org/drawingml/2006/main">
               <a:ext uri="{FF2B5EF4-FFF2-40B4-BE49-F238E27FC236}">
-                <a16:creationId xmlns:a16="http://schemas.microsoft.com/office/drawing/2014/main" id="{A1402768-0258-443F-9636-8DCBBB1D1704}"/>
+                <a16:creationId xmlns:a16="http://schemas.microsoft.com/office/drawing/2014/main" id="{0193C20A-32F5-4936-B437-52EB319F9645}"/>
               </a:ext>
             </a:extLst>
           </p:cNvPr>
@@ -11501,7 +11501,7 @@
           <p:cNvPr id="34" name="">
             <a:extLst xmlns:a="http://schemas.openxmlformats.org/drawingml/2006/main">
               <a:ext uri="{FF2B5EF4-FFF2-40B4-BE49-F238E27FC236}">
-                <a16:creationId xmlns:a16="http://schemas.microsoft.com/office/drawing/2014/main" id="{4F4BBD86-A5FC-486E-9C56-3D60A31C9191}"/>
+                <a16:creationId xmlns:a16="http://schemas.microsoft.com/office/drawing/2014/main" id="{3FD7592A-42FA-4D7B-BF07-EFA59E86AF11}"/>
               </a:ext>
             </a:extLst>
           </p:cNvPr>
@@ -11558,19 +11558,19 @@
           <p:cNvPr id="35" name="">
             <a:extLst xmlns:a="http://schemas.openxmlformats.org/drawingml/2006/main">
               <a:ext uri="{FF2B5EF4-FFF2-40B4-BE49-F238E27FC236}">
-                <a16:creationId xmlns:a16="http://schemas.microsoft.com/office/drawing/2014/main" id="{97631999-5C6F-4265-B7C6-16CB3E48BB33}"/>
-              </a:ext>
-            </a:extLst>
-          </p:cNvPr>
-          <p:cNvSpPr>
-            <a:spLocks xmlns:a="http://schemas.openxmlformats.org/drawingml/2006/main" noGrp="1"/>
-          </p:cNvSpPr>
-          <p:nvPr/>
-        </p:nvSpPr>
-        <p:spPr>
-          <a:xfrm xmlns:a="http://schemas.openxmlformats.org/drawingml/2006/main">
-            <a:off x="11049000" y="6515100"/>
-            <a:ext cx="609600" cy="190500"/>
+                <a16:creationId xmlns:a16="http://schemas.microsoft.com/office/drawing/2014/main" id="{D08F0D8F-48B5-4C9E-BA26-20938CBE8BEA}"/>
+              </a:ext>
+            </a:extLst>
+          </p:cNvPr>
+          <p:cNvSpPr>
+            <a:spLocks xmlns:a="http://schemas.openxmlformats.org/drawingml/2006/main" noGrp="1"/>
+          </p:cNvSpPr>
+          <p:nvPr/>
+        </p:nvSpPr>
+        <p:spPr>
+          <a:xfrm xmlns:a="http://schemas.openxmlformats.org/drawingml/2006/main">
+            <a:off x="11144250" y="6515100"/>
+            <a:ext cx="514350" cy="190500"/>
           </a:xfrm>
           <a:prstGeom xmlns:a="http://schemas.openxmlformats.org/drawingml/2006/main" prst="rect">
             <a:avLst/>
@@ -11605,7 +11605,7 @@
                 <a:ea typeface="Arial"/>
                 <a:cs typeface="Arial"/>
               </a:rPr>
-              <a:t>5/5</a:t>
+              <a:t>5</a:t>
             </a:r>
           </a:p>
         </p:txBody>
@@ -11613,7 +11613,7 @@
     </p:spTree>
     <p:extLst>
       <p:ext uri="{BB962C8B-B14F-4D97-AF65-F5344CB8AC3E}">
-        <p14:creationId xmlns:p14="http://schemas.microsoft.com/office/powerpoint/2010/main" val="1738193066"/>
+        <p14:creationId xmlns:p14="http://schemas.microsoft.com/office/powerpoint/2010/main" val="742594878"/>
       </p:ext>
     </p:extLst>
   </p:cSld>

</xml_diff>

<commit_message>
docs: sync hardening evidence and cloud plan
</commit_message>
<xml_diff>
--- a/AURA/submission/AURA_5_SLIDES.pptx
+++ b/AURA/submission/AURA_5_SLIDES.pptx
@@ -2,17 +2,17 @@
 <file path=ppt/presentation.xml><?xml version="1.0" encoding="utf-8"?>
 <p:presentation xmlns:p="http://schemas.openxmlformats.org/presentationml/2006/main">
   <p:sldMasterIdLst>
-    <p:sldMasterId xmlns:r="http://schemas.openxmlformats.org/officeDocument/2006/relationships" id="2147483648" r:id="R9e7193389c4c479f"/>
+    <p:sldMasterId xmlns:r="http://schemas.openxmlformats.org/officeDocument/2006/relationships" id="2147483648" r:id="R464bb367d2554eda"/>
   </p:sldMasterIdLst>
   <p:notesMasterIdLst>
-    <p:notesMasterId xmlns:r="http://schemas.openxmlformats.org/officeDocument/2006/relationships" r:id="Rfba7543f2a224346"/>
+    <p:notesMasterId xmlns:r="http://schemas.openxmlformats.org/officeDocument/2006/relationships" r:id="R4900fff3c0e74b80"/>
   </p:notesMasterIdLst>
   <p:sldIdLst>
-    <p:sldId xmlns:r="http://schemas.openxmlformats.org/officeDocument/2006/relationships" id="256" r:id="R444b5d8215c843a4"/>
-    <p:sldId xmlns:r="http://schemas.openxmlformats.org/officeDocument/2006/relationships" id="257" r:id="Rcad3797ea7e947bf"/>
-    <p:sldId xmlns:r="http://schemas.openxmlformats.org/officeDocument/2006/relationships" id="258" r:id="R058fd522820b4899"/>
-    <p:sldId xmlns:r="http://schemas.openxmlformats.org/officeDocument/2006/relationships" id="259" r:id="R9dd385b2feae4e4f"/>
-    <p:sldId xmlns:r="http://schemas.openxmlformats.org/officeDocument/2006/relationships" id="260" r:id="Rdd6f2d6b3eac404a"/>
+    <p:sldId xmlns:r="http://schemas.openxmlformats.org/officeDocument/2006/relationships" id="256" r:id="Rae91ebc4f2d94a8f"/>
+    <p:sldId xmlns:r="http://schemas.openxmlformats.org/officeDocument/2006/relationships" id="257" r:id="Rf45f4e4efcd64bee"/>
+    <p:sldId xmlns:r="http://schemas.openxmlformats.org/officeDocument/2006/relationships" id="258" r:id="R6bc86ff904334479"/>
+    <p:sldId xmlns:r="http://schemas.openxmlformats.org/officeDocument/2006/relationships" id="259" r:id="R3d875320c4cc4580"/>
+    <p:sldId xmlns:r="http://schemas.openxmlformats.org/officeDocument/2006/relationships" id="260" r:id="R5ede8306f23b40bb"/>
   </p:sldIdLst>
   <p:sldSz cx="12192000" cy="6858000"/>
   <p:notesSz cx="6858000" cy="9144000"/>
@@ -586,7 +586,7 @@
           <a:lstStyle xmlns:a="http://schemas.openxmlformats.org/drawingml/2006/main"/>
           <a:p xmlns:a="http://schemas.openxmlformats.org/drawingml/2006/main">
             <a:r>
-              <a:t>Nguồn nội bộ ngày 29/09/2026: 88 test offline. Trên cùng judge set 15 ca và fallback tắt, OpenRouter 8B đạt 15/15 quyết định, 70/75 field, P95 16,459 giây; Ollama 4B đạt 14/15, 73/75 field, P95 58,318 giây và bỏ sót escalation TK-12. Đây là regression trên dữ liệu tổng hợp, không phải accuracy thực tế.</a:t>
+              <a:t>Nguồn nội bộ cập nhật ngày 30/09/2026: 93 test offline. Trên cùng judge set 15 ca và fallback tắt, OpenRouter 8B đạt 15/15 quyết định, 70/75 field, P95 16,459 giây; Ollama 4B đạt 14/15, 73/75 field, P95 58,318 giây và bỏ sót escalation TK-12. Contract mới tách invoiceNumber, receiptNumber và transactionReference; cần benchmark live lại sau thay đổi schema. Đây là regression trên dữ liệu tổng hợp, không phải accuracy thực tế.</a:t>
             </a:r>
           </a:p>
         </p:txBody>
@@ -794,7 +794,7 @@
   </p:cSld>
   <p:clrMap bg1="lt1" tx1="dk1" bg2="lt2" tx2="dk2" accent1="accent1" accent2="accent2" accent3="accent3" accent4="accent4" accent5="accent5" accent6="accent6" hlink="hlink" folHlink="folHlink"/>
   <p:sldLayoutIdLst>
-    <p:sldLayoutId xmlns:r="http://schemas.openxmlformats.org/officeDocument/2006/relationships" id="2147483649" r:id="Rda69367881ac4482"/>
+    <p:sldLayoutId xmlns:r="http://schemas.openxmlformats.org/officeDocument/2006/relationships" id="2147483649" r:id="Rec53c80f347744bd"/>
   </p:sldLayoutIdLst>
   <p:txStyles>
     <p:titleStyle>
@@ -1345,7 +1345,7 @@
           <p:cNvPr id="47" name="">
             <a:extLst xmlns:a="http://schemas.openxmlformats.org/drawingml/2006/main">
               <a:ext uri="{FF2B5EF4-FFF2-40B4-BE49-F238E27FC236}">
-                <a16:creationId xmlns:a16="http://schemas.microsoft.com/office/drawing/2014/main" id="{A9D3DD7C-AB40-45FF-9C5C-A1A1ABDE6211}"/>
+                <a16:creationId xmlns:a16="http://schemas.microsoft.com/office/drawing/2014/main" id="{85913668-1E7F-4A81-AA65-53BBD2626B63}"/>
               </a:ext>
             </a:extLst>
           </p:cNvPr>
@@ -1402,7 +1402,7 @@
           <p:cNvPr id="2" name="">
             <a:extLst xmlns:a="http://schemas.openxmlformats.org/drawingml/2006/main">
               <a:ext uri="{FF2B5EF4-FFF2-40B4-BE49-F238E27FC236}">
-                <a16:creationId xmlns:a16="http://schemas.microsoft.com/office/drawing/2014/main" id="{B14C883B-9F82-42C5-97DE-9A2C5C7BF395}"/>
+                <a16:creationId xmlns:a16="http://schemas.microsoft.com/office/drawing/2014/main" id="{922D6BC3-275D-47C7-AB4D-7026F2D709F1}"/>
               </a:ext>
             </a:extLst>
           </p:cNvPr>
@@ -1459,7 +1459,7 @@
           <p:cNvPr id="3" name="">
             <a:extLst xmlns:a="http://schemas.openxmlformats.org/drawingml/2006/main">
               <a:ext uri="{FF2B5EF4-FFF2-40B4-BE49-F238E27FC236}">
-                <a16:creationId xmlns:a16="http://schemas.microsoft.com/office/drawing/2014/main" id="{2ACF1AD1-832E-4828-A54E-E602C33C18A5}"/>
+                <a16:creationId xmlns:a16="http://schemas.microsoft.com/office/drawing/2014/main" id="{962D11CA-12CF-4D22-94B3-C12FE70ACAFC}"/>
               </a:ext>
             </a:extLst>
           </p:cNvPr>
@@ -1516,7 +1516,7 @@
           <p:cNvPr id="4" name="">
             <a:extLst xmlns:a="http://schemas.openxmlformats.org/drawingml/2006/main">
               <a:ext uri="{FF2B5EF4-FFF2-40B4-BE49-F238E27FC236}">
-                <a16:creationId xmlns:a16="http://schemas.microsoft.com/office/drawing/2014/main" id="{D80B92E6-E58F-4E63-90DA-06E0EE4F56EF}"/>
+                <a16:creationId xmlns:a16="http://schemas.microsoft.com/office/drawing/2014/main" id="{CE57666E-846E-4AD2-BDD4-779AC891F0E2}"/>
               </a:ext>
             </a:extLst>
           </p:cNvPr>
@@ -1547,7 +1547,7 @@
           <p:cNvPr id="5" name="">
             <a:extLst xmlns:a="http://schemas.openxmlformats.org/drawingml/2006/main">
               <a:ext uri="{FF2B5EF4-FFF2-40B4-BE49-F238E27FC236}">
-                <a16:creationId xmlns:a16="http://schemas.microsoft.com/office/drawing/2014/main" id="{07409AF2-B64A-4FC9-8BCA-194AA041423F}"/>
+                <a16:creationId xmlns:a16="http://schemas.microsoft.com/office/drawing/2014/main" id="{1D7A40C7-B3D5-42D2-8041-FD2E1951F109}"/>
               </a:ext>
             </a:extLst>
           </p:cNvPr>
@@ -1582,7 +1582,7 @@
           <p:cNvPr id="6" name="">
             <a:extLst xmlns:a="http://schemas.openxmlformats.org/drawingml/2006/main">
               <a:ext uri="{FF2B5EF4-FFF2-40B4-BE49-F238E27FC236}">
-                <a16:creationId xmlns:a16="http://schemas.microsoft.com/office/drawing/2014/main" id="{0D34F22A-B4E5-4371-B6DB-E55046191767}"/>
+                <a16:creationId xmlns:a16="http://schemas.microsoft.com/office/drawing/2014/main" id="{7D9FA6EC-31A9-4E07-A87C-A1D29B0AADBF}"/>
               </a:ext>
             </a:extLst>
           </p:cNvPr>
@@ -1646,7 +1646,7 @@
           <p:cNvPr id="7" name="">
             <a:extLst xmlns:a="http://schemas.openxmlformats.org/drawingml/2006/main">
               <a:ext uri="{FF2B5EF4-FFF2-40B4-BE49-F238E27FC236}">
-                <a16:creationId xmlns:a16="http://schemas.microsoft.com/office/drawing/2014/main" id="{3AA2E305-F3CA-42C8-AA0F-823ABDD7D193}"/>
+                <a16:creationId xmlns:a16="http://schemas.microsoft.com/office/drawing/2014/main" id="{C6790FE4-44C6-4060-96E4-5418175D541B}"/>
               </a:ext>
             </a:extLst>
           </p:cNvPr>
@@ -1703,7 +1703,7 @@
           <p:cNvPr id="8" name="">
             <a:extLst xmlns:a="http://schemas.openxmlformats.org/drawingml/2006/main">
               <a:ext uri="{FF2B5EF4-FFF2-40B4-BE49-F238E27FC236}">
-                <a16:creationId xmlns:a16="http://schemas.microsoft.com/office/drawing/2014/main" id="{96DFA13C-4D28-421F-930C-4DA473082837}"/>
+                <a16:creationId xmlns:a16="http://schemas.microsoft.com/office/drawing/2014/main" id="{CB739D44-33EB-4573-A194-A95CCFA6CAC4}"/>
               </a:ext>
             </a:extLst>
           </p:cNvPr>
@@ -1760,7 +1760,7 @@
           <p:cNvPr id="9" name="">
             <a:extLst xmlns:a="http://schemas.openxmlformats.org/drawingml/2006/main">
               <a:ext uri="{FF2B5EF4-FFF2-40B4-BE49-F238E27FC236}">
-                <a16:creationId xmlns:a16="http://schemas.microsoft.com/office/drawing/2014/main" id="{12272AB9-EA50-46C7-A3A1-E69D50CD828D}"/>
+                <a16:creationId xmlns:a16="http://schemas.microsoft.com/office/drawing/2014/main" id="{F801387C-B89D-4F6E-A4F9-C4C5EB586A81}"/>
               </a:ext>
             </a:extLst>
           </p:cNvPr>
@@ -1792,7 +1792,7 @@
           <p:cNvPr id="10" name="">
             <a:extLst xmlns:a="http://schemas.openxmlformats.org/drawingml/2006/main">
               <a:ext uri="{FF2B5EF4-FFF2-40B4-BE49-F238E27FC236}">
-                <a16:creationId xmlns:a16="http://schemas.microsoft.com/office/drawing/2014/main" id="{C6F56CF6-0E19-4709-AFAF-A22CA5F14DCD}"/>
+                <a16:creationId xmlns:a16="http://schemas.microsoft.com/office/drawing/2014/main" id="{1D665C42-A7D6-4227-B83E-4D56BD996DAE}"/>
               </a:ext>
             </a:extLst>
           </p:cNvPr>
@@ -1827,7 +1827,7 @@
           <p:cNvPr id="11" name="">
             <a:extLst xmlns:a="http://schemas.openxmlformats.org/drawingml/2006/main">
               <a:ext uri="{FF2B5EF4-FFF2-40B4-BE49-F238E27FC236}">
-                <a16:creationId xmlns:a16="http://schemas.microsoft.com/office/drawing/2014/main" id="{4A9F99B2-35BD-4351-8C8F-557DD3E6D27A}"/>
+                <a16:creationId xmlns:a16="http://schemas.microsoft.com/office/drawing/2014/main" id="{3B3728D4-EF1D-4BE5-B34F-7479529A0E3B}"/>
               </a:ext>
             </a:extLst>
           </p:cNvPr>
@@ -1891,7 +1891,7 @@
           <p:cNvPr id="12" name="">
             <a:extLst xmlns:a="http://schemas.openxmlformats.org/drawingml/2006/main">
               <a:ext uri="{FF2B5EF4-FFF2-40B4-BE49-F238E27FC236}">
-                <a16:creationId xmlns:a16="http://schemas.microsoft.com/office/drawing/2014/main" id="{6F30783E-EA33-44A7-93FD-D3F6666BBEA9}"/>
+                <a16:creationId xmlns:a16="http://schemas.microsoft.com/office/drawing/2014/main" id="{8D674B7A-7776-4C77-B6D9-E5FB72AB129C}"/>
               </a:ext>
             </a:extLst>
           </p:cNvPr>
@@ -1948,7 +1948,7 @@
           <p:cNvPr id="13" name="">
             <a:extLst xmlns:a="http://schemas.openxmlformats.org/drawingml/2006/main">
               <a:ext uri="{FF2B5EF4-FFF2-40B4-BE49-F238E27FC236}">
-                <a16:creationId xmlns:a16="http://schemas.microsoft.com/office/drawing/2014/main" id="{B3B11663-267D-46D1-B6C3-4FE6BB6DE4A0}"/>
+                <a16:creationId xmlns:a16="http://schemas.microsoft.com/office/drawing/2014/main" id="{5AE2964A-C218-4D41-BF26-B9A13DDE2997}"/>
               </a:ext>
             </a:extLst>
           </p:cNvPr>
@@ -2005,7 +2005,7 @@
           <p:cNvPr id="14" name="">
             <a:extLst xmlns:a="http://schemas.openxmlformats.org/drawingml/2006/main">
               <a:ext uri="{FF2B5EF4-FFF2-40B4-BE49-F238E27FC236}">
-                <a16:creationId xmlns:a16="http://schemas.microsoft.com/office/drawing/2014/main" id="{914118FC-E3BB-450F-A7D0-A4346A63B6BE}"/>
+                <a16:creationId xmlns:a16="http://schemas.microsoft.com/office/drawing/2014/main" id="{BC1E4B1A-6D61-43DA-9E0A-544114E68AD9}"/>
               </a:ext>
             </a:extLst>
           </p:cNvPr>
@@ -2037,7 +2037,7 @@
           <p:cNvPr id="15" name="">
             <a:extLst xmlns:a="http://schemas.openxmlformats.org/drawingml/2006/main">
               <a:ext uri="{FF2B5EF4-FFF2-40B4-BE49-F238E27FC236}">
-                <a16:creationId xmlns:a16="http://schemas.microsoft.com/office/drawing/2014/main" id="{4319B866-DDDE-46A3-83D0-C6075CAD2E63}"/>
+                <a16:creationId xmlns:a16="http://schemas.microsoft.com/office/drawing/2014/main" id="{13570192-8289-4E8D-BA5F-E7A57AC77241}"/>
               </a:ext>
             </a:extLst>
           </p:cNvPr>
@@ -2072,7 +2072,7 @@
           <p:cNvPr id="16" name="">
             <a:extLst xmlns:a="http://schemas.openxmlformats.org/drawingml/2006/main">
               <a:ext uri="{FF2B5EF4-FFF2-40B4-BE49-F238E27FC236}">
-                <a16:creationId xmlns:a16="http://schemas.microsoft.com/office/drawing/2014/main" id="{8CC895C2-1DBA-4746-9417-687FAAC53848}"/>
+                <a16:creationId xmlns:a16="http://schemas.microsoft.com/office/drawing/2014/main" id="{182649F2-3A06-4325-99D8-0C9573B0F225}"/>
               </a:ext>
             </a:extLst>
           </p:cNvPr>
@@ -2136,7 +2136,7 @@
           <p:cNvPr id="17" name="">
             <a:extLst xmlns:a="http://schemas.openxmlformats.org/drawingml/2006/main">
               <a:ext uri="{FF2B5EF4-FFF2-40B4-BE49-F238E27FC236}">
-                <a16:creationId xmlns:a16="http://schemas.microsoft.com/office/drawing/2014/main" id="{3794DD8C-C792-4CAF-952C-7DA032A32826}"/>
+                <a16:creationId xmlns:a16="http://schemas.microsoft.com/office/drawing/2014/main" id="{4925D1E8-7572-45E4-AC1A-6CBF953C5D93}"/>
               </a:ext>
             </a:extLst>
           </p:cNvPr>
@@ -2193,7 +2193,7 @@
           <p:cNvPr id="18" name="">
             <a:extLst xmlns:a="http://schemas.openxmlformats.org/drawingml/2006/main">
               <a:ext uri="{FF2B5EF4-FFF2-40B4-BE49-F238E27FC236}">
-                <a16:creationId xmlns:a16="http://schemas.microsoft.com/office/drawing/2014/main" id="{36B63EBD-E08B-49C8-B007-65157047A159}"/>
+                <a16:creationId xmlns:a16="http://schemas.microsoft.com/office/drawing/2014/main" id="{41C89BB0-BC30-4A86-9199-BA17A955CA64}"/>
               </a:ext>
             </a:extLst>
           </p:cNvPr>
@@ -2250,7 +2250,7 @@
           <p:cNvPr id="19" name="">
             <a:extLst xmlns:a="http://schemas.openxmlformats.org/drawingml/2006/main">
               <a:ext uri="{FF2B5EF4-FFF2-40B4-BE49-F238E27FC236}">
-                <a16:creationId xmlns:a16="http://schemas.microsoft.com/office/drawing/2014/main" id="{686798EA-0BD9-484A-96C3-B705D6EED67D}"/>
+                <a16:creationId xmlns:a16="http://schemas.microsoft.com/office/drawing/2014/main" id="{701AAF40-62FB-428F-A568-876DA7FF58E1}"/>
               </a:ext>
             </a:extLst>
           </p:cNvPr>
@@ -2282,7 +2282,7 @@
           <p:cNvPr id="20" name="">
             <a:extLst xmlns:a="http://schemas.openxmlformats.org/drawingml/2006/main">
               <a:ext uri="{FF2B5EF4-FFF2-40B4-BE49-F238E27FC236}">
-                <a16:creationId xmlns:a16="http://schemas.microsoft.com/office/drawing/2014/main" id="{4DA1CFD3-CBDC-4057-AA08-097069D80B44}"/>
+                <a16:creationId xmlns:a16="http://schemas.microsoft.com/office/drawing/2014/main" id="{65B775CB-69B8-441F-93D1-5D37AFACE47E}"/>
               </a:ext>
             </a:extLst>
           </p:cNvPr>
@@ -2317,7 +2317,7 @@
           <p:cNvPr id="21" name="">
             <a:extLst xmlns:a="http://schemas.openxmlformats.org/drawingml/2006/main">
               <a:ext uri="{FF2B5EF4-FFF2-40B4-BE49-F238E27FC236}">
-                <a16:creationId xmlns:a16="http://schemas.microsoft.com/office/drawing/2014/main" id="{A42C4FBA-A8D8-463D-B314-4C6E78473E77}"/>
+                <a16:creationId xmlns:a16="http://schemas.microsoft.com/office/drawing/2014/main" id="{5C47519F-FE03-453D-B012-E945B7898822}"/>
               </a:ext>
             </a:extLst>
           </p:cNvPr>
@@ -2381,7 +2381,7 @@
           <p:cNvPr id="22" name="">
             <a:extLst xmlns:a="http://schemas.openxmlformats.org/drawingml/2006/main">
               <a:ext uri="{FF2B5EF4-FFF2-40B4-BE49-F238E27FC236}">
-                <a16:creationId xmlns:a16="http://schemas.microsoft.com/office/drawing/2014/main" id="{D774019D-AEDE-4140-8AE9-7DDBA272E526}"/>
+                <a16:creationId xmlns:a16="http://schemas.microsoft.com/office/drawing/2014/main" id="{57F46540-15FC-4D95-A9E5-230188F162EF}"/>
               </a:ext>
             </a:extLst>
           </p:cNvPr>
@@ -2438,7 +2438,7 @@
           <p:cNvPr id="23" name="">
             <a:extLst xmlns:a="http://schemas.openxmlformats.org/drawingml/2006/main">
               <a:ext uri="{FF2B5EF4-FFF2-40B4-BE49-F238E27FC236}">
-                <a16:creationId xmlns:a16="http://schemas.microsoft.com/office/drawing/2014/main" id="{D3DEC7F0-88C1-4D66-938E-9824F0E61B41}"/>
+                <a16:creationId xmlns:a16="http://schemas.microsoft.com/office/drawing/2014/main" id="{CC4198DA-2F24-4139-A20B-123CDDAFC1EE}"/>
               </a:ext>
             </a:extLst>
           </p:cNvPr>
@@ -2495,7 +2495,7 @@
           <p:cNvPr id="24" name="">
             <a:extLst xmlns:a="http://schemas.openxmlformats.org/drawingml/2006/main">
               <a:ext uri="{FF2B5EF4-FFF2-40B4-BE49-F238E27FC236}">
-                <a16:creationId xmlns:a16="http://schemas.microsoft.com/office/drawing/2014/main" id="{A1F92B6B-E025-40EC-8C2A-7DFDAEEF17A7}"/>
+                <a16:creationId xmlns:a16="http://schemas.microsoft.com/office/drawing/2014/main" id="{E7229C17-74E5-4BFA-9778-AF0EE82E3356}"/>
               </a:ext>
             </a:extLst>
           </p:cNvPr>
@@ -2527,7 +2527,7 @@
           <p:cNvPr id="25" name="">
             <a:extLst xmlns:a="http://schemas.openxmlformats.org/drawingml/2006/main">
               <a:ext uri="{FF2B5EF4-FFF2-40B4-BE49-F238E27FC236}">
-                <a16:creationId xmlns:a16="http://schemas.microsoft.com/office/drawing/2014/main" id="{30815BA1-7720-454C-A17E-7B12535128E7}"/>
+                <a16:creationId xmlns:a16="http://schemas.microsoft.com/office/drawing/2014/main" id="{85EA2F83-14EE-4A9E-BE84-7CB2176BCA78}"/>
               </a:ext>
             </a:extLst>
           </p:cNvPr>
@@ -2562,7 +2562,7 @@
           <p:cNvPr id="26" name="">
             <a:extLst xmlns:a="http://schemas.openxmlformats.org/drawingml/2006/main">
               <a:ext uri="{FF2B5EF4-FFF2-40B4-BE49-F238E27FC236}">
-                <a16:creationId xmlns:a16="http://schemas.microsoft.com/office/drawing/2014/main" id="{7BF1CC40-C2FB-4D9C-B597-3632E21C9E95}"/>
+                <a16:creationId xmlns:a16="http://schemas.microsoft.com/office/drawing/2014/main" id="{07ECE9E6-94FD-46DE-9FE5-C420F580BF93}"/>
               </a:ext>
             </a:extLst>
           </p:cNvPr>
@@ -2626,7 +2626,7 @@
           <p:cNvPr id="27" name="">
             <a:extLst xmlns:a="http://schemas.openxmlformats.org/drawingml/2006/main">
               <a:ext uri="{FF2B5EF4-FFF2-40B4-BE49-F238E27FC236}">
-                <a16:creationId xmlns:a16="http://schemas.microsoft.com/office/drawing/2014/main" id="{8EECFBFC-C4CE-462C-8E65-1B8FA8F2596F}"/>
+                <a16:creationId xmlns:a16="http://schemas.microsoft.com/office/drawing/2014/main" id="{9BCE5A4B-C776-483B-8A94-D275927354A5}"/>
               </a:ext>
             </a:extLst>
           </p:cNvPr>
@@ -2683,7 +2683,7 @@
           <p:cNvPr id="28" name="">
             <a:extLst xmlns:a="http://schemas.openxmlformats.org/drawingml/2006/main">
               <a:ext uri="{FF2B5EF4-FFF2-40B4-BE49-F238E27FC236}">
-                <a16:creationId xmlns:a16="http://schemas.microsoft.com/office/drawing/2014/main" id="{AD6EFCB5-BB9B-4BC6-BCC9-00068898F325}"/>
+                <a16:creationId xmlns:a16="http://schemas.microsoft.com/office/drawing/2014/main" id="{39FAB675-20F6-4EAD-9D01-D07D5A2B8BA8}"/>
               </a:ext>
             </a:extLst>
           </p:cNvPr>
@@ -2740,7 +2740,7 @@
           <p:cNvPr id="29" name="">
             <a:extLst xmlns:a="http://schemas.openxmlformats.org/drawingml/2006/main">
               <a:ext uri="{FF2B5EF4-FFF2-40B4-BE49-F238E27FC236}">
-                <a16:creationId xmlns:a16="http://schemas.microsoft.com/office/drawing/2014/main" id="{3A1C41CC-F1FC-4BD0-AF0D-8D843AB434A1}"/>
+                <a16:creationId xmlns:a16="http://schemas.microsoft.com/office/drawing/2014/main" id="{C9D9B4F5-E6BE-49A8-B06C-07E6FAB82FCB}"/>
               </a:ext>
             </a:extLst>
           </p:cNvPr>
@@ -2775,7 +2775,7 @@
           <p:cNvPr id="30" name="">
             <a:extLst xmlns:a="http://schemas.openxmlformats.org/drawingml/2006/main">
               <a:ext uri="{FF2B5EF4-FFF2-40B4-BE49-F238E27FC236}">
-                <a16:creationId xmlns:a16="http://schemas.microsoft.com/office/drawing/2014/main" id="{43B797F0-54BA-45DB-A22A-A46935985E17}"/>
+                <a16:creationId xmlns:a16="http://schemas.microsoft.com/office/drawing/2014/main" id="{0C47628D-7438-40D8-A4EF-2F5A5EDC70D5}"/>
               </a:ext>
             </a:extLst>
           </p:cNvPr>
@@ -2832,7 +2832,7 @@
           <p:cNvPr id="31" name="">
             <a:extLst xmlns:a="http://schemas.openxmlformats.org/drawingml/2006/main">
               <a:ext uri="{FF2B5EF4-FFF2-40B4-BE49-F238E27FC236}">
-                <a16:creationId xmlns:a16="http://schemas.microsoft.com/office/drawing/2014/main" id="{08EE402C-8437-466A-A04B-E2E197C6D53E}"/>
+                <a16:creationId xmlns:a16="http://schemas.microsoft.com/office/drawing/2014/main" id="{B0A230F5-31A3-4798-832B-D2008DAF7D68}"/>
               </a:ext>
             </a:extLst>
           </p:cNvPr>
@@ -2889,7 +2889,7 @@
           <p:cNvPr id="32" name="">
             <a:extLst xmlns:a="http://schemas.openxmlformats.org/drawingml/2006/main">
               <a:ext uri="{FF2B5EF4-FFF2-40B4-BE49-F238E27FC236}">
-                <a16:creationId xmlns:a16="http://schemas.microsoft.com/office/drawing/2014/main" id="{282570A2-D7D0-409B-87AA-EB4E4FBB33A5}"/>
+                <a16:creationId xmlns:a16="http://schemas.microsoft.com/office/drawing/2014/main" id="{F58DA844-9432-4AE7-9465-304B15C67579}"/>
               </a:ext>
             </a:extLst>
           </p:cNvPr>
@@ -2946,7 +2946,7 @@
           <p:cNvPr id="33" name="">
             <a:extLst xmlns:a="http://schemas.openxmlformats.org/drawingml/2006/main">
               <a:ext uri="{FF2B5EF4-FFF2-40B4-BE49-F238E27FC236}">
-                <a16:creationId xmlns:a16="http://schemas.microsoft.com/office/drawing/2014/main" id="{06EB1464-4294-44EB-9A11-CEA2A2E92F9D}"/>
+                <a16:creationId xmlns:a16="http://schemas.microsoft.com/office/drawing/2014/main" id="{542B4836-EB2E-45F1-A7D5-40B85BB9D17E}"/>
               </a:ext>
             </a:extLst>
           </p:cNvPr>
@@ -2981,7 +2981,7 @@
           <p:cNvPr id="34" name="">
             <a:extLst xmlns:a="http://schemas.openxmlformats.org/drawingml/2006/main">
               <a:ext uri="{FF2B5EF4-FFF2-40B4-BE49-F238E27FC236}">
-                <a16:creationId xmlns:a16="http://schemas.microsoft.com/office/drawing/2014/main" id="{A3C096B4-61CB-46AF-A339-69F54224E55E}"/>
+                <a16:creationId xmlns:a16="http://schemas.microsoft.com/office/drawing/2014/main" id="{6ACB2B3B-8D1F-41EE-BA4A-4045823A5C81}"/>
               </a:ext>
             </a:extLst>
           </p:cNvPr>
@@ -3045,7 +3045,7 @@
           <p:cNvPr id="35" name="">
             <a:extLst xmlns:a="http://schemas.openxmlformats.org/drawingml/2006/main">
               <a:ext uri="{FF2B5EF4-FFF2-40B4-BE49-F238E27FC236}">
-                <a16:creationId xmlns:a16="http://schemas.microsoft.com/office/drawing/2014/main" id="{58D85E29-E49D-4E82-9950-65BDBD70325D}"/>
+                <a16:creationId xmlns:a16="http://schemas.microsoft.com/office/drawing/2014/main" id="{AADC3238-23AD-4FF0-8DB5-9F057F396FEC}"/>
               </a:ext>
             </a:extLst>
           </p:cNvPr>
@@ -3102,7 +3102,7 @@
           <p:cNvPr id="36" name="">
             <a:extLst xmlns:a="http://schemas.openxmlformats.org/drawingml/2006/main">
               <a:ext uri="{FF2B5EF4-FFF2-40B4-BE49-F238E27FC236}">
-                <a16:creationId xmlns:a16="http://schemas.microsoft.com/office/drawing/2014/main" id="{E2DE8B14-5D3C-4E14-A4D1-24A1DF9BD445}"/>
+                <a16:creationId xmlns:a16="http://schemas.microsoft.com/office/drawing/2014/main" id="{A45955C6-F770-4FCD-AA67-F14EA143F1CA}"/>
               </a:ext>
             </a:extLst>
           </p:cNvPr>
@@ -3159,7 +3159,7 @@
           <p:cNvPr id="37" name="">
             <a:extLst xmlns:a="http://schemas.openxmlformats.org/drawingml/2006/main">
               <a:ext uri="{FF2B5EF4-FFF2-40B4-BE49-F238E27FC236}">
-                <a16:creationId xmlns:a16="http://schemas.microsoft.com/office/drawing/2014/main" id="{39743324-0A15-4587-A54D-7AB28050BCF9}"/>
+                <a16:creationId xmlns:a16="http://schemas.microsoft.com/office/drawing/2014/main" id="{D15833A4-8C34-469E-B729-6C6AA1E1CE07}"/>
               </a:ext>
             </a:extLst>
           </p:cNvPr>
@@ -3194,7 +3194,7 @@
           <p:cNvPr id="38" name="">
             <a:extLst xmlns:a="http://schemas.openxmlformats.org/drawingml/2006/main">
               <a:ext uri="{FF2B5EF4-FFF2-40B4-BE49-F238E27FC236}">
-                <a16:creationId xmlns:a16="http://schemas.microsoft.com/office/drawing/2014/main" id="{AF2785C6-610E-4D14-9672-0ACB17C15CC6}"/>
+                <a16:creationId xmlns:a16="http://schemas.microsoft.com/office/drawing/2014/main" id="{FA13FBCC-86DD-4845-B822-EC19EB4BE1F4}"/>
               </a:ext>
             </a:extLst>
           </p:cNvPr>
@@ -3258,7 +3258,7 @@
           <p:cNvPr id="39" name="">
             <a:extLst xmlns:a="http://schemas.openxmlformats.org/drawingml/2006/main">
               <a:ext uri="{FF2B5EF4-FFF2-40B4-BE49-F238E27FC236}">
-                <a16:creationId xmlns:a16="http://schemas.microsoft.com/office/drawing/2014/main" id="{76D30F6B-E613-43C8-9CFF-DE0F6030E300}"/>
+                <a16:creationId xmlns:a16="http://schemas.microsoft.com/office/drawing/2014/main" id="{F55C8DB6-BD7C-4FEE-8C6C-6FC75E122D28}"/>
               </a:ext>
             </a:extLst>
           </p:cNvPr>
@@ -3315,7 +3315,7 @@
           <p:cNvPr id="40" name="">
             <a:extLst xmlns:a="http://schemas.openxmlformats.org/drawingml/2006/main">
               <a:ext uri="{FF2B5EF4-FFF2-40B4-BE49-F238E27FC236}">
-                <a16:creationId xmlns:a16="http://schemas.microsoft.com/office/drawing/2014/main" id="{3C960F8D-BB57-4314-AA55-E5AC3C83D008}"/>
+                <a16:creationId xmlns:a16="http://schemas.microsoft.com/office/drawing/2014/main" id="{0A65804A-0021-497A-92F2-2D7C70C819C0}"/>
               </a:ext>
             </a:extLst>
           </p:cNvPr>
@@ -3372,7 +3372,7 @@
           <p:cNvPr id="41" name="">
             <a:extLst xmlns:a="http://schemas.openxmlformats.org/drawingml/2006/main">
               <a:ext uri="{FF2B5EF4-FFF2-40B4-BE49-F238E27FC236}">
-                <a16:creationId xmlns:a16="http://schemas.microsoft.com/office/drawing/2014/main" id="{A14CB60A-57BE-4C19-BBBA-6F00B52A9B22}"/>
+                <a16:creationId xmlns:a16="http://schemas.microsoft.com/office/drawing/2014/main" id="{8ABDBA41-8A9F-4029-A7DB-8B03A5FDB441}"/>
               </a:ext>
             </a:extLst>
           </p:cNvPr>
@@ -3407,7 +3407,7 @@
           <p:cNvPr id="42" name="">
             <a:extLst xmlns:a="http://schemas.openxmlformats.org/drawingml/2006/main">
               <a:ext uri="{FF2B5EF4-FFF2-40B4-BE49-F238E27FC236}">
-                <a16:creationId xmlns:a16="http://schemas.microsoft.com/office/drawing/2014/main" id="{6E06BF3D-1B94-4729-9102-A4D5841ED5C2}"/>
+                <a16:creationId xmlns:a16="http://schemas.microsoft.com/office/drawing/2014/main" id="{852C545A-EA68-45D3-8E02-14C28BE85F09}"/>
               </a:ext>
             </a:extLst>
           </p:cNvPr>
@@ -3471,7 +3471,7 @@
           <p:cNvPr id="43" name="">
             <a:extLst xmlns:a="http://schemas.openxmlformats.org/drawingml/2006/main">
               <a:ext uri="{FF2B5EF4-FFF2-40B4-BE49-F238E27FC236}">
-                <a16:creationId xmlns:a16="http://schemas.microsoft.com/office/drawing/2014/main" id="{4A1BB0A0-AD8E-481B-9910-7C76F3339786}"/>
+                <a16:creationId xmlns:a16="http://schemas.microsoft.com/office/drawing/2014/main" id="{0192B43C-130D-48C0-97C0-C629AD40B37B}"/>
               </a:ext>
             </a:extLst>
           </p:cNvPr>
@@ -3528,7 +3528,7 @@
           <p:cNvPr id="44" name="">
             <a:extLst xmlns:a="http://schemas.openxmlformats.org/drawingml/2006/main">
               <a:ext uri="{FF2B5EF4-FFF2-40B4-BE49-F238E27FC236}">
-                <a16:creationId xmlns:a16="http://schemas.microsoft.com/office/drawing/2014/main" id="{93E465CE-1914-4E20-806D-1277B6672388}"/>
+                <a16:creationId xmlns:a16="http://schemas.microsoft.com/office/drawing/2014/main" id="{86D88CF9-D1B6-433D-8068-367B950F497D}"/>
               </a:ext>
             </a:extLst>
           </p:cNvPr>
@@ -3585,7 +3585,7 @@
           <p:cNvPr id="45" name="">
             <a:extLst xmlns:a="http://schemas.openxmlformats.org/drawingml/2006/main">
               <a:ext uri="{FF2B5EF4-FFF2-40B4-BE49-F238E27FC236}">
-                <a16:creationId xmlns:a16="http://schemas.microsoft.com/office/drawing/2014/main" id="{98961D38-EC24-4731-8F98-C44AEBE83878}"/>
+                <a16:creationId xmlns:a16="http://schemas.microsoft.com/office/drawing/2014/main" id="{CEBD4FBC-E636-4A9C-994E-5AA9DB0CFFED}"/>
               </a:ext>
             </a:extLst>
           </p:cNvPr>
@@ -3632,7 +3632,7 @@
                 <a:ea typeface="Arial"/>
                 <a:cs typeface="Arial"/>
               </a:rPr>
-              <a:t>AURA • Track A • 29/09/2026</a:t>
+              <a:t>AURA • Track A • 30/09/2026</a:t>
             </a:r>
           </a:p>
         </p:txBody>
@@ -3642,7 +3642,7 @@
           <p:cNvPr id="46" name="">
             <a:extLst xmlns:a="http://schemas.openxmlformats.org/drawingml/2006/main">
               <a:ext uri="{FF2B5EF4-FFF2-40B4-BE49-F238E27FC236}">
-                <a16:creationId xmlns:a16="http://schemas.microsoft.com/office/drawing/2014/main" id="{18F16737-2A42-444A-AA24-7BCCE0690D9E}"/>
+                <a16:creationId xmlns:a16="http://schemas.microsoft.com/office/drawing/2014/main" id="{4FFFF5C5-C7C0-40D1-885D-47A93187A7AB}"/>
               </a:ext>
             </a:extLst>
           </p:cNvPr>
@@ -3697,7 +3697,7 @@
     </p:spTree>
     <p:extLst>
       <p:ext uri="{BB962C8B-B14F-4D97-AF65-F5344CB8AC3E}">
-        <p14:creationId xmlns:p14="http://schemas.microsoft.com/office/powerpoint/2010/main" val="1301676064"/>
+        <p14:creationId xmlns:p14="http://schemas.microsoft.com/office/powerpoint/2010/main" val="426790140"/>
       </p:ext>
     </p:extLst>
   </p:cSld>
@@ -3728,7 +3728,7 @@
           <p:cNvPr id="46" name="">
             <a:extLst xmlns:a="http://schemas.openxmlformats.org/drawingml/2006/main">
               <a:ext uri="{FF2B5EF4-FFF2-40B4-BE49-F238E27FC236}">
-                <a16:creationId xmlns:a16="http://schemas.microsoft.com/office/drawing/2014/main" id="{D2214A10-3A76-409B-90B5-6D4EE7B256B9}"/>
+                <a16:creationId xmlns:a16="http://schemas.microsoft.com/office/drawing/2014/main" id="{C11D6DB4-8490-426B-A861-94D1A4BD2DF8}"/>
               </a:ext>
             </a:extLst>
           </p:cNvPr>
@@ -3785,7 +3785,7 @@
           <p:cNvPr id="2" name="">
             <a:extLst xmlns:a="http://schemas.openxmlformats.org/drawingml/2006/main">
               <a:ext uri="{FF2B5EF4-FFF2-40B4-BE49-F238E27FC236}">
-                <a16:creationId xmlns:a16="http://schemas.microsoft.com/office/drawing/2014/main" id="{B8C1D48B-7ED0-4966-B46F-73223077C43B}"/>
+                <a16:creationId xmlns:a16="http://schemas.microsoft.com/office/drawing/2014/main" id="{DCABFE51-CEDC-4FA9-90A0-47B01CD3FF0B}"/>
               </a:ext>
             </a:extLst>
           </p:cNvPr>
@@ -3842,7 +3842,7 @@
           <p:cNvPr id="3" name="">
             <a:extLst xmlns:a="http://schemas.openxmlformats.org/drawingml/2006/main">
               <a:ext uri="{FF2B5EF4-FFF2-40B4-BE49-F238E27FC236}">
-                <a16:creationId xmlns:a16="http://schemas.microsoft.com/office/drawing/2014/main" id="{7B88E3D0-ED25-4410-B597-38C712242067}"/>
+                <a16:creationId xmlns:a16="http://schemas.microsoft.com/office/drawing/2014/main" id="{81A91161-9D85-43BF-A85E-F26F5754A45B}"/>
               </a:ext>
             </a:extLst>
           </p:cNvPr>
@@ -3899,7 +3899,7 @@
           <p:cNvPr id="4" name="">
             <a:extLst xmlns:a="http://schemas.openxmlformats.org/drawingml/2006/main">
               <a:ext uri="{FF2B5EF4-FFF2-40B4-BE49-F238E27FC236}">
-                <a16:creationId xmlns:a16="http://schemas.microsoft.com/office/drawing/2014/main" id="{8AAAC328-2C5E-46CD-9242-3F2B27118F90}"/>
+                <a16:creationId xmlns:a16="http://schemas.microsoft.com/office/drawing/2014/main" id="{DE061ABB-6855-4827-9246-D8EE31EEEB2F}"/>
               </a:ext>
             </a:extLst>
           </p:cNvPr>
@@ -3930,7 +3930,7 @@
           <p:cNvPr id="5" name="">
             <a:extLst xmlns:a="http://schemas.openxmlformats.org/drawingml/2006/main">
               <a:ext uri="{FF2B5EF4-FFF2-40B4-BE49-F238E27FC236}">
-                <a16:creationId xmlns:a16="http://schemas.microsoft.com/office/drawing/2014/main" id="{EFC6F7E2-95DA-47DE-AB40-05579A8F2699}"/>
+                <a16:creationId xmlns:a16="http://schemas.microsoft.com/office/drawing/2014/main" id="{C881C7CF-7AB5-4704-B050-B10CA52C1A65}"/>
               </a:ext>
             </a:extLst>
           </p:cNvPr>
@@ -3965,7 +3965,7 @@
           <p:cNvPr id="6" name="">
             <a:extLst xmlns:a="http://schemas.openxmlformats.org/drawingml/2006/main">
               <a:ext uri="{FF2B5EF4-FFF2-40B4-BE49-F238E27FC236}">
-                <a16:creationId xmlns:a16="http://schemas.microsoft.com/office/drawing/2014/main" id="{96D369E3-441D-41DC-AE4C-CB1C0007EB6E}"/>
+                <a16:creationId xmlns:a16="http://schemas.microsoft.com/office/drawing/2014/main" id="{46026608-C0CC-4DFD-9477-81502C005F2D}"/>
               </a:ext>
             </a:extLst>
           </p:cNvPr>
@@ -4029,7 +4029,7 @@
           <p:cNvPr id="7" name="">
             <a:extLst xmlns:a="http://schemas.openxmlformats.org/drawingml/2006/main">
               <a:ext uri="{FF2B5EF4-FFF2-40B4-BE49-F238E27FC236}">
-                <a16:creationId xmlns:a16="http://schemas.microsoft.com/office/drawing/2014/main" id="{55FB52E9-B781-421D-83A0-0A49048DBBA5}"/>
+                <a16:creationId xmlns:a16="http://schemas.microsoft.com/office/drawing/2014/main" id="{0640CFA0-45DA-4D98-8E3A-C5AD789D5DB8}"/>
               </a:ext>
             </a:extLst>
           </p:cNvPr>
@@ -4086,7 +4086,7 @@
           <p:cNvPr id="8" name="">
             <a:extLst xmlns:a="http://schemas.openxmlformats.org/drawingml/2006/main">
               <a:ext uri="{FF2B5EF4-FFF2-40B4-BE49-F238E27FC236}">
-                <a16:creationId xmlns:a16="http://schemas.microsoft.com/office/drawing/2014/main" id="{09C2A86A-0CCF-46C8-9B55-C66B44C977C5}"/>
+                <a16:creationId xmlns:a16="http://schemas.microsoft.com/office/drawing/2014/main" id="{E13CD048-54BC-4A37-BC94-7F22B91FA38C}"/>
               </a:ext>
             </a:extLst>
           </p:cNvPr>
@@ -4166,7 +4166,7 @@
           <p:cNvPr id="9" name="">
             <a:extLst xmlns:a="http://schemas.openxmlformats.org/drawingml/2006/main">
               <a:ext uri="{FF2B5EF4-FFF2-40B4-BE49-F238E27FC236}">
-                <a16:creationId xmlns:a16="http://schemas.microsoft.com/office/drawing/2014/main" id="{6CB3AF58-1B76-433E-A14E-93D31CFB7AED}"/>
+                <a16:creationId xmlns:a16="http://schemas.microsoft.com/office/drawing/2014/main" id="{1CC2E66C-597A-4059-A8F8-BF0292CF4B6A}"/>
               </a:ext>
             </a:extLst>
           </p:cNvPr>
@@ -4198,7 +4198,7 @@
           <p:cNvPr id="10" name="">
             <a:extLst xmlns:a="http://schemas.openxmlformats.org/drawingml/2006/main">
               <a:ext uri="{FF2B5EF4-FFF2-40B4-BE49-F238E27FC236}">
-                <a16:creationId xmlns:a16="http://schemas.microsoft.com/office/drawing/2014/main" id="{3884C95F-6AC8-43AD-8F2A-A02A3588FFE3}"/>
+                <a16:creationId xmlns:a16="http://schemas.microsoft.com/office/drawing/2014/main" id="{4E8FE002-5CFA-4718-9BD9-C9328AB2931A}"/>
               </a:ext>
             </a:extLst>
           </p:cNvPr>
@@ -4233,7 +4233,7 @@
           <p:cNvPr id="11" name="">
             <a:extLst xmlns:a="http://schemas.openxmlformats.org/drawingml/2006/main">
               <a:ext uri="{FF2B5EF4-FFF2-40B4-BE49-F238E27FC236}">
-                <a16:creationId xmlns:a16="http://schemas.microsoft.com/office/drawing/2014/main" id="{8D176936-37F7-4280-82E5-00A7931CD362}"/>
+                <a16:creationId xmlns:a16="http://schemas.microsoft.com/office/drawing/2014/main" id="{17F5141A-A918-4238-A255-580899B79D6D}"/>
               </a:ext>
             </a:extLst>
           </p:cNvPr>
@@ -4297,7 +4297,7 @@
           <p:cNvPr id="12" name="">
             <a:extLst xmlns:a="http://schemas.openxmlformats.org/drawingml/2006/main">
               <a:ext uri="{FF2B5EF4-FFF2-40B4-BE49-F238E27FC236}">
-                <a16:creationId xmlns:a16="http://schemas.microsoft.com/office/drawing/2014/main" id="{32252EB2-EECF-4863-A79B-6C6AB577EE8A}"/>
+                <a16:creationId xmlns:a16="http://schemas.microsoft.com/office/drawing/2014/main" id="{A969FD06-7D2C-4B9C-86E8-1E9402FF4387}"/>
               </a:ext>
             </a:extLst>
           </p:cNvPr>
@@ -4354,7 +4354,7 @@
           <p:cNvPr id="13" name="">
             <a:extLst xmlns:a="http://schemas.openxmlformats.org/drawingml/2006/main">
               <a:ext uri="{FF2B5EF4-FFF2-40B4-BE49-F238E27FC236}">
-                <a16:creationId xmlns:a16="http://schemas.microsoft.com/office/drawing/2014/main" id="{84A4D7F0-E782-435A-A922-90F3AC5F8D37}"/>
+                <a16:creationId xmlns:a16="http://schemas.microsoft.com/office/drawing/2014/main" id="{544CD196-D2D6-47F2-816E-1F04D5F0BF60}"/>
               </a:ext>
             </a:extLst>
           </p:cNvPr>
@@ -4434,7 +4434,7 @@
           <p:cNvPr id="14" name="">
             <a:extLst xmlns:a="http://schemas.openxmlformats.org/drawingml/2006/main">
               <a:ext uri="{FF2B5EF4-FFF2-40B4-BE49-F238E27FC236}">
-                <a16:creationId xmlns:a16="http://schemas.microsoft.com/office/drawing/2014/main" id="{39B7F54D-2066-4578-AE7B-F29E90B6DD4A}"/>
+                <a16:creationId xmlns:a16="http://schemas.microsoft.com/office/drawing/2014/main" id="{703EDFEC-58DF-431E-9490-3304B1AB010E}"/>
               </a:ext>
             </a:extLst>
           </p:cNvPr>
@@ -4466,7 +4466,7 @@
           <p:cNvPr id="15" name="">
             <a:extLst xmlns:a="http://schemas.openxmlformats.org/drawingml/2006/main">
               <a:ext uri="{FF2B5EF4-FFF2-40B4-BE49-F238E27FC236}">
-                <a16:creationId xmlns:a16="http://schemas.microsoft.com/office/drawing/2014/main" id="{3DC7A1FD-C8A1-4A91-98C2-4C3BC6AC9A5D}"/>
+                <a16:creationId xmlns:a16="http://schemas.microsoft.com/office/drawing/2014/main" id="{630E99AB-93F7-4EEA-B8FC-7D625896AF35}"/>
               </a:ext>
             </a:extLst>
           </p:cNvPr>
@@ -4501,7 +4501,7 @@
           <p:cNvPr id="16" name="">
             <a:extLst xmlns:a="http://schemas.openxmlformats.org/drawingml/2006/main">
               <a:ext uri="{FF2B5EF4-FFF2-40B4-BE49-F238E27FC236}">
-                <a16:creationId xmlns:a16="http://schemas.microsoft.com/office/drawing/2014/main" id="{F2E11145-3AD7-48D1-967E-3CF19DFFDFC7}"/>
+                <a16:creationId xmlns:a16="http://schemas.microsoft.com/office/drawing/2014/main" id="{7B1B6CE3-87BC-44D8-AD3D-5F2412F52C80}"/>
               </a:ext>
             </a:extLst>
           </p:cNvPr>
@@ -4565,7 +4565,7 @@
           <p:cNvPr id="17" name="">
             <a:extLst xmlns:a="http://schemas.openxmlformats.org/drawingml/2006/main">
               <a:ext uri="{FF2B5EF4-FFF2-40B4-BE49-F238E27FC236}">
-                <a16:creationId xmlns:a16="http://schemas.microsoft.com/office/drawing/2014/main" id="{F0D0B5A7-524A-442F-A014-EA450AE2E52C}"/>
+                <a16:creationId xmlns:a16="http://schemas.microsoft.com/office/drawing/2014/main" id="{D03A1B94-D208-4F58-863C-488E7FA5EBDA}"/>
               </a:ext>
             </a:extLst>
           </p:cNvPr>
@@ -4622,7 +4622,7 @@
           <p:cNvPr id="18" name="">
             <a:extLst xmlns:a="http://schemas.openxmlformats.org/drawingml/2006/main">
               <a:ext uri="{FF2B5EF4-FFF2-40B4-BE49-F238E27FC236}">
-                <a16:creationId xmlns:a16="http://schemas.microsoft.com/office/drawing/2014/main" id="{82127236-45C2-4F5D-AD3F-95346500DDFF}"/>
+                <a16:creationId xmlns:a16="http://schemas.microsoft.com/office/drawing/2014/main" id="{A2A90177-813C-4CE0-8CBF-82EE11235AF3}"/>
               </a:ext>
             </a:extLst>
           </p:cNvPr>
@@ -4702,7 +4702,7 @@
           <p:cNvPr id="19" name="">
             <a:extLst xmlns:a="http://schemas.openxmlformats.org/drawingml/2006/main">
               <a:ext uri="{FF2B5EF4-FFF2-40B4-BE49-F238E27FC236}">
-                <a16:creationId xmlns:a16="http://schemas.microsoft.com/office/drawing/2014/main" id="{CDCF6E4E-A334-46F9-9CB2-51ABF0EACA6F}"/>
+                <a16:creationId xmlns:a16="http://schemas.microsoft.com/office/drawing/2014/main" id="{566149F8-2862-4354-B326-F1CEE3F90141}"/>
               </a:ext>
             </a:extLst>
           </p:cNvPr>
@@ -4734,7 +4734,7 @@
           <p:cNvPr id="20" name="">
             <a:extLst xmlns:a="http://schemas.openxmlformats.org/drawingml/2006/main">
               <a:ext uri="{FF2B5EF4-FFF2-40B4-BE49-F238E27FC236}">
-                <a16:creationId xmlns:a16="http://schemas.microsoft.com/office/drawing/2014/main" id="{D1AC6ABB-A934-4671-B55C-58A6129CC98E}"/>
+                <a16:creationId xmlns:a16="http://schemas.microsoft.com/office/drawing/2014/main" id="{4D81A323-0C33-422C-A2A2-773B06345213}"/>
               </a:ext>
             </a:extLst>
           </p:cNvPr>
@@ -4769,7 +4769,7 @@
           <p:cNvPr id="21" name="">
             <a:extLst xmlns:a="http://schemas.openxmlformats.org/drawingml/2006/main">
               <a:ext uri="{FF2B5EF4-FFF2-40B4-BE49-F238E27FC236}">
-                <a16:creationId xmlns:a16="http://schemas.microsoft.com/office/drawing/2014/main" id="{E344DBE8-0CF4-41F1-99B2-57BB8F38E7FE}"/>
+                <a16:creationId xmlns:a16="http://schemas.microsoft.com/office/drawing/2014/main" id="{874D0DFB-923D-48F6-8242-6E54515DFFDC}"/>
               </a:ext>
             </a:extLst>
           </p:cNvPr>
@@ -4833,7 +4833,7 @@
           <p:cNvPr id="22" name="">
             <a:extLst xmlns:a="http://schemas.openxmlformats.org/drawingml/2006/main">
               <a:ext uri="{FF2B5EF4-FFF2-40B4-BE49-F238E27FC236}">
-                <a16:creationId xmlns:a16="http://schemas.microsoft.com/office/drawing/2014/main" id="{0EF344E7-18C4-4C8B-8487-AEDFBEB25D9F}"/>
+                <a16:creationId xmlns:a16="http://schemas.microsoft.com/office/drawing/2014/main" id="{0150000F-A892-4BA7-8DE4-87A2A70BF897}"/>
               </a:ext>
             </a:extLst>
           </p:cNvPr>
@@ -4890,7 +4890,7 @@
           <p:cNvPr id="23" name="">
             <a:extLst xmlns:a="http://schemas.openxmlformats.org/drawingml/2006/main">
               <a:ext uri="{FF2B5EF4-FFF2-40B4-BE49-F238E27FC236}">
-                <a16:creationId xmlns:a16="http://schemas.microsoft.com/office/drawing/2014/main" id="{96D1C6BA-47DF-4C86-8410-35A6C4DE24A8}"/>
+                <a16:creationId xmlns:a16="http://schemas.microsoft.com/office/drawing/2014/main" id="{2008459B-59E1-448B-ADAC-09D0AA3FDFD1}"/>
               </a:ext>
             </a:extLst>
           </p:cNvPr>
@@ -4970,7 +4970,7 @@
           <p:cNvPr id="24" name="">
             <a:extLst xmlns:a="http://schemas.openxmlformats.org/drawingml/2006/main">
               <a:ext uri="{FF2B5EF4-FFF2-40B4-BE49-F238E27FC236}">
-                <a16:creationId xmlns:a16="http://schemas.microsoft.com/office/drawing/2014/main" id="{AC0DABF3-E205-4EE8-86D2-5B299091FE68}"/>
+                <a16:creationId xmlns:a16="http://schemas.microsoft.com/office/drawing/2014/main" id="{F36A861B-3352-4909-BE60-19DA7732E5F8}"/>
               </a:ext>
             </a:extLst>
           </p:cNvPr>
@@ -5002,7 +5002,7 @@
           <p:cNvPr id="25" name="">
             <a:extLst xmlns:a="http://schemas.openxmlformats.org/drawingml/2006/main">
               <a:ext uri="{FF2B5EF4-FFF2-40B4-BE49-F238E27FC236}">
-                <a16:creationId xmlns:a16="http://schemas.microsoft.com/office/drawing/2014/main" id="{BC900DCB-13D9-4B4C-A3AF-27753B8C4EFD}"/>
+                <a16:creationId xmlns:a16="http://schemas.microsoft.com/office/drawing/2014/main" id="{718AD49A-37EC-4A77-A211-AB1B07BF74EC}"/>
               </a:ext>
             </a:extLst>
           </p:cNvPr>
@@ -5037,7 +5037,7 @@
           <p:cNvPr id="26" name="">
             <a:extLst xmlns:a="http://schemas.openxmlformats.org/drawingml/2006/main">
               <a:ext uri="{FF2B5EF4-FFF2-40B4-BE49-F238E27FC236}">
-                <a16:creationId xmlns:a16="http://schemas.microsoft.com/office/drawing/2014/main" id="{A1D910F7-ED4A-4136-B553-2A4134CE9BB7}"/>
+                <a16:creationId xmlns:a16="http://schemas.microsoft.com/office/drawing/2014/main" id="{FF203CF0-52A6-4035-98B1-2BA2C8AE921C}"/>
               </a:ext>
             </a:extLst>
           </p:cNvPr>
@@ -5101,7 +5101,7 @@
           <p:cNvPr id="27" name="">
             <a:extLst xmlns:a="http://schemas.openxmlformats.org/drawingml/2006/main">
               <a:ext uri="{FF2B5EF4-FFF2-40B4-BE49-F238E27FC236}">
-                <a16:creationId xmlns:a16="http://schemas.microsoft.com/office/drawing/2014/main" id="{4CBC92FD-E461-43FD-8AD3-64FA06A4E903}"/>
+                <a16:creationId xmlns:a16="http://schemas.microsoft.com/office/drawing/2014/main" id="{5C49E077-ECDC-4D95-922D-26356F76D1A5}"/>
               </a:ext>
             </a:extLst>
           </p:cNvPr>
@@ -5158,7 +5158,7 @@
           <p:cNvPr id="28" name="">
             <a:extLst xmlns:a="http://schemas.openxmlformats.org/drawingml/2006/main">
               <a:ext uri="{FF2B5EF4-FFF2-40B4-BE49-F238E27FC236}">
-                <a16:creationId xmlns:a16="http://schemas.microsoft.com/office/drawing/2014/main" id="{C96C360E-9D17-42A3-BEEC-081F134A00D9}"/>
+                <a16:creationId xmlns:a16="http://schemas.microsoft.com/office/drawing/2014/main" id="{C92B8515-9A17-4E8D-A9AA-41B273E63B73}"/>
               </a:ext>
             </a:extLst>
           </p:cNvPr>
@@ -5238,7 +5238,7 @@
           <p:cNvPr id="29" name="">
             <a:extLst xmlns:a="http://schemas.openxmlformats.org/drawingml/2006/main">
               <a:ext uri="{FF2B5EF4-FFF2-40B4-BE49-F238E27FC236}">
-                <a16:creationId xmlns:a16="http://schemas.microsoft.com/office/drawing/2014/main" id="{4CCEAF37-05E0-4979-93C7-074919A6E2F7}"/>
+                <a16:creationId xmlns:a16="http://schemas.microsoft.com/office/drawing/2014/main" id="{F5417632-D754-4CCD-8F0C-F7496714D3FC}"/>
               </a:ext>
             </a:extLst>
           </p:cNvPr>
@@ -5295,7 +5295,7 @@
           <p:cNvPr id="30" name="">
             <a:extLst xmlns:a="http://schemas.openxmlformats.org/drawingml/2006/main">
               <a:ext uri="{FF2B5EF4-FFF2-40B4-BE49-F238E27FC236}">
-                <a16:creationId xmlns:a16="http://schemas.microsoft.com/office/drawing/2014/main" id="{0F60504B-B519-4ED4-A0BD-B9FC9C8FA552}"/>
+                <a16:creationId xmlns:a16="http://schemas.microsoft.com/office/drawing/2014/main" id="{6A2F8910-15C0-49F8-AD84-57DFB3710BDA}"/>
               </a:ext>
             </a:extLst>
           </p:cNvPr>
@@ -5330,7 +5330,7 @@
           <p:cNvPr id="31" name="">
             <a:extLst xmlns:a="http://schemas.openxmlformats.org/drawingml/2006/main">
               <a:ext uri="{FF2B5EF4-FFF2-40B4-BE49-F238E27FC236}">
-                <a16:creationId xmlns:a16="http://schemas.microsoft.com/office/drawing/2014/main" id="{C50002B9-D32B-48C0-B094-491F9F7B67B6}"/>
+                <a16:creationId xmlns:a16="http://schemas.microsoft.com/office/drawing/2014/main" id="{F0061632-CE76-4988-84B2-CB63B0FA340C}"/>
               </a:ext>
             </a:extLst>
           </p:cNvPr>
@@ -5387,7 +5387,7 @@
           <p:cNvPr id="32" name="">
             <a:extLst xmlns:a="http://schemas.openxmlformats.org/drawingml/2006/main">
               <a:ext uri="{FF2B5EF4-FFF2-40B4-BE49-F238E27FC236}">
-                <a16:creationId xmlns:a16="http://schemas.microsoft.com/office/drawing/2014/main" id="{45C3E939-D54A-45CD-A52F-C38387ABE473}"/>
+                <a16:creationId xmlns:a16="http://schemas.microsoft.com/office/drawing/2014/main" id="{48178020-A016-4DAA-9EBD-1CECCEFA9263}"/>
               </a:ext>
             </a:extLst>
           </p:cNvPr>
@@ -5490,7 +5490,7 @@
           <p:cNvPr id="33" name="">
             <a:extLst xmlns:a="http://schemas.openxmlformats.org/drawingml/2006/main">
               <a:ext uri="{FF2B5EF4-FFF2-40B4-BE49-F238E27FC236}">
-                <a16:creationId xmlns:a16="http://schemas.microsoft.com/office/drawing/2014/main" id="{BE0792BD-00CE-4DFD-A2A5-6D86A44041EC}"/>
+                <a16:creationId xmlns:a16="http://schemas.microsoft.com/office/drawing/2014/main" id="{96DCB6BF-7962-4D1B-A2E3-15C9DA5AB91D}"/>
               </a:ext>
             </a:extLst>
           </p:cNvPr>
@@ -5554,7 +5554,7 @@
           <p:cNvPr id="34" name="">
             <a:extLst xmlns:a="http://schemas.openxmlformats.org/drawingml/2006/main">
               <a:ext uri="{FF2B5EF4-FFF2-40B4-BE49-F238E27FC236}">
-                <a16:creationId xmlns:a16="http://schemas.microsoft.com/office/drawing/2014/main" id="{03945626-0DC8-4D0B-8CA6-BCE4750BEDA5}"/>
+                <a16:creationId xmlns:a16="http://schemas.microsoft.com/office/drawing/2014/main" id="{170457E1-8958-493F-9A38-B408858E2B1B}"/>
               </a:ext>
             </a:extLst>
           </p:cNvPr>
@@ -5611,7 +5611,7 @@
           <p:cNvPr id="35" name="">
             <a:extLst xmlns:a="http://schemas.openxmlformats.org/drawingml/2006/main">
               <a:ext uri="{FF2B5EF4-FFF2-40B4-BE49-F238E27FC236}">
-                <a16:creationId xmlns:a16="http://schemas.microsoft.com/office/drawing/2014/main" id="{7A10B349-25EB-4832-BE8A-63E308C0263F}"/>
+                <a16:creationId xmlns:a16="http://schemas.microsoft.com/office/drawing/2014/main" id="{51004CCD-BF75-4ABA-9A53-BF2417EDB01B}"/>
               </a:ext>
             </a:extLst>
           </p:cNvPr>
@@ -5646,7 +5646,7 @@
           <p:cNvPr id="36" name="">
             <a:extLst xmlns:a="http://schemas.openxmlformats.org/drawingml/2006/main">
               <a:ext uri="{FF2B5EF4-FFF2-40B4-BE49-F238E27FC236}">
-                <a16:creationId xmlns:a16="http://schemas.microsoft.com/office/drawing/2014/main" id="{4695052A-FE11-4BB3-ABB9-62CF8E633C55}"/>
+                <a16:creationId xmlns:a16="http://schemas.microsoft.com/office/drawing/2014/main" id="{F884E97C-D2E7-4993-9EF0-A3F08179BB0B}"/>
               </a:ext>
             </a:extLst>
           </p:cNvPr>
@@ -5703,7 +5703,7 @@
           <p:cNvPr id="37" name="">
             <a:extLst xmlns:a="http://schemas.openxmlformats.org/drawingml/2006/main">
               <a:ext uri="{FF2B5EF4-FFF2-40B4-BE49-F238E27FC236}">
-                <a16:creationId xmlns:a16="http://schemas.microsoft.com/office/drawing/2014/main" id="{4F086726-399D-4313-8188-535711382CD1}"/>
+                <a16:creationId xmlns:a16="http://schemas.microsoft.com/office/drawing/2014/main" id="{55260737-256B-47BE-A10B-B5562A925451}"/>
               </a:ext>
             </a:extLst>
           </p:cNvPr>
@@ -5738,7 +5738,7 @@
           <p:cNvPr id="38" name="">
             <a:extLst xmlns:a="http://schemas.openxmlformats.org/drawingml/2006/main">
               <a:ext uri="{FF2B5EF4-FFF2-40B4-BE49-F238E27FC236}">
-                <a16:creationId xmlns:a16="http://schemas.microsoft.com/office/drawing/2014/main" id="{359E557A-85C9-4BBD-BAC0-1A1A8DA8593B}"/>
+                <a16:creationId xmlns:a16="http://schemas.microsoft.com/office/drawing/2014/main" id="{1A6C8665-2BF0-48DE-AF4A-23ED2262F7DA}"/>
               </a:ext>
             </a:extLst>
           </p:cNvPr>
@@ -5795,7 +5795,7 @@
           <p:cNvPr id="39" name="">
             <a:extLst xmlns:a="http://schemas.openxmlformats.org/drawingml/2006/main">
               <a:ext uri="{FF2B5EF4-FFF2-40B4-BE49-F238E27FC236}">
-                <a16:creationId xmlns:a16="http://schemas.microsoft.com/office/drawing/2014/main" id="{27DFE4B2-5726-4900-B5EC-7F08BB6A8A67}"/>
+                <a16:creationId xmlns:a16="http://schemas.microsoft.com/office/drawing/2014/main" id="{FDE0A53A-5C2A-4099-B44B-92D677B92C66}"/>
               </a:ext>
             </a:extLst>
           </p:cNvPr>
@@ -5852,7 +5852,7 @@
           <p:cNvPr id="40" name="">
             <a:extLst xmlns:a="http://schemas.openxmlformats.org/drawingml/2006/main">
               <a:ext uri="{FF2B5EF4-FFF2-40B4-BE49-F238E27FC236}">
-                <a16:creationId xmlns:a16="http://schemas.microsoft.com/office/drawing/2014/main" id="{94DE32EC-29BF-43DB-91DF-83E7AA5795F1}"/>
+                <a16:creationId xmlns:a16="http://schemas.microsoft.com/office/drawing/2014/main" id="{230DCF66-746D-4FA5-9BC1-A1EB41CBB640}"/>
               </a:ext>
             </a:extLst>
           </p:cNvPr>
@@ -5887,7 +5887,7 @@
           <p:cNvPr id="41" name="">
             <a:extLst xmlns:a="http://schemas.openxmlformats.org/drawingml/2006/main">
               <a:ext uri="{FF2B5EF4-FFF2-40B4-BE49-F238E27FC236}">
-                <a16:creationId xmlns:a16="http://schemas.microsoft.com/office/drawing/2014/main" id="{26D848C2-5642-4C5C-AD94-CCA0E1AF85EB}"/>
+                <a16:creationId xmlns:a16="http://schemas.microsoft.com/office/drawing/2014/main" id="{46A1397A-A866-49FF-9570-31B96317B1BA}"/>
               </a:ext>
             </a:extLst>
           </p:cNvPr>
@@ -5944,7 +5944,7 @@
           <p:cNvPr id="42" name="">
             <a:extLst xmlns:a="http://schemas.openxmlformats.org/drawingml/2006/main">
               <a:ext uri="{FF2B5EF4-FFF2-40B4-BE49-F238E27FC236}">
-                <a16:creationId xmlns:a16="http://schemas.microsoft.com/office/drawing/2014/main" id="{C592658B-16BE-4E60-B98C-ABC6E24CEC40}"/>
+                <a16:creationId xmlns:a16="http://schemas.microsoft.com/office/drawing/2014/main" id="{44C871B9-9F82-4ADE-951C-D63C9F2A7BF1}"/>
               </a:ext>
             </a:extLst>
           </p:cNvPr>
@@ -6001,7 +6001,7 @@
           <p:cNvPr id="43" name="">
             <a:extLst xmlns:a="http://schemas.openxmlformats.org/drawingml/2006/main">
               <a:ext uri="{FF2B5EF4-FFF2-40B4-BE49-F238E27FC236}">
-                <a16:creationId xmlns:a16="http://schemas.microsoft.com/office/drawing/2014/main" id="{0F236101-C0B0-44EE-9EC9-FB22A53A1B57}"/>
+                <a16:creationId xmlns:a16="http://schemas.microsoft.com/office/drawing/2014/main" id="{1DFB6A74-1B4A-4D97-924C-B057989E371D}"/>
               </a:ext>
             </a:extLst>
           </p:cNvPr>
@@ -6058,7 +6058,7 @@
           <p:cNvPr id="44" name="">
             <a:extLst xmlns:a="http://schemas.openxmlformats.org/drawingml/2006/main">
               <a:ext uri="{FF2B5EF4-FFF2-40B4-BE49-F238E27FC236}">
-                <a16:creationId xmlns:a16="http://schemas.microsoft.com/office/drawing/2014/main" id="{7F88C814-A85C-4FAF-AA3D-951C6E78A169}"/>
+                <a16:creationId xmlns:a16="http://schemas.microsoft.com/office/drawing/2014/main" id="{2F4D9861-66CC-42AA-BB64-7F68CBF59A93}"/>
               </a:ext>
             </a:extLst>
           </p:cNvPr>
@@ -6105,7 +6105,7 @@
                 <a:ea typeface="Arial"/>
                 <a:cs typeface="Arial"/>
               </a:rPr>
-              <a:t>AURA • Track A • 29/09/2026</a:t>
+              <a:t>AURA • Track A • 30/09/2026</a:t>
             </a:r>
           </a:p>
         </p:txBody>
@@ -6115,7 +6115,7 @@
           <p:cNvPr id="45" name="">
             <a:extLst xmlns:a="http://schemas.openxmlformats.org/drawingml/2006/main">
               <a:ext uri="{FF2B5EF4-FFF2-40B4-BE49-F238E27FC236}">
-                <a16:creationId xmlns:a16="http://schemas.microsoft.com/office/drawing/2014/main" id="{54D8EB5D-0920-4769-A423-4BD0182DE530}"/>
+                <a16:creationId xmlns:a16="http://schemas.microsoft.com/office/drawing/2014/main" id="{955D9374-2590-4D8C-AD78-E586C96579E3}"/>
               </a:ext>
             </a:extLst>
           </p:cNvPr>
@@ -6170,7 +6170,7 @@
     </p:spTree>
     <p:extLst>
       <p:ext uri="{BB962C8B-B14F-4D97-AF65-F5344CB8AC3E}">
-        <p14:creationId xmlns:p14="http://schemas.microsoft.com/office/powerpoint/2010/main" val="1428657496"/>
+        <p14:creationId xmlns:p14="http://schemas.microsoft.com/office/powerpoint/2010/main" val="1752561999"/>
       </p:ext>
     </p:extLst>
   </p:cSld>
@@ -6201,7 +6201,7 @@
           <p:cNvPr id="32" name="">
             <a:extLst xmlns:a="http://schemas.openxmlformats.org/drawingml/2006/main">
               <a:ext uri="{FF2B5EF4-FFF2-40B4-BE49-F238E27FC236}">
-                <a16:creationId xmlns:a16="http://schemas.microsoft.com/office/drawing/2014/main" id="{BE538872-EC6D-4C9A-8C4B-AE44C7D96BE5}"/>
+                <a16:creationId xmlns:a16="http://schemas.microsoft.com/office/drawing/2014/main" id="{DA09B3A0-1D91-47FA-90B7-EFD7F37F9046}"/>
               </a:ext>
             </a:extLst>
           </p:cNvPr>
@@ -6258,7 +6258,7 @@
           <p:cNvPr id="2" name="">
             <a:extLst xmlns:a="http://schemas.openxmlformats.org/drawingml/2006/main">
               <a:ext uri="{FF2B5EF4-FFF2-40B4-BE49-F238E27FC236}">
-                <a16:creationId xmlns:a16="http://schemas.microsoft.com/office/drawing/2014/main" id="{E780E054-5D38-4922-A26A-2BBBE74272E9}"/>
+                <a16:creationId xmlns:a16="http://schemas.microsoft.com/office/drawing/2014/main" id="{49352F2A-A939-43D7-AB3E-20541C488B35}"/>
               </a:ext>
             </a:extLst>
           </p:cNvPr>
@@ -6315,7 +6315,7 @@
           <p:cNvPr id="3" name="">
             <a:extLst xmlns:a="http://schemas.openxmlformats.org/drawingml/2006/main">
               <a:ext uri="{FF2B5EF4-FFF2-40B4-BE49-F238E27FC236}">
-                <a16:creationId xmlns:a16="http://schemas.microsoft.com/office/drawing/2014/main" id="{03BACAEB-9ED8-489C-9FE4-64DB35CD7348}"/>
+                <a16:creationId xmlns:a16="http://schemas.microsoft.com/office/drawing/2014/main" id="{9C036D46-5E1A-41C1-B572-45A8699E8D5C}"/>
               </a:ext>
             </a:extLst>
           </p:cNvPr>
@@ -6372,7 +6372,7 @@
           <p:cNvPr id="4" name="">
             <a:extLst xmlns:a="http://schemas.openxmlformats.org/drawingml/2006/main">
               <a:ext uri="{FF2B5EF4-FFF2-40B4-BE49-F238E27FC236}">
-                <a16:creationId xmlns:a16="http://schemas.microsoft.com/office/drawing/2014/main" id="{69B79DC7-53FC-449A-86D9-7EA5146E2104}"/>
+                <a16:creationId xmlns:a16="http://schemas.microsoft.com/office/drawing/2014/main" id="{7C912B59-32EC-4BB2-842F-C50592904683}"/>
               </a:ext>
             </a:extLst>
           </p:cNvPr>
@@ -6403,7 +6403,7 @@
           <p:cNvPr id="5" name="">
             <a:extLst xmlns:a="http://schemas.openxmlformats.org/drawingml/2006/main">
               <a:ext uri="{FF2B5EF4-FFF2-40B4-BE49-F238E27FC236}">
-                <a16:creationId xmlns:a16="http://schemas.microsoft.com/office/drawing/2014/main" id="{B95024D4-9D84-4907-B25D-83CFCE694A5D}"/>
+                <a16:creationId xmlns:a16="http://schemas.microsoft.com/office/drawing/2014/main" id="{0856DDD9-33D5-4A96-8576-AD414FBCE0C3}"/>
               </a:ext>
             </a:extLst>
           </p:cNvPr>
@@ -6438,7 +6438,7 @@
           <p:cNvPr id="6" name="">
             <a:extLst xmlns:a="http://schemas.openxmlformats.org/drawingml/2006/main">
               <a:ext uri="{FF2B5EF4-FFF2-40B4-BE49-F238E27FC236}">
-                <a16:creationId xmlns:a16="http://schemas.microsoft.com/office/drawing/2014/main" id="{1EDCA404-84FE-4476-9C3E-71B2A29F396A}"/>
+                <a16:creationId xmlns:a16="http://schemas.microsoft.com/office/drawing/2014/main" id="{3B7631DA-0C60-42B5-91F0-EDBB398B6BC0}"/>
               </a:ext>
             </a:extLst>
           </p:cNvPr>
@@ -6502,7 +6502,7 @@
           <p:cNvPr id="7" name="">
             <a:extLst xmlns:a="http://schemas.openxmlformats.org/drawingml/2006/main">
               <a:ext uri="{FF2B5EF4-FFF2-40B4-BE49-F238E27FC236}">
-                <a16:creationId xmlns:a16="http://schemas.microsoft.com/office/drawing/2014/main" id="{0C1F17F0-1720-4A3B-AF3E-01325A1E8102}"/>
+                <a16:creationId xmlns:a16="http://schemas.microsoft.com/office/drawing/2014/main" id="{630659E9-495A-4849-B489-92DA8497A7AC}"/>
               </a:ext>
             </a:extLst>
           </p:cNvPr>
@@ -6559,7 +6559,7 @@
           <p:cNvPr id="8" name="">
             <a:extLst xmlns:a="http://schemas.openxmlformats.org/drawingml/2006/main">
               <a:ext uri="{FF2B5EF4-FFF2-40B4-BE49-F238E27FC236}">
-                <a16:creationId xmlns:a16="http://schemas.microsoft.com/office/drawing/2014/main" id="{AA7AEAE4-41E3-461A-8FEF-EAFBEC7E7D7F}"/>
+                <a16:creationId xmlns:a16="http://schemas.microsoft.com/office/drawing/2014/main" id="{9B6664E4-33E6-4314-9B3F-A31DB0D2DED1}"/>
               </a:ext>
             </a:extLst>
           </p:cNvPr>
@@ -6662,7 +6662,7 @@
           <p:cNvPr id="9" name="">
             <a:extLst xmlns:a="http://schemas.openxmlformats.org/drawingml/2006/main">
               <a:ext uri="{FF2B5EF4-FFF2-40B4-BE49-F238E27FC236}">
-                <a16:creationId xmlns:a16="http://schemas.microsoft.com/office/drawing/2014/main" id="{178F698E-F610-455D-970D-65B1E1ABE903}"/>
+                <a16:creationId xmlns:a16="http://schemas.microsoft.com/office/drawing/2014/main" id="{26CABCE5-5B62-478B-BBDB-418E5F998342}"/>
               </a:ext>
             </a:extLst>
           </p:cNvPr>
@@ -6697,7 +6697,7 @@
           <p:cNvPr id="10" name="">
             <a:extLst xmlns:a="http://schemas.openxmlformats.org/drawingml/2006/main">
               <a:ext uri="{FF2B5EF4-FFF2-40B4-BE49-F238E27FC236}">
-                <a16:creationId xmlns:a16="http://schemas.microsoft.com/office/drawing/2014/main" id="{8324D67F-5CE5-4D34-A9EC-F0B91CF9FDE8}"/>
+                <a16:creationId xmlns:a16="http://schemas.microsoft.com/office/drawing/2014/main" id="{C44369FD-C591-453F-96E7-CDD0FD097FB9}"/>
               </a:ext>
             </a:extLst>
           </p:cNvPr>
@@ -6761,7 +6761,7 @@
           <p:cNvPr id="11" name="">
             <a:extLst xmlns:a="http://schemas.openxmlformats.org/drawingml/2006/main">
               <a:ext uri="{FF2B5EF4-FFF2-40B4-BE49-F238E27FC236}">
-                <a16:creationId xmlns:a16="http://schemas.microsoft.com/office/drawing/2014/main" id="{B9BFFC87-5A0A-4556-B29B-A3F5A0DDDC10}"/>
+                <a16:creationId xmlns:a16="http://schemas.microsoft.com/office/drawing/2014/main" id="{263A9736-222F-47C3-8E8A-8FF130D5BDC2}"/>
               </a:ext>
             </a:extLst>
           </p:cNvPr>
@@ -6818,7 +6818,7 @@
           <p:cNvPr id="12" name="">
             <a:extLst xmlns:a="http://schemas.openxmlformats.org/drawingml/2006/main">
               <a:ext uri="{FF2B5EF4-FFF2-40B4-BE49-F238E27FC236}">
-                <a16:creationId xmlns:a16="http://schemas.microsoft.com/office/drawing/2014/main" id="{7EF55849-DC5E-4779-8805-E0785A486F42}"/>
+                <a16:creationId xmlns:a16="http://schemas.microsoft.com/office/drawing/2014/main" id="{FFA9AECB-50DA-499D-9B8B-ADF397FCA46A}"/>
               </a:ext>
             </a:extLst>
           </p:cNvPr>
@@ -6921,7 +6921,7 @@
           <p:cNvPr id="13" name="">
             <a:extLst xmlns:a="http://schemas.openxmlformats.org/drawingml/2006/main">
               <a:ext uri="{FF2B5EF4-FFF2-40B4-BE49-F238E27FC236}">
-                <a16:creationId xmlns:a16="http://schemas.microsoft.com/office/drawing/2014/main" id="{AFE5A64E-DF54-4C16-8801-2BF9F389F37F}"/>
+                <a16:creationId xmlns:a16="http://schemas.microsoft.com/office/drawing/2014/main" id="{CEF97CED-22F7-4C5C-9D58-D62CA0EA1331}"/>
               </a:ext>
             </a:extLst>
           </p:cNvPr>
@@ -6978,7 +6978,7 @@
           <p:cNvPr id="14" name="">
             <a:extLst xmlns:a="http://schemas.openxmlformats.org/drawingml/2006/main">
               <a:ext uri="{FF2B5EF4-FFF2-40B4-BE49-F238E27FC236}">
-                <a16:creationId xmlns:a16="http://schemas.microsoft.com/office/drawing/2014/main" id="{AFD66E98-2A43-4161-A809-CF8F87DE964D}"/>
+                <a16:creationId xmlns:a16="http://schemas.microsoft.com/office/drawing/2014/main" id="{53E1362B-DF3A-4787-BEB4-0419E0044DE1}"/>
               </a:ext>
             </a:extLst>
           </p:cNvPr>
@@ -7013,7 +7013,7 @@
           <p:cNvPr id="15" name="">
             <a:extLst xmlns:a="http://schemas.openxmlformats.org/drawingml/2006/main">
               <a:ext uri="{FF2B5EF4-FFF2-40B4-BE49-F238E27FC236}">
-                <a16:creationId xmlns:a16="http://schemas.microsoft.com/office/drawing/2014/main" id="{06A01848-4061-4037-923A-886AFEBDA554}"/>
+                <a16:creationId xmlns:a16="http://schemas.microsoft.com/office/drawing/2014/main" id="{4F55FD17-9599-4D76-A926-345BFF084711}"/>
               </a:ext>
             </a:extLst>
           </p:cNvPr>
@@ -7060,7 +7060,7 @@
                 <a:ea typeface="Arial"/>
                 <a:cs typeface="Arial"/>
               </a:rPr>
-              <a:t>88/88</a:t>
+              <a:t>93/93</a:t>
             </a:r>
           </a:p>
         </p:txBody>
@@ -7070,7 +7070,7 @@
           <p:cNvPr id="16" name="">
             <a:extLst xmlns:a="http://schemas.openxmlformats.org/drawingml/2006/main">
               <a:ext uri="{FF2B5EF4-FFF2-40B4-BE49-F238E27FC236}">
-                <a16:creationId xmlns:a16="http://schemas.microsoft.com/office/drawing/2014/main" id="{C9CA77E4-A57E-4128-B0C8-59479913FFB6}"/>
+                <a16:creationId xmlns:a16="http://schemas.microsoft.com/office/drawing/2014/main" id="{E14EF1D7-B80A-4594-89C8-86DBA94A3598}"/>
               </a:ext>
             </a:extLst>
           </p:cNvPr>
@@ -7127,7 +7127,7 @@
           <p:cNvPr id="17" name="">
             <a:extLst xmlns:a="http://schemas.openxmlformats.org/drawingml/2006/main">
               <a:ext uri="{FF2B5EF4-FFF2-40B4-BE49-F238E27FC236}">
-                <a16:creationId xmlns:a16="http://schemas.microsoft.com/office/drawing/2014/main" id="{DC3C45E0-3F26-45B9-8C2E-EADDDF2E832E}"/>
+                <a16:creationId xmlns:a16="http://schemas.microsoft.com/office/drawing/2014/main" id="{42396F11-8A17-45C1-82C9-9F129CF72322}"/>
               </a:ext>
             </a:extLst>
           </p:cNvPr>
@@ -7162,7 +7162,7 @@
           <p:cNvPr id="18" name="">
             <a:extLst xmlns:a="http://schemas.openxmlformats.org/drawingml/2006/main">
               <a:ext uri="{FF2B5EF4-FFF2-40B4-BE49-F238E27FC236}">
-                <a16:creationId xmlns:a16="http://schemas.microsoft.com/office/drawing/2014/main" id="{813A5899-EAB9-424D-BAA7-2393ECA055F1}"/>
+                <a16:creationId xmlns:a16="http://schemas.microsoft.com/office/drawing/2014/main" id="{7708888A-A6B9-45A2-A30C-C79BAE57F899}"/>
               </a:ext>
             </a:extLst>
           </p:cNvPr>
@@ -7219,7 +7219,7 @@
           <p:cNvPr id="19" name="">
             <a:extLst xmlns:a="http://schemas.openxmlformats.org/drawingml/2006/main">
               <a:ext uri="{FF2B5EF4-FFF2-40B4-BE49-F238E27FC236}">
-                <a16:creationId xmlns:a16="http://schemas.microsoft.com/office/drawing/2014/main" id="{85E66399-AD72-4D5A-940D-A5A417CDB3F2}"/>
+                <a16:creationId xmlns:a16="http://schemas.microsoft.com/office/drawing/2014/main" id="{2C5D17CC-33C3-4BDD-8617-B372D1D973DC}"/>
               </a:ext>
             </a:extLst>
           </p:cNvPr>
@@ -7276,7 +7276,7 @@
           <p:cNvPr id="20" name="">
             <a:extLst xmlns:a="http://schemas.openxmlformats.org/drawingml/2006/main">
               <a:ext uri="{FF2B5EF4-FFF2-40B4-BE49-F238E27FC236}">
-                <a16:creationId xmlns:a16="http://schemas.microsoft.com/office/drawing/2014/main" id="{7D9C7005-D313-401E-A86F-36D72AD76F60}"/>
+                <a16:creationId xmlns:a16="http://schemas.microsoft.com/office/drawing/2014/main" id="{88C69ED6-E63D-48FF-895F-17E898A20253}"/>
               </a:ext>
             </a:extLst>
           </p:cNvPr>
@@ -7311,7 +7311,7 @@
           <p:cNvPr id="21" name="">
             <a:extLst xmlns:a="http://schemas.openxmlformats.org/drawingml/2006/main">
               <a:ext uri="{FF2B5EF4-FFF2-40B4-BE49-F238E27FC236}">
-                <a16:creationId xmlns:a16="http://schemas.microsoft.com/office/drawing/2014/main" id="{EB66505E-8547-46B7-BD26-3AD894E82A0E}"/>
+                <a16:creationId xmlns:a16="http://schemas.microsoft.com/office/drawing/2014/main" id="{72B3F745-F4BE-4163-9856-69F99205F11E}"/>
               </a:ext>
             </a:extLst>
           </p:cNvPr>
@@ -7368,7 +7368,7 @@
           <p:cNvPr id="22" name="">
             <a:extLst xmlns:a="http://schemas.openxmlformats.org/drawingml/2006/main">
               <a:ext uri="{FF2B5EF4-FFF2-40B4-BE49-F238E27FC236}">
-                <a16:creationId xmlns:a16="http://schemas.microsoft.com/office/drawing/2014/main" id="{4EFFB63F-F7CE-4333-B6B1-DA9C59779A92}"/>
+                <a16:creationId xmlns:a16="http://schemas.microsoft.com/office/drawing/2014/main" id="{F9900FB4-1E7F-4E13-9241-5779E15203E4}"/>
               </a:ext>
             </a:extLst>
           </p:cNvPr>
@@ -7425,7 +7425,7 @@
           <p:cNvPr id="23" name="">
             <a:extLst xmlns:a="http://schemas.openxmlformats.org/drawingml/2006/main">
               <a:ext uri="{FF2B5EF4-FFF2-40B4-BE49-F238E27FC236}">
-                <a16:creationId xmlns:a16="http://schemas.microsoft.com/office/drawing/2014/main" id="{3324DA6B-5C0A-4257-AC2A-EF66C836D5F0}"/>
+                <a16:creationId xmlns:a16="http://schemas.microsoft.com/office/drawing/2014/main" id="{24DE3B5D-8232-4B4A-8EDC-7DC9914ED689}"/>
               </a:ext>
             </a:extLst>
           </p:cNvPr>
@@ -7460,7 +7460,7 @@
           <p:cNvPr id="24" name="">
             <a:extLst xmlns:a="http://schemas.openxmlformats.org/drawingml/2006/main">
               <a:ext uri="{FF2B5EF4-FFF2-40B4-BE49-F238E27FC236}">
-                <a16:creationId xmlns:a16="http://schemas.microsoft.com/office/drawing/2014/main" id="{9B8E0151-6E91-47AD-BEFD-9C21CBCEAC6E}"/>
+                <a16:creationId xmlns:a16="http://schemas.microsoft.com/office/drawing/2014/main" id="{1DE71A65-1C58-4ED7-B62E-23164182C15E}"/>
               </a:ext>
             </a:extLst>
           </p:cNvPr>
@@ -7517,7 +7517,7 @@
           <p:cNvPr id="25" name="">
             <a:extLst xmlns:a="http://schemas.openxmlformats.org/drawingml/2006/main">
               <a:ext uri="{FF2B5EF4-FFF2-40B4-BE49-F238E27FC236}">
-                <a16:creationId xmlns:a16="http://schemas.microsoft.com/office/drawing/2014/main" id="{BBB8178F-5FF6-4F14-A52B-A5CF9721FF92}"/>
+                <a16:creationId xmlns:a16="http://schemas.microsoft.com/office/drawing/2014/main" id="{ACF0264F-78A2-4D34-BE94-152C664DAA26}"/>
               </a:ext>
             </a:extLst>
           </p:cNvPr>
@@ -7581,7 +7581,7 @@
           <p:cNvPr id="26" name="">
             <a:extLst xmlns:a="http://schemas.openxmlformats.org/drawingml/2006/main">
               <a:ext uri="{FF2B5EF4-FFF2-40B4-BE49-F238E27FC236}">
-                <a16:creationId xmlns:a16="http://schemas.microsoft.com/office/drawing/2014/main" id="{03F7FEC1-42E4-4538-A342-59FBBB2BC740}"/>
+                <a16:creationId xmlns:a16="http://schemas.microsoft.com/office/drawing/2014/main" id="{140FD54F-AF1C-4D8B-9314-FA275CB91059}"/>
               </a:ext>
             </a:extLst>
           </p:cNvPr>
@@ -7645,7 +7645,7 @@
           <p:cNvPr id="27" name="">
             <a:extLst xmlns:a="http://schemas.openxmlformats.org/drawingml/2006/main">
               <a:ext uri="{FF2B5EF4-FFF2-40B4-BE49-F238E27FC236}">
-                <a16:creationId xmlns:a16="http://schemas.microsoft.com/office/drawing/2014/main" id="{91E6E5B5-086E-46C6-8786-4292E07A69DC}"/>
+                <a16:creationId xmlns:a16="http://schemas.microsoft.com/office/drawing/2014/main" id="{2765C1CB-3FD7-4003-8167-5EE50E6C33D7}"/>
               </a:ext>
             </a:extLst>
           </p:cNvPr>
@@ -7709,7 +7709,7 @@
           <p:cNvPr id="28" name="">
             <a:extLst xmlns:a="http://schemas.openxmlformats.org/drawingml/2006/main">
               <a:ext uri="{FF2B5EF4-FFF2-40B4-BE49-F238E27FC236}">
-                <a16:creationId xmlns:a16="http://schemas.microsoft.com/office/drawing/2014/main" id="{A7DBC37A-5F3B-4861-BA4D-A1F92E0B5E8F}"/>
+                <a16:creationId xmlns:a16="http://schemas.microsoft.com/office/drawing/2014/main" id="{7CD754EA-07DF-4B34-93A1-D4F60F9E8F73}"/>
               </a:ext>
             </a:extLst>
           </p:cNvPr>
@@ -7773,7 +7773,7 @@
           <p:cNvPr id="29" name="">
             <a:extLst xmlns:a="http://schemas.openxmlformats.org/drawingml/2006/main">
               <a:ext uri="{FF2B5EF4-FFF2-40B4-BE49-F238E27FC236}">
-                <a16:creationId xmlns:a16="http://schemas.microsoft.com/office/drawing/2014/main" id="{867049EB-F346-45A6-88CE-B0F104A6CBA9}"/>
+                <a16:creationId xmlns:a16="http://schemas.microsoft.com/office/drawing/2014/main" id="{2D005EB0-5567-4CAA-9A05-F34464DBF8D3}"/>
               </a:ext>
             </a:extLst>
           </p:cNvPr>
@@ -7830,7 +7830,7 @@
           <p:cNvPr id="30" name="">
             <a:extLst xmlns:a="http://schemas.openxmlformats.org/drawingml/2006/main">
               <a:ext uri="{FF2B5EF4-FFF2-40B4-BE49-F238E27FC236}">
-                <a16:creationId xmlns:a16="http://schemas.microsoft.com/office/drawing/2014/main" id="{3A28D2E1-F9A6-4667-94C9-A115539ADA73}"/>
+                <a16:creationId xmlns:a16="http://schemas.microsoft.com/office/drawing/2014/main" id="{3C4089AC-14CD-4565-9685-ADB6D458F47E}"/>
               </a:ext>
             </a:extLst>
           </p:cNvPr>
@@ -7877,7 +7877,7 @@
                 <a:ea typeface="Arial"/>
                 <a:cs typeface="Arial"/>
               </a:rPr>
-              <a:t>AURA • Track A • 29/09/2026</a:t>
+              <a:t>AURA • Track A • 30/09/2026</a:t>
             </a:r>
           </a:p>
         </p:txBody>
@@ -7887,7 +7887,7 @@
           <p:cNvPr id="31" name="">
             <a:extLst xmlns:a="http://schemas.openxmlformats.org/drawingml/2006/main">
               <a:ext uri="{FF2B5EF4-FFF2-40B4-BE49-F238E27FC236}">
-                <a16:creationId xmlns:a16="http://schemas.microsoft.com/office/drawing/2014/main" id="{ACCE9224-371A-4758-BC41-8E2E838669EC}"/>
+                <a16:creationId xmlns:a16="http://schemas.microsoft.com/office/drawing/2014/main" id="{A5AB0C78-0770-4F5A-9183-4A05DE73B68E}"/>
               </a:ext>
             </a:extLst>
           </p:cNvPr>
@@ -7942,7 +7942,7 @@
     </p:spTree>
     <p:extLst>
       <p:ext uri="{BB962C8B-B14F-4D97-AF65-F5344CB8AC3E}">
-        <p14:creationId xmlns:p14="http://schemas.microsoft.com/office/powerpoint/2010/main" val="1010242632"/>
+        <p14:creationId xmlns:p14="http://schemas.microsoft.com/office/powerpoint/2010/main" val="888229003"/>
       </p:ext>
     </p:extLst>
   </p:cSld>
@@ -7973,7 +7973,7 @@
           <p:cNvPr id="32" name="">
             <a:extLst xmlns:a="http://schemas.openxmlformats.org/drawingml/2006/main">
               <a:ext uri="{FF2B5EF4-FFF2-40B4-BE49-F238E27FC236}">
-                <a16:creationId xmlns:a16="http://schemas.microsoft.com/office/drawing/2014/main" id="{C3797956-D0AB-4ABE-8237-256A67E996B7}"/>
+                <a16:creationId xmlns:a16="http://schemas.microsoft.com/office/drawing/2014/main" id="{E03C72AA-BF3E-4521-91C7-28A4C3D00BE8}"/>
               </a:ext>
             </a:extLst>
           </p:cNvPr>
@@ -8030,7 +8030,7 @@
           <p:cNvPr id="2" name="">
             <a:extLst xmlns:a="http://schemas.openxmlformats.org/drawingml/2006/main">
               <a:ext uri="{FF2B5EF4-FFF2-40B4-BE49-F238E27FC236}">
-                <a16:creationId xmlns:a16="http://schemas.microsoft.com/office/drawing/2014/main" id="{584FD613-F647-45A0-B3A3-403EBF9545C0}"/>
+                <a16:creationId xmlns:a16="http://schemas.microsoft.com/office/drawing/2014/main" id="{496E9CB4-8C22-4D4B-A365-1A1DBF52A9C7}"/>
               </a:ext>
             </a:extLst>
           </p:cNvPr>
@@ -8087,7 +8087,7 @@
           <p:cNvPr id="3" name="">
             <a:extLst xmlns:a="http://schemas.openxmlformats.org/drawingml/2006/main">
               <a:ext uri="{FF2B5EF4-FFF2-40B4-BE49-F238E27FC236}">
-                <a16:creationId xmlns:a16="http://schemas.microsoft.com/office/drawing/2014/main" id="{DDAF7492-EF35-4CB8-A7D7-1BFAF8DAC934}"/>
+                <a16:creationId xmlns:a16="http://schemas.microsoft.com/office/drawing/2014/main" id="{8AF59173-4645-4C52-8E0D-7C220BF64C55}"/>
               </a:ext>
             </a:extLst>
           </p:cNvPr>
@@ -8144,7 +8144,7 @@
           <p:cNvPr id="4" name="">
             <a:extLst xmlns:a="http://schemas.openxmlformats.org/drawingml/2006/main">
               <a:ext uri="{FF2B5EF4-FFF2-40B4-BE49-F238E27FC236}">
-                <a16:creationId xmlns:a16="http://schemas.microsoft.com/office/drawing/2014/main" id="{C68FC1DA-61E2-4196-8AAE-3AFF0F5B11AE}"/>
+                <a16:creationId xmlns:a16="http://schemas.microsoft.com/office/drawing/2014/main" id="{AEDFA333-5055-4A8A-8AAC-85A7CE220586}"/>
               </a:ext>
             </a:extLst>
           </p:cNvPr>
@@ -8175,7 +8175,7 @@
           <p:cNvPr id="5" name="">
             <a:extLst xmlns:a="http://schemas.openxmlformats.org/drawingml/2006/main">
               <a:ext uri="{FF2B5EF4-FFF2-40B4-BE49-F238E27FC236}">
-                <a16:creationId xmlns:a16="http://schemas.microsoft.com/office/drawing/2014/main" id="{0947BFFA-6A40-4B65-93B3-B6CD23776516}"/>
+                <a16:creationId xmlns:a16="http://schemas.microsoft.com/office/drawing/2014/main" id="{AABB02EC-232F-4DF2-AD4D-F9DD34BF1BFD}"/>
               </a:ext>
             </a:extLst>
           </p:cNvPr>
@@ -8210,7 +8210,7 @@
           <p:cNvPr id="6" name="">
             <a:extLst xmlns:a="http://schemas.openxmlformats.org/drawingml/2006/main">
               <a:ext uri="{FF2B5EF4-FFF2-40B4-BE49-F238E27FC236}">
-                <a16:creationId xmlns:a16="http://schemas.microsoft.com/office/drawing/2014/main" id="{8BE2A748-C40B-41CE-B5B9-AF472279F817}"/>
+                <a16:creationId xmlns:a16="http://schemas.microsoft.com/office/drawing/2014/main" id="{B584D3C1-235F-41C3-9CC8-F19DD70DA243}"/>
               </a:ext>
             </a:extLst>
           </p:cNvPr>
@@ -8274,7 +8274,7 @@
           <p:cNvPr id="7" name="">
             <a:extLst xmlns:a="http://schemas.openxmlformats.org/drawingml/2006/main">
               <a:ext uri="{FF2B5EF4-FFF2-40B4-BE49-F238E27FC236}">
-                <a16:creationId xmlns:a16="http://schemas.microsoft.com/office/drawing/2014/main" id="{C64947A7-EF2C-4DFB-AD11-8E8AA244ACF4}"/>
+                <a16:creationId xmlns:a16="http://schemas.microsoft.com/office/drawing/2014/main" id="{1327D169-E558-4AEB-8BCE-EC312702A2CE}"/>
               </a:ext>
             </a:extLst>
           </p:cNvPr>
@@ -8331,7 +8331,7 @@
           <p:cNvPr id="8" name="">
             <a:extLst xmlns:a="http://schemas.openxmlformats.org/drawingml/2006/main">
               <a:ext uri="{FF2B5EF4-FFF2-40B4-BE49-F238E27FC236}">
-                <a16:creationId xmlns:a16="http://schemas.microsoft.com/office/drawing/2014/main" id="{038EA3FD-5A69-40AC-BE2A-08E43F871C36}"/>
+                <a16:creationId xmlns:a16="http://schemas.microsoft.com/office/drawing/2014/main" id="{5126B025-08AF-4C0F-B4D7-E66995CA0945}"/>
               </a:ext>
             </a:extLst>
           </p:cNvPr>
@@ -8362,7 +8362,7 @@
           <p:cNvPr id="9" name="">
             <a:extLst xmlns:a="http://schemas.openxmlformats.org/drawingml/2006/main">
               <a:ext uri="{FF2B5EF4-FFF2-40B4-BE49-F238E27FC236}">
-                <a16:creationId xmlns:a16="http://schemas.microsoft.com/office/drawing/2014/main" id="{4F713B53-810C-4735-B11B-3B4F0B13A3C6}"/>
+                <a16:creationId xmlns:a16="http://schemas.microsoft.com/office/drawing/2014/main" id="{EF6E67E1-CA2E-4579-B2F4-AE19AB0C70E2}"/>
               </a:ext>
             </a:extLst>
           </p:cNvPr>
@@ -8397,7 +8397,7 @@
           <p:cNvPr id="10" name="">
             <a:extLst xmlns:a="http://schemas.openxmlformats.org/drawingml/2006/main">
               <a:ext uri="{FF2B5EF4-FFF2-40B4-BE49-F238E27FC236}">
-                <a16:creationId xmlns:a16="http://schemas.microsoft.com/office/drawing/2014/main" id="{9A171F2B-C0A9-4A0E-90BE-A44CF697DC87}"/>
+                <a16:creationId xmlns:a16="http://schemas.microsoft.com/office/drawing/2014/main" id="{46D8B4D9-1DF7-4341-A409-97F76FB69A44}"/>
               </a:ext>
             </a:extLst>
           </p:cNvPr>
@@ -8461,7 +8461,7 @@
           <p:cNvPr id="11" name="">
             <a:extLst xmlns:a="http://schemas.openxmlformats.org/drawingml/2006/main">
               <a:ext uri="{FF2B5EF4-FFF2-40B4-BE49-F238E27FC236}">
-                <a16:creationId xmlns:a16="http://schemas.microsoft.com/office/drawing/2014/main" id="{358EF0B2-D731-4039-AF85-CA1FE4013427}"/>
+                <a16:creationId xmlns:a16="http://schemas.microsoft.com/office/drawing/2014/main" id="{1D3986FC-EB26-43F1-A4A3-D2645BBF669D}"/>
               </a:ext>
             </a:extLst>
           </p:cNvPr>
@@ -8518,7 +8518,7 @@
           <p:cNvPr id="12" name="">
             <a:extLst xmlns:a="http://schemas.openxmlformats.org/drawingml/2006/main">
               <a:ext uri="{FF2B5EF4-FFF2-40B4-BE49-F238E27FC236}">
-                <a16:creationId xmlns:a16="http://schemas.microsoft.com/office/drawing/2014/main" id="{F1361D28-EC35-4048-ABA0-5CA77EA6916F}"/>
+                <a16:creationId xmlns:a16="http://schemas.microsoft.com/office/drawing/2014/main" id="{7D3F566F-C264-4125-B3C5-E35541EFBAE7}"/>
               </a:ext>
             </a:extLst>
           </p:cNvPr>
@@ -8549,7 +8549,7 @@
           <p:cNvPr id="13" name="">
             <a:extLst xmlns:a="http://schemas.openxmlformats.org/drawingml/2006/main">
               <a:ext uri="{FF2B5EF4-FFF2-40B4-BE49-F238E27FC236}">
-                <a16:creationId xmlns:a16="http://schemas.microsoft.com/office/drawing/2014/main" id="{B6D06C3B-8363-4CA6-B36A-1ABE910BC47A}"/>
+                <a16:creationId xmlns:a16="http://schemas.microsoft.com/office/drawing/2014/main" id="{5E271AC8-57AE-4392-BE2E-82E06FF1EDEF}"/>
               </a:ext>
             </a:extLst>
           </p:cNvPr>
@@ -8584,7 +8584,7 @@
           <p:cNvPr id="14" name="">
             <a:extLst xmlns:a="http://schemas.openxmlformats.org/drawingml/2006/main">
               <a:ext uri="{FF2B5EF4-FFF2-40B4-BE49-F238E27FC236}">
-                <a16:creationId xmlns:a16="http://schemas.microsoft.com/office/drawing/2014/main" id="{012012A0-B699-48A7-A0FC-3D178EAF882D}"/>
+                <a16:creationId xmlns:a16="http://schemas.microsoft.com/office/drawing/2014/main" id="{78818176-C619-4424-9B90-F66F300513BF}"/>
               </a:ext>
             </a:extLst>
           </p:cNvPr>
@@ -8648,7 +8648,7 @@
           <p:cNvPr id="15" name="">
             <a:extLst xmlns:a="http://schemas.openxmlformats.org/drawingml/2006/main">
               <a:ext uri="{FF2B5EF4-FFF2-40B4-BE49-F238E27FC236}">
-                <a16:creationId xmlns:a16="http://schemas.microsoft.com/office/drawing/2014/main" id="{92DE37FE-2809-45E7-B66A-FEC91E2281E7}"/>
+                <a16:creationId xmlns:a16="http://schemas.microsoft.com/office/drawing/2014/main" id="{CF6074B0-B305-4EBB-8D47-CB0ABA8DEB70}"/>
               </a:ext>
             </a:extLst>
           </p:cNvPr>
@@ -8695,7 +8695,7 @@
                 <a:ea typeface="Arial"/>
                 <a:cs typeface="Arial"/>
               </a:rPr>
-              <a:t>Semantic validator → PolicyDecisionEngine → EscalationWorkflow</a:t>
+              <a:t>Schema + identifier validation → Policy C# → human review</a:t>
             </a:r>
           </a:p>
         </p:txBody>
@@ -8705,7 +8705,7 @@
           <p:cNvPr id="16" name="">
             <a:extLst xmlns:a="http://schemas.openxmlformats.org/drawingml/2006/main">
               <a:ext uri="{FF2B5EF4-FFF2-40B4-BE49-F238E27FC236}">
-                <a16:creationId xmlns:a16="http://schemas.microsoft.com/office/drawing/2014/main" id="{36D34321-C0F6-45D2-8748-5B32DD85BDCB}"/>
+                <a16:creationId xmlns:a16="http://schemas.microsoft.com/office/drawing/2014/main" id="{08B62DAF-9AAA-47C7-9E3B-4874679928B4}"/>
               </a:ext>
             </a:extLst>
           </p:cNvPr>
@@ -8736,7 +8736,7 @@
           <p:cNvPr id="17" name="">
             <a:extLst xmlns:a="http://schemas.openxmlformats.org/drawingml/2006/main">
               <a:ext uri="{FF2B5EF4-FFF2-40B4-BE49-F238E27FC236}">
-                <a16:creationId xmlns:a16="http://schemas.microsoft.com/office/drawing/2014/main" id="{2B100DBD-C125-4B5C-B893-4BCDB102CB82}"/>
+                <a16:creationId xmlns:a16="http://schemas.microsoft.com/office/drawing/2014/main" id="{2A6FFF23-71F8-4D7C-9722-E6EC6AEBF17E}"/>
               </a:ext>
             </a:extLst>
           </p:cNvPr>
@@ -8771,7 +8771,7 @@
           <p:cNvPr id="18" name="">
             <a:extLst xmlns:a="http://schemas.openxmlformats.org/drawingml/2006/main">
               <a:ext uri="{FF2B5EF4-FFF2-40B4-BE49-F238E27FC236}">
-                <a16:creationId xmlns:a16="http://schemas.microsoft.com/office/drawing/2014/main" id="{5B2BE495-6DAA-4C39-B090-44F8ECF5CFDB}"/>
+                <a16:creationId xmlns:a16="http://schemas.microsoft.com/office/drawing/2014/main" id="{366E79B7-07E4-449F-B36A-5126C49370BE}"/>
               </a:ext>
             </a:extLst>
           </p:cNvPr>
@@ -8835,7 +8835,7 @@
           <p:cNvPr id="19" name="">
             <a:extLst xmlns:a="http://schemas.openxmlformats.org/drawingml/2006/main">
               <a:ext uri="{FF2B5EF4-FFF2-40B4-BE49-F238E27FC236}">
-                <a16:creationId xmlns:a16="http://schemas.microsoft.com/office/drawing/2014/main" id="{E2ACBCB5-1186-4093-A1E9-61BA11089E11}"/>
+                <a16:creationId xmlns:a16="http://schemas.microsoft.com/office/drawing/2014/main" id="{B310DD9D-B154-4B37-ADCF-7C41A3074D8E}"/>
               </a:ext>
             </a:extLst>
           </p:cNvPr>
@@ -8892,7 +8892,7 @@
           <p:cNvPr id="20" name="">
             <a:extLst xmlns:a="http://schemas.openxmlformats.org/drawingml/2006/main">
               <a:ext uri="{FF2B5EF4-FFF2-40B4-BE49-F238E27FC236}">
-                <a16:creationId xmlns:a16="http://schemas.microsoft.com/office/drawing/2014/main" id="{8AFD75CD-F46E-4FC3-9FDA-C710708228CE}"/>
+                <a16:creationId xmlns:a16="http://schemas.microsoft.com/office/drawing/2014/main" id="{F3FBB813-C3CA-4703-9AA3-954CF3D0E630}"/>
               </a:ext>
             </a:extLst>
           </p:cNvPr>
@@ -8927,7 +8927,7 @@
           <p:cNvPr id="21" name="">
             <a:extLst xmlns:a="http://schemas.openxmlformats.org/drawingml/2006/main">
               <a:ext uri="{FF2B5EF4-FFF2-40B4-BE49-F238E27FC236}">
-                <a16:creationId xmlns:a16="http://schemas.microsoft.com/office/drawing/2014/main" id="{EB5A99A9-9124-4D91-908C-2593A41F62BF}"/>
+                <a16:creationId xmlns:a16="http://schemas.microsoft.com/office/drawing/2014/main" id="{D2DE82D0-5F54-4F12-A583-4C18EFE0ED11}"/>
               </a:ext>
             </a:extLst>
           </p:cNvPr>
@@ -8984,7 +8984,7 @@
           <p:cNvPr id="22" name="">
             <a:extLst xmlns:a="http://schemas.openxmlformats.org/drawingml/2006/main">
               <a:ext uri="{FF2B5EF4-FFF2-40B4-BE49-F238E27FC236}">
-                <a16:creationId xmlns:a16="http://schemas.microsoft.com/office/drawing/2014/main" id="{097B3A0C-7B05-4679-9412-892C86D5E6B1}"/>
+                <a16:creationId xmlns:a16="http://schemas.microsoft.com/office/drawing/2014/main" id="{126B9420-2999-40A4-9E4A-9EBBC0823D53}"/>
               </a:ext>
             </a:extLst>
           </p:cNvPr>
@@ -9041,7 +9041,7 @@
           <p:cNvPr id="23" name="">
             <a:extLst xmlns:a="http://schemas.openxmlformats.org/drawingml/2006/main">
               <a:ext uri="{FF2B5EF4-FFF2-40B4-BE49-F238E27FC236}">
-                <a16:creationId xmlns:a16="http://schemas.microsoft.com/office/drawing/2014/main" id="{F4DEE146-82BD-4027-8398-91E4E8257EA2}"/>
+                <a16:creationId xmlns:a16="http://schemas.microsoft.com/office/drawing/2014/main" id="{6B1A3E90-A481-4BB6-AF97-D99E7E756135}"/>
               </a:ext>
             </a:extLst>
           </p:cNvPr>
@@ -9076,7 +9076,7 @@
           <p:cNvPr id="24" name="">
             <a:extLst xmlns:a="http://schemas.openxmlformats.org/drawingml/2006/main">
               <a:ext uri="{FF2B5EF4-FFF2-40B4-BE49-F238E27FC236}">
-                <a16:creationId xmlns:a16="http://schemas.microsoft.com/office/drawing/2014/main" id="{54581F25-E189-4B17-8588-E502C3945BB7}"/>
+                <a16:creationId xmlns:a16="http://schemas.microsoft.com/office/drawing/2014/main" id="{CE6895B6-F7F3-4520-9C96-301AED347870}"/>
               </a:ext>
             </a:extLst>
           </p:cNvPr>
@@ -9140,7 +9140,7 @@
           <p:cNvPr id="25" name="">
             <a:extLst xmlns:a="http://schemas.openxmlformats.org/drawingml/2006/main">
               <a:ext uri="{FF2B5EF4-FFF2-40B4-BE49-F238E27FC236}">
-                <a16:creationId xmlns:a16="http://schemas.microsoft.com/office/drawing/2014/main" id="{0C3227FA-61B5-461F-82D9-9AE24B495BB7}"/>
+                <a16:creationId xmlns:a16="http://schemas.microsoft.com/office/drawing/2014/main" id="{20AD7814-DD54-4377-B028-FBDB2F2771CC}"/>
               </a:ext>
             </a:extLst>
           </p:cNvPr>
@@ -9266,7 +9266,7 @@
           <p:cNvPr id="26" name="">
             <a:extLst xmlns:a="http://schemas.openxmlformats.org/drawingml/2006/main">
               <a:ext uri="{FF2B5EF4-FFF2-40B4-BE49-F238E27FC236}">
-                <a16:creationId xmlns:a16="http://schemas.microsoft.com/office/drawing/2014/main" id="{6500BE82-ADB8-45F2-9216-93D025EFF740}"/>
+                <a16:creationId xmlns:a16="http://schemas.microsoft.com/office/drawing/2014/main" id="{014175E2-8D50-49F6-A8BA-AFD981DC2810}"/>
               </a:ext>
             </a:extLst>
           </p:cNvPr>
@@ -9301,7 +9301,7 @@
           <p:cNvPr id="27" name="">
             <a:extLst xmlns:a="http://schemas.openxmlformats.org/drawingml/2006/main">
               <a:ext uri="{FF2B5EF4-FFF2-40B4-BE49-F238E27FC236}">
-                <a16:creationId xmlns:a16="http://schemas.microsoft.com/office/drawing/2014/main" id="{4052A8CE-7B55-4A4C-BA69-B8DAF84B0E98}"/>
+                <a16:creationId xmlns:a16="http://schemas.microsoft.com/office/drawing/2014/main" id="{448FBD63-1A4A-4F80-AF45-5901A2FEF706}"/>
               </a:ext>
             </a:extLst>
           </p:cNvPr>
@@ -9365,7 +9365,7 @@
           <p:cNvPr id="28" name="">
             <a:extLst xmlns:a="http://schemas.openxmlformats.org/drawingml/2006/main">
               <a:ext uri="{FF2B5EF4-FFF2-40B4-BE49-F238E27FC236}">
-                <a16:creationId xmlns:a16="http://schemas.microsoft.com/office/drawing/2014/main" id="{89F5758B-8147-4705-88A2-D70E41BCCE76}"/>
+                <a16:creationId xmlns:a16="http://schemas.microsoft.com/office/drawing/2014/main" id="{54E9A6F8-C678-4727-B0D0-573E93051793}"/>
               </a:ext>
             </a:extLst>
           </p:cNvPr>
@@ -9468,7 +9468,7 @@
           <p:cNvPr id="29" name="">
             <a:extLst xmlns:a="http://schemas.openxmlformats.org/drawingml/2006/main">
               <a:ext uri="{FF2B5EF4-FFF2-40B4-BE49-F238E27FC236}">
-                <a16:creationId xmlns:a16="http://schemas.microsoft.com/office/drawing/2014/main" id="{45FDFC91-52B1-4998-9203-6677A7F07DB1}"/>
+                <a16:creationId xmlns:a16="http://schemas.microsoft.com/office/drawing/2014/main" id="{9DAE7460-35EE-497B-9250-FE742A12E536}"/>
               </a:ext>
             </a:extLst>
           </p:cNvPr>
@@ -9548,7 +9548,7 @@
           <p:cNvPr id="30" name="">
             <a:extLst xmlns:a="http://schemas.openxmlformats.org/drawingml/2006/main">
               <a:ext uri="{FF2B5EF4-FFF2-40B4-BE49-F238E27FC236}">
-                <a16:creationId xmlns:a16="http://schemas.microsoft.com/office/drawing/2014/main" id="{9AF184A3-E8CB-4E03-B489-716B8EAB1E69}"/>
+                <a16:creationId xmlns:a16="http://schemas.microsoft.com/office/drawing/2014/main" id="{2DD09E61-7B60-4BCC-A115-23EAF50CC86D}"/>
               </a:ext>
             </a:extLst>
           </p:cNvPr>
@@ -9595,7 +9595,7 @@
                 <a:ea typeface="Arial"/>
                 <a:cs typeface="Arial"/>
               </a:rPr>
-              <a:t>AURA • Track A • 29/09/2026</a:t>
+              <a:t>AURA • Track A • 30/09/2026</a:t>
             </a:r>
           </a:p>
         </p:txBody>
@@ -9605,7 +9605,7 @@
           <p:cNvPr id="31" name="">
             <a:extLst xmlns:a="http://schemas.openxmlformats.org/drawingml/2006/main">
               <a:ext uri="{FF2B5EF4-FFF2-40B4-BE49-F238E27FC236}">
-                <a16:creationId xmlns:a16="http://schemas.microsoft.com/office/drawing/2014/main" id="{5D4A919A-9CD0-47CC-B372-451FDCCFCB5A}"/>
+                <a16:creationId xmlns:a16="http://schemas.microsoft.com/office/drawing/2014/main" id="{22BE339F-F67B-43C2-87BA-DBF5E2AF05E2}"/>
               </a:ext>
             </a:extLst>
           </p:cNvPr>
@@ -9660,7 +9660,7 @@
     </p:spTree>
     <p:extLst>
       <p:ext uri="{BB962C8B-B14F-4D97-AF65-F5344CB8AC3E}">
-        <p14:creationId xmlns:p14="http://schemas.microsoft.com/office/powerpoint/2010/main" val="256710604"/>
+        <p14:creationId xmlns:p14="http://schemas.microsoft.com/office/powerpoint/2010/main" val="820372696"/>
       </p:ext>
     </p:extLst>
   </p:cSld>
@@ -9691,7 +9691,7 @@
           <p:cNvPr id="36" name="">
             <a:extLst xmlns:a="http://schemas.openxmlformats.org/drawingml/2006/main">
               <a:ext uri="{FF2B5EF4-FFF2-40B4-BE49-F238E27FC236}">
-                <a16:creationId xmlns:a16="http://schemas.microsoft.com/office/drawing/2014/main" id="{A16660F7-6B35-4B54-8E85-1650FA0E0DC2}"/>
+                <a16:creationId xmlns:a16="http://schemas.microsoft.com/office/drawing/2014/main" id="{2EF3EB0F-6976-4876-895E-DCC343AE3E8F}"/>
               </a:ext>
             </a:extLst>
           </p:cNvPr>
@@ -9748,7 +9748,7 @@
           <p:cNvPr id="2" name="">
             <a:extLst xmlns:a="http://schemas.openxmlformats.org/drawingml/2006/main">
               <a:ext uri="{FF2B5EF4-FFF2-40B4-BE49-F238E27FC236}">
-                <a16:creationId xmlns:a16="http://schemas.microsoft.com/office/drawing/2014/main" id="{B51DE4AB-F50F-4263-A5BF-7E2EBF5AB805}"/>
+                <a16:creationId xmlns:a16="http://schemas.microsoft.com/office/drawing/2014/main" id="{D9E8CB3A-9B8B-418F-9E59-11A5848572D4}"/>
               </a:ext>
             </a:extLst>
           </p:cNvPr>
@@ -9805,7 +9805,7 @@
           <p:cNvPr id="3" name="">
             <a:extLst xmlns:a="http://schemas.openxmlformats.org/drawingml/2006/main">
               <a:ext uri="{FF2B5EF4-FFF2-40B4-BE49-F238E27FC236}">
-                <a16:creationId xmlns:a16="http://schemas.microsoft.com/office/drawing/2014/main" id="{576A80D2-565A-473F-8B84-4D35C4E15EAE}"/>
+                <a16:creationId xmlns:a16="http://schemas.microsoft.com/office/drawing/2014/main" id="{6490C603-C39D-4EEC-B2D3-861F4197D0F3}"/>
               </a:ext>
             </a:extLst>
           </p:cNvPr>
@@ -9862,7 +9862,7 @@
           <p:cNvPr id="4" name="">
             <a:extLst xmlns:a="http://schemas.openxmlformats.org/drawingml/2006/main">
               <a:ext uri="{FF2B5EF4-FFF2-40B4-BE49-F238E27FC236}">
-                <a16:creationId xmlns:a16="http://schemas.microsoft.com/office/drawing/2014/main" id="{3760200E-956C-4A65-8026-AA43D8C08C4A}"/>
+                <a16:creationId xmlns:a16="http://schemas.microsoft.com/office/drawing/2014/main" id="{534C036C-640B-4350-ABC8-1F7543DCD76E}"/>
               </a:ext>
             </a:extLst>
           </p:cNvPr>
@@ -9893,7 +9893,7 @@
           <p:cNvPr id="5" name="">
             <a:extLst xmlns:a="http://schemas.openxmlformats.org/drawingml/2006/main">
               <a:ext uri="{FF2B5EF4-FFF2-40B4-BE49-F238E27FC236}">
-                <a16:creationId xmlns:a16="http://schemas.microsoft.com/office/drawing/2014/main" id="{7EFD42A3-2DAD-4852-B4B4-EF4551F96EB9}"/>
+                <a16:creationId xmlns:a16="http://schemas.microsoft.com/office/drawing/2014/main" id="{FB93B601-CEA0-4507-BF61-3E1C9CE7E1DB}"/>
               </a:ext>
             </a:extLst>
           </p:cNvPr>
@@ -9928,7 +9928,7 @@
           <p:cNvPr id="6" name="">
             <a:extLst xmlns:a="http://schemas.openxmlformats.org/drawingml/2006/main">
               <a:ext uri="{FF2B5EF4-FFF2-40B4-BE49-F238E27FC236}">
-                <a16:creationId xmlns:a16="http://schemas.microsoft.com/office/drawing/2014/main" id="{6390E90F-65F0-4FE7-AC47-64CD57EC2706}"/>
+                <a16:creationId xmlns:a16="http://schemas.microsoft.com/office/drawing/2014/main" id="{33369D57-5868-4339-B5D7-14A2AC12A1BE}"/>
               </a:ext>
             </a:extLst>
           </p:cNvPr>
@@ -9992,7 +9992,7 @@
           <p:cNvPr id="7" name="">
             <a:extLst xmlns:a="http://schemas.openxmlformats.org/drawingml/2006/main">
               <a:ext uri="{FF2B5EF4-FFF2-40B4-BE49-F238E27FC236}">
-                <a16:creationId xmlns:a16="http://schemas.microsoft.com/office/drawing/2014/main" id="{C49BAB55-DDDC-40B3-A340-D9478987D9E3}"/>
+                <a16:creationId xmlns:a16="http://schemas.microsoft.com/office/drawing/2014/main" id="{61029A50-7FEB-42F0-985D-CF2C33D6714C}"/>
               </a:ext>
             </a:extLst>
           </p:cNvPr>
@@ -10049,7 +10049,7 @@
           <p:cNvPr id="8" name="">
             <a:extLst xmlns:a="http://schemas.openxmlformats.org/drawingml/2006/main">
               <a:ext uri="{FF2B5EF4-FFF2-40B4-BE49-F238E27FC236}">
-                <a16:creationId xmlns:a16="http://schemas.microsoft.com/office/drawing/2014/main" id="{971BE1AE-F9A3-45FB-8DB9-6BF1D70C7258}"/>
+                <a16:creationId xmlns:a16="http://schemas.microsoft.com/office/drawing/2014/main" id="{BE3448DA-4B09-493E-AF31-31F394475F52}"/>
               </a:ext>
             </a:extLst>
           </p:cNvPr>
@@ -10084,7 +10084,7 @@
           <p:cNvPr id="9" name="">
             <a:extLst xmlns:a="http://schemas.openxmlformats.org/drawingml/2006/main">
               <a:ext uri="{FF2B5EF4-FFF2-40B4-BE49-F238E27FC236}">
-                <a16:creationId xmlns:a16="http://schemas.microsoft.com/office/drawing/2014/main" id="{AA76DA5F-4173-4BAD-BBBE-491D06203558}"/>
+                <a16:creationId xmlns:a16="http://schemas.microsoft.com/office/drawing/2014/main" id="{49190381-12D6-46EA-B0C9-C1AD55F2336C}"/>
               </a:ext>
             </a:extLst>
           </p:cNvPr>
@@ -10148,7 +10148,7 @@
           <p:cNvPr id="10" name="">
             <a:extLst xmlns:a="http://schemas.openxmlformats.org/drawingml/2006/main">
               <a:ext uri="{FF2B5EF4-FFF2-40B4-BE49-F238E27FC236}">
-                <a16:creationId xmlns:a16="http://schemas.microsoft.com/office/drawing/2014/main" id="{5FF8EC0D-8F1A-4032-AA1B-5EBAF3268AC6}"/>
+                <a16:creationId xmlns:a16="http://schemas.microsoft.com/office/drawing/2014/main" id="{2B159FBD-A456-4D04-970F-772D39DB691C}"/>
               </a:ext>
             </a:extLst>
           </p:cNvPr>
@@ -10205,7 +10205,7 @@
           <p:cNvPr id="11" name="">
             <a:extLst xmlns:a="http://schemas.openxmlformats.org/drawingml/2006/main">
               <a:ext uri="{FF2B5EF4-FFF2-40B4-BE49-F238E27FC236}">
-                <a16:creationId xmlns:a16="http://schemas.microsoft.com/office/drawing/2014/main" id="{FF402F3F-E8C0-4015-9CB6-112AAACAD414}"/>
+                <a16:creationId xmlns:a16="http://schemas.microsoft.com/office/drawing/2014/main" id="{F2163021-83C0-4C50-AD7B-F4EDFC2D72DD}"/>
               </a:ext>
             </a:extLst>
           </p:cNvPr>
@@ -10240,7 +10240,7 @@
           <p:cNvPr id="12" name="">
             <a:extLst xmlns:a="http://schemas.openxmlformats.org/drawingml/2006/main">
               <a:ext uri="{FF2B5EF4-FFF2-40B4-BE49-F238E27FC236}">
-                <a16:creationId xmlns:a16="http://schemas.microsoft.com/office/drawing/2014/main" id="{9FF10EF8-C01F-4DB2-855B-46CBB70F2E0F}"/>
+                <a16:creationId xmlns:a16="http://schemas.microsoft.com/office/drawing/2014/main" id="{DBEC324A-8DBF-4515-874E-0C6A0A085CBB}"/>
               </a:ext>
             </a:extLst>
           </p:cNvPr>
@@ -10304,7 +10304,7 @@
           <p:cNvPr id="13" name="">
             <a:extLst xmlns:a="http://schemas.openxmlformats.org/drawingml/2006/main">
               <a:ext uri="{FF2B5EF4-FFF2-40B4-BE49-F238E27FC236}">
-                <a16:creationId xmlns:a16="http://schemas.microsoft.com/office/drawing/2014/main" id="{EDBE5333-C63A-4B4C-8666-BB594203F6BD}"/>
+                <a16:creationId xmlns:a16="http://schemas.microsoft.com/office/drawing/2014/main" id="{94DE0B72-C843-49EB-905E-D16D50B9CB78}"/>
               </a:ext>
             </a:extLst>
           </p:cNvPr>
@@ -10361,7 +10361,7 @@
           <p:cNvPr id="14" name="">
             <a:extLst xmlns:a="http://schemas.openxmlformats.org/drawingml/2006/main">
               <a:ext uri="{FF2B5EF4-FFF2-40B4-BE49-F238E27FC236}">
-                <a16:creationId xmlns:a16="http://schemas.microsoft.com/office/drawing/2014/main" id="{CD5A9DA9-FBC4-4BAE-B2A6-E48B8DCD558B}"/>
+                <a16:creationId xmlns:a16="http://schemas.microsoft.com/office/drawing/2014/main" id="{73BFFBC4-F856-4424-B731-B7083CD145C1}"/>
               </a:ext>
             </a:extLst>
           </p:cNvPr>
@@ -10396,7 +10396,7 @@
           <p:cNvPr id="15" name="">
             <a:extLst xmlns:a="http://schemas.openxmlformats.org/drawingml/2006/main">
               <a:ext uri="{FF2B5EF4-FFF2-40B4-BE49-F238E27FC236}">
-                <a16:creationId xmlns:a16="http://schemas.microsoft.com/office/drawing/2014/main" id="{F65F1017-AEF8-4FF3-AC3E-A8D3B9BE9A4B}"/>
+                <a16:creationId xmlns:a16="http://schemas.microsoft.com/office/drawing/2014/main" id="{A05A5919-39FF-4CA5-816C-16C67349E113}"/>
               </a:ext>
             </a:extLst>
           </p:cNvPr>
@@ -10460,7 +10460,7 @@
           <p:cNvPr id="16" name="">
             <a:extLst xmlns:a="http://schemas.openxmlformats.org/drawingml/2006/main">
               <a:ext uri="{FF2B5EF4-FFF2-40B4-BE49-F238E27FC236}">
-                <a16:creationId xmlns:a16="http://schemas.microsoft.com/office/drawing/2014/main" id="{9BB7DF9A-C022-4D2F-8A3C-7A68E2F0D510}"/>
+                <a16:creationId xmlns:a16="http://schemas.microsoft.com/office/drawing/2014/main" id="{13437057-F959-4FB8-8919-F7BE1F7AF80C}"/>
               </a:ext>
             </a:extLst>
           </p:cNvPr>
@@ -10517,7 +10517,7 @@
           <p:cNvPr id="17" name="">
             <a:extLst xmlns:a="http://schemas.openxmlformats.org/drawingml/2006/main">
               <a:ext uri="{FF2B5EF4-FFF2-40B4-BE49-F238E27FC236}">
-                <a16:creationId xmlns:a16="http://schemas.microsoft.com/office/drawing/2014/main" id="{3110C781-4201-4081-8F4A-8E0662B9C1F7}"/>
+                <a16:creationId xmlns:a16="http://schemas.microsoft.com/office/drawing/2014/main" id="{7E688343-32EE-4672-A522-A0465790A096}"/>
               </a:ext>
             </a:extLst>
           </p:cNvPr>
@@ -10552,7 +10552,7 @@
           <p:cNvPr id="18" name="">
             <a:extLst xmlns:a="http://schemas.openxmlformats.org/drawingml/2006/main">
               <a:ext uri="{FF2B5EF4-FFF2-40B4-BE49-F238E27FC236}">
-                <a16:creationId xmlns:a16="http://schemas.microsoft.com/office/drawing/2014/main" id="{B94A8D97-B80C-4B75-8C14-B2B75C1584CC}"/>
+                <a16:creationId xmlns:a16="http://schemas.microsoft.com/office/drawing/2014/main" id="{C5CB8449-9E81-424E-ABC9-ECE67774BB5E}"/>
               </a:ext>
             </a:extLst>
           </p:cNvPr>
@@ -10616,7 +10616,7 @@
           <p:cNvPr id="19" name="">
             <a:extLst xmlns:a="http://schemas.openxmlformats.org/drawingml/2006/main">
               <a:ext uri="{FF2B5EF4-FFF2-40B4-BE49-F238E27FC236}">
-                <a16:creationId xmlns:a16="http://schemas.microsoft.com/office/drawing/2014/main" id="{C4612155-6BB9-4BA4-9392-A31F56F2BC41}"/>
+                <a16:creationId xmlns:a16="http://schemas.microsoft.com/office/drawing/2014/main" id="{A3258AA8-AF5D-4884-A8B0-B3C031AA9440}"/>
               </a:ext>
             </a:extLst>
           </p:cNvPr>
@@ -10673,7 +10673,7 @@
           <p:cNvPr id="20" name="">
             <a:extLst xmlns:a="http://schemas.openxmlformats.org/drawingml/2006/main">
               <a:ext uri="{FF2B5EF4-FFF2-40B4-BE49-F238E27FC236}">
-                <a16:creationId xmlns:a16="http://schemas.microsoft.com/office/drawing/2014/main" id="{063BC6BA-2D26-47FE-B6CF-778123DAF5D3}"/>
+                <a16:creationId xmlns:a16="http://schemas.microsoft.com/office/drawing/2014/main" id="{5CD079F9-CDBA-4643-BCBC-B76DEBD68938}"/>
               </a:ext>
             </a:extLst>
           </p:cNvPr>
@@ -10708,7 +10708,7 @@
           <p:cNvPr id="21" name="">
             <a:extLst xmlns:a="http://schemas.openxmlformats.org/drawingml/2006/main">
               <a:ext uri="{FF2B5EF4-FFF2-40B4-BE49-F238E27FC236}">
-                <a16:creationId xmlns:a16="http://schemas.microsoft.com/office/drawing/2014/main" id="{2DD09EC1-2B82-4265-9B64-CC1D62B3F581}"/>
+                <a16:creationId xmlns:a16="http://schemas.microsoft.com/office/drawing/2014/main" id="{F95C329A-B51E-4134-B208-72B4E7C18463}"/>
               </a:ext>
             </a:extLst>
           </p:cNvPr>
@@ -10765,7 +10765,7 @@
           <p:cNvPr id="22" name="">
             <a:extLst xmlns:a="http://schemas.openxmlformats.org/drawingml/2006/main">
               <a:ext uri="{FF2B5EF4-FFF2-40B4-BE49-F238E27FC236}">
-                <a16:creationId xmlns:a16="http://schemas.microsoft.com/office/drawing/2014/main" id="{9EC00940-8144-4DBD-BE2F-F2876EA4FA13}"/>
+                <a16:creationId xmlns:a16="http://schemas.microsoft.com/office/drawing/2014/main" id="{B4C9EAFC-D275-44DE-8A61-EC2CA1898EA4}"/>
               </a:ext>
             </a:extLst>
           </p:cNvPr>
@@ -10829,7 +10829,7 @@
           <p:cNvPr id="23" name="">
             <a:extLst xmlns:a="http://schemas.openxmlformats.org/drawingml/2006/main">
               <a:ext uri="{FF2B5EF4-FFF2-40B4-BE49-F238E27FC236}">
-                <a16:creationId xmlns:a16="http://schemas.microsoft.com/office/drawing/2014/main" id="{E4263592-ADBB-47B0-B960-BDA2900952E7}"/>
+                <a16:creationId xmlns:a16="http://schemas.microsoft.com/office/drawing/2014/main" id="{ADD3C5C7-C570-4231-8C95-F3FCC1D776F0}"/>
               </a:ext>
             </a:extLst>
           </p:cNvPr>
@@ -10886,7 +10886,7 @@
           <p:cNvPr id="24" name="">
             <a:extLst xmlns:a="http://schemas.openxmlformats.org/drawingml/2006/main">
               <a:ext uri="{FF2B5EF4-FFF2-40B4-BE49-F238E27FC236}">
-                <a16:creationId xmlns:a16="http://schemas.microsoft.com/office/drawing/2014/main" id="{3E3E10A3-F978-4168-B8E4-CAB1EC173477}"/>
+                <a16:creationId xmlns:a16="http://schemas.microsoft.com/office/drawing/2014/main" id="{D82C931C-D071-49F6-8CD4-BDA4E8FC1F5A}"/>
               </a:ext>
             </a:extLst>
           </p:cNvPr>
@@ -10950,7 +10950,7 @@
           <p:cNvPr id="25" name="">
             <a:extLst xmlns:a="http://schemas.openxmlformats.org/drawingml/2006/main">
               <a:ext uri="{FF2B5EF4-FFF2-40B4-BE49-F238E27FC236}">
-                <a16:creationId xmlns:a16="http://schemas.microsoft.com/office/drawing/2014/main" id="{61C89442-DF5A-4FD4-A477-EC749C64EDED}"/>
+                <a16:creationId xmlns:a16="http://schemas.microsoft.com/office/drawing/2014/main" id="{41BCC27B-C130-4662-8F50-F13F6261F544}"/>
               </a:ext>
             </a:extLst>
           </p:cNvPr>
@@ -10997,7 +10997,7 @@
                 <a:ea typeface="Arial"/>
                 <a:cs typeface="Arial"/>
               </a:rPr>
-              <a:t>88 test • dependency sạch</a:t>
+              <a:t>93 test • dependency sạch</a:t>
             </a:r>
           </a:p>
         </p:txBody>
@@ -11007,7 +11007,7 @@
           <p:cNvPr id="26" name="">
             <a:extLst xmlns:a="http://schemas.openxmlformats.org/drawingml/2006/main">
               <a:ext uri="{FF2B5EF4-FFF2-40B4-BE49-F238E27FC236}">
-                <a16:creationId xmlns:a16="http://schemas.microsoft.com/office/drawing/2014/main" id="{17E96996-977A-4D9F-AABB-F8C463DCCF2E}"/>
+                <a16:creationId xmlns:a16="http://schemas.microsoft.com/office/drawing/2014/main" id="{B325E3E8-BBE7-47EF-9524-BB4307D93808}"/>
               </a:ext>
             </a:extLst>
           </p:cNvPr>
@@ -11071,7 +11071,7 @@
           <p:cNvPr id="27" name="">
             <a:extLst xmlns:a="http://schemas.openxmlformats.org/drawingml/2006/main">
               <a:ext uri="{FF2B5EF4-FFF2-40B4-BE49-F238E27FC236}">
-                <a16:creationId xmlns:a16="http://schemas.microsoft.com/office/drawing/2014/main" id="{1FA98ECF-16D4-4814-BEFE-D219AB884394}"/>
+                <a16:creationId xmlns:a16="http://schemas.microsoft.com/office/drawing/2014/main" id="{5C954D00-BEBF-4B43-ACD1-79742A736955}"/>
               </a:ext>
             </a:extLst>
           </p:cNvPr>
@@ -11128,7 +11128,7 @@
           <p:cNvPr id="28" name="">
             <a:extLst xmlns:a="http://schemas.openxmlformats.org/drawingml/2006/main">
               <a:ext uri="{FF2B5EF4-FFF2-40B4-BE49-F238E27FC236}">
-                <a16:creationId xmlns:a16="http://schemas.microsoft.com/office/drawing/2014/main" id="{60025AA3-2C9F-4266-9780-5054685676F7}"/>
+                <a16:creationId xmlns:a16="http://schemas.microsoft.com/office/drawing/2014/main" id="{60BFC383-1A44-4123-B0F4-637DA9DA24E0}"/>
               </a:ext>
             </a:extLst>
           </p:cNvPr>
@@ -11192,7 +11192,7 @@
           <p:cNvPr id="29" name="">
             <a:extLst xmlns:a="http://schemas.openxmlformats.org/drawingml/2006/main">
               <a:ext uri="{FF2B5EF4-FFF2-40B4-BE49-F238E27FC236}">
-                <a16:creationId xmlns:a16="http://schemas.microsoft.com/office/drawing/2014/main" id="{60E40681-1D09-4C36-99DC-943D0C9E7960}"/>
+                <a16:creationId xmlns:a16="http://schemas.microsoft.com/office/drawing/2014/main" id="{0C53AEAB-0DE8-46A5-9478-1ED1B062188A}"/>
               </a:ext>
             </a:extLst>
           </p:cNvPr>
@@ -11249,7 +11249,7 @@
           <p:cNvPr id="30" name="">
             <a:extLst xmlns:a="http://schemas.openxmlformats.org/drawingml/2006/main">
               <a:ext uri="{FF2B5EF4-FFF2-40B4-BE49-F238E27FC236}">
-                <a16:creationId xmlns:a16="http://schemas.microsoft.com/office/drawing/2014/main" id="{120659C5-313F-4279-B596-4D52BB5BCA8B}"/>
+                <a16:creationId xmlns:a16="http://schemas.microsoft.com/office/drawing/2014/main" id="{515C49AA-45E6-46B7-A027-9F4D6965D199}"/>
               </a:ext>
             </a:extLst>
           </p:cNvPr>
@@ -11284,7 +11284,7 @@
           <p:cNvPr id="31" name="">
             <a:extLst xmlns:a="http://schemas.openxmlformats.org/drawingml/2006/main">
               <a:ext uri="{FF2B5EF4-FFF2-40B4-BE49-F238E27FC236}">
-                <a16:creationId xmlns:a16="http://schemas.microsoft.com/office/drawing/2014/main" id="{5C99FB65-877E-4CA3-8C54-0D404849106A}"/>
+                <a16:creationId xmlns:a16="http://schemas.microsoft.com/office/drawing/2014/main" id="{8EBF99B3-B6D1-4E55-8C8A-A56E030FAC2B}"/>
               </a:ext>
             </a:extLst>
           </p:cNvPr>
@@ -11341,7 +11341,7 @@
           <p:cNvPr id="32" name="">
             <a:extLst xmlns:a="http://schemas.openxmlformats.org/drawingml/2006/main">
               <a:ext uri="{FF2B5EF4-FFF2-40B4-BE49-F238E27FC236}">
-                <a16:creationId xmlns:a16="http://schemas.microsoft.com/office/drawing/2014/main" id="{193D3B54-4658-409A-9182-6AD57E038F3D}"/>
+                <a16:creationId xmlns:a16="http://schemas.microsoft.com/office/drawing/2014/main" id="{435F9BA0-BD67-4280-819A-7CBD906BDABC}"/>
               </a:ext>
             </a:extLst>
           </p:cNvPr>
@@ -11444,7 +11444,7 @@
           <p:cNvPr id="33" name="">
             <a:extLst xmlns:a="http://schemas.openxmlformats.org/drawingml/2006/main">
               <a:ext uri="{FF2B5EF4-FFF2-40B4-BE49-F238E27FC236}">
-                <a16:creationId xmlns:a16="http://schemas.microsoft.com/office/drawing/2014/main" id="{0193C20A-32F5-4936-B437-52EB319F9645}"/>
+                <a16:creationId xmlns:a16="http://schemas.microsoft.com/office/drawing/2014/main" id="{CBFDBA68-7549-4825-B2EC-0DA469E7791A}"/>
               </a:ext>
             </a:extLst>
           </p:cNvPr>
@@ -11501,7 +11501,7 @@
           <p:cNvPr id="34" name="">
             <a:extLst xmlns:a="http://schemas.openxmlformats.org/drawingml/2006/main">
               <a:ext uri="{FF2B5EF4-FFF2-40B4-BE49-F238E27FC236}">
-                <a16:creationId xmlns:a16="http://schemas.microsoft.com/office/drawing/2014/main" id="{3FD7592A-42FA-4D7B-BF07-EFA59E86AF11}"/>
+                <a16:creationId xmlns:a16="http://schemas.microsoft.com/office/drawing/2014/main" id="{EA4008D2-75CB-493A-A687-2DC308479C86}"/>
               </a:ext>
             </a:extLst>
           </p:cNvPr>
@@ -11558,7 +11558,7 @@
           <p:cNvPr id="35" name="">
             <a:extLst xmlns:a="http://schemas.openxmlformats.org/drawingml/2006/main">
               <a:ext uri="{FF2B5EF4-FFF2-40B4-BE49-F238E27FC236}">
-                <a16:creationId xmlns:a16="http://schemas.microsoft.com/office/drawing/2014/main" id="{D08F0D8F-48B5-4C9E-BA26-20938CBE8BEA}"/>
+                <a16:creationId xmlns:a16="http://schemas.microsoft.com/office/drawing/2014/main" id="{85F45F09-7541-41F1-870B-685A99DF6948}"/>
               </a:ext>
             </a:extLst>
           </p:cNvPr>
@@ -11613,7 +11613,7 @@
     </p:spTree>
     <p:extLst>
       <p:ext uri="{BB962C8B-B14F-4D97-AF65-F5344CB8AC3E}">
-        <p14:creationId xmlns:p14="http://schemas.microsoft.com/office/powerpoint/2010/main" val="742594878"/>
+        <p14:creationId xmlns:p14="http://schemas.microsoft.com/office/powerpoint/2010/main" val="855391597"/>
       </p:ext>
     </p:extLst>
   </p:cSld>

</xml_diff>

<commit_message>
feat: reconcile receipt discounts with final payable amount
</commit_message>
<xml_diff>
--- a/AURA/submission/AURA_5_SLIDES.pptx
+++ b/AURA/submission/AURA_5_SLIDES.pptx
@@ -2,17 +2,17 @@
 <file path=ppt/presentation.xml><?xml version="1.0" encoding="utf-8"?>
 <p:presentation xmlns:p="http://schemas.openxmlformats.org/presentationml/2006/main">
   <p:sldMasterIdLst>
-    <p:sldMasterId xmlns:r="http://schemas.openxmlformats.org/officeDocument/2006/relationships" id="2147483648" r:id="R464bb367d2554eda"/>
+    <p:sldMasterId xmlns:r="http://schemas.openxmlformats.org/officeDocument/2006/relationships" id="2147483648" r:id="R4f1fe2e40c0847ef"/>
   </p:sldMasterIdLst>
   <p:notesMasterIdLst>
-    <p:notesMasterId xmlns:r="http://schemas.openxmlformats.org/officeDocument/2006/relationships" r:id="R4900fff3c0e74b80"/>
+    <p:notesMasterId xmlns:r="http://schemas.openxmlformats.org/officeDocument/2006/relationships" r:id="Rc72c11c93d064475"/>
   </p:notesMasterIdLst>
   <p:sldIdLst>
-    <p:sldId xmlns:r="http://schemas.openxmlformats.org/officeDocument/2006/relationships" id="256" r:id="Rae91ebc4f2d94a8f"/>
-    <p:sldId xmlns:r="http://schemas.openxmlformats.org/officeDocument/2006/relationships" id="257" r:id="Rf45f4e4efcd64bee"/>
-    <p:sldId xmlns:r="http://schemas.openxmlformats.org/officeDocument/2006/relationships" id="258" r:id="R6bc86ff904334479"/>
-    <p:sldId xmlns:r="http://schemas.openxmlformats.org/officeDocument/2006/relationships" id="259" r:id="R3d875320c4cc4580"/>
-    <p:sldId xmlns:r="http://schemas.openxmlformats.org/officeDocument/2006/relationships" id="260" r:id="R5ede8306f23b40bb"/>
+    <p:sldId xmlns:r="http://schemas.openxmlformats.org/officeDocument/2006/relationships" id="256" r:id="R629f528ee38844bf"/>
+    <p:sldId xmlns:r="http://schemas.openxmlformats.org/officeDocument/2006/relationships" id="257" r:id="R521a83534e624cfa"/>
+    <p:sldId xmlns:r="http://schemas.openxmlformats.org/officeDocument/2006/relationships" id="258" r:id="R7e776233fdaa4db8"/>
+    <p:sldId xmlns:r="http://schemas.openxmlformats.org/officeDocument/2006/relationships" id="259" r:id="R93b5a74b349c4ee0"/>
+    <p:sldId xmlns:r="http://schemas.openxmlformats.org/officeDocument/2006/relationships" id="260" r:id="Rb182db39ee1244ec"/>
   </p:sldIdLst>
   <p:sldSz cx="12192000" cy="6858000"/>
   <p:notesSz cx="6858000" cy="9144000"/>
@@ -586,7 +586,7 @@
           <a:lstStyle xmlns:a="http://schemas.openxmlformats.org/drawingml/2006/main"/>
           <a:p xmlns:a="http://schemas.openxmlformats.org/drawingml/2006/main">
             <a:r>
-              <a:t>Nguồn nội bộ cập nhật ngày 30/09/2026: 93 test offline. Trên cùng judge set 15 ca và fallback tắt, OpenRouter 8B đạt 15/15 quyết định, 70/75 field, P95 16,459 giây; Ollama 4B đạt 14/15, 73/75 field, P95 58,318 giây và bỏ sót escalation TK-12. Contract mới tách invoiceNumber, receiptNumber và transactionReference; cần benchmark live lại sau thay đổi schema. Đây là regression trên dữ liệu tổng hợp, không phải accuracy thực tế.</a:t>
+              <a:t>Nguồn nội bộ cập nhật ngày 01/10/2026: 100 test offline. Trên cùng judge set 15 ca và fallback tắt, OpenRouter 8B đạt 15/15 quyết định, 70/75 field, P95 16,459 giây; Ollama 4B đạt 14/15, 73/75 field, P95 58,318 giây và bỏ sót escalation TK-12. Contract hiện tách ba loại identifier, canonical date và discountAmount; kết quả live sau schema giảm giá phải được ghi riêng. Đây là regression trên dữ liệu tổng hợp, không phải accuracy thực tế.</a:t>
             </a:r>
           </a:p>
         </p:txBody>
@@ -794,7 +794,7 @@
   </p:cSld>
   <p:clrMap bg1="lt1" tx1="dk1" bg2="lt2" tx2="dk2" accent1="accent1" accent2="accent2" accent3="accent3" accent4="accent4" accent5="accent5" accent6="accent6" hlink="hlink" folHlink="folHlink"/>
   <p:sldLayoutIdLst>
-    <p:sldLayoutId xmlns:r="http://schemas.openxmlformats.org/officeDocument/2006/relationships" id="2147483649" r:id="Rec53c80f347744bd"/>
+    <p:sldLayoutId xmlns:r="http://schemas.openxmlformats.org/officeDocument/2006/relationships" id="2147483649" r:id="Rd2556133d6d94bac"/>
   </p:sldLayoutIdLst>
   <p:txStyles>
     <p:titleStyle>
@@ -1345,7 +1345,7 @@
           <p:cNvPr id="47" name="">
             <a:extLst xmlns:a="http://schemas.openxmlformats.org/drawingml/2006/main">
               <a:ext uri="{FF2B5EF4-FFF2-40B4-BE49-F238E27FC236}">
-                <a16:creationId xmlns:a16="http://schemas.microsoft.com/office/drawing/2014/main" id="{85913668-1E7F-4A81-AA65-53BBD2626B63}"/>
+                <a16:creationId xmlns:a16="http://schemas.microsoft.com/office/drawing/2014/main" id="{D244D851-CF51-452E-8504-7FAF7BE2CCED}"/>
               </a:ext>
             </a:extLst>
           </p:cNvPr>
@@ -1402,7 +1402,7 @@
           <p:cNvPr id="2" name="">
             <a:extLst xmlns:a="http://schemas.openxmlformats.org/drawingml/2006/main">
               <a:ext uri="{FF2B5EF4-FFF2-40B4-BE49-F238E27FC236}">
-                <a16:creationId xmlns:a16="http://schemas.microsoft.com/office/drawing/2014/main" id="{922D6BC3-275D-47C7-AB4D-7026F2D709F1}"/>
+                <a16:creationId xmlns:a16="http://schemas.microsoft.com/office/drawing/2014/main" id="{F600F44B-5A78-4014-8A5C-E206CE5E6155}"/>
               </a:ext>
             </a:extLst>
           </p:cNvPr>
@@ -1459,7 +1459,7 @@
           <p:cNvPr id="3" name="">
             <a:extLst xmlns:a="http://schemas.openxmlformats.org/drawingml/2006/main">
               <a:ext uri="{FF2B5EF4-FFF2-40B4-BE49-F238E27FC236}">
-                <a16:creationId xmlns:a16="http://schemas.microsoft.com/office/drawing/2014/main" id="{962D11CA-12CF-4D22-94B3-C12FE70ACAFC}"/>
+                <a16:creationId xmlns:a16="http://schemas.microsoft.com/office/drawing/2014/main" id="{30A3AB8E-C3AC-4435-AC39-743760A254D0}"/>
               </a:ext>
             </a:extLst>
           </p:cNvPr>
@@ -1516,7 +1516,7 @@
           <p:cNvPr id="4" name="">
             <a:extLst xmlns:a="http://schemas.openxmlformats.org/drawingml/2006/main">
               <a:ext uri="{FF2B5EF4-FFF2-40B4-BE49-F238E27FC236}">
-                <a16:creationId xmlns:a16="http://schemas.microsoft.com/office/drawing/2014/main" id="{CE57666E-846E-4AD2-BDD4-779AC891F0E2}"/>
+                <a16:creationId xmlns:a16="http://schemas.microsoft.com/office/drawing/2014/main" id="{82063A62-D48F-4A09-91C7-6FB55D82D54D}"/>
               </a:ext>
             </a:extLst>
           </p:cNvPr>
@@ -1547,7 +1547,7 @@
           <p:cNvPr id="5" name="">
             <a:extLst xmlns:a="http://schemas.openxmlformats.org/drawingml/2006/main">
               <a:ext uri="{FF2B5EF4-FFF2-40B4-BE49-F238E27FC236}">
-                <a16:creationId xmlns:a16="http://schemas.microsoft.com/office/drawing/2014/main" id="{1D7A40C7-B3D5-42D2-8041-FD2E1951F109}"/>
+                <a16:creationId xmlns:a16="http://schemas.microsoft.com/office/drawing/2014/main" id="{EC186BC1-1AA2-4784-A882-91D5F4D2C154}"/>
               </a:ext>
             </a:extLst>
           </p:cNvPr>
@@ -1582,7 +1582,7 @@
           <p:cNvPr id="6" name="">
             <a:extLst xmlns:a="http://schemas.openxmlformats.org/drawingml/2006/main">
               <a:ext uri="{FF2B5EF4-FFF2-40B4-BE49-F238E27FC236}">
-                <a16:creationId xmlns:a16="http://schemas.microsoft.com/office/drawing/2014/main" id="{7D9FA6EC-31A9-4E07-A87C-A1D29B0AADBF}"/>
+                <a16:creationId xmlns:a16="http://schemas.microsoft.com/office/drawing/2014/main" id="{8FCBD2A9-7240-4CE0-834A-6B43C1F6A575}"/>
               </a:ext>
             </a:extLst>
           </p:cNvPr>
@@ -1646,7 +1646,7 @@
           <p:cNvPr id="7" name="">
             <a:extLst xmlns:a="http://schemas.openxmlformats.org/drawingml/2006/main">
               <a:ext uri="{FF2B5EF4-FFF2-40B4-BE49-F238E27FC236}">
-                <a16:creationId xmlns:a16="http://schemas.microsoft.com/office/drawing/2014/main" id="{C6790FE4-44C6-4060-96E4-5418175D541B}"/>
+                <a16:creationId xmlns:a16="http://schemas.microsoft.com/office/drawing/2014/main" id="{5DAD04E0-2C99-46EE-96B8-19EEF9BEAEF7}"/>
               </a:ext>
             </a:extLst>
           </p:cNvPr>
@@ -1703,7 +1703,7 @@
           <p:cNvPr id="8" name="">
             <a:extLst xmlns:a="http://schemas.openxmlformats.org/drawingml/2006/main">
               <a:ext uri="{FF2B5EF4-FFF2-40B4-BE49-F238E27FC236}">
-                <a16:creationId xmlns:a16="http://schemas.microsoft.com/office/drawing/2014/main" id="{CB739D44-33EB-4573-A194-A95CCFA6CAC4}"/>
+                <a16:creationId xmlns:a16="http://schemas.microsoft.com/office/drawing/2014/main" id="{BDFEA2E7-9C9A-4D96-B5AF-32735ADBA08B}"/>
               </a:ext>
             </a:extLst>
           </p:cNvPr>
@@ -1760,7 +1760,7 @@
           <p:cNvPr id="9" name="">
             <a:extLst xmlns:a="http://schemas.openxmlformats.org/drawingml/2006/main">
               <a:ext uri="{FF2B5EF4-FFF2-40B4-BE49-F238E27FC236}">
-                <a16:creationId xmlns:a16="http://schemas.microsoft.com/office/drawing/2014/main" id="{F801387C-B89D-4F6E-A4F9-C4C5EB586A81}"/>
+                <a16:creationId xmlns:a16="http://schemas.microsoft.com/office/drawing/2014/main" id="{FF31B1C4-2365-43EC-9BCC-BF38F7181780}"/>
               </a:ext>
             </a:extLst>
           </p:cNvPr>
@@ -1792,7 +1792,7 @@
           <p:cNvPr id="10" name="">
             <a:extLst xmlns:a="http://schemas.openxmlformats.org/drawingml/2006/main">
               <a:ext uri="{FF2B5EF4-FFF2-40B4-BE49-F238E27FC236}">
-                <a16:creationId xmlns:a16="http://schemas.microsoft.com/office/drawing/2014/main" id="{1D665C42-A7D6-4227-B83E-4D56BD996DAE}"/>
+                <a16:creationId xmlns:a16="http://schemas.microsoft.com/office/drawing/2014/main" id="{B4C80FC5-A6A3-4CFD-B819-DBF3A53BF099}"/>
               </a:ext>
             </a:extLst>
           </p:cNvPr>
@@ -1827,7 +1827,7 @@
           <p:cNvPr id="11" name="">
             <a:extLst xmlns:a="http://schemas.openxmlformats.org/drawingml/2006/main">
               <a:ext uri="{FF2B5EF4-FFF2-40B4-BE49-F238E27FC236}">
-                <a16:creationId xmlns:a16="http://schemas.microsoft.com/office/drawing/2014/main" id="{3B3728D4-EF1D-4BE5-B34F-7479529A0E3B}"/>
+                <a16:creationId xmlns:a16="http://schemas.microsoft.com/office/drawing/2014/main" id="{5F67399C-DBB6-4EEA-B010-CB0A72CC2C63}"/>
               </a:ext>
             </a:extLst>
           </p:cNvPr>
@@ -1891,7 +1891,7 @@
           <p:cNvPr id="12" name="">
             <a:extLst xmlns:a="http://schemas.openxmlformats.org/drawingml/2006/main">
               <a:ext uri="{FF2B5EF4-FFF2-40B4-BE49-F238E27FC236}">
-                <a16:creationId xmlns:a16="http://schemas.microsoft.com/office/drawing/2014/main" id="{8D674B7A-7776-4C77-B6D9-E5FB72AB129C}"/>
+                <a16:creationId xmlns:a16="http://schemas.microsoft.com/office/drawing/2014/main" id="{9DDE71FC-FBCB-484F-9367-B4B5C3261A66}"/>
               </a:ext>
             </a:extLst>
           </p:cNvPr>
@@ -1948,7 +1948,7 @@
           <p:cNvPr id="13" name="">
             <a:extLst xmlns:a="http://schemas.openxmlformats.org/drawingml/2006/main">
               <a:ext uri="{FF2B5EF4-FFF2-40B4-BE49-F238E27FC236}">
-                <a16:creationId xmlns:a16="http://schemas.microsoft.com/office/drawing/2014/main" id="{5AE2964A-C218-4D41-BF26-B9A13DDE2997}"/>
+                <a16:creationId xmlns:a16="http://schemas.microsoft.com/office/drawing/2014/main" id="{B2062304-71CA-4BEE-B6ED-D22A03C3F422}"/>
               </a:ext>
             </a:extLst>
           </p:cNvPr>
@@ -2005,7 +2005,7 @@
           <p:cNvPr id="14" name="">
             <a:extLst xmlns:a="http://schemas.openxmlformats.org/drawingml/2006/main">
               <a:ext uri="{FF2B5EF4-FFF2-40B4-BE49-F238E27FC236}">
-                <a16:creationId xmlns:a16="http://schemas.microsoft.com/office/drawing/2014/main" id="{BC1E4B1A-6D61-43DA-9E0A-544114E68AD9}"/>
+                <a16:creationId xmlns:a16="http://schemas.microsoft.com/office/drawing/2014/main" id="{1487B93F-2F8F-4EFC-BAB2-21D984584C2B}"/>
               </a:ext>
             </a:extLst>
           </p:cNvPr>
@@ -2037,7 +2037,7 @@
           <p:cNvPr id="15" name="">
             <a:extLst xmlns:a="http://schemas.openxmlformats.org/drawingml/2006/main">
               <a:ext uri="{FF2B5EF4-FFF2-40B4-BE49-F238E27FC236}">
-                <a16:creationId xmlns:a16="http://schemas.microsoft.com/office/drawing/2014/main" id="{13570192-8289-4E8D-BA5F-E7A57AC77241}"/>
+                <a16:creationId xmlns:a16="http://schemas.microsoft.com/office/drawing/2014/main" id="{A911FCC4-95B5-482B-B379-5A8D6139A16F}"/>
               </a:ext>
             </a:extLst>
           </p:cNvPr>
@@ -2072,7 +2072,7 @@
           <p:cNvPr id="16" name="">
             <a:extLst xmlns:a="http://schemas.openxmlformats.org/drawingml/2006/main">
               <a:ext uri="{FF2B5EF4-FFF2-40B4-BE49-F238E27FC236}">
-                <a16:creationId xmlns:a16="http://schemas.microsoft.com/office/drawing/2014/main" id="{182649F2-3A06-4325-99D8-0C9573B0F225}"/>
+                <a16:creationId xmlns:a16="http://schemas.microsoft.com/office/drawing/2014/main" id="{E8C138AF-1E03-44BA-853D-1228349DDAB6}"/>
               </a:ext>
             </a:extLst>
           </p:cNvPr>
@@ -2136,7 +2136,7 @@
           <p:cNvPr id="17" name="">
             <a:extLst xmlns:a="http://schemas.openxmlformats.org/drawingml/2006/main">
               <a:ext uri="{FF2B5EF4-FFF2-40B4-BE49-F238E27FC236}">
-                <a16:creationId xmlns:a16="http://schemas.microsoft.com/office/drawing/2014/main" id="{4925D1E8-7572-45E4-AC1A-6CBF953C5D93}"/>
+                <a16:creationId xmlns:a16="http://schemas.microsoft.com/office/drawing/2014/main" id="{29268C51-5783-4E9A-9B3A-84FF676C8902}"/>
               </a:ext>
             </a:extLst>
           </p:cNvPr>
@@ -2193,7 +2193,7 @@
           <p:cNvPr id="18" name="">
             <a:extLst xmlns:a="http://schemas.openxmlformats.org/drawingml/2006/main">
               <a:ext uri="{FF2B5EF4-FFF2-40B4-BE49-F238E27FC236}">
-                <a16:creationId xmlns:a16="http://schemas.microsoft.com/office/drawing/2014/main" id="{41C89BB0-BC30-4A86-9199-BA17A955CA64}"/>
+                <a16:creationId xmlns:a16="http://schemas.microsoft.com/office/drawing/2014/main" id="{0DE81398-F340-4D3A-B64E-246343D6DA6E}"/>
               </a:ext>
             </a:extLst>
           </p:cNvPr>
@@ -2250,7 +2250,7 @@
           <p:cNvPr id="19" name="">
             <a:extLst xmlns:a="http://schemas.openxmlformats.org/drawingml/2006/main">
               <a:ext uri="{FF2B5EF4-FFF2-40B4-BE49-F238E27FC236}">
-                <a16:creationId xmlns:a16="http://schemas.microsoft.com/office/drawing/2014/main" id="{701AAF40-62FB-428F-A568-876DA7FF58E1}"/>
+                <a16:creationId xmlns:a16="http://schemas.microsoft.com/office/drawing/2014/main" id="{5361F7DA-F69E-452E-B9A2-AB9B991285F1}"/>
               </a:ext>
             </a:extLst>
           </p:cNvPr>
@@ -2282,7 +2282,7 @@
           <p:cNvPr id="20" name="">
             <a:extLst xmlns:a="http://schemas.openxmlformats.org/drawingml/2006/main">
               <a:ext uri="{FF2B5EF4-FFF2-40B4-BE49-F238E27FC236}">
-                <a16:creationId xmlns:a16="http://schemas.microsoft.com/office/drawing/2014/main" id="{65B775CB-69B8-441F-93D1-5D37AFACE47E}"/>
+                <a16:creationId xmlns:a16="http://schemas.microsoft.com/office/drawing/2014/main" id="{8A2277C2-81BD-46C8-89BF-C0F4BA475CAE}"/>
               </a:ext>
             </a:extLst>
           </p:cNvPr>
@@ -2317,7 +2317,7 @@
           <p:cNvPr id="21" name="">
             <a:extLst xmlns:a="http://schemas.openxmlformats.org/drawingml/2006/main">
               <a:ext uri="{FF2B5EF4-FFF2-40B4-BE49-F238E27FC236}">
-                <a16:creationId xmlns:a16="http://schemas.microsoft.com/office/drawing/2014/main" id="{5C47519F-FE03-453D-B012-E945B7898822}"/>
+                <a16:creationId xmlns:a16="http://schemas.microsoft.com/office/drawing/2014/main" id="{2BFB971B-901F-445D-9280-0CA9525ADB15}"/>
               </a:ext>
             </a:extLst>
           </p:cNvPr>
@@ -2381,7 +2381,7 @@
           <p:cNvPr id="22" name="">
             <a:extLst xmlns:a="http://schemas.openxmlformats.org/drawingml/2006/main">
               <a:ext uri="{FF2B5EF4-FFF2-40B4-BE49-F238E27FC236}">
-                <a16:creationId xmlns:a16="http://schemas.microsoft.com/office/drawing/2014/main" id="{57F46540-15FC-4D95-A9E5-230188F162EF}"/>
+                <a16:creationId xmlns:a16="http://schemas.microsoft.com/office/drawing/2014/main" id="{CB7F60E1-1FFD-489F-8984-5C94466DA0DF}"/>
               </a:ext>
             </a:extLst>
           </p:cNvPr>
@@ -2438,7 +2438,7 @@
           <p:cNvPr id="23" name="">
             <a:extLst xmlns:a="http://schemas.openxmlformats.org/drawingml/2006/main">
               <a:ext uri="{FF2B5EF4-FFF2-40B4-BE49-F238E27FC236}">
-                <a16:creationId xmlns:a16="http://schemas.microsoft.com/office/drawing/2014/main" id="{CC4198DA-2F24-4139-A20B-123CDDAFC1EE}"/>
+                <a16:creationId xmlns:a16="http://schemas.microsoft.com/office/drawing/2014/main" id="{E45B9D1A-5A18-43CC-A116-F3A72AB6EFE7}"/>
               </a:ext>
             </a:extLst>
           </p:cNvPr>
@@ -2495,7 +2495,7 @@
           <p:cNvPr id="24" name="">
             <a:extLst xmlns:a="http://schemas.openxmlformats.org/drawingml/2006/main">
               <a:ext uri="{FF2B5EF4-FFF2-40B4-BE49-F238E27FC236}">
-                <a16:creationId xmlns:a16="http://schemas.microsoft.com/office/drawing/2014/main" id="{E7229C17-74E5-4BFA-9778-AF0EE82E3356}"/>
+                <a16:creationId xmlns:a16="http://schemas.microsoft.com/office/drawing/2014/main" id="{EE656FC7-F1A4-4507-AED5-20432DC4A840}"/>
               </a:ext>
             </a:extLst>
           </p:cNvPr>
@@ -2527,7 +2527,7 @@
           <p:cNvPr id="25" name="">
             <a:extLst xmlns:a="http://schemas.openxmlformats.org/drawingml/2006/main">
               <a:ext uri="{FF2B5EF4-FFF2-40B4-BE49-F238E27FC236}">
-                <a16:creationId xmlns:a16="http://schemas.microsoft.com/office/drawing/2014/main" id="{85EA2F83-14EE-4A9E-BE84-7CB2176BCA78}"/>
+                <a16:creationId xmlns:a16="http://schemas.microsoft.com/office/drawing/2014/main" id="{56A8B8EA-8BDC-472D-A648-10C4113B6718}"/>
               </a:ext>
             </a:extLst>
           </p:cNvPr>
@@ -2562,7 +2562,7 @@
           <p:cNvPr id="26" name="">
             <a:extLst xmlns:a="http://schemas.openxmlformats.org/drawingml/2006/main">
               <a:ext uri="{FF2B5EF4-FFF2-40B4-BE49-F238E27FC236}">
-                <a16:creationId xmlns:a16="http://schemas.microsoft.com/office/drawing/2014/main" id="{07ECE9E6-94FD-46DE-9FE5-C420F580BF93}"/>
+                <a16:creationId xmlns:a16="http://schemas.microsoft.com/office/drawing/2014/main" id="{0AB7535F-856F-4098-93DE-6BF578EACB38}"/>
               </a:ext>
             </a:extLst>
           </p:cNvPr>
@@ -2626,7 +2626,7 @@
           <p:cNvPr id="27" name="">
             <a:extLst xmlns:a="http://schemas.openxmlformats.org/drawingml/2006/main">
               <a:ext uri="{FF2B5EF4-FFF2-40B4-BE49-F238E27FC236}">
-                <a16:creationId xmlns:a16="http://schemas.microsoft.com/office/drawing/2014/main" id="{9BCE5A4B-C776-483B-8A94-D275927354A5}"/>
+                <a16:creationId xmlns:a16="http://schemas.microsoft.com/office/drawing/2014/main" id="{996C3EC6-D816-4305-B98D-F24F08CAB7AC}"/>
               </a:ext>
             </a:extLst>
           </p:cNvPr>
@@ -2683,7 +2683,7 @@
           <p:cNvPr id="28" name="">
             <a:extLst xmlns:a="http://schemas.openxmlformats.org/drawingml/2006/main">
               <a:ext uri="{FF2B5EF4-FFF2-40B4-BE49-F238E27FC236}">
-                <a16:creationId xmlns:a16="http://schemas.microsoft.com/office/drawing/2014/main" id="{39FAB675-20F6-4EAD-9D01-D07D5A2B8BA8}"/>
+                <a16:creationId xmlns:a16="http://schemas.microsoft.com/office/drawing/2014/main" id="{051CEEA0-5C8B-44BD-9424-82A4674EF4D2}"/>
               </a:ext>
             </a:extLst>
           </p:cNvPr>
@@ -2740,7 +2740,7 @@
           <p:cNvPr id="29" name="">
             <a:extLst xmlns:a="http://schemas.openxmlformats.org/drawingml/2006/main">
               <a:ext uri="{FF2B5EF4-FFF2-40B4-BE49-F238E27FC236}">
-                <a16:creationId xmlns:a16="http://schemas.microsoft.com/office/drawing/2014/main" id="{C9D9B4F5-E6BE-49A8-B06C-07E6FAB82FCB}"/>
+                <a16:creationId xmlns:a16="http://schemas.microsoft.com/office/drawing/2014/main" id="{A89DFBE6-9E3A-4FAA-AA11-88B947B280CB}"/>
               </a:ext>
             </a:extLst>
           </p:cNvPr>
@@ -2775,7 +2775,7 @@
           <p:cNvPr id="30" name="">
             <a:extLst xmlns:a="http://schemas.openxmlformats.org/drawingml/2006/main">
               <a:ext uri="{FF2B5EF4-FFF2-40B4-BE49-F238E27FC236}">
-                <a16:creationId xmlns:a16="http://schemas.microsoft.com/office/drawing/2014/main" id="{0C47628D-7438-40D8-A4EF-2F5A5EDC70D5}"/>
+                <a16:creationId xmlns:a16="http://schemas.microsoft.com/office/drawing/2014/main" id="{41D59421-6267-4C30-A5D9-29B47AEA2FB6}"/>
               </a:ext>
             </a:extLst>
           </p:cNvPr>
@@ -2832,7 +2832,7 @@
           <p:cNvPr id="31" name="">
             <a:extLst xmlns:a="http://schemas.openxmlformats.org/drawingml/2006/main">
               <a:ext uri="{FF2B5EF4-FFF2-40B4-BE49-F238E27FC236}">
-                <a16:creationId xmlns:a16="http://schemas.microsoft.com/office/drawing/2014/main" id="{B0A230F5-31A3-4798-832B-D2008DAF7D68}"/>
+                <a16:creationId xmlns:a16="http://schemas.microsoft.com/office/drawing/2014/main" id="{847F850B-550B-4262-9E30-A9E7FBEADF79}"/>
               </a:ext>
             </a:extLst>
           </p:cNvPr>
@@ -2889,7 +2889,7 @@
           <p:cNvPr id="32" name="">
             <a:extLst xmlns:a="http://schemas.openxmlformats.org/drawingml/2006/main">
               <a:ext uri="{FF2B5EF4-FFF2-40B4-BE49-F238E27FC236}">
-                <a16:creationId xmlns:a16="http://schemas.microsoft.com/office/drawing/2014/main" id="{F58DA844-9432-4AE7-9465-304B15C67579}"/>
+                <a16:creationId xmlns:a16="http://schemas.microsoft.com/office/drawing/2014/main" id="{8DA3B860-3F72-46E9-ABC5-8B1FFA533857}"/>
               </a:ext>
             </a:extLst>
           </p:cNvPr>
@@ -2946,7 +2946,7 @@
           <p:cNvPr id="33" name="">
             <a:extLst xmlns:a="http://schemas.openxmlformats.org/drawingml/2006/main">
               <a:ext uri="{FF2B5EF4-FFF2-40B4-BE49-F238E27FC236}">
-                <a16:creationId xmlns:a16="http://schemas.microsoft.com/office/drawing/2014/main" id="{542B4836-EB2E-45F1-A7D5-40B85BB9D17E}"/>
+                <a16:creationId xmlns:a16="http://schemas.microsoft.com/office/drawing/2014/main" id="{11134BD5-1C1E-4530-9FE8-9E4D4985A5DE}"/>
               </a:ext>
             </a:extLst>
           </p:cNvPr>
@@ -2981,7 +2981,7 @@
           <p:cNvPr id="34" name="">
             <a:extLst xmlns:a="http://schemas.openxmlformats.org/drawingml/2006/main">
               <a:ext uri="{FF2B5EF4-FFF2-40B4-BE49-F238E27FC236}">
-                <a16:creationId xmlns:a16="http://schemas.microsoft.com/office/drawing/2014/main" id="{6ACB2B3B-8D1F-41EE-BA4A-4045823A5C81}"/>
+                <a16:creationId xmlns:a16="http://schemas.microsoft.com/office/drawing/2014/main" id="{131712B8-F54C-4554-AB0F-B348FD8D8E6D}"/>
               </a:ext>
             </a:extLst>
           </p:cNvPr>
@@ -3045,7 +3045,7 @@
           <p:cNvPr id="35" name="">
             <a:extLst xmlns:a="http://schemas.openxmlformats.org/drawingml/2006/main">
               <a:ext uri="{FF2B5EF4-FFF2-40B4-BE49-F238E27FC236}">
-                <a16:creationId xmlns:a16="http://schemas.microsoft.com/office/drawing/2014/main" id="{AADC3238-23AD-4FF0-8DB5-9F057F396FEC}"/>
+                <a16:creationId xmlns:a16="http://schemas.microsoft.com/office/drawing/2014/main" id="{FD6ABA93-B76D-4B21-A9B9-5AE8F4593244}"/>
               </a:ext>
             </a:extLst>
           </p:cNvPr>
@@ -3102,7 +3102,7 @@
           <p:cNvPr id="36" name="">
             <a:extLst xmlns:a="http://schemas.openxmlformats.org/drawingml/2006/main">
               <a:ext uri="{FF2B5EF4-FFF2-40B4-BE49-F238E27FC236}">
-                <a16:creationId xmlns:a16="http://schemas.microsoft.com/office/drawing/2014/main" id="{A45955C6-F770-4FCD-AA67-F14EA143F1CA}"/>
+                <a16:creationId xmlns:a16="http://schemas.microsoft.com/office/drawing/2014/main" id="{DEB3463C-CAED-497E-B84C-91DA966E56B5}"/>
               </a:ext>
             </a:extLst>
           </p:cNvPr>
@@ -3159,7 +3159,7 @@
           <p:cNvPr id="37" name="">
             <a:extLst xmlns:a="http://schemas.openxmlformats.org/drawingml/2006/main">
               <a:ext uri="{FF2B5EF4-FFF2-40B4-BE49-F238E27FC236}">
-                <a16:creationId xmlns:a16="http://schemas.microsoft.com/office/drawing/2014/main" id="{D15833A4-8C34-469E-B729-6C6AA1E1CE07}"/>
+                <a16:creationId xmlns:a16="http://schemas.microsoft.com/office/drawing/2014/main" id="{1C7A0F8C-6EF5-43A4-84B4-E796CC4D0AE3}"/>
               </a:ext>
             </a:extLst>
           </p:cNvPr>
@@ -3194,7 +3194,7 @@
           <p:cNvPr id="38" name="">
             <a:extLst xmlns:a="http://schemas.openxmlformats.org/drawingml/2006/main">
               <a:ext uri="{FF2B5EF4-FFF2-40B4-BE49-F238E27FC236}">
-                <a16:creationId xmlns:a16="http://schemas.microsoft.com/office/drawing/2014/main" id="{FA13FBCC-86DD-4845-B822-EC19EB4BE1F4}"/>
+                <a16:creationId xmlns:a16="http://schemas.microsoft.com/office/drawing/2014/main" id="{AEE98B5B-0817-4BB8-924F-F3732B086F6C}"/>
               </a:ext>
             </a:extLst>
           </p:cNvPr>
@@ -3258,7 +3258,7 @@
           <p:cNvPr id="39" name="">
             <a:extLst xmlns:a="http://schemas.openxmlformats.org/drawingml/2006/main">
               <a:ext uri="{FF2B5EF4-FFF2-40B4-BE49-F238E27FC236}">
-                <a16:creationId xmlns:a16="http://schemas.microsoft.com/office/drawing/2014/main" id="{F55C8DB6-BD7C-4FEE-8C6C-6FC75E122D28}"/>
+                <a16:creationId xmlns:a16="http://schemas.microsoft.com/office/drawing/2014/main" id="{E41C9734-333E-4823-B5FA-11C9FF0B83F7}"/>
               </a:ext>
             </a:extLst>
           </p:cNvPr>
@@ -3315,7 +3315,7 @@
           <p:cNvPr id="40" name="">
             <a:extLst xmlns:a="http://schemas.openxmlformats.org/drawingml/2006/main">
               <a:ext uri="{FF2B5EF4-FFF2-40B4-BE49-F238E27FC236}">
-                <a16:creationId xmlns:a16="http://schemas.microsoft.com/office/drawing/2014/main" id="{0A65804A-0021-497A-92F2-2D7C70C819C0}"/>
+                <a16:creationId xmlns:a16="http://schemas.microsoft.com/office/drawing/2014/main" id="{9ACA0DBC-8CFE-44E4-B133-46BCEFDB3A46}"/>
               </a:ext>
             </a:extLst>
           </p:cNvPr>
@@ -3372,7 +3372,7 @@
           <p:cNvPr id="41" name="">
             <a:extLst xmlns:a="http://schemas.openxmlformats.org/drawingml/2006/main">
               <a:ext uri="{FF2B5EF4-FFF2-40B4-BE49-F238E27FC236}">
-                <a16:creationId xmlns:a16="http://schemas.microsoft.com/office/drawing/2014/main" id="{8ABDBA41-8A9F-4029-A7DB-8B03A5FDB441}"/>
+                <a16:creationId xmlns:a16="http://schemas.microsoft.com/office/drawing/2014/main" id="{332E94CF-37D4-4F86-B31D-CD8E344D9B57}"/>
               </a:ext>
             </a:extLst>
           </p:cNvPr>
@@ -3407,7 +3407,7 @@
           <p:cNvPr id="42" name="">
             <a:extLst xmlns:a="http://schemas.openxmlformats.org/drawingml/2006/main">
               <a:ext uri="{FF2B5EF4-FFF2-40B4-BE49-F238E27FC236}">
-                <a16:creationId xmlns:a16="http://schemas.microsoft.com/office/drawing/2014/main" id="{852C545A-EA68-45D3-8E02-14C28BE85F09}"/>
+                <a16:creationId xmlns:a16="http://schemas.microsoft.com/office/drawing/2014/main" id="{CB30C98F-43A6-41CE-AC23-92687125A7EF}"/>
               </a:ext>
             </a:extLst>
           </p:cNvPr>
@@ -3471,7 +3471,7 @@
           <p:cNvPr id="43" name="">
             <a:extLst xmlns:a="http://schemas.openxmlformats.org/drawingml/2006/main">
               <a:ext uri="{FF2B5EF4-FFF2-40B4-BE49-F238E27FC236}">
-                <a16:creationId xmlns:a16="http://schemas.microsoft.com/office/drawing/2014/main" id="{0192B43C-130D-48C0-97C0-C629AD40B37B}"/>
+                <a16:creationId xmlns:a16="http://schemas.microsoft.com/office/drawing/2014/main" id="{B5DD5FCB-B9D2-4B44-BD24-8440B036DD90}"/>
               </a:ext>
             </a:extLst>
           </p:cNvPr>
@@ -3528,7 +3528,7 @@
           <p:cNvPr id="44" name="">
             <a:extLst xmlns:a="http://schemas.openxmlformats.org/drawingml/2006/main">
               <a:ext uri="{FF2B5EF4-FFF2-40B4-BE49-F238E27FC236}">
-                <a16:creationId xmlns:a16="http://schemas.microsoft.com/office/drawing/2014/main" id="{86D88CF9-D1B6-433D-8068-367B950F497D}"/>
+                <a16:creationId xmlns:a16="http://schemas.microsoft.com/office/drawing/2014/main" id="{0DDBAF94-787B-4E5B-BD06-111FEBA643CF}"/>
               </a:ext>
             </a:extLst>
           </p:cNvPr>
@@ -3585,7 +3585,7 @@
           <p:cNvPr id="45" name="">
             <a:extLst xmlns:a="http://schemas.openxmlformats.org/drawingml/2006/main">
               <a:ext uri="{FF2B5EF4-FFF2-40B4-BE49-F238E27FC236}">
-                <a16:creationId xmlns:a16="http://schemas.microsoft.com/office/drawing/2014/main" id="{CEBD4FBC-E636-4A9C-994E-5AA9DB0CFFED}"/>
+                <a16:creationId xmlns:a16="http://schemas.microsoft.com/office/drawing/2014/main" id="{6496C0D8-6EC4-488D-A9A8-0425F13865E2}"/>
               </a:ext>
             </a:extLst>
           </p:cNvPr>
@@ -3632,7 +3632,7 @@
                 <a:ea typeface="Arial"/>
                 <a:cs typeface="Arial"/>
               </a:rPr>
-              <a:t>AURA • Track A • 30/09/2026</a:t>
+              <a:t>AURA • Track A • 01/10/2026</a:t>
             </a:r>
           </a:p>
         </p:txBody>
@@ -3642,7 +3642,7 @@
           <p:cNvPr id="46" name="">
             <a:extLst xmlns:a="http://schemas.openxmlformats.org/drawingml/2006/main">
               <a:ext uri="{FF2B5EF4-FFF2-40B4-BE49-F238E27FC236}">
-                <a16:creationId xmlns:a16="http://schemas.microsoft.com/office/drawing/2014/main" id="{4FFFF5C5-C7C0-40D1-885D-47A93187A7AB}"/>
+                <a16:creationId xmlns:a16="http://schemas.microsoft.com/office/drawing/2014/main" id="{A56E86DC-2547-465A-BDE0-0AE27A4FF054}"/>
               </a:ext>
             </a:extLst>
           </p:cNvPr>
@@ -3697,7 +3697,7 @@
     </p:spTree>
     <p:extLst>
       <p:ext uri="{BB962C8B-B14F-4D97-AF65-F5344CB8AC3E}">
-        <p14:creationId xmlns:p14="http://schemas.microsoft.com/office/powerpoint/2010/main" val="426790140"/>
+        <p14:creationId xmlns:p14="http://schemas.microsoft.com/office/powerpoint/2010/main" val="2093502829"/>
       </p:ext>
     </p:extLst>
   </p:cSld>
@@ -3728,7 +3728,7 @@
           <p:cNvPr id="46" name="">
             <a:extLst xmlns:a="http://schemas.openxmlformats.org/drawingml/2006/main">
               <a:ext uri="{FF2B5EF4-FFF2-40B4-BE49-F238E27FC236}">
-                <a16:creationId xmlns:a16="http://schemas.microsoft.com/office/drawing/2014/main" id="{C11D6DB4-8490-426B-A861-94D1A4BD2DF8}"/>
+                <a16:creationId xmlns:a16="http://schemas.microsoft.com/office/drawing/2014/main" id="{F0586C75-C98B-4252-B986-02A670090769}"/>
               </a:ext>
             </a:extLst>
           </p:cNvPr>
@@ -3785,7 +3785,7 @@
           <p:cNvPr id="2" name="">
             <a:extLst xmlns:a="http://schemas.openxmlformats.org/drawingml/2006/main">
               <a:ext uri="{FF2B5EF4-FFF2-40B4-BE49-F238E27FC236}">
-                <a16:creationId xmlns:a16="http://schemas.microsoft.com/office/drawing/2014/main" id="{DCABFE51-CEDC-4FA9-90A0-47B01CD3FF0B}"/>
+                <a16:creationId xmlns:a16="http://schemas.microsoft.com/office/drawing/2014/main" id="{5A2BA3EF-9496-4BAA-8798-0447EB159596}"/>
               </a:ext>
             </a:extLst>
           </p:cNvPr>
@@ -3842,7 +3842,7 @@
           <p:cNvPr id="3" name="">
             <a:extLst xmlns:a="http://schemas.openxmlformats.org/drawingml/2006/main">
               <a:ext uri="{FF2B5EF4-FFF2-40B4-BE49-F238E27FC236}">
-                <a16:creationId xmlns:a16="http://schemas.microsoft.com/office/drawing/2014/main" id="{81A91161-9D85-43BF-A85E-F26F5754A45B}"/>
+                <a16:creationId xmlns:a16="http://schemas.microsoft.com/office/drawing/2014/main" id="{747E458F-159B-4A93-9B22-AAB71DFF6E91}"/>
               </a:ext>
             </a:extLst>
           </p:cNvPr>
@@ -3899,7 +3899,7 @@
           <p:cNvPr id="4" name="">
             <a:extLst xmlns:a="http://schemas.openxmlformats.org/drawingml/2006/main">
               <a:ext uri="{FF2B5EF4-FFF2-40B4-BE49-F238E27FC236}">
-                <a16:creationId xmlns:a16="http://schemas.microsoft.com/office/drawing/2014/main" id="{DE061ABB-6855-4827-9246-D8EE31EEEB2F}"/>
+                <a16:creationId xmlns:a16="http://schemas.microsoft.com/office/drawing/2014/main" id="{E63779C2-2ACA-4288-98DD-5EA2ED97807A}"/>
               </a:ext>
             </a:extLst>
           </p:cNvPr>
@@ -3930,7 +3930,7 @@
           <p:cNvPr id="5" name="">
             <a:extLst xmlns:a="http://schemas.openxmlformats.org/drawingml/2006/main">
               <a:ext uri="{FF2B5EF4-FFF2-40B4-BE49-F238E27FC236}">
-                <a16:creationId xmlns:a16="http://schemas.microsoft.com/office/drawing/2014/main" id="{C881C7CF-7AB5-4704-B050-B10CA52C1A65}"/>
+                <a16:creationId xmlns:a16="http://schemas.microsoft.com/office/drawing/2014/main" id="{849AB02D-EE31-4549-9F77-57AB1BCC470A}"/>
               </a:ext>
             </a:extLst>
           </p:cNvPr>
@@ -3965,7 +3965,7 @@
           <p:cNvPr id="6" name="">
             <a:extLst xmlns:a="http://schemas.openxmlformats.org/drawingml/2006/main">
               <a:ext uri="{FF2B5EF4-FFF2-40B4-BE49-F238E27FC236}">
-                <a16:creationId xmlns:a16="http://schemas.microsoft.com/office/drawing/2014/main" id="{46026608-C0CC-4DFD-9477-81502C005F2D}"/>
+                <a16:creationId xmlns:a16="http://schemas.microsoft.com/office/drawing/2014/main" id="{ACCC908C-C9CF-4F97-B272-56DF03162F63}"/>
               </a:ext>
             </a:extLst>
           </p:cNvPr>
@@ -4029,7 +4029,7 @@
           <p:cNvPr id="7" name="">
             <a:extLst xmlns:a="http://schemas.openxmlformats.org/drawingml/2006/main">
               <a:ext uri="{FF2B5EF4-FFF2-40B4-BE49-F238E27FC236}">
-                <a16:creationId xmlns:a16="http://schemas.microsoft.com/office/drawing/2014/main" id="{0640CFA0-45DA-4D98-8E3A-C5AD789D5DB8}"/>
+                <a16:creationId xmlns:a16="http://schemas.microsoft.com/office/drawing/2014/main" id="{33DDF355-2C1A-4EE3-9332-2C3311B89E19}"/>
               </a:ext>
             </a:extLst>
           </p:cNvPr>
@@ -4086,7 +4086,7 @@
           <p:cNvPr id="8" name="">
             <a:extLst xmlns:a="http://schemas.openxmlformats.org/drawingml/2006/main">
               <a:ext uri="{FF2B5EF4-FFF2-40B4-BE49-F238E27FC236}">
-                <a16:creationId xmlns:a16="http://schemas.microsoft.com/office/drawing/2014/main" id="{E13CD048-54BC-4A37-BC94-7F22B91FA38C}"/>
+                <a16:creationId xmlns:a16="http://schemas.microsoft.com/office/drawing/2014/main" id="{F30229A5-820C-4BA5-8B26-BA77842772EC}"/>
               </a:ext>
             </a:extLst>
           </p:cNvPr>
@@ -4166,7 +4166,7 @@
           <p:cNvPr id="9" name="">
             <a:extLst xmlns:a="http://schemas.openxmlformats.org/drawingml/2006/main">
               <a:ext uri="{FF2B5EF4-FFF2-40B4-BE49-F238E27FC236}">
-                <a16:creationId xmlns:a16="http://schemas.microsoft.com/office/drawing/2014/main" id="{1CC2E66C-597A-4059-A8F8-BF0292CF4B6A}"/>
+                <a16:creationId xmlns:a16="http://schemas.microsoft.com/office/drawing/2014/main" id="{DF68492C-1280-46E6-92EB-77FA3FBD54F3}"/>
               </a:ext>
             </a:extLst>
           </p:cNvPr>
@@ -4198,7 +4198,7 @@
           <p:cNvPr id="10" name="">
             <a:extLst xmlns:a="http://schemas.openxmlformats.org/drawingml/2006/main">
               <a:ext uri="{FF2B5EF4-FFF2-40B4-BE49-F238E27FC236}">
-                <a16:creationId xmlns:a16="http://schemas.microsoft.com/office/drawing/2014/main" id="{4E8FE002-5CFA-4718-9BD9-C9328AB2931A}"/>
+                <a16:creationId xmlns:a16="http://schemas.microsoft.com/office/drawing/2014/main" id="{F08C9F4E-C7C7-44BD-AE40-FFCB4664F020}"/>
               </a:ext>
             </a:extLst>
           </p:cNvPr>
@@ -4233,7 +4233,7 @@
           <p:cNvPr id="11" name="">
             <a:extLst xmlns:a="http://schemas.openxmlformats.org/drawingml/2006/main">
               <a:ext uri="{FF2B5EF4-FFF2-40B4-BE49-F238E27FC236}">
-                <a16:creationId xmlns:a16="http://schemas.microsoft.com/office/drawing/2014/main" id="{17F5141A-A918-4238-A255-580899B79D6D}"/>
+                <a16:creationId xmlns:a16="http://schemas.microsoft.com/office/drawing/2014/main" id="{8E1EF217-1CCC-4D7F-B1A1-0F7E9596D13A}"/>
               </a:ext>
             </a:extLst>
           </p:cNvPr>
@@ -4297,7 +4297,7 @@
           <p:cNvPr id="12" name="">
             <a:extLst xmlns:a="http://schemas.openxmlformats.org/drawingml/2006/main">
               <a:ext uri="{FF2B5EF4-FFF2-40B4-BE49-F238E27FC236}">
-                <a16:creationId xmlns:a16="http://schemas.microsoft.com/office/drawing/2014/main" id="{A969FD06-7D2C-4B9C-86E8-1E9402FF4387}"/>
+                <a16:creationId xmlns:a16="http://schemas.microsoft.com/office/drawing/2014/main" id="{421EF4DE-E7F8-49B1-BAC2-75CDBCDC30E5}"/>
               </a:ext>
             </a:extLst>
           </p:cNvPr>
@@ -4354,7 +4354,7 @@
           <p:cNvPr id="13" name="">
             <a:extLst xmlns:a="http://schemas.openxmlformats.org/drawingml/2006/main">
               <a:ext uri="{FF2B5EF4-FFF2-40B4-BE49-F238E27FC236}">
-                <a16:creationId xmlns:a16="http://schemas.microsoft.com/office/drawing/2014/main" id="{544CD196-D2D6-47F2-816E-1F04D5F0BF60}"/>
+                <a16:creationId xmlns:a16="http://schemas.microsoft.com/office/drawing/2014/main" id="{4E020E29-9597-4F41-BA74-611BA77C56BD}"/>
               </a:ext>
             </a:extLst>
           </p:cNvPr>
@@ -4434,7 +4434,7 @@
           <p:cNvPr id="14" name="">
             <a:extLst xmlns:a="http://schemas.openxmlformats.org/drawingml/2006/main">
               <a:ext uri="{FF2B5EF4-FFF2-40B4-BE49-F238E27FC236}">
-                <a16:creationId xmlns:a16="http://schemas.microsoft.com/office/drawing/2014/main" id="{703EDFEC-58DF-431E-9490-3304B1AB010E}"/>
+                <a16:creationId xmlns:a16="http://schemas.microsoft.com/office/drawing/2014/main" id="{95E0EE37-93B7-4C5F-9506-878236FD3D34}"/>
               </a:ext>
             </a:extLst>
           </p:cNvPr>
@@ -4466,7 +4466,7 @@
           <p:cNvPr id="15" name="">
             <a:extLst xmlns:a="http://schemas.openxmlformats.org/drawingml/2006/main">
               <a:ext uri="{FF2B5EF4-FFF2-40B4-BE49-F238E27FC236}">
-                <a16:creationId xmlns:a16="http://schemas.microsoft.com/office/drawing/2014/main" id="{630E99AB-93F7-4EEA-B8FC-7D625896AF35}"/>
+                <a16:creationId xmlns:a16="http://schemas.microsoft.com/office/drawing/2014/main" id="{8E3410E9-160B-470F-80E9-A23031DFEDC7}"/>
               </a:ext>
             </a:extLst>
           </p:cNvPr>
@@ -4501,7 +4501,7 @@
           <p:cNvPr id="16" name="">
             <a:extLst xmlns:a="http://schemas.openxmlformats.org/drawingml/2006/main">
               <a:ext uri="{FF2B5EF4-FFF2-40B4-BE49-F238E27FC236}">
-                <a16:creationId xmlns:a16="http://schemas.microsoft.com/office/drawing/2014/main" id="{7B1B6CE3-87BC-44D8-AD3D-5F2412F52C80}"/>
+                <a16:creationId xmlns:a16="http://schemas.microsoft.com/office/drawing/2014/main" id="{6AA9C234-52C5-4E5A-AA61-5150F9B11C10}"/>
               </a:ext>
             </a:extLst>
           </p:cNvPr>
@@ -4565,7 +4565,7 @@
           <p:cNvPr id="17" name="">
             <a:extLst xmlns:a="http://schemas.openxmlformats.org/drawingml/2006/main">
               <a:ext uri="{FF2B5EF4-FFF2-40B4-BE49-F238E27FC236}">
-                <a16:creationId xmlns:a16="http://schemas.microsoft.com/office/drawing/2014/main" id="{D03A1B94-D208-4F58-863C-488E7FA5EBDA}"/>
+                <a16:creationId xmlns:a16="http://schemas.microsoft.com/office/drawing/2014/main" id="{A834956C-E8EF-45B0-9A3D-51B9CE6DE2E3}"/>
               </a:ext>
             </a:extLst>
           </p:cNvPr>
@@ -4622,7 +4622,7 @@
           <p:cNvPr id="18" name="">
             <a:extLst xmlns:a="http://schemas.openxmlformats.org/drawingml/2006/main">
               <a:ext uri="{FF2B5EF4-FFF2-40B4-BE49-F238E27FC236}">
-                <a16:creationId xmlns:a16="http://schemas.microsoft.com/office/drawing/2014/main" id="{A2A90177-813C-4CE0-8CBF-82EE11235AF3}"/>
+                <a16:creationId xmlns:a16="http://schemas.microsoft.com/office/drawing/2014/main" id="{01BCAEB7-378B-455C-BA43-1DEB35FE0AC4}"/>
               </a:ext>
             </a:extLst>
           </p:cNvPr>
@@ -4702,7 +4702,7 @@
           <p:cNvPr id="19" name="">
             <a:extLst xmlns:a="http://schemas.openxmlformats.org/drawingml/2006/main">
               <a:ext uri="{FF2B5EF4-FFF2-40B4-BE49-F238E27FC236}">
-                <a16:creationId xmlns:a16="http://schemas.microsoft.com/office/drawing/2014/main" id="{566149F8-2862-4354-B326-F1CEE3F90141}"/>
+                <a16:creationId xmlns:a16="http://schemas.microsoft.com/office/drawing/2014/main" id="{F8E67C9A-F0A0-4D03-AFEA-92E4B9012186}"/>
               </a:ext>
             </a:extLst>
           </p:cNvPr>
@@ -4734,7 +4734,7 @@
           <p:cNvPr id="20" name="">
             <a:extLst xmlns:a="http://schemas.openxmlformats.org/drawingml/2006/main">
               <a:ext uri="{FF2B5EF4-FFF2-40B4-BE49-F238E27FC236}">
-                <a16:creationId xmlns:a16="http://schemas.microsoft.com/office/drawing/2014/main" id="{4D81A323-0C33-422C-A2A2-773B06345213}"/>
+                <a16:creationId xmlns:a16="http://schemas.microsoft.com/office/drawing/2014/main" id="{12E8ABC7-1C72-411C-89E4-06613F507478}"/>
               </a:ext>
             </a:extLst>
           </p:cNvPr>
@@ -4769,7 +4769,7 @@
           <p:cNvPr id="21" name="">
             <a:extLst xmlns:a="http://schemas.openxmlformats.org/drawingml/2006/main">
               <a:ext uri="{FF2B5EF4-FFF2-40B4-BE49-F238E27FC236}">
-                <a16:creationId xmlns:a16="http://schemas.microsoft.com/office/drawing/2014/main" id="{874D0DFB-923D-48F6-8242-6E54515DFFDC}"/>
+                <a16:creationId xmlns:a16="http://schemas.microsoft.com/office/drawing/2014/main" id="{6C6D4DB4-BC2F-4967-A19E-05E42BAABED5}"/>
               </a:ext>
             </a:extLst>
           </p:cNvPr>
@@ -4833,7 +4833,7 @@
           <p:cNvPr id="22" name="">
             <a:extLst xmlns:a="http://schemas.openxmlformats.org/drawingml/2006/main">
               <a:ext uri="{FF2B5EF4-FFF2-40B4-BE49-F238E27FC236}">
-                <a16:creationId xmlns:a16="http://schemas.microsoft.com/office/drawing/2014/main" id="{0150000F-A892-4BA7-8DE4-87A2A70BF897}"/>
+                <a16:creationId xmlns:a16="http://schemas.microsoft.com/office/drawing/2014/main" id="{656BF8CC-EBED-4562-973A-8C6089EC43CB}"/>
               </a:ext>
             </a:extLst>
           </p:cNvPr>
@@ -4890,7 +4890,7 @@
           <p:cNvPr id="23" name="">
             <a:extLst xmlns:a="http://schemas.openxmlformats.org/drawingml/2006/main">
               <a:ext uri="{FF2B5EF4-FFF2-40B4-BE49-F238E27FC236}">
-                <a16:creationId xmlns:a16="http://schemas.microsoft.com/office/drawing/2014/main" id="{2008459B-59E1-448B-ADAC-09D0AA3FDFD1}"/>
+                <a16:creationId xmlns:a16="http://schemas.microsoft.com/office/drawing/2014/main" id="{35491D20-8797-4871-A258-C74FB49A7D56}"/>
               </a:ext>
             </a:extLst>
           </p:cNvPr>
@@ -4970,7 +4970,7 @@
           <p:cNvPr id="24" name="">
             <a:extLst xmlns:a="http://schemas.openxmlformats.org/drawingml/2006/main">
               <a:ext uri="{FF2B5EF4-FFF2-40B4-BE49-F238E27FC236}">
-                <a16:creationId xmlns:a16="http://schemas.microsoft.com/office/drawing/2014/main" id="{F36A861B-3352-4909-BE60-19DA7732E5F8}"/>
+                <a16:creationId xmlns:a16="http://schemas.microsoft.com/office/drawing/2014/main" id="{43E6336B-D178-4F70-84F8-38EFAFA72A37}"/>
               </a:ext>
             </a:extLst>
           </p:cNvPr>
@@ -5002,7 +5002,7 @@
           <p:cNvPr id="25" name="">
             <a:extLst xmlns:a="http://schemas.openxmlformats.org/drawingml/2006/main">
               <a:ext uri="{FF2B5EF4-FFF2-40B4-BE49-F238E27FC236}">
-                <a16:creationId xmlns:a16="http://schemas.microsoft.com/office/drawing/2014/main" id="{718AD49A-37EC-4A77-A211-AB1B07BF74EC}"/>
+                <a16:creationId xmlns:a16="http://schemas.microsoft.com/office/drawing/2014/main" id="{640D047A-0390-4933-9BAC-17B504592E65}"/>
               </a:ext>
             </a:extLst>
           </p:cNvPr>
@@ -5037,7 +5037,7 @@
           <p:cNvPr id="26" name="">
             <a:extLst xmlns:a="http://schemas.openxmlformats.org/drawingml/2006/main">
               <a:ext uri="{FF2B5EF4-FFF2-40B4-BE49-F238E27FC236}">
-                <a16:creationId xmlns:a16="http://schemas.microsoft.com/office/drawing/2014/main" id="{FF203CF0-52A6-4035-98B1-2BA2C8AE921C}"/>
+                <a16:creationId xmlns:a16="http://schemas.microsoft.com/office/drawing/2014/main" id="{844DEE74-B7CE-4777-8AF3-B92E301BC944}"/>
               </a:ext>
             </a:extLst>
           </p:cNvPr>
@@ -5101,7 +5101,7 @@
           <p:cNvPr id="27" name="">
             <a:extLst xmlns:a="http://schemas.openxmlformats.org/drawingml/2006/main">
               <a:ext uri="{FF2B5EF4-FFF2-40B4-BE49-F238E27FC236}">
-                <a16:creationId xmlns:a16="http://schemas.microsoft.com/office/drawing/2014/main" id="{5C49E077-ECDC-4D95-922D-26356F76D1A5}"/>
+                <a16:creationId xmlns:a16="http://schemas.microsoft.com/office/drawing/2014/main" id="{501DEDC2-2813-482D-808A-18AA640974CD}"/>
               </a:ext>
             </a:extLst>
           </p:cNvPr>
@@ -5158,7 +5158,7 @@
           <p:cNvPr id="28" name="">
             <a:extLst xmlns:a="http://schemas.openxmlformats.org/drawingml/2006/main">
               <a:ext uri="{FF2B5EF4-FFF2-40B4-BE49-F238E27FC236}">
-                <a16:creationId xmlns:a16="http://schemas.microsoft.com/office/drawing/2014/main" id="{C92B8515-9A17-4E8D-A9AA-41B273E63B73}"/>
+                <a16:creationId xmlns:a16="http://schemas.microsoft.com/office/drawing/2014/main" id="{AA8E4084-89BF-4BC8-ACB0-0C3AAB6E1C48}"/>
               </a:ext>
             </a:extLst>
           </p:cNvPr>
@@ -5238,7 +5238,7 @@
           <p:cNvPr id="29" name="">
             <a:extLst xmlns:a="http://schemas.openxmlformats.org/drawingml/2006/main">
               <a:ext uri="{FF2B5EF4-FFF2-40B4-BE49-F238E27FC236}">
-                <a16:creationId xmlns:a16="http://schemas.microsoft.com/office/drawing/2014/main" id="{F5417632-D754-4CCD-8F0C-F7496714D3FC}"/>
+                <a16:creationId xmlns:a16="http://schemas.microsoft.com/office/drawing/2014/main" id="{A5984B40-447F-47B3-930D-79E11A692C8E}"/>
               </a:ext>
             </a:extLst>
           </p:cNvPr>
@@ -5295,7 +5295,7 @@
           <p:cNvPr id="30" name="">
             <a:extLst xmlns:a="http://schemas.openxmlformats.org/drawingml/2006/main">
               <a:ext uri="{FF2B5EF4-FFF2-40B4-BE49-F238E27FC236}">
-                <a16:creationId xmlns:a16="http://schemas.microsoft.com/office/drawing/2014/main" id="{6A2F8910-15C0-49F8-AD84-57DFB3710BDA}"/>
+                <a16:creationId xmlns:a16="http://schemas.microsoft.com/office/drawing/2014/main" id="{493894BE-46F6-4990-9C04-391D84005E71}"/>
               </a:ext>
             </a:extLst>
           </p:cNvPr>
@@ -5330,7 +5330,7 @@
           <p:cNvPr id="31" name="">
             <a:extLst xmlns:a="http://schemas.openxmlformats.org/drawingml/2006/main">
               <a:ext uri="{FF2B5EF4-FFF2-40B4-BE49-F238E27FC236}">
-                <a16:creationId xmlns:a16="http://schemas.microsoft.com/office/drawing/2014/main" id="{F0061632-CE76-4988-84B2-CB63B0FA340C}"/>
+                <a16:creationId xmlns:a16="http://schemas.microsoft.com/office/drawing/2014/main" id="{03650ABA-8208-4E6E-99D3-E14E0963DC0A}"/>
               </a:ext>
             </a:extLst>
           </p:cNvPr>
@@ -5387,7 +5387,7 @@
           <p:cNvPr id="32" name="">
             <a:extLst xmlns:a="http://schemas.openxmlformats.org/drawingml/2006/main">
               <a:ext uri="{FF2B5EF4-FFF2-40B4-BE49-F238E27FC236}">
-                <a16:creationId xmlns:a16="http://schemas.microsoft.com/office/drawing/2014/main" id="{48178020-A016-4DAA-9EBD-1CECCEFA9263}"/>
+                <a16:creationId xmlns:a16="http://schemas.microsoft.com/office/drawing/2014/main" id="{9B20AB6D-769C-46E8-9F8F-AFE6DFFD5F44}"/>
               </a:ext>
             </a:extLst>
           </p:cNvPr>
@@ -5490,7 +5490,7 @@
           <p:cNvPr id="33" name="">
             <a:extLst xmlns:a="http://schemas.openxmlformats.org/drawingml/2006/main">
               <a:ext uri="{FF2B5EF4-FFF2-40B4-BE49-F238E27FC236}">
-                <a16:creationId xmlns:a16="http://schemas.microsoft.com/office/drawing/2014/main" id="{96DCB6BF-7962-4D1B-A2E3-15C9DA5AB91D}"/>
+                <a16:creationId xmlns:a16="http://schemas.microsoft.com/office/drawing/2014/main" id="{CC43028B-0556-4558-9472-D2F5CE8E94B1}"/>
               </a:ext>
             </a:extLst>
           </p:cNvPr>
@@ -5554,7 +5554,7 @@
           <p:cNvPr id="34" name="">
             <a:extLst xmlns:a="http://schemas.openxmlformats.org/drawingml/2006/main">
               <a:ext uri="{FF2B5EF4-FFF2-40B4-BE49-F238E27FC236}">
-                <a16:creationId xmlns:a16="http://schemas.microsoft.com/office/drawing/2014/main" id="{170457E1-8958-493F-9A38-B408858E2B1B}"/>
+                <a16:creationId xmlns:a16="http://schemas.microsoft.com/office/drawing/2014/main" id="{FEAE5E12-D3C6-4F94-917C-2C7C00741191}"/>
               </a:ext>
             </a:extLst>
           </p:cNvPr>
@@ -5611,7 +5611,7 @@
           <p:cNvPr id="35" name="">
             <a:extLst xmlns:a="http://schemas.openxmlformats.org/drawingml/2006/main">
               <a:ext uri="{FF2B5EF4-FFF2-40B4-BE49-F238E27FC236}">
-                <a16:creationId xmlns:a16="http://schemas.microsoft.com/office/drawing/2014/main" id="{51004CCD-BF75-4ABA-9A53-BF2417EDB01B}"/>
+                <a16:creationId xmlns:a16="http://schemas.microsoft.com/office/drawing/2014/main" id="{E9845954-9B77-43FC-8441-C58025B2B1B3}"/>
               </a:ext>
             </a:extLst>
           </p:cNvPr>
@@ -5646,7 +5646,7 @@
           <p:cNvPr id="36" name="">
             <a:extLst xmlns:a="http://schemas.openxmlformats.org/drawingml/2006/main">
               <a:ext uri="{FF2B5EF4-FFF2-40B4-BE49-F238E27FC236}">
-                <a16:creationId xmlns:a16="http://schemas.microsoft.com/office/drawing/2014/main" id="{F884E97C-D2E7-4993-9EF0-A3F08179BB0B}"/>
+                <a16:creationId xmlns:a16="http://schemas.microsoft.com/office/drawing/2014/main" id="{FB092659-9744-4F91-B37A-B7C98F754DBA}"/>
               </a:ext>
             </a:extLst>
           </p:cNvPr>
@@ -5703,7 +5703,7 @@
           <p:cNvPr id="37" name="">
             <a:extLst xmlns:a="http://schemas.openxmlformats.org/drawingml/2006/main">
               <a:ext uri="{FF2B5EF4-FFF2-40B4-BE49-F238E27FC236}">
-                <a16:creationId xmlns:a16="http://schemas.microsoft.com/office/drawing/2014/main" id="{55260737-256B-47BE-A10B-B5562A925451}"/>
+                <a16:creationId xmlns:a16="http://schemas.microsoft.com/office/drawing/2014/main" id="{EDAC24FD-9AD9-4628-8E2F-D8FB47E6A170}"/>
               </a:ext>
             </a:extLst>
           </p:cNvPr>
@@ -5738,7 +5738,7 @@
           <p:cNvPr id="38" name="">
             <a:extLst xmlns:a="http://schemas.openxmlformats.org/drawingml/2006/main">
               <a:ext uri="{FF2B5EF4-FFF2-40B4-BE49-F238E27FC236}">
-                <a16:creationId xmlns:a16="http://schemas.microsoft.com/office/drawing/2014/main" id="{1A6C8665-2BF0-48DE-AF4A-23ED2262F7DA}"/>
+                <a16:creationId xmlns:a16="http://schemas.microsoft.com/office/drawing/2014/main" id="{2E15FC81-A5F7-4244-8BF1-37B657AAD139}"/>
               </a:ext>
             </a:extLst>
           </p:cNvPr>
@@ -5795,7 +5795,7 @@
           <p:cNvPr id="39" name="">
             <a:extLst xmlns:a="http://schemas.openxmlformats.org/drawingml/2006/main">
               <a:ext uri="{FF2B5EF4-FFF2-40B4-BE49-F238E27FC236}">
-                <a16:creationId xmlns:a16="http://schemas.microsoft.com/office/drawing/2014/main" id="{FDE0A53A-5C2A-4099-B44B-92D677B92C66}"/>
+                <a16:creationId xmlns:a16="http://schemas.microsoft.com/office/drawing/2014/main" id="{CE358DD8-17E8-4F68-8F94-12F35A6C3717}"/>
               </a:ext>
             </a:extLst>
           </p:cNvPr>
@@ -5852,7 +5852,7 @@
           <p:cNvPr id="40" name="">
             <a:extLst xmlns:a="http://schemas.openxmlformats.org/drawingml/2006/main">
               <a:ext uri="{FF2B5EF4-FFF2-40B4-BE49-F238E27FC236}">
-                <a16:creationId xmlns:a16="http://schemas.microsoft.com/office/drawing/2014/main" id="{230DCF66-746D-4FA5-9BC1-A1EB41CBB640}"/>
+                <a16:creationId xmlns:a16="http://schemas.microsoft.com/office/drawing/2014/main" id="{43BC5806-17BB-41AB-99E5-8DD63C5752FB}"/>
               </a:ext>
             </a:extLst>
           </p:cNvPr>
@@ -5887,7 +5887,7 @@
           <p:cNvPr id="41" name="">
             <a:extLst xmlns:a="http://schemas.openxmlformats.org/drawingml/2006/main">
               <a:ext uri="{FF2B5EF4-FFF2-40B4-BE49-F238E27FC236}">
-                <a16:creationId xmlns:a16="http://schemas.microsoft.com/office/drawing/2014/main" id="{46A1397A-A866-49FF-9570-31B96317B1BA}"/>
+                <a16:creationId xmlns:a16="http://schemas.microsoft.com/office/drawing/2014/main" id="{4AEF675E-5DBA-4A20-92CA-D57BDF942E72}"/>
               </a:ext>
             </a:extLst>
           </p:cNvPr>
@@ -5944,7 +5944,7 @@
           <p:cNvPr id="42" name="">
             <a:extLst xmlns:a="http://schemas.openxmlformats.org/drawingml/2006/main">
               <a:ext uri="{FF2B5EF4-FFF2-40B4-BE49-F238E27FC236}">
-                <a16:creationId xmlns:a16="http://schemas.microsoft.com/office/drawing/2014/main" id="{44C871B9-9F82-4ADE-951C-D63C9F2A7BF1}"/>
+                <a16:creationId xmlns:a16="http://schemas.microsoft.com/office/drawing/2014/main" id="{50C35F6A-0BDD-4143-B675-B3DA91E8C1FB}"/>
               </a:ext>
             </a:extLst>
           </p:cNvPr>
@@ -6001,7 +6001,7 @@
           <p:cNvPr id="43" name="">
             <a:extLst xmlns:a="http://schemas.openxmlformats.org/drawingml/2006/main">
               <a:ext uri="{FF2B5EF4-FFF2-40B4-BE49-F238E27FC236}">
-                <a16:creationId xmlns:a16="http://schemas.microsoft.com/office/drawing/2014/main" id="{1DFB6A74-1B4A-4D97-924C-B057989E371D}"/>
+                <a16:creationId xmlns:a16="http://schemas.microsoft.com/office/drawing/2014/main" id="{F43BE1B8-7602-4AB8-AB28-36271404B328}"/>
               </a:ext>
             </a:extLst>
           </p:cNvPr>
@@ -6058,7 +6058,7 @@
           <p:cNvPr id="44" name="">
             <a:extLst xmlns:a="http://schemas.openxmlformats.org/drawingml/2006/main">
               <a:ext uri="{FF2B5EF4-FFF2-40B4-BE49-F238E27FC236}">
-                <a16:creationId xmlns:a16="http://schemas.microsoft.com/office/drawing/2014/main" id="{2F4D9861-66CC-42AA-BB64-7F68CBF59A93}"/>
+                <a16:creationId xmlns:a16="http://schemas.microsoft.com/office/drawing/2014/main" id="{09E90B63-3BB3-4C33-A2E7-93EDC0B86D70}"/>
               </a:ext>
             </a:extLst>
           </p:cNvPr>
@@ -6105,7 +6105,7 @@
                 <a:ea typeface="Arial"/>
                 <a:cs typeface="Arial"/>
               </a:rPr>
-              <a:t>AURA • Track A • 30/09/2026</a:t>
+              <a:t>AURA • Track A • 01/10/2026</a:t>
             </a:r>
           </a:p>
         </p:txBody>
@@ -6115,7 +6115,7 @@
           <p:cNvPr id="45" name="">
             <a:extLst xmlns:a="http://schemas.openxmlformats.org/drawingml/2006/main">
               <a:ext uri="{FF2B5EF4-FFF2-40B4-BE49-F238E27FC236}">
-                <a16:creationId xmlns:a16="http://schemas.microsoft.com/office/drawing/2014/main" id="{955D9374-2590-4D8C-AD78-E586C96579E3}"/>
+                <a16:creationId xmlns:a16="http://schemas.microsoft.com/office/drawing/2014/main" id="{912E1AEA-B9B0-4976-ABF5-EDED3B8CE1FE}"/>
               </a:ext>
             </a:extLst>
           </p:cNvPr>
@@ -6170,7 +6170,7 @@
     </p:spTree>
     <p:extLst>
       <p:ext uri="{BB962C8B-B14F-4D97-AF65-F5344CB8AC3E}">
-        <p14:creationId xmlns:p14="http://schemas.microsoft.com/office/powerpoint/2010/main" val="1752561999"/>
+        <p14:creationId xmlns:p14="http://schemas.microsoft.com/office/powerpoint/2010/main" val="1050134164"/>
       </p:ext>
     </p:extLst>
   </p:cSld>
@@ -6201,7 +6201,7 @@
           <p:cNvPr id="32" name="">
             <a:extLst xmlns:a="http://schemas.openxmlformats.org/drawingml/2006/main">
               <a:ext uri="{FF2B5EF4-FFF2-40B4-BE49-F238E27FC236}">
-                <a16:creationId xmlns:a16="http://schemas.microsoft.com/office/drawing/2014/main" id="{DA09B3A0-1D91-47FA-90B7-EFD7F37F9046}"/>
+                <a16:creationId xmlns:a16="http://schemas.microsoft.com/office/drawing/2014/main" id="{6745D9E7-A059-4AE6-9F23-C85C165790BF}"/>
               </a:ext>
             </a:extLst>
           </p:cNvPr>
@@ -6258,7 +6258,7 @@
           <p:cNvPr id="2" name="">
             <a:extLst xmlns:a="http://schemas.openxmlformats.org/drawingml/2006/main">
               <a:ext uri="{FF2B5EF4-FFF2-40B4-BE49-F238E27FC236}">
-                <a16:creationId xmlns:a16="http://schemas.microsoft.com/office/drawing/2014/main" id="{49352F2A-A939-43D7-AB3E-20541C488B35}"/>
+                <a16:creationId xmlns:a16="http://schemas.microsoft.com/office/drawing/2014/main" id="{1F1224A1-35EF-434E-8089-3C0DBEEFD258}"/>
               </a:ext>
             </a:extLst>
           </p:cNvPr>
@@ -6315,7 +6315,7 @@
           <p:cNvPr id="3" name="">
             <a:extLst xmlns:a="http://schemas.openxmlformats.org/drawingml/2006/main">
               <a:ext uri="{FF2B5EF4-FFF2-40B4-BE49-F238E27FC236}">
-                <a16:creationId xmlns:a16="http://schemas.microsoft.com/office/drawing/2014/main" id="{9C036D46-5E1A-41C1-B572-45A8699E8D5C}"/>
+                <a16:creationId xmlns:a16="http://schemas.microsoft.com/office/drawing/2014/main" id="{8E856892-A6CC-40E4-990C-0801C7D7B59B}"/>
               </a:ext>
             </a:extLst>
           </p:cNvPr>
@@ -6372,7 +6372,7 @@
           <p:cNvPr id="4" name="">
             <a:extLst xmlns:a="http://schemas.openxmlformats.org/drawingml/2006/main">
               <a:ext uri="{FF2B5EF4-FFF2-40B4-BE49-F238E27FC236}">
-                <a16:creationId xmlns:a16="http://schemas.microsoft.com/office/drawing/2014/main" id="{7C912B59-32EC-4BB2-842F-C50592904683}"/>
+                <a16:creationId xmlns:a16="http://schemas.microsoft.com/office/drawing/2014/main" id="{2BD52939-A942-4110-B881-08AE1FD0A6A2}"/>
               </a:ext>
             </a:extLst>
           </p:cNvPr>
@@ -6403,7 +6403,7 @@
           <p:cNvPr id="5" name="">
             <a:extLst xmlns:a="http://schemas.openxmlformats.org/drawingml/2006/main">
               <a:ext uri="{FF2B5EF4-FFF2-40B4-BE49-F238E27FC236}">
-                <a16:creationId xmlns:a16="http://schemas.microsoft.com/office/drawing/2014/main" id="{0856DDD9-33D5-4A96-8576-AD414FBCE0C3}"/>
+                <a16:creationId xmlns:a16="http://schemas.microsoft.com/office/drawing/2014/main" id="{08C9D95A-83F7-4666-9217-1694367ECE50}"/>
               </a:ext>
             </a:extLst>
           </p:cNvPr>
@@ -6438,7 +6438,7 @@
           <p:cNvPr id="6" name="">
             <a:extLst xmlns:a="http://schemas.openxmlformats.org/drawingml/2006/main">
               <a:ext uri="{FF2B5EF4-FFF2-40B4-BE49-F238E27FC236}">
-                <a16:creationId xmlns:a16="http://schemas.microsoft.com/office/drawing/2014/main" id="{3B7631DA-0C60-42B5-91F0-EDBB398B6BC0}"/>
+                <a16:creationId xmlns:a16="http://schemas.microsoft.com/office/drawing/2014/main" id="{B7B0FCCF-AF53-42FD-9797-599F2DE6737F}"/>
               </a:ext>
             </a:extLst>
           </p:cNvPr>
@@ -6502,7 +6502,7 @@
           <p:cNvPr id="7" name="">
             <a:extLst xmlns:a="http://schemas.openxmlformats.org/drawingml/2006/main">
               <a:ext uri="{FF2B5EF4-FFF2-40B4-BE49-F238E27FC236}">
-                <a16:creationId xmlns:a16="http://schemas.microsoft.com/office/drawing/2014/main" id="{630659E9-495A-4849-B489-92DA8497A7AC}"/>
+                <a16:creationId xmlns:a16="http://schemas.microsoft.com/office/drawing/2014/main" id="{3A6A8AAD-BB5A-4411-9951-536E4E828223}"/>
               </a:ext>
             </a:extLst>
           </p:cNvPr>
@@ -6559,7 +6559,7 @@
           <p:cNvPr id="8" name="">
             <a:extLst xmlns:a="http://schemas.openxmlformats.org/drawingml/2006/main">
               <a:ext uri="{FF2B5EF4-FFF2-40B4-BE49-F238E27FC236}">
-                <a16:creationId xmlns:a16="http://schemas.microsoft.com/office/drawing/2014/main" id="{9B6664E4-33E6-4314-9B3F-A31DB0D2DED1}"/>
+                <a16:creationId xmlns:a16="http://schemas.microsoft.com/office/drawing/2014/main" id="{D22B9F17-8726-4632-A379-0F14A900071D}"/>
               </a:ext>
             </a:extLst>
           </p:cNvPr>
@@ -6662,7 +6662,7 @@
           <p:cNvPr id="9" name="">
             <a:extLst xmlns:a="http://schemas.openxmlformats.org/drawingml/2006/main">
               <a:ext uri="{FF2B5EF4-FFF2-40B4-BE49-F238E27FC236}">
-                <a16:creationId xmlns:a16="http://schemas.microsoft.com/office/drawing/2014/main" id="{26CABCE5-5B62-478B-BBDB-418E5F998342}"/>
+                <a16:creationId xmlns:a16="http://schemas.microsoft.com/office/drawing/2014/main" id="{4ABBB5D3-C717-4A0E-83CF-71BAE21EF202}"/>
               </a:ext>
             </a:extLst>
           </p:cNvPr>
@@ -6697,7 +6697,7 @@
           <p:cNvPr id="10" name="">
             <a:extLst xmlns:a="http://schemas.openxmlformats.org/drawingml/2006/main">
               <a:ext uri="{FF2B5EF4-FFF2-40B4-BE49-F238E27FC236}">
-                <a16:creationId xmlns:a16="http://schemas.microsoft.com/office/drawing/2014/main" id="{C44369FD-C591-453F-96E7-CDD0FD097FB9}"/>
+                <a16:creationId xmlns:a16="http://schemas.microsoft.com/office/drawing/2014/main" id="{2BD4CCBE-F333-44A2-88BD-9CB597C23191}"/>
               </a:ext>
             </a:extLst>
           </p:cNvPr>
@@ -6761,7 +6761,7 @@
           <p:cNvPr id="11" name="">
             <a:extLst xmlns:a="http://schemas.openxmlformats.org/drawingml/2006/main">
               <a:ext uri="{FF2B5EF4-FFF2-40B4-BE49-F238E27FC236}">
-                <a16:creationId xmlns:a16="http://schemas.microsoft.com/office/drawing/2014/main" id="{263A9736-222F-47C3-8E8A-8FF130D5BDC2}"/>
+                <a16:creationId xmlns:a16="http://schemas.microsoft.com/office/drawing/2014/main" id="{5420D233-BA36-4BAE-8A31-5BB12479860C}"/>
               </a:ext>
             </a:extLst>
           </p:cNvPr>
@@ -6818,7 +6818,7 @@
           <p:cNvPr id="12" name="">
             <a:extLst xmlns:a="http://schemas.openxmlformats.org/drawingml/2006/main">
               <a:ext uri="{FF2B5EF4-FFF2-40B4-BE49-F238E27FC236}">
-                <a16:creationId xmlns:a16="http://schemas.microsoft.com/office/drawing/2014/main" id="{FFA9AECB-50DA-499D-9B8B-ADF397FCA46A}"/>
+                <a16:creationId xmlns:a16="http://schemas.microsoft.com/office/drawing/2014/main" id="{1D8C96A5-C221-44F2-AA99-E9F056900D35}"/>
               </a:ext>
             </a:extLst>
           </p:cNvPr>
@@ -6921,7 +6921,7 @@
           <p:cNvPr id="13" name="">
             <a:extLst xmlns:a="http://schemas.openxmlformats.org/drawingml/2006/main">
               <a:ext uri="{FF2B5EF4-FFF2-40B4-BE49-F238E27FC236}">
-                <a16:creationId xmlns:a16="http://schemas.microsoft.com/office/drawing/2014/main" id="{CEF97CED-22F7-4C5C-9D58-D62CA0EA1331}"/>
+                <a16:creationId xmlns:a16="http://schemas.microsoft.com/office/drawing/2014/main" id="{6BB9B0CE-6C90-43DF-859D-8D92BF89EC75}"/>
               </a:ext>
             </a:extLst>
           </p:cNvPr>
@@ -6978,7 +6978,7 @@
           <p:cNvPr id="14" name="">
             <a:extLst xmlns:a="http://schemas.openxmlformats.org/drawingml/2006/main">
               <a:ext uri="{FF2B5EF4-FFF2-40B4-BE49-F238E27FC236}">
-                <a16:creationId xmlns:a16="http://schemas.microsoft.com/office/drawing/2014/main" id="{53E1362B-DF3A-4787-BEB4-0419E0044DE1}"/>
+                <a16:creationId xmlns:a16="http://schemas.microsoft.com/office/drawing/2014/main" id="{B8968228-F613-42F9-9E2E-37B8E0289E5E}"/>
               </a:ext>
             </a:extLst>
           </p:cNvPr>
@@ -7013,7 +7013,7 @@
           <p:cNvPr id="15" name="">
             <a:extLst xmlns:a="http://schemas.openxmlformats.org/drawingml/2006/main">
               <a:ext uri="{FF2B5EF4-FFF2-40B4-BE49-F238E27FC236}">
-                <a16:creationId xmlns:a16="http://schemas.microsoft.com/office/drawing/2014/main" id="{4F55FD17-9599-4D76-A926-345BFF084711}"/>
+                <a16:creationId xmlns:a16="http://schemas.microsoft.com/office/drawing/2014/main" id="{C3294B12-D3A1-4E38-99F5-6A33BC09320A}"/>
               </a:ext>
             </a:extLst>
           </p:cNvPr>
@@ -7060,7 +7060,7 @@
                 <a:ea typeface="Arial"/>
                 <a:cs typeface="Arial"/>
               </a:rPr>
-              <a:t>93/93</a:t>
+              <a:t>100/100</a:t>
             </a:r>
           </a:p>
         </p:txBody>
@@ -7070,7 +7070,7 @@
           <p:cNvPr id="16" name="">
             <a:extLst xmlns:a="http://schemas.openxmlformats.org/drawingml/2006/main">
               <a:ext uri="{FF2B5EF4-FFF2-40B4-BE49-F238E27FC236}">
-                <a16:creationId xmlns:a16="http://schemas.microsoft.com/office/drawing/2014/main" id="{E14EF1D7-B80A-4594-89C8-86DBA94A3598}"/>
+                <a16:creationId xmlns:a16="http://schemas.microsoft.com/office/drawing/2014/main" id="{3BCF3E88-2DC6-428C-9BC7-D0981D63DFE3}"/>
               </a:ext>
             </a:extLst>
           </p:cNvPr>
@@ -7127,7 +7127,7 @@
           <p:cNvPr id="17" name="">
             <a:extLst xmlns:a="http://schemas.openxmlformats.org/drawingml/2006/main">
               <a:ext uri="{FF2B5EF4-FFF2-40B4-BE49-F238E27FC236}">
-                <a16:creationId xmlns:a16="http://schemas.microsoft.com/office/drawing/2014/main" id="{42396F11-8A17-45C1-82C9-9F129CF72322}"/>
+                <a16:creationId xmlns:a16="http://schemas.microsoft.com/office/drawing/2014/main" id="{BFDA36CC-19BE-4AE8-8776-6D12C91681BC}"/>
               </a:ext>
             </a:extLst>
           </p:cNvPr>
@@ -7162,7 +7162,7 @@
           <p:cNvPr id="18" name="">
             <a:extLst xmlns:a="http://schemas.openxmlformats.org/drawingml/2006/main">
               <a:ext uri="{FF2B5EF4-FFF2-40B4-BE49-F238E27FC236}">
-                <a16:creationId xmlns:a16="http://schemas.microsoft.com/office/drawing/2014/main" id="{7708888A-A6B9-45A2-A30C-C79BAE57F899}"/>
+                <a16:creationId xmlns:a16="http://schemas.microsoft.com/office/drawing/2014/main" id="{9E3F7CB7-3F59-4C44-82F3-08C88C5C497F}"/>
               </a:ext>
             </a:extLst>
           </p:cNvPr>
@@ -7219,7 +7219,7 @@
           <p:cNvPr id="19" name="">
             <a:extLst xmlns:a="http://schemas.openxmlformats.org/drawingml/2006/main">
               <a:ext uri="{FF2B5EF4-FFF2-40B4-BE49-F238E27FC236}">
-                <a16:creationId xmlns:a16="http://schemas.microsoft.com/office/drawing/2014/main" id="{2C5D17CC-33C3-4BDD-8617-B372D1D973DC}"/>
+                <a16:creationId xmlns:a16="http://schemas.microsoft.com/office/drawing/2014/main" id="{156A9C10-1AD4-4BE3-9361-4AC699FB3B40}"/>
               </a:ext>
             </a:extLst>
           </p:cNvPr>
@@ -7276,7 +7276,7 @@
           <p:cNvPr id="20" name="">
             <a:extLst xmlns:a="http://schemas.openxmlformats.org/drawingml/2006/main">
               <a:ext uri="{FF2B5EF4-FFF2-40B4-BE49-F238E27FC236}">
-                <a16:creationId xmlns:a16="http://schemas.microsoft.com/office/drawing/2014/main" id="{88C69ED6-E63D-48FF-895F-17E898A20253}"/>
+                <a16:creationId xmlns:a16="http://schemas.microsoft.com/office/drawing/2014/main" id="{9579187B-C955-4980-9261-19FCD3D339E5}"/>
               </a:ext>
             </a:extLst>
           </p:cNvPr>
@@ -7311,7 +7311,7 @@
           <p:cNvPr id="21" name="">
             <a:extLst xmlns:a="http://schemas.openxmlformats.org/drawingml/2006/main">
               <a:ext uri="{FF2B5EF4-FFF2-40B4-BE49-F238E27FC236}">
-                <a16:creationId xmlns:a16="http://schemas.microsoft.com/office/drawing/2014/main" id="{72B3F745-F4BE-4163-9856-69F99205F11E}"/>
+                <a16:creationId xmlns:a16="http://schemas.microsoft.com/office/drawing/2014/main" id="{B6E65EF0-0655-4406-B6BB-FF6E172D9BAC}"/>
               </a:ext>
             </a:extLst>
           </p:cNvPr>
@@ -7368,7 +7368,7 @@
           <p:cNvPr id="22" name="">
             <a:extLst xmlns:a="http://schemas.openxmlformats.org/drawingml/2006/main">
               <a:ext uri="{FF2B5EF4-FFF2-40B4-BE49-F238E27FC236}">
-                <a16:creationId xmlns:a16="http://schemas.microsoft.com/office/drawing/2014/main" id="{F9900FB4-1E7F-4E13-9241-5779E15203E4}"/>
+                <a16:creationId xmlns:a16="http://schemas.microsoft.com/office/drawing/2014/main" id="{CCE23FE2-549B-4424-BA44-28634D4EBF87}"/>
               </a:ext>
             </a:extLst>
           </p:cNvPr>
@@ -7425,7 +7425,7 @@
           <p:cNvPr id="23" name="">
             <a:extLst xmlns:a="http://schemas.openxmlformats.org/drawingml/2006/main">
               <a:ext uri="{FF2B5EF4-FFF2-40B4-BE49-F238E27FC236}">
-                <a16:creationId xmlns:a16="http://schemas.microsoft.com/office/drawing/2014/main" id="{24DE3B5D-8232-4B4A-8EDC-7DC9914ED689}"/>
+                <a16:creationId xmlns:a16="http://schemas.microsoft.com/office/drawing/2014/main" id="{5406DD63-D692-43E4-BCCC-F7844721499A}"/>
               </a:ext>
             </a:extLst>
           </p:cNvPr>
@@ -7460,7 +7460,7 @@
           <p:cNvPr id="24" name="">
             <a:extLst xmlns:a="http://schemas.openxmlformats.org/drawingml/2006/main">
               <a:ext uri="{FF2B5EF4-FFF2-40B4-BE49-F238E27FC236}">
-                <a16:creationId xmlns:a16="http://schemas.microsoft.com/office/drawing/2014/main" id="{1DE71A65-1C58-4ED7-B62E-23164182C15E}"/>
+                <a16:creationId xmlns:a16="http://schemas.microsoft.com/office/drawing/2014/main" id="{362B61AD-E7A1-4349-B99E-E1221FCC40F4}"/>
               </a:ext>
             </a:extLst>
           </p:cNvPr>
@@ -7517,7 +7517,7 @@
           <p:cNvPr id="25" name="">
             <a:extLst xmlns:a="http://schemas.openxmlformats.org/drawingml/2006/main">
               <a:ext uri="{FF2B5EF4-FFF2-40B4-BE49-F238E27FC236}">
-                <a16:creationId xmlns:a16="http://schemas.microsoft.com/office/drawing/2014/main" id="{ACF0264F-78A2-4D34-BE94-152C664DAA26}"/>
+                <a16:creationId xmlns:a16="http://schemas.microsoft.com/office/drawing/2014/main" id="{EA73F1B7-AB65-4C2F-8703-2C62BAC241E1}"/>
               </a:ext>
             </a:extLst>
           </p:cNvPr>
@@ -7581,7 +7581,7 @@
           <p:cNvPr id="26" name="">
             <a:extLst xmlns:a="http://schemas.openxmlformats.org/drawingml/2006/main">
               <a:ext uri="{FF2B5EF4-FFF2-40B4-BE49-F238E27FC236}">
-                <a16:creationId xmlns:a16="http://schemas.microsoft.com/office/drawing/2014/main" id="{140FD54F-AF1C-4D8B-9314-FA275CB91059}"/>
+                <a16:creationId xmlns:a16="http://schemas.microsoft.com/office/drawing/2014/main" id="{1294321B-D753-4CF4-92D9-0B1730C992E8}"/>
               </a:ext>
             </a:extLst>
           </p:cNvPr>
@@ -7645,7 +7645,7 @@
           <p:cNvPr id="27" name="">
             <a:extLst xmlns:a="http://schemas.openxmlformats.org/drawingml/2006/main">
               <a:ext uri="{FF2B5EF4-FFF2-40B4-BE49-F238E27FC236}">
-                <a16:creationId xmlns:a16="http://schemas.microsoft.com/office/drawing/2014/main" id="{2765C1CB-3FD7-4003-8167-5EE50E6C33D7}"/>
+                <a16:creationId xmlns:a16="http://schemas.microsoft.com/office/drawing/2014/main" id="{080B1DD2-DB10-4F2A-9FA6-5FA79587EC58}"/>
               </a:ext>
             </a:extLst>
           </p:cNvPr>
@@ -7709,7 +7709,7 @@
           <p:cNvPr id="28" name="">
             <a:extLst xmlns:a="http://schemas.openxmlformats.org/drawingml/2006/main">
               <a:ext uri="{FF2B5EF4-FFF2-40B4-BE49-F238E27FC236}">
-                <a16:creationId xmlns:a16="http://schemas.microsoft.com/office/drawing/2014/main" id="{7CD754EA-07DF-4B34-93A1-D4F60F9E8F73}"/>
+                <a16:creationId xmlns:a16="http://schemas.microsoft.com/office/drawing/2014/main" id="{38A98F28-FB38-4F82-90FE-40089BBAB768}"/>
               </a:ext>
             </a:extLst>
           </p:cNvPr>
@@ -7773,7 +7773,7 @@
           <p:cNvPr id="29" name="">
             <a:extLst xmlns:a="http://schemas.openxmlformats.org/drawingml/2006/main">
               <a:ext uri="{FF2B5EF4-FFF2-40B4-BE49-F238E27FC236}">
-                <a16:creationId xmlns:a16="http://schemas.microsoft.com/office/drawing/2014/main" id="{2D005EB0-5567-4CAA-9A05-F34464DBF8D3}"/>
+                <a16:creationId xmlns:a16="http://schemas.microsoft.com/office/drawing/2014/main" id="{EE048D49-7F53-4CD4-98A3-33EDEBAAB107}"/>
               </a:ext>
             </a:extLst>
           </p:cNvPr>
@@ -7830,7 +7830,7 @@
           <p:cNvPr id="30" name="">
             <a:extLst xmlns:a="http://schemas.openxmlformats.org/drawingml/2006/main">
               <a:ext uri="{FF2B5EF4-FFF2-40B4-BE49-F238E27FC236}">
-                <a16:creationId xmlns:a16="http://schemas.microsoft.com/office/drawing/2014/main" id="{3C4089AC-14CD-4565-9685-ADB6D458F47E}"/>
+                <a16:creationId xmlns:a16="http://schemas.microsoft.com/office/drawing/2014/main" id="{223842FB-36B4-4814-9D73-B7A0A841598A}"/>
               </a:ext>
             </a:extLst>
           </p:cNvPr>
@@ -7877,7 +7877,7 @@
                 <a:ea typeface="Arial"/>
                 <a:cs typeface="Arial"/>
               </a:rPr>
-              <a:t>AURA • Track A • 30/09/2026</a:t>
+              <a:t>AURA • Track A • 01/10/2026</a:t>
             </a:r>
           </a:p>
         </p:txBody>
@@ -7887,7 +7887,7 @@
           <p:cNvPr id="31" name="">
             <a:extLst xmlns:a="http://schemas.openxmlformats.org/drawingml/2006/main">
               <a:ext uri="{FF2B5EF4-FFF2-40B4-BE49-F238E27FC236}">
-                <a16:creationId xmlns:a16="http://schemas.microsoft.com/office/drawing/2014/main" id="{A5AB0C78-0770-4F5A-9183-4A05DE73B68E}"/>
+                <a16:creationId xmlns:a16="http://schemas.microsoft.com/office/drawing/2014/main" id="{758138DA-1E15-409E-993A-241B02FC697B}"/>
               </a:ext>
             </a:extLst>
           </p:cNvPr>
@@ -7942,7 +7942,7 @@
     </p:spTree>
     <p:extLst>
       <p:ext uri="{BB962C8B-B14F-4D97-AF65-F5344CB8AC3E}">
-        <p14:creationId xmlns:p14="http://schemas.microsoft.com/office/powerpoint/2010/main" val="888229003"/>
+        <p14:creationId xmlns:p14="http://schemas.microsoft.com/office/powerpoint/2010/main" val="993980658"/>
       </p:ext>
     </p:extLst>
   </p:cSld>
@@ -7973,7 +7973,7 @@
           <p:cNvPr id="32" name="">
             <a:extLst xmlns:a="http://schemas.openxmlformats.org/drawingml/2006/main">
               <a:ext uri="{FF2B5EF4-FFF2-40B4-BE49-F238E27FC236}">
-                <a16:creationId xmlns:a16="http://schemas.microsoft.com/office/drawing/2014/main" id="{E03C72AA-BF3E-4521-91C7-28A4C3D00BE8}"/>
+                <a16:creationId xmlns:a16="http://schemas.microsoft.com/office/drawing/2014/main" id="{3F6368C2-EF15-4E21-B5B6-9E6950324D2F}"/>
               </a:ext>
             </a:extLst>
           </p:cNvPr>
@@ -8030,7 +8030,7 @@
           <p:cNvPr id="2" name="">
             <a:extLst xmlns:a="http://schemas.openxmlformats.org/drawingml/2006/main">
               <a:ext uri="{FF2B5EF4-FFF2-40B4-BE49-F238E27FC236}">
-                <a16:creationId xmlns:a16="http://schemas.microsoft.com/office/drawing/2014/main" id="{496E9CB4-8C22-4D4B-A365-1A1DBF52A9C7}"/>
+                <a16:creationId xmlns:a16="http://schemas.microsoft.com/office/drawing/2014/main" id="{FD243860-C015-4BD2-BFBD-9D82E6EDAE47}"/>
               </a:ext>
             </a:extLst>
           </p:cNvPr>
@@ -8087,7 +8087,7 @@
           <p:cNvPr id="3" name="">
             <a:extLst xmlns:a="http://schemas.openxmlformats.org/drawingml/2006/main">
               <a:ext uri="{FF2B5EF4-FFF2-40B4-BE49-F238E27FC236}">
-                <a16:creationId xmlns:a16="http://schemas.microsoft.com/office/drawing/2014/main" id="{8AF59173-4645-4C52-8E0D-7C220BF64C55}"/>
+                <a16:creationId xmlns:a16="http://schemas.microsoft.com/office/drawing/2014/main" id="{6A061645-D0D3-4E84-8CFD-DA3EA545803B}"/>
               </a:ext>
             </a:extLst>
           </p:cNvPr>
@@ -8144,7 +8144,7 @@
           <p:cNvPr id="4" name="">
             <a:extLst xmlns:a="http://schemas.openxmlformats.org/drawingml/2006/main">
               <a:ext uri="{FF2B5EF4-FFF2-40B4-BE49-F238E27FC236}">
-                <a16:creationId xmlns:a16="http://schemas.microsoft.com/office/drawing/2014/main" id="{AEDFA333-5055-4A8A-8AAC-85A7CE220586}"/>
+                <a16:creationId xmlns:a16="http://schemas.microsoft.com/office/drawing/2014/main" id="{C61552CA-CC2B-4D1B-B771-E88551FD06F1}"/>
               </a:ext>
             </a:extLst>
           </p:cNvPr>
@@ -8175,7 +8175,7 @@
           <p:cNvPr id="5" name="">
             <a:extLst xmlns:a="http://schemas.openxmlformats.org/drawingml/2006/main">
               <a:ext uri="{FF2B5EF4-FFF2-40B4-BE49-F238E27FC236}">
-                <a16:creationId xmlns:a16="http://schemas.microsoft.com/office/drawing/2014/main" id="{AABB02EC-232F-4DF2-AD4D-F9DD34BF1BFD}"/>
+                <a16:creationId xmlns:a16="http://schemas.microsoft.com/office/drawing/2014/main" id="{25FFE432-E577-4458-B0FB-50C2321443A9}"/>
               </a:ext>
             </a:extLst>
           </p:cNvPr>
@@ -8210,7 +8210,7 @@
           <p:cNvPr id="6" name="">
             <a:extLst xmlns:a="http://schemas.openxmlformats.org/drawingml/2006/main">
               <a:ext uri="{FF2B5EF4-FFF2-40B4-BE49-F238E27FC236}">
-                <a16:creationId xmlns:a16="http://schemas.microsoft.com/office/drawing/2014/main" id="{B584D3C1-235F-41C3-9CC8-F19DD70DA243}"/>
+                <a16:creationId xmlns:a16="http://schemas.microsoft.com/office/drawing/2014/main" id="{04108DC5-DA5D-4531-87C6-EE447B2498A0}"/>
               </a:ext>
             </a:extLst>
           </p:cNvPr>
@@ -8274,7 +8274,7 @@
           <p:cNvPr id="7" name="">
             <a:extLst xmlns:a="http://schemas.openxmlformats.org/drawingml/2006/main">
               <a:ext uri="{FF2B5EF4-FFF2-40B4-BE49-F238E27FC236}">
-                <a16:creationId xmlns:a16="http://schemas.microsoft.com/office/drawing/2014/main" id="{1327D169-E558-4AEB-8BCE-EC312702A2CE}"/>
+                <a16:creationId xmlns:a16="http://schemas.microsoft.com/office/drawing/2014/main" id="{5DE598B2-A31E-4743-BFF6-DA106CDB4603}"/>
               </a:ext>
             </a:extLst>
           </p:cNvPr>
@@ -8331,7 +8331,7 @@
           <p:cNvPr id="8" name="">
             <a:extLst xmlns:a="http://schemas.openxmlformats.org/drawingml/2006/main">
               <a:ext uri="{FF2B5EF4-FFF2-40B4-BE49-F238E27FC236}">
-                <a16:creationId xmlns:a16="http://schemas.microsoft.com/office/drawing/2014/main" id="{5126B025-08AF-4C0F-B4D7-E66995CA0945}"/>
+                <a16:creationId xmlns:a16="http://schemas.microsoft.com/office/drawing/2014/main" id="{5B1654BB-3B6D-43AD-81E4-C55A328A30D9}"/>
               </a:ext>
             </a:extLst>
           </p:cNvPr>
@@ -8362,7 +8362,7 @@
           <p:cNvPr id="9" name="">
             <a:extLst xmlns:a="http://schemas.openxmlformats.org/drawingml/2006/main">
               <a:ext uri="{FF2B5EF4-FFF2-40B4-BE49-F238E27FC236}">
-                <a16:creationId xmlns:a16="http://schemas.microsoft.com/office/drawing/2014/main" id="{EF6E67E1-CA2E-4579-B2F4-AE19AB0C70E2}"/>
+                <a16:creationId xmlns:a16="http://schemas.microsoft.com/office/drawing/2014/main" id="{9128CB24-E441-46FA-8C14-775BFB78A865}"/>
               </a:ext>
             </a:extLst>
           </p:cNvPr>
@@ -8397,7 +8397,7 @@
           <p:cNvPr id="10" name="">
             <a:extLst xmlns:a="http://schemas.openxmlformats.org/drawingml/2006/main">
               <a:ext uri="{FF2B5EF4-FFF2-40B4-BE49-F238E27FC236}">
-                <a16:creationId xmlns:a16="http://schemas.microsoft.com/office/drawing/2014/main" id="{46D8B4D9-1DF7-4341-A409-97F76FB69A44}"/>
+                <a16:creationId xmlns:a16="http://schemas.microsoft.com/office/drawing/2014/main" id="{E45F118A-4D56-42BB-9E01-138D4DB440F9}"/>
               </a:ext>
             </a:extLst>
           </p:cNvPr>
@@ -8461,7 +8461,7 @@
           <p:cNvPr id="11" name="">
             <a:extLst xmlns:a="http://schemas.openxmlformats.org/drawingml/2006/main">
               <a:ext uri="{FF2B5EF4-FFF2-40B4-BE49-F238E27FC236}">
-                <a16:creationId xmlns:a16="http://schemas.microsoft.com/office/drawing/2014/main" id="{1D3986FC-EB26-43F1-A4A3-D2645BBF669D}"/>
+                <a16:creationId xmlns:a16="http://schemas.microsoft.com/office/drawing/2014/main" id="{5A544300-559B-42A1-95F0-379734A95ED3}"/>
               </a:ext>
             </a:extLst>
           </p:cNvPr>
@@ -8518,7 +8518,7 @@
           <p:cNvPr id="12" name="">
             <a:extLst xmlns:a="http://schemas.openxmlformats.org/drawingml/2006/main">
               <a:ext uri="{FF2B5EF4-FFF2-40B4-BE49-F238E27FC236}">
-                <a16:creationId xmlns:a16="http://schemas.microsoft.com/office/drawing/2014/main" id="{7D3F566F-C264-4125-B3C5-E35541EFBAE7}"/>
+                <a16:creationId xmlns:a16="http://schemas.microsoft.com/office/drawing/2014/main" id="{C1036A00-AF41-4069-8F3A-B945CCA02A41}"/>
               </a:ext>
             </a:extLst>
           </p:cNvPr>
@@ -8549,7 +8549,7 @@
           <p:cNvPr id="13" name="">
             <a:extLst xmlns:a="http://schemas.openxmlformats.org/drawingml/2006/main">
               <a:ext uri="{FF2B5EF4-FFF2-40B4-BE49-F238E27FC236}">
-                <a16:creationId xmlns:a16="http://schemas.microsoft.com/office/drawing/2014/main" id="{5E271AC8-57AE-4392-BE2E-82E06FF1EDEF}"/>
+                <a16:creationId xmlns:a16="http://schemas.microsoft.com/office/drawing/2014/main" id="{D7397FEE-7AE7-4D65-8884-63C3252D6318}"/>
               </a:ext>
             </a:extLst>
           </p:cNvPr>
@@ -8584,7 +8584,7 @@
           <p:cNvPr id="14" name="">
             <a:extLst xmlns:a="http://schemas.openxmlformats.org/drawingml/2006/main">
               <a:ext uri="{FF2B5EF4-FFF2-40B4-BE49-F238E27FC236}">
-                <a16:creationId xmlns:a16="http://schemas.microsoft.com/office/drawing/2014/main" id="{78818176-C619-4424-9B90-F66F300513BF}"/>
+                <a16:creationId xmlns:a16="http://schemas.microsoft.com/office/drawing/2014/main" id="{CD617055-C90B-473C-AE2B-F0F74D1A30B5}"/>
               </a:ext>
             </a:extLst>
           </p:cNvPr>
@@ -8648,7 +8648,7 @@
           <p:cNvPr id="15" name="">
             <a:extLst xmlns:a="http://schemas.openxmlformats.org/drawingml/2006/main">
               <a:ext uri="{FF2B5EF4-FFF2-40B4-BE49-F238E27FC236}">
-                <a16:creationId xmlns:a16="http://schemas.microsoft.com/office/drawing/2014/main" id="{CF6074B0-B305-4EBB-8D47-CB0ABA8DEB70}"/>
+                <a16:creationId xmlns:a16="http://schemas.microsoft.com/office/drawing/2014/main" id="{4CD1F8CC-1FA3-4261-88E0-3849D64BE857}"/>
               </a:ext>
             </a:extLst>
           </p:cNvPr>
@@ -8705,7 +8705,7 @@
           <p:cNvPr id="16" name="">
             <a:extLst xmlns:a="http://schemas.openxmlformats.org/drawingml/2006/main">
               <a:ext uri="{FF2B5EF4-FFF2-40B4-BE49-F238E27FC236}">
-                <a16:creationId xmlns:a16="http://schemas.microsoft.com/office/drawing/2014/main" id="{08B62DAF-9AAA-47C7-9E3B-4874679928B4}"/>
+                <a16:creationId xmlns:a16="http://schemas.microsoft.com/office/drawing/2014/main" id="{0CCAEF49-50E2-4B4C-BB16-4BDCA577D48D}"/>
               </a:ext>
             </a:extLst>
           </p:cNvPr>
@@ -8736,7 +8736,7 @@
           <p:cNvPr id="17" name="">
             <a:extLst xmlns:a="http://schemas.openxmlformats.org/drawingml/2006/main">
               <a:ext uri="{FF2B5EF4-FFF2-40B4-BE49-F238E27FC236}">
-                <a16:creationId xmlns:a16="http://schemas.microsoft.com/office/drawing/2014/main" id="{2A6FFF23-71F8-4D7C-9722-E6EC6AEBF17E}"/>
+                <a16:creationId xmlns:a16="http://schemas.microsoft.com/office/drawing/2014/main" id="{7C99B210-6E23-4464-BFF3-55CF26B840A5}"/>
               </a:ext>
             </a:extLst>
           </p:cNvPr>
@@ -8771,7 +8771,7 @@
           <p:cNvPr id="18" name="">
             <a:extLst xmlns:a="http://schemas.openxmlformats.org/drawingml/2006/main">
               <a:ext uri="{FF2B5EF4-FFF2-40B4-BE49-F238E27FC236}">
-                <a16:creationId xmlns:a16="http://schemas.microsoft.com/office/drawing/2014/main" id="{366E79B7-07E4-449F-B36A-5126C49370BE}"/>
+                <a16:creationId xmlns:a16="http://schemas.microsoft.com/office/drawing/2014/main" id="{F954BE21-13B4-46F6-8CC6-3D098F39A5CF}"/>
               </a:ext>
             </a:extLst>
           </p:cNvPr>
@@ -8835,7 +8835,7 @@
           <p:cNvPr id="19" name="">
             <a:extLst xmlns:a="http://schemas.openxmlformats.org/drawingml/2006/main">
               <a:ext uri="{FF2B5EF4-FFF2-40B4-BE49-F238E27FC236}">
-                <a16:creationId xmlns:a16="http://schemas.microsoft.com/office/drawing/2014/main" id="{B310DD9D-B154-4B37-ADCF-7C41A3074D8E}"/>
+                <a16:creationId xmlns:a16="http://schemas.microsoft.com/office/drawing/2014/main" id="{5CF71D95-FCB5-4F21-954E-D08116B31CD9}"/>
               </a:ext>
             </a:extLst>
           </p:cNvPr>
@@ -8892,7 +8892,7 @@
           <p:cNvPr id="20" name="">
             <a:extLst xmlns:a="http://schemas.openxmlformats.org/drawingml/2006/main">
               <a:ext uri="{FF2B5EF4-FFF2-40B4-BE49-F238E27FC236}">
-                <a16:creationId xmlns:a16="http://schemas.microsoft.com/office/drawing/2014/main" id="{F3FBB813-C3CA-4703-9AA3-954CF3D0E630}"/>
+                <a16:creationId xmlns:a16="http://schemas.microsoft.com/office/drawing/2014/main" id="{A90D1F6E-B092-4D6C-9CDE-B8BB9151CAB9}"/>
               </a:ext>
             </a:extLst>
           </p:cNvPr>
@@ -8927,7 +8927,7 @@
           <p:cNvPr id="21" name="">
             <a:extLst xmlns:a="http://schemas.openxmlformats.org/drawingml/2006/main">
               <a:ext uri="{FF2B5EF4-FFF2-40B4-BE49-F238E27FC236}">
-                <a16:creationId xmlns:a16="http://schemas.microsoft.com/office/drawing/2014/main" id="{D2DE82D0-5F54-4F12-A583-4C18EFE0ED11}"/>
+                <a16:creationId xmlns:a16="http://schemas.microsoft.com/office/drawing/2014/main" id="{AE15003E-E095-4B84-B253-78745D5DA40E}"/>
               </a:ext>
             </a:extLst>
           </p:cNvPr>
@@ -8984,7 +8984,7 @@
           <p:cNvPr id="22" name="">
             <a:extLst xmlns:a="http://schemas.openxmlformats.org/drawingml/2006/main">
               <a:ext uri="{FF2B5EF4-FFF2-40B4-BE49-F238E27FC236}">
-                <a16:creationId xmlns:a16="http://schemas.microsoft.com/office/drawing/2014/main" id="{126B9420-2999-40A4-9E4A-9EBBC0823D53}"/>
+                <a16:creationId xmlns:a16="http://schemas.microsoft.com/office/drawing/2014/main" id="{C5EECD3A-CF6D-41F6-9F60-CE031713852A}"/>
               </a:ext>
             </a:extLst>
           </p:cNvPr>
@@ -9041,7 +9041,7 @@
           <p:cNvPr id="23" name="">
             <a:extLst xmlns:a="http://schemas.openxmlformats.org/drawingml/2006/main">
               <a:ext uri="{FF2B5EF4-FFF2-40B4-BE49-F238E27FC236}">
-                <a16:creationId xmlns:a16="http://schemas.microsoft.com/office/drawing/2014/main" id="{6B1A3E90-A481-4BB6-AF97-D99E7E756135}"/>
+                <a16:creationId xmlns:a16="http://schemas.microsoft.com/office/drawing/2014/main" id="{152B6D70-3573-4627-A8F9-5B28AD7F5F4F}"/>
               </a:ext>
             </a:extLst>
           </p:cNvPr>
@@ -9076,7 +9076,7 @@
           <p:cNvPr id="24" name="">
             <a:extLst xmlns:a="http://schemas.openxmlformats.org/drawingml/2006/main">
               <a:ext uri="{FF2B5EF4-FFF2-40B4-BE49-F238E27FC236}">
-                <a16:creationId xmlns:a16="http://schemas.microsoft.com/office/drawing/2014/main" id="{CE6895B6-F7F3-4520-9C96-301AED347870}"/>
+                <a16:creationId xmlns:a16="http://schemas.microsoft.com/office/drawing/2014/main" id="{C839FCF7-8EBD-4FC9-B229-2D96584A96BB}"/>
               </a:ext>
             </a:extLst>
           </p:cNvPr>
@@ -9140,7 +9140,7 @@
           <p:cNvPr id="25" name="">
             <a:extLst xmlns:a="http://schemas.openxmlformats.org/drawingml/2006/main">
               <a:ext uri="{FF2B5EF4-FFF2-40B4-BE49-F238E27FC236}">
-                <a16:creationId xmlns:a16="http://schemas.microsoft.com/office/drawing/2014/main" id="{20AD7814-DD54-4377-B028-FBDB2F2771CC}"/>
+                <a16:creationId xmlns:a16="http://schemas.microsoft.com/office/drawing/2014/main" id="{735EAC37-CEAE-4294-B6A5-1620A9D9679E}"/>
               </a:ext>
             </a:extLst>
           </p:cNvPr>
@@ -9266,7 +9266,7 @@
           <p:cNvPr id="26" name="">
             <a:extLst xmlns:a="http://schemas.openxmlformats.org/drawingml/2006/main">
               <a:ext uri="{FF2B5EF4-FFF2-40B4-BE49-F238E27FC236}">
-                <a16:creationId xmlns:a16="http://schemas.microsoft.com/office/drawing/2014/main" id="{014175E2-8D50-49F6-A8BA-AFD981DC2810}"/>
+                <a16:creationId xmlns:a16="http://schemas.microsoft.com/office/drawing/2014/main" id="{E5487ECA-6C22-43BB-A57B-D4C53FC41DB1}"/>
               </a:ext>
             </a:extLst>
           </p:cNvPr>
@@ -9301,7 +9301,7 @@
           <p:cNvPr id="27" name="">
             <a:extLst xmlns:a="http://schemas.openxmlformats.org/drawingml/2006/main">
               <a:ext uri="{FF2B5EF4-FFF2-40B4-BE49-F238E27FC236}">
-                <a16:creationId xmlns:a16="http://schemas.microsoft.com/office/drawing/2014/main" id="{448FBD63-1A4A-4F80-AF45-5901A2FEF706}"/>
+                <a16:creationId xmlns:a16="http://schemas.microsoft.com/office/drawing/2014/main" id="{BB3CCCEE-9568-4A6D-BD5C-9AEC67A5EE93}"/>
               </a:ext>
             </a:extLst>
           </p:cNvPr>
@@ -9365,7 +9365,7 @@
           <p:cNvPr id="28" name="">
             <a:extLst xmlns:a="http://schemas.openxmlformats.org/drawingml/2006/main">
               <a:ext uri="{FF2B5EF4-FFF2-40B4-BE49-F238E27FC236}">
-                <a16:creationId xmlns:a16="http://schemas.microsoft.com/office/drawing/2014/main" id="{54E9A6F8-C678-4727-B0D0-573E93051793}"/>
+                <a16:creationId xmlns:a16="http://schemas.microsoft.com/office/drawing/2014/main" id="{FA609570-0626-4AD8-A510-F08C21F1C44C}"/>
               </a:ext>
             </a:extLst>
           </p:cNvPr>
@@ -9468,7 +9468,7 @@
           <p:cNvPr id="29" name="">
             <a:extLst xmlns:a="http://schemas.openxmlformats.org/drawingml/2006/main">
               <a:ext uri="{FF2B5EF4-FFF2-40B4-BE49-F238E27FC236}">
-                <a16:creationId xmlns:a16="http://schemas.microsoft.com/office/drawing/2014/main" id="{9DAE7460-35EE-497B-9250-FE742A12E536}"/>
+                <a16:creationId xmlns:a16="http://schemas.microsoft.com/office/drawing/2014/main" id="{17D64F9C-D8C7-4603-958F-60128511AECB}"/>
               </a:ext>
             </a:extLst>
           </p:cNvPr>
@@ -9548,7 +9548,7 @@
           <p:cNvPr id="30" name="">
             <a:extLst xmlns:a="http://schemas.openxmlformats.org/drawingml/2006/main">
               <a:ext uri="{FF2B5EF4-FFF2-40B4-BE49-F238E27FC236}">
-                <a16:creationId xmlns:a16="http://schemas.microsoft.com/office/drawing/2014/main" id="{2DD09E61-7B60-4BCC-A115-23EAF50CC86D}"/>
+                <a16:creationId xmlns:a16="http://schemas.microsoft.com/office/drawing/2014/main" id="{655B58D9-CDD8-4437-BC01-3F9761AB628A}"/>
               </a:ext>
             </a:extLst>
           </p:cNvPr>
@@ -9595,7 +9595,7 @@
                 <a:ea typeface="Arial"/>
                 <a:cs typeface="Arial"/>
               </a:rPr>
-              <a:t>AURA • Track A • 30/09/2026</a:t>
+              <a:t>AURA • Track A • 01/10/2026</a:t>
             </a:r>
           </a:p>
         </p:txBody>
@@ -9605,7 +9605,7 @@
           <p:cNvPr id="31" name="">
             <a:extLst xmlns:a="http://schemas.openxmlformats.org/drawingml/2006/main">
               <a:ext uri="{FF2B5EF4-FFF2-40B4-BE49-F238E27FC236}">
-                <a16:creationId xmlns:a16="http://schemas.microsoft.com/office/drawing/2014/main" id="{22BE339F-F67B-43C2-87BA-DBF5E2AF05E2}"/>
+                <a16:creationId xmlns:a16="http://schemas.microsoft.com/office/drawing/2014/main" id="{4C916219-4E0C-422E-9530-EE117A39F52D}"/>
               </a:ext>
             </a:extLst>
           </p:cNvPr>
@@ -9660,7 +9660,7 @@
     </p:spTree>
     <p:extLst>
       <p:ext uri="{BB962C8B-B14F-4D97-AF65-F5344CB8AC3E}">
-        <p14:creationId xmlns:p14="http://schemas.microsoft.com/office/powerpoint/2010/main" val="820372696"/>
+        <p14:creationId xmlns:p14="http://schemas.microsoft.com/office/powerpoint/2010/main" val="617991746"/>
       </p:ext>
     </p:extLst>
   </p:cSld>
@@ -9691,7 +9691,7 @@
           <p:cNvPr id="36" name="">
             <a:extLst xmlns:a="http://schemas.openxmlformats.org/drawingml/2006/main">
               <a:ext uri="{FF2B5EF4-FFF2-40B4-BE49-F238E27FC236}">
-                <a16:creationId xmlns:a16="http://schemas.microsoft.com/office/drawing/2014/main" id="{2EF3EB0F-6976-4876-895E-DCC343AE3E8F}"/>
+                <a16:creationId xmlns:a16="http://schemas.microsoft.com/office/drawing/2014/main" id="{7DF26C60-258A-465D-ACF7-8A1B63A1F882}"/>
               </a:ext>
             </a:extLst>
           </p:cNvPr>
@@ -9748,7 +9748,7 @@
           <p:cNvPr id="2" name="">
             <a:extLst xmlns:a="http://schemas.openxmlformats.org/drawingml/2006/main">
               <a:ext uri="{FF2B5EF4-FFF2-40B4-BE49-F238E27FC236}">
-                <a16:creationId xmlns:a16="http://schemas.microsoft.com/office/drawing/2014/main" id="{D9E8CB3A-9B8B-418F-9E59-11A5848572D4}"/>
+                <a16:creationId xmlns:a16="http://schemas.microsoft.com/office/drawing/2014/main" id="{B1AD1E0C-A595-4257-A004-950CEC529C6F}"/>
               </a:ext>
             </a:extLst>
           </p:cNvPr>
@@ -9805,7 +9805,7 @@
           <p:cNvPr id="3" name="">
             <a:extLst xmlns:a="http://schemas.openxmlformats.org/drawingml/2006/main">
               <a:ext uri="{FF2B5EF4-FFF2-40B4-BE49-F238E27FC236}">
-                <a16:creationId xmlns:a16="http://schemas.microsoft.com/office/drawing/2014/main" id="{6490C603-C39D-4EEC-B2D3-861F4197D0F3}"/>
+                <a16:creationId xmlns:a16="http://schemas.microsoft.com/office/drawing/2014/main" id="{E7C48F8A-F033-4B18-9A30-F9B9EA4060E1}"/>
               </a:ext>
             </a:extLst>
           </p:cNvPr>
@@ -9862,7 +9862,7 @@
           <p:cNvPr id="4" name="">
             <a:extLst xmlns:a="http://schemas.openxmlformats.org/drawingml/2006/main">
               <a:ext uri="{FF2B5EF4-FFF2-40B4-BE49-F238E27FC236}">
-                <a16:creationId xmlns:a16="http://schemas.microsoft.com/office/drawing/2014/main" id="{534C036C-640B-4350-ABC8-1F7543DCD76E}"/>
+                <a16:creationId xmlns:a16="http://schemas.microsoft.com/office/drawing/2014/main" id="{C0BBE817-1A09-4535-9A2A-E2377C649C21}"/>
               </a:ext>
             </a:extLst>
           </p:cNvPr>
@@ -9893,7 +9893,7 @@
           <p:cNvPr id="5" name="">
             <a:extLst xmlns:a="http://schemas.openxmlformats.org/drawingml/2006/main">
               <a:ext uri="{FF2B5EF4-FFF2-40B4-BE49-F238E27FC236}">
-                <a16:creationId xmlns:a16="http://schemas.microsoft.com/office/drawing/2014/main" id="{FB93B601-CEA0-4507-BF61-3E1C9CE7E1DB}"/>
+                <a16:creationId xmlns:a16="http://schemas.microsoft.com/office/drawing/2014/main" id="{42C1E4F0-08FF-483E-8634-3692E6F2598B}"/>
               </a:ext>
             </a:extLst>
           </p:cNvPr>
@@ -9928,7 +9928,7 @@
           <p:cNvPr id="6" name="">
             <a:extLst xmlns:a="http://schemas.openxmlformats.org/drawingml/2006/main">
               <a:ext uri="{FF2B5EF4-FFF2-40B4-BE49-F238E27FC236}">
-                <a16:creationId xmlns:a16="http://schemas.microsoft.com/office/drawing/2014/main" id="{33369D57-5868-4339-B5D7-14A2AC12A1BE}"/>
+                <a16:creationId xmlns:a16="http://schemas.microsoft.com/office/drawing/2014/main" id="{0DAC9EAB-CD9B-49C7-90E2-A46749E4D7BD}"/>
               </a:ext>
             </a:extLst>
           </p:cNvPr>
@@ -9992,7 +9992,7 @@
           <p:cNvPr id="7" name="">
             <a:extLst xmlns:a="http://schemas.openxmlformats.org/drawingml/2006/main">
               <a:ext uri="{FF2B5EF4-FFF2-40B4-BE49-F238E27FC236}">
-                <a16:creationId xmlns:a16="http://schemas.microsoft.com/office/drawing/2014/main" id="{61029A50-7FEB-42F0-985D-CF2C33D6714C}"/>
+                <a16:creationId xmlns:a16="http://schemas.microsoft.com/office/drawing/2014/main" id="{38611B57-7077-45DC-A2B0-61AF90CE9243}"/>
               </a:ext>
             </a:extLst>
           </p:cNvPr>
@@ -10049,7 +10049,7 @@
           <p:cNvPr id="8" name="">
             <a:extLst xmlns:a="http://schemas.openxmlformats.org/drawingml/2006/main">
               <a:ext uri="{FF2B5EF4-FFF2-40B4-BE49-F238E27FC236}">
-                <a16:creationId xmlns:a16="http://schemas.microsoft.com/office/drawing/2014/main" id="{BE3448DA-4B09-493E-AF31-31F394475F52}"/>
+                <a16:creationId xmlns:a16="http://schemas.microsoft.com/office/drawing/2014/main" id="{62CCFBB8-87C7-458A-A467-21C91AAE2A92}"/>
               </a:ext>
             </a:extLst>
           </p:cNvPr>
@@ -10084,7 +10084,7 @@
           <p:cNvPr id="9" name="">
             <a:extLst xmlns:a="http://schemas.openxmlformats.org/drawingml/2006/main">
               <a:ext uri="{FF2B5EF4-FFF2-40B4-BE49-F238E27FC236}">
-                <a16:creationId xmlns:a16="http://schemas.microsoft.com/office/drawing/2014/main" id="{49190381-12D6-46EA-B0C9-C1AD55F2336C}"/>
+                <a16:creationId xmlns:a16="http://schemas.microsoft.com/office/drawing/2014/main" id="{BDA28040-4834-453E-B17C-8DE56331480C}"/>
               </a:ext>
             </a:extLst>
           </p:cNvPr>
@@ -10148,7 +10148,7 @@
           <p:cNvPr id="10" name="">
             <a:extLst xmlns:a="http://schemas.openxmlformats.org/drawingml/2006/main">
               <a:ext uri="{FF2B5EF4-FFF2-40B4-BE49-F238E27FC236}">
-                <a16:creationId xmlns:a16="http://schemas.microsoft.com/office/drawing/2014/main" id="{2B159FBD-A456-4D04-970F-772D39DB691C}"/>
+                <a16:creationId xmlns:a16="http://schemas.microsoft.com/office/drawing/2014/main" id="{A682FD07-F12B-43AA-92E9-FD90CF0BDB9F}"/>
               </a:ext>
             </a:extLst>
           </p:cNvPr>
@@ -10205,7 +10205,7 @@
           <p:cNvPr id="11" name="">
             <a:extLst xmlns:a="http://schemas.openxmlformats.org/drawingml/2006/main">
               <a:ext uri="{FF2B5EF4-FFF2-40B4-BE49-F238E27FC236}">
-                <a16:creationId xmlns:a16="http://schemas.microsoft.com/office/drawing/2014/main" id="{F2163021-83C0-4C50-AD7B-F4EDFC2D72DD}"/>
+                <a16:creationId xmlns:a16="http://schemas.microsoft.com/office/drawing/2014/main" id="{5463DC74-5B15-434A-AA57-D7E3917880CE}"/>
               </a:ext>
             </a:extLst>
           </p:cNvPr>
@@ -10240,7 +10240,7 @@
           <p:cNvPr id="12" name="">
             <a:extLst xmlns:a="http://schemas.openxmlformats.org/drawingml/2006/main">
               <a:ext uri="{FF2B5EF4-FFF2-40B4-BE49-F238E27FC236}">
-                <a16:creationId xmlns:a16="http://schemas.microsoft.com/office/drawing/2014/main" id="{DBEC324A-8DBF-4515-874E-0C6A0A085CBB}"/>
+                <a16:creationId xmlns:a16="http://schemas.microsoft.com/office/drawing/2014/main" id="{66AC0F4A-E306-4FDB-A603-A880BAA582C8}"/>
               </a:ext>
             </a:extLst>
           </p:cNvPr>
@@ -10304,7 +10304,7 @@
           <p:cNvPr id="13" name="">
             <a:extLst xmlns:a="http://schemas.openxmlformats.org/drawingml/2006/main">
               <a:ext uri="{FF2B5EF4-FFF2-40B4-BE49-F238E27FC236}">
-                <a16:creationId xmlns:a16="http://schemas.microsoft.com/office/drawing/2014/main" id="{94DE0B72-C843-49EB-905E-D16D50B9CB78}"/>
+                <a16:creationId xmlns:a16="http://schemas.microsoft.com/office/drawing/2014/main" id="{F1B6907A-0C26-490F-BF3F-F3E8B040A6C7}"/>
               </a:ext>
             </a:extLst>
           </p:cNvPr>
@@ -10361,7 +10361,7 @@
           <p:cNvPr id="14" name="">
             <a:extLst xmlns:a="http://schemas.openxmlformats.org/drawingml/2006/main">
               <a:ext uri="{FF2B5EF4-FFF2-40B4-BE49-F238E27FC236}">
-                <a16:creationId xmlns:a16="http://schemas.microsoft.com/office/drawing/2014/main" id="{73BFFBC4-F856-4424-B731-B7083CD145C1}"/>
+                <a16:creationId xmlns:a16="http://schemas.microsoft.com/office/drawing/2014/main" id="{4705322D-33D0-4535-94D0-71260F8664E4}"/>
               </a:ext>
             </a:extLst>
           </p:cNvPr>
@@ -10396,7 +10396,7 @@
           <p:cNvPr id="15" name="">
             <a:extLst xmlns:a="http://schemas.openxmlformats.org/drawingml/2006/main">
               <a:ext uri="{FF2B5EF4-FFF2-40B4-BE49-F238E27FC236}">
-                <a16:creationId xmlns:a16="http://schemas.microsoft.com/office/drawing/2014/main" id="{A05A5919-39FF-4CA5-816C-16C67349E113}"/>
+                <a16:creationId xmlns:a16="http://schemas.microsoft.com/office/drawing/2014/main" id="{78E760B5-EAFF-48BC-B8B5-14DE1DDF754D}"/>
               </a:ext>
             </a:extLst>
           </p:cNvPr>
@@ -10460,7 +10460,7 @@
           <p:cNvPr id="16" name="">
             <a:extLst xmlns:a="http://schemas.openxmlformats.org/drawingml/2006/main">
               <a:ext uri="{FF2B5EF4-FFF2-40B4-BE49-F238E27FC236}">
-                <a16:creationId xmlns:a16="http://schemas.microsoft.com/office/drawing/2014/main" id="{13437057-F959-4FB8-8919-F7BE1F7AF80C}"/>
+                <a16:creationId xmlns:a16="http://schemas.microsoft.com/office/drawing/2014/main" id="{C09A2A2C-FB2F-4AF8-B6F9-6297D14E37E9}"/>
               </a:ext>
             </a:extLst>
           </p:cNvPr>
@@ -10517,7 +10517,7 @@
           <p:cNvPr id="17" name="">
             <a:extLst xmlns:a="http://schemas.openxmlformats.org/drawingml/2006/main">
               <a:ext uri="{FF2B5EF4-FFF2-40B4-BE49-F238E27FC236}">
-                <a16:creationId xmlns:a16="http://schemas.microsoft.com/office/drawing/2014/main" id="{7E688343-32EE-4672-A522-A0465790A096}"/>
+                <a16:creationId xmlns:a16="http://schemas.microsoft.com/office/drawing/2014/main" id="{88970752-45F6-4DA4-909C-6EA275751A6C}"/>
               </a:ext>
             </a:extLst>
           </p:cNvPr>
@@ -10552,7 +10552,7 @@
           <p:cNvPr id="18" name="">
             <a:extLst xmlns:a="http://schemas.openxmlformats.org/drawingml/2006/main">
               <a:ext uri="{FF2B5EF4-FFF2-40B4-BE49-F238E27FC236}">
-                <a16:creationId xmlns:a16="http://schemas.microsoft.com/office/drawing/2014/main" id="{C5CB8449-9E81-424E-ABC9-ECE67774BB5E}"/>
+                <a16:creationId xmlns:a16="http://schemas.microsoft.com/office/drawing/2014/main" id="{0E11A681-AD95-4426-92E6-AD4FCEF3181C}"/>
               </a:ext>
             </a:extLst>
           </p:cNvPr>
@@ -10616,7 +10616,7 @@
           <p:cNvPr id="19" name="">
             <a:extLst xmlns:a="http://schemas.openxmlformats.org/drawingml/2006/main">
               <a:ext uri="{FF2B5EF4-FFF2-40B4-BE49-F238E27FC236}">
-                <a16:creationId xmlns:a16="http://schemas.microsoft.com/office/drawing/2014/main" id="{A3258AA8-AF5D-4884-A8B0-B3C031AA9440}"/>
+                <a16:creationId xmlns:a16="http://schemas.microsoft.com/office/drawing/2014/main" id="{66146B86-4C1C-410B-9FFE-5713568617C0}"/>
               </a:ext>
             </a:extLst>
           </p:cNvPr>
@@ -10673,7 +10673,7 @@
           <p:cNvPr id="20" name="">
             <a:extLst xmlns:a="http://schemas.openxmlformats.org/drawingml/2006/main">
               <a:ext uri="{FF2B5EF4-FFF2-40B4-BE49-F238E27FC236}">
-                <a16:creationId xmlns:a16="http://schemas.microsoft.com/office/drawing/2014/main" id="{5CD079F9-CDBA-4643-BCBC-B76DEBD68938}"/>
+                <a16:creationId xmlns:a16="http://schemas.microsoft.com/office/drawing/2014/main" id="{CCDDBDE9-E973-479D-9587-B10CA3B91AEE}"/>
               </a:ext>
             </a:extLst>
           </p:cNvPr>
@@ -10708,7 +10708,7 @@
           <p:cNvPr id="21" name="">
             <a:extLst xmlns:a="http://schemas.openxmlformats.org/drawingml/2006/main">
               <a:ext uri="{FF2B5EF4-FFF2-40B4-BE49-F238E27FC236}">
-                <a16:creationId xmlns:a16="http://schemas.microsoft.com/office/drawing/2014/main" id="{F95C329A-B51E-4134-B208-72B4E7C18463}"/>
+                <a16:creationId xmlns:a16="http://schemas.microsoft.com/office/drawing/2014/main" id="{E22336FD-ED4F-43D5-B800-47957A12A609}"/>
               </a:ext>
             </a:extLst>
           </p:cNvPr>
@@ -10765,7 +10765,7 @@
           <p:cNvPr id="22" name="">
             <a:extLst xmlns:a="http://schemas.openxmlformats.org/drawingml/2006/main">
               <a:ext uri="{FF2B5EF4-FFF2-40B4-BE49-F238E27FC236}">
-                <a16:creationId xmlns:a16="http://schemas.microsoft.com/office/drawing/2014/main" id="{B4C9EAFC-D275-44DE-8A61-EC2CA1898EA4}"/>
+                <a16:creationId xmlns:a16="http://schemas.microsoft.com/office/drawing/2014/main" id="{030156C3-97B7-4BB7-84F1-C4E88202B565}"/>
               </a:ext>
             </a:extLst>
           </p:cNvPr>
@@ -10829,7 +10829,7 @@
           <p:cNvPr id="23" name="">
             <a:extLst xmlns:a="http://schemas.openxmlformats.org/drawingml/2006/main">
               <a:ext uri="{FF2B5EF4-FFF2-40B4-BE49-F238E27FC236}">
-                <a16:creationId xmlns:a16="http://schemas.microsoft.com/office/drawing/2014/main" id="{ADD3C5C7-C570-4231-8C95-F3FCC1D776F0}"/>
+                <a16:creationId xmlns:a16="http://schemas.microsoft.com/office/drawing/2014/main" id="{EBCC58E1-49E7-40EA-ABD4-9238724125C6}"/>
               </a:ext>
             </a:extLst>
           </p:cNvPr>
@@ -10886,7 +10886,7 @@
           <p:cNvPr id="24" name="">
             <a:extLst xmlns:a="http://schemas.openxmlformats.org/drawingml/2006/main">
               <a:ext uri="{FF2B5EF4-FFF2-40B4-BE49-F238E27FC236}">
-                <a16:creationId xmlns:a16="http://schemas.microsoft.com/office/drawing/2014/main" id="{D82C931C-D071-49F6-8CD4-BDA4E8FC1F5A}"/>
+                <a16:creationId xmlns:a16="http://schemas.microsoft.com/office/drawing/2014/main" id="{03935903-CA86-4753-A3B1-FDB9FB3A8EFD}"/>
               </a:ext>
             </a:extLst>
           </p:cNvPr>
@@ -10950,7 +10950,7 @@
           <p:cNvPr id="25" name="">
             <a:extLst xmlns:a="http://schemas.openxmlformats.org/drawingml/2006/main">
               <a:ext uri="{FF2B5EF4-FFF2-40B4-BE49-F238E27FC236}">
-                <a16:creationId xmlns:a16="http://schemas.microsoft.com/office/drawing/2014/main" id="{41BCC27B-C130-4662-8F50-F13F6261F544}"/>
+                <a16:creationId xmlns:a16="http://schemas.microsoft.com/office/drawing/2014/main" id="{8E724680-57CE-4C01-A48D-CB5145CA7B8E}"/>
               </a:ext>
             </a:extLst>
           </p:cNvPr>
@@ -10997,7 +10997,7 @@
                 <a:ea typeface="Arial"/>
                 <a:cs typeface="Arial"/>
               </a:rPr>
-              <a:t>93 test • dependency sạch</a:t>
+              <a:t>100 test • dependency sạch</a:t>
             </a:r>
           </a:p>
         </p:txBody>
@@ -11007,7 +11007,7 @@
           <p:cNvPr id="26" name="">
             <a:extLst xmlns:a="http://schemas.openxmlformats.org/drawingml/2006/main">
               <a:ext uri="{FF2B5EF4-FFF2-40B4-BE49-F238E27FC236}">
-                <a16:creationId xmlns:a16="http://schemas.microsoft.com/office/drawing/2014/main" id="{B325E3E8-BBE7-47EF-9524-BB4307D93808}"/>
+                <a16:creationId xmlns:a16="http://schemas.microsoft.com/office/drawing/2014/main" id="{72F40DE6-DF50-4A02-B819-89789BFF7B78}"/>
               </a:ext>
             </a:extLst>
           </p:cNvPr>
@@ -11071,7 +11071,7 @@
           <p:cNvPr id="27" name="">
             <a:extLst xmlns:a="http://schemas.openxmlformats.org/drawingml/2006/main">
               <a:ext uri="{FF2B5EF4-FFF2-40B4-BE49-F238E27FC236}">
-                <a16:creationId xmlns:a16="http://schemas.microsoft.com/office/drawing/2014/main" id="{5C954D00-BEBF-4B43-ACD1-79742A736955}"/>
+                <a16:creationId xmlns:a16="http://schemas.microsoft.com/office/drawing/2014/main" id="{183F2632-D975-444F-A156-9C45E24649A0}"/>
               </a:ext>
             </a:extLst>
           </p:cNvPr>
@@ -11128,7 +11128,7 @@
           <p:cNvPr id="28" name="">
             <a:extLst xmlns:a="http://schemas.openxmlformats.org/drawingml/2006/main">
               <a:ext uri="{FF2B5EF4-FFF2-40B4-BE49-F238E27FC236}">
-                <a16:creationId xmlns:a16="http://schemas.microsoft.com/office/drawing/2014/main" id="{60BFC383-1A44-4123-B0F4-637DA9DA24E0}"/>
+                <a16:creationId xmlns:a16="http://schemas.microsoft.com/office/drawing/2014/main" id="{06082487-7CFE-494A-888D-AFB2FE0106C9}"/>
               </a:ext>
             </a:extLst>
           </p:cNvPr>
@@ -11192,7 +11192,7 @@
           <p:cNvPr id="29" name="">
             <a:extLst xmlns:a="http://schemas.openxmlformats.org/drawingml/2006/main">
               <a:ext uri="{FF2B5EF4-FFF2-40B4-BE49-F238E27FC236}">
-                <a16:creationId xmlns:a16="http://schemas.microsoft.com/office/drawing/2014/main" id="{0C53AEAB-0DE8-46A5-9478-1ED1B062188A}"/>
+                <a16:creationId xmlns:a16="http://schemas.microsoft.com/office/drawing/2014/main" id="{6FB7CA6B-7A0C-4C2F-8D17-37C70AE5DBCC}"/>
               </a:ext>
             </a:extLst>
           </p:cNvPr>
@@ -11249,7 +11249,7 @@
           <p:cNvPr id="30" name="">
             <a:extLst xmlns:a="http://schemas.openxmlformats.org/drawingml/2006/main">
               <a:ext uri="{FF2B5EF4-FFF2-40B4-BE49-F238E27FC236}">
-                <a16:creationId xmlns:a16="http://schemas.microsoft.com/office/drawing/2014/main" id="{515C49AA-45E6-46B7-A027-9F4D6965D199}"/>
+                <a16:creationId xmlns:a16="http://schemas.microsoft.com/office/drawing/2014/main" id="{473D36D4-C0CE-493E-AE54-F740F952382D}"/>
               </a:ext>
             </a:extLst>
           </p:cNvPr>
@@ -11284,7 +11284,7 @@
           <p:cNvPr id="31" name="">
             <a:extLst xmlns:a="http://schemas.openxmlformats.org/drawingml/2006/main">
               <a:ext uri="{FF2B5EF4-FFF2-40B4-BE49-F238E27FC236}">
-                <a16:creationId xmlns:a16="http://schemas.microsoft.com/office/drawing/2014/main" id="{8EBF99B3-B6D1-4E55-8C8A-A56E030FAC2B}"/>
+                <a16:creationId xmlns:a16="http://schemas.microsoft.com/office/drawing/2014/main" id="{A7EE4CF7-01F2-47D2-A729-A8E918CF3C2E}"/>
               </a:ext>
             </a:extLst>
           </p:cNvPr>
@@ -11341,7 +11341,7 @@
           <p:cNvPr id="32" name="">
             <a:extLst xmlns:a="http://schemas.openxmlformats.org/drawingml/2006/main">
               <a:ext uri="{FF2B5EF4-FFF2-40B4-BE49-F238E27FC236}">
-                <a16:creationId xmlns:a16="http://schemas.microsoft.com/office/drawing/2014/main" id="{435F9BA0-BD67-4280-819A-7CBD906BDABC}"/>
+                <a16:creationId xmlns:a16="http://schemas.microsoft.com/office/drawing/2014/main" id="{CCD48215-2F57-4073-A442-34406346ED3D}"/>
               </a:ext>
             </a:extLst>
           </p:cNvPr>
@@ -11444,7 +11444,7 @@
           <p:cNvPr id="33" name="">
             <a:extLst xmlns:a="http://schemas.openxmlformats.org/drawingml/2006/main">
               <a:ext uri="{FF2B5EF4-FFF2-40B4-BE49-F238E27FC236}">
-                <a16:creationId xmlns:a16="http://schemas.microsoft.com/office/drawing/2014/main" id="{CBFDBA68-7549-4825-B2EC-0DA469E7791A}"/>
+                <a16:creationId xmlns:a16="http://schemas.microsoft.com/office/drawing/2014/main" id="{CAAD36BE-345A-4913-A83C-2F20A4207AA1}"/>
               </a:ext>
             </a:extLst>
           </p:cNvPr>
@@ -11501,7 +11501,7 @@
           <p:cNvPr id="34" name="">
             <a:extLst xmlns:a="http://schemas.openxmlformats.org/drawingml/2006/main">
               <a:ext uri="{FF2B5EF4-FFF2-40B4-BE49-F238E27FC236}">
-                <a16:creationId xmlns:a16="http://schemas.microsoft.com/office/drawing/2014/main" id="{EA4008D2-75CB-493A-A687-2DC308479C86}"/>
+                <a16:creationId xmlns:a16="http://schemas.microsoft.com/office/drawing/2014/main" id="{AD18627D-BFC1-4CC6-A3D7-6D697184A12E}"/>
               </a:ext>
             </a:extLst>
           </p:cNvPr>
@@ -11558,7 +11558,7 @@
           <p:cNvPr id="35" name="">
             <a:extLst xmlns:a="http://schemas.openxmlformats.org/drawingml/2006/main">
               <a:ext uri="{FF2B5EF4-FFF2-40B4-BE49-F238E27FC236}">
-                <a16:creationId xmlns:a16="http://schemas.microsoft.com/office/drawing/2014/main" id="{85F45F09-7541-41F1-870B-685A99DF6948}"/>
+                <a16:creationId xmlns:a16="http://schemas.microsoft.com/office/drawing/2014/main" id="{B449398F-E614-4B28-9CC4-EC36407A78BE}"/>
               </a:ext>
             </a:extLst>
           </p:cNvPr>
@@ -11613,7 +11613,7 @@
     </p:spTree>
     <p:extLst>
       <p:ext uri="{BB962C8B-B14F-4D97-AF65-F5344CB8AC3E}">
-        <p14:creationId xmlns:p14="http://schemas.microsoft.com/office/powerpoint/2010/main" val="855391597"/>
+        <p14:creationId xmlns:p14="http://schemas.microsoft.com/office/powerpoint/2010/main" val="612083574"/>
       </p:ext>
     </p:extLst>
   </p:cSld>

</xml_diff>

<commit_message>
docs: sync postfix evidence and submission artifacts
</commit_message>
<xml_diff>
--- a/AURA/submission/AURA_5_SLIDES.pptx
+++ b/AURA/submission/AURA_5_SLIDES.pptx
@@ -2,17 +2,17 @@
 <file path=ppt/presentation.xml><?xml version="1.0" encoding="utf-8"?>
 <p:presentation xmlns:p="http://schemas.openxmlformats.org/presentationml/2006/main">
   <p:sldMasterIdLst>
-    <p:sldMasterId xmlns:r="http://schemas.openxmlformats.org/officeDocument/2006/relationships" id="2147483648" r:id="R4f1fe2e40c0847ef"/>
+    <p:sldMasterId xmlns:r="http://schemas.openxmlformats.org/officeDocument/2006/relationships" id="2147483648" r:id="R9beea6bf059c4497"/>
   </p:sldMasterIdLst>
   <p:notesMasterIdLst>
-    <p:notesMasterId xmlns:r="http://schemas.openxmlformats.org/officeDocument/2006/relationships" r:id="Rc72c11c93d064475"/>
+    <p:notesMasterId xmlns:r="http://schemas.openxmlformats.org/officeDocument/2006/relationships" r:id="R7a0643453675435e"/>
   </p:notesMasterIdLst>
   <p:sldIdLst>
-    <p:sldId xmlns:r="http://schemas.openxmlformats.org/officeDocument/2006/relationships" id="256" r:id="R629f528ee38844bf"/>
-    <p:sldId xmlns:r="http://schemas.openxmlformats.org/officeDocument/2006/relationships" id="257" r:id="R521a83534e624cfa"/>
-    <p:sldId xmlns:r="http://schemas.openxmlformats.org/officeDocument/2006/relationships" id="258" r:id="R7e776233fdaa4db8"/>
-    <p:sldId xmlns:r="http://schemas.openxmlformats.org/officeDocument/2006/relationships" id="259" r:id="R93b5a74b349c4ee0"/>
-    <p:sldId xmlns:r="http://schemas.openxmlformats.org/officeDocument/2006/relationships" id="260" r:id="Rb182db39ee1244ec"/>
+    <p:sldId xmlns:r="http://schemas.openxmlformats.org/officeDocument/2006/relationships" id="256" r:id="R1112f2f24a2c4b12"/>
+    <p:sldId xmlns:r="http://schemas.openxmlformats.org/officeDocument/2006/relationships" id="257" r:id="R85dcab4e9d4049d5"/>
+    <p:sldId xmlns:r="http://schemas.openxmlformats.org/officeDocument/2006/relationships" id="258" r:id="R066e96bf84404226"/>
+    <p:sldId xmlns:r="http://schemas.openxmlformats.org/officeDocument/2006/relationships" id="259" r:id="Raf80bdb4dc544f78"/>
+    <p:sldId xmlns:r="http://schemas.openxmlformats.org/officeDocument/2006/relationships" id="260" r:id="R095afc72d83947f4"/>
   </p:sldIdLst>
   <p:sldSz cx="12192000" cy="6858000"/>
   <p:notesSz cx="6858000" cy="9144000"/>
@@ -586,7 +586,7 @@
           <a:lstStyle xmlns:a="http://schemas.openxmlformats.org/drawingml/2006/main"/>
           <a:p xmlns:a="http://schemas.openxmlformats.org/drawingml/2006/main">
             <a:r>
-              <a:t>Nguồn nội bộ cập nhật ngày 01/10/2026: 100 test offline. Trên cùng judge set 15 ca và fallback tắt, OpenRouter 8B đạt 15/15 quyết định, 70/75 field, P95 16,459 giây; Ollama 4B đạt 14/15, 73/75 field, P95 58,318 giây và bỏ sót escalation TK-12. Contract hiện tách ba loại identifier, canonical date và discountAmount; kết quả live sau schema giảm giá phải được ghi riêng. Đây là regression trên dữ liệu tổng hợp, không phải accuracy thực tế.</a:t>
+              <a:t>Nguồn nội bộ cập nhật ngày 01/10/2026: 102 test offline. Trên cùng judge set 15 ca và fallback tắt, OpenRouter 8B đạt 15/15 quyết định, 70/75 field, P95 16,459 giây; Ollama 4B đạt 14/15, 73/75 field, P95 58,318 giây và bỏ sót escalation TK-12. Contract hiện tách ba loại identifier, chuẩn hóa lossless ngày giao dịch trên chứng từ giấy và đối chiếu discountAmount; kết quả live postfix phải được ghi riêng. Đây là regression trên dữ liệu tổng hợp, không phải accuracy thực tế.</a:t>
             </a:r>
           </a:p>
         </p:txBody>
@@ -794,7 +794,7 @@
   </p:cSld>
   <p:clrMap bg1="lt1" tx1="dk1" bg2="lt2" tx2="dk2" accent1="accent1" accent2="accent2" accent3="accent3" accent4="accent4" accent5="accent5" accent6="accent6" hlink="hlink" folHlink="folHlink"/>
   <p:sldLayoutIdLst>
-    <p:sldLayoutId xmlns:r="http://schemas.openxmlformats.org/officeDocument/2006/relationships" id="2147483649" r:id="Rd2556133d6d94bac"/>
+    <p:sldLayoutId xmlns:r="http://schemas.openxmlformats.org/officeDocument/2006/relationships" id="2147483649" r:id="Rd2fc839d16fb4265"/>
   </p:sldLayoutIdLst>
   <p:txStyles>
     <p:titleStyle>
@@ -1345,7 +1345,7 @@
           <p:cNvPr id="47" name="">
             <a:extLst xmlns:a="http://schemas.openxmlformats.org/drawingml/2006/main">
               <a:ext uri="{FF2B5EF4-FFF2-40B4-BE49-F238E27FC236}">
-                <a16:creationId xmlns:a16="http://schemas.microsoft.com/office/drawing/2014/main" id="{D244D851-CF51-452E-8504-7FAF7BE2CCED}"/>
+                <a16:creationId xmlns:a16="http://schemas.microsoft.com/office/drawing/2014/main" id="{31D0D8EA-B290-4C8A-B1FA-1F4511AA16CE}"/>
               </a:ext>
             </a:extLst>
           </p:cNvPr>
@@ -1402,7 +1402,7 @@
           <p:cNvPr id="2" name="">
             <a:extLst xmlns:a="http://schemas.openxmlformats.org/drawingml/2006/main">
               <a:ext uri="{FF2B5EF4-FFF2-40B4-BE49-F238E27FC236}">
-                <a16:creationId xmlns:a16="http://schemas.microsoft.com/office/drawing/2014/main" id="{F600F44B-5A78-4014-8A5C-E206CE5E6155}"/>
+                <a16:creationId xmlns:a16="http://schemas.microsoft.com/office/drawing/2014/main" id="{49D72C47-8E68-41B9-A043-984D8803158B}"/>
               </a:ext>
             </a:extLst>
           </p:cNvPr>
@@ -1459,7 +1459,7 @@
           <p:cNvPr id="3" name="">
             <a:extLst xmlns:a="http://schemas.openxmlformats.org/drawingml/2006/main">
               <a:ext uri="{FF2B5EF4-FFF2-40B4-BE49-F238E27FC236}">
-                <a16:creationId xmlns:a16="http://schemas.microsoft.com/office/drawing/2014/main" id="{30A3AB8E-C3AC-4435-AC39-743760A254D0}"/>
+                <a16:creationId xmlns:a16="http://schemas.microsoft.com/office/drawing/2014/main" id="{C411AB07-12FA-4A43-AE63-61065E318DED}"/>
               </a:ext>
             </a:extLst>
           </p:cNvPr>
@@ -1516,7 +1516,7 @@
           <p:cNvPr id="4" name="">
             <a:extLst xmlns:a="http://schemas.openxmlformats.org/drawingml/2006/main">
               <a:ext uri="{FF2B5EF4-FFF2-40B4-BE49-F238E27FC236}">
-                <a16:creationId xmlns:a16="http://schemas.microsoft.com/office/drawing/2014/main" id="{82063A62-D48F-4A09-91C7-6FB55D82D54D}"/>
+                <a16:creationId xmlns:a16="http://schemas.microsoft.com/office/drawing/2014/main" id="{6322D52C-7B98-490A-9339-E26033306A88}"/>
               </a:ext>
             </a:extLst>
           </p:cNvPr>
@@ -1547,7 +1547,7 @@
           <p:cNvPr id="5" name="">
             <a:extLst xmlns:a="http://schemas.openxmlformats.org/drawingml/2006/main">
               <a:ext uri="{FF2B5EF4-FFF2-40B4-BE49-F238E27FC236}">
-                <a16:creationId xmlns:a16="http://schemas.microsoft.com/office/drawing/2014/main" id="{EC186BC1-1AA2-4784-A882-91D5F4D2C154}"/>
+                <a16:creationId xmlns:a16="http://schemas.microsoft.com/office/drawing/2014/main" id="{C631D7ED-A6B8-4E15-9618-A0859078922C}"/>
               </a:ext>
             </a:extLst>
           </p:cNvPr>
@@ -1582,7 +1582,7 @@
           <p:cNvPr id="6" name="">
             <a:extLst xmlns:a="http://schemas.openxmlformats.org/drawingml/2006/main">
               <a:ext uri="{FF2B5EF4-FFF2-40B4-BE49-F238E27FC236}">
-                <a16:creationId xmlns:a16="http://schemas.microsoft.com/office/drawing/2014/main" id="{8FCBD2A9-7240-4CE0-834A-6B43C1F6A575}"/>
+                <a16:creationId xmlns:a16="http://schemas.microsoft.com/office/drawing/2014/main" id="{8B6CDC57-ACD8-4E58-99D7-C7AC66BEDCCA}"/>
               </a:ext>
             </a:extLst>
           </p:cNvPr>
@@ -1646,7 +1646,7 @@
           <p:cNvPr id="7" name="">
             <a:extLst xmlns:a="http://schemas.openxmlformats.org/drawingml/2006/main">
               <a:ext uri="{FF2B5EF4-FFF2-40B4-BE49-F238E27FC236}">
-                <a16:creationId xmlns:a16="http://schemas.microsoft.com/office/drawing/2014/main" id="{5DAD04E0-2C99-46EE-96B8-19EEF9BEAEF7}"/>
+                <a16:creationId xmlns:a16="http://schemas.microsoft.com/office/drawing/2014/main" id="{D3CEC49B-2175-4AAA-B84B-83ACF97C6057}"/>
               </a:ext>
             </a:extLst>
           </p:cNvPr>
@@ -1703,7 +1703,7 @@
           <p:cNvPr id="8" name="">
             <a:extLst xmlns:a="http://schemas.openxmlformats.org/drawingml/2006/main">
               <a:ext uri="{FF2B5EF4-FFF2-40B4-BE49-F238E27FC236}">
-                <a16:creationId xmlns:a16="http://schemas.microsoft.com/office/drawing/2014/main" id="{BDFEA2E7-9C9A-4D96-B5AF-32735ADBA08B}"/>
+                <a16:creationId xmlns:a16="http://schemas.microsoft.com/office/drawing/2014/main" id="{D95F860A-3CE8-4595-B113-38622F2294EE}"/>
               </a:ext>
             </a:extLst>
           </p:cNvPr>
@@ -1760,7 +1760,7 @@
           <p:cNvPr id="9" name="">
             <a:extLst xmlns:a="http://schemas.openxmlformats.org/drawingml/2006/main">
               <a:ext uri="{FF2B5EF4-FFF2-40B4-BE49-F238E27FC236}">
-                <a16:creationId xmlns:a16="http://schemas.microsoft.com/office/drawing/2014/main" id="{FF31B1C4-2365-43EC-9BCC-BF38F7181780}"/>
+                <a16:creationId xmlns:a16="http://schemas.microsoft.com/office/drawing/2014/main" id="{0AFB62C1-C451-4CC2-A249-732AE80E5828}"/>
               </a:ext>
             </a:extLst>
           </p:cNvPr>
@@ -1792,7 +1792,7 @@
           <p:cNvPr id="10" name="">
             <a:extLst xmlns:a="http://schemas.openxmlformats.org/drawingml/2006/main">
               <a:ext uri="{FF2B5EF4-FFF2-40B4-BE49-F238E27FC236}">
-                <a16:creationId xmlns:a16="http://schemas.microsoft.com/office/drawing/2014/main" id="{B4C80FC5-A6A3-4CFD-B819-DBF3A53BF099}"/>
+                <a16:creationId xmlns:a16="http://schemas.microsoft.com/office/drawing/2014/main" id="{C440F7C3-A83A-49BF-991F-CB4D19B473EB}"/>
               </a:ext>
             </a:extLst>
           </p:cNvPr>
@@ -1827,7 +1827,7 @@
           <p:cNvPr id="11" name="">
             <a:extLst xmlns:a="http://schemas.openxmlformats.org/drawingml/2006/main">
               <a:ext uri="{FF2B5EF4-FFF2-40B4-BE49-F238E27FC236}">
-                <a16:creationId xmlns:a16="http://schemas.microsoft.com/office/drawing/2014/main" id="{5F67399C-DBB6-4EEA-B010-CB0A72CC2C63}"/>
+                <a16:creationId xmlns:a16="http://schemas.microsoft.com/office/drawing/2014/main" id="{32A0A7D7-A443-4F21-B9F0-4D6EC4474C8E}"/>
               </a:ext>
             </a:extLst>
           </p:cNvPr>
@@ -1891,7 +1891,7 @@
           <p:cNvPr id="12" name="">
             <a:extLst xmlns:a="http://schemas.openxmlformats.org/drawingml/2006/main">
               <a:ext uri="{FF2B5EF4-FFF2-40B4-BE49-F238E27FC236}">
-                <a16:creationId xmlns:a16="http://schemas.microsoft.com/office/drawing/2014/main" id="{9DDE71FC-FBCB-484F-9367-B4B5C3261A66}"/>
+                <a16:creationId xmlns:a16="http://schemas.microsoft.com/office/drawing/2014/main" id="{1D5FB1AE-DA90-40E6-B1FE-613D6CD86E7D}"/>
               </a:ext>
             </a:extLst>
           </p:cNvPr>
@@ -1948,7 +1948,7 @@
           <p:cNvPr id="13" name="">
             <a:extLst xmlns:a="http://schemas.openxmlformats.org/drawingml/2006/main">
               <a:ext uri="{FF2B5EF4-FFF2-40B4-BE49-F238E27FC236}">
-                <a16:creationId xmlns:a16="http://schemas.microsoft.com/office/drawing/2014/main" id="{B2062304-71CA-4BEE-B6ED-D22A03C3F422}"/>
+                <a16:creationId xmlns:a16="http://schemas.microsoft.com/office/drawing/2014/main" id="{D4960FD8-A42C-40B4-A473-82AA06838270}"/>
               </a:ext>
             </a:extLst>
           </p:cNvPr>
@@ -2005,7 +2005,7 @@
           <p:cNvPr id="14" name="">
             <a:extLst xmlns:a="http://schemas.openxmlformats.org/drawingml/2006/main">
               <a:ext uri="{FF2B5EF4-FFF2-40B4-BE49-F238E27FC236}">
-                <a16:creationId xmlns:a16="http://schemas.microsoft.com/office/drawing/2014/main" id="{1487B93F-2F8F-4EFC-BAB2-21D984584C2B}"/>
+                <a16:creationId xmlns:a16="http://schemas.microsoft.com/office/drawing/2014/main" id="{41EE0921-F67E-4DAD-861D-90AEF2BA214D}"/>
               </a:ext>
             </a:extLst>
           </p:cNvPr>
@@ -2037,7 +2037,7 @@
           <p:cNvPr id="15" name="">
             <a:extLst xmlns:a="http://schemas.openxmlformats.org/drawingml/2006/main">
               <a:ext uri="{FF2B5EF4-FFF2-40B4-BE49-F238E27FC236}">
-                <a16:creationId xmlns:a16="http://schemas.microsoft.com/office/drawing/2014/main" id="{A911FCC4-95B5-482B-B379-5A8D6139A16F}"/>
+                <a16:creationId xmlns:a16="http://schemas.microsoft.com/office/drawing/2014/main" id="{5BC7DA21-5533-4756-A142-F4BB989EEBEB}"/>
               </a:ext>
             </a:extLst>
           </p:cNvPr>
@@ -2072,7 +2072,7 @@
           <p:cNvPr id="16" name="">
             <a:extLst xmlns:a="http://schemas.openxmlformats.org/drawingml/2006/main">
               <a:ext uri="{FF2B5EF4-FFF2-40B4-BE49-F238E27FC236}">
-                <a16:creationId xmlns:a16="http://schemas.microsoft.com/office/drawing/2014/main" id="{E8C138AF-1E03-44BA-853D-1228349DDAB6}"/>
+                <a16:creationId xmlns:a16="http://schemas.microsoft.com/office/drawing/2014/main" id="{0832F3A4-A33C-4566-A2BE-AAF6656CF5A8}"/>
               </a:ext>
             </a:extLst>
           </p:cNvPr>
@@ -2136,7 +2136,7 @@
           <p:cNvPr id="17" name="">
             <a:extLst xmlns:a="http://schemas.openxmlformats.org/drawingml/2006/main">
               <a:ext uri="{FF2B5EF4-FFF2-40B4-BE49-F238E27FC236}">
-                <a16:creationId xmlns:a16="http://schemas.microsoft.com/office/drawing/2014/main" id="{29268C51-5783-4E9A-9B3A-84FF676C8902}"/>
+                <a16:creationId xmlns:a16="http://schemas.microsoft.com/office/drawing/2014/main" id="{0B4E3FDE-AEC9-418D-9615-02CCB2916F3F}"/>
               </a:ext>
             </a:extLst>
           </p:cNvPr>
@@ -2193,7 +2193,7 @@
           <p:cNvPr id="18" name="">
             <a:extLst xmlns:a="http://schemas.openxmlformats.org/drawingml/2006/main">
               <a:ext uri="{FF2B5EF4-FFF2-40B4-BE49-F238E27FC236}">
-                <a16:creationId xmlns:a16="http://schemas.microsoft.com/office/drawing/2014/main" id="{0DE81398-F340-4D3A-B64E-246343D6DA6E}"/>
+                <a16:creationId xmlns:a16="http://schemas.microsoft.com/office/drawing/2014/main" id="{6CBE8C7F-6CC1-4C7F-B666-E4CF3895B534}"/>
               </a:ext>
             </a:extLst>
           </p:cNvPr>
@@ -2250,7 +2250,7 @@
           <p:cNvPr id="19" name="">
             <a:extLst xmlns:a="http://schemas.openxmlformats.org/drawingml/2006/main">
               <a:ext uri="{FF2B5EF4-FFF2-40B4-BE49-F238E27FC236}">
-                <a16:creationId xmlns:a16="http://schemas.microsoft.com/office/drawing/2014/main" id="{5361F7DA-F69E-452E-B9A2-AB9B991285F1}"/>
+                <a16:creationId xmlns:a16="http://schemas.microsoft.com/office/drawing/2014/main" id="{7FA68161-A341-4287-AD57-4E52765C635F}"/>
               </a:ext>
             </a:extLst>
           </p:cNvPr>
@@ -2282,7 +2282,7 @@
           <p:cNvPr id="20" name="">
             <a:extLst xmlns:a="http://schemas.openxmlformats.org/drawingml/2006/main">
               <a:ext uri="{FF2B5EF4-FFF2-40B4-BE49-F238E27FC236}">
-                <a16:creationId xmlns:a16="http://schemas.microsoft.com/office/drawing/2014/main" id="{8A2277C2-81BD-46C8-89BF-C0F4BA475CAE}"/>
+                <a16:creationId xmlns:a16="http://schemas.microsoft.com/office/drawing/2014/main" id="{47CB2C63-B675-48F6-B5CC-C1B04A3624F8}"/>
               </a:ext>
             </a:extLst>
           </p:cNvPr>
@@ -2317,7 +2317,7 @@
           <p:cNvPr id="21" name="">
             <a:extLst xmlns:a="http://schemas.openxmlformats.org/drawingml/2006/main">
               <a:ext uri="{FF2B5EF4-FFF2-40B4-BE49-F238E27FC236}">
-                <a16:creationId xmlns:a16="http://schemas.microsoft.com/office/drawing/2014/main" id="{2BFB971B-901F-445D-9280-0CA9525ADB15}"/>
+                <a16:creationId xmlns:a16="http://schemas.microsoft.com/office/drawing/2014/main" id="{7A646612-7B67-4AAA-BE68-FE045D8C52AE}"/>
               </a:ext>
             </a:extLst>
           </p:cNvPr>
@@ -2381,7 +2381,7 @@
           <p:cNvPr id="22" name="">
             <a:extLst xmlns:a="http://schemas.openxmlformats.org/drawingml/2006/main">
               <a:ext uri="{FF2B5EF4-FFF2-40B4-BE49-F238E27FC236}">
-                <a16:creationId xmlns:a16="http://schemas.microsoft.com/office/drawing/2014/main" id="{CB7F60E1-1FFD-489F-8984-5C94466DA0DF}"/>
+                <a16:creationId xmlns:a16="http://schemas.microsoft.com/office/drawing/2014/main" id="{84FF6114-300D-45B5-A281-2BA041897B2A}"/>
               </a:ext>
             </a:extLst>
           </p:cNvPr>
@@ -2438,7 +2438,7 @@
           <p:cNvPr id="23" name="">
             <a:extLst xmlns:a="http://schemas.openxmlformats.org/drawingml/2006/main">
               <a:ext uri="{FF2B5EF4-FFF2-40B4-BE49-F238E27FC236}">
-                <a16:creationId xmlns:a16="http://schemas.microsoft.com/office/drawing/2014/main" id="{E45B9D1A-5A18-43CC-A116-F3A72AB6EFE7}"/>
+                <a16:creationId xmlns:a16="http://schemas.microsoft.com/office/drawing/2014/main" id="{8AB3E568-CF42-4848-8988-EAFDE2A920D7}"/>
               </a:ext>
             </a:extLst>
           </p:cNvPr>
@@ -2495,7 +2495,7 @@
           <p:cNvPr id="24" name="">
             <a:extLst xmlns:a="http://schemas.openxmlformats.org/drawingml/2006/main">
               <a:ext uri="{FF2B5EF4-FFF2-40B4-BE49-F238E27FC236}">
-                <a16:creationId xmlns:a16="http://schemas.microsoft.com/office/drawing/2014/main" id="{EE656FC7-F1A4-4507-AED5-20432DC4A840}"/>
+                <a16:creationId xmlns:a16="http://schemas.microsoft.com/office/drawing/2014/main" id="{11516136-3E5C-474E-B267-A1651F751438}"/>
               </a:ext>
             </a:extLst>
           </p:cNvPr>
@@ -2527,7 +2527,7 @@
           <p:cNvPr id="25" name="">
             <a:extLst xmlns:a="http://schemas.openxmlformats.org/drawingml/2006/main">
               <a:ext uri="{FF2B5EF4-FFF2-40B4-BE49-F238E27FC236}">
-                <a16:creationId xmlns:a16="http://schemas.microsoft.com/office/drawing/2014/main" id="{56A8B8EA-8BDC-472D-A648-10C4113B6718}"/>
+                <a16:creationId xmlns:a16="http://schemas.microsoft.com/office/drawing/2014/main" id="{462A1300-1607-4AAA-8343-CDA0DD1D988A}"/>
               </a:ext>
             </a:extLst>
           </p:cNvPr>
@@ -2562,7 +2562,7 @@
           <p:cNvPr id="26" name="">
             <a:extLst xmlns:a="http://schemas.openxmlformats.org/drawingml/2006/main">
               <a:ext uri="{FF2B5EF4-FFF2-40B4-BE49-F238E27FC236}">
-                <a16:creationId xmlns:a16="http://schemas.microsoft.com/office/drawing/2014/main" id="{0AB7535F-856F-4098-93DE-6BF578EACB38}"/>
+                <a16:creationId xmlns:a16="http://schemas.microsoft.com/office/drawing/2014/main" id="{FD6AF2E2-CC1B-47EF-8D29-E4AFA2CA0093}"/>
               </a:ext>
             </a:extLst>
           </p:cNvPr>
@@ -2626,7 +2626,7 @@
           <p:cNvPr id="27" name="">
             <a:extLst xmlns:a="http://schemas.openxmlformats.org/drawingml/2006/main">
               <a:ext uri="{FF2B5EF4-FFF2-40B4-BE49-F238E27FC236}">
-                <a16:creationId xmlns:a16="http://schemas.microsoft.com/office/drawing/2014/main" id="{996C3EC6-D816-4305-B98D-F24F08CAB7AC}"/>
+                <a16:creationId xmlns:a16="http://schemas.microsoft.com/office/drawing/2014/main" id="{7A7D6E21-DF15-4BB9-A983-E8D6793DD27D}"/>
               </a:ext>
             </a:extLst>
           </p:cNvPr>
@@ -2683,7 +2683,7 @@
           <p:cNvPr id="28" name="">
             <a:extLst xmlns:a="http://schemas.openxmlformats.org/drawingml/2006/main">
               <a:ext uri="{FF2B5EF4-FFF2-40B4-BE49-F238E27FC236}">
-                <a16:creationId xmlns:a16="http://schemas.microsoft.com/office/drawing/2014/main" id="{051CEEA0-5C8B-44BD-9424-82A4674EF4D2}"/>
+                <a16:creationId xmlns:a16="http://schemas.microsoft.com/office/drawing/2014/main" id="{3BB2872B-31B2-4A89-8143-A568B70ADE04}"/>
               </a:ext>
             </a:extLst>
           </p:cNvPr>
@@ -2740,7 +2740,7 @@
           <p:cNvPr id="29" name="">
             <a:extLst xmlns:a="http://schemas.openxmlformats.org/drawingml/2006/main">
               <a:ext uri="{FF2B5EF4-FFF2-40B4-BE49-F238E27FC236}">
-                <a16:creationId xmlns:a16="http://schemas.microsoft.com/office/drawing/2014/main" id="{A89DFBE6-9E3A-4FAA-AA11-88B947B280CB}"/>
+                <a16:creationId xmlns:a16="http://schemas.microsoft.com/office/drawing/2014/main" id="{A3812EE5-E4D9-44AC-8E98-A44713AF2281}"/>
               </a:ext>
             </a:extLst>
           </p:cNvPr>
@@ -2775,7 +2775,7 @@
           <p:cNvPr id="30" name="">
             <a:extLst xmlns:a="http://schemas.openxmlformats.org/drawingml/2006/main">
               <a:ext uri="{FF2B5EF4-FFF2-40B4-BE49-F238E27FC236}">
-                <a16:creationId xmlns:a16="http://schemas.microsoft.com/office/drawing/2014/main" id="{41D59421-6267-4C30-A5D9-29B47AEA2FB6}"/>
+                <a16:creationId xmlns:a16="http://schemas.microsoft.com/office/drawing/2014/main" id="{CAFCF40F-4593-4999-A47C-53B1521F1398}"/>
               </a:ext>
             </a:extLst>
           </p:cNvPr>
@@ -2832,7 +2832,7 @@
           <p:cNvPr id="31" name="">
             <a:extLst xmlns:a="http://schemas.openxmlformats.org/drawingml/2006/main">
               <a:ext uri="{FF2B5EF4-FFF2-40B4-BE49-F238E27FC236}">
-                <a16:creationId xmlns:a16="http://schemas.microsoft.com/office/drawing/2014/main" id="{847F850B-550B-4262-9E30-A9E7FBEADF79}"/>
+                <a16:creationId xmlns:a16="http://schemas.microsoft.com/office/drawing/2014/main" id="{640AF953-D773-4DBA-8737-42F079492BED}"/>
               </a:ext>
             </a:extLst>
           </p:cNvPr>
@@ -2889,7 +2889,7 @@
           <p:cNvPr id="32" name="">
             <a:extLst xmlns:a="http://schemas.openxmlformats.org/drawingml/2006/main">
               <a:ext uri="{FF2B5EF4-FFF2-40B4-BE49-F238E27FC236}">
-                <a16:creationId xmlns:a16="http://schemas.microsoft.com/office/drawing/2014/main" id="{8DA3B860-3F72-46E9-ABC5-8B1FFA533857}"/>
+                <a16:creationId xmlns:a16="http://schemas.microsoft.com/office/drawing/2014/main" id="{0C1982D5-7EDB-4983-9BF1-AF648157A1C6}"/>
               </a:ext>
             </a:extLst>
           </p:cNvPr>
@@ -2946,7 +2946,7 @@
           <p:cNvPr id="33" name="">
             <a:extLst xmlns:a="http://schemas.openxmlformats.org/drawingml/2006/main">
               <a:ext uri="{FF2B5EF4-FFF2-40B4-BE49-F238E27FC236}">
-                <a16:creationId xmlns:a16="http://schemas.microsoft.com/office/drawing/2014/main" id="{11134BD5-1C1E-4530-9FE8-9E4D4985A5DE}"/>
+                <a16:creationId xmlns:a16="http://schemas.microsoft.com/office/drawing/2014/main" id="{30C69ECF-549B-4D8B-94AD-79A38182D1A5}"/>
               </a:ext>
             </a:extLst>
           </p:cNvPr>
@@ -2981,7 +2981,7 @@
           <p:cNvPr id="34" name="">
             <a:extLst xmlns:a="http://schemas.openxmlformats.org/drawingml/2006/main">
               <a:ext uri="{FF2B5EF4-FFF2-40B4-BE49-F238E27FC236}">
-                <a16:creationId xmlns:a16="http://schemas.microsoft.com/office/drawing/2014/main" id="{131712B8-F54C-4554-AB0F-B348FD8D8E6D}"/>
+                <a16:creationId xmlns:a16="http://schemas.microsoft.com/office/drawing/2014/main" id="{1BFBA543-37D9-4870-9BBA-2E0A2DCFD45B}"/>
               </a:ext>
             </a:extLst>
           </p:cNvPr>
@@ -3045,7 +3045,7 @@
           <p:cNvPr id="35" name="">
             <a:extLst xmlns:a="http://schemas.openxmlformats.org/drawingml/2006/main">
               <a:ext uri="{FF2B5EF4-FFF2-40B4-BE49-F238E27FC236}">
-                <a16:creationId xmlns:a16="http://schemas.microsoft.com/office/drawing/2014/main" id="{FD6ABA93-B76D-4B21-A9B9-5AE8F4593244}"/>
+                <a16:creationId xmlns:a16="http://schemas.microsoft.com/office/drawing/2014/main" id="{7EB87074-0D73-4401-AE4D-6338E5963D8C}"/>
               </a:ext>
             </a:extLst>
           </p:cNvPr>
@@ -3102,7 +3102,7 @@
           <p:cNvPr id="36" name="">
             <a:extLst xmlns:a="http://schemas.openxmlformats.org/drawingml/2006/main">
               <a:ext uri="{FF2B5EF4-FFF2-40B4-BE49-F238E27FC236}">
-                <a16:creationId xmlns:a16="http://schemas.microsoft.com/office/drawing/2014/main" id="{DEB3463C-CAED-497E-B84C-91DA966E56B5}"/>
+                <a16:creationId xmlns:a16="http://schemas.microsoft.com/office/drawing/2014/main" id="{B352C202-35F3-4B5B-9417-CCCFBACAD938}"/>
               </a:ext>
             </a:extLst>
           </p:cNvPr>
@@ -3159,7 +3159,7 @@
           <p:cNvPr id="37" name="">
             <a:extLst xmlns:a="http://schemas.openxmlformats.org/drawingml/2006/main">
               <a:ext uri="{FF2B5EF4-FFF2-40B4-BE49-F238E27FC236}">
-                <a16:creationId xmlns:a16="http://schemas.microsoft.com/office/drawing/2014/main" id="{1C7A0F8C-6EF5-43A4-84B4-E796CC4D0AE3}"/>
+                <a16:creationId xmlns:a16="http://schemas.microsoft.com/office/drawing/2014/main" id="{3433DBEA-A4FD-4C2B-A554-B2DD252A5438}"/>
               </a:ext>
             </a:extLst>
           </p:cNvPr>
@@ -3194,7 +3194,7 @@
           <p:cNvPr id="38" name="">
             <a:extLst xmlns:a="http://schemas.openxmlformats.org/drawingml/2006/main">
               <a:ext uri="{FF2B5EF4-FFF2-40B4-BE49-F238E27FC236}">
-                <a16:creationId xmlns:a16="http://schemas.microsoft.com/office/drawing/2014/main" id="{AEE98B5B-0817-4BB8-924F-F3732B086F6C}"/>
+                <a16:creationId xmlns:a16="http://schemas.microsoft.com/office/drawing/2014/main" id="{559C1965-7A5B-44BB-8036-965EBA480425}"/>
               </a:ext>
             </a:extLst>
           </p:cNvPr>
@@ -3258,7 +3258,7 @@
           <p:cNvPr id="39" name="">
             <a:extLst xmlns:a="http://schemas.openxmlformats.org/drawingml/2006/main">
               <a:ext uri="{FF2B5EF4-FFF2-40B4-BE49-F238E27FC236}">
-                <a16:creationId xmlns:a16="http://schemas.microsoft.com/office/drawing/2014/main" id="{E41C9734-333E-4823-B5FA-11C9FF0B83F7}"/>
+                <a16:creationId xmlns:a16="http://schemas.microsoft.com/office/drawing/2014/main" id="{75491AF6-4F5F-4451-9971-4C6BAC7B94AA}"/>
               </a:ext>
             </a:extLst>
           </p:cNvPr>
@@ -3315,7 +3315,7 @@
           <p:cNvPr id="40" name="">
             <a:extLst xmlns:a="http://schemas.openxmlformats.org/drawingml/2006/main">
               <a:ext uri="{FF2B5EF4-FFF2-40B4-BE49-F238E27FC236}">
-                <a16:creationId xmlns:a16="http://schemas.microsoft.com/office/drawing/2014/main" id="{9ACA0DBC-8CFE-44E4-B133-46BCEFDB3A46}"/>
+                <a16:creationId xmlns:a16="http://schemas.microsoft.com/office/drawing/2014/main" id="{DB69D2DB-9A2D-4DA6-A778-49615DF049CF}"/>
               </a:ext>
             </a:extLst>
           </p:cNvPr>
@@ -3372,7 +3372,7 @@
           <p:cNvPr id="41" name="">
             <a:extLst xmlns:a="http://schemas.openxmlformats.org/drawingml/2006/main">
               <a:ext uri="{FF2B5EF4-FFF2-40B4-BE49-F238E27FC236}">
-                <a16:creationId xmlns:a16="http://schemas.microsoft.com/office/drawing/2014/main" id="{332E94CF-37D4-4F86-B31D-CD8E344D9B57}"/>
+                <a16:creationId xmlns:a16="http://schemas.microsoft.com/office/drawing/2014/main" id="{55EE4FA6-E0FD-4296-8B1C-A914F4B7FB68}"/>
               </a:ext>
             </a:extLst>
           </p:cNvPr>
@@ -3407,7 +3407,7 @@
           <p:cNvPr id="42" name="">
             <a:extLst xmlns:a="http://schemas.openxmlformats.org/drawingml/2006/main">
               <a:ext uri="{FF2B5EF4-FFF2-40B4-BE49-F238E27FC236}">
-                <a16:creationId xmlns:a16="http://schemas.microsoft.com/office/drawing/2014/main" id="{CB30C98F-43A6-41CE-AC23-92687125A7EF}"/>
+                <a16:creationId xmlns:a16="http://schemas.microsoft.com/office/drawing/2014/main" id="{A9AABDD5-7A70-420F-87E6-78DDD7F9649D}"/>
               </a:ext>
             </a:extLst>
           </p:cNvPr>
@@ -3471,7 +3471,7 @@
           <p:cNvPr id="43" name="">
             <a:extLst xmlns:a="http://schemas.openxmlformats.org/drawingml/2006/main">
               <a:ext uri="{FF2B5EF4-FFF2-40B4-BE49-F238E27FC236}">
-                <a16:creationId xmlns:a16="http://schemas.microsoft.com/office/drawing/2014/main" id="{B5DD5FCB-B9D2-4B44-BD24-8440B036DD90}"/>
+                <a16:creationId xmlns:a16="http://schemas.microsoft.com/office/drawing/2014/main" id="{EA32965B-0E86-48DB-A038-420EDEC8DE7D}"/>
               </a:ext>
             </a:extLst>
           </p:cNvPr>
@@ -3528,7 +3528,7 @@
           <p:cNvPr id="44" name="">
             <a:extLst xmlns:a="http://schemas.openxmlformats.org/drawingml/2006/main">
               <a:ext uri="{FF2B5EF4-FFF2-40B4-BE49-F238E27FC236}">
-                <a16:creationId xmlns:a16="http://schemas.microsoft.com/office/drawing/2014/main" id="{0DDBAF94-787B-4E5B-BD06-111FEBA643CF}"/>
+                <a16:creationId xmlns:a16="http://schemas.microsoft.com/office/drawing/2014/main" id="{ED691D89-BD8A-488D-8579-EAAF02B8E35E}"/>
               </a:ext>
             </a:extLst>
           </p:cNvPr>
@@ -3585,7 +3585,7 @@
           <p:cNvPr id="45" name="">
             <a:extLst xmlns:a="http://schemas.openxmlformats.org/drawingml/2006/main">
               <a:ext uri="{FF2B5EF4-FFF2-40B4-BE49-F238E27FC236}">
-                <a16:creationId xmlns:a16="http://schemas.microsoft.com/office/drawing/2014/main" id="{6496C0D8-6EC4-488D-A9A8-0425F13865E2}"/>
+                <a16:creationId xmlns:a16="http://schemas.microsoft.com/office/drawing/2014/main" id="{CA3E3777-0FAE-413C-BCE4-44A42A6D79AB}"/>
               </a:ext>
             </a:extLst>
           </p:cNvPr>
@@ -3642,7 +3642,7 @@
           <p:cNvPr id="46" name="">
             <a:extLst xmlns:a="http://schemas.openxmlformats.org/drawingml/2006/main">
               <a:ext uri="{FF2B5EF4-FFF2-40B4-BE49-F238E27FC236}">
-                <a16:creationId xmlns:a16="http://schemas.microsoft.com/office/drawing/2014/main" id="{A56E86DC-2547-465A-BDE0-0AE27A4FF054}"/>
+                <a16:creationId xmlns:a16="http://schemas.microsoft.com/office/drawing/2014/main" id="{E761AEE5-1569-4BA3-9B7A-B8C74ADEFB04}"/>
               </a:ext>
             </a:extLst>
           </p:cNvPr>
@@ -3697,7 +3697,7 @@
     </p:spTree>
     <p:extLst>
       <p:ext uri="{BB962C8B-B14F-4D97-AF65-F5344CB8AC3E}">
-        <p14:creationId xmlns:p14="http://schemas.microsoft.com/office/powerpoint/2010/main" val="2093502829"/>
+        <p14:creationId xmlns:p14="http://schemas.microsoft.com/office/powerpoint/2010/main" val="1506174443"/>
       </p:ext>
     </p:extLst>
   </p:cSld>
@@ -3728,7 +3728,7 @@
           <p:cNvPr id="46" name="">
             <a:extLst xmlns:a="http://schemas.openxmlformats.org/drawingml/2006/main">
               <a:ext uri="{FF2B5EF4-FFF2-40B4-BE49-F238E27FC236}">
-                <a16:creationId xmlns:a16="http://schemas.microsoft.com/office/drawing/2014/main" id="{F0586C75-C98B-4252-B986-02A670090769}"/>
+                <a16:creationId xmlns:a16="http://schemas.microsoft.com/office/drawing/2014/main" id="{34034B0B-04A7-4161-92A2-5BEAC30C43EE}"/>
               </a:ext>
             </a:extLst>
           </p:cNvPr>
@@ -3785,7 +3785,7 @@
           <p:cNvPr id="2" name="">
             <a:extLst xmlns:a="http://schemas.openxmlformats.org/drawingml/2006/main">
               <a:ext uri="{FF2B5EF4-FFF2-40B4-BE49-F238E27FC236}">
-                <a16:creationId xmlns:a16="http://schemas.microsoft.com/office/drawing/2014/main" id="{5A2BA3EF-9496-4BAA-8798-0447EB159596}"/>
+                <a16:creationId xmlns:a16="http://schemas.microsoft.com/office/drawing/2014/main" id="{FDC709CB-61A0-4BE9-AAA9-0ADE6D87E267}"/>
               </a:ext>
             </a:extLst>
           </p:cNvPr>
@@ -3842,7 +3842,7 @@
           <p:cNvPr id="3" name="">
             <a:extLst xmlns:a="http://schemas.openxmlformats.org/drawingml/2006/main">
               <a:ext uri="{FF2B5EF4-FFF2-40B4-BE49-F238E27FC236}">
-                <a16:creationId xmlns:a16="http://schemas.microsoft.com/office/drawing/2014/main" id="{747E458F-159B-4A93-9B22-AAB71DFF6E91}"/>
+                <a16:creationId xmlns:a16="http://schemas.microsoft.com/office/drawing/2014/main" id="{0FB056E8-B13D-4592-B34D-D6C8CA0A80A6}"/>
               </a:ext>
             </a:extLst>
           </p:cNvPr>
@@ -3899,7 +3899,7 @@
           <p:cNvPr id="4" name="">
             <a:extLst xmlns:a="http://schemas.openxmlformats.org/drawingml/2006/main">
               <a:ext uri="{FF2B5EF4-FFF2-40B4-BE49-F238E27FC236}">
-                <a16:creationId xmlns:a16="http://schemas.microsoft.com/office/drawing/2014/main" id="{E63779C2-2ACA-4288-98DD-5EA2ED97807A}"/>
+                <a16:creationId xmlns:a16="http://schemas.microsoft.com/office/drawing/2014/main" id="{FDAE2C48-5757-464E-9BD7-107131A3776E}"/>
               </a:ext>
             </a:extLst>
           </p:cNvPr>
@@ -3930,7 +3930,7 @@
           <p:cNvPr id="5" name="">
             <a:extLst xmlns:a="http://schemas.openxmlformats.org/drawingml/2006/main">
               <a:ext uri="{FF2B5EF4-FFF2-40B4-BE49-F238E27FC236}">
-                <a16:creationId xmlns:a16="http://schemas.microsoft.com/office/drawing/2014/main" id="{849AB02D-EE31-4549-9F77-57AB1BCC470A}"/>
+                <a16:creationId xmlns:a16="http://schemas.microsoft.com/office/drawing/2014/main" id="{1D8876D4-55B3-4F53-AAAB-1F9CFDFE561B}"/>
               </a:ext>
             </a:extLst>
           </p:cNvPr>
@@ -3965,7 +3965,7 @@
           <p:cNvPr id="6" name="">
             <a:extLst xmlns:a="http://schemas.openxmlformats.org/drawingml/2006/main">
               <a:ext uri="{FF2B5EF4-FFF2-40B4-BE49-F238E27FC236}">
-                <a16:creationId xmlns:a16="http://schemas.microsoft.com/office/drawing/2014/main" id="{ACCC908C-C9CF-4F97-B272-56DF03162F63}"/>
+                <a16:creationId xmlns:a16="http://schemas.microsoft.com/office/drawing/2014/main" id="{B6EC96E3-30B4-46C3-B8FD-7591FB808341}"/>
               </a:ext>
             </a:extLst>
           </p:cNvPr>
@@ -4029,7 +4029,7 @@
           <p:cNvPr id="7" name="">
             <a:extLst xmlns:a="http://schemas.openxmlformats.org/drawingml/2006/main">
               <a:ext uri="{FF2B5EF4-FFF2-40B4-BE49-F238E27FC236}">
-                <a16:creationId xmlns:a16="http://schemas.microsoft.com/office/drawing/2014/main" id="{33DDF355-2C1A-4EE3-9332-2C3311B89E19}"/>
+                <a16:creationId xmlns:a16="http://schemas.microsoft.com/office/drawing/2014/main" id="{A73BA572-2EFB-4531-A6D4-99ACB65E90B0}"/>
               </a:ext>
             </a:extLst>
           </p:cNvPr>
@@ -4086,7 +4086,7 @@
           <p:cNvPr id="8" name="">
             <a:extLst xmlns:a="http://schemas.openxmlformats.org/drawingml/2006/main">
               <a:ext uri="{FF2B5EF4-FFF2-40B4-BE49-F238E27FC236}">
-                <a16:creationId xmlns:a16="http://schemas.microsoft.com/office/drawing/2014/main" id="{F30229A5-820C-4BA5-8B26-BA77842772EC}"/>
+                <a16:creationId xmlns:a16="http://schemas.microsoft.com/office/drawing/2014/main" id="{F03C9CF0-EC89-4ABB-AA8E-C377AEE7B249}"/>
               </a:ext>
             </a:extLst>
           </p:cNvPr>
@@ -4166,7 +4166,7 @@
           <p:cNvPr id="9" name="">
             <a:extLst xmlns:a="http://schemas.openxmlformats.org/drawingml/2006/main">
               <a:ext uri="{FF2B5EF4-FFF2-40B4-BE49-F238E27FC236}">
-                <a16:creationId xmlns:a16="http://schemas.microsoft.com/office/drawing/2014/main" id="{DF68492C-1280-46E6-92EB-77FA3FBD54F3}"/>
+                <a16:creationId xmlns:a16="http://schemas.microsoft.com/office/drawing/2014/main" id="{00F2376D-FCF5-491D-AFFC-C197EFF2270C}"/>
               </a:ext>
             </a:extLst>
           </p:cNvPr>
@@ -4198,7 +4198,7 @@
           <p:cNvPr id="10" name="">
             <a:extLst xmlns:a="http://schemas.openxmlformats.org/drawingml/2006/main">
               <a:ext uri="{FF2B5EF4-FFF2-40B4-BE49-F238E27FC236}">
-                <a16:creationId xmlns:a16="http://schemas.microsoft.com/office/drawing/2014/main" id="{F08C9F4E-C7C7-44BD-AE40-FFCB4664F020}"/>
+                <a16:creationId xmlns:a16="http://schemas.microsoft.com/office/drawing/2014/main" id="{27B0698B-4C6C-4D3E-80E0-CE139F5E88FF}"/>
               </a:ext>
             </a:extLst>
           </p:cNvPr>
@@ -4233,7 +4233,7 @@
           <p:cNvPr id="11" name="">
             <a:extLst xmlns:a="http://schemas.openxmlformats.org/drawingml/2006/main">
               <a:ext uri="{FF2B5EF4-FFF2-40B4-BE49-F238E27FC236}">
-                <a16:creationId xmlns:a16="http://schemas.microsoft.com/office/drawing/2014/main" id="{8E1EF217-1CCC-4D7F-B1A1-0F7E9596D13A}"/>
+                <a16:creationId xmlns:a16="http://schemas.microsoft.com/office/drawing/2014/main" id="{A223A746-4A9E-4463-B418-CA79B3309B31}"/>
               </a:ext>
             </a:extLst>
           </p:cNvPr>
@@ -4297,7 +4297,7 @@
           <p:cNvPr id="12" name="">
             <a:extLst xmlns:a="http://schemas.openxmlformats.org/drawingml/2006/main">
               <a:ext uri="{FF2B5EF4-FFF2-40B4-BE49-F238E27FC236}">
-                <a16:creationId xmlns:a16="http://schemas.microsoft.com/office/drawing/2014/main" id="{421EF4DE-E7F8-49B1-BAC2-75CDBCDC30E5}"/>
+                <a16:creationId xmlns:a16="http://schemas.microsoft.com/office/drawing/2014/main" id="{EC752732-656B-4D24-8185-253F98F580F5}"/>
               </a:ext>
             </a:extLst>
           </p:cNvPr>
@@ -4354,7 +4354,7 @@
           <p:cNvPr id="13" name="">
             <a:extLst xmlns:a="http://schemas.openxmlformats.org/drawingml/2006/main">
               <a:ext uri="{FF2B5EF4-FFF2-40B4-BE49-F238E27FC236}">
-                <a16:creationId xmlns:a16="http://schemas.microsoft.com/office/drawing/2014/main" id="{4E020E29-9597-4F41-BA74-611BA77C56BD}"/>
+                <a16:creationId xmlns:a16="http://schemas.microsoft.com/office/drawing/2014/main" id="{3AA028AE-B222-4ADF-A904-FD94B131A59C}"/>
               </a:ext>
             </a:extLst>
           </p:cNvPr>
@@ -4434,7 +4434,7 @@
           <p:cNvPr id="14" name="">
             <a:extLst xmlns:a="http://schemas.openxmlformats.org/drawingml/2006/main">
               <a:ext uri="{FF2B5EF4-FFF2-40B4-BE49-F238E27FC236}">
-                <a16:creationId xmlns:a16="http://schemas.microsoft.com/office/drawing/2014/main" id="{95E0EE37-93B7-4C5F-9506-878236FD3D34}"/>
+                <a16:creationId xmlns:a16="http://schemas.microsoft.com/office/drawing/2014/main" id="{7F24AE29-842F-4842-99D5-85FCED0CD9A0}"/>
               </a:ext>
             </a:extLst>
           </p:cNvPr>
@@ -4466,7 +4466,7 @@
           <p:cNvPr id="15" name="">
             <a:extLst xmlns:a="http://schemas.openxmlformats.org/drawingml/2006/main">
               <a:ext uri="{FF2B5EF4-FFF2-40B4-BE49-F238E27FC236}">
-                <a16:creationId xmlns:a16="http://schemas.microsoft.com/office/drawing/2014/main" id="{8E3410E9-160B-470F-80E9-A23031DFEDC7}"/>
+                <a16:creationId xmlns:a16="http://schemas.microsoft.com/office/drawing/2014/main" id="{A9B62746-C8CB-4973-933C-68029C934767}"/>
               </a:ext>
             </a:extLst>
           </p:cNvPr>
@@ -4501,7 +4501,7 @@
           <p:cNvPr id="16" name="">
             <a:extLst xmlns:a="http://schemas.openxmlformats.org/drawingml/2006/main">
               <a:ext uri="{FF2B5EF4-FFF2-40B4-BE49-F238E27FC236}">
-                <a16:creationId xmlns:a16="http://schemas.microsoft.com/office/drawing/2014/main" id="{6AA9C234-52C5-4E5A-AA61-5150F9B11C10}"/>
+                <a16:creationId xmlns:a16="http://schemas.microsoft.com/office/drawing/2014/main" id="{AADA293A-624A-4778-AB22-528EA7BFFD94}"/>
               </a:ext>
             </a:extLst>
           </p:cNvPr>
@@ -4565,7 +4565,7 @@
           <p:cNvPr id="17" name="">
             <a:extLst xmlns:a="http://schemas.openxmlformats.org/drawingml/2006/main">
               <a:ext uri="{FF2B5EF4-FFF2-40B4-BE49-F238E27FC236}">
-                <a16:creationId xmlns:a16="http://schemas.microsoft.com/office/drawing/2014/main" id="{A834956C-E8EF-45B0-9A3D-51B9CE6DE2E3}"/>
+                <a16:creationId xmlns:a16="http://schemas.microsoft.com/office/drawing/2014/main" id="{D40FC672-2631-4418-A56F-78C67CC33C8C}"/>
               </a:ext>
             </a:extLst>
           </p:cNvPr>
@@ -4622,7 +4622,7 @@
           <p:cNvPr id="18" name="">
             <a:extLst xmlns:a="http://schemas.openxmlformats.org/drawingml/2006/main">
               <a:ext uri="{FF2B5EF4-FFF2-40B4-BE49-F238E27FC236}">
-                <a16:creationId xmlns:a16="http://schemas.microsoft.com/office/drawing/2014/main" id="{01BCAEB7-378B-455C-BA43-1DEB35FE0AC4}"/>
+                <a16:creationId xmlns:a16="http://schemas.microsoft.com/office/drawing/2014/main" id="{20DFEFF6-0F07-427E-80B5-A68FF551DB1E}"/>
               </a:ext>
             </a:extLst>
           </p:cNvPr>
@@ -4702,7 +4702,7 @@
           <p:cNvPr id="19" name="">
             <a:extLst xmlns:a="http://schemas.openxmlformats.org/drawingml/2006/main">
               <a:ext uri="{FF2B5EF4-FFF2-40B4-BE49-F238E27FC236}">
-                <a16:creationId xmlns:a16="http://schemas.microsoft.com/office/drawing/2014/main" id="{F8E67C9A-F0A0-4D03-AFEA-92E4B9012186}"/>
+                <a16:creationId xmlns:a16="http://schemas.microsoft.com/office/drawing/2014/main" id="{AAFF1E78-0904-4D9B-B005-4326F5865226}"/>
               </a:ext>
             </a:extLst>
           </p:cNvPr>
@@ -4734,7 +4734,7 @@
           <p:cNvPr id="20" name="">
             <a:extLst xmlns:a="http://schemas.openxmlformats.org/drawingml/2006/main">
               <a:ext uri="{FF2B5EF4-FFF2-40B4-BE49-F238E27FC236}">
-                <a16:creationId xmlns:a16="http://schemas.microsoft.com/office/drawing/2014/main" id="{12E8ABC7-1C72-411C-89E4-06613F507478}"/>
+                <a16:creationId xmlns:a16="http://schemas.microsoft.com/office/drawing/2014/main" id="{E91B812E-F482-494C-9821-370767633E90}"/>
               </a:ext>
             </a:extLst>
           </p:cNvPr>
@@ -4769,7 +4769,7 @@
           <p:cNvPr id="21" name="">
             <a:extLst xmlns:a="http://schemas.openxmlformats.org/drawingml/2006/main">
               <a:ext uri="{FF2B5EF4-FFF2-40B4-BE49-F238E27FC236}">
-                <a16:creationId xmlns:a16="http://schemas.microsoft.com/office/drawing/2014/main" id="{6C6D4DB4-BC2F-4967-A19E-05E42BAABED5}"/>
+                <a16:creationId xmlns:a16="http://schemas.microsoft.com/office/drawing/2014/main" id="{4DE36F8D-7157-4172-B4CC-A1316187B7B4}"/>
               </a:ext>
             </a:extLst>
           </p:cNvPr>
@@ -4833,7 +4833,7 @@
           <p:cNvPr id="22" name="">
             <a:extLst xmlns:a="http://schemas.openxmlformats.org/drawingml/2006/main">
               <a:ext uri="{FF2B5EF4-FFF2-40B4-BE49-F238E27FC236}">
-                <a16:creationId xmlns:a16="http://schemas.microsoft.com/office/drawing/2014/main" id="{656BF8CC-EBED-4562-973A-8C6089EC43CB}"/>
+                <a16:creationId xmlns:a16="http://schemas.microsoft.com/office/drawing/2014/main" id="{920C9D38-151A-4ECA-AAD1-6F20C66E1BD8}"/>
               </a:ext>
             </a:extLst>
           </p:cNvPr>
@@ -4890,7 +4890,7 @@
           <p:cNvPr id="23" name="">
             <a:extLst xmlns:a="http://schemas.openxmlformats.org/drawingml/2006/main">
               <a:ext uri="{FF2B5EF4-FFF2-40B4-BE49-F238E27FC236}">
-                <a16:creationId xmlns:a16="http://schemas.microsoft.com/office/drawing/2014/main" id="{35491D20-8797-4871-A258-C74FB49A7D56}"/>
+                <a16:creationId xmlns:a16="http://schemas.microsoft.com/office/drawing/2014/main" id="{7E73DF2A-13F3-416D-B3F9-8A07D8CE9766}"/>
               </a:ext>
             </a:extLst>
           </p:cNvPr>
@@ -4970,7 +4970,7 @@
           <p:cNvPr id="24" name="">
             <a:extLst xmlns:a="http://schemas.openxmlformats.org/drawingml/2006/main">
               <a:ext uri="{FF2B5EF4-FFF2-40B4-BE49-F238E27FC236}">
-                <a16:creationId xmlns:a16="http://schemas.microsoft.com/office/drawing/2014/main" id="{43E6336B-D178-4F70-84F8-38EFAFA72A37}"/>
+                <a16:creationId xmlns:a16="http://schemas.microsoft.com/office/drawing/2014/main" id="{627DD804-CA21-4E34-9312-20B30B799725}"/>
               </a:ext>
             </a:extLst>
           </p:cNvPr>
@@ -5002,7 +5002,7 @@
           <p:cNvPr id="25" name="">
             <a:extLst xmlns:a="http://schemas.openxmlformats.org/drawingml/2006/main">
               <a:ext uri="{FF2B5EF4-FFF2-40B4-BE49-F238E27FC236}">
-                <a16:creationId xmlns:a16="http://schemas.microsoft.com/office/drawing/2014/main" id="{640D047A-0390-4933-9BAC-17B504592E65}"/>
+                <a16:creationId xmlns:a16="http://schemas.microsoft.com/office/drawing/2014/main" id="{C87661B0-725C-4108-8D2D-0411469F728B}"/>
               </a:ext>
             </a:extLst>
           </p:cNvPr>
@@ -5037,7 +5037,7 @@
           <p:cNvPr id="26" name="">
             <a:extLst xmlns:a="http://schemas.openxmlformats.org/drawingml/2006/main">
               <a:ext uri="{FF2B5EF4-FFF2-40B4-BE49-F238E27FC236}">
-                <a16:creationId xmlns:a16="http://schemas.microsoft.com/office/drawing/2014/main" id="{844DEE74-B7CE-4777-8AF3-B92E301BC944}"/>
+                <a16:creationId xmlns:a16="http://schemas.microsoft.com/office/drawing/2014/main" id="{428FEE29-106F-46A6-9989-7B6DAA13376A}"/>
               </a:ext>
             </a:extLst>
           </p:cNvPr>
@@ -5101,7 +5101,7 @@
           <p:cNvPr id="27" name="">
             <a:extLst xmlns:a="http://schemas.openxmlformats.org/drawingml/2006/main">
               <a:ext uri="{FF2B5EF4-FFF2-40B4-BE49-F238E27FC236}">
-                <a16:creationId xmlns:a16="http://schemas.microsoft.com/office/drawing/2014/main" id="{501DEDC2-2813-482D-808A-18AA640974CD}"/>
+                <a16:creationId xmlns:a16="http://schemas.microsoft.com/office/drawing/2014/main" id="{E25EA7AD-B544-4913-B0CD-A5A0714391BD}"/>
               </a:ext>
             </a:extLst>
           </p:cNvPr>
@@ -5158,7 +5158,7 @@
           <p:cNvPr id="28" name="">
             <a:extLst xmlns:a="http://schemas.openxmlformats.org/drawingml/2006/main">
               <a:ext uri="{FF2B5EF4-FFF2-40B4-BE49-F238E27FC236}">
-                <a16:creationId xmlns:a16="http://schemas.microsoft.com/office/drawing/2014/main" id="{AA8E4084-89BF-4BC8-ACB0-0C3AAB6E1C48}"/>
+                <a16:creationId xmlns:a16="http://schemas.microsoft.com/office/drawing/2014/main" id="{47409356-290F-4951-B5B1-2D9FBC802A38}"/>
               </a:ext>
             </a:extLst>
           </p:cNvPr>
@@ -5238,7 +5238,7 @@
           <p:cNvPr id="29" name="">
             <a:extLst xmlns:a="http://schemas.openxmlformats.org/drawingml/2006/main">
               <a:ext uri="{FF2B5EF4-FFF2-40B4-BE49-F238E27FC236}">
-                <a16:creationId xmlns:a16="http://schemas.microsoft.com/office/drawing/2014/main" id="{A5984B40-447F-47B3-930D-79E11A692C8E}"/>
+                <a16:creationId xmlns:a16="http://schemas.microsoft.com/office/drawing/2014/main" id="{8114CA65-5DA4-459F-B9A1-00FE8DC671D8}"/>
               </a:ext>
             </a:extLst>
           </p:cNvPr>
@@ -5295,7 +5295,7 @@
           <p:cNvPr id="30" name="">
             <a:extLst xmlns:a="http://schemas.openxmlformats.org/drawingml/2006/main">
               <a:ext uri="{FF2B5EF4-FFF2-40B4-BE49-F238E27FC236}">
-                <a16:creationId xmlns:a16="http://schemas.microsoft.com/office/drawing/2014/main" id="{493894BE-46F6-4990-9C04-391D84005E71}"/>
+                <a16:creationId xmlns:a16="http://schemas.microsoft.com/office/drawing/2014/main" id="{719495DE-F2B9-42D9-BFF8-728C41922700}"/>
               </a:ext>
             </a:extLst>
           </p:cNvPr>
@@ -5330,7 +5330,7 @@
           <p:cNvPr id="31" name="">
             <a:extLst xmlns:a="http://schemas.openxmlformats.org/drawingml/2006/main">
               <a:ext uri="{FF2B5EF4-FFF2-40B4-BE49-F238E27FC236}">
-                <a16:creationId xmlns:a16="http://schemas.microsoft.com/office/drawing/2014/main" id="{03650ABA-8208-4E6E-99D3-E14E0963DC0A}"/>
+                <a16:creationId xmlns:a16="http://schemas.microsoft.com/office/drawing/2014/main" id="{585BD8BC-5ACA-4C5D-98F7-6DEF97E1787D}"/>
               </a:ext>
             </a:extLst>
           </p:cNvPr>
@@ -5387,7 +5387,7 @@
           <p:cNvPr id="32" name="">
             <a:extLst xmlns:a="http://schemas.openxmlformats.org/drawingml/2006/main">
               <a:ext uri="{FF2B5EF4-FFF2-40B4-BE49-F238E27FC236}">
-                <a16:creationId xmlns:a16="http://schemas.microsoft.com/office/drawing/2014/main" id="{9B20AB6D-769C-46E8-9F8F-AFE6DFFD5F44}"/>
+                <a16:creationId xmlns:a16="http://schemas.microsoft.com/office/drawing/2014/main" id="{F868A118-4C33-4D26-B25A-3057BED69E50}"/>
               </a:ext>
             </a:extLst>
           </p:cNvPr>
@@ -5490,7 +5490,7 @@
           <p:cNvPr id="33" name="">
             <a:extLst xmlns:a="http://schemas.openxmlformats.org/drawingml/2006/main">
               <a:ext uri="{FF2B5EF4-FFF2-40B4-BE49-F238E27FC236}">
-                <a16:creationId xmlns:a16="http://schemas.microsoft.com/office/drawing/2014/main" id="{CC43028B-0556-4558-9472-D2F5CE8E94B1}"/>
+                <a16:creationId xmlns:a16="http://schemas.microsoft.com/office/drawing/2014/main" id="{2EE4D0A8-8ED7-4A86-BA64-5420590517CF}"/>
               </a:ext>
             </a:extLst>
           </p:cNvPr>
@@ -5554,7 +5554,7 @@
           <p:cNvPr id="34" name="">
             <a:extLst xmlns:a="http://schemas.openxmlformats.org/drawingml/2006/main">
               <a:ext uri="{FF2B5EF4-FFF2-40B4-BE49-F238E27FC236}">
-                <a16:creationId xmlns:a16="http://schemas.microsoft.com/office/drawing/2014/main" id="{FEAE5E12-D3C6-4F94-917C-2C7C00741191}"/>
+                <a16:creationId xmlns:a16="http://schemas.microsoft.com/office/drawing/2014/main" id="{47DF43A6-44FE-407B-AB34-51D9B61E2C4C}"/>
               </a:ext>
             </a:extLst>
           </p:cNvPr>
@@ -5611,7 +5611,7 @@
           <p:cNvPr id="35" name="">
             <a:extLst xmlns:a="http://schemas.openxmlformats.org/drawingml/2006/main">
               <a:ext uri="{FF2B5EF4-FFF2-40B4-BE49-F238E27FC236}">
-                <a16:creationId xmlns:a16="http://schemas.microsoft.com/office/drawing/2014/main" id="{E9845954-9B77-43FC-8441-C58025B2B1B3}"/>
+                <a16:creationId xmlns:a16="http://schemas.microsoft.com/office/drawing/2014/main" id="{A2EA5367-EC49-4DCE-A467-83A67A2E0892}"/>
               </a:ext>
             </a:extLst>
           </p:cNvPr>
@@ -5646,7 +5646,7 @@
           <p:cNvPr id="36" name="">
             <a:extLst xmlns:a="http://schemas.openxmlformats.org/drawingml/2006/main">
               <a:ext uri="{FF2B5EF4-FFF2-40B4-BE49-F238E27FC236}">
-                <a16:creationId xmlns:a16="http://schemas.microsoft.com/office/drawing/2014/main" id="{FB092659-9744-4F91-B37A-B7C98F754DBA}"/>
+                <a16:creationId xmlns:a16="http://schemas.microsoft.com/office/drawing/2014/main" id="{9580D55C-E064-4385-88D5-10431B43C9F6}"/>
               </a:ext>
             </a:extLst>
           </p:cNvPr>
@@ -5703,7 +5703,7 @@
           <p:cNvPr id="37" name="">
             <a:extLst xmlns:a="http://schemas.openxmlformats.org/drawingml/2006/main">
               <a:ext uri="{FF2B5EF4-FFF2-40B4-BE49-F238E27FC236}">
-                <a16:creationId xmlns:a16="http://schemas.microsoft.com/office/drawing/2014/main" id="{EDAC24FD-9AD9-4628-8E2F-D8FB47E6A170}"/>
+                <a16:creationId xmlns:a16="http://schemas.microsoft.com/office/drawing/2014/main" id="{678AFBFF-395C-4782-9F29-68F9943265CA}"/>
               </a:ext>
             </a:extLst>
           </p:cNvPr>
@@ -5738,7 +5738,7 @@
           <p:cNvPr id="38" name="">
             <a:extLst xmlns:a="http://schemas.openxmlformats.org/drawingml/2006/main">
               <a:ext uri="{FF2B5EF4-FFF2-40B4-BE49-F238E27FC236}">
-                <a16:creationId xmlns:a16="http://schemas.microsoft.com/office/drawing/2014/main" id="{2E15FC81-A5F7-4244-8BF1-37B657AAD139}"/>
+                <a16:creationId xmlns:a16="http://schemas.microsoft.com/office/drawing/2014/main" id="{961B5069-893B-4EA6-9B37-FDBD2BC92910}"/>
               </a:ext>
             </a:extLst>
           </p:cNvPr>
@@ -5795,7 +5795,7 @@
           <p:cNvPr id="39" name="">
             <a:extLst xmlns:a="http://schemas.openxmlformats.org/drawingml/2006/main">
               <a:ext uri="{FF2B5EF4-FFF2-40B4-BE49-F238E27FC236}">
-                <a16:creationId xmlns:a16="http://schemas.microsoft.com/office/drawing/2014/main" id="{CE358DD8-17E8-4F68-8F94-12F35A6C3717}"/>
+                <a16:creationId xmlns:a16="http://schemas.microsoft.com/office/drawing/2014/main" id="{5C3A3AB7-64B7-46A6-99DE-652B83EDE0AE}"/>
               </a:ext>
             </a:extLst>
           </p:cNvPr>
@@ -5852,7 +5852,7 @@
           <p:cNvPr id="40" name="">
             <a:extLst xmlns:a="http://schemas.openxmlformats.org/drawingml/2006/main">
               <a:ext uri="{FF2B5EF4-FFF2-40B4-BE49-F238E27FC236}">
-                <a16:creationId xmlns:a16="http://schemas.microsoft.com/office/drawing/2014/main" id="{43BC5806-17BB-41AB-99E5-8DD63C5752FB}"/>
+                <a16:creationId xmlns:a16="http://schemas.microsoft.com/office/drawing/2014/main" id="{44475B7B-7128-493D-8906-631CE2B72D10}"/>
               </a:ext>
             </a:extLst>
           </p:cNvPr>
@@ -5887,7 +5887,7 @@
           <p:cNvPr id="41" name="">
             <a:extLst xmlns:a="http://schemas.openxmlformats.org/drawingml/2006/main">
               <a:ext uri="{FF2B5EF4-FFF2-40B4-BE49-F238E27FC236}">
-                <a16:creationId xmlns:a16="http://schemas.microsoft.com/office/drawing/2014/main" id="{4AEF675E-5DBA-4A20-92CA-D57BDF942E72}"/>
+                <a16:creationId xmlns:a16="http://schemas.microsoft.com/office/drawing/2014/main" id="{55B4506B-BCE3-4820-BABF-CFB78F5A021F}"/>
               </a:ext>
             </a:extLst>
           </p:cNvPr>
@@ -5944,7 +5944,7 @@
           <p:cNvPr id="42" name="">
             <a:extLst xmlns:a="http://schemas.openxmlformats.org/drawingml/2006/main">
               <a:ext uri="{FF2B5EF4-FFF2-40B4-BE49-F238E27FC236}">
-                <a16:creationId xmlns:a16="http://schemas.microsoft.com/office/drawing/2014/main" id="{50C35F6A-0BDD-4143-B675-B3DA91E8C1FB}"/>
+                <a16:creationId xmlns:a16="http://schemas.microsoft.com/office/drawing/2014/main" id="{BEA32EB8-68E0-4BF7-B8FD-FD8826E39B13}"/>
               </a:ext>
             </a:extLst>
           </p:cNvPr>
@@ -6001,7 +6001,7 @@
           <p:cNvPr id="43" name="">
             <a:extLst xmlns:a="http://schemas.openxmlformats.org/drawingml/2006/main">
               <a:ext uri="{FF2B5EF4-FFF2-40B4-BE49-F238E27FC236}">
-                <a16:creationId xmlns:a16="http://schemas.microsoft.com/office/drawing/2014/main" id="{F43BE1B8-7602-4AB8-AB28-36271404B328}"/>
+                <a16:creationId xmlns:a16="http://schemas.microsoft.com/office/drawing/2014/main" id="{BE25CF04-0570-46F9-AA4F-17788A988EC3}"/>
               </a:ext>
             </a:extLst>
           </p:cNvPr>
@@ -6058,7 +6058,7 @@
           <p:cNvPr id="44" name="">
             <a:extLst xmlns:a="http://schemas.openxmlformats.org/drawingml/2006/main">
               <a:ext uri="{FF2B5EF4-FFF2-40B4-BE49-F238E27FC236}">
-                <a16:creationId xmlns:a16="http://schemas.microsoft.com/office/drawing/2014/main" id="{09E90B63-3BB3-4C33-A2E7-93EDC0B86D70}"/>
+                <a16:creationId xmlns:a16="http://schemas.microsoft.com/office/drawing/2014/main" id="{13A2AEDE-E5E5-4984-9FD3-A82373F5E5AE}"/>
               </a:ext>
             </a:extLst>
           </p:cNvPr>
@@ -6115,7 +6115,7 @@
           <p:cNvPr id="45" name="">
             <a:extLst xmlns:a="http://schemas.openxmlformats.org/drawingml/2006/main">
               <a:ext uri="{FF2B5EF4-FFF2-40B4-BE49-F238E27FC236}">
-                <a16:creationId xmlns:a16="http://schemas.microsoft.com/office/drawing/2014/main" id="{912E1AEA-B9B0-4976-ABF5-EDED3B8CE1FE}"/>
+                <a16:creationId xmlns:a16="http://schemas.microsoft.com/office/drawing/2014/main" id="{9870032B-322F-437F-9C8F-ECFCA8781160}"/>
               </a:ext>
             </a:extLst>
           </p:cNvPr>
@@ -6170,7 +6170,7 @@
     </p:spTree>
     <p:extLst>
       <p:ext uri="{BB962C8B-B14F-4D97-AF65-F5344CB8AC3E}">
-        <p14:creationId xmlns:p14="http://schemas.microsoft.com/office/powerpoint/2010/main" val="1050134164"/>
+        <p14:creationId xmlns:p14="http://schemas.microsoft.com/office/powerpoint/2010/main" val="333571261"/>
       </p:ext>
     </p:extLst>
   </p:cSld>
@@ -6201,7 +6201,7 @@
           <p:cNvPr id="32" name="">
             <a:extLst xmlns:a="http://schemas.openxmlformats.org/drawingml/2006/main">
               <a:ext uri="{FF2B5EF4-FFF2-40B4-BE49-F238E27FC236}">
-                <a16:creationId xmlns:a16="http://schemas.microsoft.com/office/drawing/2014/main" id="{6745D9E7-A059-4AE6-9F23-C85C165790BF}"/>
+                <a16:creationId xmlns:a16="http://schemas.microsoft.com/office/drawing/2014/main" id="{D6814511-6D5A-47AB-B83B-0C7B2F64AB4E}"/>
               </a:ext>
             </a:extLst>
           </p:cNvPr>
@@ -6258,7 +6258,7 @@
           <p:cNvPr id="2" name="">
             <a:extLst xmlns:a="http://schemas.openxmlformats.org/drawingml/2006/main">
               <a:ext uri="{FF2B5EF4-FFF2-40B4-BE49-F238E27FC236}">
-                <a16:creationId xmlns:a16="http://schemas.microsoft.com/office/drawing/2014/main" id="{1F1224A1-35EF-434E-8089-3C0DBEEFD258}"/>
+                <a16:creationId xmlns:a16="http://schemas.microsoft.com/office/drawing/2014/main" id="{398BFE22-C547-45B4-A805-520D25D785F4}"/>
               </a:ext>
             </a:extLst>
           </p:cNvPr>
@@ -6315,7 +6315,7 @@
           <p:cNvPr id="3" name="">
             <a:extLst xmlns:a="http://schemas.openxmlformats.org/drawingml/2006/main">
               <a:ext uri="{FF2B5EF4-FFF2-40B4-BE49-F238E27FC236}">
-                <a16:creationId xmlns:a16="http://schemas.microsoft.com/office/drawing/2014/main" id="{8E856892-A6CC-40E4-990C-0801C7D7B59B}"/>
+                <a16:creationId xmlns:a16="http://schemas.microsoft.com/office/drawing/2014/main" id="{8AAFEFC3-0DDE-4E42-A6BD-1FB379F4796C}"/>
               </a:ext>
             </a:extLst>
           </p:cNvPr>
@@ -6372,7 +6372,7 @@
           <p:cNvPr id="4" name="">
             <a:extLst xmlns:a="http://schemas.openxmlformats.org/drawingml/2006/main">
               <a:ext uri="{FF2B5EF4-FFF2-40B4-BE49-F238E27FC236}">
-                <a16:creationId xmlns:a16="http://schemas.microsoft.com/office/drawing/2014/main" id="{2BD52939-A942-4110-B881-08AE1FD0A6A2}"/>
+                <a16:creationId xmlns:a16="http://schemas.microsoft.com/office/drawing/2014/main" id="{A19EA75F-90CF-48D3-BB59-073E637B9C22}"/>
               </a:ext>
             </a:extLst>
           </p:cNvPr>
@@ -6403,7 +6403,7 @@
           <p:cNvPr id="5" name="">
             <a:extLst xmlns:a="http://schemas.openxmlformats.org/drawingml/2006/main">
               <a:ext uri="{FF2B5EF4-FFF2-40B4-BE49-F238E27FC236}">
-                <a16:creationId xmlns:a16="http://schemas.microsoft.com/office/drawing/2014/main" id="{08C9D95A-83F7-4666-9217-1694367ECE50}"/>
+                <a16:creationId xmlns:a16="http://schemas.microsoft.com/office/drawing/2014/main" id="{26668893-0187-4858-A289-1732354463AD}"/>
               </a:ext>
             </a:extLst>
           </p:cNvPr>
@@ -6438,7 +6438,7 @@
           <p:cNvPr id="6" name="">
             <a:extLst xmlns:a="http://schemas.openxmlformats.org/drawingml/2006/main">
               <a:ext uri="{FF2B5EF4-FFF2-40B4-BE49-F238E27FC236}">
-                <a16:creationId xmlns:a16="http://schemas.microsoft.com/office/drawing/2014/main" id="{B7B0FCCF-AF53-42FD-9797-599F2DE6737F}"/>
+                <a16:creationId xmlns:a16="http://schemas.microsoft.com/office/drawing/2014/main" id="{812373ED-144D-4F1F-9AA8-11D36BE1E5DF}"/>
               </a:ext>
             </a:extLst>
           </p:cNvPr>
@@ -6502,7 +6502,7 @@
           <p:cNvPr id="7" name="">
             <a:extLst xmlns:a="http://schemas.openxmlformats.org/drawingml/2006/main">
               <a:ext uri="{FF2B5EF4-FFF2-40B4-BE49-F238E27FC236}">
-                <a16:creationId xmlns:a16="http://schemas.microsoft.com/office/drawing/2014/main" id="{3A6A8AAD-BB5A-4411-9951-536E4E828223}"/>
+                <a16:creationId xmlns:a16="http://schemas.microsoft.com/office/drawing/2014/main" id="{6EBD209D-C26A-477D-B9BD-9D2FD454727B}"/>
               </a:ext>
             </a:extLst>
           </p:cNvPr>
@@ -6559,7 +6559,7 @@
           <p:cNvPr id="8" name="">
             <a:extLst xmlns:a="http://schemas.openxmlformats.org/drawingml/2006/main">
               <a:ext uri="{FF2B5EF4-FFF2-40B4-BE49-F238E27FC236}">
-                <a16:creationId xmlns:a16="http://schemas.microsoft.com/office/drawing/2014/main" id="{D22B9F17-8726-4632-A379-0F14A900071D}"/>
+                <a16:creationId xmlns:a16="http://schemas.microsoft.com/office/drawing/2014/main" id="{FA5019B4-6E6D-4E65-A04A-EF5E1083A91E}"/>
               </a:ext>
             </a:extLst>
           </p:cNvPr>
@@ -6662,7 +6662,7 @@
           <p:cNvPr id="9" name="">
             <a:extLst xmlns:a="http://schemas.openxmlformats.org/drawingml/2006/main">
               <a:ext uri="{FF2B5EF4-FFF2-40B4-BE49-F238E27FC236}">
-                <a16:creationId xmlns:a16="http://schemas.microsoft.com/office/drawing/2014/main" id="{4ABBB5D3-C717-4A0E-83CF-71BAE21EF202}"/>
+                <a16:creationId xmlns:a16="http://schemas.microsoft.com/office/drawing/2014/main" id="{4DA1F89F-F9E2-4553-99E8-733E488A728E}"/>
               </a:ext>
             </a:extLst>
           </p:cNvPr>
@@ -6697,7 +6697,7 @@
           <p:cNvPr id="10" name="">
             <a:extLst xmlns:a="http://schemas.openxmlformats.org/drawingml/2006/main">
               <a:ext uri="{FF2B5EF4-FFF2-40B4-BE49-F238E27FC236}">
-                <a16:creationId xmlns:a16="http://schemas.microsoft.com/office/drawing/2014/main" id="{2BD4CCBE-F333-44A2-88BD-9CB597C23191}"/>
+                <a16:creationId xmlns:a16="http://schemas.microsoft.com/office/drawing/2014/main" id="{D538C8F4-E17B-43DA-BEB4-71666E7AFEF4}"/>
               </a:ext>
             </a:extLst>
           </p:cNvPr>
@@ -6761,7 +6761,7 @@
           <p:cNvPr id="11" name="">
             <a:extLst xmlns:a="http://schemas.openxmlformats.org/drawingml/2006/main">
               <a:ext uri="{FF2B5EF4-FFF2-40B4-BE49-F238E27FC236}">
-                <a16:creationId xmlns:a16="http://schemas.microsoft.com/office/drawing/2014/main" id="{5420D233-BA36-4BAE-8A31-5BB12479860C}"/>
+                <a16:creationId xmlns:a16="http://schemas.microsoft.com/office/drawing/2014/main" id="{26615079-BC91-4112-8298-BFF1B90815F0}"/>
               </a:ext>
             </a:extLst>
           </p:cNvPr>
@@ -6818,7 +6818,7 @@
           <p:cNvPr id="12" name="">
             <a:extLst xmlns:a="http://schemas.openxmlformats.org/drawingml/2006/main">
               <a:ext uri="{FF2B5EF4-FFF2-40B4-BE49-F238E27FC236}">
-                <a16:creationId xmlns:a16="http://schemas.microsoft.com/office/drawing/2014/main" id="{1D8C96A5-C221-44F2-AA99-E9F056900D35}"/>
+                <a16:creationId xmlns:a16="http://schemas.microsoft.com/office/drawing/2014/main" id="{DD306B08-D72B-4DE1-BAF1-A1CB52B03637}"/>
               </a:ext>
             </a:extLst>
           </p:cNvPr>
@@ -6921,7 +6921,7 @@
           <p:cNvPr id="13" name="">
             <a:extLst xmlns:a="http://schemas.openxmlformats.org/drawingml/2006/main">
               <a:ext uri="{FF2B5EF4-FFF2-40B4-BE49-F238E27FC236}">
-                <a16:creationId xmlns:a16="http://schemas.microsoft.com/office/drawing/2014/main" id="{6BB9B0CE-6C90-43DF-859D-8D92BF89EC75}"/>
+                <a16:creationId xmlns:a16="http://schemas.microsoft.com/office/drawing/2014/main" id="{756BDACE-45C7-4B58-A39A-7A340BF43444}"/>
               </a:ext>
             </a:extLst>
           </p:cNvPr>
@@ -6978,7 +6978,7 @@
           <p:cNvPr id="14" name="">
             <a:extLst xmlns:a="http://schemas.openxmlformats.org/drawingml/2006/main">
               <a:ext uri="{FF2B5EF4-FFF2-40B4-BE49-F238E27FC236}">
-                <a16:creationId xmlns:a16="http://schemas.microsoft.com/office/drawing/2014/main" id="{B8968228-F613-42F9-9E2E-37B8E0289E5E}"/>
+                <a16:creationId xmlns:a16="http://schemas.microsoft.com/office/drawing/2014/main" id="{B92C8A78-0B92-44A4-8E17-CDD16861D741}"/>
               </a:ext>
             </a:extLst>
           </p:cNvPr>
@@ -7013,7 +7013,7 @@
           <p:cNvPr id="15" name="">
             <a:extLst xmlns:a="http://schemas.openxmlformats.org/drawingml/2006/main">
               <a:ext uri="{FF2B5EF4-FFF2-40B4-BE49-F238E27FC236}">
-                <a16:creationId xmlns:a16="http://schemas.microsoft.com/office/drawing/2014/main" id="{C3294B12-D3A1-4E38-99F5-6A33BC09320A}"/>
+                <a16:creationId xmlns:a16="http://schemas.microsoft.com/office/drawing/2014/main" id="{20C0178F-E5A0-4AFC-ABE9-6A3648287C03}"/>
               </a:ext>
             </a:extLst>
           </p:cNvPr>
@@ -7060,7 +7060,7 @@
                 <a:ea typeface="Arial"/>
                 <a:cs typeface="Arial"/>
               </a:rPr>
-              <a:t>100/100</a:t>
+              <a:t>102/102</a:t>
             </a:r>
           </a:p>
         </p:txBody>
@@ -7070,7 +7070,7 @@
           <p:cNvPr id="16" name="">
             <a:extLst xmlns:a="http://schemas.openxmlformats.org/drawingml/2006/main">
               <a:ext uri="{FF2B5EF4-FFF2-40B4-BE49-F238E27FC236}">
-                <a16:creationId xmlns:a16="http://schemas.microsoft.com/office/drawing/2014/main" id="{3BCF3E88-2DC6-428C-9BC7-D0981D63DFE3}"/>
+                <a16:creationId xmlns:a16="http://schemas.microsoft.com/office/drawing/2014/main" id="{B239CC4D-E555-4D1B-B514-B9723A18A49C}"/>
               </a:ext>
             </a:extLst>
           </p:cNvPr>
@@ -7127,7 +7127,7 @@
           <p:cNvPr id="17" name="">
             <a:extLst xmlns:a="http://schemas.openxmlformats.org/drawingml/2006/main">
               <a:ext uri="{FF2B5EF4-FFF2-40B4-BE49-F238E27FC236}">
-                <a16:creationId xmlns:a16="http://schemas.microsoft.com/office/drawing/2014/main" id="{BFDA36CC-19BE-4AE8-8776-6D12C91681BC}"/>
+                <a16:creationId xmlns:a16="http://schemas.microsoft.com/office/drawing/2014/main" id="{CF424080-C145-47ED-B130-D77ADD17EB55}"/>
               </a:ext>
             </a:extLst>
           </p:cNvPr>
@@ -7162,7 +7162,7 @@
           <p:cNvPr id="18" name="">
             <a:extLst xmlns:a="http://schemas.openxmlformats.org/drawingml/2006/main">
               <a:ext uri="{FF2B5EF4-FFF2-40B4-BE49-F238E27FC236}">
-                <a16:creationId xmlns:a16="http://schemas.microsoft.com/office/drawing/2014/main" id="{9E3F7CB7-3F59-4C44-82F3-08C88C5C497F}"/>
+                <a16:creationId xmlns:a16="http://schemas.microsoft.com/office/drawing/2014/main" id="{BB3DDA25-E75D-4201-A33D-510937E5A299}"/>
               </a:ext>
             </a:extLst>
           </p:cNvPr>
@@ -7219,7 +7219,7 @@
           <p:cNvPr id="19" name="">
             <a:extLst xmlns:a="http://schemas.openxmlformats.org/drawingml/2006/main">
               <a:ext uri="{FF2B5EF4-FFF2-40B4-BE49-F238E27FC236}">
-                <a16:creationId xmlns:a16="http://schemas.microsoft.com/office/drawing/2014/main" id="{156A9C10-1AD4-4BE3-9361-4AC699FB3B40}"/>
+                <a16:creationId xmlns:a16="http://schemas.microsoft.com/office/drawing/2014/main" id="{E65D7868-C534-47DA-9549-A840DFEC57F3}"/>
               </a:ext>
             </a:extLst>
           </p:cNvPr>
@@ -7276,7 +7276,7 @@
           <p:cNvPr id="20" name="">
             <a:extLst xmlns:a="http://schemas.openxmlformats.org/drawingml/2006/main">
               <a:ext uri="{FF2B5EF4-FFF2-40B4-BE49-F238E27FC236}">
-                <a16:creationId xmlns:a16="http://schemas.microsoft.com/office/drawing/2014/main" id="{9579187B-C955-4980-9261-19FCD3D339E5}"/>
+                <a16:creationId xmlns:a16="http://schemas.microsoft.com/office/drawing/2014/main" id="{CD7F7E16-0BA5-4CC1-B522-F5445ADB5DC4}"/>
               </a:ext>
             </a:extLst>
           </p:cNvPr>
@@ -7311,7 +7311,7 @@
           <p:cNvPr id="21" name="">
             <a:extLst xmlns:a="http://schemas.openxmlformats.org/drawingml/2006/main">
               <a:ext uri="{FF2B5EF4-FFF2-40B4-BE49-F238E27FC236}">
-                <a16:creationId xmlns:a16="http://schemas.microsoft.com/office/drawing/2014/main" id="{B6E65EF0-0655-4406-B6BB-FF6E172D9BAC}"/>
+                <a16:creationId xmlns:a16="http://schemas.microsoft.com/office/drawing/2014/main" id="{BE434766-582F-42A4-A878-BE7F6691F90D}"/>
               </a:ext>
             </a:extLst>
           </p:cNvPr>
@@ -7368,7 +7368,7 @@
           <p:cNvPr id="22" name="">
             <a:extLst xmlns:a="http://schemas.openxmlformats.org/drawingml/2006/main">
               <a:ext uri="{FF2B5EF4-FFF2-40B4-BE49-F238E27FC236}">
-                <a16:creationId xmlns:a16="http://schemas.microsoft.com/office/drawing/2014/main" id="{CCE23FE2-549B-4424-BA44-28634D4EBF87}"/>
+                <a16:creationId xmlns:a16="http://schemas.microsoft.com/office/drawing/2014/main" id="{0C31D985-5000-439E-9FE8-D9F71459142D}"/>
               </a:ext>
             </a:extLst>
           </p:cNvPr>
@@ -7425,7 +7425,7 @@
           <p:cNvPr id="23" name="">
             <a:extLst xmlns:a="http://schemas.openxmlformats.org/drawingml/2006/main">
               <a:ext uri="{FF2B5EF4-FFF2-40B4-BE49-F238E27FC236}">
-                <a16:creationId xmlns:a16="http://schemas.microsoft.com/office/drawing/2014/main" id="{5406DD63-D692-43E4-BCCC-F7844721499A}"/>
+                <a16:creationId xmlns:a16="http://schemas.microsoft.com/office/drawing/2014/main" id="{94A98405-26AE-4900-9896-BDF7EB6275D2}"/>
               </a:ext>
             </a:extLst>
           </p:cNvPr>
@@ -7460,7 +7460,7 @@
           <p:cNvPr id="24" name="">
             <a:extLst xmlns:a="http://schemas.openxmlformats.org/drawingml/2006/main">
               <a:ext uri="{FF2B5EF4-FFF2-40B4-BE49-F238E27FC236}">
-                <a16:creationId xmlns:a16="http://schemas.microsoft.com/office/drawing/2014/main" id="{362B61AD-E7A1-4349-B99E-E1221FCC40F4}"/>
+                <a16:creationId xmlns:a16="http://schemas.microsoft.com/office/drawing/2014/main" id="{9229AB64-BF06-4E05-90B3-D5FD18E852B2}"/>
               </a:ext>
             </a:extLst>
           </p:cNvPr>
@@ -7517,7 +7517,7 @@
           <p:cNvPr id="25" name="">
             <a:extLst xmlns:a="http://schemas.openxmlformats.org/drawingml/2006/main">
               <a:ext uri="{FF2B5EF4-FFF2-40B4-BE49-F238E27FC236}">
-                <a16:creationId xmlns:a16="http://schemas.microsoft.com/office/drawing/2014/main" id="{EA73F1B7-AB65-4C2F-8703-2C62BAC241E1}"/>
+                <a16:creationId xmlns:a16="http://schemas.microsoft.com/office/drawing/2014/main" id="{918526C3-96C9-4F11-8BBF-3B2FE65905DF}"/>
               </a:ext>
             </a:extLst>
           </p:cNvPr>
@@ -7581,7 +7581,7 @@
           <p:cNvPr id="26" name="">
             <a:extLst xmlns:a="http://schemas.openxmlformats.org/drawingml/2006/main">
               <a:ext uri="{FF2B5EF4-FFF2-40B4-BE49-F238E27FC236}">
-                <a16:creationId xmlns:a16="http://schemas.microsoft.com/office/drawing/2014/main" id="{1294321B-D753-4CF4-92D9-0B1730C992E8}"/>
+                <a16:creationId xmlns:a16="http://schemas.microsoft.com/office/drawing/2014/main" id="{3C04AA49-3608-46FE-9347-098751FECDCD}"/>
               </a:ext>
             </a:extLst>
           </p:cNvPr>
@@ -7645,7 +7645,7 @@
           <p:cNvPr id="27" name="">
             <a:extLst xmlns:a="http://schemas.openxmlformats.org/drawingml/2006/main">
               <a:ext uri="{FF2B5EF4-FFF2-40B4-BE49-F238E27FC236}">
-                <a16:creationId xmlns:a16="http://schemas.microsoft.com/office/drawing/2014/main" id="{080B1DD2-DB10-4F2A-9FA6-5FA79587EC58}"/>
+                <a16:creationId xmlns:a16="http://schemas.microsoft.com/office/drawing/2014/main" id="{7CC95793-5680-4FB1-AE6F-2070493FB284}"/>
               </a:ext>
             </a:extLst>
           </p:cNvPr>
@@ -7709,7 +7709,7 @@
           <p:cNvPr id="28" name="">
             <a:extLst xmlns:a="http://schemas.openxmlformats.org/drawingml/2006/main">
               <a:ext uri="{FF2B5EF4-FFF2-40B4-BE49-F238E27FC236}">
-                <a16:creationId xmlns:a16="http://schemas.microsoft.com/office/drawing/2014/main" id="{38A98F28-FB38-4F82-90FE-40089BBAB768}"/>
+                <a16:creationId xmlns:a16="http://schemas.microsoft.com/office/drawing/2014/main" id="{4611F663-CB75-4B46-86E8-ED7444A8919D}"/>
               </a:ext>
             </a:extLst>
           </p:cNvPr>
@@ -7773,7 +7773,7 @@
           <p:cNvPr id="29" name="">
             <a:extLst xmlns:a="http://schemas.openxmlformats.org/drawingml/2006/main">
               <a:ext uri="{FF2B5EF4-FFF2-40B4-BE49-F238E27FC236}">
-                <a16:creationId xmlns:a16="http://schemas.microsoft.com/office/drawing/2014/main" id="{EE048D49-7F53-4CD4-98A3-33EDEBAAB107}"/>
+                <a16:creationId xmlns:a16="http://schemas.microsoft.com/office/drawing/2014/main" id="{B99F579D-333B-482F-A2AA-08AA962499EB}"/>
               </a:ext>
             </a:extLst>
           </p:cNvPr>
@@ -7830,7 +7830,7 @@
           <p:cNvPr id="30" name="">
             <a:extLst xmlns:a="http://schemas.openxmlformats.org/drawingml/2006/main">
               <a:ext uri="{FF2B5EF4-FFF2-40B4-BE49-F238E27FC236}">
-                <a16:creationId xmlns:a16="http://schemas.microsoft.com/office/drawing/2014/main" id="{223842FB-36B4-4814-9D73-B7A0A841598A}"/>
+                <a16:creationId xmlns:a16="http://schemas.microsoft.com/office/drawing/2014/main" id="{36E69601-1EC7-453E-BDA2-46855A8A74D0}"/>
               </a:ext>
             </a:extLst>
           </p:cNvPr>
@@ -7887,7 +7887,7 @@
           <p:cNvPr id="31" name="">
             <a:extLst xmlns:a="http://schemas.openxmlformats.org/drawingml/2006/main">
               <a:ext uri="{FF2B5EF4-FFF2-40B4-BE49-F238E27FC236}">
-                <a16:creationId xmlns:a16="http://schemas.microsoft.com/office/drawing/2014/main" id="{758138DA-1E15-409E-993A-241B02FC697B}"/>
+                <a16:creationId xmlns:a16="http://schemas.microsoft.com/office/drawing/2014/main" id="{3C3192F5-FDE9-4AFD-9C95-AA3CE69AB64C}"/>
               </a:ext>
             </a:extLst>
           </p:cNvPr>
@@ -7942,7 +7942,7 @@
     </p:spTree>
     <p:extLst>
       <p:ext uri="{BB962C8B-B14F-4D97-AF65-F5344CB8AC3E}">
-        <p14:creationId xmlns:p14="http://schemas.microsoft.com/office/powerpoint/2010/main" val="993980658"/>
+        <p14:creationId xmlns:p14="http://schemas.microsoft.com/office/powerpoint/2010/main" val="1657473617"/>
       </p:ext>
     </p:extLst>
   </p:cSld>
@@ -7973,7 +7973,7 @@
           <p:cNvPr id="32" name="">
             <a:extLst xmlns:a="http://schemas.openxmlformats.org/drawingml/2006/main">
               <a:ext uri="{FF2B5EF4-FFF2-40B4-BE49-F238E27FC236}">
-                <a16:creationId xmlns:a16="http://schemas.microsoft.com/office/drawing/2014/main" id="{3F6368C2-EF15-4E21-B5B6-9E6950324D2F}"/>
+                <a16:creationId xmlns:a16="http://schemas.microsoft.com/office/drawing/2014/main" id="{9D912624-0463-475E-BC70-DB426C9C071E}"/>
               </a:ext>
             </a:extLst>
           </p:cNvPr>
@@ -8030,7 +8030,7 @@
           <p:cNvPr id="2" name="">
             <a:extLst xmlns:a="http://schemas.openxmlformats.org/drawingml/2006/main">
               <a:ext uri="{FF2B5EF4-FFF2-40B4-BE49-F238E27FC236}">
-                <a16:creationId xmlns:a16="http://schemas.microsoft.com/office/drawing/2014/main" id="{FD243860-C015-4BD2-BFBD-9D82E6EDAE47}"/>
+                <a16:creationId xmlns:a16="http://schemas.microsoft.com/office/drawing/2014/main" id="{67BDC499-CD26-4E3F-BAC7-45E2DB9918DF}"/>
               </a:ext>
             </a:extLst>
           </p:cNvPr>
@@ -8087,7 +8087,7 @@
           <p:cNvPr id="3" name="">
             <a:extLst xmlns:a="http://schemas.openxmlformats.org/drawingml/2006/main">
               <a:ext uri="{FF2B5EF4-FFF2-40B4-BE49-F238E27FC236}">
-                <a16:creationId xmlns:a16="http://schemas.microsoft.com/office/drawing/2014/main" id="{6A061645-D0D3-4E84-8CFD-DA3EA545803B}"/>
+                <a16:creationId xmlns:a16="http://schemas.microsoft.com/office/drawing/2014/main" id="{815A005D-2F91-43A8-8E17-08DF564531D6}"/>
               </a:ext>
             </a:extLst>
           </p:cNvPr>
@@ -8144,7 +8144,7 @@
           <p:cNvPr id="4" name="">
             <a:extLst xmlns:a="http://schemas.openxmlformats.org/drawingml/2006/main">
               <a:ext uri="{FF2B5EF4-FFF2-40B4-BE49-F238E27FC236}">
-                <a16:creationId xmlns:a16="http://schemas.microsoft.com/office/drawing/2014/main" id="{C61552CA-CC2B-4D1B-B771-E88551FD06F1}"/>
+                <a16:creationId xmlns:a16="http://schemas.microsoft.com/office/drawing/2014/main" id="{0F6C4A03-25E5-4B8B-8966-F9EE6E099C36}"/>
               </a:ext>
             </a:extLst>
           </p:cNvPr>
@@ -8175,7 +8175,7 @@
           <p:cNvPr id="5" name="">
             <a:extLst xmlns:a="http://schemas.openxmlformats.org/drawingml/2006/main">
               <a:ext uri="{FF2B5EF4-FFF2-40B4-BE49-F238E27FC236}">
-                <a16:creationId xmlns:a16="http://schemas.microsoft.com/office/drawing/2014/main" id="{25FFE432-E577-4458-B0FB-50C2321443A9}"/>
+                <a16:creationId xmlns:a16="http://schemas.microsoft.com/office/drawing/2014/main" id="{1544EDCC-69C8-4584-868C-22B9F4BBA28C}"/>
               </a:ext>
             </a:extLst>
           </p:cNvPr>
@@ -8210,7 +8210,7 @@
           <p:cNvPr id="6" name="">
             <a:extLst xmlns:a="http://schemas.openxmlformats.org/drawingml/2006/main">
               <a:ext uri="{FF2B5EF4-FFF2-40B4-BE49-F238E27FC236}">
-                <a16:creationId xmlns:a16="http://schemas.microsoft.com/office/drawing/2014/main" id="{04108DC5-DA5D-4531-87C6-EE447B2498A0}"/>
+                <a16:creationId xmlns:a16="http://schemas.microsoft.com/office/drawing/2014/main" id="{5C905C93-4D2D-431B-A99D-1D322E6DA15F}"/>
               </a:ext>
             </a:extLst>
           </p:cNvPr>
@@ -8274,7 +8274,7 @@
           <p:cNvPr id="7" name="">
             <a:extLst xmlns:a="http://schemas.openxmlformats.org/drawingml/2006/main">
               <a:ext uri="{FF2B5EF4-FFF2-40B4-BE49-F238E27FC236}">
-                <a16:creationId xmlns:a16="http://schemas.microsoft.com/office/drawing/2014/main" id="{5DE598B2-A31E-4743-BFF6-DA106CDB4603}"/>
+                <a16:creationId xmlns:a16="http://schemas.microsoft.com/office/drawing/2014/main" id="{4E7E181A-B40C-4EBA-A308-C6DBF73ABB20}"/>
               </a:ext>
             </a:extLst>
           </p:cNvPr>
@@ -8331,7 +8331,7 @@
           <p:cNvPr id="8" name="">
             <a:extLst xmlns:a="http://schemas.openxmlformats.org/drawingml/2006/main">
               <a:ext uri="{FF2B5EF4-FFF2-40B4-BE49-F238E27FC236}">
-                <a16:creationId xmlns:a16="http://schemas.microsoft.com/office/drawing/2014/main" id="{5B1654BB-3B6D-43AD-81E4-C55A328A30D9}"/>
+                <a16:creationId xmlns:a16="http://schemas.microsoft.com/office/drawing/2014/main" id="{22DCF3A0-E93B-4E10-8A7A-19FD69376D9F}"/>
               </a:ext>
             </a:extLst>
           </p:cNvPr>
@@ -8362,7 +8362,7 @@
           <p:cNvPr id="9" name="">
             <a:extLst xmlns:a="http://schemas.openxmlformats.org/drawingml/2006/main">
               <a:ext uri="{FF2B5EF4-FFF2-40B4-BE49-F238E27FC236}">
-                <a16:creationId xmlns:a16="http://schemas.microsoft.com/office/drawing/2014/main" id="{9128CB24-E441-46FA-8C14-775BFB78A865}"/>
+                <a16:creationId xmlns:a16="http://schemas.microsoft.com/office/drawing/2014/main" id="{BDB3A13D-8556-4A79-9FFB-DEE594112A55}"/>
               </a:ext>
             </a:extLst>
           </p:cNvPr>
@@ -8397,7 +8397,7 @@
           <p:cNvPr id="10" name="">
             <a:extLst xmlns:a="http://schemas.openxmlformats.org/drawingml/2006/main">
               <a:ext uri="{FF2B5EF4-FFF2-40B4-BE49-F238E27FC236}">
-                <a16:creationId xmlns:a16="http://schemas.microsoft.com/office/drawing/2014/main" id="{E45F118A-4D56-42BB-9E01-138D4DB440F9}"/>
+                <a16:creationId xmlns:a16="http://schemas.microsoft.com/office/drawing/2014/main" id="{1BA637A6-B0F8-4FAE-9073-24FE8C4A0384}"/>
               </a:ext>
             </a:extLst>
           </p:cNvPr>
@@ -8461,7 +8461,7 @@
           <p:cNvPr id="11" name="">
             <a:extLst xmlns:a="http://schemas.openxmlformats.org/drawingml/2006/main">
               <a:ext uri="{FF2B5EF4-FFF2-40B4-BE49-F238E27FC236}">
-                <a16:creationId xmlns:a16="http://schemas.microsoft.com/office/drawing/2014/main" id="{5A544300-559B-42A1-95F0-379734A95ED3}"/>
+                <a16:creationId xmlns:a16="http://schemas.microsoft.com/office/drawing/2014/main" id="{73AC6A0E-8980-4CEB-AF84-09182D1451B3}"/>
               </a:ext>
             </a:extLst>
           </p:cNvPr>
@@ -8518,7 +8518,7 @@
           <p:cNvPr id="12" name="">
             <a:extLst xmlns:a="http://schemas.openxmlformats.org/drawingml/2006/main">
               <a:ext uri="{FF2B5EF4-FFF2-40B4-BE49-F238E27FC236}">
-                <a16:creationId xmlns:a16="http://schemas.microsoft.com/office/drawing/2014/main" id="{C1036A00-AF41-4069-8F3A-B945CCA02A41}"/>
+                <a16:creationId xmlns:a16="http://schemas.microsoft.com/office/drawing/2014/main" id="{417F107E-2CC4-4450-BE77-7D6A6628DA87}"/>
               </a:ext>
             </a:extLst>
           </p:cNvPr>
@@ -8549,7 +8549,7 @@
           <p:cNvPr id="13" name="">
             <a:extLst xmlns:a="http://schemas.openxmlformats.org/drawingml/2006/main">
               <a:ext uri="{FF2B5EF4-FFF2-40B4-BE49-F238E27FC236}">
-                <a16:creationId xmlns:a16="http://schemas.microsoft.com/office/drawing/2014/main" id="{D7397FEE-7AE7-4D65-8884-63C3252D6318}"/>
+                <a16:creationId xmlns:a16="http://schemas.microsoft.com/office/drawing/2014/main" id="{872145CF-D9DE-4A1E-8D66-1628E93D0B83}"/>
               </a:ext>
             </a:extLst>
           </p:cNvPr>
@@ -8584,7 +8584,7 @@
           <p:cNvPr id="14" name="">
             <a:extLst xmlns:a="http://schemas.openxmlformats.org/drawingml/2006/main">
               <a:ext uri="{FF2B5EF4-FFF2-40B4-BE49-F238E27FC236}">
-                <a16:creationId xmlns:a16="http://schemas.microsoft.com/office/drawing/2014/main" id="{CD617055-C90B-473C-AE2B-F0F74D1A30B5}"/>
+                <a16:creationId xmlns:a16="http://schemas.microsoft.com/office/drawing/2014/main" id="{DCC8EA7D-528D-4D46-AABE-3D8C80ADC87B}"/>
               </a:ext>
             </a:extLst>
           </p:cNvPr>
@@ -8648,7 +8648,7 @@
           <p:cNvPr id="15" name="">
             <a:extLst xmlns:a="http://schemas.openxmlformats.org/drawingml/2006/main">
               <a:ext uri="{FF2B5EF4-FFF2-40B4-BE49-F238E27FC236}">
-                <a16:creationId xmlns:a16="http://schemas.microsoft.com/office/drawing/2014/main" id="{4CD1F8CC-1FA3-4261-88E0-3849D64BE857}"/>
+                <a16:creationId xmlns:a16="http://schemas.microsoft.com/office/drawing/2014/main" id="{854AA6FD-5B50-4D8D-9762-EC1512F3E355}"/>
               </a:ext>
             </a:extLst>
           </p:cNvPr>
@@ -8705,7 +8705,7 @@
           <p:cNvPr id="16" name="">
             <a:extLst xmlns:a="http://schemas.openxmlformats.org/drawingml/2006/main">
               <a:ext uri="{FF2B5EF4-FFF2-40B4-BE49-F238E27FC236}">
-                <a16:creationId xmlns:a16="http://schemas.microsoft.com/office/drawing/2014/main" id="{0CCAEF49-50E2-4B4C-BB16-4BDCA577D48D}"/>
+                <a16:creationId xmlns:a16="http://schemas.microsoft.com/office/drawing/2014/main" id="{03438DFE-0961-4C7D-9FFB-E3BFB48A78F6}"/>
               </a:ext>
             </a:extLst>
           </p:cNvPr>
@@ -8736,7 +8736,7 @@
           <p:cNvPr id="17" name="">
             <a:extLst xmlns:a="http://schemas.openxmlformats.org/drawingml/2006/main">
               <a:ext uri="{FF2B5EF4-FFF2-40B4-BE49-F238E27FC236}">
-                <a16:creationId xmlns:a16="http://schemas.microsoft.com/office/drawing/2014/main" id="{7C99B210-6E23-4464-BFF3-55CF26B840A5}"/>
+                <a16:creationId xmlns:a16="http://schemas.microsoft.com/office/drawing/2014/main" id="{D1805003-1468-44FA-A161-09614A0E24B1}"/>
               </a:ext>
             </a:extLst>
           </p:cNvPr>
@@ -8771,7 +8771,7 @@
           <p:cNvPr id="18" name="">
             <a:extLst xmlns:a="http://schemas.openxmlformats.org/drawingml/2006/main">
               <a:ext uri="{FF2B5EF4-FFF2-40B4-BE49-F238E27FC236}">
-                <a16:creationId xmlns:a16="http://schemas.microsoft.com/office/drawing/2014/main" id="{F954BE21-13B4-46F6-8CC6-3D098F39A5CF}"/>
+                <a16:creationId xmlns:a16="http://schemas.microsoft.com/office/drawing/2014/main" id="{520521A3-34ED-43E8-AC9A-49548C47757F}"/>
               </a:ext>
             </a:extLst>
           </p:cNvPr>
@@ -8835,7 +8835,7 @@
           <p:cNvPr id="19" name="">
             <a:extLst xmlns:a="http://schemas.openxmlformats.org/drawingml/2006/main">
               <a:ext uri="{FF2B5EF4-FFF2-40B4-BE49-F238E27FC236}">
-                <a16:creationId xmlns:a16="http://schemas.microsoft.com/office/drawing/2014/main" id="{5CF71D95-FCB5-4F21-954E-D08116B31CD9}"/>
+                <a16:creationId xmlns:a16="http://schemas.microsoft.com/office/drawing/2014/main" id="{E144F6B0-EBAF-44F8-BA05-D968E14BE8BD}"/>
               </a:ext>
             </a:extLst>
           </p:cNvPr>
@@ -8892,7 +8892,7 @@
           <p:cNvPr id="20" name="">
             <a:extLst xmlns:a="http://schemas.openxmlformats.org/drawingml/2006/main">
               <a:ext uri="{FF2B5EF4-FFF2-40B4-BE49-F238E27FC236}">
-                <a16:creationId xmlns:a16="http://schemas.microsoft.com/office/drawing/2014/main" id="{A90D1F6E-B092-4D6C-9CDE-B8BB9151CAB9}"/>
+                <a16:creationId xmlns:a16="http://schemas.microsoft.com/office/drawing/2014/main" id="{C5067686-C119-4453-A755-BFA73504A1EE}"/>
               </a:ext>
             </a:extLst>
           </p:cNvPr>
@@ -8927,7 +8927,7 @@
           <p:cNvPr id="21" name="">
             <a:extLst xmlns:a="http://schemas.openxmlformats.org/drawingml/2006/main">
               <a:ext uri="{FF2B5EF4-FFF2-40B4-BE49-F238E27FC236}">
-                <a16:creationId xmlns:a16="http://schemas.microsoft.com/office/drawing/2014/main" id="{AE15003E-E095-4B84-B253-78745D5DA40E}"/>
+                <a16:creationId xmlns:a16="http://schemas.microsoft.com/office/drawing/2014/main" id="{EB37EC33-2EBC-4A07-B163-E4FB911937C0}"/>
               </a:ext>
             </a:extLst>
           </p:cNvPr>
@@ -8984,7 +8984,7 @@
           <p:cNvPr id="22" name="">
             <a:extLst xmlns:a="http://schemas.openxmlformats.org/drawingml/2006/main">
               <a:ext uri="{FF2B5EF4-FFF2-40B4-BE49-F238E27FC236}">
-                <a16:creationId xmlns:a16="http://schemas.microsoft.com/office/drawing/2014/main" id="{C5EECD3A-CF6D-41F6-9F60-CE031713852A}"/>
+                <a16:creationId xmlns:a16="http://schemas.microsoft.com/office/drawing/2014/main" id="{5292B5F8-97B2-4803-8FFC-A3DB9DD09BFA}"/>
               </a:ext>
             </a:extLst>
           </p:cNvPr>
@@ -9041,7 +9041,7 @@
           <p:cNvPr id="23" name="">
             <a:extLst xmlns:a="http://schemas.openxmlformats.org/drawingml/2006/main">
               <a:ext uri="{FF2B5EF4-FFF2-40B4-BE49-F238E27FC236}">
-                <a16:creationId xmlns:a16="http://schemas.microsoft.com/office/drawing/2014/main" id="{152B6D70-3573-4627-A8F9-5B28AD7F5F4F}"/>
+                <a16:creationId xmlns:a16="http://schemas.microsoft.com/office/drawing/2014/main" id="{B0D06311-7725-4E30-B8C7-5FDF4DD096D6}"/>
               </a:ext>
             </a:extLst>
           </p:cNvPr>
@@ -9076,7 +9076,7 @@
           <p:cNvPr id="24" name="">
             <a:extLst xmlns:a="http://schemas.openxmlformats.org/drawingml/2006/main">
               <a:ext uri="{FF2B5EF4-FFF2-40B4-BE49-F238E27FC236}">
-                <a16:creationId xmlns:a16="http://schemas.microsoft.com/office/drawing/2014/main" id="{C839FCF7-8EBD-4FC9-B229-2D96584A96BB}"/>
+                <a16:creationId xmlns:a16="http://schemas.microsoft.com/office/drawing/2014/main" id="{4DD85AF0-9809-4524-BC4F-5192F8692F62}"/>
               </a:ext>
             </a:extLst>
           </p:cNvPr>
@@ -9140,7 +9140,7 @@
           <p:cNvPr id="25" name="">
             <a:extLst xmlns:a="http://schemas.openxmlformats.org/drawingml/2006/main">
               <a:ext uri="{FF2B5EF4-FFF2-40B4-BE49-F238E27FC236}">
-                <a16:creationId xmlns:a16="http://schemas.microsoft.com/office/drawing/2014/main" id="{735EAC37-CEAE-4294-B6A5-1620A9D9679E}"/>
+                <a16:creationId xmlns:a16="http://schemas.microsoft.com/office/drawing/2014/main" id="{E378D3A7-D92C-4388-9B3A-17CBA5746F75}"/>
               </a:ext>
             </a:extLst>
           </p:cNvPr>
@@ -9266,7 +9266,7 @@
           <p:cNvPr id="26" name="">
             <a:extLst xmlns:a="http://schemas.openxmlformats.org/drawingml/2006/main">
               <a:ext uri="{FF2B5EF4-FFF2-40B4-BE49-F238E27FC236}">
-                <a16:creationId xmlns:a16="http://schemas.microsoft.com/office/drawing/2014/main" id="{E5487ECA-6C22-43BB-A57B-D4C53FC41DB1}"/>
+                <a16:creationId xmlns:a16="http://schemas.microsoft.com/office/drawing/2014/main" id="{5679F992-0956-48DA-B546-D07D02B7C665}"/>
               </a:ext>
             </a:extLst>
           </p:cNvPr>
@@ -9301,7 +9301,7 @@
           <p:cNvPr id="27" name="">
             <a:extLst xmlns:a="http://schemas.openxmlformats.org/drawingml/2006/main">
               <a:ext uri="{FF2B5EF4-FFF2-40B4-BE49-F238E27FC236}">
-                <a16:creationId xmlns:a16="http://schemas.microsoft.com/office/drawing/2014/main" id="{BB3CCCEE-9568-4A6D-BD5C-9AEC67A5EE93}"/>
+                <a16:creationId xmlns:a16="http://schemas.microsoft.com/office/drawing/2014/main" id="{DD5E4A84-D521-428A-A753-C1528F217121}"/>
               </a:ext>
             </a:extLst>
           </p:cNvPr>
@@ -9365,7 +9365,7 @@
           <p:cNvPr id="28" name="">
             <a:extLst xmlns:a="http://schemas.openxmlformats.org/drawingml/2006/main">
               <a:ext uri="{FF2B5EF4-FFF2-40B4-BE49-F238E27FC236}">
-                <a16:creationId xmlns:a16="http://schemas.microsoft.com/office/drawing/2014/main" id="{FA609570-0626-4AD8-A510-F08C21F1C44C}"/>
+                <a16:creationId xmlns:a16="http://schemas.microsoft.com/office/drawing/2014/main" id="{10AC7676-290D-47ED-A30B-24AFF04939B9}"/>
               </a:ext>
             </a:extLst>
           </p:cNvPr>
@@ -9468,7 +9468,7 @@
           <p:cNvPr id="29" name="">
             <a:extLst xmlns:a="http://schemas.openxmlformats.org/drawingml/2006/main">
               <a:ext uri="{FF2B5EF4-FFF2-40B4-BE49-F238E27FC236}">
-                <a16:creationId xmlns:a16="http://schemas.microsoft.com/office/drawing/2014/main" id="{17D64F9C-D8C7-4603-958F-60128511AECB}"/>
+                <a16:creationId xmlns:a16="http://schemas.microsoft.com/office/drawing/2014/main" id="{16D3929F-D423-4240-9688-D1F6BAA219B1}"/>
               </a:ext>
             </a:extLst>
           </p:cNvPr>
@@ -9548,7 +9548,7 @@
           <p:cNvPr id="30" name="">
             <a:extLst xmlns:a="http://schemas.openxmlformats.org/drawingml/2006/main">
               <a:ext uri="{FF2B5EF4-FFF2-40B4-BE49-F238E27FC236}">
-                <a16:creationId xmlns:a16="http://schemas.microsoft.com/office/drawing/2014/main" id="{655B58D9-CDD8-4437-BC01-3F9761AB628A}"/>
+                <a16:creationId xmlns:a16="http://schemas.microsoft.com/office/drawing/2014/main" id="{0C234EF8-DA74-45F3-94D9-5A00C7FF8573}"/>
               </a:ext>
             </a:extLst>
           </p:cNvPr>
@@ -9605,7 +9605,7 @@
           <p:cNvPr id="31" name="">
             <a:extLst xmlns:a="http://schemas.openxmlformats.org/drawingml/2006/main">
               <a:ext uri="{FF2B5EF4-FFF2-40B4-BE49-F238E27FC236}">
-                <a16:creationId xmlns:a16="http://schemas.microsoft.com/office/drawing/2014/main" id="{4C916219-4E0C-422E-9530-EE117A39F52D}"/>
+                <a16:creationId xmlns:a16="http://schemas.microsoft.com/office/drawing/2014/main" id="{3FD02701-A0B7-4EFF-91AC-EE4685B8BEAC}"/>
               </a:ext>
             </a:extLst>
           </p:cNvPr>
@@ -9660,7 +9660,7 @@
     </p:spTree>
     <p:extLst>
       <p:ext uri="{BB962C8B-B14F-4D97-AF65-F5344CB8AC3E}">
-        <p14:creationId xmlns:p14="http://schemas.microsoft.com/office/powerpoint/2010/main" val="617991746"/>
+        <p14:creationId xmlns:p14="http://schemas.microsoft.com/office/powerpoint/2010/main" val="894816136"/>
       </p:ext>
     </p:extLst>
   </p:cSld>
@@ -9691,7 +9691,7 @@
           <p:cNvPr id="36" name="">
             <a:extLst xmlns:a="http://schemas.openxmlformats.org/drawingml/2006/main">
               <a:ext uri="{FF2B5EF4-FFF2-40B4-BE49-F238E27FC236}">
-                <a16:creationId xmlns:a16="http://schemas.microsoft.com/office/drawing/2014/main" id="{7DF26C60-258A-465D-ACF7-8A1B63A1F882}"/>
+                <a16:creationId xmlns:a16="http://schemas.microsoft.com/office/drawing/2014/main" id="{3A12FEA0-71A1-44B4-8802-0C8A18FDE034}"/>
               </a:ext>
             </a:extLst>
           </p:cNvPr>
@@ -9748,7 +9748,7 @@
           <p:cNvPr id="2" name="">
             <a:extLst xmlns:a="http://schemas.openxmlformats.org/drawingml/2006/main">
               <a:ext uri="{FF2B5EF4-FFF2-40B4-BE49-F238E27FC236}">
-                <a16:creationId xmlns:a16="http://schemas.microsoft.com/office/drawing/2014/main" id="{B1AD1E0C-A595-4257-A004-950CEC529C6F}"/>
+                <a16:creationId xmlns:a16="http://schemas.microsoft.com/office/drawing/2014/main" id="{69EF080A-956A-439D-A5B7-B482EE50E900}"/>
               </a:ext>
             </a:extLst>
           </p:cNvPr>
@@ -9805,7 +9805,7 @@
           <p:cNvPr id="3" name="">
             <a:extLst xmlns:a="http://schemas.openxmlformats.org/drawingml/2006/main">
               <a:ext uri="{FF2B5EF4-FFF2-40B4-BE49-F238E27FC236}">
-                <a16:creationId xmlns:a16="http://schemas.microsoft.com/office/drawing/2014/main" id="{E7C48F8A-F033-4B18-9A30-F9B9EA4060E1}"/>
+                <a16:creationId xmlns:a16="http://schemas.microsoft.com/office/drawing/2014/main" id="{8AFAC233-E03E-4A7C-91EE-B9981E276845}"/>
               </a:ext>
             </a:extLst>
           </p:cNvPr>
@@ -9862,7 +9862,7 @@
           <p:cNvPr id="4" name="">
             <a:extLst xmlns:a="http://schemas.openxmlformats.org/drawingml/2006/main">
               <a:ext uri="{FF2B5EF4-FFF2-40B4-BE49-F238E27FC236}">
-                <a16:creationId xmlns:a16="http://schemas.microsoft.com/office/drawing/2014/main" id="{C0BBE817-1A09-4535-9A2A-E2377C649C21}"/>
+                <a16:creationId xmlns:a16="http://schemas.microsoft.com/office/drawing/2014/main" id="{8BF9593D-A720-437F-B1DD-7968C715EB8E}"/>
               </a:ext>
             </a:extLst>
           </p:cNvPr>
@@ -9893,7 +9893,7 @@
           <p:cNvPr id="5" name="">
             <a:extLst xmlns:a="http://schemas.openxmlformats.org/drawingml/2006/main">
               <a:ext uri="{FF2B5EF4-FFF2-40B4-BE49-F238E27FC236}">
-                <a16:creationId xmlns:a16="http://schemas.microsoft.com/office/drawing/2014/main" id="{42C1E4F0-08FF-483E-8634-3692E6F2598B}"/>
+                <a16:creationId xmlns:a16="http://schemas.microsoft.com/office/drawing/2014/main" id="{5B2775BF-9765-412F-BDC9-EC6840A2218D}"/>
               </a:ext>
             </a:extLst>
           </p:cNvPr>
@@ -9928,7 +9928,7 @@
           <p:cNvPr id="6" name="">
             <a:extLst xmlns:a="http://schemas.openxmlformats.org/drawingml/2006/main">
               <a:ext uri="{FF2B5EF4-FFF2-40B4-BE49-F238E27FC236}">
-                <a16:creationId xmlns:a16="http://schemas.microsoft.com/office/drawing/2014/main" id="{0DAC9EAB-CD9B-49C7-90E2-A46749E4D7BD}"/>
+                <a16:creationId xmlns:a16="http://schemas.microsoft.com/office/drawing/2014/main" id="{1DA779E3-4BDB-4CEA-BCE8-105F362D796A}"/>
               </a:ext>
             </a:extLst>
           </p:cNvPr>
@@ -9992,7 +9992,7 @@
           <p:cNvPr id="7" name="">
             <a:extLst xmlns:a="http://schemas.openxmlformats.org/drawingml/2006/main">
               <a:ext uri="{FF2B5EF4-FFF2-40B4-BE49-F238E27FC236}">
-                <a16:creationId xmlns:a16="http://schemas.microsoft.com/office/drawing/2014/main" id="{38611B57-7077-45DC-A2B0-61AF90CE9243}"/>
+                <a16:creationId xmlns:a16="http://schemas.microsoft.com/office/drawing/2014/main" id="{19A8F8F5-E291-4676-BD29-9EC8148CBBBF}"/>
               </a:ext>
             </a:extLst>
           </p:cNvPr>
@@ -10049,7 +10049,7 @@
           <p:cNvPr id="8" name="">
             <a:extLst xmlns:a="http://schemas.openxmlformats.org/drawingml/2006/main">
               <a:ext uri="{FF2B5EF4-FFF2-40B4-BE49-F238E27FC236}">
-                <a16:creationId xmlns:a16="http://schemas.microsoft.com/office/drawing/2014/main" id="{62CCFBB8-87C7-458A-A467-21C91AAE2A92}"/>
+                <a16:creationId xmlns:a16="http://schemas.microsoft.com/office/drawing/2014/main" id="{D5D8B025-E1FE-4320-8AB8-C0F98333996F}"/>
               </a:ext>
             </a:extLst>
           </p:cNvPr>
@@ -10084,7 +10084,7 @@
           <p:cNvPr id="9" name="">
             <a:extLst xmlns:a="http://schemas.openxmlformats.org/drawingml/2006/main">
               <a:ext uri="{FF2B5EF4-FFF2-40B4-BE49-F238E27FC236}">
-                <a16:creationId xmlns:a16="http://schemas.microsoft.com/office/drawing/2014/main" id="{BDA28040-4834-453E-B17C-8DE56331480C}"/>
+                <a16:creationId xmlns:a16="http://schemas.microsoft.com/office/drawing/2014/main" id="{20DEFEE4-8B4A-4D1E-ADA0-D67FDE976158}"/>
               </a:ext>
             </a:extLst>
           </p:cNvPr>
@@ -10148,7 +10148,7 @@
           <p:cNvPr id="10" name="">
             <a:extLst xmlns:a="http://schemas.openxmlformats.org/drawingml/2006/main">
               <a:ext uri="{FF2B5EF4-FFF2-40B4-BE49-F238E27FC236}">
-                <a16:creationId xmlns:a16="http://schemas.microsoft.com/office/drawing/2014/main" id="{A682FD07-F12B-43AA-92E9-FD90CF0BDB9F}"/>
+                <a16:creationId xmlns:a16="http://schemas.microsoft.com/office/drawing/2014/main" id="{A3C5A063-5322-4392-B975-7FF00BFFC96F}"/>
               </a:ext>
             </a:extLst>
           </p:cNvPr>
@@ -10205,7 +10205,7 @@
           <p:cNvPr id="11" name="">
             <a:extLst xmlns:a="http://schemas.openxmlformats.org/drawingml/2006/main">
               <a:ext uri="{FF2B5EF4-FFF2-40B4-BE49-F238E27FC236}">
-                <a16:creationId xmlns:a16="http://schemas.microsoft.com/office/drawing/2014/main" id="{5463DC74-5B15-434A-AA57-D7E3917880CE}"/>
+                <a16:creationId xmlns:a16="http://schemas.microsoft.com/office/drawing/2014/main" id="{D98448C4-FAF7-4117-96F2-A90694D22F57}"/>
               </a:ext>
             </a:extLst>
           </p:cNvPr>
@@ -10240,7 +10240,7 @@
           <p:cNvPr id="12" name="">
             <a:extLst xmlns:a="http://schemas.openxmlformats.org/drawingml/2006/main">
               <a:ext uri="{FF2B5EF4-FFF2-40B4-BE49-F238E27FC236}">
-                <a16:creationId xmlns:a16="http://schemas.microsoft.com/office/drawing/2014/main" id="{66AC0F4A-E306-4FDB-A603-A880BAA582C8}"/>
+                <a16:creationId xmlns:a16="http://schemas.microsoft.com/office/drawing/2014/main" id="{D25CD79C-18AF-4F31-AB5B-B7E88BD96706}"/>
               </a:ext>
             </a:extLst>
           </p:cNvPr>
@@ -10304,7 +10304,7 @@
           <p:cNvPr id="13" name="">
             <a:extLst xmlns:a="http://schemas.openxmlformats.org/drawingml/2006/main">
               <a:ext uri="{FF2B5EF4-FFF2-40B4-BE49-F238E27FC236}">
-                <a16:creationId xmlns:a16="http://schemas.microsoft.com/office/drawing/2014/main" id="{F1B6907A-0C26-490F-BF3F-F3E8B040A6C7}"/>
+                <a16:creationId xmlns:a16="http://schemas.microsoft.com/office/drawing/2014/main" id="{6FE22E8E-08A2-48FC-B5DC-A25F728968BF}"/>
               </a:ext>
             </a:extLst>
           </p:cNvPr>
@@ -10361,7 +10361,7 @@
           <p:cNvPr id="14" name="">
             <a:extLst xmlns:a="http://schemas.openxmlformats.org/drawingml/2006/main">
               <a:ext uri="{FF2B5EF4-FFF2-40B4-BE49-F238E27FC236}">
-                <a16:creationId xmlns:a16="http://schemas.microsoft.com/office/drawing/2014/main" id="{4705322D-33D0-4535-94D0-71260F8664E4}"/>
+                <a16:creationId xmlns:a16="http://schemas.microsoft.com/office/drawing/2014/main" id="{6792B84D-B84C-4ACE-B46B-343A1F7F63DA}"/>
               </a:ext>
             </a:extLst>
           </p:cNvPr>
@@ -10396,7 +10396,7 @@
           <p:cNvPr id="15" name="">
             <a:extLst xmlns:a="http://schemas.openxmlformats.org/drawingml/2006/main">
               <a:ext uri="{FF2B5EF4-FFF2-40B4-BE49-F238E27FC236}">
-                <a16:creationId xmlns:a16="http://schemas.microsoft.com/office/drawing/2014/main" id="{78E760B5-EAFF-48BC-B8B5-14DE1DDF754D}"/>
+                <a16:creationId xmlns:a16="http://schemas.microsoft.com/office/drawing/2014/main" id="{0021AA05-B24F-4AB0-907C-6AAA2B94B3DB}"/>
               </a:ext>
             </a:extLst>
           </p:cNvPr>
@@ -10460,7 +10460,7 @@
           <p:cNvPr id="16" name="">
             <a:extLst xmlns:a="http://schemas.openxmlformats.org/drawingml/2006/main">
               <a:ext uri="{FF2B5EF4-FFF2-40B4-BE49-F238E27FC236}">
-                <a16:creationId xmlns:a16="http://schemas.microsoft.com/office/drawing/2014/main" id="{C09A2A2C-FB2F-4AF8-B6F9-6297D14E37E9}"/>
+                <a16:creationId xmlns:a16="http://schemas.microsoft.com/office/drawing/2014/main" id="{EA32F119-2735-4CE6-A35F-748620C1B9A4}"/>
               </a:ext>
             </a:extLst>
           </p:cNvPr>
@@ -10517,7 +10517,7 @@
           <p:cNvPr id="17" name="">
             <a:extLst xmlns:a="http://schemas.openxmlformats.org/drawingml/2006/main">
               <a:ext uri="{FF2B5EF4-FFF2-40B4-BE49-F238E27FC236}">
-                <a16:creationId xmlns:a16="http://schemas.microsoft.com/office/drawing/2014/main" id="{88970752-45F6-4DA4-909C-6EA275751A6C}"/>
+                <a16:creationId xmlns:a16="http://schemas.microsoft.com/office/drawing/2014/main" id="{F9C24527-CE72-43EB-BE9F-A7E1D91485CF}"/>
               </a:ext>
             </a:extLst>
           </p:cNvPr>
@@ -10552,7 +10552,7 @@
           <p:cNvPr id="18" name="">
             <a:extLst xmlns:a="http://schemas.openxmlformats.org/drawingml/2006/main">
               <a:ext uri="{FF2B5EF4-FFF2-40B4-BE49-F238E27FC236}">
-                <a16:creationId xmlns:a16="http://schemas.microsoft.com/office/drawing/2014/main" id="{0E11A681-AD95-4426-92E6-AD4FCEF3181C}"/>
+                <a16:creationId xmlns:a16="http://schemas.microsoft.com/office/drawing/2014/main" id="{4A41F64D-8E85-43B2-8CFC-FA8293FD988D}"/>
               </a:ext>
             </a:extLst>
           </p:cNvPr>
@@ -10616,7 +10616,7 @@
           <p:cNvPr id="19" name="">
             <a:extLst xmlns:a="http://schemas.openxmlformats.org/drawingml/2006/main">
               <a:ext uri="{FF2B5EF4-FFF2-40B4-BE49-F238E27FC236}">
-                <a16:creationId xmlns:a16="http://schemas.microsoft.com/office/drawing/2014/main" id="{66146B86-4C1C-410B-9FFE-5713568617C0}"/>
+                <a16:creationId xmlns:a16="http://schemas.microsoft.com/office/drawing/2014/main" id="{907BC94D-D1E2-4CCF-8E48-E6094B4E932D}"/>
               </a:ext>
             </a:extLst>
           </p:cNvPr>
@@ -10673,7 +10673,7 @@
           <p:cNvPr id="20" name="">
             <a:extLst xmlns:a="http://schemas.openxmlformats.org/drawingml/2006/main">
               <a:ext uri="{FF2B5EF4-FFF2-40B4-BE49-F238E27FC236}">
-                <a16:creationId xmlns:a16="http://schemas.microsoft.com/office/drawing/2014/main" id="{CCDDBDE9-E973-479D-9587-B10CA3B91AEE}"/>
+                <a16:creationId xmlns:a16="http://schemas.microsoft.com/office/drawing/2014/main" id="{946CB0DD-1E02-4D87-98F9-0D29CC6352F4}"/>
               </a:ext>
             </a:extLst>
           </p:cNvPr>
@@ -10708,7 +10708,7 @@
           <p:cNvPr id="21" name="">
             <a:extLst xmlns:a="http://schemas.openxmlformats.org/drawingml/2006/main">
               <a:ext uri="{FF2B5EF4-FFF2-40B4-BE49-F238E27FC236}">
-                <a16:creationId xmlns:a16="http://schemas.microsoft.com/office/drawing/2014/main" id="{E22336FD-ED4F-43D5-B800-47957A12A609}"/>
+                <a16:creationId xmlns:a16="http://schemas.microsoft.com/office/drawing/2014/main" id="{983340D8-D1BA-4BDB-8BCA-519E7C2B7453}"/>
               </a:ext>
             </a:extLst>
           </p:cNvPr>
@@ -10765,7 +10765,7 @@
           <p:cNvPr id="22" name="">
             <a:extLst xmlns:a="http://schemas.openxmlformats.org/drawingml/2006/main">
               <a:ext uri="{FF2B5EF4-FFF2-40B4-BE49-F238E27FC236}">
-                <a16:creationId xmlns:a16="http://schemas.microsoft.com/office/drawing/2014/main" id="{030156C3-97B7-4BB7-84F1-C4E88202B565}"/>
+                <a16:creationId xmlns:a16="http://schemas.microsoft.com/office/drawing/2014/main" id="{CBF78521-6A6A-471D-98E3-70D1E47C8D39}"/>
               </a:ext>
             </a:extLst>
           </p:cNvPr>
@@ -10829,7 +10829,7 @@
           <p:cNvPr id="23" name="">
             <a:extLst xmlns:a="http://schemas.openxmlformats.org/drawingml/2006/main">
               <a:ext uri="{FF2B5EF4-FFF2-40B4-BE49-F238E27FC236}">
-                <a16:creationId xmlns:a16="http://schemas.microsoft.com/office/drawing/2014/main" id="{EBCC58E1-49E7-40EA-ABD4-9238724125C6}"/>
+                <a16:creationId xmlns:a16="http://schemas.microsoft.com/office/drawing/2014/main" id="{E75A22DB-0296-429B-8E51-BD2330CE6803}"/>
               </a:ext>
             </a:extLst>
           </p:cNvPr>
@@ -10886,7 +10886,7 @@
           <p:cNvPr id="24" name="">
             <a:extLst xmlns:a="http://schemas.openxmlformats.org/drawingml/2006/main">
               <a:ext uri="{FF2B5EF4-FFF2-40B4-BE49-F238E27FC236}">
-                <a16:creationId xmlns:a16="http://schemas.microsoft.com/office/drawing/2014/main" id="{03935903-CA86-4753-A3B1-FDB9FB3A8EFD}"/>
+                <a16:creationId xmlns:a16="http://schemas.microsoft.com/office/drawing/2014/main" id="{B4085F1A-FD05-44D1-804A-EBC250E2ED51}"/>
               </a:ext>
             </a:extLst>
           </p:cNvPr>
@@ -10950,7 +10950,7 @@
           <p:cNvPr id="25" name="">
             <a:extLst xmlns:a="http://schemas.openxmlformats.org/drawingml/2006/main">
               <a:ext uri="{FF2B5EF4-FFF2-40B4-BE49-F238E27FC236}">
-                <a16:creationId xmlns:a16="http://schemas.microsoft.com/office/drawing/2014/main" id="{8E724680-57CE-4C01-A48D-CB5145CA7B8E}"/>
+                <a16:creationId xmlns:a16="http://schemas.microsoft.com/office/drawing/2014/main" id="{9B7851D5-ACCE-4263-B204-97BF45659584}"/>
               </a:ext>
             </a:extLst>
           </p:cNvPr>
@@ -10997,7 +10997,7 @@
                 <a:ea typeface="Arial"/>
                 <a:cs typeface="Arial"/>
               </a:rPr>
-              <a:t>100 test • dependency sạch</a:t>
+              <a:t>102 test • dependency sạch</a:t>
             </a:r>
           </a:p>
         </p:txBody>
@@ -11007,7 +11007,7 @@
           <p:cNvPr id="26" name="">
             <a:extLst xmlns:a="http://schemas.openxmlformats.org/drawingml/2006/main">
               <a:ext uri="{FF2B5EF4-FFF2-40B4-BE49-F238E27FC236}">
-                <a16:creationId xmlns:a16="http://schemas.microsoft.com/office/drawing/2014/main" id="{72F40DE6-DF50-4A02-B819-89789BFF7B78}"/>
+                <a16:creationId xmlns:a16="http://schemas.microsoft.com/office/drawing/2014/main" id="{3EDD6B3E-ECFF-4299-A248-6541F037A4F1}"/>
               </a:ext>
             </a:extLst>
           </p:cNvPr>
@@ -11071,7 +11071,7 @@
           <p:cNvPr id="27" name="">
             <a:extLst xmlns:a="http://schemas.openxmlformats.org/drawingml/2006/main">
               <a:ext uri="{FF2B5EF4-FFF2-40B4-BE49-F238E27FC236}">
-                <a16:creationId xmlns:a16="http://schemas.microsoft.com/office/drawing/2014/main" id="{183F2632-D975-444F-A156-9C45E24649A0}"/>
+                <a16:creationId xmlns:a16="http://schemas.microsoft.com/office/drawing/2014/main" id="{5C7E3ED5-90A9-47C6-AB75-A2C127DCF869}"/>
               </a:ext>
             </a:extLst>
           </p:cNvPr>
@@ -11128,7 +11128,7 @@
           <p:cNvPr id="28" name="">
             <a:extLst xmlns:a="http://schemas.openxmlformats.org/drawingml/2006/main">
               <a:ext uri="{FF2B5EF4-FFF2-40B4-BE49-F238E27FC236}">
-                <a16:creationId xmlns:a16="http://schemas.microsoft.com/office/drawing/2014/main" id="{06082487-7CFE-494A-888D-AFB2FE0106C9}"/>
+                <a16:creationId xmlns:a16="http://schemas.microsoft.com/office/drawing/2014/main" id="{C0A88352-E10A-42AD-AA9A-8E98437D8B56}"/>
               </a:ext>
             </a:extLst>
           </p:cNvPr>
@@ -11192,7 +11192,7 @@
           <p:cNvPr id="29" name="">
             <a:extLst xmlns:a="http://schemas.openxmlformats.org/drawingml/2006/main">
               <a:ext uri="{FF2B5EF4-FFF2-40B4-BE49-F238E27FC236}">
-                <a16:creationId xmlns:a16="http://schemas.microsoft.com/office/drawing/2014/main" id="{6FB7CA6B-7A0C-4C2F-8D17-37C70AE5DBCC}"/>
+                <a16:creationId xmlns:a16="http://schemas.microsoft.com/office/drawing/2014/main" id="{9A76A2BC-E960-4104-A17A-CF0104F707EF}"/>
               </a:ext>
             </a:extLst>
           </p:cNvPr>
@@ -11249,7 +11249,7 @@
           <p:cNvPr id="30" name="">
             <a:extLst xmlns:a="http://schemas.openxmlformats.org/drawingml/2006/main">
               <a:ext uri="{FF2B5EF4-FFF2-40B4-BE49-F238E27FC236}">
-                <a16:creationId xmlns:a16="http://schemas.microsoft.com/office/drawing/2014/main" id="{473D36D4-C0CE-493E-AE54-F740F952382D}"/>
+                <a16:creationId xmlns:a16="http://schemas.microsoft.com/office/drawing/2014/main" id="{0E72AE8B-EAC9-410D-8ADC-D4A01BD09BE9}"/>
               </a:ext>
             </a:extLst>
           </p:cNvPr>
@@ -11284,7 +11284,7 @@
           <p:cNvPr id="31" name="">
             <a:extLst xmlns:a="http://schemas.openxmlformats.org/drawingml/2006/main">
               <a:ext uri="{FF2B5EF4-FFF2-40B4-BE49-F238E27FC236}">
-                <a16:creationId xmlns:a16="http://schemas.microsoft.com/office/drawing/2014/main" id="{A7EE4CF7-01F2-47D2-A729-A8E918CF3C2E}"/>
+                <a16:creationId xmlns:a16="http://schemas.microsoft.com/office/drawing/2014/main" id="{05B268EA-B2BC-4C5D-BF5A-1283C6A7BCCD}"/>
               </a:ext>
             </a:extLst>
           </p:cNvPr>
@@ -11341,7 +11341,7 @@
           <p:cNvPr id="32" name="">
             <a:extLst xmlns:a="http://schemas.openxmlformats.org/drawingml/2006/main">
               <a:ext uri="{FF2B5EF4-FFF2-40B4-BE49-F238E27FC236}">
-                <a16:creationId xmlns:a16="http://schemas.microsoft.com/office/drawing/2014/main" id="{CCD48215-2F57-4073-A442-34406346ED3D}"/>
+                <a16:creationId xmlns:a16="http://schemas.microsoft.com/office/drawing/2014/main" id="{9F799164-C307-416B-8C2F-A9A6747F3D81}"/>
               </a:ext>
             </a:extLst>
           </p:cNvPr>
@@ -11444,7 +11444,7 @@
           <p:cNvPr id="33" name="">
             <a:extLst xmlns:a="http://schemas.openxmlformats.org/drawingml/2006/main">
               <a:ext uri="{FF2B5EF4-FFF2-40B4-BE49-F238E27FC236}">
-                <a16:creationId xmlns:a16="http://schemas.microsoft.com/office/drawing/2014/main" id="{CAAD36BE-345A-4913-A83C-2F20A4207AA1}"/>
+                <a16:creationId xmlns:a16="http://schemas.microsoft.com/office/drawing/2014/main" id="{EC7E1D2A-4CDB-4E81-8AC3-C4B933F10F01}"/>
               </a:ext>
             </a:extLst>
           </p:cNvPr>
@@ -11501,7 +11501,7 @@
           <p:cNvPr id="34" name="">
             <a:extLst xmlns:a="http://schemas.openxmlformats.org/drawingml/2006/main">
               <a:ext uri="{FF2B5EF4-FFF2-40B4-BE49-F238E27FC236}">
-                <a16:creationId xmlns:a16="http://schemas.microsoft.com/office/drawing/2014/main" id="{AD18627D-BFC1-4CC6-A3D7-6D697184A12E}"/>
+                <a16:creationId xmlns:a16="http://schemas.microsoft.com/office/drawing/2014/main" id="{28820217-C860-496C-BF7C-3889538F96A1}"/>
               </a:ext>
             </a:extLst>
           </p:cNvPr>
@@ -11558,7 +11558,7 @@
           <p:cNvPr id="35" name="">
             <a:extLst xmlns:a="http://schemas.openxmlformats.org/drawingml/2006/main">
               <a:ext uri="{FF2B5EF4-FFF2-40B4-BE49-F238E27FC236}">
-                <a16:creationId xmlns:a16="http://schemas.microsoft.com/office/drawing/2014/main" id="{B449398F-E614-4B28-9CC4-EC36407A78BE}"/>
+                <a16:creationId xmlns:a16="http://schemas.microsoft.com/office/drawing/2014/main" id="{D7FEE78A-AB72-4011-92D9-C9B2C4FF802C}"/>
               </a:ext>
             </a:extLst>
           </p:cNvPr>
@@ -11613,7 +11613,7 @@
     </p:spTree>
     <p:extLst>
       <p:ext uri="{BB962C8B-B14F-4D97-AF65-F5344CB8AC3E}">
-        <p14:creationId xmlns:p14="http://schemas.microsoft.com/office/powerpoint/2010/main" val="612083574"/>
+        <p14:creationId xmlns:p14="http://schemas.microsoft.com/office/powerpoint/2010/main" val="1023837908"/>
       </p:ext>
     </p:extLst>
   </p:cSld>

</xml_diff>

<commit_message>
docs: sync demo baseline and judge setup
</commit_message>
<xml_diff>
--- a/AURA/submission/AURA_5_SLIDES.pptx
+++ b/AURA/submission/AURA_5_SLIDES.pptx
@@ -2,17 +2,17 @@
 <file path=ppt/presentation.xml><?xml version="1.0" encoding="utf-8"?>
 <p:presentation xmlns:p="http://schemas.openxmlformats.org/presentationml/2006/main">
   <p:sldMasterIdLst>
-    <p:sldMasterId xmlns:r="http://schemas.openxmlformats.org/officeDocument/2006/relationships" id="2147483648" r:id="R9beea6bf059c4497"/>
+    <p:sldMasterId xmlns:r="http://schemas.openxmlformats.org/officeDocument/2006/relationships" id="2147483648" r:id="R72ab4a67041e41dd"/>
   </p:sldMasterIdLst>
   <p:notesMasterIdLst>
-    <p:notesMasterId xmlns:r="http://schemas.openxmlformats.org/officeDocument/2006/relationships" r:id="R7a0643453675435e"/>
+    <p:notesMasterId xmlns:r="http://schemas.openxmlformats.org/officeDocument/2006/relationships" r:id="R40b4bdfc841a4422"/>
   </p:notesMasterIdLst>
   <p:sldIdLst>
-    <p:sldId xmlns:r="http://schemas.openxmlformats.org/officeDocument/2006/relationships" id="256" r:id="R1112f2f24a2c4b12"/>
-    <p:sldId xmlns:r="http://schemas.openxmlformats.org/officeDocument/2006/relationships" id="257" r:id="R85dcab4e9d4049d5"/>
-    <p:sldId xmlns:r="http://schemas.openxmlformats.org/officeDocument/2006/relationships" id="258" r:id="R066e96bf84404226"/>
-    <p:sldId xmlns:r="http://schemas.openxmlformats.org/officeDocument/2006/relationships" id="259" r:id="Raf80bdb4dc544f78"/>
-    <p:sldId xmlns:r="http://schemas.openxmlformats.org/officeDocument/2006/relationships" id="260" r:id="R095afc72d83947f4"/>
+    <p:sldId xmlns:r="http://schemas.openxmlformats.org/officeDocument/2006/relationships" id="256" r:id="R45fa600595be4e20"/>
+    <p:sldId xmlns:r="http://schemas.openxmlformats.org/officeDocument/2006/relationships" id="257" r:id="R7b9db5fae94243a0"/>
+    <p:sldId xmlns:r="http://schemas.openxmlformats.org/officeDocument/2006/relationships" id="258" r:id="Rb1ba1da4038a4448"/>
+    <p:sldId xmlns:r="http://schemas.openxmlformats.org/officeDocument/2006/relationships" id="259" r:id="R03a24ee21533486b"/>
+    <p:sldId xmlns:r="http://schemas.openxmlformats.org/officeDocument/2006/relationships" id="260" r:id="R61153d56259f425e"/>
   </p:sldIdLst>
   <p:sldSz cx="12192000" cy="6858000"/>
   <p:notesSz cx="6858000" cy="9144000"/>
@@ -586,7 +586,7 @@
           <a:lstStyle xmlns:a="http://schemas.openxmlformats.org/drawingml/2006/main"/>
           <a:p xmlns:a="http://schemas.openxmlformats.org/drawingml/2006/main">
             <a:r>
-              <a:t>Nguồn nội bộ cập nhật ngày 01/10/2026: 102 test offline. Trên cùng judge set 15 ca và fallback tắt, OpenRouter 8B đạt 15/15 quyết định, 70/75 field, P95 16,459 giây; Ollama 4B đạt 14/15, 73/75 field, P95 58,318 giây và bỏ sót escalation TK-12. Contract hiện tách ba loại identifier, chuẩn hóa lossless ngày giao dịch trên chứng từ giấy và đối chiếu discountAmount; kết quả live postfix phải được ghi riêng. Đây là regression trên dữ liệu tổng hợp, không phải accuracy thực tế.</a:t>
+              <a:t>Nguồn nội bộ cập nhật ngày 02/10/2026: 102 test offline. Judge set tổng hợp với fallback tắt giữ OpenRouter 8B ở 15/15 quyết định và Ollama 4B ở 14/15 với missed escalation TK-12. Live gate sau guard đạt Phê La FACT, Vinamilk AUTO, Official Verify 5/5, restart giữ status/ảnh/audit và concurrent smoke 5/5 với end-to-end P95 39,380 giây. Đây là regression evidence, không phải accuracy production.</a:t>
             </a:r>
           </a:p>
         </p:txBody>
@@ -794,7 +794,7 @@
   </p:cSld>
   <p:clrMap bg1="lt1" tx1="dk1" bg2="lt2" tx2="dk2" accent1="accent1" accent2="accent2" accent3="accent3" accent4="accent4" accent5="accent5" accent6="accent6" hlink="hlink" folHlink="folHlink"/>
   <p:sldLayoutIdLst>
-    <p:sldLayoutId xmlns:r="http://schemas.openxmlformats.org/officeDocument/2006/relationships" id="2147483649" r:id="Rd2fc839d16fb4265"/>
+    <p:sldLayoutId xmlns:r="http://schemas.openxmlformats.org/officeDocument/2006/relationships" id="2147483649" r:id="Rcf999f84d5bb482d"/>
   </p:sldLayoutIdLst>
   <p:txStyles>
     <p:titleStyle>
@@ -1374,6 +1374,7 @@
           <a:lstStyle xmlns:a="http://schemas.openxmlformats.org/drawingml/2006/main"/>
           <a:p xmlns:a="http://schemas.openxmlformats.org/drawingml/2006/main">
             <a:pPr algn="l">
+              <a:buNone/>
               <a:defRPr sz="1350" b="1">
                 <a:solidFill>
                   <a:srgbClr val="22D3EE"/>
@@ -1431,6 +1432,7 @@
           <a:lstStyle xmlns:a="http://schemas.openxmlformats.org/drawingml/2006/main"/>
           <a:p xmlns:a="http://schemas.openxmlformats.org/drawingml/2006/main">
             <a:pPr algn="l">
+              <a:buNone/>
               <a:defRPr sz="2550" b="1">
                 <a:solidFill>
                   <a:srgbClr val="F5F8FF"/>
@@ -1488,6 +1490,7 @@
           <a:lstStyle xmlns:a="http://schemas.openxmlformats.org/drawingml/2006/main"/>
           <a:p xmlns:a="http://schemas.openxmlformats.org/drawingml/2006/main">
             <a:pPr algn="l">
+              <a:buNone/>
               <a:defRPr sz="1275" b="0">
                 <a:solidFill>
                   <a:srgbClr val="9FB1CA"/>
@@ -1618,6 +1621,7 @@
           <a:lstStyle xmlns:a="http://schemas.openxmlformats.org/drawingml/2006/main"/>
           <a:p xmlns:a="http://schemas.openxmlformats.org/drawingml/2006/main">
             <a:pPr algn="ctr">
+              <a:buNone/>
               <a:defRPr sz="1050" b="1">
                 <a:solidFill>
                   <a:srgbClr val="081426"/>
@@ -1675,6 +1679,7 @@
           <a:lstStyle xmlns:a="http://schemas.openxmlformats.org/drawingml/2006/main"/>
           <a:p xmlns:a="http://schemas.openxmlformats.org/drawingml/2006/main">
             <a:pPr algn="l">
+              <a:buNone/>
               <a:defRPr sz="1275" b="1">
                 <a:solidFill>
                   <a:srgbClr val="F5F8FF"/>
@@ -1732,6 +1737,7 @@
           <a:lstStyle xmlns:a="http://schemas.openxmlformats.org/drawingml/2006/main"/>
           <a:p xmlns:a="http://schemas.openxmlformats.org/drawingml/2006/main">
             <a:pPr algn="l">
+              <a:buNone/>
               <a:defRPr sz="900" b="0">
                 <a:solidFill>
                   <a:srgbClr val="9FB1CA"/>
@@ -1863,6 +1869,7 @@
           <a:lstStyle xmlns:a="http://schemas.openxmlformats.org/drawingml/2006/main"/>
           <a:p xmlns:a="http://schemas.openxmlformats.org/drawingml/2006/main">
             <a:pPr algn="ctr">
+              <a:buNone/>
               <a:defRPr sz="1050" b="1">
                 <a:solidFill>
                   <a:srgbClr val="081426"/>
@@ -1920,6 +1927,7 @@
           <a:lstStyle xmlns:a="http://schemas.openxmlformats.org/drawingml/2006/main"/>
           <a:p xmlns:a="http://schemas.openxmlformats.org/drawingml/2006/main">
             <a:pPr algn="l">
+              <a:buNone/>
               <a:defRPr sz="1275" b="1">
                 <a:solidFill>
                   <a:srgbClr val="F5F8FF"/>
@@ -1977,6 +1985,7 @@
           <a:lstStyle xmlns:a="http://schemas.openxmlformats.org/drawingml/2006/main"/>
           <a:p xmlns:a="http://schemas.openxmlformats.org/drawingml/2006/main">
             <a:pPr algn="l">
+              <a:buNone/>
               <a:defRPr sz="900" b="0">
                 <a:solidFill>
                   <a:srgbClr val="9FB1CA"/>
@@ -2108,6 +2117,7 @@
           <a:lstStyle xmlns:a="http://schemas.openxmlformats.org/drawingml/2006/main"/>
           <a:p xmlns:a="http://schemas.openxmlformats.org/drawingml/2006/main">
             <a:pPr algn="ctr">
+              <a:buNone/>
               <a:defRPr sz="1050" b="1">
                 <a:solidFill>
                   <a:srgbClr val="081426"/>
@@ -2165,6 +2175,7 @@
           <a:lstStyle xmlns:a="http://schemas.openxmlformats.org/drawingml/2006/main"/>
           <a:p xmlns:a="http://schemas.openxmlformats.org/drawingml/2006/main">
             <a:pPr algn="l">
+              <a:buNone/>
               <a:defRPr sz="1275" b="1">
                 <a:solidFill>
                   <a:srgbClr val="F5F8FF"/>
@@ -2222,6 +2233,7 @@
           <a:lstStyle xmlns:a="http://schemas.openxmlformats.org/drawingml/2006/main"/>
           <a:p xmlns:a="http://schemas.openxmlformats.org/drawingml/2006/main">
             <a:pPr algn="l">
+              <a:buNone/>
               <a:defRPr sz="900" b="0">
                 <a:solidFill>
                   <a:srgbClr val="9FB1CA"/>
@@ -2353,6 +2365,7 @@
           <a:lstStyle xmlns:a="http://schemas.openxmlformats.org/drawingml/2006/main"/>
           <a:p xmlns:a="http://schemas.openxmlformats.org/drawingml/2006/main">
             <a:pPr algn="ctr">
+              <a:buNone/>
               <a:defRPr sz="1050" b="1">
                 <a:solidFill>
                   <a:srgbClr val="081426"/>
@@ -2410,6 +2423,7 @@
           <a:lstStyle xmlns:a="http://schemas.openxmlformats.org/drawingml/2006/main"/>
           <a:p xmlns:a="http://schemas.openxmlformats.org/drawingml/2006/main">
             <a:pPr algn="l">
+              <a:buNone/>
               <a:defRPr sz="1275" b="1">
                 <a:solidFill>
                   <a:srgbClr val="F5F8FF"/>
@@ -2467,6 +2481,7 @@
           <a:lstStyle xmlns:a="http://schemas.openxmlformats.org/drawingml/2006/main"/>
           <a:p xmlns:a="http://schemas.openxmlformats.org/drawingml/2006/main">
             <a:pPr algn="l">
+              <a:buNone/>
               <a:defRPr sz="900" b="0">
                 <a:solidFill>
                   <a:srgbClr val="9FB1CA"/>
@@ -2598,6 +2613,7 @@
           <a:lstStyle xmlns:a="http://schemas.openxmlformats.org/drawingml/2006/main"/>
           <a:p xmlns:a="http://schemas.openxmlformats.org/drawingml/2006/main">
             <a:pPr algn="ctr">
+              <a:buNone/>
               <a:defRPr sz="1050" b="1">
                 <a:solidFill>
                   <a:srgbClr val="081426"/>
@@ -2655,6 +2671,7 @@
           <a:lstStyle xmlns:a="http://schemas.openxmlformats.org/drawingml/2006/main"/>
           <a:p xmlns:a="http://schemas.openxmlformats.org/drawingml/2006/main">
             <a:pPr algn="l">
+              <a:buNone/>
               <a:defRPr sz="1275" b="1">
                 <a:solidFill>
                   <a:srgbClr val="F5F8FF"/>
@@ -2712,6 +2729,7 @@
           <a:lstStyle xmlns:a="http://schemas.openxmlformats.org/drawingml/2006/main"/>
           <a:p xmlns:a="http://schemas.openxmlformats.org/drawingml/2006/main">
             <a:pPr algn="l">
+              <a:buNone/>
               <a:defRPr sz="900" b="0">
                 <a:solidFill>
                   <a:srgbClr val="9FB1CA"/>
@@ -2804,6 +2822,7 @@
           <a:lstStyle xmlns:a="http://schemas.openxmlformats.org/drawingml/2006/main"/>
           <a:p xmlns:a="http://schemas.openxmlformats.org/drawingml/2006/main">
             <a:pPr algn="l">
+              <a:buNone/>
               <a:defRPr sz="1125" b="1">
                 <a:solidFill>
                   <a:srgbClr val="22D3EE"/>
@@ -2861,6 +2880,7 @@
           <a:lstStyle xmlns:a="http://schemas.openxmlformats.org/drawingml/2006/main"/>
           <a:p xmlns:a="http://schemas.openxmlformats.org/drawingml/2006/main">
             <a:pPr algn="l">
+              <a:buNone/>
               <a:defRPr sz="1350" b="1">
                 <a:solidFill>
                   <a:srgbClr val="F5F8FF"/>
@@ -2918,6 +2938,7 @@
           <a:lstStyle xmlns:a="http://schemas.openxmlformats.org/drawingml/2006/main"/>
           <a:p xmlns:a="http://schemas.openxmlformats.org/drawingml/2006/main">
             <a:pPr algn="l">
+              <a:buNone/>
               <a:defRPr sz="1800" b="1">
                 <a:solidFill>
                   <a:srgbClr val="F5F8FF"/>
@@ -3017,6 +3038,7 @@
           <a:lstStyle xmlns:a="http://schemas.openxmlformats.org/drawingml/2006/main"/>
           <a:p xmlns:a="http://schemas.openxmlformats.org/drawingml/2006/main">
             <a:pPr algn="ctr">
+              <a:buNone/>
               <a:defRPr sz="1050" b="1">
                 <a:solidFill>
                   <a:srgbClr val="081426"/>
@@ -3074,6 +3096,7 @@
           <a:lstStyle xmlns:a="http://schemas.openxmlformats.org/drawingml/2006/main"/>
           <a:p xmlns:a="http://schemas.openxmlformats.org/drawingml/2006/main">
             <a:pPr algn="l">
+              <a:buNone/>
               <a:defRPr sz="1575" b="1">
                 <a:solidFill>
                   <a:srgbClr val="F5F8FF"/>
@@ -3131,6 +3154,7 @@
           <a:lstStyle xmlns:a="http://schemas.openxmlformats.org/drawingml/2006/main"/>
           <a:p xmlns:a="http://schemas.openxmlformats.org/drawingml/2006/main">
             <a:pPr algn="l">
+              <a:buNone/>
               <a:defRPr sz="1050" b="0">
                 <a:solidFill>
                   <a:srgbClr val="9FB1CA"/>
@@ -3230,6 +3254,7 @@
           <a:lstStyle xmlns:a="http://schemas.openxmlformats.org/drawingml/2006/main"/>
           <a:p xmlns:a="http://schemas.openxmlformats.org/drawingml/2006/main">
             <a:pPr algn="ctr">
+              <a:buNone/>
               <a:defRPr sz="1050" b="1">
                 <a:solidFill>
                   <a:srgbClr val="081426"/>
@@ -3287,6 +3312,7 @@
           <a:lstStyle xmlns:a="http://schemas.openxmlformats.org/drawingml/2006/main"/>
           <a:p xmlns:a="http://schemas.openxmlformats.org/drawingml/2006/main">
             <a:pPr algn="l">
+              <a:buNone/>
               <a:defRPr sz="1575" b="1">
                 <a:solidFill>
                   <a:srgbClr val="F5F8FF"/>
@@ -3344,6 +3370,7 @@
           <a:lstStyle xmlns:a="http://schemas.openxmlformats.org/drawingml/2006/main"/>
           <a:p xmlns:a="http://schemas.openxmlformats.org/drawingml/2006/main">
             <a:pPr algn="l">
+              <a:buNone/>
               <a:defRPr sz="1050" b="0">
                 <a:solidFill>
                   <a:srgbClr val="9FB1CA"/>
@@ -3443,6 +3470,7 @@
           <a:lstStyle xmlns:a="http://schemas.openxmlformats.org/drawingml/2006/main"/>
           <a:p xmlns:a="http://schemas.openxmlformats.org/drawingml/2006/main">
             <a:pPr algn="ctr">
+              <a:buNone/>
               <a:defRPr sz="1050" b="1">
                 <a:solidFill>
                   <a:srgbClr val="081426"/>
@@ -3500,6 +3528,7 @@
           <a:lstStyle xmlns:a="http://schemas.openxmlformats.org/drawingml/2006/main"/>
           <a:p xmlns:a="http://schemas.openxmlformats.org/drawingml/2006/main">
             <a:pPr algn="l">
+              <a:buNone/>
               <a:defRPr sz="1575" b="1">
                 <a:solidFill>
                   <a:srgbClr val="F5F8FF"/>
@@ -3557,6 +3586,7 @@
           <a:lstStyle xmlns:a="http://schemas.openxmlformats.org/drawingml/2006/main"/>
           <a:p xmlns:a="http://schemas.openxmlformats.org/drawingml/2006/main">
             <a:pPr algn="l">
+              <a:buNone/>
               <a:defRPr sz="1050" b="0">
                 <a:solidFill>
                   <a:srgbClr val="9FB1CA"/>
@@ -3614,6 +3644,7 @@
           <a:lstStyle xmlns:a="http://schemas.openxmlformats.org/drawingml/2006/main"/>
           <a:p xmlns:a="http://schemas.openxmlformats.org/drawingml/2006/main">
             <a:pPr algn="l">
+              <a:buNone/>
               <a:defRPr sz="900" b="0">
                 <a:solidFill>
                   <a:srgbClr val="9FB1CA"/>
@@ -3632,7 +3663,7 @@
                 <a:ea typeface="Arial"/>
                 <a:cs typeface="Arial"/>
               </a:rPr>
-              <a:t>AURA • Track A • 01/10/2026</a:t>
+              <a:t>AURA • Track A • 02/10/2026</a:t>
             </a:r>
           </a:p>
         </p:txBody>
@@ -3671,6 +3702,7 @@
           <a:lstStyle xmlns:a="http://schemas.openxmlformats.org/drawingml/2006/main"/>
           <a:p xmlns:a="http://schemas.openxmlformats.org/drawingml/2006/main">
             <a:pPr algn="r">
+              <a:buNone/>
               <a:defRPr sz="975" b="1">
                 <a:solidFill>
                   <a:srgbClr val="9FB1CA"/>
@@ -3757,6 +3789,7 @@
           <a:lstStyle xmlns:a="http://schemas.openxmlformats.org/drawingml/2006/main"/>
           <a:p xmlns:a="http://schemas.openxmlformats.org/drawingml/2006/main">
             <a:pPr algn="l">
+              <a:buNone/>
               <a:defRPr sz="1350" b="1">
                 <a:solidFill>
                   <a:srgbClr val="22D3EE"/>
@@ -3814,6 +3847,7 @@
           <a:lstStyle xmlns:a="http://schemas.openxmlformats.org/drawingml/2006/main"/>
           <a:p xmlns:a="http://schemas.openxmlformats.org/drawingml/2006/main">
             <a:pPr algn="l">
+              <a:buNone/>
               <a:defRPr sz="2550" b="1">
                 <a:solidFill>
                   <a:srgbClr val="F5F8FF"/>
@@ -3871,6 +3905,7 @@
           <a:lstStyle xmlns:a="http://schemas.openxmlformats.org/drawingml/2006/main"/>
           <a:p xmlns:a="http://schemas.openxmlformats.org/drawingml/2006/main">
             <a:pPr algn="l">
+              <a:buNone/>
               <a:defRPr sz="1275" b="0">
                 <a:solidFill>
                   <a:srgbClr val="9FB1CA"/>
@@ -4001,6 +4036,7 @@
           <a:lstStyle xmlns:a="http://schemas.openxmlformats.org/drawingml/2006/main"/>
           <a:p xmlns:a="http://schemas.openxmlformats.org/drawingml/2006/main">
             <a:pPr algn="ctr">
+              <a:buNone/>
               <a:defRPr sz="1050" b="1">
                 <a:solidFill>
                   <a:srgbClr val="081426"/>
@@ -4058,6 +4094,7 @@
           <a:lstStyle xmlns:a="http://schemas.openxmlformats.org/drawingml/2006/main"/>
           <a:p xmlns:a="http://schemas.openxmlformats.org/drawingml/2006/main">
             <a:pPr algn="l">
+              <a:buNone/>
               <a:defRPr sz="1275" b="1">
                 <a:solidFill>
                   <a:srgbClr val="F5F8FF"/>
@@ -4115,6 +4152,7 @@
           <a:lstStyle xmlns:a="http://schemas.openxmlformats.org/drawingml/2006/main"/>
           <a:p xmlns:a="http://schemas.openxmlformats.org/drawingml/2006/main">
             <a:pPr algn="ctr">
+              <a:buNone/>
               <a:defRPr sz="1200" b="0">
                 <a:solidFill>
                   <a:srgbClr val="9FB1CA"/>
@@ -4138,6 +4176,7 @@
           </a:p>
           <a:p xmlns:a="http://schemas.openxmlformats.org/drawingml/2006/main">
             <a:pPr algn="ctr">
+              <a:buNone/>
               <a:defRPr sz="1200" b="0">
                 <a:solidFill>
                   <a:srgbClr val="9FB1CA"/>
@@ -4269,6 +4308,7 @@
           <a:lstStyle xmlns:a="http://schemas.openxmlformats.org/drawingml/2006/main"/>
           <a:p xmlns:a="http://schemas.openxmlformats.org/drawingml/2006/main">
             <a:pPr algn="ctr">
+              <a:buNone/>
               <a:defRPr sz="1050" b="1">
                 <a:solidFill>
                   <a:srgbClr val="081426"/>
@@ -4326,6 +4366,7 @@
           <a:lstStyle xmlns:a="http://schemas.openxmlformats.org/drawingml/2006/main"/>
           <a:p xmlns:a="http://schemas.openxmlformats.org/drawingml/2006/main">
             <a:pPr algn="l">
+              <a:buNone/>
               <a:defRPr sz="1275" b="1">
                 <a:solidFill>
                   <a:srgbClr val="F5F8FF"/>
@@ -4383,6 +4424,7 @@
           <a:lstStyle xmlns:a="http://schemas.openxmlformats.org/drawingml/2006/main"/>
           <a:p xmlns:a="http://schemas.openxmlformats.org/drawingml/2006/main">
             <a:pPr algn="ctr">
+              <a:buNone/>
               <a:defRPr sz="1200" b="0">
                 <a:solidFill>
                   <a:srgbClr val="9FB1CA"/>
@@ -4406,6 +4448,7 @@
           </a:p>
           <a:p xmlns:a="http://schemas.openxmlformats.org/drawingml/2006/main">
             <a:pPr algn="ctr">
+              <a:buNone/>
               <a:defRPr sz="1200" b="0">
                 <a:solidFill>
                   <a:srgbClr val="9FB1CA"/>
@@ -4537,6 +4580,7 @@
           <a:lstStyle xmlns:a="http://schemas.openxmlformats.org/drawingml/2006/main"/>
           <a:p xmlns:a="http://schemas.openxmlformats.org/drawingml/2006/main">
             <a:pPr algn="ctr">
+              <a:buNone/>
               <a:defRPr sz="1050" b="1">
                 <a:solidFill>
                   <a:srgbClr val="081426"/>
@@ -4594,6 +4638,7 @@
           <a:lstStyle xmlns:a="http://schemas.openxmlformats.org/drawingml/2006/main"/>
           <a:p xmlns:a="http://schemas.openxmlformats.org/drawingml/2006/main">
             <a:pPr algn="l">
+              <a:buNone/>
               <a:defRPr sz="1275" b="1">
                 <a:solidFill>
                   <a:srgbClr val="F5F8FF"/>
@@ -4651,6 +4696,7 @@
           <a:lstStyle xmlns:a="http://schemas.openxmlformats.org/drawingml/2006/main"/>
           <a:p xmlns:a="http://schemas.openxmlformats.org/drawingml/2006/main">
             <a:pPr algn="ctr">
+              <a:buNone/>
               <a:defRPr sz="1200" b="0">
                 <a:solidFill>
                   <a:srgbClr val="9FB1CA"/>
@@ -4674,6 +4720,7 @@
           </a:p>
           <a:p xmlns:a="http://schemas.openxmlformats.org/drawingml/2006/main">
             <a:pPr algn="ctr">
+              <a:buNone/>
               <a:defRPr sz="1200" b="0">
                 <a:solidFill>
                   <a:srgbClr val="9FB1CA"/>
@@ -4805,6 +4852,7 @@
           <a:lstStyle xmlns:a="http://schemas.openxmlformats.org/drawingml/2006/main"/>
           <a:p xmlns:a="http://schemas.openxmlformats.org/drawingml/2006/main">
             <a:pPr algn="ctr">
+              <a:buNone/>
               <a:defRPr sz="1050" b="1">
                 <a:solidFill>
                   <a:srgbClr val="081426"/>
@@ -4862,6 +4910,7 @@
           <a:lstStyle xmlns:a="http://schemas.openxmlformats.org/drawingml/2006/main"/>
           <a:p xmlns:a="http://schemas.openxmlformats.org/drawingml/2006/main">
             <a:pPr algn="l">
+              <a:buNone/>
               <a:defRPr sz="1275" b="1">
                 <a:solidFill>
                   <a:srgbClr val="F5F8FF"/>
@@ -4919,6 +4968,7 @@
           <a:lstStyle xmlns:a="http://schemas.openxmlformats.org/drawingml/2006/main"/>
           <a:p xmlns:a="http://schemas.openxmlformats.org/drawingml/2006/main">
             <a:pPr algn="ctr">
+              <a:buNone/>
               <a:defRPr sz="1200" b="0">
                 <a:solidFill>
                   <a:srgbClr val="9FB1CA"/>
@@ -4942,6 +4992,7 @@
           </a:p>
           <a:p xmlns:a="http://schemas.openxmlformats.org/drawingml/2006/main">
             <a:pPr algn="ctr">
+              <a:buNone/>
               <a:defRPr sz="1200" b="0">
                 <a:solidFill>
                   <a:srgbClr val="9FB1CA"/>
@@ -5073,6 +5124,7 @@
           <a:lstStyle xmlns:a="http://schemas.openxmlformats.org/drawingml/2006/main"/>
           <a:p xmlns:a="http://schemas.openxmlformats.org/drawingml/2006/main">
             <a:pPr algn="ctr">
+              <a:buNone/>
               <a:defRPr sz="1050" b="1">
                 <a:solidFill>
                   <a:srgbClr val="081426"/>
@@ -5130,6 +5182,7 @@
           <a:lstStyle xmlns:a="http://schemas.openxmlformats.org/drawingml/2006/main"/>
           <a:p xmlns:a="http://schemas.openxmlformats.org/drawingml/2006/main">
             <a:pPr algn="l">
+              <a:buNone/>
               <a:defRPr sz="1275" b="1">
                 <a:solidFill>
                   <a:srgbClr val="F5F8FF"/>
@@ -5187,6 +5240,7 @@
           <a:lstStyle xmlns:a="http://schemas.openxmlformats.org/drawingml/2006/main"/>
           <a:p xmlns:a="http://schemas.openxmlformats.org/drawingml/2006/main">
             <a:pPr algn="ctr">
+              <a:buNone/>
               <a:defRPr sz="1200" b="0">
                 <a:solidFill>
                   <a:srgbClr val="9FB1CA"/>
@@ -5210,6 +5264,7 @@
           </a:p>
           <a:p xmlns:a="http://schemas.openxmlformats.org/drawingml/2006/main">
             <a:pPr algn="ctr">
+              <a:buNone/>
               <a:defRPr sz="1200" b="0">
                 <a:solidFill>
                   <a:srgbClr val="9FB1CA"/>
@@ -5267,6 +5322,7 @@
           <a:lstStyle xmlns:a="http://schemas.openxmlformats.org/drawingml/2006/main"/>
           <a:p xmlns:a="http://schemas.openxmlformats.org/drawingml/2006/main">
             <a:pPr algn="l">
+              <a:buNone/>
               <a:defRPr sz="1125" b="1">
                 <a:solidFill>
                   <a:srgbClr val="22D3EE"/>
@@ -5359,6 +5415,7 @@
           <a:lstStyle xmlns:a="http://schemas.openxmlformats.org/drawingml/2006/main"/>
           <a:p xmlns:a="http://schemas.openxmlformats.org/drawingml/2006/main">
             <a:pPr algn="l">
+              <a:buNone/>
               <a:defRPr sz="1725" b="1">
                 <a:solidFill>
                   <a:srgbClr val="F5F8FF"/>
@@ -5416,6 +5473,7 @@
           <a:lstStyle xmlns:a="http://schemas.openxmlformats.org/drawingml/2006/main"/>
           <a:p xmlns:a="http://schemas.openxmlformats.org/drawingml/2006/main">
             <a:pPr algn="l">
+              <a:buNone/>
               <a:defRPr sz="1350" b="0">
                 <a:solidFill>
                   <a:srgbClr val="9FB1CA"/>
@@ -5439,6 +5497,7 @@
           </a:p>
           <a:p xmlns:a="http://schemas.openxmlformats.org/drawingml/2006/main">
             <a:pPr algn="l">
+              <a:buNone/>
               <a:defRPr sz="1350" b="0">
                 <a:solidFill>
                   <a:srgbClr val="9FB1CA"/>
@@ -5462,6 +5521,7 @@
           </a:p>
           <a:p xmlns:a="http://schemas.openxmlformats.org/drawingml/2006/main">
             <a:pPr algn="l">
+              <a:buNone/>
               <a:defRPr sz="1350" b="0">
                 <a:solidFill>
                   <a:srgbClr val="9FB1CA"/>
@@ -5526,6 +5586,7 @@
           <a:lstStyle xmlns:a="http://schemas.openxmlformats.org/drawingml/2006/main"/>
           <a:p xmlns:a="http://schemas.openxmlformats.org/drawingml/2006/main">
             <a:pPr algn="ctr">
+              <a:buNone/>
               <a:defRPr sz="1050" b="1">
                 <a:solidFill>
                   <a:srgbClr val="081426"/>
@@ -5583,6 +5644,7 @@
           <a:lstStyle xmlns:a="http://schemas.openxmlformats.org/drawingml/2006/main"/>
           <a:p xmlns:a="http://schemas.openxmlformats.org/drawingml/2006/main">
             <a:pPr algn="l">
+              <a:buNone/>
               <a:defRPr sz="1125" b="1">
                 <a:solidFill>
                   <a:srgbClr val="F8C14C"/>
@@ -5675,6 +5737,7 @@
           <a:lstStyle xmlns:a="http://schemas.openxmlformats.org/drawingml/2006/main"/>
           <a:p xmlns:a="http://schemas.openxmlformats.org/drawingml/2006/main">
             <a:pPr algn="l">
+              <a:buNone/>
               <a:defRPr sz="1725" b="1">
                 <a:solidFill>
                   <a:srgbClr val="F5F8FF"/>
@@ -5767,6 +5830,7 @@
           <a:lstStyle xmlns:a="http://schemas.openxmlformats.org/drawingml/2006/main"/>
           <a:p xmlns:a="http://schemas.openxmlformats.org/drawingml/2006/main">
             <a:pPr algn="ctr">
+              <a:buNone/>
               <a:defRPr sz="1200" b="1">
                 <a:solidFill>
                   <a:srgbClr val="2DD4A7"/>
@@ -5824,6 +5888,7 @@
           <a:lstStyle xmlns:a="http://schemas.openxmlformats.org/drawingml/2006/main"/>
           <a:p xmlns:a="http://schemas.openxmlformats.org/drawingml/2006/main">
             <a:pPr algn="ctr">
+              <a:buNone/>
               <a:defRPr sz="975" b="0">
                 <a:solidFill>
                   <a:srgbClr val="9FB1CA"/>
@@ -5916,6 +5981,7 @@
           <a:lstStyle xmlns:a="http://schemas.openxmlformats.org/drawingml/2006/main"/>
           <a:p xmlns:a="http://schemas.openxmlformats.org/drawingml/2006/main">
             <a:pPr algn="ctr">
+              <a:buNone/>
               <a:defRPr sz="1200" b="1">
                 <a:solidFill>
                   <a:srgbClr val="FF6B7A"/>
@@ -5973,6 +6039,7 @@
           <a:lstStyle xmlns:a="http://schemas.openxmlformats.org/drawingml/2006/main"/>
           <a:p xmlns:a="http://schemas.openxmlformats.org/drawingml/2006/main">
             <a:pPr algn="ctr">
+              <a:buNone/>
               <a:defRPr sz="975" b="0">
                 <a:solidFill>
                   <a:srgbClr val="9FB1CA"/>
@@ -6030,6 +6097,7 @@
           <a:lstStyle xmlns:a="http://schemas.openxmlformats.org/drawingml/2006/main"/>
           <a:p xmlns:a="http://schemas.openxmlformats.org/drawingml/2006/main">
             <a:pPr algn="ctr">
+              <a:buNone/>
               <a:defRPr sz="1125" b="1">
                 <a:solidFill>
                   <a:srgbClr val="F5F8FF"/>
@@ -6087,6 +6155,7 @@
           <a:lstStyle xmlns:a="http://schemas.openxmlformats.org/drawingml/2006/main"/>
           <a:p xmlns:a="http://schemas.openxmlformats.org/drawingml/2006/main">
             <a:pPr algn="l">
+              <a:buNone/>
               <a:defRPr sz="900" b="0">
                 <a:solidFill>
                   <a:srgbClr val="9FB1CA"/>
@@ -6105,7 +6174,7 @@
                 <a:ea typeface="Arial"/>
                 <a:cs typeface="Arial"/>
               </a:rPr>
-              <a:t>AURA • Track A • 01/10/2026</a:t>
+              <a:t>AURA • Track A • 02/10/2026</a:t>
             </a:r>
           </a:p>
         </p:txBody>
@@ -6144,6 +6213,7 @@
           <a:lstStyle xmlns:a="http://schemas.openxmlformats.org/drawingml/2006/main"/>
           <a:p xmlns:a="http://schemas.openxmlformats.org/drawingml/2006/main">
             <a:pPr algn="r">
+              <a:buNone/>
               <a:defRPr sz="975" b="1">
                 <a:solidFill>
                   <a:srgbClr val="9FB1CA"/>
@@ -6230,6 +6300,7 @@
           <a:lstStyle xmlns:a="http://schemas.openxmlformats.org/drawingml/2006/main"/>
           <a:p xmlns:a="http://schemas.openxmlformats.org/drawingml/2006/main">
             <a:pPr algn="l">
+              <a:buNone/>
               <a:defRPr sz="1350" b="1">
                 <a:solidFill>
                   <a:srgbClr val="22D3EE"/>
@@ -6287,6 +6358,7 @@
           <a:lstStyle xmlns:a="http://schemas.openxmlformats.org/drawingml/2006/main"/>
           <a:p xmlns:a="http://schemas.openxmlformats.org/drawingml/2006/main">
             <a:pPr algn="l">
+              <a:buNone/>
               <a:defRPr sz="2550" b="1">
                 <a:solidFill>
                   <a:srgbClr val="F5F8FF"/>
@@ -6344,6 +6416,7 @@
           <a:lstStyle xmlns:a="http://schemas.openxmlformats.org/drawingml/2006/main"/>
           <a:p xmlns:a="http://schemas.openxmlformats.org/drawingml/2006/main">
             <a:pPr algn="l">
+              <a:buNone/>
               <a:defRPr sz="1275" b="0">
                 <a:solidFill>
                   <a:srgbClr val="9FB1CA"/>
@@ -6362,7 +6435,7 @@
                 <a:ea typeface="Arial"/>
                 <a:cs typeface="Arial"/>
               </a:rPr>
-              <a:t>Kết quả regression đã có; hiệu quả vận hành chỉ kết luận sau pilot độc lập.</a:t>
+              <a:t>Regression kỹ thuật đã pass. Hiệu quả vận hành cần pilot độc lập.</a:t>
             </a:r>
           </a:p>
         </p:txBody>
@@ -6474,6 +6547,7 @@
           <a:lstStyle xmlns:a="http://schemas.openxmlformats.org/drawingml/2006/main"/>
           <a:p xmlns:a="http://schemas.openxmlformats.org/drawingml/2006/main">
             <a:pPr algn="ctr">
+              <a:buNone/>
               <a:defRPr sz="1050" b="1">
                 <a:solidFill>
                   <a:srgbClr val="081426"/>
@@ -6531,6 +6605,7 @@
           <a:lstStyle xmlns:a="http://schemas.openxmlformats.org/drawingml/2006/main"/>
           <a:p xmlns:a="http://schemas.openxmlformats.org/drawingml/2006/main">
             <a:pPr algn="l">
+              <a:buNone/>
               <a:defRPr sz="1800" b="1">
                 <a:solidFill>
                   <a:srgbClr val="F5F8FF"/>
@@ -6588,6 +6663,7 @@
           <a:lstStyle xmlns:a="http://schemas.openxmlformats.org/drawingml/2006/main"/>
           <a:p xmlns:a="http://schemas.openxmlformats.org/drawingml/2006/main">
             <a:pPr algn="l">
+              <a:buNone/>
               <a:defRPr sz="1350" b="0">
                 <a:solidFill>
                   <a:srgbClr val="9FB1CA"/>
@@ -6611,6 +6687,7 @@
           </a:p>
           <a:p xmlns:a="http://schemas.openxmlformats.org/drawingml/2006/main">
             <a:pPr algn="l">
+              <a:buNone/>
               <a:defRPr sz="1350" b="0">
                 <a:solidFill>
                   <a:srgbClr val="9FB1CA"/>
@@ -6634,6 +6711,7 @@
           </a:p>
           <a:p xmlns:a="http://schemas.openxmlformats.org/drawingml/2006/main">
             <a:pPr algn="l">
+              <a:buNone/>
               <a:defRPr sz="1350" b="0">
                 <a:solidFill>
                   <a:srgbClr val="9FB1CA"/>
@@ -6733,6 +6811,7 @@
           <a:lstStyle xmlns:a="http://schemas.openxmlformats.org/drawingml/2006/main"/>
           <a:p xmlns:a="http://schemas.openxmlformats.org/drawingml/2006/main">
             <a:pPr algn="ctr">
+              <a:buNone/>
               <a:defRPr sz="1050" b="1">
                 <a:solidFill>
                   <a:srgbClr val="081426"/>
@@ -6790,6 +6869,7 @@
           <a:lstStyle xmlns:a="http://schemas.openxmlformats.org/drawingml/2006/main"/>
           <a:p xmlns:a="http://schemas.openxmlformats.org/drawingml/2006/main">
             <a:pPr algn="l">
+              <a:buNone/>
               <a:defRPr sz="1800" b="1">
                 <a:solidFill>
                   <a:srgbClr val="F5F8FF"/>
@@ -6847,6 +6927,7 @@
           <a:lstStyle xmlns:a="http://schemas.openxmlformats.org/drawingml/2006/main"/>
           <a:p xmlns:a="http://schemas.openxmlformats.org/drawingml/2006/main">
             <a:pPr algn="l">
+              <a:buNone/>
               <a:defRPr sz="1350" b="0">
                 <a:solidFill>
                   <a:srgbClr val="9FB1CA"/>
@@ -6870,6 +6951,7 @@
           </a:p>
           <a:p xmlns:a="http://schemas.openxmlformats.org/drawingml/2006/main">
             <a:pPr algn="l">
+              <a:buNone/>
               <a:defRPr sz="1350" b="0">
                 <a:solidFill>
                   <a:srgbClr val="9FB1CA"/>
@@ -6893,6 +6975,7 @@
           </a:p>
           <a:p xmlns:a="http://schemas.openxmlformats.org/drawingml/2006/main">
             <a:pPr algn="l">
+              <a:buNone/>
               <a:defRPr sz="1350" b="0">
                 <a:solidFill>
                   <a:srgbClr val="9FB1CA"/>
@@ -6950,6 +7033,7 @@
           <a:lstStyle xmlns:a="http://schemas.openxmlformats.org/drawingml/2006/main"/>
           <a:p xmlns:a="http://schemas.openxmlformats.org/drawingml/2006/main">
             <a:pPr algn="l">
+              <a:buNone/>
               <a:defRPr sz="1500" b="1">
                 <a:solidFill>
                   <a:srgbClr val="F5F8FF"/>
@@ -7042,6 +7126,7 @@
           <a:lstStyle xmlns:a="http://schemas.openxmlformats.org/drawingml/2006/main"/>
           <a:p xmlns:a="http://schemas.openxmlformats.org/drawingml/2006/main">
             <a:pPr algn="ctr">
+              <a:buNone/>
               <a:defRPr sz="2325" b="1">
                 <a:solidFill>
                   <a:srgbClr val="4D8DFF"/>
@@ -7099,6 +7184,7 @@
           <a:lstStyle xmlns:a="http://schemas.openxmlformats.org/drawingml/2006/main"/>
           <a:p xmlns:a="http://schemas.openxmlformats.org/drawingml/2006/main">
             <a:pPr algn="ctr">
+              <a:buNone/>
               <a:defRPr sz="1050" b="1">
                 <a:solidFill>
                   <a:srgbClr val="9FB1CA"/>
@@ -7191,6 +7277,7 @@
           <a:lstStyle xmlns:a="http://schemas.openxmlformats.org/drawingml/2006/main"/>
           <a:p xmlns:a="http://schemas.openxmlformats.org/drawingml/2006/main">
             <a:pPr algn="ctr">
+              <a:buNone/>
               <a:defRPr sz="2325" b="1">
                 <a:solidFill>
                   <a:srgbClr val="2DD4A7"/>
@@ -7248,6 +7335,7 @@
           <a:lstStyle xmlns:a="http://schemas.openxmlformats.org/drawingml/2006/main"/>
           <a:p xmlns:a="http://schemas.openxmlformats.org/drawingml/2006/main">
             <a:pPr algn="ctr">
+              <a:buNone/>
               <a:defRPr sz="1050" b="1">
                 <a:solidFill>
                   <a:srgbClr val="9FB1CA"/>
@@ -7340,6 +7428,7 @@
           <a:lstStyle xmlns:a="http://schemas.openxmlformats.org/drawingml/2006/main"/>
           <a:p xmlns:a="http://schemas.openxmlformats.org/drawingml/2006/main">
             <a:pPr algn="ctr">
+              <a:buNone/>
               <a:defRPr sz="2325" b="1">
                 <a:solidFill>
                   <a:srgbClr val="A78BFA"/>
@@ -7397,6 +7486,7 @@
           <a:lstStyle xmlns:a="http://schemas.openxmlformats.org/drawingml/2006/main"/>
           <a:p xmlns:a="http://schemas.openxmlformats.org/drawingml/2006/main">
             <a:pPr algn="ctr">
+              <a:buNone/>
               <a:defRPr sz="1050" b="1">
                 <a:solidFill>
                   <a:srgbClr val="9FB1CA"/>
@@ -7489,6 +7579,7 @@
           <a:lstStyle xmlns:a="http://schemas.openxmlformats.org/drawingml/2006/main"/>
           <a:p xmlns:a="http://schemas.openxmlformats.org/drawingml/2006/main">
             <a:pPr algn="l">
+              <a:buNone/>
               <a:defRPr sz="1500" b="1">
                 <a:solidFill>
                   <a:srgbClr val="F5F8FF"/>
@@ -7553,6 +7644,7 @@
           <a:lstStyle xmlns:a="http://schemas.openxmlformats.org/drawingml/2006/main"/>
           <a:p xmlns:a="http://schemas.openxmlformats.org/drawingml/2006/main">
             <a:pPr algn="ctr">
+              <a:buNone/>
               <a:defRPr sz="1050" b="1">
                 <a:solidFill>
                   <a:srgbClr val="081426"/>
@@ -7617,6 +7709,7 @@
           <a:lstStyle xmlns:a="http://schemas.openxmlformats.org/drawingml/2006/main"/>
           <a:p xmlns:a="http://schemas.openxmlformats.org/drawingml/2006/main">
             <a:pPr algn="ctr">
+              <a:buNone/>
               <a:defRPr sz="1050" b="1">
                 <a:solidFill>
                   <a:srgbClr val="081426"/>
@@ -7681,6 +7774,7 @@
           <a:lstStyle xmlns:a="http://schemas.openxmlformats.org/drawingml/2006/main"/>
           <a:p xmlns:a="http://schemas.openxmlformats.org/drawingml/2006/main">
             <a:pPr algn="ctr">
+              <a:buNone/>
               <a:defRPr sz="1050" b="1">
                 <a:solidFill>
                   <a:srgbClr val="081426"/>
@@ -7745,6 +7839,7 @@
           <a:lstStyle xmlns:a="http://schemas.openxmlformats.org/drawingml/2006/main"/>
           <a:p xmlns:a="http://schemas.openxmlformats.org/drawingml/2006/main">
             <a:pPr algn="ctr">
+              <a:buNone/>
               <a:defRPr sz="1050" b="1">
                 <a:solidFill>
                   <a:srgbClr val="081426"/>
@@ -7802,6 +7897,7 @@
           <a:lstStyle xmlns:a="http://schemas.openxmlformats.org/drawingml/2006/main"/>
           <a:p xmlns:a="http://schemas.openxmlformats.org/drawingml/2006/main">
             <a:pPr algn="ctr">
+              <a:buNone/>
               <a:defRPr sz="1125" b="1">
                 <a:solidFill>
                   <a:srgbClr val="F8C14C"/>
@@ -7820,7 +7916,7 @@
                 <a:ea typeface="Arial"/>
                 <a:cs typeface="Arial"/>
               </a:rPr>
-              <a:t>Baseline và target chỉ điền sau khi có dữ liệu người dùng thật.</a:t>
+              <a:t>Live gate 02/10: Phê La FACT • Vinamilk AUTO • Verify 5/5</a:t>
             </a:r>
           </a:p>
         </p:txBody>
@@ -7859,6 +7955,7 @@
           <a:lstStyle xmlns:a="http://schemas.openxmlformats.org/drawingml/2006/main"/>
           <a:p xmlns:a="http://schemas.openxmlformats.org/drawingml/2006/main">
             <a:pPr algn="l">
+              <a:buNone/>
               <a:defRPr sz="900" b="0">
                 <a:solidFill>
                   <a:srgbClr val="9FB1CA"/>
@@ -7877,7 +7974,7 @@
                 <a:ea typeface="Arial"/>
                 <a:cs typeface="Arial"/>
               </a:rPr>
-              <a:t>AURA • Track A • 01/10/2026</a:t>
+              <a:t>AURA • Track A • 02/10/2026</a:t>
             </a:r>
           </a:p>
         </p:txBody>
@@ -7916,6 +8013,7 @@
           <a:lstStyle xmlns:a="http://schemas.openxmlformats.org/drawingml/2006/main"/>
           <a:p xmlns:a="http://schemas.openxmlformats.org/drawingml/2006/main">
             <a:pPr algn="r">
+              <a:buNone/>
               <a:defRPr sz="975" b="1">
                 <a:solidFill>
                   <a:srgbClr val="9FB1CA"/>
@@ -8002,6 +8100,7 @@
           <a:lstStyle xmlns:a="http://schemas.openxmlformats.org/drawingml/2006/main"/>
           <a:p xmlns:a="http://schemas.openxmlformats.org/drawingml/2006/main">
             <a:pPr algn="l">
+              <a:buNone/>
               <a:defRPr sz="1350" b="1">
                 <a:solidFill>
                   <a:srgbClr val="22D3EE"/>
@@ -8059,6 +8158,7 @@
           <a:lstStyle xmlns:a="http://schemas.openxmlformats.org/drawingml/2006/main"/>
           <a:p xmlns:a="http://schemas.openxmlformats.org/drawingml/2006/main">
             <a:pPr algn="l">
+              <a:buNone/>
               <a:defRPr sz="2550" b="1">
                 <a:solidFill>
                   <a:srgbClr val="F5F8FF"/>
@@ -8116,6 +8216,7 @@
           <a:lstStyle xmlns:a="http://schemas.openxmlformats.org/drawingml/2006/main"/>
           <a:p xmlns:a="http://schemas.openxmlformats.org/drawingml/2006/main">
             <a:pPr algn="l">
+              <a:buNone/>
               <a:defRPr sz="1275" b="0">
                 <a:solidFill>
                   <a:srgbClr val="9FB1CA"/>
@@ -8246,6 +8347,7 @@
           <a:lstStyle xmlns:a="http://schemas.openxmlformats.org/drawingml/2006/main"/>
           <a:p xmlns:a="http://schemas.openxmlformats.org/drawingml/2006/main">
             <a:pPr algn="ctr">
+              <a:buNone/>
               <a:defRPr sz="1050" b="1">
                 <a:solidFill>
                   <a:srgbClr val="081426"/>
@@ -8303,6 +8405,7 @@
           <a:lstStyle xmlns:a="http://schemas.openxmlformats.org/drawingml/2006/main"/>
           <a:p xmlns:a="http://schemas.openxmlformats.org/drawingml/2006/main">
             <a:pPr algn="l">
+              <a:buNone/>
               <a:defRPr sz="1275" b="1">
                 <a:solidFill>
                   <a:srgbClr val="F5F8FF"/>
@@ -8433,6 +8536,7 @@
           <a:lstStyle xmlns:a="http://schemas.openxmlformats.org/drawingml/2006/main"/>
           <a:p xmlns:a="http://schemas.openxmlformats.org/drawingml/2006/main">
             <a:pPr algn="ctr">
+              <a:buNone/>
               <a:defRPr sz="1050" b="1">
                 <a:solidFill>
                   <a:srgbClr val="081426"/>
@@ -8490,6 +8594,7 @@
           <a:lstStyle xmlns:a="http://schemas.openxmlformats.org/drawingml/2006/main"/>
           <a:p xmlns:a="http://schemas.openxmlformats.org/drawingml/2006/main">
             <a:pPr algn="l">
+              <a:buNone/>
               <a:defRPr sz="1275" b="1">
                 <a:solidFill>
                   <a:srgbClr val="F5F8FF"/>
@@ -8620,6 +8725,7 @@
           <a:lstStyle xmlns:a="http://schemas.openxmlformats.org/drawingml/2006/main"/>
           <a:p xmlns:a="http://schemas.openxmlformats.org/drawingml/2006/main">
             <a:pPr algn="ctr">
+              <a:buNone/>
               <a:defRPr sz="1050" b="1">
                 <a:solidFill>
                   <a:srgbClr val="081426"/>
@@ -8677,6 +8783,7 @@
           <a:lstStyle xmlns:a="http://schemas.openxmlformats.org/drawingml/2006/main"/>
           <a:p xmlns:a="http://schemas.openxmlformats.org/drawingml/2006/main">
             <a:pPr algn="l">
+              <a:buNone/>
               <a:defRPr sz="1275" b="1">
                 <a:solidFill>
                   <a:srgbClr val="F5F8FF"/>
@@ -8695,7 +8802,7 @@
                 <a:ea typeface="Arial"/>
                 <a:cs typeface="Arial"/>
               </a:rPr>
-              <a:t>Schema + identifier validation → Policy C# → human review</a:t>
+              <a:t>Schema + semantic guard → Policy C# → human review</a:t>
             </a:r>
           </a:p>
         </p:txBody>
@@ -8807,6 +8914,7 @@
           <a:lstStyle xmlns:a="http://schemas.openxmlformats.org/drawingml/2006/main"/>
           <a:p xmlns:a="http://schemas.openxmlformats.org/drawingml/2006/main">
             <a:pPr algn="ctr">
+              <a:buNone/>
               <a:defRPr sz="1050" b="1">
                 <a:solidFill>
                   <a:srgbClr val="081426"/>
@@ -8864,6 +8972,7 @@
           <a:lstStyle xmlns:a="http://schemas.openxmlformats.org/drawingml/2006/main"/>
           <a:p xmlns:a="http://schemas.openxmlformats.org/drawingml/2006/main">
             <a:pPr algn="l">
+              <a:buNone/>
               <a:defRPr sz="1275" b="1">
                 <a:solidFill>
                   <a:srgbClr val="F5F8FF"/>
@@ -8956,6 +9065,7 @@
           <a:lstStyle xmlns:a="http://schemas.openxmlformats.org/drawingml/2006/main"/>
           <a:p xmlns:a="http://schemas.openxmlformats.org/drawingml/2006/main">
             <a:pPr algn="l">
+              <a:buNone/>
               <a:defRPr sz="1125" b="1">
                 <a:solidFill>
                   <a:srgbClr val="22D3EE"/>
@@ -9013,6 +9123,7 @@
           <a:lstStyle xmlns:a="http://schemas.openxmlformats.org/drawingml/2006/main"/>
           <a:p xmlns:a="http://schemas.openxmlformats.org/drawingml/2006/main">
             <a:pPr algn="l">
+              <a:buNone/>
               <a:defRPr sz="1350" b="1">
                 <a:solidFill>
                   <a:srgbClr val="F5F8FF"/>
@@ -9112,6 +9223,7 @@
           <a:lstStyle xmlns:a="http://schemas.openxmlformats.org/drawingml/2006/main"/>
           <a:p xmlns:a="http://schemas.openxmlformats.org/drawingml/2006/main">
             <a:pPr algn="ctr">
+              <a:buNone/>
               <a:defRPr sz="1050" b="1">
                 <a:solidFill>
                   <a:srgbClr val="081426"/>
@@ -9169,6 +9281,7 @@
           <a:lstStyle xmlns:a="http://schemas.openxmlformats.org/drawingml/2006/main"/>
           <a:p xmlns:a="http://schemas.openxmlformats.org/drawingml/2006/main">
             <a:pPr algn="l">
+              <a:buNone/>
               <a:defRPr sz="1500" b="1">
                 <a:solidFill>
                   <a:srgbClr val="F5F8FF"/>
@@ -9192,6 +9305,7 @@
           </a:p>
           <a:p xmlns:a="http://schemas.openxmlformats.org/drawingml/2006/main">
             <a:pPr algn="l">
+              <a:buNone/>
               <a:defRPr sz="1500" b="1">
                 <a:solidFill>
                   <a:srgbClr val="F5F8FF"/>
@@ -9215,6 +9329,7 @@
           </a:p>
           <a:p xmlns:a="http://schemas.openxmlformats.org/drawingml/2006/main">
             <a:pPr algn="l">
+              <a:buNone/>
               <a:defRPr sz="1500" b="1">
                 <a:solidFill>
                   <a:srgbClr val="F5F8FF"/>
@@ -9238,6 +9353,7 @@
           </a:p>
           <a:p xmlns:a="http://schemas.openxmlformats.org/drawingml/2006/main">
             <a:pPr algn="l">
+              <a:buNone/>
               <a:defRPr sz="1500" b="1">
                 <a:solidFill>
                   <a:srgbClr val="F5F8FF"/>
@@ -9337,6 +9453,7 @@
           <a:lstStyle xmlns:a="http://schemas.openxmlformats.org/drawingml/2006/main"/>
           <a:p xmlns:a="http://schemas.openxmlformats.org/drawingml/2006/main">
             <a:pPr algn="ctr">
+              <a:buNone/>
               <a:defRPr sz="1050" b="1">
                 <a:solidFill>
                   <a:srgbClr val="081426"/>
@@ -9394,6 +9511,7 @@
           <a:lstStyle xmlns:a="http://schemas.openxmlformats.org/drawingml/2006/main"/>
           <a:p xmlns:a="http://schemas.openxmlformats.org/drawingml/2006/main">
             <a:pPr algn="l">
+              <a:buNone/>
               <a:defRPr sz="1500" b="1">
                 <a:solidFill>
                   <a:srgbClr val="F5F8FF"/>
@@ -9417,6 +9535,7 @@
           </a:p>
           <a:p xmlns:a="http://schemas.openxmlformats.org/drawingml/2006/main">
             <a:pPr algn="l">
+              <a:buNone/>
               <a:defRPr sz="1500" b="1">
                 <a:solidFill>
                   <a:srgbClr val="F5F8FF"/>
@@ -9440,6 +9559,7 @@
           </a:p>
           <a:p xmlns:a="http://schemas.openxmlformats.org/drawingml/2006/main">
             <a:pPr algn="l">
+              <a:buNone/>
               <a:defRPr sz="1500" b="1">
                 <a:solidFill>
                   <a:srgbClr val="F5F8FF"/>
@@ -9497,6 +9617,7 @@
           <a:lstStyle xmlns:a="http://schemas.openxmlformats.org/drawingml/2006/main"/>
           <a:p xmlns:a="http://schemas.openxmlformats.org/drawingml/2006/main">
             <a:pPr algn="l">
+              <a:buNone/>
               <a:defRPr sz="1050" b="0">
                 <a:solidFill>
                   <a:srgbClr val="9FB1CA"/>
@@ -9520,6 +9641,7 @@
           </a:p>
           <a:p xmlns:a="http://schemas.openxmlformats.org/drawingml/2006/main">
             <a:pPr algn="l">
+              <a:buNone/>
               <a:defRPr sz="1050" b="0">
                 <a:solidFill>
                   <a:srgbClr val="9FB1CA"/>
@@ -9577,6 +9699,7 @@
           <a:lstStyle xmlns:a="http://schemas.openxmlformats.org/drawingml/2006/main"/>
           <a:p xmlns:a="http://schemas.openxmlformats.org/drawingml/2006/main">
             <a:pPr algn="l">
+              <a:buNone/>
               <a:defRPr sz="900" b="0">
                 <a:solidFill>
                   <a:srgbClr val="9FB1CA"/>
@@ -9595,7 +9718,7 @@
                 <a:ea typeface="Arial"/>
                 <a:cs typeface="Arial"/>
               </a:rPr>
-              <a:t>AURA • Track A • 01/10/2026</a:t>
+              <a:t>AURA • Track A • 02/10/2026</a:t>
             </a:r>
           </a:p>
         </p:txBody>
@@ -9634,6 +9757,7 @@
           <a:lstStyle xmlns:a="http://schemas.openxmlformats.org/drawingml/2006/main"/>
           <a:p xmlns:a="http://schemas.openxmlformats.org/drawingml/2006/main">
             <a:pPr algn="r">
+              <a:buNone/>
               <a:defRPr sz="975" b="1">
                 <a:solidFill>
                   <a:srgbClr val="9FB1CA"/>
@@ -9720,6 +9844,7 @@
           <a:lstStyle xmlns:a="http://schemas.openxmlformats.org/drawingml/2006/main"/>
           <a:p xmlns:a="http://schemas.openxmlformats.org/drawingml/2006/main">
             <a:pPr algn="l">
+              <a:buNone/>
               <a:defRPr sz="1350" b="1">
                 <a:solidFill>
                   <a:srgbClr val="22D3EE"/>
@@ -9777,6 +9902,7 @@
           <a:lstStyle xmlns:a="http://schemas.openxmlformats.org/drawingml/2006/main"/>
           <a:p xmlns:a="http://schemas.openxmlformats.org/drawingml/2006/main">
             <a:pPr algn="l">
+              <a:buNone/>
               <a:defRPr sz="2550" b="1">
                 <a:solidFill>
                   <a:srgbClr val="F5F8FF"/>
@@ -9834,6 +9960,7 @@
           <a:lstStyle xmlns:a="http://schemas.openxmlformats.org/drawingml/2006/main"/>
           <a:p xmlns:a="http://schemas.openxmlformats.org/drawingml/2006/main">
             <a:pPr algn="l">
+              <a:buNone/>
               <a:defRPr sz="1275" b="0">
                 <a:solidFill>
                   <a:srgbClr val="9FB1CA"/>
@@ -9964,6 +10091,7 @@
           <a:lstStyle xmlns:a="http://schemas.openxmlformats.org/drawingml/2006/main"/>
           <a:p xmlns:a="http://schemas.openxmlformats.org/drawingml/2006/main">
             <a:pPr algn="ctr">
+              <a:buNone/>
               <a:defRPr sz="1050" b="1">
                 <a:solidFill>
                   <a:srgbClr val="081426"/>
@@ -10021,6 +10149,7 @@
           <a:lstStyle xmlns:a="http://schemas.openxmlformats.org/drawingml/2006/main"/>
           <a:p xmlns:a="http://schemas.openxmlformats.org/drawingml/2006/main">
             <a:pPr algn="l">
+              <a:buNone/>
               <a:defRPr sz="1275" b="1">
                 <a:solidFill>
                   <a:srgbClr val="F5F8FF"/>
@@ -10120,6 +10249,7 @@
           <a:lstStyle xmlns:a="http://schemas.openxmlformats.org/drawingml/2006/main"/>
           <a:p xmlns:a="http://schemas.openxmlformats.org/drawingml/2006/main">
             <a:pPr algn="ctr">
+              <a:buNone/>
               <a:defRPr sz="1050" b="1">
                 <a:solidFill>
                   <a:srgbClr val="081426"/>
@@ -10177,6 +10307,7 @@
           <a:lstStyle xmlns:a="http://schemas.openxmlformats.org/drawingml/2006/main"/>
           <a:p xmlns:a="http://schemas.openxmlformats.org/drawingml/2006/main">
             <a:pPr algn="l">
+              <a:buNone/>
               <a:defRPr sz="1275" b="1">
                 <a:solidFill>
                   <a:srgbClr val="F5F8FF"/>
@@ -10276,6 +10407,7 @@
           <a:lstStyle xmlns:a="http://schemas.openxmlformats.org/drawingml/2006/main"/>
           <a:p xmlns:a="http://schemas.openxmlformats.org/drawingml/2006/main">
             <a:pPr algn="ctr">
+              <a:buNone/>
               <a:defRPr sz="1050" b="1">
                 <a:solidFill>
                   <a:srgbClr val="081426"/>
@@ -10333,6 +10465,7 @@
           <a:lstStyle xmlns:a="http://schemas.openxmlformats.org/drawingml/2006/main"/>
           <a:p xmlns:a="http://schemas.openxmlformats.org/drawingml/2006/main">
             <a:pPr algn="l">
+              <a:buNone/>
               <a:defRPr sz="1275" b="1">
                 <a:solidFill>
                   <a:srgbClr val="F5F8FF"/>
@@ -10432,6 +10565,7 @@
           <a:lstStyle xmlns:a="http://schemas.openxmlformats.org/drawingml/2006/main"/>
           <a:p xmlns:a="http://schemas.openxmlformats.org/drawingml/2006/main">
             <a:pPr algn="ctr">
+              <a:buNone/>
               <a:defRPr sz="1050" b="1">
                 <a:solidFill>
                   <a:srgbClr val="081426"/>
@@ -10489,6 +10623,7 @@
           <a:lstStyle xmlns:a="http://schemas.openxmlformats.org/drawingml/2006/main"/>
           <a:p xmlns:a="http://schemas.openxmlformats.org/drawingml/2006/main">
             <a:pPr algn="l">
+              <a:buNone/>
               <a:defRPr sz="1275" b="1">
                 <a:solidFill>
                   <a:srgbClr val="F5F8FF"/>
@@ -10588,6 +10723,7 @@
           <a:lstStyle xmlns:a="http://schemas.openxmlformats.org/drawingml/2006/main"/>
           <a:p xmlns:a="http://schemas.openxmlformats.org/drawingml/2006/main">
             <a:pPr algn="ctr">
+              <a:buNone/>
               <a:defRPr sz="1050" b="1">
                 <a:solidFill>
                   <a:srgbClr val="081426"/>
@@ -10606,7 +10742,7 @@
                 <a:ea typeface="Arial"/>
                 <a:cs typeface="Arial"/>
               </a:rPr>
-              <a:t>Ảnh mơ hồ / giả</a:t>
+              <a:t>Ảnh mơ hồ / thiếu món</a:t>
             </a:r>
           </a:p>
         </p:txBody>
@@ -10645,6 +10781,7 @@
           <a:lstStyle xmlns:a="http://schemas.openxmlformats.org/drawingml/2006/main"/>
           <a:p xmlns:a="http://schemas.openxmlformats.org/drawingml/2006/main">
             <a:pPr algn="l">
+              <a:buNone/>
               <a:defRPr sz="1275" b="1">
                 <a:solidFill>
                   <a:srgbClr val="F5F8FF"/>
@@ -10737,6 +10874,7 @@
           <a:lstStyle xmlns:a="http://schemas.openxmlformats.org/drawingml/2006/main"/>
           <a:p xmlns:a="http://schemas.openxmlformats.org/drawingml/2006/main">
             <a:pPr algn="l">
+              <a:buNone/>
               <a:defRPr sz="1125" b="1">
                 <a:solidFill>
                   <a:srgbClr val="2DD4A7"/>
@@ -10801,6 +10939,7 @@
           <a:lstStyle xmlns:a="http://schemas.openxmlformats.org/drawingml/2006/main"/>
           <a:p xmlns:a="http://schemas.openxmlformats.org/drawingml/2006/main">
             <a:pPr algn="ctr">
+              <a:buNone/>
               <a:defRPr sz="1050" b="1">
                 <a:solidFill>
                   <a:srgbClr val="081426"/>
@@ -10858,6 +10997,7 @@
           <a:lstStyle xmlns:a="http://schemas.openxmlformats.org/drawingml/2006/main"/>
           <a:p xmlns:a="http://schemas.openxmlformats.org/drawingml/2006/main">
             <a:pPr algn="l">
+              <a:buNone/>
               <a:defRPr sz="1200" b="1">
                 <a:solidFill>
                   <a:srgbClr val="F5F8FF"/>
@@ -10922,6 +11062,7 @@
           <a:lstStyle xmlns:a="http://schemas.openxmlformats.org/drawingml/2006/main"/>
           <a:p xmlns:a="http://schemas.openxmlformats.org/drawingml/2006/main">
             <a:pPr algn="ctr">
+              <a:buNone/>
               <a:defRPr sz="1050" b="1">
                 <a:solidFill>
                   <a:srgbClr val="081426"/>
@@ -10979,6 +11120,7 @@
           <a:lstStyle xmlns:a="http://schemas.openxmlformats.org/drawingml/2006/main"/>
           <a:p xmlns:a="http://schemas.openxmlformats.org/drawingml/2006/main">
             <a:pPr algn="l">
+              <a:buNone/>
               <a:defRPr sz="1200" b="1">
                 <a:solidFill>
                   <a:srgbClr val="F5F8FF"/>
@@ -11043,6 +11185,7 @@
           <a:lstStyle xmlns:a="http://schemas.openxmlformats.org/drawingml/2006/main"/>
           <a:p xmlns:a="http://schemas.openxmlformats.org/drawingml/2006/main">
             <a:pPr algn="ctr">
+              <a:buNone/>
               <a:defRPr sz="1050" b="1">
                 <a:solidFill>
                   <a:srgbClr val="081426"/>
@@ -11100,6 +11243,7 @@
           <a:lstStyle xmlns:a="http://schemas.openxmlformats.org/drawingml/2006/main"/>
           <a:p xmlns:a="http://schemas.openxmlformats.org/drawingml/2006/main">
             <a:pPr algn="l">
+              <a:buNone/>
               <a:defRPr sz="1200" b="1">
                 <a:solidFill>
                   <a:srgbClr val="F5F8FF"/>
@@ -11164,6 +11308,7 @@
           <a:lstStyle xmlns:a="http://schemas.openxmlformats.org/drawingml/2006/main"/>
           <a:p xmlns:a="http://schemas.openxmlformats.org/drawingml/2006/main">
             <a:pPr algn="ctr">
+              <a:buNone/>
               <a:defRPr sz="1050" b="1">
                 <a:solidFill>
                   <a:srgbClr val="081426"/>
@@ -11221,6 +11366,7 @@
           <a:lstStyle xmlns:a="http://schemas.openxmlformats.org/drawingml/2006/main"/>
           <a:p xmlns:a="http://schemas.openxmlformats.org/drawingml/2006/main">
             <a:pPr algn="l">
+              <a:buNone/>
               <a:defRPr sz="1200" b="1">
                 <a:solidFill>
                   <a:srgbClr val="F5F8FF"/>
@@ -11313,6 +11459,7 @@
           <a:lstStyle xmlns:a="http://schemas.openxmlformats.org/drawingml/2006/main"/>
           <a:p xmlns:a="http://schemas.openxmlformats.org/drawingml/2006/main">
             <a:pPr algn="l">
+              <a:buNone/>
               <a:defRPr sz="1125" b="1">
                 <a:solidFill>
                   <a:srgbClr val="FF6B7A"/>
@@ -11370,6 +11517,7 @@
           <a:lstStyle xmlns:a="http://schemas.openxmlformats.org/drawingml/2006/main"/>
           <a:p xmlns:a="http://schemas.openxmlformats.org/drawingml/2006/main">
             <a:pPr algn="l">
+              <a:buNone/>
               <a:defRPr sz="1275" b="1">
                 <a:solidFill>
                   <a:srgbClr val="F5F8FF"/>
@@ -11393,6 +11541,7 @@
           </a:p>
           <a:p xmlns:a="http://schemas.openxmlformats.org/drawingml/2006/main">
             <a:pPr algn="l">
+              <a:buNone/>
               <a:defRPr sz="1275" b="1">
                 <a:solidFill>
                   <a:srgbClr val="F5F8FF"/>
@@ -11416,6 +11565,7 @@
           </a:p>
           <a:p xmlns:a="http://schemas.openxmlformats.org/drawingml/2006/main">
             <a:pPr algn="l">
+              <a:buNone/>
               <a:defRPr sz="1275" b="1">
                 <a:solidFill>
                   <a:srgbClr val="F5F8FF"/>
@@ -11473,6 +11623,7 @@
           <a:lstStyle xmlns:a="http://schemas.openxmlformats.org/drawingml/2006/main"/>
           <a:p xmlns:a="http://schemas.openxmlformats.org/drawingml/2006/main">
             <a:pPr algn="ctr">
+              <a:buNone/>
               <a:defRPr sz="1050" b="1">
                 <a:solidFill>
                   <a:srgbClr val="F8C14C"/>
@@ -11530,6 +11681,7 @@
           <a:lstStyle xmlns:a="http://schemas.openxmlformats.org/drawingml/2006/main"/>
           <a:p xmlns:a="http://schemas.openxmlformats.org/drawingml/2006/main">
             <a:pPr algn="l">
+              <a:buNone/>
               <a:defRPr sz="900" b="0">
                 <a:solidFill>
                   <a:srgbClr val="9FB1CA"/>
@@ -11587,6 +11739,7 @@
           <a:lstStyle xmlns:a="http://schemas.openxmlformats.org/drawingml/2006/main"/>
           <a:p xmlns:a="http://schemas.openxmlformats.org/drawingml/2006/main">
             <a:pPr algn="r">
+              <a:buNone/>
               <a:defRPr sz="975" b="1">
                 <a:solidFill>
                   <a:srgbClr val="9FB1CA"/>

</xml_diff>

<commit_message>
docs: close live workflow validation evidence
</commit_message>
<xml_diff>
--- a/AURA/submission/AURA_5_SLIDES.pptx
+++ b/AURA/submission/AURA_5_SLIDES.pptx
@@ -2,17 +2,17 @@
 <file path=ppt/presentation.xml><?xml version="1.0" encoding="utf-8"?>
 <p:presentation xmlns:p="http://schemas.openxmlformats.org/presentationml/2006/main">
   <p:sldMasterIdLst>
-    <p:sldMasterId xmlns:r="http://schemas.openxmlformats.org/officeDocument/2006/relationships" id="2147483648" r:id="Rd6996ee539084628"/>
+    <p:sldMasterId xmlns:r="http://schemas.openxmlformats.org/officeDocument/2006/relationships" id="2147483648" r:id="Rc61e1d52569248da"/>
   </p:sldMasterIdLst>
   <p:notesMasterIdLst>
-    <p:notesMasterId xmlns:r="http://schemas.openxmlformats.org/officeDocument/2006/relationships" r:id="Rcc67117d70f14d39"/>
+    <p:notesMasterId xmlns:r="http://schemas.openxmlformats.org/officeDocument/2006/relationships" r:id="R35424368232f49c6"/>
   </p:notesMasterIdLst>
   <p:sldIdLst>
-    <p:sldId xmlns:r="http://schemas.openxmlformats.org/officeDocument/2006/relationships" id="256" r:id="R3fd11b9d6dc440dd"/>
-    <p:sldId xmlns:r="http://schemas.openxmlformats.org/officeDocument/2006/relationships" id="257" r:id="R9343623ee420440b"/>
-    <p:sldId xmlns:r="http://schemas.openxmlformats.org/officeDocument/2006/relationships" id="258" r:id="Rb138579f350b44f0"/>
-    <p:sldId xmlns:r="http://schemas.openxmlformats.org/officeDocument/2006/relationships" id="259" r:id="R592cd6f648134a12"/>
-    <p:sldId xmlns:r="http://schemas.openxmlformats.org/officeDocument/2006/relationships" id="260" r:id="R600f9eac18244536"/>
+    <p:sldId xmlns:r="http://schemas.openxmlformats.org/officeDocument/2006/relationships" id="256" r:id="R8c190628d8ba439d"/>
+    <p:sldId xmlns:r="http://schemas.openxmlformats.org/officeDocument/2006/relationships" id="257" r:id="R92620e8d34bb40e5"/>
+    <p:sldId xmlns:r="http://schemas.openxmlformats.org/officeDocument/2006/relationships" id="258" r:id="R9fbe8dee174548b8"/>
+    <p:sldId xmlns:r="http://schemas.openxmlformats.org/officeDocument/2006/relationships" id="259" r:id="R9aee3d8ad0b94b51"/>
+    <p:sldId xmlns:r="http://schemas.openxmlformats.org/officeDocument/2006/relationships" id="260" r:id="R61b1076e48a64b81"/>
   </p:sldIdLst>
   <p:sldSz cx="12192000" cy="6858000"/>
   <p:notesSz cx="6858000" cy="9144000"/>
@@ -586,7 +586,7 @@
           <a:lstStyle xmlns:a="http://schemas.openxmlformats.org/drawingml/2006/main"/>
           <a:p xmlns:a="http://schemas.openxmlformats.org/drawingml/2006/main">
             <a:r>
-              <a:t>Nguồn cập nhật 06/10/2026: source hậu holdout đạt 122/122 test offline. Live c382ce7 đạt health 5/5, security negative và Verify 5/5; bản vá hiển thị Audit UTC+7 còn cần publish lại. Official holdout thật một lượt: raw 10/15, adjusted 11/15 do một nhãn người sai, một missed escalation và không có system error. Đây là mẫu nhỏ, không phải accuracy production; ba user session vẫn là gate.</a:t>
+              <a:t>Nguồn cập nhật 06/10/2026: source hậu holdout đạt 122/122 test offline. Live c382ce7 đạt health 5/5, security negative, Verify 5/5 và workflow fixture 2/2; bản vá hiển thị Audit UTC+7 còn cần publish lại. Official holdout thật một lượt: raw 10/15, adjusted 11/15 do một nhãn người sai, một missed escalation và không có system error. Đây là mẫu nhỏ, không phải accuracy production; ba user session vẫn là gate.</a:t>
             </a:r>
           </a:p>
         </p:txBody>
@@ -794,7 +794,7 @@
   </p:cSld>
   <p:clrMap bg1="lt1" tx1="dk1" bg2="lt2" tx2="dk2" accent1="accent1" accent2="accent2" accent3="accent3" accent4="accent4" accent5="accent5" accent6="accent6" hlink="hlink" folHlink="folHlink"/>
   <p:sldLayoutIdLst>
-    <p:sldLayoutId xmlns:r="http://schemas.openxmlformats.org/officeDocument/2006/relationships" id="2147483649" r:id="Rd09e0a86120f4c38"/>
+    <p:sldLayoutId xmlns:r="http://schemas.openxmlformats.org/officeDocument/2006/relationships" id="2147483649" r:id="R9832fe8c32b34cd0"/>
   </p:sldLayoutIdLst>
   <p:txStyles>
     <p:titleStyle>
@@ -1345,7 +1345,7 @@
           <p:cNvPr id="47" name="">
             <a:extLst xmlns:a="http://schemas.openxmlformats.org/drawingml/2006/main">
               <a:ext uri="{FF2B5EF4-FFF2-40B4-BE49-F238E27FC236}">
-                <a16:creationId xmlns:a16="http://schemas.microsoft.com/office/drawing/2014/main" id="{052E3C3A-8591-4808-B9E9-3C1BC32C5BED}"/>
+                <a16:creationId xmlns:a16="http://schemas.microsoft.com/office/drawing/2014/main" id="{9E827A72-B6D0-4EF9-8AD6-C5FDBDB8B5A1}"/>
               </a:ext>
             </a:extLst>
           </p:cNvPr>
@@ -1402,7 +1402,7 @@
           <p:cNvPr id="2" name="">
             <a:extLst xmlns:a="http://schemas.openxmlformats.org/drawingml/2006/main">
               <a:ext uri="{FF2B5EF4-FFF2-40B4-BE49-F238E27FC236}">
-                <a16:creationId xmlns:a16="http://schemas.microsoft.com/office/drawing/2014/main" id="{E0A4FBF1-969C-45AC-A922-A5F12B3BD3CB}"/>
+                <a16:creationId xmlns:a16="http://schemas.microsoft.com/office/drawing/2014/main" id="{0CBB6C24-7F5D-426D-89EA-2705DBA9F856}"/>
               </a:ext>
             </a:extLst>
           </p:cNvPr>
@@ -1459,7 +1459,7 @@
           <p:cNvPr id="3" name="">
             <a:extLst xmlns:a="http://schemas.openxmlformats.org/drawingml/2006/main">
               <a:ext uri="{FF2B5EF4-FFF2-40B4-BE49-F238E27FC236}">
-                <a16:creationId xmlns:a16="http://schemas.microsoft.com/office/drawing/2014/main" id="{6B03B78A-F515-4D47-B6F1-4B3522A92A36}"/>
+                <a16:creationId xmlns:a16="http://schemas.microsoft.com/office/drawing/2014/main" id="{C4124E5E-980F-4C2A-81A0-C2A67288AFF3}"/>
               </a:ext>
             </a:extLst>
           </p:cNvPr>
@@ -1516,7 +1516,7 @@
           <p:cNvPr id="4" name="">
             <a:extLst xmlns:a="http://schemas.openxmlformats.org/drawingml/2006/main">
               <a:ext uri="{FF2B5EF4-FFF2-40B4-BE49-F238E27FC236}">
-                <a16:creationId xmlns:a16="http://schemas.microsoft.com/office/drawing/2014/main" id="{66A48F25-BBB0-4310-9AA4-81F575B70599}"/>
+                <a16:creationId xmlns:a16="http://schemas.microsoft.com/office/drawing/2014/main" id="{0636315E-A163-4E9B-AB7F-422DC8BF6744}"/>
               </a:ext>
             </a:extLst>
           </p:cNvPr>
@@ -1547,7 +1547,7 @@
           <p:cNvPr id="5" name="">
             <a:extLst xmlns:a="http://schemas.openxmlformats.org/drawingml/2006/main">
               <a:ext uri="{FF2B5EF4-FFF2-40B4-BE49-F238E27FC236}">
-                <a16:creationId xmlns:a16="http://schemas.microsoft.com/office/drawing/2014/main" id="{930F303C-2B43-433C-B7A7-9E742F58807D}"/>
+                <a16:creationId xmlns:a16="http://schemas.microsoft.com/office/drawing/2014/main" id="{DA7E051B-DF8E-42E1-AE07-F4C57F9E8B3C}"/>
               </a:ext>
             </a:extLst>
           </p:cNvPr>
@@ -1582,7 +1582,7 @@
           <p:cNvPr id="6" name="">
             <a:extLst xmlns:a="http://schemas.openxmlformats.org/drawingml/2006/main">
               <a:ext uri="{FF2B5EF4-FFF2-40B4-BE49-F238E27FC236}">
-                <a16:creationId xmlns:a16="http://schemas.microsoft.com/office/drawing/2014/main" id="{04DBDA73-C454-4F5A-A546-AF97129E6315}"/>
+                <a16:creationId xmlns:a16="http://schemas.microsoft.com/office/drawing/2014/main" id="{B0CD9275-95E8-4173-AF6C-086456F51669}"/>
               </a:ext>
             </a:extLst>
           </p:cNvPr>
@@ -1646,7 +1646,7 @@
           <p:cNvPr id="7" name="">
             <a:extLst xmlns:a="http://schemas.openxmlformats.org/drawingml/2006/main">
               <a:ext uri="{FF2B5EF4-FFF2-40B4-BE49-F238E27FC236}">
-                <a16:creationId xmlns:a16="http://schemas.microsoft.com/office/drawing/2014/main" id="{49B752A4-6DA8-47C6-9EB1-3A0F22868305}"/>
+                <a16:creationId xmlns:a16="http://schemas.microsoft.com/office/drawing/2014/main" id="{91D6FA51-64B3-43B0-8E52-C2945DCF7734}"/>
               </a:ext>
             </a:extLst>
           </p:cNvPr>
@@ -1703,7 +1703,7 @@
           <p:cNvPr id="8" name="">
             <a:extLst xmlns:a="http://schemas.openxmlformats.org/drawingml/2006/main">
               <a:ext uri="{FF2B5EF4-FFF2-40B4-BE49-F238E27FC236}">
-                <a16:creationId xmlns:a16="http://schemas.microsoft.com/office/drawing/2014/main" id="{62802C36-F2D2-43A9-85D4-5591A0D6BFB1}"/>
+                <a16:creationId xmlns:a16="http://schemas.microsoft.com/office/drawing/2014/main" id="{57EDBA80-53FB-4807-AAB8-44900B0DF80B}"/>
               </a:ext>
             </a:extLst>
           </p:cNvPr>
@@ -1760,7 +1760,7 @@
           <p:cNvPr id="9" name="">
             <a:extLst xmlns:a="http://schemas.openxmlformats.org/drawingml/2006/main">
               <a:ext uri="{FF2B5EF4-FFF2-40B4-BE49-F238E27FC236}">
-                <a16:creationId xmlns:a16="http://schemas.microsoft.com/office/drawing/2014/main" id="{F3EB97B0-CD9D-490F-8C44-01EBECD2772E}"/>
+                <a16:creationId xmlns:a16="http://schemas.microsoft.com/office/drawing/2014/main" id="{F9E13622-73C4-46D3-AC79-404497B355C5}"/>
               </a:ext>
             </a:extLst>
           </p:cNvPr>
@@ -1792,7 +1792,7 @@
           <p:cNvPr id="10" name="">
             <a:extLst xmlns:a="http://schemas.openxmlformats.org/drawingml/2006/main">
               <a:ext uri="{FF2B5EF4-FFF2-40B4-BE49-F238E27FC236}">
-                <a16:creationId xmlns:a16="http://schemas.microsoft.com/office/drawing/2014/main" id="{DDD73A5C-596E-4C18-9F5E-BC181E46556E}"/>
+                <a16:creationId xmlns:a16="http://schemas.microsoft.com/office/drawing/2014/main" id="{A1A30432-3D7E-412E-940C-24D4A75D4064}"/>
               </a:ext>
             </a:extLst>
           </p:cNvPr>
@@ -1827,7 +1827,7 @@
           <p:cNvPr id="11" name="">
             <a:extLst xmlns:a="http://schemas.openxmlformats.org/drawingml/2006/main">
               <a:ext uri="{FF2B5EF4-FFF2-40B4-BE49-F238E27FC236}">
-                <a16:creationId xmlns:a16="http://schemas.microsoft.com/office/drawing/2014/main" id="{588BAF73-B940-4296-B03F-A8533C91DAEA}"/>
+                <a16:creationId xmlns:a16="http://schemas.microsoft.com/office/drawing/2014/main" id="{4E494617-E16C-4218-8FA6-197DE31ED98A}"/>
               </a:ext>
             </a:extLst>
           </p:cNvPr>
@@ -1891,7 +1891,7 @@
           <p:cNvPr id="12" name="">
             <a:extLst xmlns:a="http://schemas.openxmlformats.org/drawingml/2006/main">
               <a:ext uri="{FF2B5EF4-FFF2-40B4-BE49-F238E27FC236}">
-                <a16:creationId xmlns:a16="http://schemas.microsoft.com/office/drawing/2014/main" id="{95645FBC-AEDA-4C15-9E25-BF47DFA8077F}"/>
+                <a16:creationId xmlns:a16="http://schemas.microsoft.com/office/drawing/2014/main" id="{8D7ABD5D-F83B-475C-BA84-6C3618FBF19A}"/>
               </a:ext>
             </a:extLst>
           </p:cNvPr>
@@ -1948,7 +1948,7 @@
           <p:cNvPr id="13" name="">
             <a:extLst xmlns:a="http://schemas.openxmlformats.org/drawingml/2006/main">
               <a:ext uri="{FF2B5EF4-FFF2-40B4-BE49-F238E27FC236}">
-                <a16:creationId xmlns:a16="http://schemas.microsoft.com/office/drawing/2014/main" id="{77D7C1B6-9109-45EA-A4FA-159104E49D5B}"/>
+                <a16:creationId xmlns:a16="http://schemas.microsoft.com/office/drawing/2014/main" id="{91696DFD-9FB0-4AB5-B70E-8346DDF56D81}"/>
               </a:ext>
             </a:extLst>
           </p:cNvPr>
@@ -2005,7 +2005,7 @@
           <p:cNvPr id="14" name="">
             <a:extLst xmlns:a="http://schemas.openxmlformats.org/drawingml/2006/main">
               <a:ext uri="{FF2B5EF4-FFF2-40B4-BE49-F238E27FC236}">
-                <a16:creationId xmlns:a16="http://schemas.microsoft.com/office/drawing/2014/main" id="{2C385F8A-1CD3-4434-8208-D7F862679BF8}"/>
+                <a16:creationId xmlns:a16="http://schemas.microsoft.com/office/drawing/2014/main" id="{064B2626-999E-4DDE-BAE9-D69944E697CE}"/>
               </a:ext>
             </a:extLst>
           </p:cNvPr>
@@ -2037,7 +2037,7 @@
           <p:cNvPr id="15" name="">
             <a:extLst xmlns:a="http://schemas.openxmlformats.org/drawingml/2006/main">
               <a:ext uri="{FF2B5EF4-FFF2-40B4-BE49-F238E27FC236}">
-                <a16:creationId xmlns:a16="http://schemas.microsoft.com/office/drawing/2014/main" id="{8644FBDB-7242-4172-B70E-8BFC446D8FD4}"/>
+                <a16:creationId xmlns:a16="http://schemas.microsoft.com/office/drawing/2014/main" id="{BA319F7B-303E-42ED-BAE4-6346DBB057D7}"/>
               </a:ext>
             </a:extLst>
           </p:cNvPr>
@@ -2072,7 +2072,7 @@
           <p:cNvPr id="16" name="">
             <a:extLst xmlns:a="http://schemas.openxmlformats.org/drawingml/2006/main">
               <a:ext uri="{FF2B5EF4-FFF2-40B4-BE49-F238E27FC236}">
-                <a16:creationId xmlns:a16="http://schemas.microsoft.com/office/drawing/2014/main" id="{7B364CCD-8C94-4B79-8917-D0521386C097}"/>
+                <a16:creationId xmlns:a16="http://schemas.microsoft.com/office/drawing/2014/main" id="{30FB3456-304F-4561-96F5-E6E819C5B422}"/>
               </a:ext>
             </a:extLst>
           </p:cNvPr>
@@ -2136,7 +2136,7 @@
           <p:cNvPr id="17" name="">
             <a:extLst xmlns:a="http://schemas.openxmlformats.org/drawingml/2006/main">
               <a:ext uri="{FF2B5EF4-FFF2-40B4-BE49-F238E27FC236}">
-                <a16:creationId xmlns:a16="http://schemas.microsoft.com/office/drawing/2014/main" id="{FD2C4F52-3BE9-469B-9F04-69757CF4C9ED}"/>
+                <a16:creationId xmlns:a16="http://schemas.microsoft.com/office/drawing/2014/main" id="{40870048-AA13-4FA3-BB83-AEF13C9C304E}"/>
               </a:ext>
             </a:extLst>
           </p:cNvPr>
@@ -2193,7 +2193,7 @@
           <p:cNvPr id="18" name="">
             <a:extLst xmlns:a="http://schemas.openxmlformats.org/drawingml/2006/main">
               <a:ext uri="{FF2B5EF4-FFF2-40B4-BE49-F238E27FC236}">
-                <a16:creationId xmlns:a16="http://schemas.microsoft.com/office/drawing/2014/main" id="{91416AE9-F88F-490E-A475-19B629A968E2}"/>
+                <a16:creationId xmlns:a16="http://schemas.microsoft.com/office/drawing/2014/main" id="{CB4D5C7D-0B38-4151-B315-6901DC9F11DF}"/>
               </a:ext>
             </a:extLst>
           </p:cNvPr>
@@ -2250,7 +2250,7 @@
           <p:cNvPr id="19" name="">
             <a:extLst xmlns:a="http://schemas.openxmlformats.org/drawingml/2006/main">
               <a:ext uri="{FF2B5EF4-FFF2-40B4-BE49-F238E27FC236}">
-                <a16:creationId xmlns:a16="http://schemas.microsoft.com/office/drawing/2014/main" id="{7BBB6E9B-4615-4561-BA48-98C5FF9184EB}"/>
+                <a16:creationId xmlns:a16="http://schemas.microsoft.com/office/drawing/2014/main" id="{8A48CD23-D73B-4EB8-8A96-4144566AEDAF}"/>
               </a:ext>
             </a:extLst>
           </p:cNvPr>
@@ -2282,7 +2282,7 @@
           <p:cNvPr id="20" name="">
             <a:extLst xmlns:a="http://schemas.openxmlformats.org/drawingml/2006/main">
               <a:ext uri="{FF2B5EF4-FFF2-40B4-BE49-F238E27FC236}">
-                <a16:creationId xmlns:a16="http://schemas.microsoft.com/office/drawing/2014/main" id="{DCAE4CA6-1CB9-4482-958C-1DE83A54E627}"/>
+                <a16:creationId xmlns:a16="http://schemas.microsoft.com/office/drawing/2014/main" id="{47A7BA69-49C0-441F-951B-E55CF5E11AD6}"/>
               </a:ext>
             </a:extLst>
           </p:cNvPr>
@@ -2317,7 +2317,7 @@
           <p:cNvPr id="21" name="">
             <a:extLst xmlns:a="http://schemas.openxmlformats.org/drawingml/2006/main">
               <a:ext uri="{FF2B5EF4-FFF2-40B4-BE49-F238E27FC236}">
-                <a16:creationId xmlns:a16="http://schemas.microsoft.com/office/drawing/2014/main" id="{7E082F04-EC88-48DE-A9E9-5E235BD5EEA1}"/>
+                <a16:creationId xmlns:a16="http://schemas.microsoft.com/office/drawing/2014/main" id="{6D5CE2D5-D37E-4698-862D-5D8B565D51C1}"/>
               </a:ext>
             </a:extLst>
           </p:cNvPr>
@@ -2381,7 +2381,7 @@
           <p:cNvPr id="22" name="">
             <a:extLst xmlns:a="http://schemas.openxmlformats.org/drawingml/2006/main">
               <a:ext uri="{FF2B5EF4-FFF2-40B4-BE49-F238E27FC236}">
-                <a16:creationId xmlns:a16="http://schemas.microsoft.com/office/drawing/2014/main" id="{BC8B905B-24A7-49F3-8344-47E2DD9DAEEE}"/>
+                <a16:creationId xmlns:a16="http://schemas.microsoft.com/office/drawing/2014/main" id="{CC79F104-0031-4820-B997-24F9144B7667}"/>
               </a:ext>
             </a:extLst>
           </p:cNvPr>
@@ -2438,7 +2438,7 @@
           <p:cNvPr id="23" name="">
             <a:extLst xmlns:a="http://schemas.openxmlformats.org/drawingml/2006/main">
               <a:ext uri="{FF2B5EF4-FFF2-40B4-BE49-F238E27FC236}">
-                <a16:creationId xmlns:a16="http://schemas.microsoft.com/office/drawing/2014/main" id="{0D8CCC0F-941A-497B-A077-6F8227122A0F}"/>
+                <a16:creationId xmlns:a16="http://schemas.microsoft.com/office/drawing/2014/main" id="{BB6A9C02-BD5B-406B-8037-03668D8B16DA}"/>
               </a:ext>
             </a:extLst>
           </p:cNvPr>
@@ -2495,7 +2495,7 @@
           <p:cNvPr id="24" name="">
             <a:extLst xmlns:a="http://schemas.openxmlformats.org/drawingml/2006/main">
               <a:ext uri="{FF2B5EF4-FFF2-40B4-BE49-F238E27FC236}">
-                <a16:creationId xmlns:a16="http://schemas.microsoft.com/office/drawing/2014/main" id="{32BAC999-F883-4408-BA2F-70B2A5C2E1EE}"/>
+                <a16:creationId xmlns:a16="http://schemas.microsoft.com/office/drawing/2014/main" id="{5AB77F0A-3479-42F3-B2FB-C52F08ECA5F1}"/>
               </a:ext>
             </a:extLst>
           </p:cNvPr>
@@ -2527,7 +2527,7 @@
           <p:cNvPr id="25" name="">
             <a:extLst xmlns:a="http://schemas.openxmlformats.org/drawingml/2006/main">
               <a:ext uri="{FF2B5EF4-FFF2-40B4-BE49-F238E27FC236}">
-                <a16:creationId xmlns:a16="http://schemas.microsoft.com/office/drawing/2014/main" id="{A97ACCBD-C813-4D32-86C7-C5A09D5460B9}"/>
+                <a16:creationId xmlns:a16="http://schemas.microsoft.com/office/drawing/2014/main" id="{748CAEC1-DEB2-494F-89E0-277E54BC9D5B}"/>
               </a:ext>
             </a:extLst>
           </p:cNvPr>
@@ -2562,7 +2562,7 @@
           <p:cNvPr id="26" name="">
             <a:extLst xmlns:a="http://schemas.openxmlformats.org/drawingml/2006/main">
               <a:ext uri="{FF2B5EF4-FFF2-40B4-BE49-F238E27FC236}">
-                <a16:creationId xmlns:a16="http://schemas.microsoft.com/office/drawing/2014/main" id="{96131857-397C-449D-81C3-6467DD26FD54}"/>
+                <a16:creationId xmlns:a16="http://schemas.microsoft.com/office/drawing/2014/main" id="{A8F0B3F8-BE61-4F12-AA69-6F2013E666E5}"/>
               </a:ext>
             </a:extLst>
           </p:cNvPr>
@@ -2626,7 +2626,7 @@
           <p:cNvPr id="27" name="">
             <a:extLst xmlns:a="http://schemas.openxmlformats.org/drawingml/2006/main">
               <a:ext uri="{FF2B5EF4-FFF2-40B4-BE49-F238E27FC236}">
-                <a16:creationId xmlns:a16="http://schemas.microsoft.com/office/drawing/2014/main" id="{0515CE89-E58A-4D16-95FC-805B74A55FD7}"/>
+                <a16:creationId xmlns:a16="http://schemas.microsoft.com/office/drawing/2014/main" id="{0E66BBF0-BBB9-4E54-899F-A76A4CA94C57}"/>
               </a:ext>
             </a:extLst>
           </p:cNvPr>
@@ -2683,7 +2683,7 @@
           <p:cNvPr id="28" name="">
             <a:extLst xmlns:a="http://schemas.openxmlformats.org/drawingml/2006/main">
               <a:ext uri="{FF2B5EF4-FFF2-40B4-BE49-F238E27FC236}">
-                <a16:creationId xmlns:a16="http://schemas.microsoft.com/office/drawing/2014/main" id="{CE58015A-F58D-41B4-B71F-A0786CA4C847}"/>
+                <a16:creationId xmlns:a16="http://schemas.microsoft.com/office/drawing/2014/main" id="{19608202-C4C2-46C4-A5E4-9A8A3ADC3E2E}"/>
               </a:ext>
             </a:extLst>
           </p:cNvPr>
@@ -2740,7 +2740,7 @@
           <p:cNvPr id="29" name="">
             <a:extLst xmlns:a="http://schemas.openxmlformats.org/drawingml/2006/main">
               <a:ext uri="{FF2B5EF4-FFF2-40B4-BE49-F238E27FC236}">
-                <a16:creationId xmlns:a16="http://schemas.microsoft.com/office/drawing/2014/main" id="{D39BE24C-6237-48B1-A87B-A478DF519528}"/>
+                <a16:creationId xmlns:a16="http://schemas.microsoft.com/office/drawing/2014/main" id="{B5653293-E070-4821-9016-F3EDFEB77C59}"/>
               </a:ext>
             </a:extLst>
           </p:cNvPr>
@@ -2775,7 +2775,7 @@
           <p:cNvPr id="30" name="">
             <a:extLst xmlns:a="http://schemas.openxmlformats.org/drawingml/2006/main">
               <a:ext uri="{FF2B5EF4-FFF2-40B4-BE49-F238E27FC236}">
-                <a16:creationId xmlns:a16="http://schemas.microsoft.com/office/drawing/2014/main" id="{DC5BC77B-7AD1-43B9-845E-9E4E6AF49A98}"/>
+                <a16:creationId xmlns:a16="http://schemas.microsoft.com/office/drawing/2014/main" id="{62CAFA38-2B7F-47B0-B368-E1F650C5E3DC}"/>
               </a:ext>
             </a:extLst>
           </p:cNvPr>
@@ -2832,7 +2832,7 @@
           <p:cNvPr id="31" name="">
             <a:extLst xmlns:a="http://schemas.openxmlformats.org/drawingml/2006/main">
               <a:ext uri="{FF2B5EF4-FFF2-40B4-BE49-F238E27FC236}">
-                <a16:creationId xmlns:a16="http://schemas.microsoft.com/office/drawing/2014/main" id="{991011AE-5178-43B0-AA73-D95AD7147E2C}"/>
+                <a16:creationId xmlns:a16="http://schemas.microsoft.com/office/drawing/2014/main" id="{823B59C4-9948-4D21-BE2A-3FAC9668B59B}"/>
               </a:ext>
             </a:extLst>
           </p:cNvPr>
@@ -2889,7 +2889,7 @@
           <p:cNvPr id="32" name="">
             <a:extLst xmlns:a="http://schemas.openxmlformats.org/drawingml/2006/main">
               <a:ext uri="{FF2B5EF4-FFF2-40B4-BE49-F238E27FC236}">
-                <a16:creationId xmlns:a16="http://schemas.microsoft.com/office/drawing/2014/main" id="{48EE81CC-08E9-4CCA-83F5-3F7E364E2A38}"/>
+                <a16:creationId xmlns:a16="http://schemas.microsoft.com/office/drawing/2014/main" id="{303EC212-D3C2-4100-8425-91462825697E}"/>
               </a:ext>
             </a:extLst>
           </p:cNvPr>
@@ -2946,7 +2946,7 @@
           <p:cNvPr id="33" name="">
             <a:extLst xmlns:a="http://schemas.openxmlformats.org/drawingml/2006/main">
               <a:ext uri="{FF2B5EF4-FFF2-40B4-BE49-F238E27FC236}">
-                <a16:creationId xmlns:a16="http://schemas.microsoft.com/office/drawing/2014/main" id="{3A17A8B2-B138-4A02-9992-905DAC1EB262}"/>
+                <a16:creationId xmlns:a16="http://schemas.microsoft.com/office/drawing/2014/main" id="{BDD0D773-1B0B-4877-A5DD-298CBD5C18A0}"/>
               </a:ext>
             </a:extLst>
           </p:cNvPr>
@@ -2981,7 +2981,7 @@
           <p:cNvPr id="34" name="">
             <a:extLst xmlns:a="http://schemas.openxmlformats.org/drawingml/2006/main">
               <a:ext uri="{FF2B5EF4-FFF2-40B4-BE49-F238E27FC236}">
-                <a16:creationId xmlns:a16="http://schemas.microsoft.com/office/drawing/2014/main" id="{8FECC157-F8A5-48EE-BEFD-578FC54E496A}"/>
+                <a16:creationId xmlns:a16="http://schemas.microsoft.com/office/drawing/2014/main" id="{D91E4A47-D6FE-452A-9859-6635F3319F3E}"/>
               </a:ext>
             </a:extLst>
           </p:cNvPr>
@@ -3045,7 +3045,7 @@
           <p:cNvPr id="35" name="">
             <a:extLst xmlns:a="http://schemas.openxmlformats.org/drawingml/2006/main">
               <a:ext uri="{FF2B5EF4-FFF2-40B4-BE49-F238E27FC236}">
-                <a16:creationId xmlns:a16="http://schemas.microsoft.com/office/drawing/2014/main" id="{8E381A0E-3293-46C7-B159-D41AFF7BB34C}"/>
+                <a16:creationId xmlns:a16="http://schemas.microsoft.com/office/drawing/2014/main" id="{32C91EA6-75CB-47AB-92D7-AE91633A70A6}"/>
               </a:ext>
             </a:extLst>
           </p:cNvPr>
@@ -3102,7 +3102,7 @@
           <p:cNvPr id="36" name="">
             <a:extLst xmlns:a="http://schemas.openxmlformats.org/drawingml/2006/main">
               <a:ext uri="{FF2B5EF4-FFF2-40B4-BE49-F238E27FC236}">
-                <a16:creationId xmlns:a16="http://schemas.microsoft.com/office/drawing/2014/main" id="{D614EFB2-5468-4432-9D5E-BBA65A9112F8}"/>
+                <a16:creationId xmlns:a16="http://schemas.microsoft.com/office/drawing/2014/main" id="{69001A6F-E35F-4263-AC5E-D9C8D3FBD37D}"/>
               </a:ext>
             </a:extLst>
           </p:cNvPr>
@@ -3159,7 +3159,7 @@
           <p:cNvPr id="37" name="">
             <a:extLst xmlns:a="http://schemas.openxmlformats.org/drawingml/2006/main">
               <a:ext uri="{FF2B5EF4-FFF2-40B4-BE49-F238E27FC236}">
-                <a16:creationId xmlns:a16="http://schemas.microsoft.com/office/drawing/2014/main" id="{1F66E2AC-F338-45F9-A14B-E4A033F48F55}"/>
+                <a16:creationId xmlns:a16="http://schemas.microsoft.com/office/drawing/2014/main" id="{C62ADEDC-73EB-4013-81D0-06F1492B8E23}"/>
               </a:ext>
             </a:extLst>
           </p:cNvPr>
@@ -3194,7 +3194,7 @@
           <p:cNvPr id="38" name="">
             <a:extLst xmlns:a="http://schemas.openxmlformats.org/drawingml/2006/main">
               <a:ext uri="{FF2B5EF4-FFF2-40B4-BE49-F238E27FC236}">
-                <a16:creationId xmlns:a16="http://schemas.microsoft.com/office/drawing/2014/main" id="{AB920CB1-EF02-46BE-B157-B2C1281E4B9E}"/>
+                <a16:creationId xmlns:a16="http://schemas.microsoft.com/office/drawing/2014/main" id="{0F54605A-2C50-4E21-8617-7544F893093C}"/>
               </a:ext>
             </a:extLst>
           </p:cNvPr>
@@ -3258,7 +3258,7 @@
           <p:cNvPr id="39" name="">
             <a:extLst xmlns:a="http://schemas.openxmlformats.org/drawingml/2006/main">
               <a:ext uri="{FF2B5EF4-FFF2-40B4-BE49-F238E27FC236}">
-                <a16:creationId xmlns:a16="http://schemas.microsoft.com/office/drawing/2014/main" id="{B695EB4B-859D-4692-9F8C-54290318C021}"/>
+                <a16:creationId xmlns:a16="http://schemas.microsoft.com/office/drawing/2014/main" id="{7A80B913-464F-4082-88DF-CA2266262304}"/>
               </a:ext>
             </a:extLst>
           </p:cNvPr>
@@ -3315,7 +3315,7 @@
           <p:cNvPr id="40" name="">
             <a:extLst xmlns:a="http://schemas.openxmlformats.org/drawingml/2006/main">
               <a:ext uri="{FF2B5EF4-FFF2-40B4-BE49-F238E27FC236}">
-                <a16:creationId xmlns:a16="http://schemas.microsoft.com/office/drawing/2014/main" id="{276402CC-5B7A-484C-9FC8-402B09D328DF}"/>
+                <a16:creationId xmlns:a16="http://schemas.microsoft.com/office/drawing/2014/main" id="{4CA6D8FB-D692-4865-9AE9-393423B2977C}"/>
               </a:ext>
             </a:extLst>
           </p:cNvPr>
@@ -3372,7 +3372,7 @@
           <p:cNvPr id="41" name="">
             <a:extLst xmlns:a="http://schemas.openxmlformats.org/drawingml/2006/main">
               <a:ext uri="{FF2B5EF4-FFF2-40B4-BE49-F238E27FC236}">
-                <a16:creationId xmlns:a16="http://schemas.microsoft.com/office/drawing/2014/main" id="{6CA72441-918F-4B5F-B74A-383FD4F803EE}"/>
+                <a16:creationId xmlns:a16="http://schemas.microsoft.com/office/drawing/2014/main" id="{3A8A396F-5F5D-4665-A6EE-03AEFEE33444}"/>
               </a:ext>
             </a:extLst>
           </p:cNvPr>
@@ -3407,7 +3407,7 @@
           <p:cNvPr id="42" name="">
             <a:extLst xmlns:a="http://schemas.openxmlformats.org/drawingml/2006/main">
               <a:ext uri="{FF2B5EF4-FFF2-40B4-BE49-F238E27FC236}">
-                <a16:creationId xmlns:a16="http://schemas.microsoft.com/office/drawing/2014/main" id="{9F5F795F-FC81-4416-B33E-C27A4AC4689A}"/>
+                <a16:creationId xmlns:a16="http://schemas.microsoft.com/office/drawing/2014/main" id="{407BF8CD-9F35-4737-A53D-FC2242D35F0A}"/>
               </a:ext>
             </a:extLst>
           </p:cNvPr>
@@ -3471,7 +3471,7 @@
           <p:cNvPr id="43" name="">
             <a:extLst xmlns:a="http://schemas.openxmlformats.org/drawingml/2006/main">
               <a:ext uri="{FF2B5EF4-FFF2-40B4-BE49-F238E27FC236}">
-                <a16:creationId xmlns:a16="http://schemas.microsoft.com/office/drawing/2014/main" id="{C3B03CE2-5FD1-484F-919F-CEC399BD1E3D}"/>
+                <a16:creationId xmlns:a16="http://schemas.microsoft.com/office/drawing/2014/main" id="{F194F832-C365-4340-AE38-A9D9BFF12AAC}"/>
               </a:ext>
             </a:extLst>
           </p:cNvPr>
@@ -3528,7 +3528,7 @@
           <p:cNvPr id="44" name="">
             <a:extLst xmlns:a="http://schemas.openxmlformats.org/drawingml/2006/main">
               <a:ext uri="{FF2B5EF4-FFF2-40B4-BE49-F238E27FC236}">
-                <a16:creationId xmlns:a16="http://schemas.microsoft.com/office/drawing/2014/main" id="{68D141F9-213C-46ED-AB54-068566A09A86}"/>
+                <a16:creationId xmlns:a16="http://schemas.microsoft.com/office/drawing/2014/main" id="{E00E998A-A522-4B8D-A4B8-3121801E9E1E}"/>
               </a:ext>
             </a:extLst>
           </p:cNvPr>
@@ -3585,7 +3585,7 @@
           <p:cNvPr id="45" name="">
             <a:extLst xmlns:a="http://schemas.openxmlformats.org/drawingml/2006/main">
               <a:ext uri="{FF2B5EF4-FFF2-40B4-BE49-F238E27FC236}">
-                <a16:creationId xmlns:a16="http://schemas.microsoft.com/office/drawing/2014/main" id="{B388B3CC-DD1C-4259-B0A8-67DA00B8F00F}"/>
+                <a16:creationId xmlns:a16="http://schemas.microsoft.com/office/drawing/2014/main" id="{F8176400-CDB4-44CE-B785-8B6D27C18399}"/>
               </a:ext>
             </a:extLst>
           </p:cNvPr>
@@ -3642,7 +3642,7 @@
           <p:cNvPr id="46" name="">
             <a:extLst xmlns:a="http://schemas.openxmlformats.org/drawingml/2006/main">
               <a:ext uri="{FF2B5EF4-FFF2-40B4-BE49-F238E27FC236}">
-                <a16:creationId xmlns:a16="http://schemas.microsoft.com/office/drawing/2014/main" id="{2E324A95-1637-415F-B42A-03E7EEC81CE9}"/>
+                <a16:creationId xmlns:a16="http://schemas.microsoft.com/office/drawing/2014/main" id="{C80B5297-CA6F-4941-A6BA-0F6AD7C92321}"/>
               </a:ext>
             </a:extLst>
           </p:cNvPr>
@@ -3697,7 +3697,7 @@
     </p:spTree>
     <p:extLst>
       <p:ext uri="{BB962C8B-B14F-4D97-AF65-F5344CB8AC3E}">
-        <p14:creationId xmlns:p14="http://schemas.microsoft.com/office/powerpoint/2010/main" val="571390085"/>
+        <p14:creationId xmlns:p14="http://schemas.microsoft.com/office/powerpoint/2010/main" val="2117967631"/>
       </p:ext>
     </p:extLst>
   </p:cSld>
@@ -3728,7 +3728,7 @@
           <p:cNvPr id="46" name="">
             <a:extLst xmlns:a="http://schemas.openxmlformats.org/drawingml/2006/main">
               <a:ext uri="{FF2B5EF4-FFF2-40B4-BE49-F238E27FC236}">
-                <a16:creationId xmlns:a16="http://schemas.microsoft.com/office/drawing/2014/main" id="{B677882C-2E65-4CCC-8D28-CAE4DECE60D0}"/>
+                <a16:creationId xmlns:a16="http://schemas.microsoft.com/office/drawing/2014/main" id="{4F2E62F4-9281-497B-A567-FA00AE0D2C30}"/>
               </a:ext>
             </a:extLst>
           </p:cNvPr>
@@ -3785,7 +3785,7 @@
           <p:cNvPr id="2" name="">
             <a:extLst xmlns:a="http://schemas.openxmlformats.org/drawingml/2006/main">
               <a:ext uri="{FF2B5EF4-FFF2-40B4-BE49-F238E27FC236}">
-                <a16:creationId xmlns:a16="http://schemas.microsoft.com/office/drawing/2014/main" id="{C0CBCF4B-4BCC-47C5-9677-31409A0247C2}"/>
+                <a16:creationId xmlns:a16="http://schemas.microsoft.com/office/drawing/2014/main" id="{9788B822-AD6B-4116-A1FF-58AF91A95477}"/>
               </a:ext>
             </a:extLst>
           </p:cNvPr>
@@ -3842,7 +3842,7 @@
           <p:cNvPr id="3" name="">
             <a:extLst xmlns:a="http://schemas.openxmlformats.org/drawingml/2006/main">
               <a:ext uri="{FF2B5EF4-FFF2-40B4-BE49-F238E27FC236}">
-                <a16:creationId xmlns:a16="http://schemas.microsoft.com/office/drawing/2014/main" id="{57CF3F30-2A40-4852-8AB5-9C7DA4D3F94E}"/>
+                <a16:creationId xmlns:a16="http://schemas.microsoft.com/office/drawing/2014/main" id="{6FAB5BD0-A0BC-4AF8-B2D6-CA6822E26DA3}"/>
               </a:ext>
             </a:extLst>
           </p:cNvPr>
@@ -3899,7 +3899,7 @@
           <p:cNvPr id="4" name="">
             <a:extLst xmlns:a="http://schemas.openxmlformats.org/drawingml/2006/main">
               <a:ext uri="{FF2B5EF4-FFF2-40B4-BE49-F238E27FC236}">
-                <a16:creationId xmlns:a16="http://schemas.microsoft.com/office/drawing/2014/main" id="{8AF91405-AFA5-44CE-90A0-1C107E6899FB}"/>
+                <a16:creationId xmlns:a16="http://schemas.microsoft.com/office/drawing/2014/main" id="{8481C445-F362-41AB-A12B-893D7E5A3A98}"/>
               </a:ext>
             </a:extLst>
           </p:cNvPr>
@@ -3930,7 +3930,7 @@
           <p:cNvPr id="5" name="">
             <a:extLst xmlns:a="http://schemas.openxmlformats.org/drawingml/2006/main">
               <a:ext uri="{FF2B5EF4-FFF2-40B4-BE49-F238E27FC236}">
-                <a16:creationId xmlns:a16="http://schemas.microsoft.com/office/drawing/2014/main" id="{30341626-460E-4CE7-8F5F-AF9FD35135CA}"/>
+                <a16:creationId xmlns:a16="http://schemas.microsoft.com/office/drawing/2014/main" id="{087A90FD-484C-42BC-8D12-D92D78CB9DFB}"/>
               </a:ext>
             </a:extLst>
           </p:cNvPr>
@@ -3965,7 +3965,7 @@
           <p:cNvPr id="6" name="">
             <a:extLst xmlns:a="http://schemas.openxmlformats.org/drawingml/2006/main">
               <a:ext uri="{FF2B5EF4-FFF2-40B4-BE49-F238E27FC236}">
-                <a16:creationId xmlns:a16="http://schemas.microsoft.com/office/drawing/2014/main" id="{B1C08F06-3610-43D4-8739-F5762C2F58E9}"/>
+                <a16:creationId xmlns:a16="http://schemas.microsoft.com/office/drawing/2014/main" id="{8461536D-B381-4E8E-82A7-FE722658583B}"/>
               </a:ext>
             </a:extLst>
           </p:cNvPr>
@@ -4029,7 +4029,7 @@
           <p:cNvPr id="7" name="">
             <a:extLst xmlns:a="http://schemas.openxmlformats.org/drawingml/2006/main">
               <a:ext uri="{FF2B5EF4-FFF2-40B4-BE49-F238E27FC236}">
-                <a16:creationId xmlns:a16="http://schemas.microsoft.com/office/drawing/2014/main" id="{0C15E3E4-DFB3-42FD-A929-2AE5C48B3D13}"/>
+                <a16:creationId xmlns:a16="http://schemas.microsoft.com/office/drawing/2014/main" id="{58197365-C26B-4F27-AFB9-41CF7457C252}"/>
               </a:ext>
             </a:extLst>
           </p:cNvPr>
@@ -4086,7 +4086,7 @@
           <p:cNvPr id="8" name="">
             <a:extLst xmlns:a="http://schemas.openxmlformats.org/drawingml/2006/main">
               <a:ext uri="{FF2B5EF4-FFF2-40B4-BE49-F238E27FC236}">
-                <a16:creationId xmlns:a16="http://schemas.microsoft.com/office/drawing/2014/main" id="{090C6387-834C-4077-B3F9-CA319548E64A}"/>
+                <a16:creationId xmlns:a16="http://schemas.microsoft.com/office/drawing/2014/main" id="{1BB41275-AAA4-4E7A-951A-521D363A63CB}"/>
               </a:ext>
             </a:extLst>
           </p:cNvPr>
@@ -4166,7 +4166,7 @@
           <p:cNvPr id="9" name="">
             <a:extLst xmlns:a="http://schemas.openxmlformats.org/drawingml/2006/main">
               <a:ext uri="{FF2B5EF4-FFF2-40B4-BE49-F238E27FC236}">
-                <a16:creationId xmlns:a16="http://schemas.microsoft.com/office/drawing/2014/main" id="{86F9E2BA-B662-4458-BFB8-D6DDD9E7EFB0}"/>
+                <a16:creationId xmlns:a16="http://schemas.microsoft.com/office/drawing/2014/main" id="{90FDBFF3-E7B4-4BE8-B6A0-465C0FFD330C}"/>
               </a:ext>
             </a:extLst>
           </p:cNvPr>
@@ -4198,7 +4198,7 @@
           <p:cNvPr id="10" name="">
             <a:extLst xmlns:a="http://schemas.openxmlformats.org/drawingml/2006/main">
               <a:ext uri="{FF2B5EF4-FFF2-40B4-BE49-F238E27FC236}">
-                <a16:creationId xmlns:a16="http://schemas.microsoft.com/office/drawing/2014/main" id="{1DF419D0-302D-4B98-825F-F1EF14C1998E}"/>
+                <a16:creationId xmlns:a16="http://schemas.microsoft.com/office/drawing/2014/main" id="{54FA1866-62DB-4DA6-9E81-CF18833EE6AC}"/>
               </a:ext>
             </a:extLst>
           </p:cNvPr>
@@ -4233,7 +4233,7 @@
           <p:cNvPr id="11" name="">
             <a:extLst xmlns:a="http://schemas.openxmlformats.org/drawingml/2006/main">
               <a:ext uri="{FF2B5EF4-FFF2-40B4-BE49-F238E27FC236}">
-                <a16:creationId xmlns:a16="http://schemas.microsoft.com/office/drawing/2014/main" id="{AC0462A1-A71F-40B3-817F-ED3A6A19A56A}"/>
+                <a16:creationId xmlns:a16="http://schemas.microsoft.com/office/drawing/2014/main" id="{239D30B4-5ED0-41C6-92A3-AFAE90771090}"/>
               </a:ext>
             </a:extLst>
           </p:cNvPr>
@@ -4297,7 +4297,7 @@
           <p:cNvPr id="12" name="">
             <a:extLst xmlns:a="http://schemas.openxmlformats.org/drawingml/2006/main">
               <a:ext uri="{FF2B5EF4-FFF2-40B4-BE49-F238E27FC236}">
-                <a16:creationId xmlns:a16="http://schemas.microsoft.com/office/drawing/2014/main" id="{51C2E6EA-6344-4780-9489-28A9B93E0702}"/>
+                <a16:creationId xmlns:a16="http://schemas.microsoft.com/office/drawing/2014/main" id="{74C062B7-E151-4BF6-844B-09E8BD24D73D}"/>
               </a:ext>
             </a:extLst>
           </p:cNvPr>
@@ -4354,7 +4354,7 @@
           <p:cNvPr id="13" name="">
             <a:extLst xmlns:a="http://schemas.openxmlformats.org/drawingml/2006/main">
               <a:ext uri="{FF2B5EF4-FFF2-40B4-BE49-F238E27FC236}">
-                <a16:creationId xmlns:a16="http://schemas.microsoft.com/office/drawing/2014/main" id="{0B88E75E-2E92-42E5-B5E7-3AE1E825B085}"/>
+                <a16:creationId xmlns:a16="http://schemas.microsoft.com/office/drawing/2014/main" id="{7AF9DADC-80D8-4748-9CD7-47ECA56439BC}"/>
               </a:ext>
             </a:extLst>
           </p:cNvPr>
@@ -4434,7 +4434,7 @@
           <p:cNvPr id="14" name="">
             <a:extLst xmlns:a="http://schemas.openxmlformats.org/drawingml/2006/main">
               <a:ext uri="{FF2B5EF4-FFF2-40B4-BE49-F238E27FC236}">
-                <a16:creationId xmlns:a16="http://schemas.microsoft.com/office/drawing/2014/main" id="{FADF1750-9898-41FD-92EA-3F5BDB3E18D9}"/>
+                <a16:creationId xmlns:a16="http://schemas.microsoft.com/office/drawing/2014/main" id="{FE30B606-0BFC-4A34-8124-2307AD4EE3BC}"/>
               </a:ext>
             </a:extLst>
           </p:cNvPr>
@@ -4466,7 +4466,7 @@
           <p:cNvPr id="15" name="">
             <a:extLst xmlns:a="http://schemas.openxmlformats.org/drawingml/2006/main">
               <a:ext uri="{FF2B5EF4-FFF2-40B4-BE49-F238E27FC236}">
-                <a16:creationId xmlns:a16="http://schemas.microsoft.com/office/drawing/2014/main" id="{A5FB0760-A621-4CDE-89ED-79BE1C6C0195}"/>
+                <a16:creationId xmlns:a16="http://schemas.microsoft.com/office/drawing/2014/main" id="{1D56E40F-E17B-4BE6-8411-F91DE331283F}"/>
               </a:ext>
             </a:extLst>
           </p:cNvPr>
@@ -4501,7 +4501,7 @@
           <p:cNvPr id="16" name="">
             <a:extLst xmlns:a="http://schemas.openxmlformats.org/drawingml/2006/main">
               <a:ext uri="{FF2B5EF4-FFF2-40B4-BE49-F238E27FC236}">
-                <a16:creationId xmlns:a16="http://schemas.microsoft.com/office/drawing/2014/main" id="{E96976EC-02D7-4E54-98F3-06B09E378C87}"/>
+                <a16:creationId xmlns:a16="http://schemas.microsoft.com/office/drawing/2014/main" id="{CF81EB6E-18F8-4276-A0E5-F20C94F44332}"/>
               </a:ext>
             </a:extLst>
           </p:cNvPr>
@@ -4565,7 +4565,7 @@
           <p:cNvPr id="17" name="">
             <a:extLst xmlns:a="http://schemas.openxmlformats.org/drawingml/2006/main">
               <a:ext uri="{FF2B5EF4-FFF2-40B4-BE49-F238E27FC236}">
-                <a16:creationId xmlns:a16="http://schemas.microsoft.com/office/drawing/2014/main" id="{9A7FC989-3FC4-4F5C-8CB6-8706E37F55B0}"/>
+                <a16:creationId xmlns:a16="http://schemas.microsoft.com/office/drawing/2014/main" id="{D8FA24FD-023F-46A3-B762-4BDE00E3CA70}"/>
               </a:ext>
             </a:extLst>
           </p:cNvPr>
@@ -4622,7 +4622,7 @@
           <p:cNvPr id="18" name="">
             <a:extLst xmlns:a="http://schemas.openxmlformats.org/drawingml/2006/main">
               <a:ext uri="{FF2B5EF4-FFF2-40B4-BE49-F238E27FC236}">
-                <a16:creationId xmlns:a16="http://schemas.microsoft.com/office/drawing/2014/main" id="{3186B64F-0B9C-4664-9D74-2C19D11DA1FA}"/>
+                <a16:creationId xmlns:a16="http://schemas.microsoft.com/office/drawing/2014/main" id="{1EB536F7-71B4-46F1-BEC3-132E0B65C433}"/>
               </a:ext>
             </a:extLst>
           </p:cNvPr>
@@ -4702,7 +4702,7 @@
           <p:cNvPr id="19" name="">
             <a:extLst xmlns:a="http://schemas.openxmlformats.org/drawingml/2006/main">
               <a:ext uri="{FF2B5EF4-FFF2-40B4-BE49-F238E27FC236}">
-                <a16:creationId xmlns:a16="http://schemas.microsoft.com/office/drawing/2014/main" id="{434E6522-5A24-420D-9229-F35ED61E6333}"/>
+                <a16:creationId xmlns:a16="http://schemas.microsoft.com/office/drawing/2014/main" id="{04CD4CB9-CB51-430A-B64C-F6CACAF31074}"/>
               </a:ext>
             </a:extLst>
           </p:cNvPr>
@@ -4734,7 +4734,7 @@
           <p:cNvPr id="20" name="">
             <a:extLst xmlns:a="http://schemas.openxmlformats.org/drawingml/2006/main">
               <a:ext uri="{FF2B5EF4-FFF2-40B4-BE49-F238E27FC236}">
-                <a16:creationId xmlns:a16="http://schemas.microsoft.com/office/drawing/2014/main" id="{BC184D4E-B5BC-4CBB-B55D-EAEEA33BB223}"/>
+                <a16:creationId xmlns:a16="http://schemas.microsoft.com/office/drawing/2014/main" id="{E573D261-2794-4C7F-980B-B65EB6FE5A53}"/>
               </a:ext>
             </a:extLst>
           </p:cNvPr>
@@ -4769,7 +4769,7 @@
           <p:cNvPr id="21" name="">
             <a:extLst xmlns:a="http://schemas.openxmlformats.org/drawingml/2006/main">
               <a:ext uri="{FF2B5EF4-FFF2-40B4-BE49-F238E27FC236}">
-                <a16:creationId xmlns:a16="http://schemas.microsoft.com/office/drawing/2014/main" id="{2CDA1149-326B-4BFB-B1A7-7ACC7D259BA0}"/>
+                <a16:creationId xmlns:a16="http://schemas.microsoft.com/office/drawing/2014/main" id="{59C46AAA-C0B8-49CF-9F17-067FDCC72765}"/>
               </a:ext>
             </a:extLst>
           </p:cNvPr>
@@ -4833,7 +4833,7 @@
           <p:cNvPr id="22" name="">
             <a:extLst xmlns:a="http://schemas.openxmlformats.org/drawingml/2006/main">
               <a:ext uri="{FF2B5EF4-FFF2-40B4-BE49-F238E27FC236}">
-                <a16:creationId xmlns:a16="http://schemas.microsoft.com/office/drawing/2014/main" id="{A97D9E06-8E13-48E4-B70B-7E0FF3306868}"/>
+                <a16:creationId xmlns:a16="http://schemas.microsoft.com/office/drawing/2014/main" id="{3CA3FFAC-87E2-4C97-AADB-CE096469B6C4}"/>
               </a:ext>
             </a:extLst>
           </p:cNvPr>
@@ -4890,7 +4890,7 @@
           <p:cNvPr id="23" name="">
             <a:extLst xmlns:a="http://schemas.openxmlformats.org/drawingml/2006/main">
               <a:ext uri="{FF2B5EF4-FFF2-40B4-BE49-F238E27FC236}">
-                <a16:creationId xmlns:a16="http://schemas.microsoft.com/office/drawing/2014/main" id="{9EAB0AEE-6D41-4B36-A5D7-A117CCF8196D}"/>
+                <a16:creationId xmlns:a16="http://schemas.microsoft.com/office/drawing/2014/main" id="{BF643783-FCAC-4DA3-8B68-E382B1F68E9E}"/>
               </a:ext>
             </a:extLst>
           </p:cNvPr>
@@ -4970,7 +4970,7 @@
           <p:cNvPr id="24" name="">
             <a:extLst xmlns:a="http://schemas.openxmlformats.org/drawingml/2006/main">
               <a:ext uri="{FF2B5EF4-FFF2-40B4-BE49-F238E27FC236}">
-                <a16:creationId xmlns:a16="http://schemas.microsoft.com/office/drawing/2014/main" id="{CE76C726-25B9-413A-94AF-BD6EED2ED53F}"/>
+                <a16:creationId xmlns:a16="http://schemas.microsoft.com/office/drawing/2014/main" id="{A9AC8CED-F6B9-498C-9BAD-7062D99B0429}"/>
               </a:ext>
             </a:extLst>
           </p:cNvPr>
@@ -5002,7 +5002,7 @@
           <p:cNvPr id="25" name="">
             <a:extLst xmlns:a="http://schemas.openxmlformats.org/drawingml/2006/main">
               <a:ext uri="{FF2B5EF4-FFF2-40B4-BE49-F238E27FC236}">
-                <a16:creationId xmlns:a16="http://schemas.microsoft.com/office/drawing/2014/main" id="{6E2BEB71-498C-4057-B3F4-24D9650A3DD9}"/>
+                <a16:creationId xmlns:a16="http://schemas.microsoft.com/office/drawing/2014/main" id="{6D919EF2-129B-41E3-874F-C60CE7FF38B4}"/>
               </a:ext>
             </a:extLst>
           </p:cNvPr>
@@ -5037,7 +5037,7 @@
           <p:cNvPr id="26" name="">
             <a:extLst xmlns:a="http://schemas.openxmlformats.org/drawingml/2006/main">
               <a:ext uri="{FF2B5EF4-FFF2-40B4-BE49-F238E27FC236}">
-                <a16:creationId xmlns:a16="http://schemas.microsoft.com/office/drawing/2014/main" id="{653DE267-A0CE-4C92-B754-23E6E582AD09}"/>
+                <a16:creationId xmlns:a16="http://schemas.microsoft.com/office/drawing/2014/main" id="{38E4D690-DC98-479E-A78C-35807902F457}"/>
               </a:ext>
             </a:extLst>
           </p:cNvPr>
@@ -5101,7 +5101,7 @@
           <p:cNvPr id="27" name="">
             <a:extLst xmlns:a="http://schemas.openxmlformats.org/drawingml/2006/main">
               <a:ext uri="{FF2B5EF4-FFF2-40B4-BE49-F238E27FC236}">
-                <a16:creationId xmlns:a16="http://schemas.microsoft.com/office/drawing/2014/main" id="{D95B3B9F-097C-4D37-A8A6-FCA0CB9E6C3A}"/>
+                <a16:creationId xmlns:a16="http://schemas.microsoft.com/office/drawing/2014/main" id="{1798CF40-F05E-44ED-A0E2-69350F2770A5}"/>
               </a:ext>
             </a:extLst>
           </p:cNvPr>
@@ -5158,7 +5158,7 @@
           <p:cNvPr id="28" name="">
             <a:extLst xmlns:a="http://schemas.openxmlformats.org/drawingml/2006/main">
               <a:ext uri="{FF2B5EF4-FFF2-40B4-BE49-F238E27FC236}">
-                <a16:creationId xmlns:a16="http://schemas.microsoft.com/office/drawing/2014/main" id="{33B72D39-7D2D-422E-94EF-B7B11B496830}"/>
+                <a16:creationId xmlns:a16="http://schemas.microsoft.com/office/drawing/2014/main" id="{981511D9-9CB7-448C-BC7D-ABCA0AFE5046}"/>
               </a:ext>
             </a:extLst>
           </p:cNvPr>
@@ -5238,7 +5238,7 @@
           <p:cNvPr id="29" name="">
             <a:extLst xmlns:a="http://schemas.openxmlformats.org/drawingml/2006/main">
               <a:ext uri="{FF2B5EF4-FFF2-40B4-BE49-F238E27FC236}">
-                <a16:creationId xmlns:a16="http://schemas.microsoft.com/office/drawing/2014/main" id="{7EC49D61-A325-4562-83C2-CB645B8B312E}"/>
+                <a16:creationId xmlns:a16="http://schemas.microsoft.com/office/drawing/2014/main" id="{4985C94E-5F03-45BA-A717-0F5C230D1FF6}"/>
               </a:ext>
             </a:extLst>
           </p:cNvPr>
@@ -5295,7 +5295,7 @@
           <p:cNvPr id="30" name="">
             <a:extLst xmlns:a="http://schemas.openxmlformats.org/drawingml/2006/main">
               <a:ext uri="{FF2B5EF4-FFF2-40B4-BE49-F238E27FC236}">
-                <a16:creationId xmlns:a16="http://schemas.microsoft.com/office/drawing/2014/main" id="{8BB3F30D-937C-4D6A-9DE0-AFE6C98FFC1F}"/>
+                <a16:creationId xmlns:a16="http://schemas.microsoft.com/office/drawing/2014/main" id="{09584917-53F8-4DFE-9E61-57EBE87B60B2}"/>
               </a:ext>
             </a:extLst>
           </p:cNvPr>
@@ -5330,7 +5330,7 @@
           <p:cNvPr id="31" name="">
             <a:extLst xmlns:a="http://schemas.openxmlformats.org/drawingml/2006/main">
               <a:ext uri="{FF2B5EF4-FFF2-40B4-BE49-F238E27FC236}">
-                <a16:creationId xmlns:a16="http://schemas.microsoft.com/office/drawing/2014/main" id="{64530648-5472-4783-BD7C-2A202993BA55}"/>
+                <a16:creationId xmlns:a16="http://schemas.microsoft.com/office/drawing/2014/main" id="{27D945B9-713D-417A-8919-3549C027C003}"/>
               </a:ext>
             </a:extLst>
           </p:cNvPr>
@@ -5387,7 +5387,7 @@
           <p:cNvPr id="32" name="">
             <a:extLst xmlns:a="http://schemas.openxmlformats.org/drawingml/2006/main">
               <a:ext uri="{FF2B5EF4-FFF2-40B4-BE49-F238E27FC236}">
-                <a16:creationId xmlns:a16="http://schemas.microsoft.com/office/drawing/2014/main" id="{EFF31346-BA20-4C60-B536-B68CDB697AFE}"/>
+                <a16:creationId xmlns:a16="http://schemas.microsoft.com/office/drawing/2014/main" id="{73F66486-C428-4BA5-A846-DABD74F1A5F7}"/>
               </a:ext>
             </a:extLst>
           </p:cNvPr>
@@ -5490,7 +5490,7 @@
           <p:cNvPr id="33" name="">
             <a:extLst xmlns:a="http://schemas.openxmlformats.org/drawingml/2006/main">
               <a:ext uri="{FF2B5EF4-FFF2-40B4-BE49-F238E27FC236}">
-                <a16:creationId xmlns:a16="http://schemas.microsoft.com/office/drawing/2014/main" id="{818FAA44-284B-4146-AE1A-92ADE91EEC29}"/>
+                <a16:creationId xmlns:a16="http://schemas.microsoft.com/office/drawing/2014/main" id="{83169C01-9458-48D5-8C86-F37D47B4A288}"/>
               </a:ext>
             </a:extLst>
           </p:cNvPr>
@@ -5554,7 +5554,7 @@
           <p:cNvPr id="34" name="">
             <a:extLst xmlns:a="http://schemas.openxmlformats.org/drawingml/2006/main">
               <a:ext uri="{FF2B5EF4-FFF2-40B4-BE49-F238E27FC236}">
-                <a16:creationId xmlns:a16="http://schemas.microsoft.com/office/drawing/2014/main" id="{3F3EF115-5FEB-4541-8A0C-8529F4A9968E}"/>
+                <a16:creationId xmlns:a16="http://schemas.microsoft.com/office/drawing/2014/main" id="{74B04169-B273-4129-94F8-2B3DFA646F20}"/>
               </a:ext>
             </a:extLst>
           </p:cNvPr>
@@ -5611,7 +5611,7 @@
           <p:cNvPr id="35" name="">
             <a:extLst xmlns:a="http://schemas.openxmlformats.org/drawingml/2006/main">
               <a:ext uri="{FF2B5EF4-FFF2-40B4-BE49-F238E27FC236}">
-                <a16:creationId xmlns:a16="http://schemas.microsoft.com/office/drawing/2014/main" id="{2AE29C8F-7126-4AF8-970E-B28492EA2DF5}"/>
+                <a16:creationId xmlns:a16="http://schemas.microsoft.com/office/drawing/2014/main" id="{A246D210-E352-4A59-B699-B2115EC6882C}"/>
               </a:ext>
             </a:extLst>
           </p:cNvPr>
@@ -5646,7 +5646,7 @@
           <p:cNvPr id="36" name="">
             <a:extLst xmlns:a="http://schemas.openxmlformats.org/drawingml/2006/main">
               <a:ext uri="{FF2B5EF4-FFF2-40B4-BE49-F238E27FC236}">
-                <a16:creationId xmlns:a16="http://schemas.microsoft.com/office/drawing/2014/main" id="{38F3AC40-BDEA-4FC5-AB60-60082D6E9BF1}"/>
+                <a16:creationId xmlns:a16="http://schemas.microsoft.com/office/drawing/2014/main" id="{7F8AD631-BB38-492E-AB77-FE3C5AFDBF82}"/>
               </a:ext>
             </a:extLst>
           </p:cNvPr>
@@ -5703,7 +5703,7 @@
           <p:cNvPr id="37" name="">
             <a:extLst xmlns:a="http://schemas.openxmlformats.org/drawingml/2006/main">
               <a:ext uri="{FF2B5EF4-FFF2-40B4-BE49-F238E27FC236}">
-                <a16:creationId xmlns:a16="http://schemas.microsoft.com/office/drawing/2014/main" id="{05479B67-3F4E-4BBA-AB79-653F30EECB91}"/>
+                <a16:creationId xmlns:a16="http://schemas.microsoft.com/office/drawing/2014/main" id="{D2F60F59-AFB0-4FD2-AAE0-BC23E889496F}"/>
               </a:ext>
             </a:extLst>
           </p:cNvPr>
@@ -5738,7 +5738,7 @@
           <p:cNvPr id="38" name="">
             <a:extLst xmlns:a="http://schemas.openxmlformats.org/drawingml/2006/main">
               <a:ext uri="{FF2B5EF4-FFF2-40B4-BE49-F238E27FC236}">
-                <a16:creationId xmlns:a16="http://schemas.microsoft.com/office/drawing/2014/main" id="{03CA7403-B358-47A0-AC65-DFE1F309DBBE}"/>
+                <a16:creationId xmlns:a16="http://schemas.microsoft.com/office/drawing/2014/main" id="{C7B30B61-7403-493B-8D30-6E9E3BFF9563}"/>
               </a:ext>
             </a:extLst>
           </p:cNvPr>
@@ -5795,7 +5795,7 @@
           <p:cNvPr id="39" name="">
             <a:extLst xmlns:a="http://schemas.openxmlformats.org/drawingml/2006/main">
               <a:ext uri="{FF2B5EF4-FFF2-40B4-BE49-F238E27FC236}">
-                <a16:creationId xmlns:a16="http://schemas.microsoft.com/office/drawing/2014/main" id="{4130E40B-4191-4CFB-8797-634F5657020A}"/>
+                <a16:creationId xmlns:a16="http://schemas.microsoft.com/office/drawing/2014/main" id="{C64EC2EC-9EDC-48E6-BA58-B3EA951A932D}"/>
               </a:ext>
             </a:extLst>
           </p:cNvPr>
@@ -5852,7 +5852,7 @@
           <p:cNvPr id="40" name="">
             <a:extLst xmlns:a="http://schemas.openxmlformats.org/drawingml/2006/main">
               <a:ext uri="{FF2B5EF4-FFF2-40B4-BE49-F238E27FC236}">
-                <a16:creationId xmlns:a16="http://schemas.microsoft.com/office/drawing/2014/main" id="{857B170B-848A-4000-949C-7FE36B4352EE}"/>
+                <a16:creationId xmlns:a16="http://schemas.microsoft.com/office/drawing/2014/main" id="{7EA57ECA-A8C9-4247-A9FA-2207B30CC545}"/>
               </a:ext>
             </a:extLst>
           </p:cNvPr>
@@ -5887,7 +5887,7 @@
           <p:cNvPr id="41" name="">
             <a:extLst xmlns:a="http://schemas.openxmlformats.org/drawingml/2006/main">
               <a:ext uri="{FF2B5EF4-FFF2-40B4-BE49-F238E27FC236}">
-                <a16:creationId xmlns:a16="http://schemas.microsoft.com/office/drawing/2014/main" id="{3946B3DD-BD22-4488-B793-EE0A8C77484D}"/>
+                <a16:creationId xmlns:a16="http://schemas.microsoft.com/office/drawing/2014/main" id="{313CADC3-C765-45B4-B3E5-178AF08272DA}"/>
               </a:ext>
             </a:extLst>
           </p:cNvPr>
@@ -5944,7 +5944,7 @@
           <p:cNvPr id="42" name="">
             <a:extLst xmlns:a="http://schemas.openxmlformats.org/drawingml/2006/main">
               <a:ext uri="{FF2B5EF4-FFF2-40B4-BE49-F238E27FC236}">
-                <a16:creationId xmlns:a16="http://schemas.microsoft.com/office/drawing/2014/main" id="{37F6D658-AF34-4C3D-9579-1431D732D64D}"/>
+                <a16:creationId xmlns:a16="http://schemas.microsoft.com/office/drawing/2014/main" id="{3A7E34B0-4CA5-4373-A056-D58CC4EDA702}"/>
               </a:ext>
             </a:extLst>
           </p:cNvPr>
@@ -6001,7 +6001,7 @@
           <p:cNvPr id="43" name="">
             <a:extLst xmlns:a="http://schemas.openxmlformats.org/drawingml/2006/main">
               <a:ext uri="{FF2B5EF4-FFF2-40B4-BE49-F238E27FC236}">
-                <a16:creationId xmlns:a16="http://schemas.microsoft.com/office/drawing/2014/main" id="{942CEB46-6808-4A3B-9A53-063B822AFE5E}"/>
+                <a16:creationId xmlns:a16="http://schemas.microsoft.com/office/drawing/2014/main" id="{124AC200-EBDD-4D99-98AB-49EA869506FE}"/>
               </a:ext>
             </a:extLst>
           </p:cNvPr>
@@ -6058,7 +6058,7 @@
           <p:cNvPr id="44" name="">
             <a:extLst xmlns:a="http://schemas.openxmlformats.org/drawingml/2006/main">
               <a:ext uri="{FF2B5EF4-FFF2-40B4-BE49-F238E27FC236}">
-                <a16:creationId xmlns:a16="http://schemas.microsoft.com/office/drawing/2014/main" id="{62277B90-C2CF-4620-8D31-F1FAD0D38A53}"/>
+                <a16:creationId xmlns:a16="http://schemas.microsoft.com/office/drawing/2014/main" id="{45A55EF4-A0DE-4425-9A72-3E57F22D2394}"/>
               </a:ext>
             </a:extLst>
           </p:cNvPr>
@@ -6115,7 +6115,7 @@
           <p:cNvPr id="45" name="">
             <a:extLst xmlns:a="http://schemas.openxmlformats.org/drawingml/2006/main">
               <a:ext uri="{FF2B5EF4-FFF2-40B4-BE49-F238E27FC236}">
-                <a16:creationId xmlns:a16="http://schemas.microsoft.com/office/drawing/2014/main" id="{746FC57C-8F33-47D9-9EA2-2CA2FFDCC87B}"/>
+                <a16:creationId xmlns:a16="http://schemas.microsoft.com/office/drawing/2014/main" id="{92047765-1E26-4D72-91E8-2CE5D0707B98}"/>
               </a:ext>
             </a:extLst>
           </p:cNvPr>
@@ -6170,7 +6170,7 @@
     </p:spTree>
     <p:extLst>
       <p:ext uri="{BB962C8B-B14F-4D97-AF65-F5344CB8AC3E}">
-        <p14:creationId xmlns:p14="http://schemas.microsoft.com/office/powerpoint/2010/main" val="83275567"/>
+        <p14:creationId xmlns:p14="http://schemas.microsoft.com/office/powerpoint/2010/main" val="125938981"/>
       </p:ext>
     </p:extLst>
   </p:cSld>
@@ -6201,7 +6201,7 @@
           <p:cNvPr id="32" name="">
             <a:extLst xmlns:a="http://schemas.openxmlformats.org/drawingml/2006/main">
               <a:ext uri="{FF2B5EF4-FFF2-40B4-BE49-F238E27FC236}">
-                <a16:creationId xmlns:a16="http://schemas.microsoft.com/office/drawing/2014/main" id="{BD70A18D-18AB-44EA-B425-5D4933E88FEF}"/>
+                <a16:creationId xmlns:a16="http://schemas.microsoft.com/office/drawing/2014/main" id="{42A04EF1-3B18-406F-86CB-C51CC5068079}"/>
               </a:ext>
             </a:extLst>
           </p:cNvPr>
@@ -6258,7 +6258,7 @@
           <p:cNvPr id="2" name="">
             <a:extLst xmlns:a="http://schemas.openxmlformats.org/drawingml/2006/main">
               <a:ext uri="{FF2B5EF4-FFF2-40B4-BE49-F238E27FC236}">
-                <a16:creationId xmlns:a16="http://schemas.microsoft.com/office/drawing/2014/main" id="{FA54F11D-0DB5-44E0-90F5-338A3A733F33}"/>
+                <a16:creationId xmlns:a16="http://schemas.microsoft.com/office/drawing/2014/main" id="{F54AF83A-301E-4B80-9805-97881391E925}"/>
               </a:ext>
             </a:extLst>
           </p:cNvPr>
@@ -6315,7 +6315,7 @@
           <p:cNvPr id="3" name="">
             <a:extLst xmlns:a="http://schemas.openxmlformats.org/drawingml/2006/main">
               <a:ext uri="{FF2B5EF4-FFF2-40B4-BE49-F238E27FC236}">
-                <a16:creationId xmlns:a16="http://schemas.microsoft.com/office/drawing/2014/main" id="{65377151-05B3-4065-B9EC-B1A739FC09D7}"/>
+                <a16:creationId xmlns:a16="http://schemas.microsoft.com/office/drawing/2014/main" id="{C551BA34-FC9D-4894-8F00-FCD2C8D75295}"/>
               </a:ext>
             </a:extLst>
           </p:cNvPr>
@@ -6372,7 +6372,7 @@
           <p:cNvPr id="4" name="">
             <a:extLst xmlns:a="http://schemas.openxmlformats.org/drawingml/2006/main">
               <a:ext uri="{FF2B5EF4-FFF2-40B4-BE49-F238E27FC236}">
-                <a16:creationId xmlns:a16="http://schemas.microsoft.com/office/drawing/2014/main" id="{CBBC5B77-FB80-436F-9986-0F5857D0C7F6}"/>
+                <a16:creationId xmlns:a16="http://schemas.microsoft.com/office/drawing/2014/main" id="{D8C315E7-DC28-432B-8DD4-2EE0BED35D3D}"/>
               </a:ext>
             </a:extLst>
           </p:cNvPr>
@@ -6403,7 +6403,7 @@
           <p:cNvPr id="5" name="">
             <a:extLst xmlns:a="http://schemas.openxmlformats.org/drawingml/2006/main">
               <a:ext uri="{FF2B5EF4-FFF2-40B4-BE49-F238E27FC236}">
-                <a16:creationId xmlns:a16="http://schemas.microsoft.com/office/drawing/2014/main" id="{0530E82C-4E3D-40A2-B700-60922AF42566}"/>
+                <a16:creationId xmlns:a16="http://schemas.microsoft.com/office/drawing/2014/main" id="{46257D6E-54ED-485F-A394-40B1406036C5}"/>
               </a:ext>
             </a:extLst>
           </p:cNvPr>
@@ -6438,7 +6438,7 @@
           <p:cNvPr id="6" name="">
             <a:extLst xmlns:a="http://schemas.openxmlformats.org/drawingml/2006/main">
               <a:ext uri="{FF2B5EF4-FFF2-40B4-BE49-F238E27FC236}">
-                <a16:creationId xmlns:a16="http://schemas.microsoft.com/office/drawing/2014/main" id="{41CC668F-0E70-4847-8091-5BC974627062}"/>
+                <a16:creationId xmlns:a16="http://schemas.microsoft.com/office/drawing/2014/main" id="{84A85602-1338-4069-B20F-A1BEE5ED286B}"/>
               </a:ext>
             </a:extLst>
           </p:cNvPr>
@@ -6502,7 +6502,7 @@
           <p:cNvPr id="7" name="">
             <a:extLst xmlns:a="http://schemas.openxmlformats.org/drawingml/2006/main">
               <a:ext uri="{FF2B5EF4-FFF2-40B4-BE49-F238E27FC236}">
-                <a16:creationId xmlns:a16="http://schemas.microsoft.com/office/drawing/2014/main" id="{0375CEEC-477C-4C78-9C13-1A3BFE707FD0}"/>
+                <a16:creationId xmlns:a16="http://schemas.microsoft.com/office/drawing/2014/main" id="{3FCE7CA0-920C-495D-B0CE-EFCA271DC13D}"/>
               </a:ext>
             </a:extLst>
           </p:cNvPr>
@@ -6559,7 +6559,7 @@
           <p:cNvPr id="8" name="">
             <a:extLst xmlns:a="http://schemas.openxmlformats.org/drawingml/2006/main">
               <a:ext uri="{FF2B5EF4-FFF2-40B4-BE49-F238E27FC236}">
-                <a16:creationId xmlns:a16="http://schemas.microsoft.com/office/drawing/2014/main" id="{CD362C64-48D6-47B7-95EA-88D86BBA0105}"/>
+                <a16:creationId xmlns:a16="http://schemas.microsoft.com/office/drawing/2014/main" id="{62AB5EA6-5229-4A71-980A-7D50FAE4B5C7}"/>
               </a:ext>
             </a:extLst>
           </p:cNvPr>
@@ -6662,7 +6662,7 @@
           <p:cNvPr id="9" name="">
             <a:extLst xmlns:a="http://schemas.openxmlformats.org/drawingml/2006/main">
               <a:ext uri="{FF2B5EF4-FFF2-40B4-BE49-F238E27FC236}">
-                <a16:creationId xmlns:a16="http://schemas.microsoft.com/office/drawing/2014/main" id="{9C04268D-8AE2-4F46-B971-30FCFBD53F1D}"/>
+                <a16:creationId xmlns:a16="http://schemas.microsoft.com/office/drawing/2014/main" id="{461CE15A-C552-4CD1-94F3-62C4F88817FB}"/>
               </a:ext>
             </a:extLst>
           </p:cNvPr>
@@ -6697,7 +6697,7 @@
           <p:cNvPr id="10" name="">
             <a:extLst xmlns:a="http://schemas.openxmlformats.org/drawingml/2006/main">
               <a:ext uri="{FF2B5EF4-FFF2-40B4-BE49-F238E27FC236}">
-                <a16:creationId xmlns:a16="http://schemas.microsoft.com/office/drawing/2014/main" id="{195C35CA-49F0-4E15-957C-029CAB58E9ED}"/>
+                <a16:creationId xmlns:a16="http://schemas.microsoft.com/office/drawing/2014/main" id="{367B57D0-1F9C-4310-A74F-52E96E2AE212}"/>
               </a:ext>
             </a:extLst>
           </p:cNvPr>
@@ -6761,7 +6761,7 @@
           <p:cNvPr id="11" name="">
             <a:extLst xmlns:a="http://schemas.openxmlformats.org/drawingml/2006/main">
               <a:ext uri="{FF2B5EF4-FFF2-40B4-BE49-F238E27FC236}">
-                <a16:creationId xmlns:a16="http://schemas.microsoft.com/office/drawing/2014/main" id="{01FFB5D3-E4C7-4361-8446-F05DD7B93A94}"/>
+                <a16:creationId xmlns:a16="http://schemas.microsoft.com/office/drawing/2014/main" id="{347D99D9-4034-48A2-A6D5-39C45EF264E5}"/>
               </a:ext>
             </a:extLst>
           </p:cNvPr>
@@ -6818,7 +6818,7 @@
           <p:cNvPr id="12" name="">
             <a:extLst xmlns:a="http://schemas.openxmlformats.org/drawingml/2006/main">
               <a:ext uri="{FF2B5EF4-FFF2-40B4-BE49-F238E27FC236}">
-                <a16:creationId xmlns:a16="http://schemas.microsoft.com/office/drawing/2014/main" id="{B98930CD-BD54-438E-94E4-FB5AAFD157BE}"/>
+                <a16:creationId xmlns:a16="http://schemas.microsoft.com/office/drawing/2014/main" id="{759329D8-ACBD-45C5-9DB7-AA4EE20035E0}"/>
               </a:ext>
             </a:extLst>
           </p:cNvPr>
@@ -6921,7 +6921,7 @@
           <p:cNvPr id="13" name="">
             <a:extLst xmlns:a="http://schemas.openxmlformats.org/drawingml/2006/main">
               <a:ext uri="{FF2B5EF4-FFF2-40B4-BE49-F238E27FC236}">
-                <a16:creationId xmlns:a16="http://schemas.microsoft.com/office/drawing/2014/main" id="{14CFCAEF-3D79-46FF-8C46-6C8C60D4D78D}"/>
+                <a16:creationId xmlns:a16="http://schemas.microsoft.com/office/drawing/2014/main" id="{53B8EF22-252D-4FF9-A447-A4B8BE5FDD67}"/>
               </a:ext>
             </a:extLst>
           </p:cNvPr>
@@ -6978,7 +6978,7 @@
           <p:cNvPr id="14" name="">
             <a:extLst xmlns:a="http://schemas.openxmlformats.org/drawingml/2006/main">
               <a:ext uri="{FF2B5EF4-FFF2-40B4-BE49-F238E27FC236}">
-                <a16:creationId xmlns:a16="http://schemas.microsoft.com/office/drawing/2014/main" id="{4D806C07-7644-4F1F-A96D-E0BF668C619D}"/>
+                <a16:creationId xmlns:a16="http://schemas.microsoft.com/office/drawing/2014/main" id="{71C1BEC3-22CF-4967-B71B-AF23760C1037}"/>
               </a:ext>
             </a:extLst>
           </p:cNvPr>
@@ -7013,7 +7013,7 @@
           <p:cNvPr id="15" name="">
             <a:extLst xmlns:a="http://schemas.openxmlformats.org/drawingml/2006/main">
               <a:ext uri="{FF2B5EF4-FFF2-40B4-BE49-F238E27FC236}">
-                <a16:creationId xmlns:a16="http://schemas.microsoft.com/office/drawing/2014/main" id="{753A3D32-B9E2-4E3F-A8BB-4BC30E34ACA4}"/>
+                <a16:creationId xmlns:a16="http://schemas.microsoft.com/office/drawing/2014/main" id="{1749DAEC-3E67-48C3-91D4-17CC9545BA66}"/>
               </a:ext>
             </a:extLst>
           </p:cNvPr>
@@ -7070,7 +7070,7 @@
           <p:cNvPr id="16" name="">
             <a:extLst xmlns:a="http://schemas.openxmlformats.org/drawingml/2006/main">
               <a:ext uri="{FF2B5EF4-FFF2-40B4-BE49-F238E27FC236}">
-                <a16:creationId xmlns:a16="http://schemas.microsoft.com/office/drawing/2014/main" id="{A1A4D951-054B-4625-90B4-FBD24BD93693}"/>
+                <a16:creationId xmlns:a16="http://schemas.microsoft.com/office/drawing/2014/main" id="{0930C486-1915-4E80-A25C-25ED971E7F5A}"/>
               </a:ext>
             </a:extLst>
           </p:cNvPr>
@@ -7127,7 +7127,7 @@
           <p:cNvPr id="17" name="">
             <a:extLst xmlns:a="http://schemas.openxmlformats.org/drawingml/2006/main">
               <a:ext uri="{FF2B5EF4-FFF2-40B4-BE49-F238E27FC236}">
-                <a16:creationId xmlns:a16="http://schemas.microsoft.com/office/drawing/2014/main" id="{D02D072D-91D0-49C3-9750-BF386CFA3D1A}"/>
+                <a16:creationId xmlns:a16="http://schemas.microsoft.com/office/drawing/2014/main" id="{20F8CD78-644E-40EE-83B0-53F0FA73C536}"/>
               </a:ext>
             </a:extLst>
           </p:cNvPr>
@@ -7162,7 +7162,7 @@
           <p:cNvPr id="18" name="">
             <a:extLst xmlns:a="http://schemas.openxmlformats.org/drawingml/2006/main">
               <a:ext uri="{FF2B5EF4-FFF2-40B4-BE49-F238E27FC236}">
-                <a16:creationId xmlns:a16="http://schemas.microsoft.com/office/drawing/2014/main" id="{6CA52311-5A5B-4448-B727-A438C08D19DF}"/>
+                <a16:creationId xmlns:a16="http://schemas.microsoft.com/office/drawing/2014/main" id="{DA67654C-7B46-4B41-B315-830DDCF8C4DE}"/>
               </a:ext>
             </a:extLst>
           </p:cNvPr>
@@ -7219,7 +7219,7 @@
           <p:cNvPr id="19" name="">
             <a:extLst xmlns:a="http://schemas.openxmlformats.org/drawingml/2006/main">
               <a:ext uri="{FF2B5EF4-FFF2-40B4-BE49-F238E27FC236}">
-                <a16:creationId xmlns:a16="http://schemas.microsoft.com/office/drawing/2014/main" id="{8134050A-155C-4DA3-A78E-DBBF650E91A2}"/>
+                <a16:creationId xmlns:a16="http://schemas.microsoft.com/office/drawing/2014/main" id="{EA315F89-048D-44FA-B92F-0B5B00721BC1}"/>
               </a:ext>
             </a:extLst>
           </p:cNvPr>
@@ -7276,7 +7276,7 @@
           <p:cNvPr id="20" name="">
             <a:extLst xmlns:a="http://schemas.openxmlformats.org/drawingml/2006/main">
               <a:ext uri="{FF2B5EF4-FFF2-40B4-BE49-F238E27FC236}">
-                <a16:creationId xmlns:a16="http://schemas.microsoft.com/office/drawing/2014/main" id="{48A43488-7CAF-4750-843C-4E68B5AEE7D6}"/>
+                <a16:creationId xmlns:a16="http://schemas.microsoft.com/office/drawing/2014/main" id="{E8F73572-A960-41A2-86E7-AC92750CA603}"/>
               </a:ext>
             </a:extLst>
           </p:cNvPr>
@@ -7311,7 +7311,7 @@
           <p:cNvPr id="21" name="">
             <a:extLst xmlns:a="http://schemas.openxmlformats.org/drawingml/2006/main">
               <a:ext uri="{FF2B5EF4-FFF2-40B4-BE49-F238E27FC236}">
-                <a16:creationId xmlns:a16="http://schemas.microsoft.com/office/drawing/2014/main" id="{D84CF5FB-EEAA-46DF-A0E9-667F0F8C8614}"/>
+                <a16:creationId xmlns:a16="http://schemas.microsoft.com/office/drawing/2014/main" id="{D6438493-81AB-4B1C-BFB9-A3CF685FE009}"/>
               </a:ext>
             </a:extLst>
           </p:cNvPr>
@@ -7368,7 +7368,7 @@
           <p:cNvPr id="22" name="">
             <a:extLst xmlns:a="http://schemas.openxmlformats.org/drawingml/2006/main">
               <a:ext uri="{FF2B5EF4-FFF2-40B4-BE49-F238E27FC236}">
-                <a16:creationId xmlns:a16="http://schemas.microsoft.com/office/drawing/2014/main" id="{1A240BFE-FC4F-40B8-A2DF-AF09C9536A77}"/>
+                <a16:creationId xmlns:a16="http://schemas.microsoft.com/office/drawing/2014/main" id="{9C6CF522-DAD3-463F-B0F2-64A4BFEE1678}"/>
               </a:ext>
             </a:extLst>
           </p:cNvPr>
@@ -7425,7 +7425,7 @@
           <p:cNvPr id="23" name="">
             <a:extLst xmlns:a="http://schemas.openxmlformats.org/drawingml/2006/main">
               <a:ext uri="{FF2B5EF4-FFF2-40B4-BE49-F238E27FC236}">
-                <a16:creationId xmlns:a16="http://schemas.microsoft.com/office/drawing/2014/main" id="{72F580BD-8112-439D-8B33-7B9EBDE0441A}"/>
+                <a16:creationId xmlns:a16="http://schemas.microsoft.com/office/drawing/2014/main" id="{A2C21B91-B809-420A-BD34-5F3D18200555}"/>
               </a:ext>
             </a:extLst>
           </p:cNvPr>
@@ -7460,7 +7460,7 @@
           <p:cNvPr id="24" name="">
             <a:extLst xmlns:a="http://schemas.openxmlformats.org/drawingml/2006/main">
               <a:ext uri="{FF2B5EF4-FFF2-40B4-BE49-F238E27FC236}">
-                <a16:creationId xmlns:a16="http://schemas.microsoft.com/office/drawing/2014/main" id="{0775C7EB-9507-4E1E-AD7C-691EEECF861E}"/>
+                <a16:creationId xmlns:a16="http://schemas.microsoft.com/office/drawing/2014/main" id="{E190D09A-8A37-47D3-9696-D02982C06083}"/>
               </a:ext>
             </a:extLst>
           </p:cNvPr>
@@ -7517,7 +7517,7 @@
           <p:cNvPr id="25" name="">
             <a:extLst xmlns:a="http://schemas.openxmlformats.org/drawingml/2006/main">
               <a:ext uri="{FF2B5EF4-FFF2-40B4-BE49-F238E27FC236}">
-                <a16:creationId xmlns:a16="http://schemas.microsoft.com/office/drawing/2014/main" id="{B7D08C96-E4EF-45BC-9BEA-37B3FF585EF9}"/>
+                <a16:creationId xmlns:a16="http://schemas.microsoft.com/office/drawing/2014/main" id="{727DBBE3-BB24-4E8F-9312-1573B2AB9191}"/>
               </a:ext>
             </a:extLst>
           </p:cNvPr>
@@ -7581,7 +7581,7 @@
           <p:cNvPr id="26" name="">
             <a:extLst xmlns:a="http://schemas.openxmlformats.org/drawingml/2006/main">
               <a:ext uri="{FF2B5EF4-FFF2-40B4-BE49-F238E27FC236}">
-                <a16:creationId xmlns:a16="http://schemas.microsoft.com/office/drawing/2014/main" id="{46786DC7-7658-4E52-AA41-712DACDA78E9}"/>
+                <a16:creationId xmlns:a16="http://schemas.microsoft.com/office/drawing/2014/main" id="{9940751B-B10B-4A98-BD13-FB202C2DD86C}"/>
               </a:ext>
             </a:extLst>
           </p:cNvPr>
@@ -7645,7 +7645,7 @@
           <p:cNvPr id="27" name="">
             <a:extLst xmlns:a="http://schemas.openxmlformats.org/drawingml/2006/main">
               <a:ext uri="{FF2B5EF4-FFF2-40B4-BE49-F238E27FC236}">
-                <a16:creationId xmlns:a16="http://schemas.microsoft.com/office/drawing/2014/main" id="{11880EEF-426A-4C23-8DC5-90530DB2F237}"/>
+                <a16:creationId xmlns:a16="http://schemas.microsoft.com/office/drawing/2014/main" id="{7D9EB675-FD45-42C1-9231-81E44CBD9F5E}"/>
               </a:ext>
             </a:extLst>
           </p:cNvPr>
@@ -7709,7 +7709,7 @@
           <p:cNvPr id="28" name="">
             <a:extLst xmlns:a="http://schemas.openxmlformats.org/drawingml/2006/main">
               <a:ext uri="{FF2B5EF4-FFF2-40B4-BE49-F238E27FC236}">
-                <a16:creationId xmlns:a16="http://schemas.microsoft.com/office/drawing/2014/main" id="{038B8D9C-882B-4C4C-931E-78C24C87DA8C}"/>
+                <a16:creationId xmlns:a16="http://schemas.microsoft.com/office/drawing/2014/main" id="{EB5F6B33-5D23-408E-A4E8-FC31B4090B54}"/>
               </a:ext>
             </a:extLst>
           </p:cNvPr>
@@ -7773,7 +7773,7 @@
           <p:cNvPr id="29" name="">
             <a:extLst xmlns:a="http://schemas.openxmlformats.org/drawingml/2006/main">
               <a:ext uri="{FF2B5EF4-FFF2-40B4-BE49-F238E27FC236}">
-                <a16:creationId xmlns:a16="http://schemas.microsoft.com/office/drawing/2014/main" id="{D3F541A4-BE29-43B5-A196-581449788024}"/>
+                <a16:creationId xmlns:a16="http://schemas.microsoft.com/office/drawing/2014/main" id="{660AB120-E1C5-4E74-B209-351EC361D6CB}"/>
               </a:ext>
             </a:extLst>
           </p:cNvPr>
@@ -7830,7 +7830,7 @@
           <p:cNvPr id="30" name="">
             <a:extLst xmlns:a="http://schemas.openxmlformats.org/drawingml/2006/main">
               <a:ext uri="{FF2B5EF4-FFF2-40B4-BE49-F238E27FC236}">
-                <a16:creationId xmlns:a16="http://schemas.microsoft.com/office/drawing/2014/main" id="{539E5E17-7E3A-4598-90B2-DA8185D4F1D5}"/>
+                <a16:creationId xmlns:a16="http://schemas.microsoft.com/office/drawing/2014/main" id="{FD051B14-31CB-4921-835E-39613DBD63E7}"/>
               </a:ext>
             </a:extLst>
           </p:cNvPr>
@@ -7887,7 +7887,7 @@
           <p:cNvPr id="31" name="">
             <a:extLst xmlns:a="http://schemas.openxmlformats.org/drawingml/2006/main">
               <a:ext uri="{FF2B5EF4-FFF2-40B4-BE49-F238E27FC236}">
-                <a16:creationId xmlns:a16="http://schemas.microsoft.com/office/drawing/2014/main" id="{31BF0B49-BD8F-4628-95F1-41685319C948}"/>
+                <a16:creationId xmlns:a16="http://schemas.microsoft.com/office/drawing/2014/main" id="{59B47F31-3DA8-4B1D-945C-2A1F10E391CA}"/>
               </a:ext>
             </a:extLst>
           </p:cNvPr>
@@ -7942,7 +7942,7 @@
     </p:spTree>
     <p:extLst>
       <p:ext uri="{BB962C8B-B14F-4D97-AF65-F5344CB8AC3E}">
-        <p14:creationId xmlns:p14="http://schemas.microsoft.com/office/powerpoint/2010/main" val="12185164"/>
+        <p14:creationId xmlns:p14="http://schemas.microsoft.com/office/powerpoint/2010/main" val="1151123065"/>
       </p:ext>
     </p:extLst>
   </p:cSld>
@@ -7973,7 +7973,7 @@
           <p:cNvPr id="32" name="">
             <a:extLst xmlns:a="http://schemas.openxmlformats.org/drawingml/2006/main">
               <a:ext uri="{FF2B5EF4-FFF2-40B4-BE49-F238E27FC236}">
-                <a16:creationId xmlns:a16="http://schemas.microsoft.com/office/drawing/2014/main" id="{5D3D3A80-83A5-437E-BE2F-34FE22DD5C68}"/>
+                <a16:creationId xmlns:a16="http://schemas.microsoft.com/office/drawing/2014/main" id="{B7CCBA5A-7F47-49B7-8E88-E95E64211168}"/>
               </a:ext>
             </a:extLst>
           </p:cNvPr>
@@ -8030,7 +8030,7 @@
           <p:cNvPr id="2" name="">
             <a:extLst xmlns:a="http://schemas.openxmlformats.org/drawingml/2006/main">
               <a:ext uri="{FF2B5EF4-FFF2-40B4-BE49-F238E27FC236}">
-                <a16:creationId xmlns:a16="http://schemas.microsoft.com/office/drawing/2014/main" id="{560FB14E-8386-4725-985A-40969B1F9BCC}"/>
+                <a16:creationId xmlns:a16="http://schemas.microsoft.com/office/drawing/2014/main" id="{CF2D1048-B90C-4E1C-902D-2F78F7A1F231}"/>
               </a:ext>
             </a:extLst>
           </p:cNvPr>
@@ -8087,7 +8087,7 @@
           <p:cNvPr id="3" name="">
             <a:extLst xmlns:a="http://schemas.openxmlformats.org/drawingml/2006/main">
               <a:ext uri="{FF2B5EF4-FFF2-40B4-BE49-F238E27FC236}">
-                <a16:creationId xmlns:a16="http://schemas.microsoft.com/office/drawing/2014/main" id="{2C0CD6C8-679C-43A4-BFF1-FA534FFBBF74}"/>
+                <a16:creationId xmlns:a16="http://schemas.microsoft.com/office/drawing/2014/main" id="{412953B9-D8A9-466A-AA91-9433F9DF1C30}"/>
               </a:ext>
             </a:extLst>
           </p:cNvPr>
@@ -8144,7 +8144,7 @@
           <p:cNvPr id="4" name="">
             <a:extLst xmlns:a="http://schemas.openxmlformats.org/drawingml/2006/main">
               <a:ext uri="{FF2B5EF4-FFF2-40B4-BE49-F238E27FC236}">
-                <a16:creationId xmlns:a16="http://schemas.microsoft.com/office/drawing/2014/main" id="{0A381D5F-9A80-420C-A164-9628A14D8FEB}"/>
+                <a16:creationId xmlns:a16="http://schemas.microsoft.com/office/drawing/2014/main" id="{5BFAF301-6005-44B3-B625-0D337B8AA9C8}"/>
               </a:ext>
             </a:extLst>
           </p:cNvPr>
@@ -8175,7 +8175,7 @@
           <p:cNvPr id="5" name="">
             <a:extLst xmlns:a="http://schemas.openxmlformats.org/drawingml/2006/main">
               <a:ext uri="{FF2B5EF4-FFF2-40B4-BE49-F238E27FC236}">
-                <a16:creationId xmlns:a16="http://schemas.microsoft.com/office/drawing/2014/main" id="{B3697610-870C-4408-BE53-8B4563F9FD32}"/>
+                <a16:creationId xmlns:a16="http://schemas.microsoft.com/office/drawing/2014/main" id="{234E312A-F2D0-44B8-BF39-E60487553096}"/>
               </a:ext>
             </a:extLst>
           </p:cNvPr>
@@ -8210,7 +8210,7 @@
           <p:cNvPr id="6" name="">
             <a:extLst xmlns:a="http://schemas.openxmlformats.org/drawingml/2006/main">
               <a:ext uri="{FF2B5EF4-FFF2-40B4-BE49-F238E27FC236}">
-                <a16:creationId xmlns:a16="http://schemas.microsoft.com/office/drawing/2014/main" id="{81F8224F-3CE6-4FCF-9E1F-78094420CED9}"/>
+                <a16:creationId xmlns:a16="http://schemas.microsoft.com/office/drawing/2014/main" id="{94317A26-6193-46FE-94D8-30F9425AA651}"/>
               </a:ext>
             </a:extLst>
           </p:cNvPr>
@@ -8274,7 +8274,7 @@
           <p:cNvPr id="7" name="">
             <a:extLst xmlns:a="http://schemas.openxmlformats.org/drawingml/2006/main">
               <a:ext uri="{FF2B5EF4-FFF2-40B4-BE49-F238E27FC236}">
-                <a16:creationId xmlns:a16="http://schemas.microsoft.com/office/drawing/2014/main" id="{B79A25E8-F4C3-445D-8C17-0BD2CD917B16}"/>
+                <a16:creationId xmlns:a16="http://schemas.microsoft.com/office/drawing/2014/main" id="{067EA55F-4CDB-4335-947D-586065A685C1}"/>
               </a:ext>
             </a:extLst>
           </p:cNvPr>
@@ -8331,7 +8331,7 @@
           <p:cNvPr id="8" name="">
             <a:extLst xmlns:a="http://schemas.openxmlformats.org/drawingml/2006/main">
               <a:ext uri="{FF2B5EF4-FFF2-40B4-BE49-F238E27FC236}">
-                <a16:creationId xmlns:a16="http://schemas.microsoft.com/office/drawing/2014/main" id="{5808C9F0-696C-4DB0-83F1-0658DC898888}"/>
+                <a16:creationId xmlns:a16="http://schemas.microsoft.com/office/drawing/2014/main" id="{9F4709CD-DAE6-473F-BEC1-548283791E6F}"/>
               </a:ext>
             </a:extLst>
           </p:cNvPr>
@@ -8362,7 +8362,7 @@
           <p:cNvPr id="9" name="">
             <a:extLst xmlns:a="http://schemas.openxmlformats.org/drawingml/2006/main">
               <a:ext uri="{FF2B5EF4-FFF2-40B4-BE49-F238E27FC236}">
-                <a16:creationId xmlns:a16="http://schemas.microsoft.com/office/drawing/2014/main" id="{820A6928-9FCD-4A87-8256-F46211687BA5}"/>
+                <a16:creationId xmlns:a16="http://schemas.microsoft.com/office/drawing/2014/main" id="{176379F8-4A53-4EB1-B5B3-8920570189DA}"/>
               </a:ext>
             </a:extLst>
           </p:cNvPr>
@@ -8397,7 +8397,7 @@
           <p:cNvPr id="10" name="">
             <a:extLst xmlns:a="http://schemas.openxmlformats.org/drawingml/2006/main">
               <a:ext uri="{FF2B5EF4-FFF2-40B4-BE49-F238E27FC236}">
-                <a16:creationId xmlns:a16="http://schemas.microsoft.com/office/drawing/2014/main" id="{2AFC8B84-3F0C-441C-BFC2-17734590D385}"/>
+                <a16:creationId xmlns:a16="http://schemas.microsoft.com/office/drawing/2014/main" id="{92095085-9A7A-4C96-BFB7-BA3B2FD52E77}"/>
               </a:ext>
             </a:extLst>
           </p:cNvPr>
@@ -8461,7 +8461,7 @@
           <p:cNvPr id="11" name="">
             <a:extLst xmlns:a="http://schemas.openxmlformats.org/drawingml/2006/main">
               <a:ext uri="{FF2B5EF4-FFF2-40B4-BE49-F238E27FC236}">
-                <a16:creationId xmlns:a16="http://schemas.microsoft.com/office/drawing/2014/main" id="{E324ADD4-1738-41A8-B239-E8A2F12A931D}"/>
+                <a16:creationId xmlns:a16="http://schemas.microsoft.com/office/drawing/2014/main" id="{F9F77358-1056-4B36-ABEA-83F7DB6EA344}"/>
               </a:ext>
             </a:extLst>
           </p:cNvPr>
@@ -8518,7 +8518,7 @@
           <p:cNvPr id="12" name="">
             <a:extLst xmlns:a="http://schemas.openxmlformats.org/drawingml/2006/main">
               <a:ext uri="{FF2B5EF4-FFF2-40B4-BE49-F238E27FC236}">
-                <a16:creationId xmlns:a16="http://schemas.microsoft.com/office/drawing/2014/main" id="{F9096AA0-A939-4C6C-881A-FD38AFB4F4C3}"/>
+                <a16:creationId xmlns:a16="http://schemas.microsoft.com/office/drawing/2014/main" id="{10188762-A465-4669-A7C6-3F6D9971C9C5}"/>
               </a:ext>
             </a:extLst>
           </p:cNvPr>
@@ -8549,7 +8549,7 @@
           <p:cNvPr id="13" name="">
             <a:extLst xmlns:a="http://schemas.openxmlformats.org/drawingml/2006/main">
               <a:ext uri="{FF2B5EF4-FFF2-40B4-BE49-F238E27FC236}">
-                <a16:creationId xmlns:a16="http://schemas.microsoft.com/office/drawing/2014/main" id="{F0DB1679-3749-44C7-820B-9E8AE60E0E2E}"/>
+                <a16:creationId xmlns:a16="http://schemas.microsoft.com/office/drawing/2014/main" id="{DE34626B-1071-4AC9-A240-0ADB0146BC5F}"/>
               </a:ext>
             </a:extLst>
           </p:cNvPr>
@@ -8584,7 +8584,7 @@
           <p:cNvPr id="14" name="">
             <a:extLst xmlns:a="http://schemas.openxmlformats.org/drawingml/2006/main">
               <a:ext uri="{FF2B5EF4-FFF2-40B4-BE49-F238E27FC236}">
-                <a16:creationId xmlns:a16="http://schemas.microsoft.com/office/drawing/2014/main" id="{59D2BF60-5FEA-4442-B750-F947E28AF5B2}"/>
+                <a16:creationId xmlns:a16="http://schemas.microsoft.com/office/drawing/2014/main" id="{AA9E52E0-DA70-4425-A209-A0EA00A986E1}"/>
               </a:ext>
             </a:extLst>
           </p:cNvPr>
@@ -8648,7 +8648,7 @@
           <p:cNvPr id="15" name="">
             <a:extLst xmlns:a="http://schemas.openxmlformats.org/drawingml/2006/main">
               <a:ext uri="{FF2B5EF4-FFF2-40B4-BE49-F238E27FC236}">
-                <a16:creationId xmlns:a16="http://schemas.microsoft.com/office/drawing/2014/main" id="{F3883229-C278-4065-B017-210DCAB26126}"/>
+                <a16:creationId xmlns:a16="http://schemas.microsoft.com/office/drawing/2014/main" id="{CB5CC2CE-ED0E-47DD-9BDC-0BE79C2E4120}"/>
               </a:ext>
             </a:extLst>
           </p:cNvPr>
@@ -8705,7 +8705,7 @@
           <p:cNvPr id="16" name="">
             <a:extLst xmlns:a="http://schemas.openxmlformats.org/drawingml/2006/main">
               <a:ext uri="{FF2B5EF4-FFF2-40B4-BE49-F238E27FC236}">
-                <a16:creationId xmlns:a16="http://schemas.microsoft.com/office/drawing/2014/main" id="{4B291D06-C404-4A17-BA97-F7465C786016}"/>
+                <a16:creationId xmlns:a16="http://schemas.microsoft.com/office/drawing/2014/main" id="{40CCEFB2-93C6-4535-99CC-EE5AB2BB05E4}"/>
               </a:ext>
             </a:extLst>
           </p:cNvPr>
@@ -8736,7 +8736,7 @@
           <p:cNvPr id="17" name="">
             <a:extLst xmlns:a="http://schemas.openxmlformats.org/drawingml/2006/main">
               <a:ext uri="{FF2B5EF4-FFF2-40B4-BE49-F238E27FC236}">
-                <a16:creationId xmlns:a16="http://schemas.microsoft.com/office/drawing/2014/main" id="{31CE5301-3C21-49D5-B883-2934FF4C9DCC}"/>
+                <a16:creationId xmlns:a16="http://schemas.microsoft.com/office/drawing/2014/main" id="{5BE571B2-EECE-4D26-96A0-DD207F9A2A41}"/>
               </a:ext>
             </a:extLst>
           </p:cNvPr>
@@ -8771,7 +8771,7 @@
           <p:cNvPr id="18" name="">
             <a:extLst xmlns:a="http://schemas.openxmlformats.org/drawingml/2006/main">
               <a:ext uri="{FF2B5EF4-FFF2-40B4-BE49-F238E27FC236}">
-                <a16:creationId xmlns:a16="http://schemas.microsoft.com/office/drawing/2014/main" id="{EBF65FA7-2370-48E4-9E66-F784C3C1071E}"/>
+                <a16:creationId xmlns:a16="http://schemas.microsoft.com/office/drawing/2014/main" id="{6B5B65D4-899A-4773-89C4-D309C39EC968}"/>
               </a:ext>
             </a:extLst>
           </p:cNvPr>
@@ -8835,7 +8835,7 @@
           <p:cNvPr id="19" name="">
             <a:extLst xmlns:a="http://schemas.openxmlformats.org/drawingml/2006/main">
               <a:ext uri="{FF2B5EF4-FFF2-40B4-BE49-F238E27FC236}">
-                <a16:creationId xmlns:a16="http://schemas.microsoft.com/office/drawing/2014/main" id="{EF88B394-7C7F-47E8-B006-F5327E030390}"/>
+                <a16:creationId xmlns:a16="http://schemas.microsoft.com/office/drawing/2014/main" id="{B0C0FB42-7384-4F07-9561-007A445209AB}"/>
               </a:ext>
             </a:extLst>
           </p:cNvPr>
@@ -8892,7 +8892,7 @@
           <p:cNvPr id="20" name="">
             <a:extLst xmlns:a="http://schemas.openxmlformats.org/drawingml/2006/main">
               <a:ext uri="{FF2B5EF4-FFF2-40B4-BE49-F238E27FC236}">
-                <a16:creationId xmlns:a16="http://schemas.microsoft.com/office/drawing/2014/main" id="{72B19003-E358-4DE9-9DAF-A10F28FFEE77}"/>
+                <a16:creationId xmlns:a16="http://schemas.microsoft.com/office/drawing/2014/main" id="{60A069CC-A96F-44F4-946E-52C3CE955ABB}"/>
               </a:ext>
             </a:extLst>
           </p:cNvPr>
@@ -8927,7 +8927,7 @@
           <p:cNvPr id="21" name="">
             <a:extLst xmlns:a="http://schemas.openxmlformats.org/drawingml/2006/main">
               <a:ext uri="{FF2B5EF4-FFF2-40B4-BE49-F238E27FC236}">
-                <a16:creationId xmlns:a16="http://schemas.microsoft.com/office/drawing/2014/main" id="{79B128E0-8828-49F7-B045-E73DFA697845}"/>
+                <a16:creationId xmlns:a16="http://schemas.microsoft.com/office/drawing/2014/main" id="{F0A16803-C34B-4D77-808F-F349DF20B128}"/>
               </a:ext>
             </a:extLst>
           </p:cNvPr>
@@ -8984,7 +8984,7 @@
           <p:cNvPr id="22" name="">
             <a:extLst xmlns:a="http://schemas.openxmlformats.org/drawingml/2006/main">
               <a:ext uri="{FF2B5EF4-FFF2-40B4-BE49-F238E27FC236}">
-                <a16:creationId xmlns:a16="http://schemas.microsoft.com/office/drawing/2014/main" id="{6813F79B-3EB6-42DF-BE1E-FA820CEDF20A}"/>
+                <a16:creationId xmlns:a16="http://schemas.microsoft.com/office/drawing/2014/main" id="{F4EBF568-19CB-4260-9860-0E4034E97837}"/>
               </a:ext>
             </a:extLst>
           </p:cNvPr>
@@ -9041,7 +9041,7 @@
           <p:cNvPr id="23" name="">
             <a:extLst xmlns:a="http://schemas.openxmlformats.org/drawingml/2006/main">
               <a:ext uri="{FF2B5EF4-FFF2-40B4-BE49-F238E27FC236}">
-                <a16:creationId xmlns:a16="http://schemas.microsoft.com/office/drawing/2014/main" id="{D8C1718D-C744-467F-9996-653FFF7A9A6C}"/>
+                <a16:creationId xmlns:a16="http://schemas.microsoft.com/office/drawing/2014/main" id="{7F351274-E12E-4104-B98C-BE5CB5DC1A36}"/>
               </a:ext>
             </a:extLst>
           </p:cNvPr>
@@ -9076,7 +9076,7 @@
           <p:cNvPr id="24" name="">
             <a:extLst xmlns:a="http://schemas.openxmlformats.org/drawingml/2006/main">
               <a:ext uri="{FF2B5EF4-FFF2-40B4-BE49-F238E27FC236}">
-                <a16:creationId xmlns:a16="http://schemas.microsoft.com/office/drawing/2014/main" id="{69CCFFFF-56FF-44B6-AB1B-793CFDE172DF}"/>
+                <a16:creationId xmlns:a16="http://schemas.microsoft.com/office/drawing/2014/main" id="{94A3AE2A-1366-45D2-8EC4-D4099ADB151B}"/>
               </a:ext>
             </a:extLst>
           </p:cNvPr>
@@ -9140,7 +9140,7 @@
           <p:cNvPr id="25" name="">
             <a:extLst xmlns:a="http://schemas.openxmlformats.org/drawingml/2006/main">
               <a:ext uri="{FF2B5EF4-FFF2-40B4-BE49-F238E27FC236}">
-                <a16:creationId xmlns:a16="http://schemas.microsoft.com/office/drawing/2014/main" id="{0DAE61BD-D824-4FF3-9047-7EBC4F00BF8D}"/>
+                <a16:creationId xmlns:a16="http://schemas.microsoft.com/office/drawing/2014/main" id="{B3A4B5F9-2F4A-48DF-A99F-E55BA9AAAE78}"/>
               </a:ext>
             </a:extLst>
           </p:cNvPr>
@@ -9266,7 +9266,7 @@
           <p:cNvPr id="26" name="">
             <a:extLst xmlns:a="http://schemas.openxmlformats.org/drawingml/2006/main">
               <a:ext uri="{FF2B5EF4-FFF2-40B4-BE49-F238E27FC236}">
-                <a16:creationId xmlns:a16="http://schemas.microsoft.com/office/drawing/2014/main" id="{06F01EB9-AC40-460C-97D9-DD2836C43390}"/>
+                <a16:creationId xmlns:a16="http://schemas.microsoft.com/office/drawing/2014/main" id="{FBB37E95-38B9-495F-BCC3-38AF8F69D91B}"/>
               </a:ext>
             </a:extLst>
           </p:cNvPr>
@@ -9301,7 +9301,7 @@
           <p:cNvPr id="27" name="">
             <a:extLst xmlns:a="http://schemas.openxmlformats.org/drawingml/2006/main">
               <a:ext uri="{FF2B5EF4-FFF2-40B4-BE49-F238E27FC236}">
-                <a16:creationId xmlns:a16="http://schemas.microsoft.com/office/drawing/2014/main" id="{EBDD9581-CDF5-4F00-B8A5-3E91F4430D9D}"/>
+                <a16:creationId xmlns:a16="http://schemas.microsoft.com/office/drawing/2014/main" id="{CE58BB36-ACE0-454A-A64A-43A312CC7645}"/>
               </a:ext>
             </a:extLst>
           </p:cNvPr>
@@ -9365,7 +9365,7 @@
           <p:cNvPr id="28" name="">
             <a:extLst xmlns:a="http://schemas.openxmlformats.org/drawingml/2006/main">
               <a:ext uri="{FF2B5EF4-FFF2-40B4-BE49-F238E27FC236}">
-                <a16:creationId xmlns:a16="http://schemas.microsoft.com/office/drawing/2014/main" id="{26CE9218-58B9-4B82-AD09-08CB8ADC4856}"/>
+                <a16:creationId xmlns:a16="http://schemas.microsoft.com/office/drawing/2014/main" id="{0C890F10-B39E-418A-A9F9-A6C745E9B347}"/>
               </a:ext>
             </a:extLst>
           </p:cNvPr>
@@ -9468,7 +9468,7 @@
           <p:cNvPr id="29" name="">
             <a:extLst xmlns:a="http://schemas.openxmlformats.org/drawingml/2006/main">
               <a:ext uri="{FF2B5EF4-FFF2-40B4-BE49-F238E27FC236}">
-                <a16:creationId xmlns:a16="http://schemas.microsoft.com/office/drawing/2014/main" id="{CE293CC4-740D-4555-9475-44EFD140BBB1}"/>
+                <a16:creationId xmlns:a16="http://schemas.microsoft.com/office/drawing/2014/main" id="{63396698-9F03-4584-BA61-EC5F6978CBD9}"/>
               </a:ext>
             </a:extLst>
           </p:cNvPr>
@@ -9548,7 +9548,7 @@
           <p:cNvPr id="30" name="">
             <a:extLst xmlns:a="http://schemas.openxmlformats.org/drawingml/2006/main">
               <a:ext uri="{FF2B5EF4-FFF2-40B4-BE49-F238E27FC236}">
-                <a16:creationId xmlns:a16="http://schemas.microsoft.com/office/drawing/2014/main" id="{0AC8672B-05F0-4CE5-90D5-EE8411A1B3CA}"/>
+                <a16:creationId xmlns:a16="http://schemas.microsoft.com/office/drawing/2014/main" id="{222AC306-52FE-44A0-BFA7-117DB72B4800}"/>
               </a:ext>
             </a:extLst>
           </p:cNvPr>
@@ -9605,7 +9605,7 @@
           <p:cNvPr id="31" name="">
             <a:extLst xmlns:a="http://schemas.openxmlformats.org/drawingml/2006/main">
               <a:ext uri="{FF2B5EF4-FFF2-40B4-BE49-F238E27FC236}">
-                <a16:creationId xmlns:a16="http://schemas.microsoft.com/office/drawing/2014/main" id="{EE6E2ED9-4EC1-4561-96E1-79680A2D9F25}"/>
+                <a16:creationId xmlns:a16="http://schemas.microsoft.com/office/drawing/2014/main" id="{8D9952E3-9B6E-492B-8637-A577A7E0AEE3}"/>
               </a:ext>
             </a:extLst>
           </p:cNvPr>
@@ -9660,7 +9660,7 @@
     </p:spTree>
     <p:extLst>
       <p:ext uri="{BB962C8B-B14F-4D97-AF65-F5344CB8AC3E}">
-        <p14:creationId xmlns:p14="http://schemas.microsoft.com/office/powerpoint/2010/main" val="270160168"/>
+        <p14:creationId xmlns:p14="http://schemas.microsoft.com/office/powerpoint/2010/main" val="1572335420"/>
       </p:ext>
     </p:extLst>
   </p:cSld>
@@ -9691,7 +9691,7 @@
           <p:cNvPr id="36" name="">
             <a:extLst xmlns:a="http://schemas.openxmlformats.org/drawingml/2006/main">
               <a:ext uri="{FF2B5EF4-FFF2-40B4-BE49-F238E27FC236}">
-                <a16:creationId xmlns:a16="http://schemas.microsoft.com/office/drawing/2014/main" id="{D1153A7D-21BC-42A5-853F-C81409D2CA3F}"/>
+                <a16:creationId xmlns:a16="http://schemas.microsoft.com/office/drawing/2014/main" id="{7A5FF4C6-4262-43DC-96FF-9095DE2FB38A}"/>
               </a:ext>
             </a:extLst>
           </p:cNvPr>
@@ -9748,7 +9748,7 @@
           <p:cNvPr id="2" name="">
             <a:extLst xmlns:a="http://schemas.openxmlformats.org/drawingml/2006/main">
               <a:ext uri="{FF2B5EF4-FFF2-40B4-BE49-F238E27FC236}">
-                <a16:creationId xmlns:a16="http://schemas.microsoft.com/office/drawing/2014/main" id="{355BE700-97EC-4156-9D08-86BB22B62B85}"/>
+                <a16:creationId xmlns:a16="http://schemas.microsoft.com/office/drawing/2014/main" id="{66BFA159-4757-48FD-AA19-E2FE85657BE7}"/>
               </a:ext>
             </a:extLst>
           </p:cNvPr>
@@ -9805,7 +9805,7 @@
           <p:cNvPr id="3" name="">
             <a:extLst xmlns:a="http://schemas.openxmlformats.org/drawingml/2006/main">
               <a:ext uri="{FF2B5EF4-FFF2-40B4-BE49-F238E27FC236}">
-                <a16:creationId xmlns:a16="http://schemas.microsoft.com/office/drawing/2014/main" id="{B78C9997-225B-4F0B-8B8C-D5211C380DA9}"/>
+                <a16:creationId xmlns:a16="http://schemas.microsoft.com/office/drawing/2014/main" id="{0E557CA1-F240-4DF6-A2C5-5B9A5BA97994}"/>
               </a:ext>
             </a:extLst>
           </p:cNvPr>
@@ -9862,7 +9862,7 @@
           <p:cNvPr id="4" name="">
             <a:extLst xmlns:a="http://schemas.openxmlformats.org/drawingml/2006/main">
               <a:ext uri="{FF2B5EF4-FFF2-40B4-BE49-F238E27FC236}">
-                <a16:creationId xmlns:a16="http://schemas.microsoft.com/office/drawing/2014/main" id="{E36C8240-EE10-412B-AF3F-2B45366637BF}"/>
+                <a16:creationId xmlns:a16="http://schemas.microsoft.com/office/drawing/2014/main" id="{383ADD7F-9B48-4D68-852E-B3E6226EB792}"/>
               </a:ext>
             </a:extLst>
           </p:cNvPr>
@@ -9893,7 +9893,7 @@
           <p:cNvPr id="5" name="">
             <a:extLst xmlns:a="http://schemas.openxmlformats.org/drawingml/2006/main">
               <a:ext uri="{FF2B5EF4-FFF2-40B4-BE49-F238E27FC236}">
-                <a16:creationId xmlns:a16="http://schemas.microsoft.com/office/drawing/2014/main" id="{DCB61C20-9F37-4BE9-B830-8BFE7F5611E0}"/>
+                <a16:creationId xmlns:a16="http://schemas.microsoft.com/office/drawing/2014/main" id="{91F82373-114D-46D2-99D5-722090F78DB6}"/>
               </a:ext>
             </a:extLst>
           </p:cNvPr>
@@ -9928,7 +9928,7 @@
           <p:cNvPr id="6" name="">
             <a:extLst xmlns:a="http://schemas.openxmlformats.org/drawingml/2006/main">
               <a:ext uri="{FF2B5EF4-FFF2-40B4-BE49-F238E27FC236}">
-                <a16:creationId xmlns:a16="http://schemas.microsoft.com/office/drawing/2014/main" id="{1B5B6F66-D40C-4EC6-9C80-DDEFDCBD6BC7}"/>
+                <a16:creationId xmlns:a16="http://schemas.microsoft.com/office/drawing/2014/main" id="{8A0F6494-6F50-408A-9F08-94003890394F}"/>
               </a:ext>
             </a:extLst>
           </p:cNvPr>
@@ -9992,7 +9992,7 @@
           <p:cNvPr id="7" name="">
             <a:extLst xmlns:a="http://schemas.openxmlformats.org/drawingml/2006/main">
               <a:ext uri="{FF2B5EF4-FFF2-40B4-BE49-F238E27FC236}">
-                <a16:creationId xmlns:a16="http://schemas.microsoft.com/office/drawing/2014/main" id="{ED7CD699-D236-4F1D-90F2-4E3494DD1C61}"/>
+                <a16:creationId xmlns:a16="http://schemas.microsoft.com/office/drawing/2014/main" id="{8D571B3D-9A6A-4F34-A4FE-60953B89FBE3}"/>
               </a:ext>
             </a:extLst>
           </p:cNvPr>
@@ -10049,7 +10049,7 @@
           <p:cNvPr id="8" name="">
             <a:extLst xmlns:a="http://schemas.openxmlformats.org/drawingml/2006/main">
               <a:ext uri="{FF2B5EF4-FFF2-40B4-BE49-F238E27FC236}">
-                <a16:creationId xmlns:a16="http://schemas.microsoft.com/office/drawing/2014/main" id="{AA39AAD5-A4F5-4F62-888A-A2CBA4116B18}"/>
+                <a16:creationId xmlns:a16="http://schemas.microsoft.com/office/drawing/2014/main" id="{2FBE3742-2018-443B-AA38-D0384018013D}"/>
               </a:ext>
             </a:extLst>
           </p:cNvPr>
@@ -10084,7 +10084,7 @@
           <p:cNvPr id="9" name="">
             <a:extLst xmlns:a="http://schemas.openxmlformats.org/drawingml/2006/main">
               <a:ext uri="{FF2B5EF4-FFF2-40B4-BE49-F238E27FC236}">
-                <a16:creationId xmlns:a16="http://schemas.microsoft.com/office/drawing/2014/main" id="{24F10821-D9A9-4753-971C-EE955C4AE7AE}"/>
+                <a16:creationId xmlns:a16="http://schemas.microsoft.com/office/drawing/2014/main" id="{5E5A69C8-3D39-47D0-BA22-92CCE80786C3}"/>
               </a:ext>
             </a:extLst>
           </p:cNvPr>
@@ -10148,7 +10148,7 @@
           <p:cNvPr id="10" name="">
             <a:extLst xmlns:a="http://schemas.openxmlformats.org/drawingml/2006/main">
               <a:ext uri="{FF2B5EF4-FFF2-40B4-BE49-F238E27FC236}">
-                <a16:creationId xmlns:a16="http://schemas.microsoft.com/office/drawing/2014/main" id="{E687C48A-6F5A-4403-941A-9D002EF11BFA}"/>
+                <a16:creationId xmlns:a16="http://schemas.microsoft.com/office/drawing/2014/main" id="{E1DB9878-9823-4B2D-BFB6-BCA4344CC35B}"/>
               </a:ext>
             </a:extLst>
           </p:cNvPr>
@@ -10205,7 +10205,7 @@
           <p:cNvPr id="11" name="">
             <a:extLst xmlns:a="http://schemas.openxmlformats.org/drawingml/2006/main">
               <a:ext uri="{FF2B5EF4-FFF2-40B4-BE49-F238E27FC236}">
-                <a16:creationId xmlns:a16="http://schemas.microsoft.com/office/drawing/2014/main" id="{E8CDA833-2FF6-4149-ADAB-FAA679760577}"/>
+                <a16:creationId xmlns:a16="http://schemas.microsoft.com/office/drawing/2014/main" id="{F8E6AA52-8A5C-448A-8EFD-C7B1911B18E3}"/>
               </a:ext>
             </a:extLst>
           </p:cNvPr>
@@ -10240,7 +10240,7 @@
           <p:cNvPr id="12" name="">
             <a:extLst xmlns:a="http://schemas.openxmlformats.org/drawingml/2006/main">
               <a:ext uri="{FF2B5EF4-FFF2-40B4-BE49-F238E27FC236}">
-                <a16:creationId xmlns:a16="http://schemas.microsoft.com/office/drawing/2014/main" id="{BF530D96-A07D-4BB8-AAD2-234CEE5B3719}"/>
+                <a16:creationId xmlns:a16="http://schemas.microsoft.com/office/drawing/2014/main" id="{7A9C1C48-AC97-4F84-98C5-E8F0EDBBECFF}"/>
               </a:ext>
             </a:extLst>
           </p:cNvPr>
@@ -10304,7 +10304,7 @@
           <p:cNvPr id="13" name="">
             <a:extLst xmlns:a="http://schemas.openxmlformats.org/drawingml/2006/main">
               <a:ext uri="{FF2B5EF4-FFF2-40B4-BE49-F238E27FC236}">
-                <a16:creationId xmlns:a16="http://schemas.microsoft.com/office/drawing/2014/main" id="{8031FF5C-0EC2-4E42-8194-DAA8D859DE4C}"/>
+                <a16:creationId xmlns:a16="http://schemas.microsoft.com/office/drawing/2014/main" id="{98796AA6-47A5-49FE-81E5-3D66CC1D4528}"/>
               </a:ext>
             </a:extLst>
           </p:cNvPr>
@@ -10361,7 +10361,7 @@
           <p:cNvPr id="14" name="">
             <a:extLst xmlns:a="http://schemas.openxmlformats.org/drawingml/2006/main">
               <a:ext uri="{FF2B5EF4-FFF2-40B4-BE49-F238E27FC236}">
-                <a16:creationId xmlns:a16="http://schemas.microsoft.com/office/drawing/2014/main" id="{B40638AC-5564-4D40-A399-04C8538B4949}"/>
+                <a16:creationId xmlns:a16="http://schemas.microsoft.com/office/drawing/2014/main" id="{BCF14707-2E3F-4F52-A9C4-44F1527A12A6}"/>
               </a:ext>
             </a:extLst>
           </p:cNvPr>
@@ -10396,7 +10396,7 @@
           <p:cNvPr id="15" name="">
             <a:extLst xmlns:a="http://schemas.openxmlformats.org/drawingml/2006/main">
               <a:ext uri="{FF2B5EF4-FFF2-40B4-BE49-F238E27FC236}">
-                <a16:creationId xmlns:a16="http://schemas.microsoft.com/office/drawing/2014/main" id="{325DF851-15F9-4445-86E9-933BCBC614AD}"/>
+                <a16:creationId xmlns:a16="http://schemas.microsoft.com/office/drawing/2014/main" id="{8F862A17-0694-4BCF-B799-51DE20AEF1A2}"/>
               </a:ext>
             </a:extLst>
           </p:cNvPr>
@@ -10460,7 +10460,7 @@
           <p:cNvPr id="16" name="">
             <a:extLst xmlns:a="http://schemas.openxmlformats.org/drawingml/2006/main">
               <a:ext uri="{FF2B5EF4-FFF2-40B4-BE49-F238E27FC236}">
-                <a16:creationId xmlns:a16="http://schemas.microsoft.com/office/drawing/2014/main" id="{577FE7BA-9571-41FC-8A8E-D1BFD382E0FA}"/>
+                <a16:creationId xmlns:a16="http://schemas.microsoft.com/office/drawing/2014/main" id="{1B3A8561-22A9-46ED-837F-7524BA744016}"/>
               </a:ext>
             </a:extLst>
           </p:cNvPr>
@@ -10517,7 +10517,7 @@
           <p:cNvPr id="17" name="">
             <a:extLst xmlns:a="http://schemas.openxmlformats.org/drawingml/2006/main">
               <a:ext uri="{FF2B5EF4-FFF2-40B4-BE49-F238E27FC236}">
-                <a16:creationId xmlns:a16="http://schemas.microsoft.com/office/drawing/2014/main" id="{0BA93D6B-9B5D-4353-B6BD-FF577933AC35}"/>
+                <a16:creationId xmlns:a16="http://schemas.microsoft.com/office/drawing/2014/main" id="{25FBB635-92C6-4FA6-A11A-BB9828857199}"/>
               </a:ext>
             </a:extLst>
           </p:cNvPr>
@@ -10552,7 +10552,7 @@
           <p:cNvPr id="18" name="">
             <a:extLst xmlns:a="http://schemas.openxmlformats.org/drawingml/2006/main">
               <a:ext uri="{FF2B5EF4-FFF2-40B4-BE49-F238E27FC236}">
-                <a16:creationId xmlns:a16="http://schemas.microsoft.com/office/drawing/2014/main" id="{82055495-43B2-4189-A29E-AA160EC9C024}"/>
+                <a16:creationId xmlns:a16="http://schemas.microsoft.com/office/drawing/2014/main" id="{EB26FE05-DA4E-4D82-ADAA-710A2526A37D}"/>
               </a:ext>
             </a:extLst>
           </p:cNvPr>
@@ -10616,7 +10616,7 @@
           <p:cNvPr id="19" name="">
             <a:extLst xmlns:a="http://schemas.openxmlformats.org/drawingml/2006/main">
               <a:ext uri="{FF2B5EF4-FFF2-40B4-BE49-F238E27FC236}">
-                <a16:creationId xmlns:a16="http://schemas.microsoft.com/office/drawing/2014/main" id="{0CEF1CA5-F63B-4BBD-90B4-93AAAD689C1C}"/>
+                <a16:creationId xmlns:a16="http://schemas.microsoft.com/office/drawing/2014/main" id="{97FF0538-0607-4F93-BB51-763FA5956B99}"/>
               </a:ext>
             </a:extLst>
           </p:cNvPr>
@@ -10673,7 +10673,7 @@
           <p:cNvPr id="20" name="">
             <a:extLst xmlns:a="http://schemas.openxmlformats.org/drawingml/2006/main">
               <a:ext uri="{FF2B5EF4-FFF2-40B4-BE49-F238E27FC236}">
-                <a16:creationId xmlns:a16="http://schemas.microsoft.com/office/drawing/2014/main" id="{3EA14599-6BBE-45E4-9848-2F6F56854D5D}"/>
+                <a16:creationId xmlns:a16="http://schemas.microsoft.com/office/drawing/2014/main" id="{881FC1AB-88F3-441B-9896-A77442E68827}"/>
               </a:ext>
             </a:extLst>
           </p:cNvPr>
@@ -10708,7 +10708,7 @@
           <p:cNvPr id="21" name="">
             <a:extLst xmlns:a="http://schemas.openxmlformats.org/drawingml/2006/main">
               <a:ext uri="{FF2B5EF4-FFF2-40B4-BE49-F238E27FC236}">
-                <a16:creationId xmlns:a16="http://schemas.microsoft.com/office/drawing/2014/main" id="{DFBEF7B9-AF8A-4A12-9ECB-9B9D2759171B}"/>
+                <a16:creationId xmlns:a16="http://schemas.microsoft.com/office/drawing/2014/main" id="{E3A64EF1-5236-461A-B3DA-8CEDB9405191}"/>
               </a:ext>
             </a:extLst>
           </p:cNvPr>
@@ -10765,7 +10765,7 @@
           <p:cNvPr id="22" name="">
             <a:extLst xmlns:a="http://schemas.openxmlformats.org/drawingml/2006/main">
               <a:ext uri="{FF2B5EF4-FFF2-40B4-BE49-F238E27FC236}">
-                <a16:creationId xmlns:a16="http://schemas.microsoft.com/office/drawing/2014/main" id="{8625E500-1BB4-4720-801E-46E4BF680523}"/>
+                <a16:creationId xmlns:a16="http://schemas.microsoft.com/office/drawing/2014/main" id="{A26DF04C-C9A4-4197-B8B0-871A63AE755F}"/>
               </a:ext>
             </a:extLst>
           </p:cNvPr>
@@ -10829,7 +10829,7 @@
           <p:cNvPr id="23" name="">
             <a:extLst xmlns:a="http://schemas.openxmlformats.org/drawingml/2006/main">
               <a:ext uri="{FF2B5EF4-FFF2-40B4-BE49-F238E27FC236}">
-                <a16:creationId xmlns:a16="http://schemas.microsoft.com/office/drawing/2014/main" id="{ABB971AA-0617-4E93-AC79-CF3633575636}"/>
+                <a16:creationId xmlns:a16="http://schemas.microsoft.com/office/drawing/2014/main" id="{EA665283-B358-462C-AC76-5079313790B6}"/>
               </a:ext>
             </a:extLst>
           </p:cNvPr>
@@ -10886,7 +10886,7 @@
           <p:cNvPr id="24" name="">
             <a:extLst xmlns:a="http://schemas.openxmlformats.org/drawingml/2006/main">
               <a:ext uri="{FF2B5EF4-FFF2-40B4-BE49-F238E27FC236}">
-                <a16:creationId xmlns:a16="http://schemas.microsoft.com/office/drawing/2014/main" id="{B76EC965-401A-48F6-8E3A-7CCF2160FBDA}"/>
+                <a16:creationId xmlns:a16="http://schemas.microsoft.com/office/drawing/2014/main" id="{F52FF20D-1281-4B6A-9327-96FB0937C8EB}"/>
               </a:ext>
             </a:extLst>
           </p:cNvPr>
@@ -10950,7 +10950,7 @@
           <p:cNvPr id="25" name="">
             <a:extLst xmlns:a="http://schemas.openxmlformats.org/drawingml/2006/main">
               <a:ext uri="{FF2B5EF4-FFF2-40B4-BE49-F238E27FC236}">
-                <a16:creationId xmlns:a16="http://schemas.microsoft.com/office/drawing/2014/main" id="{0227D9C3-A13D-4A2F-A442-93236500BAA5}"/>
+                <a16:creationId xmlns:a16="http://schemas.microsoft.com/office/drawing/2014/main" id="{0AD711E5-11D2-4A09-AF35-95D04753440B}"/>
               </a:ext>
             </a:extLst>
           </p:cNvPr>
@@ -11007,7 +11007,7 @@
           <p:cNvPr id="26" name="">
             <a:extLst xmlns:a="http://schemas.openxmlformats.org/drawingml/2006/main">
               <a:ext uri="{FF2B5EF4-FFF2-40B4-BE49-F238E27FC236}">
-                <a16:creationId xmlns:a16="http://schemas.microsoft.com/office/drawing/2014/main" id="{61CF745E-AAD1-423E-834E-FF519D1F8CF6}"/>
+                <a16:creationId xmlns:a16="http://schemas.microsoft.com/office/drawing/2014/main" id="{E970B15B-EC01-450F-851D-FA02B14B2564}"/>
               </a:ext>
             </a:extLst>
           </p:cNvPr>
@@ -11071,7 +11071,7 @@
           <p:cNvPr id="27" name="">
             <a:extLst xmlns:a="http://schemas.openxmlformats.org/drawingml/2006/main">
               <a:ext uri="{FF2B5EF4-FFF2-40B4-BE49-F238E27FC236}">
-                <a16:creationId xmlns:a16="http://schemas.microsoft.com/office/drawing/2014/main" id="{FB38D1F9-64CA-4B5D-AF7B-17523A3645E8}"/>
+                <a16:creationId xmlns:a16="http://schemas.microsoft.com/office/drawing/2014/main" id="{BF3BD751-F013-4269-A8B3-F3446A270AB1}"/>
               </a:ext>
             </a:extLst>
           </p:cNvPr>
@@ -11128,7 +11128,7 @@
           <p:cNvPr id="28" name="">
             <a:extLst xmlns:a="http://schemas.openxmlformats.org/drawingml/2006/main">
               <a:ext uri="{FF2B5EF4-FFF2-40B4-BE49-F238E27FC236}">
-                <a16:creationId xmlns:a16="http://schemas.microsoft.com/office/drawing/2014/main" id="{4947D859-BBF5-4651-86A4-2E4DA4638AEC}"/>
+                <a16:creationId xmlns:a16="http://schemas.microsoft.com/office/drawing/2014/main" id="{BFFC21DE-9962-4744-BFEE-82B01CDE3248}"/>
               </a:ext>
             </a:extLst>
           </p:cNvPr>
@@ -11192,7 +11192,7 @@
           <p:cNvPr id="29" name="">
             <a:extLst xmlns:a="http://schemas.openxmlformats.org/drawingml/2006/main">
               <a:ext uri="{FF2B5EF4-FFF2-40B4-BE49-F238E27FC236}">
-                <a16:creationId xmlns:a16="http://schemas.microsoft.com/office/drawing/2014/main" id="{21B3E587-57D1-43A2-9ACD-3CE4D779EF43}"/>
+                <a16:creationId xmlns:a16="http://schemas.microsoft.com/office/drawing/2014/main" id="{1C00491C-6C38-4415-9EE8-5C2385791948}"/>
               </a:ext>
             </a:extLst>
           </p:cNvPr>
@@ -11249,7 +11249,7 @@
           <p:cNvPr id="30" name="">
             <a:extLst xmlns:a="http://schemas.openxmlformats.org/drawingml/2006/main">
               <a:ext uri="{FF2B5EF4-FFF2-40B4-BE49-F238E27FC236}">
-                <a16:creationId xmlns:a16="http://schemas.microsoft.com/office/drawing/2014/main" id="{60B6D510-0D08-40B3-AEF7-3C973A484B96}"/>
+                <a16:creationId xmlns:a16="http://schemas.microsoft.com/office/drawing/2014/main" id="{5B710DDF-2598-444B-A7B1-09869654BDE0}"/>
               </a:ext>
             </a:extLst>
           </p:cNvPr>
@@ -11284,7 +11284,7 @@
           <p:cNvPr id="31" name="">
             <a:extLst xmlns:a="http://schemas.openxmlformats.org/drawingml/2006/main">
               <a:ext uri="{FF2B5EF4-FFF2-40B4-BE49-F238E27FC236}">
-                <a16:creationId xmlns:a16="http://schemas.microsoft.com/office/drawing/2014/main" id="{EDFDF691-E507-43B1-B2E3-5880243D2673}"/>
+                <a16:creationId xmlns:a16="http://schemas.microsoft.com/office/drawing/2014/main" id="{9241FADA-FEAC-43F2-9CB6-60674E26BEFE}"/>
               </a:ext>
             </a:extLst>
           </p:cNvPr>
@@ -11341,7 +11341,7 @@
           <p:cNvPr id="32" name="">
             <a:extLst xmlns:a="http://schemas.openxmlformats.org/drawingml/2006/main">
               <a:ext uri="{FF2B5EF4-FFF2-40B4-BE49-F238E27FC236}">
-                <a16:creationId xmlns:a16="http://schemas.microsoft.com/office/drawing/2014/main" id="{A333392F-5921-47F0-ADB8-5AFA77650B61}"/>
+                <a16:creationId xmlns:a16="http://schemas.microsoft.com/office/drawing/2014/main" id="{A473035A-286D-4F8A-B51D-0EEECE919F3E}"/>
               </a:ext>
             </a:extLst>
           </p:cNvPr>
@@ -11444,7 +11444,7 @@
           <p:cNvPr id="33" name="">
             <a:extLst xmlns:a="http://schemas.openxmlformats.org/drawingml/2006/main">
               <a:ext uri="{FF2B5EF4-FFF2-40B4-BE49-F238E27FC236}">
-                <a16:creationId xmlns:a16="http://schemas.microsoft.com/office/drawing/2014/main" id="{C8303F4D-91F3-4730-9094-18F127B935B5}"/>
+                <a16:creationId xmlns:a16="http://schemas.microsoft.com/office/drawing/2014/main" id="{AA59505F-5C53-4DD0-BDCC-6DF4A305994B}"/>
               </a:ext>
             </a:extLst>
           </p:cNvPr>
@@ -11501,7 +11501,7 @@
           <p:cNvPr id="34" name="">
             <a:extLst xmlns:a="http://schemas.openxmlformats.org/drawingml/2006/main">
               <a:ext uri="{FF2B5EF4-FFF2-40B4-BE49-F238E27FC236}">
-                <a16:creationId xmlns:a16="http://schemas.microsoft.com/office/drawing/2014/main" id="{4BEC85A1-61F7-4A59-BE8E-52314B08DEF3}"/>
+                <a16:creationId xmlns:a16="http://schemas.microsoft.com/office/drawing/2014/main" id="{EDBD8E8A-456D-4E24-8F93-0980288EA02F}"/>
               </a:ext>
             </a:extLst>
           </p:cNvPr>
@@ -11558,7 +11558,7 @@
           <p:cNvPr id="35" name="">
             <a:extLst xmlns:a="http://schemas.openxmlformats.org/drawingml/2006/main">
               <a:ext uri="{FF2B5EF4-FFF2-40B4-BE49-F238E27FC236}">
-                <a16:creationId xmlns:a16="http://schemas.microsoft.com/office/drawing/2014/main" id="{FAE07578-2CF7-4FF7-A66D-2FD42C1432C2}"/>
+                <a16:creationId xmlns:a16="http://schemas.microsoft.com/office/drawing/2014/main" id="{35C8DBCE-D81D-4FE9-8F59-02DA299A17E1}"/>
               </a:ext>
             </a:extLst>
           </p:cNvPr>
@@ -11613,7 +11613,7 @@
     </p:spTree>
     <p:extLst>
       <p:ext uri="{BB962C8B-B14F-4D97-AF65-F5344CB8AC3E}">
-        <p14:creationId xmlns:p14="http://schemas.microsoft.com/office/powerpoint/2010/main" val="1603463581"/>
+        <p14:creationId xmlns:p14="http://schemas.microsoft.com/office/powerpoint/2010/main" val="74472506"/>
       </p:ext>
     </p:extLst>
   </p:cSld>

</xml_diff>

<commit_message>
docs: sync final submission artifacts
</commit_message>
<xml_diff>
--- a/AURA/submission/AURA_5_SLIDES.pptx
+++ b/AURA/submission/AURA_5_SLIDES.pptx
@@ -2,17 +2,17 @@
 <file path=ppt/presentation.xml><?xml version="1.0" encoding="utf-8"?>
 <p:presentation xmlns:p="http://schemas.openxmlformats.org/presentationml/2006/main">
   <p:sldMasterIdLst>
-    <p:sldMasterId xmlns:r="http://schemas.openxmlformats.org/officeDocument/2006/relationships" id="2147483648" r:id="R293e2bd8699c4258"/>
+    <p:sldMasterId xmlns:r="http://schemas.openxmlformats.org/officeDocument/2006/relationships" id="2147483648" r:id="R8faf2e5cb38a4f3b"/>
   </p:sldMasterIdLst>
   <p:notesMasterIdLst>
-    <p:notesMasterId xmlns:r="http://schemas.openxmlformats.org/officeDocument/2006/relationships" r:id="Re92d0274163a4bc2"/>
+    <p:notesMasterId xmlns:r="http://schemas.openxmlformats.org/officeDocument/2006/relationships" r:id="Rd1c3ea1e60cd4e46"/>
   </p:notesMasterIdLst>
   <p:sldIdLst>
-    <p:sldId xmlns:r="http://schemas.openxmlformats.org/officeDocument/2006/relationships" id="256" r:id="Rfd14b3f43f6b4faa"/>
-    <p:sldId xmlns:r="http://schemas.openxmlformats.org/officeDocument/2006/relationships" id="257" r:id="Rb037570878a943af"/>
-    <p:sldId xmlns:r="http://schemas.openxmlformats.org/officeDocument/2006/relationships" id="258" r:id="R95b93b390e1b4423"/>
-    <p:sldId xmlns:r="http://schemas.openxmlformats.org/officeDocument/2006/relationships" id="259" r:id="R02580779994f41df"/>
-    <p:sldId xmlns:r="http://schemas.openxmlformats.org/officeDocument/2006/relationships" id="260" r:id="Rfaba4b4a3e454641"/>
+    <p:sldId xmlns:r="http://schemas.openxmlformats.org/officeDocument/2006/relationships" id="256" r:id="Rb8ce3629262541d8"/>
+    <p:sldId xmlns:r="http://schemas.openxmlformats.org/officeDocument/2006/relationships" id="257" r:id="Ra2b5673a09c84615"/>
+    <p:sldId xmlns:r="http://schemas.openxmlformats.org/officeDocument/2006/relationships" id="258" r:id="R219500a06ee14d02"/>
+    <p:sldId xmlns:r="http://schemas.openxmlformats.org/officeDocument/2006/relationships" id="259" r:id="R8d84d0ceec86480c"/>
+    <p:sldId xmlns:r="http://schemas.openxmlformats.org/officeDocument/2006/relationships" id="260" r:id="R9f2d53cb025d467a"/>
   </p:sldIdLst>
   <p:sldSz cx="12192000" cy="6858000"/>
   <p:notesSz cx="6858000" cy="9144000"/>
@@ -586,7 +586,7 @@
           <a:lstStyle xmlns:a="http://schemas.openxmlformats.org/drawingml/2006/main"/>
           <a:p xmlns:a="http://schemas.openxmlformats.org/drawingml/2006/main">
             <a:r>
-              <a:t>Nguồn cập nhật 06/10/2026: source hậu holdout đạt 122/122 test offline. Live 1f4b3c9 đạt health 5/5, security 6/6, Verify 5/5, workflow fixture 2/2 và Audit UTC+7; điện thoại thật 4G vẫn là gate trước public URL. Official holdout thật một lượt: raw 10/15, adjusted 11/15 do một nhãn người sai, một missed escalation và không có system error. Đây là mẫu nhỏ, không phải accuracy production; ba user session vẫn là gate.</a:t>
+              <a:t>Nguồn cập nhật 11/10/2026: 142/142 test offline và EF model sạch. Live health/public endpoint, Verify 5/5, workflow/Audit/Undo, desktop/mobile 390x844 và điện thoại thật 4G/5G đều pass. Official holdout giữ raw 10/15 và adjusted 11/15; post-holdout regression trên cùng 15 receipt đạt 11/15, 0 missed escalation, 4 over-escalation, 0 system error. Đây là mẫu nhỏ và không phải accuracy production; ba user session và rehearsal vẫn là gate.</a:t>
             </a:r>
           </a:p>
         </p:txBody>
@@ -726,7 +726,7 @@
           <a:lstStyle xmlns:a="http://schemas.openxmlformats.org/drawingml/2006/main"/>
           <a:p xmlns:a="http://schemas.openxmlformats.org/drawingml/2006/main">
             <a:r>
-              <a:t>Nguồn kỹ thuật trong repo: ReceiptProcessingWorker.cs, ReceiptExtractionContract.cs, PolicyDecisionEngine.cs, VietnamTime.cs, tools/Invoke-ExtendedDatasetEvaluation.ps1 và docs/LIVE_POST_HOLDOUT_VALIDATION_2026-10-06.md. EF Core 8.0.31 và test project đã qua vulnerability scan không còn advisory tại thời điểm kiểm tra.</a:t>
+              <a:t>Nguồn kỹ thuật trong repo: ReceiptProcessingWorker.cs, ReceiptExtractionContract.cs, PolicyDecisionEngine.cs, VietnamTime.cs, tools/Invoke-ExtendedDatasetEvaluation.ps1, docs/CURRENT_PROJECT_STATUS_2026-10-07.md và docs/REAL_RECEIPT_REGRESSION_RESULT_2026-10-07.md. Fallback vẫn opt-in và mặc định tắt; OpenRouter 8B là baseline demo.</a:t>
             </a:r>
           </a:p>
         </p:txBody>
@@ -773,7 +773,7 @@
           <p:cNvPr id="3" name="Title">
             <a:extLst xmlns:a="http://schemas.openxmlformats.org/drawingml/2006/main">
               <a:ext uri="{FF2B5EF4-FFF2-40B4-BE49-F238E27FC236}">
-                <a16:creationId xmlns:a16="http://schemas.microsoft.com/office/drawing/2014/main" id="{EB339480-3D71-4CDD-B382-19EEC78FDC19}"/>
+                <a16:creationId xmlns:a16="http://schemas.microsoft.com/office/drawing/2014/main" id="{1C7D8926-5FAC-47A8-9D01-BB9F8B3DFDEB}"/>
               </a:ext>
             </a:extLst>
           </p:cNvPr>
@@ -930,7 +930,7 @@
           <p:cNvPr id="2" name="Subtitle">
             <a:extLst xmlns:a="http://schemas.openxmlformats.org/drawingml/2006/main">
               <a:ext uri="{FF2B5EF4-FFF2-40B4-BE49-F238E27FC236}">
-                <a16:creationId xmlns:a16="http://schemas.microsoft.com/office/drawing/2014/main" id="{0ED15388-BB60-4C29-8EBB-B7C7298CEE57}"/>
+                <a16:creationId xmlns:a16="http://schemas.microsoft.com/office/drawing/2014/main" id="{B121C3F3-CC5E-4244-82A2-28DDAE10E84A}"/>
               </a:ext>
             </a:extLst>
           </p:cNvPr>
@@ -1104,7 +1104,7 @@
           <p:cNvPr id="2" name="Section title">
             <a:extLst xmlns:a="http://schemas.openxmlformats.org/drawingml/2006/main">
               <a:ext uri="{FF2B5EF4-FFF2-40B4-BE49-F238E27FC236}">
-                <a16:creationId xmlns:a16="http://schemas.microsoft.com/office/drawing/2014/main" id="{68572542-9165-4481-B207-F9C0C2FF36C4}"/>
+                <a16:creationId xmlns:a16="http://schemas.microsoft.com/office/drawing/2014/main" id="{85B5808C-FC17-4683-B8B8-16273C95E63F}"/>
               </a:ext>
             </a:extLst>
           </p:cNvPr>
@@ -1278,7 +1278,7 @@
           <p:cNvPr id="3" name="Title">
             <a:extLst xmlns:a="http://schemas.openxmlformats.org/drawingml/2006/main">
               <a:ext uri="{FF2B5EF4-FFF2-40B4-BE49-F238E27FC236}">
-                <a16:creationId xmlns:a16="http://schemas.microsoft.com/office/drawing/2014/main" id="{57CCDA2F-66CF-427E-9422-4F8D8956CAE1}"/>
+                <a16:creationId xmlns:a16="http://schemas.microsoft.com/office/drawing/2014/main" id="{1F10C778-38E2-4D51-916E-AE9ECFCCA4C9}"/>
               </a:ext>
             </a:extLst>
           </p:cNvPr>
@@ -1435,7 +1435,7 @@
           <p:cNvPr id="2" name="Body">
             <a:extLst xmlns:a="http://schemas.openxmlformats.org/drawingml/2006/main">
               <a:ext uri="{FF2B5EF4-FFF2-40B4-BE49-F238E27FC236}">
-                <a16:creationId xmlns:a16="http://schemas.microsoft.com/office/drawing/2014/main" id="{7193BDB0-0959-4513-9BAC-25989D03152D}"/>
+                <a16:creationId xmlns:a16="http://schemas.microsoft.com/office/drawing/2014/main" id="{CCD2DD1E-9898-4E78-BF69-7281761E2317}"/>
               </a:ext>
             </a:extLst>
           </p:cNvPr>
@@ -1609,7 +1609,7 @@
           <p:cNvPr id="4" name="Title">
             <a:extLst xmlns:a="http://schemas.openxmlformats.org/drawingml/2006/main">
               <a:ext uri="{FF2B5EF4-FFF2-40B4-BE49-F238E27FC236}">
-                <a16:creationId xmlns:a16="http://schemas.microsoft.com/office/drawing/2014/main" id="{C0551F11-84A3-45C6-970D-D50301778F56}"/>
+                <a16:creationId xmlns:a16="http://schemas.microsoft.com/office/drawing/2014/main" id="{14C34F14-3BF7-4971-A5DC-77D2698DEEFF}"/>
               </a:ext>
             </a:extLst>
           </p:cNvPr>
@@ -1766,7 +1766,7 @@
           <p:cNvPr id="2" name="Left column">
             <a:extLst xmlns:a="http://schemas.openxmlformats.org/drawingml/2006/main">
               <a:ext uri="{FF2B5EF4-FFF2-40B4-BE49-F238E27FC236}">
-                <a16:creationId xmlns:a16="http://schemas.microsoft.com/office/drawing/2014/main" id="{97177A07-8459-4C6F-BDE4-4B5F4335B75D}"/>
+                <a16:creationId xmlns:a16="http://schemas.microsoft.com/office/drawing/2014/main" id="{F355EECE-B311-4B26-B76B-23A4153814ED}"/>
               </a:ext>
             </a:extLst>
           </p:cNvPr>
@@ -1923,7 +1923,7 @@
           <p:cNvPr id="3" name="Right column">
             <a:extLst xmlns:a="http://schemas.openxmlformats.org/drawingml/2006/main">
               <a:ext uri="{FF2B5EF4-FFF2-40B4-BE49-F238E27FC236}">
-                <a16:creationId xmlns:a16="http://schemas.microsoft.com/office/drawing/2014/main" id="{207B9D98-66DA-4369-B222-01EF0F9C81FF}"/>
+                <a16:creationId xmlns:a16="http://schemas.microsoft.com/office/drawing/2014/main" id="{6096AAE8-A3E7-46D1-9D98-132E07D9EA78}"/>
               </a:ext>
             </a:extLst>
           </p:cNvPr>
@@ -2097,7 +2097,7 @@
           <p:cNvPr id="3" name="Title">
             <a:extLst xmlns:a="http://schemas.openxmlformats.org/drawingml/2006/main">
               <a:ext uri="{FF2B5EF4-FFF2-40B4-BE49-F238E27FC236}">
-                <a16:creationId xmlns:a16="http://schemas.microsoft.com/office/drawing/2014/main" id="{E44BAD40-E79E-466F-A1E7-CDB827194386}"/>
+                <a16:creationId xmlns:a16="http://schemas.microsoft.com/office/drawing/2014/main" id="{67912FCD-7E00-4427-86EA-8A5193EC6D33}"/>
               </a:ext>
             </a:extLst>
           </p:cNvPr>
@@ -2254,7 +2254,7 @@
           <p:cNvPr id="2" name="Left column">
             <a:extLst xmlns:a="http://schemas.openxmlformats.org/drawingml/2006/main">
               <a:ext uri="{FF2B5EF4-FFF2-40B4-BE49-F238E27FC236}">
-                <a16:creationId xmlns:a16="http://schemas.microsoft.com/office/drawing/2014/main" id="{48D12EC5-E646-4FBE-AD4C-F1E45D732CAB}"/>
+                <a16:creationId xmlns:a16="http://schemas.microsoft.com/office/drawing/2014/main" id="{D859989B-FD2C-475E-8862-06B0171F04AA}"/>
               </a:ext>
             </a:extLst>
           </p:cNvPr>
@@ -2449,12 +2449,12 @@
   </p:cSld>
   <p:clrMap bg1="lt1" tx1="dk1" bg2="lt2" tx2="dk2" accent1="accent1" accent2="accent2" accent3="accent3" accent4="accent4" accent5="accent5" accent6="accent6" hlink="hlink" folHlink="folHlink"/>
   <p:sldLayoutIdLst>
-    <p:sldLayoutId xmlns:r="http://schemas.openxmlformats.org/officeDocument/2006/relationships" id="2147483649" r:id="R6f092cc802e94057"/>
-    <p:sldLayoutId xmlns:r="http://schemas.openxmlformats.org/officeDocument/2006/relationships" id="2147483650" r:id="Raab7e83ea4924004"/>
-    <p:sldLayoutId xmlns:r="http://schemas.openxmlformats.org/officeDocument/2006/relationships" id="2147483651" r:id="R0a9326d1dee844ad"/>
-    <p:sldLayoutId xmlns:r="http://schemas.openxmlformats.org/officeDocument/2006/relationships" id="2147483652" r:id="R699b98a94235434a"/>
-    <p:sldLayoutId xmlns:r="http://schemas.openxmlformats.org/officeDocument/2006/relationships" id="2147483653" r:id="R7fc576062ea6444a"/>
-    <p:sldLayoutId xmlns:r="http://schemas.openxmlformats.org/officeDocument/2006/relationships" id="2147483654" r:id="Rf8c453ad235f42a5"/>
+    <p:sldLayoutId xmlns:r="http://schemas.openxmlformats.org/officeDocument/2006/relationships" id="2147483649" r:id="R628cd3dd48454d6a"/>
+    <p:sldLayoutId xmlns:r="http://schemas.openxmlformats.org/officeDocument/2006/relationships" id="2147483650" r:id="R5b39942f95e74090"/>
+    <p:sldLayoutId xmlns:r="http://schemas.openxmlformats.org/officeDocument/2006/relationships" id="2147483651" r:id="R62588dfdcd514b62"/>
+    <p:sldLayoutId xmlns:r="http://schemas.openxmlformats.org/officeDocument/2006/relationships" id="2147483652" r:id="R560f8c3c884543cc"/>
+    <p:sldLayoutId xmlns:r="http://schemas.openxmlformats.org/officeDocument/2006/relationships" id="2147483653" r:id="R2237240c8a9449e4"/>
+    <p:sldLayoutId xmlns:r="http://schemas.openxmlformats.org/officeDocument/2006/relationships" id="2147483654" r:id="R0d7de9d5124146d6"/>
   </p:sldLayoutIdLst>
   <p:txStyles>
     <p:titleStyle>
@@ -3005,7 +3005,7 @@
           <p:cNvPr id="24" name="">
             <a:extLst xmlns:a="http://schemas.openxmlformats.org/drawingml/2006/main">
               <a:ext uri="{FF2B5EF4-FFF2-40B4-BE49-F238E27FC236}">
-                <a16:creationId xmlns:a16="http://schemas.microsoft.com/office/drawing/2014/main" id="{88B15D0C-5913-4251-8CF4-8D3137963E24}"/>
+                <a16:creationId xmlns:a16="http://schemas.microsoft.com/office/drawing/2014/main" id="{EE710B1B-E200-4F20-96E2-C19303CD9AD0}"/>
               </a:ext>
             </a:extLst>
           </p:cNvPr>
@@ -3037,7 +3037,7 @@
           <p:cNvPr id="19" name="">
             <a:extLst xmlns:a="http://schemas.openxmlformats.org/drawingml/2006/main">
               <a:ext uri="{FF2B5EF4-FFF2-40B4-BE49-F238E27FC236}">
-                <a16:creationId xmlns:a16="http://schemas.microsoft.com/office/drawing/2014/main" id="{349C2603-3F0E-47F1-AFB8-CF6B6888C9EB}"/>
+                <a16:creationId xmlns:a16="http://schemas.microsoft.com/office/drawing/2014/main" id="{881A048B-69FA-4D02-B6A0-67750C32A8BF}"/>
               </a:ext>
             </a:extLst>
           </p:cNvPr>
@@ -3069,7 +3069,7 @@
           <p:cNvPr id="14" name="">
             <a:extLst xmlns:a="http://schemas.openxmlformats.org/drawingml/2006/main">
               <a:ext uri="{FF2B5EF4-FFF2-40B4-BE49-F238E27FC236}">
-                <a16:creationId xmlns:a16="http://schemas.microsoft.com/office/drawing/2014/main" id="{97C5E321-09A7-4614-B570-AFC2864BE41A}"/>
+                <a16:creationId xmlns:a16="http://schemas.microsoft.com/office/drawing/2014/main" id="{E36140FE-E420-4544-BC0C-926AA98D4379}"/>
               </a:ext>
             </a:extLst>
           </p:cNvPr>
@@ -3101,7 +3101,7 @@
           <p:cNvPr id="9" name="">
             <a:extLst xmlns:a="http://schemas.openxmlformats.org/drawingml/2006/main">
               <a:ext uri="{FF2B5EF4-FFF2-40B4-BE49-F238E27FC236}">
-                <a16:creationId xmlns:a16="http://schemas.microsoft.com/office/drawing/2014/main" id="{43411524-03FC-4306-8346-8925CCC62BB9}"/>
+                <a16:creationId xmlns:a16="http://schemas.microsoft.com/office/drawing/2014/main" id="{3B13C5C6-6BA4-448B-8489-8D8D7ABA29EE}"/>
               </a:ext>
             </a:extLst>
           </p:cNvPr>
@@ -3133,7 +3133,7 @@
           <p:cNvPr id="47" name="">
             <a:extLst xmlns:a="http://schemas.openxmlformats.org/drawingml/2006/main">
               <a:ext uri="{FF2B5EF4-FFF2-40B4-BE49-F238E27FC236}">
-                <a16:creationId xmlns:a16="http://schemas.microsoft.com/office/drawing/2014/main" id="{FF54448A-DFBF-4BB9-B55F-16B7324159FC}"/>
+                <a16:creationId xmlns:a16="http://schemas.microsoft.com/office/drawing/2014/main" id="{077C5426-6257-44A2-B404-A8582AE899DB}"/>
               </a:ext>
             </a:extLst>
           </p:cNvPr>
@@ -3201,7 +3201,7 @@
           <p:cNvPr id="2" name="">
             <a:extLst xmlns:a="http://schemas.openxmlformats.org/drawingml/2006/main">
               <a:ext uri="{FF2B5EF4-FFF2-40B4-BE49-F238E27FC236}">
-                <a16:creationId xmlns:a16="http://schemas.microsoft.com/office/drawing/2014/main" id="{450409B7-5334-4A2A-BEDD-D6CFBC3F7780}"/>
+                <a16:creationId xmlns:a16="http://schemas.microsoft.com/office/drawing/2014/main" id="{BC0256F3-904A-47DE-B73F-6F7CBE2A380A}"/>
               </a:ext>
             </a:extLst>
           </p:cNvPr>
@@ -3269,7 +3269,7 @@
           <p:cNvPr id="3" name="">
             <a:extLst xmlns:a="http://schemas.openxmlformats.org/drawingml/2006/main">
               <a:ext uri="{FF2B5EF4-FFF2-40B4-BE49-F238E27FC236}">
-                <a16:creationId xmlns:a16="http://schemas.microsoft.com/office/drawing/2014/main" id="{0564AF6E-5C9F-41CA-93AA-6C64FA8136FD}"/>
+                <a16:creationId xmlns:a16="http://schemas.microsoft.com/office/drawing/2014/main" id="{2B590D95-C506-4F83-9FBC-E70FBC917461}"/>
               </a:ext>
             </a:extLst>
           </p:cNvPr>
@@ -3337,7 +3337,7 @@
           <p:cNvPr id="4" name="">
             <a:extLst xmlns:a="http://schemas.openxmlformats.org/drawingml/2006/main">
               <a:ext uri="{FF2B5EF4-FFF2-40B4-BE49-F238E27FC236}">
-                <a16:creationId xmlns:a16="http://schemas.microsoft.com/office/drawing/2014/main" id="{E9828429-E700-43D5-92D5-50BA21718CBE}"/>
+                <a16:creationId xmlns:a16="http://schemas.microsoft.com/office/drawing/2014/main" id="{08A371D8-D211-4C1A-83C4-9EE525F4C46C}"/>
               </a:ext>
             </a:extLst>
           </p:cNvPr>
@@ -3368,7 +3368,7 @@
           <p:cNvPr id="5" name="">
             <a:extLst xmlns:a="http://schemas.openxmlformats.org/drawingml/2006/main">
               <a:ext uri="{FF2B5EF4-FFF2-40B4-BE49-F238E27FC236}">
-                <a16:creationId xmlns:a16="http://schemas.microsoft.com/office/drawing/2014/main" id="{AB72B8C2-7454-4735-93CC-B914EBCDCF11}"/>
+                <a16:creationId xmlns:a16="http://schemas.microsoft.com/office/drawing/2014/main" id="{F458AF6C-22C2-423F-8E4F-978C1B91D4BD}"/>
               </a:ext>
             </a:extLst>
           </p:cNvPr>
@@ -3403,7 +3403,7 @@
           <p:cNvPr id="6" name="">
             <a:extLst xmlns:a="http://schemas.openxmlformats.org/drawingml/2006/main">
               <a:ext uri="{FF2B5EF4-FFF2-40B4-BE49-F238E27FC236}">
-                <a16:creationId xmlns:a16="http://schemas.microsoft.com/office/drawing/2014/main" id="{A9151B49-52AB-4F2C-8ECD-1E25FEA1DEBE}"/>
+                <a16:creationId xmlns:a16="http://schemas.microsoft.com/office/drawing/2014/main" id="{FDB836F6-842F-4D90-A6BB-1BDC1CF26B43}"/>
               </a:ext>
             </a:extLst>
           </p:cNvPr>
@@ -3478,7 +3478,7 @@
           <p:cNvPr id="7" name="">
             <a:extLst xmlns:a="http://schemas.openxmlformats.org/drawingml/2006/main">
               <a:ext uri="{FF2B5EF4-FFF2-40B4-BE49-F238E27FC236}">
-                <a16:creationId xmlns:a16="http://schemas.microsoft.com/office/drawing/2014/main" id="{9380D379-7292-4E7A-BFB3-6C721FDEF4D7}"/>
+                <a16:creationId xmlns:a16="http://schemas.microsoft.com/office/drawing/2014/main" id="{B6209E19-F6B9-474E-995B-AFF4A755A402}"/>
               </a:ext>
             </a:extLst>
           </p:cNvPr>
@@ -3546,7 +3546,7 @@
           <p:cNvPr id="8" name="">
             <a:extLst xmlns:a="http://schemas.openxmlformats.org/drawingml/2006/main">
               <a:ext uri="{FF2B5EF4-FFF2-40B4-BE49-F238E27FC236}">
-                <a16:creationId xmlns:a16="http://schemas.microsoft.com/office/drawing/2014/main" id="{925AFEF3-F14A-45EA-8602-6F6DCEA1C567}"/>
+                <a16:creationId xmlns:a16="http://schemas.microsoft.com/office/drawing/2014/main" id="{1AA4F0AD-22A8-43D6-BC84-61720CA9B722}"/>
               </a:ext>
             </a:extLst>
           </p:cNvPr>
@@ -3614,7 +3614,7 @@
           <p:cNvPr id="10" name="">
             <a:extLst xmlns:a="http://schemas.openxmlformats.org/drawingml/2006/main">
               <a:ext uri="{FF2B5EF4-FFF2-40B4-BE49-F238E27FC236}">
-                <a16:creationId xmlns:a16="http://schemas.microsoft.com/office/drawing/2014/main" id="{985D0FB9-1732-417B-95B1-DCF71A289DDD}"/>
+                <a16:creationId xmlns:a16="http://schemas.microsoft.com/office/drawing/2014/main" id="{328D94BB-2BFF-406A-9552-A723C328D5C9}"/>
               </a:ext>
             </a:extLst>
           </p:cNvPr>
@@ -3649,7 +3649,7 @@
           <p:cNvPr id="11" name="">
             <a:extLst xmlns:a="http://schemas.openxmlformats.org/drawingml/2006/main">
               <a:ext uri="{FF2B5EF4-FFF2-40B4-BE49-F238E27FC236}">
-                <a16:creationId xmlns:a16="http://schemas.microsoft.com/office/drawing/2014/main" id="{91FAA90C-0859-4905-9CCA-ACA601805214}"/>
+                <a16:creationId xmlns:a16="http://schemas.microsoft.com/office/drawing/2014/main" id="{2105E264-4098-4BCE-9D6A-2E37190FA97E}"/>
               </a:ext>
             </a:extLst>
           </p:cNvPr>
@@ -3724,7 +3724,7 @@
           <p:cNvPr id="12" name="">
             <a:extLst xmlns:a="http://schemas.openxmlformats.org/drawingml/2006/main">
               <a:ext uri="{FF2B5EF4-FFF2-40B4-BE49-F238E27FC236}">
-                <a16:creationId xmlns:a16="http://schemas.microsoft.com/office/drawing/2014/main" id="{BCD84E02-1AC8-47D5-86B8-E2280E083583}"/>
+                <a16:creationId xmlns:a16="http://schemas.microsoft.com/office/drawing/2014/main" id="{7F4D23DE-36CB-42E6-A22E-A92EE5C09C44}"/>
               </a:ext>
             </a:extLst>
           </p:cNvPr>
@@ -3792,7 +3792,7 @@
           <p:cNvPr id="13" name="">
             <a:extLst xmlns:a="http://schemas.openxmlformats.org/drawingml/2006/main">
               <a:ext uri="{FF2B5EF4-FFF2-40B4-BE49-F238E27FC236}">
-                <a16:creationId xmlns:a16="http://schemas.microsoft.com/office/drawing/2014/main" id="{0BEAF2E0-A8A7-4272-84FF-49C2A9ABC47B}"/>
+                <a16:creationId xmlns:a16="http://schemas.microsoft.com/office/drawing/2014/main" id="{EF98664E-CAB6-4F76-BA91-BE1501DD3FDC}"/>
               </a:ext>
             </a:extLst>
           </p:cNvPr>
@@ -3860,7 +3860,7 @@
           <p:cNvPr id="15" name="">
             <a:extLst xmlns:a="http://schemas.openxmlformats.org/drawingml/2006/main">
               <a:ext uri="{FF2B5EF4-FFF2-40B4-BE49-F238E27FC236}">
-                <a16:creationId xmlns:a16="http://schemas.microsoft.com/office/drawing/2014/main" id="{E12B27C1-D2CA-431D-8FEF-C2E96C491476}"/>
+                <a16:creationId xmlns:a16="http://schemas.microsoft.com/office/drawing/2014/main" id="{D623F409-59B9-41D0-8DCA-A15AE18BA12E}"/>
               </a:ext>
             </a:extLst>
           </p:cNvPr>
@@ -3895,7 +3895,7 @@
           <p:cNvPr id="16" name="">
             <a:extLst xmlns:a="http://schemas.openxmlformats.org/drawingml/2006/main">
               <a:ext uri="{FF2B5EF4-FFF2-40B4-BE49-F238E27FC236}">
-                <a16:creationId xmlns:a16="http://schemas.microsoft.com/office/drawing/2014/main" id="{2C29E190-FCBF-4647-BF8E-C79E0B285B15}"/>
+                <a16:creationId xmlns:a16="http://schemas.microsoft.com/office/drawing/2014/main" id="{B253AA95-7676-4CBF-A381-435718D91CCB}"/>
               </a:ext>
             </a:extLst>
           </p:cNvPr>
@@ -3970,7 +3970,7 @@
           <p:cNvPr id="17" name="">
             <a:extLst xmlns:a="http://schemas.openxmlformats.org/drawingml/2006/main">
               <a:ext uri="{FF2B5EF4-FFF2-40B4-BE49-F238E27FC236}">
-                <a16:creationId xmlns:a16="http://schemas.microsoft.com/office/drawing/2014/main" id="{5D285031-1902-40B7-B48A-F07C28C76812}"/>
+                <a16:creationId xmlns:a16="http://schemas.microsoft.com/office/drawing/2014/main" id="{5A108177-3103-4F51-B877-56D6918FD8A6}"/>
               </a:ext>
             </a:extLst>
           </p:cNvPr>
@@ -4038,7 +4038,7 @@
           <p:cNvPr id="18" name="">
             <a:extLst xmlns:a="http://schemas.openxmlformats.org/drawingml/2006/main">
               <a:ext uri="{FF2B5EF4-FFF2-40B4-BE49-F238E27FC236}">
-                <a16:creationId xmlns:a16="http://schemas.microsoft.com/office/drawing/2014/main" id="{FFE1D57B-D6F1-4A94-BBD0-25E069B74AD6}"/>
+                <a16:creationId xmlns:a16="http://schemas.microsoft.com/office/drawing/2014/main" id="{B8B865E9-211C-4C1C-AA00-BE33A4BECA14}"/>
               </a:ext>
             </a:extLst>
           </p:cNvPr>
@@ -4106,7 +4106,7 @@
           <p:cNvPr id="20" name="">
             <a:extLst xmlns:a="http://schemas.openxmlformats.org/drawingml/2006/main">
               <a:ext uri="{FF2B5EF4-FFF2-40B4-BE49-F238E27FC236}">
-                <a16:creationId xmlns:a16="http://schemas.microsoft.com/office/drawing/2014/main" id="{39C599D0-D44D-415E-9A2E-C249553B423F}"/>
+                <a16:creationId xmlns:a16="http://schemas.microsoft.com/office/drawing/2014/main" id="{57FF6539-7C95-4A0A-9BB6-70C3ABED5A54}"/>
               </a:ext>
             </a:extLst>
           </p:cNvPr>
@@ -4141,7 +4141,7 @@
           <p:cNvPr id="21" name="">
             <a:extLst xmlns:a="http://schemas.openxmlformats.org/drawingml/2006/main">
               <a:ext uri="{FF2B5EF4-FFF2-40B4-BE49-F238E27FC236}">
-                <a16:creationId xmlns:a16="http://schemas.microsoft.com/office/drawing/2014/main" id="{3F084876-2FC6-4126-9F9A-66B9062EEBB8}"/>
+                <a16:creationId xmlns:a16="http://schemas.microsoft.com/office/drawing/2014/main" id="{53690952-BECE-4B74-8DE9-15221CF8D921}"/>
               </a:ext>
             </a:extLst>
           </p:cNvPr>
@@ -4216,7 +4216,7 @@
           <p:cNvPr id="22" name="">
             <a:extLst xmlns:a="http://schemas.openxmlformats.org/drawingml/2006/main">
               <a:ext uri="{FF2B5EF4-FFF2-40B4-BE49-F238E27FC236}">
-                <a16:creationId xmlns:a16="http://schemas.microsoft.com/office/drawing/2014/main" id="{1B46EB0F-1D47-47CC-AB72-8453B620AF3D}"/>
+                <a16:creationId xmlns:a16="http://schemas.microsoft.com/office/drawing/2014/main" id="{91C49E87-B418-4AC0-8D0B-D53F6226A56B}"/>
               </a:ext>
             </a:extLst>
           </p:cNvPr>
@@ -4284,7 +4284,7 @@
           <p:cNvPr id="23" name="">
             <a:extLst xmlns:a="http://schemas.openxmlformats.org/drawingml/2006/main">
               <a:ext uri="{FF2B5EF4-FFF2-40B4-BE49-F238E27FC236}">
-                <a16:creationId xmlns:a16="http://schemas.microsoft.com/office/drawing/2014/main" id="{086F18B1-E94C-4302-BDD6-518DDB4103EA}"/>
+                <a16:creationId xmlns:a16="http://schemas.microsoft.com/office/drawing/2014/main" id="{7AC156A4-F741-4929-AF3B-F4CB9B23219E}"/>
               </a:ext>
             </a:extLst>
           </p:cNvPr>
@@ -4352,7 +4352,7 @@
           <p:cNvPr id="25" name="">
             <a:extLst xmlns:a="http://schemas.openxmlformats.org/drawingml/2006/main">
               <a:ext uri="{FF2B5EF4-FFF2-40B4-BE49-F238E27FC236}">
-                <a16:creationId xmlns:a16="http://schemas.microsoft.com/office/drawing/2014/main" id="{31531393-1C66-41B9-9A80-AFF2BA86222B}"/>
+                <a16:creationId xmlns:a16="http://schemas.microsoft.com/office/drawing/2014/main" id="{29ABB77A-7C8D-4BFC-8279-B3290BCF8FBA}"/>
               </a:ext>
             </a:extLst>
           </p:cNvPr>
@@ -4387,7 +4387,7 @@
           <p:cNvPr id="26" name="">
             <a:extLst xmlns:a="http://schemas.openxmlformats.org/drawingml/2006/main">
               <a:ext uri="{FF2B5EF4-FFF2-40B4-BE49-F238E27FC236}">
-                <a16:creationId xmlns:a16="http://schemas.microsoft.com/office/drawing/2014/main" id="{BD32B0D8-DBE7-43BC-A854-873D12D61804}"/>
+                <a16:creationId xmlns:a16="http://schemas.microsoft.com/office/drawing/2014/main" id="{06B3145C-EF36-4DFB-911C-1165083E00A1}"/>
               </a:ext>
             </a:extLst>
           </p:cNvPr>
@@ -4462,7 +4462,7 @@
           <p:cNvPr id="27" name="">
             <a:extLst xmlns:a="http://schemas.openxmlformats.org/drawingml/2006/main">
               <a:ext uri="{FF2B5EF4-FFF2-40B4-BE49-F238E27FC236}">
-                <a16:creationId xmlns:a16="http://schemas.microsoft.com/office/drawing/2014/main" id="{1B3A0898-A125-4BB3-A68B-14E888E0E838}"/>
+                <a16:creationId xmlns:a16="http://schemas.microsoft.com/office/drawing/2014/main" id="{5B7721AF-F40A-41D5-ADDA-3C48BD5A9DB8}"/>
               </a:ext>
             </a:extLst>
           </p:cNvPr>
@@ -4530,7 +4530,7 @@
           <p:cNvPr id="28" name="">
             <a:extLst xmlns:a="http://schemas.openxmlformats.org/drawingml/2006/main">
               <a:ext uri="{FF2B5EF4-FFF2-40B4-BE49-F238E27FC236}">
-                <a16:creationId xmlns:a16="http://schemas.microsoft.com/office/drawing/2014/main" id="{4B47C7CA-E809-47AC-94BA-C3FC1D2FED6A}"/>
+                <a16:creationId xmlns:a16="http://schemas.microsoft.com/office/drawing/2014/main" id="{ABDF02EC-E623-41B5-B0D1-65B480DA23D4}"/>
               </a:ext>
             </a:extLst>
           </p:cNvPr>
@@ -4598,7 +4598,7 @@
           <p:cNvPr id="29" name="">
             <a:extLst xmlns:a="http://schemas.openxmlformats.org/drawingml/2006/main">
               <a:ext uri="{FF2B5EF4-FFF2-40B4-BE49-F238E27FC236}">
-                <a16:creationId xmlns:a16="http://schemas.microsoft.com/office/drawing/2014/main" id="{91B52206-7C66-4EFD-BC47-D70FCAF32B82}"/>
+                <a16:creationId xmlns:a16="http://schemas.microsoft.com/office/drawing/2014/main" id="{3FE631CD-0BC7-458B-93C7-F8E337FEB2A1}"/>
               </a:ext>
             </a:extLst>
           </p:cNvPr>
@@ -4633,7 +4633,7 @@
           <p:cNvPr id="30" name="">
             <a:extLst xmlns:a="http://schemas.openxmlformats.org/drawingml/2006/main">
               <a:ext uri="{FF2B5EF4-FFF2-40B4-BE49-F238E27FC236}">
-                <a16:creationId xmlns:a16="http://schemas.microsoft.com/office/drawing/2014/main" id="{D90C7370-483A-481D-BD42-697E7872575D}"/>
+                <a16:creationId xmlns:a16="http://schemas.microsoft.com/office/drawing/2014/main" id="{5BD0414B-E8C8-4A04-A8C2-57DAEA5DFC91}"/>
               </a:ext>
             </a:extLst>
           </p:cNvPr>
@@ -4701,7 +4701,7 @@
           <p:cNvPr id="31" name="">
             <a:extLst xmlns:a="http://schemas.openxmlformats.org/drawingml/2006/main">
               <a:ext uri="{FF2B5EF4-FFF2-40B4-BE49-F238E27FC236}">
-                <a16:creationId xmlns:a16="http://schemas.microsoft.com/office/drawing/2014/main" id="{6EF3D41A-A6C6-45FD-8C66-1F39B6525334}"/>
+                <a16:creationId xmlns:a16="http://schemas.microsoft.com/office/drawing/2014/main" id="{846BE1BF-A4E3-42BE-BCD0-E3BCBBB5707D}"/>
               </a:ext>
             </a:extLst>
           </p:cNvPr>
@@ -4769,7 +4769,7 @@
           <p:cNvPr id="32" name="">
             <a:extLst xmlns:a="http://schemas.openxmlformats.org/drawingml/2006/main">
               <a:ext uri="{FF2B5EF4-FFF2-40B4-BE49-F238E27FC236}">
-                <a16:creationId xmlns:a16="http://schemas.microsoft.com/office/drawing/2014/main" id="{374A80CF-E646-481F-895A-AED4CDC369C2}"/>
+                <a16:creationId xmlns:a16="http://schemas.microsoft.com/office/drawing/2014/main" id="{CAA63461-1D4C-4C87-BE6D-B835055FB8C7}"/>
               </a:ext>
             </a:extLst>
           </p:cNvPr>
@@ -4837,7 +4837,7 @@
           <p:cNvPr id="33" name="">
             <a:extLst xmlns:a="http://schemas.openxmlformats.org/drawingml/2006/main">
               <a:ext uri="{FF2B5EF4-FFF2-40B4-BE49-F238E27FC236}">
-                <a16:creationId xmlns:a16="http://schemas.microsoft.com/office/drawing/2014/main" id="{523D2CA0-2CA8-4EB8-B8D0-403F48A9FBCB}"/>
+                <a16:creationId xmlns:a16="http://schemas.microsoft.com/office/drawing/2014/main" id="{E0035DBC-A4DA-4606-80FB-AAA4FBB02F4D}"/>
               </a:ext>
             </a:extLst>
           </p:cNvPr>
@@ -4872,7 +4872,7 @@
           <p:cNvPr id="34" name="">
             <a:extLst xmlns:a="http://schemas.openxmlformats.org/drawingml/2006/main">
               <a:ext uri="{FF2B5EF4-FFF2-40B4-BE49-F238E27FC236}">
-                <a16:creationId xmlns:a16="http://schemas.microsoft.com/office/drawing/2014/main" id="{BFC648BF-81B8-447E-9BB2-E34CE951AEDF}"/>
+                <a16:creationId xmlns:a16="http://schemas.microsoft.com/office/drawing/2014/main" id="{9C9374A8-ACCC-4F7D-AE75-E59840F7D409}"/>
               </a:ext>
             </a:extLst>
           </p:cNvPr>
@@ -4947,7 +4947,7 @@
           <p:cNvPr id="35" name="">
             <a:extLst xmlns:a="http://schemas.openxmlformats.org/drawingml/2006/main">
               <a:ext uri="{FF2B5EF4-FFF2-40B4-BE49-F238E27FC236}">
-                <a16:creationId xmlns:a16="http://schemas.microsoft.com/office/drawing/2014/main" id="{0D911AD5-1F15-4906-A8F2-B5F9ACCFE8C6}"/>
+                <a16:creationId xmlns:a16="http://schemas.microsoft.com/office/drawing/2014/main" id="{944037BF-C38B-4A01-87F7-3E2A84760398}"/>
               </a:ext>
             </a:extLst>
           </p:cNvPr>
@@ -5015,7 +5015,7 @@
           <p:cNvPr id="36" name="">
             <a:extLst xmlns:a="http://schemas.openxmlformats.org/drawingml/2006/main">
               <a:ext uri="{FF2B5EF4-FFF2-40B4-BE49-F238E27FC236}">
-                <a16:creationId xmlns:a16="http://schemas.microsoft.com/office/drawing/2014/main" id="{DF306BFB-3207-4C49-93EC-93CBD36F4CFD}"/>
+                <a16:creationId xmlns:a16="http://schemas.microsoft.com/office/drawing/2014/main" id="{049C7FC9-27DD-472E-9BB2-F572F9DAF723}"/>
               </a:ext>
             </a:extLst>
           </p:cNvPr>
@@ -5083,7 +5083,7 @@
           <p:cNvPr id="37" name="">
             <a:extLst xmlns:a="http://schemas.openxmlformats.org/drawingml/2006/main">
               <a:ext uri="{FF2B5EF4-FFF2-40B4-BE49-F238E27FC236}">
-                <a16:creationId xmlns:a16="http://schemas.microsoft.com/office/drawing/2014/main" id="{B3E93303-EE8A-4BC3-A06E-234522863D27}"/>
+                <a16:creationId xmlns:a16="http://schemas.microsoft.com/office/drawing/2014/main" id="{2B02F459-5BC3-4FEB-A5E8-0A141A3EFD40}"/>
               </a:ext>
             </a:extLst>
           </p:cNvPr>
@@ -5118,7 +5118,7 @@
           <p:cNvPr id="38" name="">
             <a:extLst xmlns:a="http://schemas.openxmlformats.org/drawingml/2006/main">
               <a:ext uri="{FF2B5EF4-FFF2-40B4-BE49-F238E27FC236}">
-                <a16:creationId xmlns:a16="http://schemas.microsoft.com/office/drawing/2014/main" id="{7D3603F2-EC4F-4A01-9137-5C7A7FAA2229}"/>
+                <a16:creationId xmlns:a16="http://schemas.microsoft.com/office/drawing/2014/main" id="{242F581A-0595-44A9-84B5-A55586B771AA}"/>
               </a:ext>
             </a:extLst>
           </p:cNvPr>
@@ -5193,7 +5193,7 @@
           <p:cNvPr id="39" name="">
             <a:extLst xmlns:a="http://schemas.openxmlformats.org/drawingml/2006/main">
               <a:ext uri="{FF2B5EF4-FFF2-40B4-BE49-F238E27FC236}">
-                <a16:creationId xmlns:a16="http://schemas.microsoft.com/office/drawing/2014/main" id="{0A1FB55B-C9C2-43F9-8851-5B12987BD7BE}"/>
+                <a16:creationId xmlns:a16="http://schemas.microsoft.com/office/drawing/2014/main" id="{D8ECFF5B-A7E6-4121-B75A-B52AB33FA259}"/>
               </a:ext>
             </a:extLst>
           </p:cNvPr>
@@ -5261,7 +5261,7 @@
           <p:cNvPr id="40" name="">
             <a:extLst xmlns:a="http://schemas.openxmlformats.org/drawingml/2006/main">
               <a:ext uri="{FF2B5EF4-FFF2-40B4-BE49-F238E27FC236}">
-                <a16:creationId xmlns:a16="http://schemas.microsoft.com/office/drawing/2014/main" id="{EDEC2B0C-7167-4961-BAA8-4A61F3523666}"/>
+                <a16:creationId xmlns:a16="http://schemas.microsoft.com/office/drawing/2014/main" id="{975E885F-C8FC-4D5B-A518-A55C21C49763}"/>
               </a:ext>
             </a:extLst>
           </p:cNvPr>
@@ -5329,7 +5329,7 @@
           <p:cNvPr id="41" name="">
             <a:extLst xmlns:a="http://schemas.openxmlformats.org/drawingml/2006/main">
               <a:ext uri="{FF2B5EF4-FFF2-40B4-BE49-F238E27FC236}">
-                <a16:creationId xmlns:a16="http://schemas.microsoft.com/office/drawing/2014/main" id="{2440CBBA-FF65-4E46-A73C-382F67B9520C}"/>
+                <a16:creationId xmlns:a16="http://schemas.microsoft.com/office/drawing/2014/main" id="{12297978-DBDC-423C-8673-381ECA12EAA2}"/>
               </a:ext>
             </a:extLst>
           </p:cNvPr>
@@ -5364,7 +5364,7 @@
           <p:cNvPr id="42" name="">
             <a:extLst xmlns:a="http://schemas.openxmlformats.org/drawingml/2006/main">
               <a:ext uri="{FF2B5EF4-FFF2-40B4-BE49-F238E27FC236}">
-                <a16:creationId xmlns:a16="http://schemas.microsoft.com/office/drawing/2014/main" id="{C430DE0F-72D0-412A-93D5-8C858A91CA99}"/>
+                <a16:creationId xmlns:a16="http://schemas.microsoft.com/office/drawing/2014/main" id="{EB7088EF-66B0-41D4-8688-C0567A89F5F2}"/>
               </a:ext>
             </a:extLst>
           </p:cNvPr>
@@ -5439,7 +5439,7 @@
           <p:cNvPr id="43" name="">
             <a:extLst xmlns:a="http://schemas.openxmlformats.org/drawingml/2006/main">
               <a:ext uri="{FF2B5EF4-FFF2-40B4-BE49-F238E27FC236}">
-                <a16:creationId xmlns:a16="http://schemas.microsoft.com/office/drawing/2014/main" id="{8FEF2E6D-CEA0-4AAB-BB37-94844B494A8A}"/>
+                <a16:creationId xmlns:a16="http://schemas.microsoft.com/office/drawing/2014/main" id="{A084BC1D-E5F5-4F2D-935B-321AF465B089}"/>
               </a:ext>
             </a:extLst>
           </p:cNvPr>
@@ -5507,7 +5507,7 @@
           <p:cNvPr id="44" name="">
             <a:extLst xmlns:a="http://schemas.openxmlformats.org/drawingml/2006/main">
               <a:ext uri="{FF2B5EF4-FFF2-40B4-BE49-F238E27FC236}">
-                <a16:creationId xmlns:a16="http://schemas.microsoft.com/office/drawing/2014/main" id="{0FB55AFF-89D6-4DBC-AD82-9913F0172A5A}"/>
+                <a16:creationId xmlns:a16="http://schemas.microsoft.com/office/drawing/2014/main" id="{CC2D87C6-F41B-4DAD-86A8-41E975AB935C}"/>
               </a:ext>
             </a:extLst>
           </p:cNvPr>
@@ -5575,7 +5575,7 @@
           <p:cNvPr id="45" name="">
             <a:extLst xmlns:a="http://schemas.openxmlformats.org/drawingml/2006/main">
               <a:ext uri="{FF2B5EF4-FFF2-40B4-BE49-F238E27FC236}">
-                <a16:creationId xmlns:a16="http://schemas.microsoft.com/office/drawing/2014/main" id="{C464893D-93CB-4BC4-AFAB-0756AFE25AC5}"/>
+                <a16:creationId xmlns:a16="http://schemas.microsoft.com/office/drawing/2014/main" id="{E4231AB0-1D82-435F-AC57-8866C64F6798}"/>
               </a:ext>
             </a:extLst>
           </p:cNvPr>
@@ -5633,7 +5633,7 @@
                 <a:ea typeface="Arial"/>
                 <a:cs typeface="Arial"/>
               </a:rPr>
-              <a:t>AURA • Track A • 06/10/2026</a:t>
+              <a:t>AURA • Track A • 11/10/2026</a:t>
             </a:r>
           </a:p>
         </p:txBody>
@@ -5643,7 +5643,7 @@
           <p:cNvPr id="46" name="">
             <a:extLst xmlns:a="http://schemas.openxmlformats.org/drawingml/2006/main">
               <a:ext uri="{FF2B5EF4-FFF2-40B4-BE49-F238E27FC236}">
-                <a16:creationId xmlns:a16="http://schemas.microsoft.com/office/drawing/2014/main" id="{CB4C67BA-B3D3-4BFE-91C9-B79A673747D7}"/>
+                <a16:creationId xmlns:a16="http://schemas.microsoft.com/office/drawing/2014/main" id="{CE38F593-23EF-4297-BC41-1031920D58D4}"/>
               </a:ext>
             </a:extLst>
           </p:cNvPr>
@@ -5709,7 +5709,7 @@
     </p:spTree>
     <p:extLst>
       <p:ext uri="{BB962C8B-B14F-4D97-AF65-F5344CB8AC3E}">
-        <p14:creationId xmlns:p14="http://schemas.microsoft.com/office/powerpoint/2010/main" val="737600758"/>
+        <p14:creationId xmlns:p14="http://schemas.microsoft.com/office/powerpoint/2010/main" val="2092513571"/>
       </p:ext>
     </p:extLst>
   </p:cSld>
@@ -5740,7 +5740,7 @@
           <p:cNvPr id="46" name="">
             <a:extLst xmlns:a="http://schemas.openxmlformats.org/drawingml/2006/main">
               <a:ext uri="{FF2B5EF4-FFF2-40B4-BE49-F238E27FC236}">
-                <a16:creationId xmlns:a16="http://schemas.microsoft.com/office/drawing/2014/main" id="{543FBB0D-2156-4C70-8CA7-E289F7ADD82E}"/>
+                <a16:creationId xmlns:a16="http://schemas.microsoft.com/office/drawing/2014/main" id="{DF20B3C9-7348-48CA-B9DD-B51123C7E717}"/>
               </a:ext>
             </a:extLst>
           </p:cNvPr>
@@ -5808,7 +5808,7 @@
           <p:cNvPr id="2" name="">
             <a:extLst xmlns:a="http://schemas.openxmlformats.org/drawingml/2006/main">
               <a:ext uri="{FF2B5EF4-FFF2-40B4-BE49-F238E27FC236}">
-                <a16:creationId xmlns:a16="http://schemas.microsoft.com/office/drawing/2014/main" id="{96BD9809-47EF-4DBF-90E7-43FB178139EC}"/>
+                <a16:creationId xmlns:a16="http://schemas.microsoft.com/office/drawing/2014/main" id="{7982CBDF-C870-4473-9E22-FB67D0DADB01}"/>
               </a:ext>
             </a:extLst>
           </p:cNvPr>
@@ -5876,7 +5876,7 @@
           <p:cNvPr id="3" name="">
             <a:extLst xmlns:a="http://schemas.openxmlformats.org/drawingml/2006/main">
               <a:ext uri="{FF2B5EF4-FFF2-40B4-BE49-F238E27FC236}">
-                <a16:creationId xmlns:a16="http://schemas.microsoft.com/office/drawing/2014/main" id="{6BF2ABCA-6F43-4BF4-90D8-EB050BD240A4}"/>
+                <a16:creationId xmlns:a16="http://schemas.microsoft.com/office/drawing/2014/main" id="{54EF3A24-4CED-4485-9BF1-78C14B7E26DD}"/>
               </a:ext>
             </a:extLst>
           </p:cNvPr>
@@ -5944,7 +5944,7 @@
           <p:cNvPr id="4" name="">
             <a:extLst xmlns:a="http://schemas.openxmlformats.org/drawingml/2006/main">
               <a:ext uri="{FF2B5EF4-FFF2-40B4-BE49-F238E27FC236}">
-                <a16:creationId xmlns:a16="http://schemas.microsoft.com/office/drawing/2014/main" id="{11F0A352-083D-4329-B957-68D5E1FB4B4E}"/>
+                <a16:creationId xmlns:a16="http://schemas.microsoft.com/office/drawing/2014/main" id="{82C4312A-6EA6-44B3-AC6F-D4C9747D4818}"/>
               </a:ext>
             </a:extLst>
           </p:cNvPr>
@@ -5975,7 +5975,7 @@
           <p:cNvPr id="5" name="">
             <a:extLst xmlns:a="http://schemas.openxmlformats.org/drawingml/2006/main">
               <a:ext uri="{FF2B5EF4-FFF2-40B4-BE49-F238E27FC236}">
-                <a16:creationId xmlns:a16="http://schemas.microsoft.com/office/drawing/2014/main" id="{47597C03-D182-491A-BCFA-8DE8359A1EA6}"/>
+                <a16:creationId xmlns:a16="http://schemas.microsoft.com/office/drawing/2014/main" id="{E6BD944C-22C8-41C6-82D3-7079AA30D71D}"/>
               </a:ext>
             </a:extLst>
           </p:cNvPr>
@@ -6010,7 +6010,7 @@
           <p:cNvPr id="6" name="">
             <a:extLst xmlns:a="http://schemas.openxmlformats.org/drawingml/2006/main">
               <a:ext uri="{FF2B5EF4-FFF2-40B4-BE49-F238E27FC236}">
-                <a16:creationId xmlns:a16="http://schemas.microsoft.com/office/drawing/2014/main" id="{BDCD2105-C192-49CC-BBBF-50C18B2CFE0A}"/>
+                <a16:creationId xmlns:a16="http://schemas.microsoft.com/office/drawing/2014/main" id="{ADDEF674-3D4C-49DA-8412-8A6AE03956E2}"/>
               </a:ext>
             </a:extLst>
           </p:cNvPr>
@@ -6085,7 +6085,7 @@
           <p:cNvPr id="7" name="">
             <a:extLst xmlns:a="http://schemas.openxmlformats.org/drawingml/2006/main">
               <a:ext uri="{FF2B5EF4-FFF2-40B4-BE49-F238E27FC236}">
-                <a16:creationId xmlns:a16="http://schemas.microsoft.com/office/drawing/2014/main" id="{FFBF54C9-5BFD-4FEA-A2E4-BD0B7FA01EE4}"/>
+                <a16:creationId xmlns:a16="http://schemas.microsoft.com/office/drawing/2014/main" id="{259C0B77-4C84-41F7-9FE8-2E0C2B888326}"/>
               </a:ext>
             </a:extLst>
           </p:cNvPr>
@@ -6153,7 +6153,7 @@
           <p:cNvPr id="8" name="">
             <a:extLst xmlns:a="http://schemas.openxmlformats.org/drawingml/2006/main">
               <a:ext uri="{FF2B5EF4-FFF2-40B4-BE49-F238E27FC236}">
-                <a16:creationId xmlns:a16="http://schemas.microsoft.com/office/drawing/2014/main" id="{C9CCEB8C-C0F7-4F2B-95B7-FBC9E72F5235}"/>
+                <a16:creationId xmlns:a16="http://schemas.microsoft.com/office/drawing/2014/main" id="{2225B447-69F5-4BE3-83AF-632D4CE59E41}"/>
               </a:ext>
             </a:extLst>
           </p:cNvPr>
@@ -6244,7 +6244,7 @@
           <p:cNvPr id="9" name="">
             <a:extLst xmlns:a="http://schemas.openxmlformats.org/drawingml/2006/main">
               <a:ext uri="{FF2B5EF4-FFF2-40B4-BE49-F238E27FC236}">
-                <a16:creationId xmlns:a16="http://schemas.microsoft.com/office/drawing/2014/main" id="{DB028CCF-CD77-450C-B898-A380506E3FB4}"/>
+                <a16:creationId xmlns:a16="http://schemas.microsoft.com/office/drawing/2014/main" id="{FB163C2A-90FA-4511-9261-BDCA2228B3D4}"/>
               </a:ext>
             </a:extLst>
           </p:cNvPr>
@@ -6276,7 +6276,7 @@
           <p:cNvPr id="10" name="">
             <a:extLst xmlns:a="http://schemas.openxmlformats.org/drawingml/2006/main">
               <a:ext uri="{FF2B5EF4-FFF2-40B4-BE49-F238E27FC236}">
-                <a16:creationId xmlns:a16="http://schemas.microsoft.com/office/drawing/2014/main" id="{5BA480FA-8CD8-482C-911D-460295137C07}"/>
+                <a16:creationId xmlns:a16="http://schemas.microsoft.com/office/drawing/2014/main" id="{C69A7CAD-85E8-44AC-AA06-2F43CC12A600}"/>
               </a:ext>
             </a:extLst>
           </p:cNvPr>
@@ -6311,7 +6311,7 @@
           <p:cNvPr id="11" name="">
             <a:extLst xmlns:a="http://schemas.openxmlformats.org/drawingml/2006/main">
               <a:ext uri="{FF2B5EF4-FFF2-40B4-BE49-F238E27FC236}">
-                <a16:creationId xmlns:a16="http://schemas.microsoft.com/office/drawing/2014/main" id="{1C689833-4C63-4BF0-8430-CB4078FD0543}"/>
+                <a16:creationId xmlns:a16="http://schemas.microsoft.com/office/drawing/2014/main" id="{F6E28A13-7951-49D6-9171-E2428E553E5D}"/>
               </a:ext>
             </a:extLst>
           </p:cNvPr>
@@ -6386,7 +6386,7 @@
           <p:cNvPr id="12" name="">
             <a:extLst xmlns:a="http://schemas.openxmlformats.org/drawingml/2006/main">
               <a:ext uri="{FF2B5EF4-FFF2-40B4-BE49-F238E27FC236}">
-                <a16:creationId xmlns:a16="http://schemas.microsoft.com/office/drawing/2014/main" id="{6CBE1A4D-1817-4DEC-8867-72B1F85FFCCF}"/>
+                <a16:creationId xmlns:a16="http://schemas.microsoft.com/office/drawing/2014/main" id="{9B9EFDA9-E6DE-4804-BACE-39BF916D82C1}"/>
               </a:ext>
             </a:extLst>
           </p:cNvPr>
@@ -6454,7 +6454,7 @@
           <p:cNvPr id="13" name="">
             <a:extLst xmlns:a="http://schemas.openxmlformats.org/drawingml/2006/main">
               <a:ext uri="{FF2B5EF4-FFF2-40B4-BE49-F238E27FC236}">
-                <a16:creationId xmlns:a16="http://schemas.microsoft.com/office/drawing/2014/main" id="{85121026-DBDE-4762-BACD-0B9B4FC27DAA}"/>
+                <a16:creationId xmlns:a16="http://schemas.microsoft.com/office/drawing/2014/main" id="{3647836E-5F98-436D-98E3-D05BEB582387}"/>
               </a:ext>
             </a:extLst>
           </p:cNvPr>
@@ -6545,7 +6545,7 @@
           <p:cNvPr id="14" name="">
             <a:extLst xmlns:a="http://schemas.openxmlformats.org/drawingml/2006/main">
               <a:ext uri="{FF2B5EF4-FFF2-40B4-BE49-F238E27FC236}">
-                <a16:creationId xmlns:a16="http://schemas.microsoft.com/office/drawing/2014/main" id="{2926A533-35EE-4505-B9A0-02DAB7B1E4B6}"/>
+                <a16:creationId xmlns:a16="http://schemas.microsoft.com/office/drawing/2014/main" id="{6A354986-9CB8-461C-B65F-EDA77501B9A6}"/>
               </a:ext>
             </a:extLst>
           </p:cNvPr>
@@ -6577,7 +6577,7 @@
           <p:cNvPr id="15" name="">
             <a:extLst xmlns:a="http://schemas.openxmlformats.org/drawingml/2006/main">
               <a:ext uri="{FF2B5EF4-FFF2-40B4-BE49-F238E27FC236}">
-                <a16:creationId xmlns:a16="http://schemas.microsoft.com/office/drawing/2014/main" id="{296C79B1-15C2-498D-A676-99D25EDDEE9B}"/>
+                <a16:creationId xmlns:a16="http://schemas.microsoft.com/office/drawing/2014/main" id="{8E68779E-8873-4963-95D6-26CC3BBCF642}"/>
               </a:ext>
             </a:extLst>
           </p:cNvPr>
@@ -6612,7 +6612,7 @@
           <p:cNvPr id="16" name="">
             <a:extLst xmlns:a="http://schemas.openxmlformats.org/drawingml/2006/main">
               <a:ext uri="{FF2B5EF4-FFF2-40B4-BE49-F238E27FC236}">
-                <a16:creationId xmlns:a16="http://schemas.microsoft.com/office/drawing/2014/main" id="{A679DDD1-1853-4A33-8E0A-AABC189A0FDA}"/>
+                <a16:creationId xmlns:a16="http://schemas.microsoft.com/office/drawing/2014/main" id="{0FD27A0C-EBD9-48CF-AD1C-85959AB88864}"/>
               </a:ext>
             </a:extLst>
           </p:cNvPr>
@@ -6687,7 +6687,7 @@
           <p:cNvPr id="17" name="">
             <a:extLst xmlns:a="http://schemas.openxmlformats.org/drawingml/2006/main">
               <a:ext uri="{FF2B5EF4-FFF2-40B4-BE49-F238E27FC236}">
-                <a16:creationId xmlns:a16="http://schemas.microsoft.com/office/drawing/2014/main" id="{4F0F0516-4072-4627-94E1-C2D5739A4902}"/>
+                <a16:creationId xmlns:a16="http://schemas.microsoft.com/office/drawing/2014/main" id="{1A5715D8-44DD-4CA0-A8B2-E6D4CF532B5D}"/>
               </a:ext>
             </a:extLst>
           </p:cNvPr>
@@ -6755,7 +6755,7 @@
           <p:cNvPr id="18" name="">
             <a:extLst xmlns:a="http://schemas.openxmlformats.org/drawingml/2006/main">
               <a:ext uri="{FF2B5EF4-FFF2-40B4-BE49-F238E27FC236}">
-                <a16:creationId xmlns:a16="http://schemas.microsoft.com/office/drawing/2014/main" id="{5620C074-7B42-40BE-8518-651FB4BF79DD}"/>
+                <a16:creationId xmlns:a16="http://schemas.microsoft.com/office/drawing/2014/main" id="{8E8A700A-1B99-4F48-B028-960976B004F3}"/>
               </a:ext>
             </a:extLst>
           </p:cNvPr>
@@ -6846,7 +6846,7 @@
           <p:cNvPr id="19" name="">
             <a:extLst xmlns:a="http://schemas.openxmlformats.org/drawingml/2006/main">
               <a:ext uri="{FF2B5EF4-FFF2-40B4-BE49-F238E27FC236}">
-                <a16:creationId xmlns:a16="http://schemas.microsoft.com/office/drawing/2014/main" id="{3247B7DE-A5CB-43C9-A26A-6BF53A9CC333}"/>
+                <a16:creationId xmlns:a16="http://schemas.microsoft.com/office/drawing/2014/main" id="{2B8CFDD4-2E99-4373-A919-3675EF0F625C}"/>
               </a:ext>
             </a:extLst>
           </p:cNvPr>
@@ -6878,7 +6878,7 @@
           <p:cNvPr id="20" name="">
             <a:extLst xmlns:a="http://schemas.openxmlformats.org/drawingml/2006/main">
               <a:ext uri="{FF2B5EF4-FFF2-40B4-BE49-F238E27FC236}">
-                <a16:creationId xmlns:a16="http://schemas.microsoft.com/office/drawing/2014/main" id="{73F857F0-23E9-4CFD-ACE3-07A07BBD74C4}"/>
+                <a16:creationId xmlns:a16="http://schemas.microsoft.com/office/drawing/2014/main" id="{AAA0010D-F5C6-4E17-A5AD-7E57B0692C4E}"/>
               </a:ext>
             </a:extLst>
           </p:cNvPr>
@@ -6913,7 +6913,7 @@
           <p:cNvPr id="21" name="">
             <a:extLst xmlns:a="http://schemas.openxmlformats.org/drawingml/2006/main">
               <a:ext uri="{FF2B5EF4-FFF2-40B4-BE49-F238E27FC236}">
-                <a16:creationId xmlns:a16="http://schemas.microsoft.com/office/drawing/2014/main" id="{F6CAC8BE-56C4-4DC0-97ED-EA812AAAB1F5}"/>
+                <a16:creationId xmlns:a16="http://schemas.microsoft.com/office/drawing/2014/main" id="{E580D098-4F13-4C24-BAD8-43B992789A36}"/>
               </a:ext>
             </a:extLst>
           </p:cNvPr>
@@ -6988,7 +6988,7 @@
           <p:cNvPr id="22" name="">
             <a:extLst xmlns:a="http://schemas.openxmlformats.org/drawingml/2006/main">
               <a:ext uri="{FF2B5EF4-FFF2-40B4-BE49-F238E27FC236}">
-                <a16:creationId xmlns:a16="http://schemas.microsoft.com/office/drawing/2014/main" id="{1356BB56-ED81-471C-ACFF-AFF0246BE522}"/>
+                <a16:creationId xmlns:a16="http://schemas.microsoft.com/office/drawing/2014/main" id="{3FA43498-C6B0-49B3-B33C-09F79DC3B7D3}"/>
               </a:ext>
             </a:extLst>
           </p:cNvPr>
@@ -7056,7 +7056,7 @@
           <p:cNvPr id="23" name="">
             <a:extLst xmlns:a="http://schemas.openxmlformats.org/drawingml/2006/main">
               <a:ext uri="{FF2B5EF4-FFF2-40B4-BE49-F238E27FC236}">
-                <a16:creationId xmlns:a16="http://schemas.microsoft.com/office/drawing/2014/main" id="{14D41408-A346-4A9F-B70A-BE7BF5E46F5F}"/>
+                <a16:creationId xmlns:a16="http://schemas.microsoft.com/office/drawing/2014/main" id="{3CF82815-01BF-49F2-9FC6-F3DE7D0B5DB0}"/>
               </a:ext>
             </a:extLst>
           </p:cNvPr>
@@ -7147,7 +7147,7 @@
           <p:cNvPr id="24" name="">
             <a:extLst xmlns:a="http://schemas.openxmlformats.org/drawingml/2006/main">
               <a:ext uri="{FF2B5EF4-FFF2-40B4-BE49-F238E27FC236}">
-                <a16:creationId xmlns:a16="http://schemas.microsoft.com/office/drawing/2014/main" id="{863E44B5-7685-406D-9D68-432C5E028BC4}"/>
+                <a16:creationId xmlns:a16="http://schemas.microsoft.com/office/drawing/2014/main" id="{FD2D4115-D265-43CC-BEDC-923431C0E83B}"/>
               </a:ext>
             </a:extLst>
           </p:cNvPr>
@@ -7179,7 +7179,7 @@
           <p:cNvPr id="25" name="">
             <a:extLst xmlns:a="http://schemas.openxmlformats.org/drawingml/2006/main">
               <a:ext uri="{FF2B5EF4-FFF2-40B4-BE49-F238E27FC236}">
-                <a16:creationId xmlns:a16="http://schemas.microsoft.com/office/drawing/2014/main" id="{69201FD4-EC92-4568-91D1-AB0D91CD8736}"/>
+                <a16:creationId xmlns:a16="http://schemas.microsoft.com/office/drawing/2014/main" id="{182A502E-7555-4F53-B9E4-AAA63B999988}"/>
               </a:ext>
             </a:extLst>
           </p:cNvPr>
@@ -7214,7 +7214,7 @@
           <p:cNvPr id="26" name="">
             <a:extLst xmlns:a="http://schemas.openxmlformats.org/drawingml/2006/main">
               <a:ext uri="{FF2B5EF4-FFF2-40B4-BE49-F238E27FC236}">
-                <a16:creationId xmlns:a16="http://schemas.microsoft.com/office/drawing/2014/main" id="{C1BA9D0A-5B50-4348-A3CA-81ED4260D40B}"/>
+                <a16:creationId xmlns:a16="http://schemas.microsoft.com/office/drawing/2014/main" id="{873499FA-533C-43FA-9AC7-2AF2CD30A0A6}"/>
               </a:ext>
             </a:extLst>
           </p:cNvPr>
@@ -7289,7 +7289,7 @@
           <p:cNvPr id="27" name="">
             <a:extLst xmlns:a="http://schemas.openxmlformats.org/drawingml/2006/main">
               <a:ext uri="{FF2B5EF4-FFF2-40B4-BE49-F238E27FC236}">
-                <a16:creationId xmlns:a16="http://schemas.microsoft.com/office/drawing/2014/main" id="{79D533AB-EE35-4746-8454-8E91CD624E8A}"/>
+                <a16:creationId xmlns:a16="http://schemas.microsoft.com/office/drawing/2014/main" id="{CA865879-7C2C-4AE0-8F31-B2D43D718CE8}"/>
               </a:ext>
             </a:extLst>
           </p:cNvPr>
@@ -7357,7 +7357,7 @@
           <p:cNvPr id="28" name="">
             <a:extLst xmlns:a="http://schemas.openxmlformats.org/drawingml/2006/main">
               <a:ext uri="{FF2B5EF4-FFF2-40B4-BE49-F238E27FC236}">
-                <a16:creationId xmlns:a16="http://schemas.microsoft.com/office/drawing/2014/main" id="{D467DE8D-1C23-4C78-8D63-78E3062D60BD}"/>
+                <a16:creationId xmlns:a16="http://schemas.microsoft.com/office/drawing/2014/main" id="{38A503B2-D3FF-4AB2-A0B8-B5042D8539A1}"/>
               </a:ext>
             </a:extLst>
           </p:cNvPr>
@@ -7448,7 +7448,7 @@
           <p:cNvPr id="29" name="">
             <a:extLst xmlns:a="http://schemas.openxmlformats.org/drawingml/2006/main">
               <a:ext uri="{FF2B5EF4-FFF2-40B4-BE49-F238E27FC236}">
-                <a16:creationId xmlns:a16="http://schemas.microsoft.com/office/drawing/2014/main" id="{0F091B39-9711-476E-A307-AE1F36B1618C}"/>
+                <a16:creationId xmlns:a16="http://schemas.microsoft.com/office/drawing/2014/main" id="{7D036249-7C27-412B-8861-C62C5BCBAD4C}"/>
               </a:ext>
             </a:extLst>
           </p:cNvPr>
@@ -7516,7 +7516,7 @@
           <p:cNvPr id="30" name="">
             <a:extLst xmlns:a="http://schemas.openxmlformats.org/drawingml/2006/main">
               <a:ext uri="{FF2B5EF4-FFF2-40B4-BE49-F238E27FC236}">
-                <a16:creationId xmlns:a16="http://schemas.microsoft.com/office/drawing/2014/main" id="{55D6C0E0-41C9-44A0-A2CB-921CE7E8C52F}"/>
+                <a16:creationId xmlns:a16="http://schemas.microsoft.com/office/drawing/2014/main" id="{F92FE36C-CD71-4DED-951C-DBC3DCD65948}"/>
               </a:ext>
             </a:extLst>
           </p:cNvPr>
@@ -7551,7 +7551,7 @@
           <p:cNvPr id="31" name="">
             <a:extLst xmlns:a="http://schemas.openxmlformats.org/drawingml/2006/main">
               <a:ext uri="{FF2B5EF4-FFF2-40B4-BE49-F238E27FC236}">
-                <a16:creationId xmlns:a16="http://schemas.microsoft.com/office/drawing/2014/main" id="{2380EE7B-D579-4412-ACCD-3CE2694AE61E}"/>
+                <a16:creationId xmlns:a16="http://schemas.microsoft.com/office/drawing/2014/main" id="{61C03DE5-97D9-4BCA-A478-19FBA735CAF4}"/>
               </a:ext>
             </a:extLst>
           </p:cNvPr>
@@ -7619,7 +7619,7 @@
           <p:cNvPr id="32" name="">
             <a:extLst xmlns:a="http://schemas.openxmlformats.org/drawingml/2006/main">
               <a:ext uri="{FF2B5EF4-FFF2-40B4-BE49-F238E27FC236}">
-                <a16:creationId xmlns:a16="http://schemas.microsoft.com/office/drawing/2014/main" id="{17C646E2-0A78-4061-984A-CAFFE1F92A4D}"/>
+                <a16:creationId xmlns:a16="http://schemas.microsoft.com/office/drawing/2014/main" id="{E9AFD57F-2484-44E6-8AF2-8DA84BD73B8D}"/>
               </a:ext>
             </a:extLst>
           </p:cNvPr>
@@ -7733,7 +7733,7 @@
           <p:cNvPr id="33" name="">
             <a:extLst xmlns:a="http://schemas.openxmlformats.org/drawingml/2006/main">
               <a:ext uri="{FF2B5EF4-FFF2-40B4-BE49-F238E27FC236}">
-                <a16:creationId xmlns:a16="http://schemas.microsoft.com/office/drawing/2014/main" id="{2BE2C950-1DE9-4E79-828B-F0E0E80A714B}"/>
+                <a16:creationId xmlns:a16="http://schemas.microsoft.com/office/drawing/2014/main" id="{4B684244-C990-491D-B4D0-C8F86662A988}"/>
               </a:ext>
             </a:extLst>
           </p:cNvPr>
@@ -7808,7 +7808,7 @@
           <p:cNvPr id="34" name="">
             <a:extLst xmlns:a="http://schemas.openxmlformats.org/drawingml/2006/main">
               <a:ext uri="{FF2B5EF4-FFF2-40B4-BE49-F238E27FC236}">
-                <a16:creationId xmlns:a16="http://schemas.microsoft.com/office/drawing/2014/main" id="{7BE3ADB4-9647-4082-9BB6-EAC32FF9374B}"/>
+                <a16:creationId xmlns:a16="http://schemas.microsoft.com/office/drawing/2014/main" id="{92976958-097E-44DF-B3AA-A184D9303AFD}"/>
               </a:ext>
             </a:extLst>
           </p:cNvPr>
@@ -7876,7 +7876,7 @@
           <p:cNvPr id="35" name="">
             <a:extLst xmlns:a="http://schemas.openxmlformats.org/drawingml/2006/main">
               <a:ext uri="{FF2B5EF4-FFF2-40B4-BE49-F238E27FC236}">
-                <a16:creationId xmlns:a16="http://schemas.microsoft.com/office/drawing/2014/main" id="{BFD53BC9-905D-488C-9EEC-374FA4B966F8}"/>
+                <a16:creationId xmlns:a16="http://schemas.microsoft.com/office/drawing/2014/main" id="{9E5737C1-1757-4818-A59B-72D410B3B737}"/>
               </a:ext>
             </a:extLst>
           </p:cNvPr>
@@ -7911,7 +7911,7 @@
           <p:cNvPr id="36" name="">
             <a:extLst xmlns:a="http://schemas.openxmlformats.org/drawingml/2006/main">
               <a:ext uri="{FF2B5EF4-FFF2-40B4-BE49-F238E27FC236}">
-                <a16:creationId xmlns:a16="http://schemas.microsoft.com/office/drawing/2014/main" id="{4167A940-D8D5-4F63-8BC2-8646D1440FAD}"/>
+                <a16:creationId xmlns:a16="http://schemas.microsoft.com/office/drawing/2014/main" id="{2FF915CE-F690-4037-B426-544DF9D75143}"/>
               </a:ext>
             </a:extLst>
           </p:cNvPr>
@@ -7979,7 +7979,7 @@
           <p:cNvPr id="37" name="">
             <a:extLst xmlns:a="http://schemas.openxmlformats.org/drawingml/2006/main">
               <a:ext uri="{FF2B5EF4-FFF2-40B4-BE49-F238E27FC236}">
-                <a16:creationId xmlns:a16="http://schemas.microsoft.com/office/drawing/2014/main" id="{1C769F95-DE0E-4F5A-977A-18EE2CCF030C}"/>
+                <a16:creationId xmlns:a16="http://schemas.microsoft.com/office/drawing/2014/main" id="{319C092D-C924-4E0F-B5D5-68062852EB8B}"/>
               </a:ext>
             </a:extLst>
           </p:cNvPr>
@@ -8014,7 +8014,7 @@
           <p:cNvPr id="38" name="">
             <a:extLst xmlns:a="http://schemas.openxmlformats.org/drawingml/2006/main">
               <a:ext uri="{FF2B5EF4-FFF2-40B4-BE49-F238E27FC236}">
-                <a16:creationId xmlns:a16="http://schemas.microsoft.com/office/drawing/2014/main" id="{41F983F8-BEAA-4E89-A012-12C9C2CC825E}"/>
+                <a16:creationId xmlns:a16="http://schemas.microsoft.com/office/drawing/2014/main" id="{BA8BAAC5-A0C2-422A-8B64-6EFA7C7648D2}"/>
               </a:ext>
             </a:extLst>
           </p:cNvPr>
@@ -8082,7 +8082,7 @@
           <p:cNvPr id="39" name="">
             <a:extLst xmlns:a="http://schemas.openxmlformats.org/drawingml/2006/main">
               <a:ext uri="{FF2B5EF4-FFF2-40B4-BE49-F238E27FC236}">
-                <a16:creationId xmlns:a16="http://schemas.microsoft.com/office/drawing/2014/main" id="{0D7B4743-2824-45F9-A735-D5E8D007877B}"/>
+                <a16:creationId xmlns:a16="http://schemas.microsoft.com/office/drawing/2014/main" id="{73555FD1-1EA9-4405-8F0D-3E1FDC7F5924}"/>
               </a:ext>
             </a:extLst>
           </p:cNvPr>
@@ -8150,7 +8150,7 @@
           <p:cNvPr id="40" name="">
             <a:extLst xmlns:a="http://schemas.openxmlformats.org/drawingml/2006/main">
               <a:ext uri="{FF2B5EF4-FFF2-40B4-BE49-F238E27FC236}">
-                <a16:creationId xmlns:a16="http://schemas.microsoft.com/office/drawing/2014/main" id="{7723BEEF-D298-4775-8D48-4AA059C634E9}"/>
+                <a16:creationId xmlns:a16="http://schemas.microsoft.com/office/drawing/2014/main" id="{9A123355-2A14-4147-8410-3A979C8B48FF}"/>
               </a:ext>
             </a:extLst>
           </p:cNvPr>
@@ -8185,7 +8185,7 @@
           <p:cNvPr id="41" name="">
             <a:extLst xmlns:a="http://schemas.openxmlformats.org/drawingml/2006/main">
               <a:ext uri="{FF2B5EF4-FFF2-40B4-BE49-F238E27FC236}">
-                <a16:creationId xmlns:a16="http://schemas.microsoft.com/office/drawing/2014/main" id="{5AD0495D-E253-41F4-A8D3-15665A7B7341}"/>
+                <a16:creationId xmlns:a16="http://schemas.microsoft.com/office/drawing/2014/main" id="{1F33B318-6E5E-4437-BC83-3E64E948C54B}"/>
               </a:ext>
             </a:extLst>
           </p:cNvPr>
@@ -8253,7 +8253,7 @@
           <p:cNvPr id="42" name="">
             <a:extLst xmlns:a="http://schemas.openxmlformats.org/drawingml/2006/main">
               <a:ext uri="{FF2B5EF4-FFF2-40B4-BE49-F238E27FC236}">
-                <a16:creationId xmlns:a16="http://schemas.microsoft.com/office/drawing/2014/main" id="{E5A75A25-9D94-4654-B810-B40DFDDB6D07}"/>
+                <a16:creationId xmlns:a16="http://schemas.microsoft.com/office/drawing/2014/main" id="{310AD5F8-BBBB-4E1C-B8DF-E6B43844E5EF}"/>
               </a:ext>
             </a:extLst>
           </p:cNvPr>
@@ -8321,7 +8321,7 @@
           <p:cNvPr id="43" name="">
             <a:extLst xmlns:a="http://schemas.openxmlformats.org/drawingml/2006/main">
               <a:ext uri="{FF2B5EF4-FFF2-40B4-BE49-F238E27FC236}">
-                <a16:creationId xmlns:a16="http://schemas.microsoft.com/office/drawing/2014/main" id="{5820A608-1E54-455C-982A-B2B049053326}"/>
+                <a16:creationId xmlns:a16="http://schemas.microsoft.com/office/drawing/2014/main" id="{4EBF5BC1-D0EF-4A4C-BDAA-3A462918EFBF}"/>
               </a:ext>
             </a:extLst>
           </p:cNvPr>
@@ -8389,7 +8389,7 @@
           <p:cNvPr id="44" name="">
             <a:extLst xmlns:a="http://schemas.openxmlformats.org/drawingml/2006/main">
               <a:ext uri="{FF2B5EF4-FFF2-40B4-BE49-F238E27FC236}">
-                <a16:creationId xmlns:a16="http://schemas.microsoft.com/office/drawing/2014/main" id="{1E9720B0-8D7A-475E-9ABE-B4A4F55BA423}"/>
+                <a16:creationId xmlns:a16="http://schemas.microsoft.com/office/drawing/2014/main" id="{432C5499-3EF0-45AE-A4DB-6333160B47F5}"/>
               </a:ext>
             </a:extLst>
           </p:cNvPr>
@@ -8447,7 +8447,7 @@
                 <a:ea typeface="Arial"/>
                 <a:cs typeface="Arial"/>
               </a:rPr>
-              <a:t>AURA • Track A • 06/10/2026</a:t>
+              <a:t>AURA • Track A • 11/10/2026</a:t>
             </a:r>
           </a:p>
         </p:txBody>
@@ -8457,7 +8457,7 @@
           <p:cNvPr id="45" name="">
             <a:extLst xmlns:a="http://schemas.openxmlformats.org/drawingml/2006/main">
               <a:ext uri="{FF2B5EF4-FFF2-40B4-BE49-F238E27FC236}">
-                <a16:creationId xmlns:a16="http://schemas.microsoft.com/office/drawing/2014/main" id="{AEB961DF-6E51-4924-8B60-873652C6A283}"/>
+                <a16:creationId xmlns:a16="http://schemas.microsoft.com/office/drawing/2014/main" id="{8C60A756-F571-4B3B-9F60-6D13381CBCA9}"/>
               </a:ext>
             </a:extLst>
           </p:cNvPr>
@@ -8523,7 +8523,7 @@
     </p:spTree>
     <p:extLst>
       <p:ext uri="{BB962C8B-B14F-4D97-AF65-F5344CB8AC3E}">
-        <p14:creationId xmlns:p14="http://schemas.microsoft.com/office/powerpoint/2010/main" val="1491870103"/>
+        <p14:creationId xmlns:p14="http://schemas.microsoft.com/office/powerpoint/2010/main" val="130298760"/>
       </p:ext>
     </p:extLst>
   </p:cSld>
@@ -8554,7 +8554,7 @@
           <p:cNvPr id="32" name="">
             <a:extLst xmlns:a="http://schemas.openxmlformats.org/drawingml/2006/main">
               <a:ext uri="{FF2B5EF4-FFF2-40B4-BE49-F238E27FC236}">
-                <a16:creationId xmlns:a16="http://schemas.microsoft.com/office/drawing/2014/main" id="{F57A0F86-67C8-4AAB-8047-CE83F66E90FD}"/>
+                <a16:creationId xmlns:a16="http://schemas.microsoft.com/office/drawing/2014/main" id="{BC9BEFC3-8C49-4A48-B0F5-C1F90100540E}"/>
               </a:ext>
             </a:extLst>
           </p:cNvPr>
@@ -8622,7 +8622,7 @@
           <p:cNvPr id="2" name="">
             <a:extLst xmlns:a="http://schemas.openxmlformats.org/drawingml/2006/main">
               <a:ext uri="{FF2B5EF4-FFF2-40B4-BE49-F238E27FC236}">
-                <a16:creationId xmlns:a16="http://schemas.microsoft.com/office/drawing/2014/main" id="{CAC861C6-11A0-4A6F-94C0-ECC5CCCD84A9}"/>
+                <a16:creationId xmlns:a16="http://schemas.microsoft.com/office/drawing/2014/main" id="{849F21BF-3349-4982-B91D-6684A2A0DA47}"/>
               </a:ext>
             </a:extLst>
           </p:cNvPr>
@@ -8690,7 +8690,7 @@
           <p:cNvPr id="3" name="">
             <a:extLst xmlns:a="http://schemas.openxmlformats.org/drawingml/2006/main">
               <a:ext uri="{FF2B5EF4-FFF2-40B4-BE49-F238E27FC236}">
-                <a16:creationId xmlns:a16="http://schemas.microsoft.com/office/drawing/2014/main" id="{391168F9-31BA-4F54-9176-62B6A0A549C0}"/>
+                <a16:creationId xmlns:a16="http://schemas.microsoft.com/office/drawing/2014/main" id="{9C4F529A-2E4E-4738-9A13-F4DA3861B870}"/>
               </a:ext>
             </a:extLst>
           </p:cNvPr>
@@ -8758,7 +8758,7 @@
           <p:cNvPr id="4" name="">
             <a:extLst xmlns:a="http://schemas.openxmlformats.org/drawingml/2006/main">
               <a:ext uri="{FF2B5EF4-FFF2-40B4-BE49-F238E27FC236}">
-                <a16:creationId xmlns:a16="http://schemas.microsoft.com/office/drawing/2014/main" id="{56A83B37-1CD1-450D-9806-F3B8018D2059}"/>
+                <a16:creationId xmlns:a16="http://schemas.microsoft.com/office/drawing/2014/main" id="{5D275984-D957-483A-B34F-636BC19D0CA5}"/>
               </a:ext>
             </a:extLst>
           </p:cNvPr>
@@ -8789,7 +8789,7 @@
           <p:cNvPr id="5" name="">
             <a:extLst xmlns:a="http://schemas.openxmlformats.org/drawingml/2006/main">
               <a:ext uri="{FF2B5EF4-FFF2-40B4-BE49-F238E27FC236}">
-                <a16:creationId xmlns:a16="http://schemas.microsoft.com/office/drawing/2014/main" id="{356CFC02-2E50-4FB2-9F14-7BDE327E6478}"/>
+                <a16:creationId xmlns:a16="http://schemas.microsoft.com/office/drawing/2014/main" id="{E09AF19D-EEC9-4229-9B81-A80F2A85D55D}"/>
               </a:ext>
             </a:extLst>
           </p:cNvPr>
@@ -8824,7 +8824,7 @@
           <p:cNvPr id="6" name="">
             <a:extLst xmlns:a="http://schemas.openxmlformats.org/drawingml/2006/main">
               <a:ext uri="{FF2B5EF4-FFF2-40B4-BE49-F238E27FC236}">
-                <a16:creationId xmlns:a16="http://schemas.microsoft.com/office/drawing/2014/main" id="{9F8B5CE4-1E97-4444-AC5A-EA57B0925BBE}"/>
+                <a16:creationId xmlns:a16="http://schemas.microsoft.com/office/drawing/2014/main" id="{82E577BD-904B-4025-8C47-719E38051AED}"/>
               </a:ext>
             </a:extLst>
           </p:cNvPr>
@@ -8899,7 +8899,7 @@
           <p:cNvPr id="7" name="">
             <a:extLst xmlns:a="http://schemas.openxmlformats.org/drawingml/2006/main">
               <a:ext uri="{FF2B5EF4-FFF2-40B4-BE49-F238E27FC236}">
-                <a16:creationId xmlns:a16="http://schemas.microsoft.com/office/drawing/2014/main" id="{85E87C2D-E4B5-4303-B917-8BE5D06C9BC0}"/>
+                <a16:creationId xmlns:a16="http://schemas.microsoft.com/office/drawing/2014/main" id="{9A149BEB-89C3-44F5-AD98-46CB943D89BE}"/>
               </a:ext>
             </a:extLst>
           </p:cNvPr>
@@ -8967,7 +8967,7 @@
           <p:cNvPr id="8" name="">
             <a:extLst xmlns:a="http://schemas.openxmlformats.org/drawingml/2006/main">
               <a:ext uri="{FF2B5EF4-FFF2-40B4-BE49-F238E27FC236}">
-                <a16:creationId xmlns:a16="http://schemas.microsoft.com/office/drawing/2014/main" id="{B12767FF-517A-4AF1-88A5-43C3E0BE74CC}"/>
+                <a16:creationId xmlns:a16="http://schemas.microsoft.com/office/drawing/2014/main" id="{F602B184-B862-4F06-B722-0F433954E7F9}"/>
               </a:ext>
             </a:extLst>
           </p:cNvPr>
@@ -9081,7 +9081,7 @@
           <p:cNvPr id="9" name="">
             <a:extLst xmlns:a="http://schemas.openxmlformats.org/drawingml/2006/main">
               <a:ext uri="{FF2B5EF4-FFF2-40B4-BE49-F238E27FC236}">
-                <a16:creationId xmlns:a16="http://schemas.microsoft.com/office/drawing/2014/main" id="{564FD274-5924-49A0-A62E-EE2356B62A36}"/>
+                <a16:creationId xmlns:a16="http://schemas.microsoft.com/office/drawing/2014/main" id="{FB6F16B8-DAAF-4E82-BFA3-BD3C2A50DC3C}"/>
               </a:ext>
             </a:extLst>
           </p:cNvPr>
@@ -9116,7 +9116,7 @@
           <p:cNvPr id="10" name="">
             <a:extLst xmlns:a="http://schemas.openxmlformats.org/drawingml/2006/main">
               <a:ext uri="{FF2B5EF4-FFF2-40B4-BE49-F238E27FC236}">
-                <a16:creationId xmlns:a16="http://schemas.microsoft.com/office/drawing/2014/main" id="{E1491C58-05E4-4D17-BFB5-8F726C9FBDAD}"/>
+                <a16:creationId xmlns:a16="http://schemas.microsoft.com/office/drawing/2014/main" id="{8B6864D3-7965-4676-90A1-74C2D385C481}"/>
               </a:ext>
             </a:extLst>
           </p:cNvPr>
@@ -9191,7 +9191,7 @@
           <p:cNvPr id="11" name="">
             <a:extLst xmlns:a="http://schemas.openxmlformats.org/drawingml/2006/main">
               <a:ext uri="{FF2B5EF4-FFF2-40B4-BE49-F238E27FC236}">
-                <a16:creationId xmlns:a16="http://schemas.microsoft.com/office/drawing/2014/main" id="{CC660AFA-C8E1-41BB-B9EC-12270DB891C1}"/>
+                <a16:creationId xmlns:a16="http://schemas.microsoft.com/office/drawing/2014/main" id="{8E58FFC5-841E-4259-97BB-DF38EC1743B7}"/>
               </a:ext>
             </a:extLst>
           </p:cNvPr>
@@ -9259,7 +9259,7 @@
           <p:cNvPr id="12" name="">
             <a:extLst xmlns:a="http://schemas.openxmlformats.org/drawingml/2006/main">
               <a:ext uri="{FF2B5EF4-FFF2-40B4-BE49-F238E27FC236}">
-                <a16:creationId xmlns:a16="http://schemas.microsoft.com/office/drawing/2014/main" id="{CC7DFC57-A99E-4EF8-93A0-55A9F642EEA4}"/>
+                <a16:creationId xmlns:a16="http://schemas.microsoft.com/office/drawing/2014/main" id="{27CE3C12-ABD9-4D92-B08F-4AA66CAA5023}"/>
               </a:ext>
             </a:extLst>
           </p:cNvPr>
@@ -9373,7 +9373,7 @@
           <p:cNvPr id="13" name="">
             <a:extLst xmlns:a="http://schemas.openxmlformats.org/drawingml/2006/main">
               <a:ext uri="{FF2B5EF4-FFF2-40B4-BE49-F238E27FC236}">
-                <a16:creationId xmlns:a16="http://schemas.microsoft.com/office/drawing/2014/main" id="{E0872D40-AC33-4D01-8777-51660F13E453}"/>
+                <a16:creationId xmlns:a16="http://schemas.microsoft.com/office/drawing/2014/main" id="{8CEEE17A-6C4D-4686-B161-109627043215}"/>
               </a:ext>
             </a:extLst>
           </p:cNvPr>
@@ -9441,7 +9441,7 @@
           <p:cNvPr id="14" name="">
             <a:extLst xmlns:a="http://schemas.openxmlformats.org/drawingml/2006/main">
               <a:ext uri="{FF2B5EF4-FFF2-40B4-BE49-F238E27FC236}">
-                <a16:creationId xmlns:a16="http://schemas.microsoft.com/office/drawing/2014/main" id="{29EB2C63-5972-4EC1-A035-998EDF4108A6}"/>
+                <a16:creationId xmlns:a16="http://schemas.microsoft.com/office/drawing/2014/main" id="{BD1CD5FD-3F10-46EB-93CF-AE2D1D3E9744}"/>
               </a:ext>
             </a:extLst>
           </p:cNvPr>
@@ -9476,7 +9476,7 @@
           <p:cNvPr id="15" name="">
             <a:extLst xmlns:a="http://schemas.openxmlformats.org/drawingml/2006/main">
               <a:ext uri="{FF2B5EF4-FFF2-40B4-BE49-F238E27FC236}">
-                <a16:creationId xmlns:a16="http://schemas.microsoft.com/office/drawing/2014/main" id="{0241D9FF-1862-433A-8F7E-835E309B1DD5}"/>
+                <a16:creationId xmlns:a16="http://schemas.microsoft.com/office/drawing/2014/main" id="{1D93B0A7-172C-4D52-A193-F7815590C712}"/>
               </a:ext>
             </a:extLst>
           </p:cNvPr>
@@ -9534,7 +9534,7 @@
                 <a:ea typeface="Arial"/>
                 <a:cs typeface="Arial"/>
               </a:rPr>
-              <a:t>122/122</a:t>
+              <a:t>142/142</a:t>
             </a:r>
           </a:p>
         </p:txBody>
@@ -9544,7 +9544,7 @@
           <p:cNvPr id="16" name="">
             <a:extLst xmlns:a="http://schemas.openxmlformats.org/drawingml/2006/main">
               <a:ext uri="{FF2B5EF4-FFF2-40B4-BE49-F238E27FC236}">
-                <a16:creationId xmlns:a16="http://schemas.microsoft.com/office/drawing/2014/main" id="{4EEB6B0D-A84C-49F2-8626-CDDF65BA7193}"/>
+                <a16:creationId xmlns:a16="http://schemas.microsoft.com/office/drawing/2014/main" id="{19E939AC-DD9D-4EEC-AB6B-37570B09AA26}"/>
               </a:ext>
             </a:extLst>
           </p:cNvPr>
@@ -9612,7 +9612,7 @@
           <p:cNvPr id="17" name="">
             <a:extLst xmlns:a="http://schemas.openxmlformats.org/drawingml/2006/main">
               <a:ext uri="{FF2B5EF4-FFF2-40B4-BE49-F238E27FC236}">
-                <a16:creationId xmlns:a16="http://schemas.microsoft.com/office/drawing/2014/main" id="{E192A4FF-2819-436C-90EF-F26F9B91FB09}"/>
+                <a16:creationId xmlns:a16="http://schemas.microsoft.com/office/drawing/2014/main" id="{DD921B7A-A770-409E-BB48-811C6D2400B5}"/>
               </a:ext>
             </a:extLst>
           </p:cNvPr>
@@ -9647,7 +9647,7 @@
           <p:cNvPr id="18" name="">
             <a:extLst xmlns:a="http://schemas.openxmlformats.org/drawingml/2006/main">
               <a:ext uri="{FF2B5EF4-FFF2-40B4-BE49-F238E27FC236}">
-                <a16:creationId xmlns:a16="http://schemas.microsoft.com/office/drawing/2014/main" id="{9FE1F026-624C-4E37-A4E3-CDB0E61CBAEE}"/>
+                <a16:creationId xmlns:a16="http://schemas.microsoft.com/office/drawing/2014/main" id="{B562D395-BDE7-438D-A0C1-5A1FBE8037ED}"/>
               </a:ext>
             </a:extLst>
           </p:cNvPr>
@@ -9715,7 +9715,7 @@
           <p:cNvPr id="19" name="">
             <a:extLst xmlns:a="http://schemas.openxmlformats.org/drawingml/2006/main">
               <a:ext uri="{FF2B5EF4-FFF2-40B4-BE49-F238E27FC236}">
-                <a16:creationId xmlns:a16="http://schemas.microsoft.com/office/drawing/2014/main" id="{EA801832-13BC-41E6-995F-3C10E4A5FD5C}"/>
+                <a16:creationId xmlns:a16="http://schemas.microsoft.com/office/drawing/2014/main" id="{CA2A18B6-78F5-4D42-B2EB-C67323FD4B4D}"/>
               </a:ext>
             </a:extLst>
           </p:cNvPr>
@@ -9783,7 +9783,7 @@
           <p:cNvPr id="20" name="">
             <a:extLst xmlns:a="http://schemas.openxmlformats.org/drawingml/2006/main">
               <a:ext uri="{FF2B5EF4-FFF2-40B4-BE49-F238E27FC236}">
-                <a16:creationId xmlns:a16="http://schemas.microsoft.com/office/drawing/2014/main" id="{94A9C4D0-895C-4097-AA88-BC6C909FFB1D}"/>
+                <a16:creationId xmlns:a16="http://schemas.microsoft.com/office/drawing/2014/main" id="{FC930A4B-D8C0-43E8-A917-A5801EB24633}"/>
               </a:ext>
             </a:extLst>
           </p:cNvPr>
@@ -9818,7 +9818,7 @@
           <p:cNvPr id="21" name="">
             <a:extLst xmlns:a="http://schemas.openxmlformats.org/drawingml/2006/main">
               <a:ext uri="{FF2B5EF4-FFF2-40B4-BE49-F238E27FC236}">
-                <a16:creationId xmlns:a16="http://schemas.microsoft.com/office/drawing/2014/main" id="{62658269-2F5E-4320-A8AB-25DFF8E28112}"/>
+                <a16:creationId xmlns:a16="http://schemas.microsoft.com/office/drawing/2014/main" id="{1995881E-0A1E-4ABC-9558-B0A9E10E8AAE}"/>
               </a:ext>
             </a:extLst>
           </p:cNvPr>
@@ -9876,7 +9876,7 @@
                 <a:ea typeface="Arial"/>
                 <a:cs typeface="Arial"/>
               </a:rPr>
-              <a:t>7/7</a:t>
+              <a:t>0 / 4</a:t>
             </a:r>
           </a:p>
         </p:txBody>
@@ -9886,7 +9886,7 @@
           <p:cNvPr id="22" name="">
             <a:extLst xmlns:a="http://schemas.openxmlformats.org/drawingml/2006/main">
               <a:ext uri="{FF2B5EF4-FFF2-40B4-BE49-F238E27FC236}">
-                <a16:creationId xmlns:a16="http://schemas.microsoft.com/office/drawing/2014/main" id="{92F73FB1-472D-48E4-955F-DCDDD15EECAD}"/>
+                <a16:creationId xmlns:a16="http://schemas.microsoft.com/office/drawing/2014/main" id="{2309A0DF-B9EB-4973-9105-2F71820DA15C}"/>
               </a:ext>
             </a:extLst>
           </p:cNvPr>
@@ -9944,7 +9944,7 @@
                 <a:ea typeface="Arial"/>
                 <a:cs typeface="Arial"/>
               </a:rPr>
-              <a:t>concurrent live</a:t>
+              <a:t>missed / over</a:t>
             </a:r>
           </a:p>
         </p:txBody>
@@ -9954,7 +9954,7 @@
           <p:cNvPr id="23" name="">
             <a:extLst xmlns:a="http://schemas.openxmlformats.org/drawingml/2006/main">
               <a:ext uri="{FF2B5EF4-FFF2-40B4-BE49-F238E27FC236}">
-                <a16:creationId xmlns:a16="http://schemas.microsoft.com/office/drawing/2014/main" id="{FD52B3CB-CA4D-4763-90F0-8CC690F793EB}"/>
+                <a16:creationId xmlns:a16="http://schemas.microsoft.com/office/drawing/2014/main" id="{127B3B0A-96E9-4118-BCE1-CEF7EF9E1BE2}"/>
               </a:ext>
             </a:extLst>
           </p:cNvPr>
@@ -9989,7 +9989,7 @@
           <p:cNvPr id="24" name="">
             <a:extLst xmlns:a="http://schemas.openxmlformats.org/drawingml/2006/main">
               <a:ext uri="{FF2B5EF4-FFF2-40B4-BE49-F238E27FC236}">
-                <a16:creationId xmlns:a16="http://schemas.microsoft.com/office/drawing/2014/main" id="{930D7D88-B21A-428A-98DC-8754C391631B}"/>
+                <a16:creationId xmlns:a16="http://schemas.microsoft.com/office/drawing/2014/main" id="{061B1C72-736D-4FE0-B34E-507ED9F1AE40}"/>
               </a:ext>
             </a:extLst>
           </p:cNvPr>
@@ -10057,7 +10057,7 @@
           <p:cNvPr id="25" name="">
             <a:extLst xmlns:a="http://schemas.openxmlformats.org/drawingml/2006/main">
               <a:ext uri="{FF2B5EF4-FFF2-40B4-BE49-F238E27FC236}">
-                <a16:creationId xmlns:a16="http://schemas.microsoft.com/office/drawing/2014/main" id="{63A680DA-1761-4606-846F-37A7BF034DAC}"/>
+                <a16:creationId xmlns:a16="http://schemas.microsoft.com/office/drawing/2014/main" id="{4DF80EB6-33B5-44F0-8914-86B3A565453F}"/>
               </a:ext>
             </a:extLst>
           </p:cNvPr>
@@ -10132,7 +10132,7 @@
           <p:cNvPr id="26" name="">
             <a:extLst xmlns:a="http://schemas.openxmlformats.org/drawingml/2006/main">
               <a:ext uri="{FF2B5EF4-FFF2-40B4-BE49-F238E27FC236}">
-                <a16:creationId xmlns:a16="http://schemas.microsoft.com/office/drawing/2014/main" id="{495B6C70-EBE0-468D-8410-CFC6175E071B}"/>
+                <a16:creationId xmlns:a16="http://schemas.microsoft.com/office/drawing/2014/main" id="{F6D8FF42-15FA-4EDC-A94F-D3B1F618251E}"/>
               </a:ext>
             </a:extLst>
           </p:cNvPr>
@@ -10207,7 +10207,7 @@
           <p:cNvPr id="27" name="">
             <a:extLst xmlns:a="http://schemas.openxmlformats.org/drawingml/2006/main">
               <a:ext uri="{FF2B5EF4-FFF2-40B4-BE49-F238E27FC236}">
-                <a16:creationId xmlns:a16="http://schemas.microsoft.com/office/drawing/2014/main" id="{AA16893E-A323-41F4-AD1C-60504BB2E541}"/>
+                <a16:creationId xmlns:a16="http://schemas.microsoft.com/office/drawing/2014/main" id="{04969507-50BB-45A8-BE55-B1A054EBBA64}"/>
               </a:ext>
             </a:extLst>
           </p:cNvPr>
@@ -10282,7 +10282,7 @@
           <p:cNvPr id="28" name="">
             <a:extLst xmlns:a="http://schemas.openxmlformats.org/drawingml/2006/main">
               <a:ext uri="{FF2B5EF4-FFF2-40B4-BE49-F238E27FC236}">
-                <a16:creationId xmlns:a16="http://schemas.microsoft.com/office/drawing/2014/main" id="{8F499D1F-1C2A-4514-8C5E-721D94F0E8E0}"/>
+                <a16:creationId xmlns:a16="http://schemas.microsoft.com/office/drawing/2014/main" id="{3C4CCB3B-E701-4D93-BFC6-D424F779FE3E}"/>
               </a:ext>
             </a:extLst>
           </p:cNvPr>
@@ -10357,7 +10357,7 @@
           <p:cNvPr id="29" name="">
             <a:extLst xmlns:a="http://schemas.openxmlformats.org/drawingml/2006/main">
               <a:ext uri="{FF2B5EF4-FFF2-40B4-BE49-F238E27FC236}">
-                <a16:creationId xmlns:a16="http://schemas.microsoft.com/office/drawing/2014/main" id="{958E82B4-9FF9-4CC0-A22D-D447C8864987}"/>
+                <a16:creationId xmlns:a16="http://schemas.microsoft.com/office/drawing/2014/main" id="{D8BA7487-6C12-4F3D-9070-7B3F59637300}"/>
               </a:ext>
             </a:extLst>
           </p:cNvPr>
@@ -10425,7 +10425,7 @@
           <p:cNvPr id="30" name="">
             <a:extLst xmlns:a="http://schemas.openxmlformats.org/drawingml/2006/main">
               <a:ext uri="{FF2B5EF4-FFF2-40B4-BE49-F238E27FC236}">
-                <a16:creationId xmlns:a16="http://schemas.microsoft.com/office/drawing/2014/main" id="{BEDAAC92-F329-47AC-8485-3EBBED9A9ED8}"/>
+                <a16:creationId xmlns:a16="http://schemas.microsoft.com/office/drawing/2014/main" id="{32149DDD-D6ED-488E-9A69-95D7070A6E5C}"/>
               </a:ext>
             </a:extLst>
           </p:cNvPr>
@@ -10483,7 +10483,7 @@
                 <a:ea typeface="Arial"/>
                 <a:cs typeface="Arial"/>
               </a:rPr>
-              <a:t>AURA • Track A • 06/10/2026</a:t>
+              <a:t>AURA • Track A • 11/10/2026</a:t>
             </a:r>
           </a:p>
         </p:txBody>
@@ -10493,7 +10493,7 @@
           <p:cNvPr id="31" name="">
             <a:extLst xmlns:a="http://schemas.openxmlformats.org/drawingml/2006/main">
               <a:ext uri="{FF2B5EF4-FFF2-40B4-BE49-F238E27FC236}">
-                <a16:creationId xmlns:a16="http://schemas.microsoft.com/office/drawing/2014/main" id="{D39CB08A-1B35-4864-966D-79461FCF1A47}"/>
+                <a16:creationId xmlns:a16="http://schemas.microsoft.com/office/drawing/2014/main" id="{A19F0A74-95F7-4E70-B236-EC558A09FCC5}"/>
               </a:ext>
             </a:extLst>
           </p:cNvPr>
@@ -10559,7 +10559,7 @@
     </p:spTree>
     <p:extLst>
       <p:ext uri="{BB962C8B-B14F-4D97-AF65-F5344CB8AC3E}">
-        <p14:creationId xmlns:p14="http://schemas.microsoft.com/office/powerpoint/2010/main" val="176385011"/>
+        <p14:creationId xmlns:p14="http://schemas.microsoft.com/office/powerpoint/2010/main" val="1207787640"/>
       </p:ext>
     </p:extLst>
   </p:cSld>
@@ -10590,7 +10590,7 @@
           <p:cNvPr id="32" name="">
             <a:extLst xmlns:a="http://schemas.openxmlformats.org/drawingml/2006/main">
               <a:ext uri="{FF2B5EF4-FFF2-40B4-BE49-F238E27FC236}">
-                <a16:creationId xmlns:a16="http://schemas.microsoft.com/office/drawing/2014/main" id="{776C2089-46EB-4345-AC06-C45DA9E38341}"/>
+                <a16:creationId xmlns:a16="http://schemas.microsoft.com/office/drawing/2014/main" id="{0BE675BD-C3FF-42BC-A7C4-0AA13C3F5FE9}"/>
               </a:ext>
             </a:extLst>
           </p:cNvPr>
@@ -10658,7 +10658,7 @@
           <p:cNvPr id="2" name="">
             <a:extLst xmlns:a="http://schemas.openxmlformats.org/drawingml/2006/main">
               <a:ext uri="{FF2B5EF4-FFF2-40B4-BE49-F238E27FC236}">
-                <a16:creationId xmlns:a16="http://schemas.microsoft.com/office/drawing/2014/main" id="{69540A0E-70F2-4469-99A0-AFCB0F68CEBB}"/>
+                <a16:creationId xmlns:a16="http://schemas.microsoft.com/office/drawing/2014/main" id="{0CBAC2FD-D7C0-4537-8E34-1EE413B6B001}"/>
               </a:ext>
             </a:extLst>
           </p:cNvPr>
@@ -10726,7 +10726,7 @@
           <p:cNvPr id="3" name="">
             <a:extLst xmlns:a="http://schemas.openxmlformats.org/drawingml/2006/main">
               <a:ext uri="{FF2B5EF4-FFF2-40B4-BE49-F238E27FC236}">
-                <a16:creationId xmlns:a16="http://schemas.microsoft.com/office/drawing/2014/main" id="{9311876D-6193-459F-BE00-7CA36D283D50}"/>
+                <a16:creationId xmlns:a16="http://schemas.microsoft.com/office/drawing/2014/main" id="{9F5AD67F-1445-401A-989A-79E65D11498E}"/>
               </a:ext>
             </a:extLst>
           </p:cNvPr>
@@ -10794,7 +10794,7 @@
           <p:cNvPr id="4" name="">
             <a:extLst xmlns:a="http://schemas.openxmlformats.org/drawingml/2006/main">
               <a:ext uri="{FF2B5EF4-FFF2-40B4-BE49-F238E27FC236}">
-                <a16:creationId xmlns:a16="http://schemas.microsoft.com/office/drawing/2014/main" id="{3BCF763A-FB35-44CD-92A5-79EBE4F758D4}"/>
+                <a16:creationId xmlns:a16="http://schemas.microsoft.com/office/drawing/2014/main" id="{1142F870-341B-42E1-A979-497711DE0087}"/>
               </a:ext>
             </a:extLst>
           </p:cNvPr>
@@ -10825,7 +10825,7 @@
           <p:cNvPr id="5" name="">
             <a:extLst xmlns:a="http://schemas.openxmlformats.org/drawingml/2006/main">
               <a:ext uri="{FF2B5EF4-FFF2-40B4-BE49-F238E27FC236}">
-                <a16:creationId xmlns:a16="http://schemas.microsoft.com/office/drawing/2014/main" id="{1E861431-FB81-45E7-B678-AE145880E976}"/>
+                <a16:creationId xmlns:a16="http://schemas.microsoft.com/office/drawing/2014/main" id="{49E24415-A5EF-41E5-9BA6-8EAC8F3578FC}"/>
               </a:ext>
             </a:extLst>
           </p:cNvPr>
@@ -10860,7 +10860,7 @@
           <p:cNvPr id="6" name="">
             <a:extLst xmlns:a="http://schemas.openxmlformats.org/drawingml/2006/main">
               <a:ext uri="{FF2B5EF4-FFF2-40B4-BE49-F238E27FC236}">
-                <a16:creationId xmlns:a16="http://schemas.microsoft.com/office/drawing/2014/main" id="{1238D944-6918-4218-A4F6-8CD589483EAD}"/>
+                <a16:creationId xmlns:a16="http://schemas.microsoft.com/office/drawing/2014/main" id="{3976AD05-6127-4B7E-8EC7-079D510385D4}"/>
               </a:ext>
             </a:extLst>
           </p:cNvPr>
@@ -10935,7 +10935,7 @@
           <p:cNvPr id="7" name="">
             <a:extLst xmlns:a="http://schemas.openxmlformats.org/drawingml/2006/main">
               <a:ext uri="{FF2B5EF4-FFF2-40B4-BE49-F238E27FC236}">
-                <a16:creationId xmlns:a16="http://schemas.microsoft.com/office/drawing/2014/main" id="{92A75993-2A46-4621-BE8D-D539E7E1BCF0}"/>
+                <a16:creationId xmlns:a16="http://schemas.microsoft.com/office/drawing/2014/main" id="{272D898F-9814-4462-B427-58177E5CF09B}"/>
               </a:ext>
             </a:extLst>
           </p:cNvPr>
@@ -11003,7 +11003,7 @@
           <p:cNvPr id="8" name="">
             <a:extLst xmlns:a="http://schemas.openxmlformats.org/drawingml/2006/main">
               <a:ext uri="{FF2B5EF4-FFF2-40B4-BE49-F238E27FC236}">
-                <a16:creationId xmlns:a16="http://schemas.microsoft.com/office/drawing/2014/main" id="{09F3D515-FE0D-4D5D-99CE-2A3CD9692CC0}"/>
+                <a16:creationId xmlns:a16="http://schemas.microsoft.com/office/drawing/2014/main" id="{18BB1A40-9B72-4EF9-9BC3-1D98BDFBD64C}"/>
               </a:ext>
             </a:extLst>
           </p:cNvPr>
@@ -11034,7 +11034,7 @@
           <p:cNvPr id="9" name="">
             <a:extLst xmlns:a="http://schemas.openxmlformats.org/drawingml/2006/main">
               <a:ext uri="{FF2B5EF4-FFF2-40B4-BE49-F238E27FC236}">
-                <a16:creationId xmlns:a16="http://schemas.microsoft.com/office/drawing/2014/main" id="{E969614A-BDB7-4553-AB51-8B1E4D845A59}"/>
+                <a16:creationId xmlns:a16="http://schemas.microsoft.com/office/drawing/2014/main" id="{1E23FF61-0942-4D76-B327-A511DA2038FE}"/>
               </a:ext>
             </a:extLst>
           </p:cNvPr>
@@ -11069,7 +11069,7 @@
           <p:cNvPr id="10" name="">
             <a:extLst xmlns:a="http://schemas.openxmlformats.org/drawingml/2006/main">
               <a:ext uri="{FF2B5EF4-FFF2-40B4-BE49-F238E27FC236}">
-                <a16:creationId xmlns:a16="http://schemas.microsoft.com/office/drawing/2014/main" id="{86BD0A6F-1EE0-4688-B8A2-11C6333A0C92}"/>
+                <a16:creationId xmlns:a16="http://schemas.microsoft.com/office/drawing/2014/main" id="{7B7F9F46-4BB4-4295-8138-E4A00C45E6B0}"/>
               </a:ext>
             </a:extLst>
           </p:cNvPr>
@@ -11144,7 +11144,7 @@
           <p:cNvPr id="11" name="">
             <a:extLst xmlns:a="http://schemas.openxmlformats.org/drawingml/2006/main">
               <a:ext uri="{FF2B5EF4-FFF2-40B4-BE49-F238E27FC236}">
-                <a16:creationId xmlns:a16="http://schemas.microsoft.com/office/drawing/2014/main" id="{040F1FA1-CFF0-4DD9-8CC0-13AAA9614884}"/>
+                <a16:creationId xmlns:a16="http://schemas.microsoft.com/office/drawing/2014/main" id="{F8F6E56E-9C68-45AF-B13B-3BEC394B7105}"/>
               </a:ext>
             </a:extLst>
           </p:cNvPr>
@@ -11212,7 +11212,7 @@
           <p:cNvPr id="12" name="">
             <a:extLst xmlns:a="http://schemas.openxmlformats.org/drawingml/2006/main">
               <a:ext uri="{FF2B5EF4-FFF2-40B4-BE49-F238E27FC236}">
-                <a16:creationId xmlns:a16="http://schemas.microsoft.com/office/drawing/2014/main" id="{CA956561-E800-4FB5-8C42-9EA0E03524F2}"/>
+                <a16:creationId xmlns:a16="http://schemas.microsoft.com/office/drawing/2014/main" id="{0DE5347A-6969-4E76-A29A-585EFA959950}"/>
               </a:ext>
             </a:extLst>
           </p:cNvPr>
@@ -11243,7 +11243,7 @@
           <p:cNvPr id="13" name="">
             <a:extLst xmlns:a="http://schemas.openxmlformats.org/drawingml/2006/main">
               <a:ext uri="{FF2B5EF4-FFF2-40B4-BE49-F238E27FC236}">
-                <a16:creationId xmlns:a16="http://schemas.microsoft.com/office/drawing/2014/main" id="{8CBADAB3-B2E4-46A3-9E47-39D3EB290C5B}"/>
+                <a16:creationId xmlns:a16="http://schemas.microsoft.com/office/drawing/2014/main" id="{3C2CE9EE-CFDE-489B-A62E-133850DF9759}"/>
               </a:ext>
             </a:extLst>
           </p:cNvPr>
@@ -11278,7 +11278,7 @@
           <p:cNvPr id="14" name="">
             <a:extLst xmlns:a="http://schemas.openxmlformats.org/drawingml/2006/main">
               <a:ext uri="{FF2B5EF4-FFF2-40B4-BE49-F238E27FC236}">
-                <a16:creationId xmlns:a16="http://schemas.microsoft.com/office/drawing/2014/main" id="{88DD043E-D2B7-45A5-BA94-D4C10117C7B2}"/>
+                <a16:creationId xmlns:a16="http://schemas.microsoft.com/office/drawing/2014/main" id="{6928D164-63AE-4A3B-84EF-254F3EF1EBC4}"/>
               </a:ext>
             </a:extLst>
           </p:cNvPr>
@@ -11353,7 +11353,7 @@
           <p:cNvPr id="15" name="">
             <a:extLst xmlns:a="http://schemas.openxmlformats.org/drawingml/2006/main">
               <a:ext uri="{FF2B5EF4-FFF2-40B4-BE49-F238E27FC236}">
-                <a16:creationId xmlns:a16="http://schemas.microsoft.com/office/drawing/2014/main" id="{D25D3E66-5ADA-462C-9987-1B8A1D44A473}"/>
+                <a16:creationId xmlns:a16="http://schemas.microsoft.com/office/drawing/2014/main" id="{9A4FA4FF-97F3-49E0-AAAD-EAD943C422C5}"/>
               </a:ext>
             </a:extLst>
           </p:cNvPr>
@@ -11421,7 +11421,7 @@
           <p:cNvPr id="16" name="">
             <a:extLst xmlns:a="http://schemas.openxmlformats.org/drawingml/2006/main">
               <a:ext uri="{FF2B5EF4-FFF2-40B4-BE49-F238E27FC236}">
-                <a16:creationId xmlns:a16="http://schemas.microsoft.com/office/drawing/2014/main" id="{4F347894-C36A-497E-9814-C0C43A293AB0}"/>
+                <a16:creationId xmlns:a16="http://schemas.microsoft.com/office/drawing/2014/main" id="{FE70B65F-E57B-421B-945F-9F8870F60747}"/>
               </a:ext>
             </a:extLst>
           </p:cNvPr>
@@ -11452,7 +11452,7 @@
           <p:cNvPr id="17" name="">
             <a:extLst xmlns:a="http://schemas.openxmlformats.org/drawingml/2006/main">
               <a:ext uri="{FF2B5EF4-FFF2-40B4-BE49-F238E27FC236}">
-                <a16:creationId xmlns:a16="http://schemas.microsoft.com/office/drawing/2014/main" id="{2991A5DA-E1D5-4ED8-B49A-457A91D1F47F}"/>
+                <a16:creationId xmlns:a16="http://schemas.microsoft.com/office/drawing/2014/main" id="{23495B7C-92E3-4F4B-AF8A-8142772AA08E}"/>
               </a:ext>
             </a:extLst>
           </p:cNvPr>
@@ -11487,7 +11487,7 @@
           <p:cNvPr id="18" name="">
             <a:extLst xmlns:a="http://schemas.openxmlformats.org/drawingml/2006/main">
               <a:ext uri="{FF2B5EF4-FFF2-40B4-BE49-F238E27FC236}">
-                <a16:creationId xmlns:a16="http://schemas.microsoft.com/office/drawing/2014/main" id="{65A85457-D934-4DBD-A72F-D658FEC6D391}"/>
+                <a16:creationId xmlns:a16="http://schemas.microsoft.com/office/drawing/2014/main" id="{EDA0E43B-17BE-495F-AA06-77C3BA555C45}"/>
               </a:ext>
             </a:extLst>
           </p:cNvPr>
@@ -11562,7 +11562,7 @@
           <p:cNvPr id="19" name="">
             <a:extLst xmlns:a="http://schemas.openxmlformats.org/drawingml/2006/main">
               <a:ext uri="{FF2B5EF4-FFF2-40B4-BE49-F238E27FC236}">
-                <a16:creationId xmlns:a16="http://schemas.microsoft.com/office/drawing/2014/main" id="{F3DCE0AD-6D8A-4533-B6F8-525840ACE46B}"/>
+                <a16:creationId xmlns:a16="http://schemas.microsoft.com/office/drawing/2014/main" id="{6D8990F0-6ECA-41C3-81C9-C1708BEE5E03}"/>
               </a:ext>
             </a:extLst>
           </p:cNvPr>
@@ -11630,7 +11630,7 @@
           <p:cNvPr id="20" name="">
             <a:extLst xmlns:a="http://schemas.openxmlformats.org/drawingml/2006/main">
               <a:ext uri="{FF2B5EF4-FFF2-40B4-BE49-F238E27FC236}">
-                <a16:creationId xmlns:a16="http://schemas.microsoft.com/office/drawing/2014/main" id="{EF25F448-0531-4747-97F9-AB1294508055}"/>
+                <a16:creationId xmlns:a16="http://schemas.microsoft.com/office/drawing/2014/main" id="{D27BD5F5-D226-4289-B9BA-B62A330F8D4D}"/>
               </a:ext>
             </a:extLst>
           </p:cNvPr>
@@ -11665,7 +11665,7 @@
           <p:cNvPr id="21" name="">
             <a:extLst xmlns:a="http://schemas.openxmlformats.org/drawingml/2006/main">
               <a:ext uri="{FF2B5EF4-FFF2-40B4-BE49-F238E27FC236}">
-                <a16:creationId xmlns:a16="http://schemas.microsoft.com/office/drawing/2014/main" id="{0E3D2770-7F13-4C44-B5BC-FB676BEF7EC5}"/>
+                <a16:creationId xmlns:a16="http://schemas.microsoft.com/office/drawing/2014/main" id="{E8953A4F-CF6F-44DC-9035-0501783910AD}"/>
               </a:ext>
             </a:extLst>
           </p:cNvPr>
@@ -11733,7 +11733,7 @@
           <p:cNvPr id="22" name="">
             <a:extLst xmlns:a="http://schemas.openxmlformats.org/drawingml/2006/main">
               <a:ext uri="{FF2B5EF4-FFF2-40B4-BE49-F238E27FC236}">
-                <a16:creationId xmlns:a16="http://schemas.microsoft.com/office/drawing/2014/main" id="{2424A258-1996-411A-84EA-57E71FB95AF1}"/>
+                <a16:creationId xmlns:a16="http://schemas.microsoft.com/office/drawing/2014/main" id="{16056C5D-D515-42EE-8236-CC20951E75E1}"/>
               </a:ext>
             </a:extLst>
           </p:cNvPr>
@@ -11801,7 +11801,7 @@
           <p:cNvPr id="23" name="">
             <a:extLst xmlns:a="http://schemas.openxmlformats.org/drawingml/2006/main">
               <a:ext uri="{FF2B5EF4-FFF2-40B4-BE49-F238E27FC236}">
-                <a16:creationId xmlns:a16="http://schemas.microsoft.com/office/drawing/2014/main" id="{07336359-DEE1-4B26-B48B-70834AFC53C6}"/>
+                <a16:creationId xmlns:a16="http://schemas.microsoft.com/office/drawing/2014/main" id="{65DCBFC7-4D80-4E78-B818-B99A64EBB346}"/>
               </a:ext>
             </a:extLst>
           </p:cNvPr>
@@ -11836,7 +11836,7 @@
           <p:cNvPr id="24" name="">
             <a:extLst xmlns:a="http://schemas.openxmlformats.org/drawingml/2006/main">
               <a:ext uri="{FF2B5EF4-FFF2-40B4-BE49-F238E27FC236}">
-                <a16:creationId xmlns:a16="http://schemas.microsoft.com/office/drawing/2014/main" id="{DF3EFD43-34B6-43C4-8DA0-D9560FD8DC37}"/>
+                <a16:creationId xmlns:a16="http://schemas.microsoft.com/office/drawing/2014/main" id="{92884D79-B390-46EB-8E8B-128E0E2793E2}"/>
               </a:ext>
             </a:extLst>
           </p:cNvPr>
@@ -11911,7 +11911,7 @@
           <p:cNvPr id="25" name="">
             <a:extLst xmlns:a="http://schemas.openxmlformats.org/drawingml/2006/main">
               <a:ext uri="{FF2B5EF4-FFF2-40B4-BE49-F238E27FC236}">
-                <a16:creationId xmlns:a16="http://schemas.microsoft.com/office/drawing/2014/main" id="{12C15F92-6C59-4D79-A4AB-989DA169B465}"/>
+                <a16:creationId xmlns:a16="http://schemas.microsoft.com/office/drawing/2014/main" id="{71D6F1FC-FBB7-406E-869E-685160F0F3F7}"/>
               </a:ext>
             </a:extLst>
           </p:cNvPr>
@@ -12048,7 +12048,7 @@
           <p:cNvPr id="26" name="">
             <a:extLst xmlns:a="http://schemas.openxmlformats.org/drawingml/2006/main">
               <a:ext uri="{FF2B5EF4-FFF2-40B4-BE49-F238E27FC236}">
-                <a16:creationId xmlns:a16="http://schemas.microsoft.com/office/drawing/2014/main" id="{CABAEC80-B7E6-4245-9A4F-3F77A59CA4A0}"/>
+                <a16:creationId xmlns:a16="http://schemas.microsoft.com/office/drawing/2014/main" id="{11C07EA1-5E41-4D76-8950-EA7793B7E9BF}"/>
               </a:ext>
             </a:extLst>
           </p:cNvPr>
@@ -12083,7 +12083,7 @@
           <p:cNvPr id="27" name="">
             <a:extLst xmlns:a="http://schemas.openxmlformats.org/drawingml/2006/main">
               <a:ext uri="{FF2B5EF4-FFF2-40B4-BE49-F238E27FC236}">
-                <a16:creationId xmlns:a16="http://schemas.microsoft.com/office/drawing/2014/main" id="{7EF70557-5206-4ED3-8E77-E99F1692AA37}"/>
+                <a16:creationId xmlns:a16="http://schemas.microsoft.com/office/drawing/2014/main" id="{50E5D785-5E72-4AA7-BE09-6ECFD7B0994A}"/>
               </a:ext>
             </a:extLst>
           </p:cNvPr>
@@ -12158,7 +12158,7 @@
           <p:cNvPr id="28" name="">
             <a:extLst xmlns:a="http://schemas.openxmlformats.org/drawingml/2006/main">
               <a:ext uri="{FF2B5EF4-FFF2-40B4-BE49-F238E27FC236}">
-                <a16:creationId xmlns:a16="http://schemas.microsoft.com/office/drawing/2014/main" id="{130BE912-ABCD-4BB6-8942-9783703226FE}"/>
+                <a16:creationId xmlns:a16="http://schemas.microsoft.com/office/drawing/2014/main" id="{EE743BA6-92F8-4CF9-B5ED-FB7271883B22}"/>
               </a:ext>
             </a:extLst>
           </p:cNvPr>
@@ -12272,7 +12272,7 @@
           <p:cNvPr id="29" name="">
             <a:extLst xmlns:a="http://schemas.openxmlformats.org/drawingml/2006/main">
               <a:ext uri="{FF2B5EF4-FFF2-40B4-BE49-F238E27FC236}">
-                <a16:creationId xmlns:a16="http://schemas.microsoft.com/office/drawing/2014/main" id="{F50BB3CE-116E-483A-BFB4-6E7DE3BF5DB6}"/>
+                <a16:creationId xmlns:a16="http://schemas.microsoft.com/office/drawing/2014/main" id="{6D2A24D8-4513-4C34-A1CE-DB59A29FE2E0}"/>
               </a:ext>
             </a:extLst>
           </p:cNvPr>
@@ -12363,7 +12363,7 @@
           <p:cNvPr id="30" name="">
             <a:extLst xmlns:a="http://schemas.openxmlformats.org/drawingml/2006/main">
               <a:ext uri="{FF2B5EF4-FFF2-40B4-BE49-F238E27FC236}">
-                <a16:creationId xmlns:a16="http://schemas.microsoft.com/office/drawing/2014/main" id="{849B31AA-8015-4E1D-AE8C-A17FCB27FF9B}"/>
+                <a16:creationId xmlns:a16="http://schemas.microsoft.com/office/drawing/2014/main" id="{E310A0AF-3AF3-490F-83A4-779CA7AC96D4}"/>
               </a:ext>
             </a:extLst>
           </p:cNvPr>
@@ -12421,7 +12421,7 @@
                 <a:ea typeface="Arial"/>
                 <a:cs typeface="Arial"/>
               </a:rPr>
-              <a:t>AURA • Track A • 06/10/2026</a:t>
+              <a:t>AURA • Track A • 11/10/2026</a:t>
             </a:r>
           </a:p>
         </p:txBody>
@@ -12431,7 +12431,7 @@
           <p:cNvPr id="31" name="">
             <a:extLst xmlns:a="http://schemas.openxmlformats.org/drawingml/2006/main">
               <a:ext uri="{FF2B5EF4-FFF2-40B4-BE49-F238E27FC236}">
-                <a16:creationId xmlns:a16="http://schemas.microsoft.com/office/drawing/2014/main" id="{1B814748-F5B3-4A5B-BB8A-F0A21EC3B999}"/>
+                <a16:creationId xmlns:a16="http://schemas.microsoft.com/office/drawing/2014/main" id="{5F9958C8-ACDD-43A7-B164-1710794683F9}"/>
               </a:ext>
             </a:extLst>
           </p:cNvPr>
@@ -12497,7 +12497,7 @@
     </p:spTree>
     <p:extLst>
       <p:ext uri="{BB962C8B-B14F-4D97-AF65-F5344CB8AC3E}">
-        <p14:creationId xmlns:p14="http://schemas.microsoft.com/office/powerpoint/2010/main" val="1893836612"/>
+        <p14:creationId xmlns:p14="http://schemas.microsoft.com/office/powerpoint/2010/main" val="2077837686"/>
       </p:ext>
     </p:extLst>
   </p:cSld>
@@ -12528,7 +12528,7 @@
           <p:cNvPr id="36" name="">
             <a:extLst xmlns:a="http://schemas.openxmlformats.org/drawingml/2006/main">
               <a:ext uri="{FF2B5EF4-FFF2-40B4-BE49-F238E27FC236}">
-                <a16:creationId xmlns:a16="http://schemas.microsoft.com/office/drawing/2014/main" id="{10ECA4C8-0E0D-4BE4-BC61-189A77D56C99}"/>
+                <a16:creationId xmlns:a16="http://schemas.microsoft.com/office/drawing/2014/main" id="{D5344523-515E-4A34-8989-9B575095E726}"/>
               </a:ext>
             </a:extLst>
           </p:cNvPr>
@@ -12596,7 +12596,7 @@
           <p:cNvPr id="2" name="">
             <a:extLst xmlns:a="http://schemas.openxmlformats.org/drawingml/2006/main">
               <a:ext uri="{FF2B5EF4-FFF2-40B4-BE49-F238E27FC236}">
-                <a16:creationId xmlns:a16="http://schemas.microsoft.com/office/drawing/2014/main" id="{4A1A1D37-3980-4E13-9D91-19EBF466937A}"/>
+                <a16:creationId xmlns:a16="http://schemas.microsoft.com/office/drawing/2014/main" id="{DC40B02B-CD3C-43F3-8504-64BD4F341355}"/>
               </a:ext>
             </a:extLst>
           </p:cNvPr>
@@ -12664,7 +12664,7 @@
           <p:cNvPr id="3" name="">
             <a:extLst xmlns:a="http://schemas.openxmlformats.org/drawingml/2006/main">
               <a:ext uri="{FF2B5EF4-FFF2-40B4-BE49-F238E27FC236}">
-                <a16:creationId xmlns:a16="http://schemas.microsoft.com/office/drawing/2014/main" id="{32A5E845-8278-439D-817B-BEC4C0BDAD86}"/>
+                <a16:creationId xmlns:a16="http://schemas.microsoft.com/office/drawing/2014/main" id="{4D5359DA-C7C2-479D-97EE-CC577206DEEF}"/>
               </a:ext>
             </a:extLst>
           </p:cNvPr>
@@ -12732,7 +12732,7 @@
           <p:cNvPr id="4" name="">
             <a:extLst xmlns:a="http://schemas.openxmlformats.org/drawingml/2006/main">
               <a:ext uri="{FF2B5EF4-FFF2-40B4-BE49-F238E27FC236}">
-                <a16:creationId xmlns:a16="http://schemas.microsoft.com/office/drawing/2014/main" id="{EE55D742-38D2-4E06-BB50-611F4CD3A8F9}"/>
+                <a16:creationId xmlns:a16="http://schemas.microsoft.com/office/drawing/2014/main" id="{0904A14B-494F-4F02-AB61-149F5A7CB486}"/>
               </a:ext>
             </a:extLst>
           </p:cNvPr>
@@ -12763,7 +12763,7 @@
           <p:cNvPr id="5" name="">
             <a:extLst xmlns:a="http://schemas.openxmlformats.org/drawingml/2006/main">
               <a:ext uri="{FF2B5EF4-FFF2-40B4-BE49-F238E27FC236}">
-                <a16:creationId xmlns:a16="http://schemas.microsoft.com/office/drawing/2014/main" id="{F2FE898D-2230-489E-9FC2-625C890A28C9}"/>
+                <a16:creationId xmlns:a16="http://schemas.microsoft.com/office/drawing/2014/main" id="{E8E688D3-45BB-403D-8147-BB5DECC81C97}"/>
               </a:ext>
             </a:extLst>
           </p:cNvPr>
@@ -12798,7 +12798,7 @@
           <p:cNvPr id="6" name="">
             <a:extLst xmlns:a="http://schemas.openxmlformats.org/drawingml/2006/main">
               <a:ext uri="{FF2B5EF4-FFF2-40B4-BE49-F238E27FC236}">
-                <a16:creationId xmlns:a16="http://schemas.microsoft.com/office/drawing/2014/main" id="{2B60FC7E-53A7-40DF-92E2-95B171733DD8}"/>
+                <a16:creationId xmlns:a16="http://schemas.microsoft.com/office/drawing/2014/main" id="{FE0A9392-B9FB-466A-AFEF-049C96AD4B83}"/>
               </a:ext>
             </a:extLst>
           </p:cNvPr>
@@ -12873,7 +12873,7 @@
           <p:cNvPr id="7" name="">
             <a:extLst xmlns:a="http://schemas.openxmlformats.org/drawingml/2006/main">
               <a:ext uri="{FF2B5EF4-FFF2-40B4-BE49-F238E27FC236}">
-                <a16:creationId xmlns:a16="http://schemas.microsoft.com/office/drawing/2014/main" id="{1F6CB523-EB48-4A8D-ABC4-3DF3F7AC5FD2}"/>
+                <a16:creationId xmlns:a16="http://schemas.microsoft.com/office/drawing/2014/main" id="{381AD687-3B06-4CF5-9BBA-572255755BA3}"/>
               </a:ext>
             </a:extLst>
           </p:cNvPr>
@@ -12941,7 +12941,7 @@
           <p:cNvPr id="8" name="">
             <a:extLst xmlns:a="http://schemas.openxmlformats.org/drawingml/2006/main">
               <a:ext uri="{FF2B5EF4-FFF2-40B4-BE49-F238E27FC236}">
-                <a16:creationId xmlns:a16="http://schemas.microsoft.com/office/drawing/2014/main" id="{665A8811-35EB-4304-87EB-0DBEB708565B}"/>
+                <a16:creationId xmlns:a16="http://schemas.microsoft.com/office/drawing/2014/main" id="{C41EEE3D-993D-4DBB-B56E-023E43DE44B5}"/>
               </a:ext>
             </a:extLst>
           </p:cNvPr>
@@ -12976,7 +12976,7 @@
           <p:cNvPr id="9" name="">
             <a:extLst xmlns:a="http://schemas.openxmlformats.org/drawingml/2006/main">
               <a:ext uri="{FF2B5EF4-FFF2-40B4-BE49-F238E27FC236}">
-                <a16:creationId xmlns:a16="http://schemas.microsoft.com/office/drawing/2014/main" id="{3CBB3BFA-B137-4ACF-9FE6-66779C102669}"/>
+                <a16:creationId xmlns:a16="http://schemas.microsoft.com/office/drawing/2014/main" id="{ADF3410E-F398-42D6-AA3D-A2DB1F3C395F}"/>
               </a:ext>
             </a:extLst>
           </p:cNvPr>
@@ -13051,7 +13051,7 @@
           <p:cNvPr id="10" name="">
             <a:extLst xmlns:a="http://schemas.openxmlformats.org/drawingml/2006/main">
               <a:ext uri="{FF2B5EF4-FFF2-40B4-BE49-F238E27FC236}">
-                <a16:creationId xmlns:a16="http://schemas.microsoft.com/office/drawing/2014/main" id="{D498679E-6E79-4DB0-9300-14336D08768D}"/>
+                <a16:creationId xmlns:a16="http://schemas.microsoft.com/office/drawing/2014/main" id="{6158071C-264A-44AF-BE36-301DBF3AE4B4}"/>
               </a:ext>
             </a:extLst>
           </p:cNvPr>
@@ -13119,7 +13119,7 @@
           <p:cNvPr id="11" name="">
             <a:extLst xmlns:a="http://schemas.openxmlformats.org/drawingml/2006/main">
               <a:ext uri="{FF2B5EF4-FFF2-40B4-BE49-F238E27FC236}">
-                <a16:creationId xmlns:a16="http://schemas.microsoft.com/office/drawing/2014/main" id="{F47E11AF-E01A-4992-AA18-8947D5EECCCE}"/>
+                <a16:creationId xmlns:a16="http://schemas.microsoft.com/office/drawing/2014/main" id="{8D11C83F-4990-4EC7-A45C-E304B414DB1F}"/>
               </a:ext>
             </a:extLst>
           </p:cNvPr>
@@ -13154,7 +13154,7 @@
           <p:cNvPr id="12" name="">
             <a:extLst xmlns:a="http://schemas.openxmlformats.org/drawingml/2006/main">
               <a:ext uri="{FF2B5EF4-FFF2-40B4-BE49-F238E27FC236}">
-                <a16:creationId xmlns:a16="http://schemas.microsoft.com/office/drawing/2014/main" id="{8E3836F8-F8B5-4E61-A085-2ABE79C3739D}"/>
+                <a16:creationId xmlns:a16="http://schemas.microsoft.com/office/drawing/2014/main" id="{AE430B0A-29D8-485D-85B4-095CAE9A3F27}"/>
               </a:ext>
             </a:extLst>
           </p:cNvPr>
@@ -13229,7 +13229,7 @@
           <p:cNvPr id="13" name="">
             <a:extLst xmlns:a="http://schemas.openxmlformats.org/drawingml/2006/main">
               <a:ext uri="{FF2B5EF4-FFF2-40B4-BE49-F238E27FC236}">
-                <a16:creationId xmlns:a16="http://schemas.microsoft.com/office/drawing/2014/main" id="{400B9676-D1CB-4717-8CAB-B791B700CB9A}"/>
+                <a16:creationId xmlns:a16="http://schemas.microsoft.com/office/drawing/2014/main" id="{723CF7EE-363A-4D7A-833F-7C526C0A140C}"/>
               </a:ext>
             </a:extLst>
           </p:cNvPr>
@@ -13297,7 +13297,7 @@
           <p:cNvPr id="14" name="">
             <a:extLst xmlns:a="http://schemas.openxmlformats.org/drawingml/2006/main">
               <a:ext uri="{FF2B5EF4-FFF2-40B4-BE49-F238E27FC236}">
-                <a16:creationId xmlns:a16="http://schemas.microsoft.com/office/drawing/2014/main" id="{1217B7C1-3532-4155-972F-7046DEDFB446}"/>
+                <a16:creationId xmlns:a16="http://schemas.microsoft.com/office/drawing/2014/main" id="{6301752B-4DD7-44E1-9D3A-383DDB58DB5F}"/>
               </a:ext>
             </a:extLst>
           </p:cNvPr>
@@ -13332,7 +13332,7 @@
           <p:cNvPr id="15" name="">
             <a:extLst xmlns:a="http://schemas.openxmlformats.org/drawingml/2006/main">
               <a:ext uri="{FF2B5EF4-FFF2-40B4-BE49-F238E27FC236}">
-                <a16:creationId xmlns:a16="http://schemas.microsoft.com/office/drawing/2014/main" id="{0A998714-9681-492B-9D1E-5A4A1EC72FC7}"/>
+                <a16:creationId xmlns:a16="http://schemas.microsoft.com/office/drawing/2014/main" id="{96E1ACE7-3674-46FD-9CA3-A641C6A3CD90}"/>
               </a:ext>
             </a:extLst>
           </p:cNvPr>
@@ -13407,7 +13407,7 @@
           <p:cNvPr id="16" name="">
             <a:extLst xmlns:a="http://schemas.openxmlformats.org/drawingml/2006/main">
               <a:ext uri="{FF2B5EF4-FFF2-40B4-BE49-F238E27FC236}">
-                <a16:creationId xmlns:a16="http://schemas.microsoft.com/office/drawing/2014/main" id="{6F974EE2-686F-4B46-A651-F612A566F6C4}"/>
+                <a16:creationId xmlns:a16="http://schemas.microsoft.com/office/drawing/2014/main" id="{A9F9C23D-1567-4AD6-B156-AD5568FFB75E}"/>
               </a:ext>
             </a:extLst>
           </p:cNvPr>
@@ -13475,7 +13475,7 @@
           <p:cNvPr id="17" name="">
             <a:extLst xmlns:a="http://schemas.openxmlformats.org/drawingml/2006/main">
               <a:ext uri="{FF2B5EF4-FFF2-40B4-BE49-F238E27FC236}">
-                <a16:creationId xmlns:a16="http://schemas.microsoft.com/office/drawing/2014/main" id="{286BA741-C1BB-43BF-8043-6B121BCBF49E}"/>
+                <a16:creationId xmlns:a16="http://schemas.microsoft.com/office/drawing/2014/main" id="{D5F6E76E-F89F-41BB-8C5B-D03D98145F6E}"/>
               </a:ext>
             </a:extLst>
           </p:cNvPr>
@@ -13510,7 +13510,7 @@
           <p:cNvPr id="18" name="">
             <a:extLst xmlns:a="http://schemas.openxmlformats.org/drawingml/2006/main">
               <a:ext uri="{FF2B5EF4-FFF2-40B4-BE49-F238E27FC236}">
-                <a16:creationId xmlns:a16="http://schemas.microsoft.com/office/drawing/2014/main" id="{5742EEA0-B305-4BB0-98A5-21EE5B26244B}"/>
+                <a16:creationId xmlns:a16="http://schemas.microsoft.com/office/drawing/2014/main" id="{4567BBC0-D525-4587-801F-06F4A11690FC}"/>
               </a:ext>
             </a:extLst>
           </p:cNvPr>
@@ -13585,7 +13585,7 @@
           <p:cNvPr id="19" name="">
             <a:extLst xmlns:a="http://schemas.openxmlformats.org/drawingml/2006/main">
               <a:ext uri="{FF2B5EF4-FFF2-40B4-BE49-F238E27FC236}">
-                <a16:creationId xmlns:a16="http://schemas.microsoft.com/office/drawing/2014/main" id="{754DCA0C-362E-49C3-9422-39D828557A62}"/>
+                <a16:creationId xmlns:a16="http://schemas.microsoft.com/office/drawing/2014/main" id="{1D0C4519-C373-4275-A0F7-DA7E48102C01}"/>
               </a:ext>
             </a:extLst>
           </p:cNvPr>
@@ -13653,7 +13653,7 @@
           <p:cNvPr id="20" name="">
             <a:extLst xmlns:a="http://schemas.openxmlformats.org/drawingml/2006/main">
               <a:ext uri="{FF2B5EF4-FFF2-40B4-BE49-F238E27FC236}">
-                <a16:creationId xmlns:a16="http://schemas.microsoft.com/office/drawing/2014/main" id="{61166743-B528-4514-8959-A6F0F1148487}"/>
+                <a16:creationId xmlns:a16="http://schemas.microsoft.com/office/drawing/2014/main" id="{77EBB48D-4C46-44DB-A6C7-4A67806168E2}"/>
               </a:ext>
             </a:extLst>
           </p:cNvPr>
@@ -13688,7 +13688,7 @@
           <p:cNvPr id="21" name="">
             <a:extLst xmlns:a="http://schemas.openxmlformats.org/drawingml/2006/main">
               <a:ext uri="{FF2B5EF4-FFF2-40B4-BE49-F238E27FC236}">
-                <a16:creationId xmlns:a16="http://schemas.microsoft.com/office/drawing/2014/main" id="{5139FA2E-F903-4995-9935-82A84D27CDD1}"/>
+                <a16:creationId xmlns:a16="http://schemas.microsoft.com/office/drawing/2014/main" id="{54EF76BF-68F5-41C8-A2C2-82474235F851}"/>
               </a:ext>
             </a:extLst>
           </p:cNvPr>
@@ -13756,7 +13756,7 @@
           <p:cNvPr id="22" name="">
             <a:extLst xmlns:a="http://schemas.openxmlformats.org/drawingml/2006/main">
               <a:ext uri="{FF2B5EF4-FFF2-40B4-BE49-F238E27FC236}">
-                <a16:creationId xmlns:a16="http://schemas.microsoft.com/office/drawing/2014/main" id="{5B358D6B-A803-44DA-89B9-48A89E552C4D}"/>
+                <a16:creationId xmlns:a16="http://schemas.microsoft.com/office/drawing/2014/main" id="{CD20AAAA-70D5-4170-AAE4-28535C786861}"/>
               </a:ext>
             </a:extLst>
           </p:cNvPr>
@@ -13831,7 +13831,7 @@
           <p:cNvPr id="23" name="">
             <a:extLst xmlns:a="http://schemas.openxmlformats.org/drawingml/2006/main">
               <a:ext uri="{FF2B5EF4-FFF2-40B4-BE49-F238E27FC236}">
-                <a16:creationId xmlns:a16="http://schemas.microsoft.com/office/drawing/2014/main" id="{60D87050-D015-408D-96DA-FC0EB79C27A0}"/>
+                <a16:creationId xmlns:a16="http://schemas.microsoft.com/office/drawing/2014/main" id="{3F8DA9B8-D7F5-4FCE-B182-7F04F2573EC9}"/>
               </a:ext>
             </a:extLst>
           </p:cNvPr>
@@ -13899,7 +13899,7 @@
           <p:cNvPr id="24" name="">
             <a:extLst xmlns:a="http://schemas.openxmlformats.org/drawingml/2006/main">
               <a:ext uri="{FF2B5EF4-FFF2-40B4-BE49-F238E27FC236}">
-                <a16:creationId xmlns:a16="http://schemas.microsoft.com/office/drawing/2014/main" id="{A5D449F4-7806-4C0D-8EA4-D7702AFBD643}"/>
+                <a16:creationId xmlns:a16="http://schemas.microsoft.com/office/drawing/2014/main" id="{60427F6B-8126-4367-AC59-309ACE9D9224}"/>
               </a:ext>
             </a:extLst>
           </p:cNvPr>
@@ -13974,7 +13974,7 @@
           <p:cNvPr id="25" name="">
             <a:extLst xmlns:a="http://schemas.openxmlformats.org/drawingml/2006/main">
               <a:ext uri="{FF2B5EF4-FFF2-40B4-BE49-F238E27FC236}">
-                <a16:creationId xmlns:a16="http://schemas.microsoft.com/office/drawing/2014/main" id="{19F65455-5DA1-497A-BAFA-B4D03353E27C}"/>
+                <a16:creationId xmlns:a16="http://schemas.microsoft.com/office/drawing/2014/main" id="{8F2BBCEF-662B-426D-ACB4-3A5EAB871382}"/>
               </a:ext>
             </a:extLst>
           </p:cNvPr>
@@ -14032,7 +14032,7 @@
                 <a:ea typeface="Arial"/>
                 <a:cs typeface="Arial"/>
               </a:rPr>
-              <a:t>122 test • dependency sạch</a:t>
+              <a:t>142 test • EF model sạch</a:t>
             </a:r>
           </a:p>
         </p:txBody>
@@ -14042,7 +14042,7 @@
           <p:cNvPr id="26" name="">
             <a:extLst xmlns:a="http://schemas.openxmlformats.org/drawingml/2006/main">
               <a:ext uri="{FF2B5EF4-FFF2-40B4-BE49-F238E27FC236}">
-                <a16:creationId xmlns:a16="http://schemas.microsoft.com/office/drawing/2014/main" id="{CFC6E030-2637-4772-A4A6-B378064D2F41}"/>
+                <a16:creationId xmlns:a16="http://schemas.microsoft.com/office/drawing/2014/main" id="{B6FFC38A-3A99-40F8-BC05-E694FAF35216}"/>
               </a:ext>
             </a:extLst>
           </p:cNvPr>
@@ -14117,7 +14117,7 @@
           <p:cNvPr id="27" name="">
             <a:extLst xmlns:a="http://schemas.openxmlformats.org/drawingml/2006/main">
               <a:ext uri="{FF2B5EF4-FFF2-40B4-BE49-F238E27FC236}">
-                <a16:creationId xmlns:a16="http://schemas.microsoft.com/office/drawing/2014/main" id="{DDBC232A-CD72-4288-9792-82CA669B728A}"/>
+                <a16:creationId xmlns:a16="http://schemas.microsoft.com/office/drawing/2014/main" id="{B6D668BD-7E18-4388-9854-7D53BB3096C2}"/>
               </a:ext>
             </a:extLst>
           </p:cNvPr>
@@ -14185,7 +14185,7 @@
           <p:cNvPr id="28" name="">
             <a:extLst xmlns:a="http://schemas.openxmlformats.org/drawingml/2006/main">
               <a:ext uri="{FF2B5EF4-FFF2-40B4-BE49-F238E27FC236}">
-                <a16:creationId xmlns:a16="http://schemas.microsoft.com/office/drawing/2014/main" id="{48925F40-009D-46AE-824D-665A695CD8E2}"/>
+                <a16:creationId xmlns:a16="http://schemas.microsoft.com/office/drawing/2014/main" id="{1A2D6E59-4ECC-451D-96D1-C57C5D7EA2D0}"/>
               </a:ext>
             </a:extLst>
           </p:cNvPr>
@@ -14260,7 +14260,7 @@
           <p:cNvPr id="29" name="">
             <a:extLst xmlns:a="http://schemas.openxmlformats.org/drawingml/2006/main">
               <a:ext uri="{FF2B5EF4-FFF2-40B4-BE49-F238E27FC236}">
-                <a16:creationId xmlns:a16="http://schemas.microsoft.com/office/drawing/2014/main" id="{70D46FC6-A77E-46DC-84E5-EA89141BE8C6}"/>
+                <a16:creationId xmlns:a16="http://schemas.microsoft.com/office/drawing/2014/main" id="{9F6961F2-C4F8-4EE1-A603-CA9D2E870C52}"/>
               </a:ext>
             </a:extLst>
           </p:cNvPr>
@@ -14318,7 +14318,7 @@
                 <a:ea typeface="Arial"/>
                 <a:cs typeface="Arial"/>
               </a:rPr>
-              <a:t>Fallback opt-in + audit</a:t>
+              <a:t>Mobile 4G/5G đã pass</a:t>
             </a:r>
           </a:p>
         </p:txBody>
@@ -14328,7 +14328,7 @@
           <p:cNvPr id="30" name="">
             <a:extLst xmlns:a="http://schemas.openxmlformats.org/drawingml/2006/main">
               <a:ext uri="{FF2B5EF4-FFF2-40B4-BE49-F238E27FC236}">
-                <a16:creationId xmlns:a16="http://schemas.microsoft.com/office/drawing/2014/main" id="{B3A7CEF2-4477-4C77-8557-F05D84C177C6}"/>
+                <a16:creationId xmlns:a16="http://schemas.microsoft.com/office/drawing/2014/main" id="{1751A5C8-24D4-4CC5-9CAD-29DD1D5FD061}"/>
               </a:ext>
             </a:extLst>
           </p:cNvPr>
@@ -14363,7 +14363,7 @@
           <p:cNvPr id="31" name="">
             <a:extLst xmlns:a="http://schemas.openxmlformats.org/drawingml/2006/main">
               <a:ext uri="{FF2B5EF4-FFF2-40B4-BE49-F238E27FC236}">
-                <a16:creationId xmlns:a16="http://schemas.microsoft.com/office/drawing/2014/main" id="{BF4B5AA3-D4D2-44D9-8723-789123B8B820}"/>
+                <a16:creationId xmlns:a16="http://schemas.microsoft.com/office/drawing/2014/main" id="{8ACD6DD3-61E0-48AC-A79F-E152F9E169B8}"/>
               </a:ext>
             </a:extLst>
           </p:cNvPr>
@@ -14431,7 +14431,7 @@
           <p:cNvPr id="32" name="">
             <a:extLst xmlns:a="http://schemas.openxmlformats.org/drawingml/2006/main">
               <a:ext uri="{FF2B5EF4-FFF2-40B4-BE49-F238E27FC236}">
-                <a16:creationId xmlns:a16="http://schemas.microsoft.com/office/drawing/2014/main" id="{DAF68784-124F-4781-8D88-A88A40348062}"/>
+                <a16:creationId xmlns:a16="http://schemas.microsoft.com/office/drawing/2014/main" id="{45ECEF07-B0D8-4B7A-BBCD-0D0383B327D9}"/>
               </a:ext>
             </a:extLst>
           </p:cNvPr>
@@ -14489,7 +14489,7 @@
                 <a:ea typeface="Arial"/>
                 <a:cs typeface="Arial"/>
               </a:rPr>
-              <a:t>3 người dùng thực tế</a:t>
+              <a:t>3 người dùng thực tế • rehearsal</a:t>
             </a:r>
           </a:p>
           <a:p xmlns:a="http://schemas.openxmlformats.org/drawingml/2006/main">
@@ -14512,7 +14512,7 @@
                 <a:ea typeface="Arial"/>
                 <a:cs typeface="Arial"/>
               </a:rPr>
-              <a:t>mobile thật/4G • PDF/nhiều trang</a:t>
+              <a:t>PDF/nhiều trang</a:t>
             </a:r>
           </a:p>
           <a:p xmlns:a="http://schemas.openxmlformats.org/drawingml/2006/main">
@@ -14545,7 +14545,7 @@
           <p:cNvPr id="33" name="">
             <a:extLst xmlns:a="http://schemas.openxmlformats.org/drawingml/2006/main">
               <a:ext uri="{FF2B5EF4-FFF2-40B4-BE49-F238E27FC236}">
-                <a16:creationId xmlns:a16="http://schemas.microsoft.com/office/drawing/2014/main" id="{C21350A2-11F5-4CD1-A374-D9E1B66C3EC6}"/>
+                <a16:creationId xmlns:a16="http://schemas.microsoft.com/office/drawing/2014/main" id="{78FFA769-698A-47AB-856C-6439529D31F9}"/>
               </a:ext>
             </a:extLst>
           </p:cNvPr>
@@ -14613,7 +14613,7 @@
           <p:cNvPr id="34" name="">
             <a:extLst xmlns:a="http://schemas.openxmlformats.org/drawingml/2006/main">
               <a:ext uri="{FF2B5EF4-FFF2-40B4-BE49-F238E27FC236}">
-                <a16:creationId xmlns:a16="http://schemas.microsoft.com/office/drawing/2014/main" id="{7EAE1373-1EEA-4155-8437-427551509133}"/>
+                <a16:creationId xmlns:a16="http://schemas.microsoft.com/office/drawing/2014/main" id="{F81E280A-B5F1-4CA5-AF8D-F805D098230A}"/>
               </a:ext>
             </a:extLst>
           </p:cNvPr>
@@ -14681,7 +14681,7 @@
           <p:cNvPr id="35" name="">
             <a:extLst xmlns:a="http://schemas.openxmlformats.org/drawingml/2006/main">
               <a:ext uri="{FF2B5EF4-FFF2-40B4-BE49-F238E27FC236}">
-                <a16:creationId xmlns:a16="http://schemas.microsoft.com/office/drawing/2014/main" id="{5EF9BD19-E407-4F7D-A385-EBFD56B8E251}"/>
+                <a16:creationId xmlns:a16="http://schemas.microsoft.com/office/drawing/2014/main" id="{114B0E5C-1601-4B48-B484-5AC29C3208BA}"/>
               </a:ext>
             </a:extLst>
           </p:cNvPr>
@@ -14747,7 +14747,7 @@
     </p:spTree>
     <p:extLst>
       <p:ext uri="{BB962C8B-B14F-4D97-AF65-F5344CB8AC3E}">
-        <p14:creationId xmlns:p14="http://schemas.microsoft.com/office/powerpoint/2010/main" val="547623093"/>
+        <p14:creationId xmlns:p14="http://schemas.microsoft.com/office/powerpoint/2010/main" val="484913985"/>
       </p:ext>
     </p:extLst>
   </p:cSld>

</xml_diff>

<commit_message>
docs: sync receipt regression forensic evidence
</commit_message>
<xml_diff>
--- a/AURA/submission/AURA_5_SLIDES.pptx
+++ b/AURA/submission/AURA_5_SLIDES.pptx
@@ -2,17 +2,17 @@
 <file path=ppt/presentation.xml><?xml version="1.0" encoding="utf-8"?>
 <p:presentation xmlns:p="http://schemas.openxmlformats.org/presentationml/2006/main">
   <p:sldMasterIdLst>
-    <p:sldMasterId xmlns:r="http://schemas.openxmlformats.org/officeDocument/2006/relationships" id="2147483648" r:id="R8faf2e5cb38a4f3b"/>
+    <p:sldMasterId xmlns:r="http://schemas.openxmlformats.org/officeDocument/2006/relationships" id="2147483648" r:id="R3b87258b15484fad"/>
   </p:sldMasterIdLst>
   <p:notesMasterIdLst>
-    <p:notesMasterId xmlns:r="http://schemas.openxmlformats.org/officeDocument/2006/relationships" r:id="Rd1c3ea1e60cd4e46"/>
+    <p:notesMasterId xmlns:r="http://schemas.openxmlformats.org/officeDocument/2006/relationships" r:id="Rb1b0cf6340584a85"/>
   </p:notesMasterIdLst>
   <p:sldIdLst>
-    <p:sldId xmlns:r="http://schemas.openxmlformats.org/officeDocument/2006/relationships" id="256" r:id="Rb8ce3629262541d8"/>
-    <p:sldId xmlns:r="http://schemas.openxmlformats.org/officeDocument/2006/relationships" id="257" r:id="Ra2b5673a09c84615"/>
-    <p:sldId xmlns:r="http://schemas.openxmlformats.org/officeDocument/2006/relationships" id="258" r:id="R219500a06ee14d02"/>
-    <p:sldId xmlns:r="http://schemas.openxmlformats.org/officeDocument/2006/relationships" id="259" r:id="R8d84d0ceec86480c"/>
-    <p:sldId xmlns:r="http://schemas.openxmlformats.org/officeDocument/2006/relationships" id="260" r:id="R9f2d53cb025d467a"/>
+    <p:sldId xmlns:r="http://schemas.openxmlformats.org/officeDocument/2006/relationships" id="256" r:id="Rb6523978cecf486a"/>
+    <p:sldId xmlns:r="http://schemas.openxmlformats.org/officeDocument/2006/relationships" id="257" r:id="R7a8b0fd498fd409a"/>
+    <p:sldId xmlns:r="http://schemas.openxmlformats.org/officeDocument/2006/relationships" id="258" r:id="R6d9c3a125b74463a"/>
+    <p:sldId xmlns:r="http://schemas.openxmlformats.org/officeDocument/2006/relationships" id="259" r:id="Rf66c80d287f04017"/>
+    <p:sldId xmlns:r="http://schemas.openxmlformats.org/officeDocument/2006/relationships" id="260" r:id="R4a0614f7bd9a4c09"/>
   </p:sldIdLst>
   <p:sldSz cx="12192000" cy="6858000"/>
   <p:notesSz cx="6858000" cy="9144000"/>
@@ -824,6 +824,7 @@
                 <a:spcPts val="0"/>
               </a:spcAft>
               <a:buNone/>
+              <a:defRPr/>
             </a:lvl1pPr>
             <a:lvl2pPr marL="0" indent="0">
               <a:lnSpc>
@@ -836,6 +837,7 @@
                 <a:spcPts val="0"/>
               </a:spcAft>
               <a:buNone/>
+              <a:defRPr/>
             </a:lvl2pPr>
             <a:lvl3pPr marL="0" indent="0">
               <a:lnSpc>
@@ -848,6 +850,7 @@
                 <a:spcPts val="0"/>
               </a:spcAft>
               <a:buNone/>
+              <a:defRPr/>
             </a:lvl3pPr>
             <a:lvl4pPr marL="0" indent="0">
               <a:lnSpc>
@@ -860,6 +863,7 @@
                 <a:spcPts val="0"/>
               </a:spcAft>
               <a:buNone/>
+              <a:defRPr/>
             </a:lvl4pPr>
             <a:lvl5pPr marL="0" indent="0">
               <a:lnSpc>
@@ -872,6 +876,7 @@
                 <a:spcPts val="0"/>
               </a:spcAft>
               <a:buNone/>
+              <a:defRPr/>
             </a:lvl5pPr>
             <a:lvl6pPr marL="0" indent="0">
               <a:lnSpc>
@@ -884,6 +889,7 @@
                 <a:spcPts val="0"/>
               </a:spcAft>
               <a:buNone/>
+              <a:defRPr/>
             </a:lvl6pPr>
             <a:lvl7pPr marL="0" indent="0">
               <a:lnSpc>
@@ -896,6 +902,7 @@
                 <a:spcPts val="0"/>
               </a:spcAft>
               <a:buNone/>
+              <a:defRPr/>
             </a:lvl7pPr>
             <a:lvl8pPr marL="0" indent="0">
               <a:lnSpc>
@@ -908,6 +915,7 @@
                 <a:spcPts val="0"/>
               </a:spcAft>
               <a:buNone/>
+              <a:defRPr/>
             </a:lvl8pPr>
             <a:lvl9pPr marL="0" indent="0">
               <a:lnSpc>
@@ -920,6 +928,7 @@
                 <a:spcPts val="0"/>
               </a:spcAft>
               <a:buNone/>
+              <a:defRPr/>
             </a:lvl9pPr>
           </a:lstStyle>
           <a:p xmlns:a="http://schemas.openxmlformats.org/drawingml/2006/main"/>
@@ -981,6 +990,7 @@
                 <a:spcPts val="0"/>
               </a:spcAft>
               <a:buNone/>
+              <a:defRPr/>
             </a:lvl1pPr>
             <a:lvl2pPr marL="0" indent="0">
               <a:lnSpc>
@@ -993,6 +1003,7 @@
                 <a:spcPts val="0"/>
               </a:spcAft>
               <a:buNone/>
+              <a:defRPr/>
             </a:lvl2pPr>
             <a:lvl3pPr marL="0" indent="0">
               <a:lnSpc>
@@ -1005,6 +1016,7 @@
                 <a:spcPts val="0"/>
               </a:spcAft>
               <a:buNone/>
+              <a:defRPr/>
             </a:lvl3pPr>
             <a:lvl4pPr marL="0" indent="0">
               <a:lnSpc>
@@ -1017,6 +1029,7 @@
                 <a:spcPts val="0"/>
               </a:spcAft>
               <a:buNone/>
+              <a:defRPr/>
             </a:lvl4pPr>
             <a:lvl5pPr marL="0" indent="0">
               <a:lnSpc>
@@ -1029,6 +1042,7 @@
                 <a:spcPts val="0"/>
               </a:spcAft>
               <a:buNone/>
+              <a:defRPr/>
             </a:lvl5pPr>
             <a:lvl6pPr marL="0" indent="0">
               <a:lnSpc>
@@ -1041,6 +1055,7 @@
                 <a:spcPts val="0"/>
               </a:spcAft>
               <a:buNone/>
+              <a:defRPr/>
             </a:lvl6pPr>
             <a:lvl7pPr marL="0" indent="0">
               <a:lnSpc>
@@ -1053,6 +1068,7 @@
                 <a:spcPts val="0"/>
               </a:spcAft>
               <a:buNone/>
+              <a:defRPr/>
             </a:lvl7pPr>
             <a:lvl8pPr marL="0" indent="0">
               <a:lnSpc>
@@ -1065,6 +1081,7 @@
                 <a:spcPts val="0"/>
               </a:spcAft>
               <a:buNone/>
+              <a:defRPr/>
             </a:lvl8pPr>
             <a:lvl9pPr marL="0" indent="0">
               <a:lnSpc>
@@ -1077,6 +1094,7 @@
                 <a:spcPts val="0"/>
               </a:spcAft>
               <a:buNone/>
+              <a:defRPr/>
             </a:lvl9pPr>
           </a:lstStyle>
           <a:p xmlns:a="http://schemas.openxmlformats.org/drawingml/2006/main"/>
@@ -1155,6 +1173,7 @@
                 <a:spcPts val="0"/>
               </a:spcAft>
               <a:buNone/>
+              <a:defRPr/>
             </a:lvl1pPr>
             <a:lvl2pPr marL="0" indent="0">
               <a:lnSpc>
@@ -1167,6 +1186,7 @@
                 <a:spcPts val="0"/>
               </a:spcAft>
               <a:buNone/>
+              <a:defRPr/>
             </a:lvl2pPr>
             <a:lvl3pPr marL="0" indent="0">
               <a:lnSpc>
@@ -1179,6 +1199,7 @@
                 <a:spcPts val="0"/>
               </a:spcAft>
               <a:buNone/>
+              <a:defRPr/>
             </a:lvl3pPr>
             <a:lvl4pPr marL="0" indent="0">
               <a:lnSpc>
@@ -1191,6 +1212,7 @@
                 <a:spcPts val="0"/>
               </a:spcAft>
               <a:buNone/>
+              <a:defRPr/>
             </a:lvl4pPr>
             <a:lvl5pPr marL="0" indent="0">
               <a:lnSpc>
@@ -1203,6 +1225,7 @@
                 <a:spcPts val="0"/>
               </a:spcAft>
               <a:buNone/>
+              <a:defRPr/>
             </a:lvl5pPr>
             <a:lvl6pPr marL="0" indent="0">
               <a:lnSpc>
@@ -1215,6 +1238,7 @@
                 <a:spcPts val="0"/>
               </a:spcAft>
               <a:buNone/>
+              <a:defRPr/>
             </a:lvl6pPr>
             <a:lvl7pPr marL="0" indent="0">
               <a:lnSpc>
@@ -1227,6 +1251,7 @@
                 <a:spcPts val="0"/>
               </a:spcAft>
               <a:buNone/>
+              <a:defRPr/>
             </a:lvl7pPr>
             <a:lvl8pPr marL="0" indent="0">
               <a:lnSpc>
@@ -1239,6 +1264,7 @@
                 <a:spcPts val="0"/>
               </a:spcAft>
               <a:buNone/>
+              <a:defRPr/>
             </a:lvl8pPr>
             <a:lvl9pPr marL="0" indent="0">
               <a:lnSpc>
@@ -1251,6 +1277,7 @@
                 <a:spcPts val="0"/>
               </a:spcAft>
               <a:buNone/>
+              <a:defRPr/>
             </a:lvl9pPr>
           </a:lstStyle>
           <a:p xmlns:a="http://schemas.openxmlformats.org/drawingml/2006/main"/>
@@ -1329,6 +1356,7 @@
                 <a:spcPts val="0"/>
               </a:spcAft>
               <a:buNone/>
+              <a:defRPr/>
             </a:lvl1pPr>
             <a:lvl2pPr marL="0" indent="0">
               <a:lnSpc>
@@ -1341,6 +1369,7 @@
                 <a:spcPts val="0"/>
               </a:spcAft>
               <a:buNone/>
+              <a:defRPr/>
             </a:lvl2pPr>
             <a:lvl3pPr marL="0" indent="0">
               <a:lnSpc>
@@ -1353,6 +1382,7 @@
                 <a:spcPts val="0"/>
               </a:spcAft>
               <a:buNone/>
+              <a:defRPr/>
             </a:lvl3pPr>
             <a:lvl4pPr marL="0" indent="0">
               <a:lnSpc>
@@ -1365,6 +1395,7 @@
                 <a:spcPts val="0"/>
               </a:spcAft>
               <a:buNone/>
+              <a:defRPr/>
             </a:lvl4pPr>
             <a:lvl5pPr marL="0" indent="0">
               <a:lnSpc>
@@ -1377,6 +1408,7 @@
                 <a:spcPts val="0"/>
               </a:spcAft>
               <a:buNone/>
+              <a:defRPr/>
             </a:lvl5pPr>
             <a:lvl6pPr marL="0" indent="0">
               <a:lnSpc>
@@ -1389,6 +1421,7 @@
                 <a:spcPts val="0"/>
               </a:spcAft>
               <a:buNone/>
+              <a:defRPr/>
             </a:lvl6pPr>
             <a:lvl7pPr marL="0" indent="0">
               <a:lnSpc>
@@ -1401,6 +1434,7 @@
                 <a:spcPts val="0"/>
               </a:spcAft>
               <a:buNone/>
+              <a:defRPr/>
             </a:lvl7pPr>
             <a:lvl8pPr marL="0" indent="0">
               <a:lnSpc>
@@ -1413,6 +1447,7 @@
                 <a:spcPts val="0"/>
               </a:spcAft>
               <a:buNone/>
+              <a:defRPr/>
             </a:lvl8pPr>
             <a:lvl9pPr marL="0" indent="0">
               <a:lnSpc>
@@ -1425,6 +1460,7 @@
                 <a:spcPts val="0"/>
               </a:spcAft>
               <a:buNone/>
+              <a:defRPr/>
             </a:lvl9pPr>
           </a:lstStyle>
           <a:p xmlns:a="http://schemas.openxmlformats.org/drawingml/2006/main"/>
@@ -1486,6 +1522,7 @@
                 <a:spcPts val="1200"/>
               </a:spcAft>
               <a:buChar char="•"/>
+              <a:defRPr/>
             </a:lvl1pPr>
             <a:lvl2pPr marL="533400" indent="-228600">
               <a:lnSpc>
@@ -1498,6 +1535,7 @@
                 <a:spcPts val="1200"/>
               </a:spcAft>
               <a:buChar char="•"/>
+              <a:defRPr/>
             </a:lvl2pPr>
             <a:lvl3pPr marL="838200" indent="-228600">
               <a:lnSpc>
@@ -1510,6 +1548,7 @@
                 <a:spcPts val="1200"/>
               </a:spcAft>
               <a:buChar char="•"/>
+              <a:defRPr/>
             </a:lvl3pPr>
             <a:lvl4pPr marL="1143000" indent="-228600">
               <a:lnSpc>
@@ -1522,6 +1561,7 @@
                 <a:spcPts val="1200"/>
               </a:spcAft>
               <a:buChar char="•"/>
+              <a:defRPr/>
             </a:lvl4pPr>
             <a:lvl5pPr marL="1447800" indent="-228600">
               <a:lnSpc>
@@ -1534,6 +1574,7 @@
                 <a:spcPts val="1200"/>
               </a:spcAft>
               <a:buChar char="•"/>
+              <a:defRPr/>
             </a:lvl5pPr>
             <a:lvl6pPr marL="1752600" indent="-228600">
               <a:lnSpc>
@@ -1546,6 +1587,7 @@
                 <a:spcPts val="1200"/>
               </a:spcAft>
               <a:buChar char="•"/>
+              <a:defRPr/>
             </a:lvl6pPr>
             <a:lvl7pPr marL="2057400" indent="-228600">
               <a:lnSpc>
@@ -1558,6 +1600,7 @@
                 <a:spcPts val="1200"/>
               </a:spcAft>
               <a:buChar char="•"/>
+              <a:defRPr/>
             </a:lvl7pPr>
             <a:lvl8pPr marL="2362200" indent="-228600">
               <a:lnSpc>
@@ -1570,6 +1613,7 @@
                 <a:spcPts val="1200"/>
               </a:spcAft>
               <a:buChar char="•"/>
+              <a:defRPr/>
             </a:lvl8pPr>
             <a:lvl9pPr marL="2667000" indent="-228600">
               <a:lnSpc>
@@ -1582,6 +1626,7 @@
                 <a:spcPts val="1200"/>
               </a:spcAft>
               <a:buChar char="•"/>
+              <a:defRPr/>
             </a:lvl9pPr>
           </a:lstStyle>
           <a:p xmlns:a="http://schemas.openxmlformats.org/drawingml/2006/main"/>
@@ -1660,6 +1705,7 @@
                 <a:spcPts val="0"/>
               </a:spcAft>
               <a:buNone/>
+              <a:defRPr/>
             </a:lvl1pPr>
             <a:lvl2pPr marL="0" indent="0">
               <a:lnSpc>
@@ -1672,6 +1718,7 @@
                 <a:spcPts val="0"/>
               </a:spcAft>
               <a:buNone/>
+              <a:defRPr/>
             </a:lvl2pPr>
             <a:lvl3pPr marL="0" indent="0">
               <a:lnSpc>
@@ -1684,6 +1731,7 @@
                 <a:spcPts val="0"/>
               </a:spcAft>
               <a:buNone/>
+              <a:defRPr/>
             </a:lvl3pPr>
             <a:lvl4pPr marL="0" indent="0">
               <a:lnSpc>
@@ -1696,6 +1744,7 @@
                 <a:spcPts val="0"/>
               </a:spcAft>
               <a:buNone/>
+              <a:defRPr/>
             </a:lvl4pPr>
             <a:lvl5pPr marL="0" indent="0">
               <a:lnSpc>
@@ -1708,6 +1757,7 @@
                 <a:spcPts val="0"/>
               </a:spcAft>
               <a:buNone/>
+              <a:defRPr/>
             </a:lvl5pPr>
             <a:lvl6pPr marL="0" indent="0">
               <a:lnSpc>
@@ -1720,6 +1770,7 @@
                 <a:spcPts val="0"/>
               </a:spcAft>
               <a:buNone/>
+              <a:defRPr/>
             </a:lvl6pPr>
             <a:lvl7pPr marL="0" indent="0">
               <a:lnSpc>
@@ -1732,6 +1783,7 @@
                 <a:spcPts val="0"/>
               </a:spcAft>
               <a:buNone/>
+              <a:defRPr/>
             </a:lvl7pPr>
             <a:lvl8pPr marL="0" indent="0">
               <a:lnSpc>
@@ -1744,6 +1796,7 @@
                 <a:spcPts val="0"/>
               </a:spcAft>
               <a:buNone/>
+              <a:defRPr/>
             </a:lvl8pPr>
             <a:lvl9pPr marL="0" indent="0">
               <a:lnSpc>
@@ -1756,6 +1809,7 @@
                 <a:spcPts val="0"/>
               </a:spcAft>
               <a:buNone/>
+              <a:defRPr/>
             </a:lvl9pPr>
           </a:lstStyle>
           <a:p xmlns:a="http://schemas.openxmlformats.org/drawingml/2006/main"/>
@@ -1817,6 +1871,7 @@
                 <a:spcPts val="1200"/>
               </a:spcAft>
               <a:buChar char="•"/>
+              <a:defRPr/>
             </a:lvl1pPr>
             <a:lvl2pPr marL="533400" indent="-228600">
               <a:lnSpc>
@@ -1829,6 +1884,7 @@
                 <a:spcPts val="1200"/>
               </a:spcAft>
               <a:buChar char="•"/>
+              <a:defRPr/>
             </a:lvl2pPr>
             <a:lvl3pPr marL="838200" indent="-228600">
               <a:lnSpc>
@@ -1841,6 +1897,7 @@
                 <a:spcPts val="1200"/>
               </a:spcAft>
               <a:buChar char="•"/>
+              <a:defRPr/>
             </a:lvl3pPr>
             <a:lvl4pPr marL="1143000" indent="-228600">
               <a:lnSpc>
@@ -1853,6 +1910,7 @@
                 <a:spcPts val="1200"/>
               </a:spcAft>
               <a:buChar char="•"/>
+              <a:defRPr/>
             </a:lvl4pPr>
             <a:lvl5pPr marL="1447800" indent="-228600">
               <a:lnSpc>
@@ -1865,6 +1923,7 @@
                 <a:spcPts val="1200"/>
               </a:spcAft>
               <a:buChar char="•"/>
+              <a:defRPr/>
             </a:lvl5pPr>
             <a:lvl6pPr marL="1752600" indent="-228600">
               <a:lnSpc>
@@ -1877,6 +1936,7 @@
                 <a:spcPts val="1200"/>
               </a:spcAft>
               <a:buChar char="•"/>
+              <a:defRPr/>
             </a:lvl6pPr>
             <a:lvl7pPr marL="2057400" indent="-228600">
               <a:lnSpc>
@@ -1889,6 +1949,7 @@
                 <a:spcPts val="1200"/>
               </a:spcAft>
               <a:buChar char="•"/>
+              <a:defRPr/>
             </a:lvl7pPr>
             <a:lvl8pPr marL="2362200" indent="-228600">
               <a:lnSpc>
@@ -1901,6 +1962,7 @@
                 <a:spcPts val="1200"/>
               </a:spcAft>
               <a:buChar char="•"/>
+              <a:defRPr/>
             </a:lvl8pPr>
             <a:lvl9pPr marL="2667000" indent="-228600">
               <a:lnSpc>
@@ -1913,6 +1975,7 @@
                 <a:spcPts val="1200"/>
               </a:spcAft>
               <a:buChar char="•"/>
+              <a:defRPr/>
             </a:lvl9pPr>
           </a:lstStyle>
           <a:p xmlns:a="http://schemas.openxmlformats.org/drawingml/2006/main"/>
@@ -1974,6 +2037,7 @@
                 <a:spcPts val="1200"/>
               </a:spcAft>
               <a:buChar char="•"/>
+              <a:defRPr/>
             </a:lvl1pPr>
             <a:lvl2pPr marL="533400" indent="-228600">
               <a:lnSpc>
@@ -1986,6 +2050,7 @@
                 <a:spcPts val="1200"/>
               </a:spcAft>
               <a:buChar char="•"/>
+              <a:defRPr/>
             </a:lvl2pPr>
             <a:lvl3pPr marL="838200" indent="-228600">
               <a:lnSpc>
@@ -1998,6 +2063,7 @@
                 <a:spcPts val="1200"/>
               </a:spcAft>
               <a:buChar char="•"/>
+              <a:defRPr/>
             </a:lvl3pPr>
             <a:lvl4pPr marL="1143000" indent="-228600">
               <a:lnSpc>
@@ -2010,6 +2076,7 @@
                 <a:spcPts val="1200"/>
               </a:spcAft>
               <a:buChar char="•"/>
+              <a:defRPr/>
             </a:lvl4pPr>
             <a:lvl5pPr marL="1447800" indent="-228600">
               <a:lnSpc>
@@ -2022,6 +2089,7 @@
                 <a:spcPts val="1200"/>
               </a:spcAft>
               <a:buChar char="•"/>
+              <a:defRPr/>
             </a:lvl5pPr>
             <a:lvl6pPr marL="1752600" indent="-228600">
               <a:lnSpc>
@@ -2034,6 +2102,7 @@
                 <a:spcPts val="1200"/>
               </a:spcAft>
               <a:buChar char="•"/>
+              <a:defRPr/>
             </a:lvl6pPr>
             <a:lvl7pPr marL="2057400" indent="-228600">
               <a:lnSpc>
@@ -2046,6 +2115,7 @@
                 <a:spcPts val="1200"/>
               </a:spcAft>
               <a:buChar char="•"/>
+              <a:defRPr/>
             </a:lvl7pPr>
             <a:lvl8pPr marL="2362200" indent="-228600">
               <a:lnSpc>
@@ -2058,6 +2128,7 @@
                 <a:spcPts val="1200"/>
               </a:spcAft>
               <a:buChar char="•"/>
+              <a:defRPr/>
             </a:lvl8pPr>
             <a:lvl9pPr marL="2667000" indent="-228600">
               <a:lnSpc>
@@ -2070,6 +2141,7 @@
                 <a:spcPts val="1200"/>
               </a:spcAft>
               <a:buChar char="•"/>
+              <a:defRPr/>
             </a:lvl9pPr>
           </a:lstStyle>
           <a:p xmlns:a="http://schemas.openxmlformats.org/drawingml/2006/main"/>
@@ -2148,6 +2220,7 @@
                 <a:spcPts val="0"/>
               </a:spcAft>
               <a:buNone/>
+              <a:defRPr/>
             </a:lvl1pPr>
             <a:lvl2pPr marL="0" indent="0">
               <a:lnSpc>
@@ -2160,6 +2233,7 @@
                 <a:spcPts val="0"/>
               </a:spcAft>
               <a:buNone/>
+              <a:defRPr/>
             </a:lvl2pPr>
             <a:lvl3pPr marL="0" indent="0">
               <a:lnSpc>
@@ -2172,6 +2246,7 @@
                 <a:spcPts val="0"/>
               </a:spcAft>
               <a:buNone/>
+              <a:defRPr/>
             </a:lvl3pPr>
             <a:lvl4pPr marL="0" indent="0">
               <a:lnSpc>
@@ -2184,6 +2259,7 @@
                 <a:spcPts val="0"/>
               </a:spcAft>
               <a:buNone/>
+              <a:defRPr/>
             </a:lvl4pPr>
             <a:lvl5pPr marL="0" indent="0">
               <a:lnSpc>
@@ -2196,6 +2272,7 @@
                 <a:spcPts val="0"/>
               </a:spcAft>
               <a:buNone/>
+              <a:defRPr/>
             </a:lvl5pPr>
             <a:lvl6pPr marL="0" indent="0">
               <a:lnSpc>
@@ -2208,6 +2285,7 @@
                 <a:spcPts val="0"/>
               </a:spcAft>
               <a:buNone/>
+              <a:defRPr/>
             </a:lvl6pPr>
             <a:lvl7pPr marL="0" indent="0">
               <a:lnSpc>
@@ -2220,6 +2298,7 @@
                 <a:spcPts val="0"/>
               </a:spcAft>
               <a:buNone/>
+              <a:defRPr/>
             </a:lvl7pPr>
             <a:lvl8pPr marL="0" indent="0">
               <a:lnSpc>
@@ -2232,6 +2311,7 @@
                 <a:spcPts val="0"/>
               </a:spcAft>
               <a:buNone/>
+              <a:defRPr/>
             </a:lvl8pPr>
             <a:lvl9pPr marL="0" indent="0">
               <a:lnSpc>
@@ -2244,6 +2324,7 @@
                 <a:spcPts val="0"/>
               </a:spcAft>
               <a:buNone/>
+              <a:defRPr/>
             </a:lvl9pPr>
           </a:lstStyle>
           <a:p xmlns:a="http://schemas.openxmlformats.org/drawingml/2006/main"/>
@@ -2305,6 +2386,7 @@
                 <a:spcPts val="1200"/>
               </a:spcAft>
               <a:buChar char="•"/>
+              <a:defRPr/>
             </a:lvl1pPr>
             <a:lvl2pPr marL="533400" indent="-228600">
               <a:lnSpc>
@@ -2317,6 +2399,7 @@
                 <a:spcPts val="1200"/>
               </a:spcAft>
               <a:buChar char="•"/>
+              <a:defRPr/>
             </a:lvl2pPr>
             <a:lvl3pPr marL="838200" indent="-228600">
               <a:lnSpc>
@@ -2329,6 +2412,7 @@
                 <a:spcPts val="1200"/>
               </a:spcAft>
               <a:buChar char="•"/>
+              <a:defRPr/>
             </a:lvl3pPr>
             <a:lvl4pPr marL="1143000" indent="-228600">
               <a:lnSpc>
@@ -2341,6 +2425,7 @@
                 <a:spcPts val="1200"/>
               </a:spcAft>
               <a:buChar char="•"/>
+              <a:defRPr/>
             </a:lvl4pPr>
             <a:lvl5pPr marL="1447800" indent="-228600">
               <a:lnSpc>
@@ -2353,6 +2438,7 @@
                 <a:spcPts val="1200"/>
               </a:spcAft>
               <a:buChar char="•"/>
+              <a:defRPr/>
             </a:lvl5pPr>
             <a:lvl6pPr marL="1752600" indent="-228600">
               <a:lnSpc>
@@ -2365,6 +2451,7 @@
                 <a:spcPts val="1200"/>
               </a:spcAft>
               <a:buChar char="•"/>
+              <a:defRPr/>
             </a:lvl6pPr>
             <a:lvl7pPr marL="2057400" indent="-228600">
               <a:lnSpc>
@@ -2377,6 +2464,7 @@
                 <a:spcPts val="1200"/>
               </a:spcAft>
               <a:buChar char="•"/>
+              <a:defRPr/>
             </a:lvl7pPr>
             <a:lvl8pPr marL="2362200" indent="-228600">
               <a:lnSpc>
@@ -2389,6 +2477,7 @@
                 <a:spcPts val="1200"/>
               </a:spcAft>
               <a:buChar char="•"/>
+              <a:defRPr/>
             </a:lvl8pPr>
             <a:lvl9pPr marL="2667000" indent="-228600">
               <a:lnSpc>
@@ -2401,6 +2490,7 @@
                 <a:spcPts val="1200"/>
               </a:spcAft>
               <a:buChar char="•"/>
+              <a:defRPr/>
             </a:lvl9pPr>
           </a:lstStyle>
           <a:p xmlns:a="http://schemas.openxmlformats.org/drawingml/2006/main"/>
@@ -2449,12 +2539,12 @@
   </p:cSld>
   <p:clrMap bg1="lt1" tx1="dk1" bg2="lt2" tx2="dk2" accent1="accent1" accent2="accent2" accent3="accent3" accent4="accent4" accent5="accent5" accent6="accent6" hlink="hlink" folHlink="folHlink"/>
   <p:sldLayoutIdLst>
-    <p:sldLayoutId xmlns:r="http://schemas.openxmlformats.org/officeDocument/2006/relationships" id="2147483649" r:id="R628cd3dd48454d6a"/>
-    <p:sldLayoutId xmlns:r="http://schemas.openxmlformats.org/officeDocument/2006/relationships" id="2147483650" r:id="R5b39942f95e74090"/>
-    <p:sldLayoutId xmlns:r="http://schemas.openxmlformats.org/officeDocument/2006/relationships" id="2147483651" r:id="R62588dfdcd514b62"/>
-    <p:sldLayoutId xmlns:r="http://schemas.openxmlformats.org/officeDocument/2006/relationships" id="2147483652" r:id="R560f8c3c884543cc"/>
-    <p:sldLayoutId xmlns:r="http://schemas.openxmlformats.org/officeDocument/2006/relationships" id="2147483653" r:id="R2237240c8a9449e4"/>
-    <p:sldLayoutId xmlns:r="http://schemas.openxmlformats.org/officeDocument/2006/relationships" id="2147483654" r:id="R0d7de9d5124146d6"/>
+    <p:sldLayoutId xmlns:r="http://schemas.openxmlformats.org/officeDocument/2006/relationships" id="2147483649" r:id="R9c7e93061e144341"/>
+    <p:sldLayoutId xmlns:r="http://schemas.openxmlformats.org/officeDocument/2006/relationships" id="2147483650" r:id="Rb20ab0f698f94324"/>
+    <p:sldLayoutId xmlns:r="http://schemas.openxmlformats.org/officeDocument/2006/relationships" id="2147483651" r:id="Rfbf945bcedc74601"/>
+    <p:sldLayoutId xmlns:r="http://schemas.openxmlformats.org/officeDocument/2006/relationships" id="2147483652" r:id="Rad576e50864746f2"/>
+    <p:sldLayoutId xmlns:r="http://schemas.openxmlformats.org/officeDocument/2006/relationships" id="2147483653" r:id="R8b0fc88fd3194571"/>
+    <p:sldLayoutId xmlns:r="http://schemas.openxmlformats.org/officeDocument/2006/relationships" id="2147483654" r:id="R7452dfef78a9435f"/>
   </p:sldLayoutIdLst>
   <p:txStyles>
     <p:titleStyle>
@@ -3173,6 +3263,7 @@
           </a:lstStyle>
           <a:p xmlns:a="http://schemas.openxmlformats.org/drawingml/2006/main">
             <a:pPr algn="l">
+              <a:buNone/>
               <a:defRPr sz="1350" b="1">
                 <a:solidFill>
                   <a:srgbClr val="22D3EE"/>
@@ -3241,6 +3332,7 @@
           </a:lstStyle>
           <a:p xmlns:a="http://schemas.openxmlformats.org/drawingml/2006/main">
             <a:pPr algn="l">
+              <a:buNone/>
               <a:defRPr sz="2550" b="1">
                 <a:solidFill>
                   <a:srgbClr val="F5F8FF"/>
@@ -3309,6 +3401,7 @@
           </a:lstStyle>
           <a:p xmlns:a="http://schemas.openxmlformats.org/drawingml/2006/main">
             <a:pPr algn="l">
+              <a:buNone/>
               <a:defRPr sz="1275" b="0">
                 <a:solidFill>
                   <a:srgbClr val="9FB1CA"/>
@@ -3450,6 +3543,7 @@
           </a:lstStyle>
           <a:p xmlns:a="http://schemas.openxmlformats.org/drawingml/2006/main">
             <a:pPr algn="ctr">
+              <a:buNone/>
               <a:defRPr sz="1050" b="1">
                 <a:solidFill>
                   <a:srgbClr val="081426"/>
@@ -3518,6 +3612,7 @@
           </a:lstStyle>
           <a:p xmlns:a="http://schemas.openxmlformats.org/drawingml/2006/main">
             <a:pPr algn="l">
+              <a:buNone/>
               <a:defRPr sz="1275" b="1">
                 <a:solidFill>
                   <a:srgbClr val="F5F8FF"/>
@@ -3586,6 +3681,7 @@
           </a:lstStyle>
           <a:p xmlns:a="http://schemas.openxmlformats.org/drawingml/2006/main">
             <a:pPr algn="l">
+              <a:buNone/>
               <a:defRPr sz="900" b="0">
                 <a:solidFill>
                   <a:srgbClr val="9FB1CA"/>
@@ -3696,6 +3792,7 @@
           </a:lstStyle>
           <a:p xmlns:a="http://schemas.openxmlformats.org/drawingml/2006/main">
             <a:pPr algn="ctr">
+              <a:buNone/>
               <a:defRPr sz="1050" b="1">
                 <a:solidFill>
                   <a:srgbClr val="081426"/>
@@ -3764,6 +3861,7 @@
           </a:lstStyle>
           <a:p xmlns:a="http://schemas.openxmlformats.org/drawingml/2006/main">
             <a:pPr algn="l">
+              <a:buNone/>
               <a:defRPr sz="1275" b="1">
                 <a:solidFill>
                   <a:srgbClr val="F5F8FF"/>
@@ -3832,6 +3930,7 @@
           </a:lstStyle>
           <a:p xmlns:a="http://schemas.openxmlformats.org/drawingml/2006/main">
             <a:pPr algn="l">
+              <a:buNone/>
               <a:defRPr sz="900" b="0">
                 <a:solidFill>
                   <a:srgbClr val="9FB1CA"/>
@@ -3942,6 +4041,7 @@
           </a:lstStyle>
           <a:p xmlns:a="http://schemas.openxmlformats.org/drawingml/2006/main">
             <a:pPr algn="ctr">
+              <a:buNone/>
               <a:defRPr sz="1050" b="1">
                 <a:solidFill>
                   <a:srgbClr val="081426"/>
@@ -4010,6 +4110,7 @@
           </a:lstStyle>
           <a:p xmlns:a="http://schemas.openxmlformats.org/drawingml/2006/main">
             <a:pPr algn="l">
+              <a:buNone/>
               <a:defRPr sz="1275" b="1">
                 <a:solidFill>
                   <a:srgbClr val="F5F8FF"/>
@@ -4078,6 +4179,7 @@
           </a:lstStyle>
           <a:p xmlns:a="http://schemas.openxmlformats.org/drawingml/2006/main">
             <a:pPr algn="l">
+              <a:buNone/>
               <a:defRPr sz="900" b="0">
                 <a:solidFill>
                   <a:srgbClr val="9FB1CA"/>
@@ -4188,6 +4290,7 @@
           </a:lstStyle>
           <a:p xmlns:a="http://schemas.openxmlformats.org/drawingml/2006/main">
             <a:pPr algn="ctr">
+              <a:buNone/>
               <a:defRPr sz="1050" b="1">
                 <a:solidFill>
                   <a:srgbClr val="081426"/>
@@ -4256,6 +4359,7 @@
           </a:lstStyle>
           <a:p xmlns:a="http://schemas.openxmlformats.org/drawingml/2006/main">
             <a:pPr algn="l">
+              <a:buNone/>
               <a:defRPr sz="1275" b="1">
                 <a:solidFill>
                   <a:srgbClr val="F5F8FF"/>
@@ -4324,6 +4428,7 @@
           </a:lstStyle>
           <a:p xmlns:a="http://schemas.openxmlformats.org/drawingml/2006/main">
             <a:pPr algn="l">
+              <a:buNone/>
               <a:defRPr sz="900" b="0">
                 <a:solidFill>
                   <a:srgbClr val="9FB1CA"/>
@@ -4434,6 +4539,7 @@
           </a:lstStyle>
           <a:p xmlns:a="http://schemas.openxmlformats.org/drawingml/2006/main">
             <a:pPr algn="ctr">
+              <a:buNone/>
               <a:defRPr sz="1050" b="1">
                 <a:solidFill>
                   <a:srgbClr val="081426"/>
@@ -4502,6 +4608,7 @@
           </a:lstStyle>
           <a:p xmlns:a="http://schemas.openxmlformats.org/drawingml/2006/main">
             <a:pPr algn="l">
+              <a:buNone/>
               <a:defRPr sz="1275" b="1">
                 <a:solidFill>
                   <a:srgbClr val="F5F8FF"/>
@@ -4570,6 +4677,7 @@
           </a:lstStyle>
           <a:p xmlns:a="http://schemas.openxmlformats.org/drawingml/2006/main">
             <a:pPr algn="l">
+              <a:buNone/>
               <a:defRPr sz="900" b="0">
                 <a:solidFill>
                   <a:srgbClr val="9FB1CA"/>
@@ -4673,6 +4781,7 @@
           </a:lstStyle>
           <a:p xmlns:a="http://schemas.openxmlformats.org/drawingml/2006/main">
             <a:pPr algn="l">
+              <a:buNone/>
               <a:defRPr sz="1125" b="1">
                 <a:solidFill>
                   <a:srgbClr val="22D3EE"/>
@@ -4741,6 +4850,7 @@
           </a:lstStyle>
           <a:p xmlns:a="http://schemas.openxmlformats.org/drawingml/2006/main">
             <a:pPr algn="l">
+              <a:buNone/>
               <a:defRPr sz="1350" b="1">
                 <a:solidFill>
                   <a:srgbClr val="F5F8FF"/>
@@ -4809,6 +4919,7 @@
           </a:lstStyle>
           <a:p xmlns:a="http://schemas.openxmlformats.org/drawingml/2006/main">
             <a:pPr algn="l">
+              <a:buNone/>
               <a:defRPr sz="1800" b="1">
                 <a:solidFill>
                   <a:srgbClr val="F5F8FF"/>
@@ -4919,6 +5030,7 @@
           </a:lstStyle>
           <a:p xmlns:a="http://schemas.openxmlformats.org/drawingml/2006/main">
             <a:pPr algn="ctr">
+              <a:buNone/>
               <a:defRPr sz="1050" b="1">
                 <a:solidFill>
                   <a:srgbClr val="081426"/>
@@ -4987,6 +5099,7 @@
           </a:lstStyle>
           <a:p xmlns:a="http://schemas.openxmlformats.org/drawingml/2006/main">
             <a:pPr algn="l">
+              <a:buNone/>
               <a:defRPr sz="1575" b="1">
                 <a:solidFill>
                   <a:srgbClr val="F5F8FF"/>
@@ -5055,6 +5168,7 @@
           </a:lstStyle>
           <a:p xmlns:a="http://schemas.openxmlformats.org/drawingml/2006/main">
             <a:pPr algn="l">
+              <a:buNone/>
               <a:defRPr sz="1050" b="0">
                 <a:solidFill>
                   <a:srgbClr val="9FB1CA"/>
@@ -5165,6 +5279,7 @@
           </a:lstStyle>
           <a:p xmlns:a="http://schemas.openxmlformats.org/drawingml/2006/main">
             <a:pPr algn="ctr">
+              <a:buNone/>
               <a:defRPr sz="1050" b="1">
                 <a:solidFill>
                   <a:srgbClr val="081426"/>
@@ -5233,6 +5348,7 @@
           </a:lstStyle>
           <a:p xmlns:a="http://schemas.openxmlformats.org/drawingml/2006/main">
             <a:pPr algn="l">
+              <a:buNone/>
               <a:defRPr sz="1575" b="1">
                 <a:solidFill>
                   <a:srgbClr val="F5F8FF"/>
@@ -5301,6 +5417,7 @@
           </a:lstStyle>
           <a:p xmlns:a="http://schemas.openxmlformats.org/drawingml/2006/main">
             <a:pPr algn="l">
+              <a:buNone/>
               <a:defRPr sz="1050" b="0">
                 <a:solidFill>
                   <a:srgbClr val="9FB1CA"/>
@@ -5411,6 +5528,7 @@
           </a:lstStyle>
           <a:p xmlns:a="http://schemas.openxmlformats.org/drawingml/2006/main">
             <a:pPr algn="ctr">
+              <a:buNone/>
               <a:defRPr sz="1050" b="1">
                 <a:solidFill>
                   <a:srgbClr val="081426"/>
@@ -5479,6 +5597,7 @@
           </a:lstStyle>
           <a:p xmlns:a="http://schemas.openxmlformats.org/drawingml/2006/main">
             <a:pPr algn="l">
+              <a:buNone/>
               <a:defRPr sz="1575" b="1">
                 <a:solidFill>
                   <a:srgbClr val="F5F8FF"/>
@@ -5547,6 +5666,7 @@
           </a:lstStyle>
           <a:p xmlns:a="http://schemas.openxmlformats.org/drawingml/2006/main">
             <a:pPr algn="l">
+              <a:buNone/>
               <a:defRPr sz="1050" b="0">
                 <a:solidFill>
                   <a:srgbClr val="9FB1CA"/>
@@ -5615,6 +5735,7 @@
           </a:lstStyle>
           <a:p xmlns:a="http://schemas.openxmlformats.org/drawingml/2006/main">
             <a:pPr algn="l">
+              <a:buNone/>
               <a:defRPr sz="900" b="0">
                 <a:solidFill>
                   <a:srgbClr val="9FB1CA"/>
@@ -5633,7 +5754,18 @@
                 <a:ea typeface="Arial"/>
                 <a:cs typeface="Arial"/>
               </a:rPr>
-              <a:t>AURA • Track A • 11/10/2026</a:t>
+              <a:t>AURA • Track A • </a:t>
+            </a:r>
+            <a:r>
+              <a:rPr sz="900" b="0">
+                <a:solidFill>
+                  <a:srgbClr val="9FB1CA"/>
+                </a:solidFill>
+                <a:latin typeface="Arial"/>
+                <a:ea typeface="Arial"/>
+                <a:cs typeface="Arial"/>
+              </a:rPr>
+              <a:t>12/10/2026</a:t>
             </a:r>
           </a:p>
         </p:txBody>
@@ -5683,6 +5815,7 @@
           </a:lstStyle>
           <a:p xmlns:a="http://schemas.openxmlformats.org/drawingml/2006/main">
             <a:pPr algn="r">
+              <a:buNone/>
               <a:defRPr sz="975" b="1">
                 <a:solidFill>
                   <a:srgbClr val="9FB1CA"/>
@@ -5780,6 +5913,7 @@
           </a:lstStyle>
           <a:p xmlns:a="http://schemas.openxmlformats.org/drawingml/2006/main">
             <a:pPr algn="l">
+              <a:buNone/>
               <a:defRPr sz="1350" b="1">
                 <a:solidFill>
                   <a:srgbClr val="22D3EE"/>
@@ -5848,6 +5982,7 @@
           </a:lstStyle>
           <a:p xmlns:a="http://schemas.openxmlformats.org/drawingml/2006/main">
             <a:pPr algn="l">
+              <a:buNone/>
               <a:defRPr sz="2550" b="1">
                 <a:solidFill>
                   <a:srgbClr val="F5F8FF"/>
@@ -5916,6 +6051,7 @@
           </a:lstStyle>
           <a:p xmlns:a="http://schemas.openxmlformats.org/drawingml/2006/main">
             <a:pPr algn="l">
+              <a:buNone/>
               <a:defRPr sz="1275" b="0">
                 <a:solidFill>
                   <a:srgbClr val="9FB1CA"/>
@@ -6057,6 +6193,7 @@
           </a:lstStyle>
           <a:p xmlns:a="http://schemas.openxmlformats.org/drawingml/2006/main">
             <a:pPr algn="ctr">
+              <a:buNone/>
               <a:defRPr sz="1050" b="1">
                 <a:solidFill>
                   <a:srgbClr val="081426"/>
@@ -6125,6 +6262,7 @@
           </a:lstStyle>
           <a:p xmlns:a="http://schemas.openxmlformats.org/drawingml/2006/main">
             <a:pPr algn="l">
+              <a:buNone/>
               <a:defRPr sz="1275" b="1">
                 <a:solidFill>
                   <a:srgbClr val="F5F8FF"/>
@@ -6193,6 +6331,7 @@
           </a:lstStyle>
           <a:p xmlns:a="http://schemas.openxmlformats.org/drawingml/2006/main">
             <a:pPr algn="ctr">
+              <a:buNone/>
               <a:defRPr sz="1200" b="0">
                 <a:solidFill>
                   <a:srgbClr val="9FB1CA"/>
@@ -6216,6 +6355,7 @@
           </a:p>
           <a:p xmlns:a="http://schemas.openxmlformats.org/drawingml/2006/main">
             <a:pPr algn="ctr">
+              <a:buNone/>
               <a:defRPr sz="1200" b="0">
                 <a:solidFill>
                   <a:srgbClr val="9FB1CA"/>
@@ -6358,6 +6498,7 @@
           </a:lstStyle>
           <a:p xmlns:a="http://schemas.openxmlformats.org/drawingml/2006/main">
             <a:pPr algn="ctr">
+              <a:buNone/>
               <a:defRPr sz="1050" b="1">
                 <a:solidFill>
                   <a:srgbClr val="081426"/>
@@ -6426,6 +6567,7 @@
           </a:lstStyle>
           <a:p xmlns:a="http://schemas.openxmlformats.org/drawingml/2006/main">
             <a:pPr algn="l">
+              <a:buNone/>
               <a:defRPr sz="1275" b="1">
                 <a:solidFill>
                   <a:srgbClr val="F5F8FF"/>
@@ -6494,6 +6636,7 @@
           </a:lstStyle>
           <a:p xmlns:a="http://schemas.openxmlformats.org/drawingml/2006/main">
             <a:pPr algn="ctr">
+              <a:buNone/>
               <a:defRPr sz="1200" b="0">
                 <a:solidFill>
                   <a:srgbClr val="9FB1CA"/>
@@ -6517,6 +6660,7 @@
           </a:p>
           <a:p xmlns:a="http://schemas.openxmlformats.org/drawingml/2006/main">
             <a:pPr algn="ctr">
+              <a:buNone/>
               <a:defRPr sz="1200" b="0">
                 <a:solidFill>
                   <a:srgbClr val="9FB1CA"/>
@@ -6659,6 +6803,7 @@
           </a:lstStyle>
           <a:p xmlns:a="http://schemas.openxmlformats.org/drawingml/2006/main">
             <a:pPr algn="ctr">
+              <a:buNone/>
               <a:defRPr sz="1050" b="1">
                 <a:solidFill>
                   <a:srgbClr val="081426"/>
@@ -6727,6 +6872,7 @@
           </a:lstStyle>
           <a:p xmlns:a="http://schemas.openxmlformats.org/drawingml/2006/main">
             <a:pPr algn="l">
+              <a:buNone/>
               <a:defRPr sz="1275" b="1">
                 <a:solidFill>
                   <a:srgbClr val="F5F8FF"/>
@@ -6795,6 +6941,7 @@
           </a:lstStyle>
           <a:p xmlns:a="http://schemas.openxmlformats.org/drawingml/2006/main">
             <a:pPr algn="ctr">
+              <a:buNone/>
               <a:defRPr sz="1200" b="0">
                 <a:solidFill>
                   <a:srgbClr val="9FB1CA"/>
@@ -6818,6 +6965,7 @@
           </a:p>
           <a:p xmlns:a="http://schemas.openxmlformats.org/drawingml/2006/main">
             <a:pPr algn="ctr">
+              <a:buNone/>
               <a:defRPr sz="1200" b="0">
                 <a:solidFill>
                   <a:srgbClr val="9FB1CA"/>
@@ -6960,6 +7108,7 @@
           </a:lstStyle>
           <a:p xmlns:a="http://schemas.openxmlformats.org/drawingml/2006/main">
             <a:pPr algn="ctr">
+              <a:buNone/>
               <a:defRPr sz="1050" b="1">
                 <a:solidFill>
                   <a:srgbClr val="081426"/>
@@ -7028,6 +7177,7 @@
           </a:lstStyle>
           <a:p xmlns:a="http://schemas.openxmlformats.org/drawingml/2006/main">
             <a:pPr algn="l">
+              <a:buNone/>
               <a:defRPr sz="1275" b="1">
                 <a:solidFill>
                   <a:srgbClr val="F5F8FF"/>
@@ -7096,6 +7246,7 @@
           </a:lstStyle>
           <a:p xmlns:a="http://schemas.openxmlformats.org/drawingml/2006/main">
             <a:pPr algn="ctr">
+              <a:buNone/>
               <a:defRPr sz="1200" b="0">
                 <a:solidFill>
                   <a:srgbClr val="9FB1CA"/>
@@ -7119,6 +7270,7 @@
           </a:p>
           <a:p xmlns:a="http://schemas.openxmlformats.org/drawingml/2006/main">
             <a:pPr algn="ctr">
+              <a:buNone/>
               <a:defRPr sz="1200" b="0">
                 <a:solidFill>
                   <a:srgbClr val="9FB1CA"/>
@@ -7261,6 +7413,7 @@
           </a:lstStyle>
           <a:p xmlns:a="http://schemas.openxmlformats.org/drawingml/2006/main">
             <a:pPr algn="ctr">
+              <a:buNone/>
               <a:defRPr sz="1050" b="1">
                 <a:solidFill>
                   <a:srgbClr val="081426"/>
@@ -7329,6 +7482,7 @@
           </a:lstStyle>
           <a:p xmlns:a="http://schemas.openxmlformats.org/drawingml/2006/main">
             <a:pPr algn="l">
+              <a:buNone/>
               <a:defRPr sz="1275" b="1">
                 <a:solidFill>
                   <a:srgbClr val="F5F8FF"/>
@@ -7397,6 +7551,7 @@
           </a:lstStyle>
           <a:p xmlns:a="http://schemas.openxmlformats.org/drawingml/2006/main">
             <a:pPr algn="ctr">
+              <a:buNone/>
               <a:defRPr sz="1200" b="0">
                 <a:solidFill>
                   <a:srgbClr val="9FB1CA"/>
@@ -7420,6 +7575,7 @@
           </a:p>
           <a:p xmlns:a="http://schemas.openxmlformats.org/drawingml/2006/main">
             <a:pPr algn="ctr">
+              <a:buNone/>
               <a:defRPr sz="1200" b="0">
                 <a:solidFill>
                   <a:srgbClr val="9FB1CA"/>
@@ -7488,6 +7644,7 @@
           </a:lstStyle>
           <a:p xmlns:a="http://schemas.openxmlformats.org/drawingml/2006/main">
             <a:pPr algn="l">
+              <a:buNone/>
               <a:defRPr sz="1125" b="1">
                 <a:solidFill>
                   <a:srgbClr val="22D3EE"/>
@@ -7591,6 +7748,7 @@
           </a:lstStyle>
           <a:p xmlns:a="http://schemas.openxmlformats.org/drawingml/2006/main">
             <a:pPr algn="l">
+              <a:buNone/>
               <a:defRPr sz="1725" b="1">
                 <a:solidFill>
                   <a:srgbClr val="F5F8FF"/>
@@ -7659,6 +7817,7 @@
           </a:lstStyle>
           <a:p xmlns:a="http://schemas.openxmlformats.org/drawingml/2006/main">
             <a:pPr algn="l">
+              <a:buNone/>
               <a:defRPr sz="1350" b="0">
                 <a:solidFill>
                   <a:srgbClr val="9FB1CA"/>
@@ -7682,6 +7841,7 @@
           </a:p>
           <a:p xmlns:a="http://schemas.openxmlformats.org/drawingml/2006/main">
             <a:pPr algn="l">
+              <a:buNone/>
               <a:defRPr sz="1350" b="0">
                 <a:solidFill>
                   <a:srgbClr val="9FB1CA"/>
@@ -7705,6 +7865,7 @@
           </a:p>
           <a:p xmlns:a="http://schemas.openxmlformats.org/drawingml/2006/main">
             <a:pPr algn="l">
+              <a:buNone/>
               <a:defRPr sz="1350" b="0">
                 <a:solidFill>
                   <a:srgbClr val="9FB1CA"/>
@@ -7780,6 +7941,7 @@
           </a:lstStyle>
           <a:p xmlns:a="http://schemas.openxmlformats.org/drawingml/2006/main">
             <a:pPr algn="ctr">
+              <a:buNone/>
               <a:defRPr sz="1050" b="1">
                 <a:solidFill>
                   <a:srgbClr val="081426"/>
@@ -7848,6 +8010,7 @@
           </a:lstStyle>
           <a:p xmlns:a="http://schemas.openxmlformats.org/drawingml/2006/main">
             <a:pPr algn="l">
+              <a:buNone/>
               <a:defRPr sz="1125" b="1">
                 <a:solidFill>
                   <a:srgbClr val="F8C14C"/>
@@ -7951,6 +8114,7 @@
           </a:lstStyle>
           <a:p xmlns:a="http://schemas.openxmlformats.org/drawingml/2006/main">
             <a:pPr algn="l">
+              <a:buNone/>
               <a:defRPr sz="1725" b="1">
                 <a:solidFill>
                   <a:srgbClr val="F5F8FF"/>
@@ -8054,6 +8218,7 @@
           </a:lstStyle>
           <a:p xmlns:a="http://schemas.openxmlformats.org/drawingml/2006/main">
             <a:pPr algn="ctr">
+              <a:buNone/>
               <a:defRPr sz="1200" b="1">
                 <a:solidFill>
                   <a:srgbClr val="2DD4A7"/>
@@ -8122,6 +8287,7 @@
           </a:lstStyle>
           <a:p xmlns:a="http://schemas.openxmlformats.org/drawingml/2006/main">
             <a:pPr algn="ctr">
+              <a:buNone/>
               <a:defRPr sz="975" b="0">
                 <a:solidFill>
                   <a:srgbClr val="9FB1CA"/>
@@ -8225,6 +8391,7 @@
           </a:lstStyle>
           <a:p xmlns:a="http://schemas.openxmlformats.org/drawingml/2006/main">
             <a:pPr algn="ctr">
+              <a:buNone/>
               <a:defRPr sz="1200" b="1">
                 <a:solidFill>
                   <a:srgbClr val="FF6B7A"/>
@@ -8293,6 +8460,7 @@
           </a:lstStyle>
           <a:p xmlns:a="http://schemas.openxmlformats.org/drawingml/2006/main">
             <a:pPr algn="ctr">
+              <a:buNone/>
               <a:defRPr sz="975" b="0">
                 <a:solidFill>
                   <a:srgbClr val="9FB1CA"/>
@@ -8361,6 +8529,7 @@
           </a:lstStyle>
           <a:p xmlns:a="http://schemas.openxmlformats.org/drawingml/2006/main">
             <a:pPr algn="ctr">
+              <a:buNone/>
               <a:defRPr sz="1125" b="1">
                 <a:solidFill>
                   <a:srgbClr val="F5F8FF"/>
@@ -8429,6 +8598,7 @@
           </a:lstStyle>
           <a:p xmlns:a="http://schemas.openxmlformats.org/drawingml/2006/main">
             <a:pPr algn="l">
+              <a:buNone/>
               <a:defRPr sz="900" b="0">
                 <a:solidFill>
                   <a:srgbClr val="9FB1CA"/>
@@ -8447,7 +8617,18 @@
                 <a:ea typeface="Arial"/>
                 <a:cs typeface="Arial"/>
               </a:rPr>
-              <a:t>AURA • Track A • 11/10/2026</a:t>
+              <a:t>AURA • Track A • </a:t>
+            </a:r>
+            <a:r>
+              <a:rPr sz="900" b="0">
+                <a:solidFill>
+                  <a:srgbClr val="9FB1CA"/>
+                </a:solidFill>
+                <a:latin typeface="Arial"/>
+                <a:ea typeface="Arial"/>
+                <a:cs typeface="Arial"/>
+              </a:rPr>
+              <a:t>12/10/2026</a:t>
             </a:r>
           </a:p>
         </p:txBody>
@@ -8497,6 +8678,7 @@
           </a:lstStyle>
           <a:p xmlns:a="http://schemas.openxmlformats.org/drawingml/2006/main">
             <a:pPr algn="r">
+              <a:buNone/>
               <a:defRPr sz="975" b="1">
                 <a:solidFill>
                   <a:srgbClr val="9FB1CA"/>
@@ -8594,6 +8776,7 @@
           </a:lstStyle>
           <a:p xmlns:a="http://schemas.openxmlformats.org/drawingml/2006/main">
             <a:pPr algn="l">
+              <a:buNone/>
               <a:defRPr sz="1350" b="1">
                 <a:solidFill>
                   <a:srgbClr val="22D3EE"/>
@@ -8662,6 +8845,7 @@
           </a:lstStyle>
           <a:p xmlns:a="http://schemas.openxmlformats.org/drawingml/2006/main">
             <a:pPr algn="l">
+              <a:buNone/>
               <a:defRPr sz="2550" b="1">
                 <a:solidFill>
                   <a:srgbClr val="F5F8FF"/>
@@ -8730,6 +8914,7 @@
           </a:lstStyle>
           <a:p xmlns:a="http://schemas.openxmlformats.org/drawingml/2006/main">
             <a:pPr algn="l">
+              <a:buNone/>
               <a:defRPr sz="1275" b="0">
                 <a:solidFill>
                   <a:srgbClr val="9FB1CA"/>
@@ -8871,6 +9056,7 @@
           </a:lstStyle>
           <a:p xmlns:a="http://schemas.openxmlformats.org/drawingml/2006/main">
             <a:pPr algn="ctr">
+              <a:buNone/>
               <a:defRPr sz="1050" b="1">
                 <a:solidFill>
                   <a:srgbClr val="081426"/>
@@ -8939,6 +9125,7 @@
           </a:lstStyle>
           <a:p xmlns:a="http://schemas.openxmlformats.org/drawingml/2006/main">
             <a:pPr algn="l">
+              <a:buNone/>
               <a:defRPr sz="1800" b="1">
                 <a:solidFill>
                   <a:srgbClr val="F5F8FF"/>
@@ -9007,6 +9194,7 @@
           </a:lstStyle>
           <a:p xmlns:a="http://schemas.openxmlformats.org/drawingml/2006/main">
             <a:pPr algn="l">
+              <a:buNone/>
               <a:defRPr sz="1350" b="0">
                 <a:solidFill>
                   <a:srgbClr val="9FB1CA"/>
@@ -9030,6 +9218,7 @@
           </a:p>
           <a:p xmlns:a="http://schemas.openxmlformats.org/drawingml/2006/main">
             <a:pPr algn="l">
+              <a:buNone/>
               <a:defRPr sz="1350" b="0">
                 <a:solidFill>
                   <a:srgbClr val="9FB1CA"/>
@@ -9053,6 +9242,7 @@
           </a:p>
           <a:p xmlns:a="http://schemas.openxmlformats.org/drawingml/2006/main">
             <a:pPr algn="l">
+              <a:buNone/>
               <a:defRPr sz="1350" b="0">
                 <a:solidFill>
                   <a:srgbClr val="9FB1CA"/>
@@ -9163,6 +9353,7 @@
           </a:lstStyle>
           <a:p xmlns:a="http://schemas.openxmlformats.org/drawingml/2006/main">
             <a:pPr algn="ctr">
+              <a:buNone/>
               <a:defRPr sz="1050" b="1">
                 <a:solidFill>
                   <a:srgbClr val="081426"/>
@@ -9231,6 +9422,7 @@
           </a:lstStyle>
           <a:p xmlns:a="http://schemas.openxmlformats.org/drawingml/2006/main">
             <a:pPr algn="l">
+              <a:buNone/>
               <a:defRPr sz="1800" b="1">
                 <a:solidFill>
                   <a:srgbClr val="F5F8FF"/>
@@ -9299,6 +9491,7 @@
           </a:lstStyle>
           <a:p xmlns:a="http://schemas.openxmlformats.org/drawingml/2006/main">
             <a:pPr algn="l">
+              <a:buNone/>
               <a:defRPr sz="1350" b="0">
                 <a:solidFill>
                   <a:srgbClr val="9FB1CA"/>
@@ -9322,6 +9515,7 @@
           </a:p>
           <a:p xmlns:a="http://schemas.openxmlformats.org/drawingml/2006/main">
             <a:pPr algn="l">
+              <a:buNone/>
               <a:defRPr sz="1350" b="0">
                 <a:solidFill>
                   <a:srgbClr val="9FB1CA"/>
@@ -9345,6 +9539,7 @@
           </a:p>
           <a:p xmlns:a="http://schemas.openxmlformats.org/drawingml/2006/main">
             <a:pPr algn="l">
+              <a:buNone/>
               <a:defRPr sz="1350" b="0">
                 <a:solidFill>
                   <a:srgbClr val="9FB1CA"/>
@@ -9413,6 +9608,7 @@
           </a:lstStyle>
           <a:p xmlns:a="http://schemas.openxmlformats.org/drawingml/2006/main">
             <a:pPr algn="l">
+              <a:buNone/>
               <a:defRPr sz="1500" b="1">
                 <a:solidFill>
                   <a:srgbClr val="F5F8FF"/>
@@ -9516,6 +9712,7 @@
           </a:lstStyle>
           <a:p xmlns:a="http://schemas.openxmlformats.org/drawingml/2006/main">
             <a:pPr algn="ctr">
+              <a:buNone/>
               <a:defRPr sz="2325" b="1">
                 <a:solidFill>
                   <a:srgbClr val="4D8DFF"/>
@@ -9534,7 +9731,7 @@
                 <a:ea typeface="Arial"/>
                 <a:cs typeface="Arial"/>
               </a:rPr>
-              <a:t>142/142</a:t>
+              <a:t>149/149</a:t>
             </a:r>
           </a:p>
         </p:txBody>
@@ -9584,6 +9781,7 @@
           </a:lstStyle>
           <a:p xmlns:a="http://schemas.openxmlformats.org/drawingml/2006/main">
             <a:pPr algn="ctr">
+              <a:buNone/>
               <a:defRPr sz="1050" b="1">
                 <a:solidFill>
                   <a:srgbClr val="9FB1CA"/>
@@ -9687,6 +9885,7 @@
           </a:lstStyle>
           <a:p xmlns:a="http://schemas.openxmlformats.org/drawingml/2006/main">
             <a:pPr algn="ctr">
+              <a:buNone/>
               <a:defRPr sz="2325" b="1">
                 <a:solidFill>
                   <a:srgbClr val="2DD4A7"/>
@@ -9755,6 +9954,7 @@
           </a:lstStyle>
           <a:p xmlns:a="http://schemas.openxmlformats.org/drawingml/2006/main">
             <a:pPr algn="ctr">
+              <a:buNone/>
               <a:defRPr sz="1050" b="1">
                 <a:solidFill>
                   <a:srgbClr val="9FB1CA"/>
@@ -9858,6 +10058,7 @@
           </a:lstStyle>
           <a:p xmlns:a="http://schemas.openxmlformats.org/drawingml/2006/main">
             <a:pPr algn="ctr">
+              <a:buNone/>
               <a:defRPr sz="2325" b="1">
                 <a:solidFill>
                   <a:srgbClr val="A78BFA"/>
@@ -9926,6 +10127,7 @@
           </a:lstStyle>
           <a:p xmlns:a="http://schemas.openxmlformats.org/drawingml/2006/main">
             <a:pPr algn="ctr">
+              <a:buNone/>
               <a:defRPr sz="1050" b="1">
                 <a:solidFill>
                   <a:srgbClr val="9FB1CA"/>
@@ -10029,6 +10231,7 @@
           </a:lstStyle>
           <a:p xmlns:a="http://schemas.openxmlformats.org/drawingml/2006/main">
             <a:pPr algn="l">
+              <a:buNone/>
               <a:defRPr sz="1500" b="1">
                 <a:solidFill>
                   <a:srgbClr val="F5F8FF"/>
@@ -10104,6 +10307,7 @@
           </a:lstStyle>
           <a:p xmlns:a="http://schemas.openxmlformats.org/drawingml/2006/main">
             <a:pPr algn="ctr">
+              <a:buNone/>
               <a:defRPr sz="1050" b="1">
                 <a:solidFill>
                   <a:srgbClr val="081426"/>
@@ -10179,6 +10383,7 @@
           </a:lstStyle>
           <a:p xmlns:a="http://schemas.openxmlformats.org/drawingml/2006/main">
             <a:pPr algn="ctr">
+              <a:buNone/>
               <a:defRPr sz="1050" b="1">
                 <a:solidFill>
                   <a:srgbClr val="081426"/>
@@ -10254,6 +10459,7 @@
           </a:lstStyle>
           <a:p xmlns:a="http://schemas.openxmlformats.org/drawingml/2006/main">
             <a:pPr algn="ctr">
+              <a:buNone/>
               <a:defRPr sz="1050" b="1">
                 <a:solidFill>
                   <a:srgbClr val="081426"/>
@@ -10329,6 +10535,7 @@
           </a:lstStyle>
           <a:p xmlns:a="http://schemas.openxmlformats.org/drawingml/2006/main">
             <a:pPr algn="ctr">
+              <a:buNone/>
               <a:defRPr sz="1050" b="1">
                 <a:solidFill>
                   <a:srgbClr val="081426"/>
@@ -10397,6 +10604,7 @@
           </a:lstStyle>
           <a:p xmlns:a="http://schemas.openxmlformats.org/drawingml/2006/main">
             <a:pPr algn="ctr">
+              <a:buNone/>
               <a:defRPr sz="1125" b="1">
                 <a:solidFill>
                   <a:srgbClr val="F8C14C"/>
@@ -10465,6 +10673,7 @@
           </a:lstStyle>
           <a:p xmlns:a="http://schemas.openxmlformats.org/drawingml/2006/main">
             <a:pPr algn="l">
+              <a:buNone/>
               <a:defRPr sz="900" b="0">
                 <a:solidFill>
                   <a:srgbClr val="9FB1CA"/>
@@ -10483,7 +10692,18 @@
                 <a:ea typeface="Arial"/>
                 <a:cs typeface="Arial"/>
               </a:rPr>
-              <a:t>AURA • Track A • 11/10/2026</a:t>
+              <a:t>AURA • Track A • </a:t>
+            </a:r>
+            <a:r>
+              <a:rPr sz="900" b="0">
+                <a:solidFill>
+                  <a:srgbClr val="9FB1CA"/>
+                </a:solidFill>
+                <a:latin typeface="Arial"/>
+                <a:ea typeface="Arial"/>
+                <a:cs typeface="Arial"/>
+              </a:rPr>
+              <a:t>12/10/2026</a:t>
             </a:r>
           </a:p>
         </p:txBody>
@@ -10533,6 +10753,7 @@
           </a:lstStyle>
           <a:p xmlns:a="http://schemas.openxmlformats.org/drawingml/2006/main">
             <a:pPr algn="r">
+              <a:buNone/>
               <a:defRPr sz="975" b="1">
                 <a:solidFill>
                   <a:srgbClr val="9FB1CA"/>
@@ -10630,6 +10851,7 @@
           </a:lstStyle>
           <a:p xmlns:a="http://schemas.openxmlformats.org/drawingml/2006/main">
             <a:pPr algn="l">
+              <a:buNone/>
               <a:defRPr sz="1350" b="1">
                 <a:solidFill>
                   <a:srgbClr val="22D3EE"/>
@@ -10698,6 +10920,7 @@
           </a:lstStyle>
           <a:p xmlns:a="http://schemas.openxmlformats.org/drawingml/2006/main">
             <a:pPr algn="l">
+              <a:buNone/>
               <a:defRPr sz="2550" b="1">
                 <a:solidFill>
                   <a:srgbClr val="F5F8FF"/>
@@ -10766,6 +10989,7 @@
           </a:lstStyle>
           <a:p xmlns:a="http://schemas.openxmlformats.org/drawingml/2006/main">
             <a:pPr algn="l">
+              <a:buNone/>
               <a:defRPr sz="1275" b="0">
                 <a:solidFill>
                   <a:srgbClr val="9FB1CA"/>
@@ -10907,6 +11131,7 @@
           </a:lstStyle>
           <a:p xmlns:a="http://schemas.openxmlformats.org/drawingml/2006/main">
             <a:pPr algn="ctr">
+              <a:buNone/>
               <a:defRPr sz="1050" b="1">
                 <a:solidFill>
                   <a:srgbClr val="081426"/>
@@ -10975,6 +11200,7 @@
           </a:lstStyle>
           <a:p xmlns:a="http://schemas.openxmlformats.org/drawingml/2006/main">
             <a:pPr algn="l">
+              <a:buNone/>
               <a:defRPr sz="1275" b="1">
                 <a:solidFill>
                   <a:srgbClr val="F5F8FF"/>
@@ -11116,6 +11342,7 @@
           </a:lstStyle>
           <a:p xmlns:a="http://schemas.openxmlformats.org/drawingml/2006/main">
             <a:pPr algn="ctr">
+              <a:buNone/>
               <a:defRPr sz="1050" b="1">
                 <a:solidFill>
                   <a:srgbClr val="081426"/>
@@ -11184,6 +11411,7 @@
           </a:lstStyle>
           <a:p xmlns:a="http://schemas.openxmlformats.org/drawingml/2006/main">
             <a:pPr algn="l">
+              <a:buNone/>
               <a:defRPr sz="1275" b="1">
                 <a:solidFill>
                   <a:srgbClr val="F5F8FF"/>
@@ -11325,6 +11553,7 @@
           </a:lstStyle>
           <a:p xmlns:a="http://schemas.openxmlformats.org/drawingml/2006/main">
             <a:pPr algn="ctr">
+              <a:buNone/>
               <a:defRPr sz="1050" b="1">
                 <a:solidFill>
                   <a:srgbClr val="081426"/>
@@ -11393,6 +11622,7 @@
           </a:lstStyle>
           <a:p xmlns:a="http://schemas.openxmlformats.org/drawingml/2006/main">
             <a:pPr algn="l">
+              <a:buNone/>
               <a:defRPr sz="1275" b="1">
                 <a:solidFill>
                   <a:srgbClr val="F5F8FF"/>
@@ -11534,6 +11764,7 @@
           </a:lstStyle>
           <a:p xmlns:a="http://schemas.openxmlformats.org/drawingml/2006/main">
             <a:pPr algn="ctr">
+              <a:buNone/>
               <a:defRPr sz="1050" b="1">
                 <a:solidFill>
                   <a:srgbClr val="081426"/>
@@ -11602,6 +11833,7 @@
           </a:lstStyle>
           <a:p xmlns:a="http://schemas.openxmlformats.org/drawingml/2006/main">
             <a:pPr algn="l">
+              <a:buNone/>
               <a:defRPr sz="1275" b="1">
                 <a:solidFill>
                   <a:srgbClr val="F5F8FF"/>
@@ -11705,6 +11937,7 @@
           </a:lstStyle>
           <a:p xmlns:a="http://schemas.openxmlformats.org/drawingml/2006/main">
             <a:pPr algn="l">
+              <a:buNone/>
               <a:defRPr sz="1125" b="1">
                 <a:solidFill>
                   <a:srgbClr val="22D3EE"/>
@@ -11773,6 +12006,7 @@
           </a:lstStyle>
           <a:p xmlns:a="http://schemas.openxmlformats.org/drawingml/2006/main">
             <a:pPr algn="l">
+              <a:buNone/>
               <a:defRPr sz="1350" b="1">
                 <a:solidFill>
                   <a:srgbClr val="F5F8FF"/>
@@ -11883,6 +12117,7 @@
           </a:lstStyle>
           <a:p xmlns:a="http://schemas.openxmlformats.org/drawingml/2006/main">
             <a:pPr algn="ctr">
+              <a:buNone/>
               <a:defRPr sz="1050" b="1">
                 <a:solidFill>
                   <a:srgbClr val="081426"/>
@@ -11951,6 +12186,7 @@
           </a:lstStyle>
           <a:p xmlns:a="http://schemas.openxmlformats.org/drawingml/2006/main">
             <a:pPr algn="l">
+              <a:buNone/>
               <a:defRPr sz="1500" b="1">
                 <a:solidFill>
                   <a:srgbClr val="F5F8FF"/>
@@ -11974,6 +12210,7 @@
           </a:p>
           <a:p xmlns:a="http://schemas.openxmlformats.org/drawingml/2006/main">
             <a:pPr algn="l">
+              <a:buNone/>
               <a:defRPr sz="1500" b="1">
                 <a:solidFill>
                   <a:srgbClr val="F5F8FF"/>
@@ -11997,6 +12234,7 @@
           </a:p>
           <a:p xmlns:a="http://schemas.openxmlformats.org/drawingml/2006/main">
             <a:pPr algn="l">
+              <a:buNone/>
               <a:defRPr sz="1500" b="1">
                 <a:solidFill>
                   <a:srgbClr val="F5F8FF"/>
@@ -12020,6 +12258,7 @@
           </a:p>
           <a:p xmlns:a="http://schemas.openxmlformats.org/drawingml/2006/main">
             <a:pPr algn="l">
+              <a:buNone/>
               <a:defRPr sz="1500" b="1">
                 <a:solidFill>
                   <a:srgbClr val="F5F8FF"/>
@@ -12130,6 +12369,7 @@
           </a:lstStyle>
           <a:p xmlns:a="http://schemas.openxmlformats.org/drawingml/2006/main">
             <a:pPr algn="ctr">
+              <a:buNone/>
               <a:defRPr sz="1050" b="1">
                 <a:solidFill>
                   <a:srgbClr val="081426"/>
@@ -12198,6 +12438,7 @@
           </a:lstStyle>
           <a:p xmlns:a="http://schemas.openxmlformats.org/drawingml/2006/main">
             <a:pPr algn="l">
+              <a:buNone/>
               <a:defRPr sz="1500" b="1">
                 <a:solidFill>
                   <a:srgbClr val="F5F8FF"/>
@@ -12221,6 +12462,7 @@
           </a:p>
           <a:p xmlns:a="http://schemas.openxmlformats.org/drawingml/2006/main">
             <a:pPr algn="l">
+              <a:buNone/>
               <a:defRPr sz="1500" b="1">
                 <a:solidFill>
                   <a:srgbClr val="F5F8FF"/>
@@ -12244,6 +12486,7 @@
           </a:p>
           <a:p xmlns:a="http://schemas.openxmlformats.org/drawingml/2006/main">
             <a:pPr algn="l">
+              <a:buNone/>
               <a:defRPr sz="1500" b="1">
                 <a:solidFill>
                   <a:srgbClr val="F5F8FF"/>
@@ -12312,6 +12555,7 @@
           </a:lstStyle>
           <a:p xmlns:a="http://schemas.openxmlformats.org/drawingml/2006/main">
             <a:pPr algn="l">
+              <a:buNone/>
               <a:defRPr sz="1050" b="0">
                 <a:solidFill>
                   <a:srgbClr val="9FB1CA"/>
@@ -12335,6 +12579,7 @@
           </a:p>
           <a:p xmlns:a="http://schemas.openxmlformats.org/drawingml/2006/main">
             <a:pPr algn="l">
+              <a:buNone/>
               <a:defRPr sz="1050" b="0">
                 <a:solidFill>
                   <a:srgbClr val="9FB1CA"/>
@@ -12403,6 +12648,7 @@
           </a:lstStyle>
           <a:p xmlns:a="http://schemas.openxmlformats.org/drawingml/2006/main">
             <a:pPr algn="l">
+              <a:buNone/>
               <a:defRPr sz="900" b="0">
                 <a:solidFill>
                   <a:srgbClr val="9FB1CA"/>
@@ -12421,7 +12667,18 @@
                 <a:ea typeface="Arial"/>
                 <a:cs typeface="Arial"/>
               </a:rPr>
-              <a:t>AURA • Track A • 11/10/2026</a:t>
+              <a:t>AURA • Track A • </a:t>
+            </a:r>
+            <a:r>
+              <a:rPr sz="900" b="0">
+                <a:solidFill>
+                  <a:srgbClr val="9FB1CA"/>
+                </a:solidFill>
+                <a:latin typeface="Arial"/>
+                <a:ea typeface="Arial"/>
+                <a:cs typeface="Arial"/>
+              </a:rPr>
+              <a:t>12/10/2026</a:t>
             </a:r>
           </a:p>
         </p:txBody>
@@ -12471,6 +12728,7 @@
           </a:lstStyle>
           <a:p xmlns:a="http://schemas.openxmlformats.org/drawingml/2006/main">
             <a:pPr algn="r">
+              <a:buNone/>
               <a:defRPr sz="975" b="1">
                 <a:solidFill>
                   <a:srgbClr val="9FB1CA"/>
@@ -12568,6 +12826,7 @@
           </a:lstStyle>
           <a:p xmlns:a="http://schemas.openxmlformats.org/drawingml/2006/main">
             <a:pPr algn="l">
+              <a:buNone/>
               <a:defRPr sz="1350" b="1">
                 <a:solidFill>
                   <a:srgbClr val="22D3EE"/>
@@ -12636,6 +12895,7 @@
           </a:lstStyle>
           <a:p xmlns:a="http://schemas.openxmlformats.org/drawingml/2006/main">
             <a:pPr algn="l">
+              <a:buNone/>
               <a:defRPr sz="2550" b="1">
                 <a:solidFill>
                   <a:srgbClr val="F5F8FF"/>
@@ -12704,6 +12964,7 @@
           </a:lstStyle>
           <a:p xmlns:a="http://schemas.openxmlformats.org/drawingml/2006/main">
             <a:pPr algn="l">
+              <a:buNone/>
               <a:defRPr sz="1275" b="0">
                 <a:solidFill>
                   <a:srgbClr val="9FB1CA"/>
@@ -12845,6 +13106,7 @@
           </a:lstStyle>
           <a:p xmlns:a="http://schemas.openxmlformats.org/drawingml/2006/main">
             <a:pPr algn="ctr">
+              <a:buNone/>
               <a:defRPr sz="1050" b="1">
                 <a:solidFill>
                   <a:srgbClr val="081426"/>
@@ -12913,6 +13175,7 @@
           </a:lstStyle>
           <a:p xmlns:a="http://schemas.openxmlformats.org/drawingml/2006/main">
             <a:pPr algn="l">
+              <a:buNone/>
               <a:defRPr sz="1275" b="1">
                 <a:solidFill>
                   <a:srgbClr val="F5F8FF"/>
@@ -13023,6 +13286,7 @@
           </a:lstStyle>
           <a:p xmlns:a="http://schemas.openxmlformats.org/drawingml/2006/main">
             <a:pPr algn="ctr">
+              <a:buNone/>
               <a:defRPr sz="1050" b="1">
                 <a:solidFill>
                   <a:srgbClr val="081426"/>
@@ -13091,6 +13355,7 @@
           </a:lstStyle>
           <a:p xmlns:a="http://schemas.openxmlformats.org/drawingml/2006/main">
             <a:pPr algn="l">
+              <a:buNone/>
               <a:defRPr sz="1275" b="1">
                 <a:solidFill>
                   <a:srgbClr val="F5F8FF"/>
@@ -13201,6 +13466,7 @@
           </a:lstStyle>
           <a:p xmlns:a="http://schemas.openxmlformats.org/drawingml/2006/main">
             <a:pPr algn="ctr">
+              <a:buNone/>
               <a:defRPr sz="1050" b="1">
                 <a:solidFill>
                   <a:srgbClr val="081426"/>
@@ -13269,6 +13535,7 @@
           </a:lstStyle>
           <a:p xmlns:a="http://schemas.openxmlformats.org/drawingml/2006/main">
             <a:pPr algn="l">
+              <a:buNone/>
               <a:defRPr sz="1275" b="1">
                 <a:solidFill>
                   <a:srgbClr val="F5F8FF"/>
@@ -13379,6 +13646,7 @@
           </a:lstStyle>
           <a:p xmlns:a="http://schemas.openxmlformats.org/drawingml/2006/main">
             <a:pPr algn="ctr">
+              <a:buNone/>
               <a:defRPr sz="1050" b="1">
                 <a:solidFill>
                   <a:srgbClr val="081426"/>
@@ -13447,6 +13715,7 @@
           </a:lstStyle>
           <a:p xmlns:a="http://schemas.openxmlformats.org/drawingml/2006/main">
             <a:pPr algn="l">
+              <a:buNone/>
               <a:defRPr sz="1275" b="1">
                 <a:solidFill>
                   <a:srgbClr val="F5F8FF"/>
@@ -13557,6 +13826,7 @@
           </a:lstStyle>
           <a:p xmlns:a="http://schemas.openxmlformats.org/drawingml/2006/main">
             <a:pPr algn="ctr">
+              <a:buNone/>
               <a:defRPr sz="1050" b="1">
                 <a:solidFill>
                   <a:srgbClr val="081426"/>
@@ -13625,6 +13895,7 @@
           </a:lstStyle>
           <a:p xmlns:a="http://schemas.openxmlformats.org/drawingml/2006/main">
             <a:pPr algn="l">
+              <a:buNone/>
               <a:defRPr sz="1275" b="1">
                 <a:solidFill>
                   <a:srgbClr val="F5F8FF"/>
@@ -13728,6 +13999,7 @@
           </a:lstStyle>
           <a:p xmlns:a="http://schemas.openxmlformats.org/drawingml/2006/main">
             <a:pPr algn="l">
+              <a:buNone/>
               <a:defRPr sz="1125" b="1">
                 <a:solidFill>
                   <a:srgbClr val="2DD4A7"/>
@@ -13803,6 +14075,7 @@
           </a:lstStyle>
           <a:p xmlns:a="http://schemas.openxmlformats.org/drawingml/2006/main">
             <a:pPr algn="ctr">
+              <a:buNone/>
               <a:defRPr sz="1050" b="1">
                 <a:solidFill>
                   <a:srgbClr val="081426"/>
@@ -13871,6 +14144,7 @@
           </a:lstStyle>
           <a:p xmlns:a="http://schemas.openxmlformats.org/drawingml/2006/main">
             <a:pPr algn="l">
+              <a:buNone/>
               <a:defRPr sz="1200" b="1">
                 <a:solidFill>
                   <a:srgbClr val="F5F8FF"/>
@@ -13946,6 +14220,7 @@
           </a:lstStyle>
           <a:p xmlns:a="http://schemas.openxmlformats.org/drawingml/2006/main">
             <a:pPr algn="ctr">
+              <a:buNone/>
               <a:defRPr sz="1050" b="1">
                 <a:solidFill>
                   <a:srgbClr val="081426"/>
@@ -14014,6 +14289,7 @@
           </a:lstStyle>
           <a:p xmlns:a="http://schemas.openxmlformats.org/drawingml/2006/main">
             <a:pPr algn="l">
+              <a:buNone/>
               <a:defRPr sz="1200" b="1">
                 <a:solidFill>
                   <a:srgbClr val="F5F8FF"/>
@@ -14032,7 +14308,18 @@
                 <a:ea typeface="Arial"/>
                 <a:cs typeface="Arial"/>
               </a:rPr>
-              <a:t>142 test • EF model sạch</a:t>
+              <a:t>149 test</a:t>
+            </a:r>
+            <a:r>
+              <a:rPr sz="1200" b="1">
+                <a:solidFill>
+                  <a:srgbClr val="F5F8FF"/>
+                </a:solidFill>
+                <a:latin typeface="Arial"/>
+                <a:ea typeface="Arial"/>
+                <a:cs typeface="Arial"/>
+              </a:rPr>
+              <a:t> • EF model sạch</a:t>
             </a:r>
           </a:p>
         </p:txBody>
@@ -14089,6 +14376,7 @@
           </a:lstStyle>
           <a:p xmlns:a="http://schemas.openxmlformats.org/drawingml/2006/main">
             <a:pPr algn="ctr">
+              <a:buNone/>
               <a:defRPr sz="1050" b="1">
                 <a:solidFill>
                   <a:srgbClr val="081426"/>
@@ -14157,6 +14445,7 @@
           </a:lstStyle>
           <a:p xmlns:a="http://schemas.openxmlformats.org/drawingml/2006/main">
             <a:pPr algn="l">
+              <a:buNone/>
               <a:defRPr sz="1200" b="1">
                 <a:solidFill>
                   <a:srgbClr val="F5F8FF"/>
@@ -14232,6 +14521,7 @@
           </a:lstStyle>
           <a:p xmlns:a="http://schemas.openxmlformats.org/drawingml/2006/main">
             <a:pPr algn="ctr">
+              <a:buNone/>
               <a:defRPr sz="1050" b="1">
                 <a:solidFill>
                   <a:srgbClr val="081426"/>
@@ -14300,6 +14590,7 @@
           </a:lstStyle>
           <a:p xmlns:a="http://schemas.openxmlformats.org/drawingml/2006/main">
             <a:pPr algn="l">
+              <a:buNone/>
               <a:defRPr sz="1200" b="1">
                 <a:solidFill>
                   <a:srgbClr val="F5F8FF"/>
@@ -14403,6 +14694,7 @@
           </a:lstStyle>
           <a:p xmlns:a="http://schemas.openxmlformats.org/drawingml/2006/main">
             <a:pPr algn="l">
+              <a:buNone/>
               <a:defRPr sz="1125" b="1">
                 <a:solidFill>
                   <a:srgbClr val="FF6B7A"/>
@@ -14471,6 +14763,7 @@
           </a:lstStyle>
           <a:p xmlns:a="http://schemas.openxmlformats.org/drawingml/2006/main">
             <a:pPr algn="l">
+              <a:buNone/>
               <a:defRPr sz="1200" b="1">
                 <a:solidFill>
                   <a:srgbClr val="F5F8FF"/>
@@ -14494,6 +14787,7 @@
           </a:p>
           <a:p xmlns:a="http://schemas.openxmlformats.org/drawingml/2006/main">
             <a:pPr algn="l">
+              <a:buNone/>
               <a:defRPr sz="1200" b="1">
                 <a:solidFill>
                   <a:srgbClr val="F5F8FF"/>
@@ -14517,6 +14811,7 @@
           </a:p>
           <a:p xmlns:a="http://schemas.openxmlformats.org/drawingml/2006/main">
             <a:pPr algn="l">
+              <a:buNone/>
               <a:defRPr sz="1200" b="1">
                 <a:solidFill>
                   <a:srgbClr val="F5F8FF"/>
@@ -14585,6 +14880,7 @@
           </a:lstStyle>
           <a:p xmlns:a="http://schemas.openxmlformats.org/drawingml/2006/main">
             <a:pPr algn="ctr">
+              <a:buNone/>
               <a:defRPr sz="1050" b="1">
                 <a:solidFill>
                   <a:srgbClr val="F8C14C"/>
@@ -14653,6 +14949,7 @@
           </a:lstStyle>
           <a:p xmlns:a="http://schemas.openxmlformats.org/drawingml/2006/main">
             <a:pPr algn="l">
+              <a:buNone/>
               <a:defRPr sz="900" b="0">
                 <a:solidFill>
                   <a:srgbClr val="9FB1CA"/>
@@ -14721,6 +15018,7 @@
           </a:lstStyle>
           <a:p xmlns:a="http://schemas.openxmlformats.org/drawingml/2006/main">
             <a:pPr algn="r">
+              <a:buNone/>
               <a:defRPr sz="975" b="1">
                 <a:solidFill>
                   <a:srgbClr val="9FB1CA"/>

</xml_diff>

<commit_message>
docs: record live capacity gate
</commit_message>
<xml_diff>
--- a/AURA/submission/AURA_5_SLIDES.pptx
+++ b/AURA/submission/AURA_5_SLIDES.pptx
@@ -2,17 +2,17 @@
 <file path=ppt/presentation.xml><?xml version="1.0" encoding="utf-8"?>
 <p:presentation xmlns:p="http://schemas.openxmlformats.org/presentationml/2006/main">
   <p:sldMasterIdLst>
-    <p:sldMasterId xmlns:r="http://schemas.openxmlformats.org/officeDocument/2006/relationships" id="2147483648" r:id="R3b87258b15484fad"/>
+    <p:sldMasterId xmlns:r="http://schemas.openxmlformats.org/officeDocument/2006/relationships" id="2147483648" r:id="R541a2b4ab5c04a0a"/>
   </p:sldMasterIdLst>
   <p:notesMasterIdLst>
-    <p:notesMasterId xmlns:r="http://schemas.openxmlformats.org/officeDocument/2006/relationships" r:id="Rb1b0cf6340584a85"/>
+    <p:notesMasterId xmlns:r="http://schemas.openxmlformats.org/officeDocument/2006/relationships" r:id="R9360e4fee1484fd4"/>
   </p:notesMasterIdLst>
   <p:sldIdLst>
-    <p:sldId xmlns:r="http://schemas.openxmlformats.org/officeDocument/2006/relationships" id="256" r:id="Rb6523978cecf486a"/>
-    <p:sldId xmlns:r="http://schemas.openxmlformats.org/officeDocument/2006/relationships" id="257" r:id="R7a8b0fd498fd409a"/>
-    <p:sldId xmlns:r="http://schemas.openxmlformats.org/officeDocument/2006/relationships" id="258" r:id="R6d9c3a125b74463a"/>
-    <p:sldId xmlns:r="http://schemas.openxmlformats.org/officeDocument/2006/relationships" id="259" r:id="Rf66c80d287f04017"/>
-    <p:sldId xmlns:r="http://schemas.openxmlformats.org/officeDocument/2006/relationships" id="260" r:id="R4a0614f7bd9a4c09"/>
+    <p:sldId xmlns:r="http://schemas.openxmlformats.org/officeDocument/2006/relationships" id="256" r:id="R1136e4596e6d46eb"/>
+    <p:sldId xmlns:r="http://schemas.openxmlformats.org/officeDocument/2006/relationships" id="257" r:id="R0fce81601a4d4722"/>
+    <p:sldId xmlns:r="http://schemas.openxmlformats.org/officeDocument/2006/relationships" id="258" r:id="R809f3eddcc4747cd"/>
+    <p:sldId xmlns:r="http://schemas.openxmlformats.org/officeDocument/2006/relationships" id="259" r:id="Rf6f4999b44034bee"/>
+    <p:sldId xmlns:r="http://schemas.openxmlformats.org/officeDocument/2006/relationships" id="260" r:id="R1c3c767f17804b8e"/>
   </p:sldIdLst>
   <p:sldSz cx="12192000" cy="6858000"/>
   <p:notesSz cx="6858000" cy="9144000"/>
@@ -586,7 +586,7 @@
           <a:lstStyle xmlns:a="http://schemas.openxmlformats.org/drawingml/2006/main"/>
           <a:p xmlns:a="http://schemas.openxmlformats.org/drawingml/2006/main">
             <a:r>
-              <a:t>Nguồn cập nhật 11/10/2026: 142/142 test offline và EF model sạch. Live health/public endpoint, Verify 5/5, workflow/Audit/Undo, desktop/mobile 390x844 và điện thoại thật 4G/5G đều pass. Official holdout giữ raw 10/15 và adjusted 11/15; post-holdout regression trên cùng 15 receipt đạt 11/15, 0 missed escalation, 4 over-escalation, 0 system error. Đây là mẫu nhỏ và không phải accuracy production; ba user session và rehearsal vẫn là gate.</a:t>
+              <a:t>Nguồn cập nhật 12/10/2026: 149/149 test offline và EF model sạch. Live health/security/upload-negative/UI pass; gate AI hậu publish gặp OpenRouter HTTP 429 nên không tạo accuracy mới. Official holdout giữ raw 10/15 và adjusted 11/15; post-holdout regression 07/10 giữ 11/15, 0 missed escalation, 4 over-escalation, 0 system error. Demo dùng một operator và có video/evidence dự phòng; ba user session vẫn là gate.</a:t>
             </a:r>
           </a:p>
         </p:txBody>
@@ -726,7 +726,7 @@
           <a:lstStyle xmlns:a="http://schemas.openxmlformats.org/drawingml/2006/main"/>
           <a:p xmlns:a="http://schemas.openxmlformats.org/drawingml/2006/main">
             <a:r>
-              <a:t>Nguồn kỹ thuật trong repo: ReceiptProcessingWorker.cs, ReceiptExtractionContract.cs, PolicyDecisionEngine.cs, VietnamTime.cs, tools/Invoke-ExtendedDatasetEvaluation.ps1, docs/CURRENT_PROJECT_STATUS_2026-10-07.md và docs/REAL_RECEIPT_REGRESSION_RESULT_2026-10-07.md. Fallback vẫn opt-in và mặc định tắt; OpenRouter 8B là baseline demo.</a:t>
+              <a:t>Nguồn kỹ thuật trong repo: ReceiptProcessingWorker.cs, ReceiptExtractionContract.cs, PolicyDecisionEngine.cs, VietnamTime.cs, tools/Invoke-ExtendedDatasetEvaluation.ps1 và docs/LIVE_POSTPOLICY_VALIDATION_2026-10-12.md. Fallback vẫn opt-in và mặc định tắt. OpenRouter 8B là baseline demo có giám sát; live capacity gate 12/10 gặp HTTP 429 nên chỉ một operator chạy AI trong demo.</a:t>
             </a:r>
           </a:p>
         </p:txBody>
@@ -773,7 +773,7 @@
           <p:cNvPr id="3" name="Title">
             <a:extLst xmlns:a="http://schemas.openxmlformats.org/drawingml/2006/main">
               <a:ext uri="{FF2B5EF4-FFF2-40B4-BE49-F238E27FC236}">
-                <a16:creationId xmlns:a16="http://schemas.microsoft.com/office/drawing/2014/main" id="{1C7D8926-5FAC-47A8-9D01-BB9F8B3DFDEB}"/>
+                <a16:creationId xmlns:a16="http://schemas.microsoft.com/office/drawing/2014/main" id="{34B5EE76-7E65-41AF-A4E9-B79394D7CECB}"/>
               </a:ext>
             </a:extLst>
           </p:cNvPr>
@@ -824,7 +824,6 @@
                 <a:spcPts val="0"/>
               </a:spcAft>
               <a:buNone/>
-              <a:defRPr/>
             </a:lvl1pPr>
             <a:lvl2pPr marL="0" indent="0">
               <a:lnSpc>
@@ -837,7 +836,6 @@
                 <a:spcPts val="0"/>
               </a:spcAft>
               <a:buNone/>
-              <a:defRPr/>
             </a:lvl2pPr>
             <a:lvl3pPr marL="0" indent="0">
               <a:lnSpc>
@@ -850,7 +848,6 @@
                 <a:spcPts val="0"/>
               </a:spcAft>
               <a:buNone/>
-              <a:defRPr/>
             </a:lvl3pPr>
             <a:lvl4pPr marL="0" indent="0">
               <a:lnSpc>
@@ -863,7 +860,6 @@
                 <a:spcPts val="0"/>
               </a:spcAft>
               <a:buNone/>
-              <a:defRPr/>
             </a:lvl4pPr>
             <a:lvl5pPr marL="0" indent="0">
               <a:lnSpc>
@@ -876,7 +872,6 @@
                 <a:spcPts val="0"/>
               </a:spcAft>
               <a:buNone/>
-              <a:defRPr/>
             </a:lvl5pPr>
             <a:lvl6pPr marL="0" indent="0">
               <a:lnSpc>
@@ -889,7 +884,6 @@
                 <a:spcPts val="0"/>
               </a:spcAft>
               <a:buNone/>
-              <a:defRPr/>
             </a:lvl6pPr>
             <a:lvl7pPr marL="0" indent="0">
               <a:lnSpc>
@@ -902,7 +896,6 @@
                 <a:spcPts val="0"/>
               </a:spcAft>
               <a:buNone/>
-              <a:defRPr/>
             </a:lvl7pPr>
             <a:lvl8pPr marL="0" indent="0">
               <a:lnSpc>
@@ -915,7 +908,6 @@
                 <a:spcPts val="0"/>
               </a:spcAft>
               <a:buNone/>
-              <a:defRPr/>
             </a:lvl8pPr>
             <a:lvl9pPr marL="0" indent="0">
               <a:lnSpc>
@@ -928,7 +920,6 @@
                 <a:spcPts val="0"/>
               </a:spcAft>
               <a:buNone/>
-              <a:defRPr/>
             </a:lvl9pPr>
           </a:lstStyle>
           <a:p xmlns:a="http://schemas.openxmlformats.org/drawingml/2006/main"/>
@@ -939,7 +930,7 @@
           <p:cNvPr id="2" name="Subtitle">
             <a:extLst xmlns:a="http://schemas.openxmlformats.org/drawingml/2006/main">
               <a:ext uri="{FF2B5EF4-FFF2-40B4-BE49-F238E27FC236}">
-                <a16:creationId xmlns:a16="http://schemas.microsoft.com/office/drawing/2014/main" id="{B121C3F3-CC5E-4244-82A2-28DDAE10E84A}"/>
+                <a16:creationId xmlns:a16="http://schemas.microsoft.com/office/drawing/2014/main" id="{8C73A6C6-AB3F-4F9A-96E0-4E4F92A71F26}"/>
               </a:ext>
             </a:extLst>
           </p:cNvPr>
@@ -990,7 +981,6 @@
                 <a:spcPts val="0"/>
               </a:spcAft>
               <a:buNone/>
-              <a:defRPr/>
             </a:lvl1pPr>
             <a:lvl2pPr marL="0" indent="0">
               <a:lnSpc>
@@ -1003,7 +993,6 @@
                 <a:spcPts val="0"/>
               </a:spcAft>
               <a:buNone/>
-              <a:defRPr/>
             </a:lvl2pPr>
             <a:lvl3pPr marL="0" indent="0">
               <a:lnSpc>
@@ -1016,7 +1005,6 @@
                 <a:spcPts val="0"/>
               </a:spcAft>
               <a:buNone/>
-              <a:defRPr/>
             </a:lvl3pPr>
             <a:lvl4pPr marL="0" indent="0">
               <a:lnSpc>
@@ -1029,7 +1017,6 @@
                 <a:spcPts val="0"/>
               </a:spcAft>
               <a:buNone/>
-              <a:defRPr/>
             </a:lvl4pPr>
             <a:lvl5pPr marL="0" indent="0">
               <a:lnSpc>
@@ -1042,7 +1029,6 @@
                 <a:spcPts val="0"/>
               </a:spcAft>
               <a:buNone/>
-              <a:defRPr/>
             </a:lvl5pPr>
             <a:lvl6pPr marL="0" indent="0">
               <a:lnSpc>
@@ -1055,7 +1041,6 @@
                 <a:spcPts val="0"/>
               </a:spcAft>
               <a:buNone/>
-              <a:defRPr/>
             </a:lvl6pPr>
             <a:lvl7pPr marL="0" indent="0">
               <a:lnSpc>
@@ -1068,7 +1053,6 @@
                 <a:spcPts val="0"/>
               </a:spcAft>
               <a:buNone/>
-              <a:defRPr/>
             </a:lvl7pPr>
             <a:lvl8pPr marL="0" indent="0">
               <a:lnSpc>
@@ -1081,7 +1065,6 @@
                 <a:spcPts val="0"/>
               </a:spcAft>
               <a:buNone/>
-              <a:defRPr/>
             </a:lvl8pPr>
             <a:lvl9pPr marL="0" indent="0">
               <a:lnSpc>
@@ -1094,7 +1077,6 @@
                 <a:spcPts val="0"/>
               </a:spcAft>
               <a:buNone/>
-              <a:defRPr/>
             </a:lvl9pPr>
           </a:lstStyle>
           <a:p xmlns:a="http://schemas.openxmlformats.org/drawingml/2006/main"/>
@@ -1122,7 +1104,7 @@
           <p:cNvPr id="2" name="Section title">
             <a:extLst xmlns:a="http://schemas.openxmlformats.org/drawingml/2006/main">
               <a:ext uri="{FF2B5EF4-FFF2-40B4-BE49-F238E27FC236}">
-                <a16:creationId xmlns:a16="http://schemas.microsoft.com/office/drawing/2014/main" id="{85B5808C-FC17-4683-B8B8-16273C95E63F}"/>
+                <a16:creationId xmlns:a16="http://schemas.microsoft.com/office/drawing/2014/main" id="{81EC487F-CC03-420C-9A63-D31F273E5EB8}"/>
               </a:ext>
             </a:extLst>
           </p:cNvPr>
@@ -1173,7 +1155,6 @@
                 <a:spcPts val="0"/>
               </a:spcAft>
               <a:buNone/>
-              <a:defRPr/>
             </a:lvl1pPr>
             <a:lvl2pPr marL="0" indent="0">
               <a:lnSpc>
@@ -1186,7 +1167,6 @@
                 <a:spcPts val="0"/>
               </a:spcAft>
               <a:buNone/>
-              <a:defRPr/>
             </a:lvl2pPr>
             <a:lvl3pPr marL="0" indent="0">
               <a:lnSpc>
@@ -1199,7 +1179,6 @@
                 <a:spcPts val="0"/>
               </a:spcAft>
               <a:buNone/>
-              <a:defRPr/>
             </a:lvl3pPr>
             <a:lvl4pPr marL="0" indent="0">
               <a:lnSpc>
@@ -1212,7 +1191,6 @@
                 <a:spcPts val="0"/>
               </a:spcAft>
               <a:buNone/>
-              <a:defRPr/>
             </a:lvl4pPr>
             <a:lvl5pPr marL="0" indent="0">
               <a:lnSpc>
@@ -1225,7 +1203,6 @@
                 <a:spcPts val="0"/>
               </a:spcAft>
               <a:buNone/>
-              <a:defRPr/>
             </a:lvl5pPr>
             <a:lvl6pPr marL="0" indent="0">
               <a:lnSpc>
@@ -1238,7 +1215,6 @@
                 <a:spcPts val="0"/>
               </a:spcAft>
               <a:buNone/>
-              <a:defRPr/>
             </a:lvl6pPr>
             <a:lvl7pPr marL="0" indent="0">
               <a:lnSpc>
@@ -1251,7 +1227,6 @@
                 <a:spcPts val="0"/>
               </a:spcAft>
               <a:buNone/>
-              <a:defRPr/>
             </a:lvl7pPr>
             <a:lvl8pPr marL="0" indent="0">
               <a:lnSpc>
@@ -1264,7 +1239,6 @@
                 <a:spcPts val="0"/>
               </a:spcAft>
               <a:buNone/>
-              <a:defRPr/>
             </a:lvl8pPr>
             <a:lvl9pPr marL="0" indent="0">
               <a:lnSpc>
@@ -1277,7 +1251,6 @@
                 <a:spcPts val="0"/>
               </a:spcAft>
               <a:buNone/>
-              <a:defRPr/>
             </a:lvl9pPr>
           </a:lstStyle>
           <a:p xmlns:a="http://schemas.openxmlformats.org/drawingml/2006/main"/>
@@ -1305,7 +1278,7 @@
           <p:cNvPr id="3" name="Title">
             <a:extLst xmlns:a="http://schemas.openxmlformats.org/drawingml/2006/main">
               <a:ext uri="{FF2B5EF4-FFF2-40B4-BE49-F238E27FC236}">
-                <a16:creationId xmlns:a16="http://schemas.microsoft.com/office/drawing/2014/main" id="{1F10C778-38E2-4D51-916E-AE9ECFCCA4C9}"/>
+                <a16:creationId xmlns:a16="http://schemas.microsoft.com/office/drawing/2014/main" id="{92BC0BA6-7D1A-4F90-A345-98CEBE02F84E}"/>
               </a:ext>
             </a:extLst>
           </p:cNvPr>
@@ -1356,7 +1329,6 @@
                 <a:spcPts val="0"/>
               </a:spcAft>
               <a:buNone/>
-              <a:defRPr/>
             </a:lvl1pPr>
             <a:lvl2pPr marL="0" indent="0">
               <a:lnSpc>
@@ -1369,7 +1341,6 @@
                 <a:spcPts val="0"/>
               </a:spcAft>
               <a:buNone/>
-              <a:defRPr/>
             </a:lvl2pPr>
             <a:lvl3pPr marL="0" indent="0">
               <a:lnSpc>
@@ -1382,7 +1353,6 @@
                 <a:spcPts val="0"/>
               </a:spcAft>
               <a:buNone/>
-              <a:defRPr/>
             </a:lvl3pPr>
             <a:lvl4pPr marL="0" indent="0">
               <a:lnSpc>
@@ -1395,7 +1365,6 @@
                 <a:spcPts val="0"/>
               </a:spcAft>
               <a:buNone/>
-              <a:defRPr/>
             </a:lvl4pPr>
             <a:lvl5pPr marL="0" indent="0">
               <a:lnSpc>
@@ -1408,7 +1377,6 @@
                 <a:spcPts val="0"/>
               </a:spcAft>
               <a:buNone/>
-              <a:defRPr/>
             </a:lvl5pPr>
             <a:lvl6pPr marL="0" indent="0">
               <a:lnSpc>
@@ -1421,7 +1389,6 @@
                 <a:spcPts val="0"/>
               </a:spcAft>
               <a:buNone/>
-              <a:defRPr/>
             </a:lvl6pPr>
             <a:lvl7pPr marL="0" indent="0">
               <a:lnSpc>
@@ -1434,7 +1401,6 @@
                 <a:spcPts val="0"/>
               </a:spcAft>
               <a:buNone/>
-              <a:defRPr/>
             </a:lvl7pPr>
             <a:lvl8pPr marL="0" indent="0">
               <a:lnSpc>
@@ -1447,7 +1413,6 @@
                 <a:spcPts val="0"/>
               </a:spcAft>
               <a:buNone/>
-              <a:defRPr/>
             </a:lvl8pPr>
             <a:lvl9pPr marL="0" indent="0">
               <a:lnSpc>
@@ -1460,7 +1425,6 @@
                 <a:spcPts val="0"/>
               </a:spcAft>
               <a:buNone/>
-              <a:defRPr/>
             </a:lvl9pPr>
           </a:lstStyle>
           <a:p xmlns:a="http://schemas.openxmlformats.org/drawingml/2006/main"/>
@@ -1471,7 +1435,7 @@
           <p:cNvPr id="2" name="Body">
             <a:extLst xmlns:a="http://schemas.openxmlformats.org/drawingml/2006/main">
               <a:ext uri="{FF2B5EF4-FFF2-40B4-BE49-F238E27FC236}">
-                <a16:creationId xmlns:a16="http://schemas.microsoft.com/office/drawing/2014/main" id="{CCD2DD1E-9898-4E78-BF69-7281761E2317}"/>
+                <a16:creationId xmlns:a16="http://schemas.microsoft.com/office/drawing/2014/main" id="{9B70874E-CA38-476E-8C0F-AC806C10D867}"/>
               </a:ext>
             </a:extLst>
           </p:cNvPr>
@@ -1522,7 +1486,6 @@
                 <a:spcPts val="1200"/>
               </a:spcAft>
               <a:buChar char="•"/>
-              <a:defRPr/>
             </a:lvl1pPr>
             <a:lvl2pPr marL="533400" indent="-228600">
               <a:lnSpc>
@@ -1535,7 +1498,6 @@
                 <a:spcPts val="1200"/>
               </a:spcAft>
               <a:buChar char="•"/>
-              <a:defRPr/>
             </a:lvl2pPr>
             <a:lvl3pPr marL="838200" indent="-228600">
               <a:lnSpc>
@@ -1548,7 +1510,6 @@
                 <a:spcPts val="1200"/>
               </a:spcAft>
               <a:buChar char="•"/>
-              <a:defRPr/>
             </a:lvl3pPr>
             <a:lvl4pPr marL="1143000" indent="-228600">
               <a:lnSpc>
@@ -1561,7 +1522,6 @@
                 <a:spcPts val="1200"/>
               </a:spcAft>
               <a:buChar char="•"/>
-              <a:defRPr/>
             </a:lvl4pPr>
             <a:lvl5pPr marL="1447800" indent="-228600">
               <a:lnSpc>
@@ -1574,7 +1534,6 @@
                 <a:spcPts val="1200"/>
               </a:spcAft>
               <a:buChar char="•"/>
-              <a:defRPr/>
             </a:lvl5pPr>
             <a:lvl6pPr marL="1752600" indent="-228600">
               <a:lnSpc>
@@ -1587,7 +1546,6 @@
                 <a:spcPts val="1200"/>
               </a:spcAft>
               <a:buChar char="•"/>
-              <a:defRPr/>
             </a:lvl6pPr>
             <a:lvl7pPr marL="2057400" indent="-228600">
               <a:lnSpc>
@@ -1600,7 +1558,6 @@
                 <a:spcPts val="1200"/>
               </a:spcAft>
               <a:buChar char="•"/>
-              <a:defRPr/>
             </a:lvl7pPr>
             <a:lvl8pPr marL="2362200" indent="-228600">
               <a:lnSpc>
@@ -1613,7 +1570,6 @@
                 <a:spcPts val="1200"/>
               </a:spcAft>
               <a:buChar char="•"/>
-              <a:defRPr/>
             </a:lvl8pPr>
             <a:lvl9pPr marL="2667000" indent="-228600">
               <a:lnSpc>
@@ -1626,7 +1582,6 @@
                 <a:spcPts val="1200"/>
               </a:spcAft>
               <a:buChar char="•"/>
-              <a:defRPr/>
             </a:lvl9pPr>
           </a:lstStyle>
           <a:p xmlns:a="http://schemas.openxmlformats.org/drawingml/2006/main"/>
@@ -1654,7 +1609,7 @@
           <p:cNvPr id="4" name="Title">
             <a:extLst xmlns:a="http://schemas.openxmlformats.org/drawingml/2006/main">
               <a:ext uri="{FF2B5EF4-FFF2-40B4-BE49-F238E27FC236}">
-                <a16:creationId xmlns:a16="http://schemas.microsoft.com/office/drawing/2014/main" id="{14C34F14-3BF7-4971-A5DC-77D2698DEEFF}"/>
+                <a16:creationId xmlns:a16="http://schemas.microsoft.com/office/drawing/2014/main" id="{70F914F0-E018-4002-929D-C77940668C8A}"/>
               </a:ext>
             </a:extLst>
           </p:cNvPr>
@@ -1705,7 +1660,6 @@
                 <a:spcPts val="0"/>
               </a:spcAft>
               <a:buNone/>
-              <a:defRPr/>
             </a:lvl1pPr>
             <a:lvl2pPr marL="0" indent="0">
               <a:lnSpc>
@@ -1718,7 +1672,6 @@
                 <a:spcPts val="0"/>
               </a:spcAft>
               <a:buNone/>
-              <a:defRPr/>
             </a:lvl2pPr>
             <a:lvl3pPr marL="0" indent="0">
               <a:lnSpc>
@@ -1731,7 +1684,6 @@
                 <a:spcPts val="0"/>
               </a:spcAft>
               <a:buNone/>
-              <a:defRPr/>
             </a:lvl3pPr>
             <a:lvl4pPr marL="0" indent="0">
               <a:lnSpc>
@@ -1744,7 +1696,6 @@
                 <a:spcPts val="0"/>
               </a:spcAft>
               <a:buNone/>
-              <a:defRPr/>
             </a:lvl4pPr>
             <a:lvl5pPr marL="0" indent="0">
               <a:lnSpc>
@@ -1757,7 +1708,6 @@
                 <a:spcPts val="0"/>
               </a:spcAft>
               <a:buNone/>
-              <a:defRPr/>
             </a:lvl5pPr>
             <a:lvl6pPr marL="0" indent="0">
               <a:lnSpc>
@@ -1770,7 +1720,6 @@
                 <a:spcPts val="0"/>
               </a:spcAft>
               <a:buNone/>
-              <a:defRPr/>
             </a:lvl6pPr>
             <a:lvl7pPr marL="0" indent="0">
               <a:lnSpc>
@@ -1783,7 +1732,6 @@
                 <a:spcPts val="0"/>
               </a:spcAft>
               <a:buNone/>
-              <a:defRPr/>
             </a:lvl7pPr>
             <a:lvl8pPr marL="0" indent="0">
               <a:lnSpc>
@@ -1796,7 +1744,6 @@
                 <a:spcPts val="0"/>
               </a:spcAft>
               <a:buNone/>
-              <a:defRPr/>
             </a:lvl8pPr>
             <a:lvl9pPr marL="0" indent="0">
               <a:lnSpc>
@@ -1809,7 +1756,6 @@
                 <a:spcPts val="0"/>
               </a:spcAft>
               <a:buNone/>
-              <a:defRPr/>
             </a:lvl9pPr>
           </a:lstStyle>
           <a:p xmlns:a="http://schemas.openxmlformats.org/drawingml/2006/main"/>
@@ -1820,7 +1766,7 @@
           <p:cNvPr id="2" name="Left column">
             <a:extLst xmlns:a="http://schemas.openxmlformats.org/drawingml/2006/main">
               <a:ext uri="{FF2B5EF4-FFF2-40B4-BE49-F238E27FC236}">
-                <a16:creationId xmlns:a16="http://schemas.microsoft.com/office/drawing/2014/main" id="{F355EECE-B311-4B26-B76B-23A4153814ED}"/>
+                <a16:creationId xmlns:a16="http://schemas.microsoft.com/office/drawing/2014/main" id="{7B79EBA1-EB84-4ABC-92FD-03A246B4FC8C}"/>
               </a:ext>
             </a:extLst>
           </p:cNvPr>
@@ -1871,7 +1817,6 @@
                 <a:spcPts val="1200"/>
               </a:spcAft>
               <a:buChar char="•"/>
-              <a:defRPr/>
             </a:lvl1pPr>
             <a:lvl2pPr marL="533400" indent="-228600">
               <a:lnSpc>
@@ -1884,7 +1829,6 @@
                 <a:spcPts val="1200"/>
               </a:spcAft>
               <a:buChar char="•"/>
-              <a:defRPr/>
             </a:lvl2pPr>
             <a:lvl3pPr marL="838200" indent="-228600">
               <a:lnSpc>
@@ -1897,7 +1841,6 @@
                 <a:spcPts val="1200"/>
               </a:spcAft>
               <a:buChar char="•"/>
-              <a:defRPr/>
             </a:lvl3pPr>
             <a:lvl4pPr marL="1143000" indent="-228600">
               <a:lnSpc>
@@ -1910,7 +1853,6 @@
                 <a:spcPts val="1200"/>
               </a:spcAft>
               <a:buChar char="•"/>
-              <a:defRPr/>
             </a:lvl4pPr>
             <a:lvl5pPr marL="1447800" indent="-228600">
               <a:lnSpc>
@@ -1923,7 +1865,6 @@
                 <a:spcPts val="1200"/>
               </a:spcAft>
               <a:buChar char="•"/>
-              <a:defRPr/>
             </a:lvl5pPr>
             <a:lvl6pPr marL="1752600" indent="-228600">
               <a:lnSpc>
@@ -1936,7 +1877,6 @@
                 <a:spcPts val="1200"/>
               </a:spcAft>
               <a:buChar char="•"/>
-              <a:defRPr/>
             </a:lvl6pPr>
             <a:lvl7pPr marL="2057400" indent="-228600">
               <a:lnSpc>
@@ -1949,7 +1889,6 @@
                 <a:spcPts val="1200"/>
               </a:spcAft>
               <a:buChar char="•"/>
-              <a:defRPr/>
             </a:lvl7pPr>
             <a:lvl8pPr marL="2362200" indent="-228600">
               <a:lnSpc>
@@ -1962,7 +1901,6 @@
                 <a:spcPts val="1200"/>
               </a:spcAft>
               <a:buChar char="•"/>
-              <a:defRPr/>
             </a:lvl8pPr>
             <a:lvl9pPr marL="2667000" indent="-228600">
               <a:lnSpc>
@@ -1975,7 +1913,6 @@
                 <a:spcPts val="1200"/>
               </a:spcAft>
               <a:buChar char="•"/>
-              <a:defRPr/>
             </a:lvl9pPr>
           </a:lstStyle>
           <a:p xmlns:a="http://schemas.openxmlformats.org/drawingml/2006/main"/>
@@ -1986,7 +1923,7 @@
           <p:cNvPr id="3" name="Right column">
             <a:extLst xmlns:a="http://schemas.openxmlformats.org/drawingml/2006/main">
               <a:ext uri="{FF2B5EF4-FFF2-40B4-BE49-F238E27FC236}">
-                <a16:creationId xmlns:a16="http://schemas.microsoft.com/office/drawing/2014/main" id="{6096AAE8-A3E7-46D1-9D98-132E07D9EA78}"/>
+                <a16:creationId xmlns:a16="http://schemas.microsoft.com/office/drawing/2014/main" id="{B756CFB1-B61D-4560-8534-DE3F84EE8D94}"/>
               </a:ext>
             </a:extLst>
           </p:cNvPr>
@@ -2037,7 +1974,6 @@
                 <a:spcPts val="1200"/>
               </a:spcAft>
               <a:buChar char="•"/>
-              <a:defRPr/>
             </a:lvl1pPr>
             <a:lvl2pPr marL="533400" indent="-228600">
               <a:lnSpc>
@@ -2050,7 +1986,6 @@
                 <a:spcPts val="1200"/>
               </a:spcAft>
               <a:buChar char="•"/>
-              <a:defRPr/>
             </a:lvl2pPr>
             <a:lvl3pPr marL="838200" indent="-228600">
               <a:lnSpc>
@@ -2063,7 +1998,6 @@
                 <a:spcPts val="1200"/>
               </a:spcAft>
               <a:buChar char="•"/>
-              <a:defRPr/>
             </a:lvl3pPr>
             <a:lvl4pPr marL="1143000" indent="-228600">
               <a:lnSpc>
@@ -2076,7 +2010,6 @@
                 <a:spcPts val="1200"/>
               </a:spcAft>
               <a:buChar char="•"/>
-              <a:defRPr/>
             </a:lvl4pPr>
             <a:lvl5pPr marL="1447800" indent="-228600">
               <a:lnSpc>
@@ -2089,7 +2022,6 @@
                 <a:spcPts val="1200"/>
               </a:spcAft>
               <a:buChar char="•"/>
-              <a:defRPr/>
             </a:lvl5pPr>
             <a:lvl6pPr marL="1752600" indent="-228600">
               <a:lnSpc>
@@ -2102,7 +2034,6 @@
                 <a:spcPts val="1200"/>
               </a:spcAft>
               <a:buChar char="•"/>
-              <a:defRPr/>
             </a:lvl6pPr>
             <a:lvl7pPr marL="2057400" indent="-228600">
               <a:lnSpc>
@@ -2115,7 +2046,6 @@
                 <a:spcPts val="1200"/>
               </a:spcAft>
               <a:buChar char="•"/>
-              <a:defRPr/>
             </a:lvl7pPr>
             <a:lvl8pPr marL="2362200" indent="-228600">
               <a:lnSpc>
@@ -2128,7 +2058,6 @@
                 <a:spcPts val="1200"/>
               </a:spcAft>
               <a:buChar char="•"/>
-              <a:defRPr/>
             </a:lvl8pPr>
             <a:lvl9pPr marL="2667000" indent="-228600">
               <a:lnSpc>
@@ -2141,7 +2070,6 @@
                 <a:spcPts val="1200"/>
               </a:spcAft>
               <a:buChar char="•"/>
-              <a:defRPr/>
             </a:lvl9pPr>
           </a:lstStyle>
           <a:p xmlns:a="http://schemas.openxmlformats.org/drawingml/2006/main"/>
@@ -2169,7 +2097,7 @@
           <p:cNvPr id="3" name="Title">
             <a:extLst xmlns:a="http://schemas.openxmlformats.org/drawingml/2006/main">
               <a:ext uri="{FF2B5EF4-FFF2-40B4-BE49-F238E27FC236}">
-                <a16:creationId xmlns:a16="http://schemas.microsoft.com/office/drawing/2014/main" id="{67912FCD-7E00-4427-86EA-8A5193EC6D33}"/>
+                <a16:creationId xmlns:a16="http://schemas.microsoft.com/office/drawing/2014/main" id="{857E77E0-21E8-4397-BEE8-EF24AFC66A97}"/>
               </a:ext>
             </a:extLst>
           </p:cNvPr>
@@ -2220,7 +2148,6 @@
                 <a:spcPts val="0"/>
               </a:spcAft>
               <a:buNone/>
-              <a:defRPr/>
             </a:lvl1pPr>
             <a:lvl2pPr marL="0" indent="0">
               <a:lnSpc>
@@ -2233,7 +2160,6 @@
                 <a:spcPts val="0"/>
               </a:spcAft>
               <a:buNone/>
-              <a:defRPr/>
             </a:lvl2pPr>
             <a:lvl3pPr marL="0" indent="0">
               <a:lnSpc>
@@ -2246,7 +2172,6 @@
                 <a:spcPts val="0"/>
               </a:spcAft>
               <a:buNone/>
-              <a:defRPr/>
             </a:lvl3pPr>
             <a:lvl4pPr marL="0" indent="0">
               <a:lnSpc>
@@ -2259,7 +2184,6 @@
                 <a:spcPts val="0"/>
               </a:spcAft>
               <a:buNone/>
-              <a:defRPr/>
             </a:lvl4pPr>
             <a:lvl5pPr marL="0" indent="0">
               <a:lnSpc>
@@ -2272,7 +2196,6 @@
                 <a:spcPts val="0"/>
               </a:spcAft>
               <a:buNone/>
-              <a:defRPr/>
             </a:lvl5pPr>
             <a:lvl6pPr marL="0" indent="0">
               <a:lnSpc>
@@ -2285,7 +2208,6 @@
                 <a:spcPts val="0"/>
               </a:spcAft>
               <a:buNone/>
-              <a:defRPr/>
             </a:lvl6pPr>
             <a:lvl7pPr marL="0" indent="0">
               <a:lnSpc>
@@ -2298,7 +2220,6 @@
                 <a:spcPts val="0"/>
               </a:spcAft>
               <a:buNone/>
-              <a:defRPr/>
             </a:lvl7pPr>
             <a:lvl8pPr marL="0" indent="0">
               <a:lnSpc>
@@ -2311,7 +2232,6 @@
                 <a:spcPts val="0"/>
               </a:spcAft>
               <a:buNone/>
-              <a:defRPr/>
             </a:lvl8pPr>
             <a:lvl9pPr marL="0" indent="0">
               <a:lnSpc>
@@ -2324,7 +2244,6 @@
                 <a:spcPts val="0"/>
               </a:spcAft>
               <a:buNone/>
-              <a:defRPr/>
             </a:lvl9pPr>
           </a:lstStyle>
           <a:p xmlns:a="http://schemas.openxmlformats.org/drawingml/2006/main"/>
@@ -2335,7 +2254,7 @@
           <p:cNvPr id="2" name="Left column">
             <a:extLst xmlns:a="http://schemas.openxmlformats.org/drawingml/2006/main">
               <a:ext uri="{FF2B5EF4-FFF2-40B4-BE49-F238E27FC236}">
-                <a16:creationId xmlns:a16="http://schemas.microsoft.com/office/drawing/2014/main" id="{D859989B-FD2C-475E-8862-06B0171F04AA}"/>
+                <a16:creationId xmlns:a16="http://schemas.microsoft.com/office/drawing/2014/main" id="{C494BDDE-7C5A-4694-9007-BA7A31057604}"/>
               </a:ext>
             </a:extLst>
           </p:cNvPr>
@@ -2386,7 +2305,6 @@
                 <a:spcPts val="1200"/>
               </a:spcAft>
               <a:buChar char="•"/>
-              <a:defRPr/>
             </a:lvl1pPr>
             <a:lvl2pPr marL="533400" indent="-228600">
               <a:lnSpc>
@@ -2399,7 +2317,6 @@
                 <a:spcPts val="1200"/>
               </a:spcAft>
               <a:buChar char="•"/>
-              <a:defRPr/>
             </a:lvl2pPr>
             <a:lvl3pPr marL="838200" indent="-228600">
               <a:lnSpc>
@@ -2412,7 +2329,6 @@
                 <a:spcPts val="1200"/>
               </a:spcAft>
               <a:buChar char="•"/>
-              <a:defRPr/>
             </a:lvl3pPr>
             <a:lvl4pPr marL="1143000" indent="-228600">
               <a:lnSpc>
@@ -2425,7 +2341,6 @@
                 <a:spcPts val="1200"/>
               </a:spcAft>
               <a:buChar char="•"/>
-              <a:defRPr/>
             </a:lvl4pPr>
             <a:lvl5pPr marL="1447800" indent="-228600">
               <a:lnSpc>
@@ -2438,7 +2353,6 @@
                 <a:spcPts val="1200"/>
               </a:spcAft>
               <a:buChar char="•"/>
-              <a:defRPr/>
             </a:lvl5pPr>
             <a:lvl6pPr marL="1752600" indent="-228600">
               <a:lnSpc>
@@ -2451,7 +2365,6 @@
                 <a:spcPts val="1200"/>
               </a:spcAft>
               <a:buChar char="•"/>
-              <a:defRPr/>
             </a:lvl6pPr>
             <a:lvl7pPr marL="2057400" indent="-228600">
               <a:lnSpc>
@@ -2464,7 +2377,6 @@
                 <a:spcPts val="1200"/>
               </a:spcAft>
               <a:buChar char="•"/>
-              <a:defRPr/>
             </a:lvl7pPr>
             <a:lvl8pPr marL="2362200" indent="-228600">
               <a:lnSpc>
@@ -2477,7 +2389,6 @@
                 <a:spcPts val="1200"/>
               </a:spcAft>
               <a:buChar char="•"/>
-              <a:defRPr/>
             </a:lvl8pPr>
             <a:lvl9pPr marL="2667000" indent="-228600">
               <a:lnSpc>
@@ -2490,7 +2401,6 @@
                 <a:spcPts val="1200"/>
               </a:spcAft>
               <a:buChar char="•"/>
-              <a:defRPr/>
             </a:lvl9pPr>
           </a:lstStyle>
           <a:p xmlns:a="http://schemas.openxmlformats.org/drawingml/2006/main"/>
@@ -2539,12 +2449,12 @@
   </p:cSld>
   <p:clrMap bg1="lt1" tx1="dk1" bg2="lt2" tx2="dk2" accent1="accent1" accent2="accent2" accent3="accent3" accent4="accent4" accent5="accent5" accent6="accent6" hlink="hlink" folHlink="folHlink"/>
   <p:sldLayoutIdLst>
-    <p:sldLayoutId xmlns:r="http://schemas.openxmlformats.org/officeDocument/2006/relationships" id="2147483649" r:id="R9c7e93061e144341"/>
-    <p:sldLayoutId xmlns:r="http://schemas.openxmlformats.org/officeDocument/2006/relationships" id="2147483650" r:id="Rb20ab0f698f94324"/>
-    <p:sldLayoutId xmlns:r="http://schemas.openxmlformats.org/officeDocument/2006/relationships" id="2147483651" r:id="Rfbf945bcedc74601"/>
-    <p:sldLayoutId xmlns:r="http://schemas.openxmlformats.org/officeDocument/2006/relationships" id="2147483652" r:id="Rad576e50864746f2"/>
-    <p:sldLayoutId xmlns:r="http://schemas.openxmlformats.org/officeDocument/2006/relationships" id="2147483653" r:id="R8b0fc88fd3194571"/>
-    <p:sldLayoutId xmlns:r="http://schemas.openxmlformats.org/officeDocument/2006/relationships" id="2147483654" r:id="R7452dfef78a9435f"/>
+    <p:sldLayoutId xmlns:r="http://schemas.openxmlformats.org/officeDocument/2006/relationships" id="2147483649" r:id="R64a498f67ff44bde"/>
+    <p:sldLayoutId xmlns:r="http://schemas.openxmlformats.org/officeDocument/2006/relationships" id="2147483650" r:id="R4b98dbf04d6b495d"/>
+    <p:sldLayoutId xmlns:r="http://schemas.openxmlformats.org/officeDocument/2006/relationships" id="2147483651" r:id="Rcc4f3488be02483f"/>
+    <p:sldLayoutId xmlns:r="http://schemas.openxmlformats.org/officeDocument/2006/relationships" id="2147483652" r:id="R24bf9a6426644334"/>
+    <p:sldLayoutId xmlns:r="http://schemas.openxmlformats.org/officeDocument/2006/relationships" id="2147483653" r:id="Re1a50794b79b447d"/>
+    <p:sldLayoutId xmlns:r="http://schemas.openxmlformats.org/officeDocument/2006/relationships" id="2147483654" r:id="Ra34c424e71434cfc"/>
   </p:sldLayoutIdLst>
   <p:txStyles>
     <p:titleStyle>
@@ -3095,7 +3005,7 @@
           <p:cNvPr id="24" name="">
             <a:extLst xmlns:a="http://schemas.openxmlformats.org/drawingml/2006/main">
               <a:ext uri="{FF2B5EF4-FFF2-40B4-BE49-F238E27FC236}">
-                <a16:creationId xmlns:a16="http://schemas.microsoft.com/office/drawing/2014/main" id="{EE710B1B-E200-4F20-96E2-C19303CD9AD0}"/>
+                <a16:creationId xmlns:a16="http://schemas.microsoft.com/office/drawing/2014/main" id="{231D7B2F-10F7-48BE-AE9C-AED439996B78}"/>
               </a:ext>
             </a:extLst>
           </p:cNvPr>
@@ -3127,7 +3037,7 @@
           <p:cNvPr id="19" name="">
             <a:extLst xmlns:a="http://schemas.openxmlformats.org/drawingml/2006/main">
               <a:ext uri="{FF2B5EF4-FFF2-40B4-BE49-F238E27FC236}">
-                <a16:creationId xmlns:a16="http://schemas.microsoft.com/office/drawing/2014/main" id="{881A048B-69FA-4D02-B6A0-67750C32A8BF}"/>
+                <a16:creationId xmlns:a16="http://schemas.microsoft.com/office/drawing/2014/main" id="{09544EDB-3F1C-4DB7-894E-D6A5B88B9F74}"/>
               </a:ext>
             </a:extLst>
           </p:cNvPr>
@@ -3159,7 +3069,7 @@
           <p:cNvPr id="14" name="">
             <a:extLst xmlns:a="http://schemas.openxmlformats.org/drawingml/2006/main">
               <a:ext uri="{FF2B5EF4-FFF2-40B4-BE49-F238E27FC236}">
-                <a16:creationId xmlns:a16="http://schemas.microsoft.com/office/drawing/2014/main" id="{E36140FE-E420-4544-BC0C-926AA98D4379}"/>
+                <a16:creationId xmlns:a16="http://schemas.microsoft.com/office/drawing/2014/main" id="{12F60F02-EEA6-48B7-9113-17ABED3F514B}"/>
               </a:ext>
             </a:extLst>
           </p:cNvPr>
@@ -3191,7 +3101,7 @@
           <p:cNvPr id="9" name="">
             <a:extLst xmlns:a="http://schemas.openxmlformats.org/drawingml/2006/main">
               <a:ext uri="{FF2B5EF4-FFF2-40B4-BE49-F238E27FC236}">
-                <a16:creationId xmlns:a16="http://schemas.microsoft.com/office/drawing/2014/main" id="{3B13C5C6-6BA4-448B-8489-8D8D7ABA29EE}"/>
+                <a16:creationId xmlns:a16="http://schemas.microsoft.com/office/drawing/2014/main" id="{93024461-1A61-487D-B324-0E0F18131588}"/>
               </a:ext>
             </a:extLst>
           </p:cNvPr>
@@ -3223,7 +3133,7 @@
           <p:cNvPr id="47" name="">
             <a:extLst xmlns:a="http://schemas.openxmlformats.org/drawingml/2006/main">
               <a:ext uri="{FF2B5EF4-FFF2-40B4-BE49-F238E27FC236}">
-                <a16:creationId xmlns:a16="http://schemas.microsoft.com/office/drawing/2014/main" id="{077C5426-6257-44A2-B404-A8582AE899DB}"/>
+                <a16:creationId xmlns:a16="http://schemas.microsoft.com/office/drawing/2014/main" id="{E9C3766B-7502-4387-A5D4-786D03505A99}"/>
               </a:ext>
             </a:extLst>
           </p:cNvPr>
@@ -3263,7 +3173,6 @@
           </a:lstStyle>
           <a:p xmlns:a="http://schemas.openxmlformats.org/drawingml/2006/main">
             <a:pPr algn="l">
-              <a:buNone/>
               <a:defRPr sz="1350" b="1">
                 <a:solidFill>
                   <a:srgbClr val="22D3EE"/>
@@ -3292,7 +3201,7 @@
           <p:cNvPr id="2" name="">
             <a:extLst xmlns:a="http://schemas.openxmlformats.org/drawingml/2006/main">
               <a:ext uri="{FF2B5EF4-FFF2-40B4-BE49-F238E27FC236}">
-                <a16:creationId xmlns:a16="http://schemas.microsoft.com/office/drawing/2014/main" id="{BC0256F3-904A-47DE-B73F-6F7CBE2A380A}"/>
+                <a16:creationId xmlns:a16="http://schemas.microsoft.com/office/drawing/2014/main" id="{1A886C1C-19B0-41FE-AA27-ABA71C54805C}"/>
               </a:ext>
             </a:extLst>
           </p:cNvPr>
@@ -3332,7 +3241,6 @@
           </a:lstStyle>
           <a:p xmlns:a="http://schemas.openxmlformats.org/drawingml/2006/main">
             <a:pPr algn="l">
-              <a:buNone/>
               <a:defRPr sz="2550" b="1">
                 <a:solidFill>
                   <a:srgbClr val="F5F8FF"/>
@@ -3361,7 +3269,7 @@
           <p:cNvPr id="3" name="">
             <a:extLst xmlns:a="http://schemas.openxmlformats.org/drawingml/2006/main">
               <a:ext uri="{FF2B5EF4-FFF2-40B4-BE49-F238E27FC236}">
-                <a16:creationId xmlns:a16="http://schemas.microsoft.com/office/drawing/2014/main" id="{2B590D95-C506-4F83-9FBC-E70FBC917461}"/>
+                <a16:creationId xmlns:a16="http://schemas.microsoft.com/office/drawing/2014/main" id="{77E58E32-A069-440A-B15B-7CC70F77C842}"/>
               </a:ext>
             </a:extLst>
           </p:cNvPr>
@@ -3401,7 +3309,6 @@
           </a:lstStyle>
           <a:p xmlns:a="http://schemas.openxmlformats.org/drawingml/2006/main">
             <a:pPr algn="l">
-              <a:buNone/>
               <a:defRPr sz="1275" b="0">
                 <a:solidFill>
                   <a:srgbClr val="9FB1CA"/>
@@ -3430,7 +3337,7 @@
           <p:cNvPr id="4" name="">
             <a:extLst xmlns:a="http://schemas.openxmlformats.org/drawingml/2006/main">
               <a:ext uri="{FF2B5EF4-FFF2-40B4-BE49-F238E27FC236}">
-                <a16:creationId xmlns:a16="http://schemas.microsoft.com/office/drawing/2014/main" id="{08A371D8-D211-4C1A-83C4-9EE525F4C46C}"/>
+                <a16:creationId xmlns:a16="http://schemas.microsoft.com/office/drawing/2014/main" id="{E0B5AA34-BA80-4CB9-87C6-2AE44D4B9E70}"/>
               </a:ext>
             </a:extLst>
           </p:cNvPr>
@@ -3461,7 +3368,7 @@
           <p:cNvPr id="5" name="">
             <a:extLst xmlns:a="http://schemas.openxmlformats.org/drawingml/2006/main">
               <a:ext uri="{FF2B5EF4-FFF2-40B4-BE49-F238E27FC236}">
-                <a16:creationId xmlns:a16="http://schemas.microsoft.com/office/drawing/2014/main" id="{F458AF6C-22C2-423F-8E4F-978C1B91D4BD}"/>
+                <a16:creationId xmlns:a16="http://schemas.microsoft.com/office/drawing/2014/main" id="{DBAC821E-F900-4368-8F55-A67622C5C6BD}"/>
               </a:ext>
             </a:extLst>
           </p:cNvPr>
@@ -3496,7 +3403,7 @@
           <p:cNvPr id="6" name="">
             <a:extLst xmlns:a="http://schemas.openxmlformats.org/drawingml/2006/main">
               <a:ext uri="{FF2B5EF4-FFF2-40B4-BE49-F238E27FC236}">
-                <a16:creationId xmlns:a16="http://schemas.microsoft.com/office/drawing/2014/main" id="{FDB836F6-842F-4D90-A6BB-1BDC1CF26B43}"/>
+                <a16:creationId xmlns:a16="http://schemas.microsoft.com/office/drawing/2014/main" id="{9AA122BD-D4E6-4577-8A85-5FD3544B4DD7}"/>
               </a:ext>
             </a:extLst>
           </p:cNvPr>
@@ -3543,7 +3450,6 @@
           </a:lstStyle>
           <a:p xmlns:a="http://schemas.openxmlformats.org/drawingml/2006/main">
             <a:pPr algn="ctr">
-              <a:buNone/>
               <a:defRPr sz="1050" b="1">
                 <a:solidFill>
                   <a:srgbClr val="081426"/>
@@ -3572,7 +3478,7 @@
           <p:cNvPr id="7" name="">
             <a:extLst xmlns:a="http://schemas.openxmlformats.org/drawingml/2006/main">
               <a:ext uri="{FF2B5EF4-FFF2-40B4-BE49-F238E27FC236}">
-                <a16:creationId xmlns:a16="http://schemas.microsoft.com/office/drawing/2014/main" id="{B6209E19-F6B9-474E-995B-AFF4A755A402}"/>
+                <a16:creationId xmlns:a16="http://schemas.microsoft.com/office/drawing/2014/main" id="{493945E9-C18A-4800-86C4-09E2ECB7E4BA}"/>
               </a:ext>
             </a:extLst>
           </p:cNvPr>
@@ -3612,7 +3518,6 @@
           </a:lstStyle>
           <a:p xmlns:a="http://schemas.openxmlformats.org/drawingml/2006/main">
             <a:pPr algn="l">
-              <a:buNone/>
               <a:defRPr sz="1275" b="1">
                 <a:solidFill>
                   <a:srgbClr val="F5F8FF"/>
@@ -3641,7 +3546,7 @@
           <p:cNvPr id="8" name="">
             <a:extLst xmlns:a="http://schemas.openxmlformats.org/drawingml/2006/main">
               <a:ext uri="{FF2B5EF4-FFF2-40B4-BE49-F238E27FC236}">
-                <a16:creationId xmlns:a16="http://schemas.microsoft.com/office/drawing/2014/main" id="{1AA4F0AD-22A8-43D6-BC84-61720CA9B722}"/>
+                <a16:creationId xmlns:a16="http://schemas.microsoft.com/office/drawing/2014/main" id="{83853A45-CFC1-4A2E-BB5F-218BB8EE1108}"/>
               </a:ext>
             </a:extLst>
           </p:cNvPr>
@@ -3681,7 +3586,6 @@
           </a:lstStyle>
           <a:p xmlns:a="http://schemas.openxmlformats.org/drawingml/2006/main">
             <a:pPr algn="l">
-              <a:buNone/>
               <a:defRPr sz="900" b="0">
                 <a:solidFill>
                   <a:srgbClr val="9FB1CA"/>
@@ -3710,7 +3614,7 @@
           <p:cNvPr id="10" name="">
             <a:extLst xmlns:a="http://schemas.openxmlformats.org/drawingml/2006/main">
               <a:ext uri="{FF2B5EF4-FFF2-40B4-BE49-F238E27FC236}">
-                <a16:creationId xmlns:a16="http://schemas.microsoft.com/office/drawing/2014/main" id="{328D94BB-2BFF-406A-9552-A723C328D5C9}"/>
+                <a16:creationId xmlns:a16="http://schemas.microsoft.com/office/drawing/2014/main" id="{8DB7FFE3-5B0B-4587-A5C4-560F17E00B61}"/>
               </a:ext>
             </a:extLst>
           </p:cNvPr>
@@ -3745,7 +3649,7 @@
           <p:cNvPr id="11" name="">
             <a:extLst xmlns:a="http://schemas.openxmlformats.org/drawingml/2006/main">
               <a:ext uri="{FF2B5EF4-FFF2-40B4-BE49-F238E27FC236}">
-                <a16:creationId xmlns:a16="http://schemas.microsoft.com/office/drawing/2014/main" id="{2105E264-4098-4BCE-9D6A-2E37190FA97E}"/>
+                <a16:creationId xmlns:a16="http://schemas.microsoft.com/office/drawing/2014/main" id="{A8D91B80-FE88-42E1-A268-2DAA5ACA44EF}"/>
               </a:ext>
             </a:extLst>
           </p:cNvPr>
@@ -3792,7 +3696,6 @@
           </a:lstStyle>
           <a:p xmlns:a="http://schemas.openxmlformats.org/drawingml/2006/main">
             <a:pPr algn="ctr">
-              <a:buNone/>
               <a:defRPr sz="1050" b="1">
                 <a:solidFill>
                   <a:srgbClr val="081426"/>
@@ -3821,7 +3724,7 @@
           <p:cNvPr id="12" name="">
             <a:extLst xmlns:a="http://schemas.openxmlformats.org/drawingml/2006/main">
               <a:ext uri="{FF2B5EF4-FFF2-40B4-BE49-F238E27FC236}">
-                <a16:creationId xmlns:a16="http://schemas.microsoft.com/office/drawing/2014/main" id="{7F4D23DE-36CB-42E6-A22E-A92EE5C09C44}"/>
+                <a16:creationId xmlns:a16="http://schemas.microsoft.com/office/drawing/2014/main" id="{A0983703-CCDE-4638-BC20-D4B168531F29}"/>
               </a:ext>
             </a:extLst>
           </p:cNvPr>
@@ -3861,7 +3764,6 @@
           </a:lstStyle>
           <a:p xmlns:a="http://schemas.openxmlformats.org/drawingml/2006/main">
             <a:pPr algn="l">
-              <a:buNone/>
               <a:defRPr sz="1275" b="1">
                 <a:solidFill>
                   <a:srgbClr val="F5F8FF"/>
@@ -3890,7 +3792,7 @@
           <p:cNvPr id="13" name="">
             <a:extLst xmlns:a="http://schemas.openxmlformats.org/drawingml/2006/main">
               <a:ext uri="{FF2B5EF4-FFF2-40B4-BE49-F238E27FC236}">
-                <a16:creationId xmlns:a16="http://schemas.microsoft.com/office/drawing/2014/main" id="{EF98664E-CAB6-4F76-BA91-BE1501DD3FDC}"/>
+                <a16:creationId xmlns:a16="http://schemas.microsoft.com/office/drawing/2014/main" id="{B79CCA64-DD65-4E54-9821-F6BDC1E7006D}"/>
               </a:ext>
             </a:extLst>
           </p:cNvPr>
@@ -3930,7 +3832,6 @@
           </a:lstStyle>
           <a:p xmlns:a="http://schemas.openxmlformats.org/drawingml/2006/main">
             <a:pPr algn="l">
-              <a:buNone/>
               <a:defRPr sz="900" b="0">
                 <a:solidFill>
                   <a:srgbClr val="9FB1CA"/>
@@ -3959,7 +3860,7 @@
           <p:cNvPr id="15" name="">
             <a:extLst xmlns:a="http://schemas.openxmlformats.org/drawingml/2006/main">
               <a:ext uri="{FF2B5EF4-FFF2-40B4-BE49-F238E27FC236}">
-                <a16:creationId xmlns:a16="http://schemas.microsoft.com/office/drawing/2014/main" id="{D623F409-59B9-41D0-8DCA-A15AE18BA12E}"/>
+                <a16:creationId xmlns:a16="http://schemas.microsoft.com/office/drawing/2014/main" id="{162C1010-FFED-4647-85D0-06294888D22F}"/>
               </a:ext>
             </a:extLst>
           </p:cNvPr>
@@ -3994,7 +3895,7 @@
           <p:cNvPr id="16" name="">
             <a:extLst xmlns:a="http://schemas.openxmlformats.org/drawingml/2006/main">
               <a:ext uri="{FF2B5EF4-FFF2-40B4-BE49-F238E27FC236}">
-                <a16:creationId xmlns:a16="http://schemas.microsoft.com/office/drawing/2014/main" id="{B253AA95-7676-4CBF-A381-435718D91CCB}"/>
+                <a16:creationId xmlns:a16="http://schemas.microsoft.com/office/drawing/2014/main" id="{8CF6DB52-58A8-4AC2-961F-811EFE22300C}"/>
               </a:ext>
             </a:extLst>
           </p:cNvPr>
@@ -4041,7 +3942,6 @@
           </a:lstStyle>
           <a:p xmlns:a="http://schemas.openxmlformats.org/drawingml/2006/main">
             <a:pPr algn="ctr">
-              <a:buNone/>
               <a:defRPr sz="1050" b="1">
                 <a:solidFill>
                   <a:srgbClr val="081426"/>
@@ -4070,7 +3970,7 @@
           <p:cNvPr id="17" name="">
             <a:extLst xmlns:a="http://schemas.openxmlformats.org/drawingml/2006/main">
               <a:ext uri="{FF2B5EF4-FFF2-40B4-BE49-F238E27FC236}">
-                <a16:creationId xmlns:a16="http://schemas.microsoft.com/office/drawing/2014/main" id="{5A108177-3103-4F51-B877-56D6918FD8A6}"/>
+                <a16:creationId xmlns:a16="http://schemas.microsoft.com/office/drawing/2014/main" id="{6A835655-7DF1-4E16-8E1F-1E0A0A9809C9}"/>
               </a:ext>
             </a:extLst>
           </p:cNvPr>
@@ -4110,7 +4010,6 @@
           </a:lstStyle>
           <a:p xmlns:a="http://schemas.openxmlformats.org/drawingml/2006/main">
             <a:pPr algn="l">
-              <a:buNone/>
               <a:defRPr sz="1275" b="1">
                 <a:solidFill>
                   <a:srgbClr val="F5F8FF"/>
@@ -4139,7 +4038,7 @@
           <p:cNvPr id="18" name="">
             <a:extLst xmlns:a="http://schemas.openxmlformats.org/drawingml/2006/main">
               <a:ext uri="{FF2B5EF4-FFF2-40B4-BE49-F238E27FC236}">
-                <a16:creationId xmlns:a16="http://schemas.microsoft.com/office/drawing/2014/main" id="{B8B865E9-211C-4C1C-AA00-BE33A4BECA14}"/>
+                <a16:creationId xmlns:a16="http://schemas.microsoft.com/office/drawing/2014/main" id="{A01F1D40-F75C-4420-BD5C-F7011C5C34A8}"/>
               </a:ext>
             </a:extLst>
           </p:cNvPr>
@@ -4179,7 +4078,6 @@
           </a:lstStyle>
           <a:p xmlns:a="http://schemas.openxmlformats.org/drawingml/2006/main">
             <a:pPr algn="l">
-              <a:buNone/>
               <a:defRPr sz="900" b="0">
                 <a:solidFill>
                   <a:srgbClr val="9FB1CA"/>
@@ -4208,7 +4106,7 @@
           <p:cNvPr id="20" name="">
             <a:extLst xmlns:a="http://schemas.openxmlformats.org/drawingml/2006/main">
               <a:ext uri="{FF2B5EF4-FFF2-40B4-BE49-F238E27FC236}">
-                <a16:creationId xmlns:a16="http://schemas.microsoft.com/office/drawing/2014/main" id="{57FF6539-7C95-4A0A-9BB6-70C3ABED5A54}"/>
+                <a16:creationId xmlns:a16="http://schemas.microsoft.com/office/drawing/2014/main" id="{A37B96FC-E431-402F-942F-D8268FEBE4C6}"/>
               </a:ext>
             </a:extLst>
           </p:cNvPr>
@@ -4243,7 +4141,7 @@
           <p:cNvPr id="21" name="">
             <a:extLst xmlns:a="http://schemas.openxmlformats.org/drawingml/2006/main">
               <a:ext uri="{FF2B5EF4-FFF2-40B4-BE49-F238E27FC236}">
-                <a16:creationId xmlns:a16="http://schemas.microsoft.com/office/drawing/2014/main" id="{53690952-BECE-4B74-8DE9-15221CF8D921}"/>
+                <a16:creationId xmlns:a16="http://schemas.microsoft.com/office/drawing/2014/main" id="{51C42697-DFA1-461C-B7D5-33704879CB0A}"/>
               </a:ext>
             </a:extLst>
           </p:cNvPr>
@@ -4290,7 +4188,6 @@
           </a:lstStyle>
           <a:p xmlns:a="http://schemas.openxmlformats.org/drawingml/2006/main">
             <a:pPr algn="ctr">
-              <a:buNone/>
               <a:defRPr sz="1050" b="1">
                 <a:solidFill>
                   <a:srgbClr val="081426"/>
@@ -4319,7 +4216,7 @@
           <p:cNvPr id="22" name="">
             <a:extLst xmlns:a="http://schemas.openxmlformats.org/drawingml/2006/main">
               <a:ext uri="{FF2B5EF4-FFF2-40B4-BE49-F238E27FC236}">
-                <a16:creationId xmlns:a16="http://schemas.microsoft.com/office/drawing/2014/main" id="{91C49E87-B418-4AC0-8D0B-D53F6226A56B}"/>
+                <a16:creationId xmlns:a16="http://schemas.microsoft.com/office/drawing/2014/main" id="{9129913E-D971-4052-BFC0-78DA097B88ED}"/>
               </a:ext>
             </a:extLst>
           </p:cNvPr>
@@ -4359,7 +4256,6 @@
           </a:lstStyle>
           <a:p xmlns:a="http://schemas.openxmlformats.org/drawingml/2006/main">
             <a:pPr algn="l">
-              <a:buNone/>
               <a:defRPr sz="1275" b="1">
                 <a:solidFill>
                   <a:srgbClr val="F5F8FF"/>
@@ -4388,7 +4284,7 @@
           <p:cNvPr id="23" name="">
             <a:extLst xmlns:a="http://schemas.openxmlformats.org/drawingml/2006/main">
               <a:ext uri="{FF2B5EF4-FFF2-40B4-BE49-F238E27FC236}">
-                <a16:creationId xmlns:a16="http://schemas.microsoft.com/office/drawing/2014/main" id="{7AC156A4-F741-4929-AF3B-F4CB9B23219E}"/>
+                <a16:creationId xmlns:a16="http://schemas.microsoft.com/office/drawing/2014/main" id="{A050ACC6-4CFB-42D2-9445-496A5990C4B4}"/>
               </a:ext>
             </a:extLst>
           </p:cNvPr>
@@ -4428,7 +4324,6 @@
           </a:lstStyle>
           <a:p xmlns:a="http://schemas.openxmlformats.org/drawingml/2006/main">
             <a:pPr algn="l">
-              <a:buNone/>
               <a:defRPr sz="900" b="0">
                 <a:solidFill>
                   <a:srgbClr val="9FB1CA"/>
@@ -4457,7 +4352,7 @@
           <p:cNvPr id="25" name="">
             <a:extLst xmlns:a="http://schemas.openxmlformats.org/drawingml/2006/main">
               <a:ext uri="{FF2B5EF4-FFF2-40B4-BE49-F238E27FC236}">
-                <a16:creationId xmlns:a16="http://schemas.microsoft.com/office/drawing/2014/main" id="{29ABB77A-7C8D-4BFC-8279-B3290BCF8FBA}"/>
+                <a16:creationId xmlns:a16="http://schemas.microsoft.com/office/drawing/2014/main" id="{9EB2690A-18B8-479B-B846-7CF6282739FA}"/>
               </a:ext>
             </a:extLst>
           </p:cNvPr>
@@ -4492,7 +4387,7 @@
           <p:cNvPr id="26" name="">
             <a:extLst xmlns:a="http://schemas.openxmlformats.org/drawingml/2006/main">
               <a:ext uri="{FF2B5EF4-FFF2-40B4-BE49-F238E27FC236}">
-                <a16:creationId xmlns:a16="http://schemas.microsoft.com/office/drawing/2014/main" id="{06B3145C-EF36-4DFB-911C-1165083E00A1}"/>
+                <a16:creationId xmlns:a16="http://schemas.microsoft.com/office/drawing/2014/main" id="{B4783B90-B51C-4EA3-AF60-83343F18D59B}"/>
               </a:ext>
             </a:extLst>
           </p:cNvPr>
@@ -4539,7 +4434,6 @@
           </a:lstStyle>
           <a:p xmlns:a="http://schemas.openxmlformats.org/drawingml/2006/main">
             <a:pPr algn="ctr">
-              <a:buNone/>
               <a:defRPr sz="1050" b="1">
                 <a:solidFill>
                   <a:srgbClr val="081426"/>
@@ -4568,7 +4462,7 @@
           <p:cNvPr id="27" name="">
             <a:extLst xmlns:a="http://schemas.openxmlformats.org/drawingml/2006/main">
               <a:ext uri="{FF2B5EF4-FFF2-40B4-BE49-F238E27FC236}">
-                <a16:creationId xmlns:a16="http://schemas.microsoft.com/office/drawing/2014/main" id="{5B7721AF-F40A-41D5-ADDA-3C48BD5A9DB8}"/>
+                <a16:creationId xmlns:a16="http://schemas.microsoft.com/office/drawing/2014/main" id="{896E6CD2-70EB-4DA3-9B84-B0AAE1332449}"/>
               </a:ext>
             </a:extLst>
           </p:cNvPr>
@@ -4608,7 +4502,6 @@
           </a:lstStyle>
           <a:p xmlns:a="http://schemas.openxmlformats.org/drawingml/2006/main">
             <a:pPr algn="l">
-              <a:buNone/>
               <a:defRPr sz="1275" b="1">
                 <a:solidFill>
                   <a:srgbClr val="F5F8FF"/>
@@ -4637,7 +4530,7 @@
           <p:cNvPr id="28" name="">
             <a:extLst xmlns:a="http://schemas.openxmlformats.org/drawingml/2006/main">
               <a:ext uri="{FF2B5EF4-FFF2-40B4-BE49-F238E27FC236}">
-                <a16:creationId xmlns:a16="http://schemas.microsoft.com/office/drawing/2014/main" id="{ABDF02EC-E623-41B5-B0D1-65B480DA23D4}"/>
+                <a16:creationId xmlns:a16="http://schemas.microsoft.com/office/drawing/2014/main" id="{B62352BA-62E4-4424-BBE4-D4BCAF818DF9}"/>
               </a:ext>
             </a:extLst>
           </p:cNvPr>
@@ -4677,7 +4570,6 @@
           </a:lstStyle>
           <a:p xmlns:a="http://schemas.openxmlformats.org/drawingml/2006/main">
             <a:pPr algn="l">
-              <a:buNone/>
               <a:defRPr sz="900" b="0">
                 <a:solidFill>
                   <a:srgbClr val="9FB1CA"/>
@@ -4706,7 +4598,7 @@
           <p:cNvPr id="29" name="">
             <a:extLst xmlns:a="http://schemas.openxmlformats.org/drawingml/2006/main">
               <a:ext uri="{FF2B5EF4-FFF2-40B4-BE49-F238E27FC236}">
-                <a16:creationId xmlns:a16="http://schemas.microsoft.com/office/drawing/2014/main" id="{3FE631CD-0BC7-458B-93C7-F8E337FEB2A1}"/>
+                <a16:creationId xmlns:a16="http://schemas.microsoft.com/office/drawing/2014/main" id="{CC7ACD01-3585-45ED-8755-918288968851}"/>
               </a:ext>
             </a:extLst>
           </p:cNvPr>
@@ -4741,7 +4633,7 @@
           <p:cNvPr id="30" name="">
             <a:extLst xmlns:a="http://schemas.openxmlformats.org/drawingml/2006/main">
               <a:ext uri="{FF2B5EF4-FFF2-40B4-BE49-F238E27FC236}">
-                <a16:creationId xmlns:a16="http://schemas.microsoft.com/office/drawing/2014/main" id="{5BD0414B-E8C8-4A04-A8C2-57DAEA5DFC91}"/>
+                <a16:creationId xmlns:a16="http://schemas.microsoft.com/office/drawing/2014/main" id="{116F559F-FC98-44C8-87A9-46C4C739A16D}"/>
               </a:ext>
             </a:extLst>
           </p:cNvPr>
@@ -4781,7 +4673,6 @@
           </a:lstStyle>
           <a:p xmlns:a="http://schemas.openxmlformats.org/drawingml/2006/main">
             <a:pPr algn="l">
-              <a:buNone/>
               <a:defRPr sz="1125" b="1">
                 <a:solidFill>
                   <a:srgbClr val="22D3EE"/>
@@ -4810,7 +4701,7 @@
           <p:cNvPr id="31" name="">
             <a:extLst xmlns:a="http://schemas.openxmlformats.org/drawingml/2006/main">
               <a:ext uri="{FF2B5EF4-FFF2-40B4-BE49-F238E27FC236}">
-                <a16:creationId xmlns:a16="http://schemas.microsoft.com/office/drawing/2014/main" id="{846BE1BF-A4E3-42BE-BCD0-E3BCBBB5707D}"/>
+                <a16:creationId xmlns:a16="http://schemas.microsoft.com/office/drawing/2014/main" id="{C7355C7F-EEDC-4701-B98A-20726AF46E4F}"/>
               </a:ext>
             </a:extLst>
           </p:cNvPr>
@@ -4850,7 +4741,6 @@
           </a:lstStyle>
           <a:p xmlns:a="http://schemas.openxmlformats.org/drawingml/2006/main">
             <a:pPr algn="l">
-              <a:buNone/>
               <a:defRPr sz="1350" b="1">
                 <a:solidFill>
                   <a:srgbClr val="F5F8FF"/>
@@ -4879,7 +4769,7 @@
           <p:cNvPr id="32" name="">
             <a:extLst xmlns:a="http://schemas.openxmlformats.org/drawingml/2006/main">
               <a:ext uri="{FF2B5EF4-FFF2-40B4-BE49-F238E27FC236}">
-                <a16:creationId xmlns:a16="http://schemas.microsoft.com/office/drawing/2014/main" id="{CAA63461-1D4C-4C87-BE6D-B835055FB8C7}"/>
+                <a16:creationId xmlns:a16="http://schemas.microsoft.com/office/drawing/2014/main" id="{12391185-7000-4D64-9D8D-559AE4855B87}"/>
               </a:ext>
             </a:extLst>
           </p:cNvPr>
@@ -4919,7 +4809,6 @@
           </a:lstStyle>
           <a:p xmlns:a="http://schemas.openxmlformats.org/drawingml/2006/main">
             <a:pPr algn="l">
-              <a:buNone/>
               <a:defRPr sz="1800" b="1">
                 <a:solidFill>
                   <a:srgbClr val="F5F8FF"/>
@@ -4948,7 +4837,7 @@
           <p:cNvPr id="33" name="">
             <a:extLst xmlns:a="http://schemas.openxmlformats.org/drawingml/2006/main">
               <a:ext uri="{FF2B5EF4-FFF2-40B4-BE49-F238E27FC236}">
-                <a16:creationId xmlns:a16="http://schemas.microsoft.com/office/drawing/2014/main" id="{E0035DBC-A4DA-4606-80FB-AAA4FBB02F4D}"/>
+                <a16:creationId xmlns:a16="http://schemas.microsoft.com/office/drawing/2014/main" id="{62274648-50EC-416B-A246-8D3D0CE4C5E1}"/>
               </a:ext>
             </a:extLst>
           </p:cNvPr>
@@ -4983,7 +4872,7 @@
           <p:cNvPr id="34" name="">
             <a:extLst xmlns:a="http://schemas.openxmlformats.org/drawingml/2006/main">
               <a:ext uri="{FF2B5EF4-FFF2-40B4-BE49-F238E27FC236}">
-                <a16:creationId xmlns:a16="http://schemas.microsoft.com/office/drawing/2014/main" id="{9C9374A8-ACCC-4F7D-AE75-E59840F7D409}"/>
+                <a16:creationId xmlns:a16="http://schemas.microsoft.com/office/drawing/2014/main" id="{A6630C4B-DD38-4189-8837-8E86CE66042E}"/>
               </a:ext>
             </a:extLst>
           </p:cNvPr>
@@ -5030,7 +4919,6 @@
           </a:lstStyle>
           <a:p xmlns:a="http://schemas.openxmlformats.org/drawingml/2006/main">
             <a:pPr algn="ctr">
-              <a:buNone/>
               <a:defRPr sz="1050" b="1">
                 <a:solidFill>
                   <a:srgbClr val="081426"/>
@@ -5059,7 +4947,7 @@
           <p:cNvPr id="35" name="">
             <a:extLst xmlns:a="http://schemas.openxmlformats.org/drawingml/2006/main">
               <a:ext uri="{FF2B5EF4-FFF2-40B4-BE49-F238E27FC236}">
-                <a16:creationId xmlns:a16="http://schemas.microsoft.com/office/drawing/2014/main" id="{944037BF-C38B-4A01-87F7-3E2A84760398}"/>
+                <a16:creationId xmlns:a16="http://schemas.microsoft.com/office/drawing/2014/main" id="{8B714F25-AC47-4E04-B974-19D67EEF9B65}"/>
               </a:ext>
             </a:extLst>
           </p:cNvPr>
@@ -5099,7 +4987,6 @@
           </a:lstStyle>
           <a:p xmlns:a="http://schemas.openxmlformats.org/drawingml/2006/main">
             <a:pPr algn="l">
-              <a:buNone/>
               <a:defRPr sz="1575" b="1">
                 <a:solidFill>
                   <a:srgbClr val="F5F8FF"/>
@@ -5128,7 +5015,7 @@
           <p:cNvPr id="36" name="">
             <a:extLst xmlns:a="http://schemas.openxmlformats.org/drawingml/2006/main">
               <a:ext uri="{FF2B5EF4-FFF2-40B4-BE49-F238E27FC236}">
-                <a16:creationId xmlns:a16="http://schemas.microsoft.com/office/drawing/2014/main" id="{049C7FC9-27DD-472E-9BB2-F572F9DAF723}"/>
+                <a16:creationId xmlns:a16="http://schemas.microsoft.com/office/drawing/2014/main" id="{8D682B47-24D3-4DE0-82CF-57BCF4669207}"/>
               </a:ext>
             </a:extLst>
           </p:cNvPr>
@@ -5168,7 +5055,6 @@
           </a:lstStyle>
           <a:p xmlns:a="http://schemas.openxmlformats.org/drawingml/2006/main">
             <a:pPr algn="l">
-              <a:buNone/>
               <a:defRPr sz="1050" b="0">
                 <a:solidFill>
                   <a:srgbClr val="9FB1CA"/>
@@ -5197,7 +5083,7 @@
           <p:cNvPr id="37" name="">
             <a:extLst xmlns:a="http://schemas.openxmlformats.org/drawingml/2006/main">
               <a:ext uri="{FF2B5EF4-FFF2-40B4-BE49-F238E27FC236}">
-                <a16:creationId xmlns:a16="http://schemas.microsoft.com/office/drawing/2014/main" id="{2B02F459-5BC3-4FEB-A5E8-0A141A3EFD40}"/>
+                <a16:creationId xmlns:a16="http://schemas.microsoft.com/office/drawing/2014/main" id="{A629804F-F1E4-4AB5-B16C-9ED5A1C31E8C}"/>
               </a:ext>
             </a:extLst>
           </p:cNvPr>
@@ -5232,7 +5118,7 @@
           <p:cNvPr id="38" name="">
             <a:extLst xmlns:a="http://schemas.openxmlformats.org/drawingml/2006/main">
               <a:ext uri="{FF2B5EF4-FFF2-40B4-BE49-F238E27FC236}">
-                <a16:creationId xmlns:a16="http://schemas.microsoft.com/office/drawing/2014/main" id="{242F581A-0595-44A9-84B5-A55586B771AA}"/>
+                <a16:creationId xmlns:a16="http://schemas.microsoft.com/office/drawing/2014/main" id="{82FF90AC-0E9D-4CA4-952E-FDDAA540A267}"/>
               </a:ext>
             </a:extLst>
           </p:cNvPr>
@@ -5279,7 +5165,6 @@
           </a:lstStyle>
           <a:p xmlns:a="http://schemas.openxmlformats.org/drawingml/2006/main">
             <a:pPr algn="ctr">
-              <a:buNone/>
               <a:defRPr sz="1050" b="1">
                 <a:solidFill>
                   <a:srgbClr val="081426"/>
@@ -5308,7 +5193,7 @@
           <p:cNvPr id="39" name="">
             <a:extLst xmlns:a="http://schemas.openxmlformats.org/drawingml/2006/main">
               <a:ext uri="{FF2B5EF4-FFF2-40B4-BE49-F238E27FC236}">
-                <a16:creationId xmlns:a16="http://schemas.microsoft.com/office/drawing/2014/main" id="{D8ECFF5B-A7E6-4121-B75A-B52AB33FA259}"/>
+                <a16:creationId xmlns:a16="http://schemas.microsoft.com/office/drawing/2014/main" id="{4421B8B6-E66E-44EA-B83E-39F7D4B75A7C}"/>
               </a:ext>
             </a:extLst>
           </p:cNvPr>
@@ -5348,7 +5233,6 @@
           </a:lstStyle>
           <a:p xmlns:a="http://schemas.openxmlformats.org/drawingml/2006/main">
             <a:pPr algn="l">
-              <a:buNone/>
               <a:defRPr sz="1575" b="1">
                 <a:solidFill>
                   <a:srgbClr val="F5F8FF"/>
@@ -5377,7 +5261,7 @@
           <p:cNvPr id="40" name="">
             <a:extLst xmlns:a="http://schemas.openxmlformats.org/drawingml/2006/main">
               <a:ext uri="{FF2B5EF4-FFF2-40B4-BE49-F238E27FC236}">
-                <a16:creationId xmlns:a16="http://schemas.microsoft.com/office/drawing/2014/main" id="{975E885F-C8FC-4D5B-A518-A55C21C49763}"/>
+                <a16:creationId xmlns:a16="http://schemas.microsoft.com/office/drawing/2014/main" id="{0C5541FF-F1CB-4867-90CA-50CC29EE6B66}"/>
               </a:ext>
             </a:extLst>
           </p:cNvPr>
@@ -5417,7 +5301,6 @@
           </a:lstStyle>
           <a:p xmlns:a="http://schemas.openxmlformats.org/drawingml/2006/main">
             <a:pPr algn="l">
-              <a:buNone/>
               <a:defRPr sz="1050" b="0">
                 <a:solidFill>
                   <a:srgbClr val="9FB1CA"/>
@@ -5446,7 +5329,7 @@
           <p:cNvPr id="41" name="">
             <a:extLst xmlns:a="http://schemas.openxmlformats.org/drawingml/2006/main">
               <a:ext uri="{FF2B5EF4-FFF2-40B4-BE49-F238E27FC236}">
-                <a16:creationId xmlns:a16="http://schemas.microsoft.com/office/drawing/2014/main" id="{12297978-DBDC-423C-8673-381ECA12EAA2}"/>
+                <a16:creationId xmlns:a16="http://schemas.microsoft.com/office/drawing/2014/main" id="{65B0F18B-0827-402F-BB9B-02DC04449BF1}"/>
               </a:ext>
             </a:extLst>
           </p:cNvPr>
@@ -5481,7 +5364,7 @@
           <p:cNvPr id="42" name="">
             <a:extLst xmlns:a="http://schemas.openxmlformats.org/drawingml/2006/main">
               <a:ext uri="{FF2B5EF4-FFF2-40B4-BE49-F238E27FC236}">
-                <a16:creationId xmlns:a16="http://schemas.microsoft.com/office/drawing/2014/main" id="{EB7088EF-66B0-41D4-8688-C0567A89F5F2}"/>
+                <a16:creationId xmlns:a16="http://schemas.microsoft.com/office/drawing/2014/main" id="{D56462E4-4135-4FAE-BB26-613B3B7C8824}"/>
               </a:ext>
             </a:extLst>
           </p:cNvPr>
@@ -5528,7 +5411,6 @@
           </a:lstStyle>
           <a:p xmlns:a="http://schemas.openxmlformats.org/drawingml/2006/main">
             <a:pPr algn="ctr">
-              <a:buNone/>
               <a:defRPr sz="1050" b="1">
                 <a:solidFill>
                   <a:srgbClr val="081426"/>
@@ -5557,7 +5439,7 @@
           <p:cNvPr id="43" name="">
             <a:extLst xmlns:a="http://schemas.openxmlformats.org/drawingml/2006/main">
               <a:ext uri="{FF2B5EF4-FFF2-40B4-BE49-F238E27FC236}">
-                <a16:creationId xmlns:a16="http://schemas.microsoft.com/office/drawing/2014/main" id="{A084BC1D-E5F5-4F2D-935B-321AF465B089}"/>
+                <a16:creationId xmlns:a16="http://schemas.microsoft.com/office/drawing/2014/main" id="{D4F37463-B234-4B1C-88F1-9E970705E0E9}"/>
               </a:ext>
             </a:extLst>
           </p:cNvPr>
@@ -5597,7 +5479,6 @@
           </a:lstStyle>
           <a:p xmlns:a="http://schemas.openxmlformats.org/drawingml/2006/main">
             <a:pPr algn="l">
-              <a:buNone/>
               <a:defRPr sz="1575" b="1">
                 <a:solidFill>
                   <a:srgbClr val="F5F8FF"/>
@@ -5626,7 +5507,7 @@
           <p:cNvPr id="44" name="">
             <a:extLst xmlns:a="http://schemas.openxmlformats.org/drawingml/2006/main">
               <a:ext uri="{FF2B5EF4-FFF2-40B4-BE49-F238E27FC236}">
-                <a16:creationId xmlns:a16="http://schemas.microsoft.com/office/drawing/2014/main" id="{CC2D87C6-F41B-4DAD-86A8-41E975AB935C}"/>
+                <a16:creationId xmlns:a16="http://schemas.microsoft.com/office/drawing/2014/main" id="{3A4FFE34-7275-4350-92C1-F54F4A9BEA0C}"/>
               </a:ext>
             </a:extLst>
           </p:cNvPr>
@@ -5666,7 +5547,6 @@
           </a:lstStyle>
           <a:p xmlns:a="http://schemas.openxmlformats.org/drawingml/2006/main">
             <a:pPr algn="l">
-              <a:buNone/>
               <a:defRPr sz="1050" b="0">
                 <a:solidFill>
                   <a:srgbClr val="9FB1CA"/>
@@ -5695,7 +5575,7 @@
           <p:cNvPr id="45" name="">
             <a:extLst xmlns:a="http://schemas.openxmlformats.org/drawingml/2006/main">
               <a:ext uri="{FF2B5EF4-FFF2-40B4-BE49-F238E27FC236}">
-                <a16:creationId xmlns:a16="http://schemas.microsoft.com/office/drawing/2014/main" id="{E4231AB0-1D82-435F-AC57-8866C64F6798}"/>
+                <a16:creationId xmlns:a16="http://schemas.microsoft.com/office/drawing/2014/main" id="{1DFFF859-301B-4FD7-AE9A-79CCD009CE4B}"/>
               </a:ext>
             </a:extLst>
           </p:cNvPr>
@@ -5735,7 +5615,6 @@
           </a:lstStyle>
           <a:p xmlns:a="http://schemas.openxmlformats.org/drawingml/2006/main">
             <a:pPr algn="l">
-              <a:buNone/>
               <a:defRPr sz="900" b="0">
                 <a:solidFill>
                   <a:srgbClr val="9FB1CA"/>
@@ -5754,18 +5633,7 @@
                 <a:ea typeface="Arial"/>
                 <a:cs typeface="Arial"/>
               </a:rPr>
-              <a:t>AURA • Track A • </a:t>
-            </a:r>
-            <a:r>
-              <a:rPr sz="900" b="0">
-                <a:solidFill>
-                  <a:srgbClr val="9FB1CA"/>
-                </a:solidFill>
-                <a:latin typeface="Arial"/>
-                <a:ea typeface="Arial"/>
-                <a:cs typeface="Arial"/>
-              </a:rPr>
-              <a:t>12/10/2026</a:t>
+              <a:t>AURA • Track A • 12/10/2026</a:t>
             </a:r>
           </a:p>
         </p:txBody>
@@ -5775,7 +5643,7 @@
           <p:cNvPr id="46" name="">
             <a:extLst xmlns:a="http://schemas.openxmlformats.org/drawingml/2006/main">
               <a:ext uri="{FF2B5EF4-FFF2-40B4-BE49-F238E27FC236}">
-                <a16:creationId xmlns:a16="http://schemas.microsoft.com/office/drawing/2014/main" id="{CE38F593-23EF-4297-BC41-1031920D58D4}"/>
+                <a16:creationId xmlns:a16="http://schemas.microsoft.com/office/drawing/2014/main" id="{C868CC98-6759-4F38-9DFE-C5C63D3D5866}"/>
               </a:ext>
             </a:extLst>
           </p:cNvPr>
@@ -5815,7 +5683,6 @@
           </a:lstStyle>
           <a:p xmlns:a="http://schemas.openxmlformats.org/drawingml/2006/main">
             <a:pPr algn="r">
-              <a:buNone/>
               <a:defRPr sz="975" b="1">
                 <a:solidFill>
                   <a:srgbClr val="9FB1CA"/>
@@ -5842,7 +5709,7 @@
     </p:spTree>
     <p:extLst>
       <p:ext uri="{BB962C8B-B14F-4D97-AF65-F5344CB8AC3E}">
-        <p14:creationId xmlns:p14="http://schemas.microsoft.com/office/powerpoint/2010/main" val="2092513571"/>
+        <p14:creationId xmlns:p14="http://schemas.microsoft.com/office/powerpoint/2010/main" val="1005716595"/>
       </p:ext>
     </p:extLst>
   </p:cSld>
@@ -5873,7 +5740,7 @@
           <p:cNvPr id="46" name="">
             <a:extLst xmlns:a="http://schemas.openxmlformats.org/drawingml/2006/main">
               <a:ext uri="{FF2B5EF4-FFF2-40B4-BE49-F238E27FC236}">
-                <a16:creationId xmlns:a16="http://schemas.microsoft.com/office/drawing/2014/main" id="{DF20B3C9-7348-48CA-B9DD-B51123C7E717}"/>
+                <a16:creationId xmlns:a16="http://schemas.microsoft.com/office/drawing/2014/main" id="{5D0B1E18-6DB7-4D1F-9C19-06B118C6798D}"/>
               </a:ext>
             </a:extLst>
           </p:cNvPr>
@@ -5913,7 +5780,6 @@
           </a:lstStyle>
           <a:p xmlns:a="http://schemas.openxmlformats.org/drawingml/2006/main">
             <a:pPr algn="l">
-              <a:buNone/>
               <a:defRPr sz="1350" b="1">
                 <a:solidFill>
                   <a:srgbClr val="22D3EE"/>
@@ -5942,7 +5808,7 @@
           <p:cNvPr id="2" name="">
             <a:extLst xmlns:a="http://schemas.openxmlformats.org/drawingml/2006/main">
               <a:ext uri="{FF2B5EF4-FFF2-40B4-BE49-F238E27FC236}">
-                <a16:creationId xmlns:a16="http://schemas.microsoft.com/office/drawing/2014/main" id="{7982CBDF-C870-4473-9E22-FB67D0DADB01}"/>
+                <a16:creationId xmlns:a16="http://schemas.microsoft.com/office/drawing/2014/main" id="{B87DC285-5CBD-4866-8452-2EEB17D07354}"/>
               </a:ext>
             </a:extLst>
           </p:cNvPr>
@@ -5982,7 +5848,6 @@
           </a:lstStyle>
           <a:p xmlns:a="http://schemas.openxmlformats.org/drawingml/2006/main">
             <a:pPr algn="l">
-              <a:buNone/>
               <a:defRPr sz="2550" b="1">
                 <a:solidFill>
                   <a:srgbClr val="F5F8FF"/>
@@ -6011,7 +5876,7 @@
           <p:cNvPr id="3" name="">
             <a:extLst xmlns:a="http://schemas.openxmlformats.org/drawingml/2006/main">
               <a:ext uri="{FF2B5EF4-FFF2-40B4-BE49-F238E27FC236}">
-                <a16:creationId xmlns:a16="http://schemas.microsoft.com/office/drawing/2014/main" id="{54EF3A24-4CED-4485-9BF1-78C14B7E26DD}"/>
+                <a16:creationId xmlns:a16="http://schemas.microsoft.com/office/drawing/2014/main" id="{14C84DEA-23C1-4871-8E5F-D00DD92B5C1A}"/>
               </a:ext>
             </a:extLst>
           </p:cNvPr>
@@ -6051,7 +5916,6 @@
           </a:lstStyle>
           <a:p xmlns:a="http://schemas.openxmlformats.org/drawingml/2006/main">
             <a:pPr algn="l">
-              <a:buNone/>
               <a:defRPr sz="1275" b="0">
                 <a:solidFill>
                   <a:srgbClr val="9FB1CA"/>
@@ -6080,7 +5944,7 @@
           <p:cNvPr id="4" name="">
             <a:extLst xmlns:a="http://schemas.openxmlformats.org/drawingml/2006/main">
               <a:ext uri="{FF2B5EF4-FFF2-40B4-BE49-F238E27FC236}">
-                <a16:creationId xmlns:a16="http://schemas.microsoft.com/office/drawing/2014/main" id="{82C4312A-6EA6-44B3-AC6F-D4C9747D4818}"/>
+                <a16:creationId xmlns:a16="http://schemas.microsoft.com/office/drawing/2014/main" id="{3D258B3D-8DFA-43E3-96A8-2197D82AD213}"/>
               </a:ext>
             </a:extLst>
           </p:cNvPr>
@@ -6111,7 +5975,7 @@
           <p:cNvPr id="5" name="">
             <a:extLst xmlns:a="http://schemas.openxmlformats.org/drawingml/2006/main">
               <a:ext uri="{FF2B5EF4-FFF2-40B4-BE49-F238E27FC236}">
-                <a16:creationId xmlns:a16="http://schemas.microsoft.com/office/drawing/2014/main" id="{E6BD944C-22C8-41C6-82D3-7079AA30D71D}"/>
+                <a16:creationId xmlns:a16="http://schemas.microsoft.com/office/drawing/2014/main" id="{7BFF3641-4E8F-446E-BBB8-15D95EC5905E}"/>
               </a:ext>
             </a:extLst>
           </p:cNvPr>
@@ -6146,7 +6010,7 @@
           <p:cNvPr id="6" name="">
             <a:extLst xmlns:a="http://schemas.openxmlformats.org/drawingml/2006/main">
               <a:ext uri="{FF2B5EF4-FFF2-40B4-BE49-F238E27FC236}">
-                <a16:creationId xmlns:a16="http://schemas.microsoft.com/office/drawing/2014/main" id="{ADDEF674-3D4C-49DA-8412-8A6AE03956E2}"/>
+                <a16:creationId xmlns:a16="http://schemas.microsoft.com/office/drawing/2014/main" id="{62A4E1CE-1C35-43C2-9F1F-5D198B530D85}"/>
               </a:ext>
             </a:extLst>
           </p:cNvPr>
@@ -6193,7 +6057,6 @@
           </a:lstStyle>
           <a:p xmlns:a="http://schemas.openxmlformats.org/drawingml/2006/main">
             <a:pPr algn="ctr">
-              <a:buNone/>
               <a:defRPr sz="1050" b="1">
                 <a:solidFill>
                   <a:srgbClr val="081426"/>
@@ -6222,7 +6085,7 @@
           <p:cNvPr id="7" name="">
             <a:extLst xmlns:a="http://schemas.openxmlformats.org/drawingml/2006/main">
               <a:ext uri="{FF2B5EF4-FFF2-40B4-BE49-F238E27FC236}">
-                <a16:creationId xmlns:a16="http://schemas.microsoft.com/office/drawing/2014/main" id="{259C0B77-4C84-41F7-9FE8-2E0C2B888326}"/>
+                <a16:creationId xmlns:a16="http://schemas.microsoft.com/office/drawing/2014/main" id="{6B3068BA-545D-45A6-81BD-73C7AED5C598}"/>
               </a:ext>
             </a:extLst>
           </p:cNvPr>
@@ -6262,7 +6125,6 @@
           </a:lstStyle>
           <a:p xmlns:a="http://schemas.openxmlformats.org/drawingml/2006/main">
             <a:pPr algn="l">
-              <a:buNone/>
               <a:defRPr sz="1275" b="1">
                 <a:solidFill>
                   <a:srgbClr val="F5F8FF"/>
@@ -6291,7 +6153,7 @@
           <p:cNvPr id="8" name="">
             <a:extLst xmlns:a="http://schemas.openxmlformats.org/drawingml/2006/main">
               <a:ext uri="{FF2B5EF4-FFF2-40B4-BE49-F238E27FC236}">
-                <a16:creationId xmlns:a16="http://schemas.microsoft.com/office/drawing/2014/main" id="{2225B447-69F5-4BE3-83AF-632D4CE59E41}"/>
+                <a16:creationId xmlns:a16="http://schemas.microsoft.com/office/drawing/2014/main" id="{8B1BAFF6-F225-438F-9446-9BE17A19F221}"/>
               </a:ext>
             </a:extLst>
           </p:cNvPr>
@@ -6331,7 +6193,6 @@
           </a:lstStyle>
           <a:p xmlns:a="http://schemas.openxmlformats.org/drawingml/2006/main">
             <a:pPr algn="ctr">
-              <a:buNone/>
               <a:defRPr sz="1200" b="0">
                 <a:solidFill>
                   <a:srgbClr val="9FB1CA"/>
@@ -6355,7 +6216,6 @@
           </a:p>
           <a:p xmlns:a="http://schemas.openxmlformats.org/drawingml/2006/main">
             <a:pPr algn="ctr">
-              <a:buNone/>
               <a:defRPr sz="1200" b="0">
                 <a:solidFill>
                   <a:srgbClr val="9FB1CA"/>
@@ -6384,7 +6244,7 @@
           <p:cNvPr id="9" name="">
             <a:extLst xmlns:a="http://schemas.openxmlformats.org/drawingml/2006/main">
               <a:ext uri="{FF2B5EF4-FFF2-40B4-BE49-F238E27FC236}">
-                <a16:creationId xmlns:a16="http://schemas.microsoft.com/office/drawing/2014/main" id="{FB163C2A-90FA-4511-9261-BDCA2228B3D4}"/>
+                <a16:creationId xmlns:a16="http://schemas.microsoft.com/office/drawing/2014/main" id="{3A8BC9D0-FADD-4137-B774-3E115C19EFCE}"/>
               </a:ext>
             </a:extLst>
           </p:cNvPr>
@@ -6416,7 +6276,7 @@
           <p:cNvPr id="10" name="">
             <a:extLst xmlns:a="http://schemas.openxmlformats.org/drawingml/2006/main">
               <a:ext uri="{FF2B5EF4-FFF2-40B4-BE49-F238E27FC236}">
-                <a16:creationId xmlns:a16="http://schemas.microsoft.com/office/drawing/2014/main" id="{C69A7CAD-85E8-44AC-AA06-2F43CC12A600}"/>
+                <a16:creationId xmlns:a16="http://schemas.microsoft.com/office/drawing/2014/main" id="{69404B72-49CC-4432-9D58-5AE4EB4E642B}"/>
               </a:ext>
             </a:extLst>
           </p:cNvPr>
@@ -6451,7 +6311,7 @@
           <p:cNvPr id="11" name="">
             <a:extLst xmlns:a="http://schemas.openxmlformats.org/drawingml/2006/main">
               <a:ext uri="{FF2B5EF4-FFF2-40B4-BE49-F238E27FC236}">
-                <a16:creationId xmlns:a16="http://schemas.microsoft.com/office/drawing/2014/main" id="{F6E28A13-7951-49D6-9171-E2428E553E5D}"/>
+                <a16:creationId xmlns:a16="http://schemas.microsoft.com/office/drawing/2014/main" id="{A8DF035B-952F-493D-A5CB-D637DFD2B01C}"/>
               </a:ext>
             </a:extLst>
           </p:cNvPr>
@@ -6498,7 +6358,6 @@
           </a:lstStyle>
           <a:p xmlns:a="http://schemas.openxmlformats.org/drawingml/2006/main">
             <a:pPr algn="ctr">
-              <a:buNone/>
               <a:defRPr sz="1050" b="1">
                 <a:solidFill>
                   <a:srgbClr val="081426"/>
@@ -6527,7 +6386,7 @@
           <p:cNvPr id="12" name="">
             <a:extLst xmlns:a="http://schemas.openxmlformats.org/drawingml/2006/main">
               <a:ext uri="{FF2B5EF4-FFF2-40B4-BE49-F238E27FC236}">
-                <a16:creationId xmlns:a16="http://schemas.microsoft.com/office/drawing/2014/main" id="{9B9EFDA9-E6DE-4804-BACE-39BF916D82C1}"/>
+                <a16:creationId xmlns:a16="http://schemas.microsoft.com/office/drawing/2014/main" id="{E6CA4D61-017C-4FA6-81CC-6C99AE020135}"/>
               </a:ext>
             </a:extLst>
           </p:cNvPr>
@@ -6567,7 +6426,6 @@
           </a:lstStyle>
           <a:p xmlns:a="http://schemas.openxmlformats.org/drawingml/2006/main">
             <a:pPr algn="l">
-              <a:buNone/>
               <a:defRPr sz="1275" b="1">
                 <a:solidFill>
                   <a:srgbClr val="F5F8FF"/>
@@ -6596,7 +6454,7 @@
           <p:cNvPr id="13" name="">
             <a:extLst xmlns:a="http://schemas.openxmlformats.org/drawingml/2006/main">
               <a:ext uri="{FF2B5EF4-FFF2-40B4-BE49-F238E27FC236}">
-                <a16:creationId xmlns:a16="http://schemas.microsoft.com/office/drawing/2014/main" id="{3647836E-5F98-436D-98E3-D05BEB582387}"/>
+                <a16:creationId xmlns:a16="http://schemas.microsoft.com/office/drawing/2014/main" id="{7E9F01DE-22DC-40D6-B6F4-A8A0CC97CBB9}"/>
               </a:ext>
             </a:extLst>
           </p:cNvPr>
@@ -6636,7 +6494,6 @@
           </a:lstStyle>
           <a:p xmlns:a="http://schemas.openxmlformats.org/drawingml/2006/main">
             <a:pPr algn="ctr">
-              <a:buNone/>
               <a:defRPr sz="1200" b="0">
                 <a:solidFill>
                   <a:srgbClr val="9FB1CA"/>
@@ -6660,7 +6517,6 @@
           </a:p>
           <a:p xmlns:a="http://schemas.openxmlformats.org/drawingml/2006/main">
             <a:pPr algn="ctr">
-              <a:buNone/>
               <a:defRPr sz="1200" b="0">
                 <a:solidFill>
                   <a:srgbClr val="9FB1CA"/>
@@ -6689,7 +6545,7 @@
           <p:cNvPr id="14" name="">
             <a:extLst xmlns:a="http://schemas.openxmlformats.org/drawingml/2006/main">
               <a:ext uri="{FF2B5EF4-FFF2-40B4-BE49-F238E27FC236}">
-                <a16:creationId xmlns:a16="http://schemas.microsoft.com/office/drawing/2014/main" id="{6A354986-9CB8-461C-B65F-EDA77501B9A6}"/>
+                <a16:creationId xmlns:a16="http://schemas.microsoft.com/office/drawing/2014/main" id="{4971690F-494C-44A8-B38D-26213021D94F}"/>
               </a:ext>
             </a:extLst>
           </p:cNvPr>
@@ -6721,7 +6577,7 @@
           <p:cNvPr id="15" name="">
             <a:extLst xmlns:a="http://schemas.openxmlformats.org/drawingml/2006/main">
               <a:ext uri="{FF2B5EF4-FFF2-40B4-BE49-F238E27FC236}">
-                <a16:creationId xmlns:a16="http://schemas.microsoft.com/office/drawing/2014/main" id="{8E68779E-8873-4963-95D6-26CC3BBCF642}"/>
+                <a16:creationId xmlns:a16="http://schemas.microsoft.com/office/drawing/2014/main" id="{91A9E85A-758E-4176-BA8B-1C30BABEDA26}"/>
               </a:ext>
             </a:extLst>
           </p:cNvPr>
@@ -6756,7 +6612,7 @@
           <p:cNvPr id="16" name="">
             <a:extLst xmlns:a="http://schemas.openxmlformats.org/drawingml/2006/main">
               <a:ext uri="{FF2B5EF4-FFF2-40B4-BE49-F238E27FC236}">
-                <a16:creationId xmlns:a16="http://schemas.microsoft.com/office/drawing/2014/main" id="{0FD27A0C-EBD9-48CF-AD1C-85959AB88864}"/>
+                <a16:creationId xmlns:a16="http://schemas.microsoft.com/office/drawing/2014/main" id="{E90ECC90-6E43-4A91-A0F1-FDD7F8EB57D8}"/>
               </a:ext>
             </a:extLst>
           </p:cNvPr>
@@ -6803,7 +6659,6 @@
           </a:lstStyle>
           <a:p xmlns:a="http://schemas.openxmlformats.org/drawingml/2006/main">
             <a:pPr algn="ctr">
-              <a:buNone/>
               <a:defRPr sz="1050" b="1">
                 <a:solidFill>
                   <a:srgbClr val="081426"/>
@@ -6832,7 +6687,7 @@
           <p:cNvPr id="17" name="">
             <a:extLst xmlns:a="http://schemas.openxmlformats.org/drawingml/2006/main">
               <a:ext uri="{FF2B5EF4-FFF2-40B4-BE49-F238E27FC236}">
-                <a16:creationId xmlns:a16="http://schemas.microsoft.com/office/drawing/2014/main" id="{1A5715D8-44DD-4CA0-A8B2-E6D4CF532B5D}"/>
+                <a16:creationId xmlns:a16="http://schemas.microsoft.com/office/drawing/2014/main" id="{1D1D9EA5-B940-430A-A1F0-D57FB81A2FE0}"/>
               </a:ext>
             </a:extLst>
           </p:cNvPr>
@@ -6872,7 +6727,6 @@
           </a:lstStyle>
           <a:p xmlns:a="http://schemas.openxmlformats.org/drawingml/2006/main">
             <a:pPr algn="l">
-              <a:buNone/>
               <a:defRPr sz="1275" b="1">
                 <a:solidFill>
                   <a:srgbClr val="F5F8FF"/>
@@ -6901,7 +6755,7 @@
           <p:cNvPr id="18" name="">
             <a:extLst xmlns:a="http://schemas.openxmlformats.org/drawingml/2006/main">
               <a:ext uri="{FF2B5EF4-FFF2-40B4-BE49-F238E27FC236}">
-                <a16:creationId xmlns:a16="http://schemas.microsoft.com/office/drawing/2014/main" id="{8E8A700A-1B99-4F48-B028-960976B004F3}"/>
+                <a16:creationId xmlns:a16="http://schemas.microsoft.com/office/drawing/2014/main" id="{86E6F6A2-3F68-4989-9931-80E2928D88D8}"/>
               </a:ext>
             </a:extLst>
           </p:cNvPr>
@@ -6941,7 +6795,6 @@
           </a:lstStyle>
           <a:p xmlns:a="http://schemas.openxmlformats.org/drawingml/2006/main">
             <a:pPr algn="ctr">
-              <a:buNone/>
               <a:defRPr sz="1200" b="0">
                 <a:solidFill>
                   <a:srgbClr val="9FB1CA"/>
@@ -6965,7 +6818,6 @@
           </a:p>
           <a:p xmlns:a="http://schemas.openxmlformats.org/drawingml/2006/main">
             <a:pPr algn="ctr">
-              <a:buNone/>
               <a:defRPr sz="1200" b="0">
                 <a:solidFill>
                   <a:srgbClr val="9FB1CA"/>
@@ -6994,7 +6846,7 @@
           <p:cNvPr id="19" name="">
             <a:extLst xmlns:a="http://schemas.openxmlformats.org/drawingml/2006/main">
               <a:ext uri="{FF2B5EF4-FFF2-40B4-BE49-F238E27FC236}">
-                <a16:creationId xmlns:a16="http://schemas.microsoft.com/office/drawing/2014/main" id="{2B8CFDD4-2E99-4373-A919-3675EF0F625C}"/>
+                <a16:creationId xmlns:a16="http://schemas.microsoft.com/office/drawing/2014/main" id="{8BB8A11B-0525-41C4-AAC5-78480EA3B62C}"/>
               </a:ext>
             </a:extLst>
           </p:cNvPr>
@@ -7026,7 +6878,7 @@
           <p:cNvPr id="20" name="">
             <a:extLst xmlns:a="http://schemas.openxmlformats.org/drawingml/2006/main">
               <a:ext uri="{FF2B5EF4-FFF2-40B4-BE49-F238E27FC236}">
-                <a16:creationId xmlns:a16="http://schemas.microsoft.com/office/drawing/2014/main" id="{AAA0010D-F5C6-4E17-A5AD-7E57B0692C4E}"/>
+                <a16:creationId xmlns:a16="http://schemas.microsoft.com/office/drawing/2014/main" id="{CB1B3755-AEEB-4A0F-913B-95872622F4D4}"/>
               </a:ext>
             </a:extLst>
           </p:cNvPr>
@@ -7061,7 +6913,7 @@
           <p:cNvPr id="21" name="">
             <a:extLst xmlns:a="http://schemas.openxmlformats.org/drawingml/2006/main">
               <a:ext uri="{FF2B5EF4-FFF2-40B4-BE49-F238E27FC236}">
-                <a16:creationId xmlns:a16="http://schemas.microsoft.com/office/drawing/2014/main" id="{E580D098-4F13-4C24-BAD8-43B992789A36}"/>
+                <a16:creationId xmlns:a16="http://schemas.microsoft.com/office/drawing/2014/main" id="{B1CCA6DF-714C-46FC-BE30-AA768B28D963}"/>
               </a:ext>
             </a:extLst>
           </p:cNvPr>
@@ -7108,7 +6960,6 @@
           </a:lstStyle>
           <a:p xmlns:a="http://schemas.openxmlformats.org/drawingml/2006/main">
             <a:pPr algn="ctr">
-              <a:buNone/>
               <a:defRPr sz="1050" b="1">
                 <a:solidFill>
                   <a:srgbClr val="081426"/>
@@ -7137,7 +6988,7 @@
           <p:cNvPr id="22" name="">
             <a:extLst xmlns:a="http://schemas.openxmlformats.org/drawingml/2006/main">
               <a:ext uri="{FF2B5EF4-FFF2-40B4-BE49-F238E27FC236}">
-                <a16:creationId xmlns:a16="http://schemas.microsoft.com/office/drawing/2014/main" id="{3FA43498-C6B0-49B3-B33C-09F79DC3B7D3}"/>
+                <a16:creationId xmlns:a16="http://schemas.microsoft.com/office/drawing/2014/main" id="{FFBEFD70-2680-4465-8701-CD56FE90AD03}"/>
               </a:ext>
             </a:extLst>
           </p:cNvPr>
@@ -7177,7 +7028,6 @@
           </a:lstStyle>
           <a:p xmlns:a="http://schemas.openxmlformats.org/drawingml/2006/main">
             <a:pPr algn="l">
-              <a:buNone/>
               <a:defRPr sz="1275" b="1">
                 <a:solidFill>
                   <a:srgbClr val="F5F8FF"/>
@@ -7206,7 +7056,7 @@
           <p:cNvPr id="23" name="">
             <a:extLst xmlns:a="http://schemas.openxmlformats.org/drawingml/2006/main">
               <a:ext uri="{FF2B5EF4-FFF2-40B4-BE49-F238E27FC236}">
-                <a16:creationId xmlns:a16="http://schemas.microsoft.com/office/drawing/2014/main" id="{3CF82815-01BF-49F2-9FC6-F3DE7D0B5DB0}"/>
+                <a16:creationId xmlns:a16="http://schemas.microsoft.com/office/drawing/2014/main" id="{A2476018-29DD-4B93-9069-26BC275AF7DD}"/>
               </a:ext>
             </a:extLst>
           </p:cNvPr>
@@ -7246,7 +7096,6 @@
           </a:lstStyle>
           <a:p xmlns:a="http://schemas.openxmlformats.org/drawingml/2006/main">
             <a:pPr algn="ctr">
-              <a:buNone/>
               <a:defRPr sz="1200" b="0">
                 <a:solidF